<commit_message>
Completa documentação e artefatos do cenário 4
</commit_message>
<xml_diff>
--- a/output/Apresentacao_Cenario_4.pptx
+++ b/output/Apresentacao_Cenario_4.pptx
@@ -2,26 +2,27 @@
 <file path=ppt/presentation.xml><?xml version="1.0" encoding="utf-8"?>
 <p:presentation xmlns:p="http://schemas.openxmlformats.org/presentationml/2006/main">
   <p:sldMasterIdLst>
-    <p:sldMasterId xmlns:r="http://schemas.openxmlformats.org/officeDocument/2006/relationships" id="2147483648" r:id="Reb6f5ffe7fdf45f3"/>
+    <p:sldMasterId xmlns:r="http://schemas.openxmlformats.org/officeDocument/2006/relationships" id="2147483648" r:id="Rb7d2d25d8e514389"/>
   </p:sldMasterIdLst>
   <p:notesMasterIdLst>
-    <p:notesMasterId xmlns:r="http://schemas.openxmlformats.org/officeDocument/2006/relationships" r:id="R5b731b2f051b4588"/>
+    <p:notesMasterId xmlns:r="http://schemas.openxmlformats.org/officeDocument/2006/relationships" r:id="Racffacf50a134154"/>
   </p:notesMasterIdLst>
   <p:sldIdLst>
-    <p:sldId xmlns:r="http://schemas.openxmlformats.org/officeDocument/2006/relationships" id="256" r:id="R87e54732273d4db3"/>
-    <p:sldId xmlns:r="http://schemas.openxmlformats.org/officeDocument/2006/relationships" id="257" r:id="R6bc14637d0ea4daf"/>
-    <p:sldId xmlns:r="http://schemas.openxmlformats.org/officeDocument/2006/relationships" id="258" r:id="Rfbd90fb79fc84548"/>
-    <p:sldId xmlns:r="http://schemas.openxmlformats.org/officeDocument/2006/relationships" id="259" r:id="Rc6547b9bc7994161"/>
-    <p:sldId xmlns:r="http://schemas.openxmlformats.org/officeDocument/2006/relationships" id="260" r:id="R52e8c99217c64ee3"/>
-    <p:sldId xmlns:r="http://schemas.openxmlformats.org/officeDocument/2006/relationships" id="261" r:id="R230a5c05c94e47b1"/>
-    <p:sldId xmlns:r="http://schemas.openxmlformats.org/officeDocument/2006/relationships" id="262" r:id="Rbd70372691a8450c"/>
-    <p:sldId xmlns:r="http://schemas.openxmlformats.org/officeDocument/2006/relationships" id="263" r:id="R9c0db81e27e34c54"/>
-    <p:sldId xmlns:r="http://schemas.openxmlformats.org/officeDocument/2006/relationships" id="264" r:id="R5318c6e3243942ff"/>
-    <p:sldId xmlns:r="http://schemas.openxmlformats.org/officeDocument/2006/relationships" id="265" r:id="R4a856d7bd93b4fd8"/>
-    <p:sldId xmlns:r="http://schemas.openxmlformats.org/officeDocument/2006/relationships" id="266" r:id="R02e8fa08567d4417"/>
-    <p:sldId xmlns:r="http://schemas.openxmlformats.org/officeDocument/2006/relationships" id="267" r:id="R03c1b51cda5c43b9"/>
-    <p:sldId xmlns:r="http://schemas.openxmlformats.org/officeDocument/2006/relationships" id="268" r:id="R05441a3bb5194558"/>
-    <p:sldId xmlns:r="http://schemas.openxmlformats.org/officeDocument/2006/relationships" id="269" r:id="R3b6935c9e5d3481a"/>
+    <p:sldId xmlns:r="http://schemas.openxmlformats.org/officeDocument/2006/relationships" id="256" r:id="R5d876cba77b64cd3"/>
+    <p:sldId xmlns:r="http://schemas.openxmlformats.org/officeDocument/2006/relationships" id="257" r:id="R18a8d225f8fa4e6c"/>
+    <p:sldId xmlns:r="http://schemas.openxmlformats.org/officeDocument/2006/relationships" id="258" r:id="Rd7a9fc273593449f"/>
+    <p:sldId xmlns:r="http://schemas.openxmlformats.org/officeDocument/2006/relationships" id="259" r:id="R1273e750469e4a55"/>
+    <p:sldId xmlns:r="http://schemas.openxmlformats.org/officeDocument/2006/relationships" id="260" r:id="R160a2cfa026f4bcd"/>
+    <p:sldId xmlns:r="http://schemas.openxmlformats.org/officeDocument/2006/relationships" id="261" r:id="Rf6d302c7173b4c55"/>
+    <p:sldId xmlns:r="http://schemas.openxmlformats.org/officeDocument/2006/relationships" id="262" r:id="R0584fdfbcca44af9"/>
+    <p:sldId xmlns:r="http://schemas.openxmlformats.org/officeDocument/2006/relationships" id="263" r:id="R458b4f597fb345d8"/>
+    <p:sldId xmlns:r="http://schemas.openxmlformats.org/officeDocument/2006/relationships" id="264" r:id="Raf43d392ae2149f9"/>
+    <p:sldId xmlns:r="http://schemas.openxmlformats.org/officeDocument/2006/relationships" id="265" r:id="R478b15ef94f645e2"/>
+    <p:sldId xmlns:r="http://schemas.openxmlformats.org/officeDocument/2006/relationships" id="266" r:id="Rfe1c7ae7d9fd4089"/>
+    <p:sldId xmlns:r="http://schemas.openxmlformats.org/officeDocument/2006/relationships" id="267" r:id="Ra20154a06f8642c5"/>
+    <p:sldId xmlns:r="http://schemas.openxmlformats.org/officeDocument/2006/relationships" id="268" r:id="R1721cd0d0aab4f8c"/>
+    <p:sldId xmlns:r="http://schemas.openxmlformats.org/officeDocument/2006/relationships" id="269" r:id="R8c8d77527fc343ef"/>
+    <p:sldId xmlns:r="http://schemas.openxmlformats.org/officeDocument/2006/relationships" id="270" r:id="R8469018e84304197"/>
   </p:sldIdLst>
   <p:sldSz cx="12192000" cy="6858000"/>
   <p:notesSz cx="6858000" cy="9144000"/>
@@ -805,7 +806,77 @@
           <a:lstStyle xmlns:a="http://schemas.openxmlformats.org/drawingml/2006/main"/>
           <a:p xmlns:a="http://schemas.openxmlformats.org/drawingml/2006/main">
             <a:r>
-              <a:t>Fonte: docs/EVIDENCIAS_VALIDACAO.md. Medição local em 12 de setembro de 2026 com 200 consultas de prontidão.</a:t>
+              <a:t>Fonte: docs/EVIDENCIAS_VALIDACAO.md. Medição local em 13 de setembro de 2026 com 200 consultas de prontidão.</a:t>
+            </a:r>
+          </a:p>
+        </p:txBody>
+      </p:sp>
+      <p:sp>
+        <p:nvSpPr>
+          <p:cNvPr id="4" name="Slide Number Placeholder 3"/>
+          <p:cNvSpPr>
+            <a:spLocks xmlns:a="http://schemas.openxmlformats.org/drawingml/2006/main" noGrp="1"/>
+          </p:cNvSpPr>
+          <p:nvPr>
+            <p:ph type="sldNum" idx="5"/>
+          </p:nvPr>
+        </p:nvSpPr>
+        <p:spPr/>
+        <p:txBody>
+          <a:bodyPr xmlns:a="http://schemas.openxmlformats.org/drawingml/2006/main"/>
+          <a:lstStyle xmlns:a="http://schemas.openxmlformats.org/drawingml/2006/main"/>
+          <a:p xmlns:a="http://schemas.openxmlformats.org/drawingml/2006/main"/>
+        </p:txBody>
+      </p:sp>
+    </p:spTree>
+  </p:cSld>
+  <p:clrMapOvr>
+    <a:masterClrMapping xmlns:a="http://schemas.openxmlformats.org/drawingml/2006/main"/>
+  </p:clrMapOvr>
+</p:notes>
+</file>
+
+<file path=ppt/notesSlides/notesSlide15.xml><?xml version="1.0" encoding="utf-8"?>
+<p:notes xmlns:p="http://schemas.openxmlformats.org/presentationml/2006/main">
+  <p:cSld>
+    <p:spTree>
+      <p:nvGrpSpPr>
+        <p:cNvPr id="1" name=""/>
+        <p:cNvGrpSpPr/>
+        <p:nvPr/>
+      </p:nvGrpSpPr>
+      <p:grpSpPr>
+        <a:xfrm xmlns:a="http://schemas.openxmlformats.org/drawingml/2006/main"/>
+      </p:grpSpPr>
+      <p:sp>
+        <p:nvSpPr>
+          <p:cNvPr id="2" name="Slide Image Placeholder 1"/>
+          <p:cNvSpPr>
+            <a:spLocks xmlns:a="http://schemas.openxmlformats.org/drawingml/2006/main" noGrp="1"/>
+          </p:cNvSpPr>
+          <p:nvPr>
+            <p:ph type="sldImg" idx="0"/>
+          </p:nvPr>
+        </p:nvSpPr>
+        <p:spPr/>
+      </p:sp>
+      <p:sp>
+        <p:nvSpPr>
+          <p:cNvPr id="3" name="Notes Placeholder 2"/>
+          <p:cNvSpPr>
+            <a:spLocks xmlns:a="http://schemas.openxmlformats.org/drawingml/2006/main" noGrp="1"/>
+          </p:cNvSpPr>
+          <p:nvPr>
+            <p:ph type="body" idx="1"/>
+          </p:nvPr>
+        </p:nvSpPr>
+        <p:spPr/>
+        <p:txBody>
+          <a:bodyPr xmlns:a="http://schemas.openxmlformats.org/drawingml/2006/main"/>
+          <a:lstStyle xmlns:a="http://schemas.openxmlformats.org/drawingml/2006/main"/>
+          <a:p xmlns:a="http://schemas.openxmlformats.org/drawingml/2006/main">
+            <a:r>
+              <a:t>Fonte: relatório técnico, seção 12, e docs/EVOLUCAO_MANUTENCAO.md. Inserir nomes e contribuições individuais antes da submissão.</a:t>
             </a:r>
           </a:p>
         </p:txBody>
@@ -1433,7 +1504,7 @@
   </p:cSld>
   <p:clrMap bg1="lt1" tx1="dk1" bg2="lt2" tx2="dk2" accent1="accent1" accent2="accent2" accent3="accent3" accent4="accent4" accent5="accent5" accent6="accent6" hlink="hlink" folHlink="folHlink"/>
   <p:sldLayoutIdLst>
-    <p:sldLayoutId xmlns:r="http://schemas.openxmlformats.org/officeDocument/2006/relationships" id="2147483649" r:id="R32444f6e6fee4a8e"/>
+    <p:sldLayoutId xmlns:r="http://schemas.openxmlformats.org/officeDocument/2006/relationships" id="2147483649" r:id="Rb4e71fcbe3b840b3"/>
   </p:sldLayoutIdLst>
   <p:txStyles>
     <p:titleStyle>
@@ -1984,7 +2055,7 @@
           <p:cNvPr id="5" name="">
             <a:extLst xmlns:a="http://schemas.openxmlformats.org/drawingml/2006/main">
               <a:ext uri="{FF2B5EF4-FFF2-40B4-BE49-F238E27FC236}">
-                <a16:creationId xmlns:a16="http://schemas.microsoft.com/office/drawing/2014/main" id="{2881B7B2-6956-4DDA-83E3-434BDFAC2A15}"/>
+                <a16:creationId xmlns:a16="http://schemas.microsoft.com/office/drawing/2014/main" id="{8B7EC844-7FD3-49B5-A6A9-26A7D0742D3D}"/>
               </a:ext>
             </a:extLst>
           </p:cNvPr>
@@ -2064,7 +2135,7 @@
           <p:cNvPr id="2" name="">
             <a:extLst xmlns:a="http://schemas.openxmlformats.org/drawingml/2006/main">
               <a:ext uri="{FF2B5EF4-FFF2-40B4-BE49-F238E27FC236}">
-                <a16:creationId xmlns:a16="http://schemas.microsoft.com/office/drawing/2014/main" id="{5423437A-DC49-4774-A91E-0A2A5AE04306}"/>
+                <a16:creationId xmlns:a16="http://schemas.microsoft.com/office/drawing/2014/main" id="{3A097520-940C-42B4-A51F-0BC01E330485}"/>
               </a:ext>
             </a:extLst>
           </p:cNvPr>
@@ -2121,7 +2192,7 @@
           <p:cNvPr id="3" name="">
             <a:extLst xmlns:a="http://schemas.openxmlformats.org/drawingml/2006/main">
               <a:ext uri="{FF2B5EF4-FFF2-40B4-BE49-F238E27FC236}">
-                <a16:creationId xmlns:a16="http://schemas.microsoft.com/office/drawing/2014/main" id="{0ED151B8-CAB8-40EE-A90C-19537E3E6CD7}"/>
+                <a16:creationId xmlns:a16="http://schemas.microsoft.com/office/drawing/2014/main" id="{8A946333-ADD3-4A8E-A008-3B4E973B75BE}"/>
               </a:ext>
             </a:extLst>
           </p:cNvPr>
@@ -2151,7 +2222,7 @@
           <p:cNvPr id="4" name="">
             <a:extLst xmlns:a="http://schemas.openxmlformats.org/drawingml/2006/main">
               <a:ext uri="{FF2B5EF4-FFF2-40B4-BE49-F238E27FC236}">
-                <a16:creationId xmlns:a16="http://schemas.microsoft.com/office/drawing/2014/main" id="{83572E54-AA30-4153-BB89-7EC224AC8548}"/>
+                <a16:creationId xmlns:a16="http://schemas.microsoft.com/office/drawing/2014/main" id="{46093CB3-0296-4630-987E-76B5302ECFC8}"/>
               </a:ext>
             </a:extLst>
           </p:cNvPr>
@@ -2221,7 +2292,7 @@
                 <a:ea typeface="Arial"/>
                 <a:cs typeface="Arial"/>
               </a:rPr>
-              <a:t>12 de setembro de 2026</a:t>
+              <a:t>14 de setembro de 2026</a:t>
             </a:r>
           </a:p>
         </p:txBody>
@@ -2229,7 +2300,7 @@
     </p:spTree>
     <p:extLst>
       <p:ext uri="{BB962C8B-B14F-4D97-AF65-F5344CB8AC3E}">
-        <p14:creationId xmlns:p14="http://schemas.microsoft.com/office/powerpoint/2010/main" val="91676072"/>
+        <p14:creationId xmlns:p14="http://schemas.microsoft.com/office/powerpoint/2010/main" val="1055820119"/>
       </p:ext>
     </p:extLst>
   </p:cSld>
@@ -2260,7 +2331,7 @@
           <p:cNvPr id="12" name="">
             <a:extLst xmlns:a="http://schemas.openxmlformats.org/drawingml/2006/main">
               <a:ext uri="{FF2B5EF4-FFF2-40B4-BE49-F238E27FC236}">
-                <a16:creationId xmlns:a16="http://schemas.microsoft.com/office/drawing/2014/main" id="{988E41BA-C591-4D8A-850A-103B38129E11}"/>
+                <a16:creationId xmlns:a16="http://schemas.microsoft.com/office/drawing/2014/main" id="{8F6D868E-598B-422C-B511-39AEE4473D9A}"/>
               </a:ext>
             </a:extLst>
           </p:cNvPr>
@@ -2290,7 +2361,7 @@
           <p:cNvPr id="2" name="">
             <a:extLst xmlns:a="http://schemas.openxmlformats.org/drawingml/2006/main">
               <a:ext uri="{FF2B5EF4-FFF2-40B4-BE49-F238E27FC236}">
-                <a16:creationId xmlns:a16="http://schemas.microsoft.com/office/drawing/2014/main" id="{DF21B21B-3025-4E23-A8CE-22EA6B29DDE0}"/>
+                <a16:creationId xmlns:a16="http://schemas.microsoft.com/office/drawing/2014/main" id="{18815DCC-0A74-4B58-A802-AFA78DED594F}"/>
               </a:ext>
             </a:extLst>
           </p:cNvPr>
@@ -2347,7 +2418,7 @@
           <p:cNvPr id="3" name="">
             <a:extLst xmlns:a="http://schemas.openxmlformats.org/drawingml/2006/main">
               <a:ext uri="{FF2B5EF4-FFF2-40B4-BE49-F238E27FC236}">
-                <a16:creationId xmlns:a16="http://schemas.microsoft.com/office/drawing/2014/main" id="{208D1D6C-EC4D-4B70-8DEC-C0CB1BB7973C}"/>
+                <a16:creationId xmlns:a16="http://schemas.microsoft.com/office/drawing/2014/main" id="{E46D94BA-E95F-45A6-8A1F-34A6A267E68C}"/>
               </a:ext>
             </a:extLst>
           </p:cNvPr>
@@ -2404,7 +2475,7 @@
           <p:cNvPr id="4" name="">
             <a:extLst xmlns:a="http://schemas.openxmlformats.org/drawingml/2006/main">
               <a:ext uri="{FF2B5EF4-FFF2-40B4-BE49-F238E27FC236}">
-                <a16:creationId xmlns:a16="http://schemas.microsoft.com/office/drawing/2014/main" id="{C92042C3-B929-4982-A5C4-A78428F98D16}"/>
+                <a16:creationId xmlns:a16="http://schemas.microsoft.com/office/drawing/2014/main" id="{E81CD4F4-EAAD-4659-BF92-1F26BE14F363}"/>
               </a:ext>
             </a:extLst>
           </p:cNvPr>
@@ -2491,7 +2562,7 @@
           <p:cNvPr id="5" name="">
             <a:extLst xmlns:a="http://schemas.openxmlformats.org/drawingml/2006/main">
               <a:ext uri="{FF2B5EF4-FFF2-40B4-BE49-F238E27FC236}">
-                <a16:creationId xmlns:a16="http://schemas.microsoft.com/office/drawing/2014/main" id="{6CF5EDB3-0504-4C45-8F79-C9CFD858C926}"/>
+                <a16:creationId xmlns:a16="http://schemas.microsoft.com/office/drawing/2014/main" id="{68CAC6E9-5EAC-42BA-8629-94132E465F3F}"/>
               </a:ext>
             </a:extLst>
           </p:cNvPr>
@@ -2578,7 +2649,7 @@
           <p:cNvPr id="6" name="">
             <a:extLst xmlns:a="http://schemas.openxmlformats.org/drawingml/2006/main">
               <a:ext uri="{FF2B5EF4-FFF2-40B4-BE49-F238E27FC236}">
-                <a16:creationId xmlns:a16="http://schemas.microsoft.com/office/drawing/2014/main" id="{E0D6D56F-FB96-4950-9BE5-387EEADA3E1D}"/>
+                <a16:creationId xmlns:a16="http://schemas.microsoft.com/office/drawing/2014/main" id="{1554CDC8-00F5-4EA7-902C-2550593E5693}"/>
               </a:ext>
             </a:extLst>
           </p:cNvPr>
@@ -2665,7 +2736,7 @@
           <p:cNvPr id="7" name="">
             <a:extLst xmlns:a="http://schemas.openxmlformats.org/drawingml/2006/main">
               <a:ext uri="{FF2B5EF4-FFF2-40B4-BE49-F238E27FC236}">
-                <a16:creationId xmlns:a16="http://schemas.microsoft.com/office/drawing/2014/main" id="{9F2FB0F4-690D-493A-AD44-DF3670D8C435}"/>
+                <a16:creationId xmlns:a16="http://schemas.microsoft.com/office/drawing/2014/main" id="{1407F8AC-2A20-4765-AD41-79CEB9737C87}"/>
               </a:ext>
             </a:extLst>
           </p:cNvPr>
@@ -2832,7 +2903,7 @@
           <p:cNvPr id="11" name="">
             <a:extLst xmlns:a="http://schemas.openxmlformats.org/drawingml/2006/main">
               <a:ext uri="{FF2B5EF4-FFF2-40B4-BE49-F238E27FC236}">
-                <a16:creationId xmlns:a16="http://schemas.microsoft.com/office/drawing/2014/main" id="{92464EC5-4EBC-41A2-A5DC-A09EC750144E}"/>
+                <a16:creationId xmlns:a16="http://schemas.microsoft.com/office/drawing/2014/main" id="{DFFF0E23-98B0-48DA-A7D1-B3FA2BB97D34}"/>
               </a:ext>
             </a:extLst>
           </p:cNvPr>
@@ -2887,7 +2958,7 @@
     </p:spTree>
     <p:extLst>
       <p:ext uri="{BB962C8B-B14F-4D97-AF65-F5344CB8AC3E}">
-        <p14:creationId xmlns:p14="http://schemas.microsoft.com/office/powerpoint/2010/main" val="1619565381"/>
+        <p14:creationId xmlns:p14="http://schemas.microsoft.com/office/powerpoint/2010/main" val="111170858"/>
       </p:ext>
     </p:extLst>
   </p:cSld>
@@ -2918,7 +2989,7 @@
           <p:cNvPr id="7" name="">
             <a:extLst xmlns:a="http://schemas.openxmlformats.org/drawingml/2006/main">
               <a:ext uri="{FF2B5EF4-FFF2-40B4-BE49-F238E27FC236}">
-                <a16:creationId xmlns:a16="http://schemas.microsoft.com/office/drawing/2014/main" id="{D7CCE6DD-C02D-45E7-A6F1-562FE310408B}"/>
+                <a16:creationId xmlns:a16="http://schemas.microsoft.com/office/drawing/2014/main" id="{9E25CF97-6FF6-4391-AAEB-B30EB9DCEA4B}"/>
               </a:ext>
             </a:extLst>
           </p:cNvPr>
@@ -2948,7 +3019,7 @@
           <p:cNvPr id="2" name="">
             <a:extLst xmlns:a="http://schemas.openxmlformats.org/drawingml/2006/main">
               <a:ext uri="{FF2B5EF4-FFF2-40B4-BE49-F238E27FC236}">
-                <a16:creationId xmlns:a16="http://schemas.microsoft.com/office/drawing/2014/main" id="{F7F06204-AF8D-409F-9AC7-8CD2598EEBA9}"/>
+                <a16:creationId xmlns:a16="http://schemas.microsoft.com/office/drawing/2014/main" id="{FE892535-8698-4343-A55E-FFE72B7FFCCD}"/>
               </a:ext>
             </a:extLst>
           </p:cNvPr>
@@ -3005,7 +3076,7 @@
           <p:cNvPr id="3" name="">
             <a:extLst xmlns:a="http://schemas.openxmlformats.org/drawingml/2006/main">
               <a:ext uri="{FF2B5EF4-FFF2-40B4-BE49-F238E27FC236}">
-                <a16:creationId xmlns:a16="http://schemas.microsoft.com/office/drawing/2014/main" id="{A94C82F2-7BDE-4E93-B735-DB8653FF8734}"/>
+                <a16:creationId xmlns:a16="http://schemas.microsoft.com/office/drawing/2014/main" id="{490DCCB2-0523-47E9-818A-FBB45A6D9F8F}"/>
               </a:ext>
             </a:extLst>
           </p:cNvPr>
@@ -3062,7 +3133,7 @@
           <p:cNvPr id="4" name="">
             <a:extLst xmlns:a="http://schemas.openxmlformats.org/drawingml/2006/main">
               <a:ext uri="{FF2B5EF4-FFF2-40B4-BE49-F238E27FC236}">
-                <a16:creationId xmlns:a16="http://schemas.microsoft.com/office/drawing/2014/main" id="{BCB54480-1183-4B3B-9DA7-F01B04493AA0}"/>
+                <a16:creationId xmlns:a16="http://schemas.microsoft.com/office/drawing/2014/main" id="{177F3C2C-F3B3-401D-AFDF-9C3E9E9B397D}"/>
               </a:ext>
             </a:extLst>
           </p:cNvPr>
@@ -3231,7 +3302,7 @@
           <p:cNvPr id="5" name="">
             <a:extLst xmlns:a="http://schemas.openxmlformats.org/drawingml/2006/main">
               <a:ext uri="{FF2B5EF4-FFF2-40B4-BE49-F238E27FC236}">
-                <a16:creationId xmlns:a16="http://schemas.microsoft.com/office/drawing/2014/main" id="{04324263-33A7-4301-B6B2-519C62B7DEA0}"/>
+                <a16:creationId xmlns:a16="http://schemas.microsoft.com/office/drawing/2014/main" id="{6AB42629-17A4-400D-BA09-776E48743ED5}"/>
               </a:ext>
             </a:extLst>
           </p:cNvPr>
@@ -3456,7 +3527,7 @@
           <p:cNvPr id="6" name="">
             <a:extLst xmlns:a="http://schemas.openxmlformats.org/drawingml/2006/main">
               <a:ext uri="{FF2B5EF4-FFF2-40B4-BE49-F238E27FC236}">
-                <a16:creationId xmlns:a16="http://schemas.microsoft.com/office/drawing/2014/main" id="{C7D1BAC5-9EA9-481B-A051-AAA7DED34451}"/>
+                <a16:creationId xmlns:a16="http://schemas.microsoft.com/office/drawing/2014/main" id="{2C5BEF2B-7203-4FFA-B415-F0BB8B935864}"/>
               </a:ext>
             </a:extLst>
           </p:cNvPr>
@@ -3511,7 +3582,7 @@
     </p:spTree>
     <p:extLst>
       <p:ext uri="{BB962C8B-B14F-4D97-AF65-F5344CB8AC3E}">
-        <p14:creationId xmlns:p14="http://schemas.microsoft.com/office/powerpoint/2010/main" val="355158503"/>
+        <p14:creationId xmlns:p14="http://schemas.microsoft.com/office/powerpoint/2010/main" val="78602995"/>
       </p:ext>
     </p:extLst>
   </p:cSld>
@@ -3542,7 +3613,7 @@
           <p:cNvPr id="11" name="">
             <a:extLst xmlns:a="http://schemas.openxmlformats.org/drawingml/2006/main">
               <a:ext uri="{FF2B5EF4-FFF2-40B4-BE49-F238E27FC236}">
-                <a16:creationId xmlns:a16="http://schemas.microsoft.com/office/drawing/2014/main" id="{92E38623-3C28-4FC9-AF45-7C5CF6C39FC8}"/>
+                <a16:creationId xmlns:a16="http://schemas.microsoft.com/office/drawing/2014/main" id="{B3E4E630-6F9B-48A9-A933-B458A2EC1C3C}"/>
               </a:ext>
             </a:extLst>
           </p:cNvPr>
@@ -3572,7 +3643,7 @@
           <p:cNvPr id="2" name="">
             <a:extLst xmlns:a="http://schemas.openxmlformats.org/drawingml/2006/main">
               <a:ext uri="{FF2B5EF4-FFF2-40B4-BE49-F238E27FC236}">
-                <a16:creationId xmlns:a16="http://schemas.microsoft.com/office/drawing/2014/main" id="{5807D7CC-D9B4-4F8E-8E25-EC19B6A8E789}"/>
+                <a16:creationId xmlns:a16="http://schemas.microsoft.com/office/drawing/2014/main" id="{2F3F4352-BC8A-4ACB-B405-41924EF31064}"/>
               </a:ext>
             </a:extLst>
           </p:cNvPr>
@@ -3629,7 +3700,7 @@
           <p:cNvPr id="3" name="">
             <a:extLst xmlns:a="http://schemas.openxmlformats.org/drawingml/2006/main">
               <a:ext uri="{FF2B5EF4-FFF2-40B4-BE49-F238E27FC236}">
-                <a16:creationId xmlns:a16="http://schemas.microsoft.com/office/drawing/2014/main" id="{9B51B61B-21C3-4050-9EF9-63F06DF62308}"/>
+                <a16:creationId xmlns:a16="http://schemas.microsoft.com/office/drawing/2014/main" id="{B65A4CB1-0A9E-4ACE-822A-B7BF471F5222}"/>
               </a:ext>
             </a:extLst>
           </p:cNvPr>
@@ -3686,7 +3757,7 @@
           <p:cNvPr id="4" name="">
             <a:extLst xmlns:a="http://schemas.openxmlformats.org/drawingml/2006/main">
               <a:ext uri="{FF2B5EF4-FFF2-40B4-BE49-F238E27FC236}">
-                <a16:creationId xmlns:a16="http://schemas.microsoft.com/office/drawing/2014/main" id="{B89B7D31-9DB4-4D61-9906-545437023B9D}"/>
+                <a16:creationId xmlns:a16="http://schemas.microsoft.com/office/drawing/2014/main" id="{7414B718-760F-465E-8204-D4FEE96428A5}"/>
               </a:ext>
             </a:extLst>
           </p:cNvPr>
@@ -3743,7 +3814,7 @@
           <p:cNvPr id="5" name="">
             <a:extLst xmlns:a="http://schemas.openxmlformats.org/drawingml/2006/main">
               <a:ext uri="{FF2B5EF4-FFF2-40B4-BE49-F238E27FC236}">
-                <a16:creationId xmlns:a16="http://schemas.microsoft.com/office/drawing/2014/main" id="{DF8B1AEB-BAC8-4789-9ACD-F6614570EF1F}"/>
+                <a16:creationId xmlns:a16="http://schemas.microsoft.com/office/drawing/2014/main" id="{3B17E4E0-13CE-4218-9C4F-8CA492C74A57}"/>
               </a:ext>
             </a:extLst>
           </p:cNvPr>
@@ -3858,7 +3929,7 @@
           <p:cNvPr id="6" name="">
             <a:extLst xmlns:a="http://schemas.openxmlformats.org/drawingml/2006/main">
               <a:ext uri="{FF2B5EF4-FFF2-40B4-BE49-F238E27FC236}">
-                <a16:creationId xmlns:a16="http://schemas.microsoft.com/office/drawing/2014/main" id="{33034AAA-932D-4B83-93B9-5A3C546653B6}"/>
+                <a16:creationId xmlns:a16="http://schemas.microsoft.com/office/drawing/2014/main" id="{B4EB9413-3749-4AE2-AEF3-05B863978CFB}"/>
               </a:ext>
             </a:extLst>
           </p:cNvPr>
@@ -3915,7 +3986,7 @@
           <p:cNvPr id="7" name="">
             <a:extLst xmlns:a="http://schemas.openxmlformats.org/drawingml/2006/main">
               <a:ext uri="{FF2B5EF4-FFF2-40B4-BE49-F238E27FC236}">
-                <a16:creationId xmlns:a16="http://schemas.microsoft.com/office/drawing/2014/main" id="{E370ED06-ABA5-4C58-9CD1-80B1C6241C4E}"/>
+                <a16:creationId xmlns:a16="http://schemas.microsoft.com/office/drawing/2014/main" id="{48339A7C-B609-484C-964D-D31B9674DC99}"/>
               </a:ext>
             </a:extLst>
           </p:cNvPr>
@@ -4030,7 +4101,7 @@
           <p:cNvPr id="8" name="">
             <a:extLst xmlns:a="http://schemas.openxmlformats.org/drawingml/2006/main">
               <a:ext uri="{FF2B5EF4-FFF2-40B4-BE49-F238E27FC236}">
-                <a16:creationId xmlns:a16="http://schemas.microsoft.com/office/drawing/2014/main" id="{2A6C4AB1-A17D-4A7F-B904-8752EC4264D2}"/>
+                <a16:creationId xmlns:a16="http://schemas.microsoft.com/office/drawing/2014/main" id="{312B5B1B-FD0E-49B5-87FD-5C02437067DE}"/>
               </a:ext>
             </a:extLst>
           </p:cNvPr>
@@ -4087,7 +4158,7 @@
           <p:cNvPr id="9" name="">
             <a:extLst xmlns:a="http://schemas.openxmlformats.org/drawingml/2006/main">
               <a:ext uri="{FF2B5EF4-FFF2-40B4-BE49-F238E27FC236}">
-                <a16:creationId xmlns:a16="http://schemas.microsoft.com/office/drawing/2014/main" id="{4EE7C952-28D2-44C8-91AD-471E1CBE94C2}"/>
+                <a16:creationId xmlns:a16="http://schemas.microsoft.com/office/drawing/2014/main" id="{A8E2385D-6982-4021-999D-4B3D6FD1314D}"/>
               </a:ext>
             </a:extLst>
           </p:cNvPr>
@@ -4202,7 +4273,7 @@
           <p:cNvPr id="10" name="">
             <a:extLst xmlns:a="http://schemas.openxmlformats.org/drawingml/2006/main">
               <a:ext uri="{FF2B5EF4-FFF2-40B4-BE49-F238E27FC236}">
-                <a16:creationId xmlns:a16="http://schemas.microsoft.com/office/drawing/2014/main" id="{67913DD0-43D3-4037-A338-6B41CF855988}"/>
+                <a16:creationId xmlns:a16="http://schemas.microsoft.com/office/drawing/2014/main" id="{9F5DCB19-E889-4B0D-9864-12D70E0661ED}"/>
               </a:ext>
             </a:extLst>
           </p:cNvPr>
@@ -4257,7 +4328,7 @@
     </p:spTree>
     <p:extLst>
       <p:ext uri="{BB962C8B-B14F-4D97-AF65-F5344CB8AC3E}">
-        <p14:creationId xmlns:p14="http://schemas.microsoft.com/office/powerpoint/2010/main" val="1776717367"/>
+        <p14:creationId xmlns:p14="http://schemas.microsoft.com/office/powerpoint/2010/main" val="1056358265"/>
       </p:ext>
     </p:extLst>
   </p:cSld>
@@ -4288,7 +4359,7 @@
           <p:cNvPr id="7" name="">
             <a:extLst xmlns:a="http://schemas.openxmlformats.org/drawingml/2006/main">
               <a:ext uri="{FF2B5EF4-FFF2-40B4-BE49-F238E27FC236}">
-                <a16:creationId xmlns:a16="http://schemas.microsoft.com/office/drawing/2014/main" id="{52084CF8-88A1-47D3-BD05-41CA9D05EA90}"/>
+                <a16:creationId xmlns:a16="http://schemas.microsoft.com/office/drawing/2014/main" id="{6A97583C-D029-4A23-AE52-87E1C32B394D}"/>
               </a:ext>
             </a:extLst>
           </p:cNvPr>
@@ -4318,7 +4389,7 @@
           <p:cNvPr id="2" name="">
             <a:extLst xmlns:a="http://schemas.openxmlformats.org/drawingml/2006/main">
               <a:ext uri="{FF2B5EF4-FFF2-40B4-BE49-F238E27FC236}">
-                <a16:creationId xmlns:a16="http://schemas.microsoft.com/office/drawing/2014/main" id="{3900B9CF-09CF-4A07-A915-78A10E3C7F19}"/>
+                <a16:creationId xmlns:a16="http://schemas.microsoft.com/office/drawing/2014/main" id="{51D90636-08A3-4D80-A46E-FEBC7D8BCF64}"/>
               </a:ext>
             </a:extLst>
           </p:cNvPr>
@@ -4375,7 +4446,7 @@
           <p:cNvPr id="3" name="">
             <a:extLst xmlns:a="http://schemas.openxmlformats.org/drawingml/2006/main">
               <a:ext uri="{FF2B5EF4-FFF2-40B4-BE49-F238E27FC236}">
-                <a16:creationId xmlns:a16="http://schemas.microsoft.com/office/drawing/2014/main" id="{E339E806-7023-46C5-A666-4879BBC95438}"/>
+                <a16:creationId xmlns:a16="http://schemas.microsoft.com/office/drawing/2014/main" id="{2370F074-A5E7-4AE9-966D-D111F3CE6A1A}"/>
               </a:ext>
             </a:extLst>
           </p:cNvPr>
@@ -4432,7 +4503,7 @@
           <p:cNvPr id="4" name="">
             <a:extLst xmlns:a="http://schemas.openxmlformats.org/drawingml/2006/main">
               <a:ext uri="{FF2B5EF4-FFF2-40B4-BE49-F238E27FC236}">
-                <a16:creationId xmlns:a16="http://schemas.microsoft.com/office/drawing/2014/main" id="{C89D0A42-CA7E-416F-B9EC-E290E88F5A79}"/>
+                <a16:creationId xmlns:a16="http://schemas.microsoft.com/office/drawing/2014/main" id="{E7B73979-387F-4331-923E-35F197050D41}"/>
               </a:ext>
             </a:extLst>
           </p:cNvPr>
@@ -4601,7 +4672,7 @@
           <p:cNvPr id="5" name="">
             <a:extLst xmlns:a="http://schemas.openxmlformats.org/drawingml/2006/main">
               <a:ext uri="{FF2B5EF4-FFF2-40B4-BE49-F238E27FC236}">
-                <a16:creationId xmlns:a16="http://schemas.microsoft.com/office/drawing/2014/main" id="{D0D404C2-04E4-4F20-AA55-51CB63AED977}"/>
+                <a16:creationId xmlns:a16="http://schemas.microsoft.com/office/drawing/2014/main" id="{841AF3FF-7DF9-4970-9667-710E315C3DB3}"/>
               </a:ext>
             </a:extLst>
           </p:cNvPr>
@@ -4658,7 +4729,7 @@
           <p:cNvPr id="6" name="">
             <a:extLst xmlns:a="http://schemas.openxmlformats.org/drawingml/2006/main">
               <a:ext uri="{FF2B5EF4-FFF2-40B4-BE49-F238E27FC236}">
-                <a16:creationId xmlns:a16="http://schemas.microsoft.com/office/drawing/2014/main" id="{65BF8681-ABAE-4789-B11D-C16565315B58}"/>
+                <a16:creationId xmlns:a16="http://schemas.microsoft.com/office/drawing/2014/main" id="{09FC565B-9A33-49D0-A4B8-D4B6C82E5E9A}"/>
               </a:ext>
             </a:extLst>
           </p:cNvPr>
@@ -4825,7 +4896,7 @@
     </p:spTree>
     <p:extLst>
       <p:ext uri="{BB962C8B-B14F-4D97-AF65-F5344CB8AC3E}">
-        <p14:creationId xmlns:p14="http://schemas.microsoft.com/office/powerpoint/2010/main" val="1858702115"/>
+        <p14:creationId xmlns:p14="http://schemas.microsoft.com/office/powerpoint/2010/main" val="551531060"/>
       </p:ext>
     </p:extLst>
   </p:cSld>
@@ -4856,7 +4927,7 @@
           <p:cNvPr id="8" name="">
             <a:extLst xmlns:a="http://schemas.openxmlformats.org/drawingml/2006/main">
               <a:ext uri="{FF2B5EF4-FFF2-40B4-BE49-F238E27FC236}">
-                <a16:creationId xmlns:a16="http://schemas.microsoft.com/office/drawing/2014/main" id="{D95F3B1E-2443-4929-9FED-E4EEA9A1E213}"/>
+                <a16:creationId xmlns:a16="http://schemas.microsoft.com/office/drawing/2014/main" id="{6A4F77D3-1911-4D99-A523-E26207620F6D}"/>
               </a:ext>
             </a:extLst>
           </p:cNvPr>
@@ -4886,7 +4957,7 @@
           <p:cNvPr id="2" name="">
             <a:extLst xmlns:a="http://schemas.openxmlformats.org/drawingml/2006/main">
               <a:ext uri="{FF2B5EF4-FFF2-40B4-BE49-F238E27FC236}">
-                <a16:creationId xmlns:a16="http://schemas.microsoft.com/office/drawing/2014/main" id="{E7E4A04D-423C-4B8F-AC13-E2E70453E2B4}"/>
+                <a16:creationId xmlns:a16="http://schemas.microsoft.com/office/drawing/2014/main" id="{19F080F1-3C8B-4A64-B66E-830A906AA835}"/>
               </a:ext>
             </a:extLst>
           </p:cNvPr>
@@ -4943,7 +5014,7 @@
           <p:cNvPr id="3" name="">
             <a:extLst xmlns:a="http://schemas.openxmlformats.org/drawingml/2006/main">
               <a:ext uri="{FF2B5EF4-FFF2-40B4-BE49-F238E27FC236}">
-                <a16:creationId xmlns:a16="http://schemas.microsoft.com/office/drawing/2014/main" id="{D4EAD8C5-2F16-4DA8-BE9D-46E5B992AB20}"/>
+                <a16:creationId xmlns:a16="http://schemas.microsoft.com/office/drawing/2014/main" id="{9C6FC782-3E0B-4970-8B7C-BCA2E4A9BFDB}"/>
               </a:ext>
             </a:extLst>
           </p:cNvPr>
@@ -5000,7 +5071,7 @@
           <p:cNvPr id="4" name="">
             <a:extLst xmlns:a="http://schemas.openxmlformats.org/drawingml/2006/main">
               <a:ext uri="{FF2B5EF4-FFF2-40B4-BE49-F238E27FC236}">
-                <a16:creationId xmlns:a16="http://schemas.microsoft.com/office/drawing/2014/main" id="{5D1D7621-FB61-49FD-A156-F815DB4C20C7}"/>
+                <a16:creationId xmlns:a16="http://schemas.microsoft.com/office/drawing/2014/main" id="{74A062A0-463F-4F62-8CF9-27886F05E6CD}"/>
               </a:ext>
             </a:extLst>
           </p:cNvPr>
@@ -5012,7 +5083,7 @@
         <p:spPr>
           <a:xfrm xmlns:a="http://schemas.openxmlformats.org/drawingml/2006/main">
             <a:off x="1000125" y="1381125"/>
-            <a:ext cx="3429000" cy="571500"/>
+            <a:ext cx="3619500" cy="571500"/>
           </a:xfrm>
           <a:prstGeom xmlns:a="http://schemas.openxmlformats.org/drawingml/2006/main" prst="rect">
             <a:avLst/>
@@ -5047,7 +5118,7 @@
                 <a:ea typeface="Arial"/>
                 <a:cs typeface="Arial"/>
               </a:rPr>
-              <a:t>11 testes aprovados</a:t>
+              <a:t>13 testes aprovados</a:t>
             </a:r>
           </a:p>
         </p:txBody>
@@ -5057,7 +5128,7 @@
           <p:cNvPr id="5" name="">
             <a:extLst xmlns:a="http://schemas.openxmlformats.org/drawingml/2006/main">
               <a:ext uri="{FF2B5EF4-FFF2-40B4-BE49-F238E27FC236}">
-                <a16:creationId xmlns:a16="http://schemas.microsoft.com/office/drawing/2014/main" id="{67AA9F35-A24C-41FD-900F-613C95F741E5}"/>
+                <a16:creationId xmlns:a16="http://schemas.microsoft.com/office/drawing/2014/main" id="{30495FDD-4C09-4094-B721-9545E3602A27}"/>
               </a:ext>
             </a:extLst>
           </p:cNvPr>
@@ -5104,7 +5175,7 @@
                 <a:ea typeface="Arial"/>
                 <a:cs typeface="Arial"/>
               </a:rPr>
-              <a:t>p95  4,75 ms</a:t>
+              <a:t>p95  6,36 ms</a:t>
             </a:r>
           </a:p>
         </p:txBody>
@@ -5114,7 +5185,7 @@
           <p:cNvPr id="6" name="">
             <a:extLst xmlns:a="http://schemas.openxmlformats.org/drawingml/2006/main">
               <a:ext uri="{FF2B5EF4-FFF2-40B4-BE49-F238E27FC236}">
-                <a16:creationId xmlns:a16="http://schemas.microsoft.com/office/drawing/2014/main" id="{5E002D2A-E02D-4243-8AE0-6EE8E7D54285}"/>
+                <a16:creationId xmlns:a16="http://schemas.microsoft.com/office/drawing/2014/main" id="{5D0B36EB-D99E-4EF9-8494-C7BC3B8DC507}"/>
               </a:ext>
             </a:extLst>
           </p:cNvPr>
@@ -5283,7 +5354,7 @@
           <p:cNvPr id="7" name="">
             <a:extLst xmlns:a="http://schemas.openxmlformats.org/drawingml/2006/main">
               <a:ext uri="{FF2B5EF4-FFF2-40B4-BE49-F238E27FC236}">
-                <a16:creationId xmlns:a16="http://schemas.microsoft.com/office/drawing/2014/main" id="{50D5B6FA-A2F7-4D9D-87C0-0EE27EE2FBE1}"/>
+                <a16:creationId xmlns:a16="http://schemas.microsoft.com/office/drawing/2014/main" id="{3C7B0C12-4443-49E1-A05C-0AE7BC4D3408}"/>
               </a:ext>
             </a:extLst>
           </p:cNvPr>
@@ -5338,7 +5409,581 @@
     </p:spTree>
     <p:extLst>
       <p:ext uri="{BB962C8B-B14F-4D97-AF65-F5344CB8AC3E}">
-        <p14:creationId xmlns:p14="http://schemas.microsoft.com/office/powerpoint/2010/main" val="241616658"/>
+        <p14:creationId xmlns:p14="http://schemas.microsoft.com/office/powerpoint/2010/main" val="23501630"/>
+      </p:ext>
+    </p:extLst>
+  </p:cSld>
+</p:sld>
+</file>
+
+<file path=ppt/slides/slide15.xml><?xml version="1.0" encoding="utf-8"?>
+<p:sld xmlns:p="http://schemas.openxmlformats.org/presentationml/2006/main">
+  <p:cSld>
+    <p:bg>
+      <p:bgPr>
+        <a:solidFill xmlns:a="http://schemas.openxmlformats.org/drawingml/2006/main">
+          <a:srgbClr val="FFFFFF"/>
+        </a:solidFill>
+      </p:bgPr>
+    </p:bg>
+    <p:spTree>
+      <p:nvGrpSpPr>
+        <p:cNvPr id="1" name=""/>
+        <p:cNvGrpSpPr/>
+        <p:nvPr/>
+      </p:nvGrpSpPr>
+      <p:grpSpPr>
+        <a:xfrm xmlns:a="http://schemas.openxmlformats.org/drawingml/2006/main"/>
+      </p:grpSpPr>
+      <p:sp>
+        <p:nvSpPr>
+          <p:cNvPr id="9" name="">
+            <a:extLst xmlns:a="http://schemas.openxmlformats.org/drawingml/2006/main">
+              <a:ext uri="{FF2B5EF4-FFF2-40B4-BE49-F238E27FC236}">
+                <a16:creationId xmlns:a16="http://schemas.microsoft.com/office/drawing/2014/main" id="{8F83F70E-DFC2-4C78-9586-119844439363}"/>
+              </a:ext>
+            </a:extLst>
+          </p:cNvPr>
+          <p:cNvSpPr>
+            <a:spLocks xmlns:a="http://schemas.openxmlformats.org/drawingml/2006/main" noGrp="1"/>
+          </p:cNvSpPr>
+          <p:nvPr/>
+        </p:nvSpPr>
+        <p:spPr>
+          <a:xfrm xmlns:a="http://schemas.openxmlformats.org/drawingml/2006/main">
+            <a:off x="0" y="0"/>
+            <a:ext cx="209550" cy="6858000"/>
+          </a:xfrm>
+          <a:prstGeom xmlns:a="http://schemas.openxmlformats.org/drawingml/2006/main" prst="rect">
+            <a:avLst/>
+          </a:prstGeom>
+          <a:solidFill xmlns:a="http://schemas.openxmlformats.org/drawingml/2006/main">
+            <a:srgbClr val="227C83"/>
+          </a:solidFill>
+          <a:ln xmlns:a="http://schemas.openxmlformats.org/drawingml/2006/main" w="0">
+            <a:noFill/>
+          </a:ln>
+        </p:spPr>
+      </p:sp>
+      <p:sp>
+        <p:nvSpPr>
+          <p:cNvPr id="2" name="">
+            <a:extLst xmlns:a="http://schemas.openxmlformats.org/drawingml/2006/main">
+              <a:ext uri="{FF2B5EF4-FFF2-40B4-BE49-F238E27FC236}">
+                <a16:creationId xmlns:a16="http://schemas.microsoft.com/office/drawing/2014/main" id="{73535231-CEC4-4593-A874-727B4744E617}"/>
+              </a:ext>
+            </a:extLst>
+          </p:cNvPr>
+          <p:cNvSpPr>
+            <a:spLocks xmlns:a="http://schemas.openxmlformats.org/drawingml/2006/main" noGrp="1"/>
+          </p:cNvSpPr>
+          <p:nvPr/>
+        </p:nvSpPr>
+        <p:spPr>
+          <a:xfrm xmlns:a="http://schemas.openxmlformats.org/drawingml/2006/main">
+            <a:off x="666750" y="361950"/>
+            <a:ext cx="10572750" cy="647700"/>
+          </a:xfrm>
+          <a:prstGeom xmlns:a="http://schemas.openxmlformats.org/drawingml/2006/main" prst="rect">
+            <a:avLst/>
+          </a:prstGeom>
+          <a:noFill xmlns:a="http://schemas.openxmlformats.org/drawingml/2006/main"/>
+          <a:ln xmlns:a="http://schemas.openxmlformats.org/drawingml/2006/main" w="0">
+            <a:noFill/>
+          </a:ln>
+        </p:spPr>
+        <p:txBody>
+          <a:bodyPr xmlns:a="http://schemas.openxmlformats.org/drawingml/2006/main">
+            <a:noAutofit/>
+          </a:bodyPr>
+          <a:lstStyle xmlns:a="http://schemas.openxmlformats.org/drawingml/2006/main"/>
+          <a:p xmlns:a="http://schemas.openxmlformats.org/drawingml/2006/main">
+            <a:pPr>
+              <a:defRPr sz="3150" b="1">
+                <a:solidFill>
+                  <a:srgbClr val="17365D"/>
+                </a:solidFill>
+                <a:latin typeface="Arial"/>
+                <a:ea typeface="Arial"/>
+                <a:cs typeface="Arial"/>
+              </a:defRPr>
+            </a:pPr>
+            <a:r>
+              <a:rPr sz="3150" b="1">
+                <a:solidFill>
+                  <a:srgbClr val="17365D"/>
+                </a:solidFill>
+                <a:latin typeface="Arial"/>
+                <a:ea typeface="Arial"/>
+                <a:cs typeface="Arial"/>
+              </a:rPr>
+              <a:t>Conclusões e próximos passos</a:t>
+            </a:r>
+          </a:p>
+        </p:txBody>
+      </p:sp>
+      <p:sp>
+        <p:nvSpPr>
+          <p:cNvPr id="3" name="">
+            <a:extLst xmlns:a="http://schemas.openxmlformats.org/drawingml/2006/main">
+              <a:ext uri="{FF2B5EF4-FFF2-40B4-BE49-F238E27FC236}">
+                <a16:creationId xmlns:a16="http://schemas.microsoft.com/office/drawing/2014/main" id="{62411538-AAA3-4F14-9FF3-3C348D0368D7}"/>
+              </a:ext>
+            </a:extLst>
+          </p:cNvPr>
+          <p:cNvSpPr>
+            <a:spLocks xmlns:a="http://schemas.openxmlformats.org/drawingml/2006/main" noGrp="1"/>
+          </p:cNvSpPr>
+          <p:nvPr/>
+        </p:nvSpPr>
+        <p:spPr>
+          <a:xfrm xmlns:a="http://schemas.openxmlformats.org/drawingml/2006/main">
+            <a:off x="685800" y="6419850"/>
+            <a:ext cx="10287000" cy="228600"/>
+          </a:xfrm>
+          <a:prstGeom xmlns:a="http://schemas.openxmlformats.org/drawingml/2006/main" prst="rect">
+            <a:avLst/>
+          </a:prstGeom>
+          <a:noFill xmlns:a="http://schemas.openxmlformats.org/drawingml/2006/main"/>
+          <a:ln xmlns:a="http://schemas.openxmlformats.org/drawingml/2006/main" w="0">
+            <a:noFill/>
+          </a:ln>
+        </p:spPr>
+        <p:txBody>
+          <a:bodyPr xmlns:a="http://schemas.openxmlformats.org/drawingml/2006/main">
+            <a:noAutofit/>
+          </a:bodyPr>
+          <a:lstStyle xmlns:a="http://schemas.openxmlformats.org/drawingml/2006/main"/>
+          <a:p xmlns:a="http://schemas.openxmlformats.org/drawingml/2006/main">
+            <a:pPr>
+              <a:defRPr sz="1200">
+                <a:solidFill>
+                  <a:srgbClr val="657786"/>
+                </a:solidFill>
+                <a:latin typeface="Arial"/>
+                <a:ea typeface="Arial"/>
+                <a:cs typeface="Arial"/>
+              </a:defRPr>
+            </a:pPr>
+            <a:r>
+              <a:rPr sz="1200">
+                <a:solidFill>
+                  <a:srgbClr val="657786"/>
+                </a:solidFill>
+                <a:latin typeface="Arial"/>
+                <a:ea typeface="Arial"/>
+                <a:cs typeface="Arial"/>
+              </a:rPr>
+              <a:t>Projeto Aplicado Cenário 4</a:t>
+            </a:r>
+          </a:p>
+        </p:txBody>
+      </p:sp>
+      <p:sp>
+        <p:nvSpPr>
+          <p:cNvPr id="4" name="">
+            <a:extLst xmlns:a="http://schemas.openxmlformats.org/drawingml/2006/main">
+              <a:ext uri="{FF2B5EF4-FFF2-40B4-BE49-F238E27FC236}">
+                <a16:creationId xmlns:a16="http://schemas.microsoft.com/office/drawing/2014/main" id="{0812F851-A153-4CC7-BE65-C28196B1CB6F}"/>
+              </a:ext>
+            </a:extLst>
+          </p:cNvPr>
+          <p:cNvSpPr>
+            <a:spLocks xmlns:a="http://schemas.openxmlformats.org/drawingml/2006/main" noGrp="1"/>
+          </p:cNvSpPr>
+          <p:nvPr/>
+        </p:nvSpPr>
+        <p:spPr>
+          <a:xfrm xmlns:a="http://schemas.openxmlformats.org/drawingml/2006/main">
+            <a:off x="857250" y="1381125"/>
+            <a:ext cx="4095750" cy="457200"/>
+          </a:xfrm>
+          <a:prstGeom xmlns:a="http://schemas.openxmlformats.org/drawingml/2006/main" prst="rect">
+            <a:avLst/>
+          </a:prstGeom>
+          <a:noFill xmlns:a="http://schemas.openxmlformats.org/drawingml/2006/main"/>
+          <a:ln xmlns:a="http://schemas.openxmlformats.org/drawingml/2006/main" w="0">
+            <a:noFill/>
+          </a:ln>
+        </p:spPr>
+        <p:txBody>
+          <a:bodyPr xmlns:a="http://schemas.openxmlformats.org/drawingml/2006/main">
+            <a:noAutofit/>
+          </a:bodyPr>
+          <a:lstStyle xmlns:a="http://schemas.openxmlformats.org/drawingml/2006/main"/>
+          <a:p xmlns:a="http://schemas.openxmlformats.org/drawingml/2006/main">
+            <a:pPr>
+              <a:defRPr sz="2175" b="1">
+                <a:solidFill>
+                  <a:srgbClr val="227C83"/>
+                </a:solidFill>
+                <a:latin typeface="Arial"/>
+                <a:ea typeface="Arial"/>
+                <a:cs typeface="Arial"/>
+              </a:defRPr>
+            </a:pPr>
+            <a:r>
+              <a:rPr sz="2175" b="1">
+                <a:solidFill>
+                  <a:srgbClr val="227C83"/>
+                </a:solidFill>
+                <a:latin typeface="Arial"/>
+                <a:ea typeface="Arial"/>
+                <a:cs typeface="Arial"/>
+              </a:rPr>
+              <a:t>Conclusões</a:t>
+            </a:r>
+          </a:p>
+        </p:txBody>
+      </p:sp>
+      <p:sp>
+        <p:nvSpPr>
+          <p:cNvPr id="5" name="">
+            <a:extLst xmlns:a="http://schemas.openxmlformats.org/drawingml/2006/main">
+              <a:ext uri="{FF2B5EF4-FFF2-40B4-BE49-F238E27FC236}">
+                <a16:creationId xmlns:a16="http://schemas.microsoft.com/office/drawing/2014/main" id="{CD63A25C-AAB1-46B9-ACA6-5E64FFB9B19E}"/>
+              </a:ext>
+            </a:extLst>
+          </p:cNvPr>
+          <p:cNvSpPr>
+            <a:spLocks xmlns:a="http://schemas.openxmlformats.org/drawingml/2006/main" noGrp="1"/>
+          </p:cNvSpPr>
+          <p:nvPr/>
+        </p:nvSpPr>
+        <p:spPr>
+          <a:xfrm xmlns:a="http://schemas.openxmlformats.org/drawingml/2006/main">
+            <a:off x="809625" y="2047875"/>
+            <a:ext cx="4953000" cy="2428875"/>
+          </a:xfrm>
+          <a:prstGeom xmlns:a="http://schemas.openxmlformats.org/drawingml/2006/main" prst="rect">
+            <a:avLst/>
+          </a:prstGeom>
+          <a:noFill xmlns:a="http://schemas.openxmlformats.org/drawingml/2006/main"/>
+          <a:ln xmlns:a="http://schemas.openxmlformats.org/drawingml/2006/main" w="0">
+            <a:noFill/>
+          </a:ln>
+        </p:spPr>
+        <p:txBody>
+          <a:bodyPr xmlns:a="http://schemas.openxmlformats.org/drawingml/2006/main">
+            <a:noAutofit/>
+          </a:bodyPr>
+          <a:lstStyle xmlns:a="http://schemas.openxmlformats.org/drawingml/2006/main"/>
+          <a:p xmlns:a="http://schemas.openxmlformats.org/drawingml/2006/main">
+            <a:pPr marL="254000" indent="-127000">
+              <a:spcAft>
+                <a:spcPts val="1000"/>
+              </a:spcAft>
+              <a:buChar char="•"/>
+              <a:defRPr sz="1800">
+                <a:solidFill>
+                  <a:srgbClr val="17212B"/>
+                </a:solidFill>
+                <a:latin typeface="Arial"/>
+                <a:ea typeface="Arial"/>
+                <a:cs typeface="Arial"/>
+              </a:defRPr>
+            </a:pPr>
+            <a:r>
+              <a:rPr sz="1800">
+                <a:solidFill>
+                  <a:srgbClr val="17212B"/>
+                </a:solidFill>
+                <a:latin typeface="Arial"/>
+                <a:ea typeface="Arial"/>
+                <a:cs typeface="Arial"/>
+              </a:rPr>
+              <a:t>A arquitetura integrou os três fluxos obrigatórios</a:t>
+            </a:r>
+          </a:p>
+          <a:p xmlns:a="http://schemas.openxmlformats.org/drawingml/2006/main">
+            <a:pPr marL="254000" indent="-127000">
+              <a:spcAft>
+                <a:spcPts val="1000"/>
+              </a:spcAft>
+              <a:buChar char="•"/>
+              <a:defRPr sz="1800">
+                <a:solidFill>
+                  <a:srgbClr val="17212B"/>
+                </a:solidFill>
+                <a:latin typeface="Arial"/>
+                <a:ea typeface="Arial"/>
+                <a:cs typeface="Arial"/>
+              </a:defRPr>
+            </a:pPr>
+            <a:r>
+              <a:rPr sz="1800">
+                <a:solidFill>
+                  <a:srgbClr val="17212B"/>
+                </a:solidFill>
+                <a:latin typeface="Arial"/>
+                <a:ea typeface="Arial"/>
+                <a:cs typeface="Arial"/>
+              </a:rPr>
+              <a:t>Contratos e fronteiras permitem evolução incremental</a:t>
+            </a:r>
+          </a:p>
+          <a:p xmlns:a="http://schemas.openxmlformats.org/drawingml/2006/main">
+            <a:pPr marL="254000" indent="-127000">
+              <a:spcAft>
+                <a:spcPts val="1000"/>
+              </a:spcAft>
+              <a:buChar char="•"/>
+              <a:defRPr sz="1800">
+                <a:solidFill>
+                  <a:srgbClr val="17212B"/>
+                </a:solidFill>
+                <a:latin typeface="Arial"/>
+                <a:ea typeface="Arial"/>
+                <a:cs typeface="Arial"/>
+              </a:defRPr>
+            </a:pPr>
+            <a:r>
+              <a:rPr sz="1800">
+                <a:solidFill>
+                  <a:srgbClr val="17212B"/>
+                </a:solidFill>
+                <a:latin typeface="Arial"/>
+                <a:ea typeface="Arial"/>
+                <a:cs typeface="Arial"/>
+              </a:rPr>
+              <a:t>Outbox, inbox e correlação tornam falhas recuperáveis</a:t>
+            </a:r>
+          </a:p>
+        </p:txBody>
+      </p:sp>
+      <p:sp>
+        <p:nvSpPr>
+          <p:cNvPr id="6" name="">
+            <a:extLst xmlns:a="http://schemas.openxmlformats.org/drawingml/2006/main">
+              <a:ext uri="{FF2B5EF4-FFF2-40B4-BE49-F238E27FC236}">
+                <a16:creationId xmlns:a16="http://schemas.microsoft.com/office/drawing/2014/main" id="{2062EC0C-2003-4F5F-BE8D-360BC5359D8A}"/>
+              </a:ext>
+            </a:extLst>
+          </p:cNvPr>
+          <p:cNvSpPr>
+            <a:spLocks xmlns:a="http://schemas.openxmlformats.org/drawingml/2006/main" noGrp="1"/>
+          </p:cNvSpPr>
+          <p:nvPr/>
+        </p:nvSpPr>
+        <p:spPr>
+          <a:xfrm xmlns:a="http://schemas.openxmlformats.org/drawingml/2006/main">
+            <a:off x="6667500" y="1381125"/>
+            <a:ext cx="4095750" cy="457200"/>
+          </a:xfrm>
+          <a:prstGeom xmlns:a="http://schemas.openxmlformats.org/drawingml/2006/main" prst="rect">
+            <a:avLst/>
+          </a:prstGeom>
+          <a:noFill xmlns:a="http://schemas.openxmlformats.org/drawingml/2006/main"/>
+          <a:ln xmlns:a="http://schemas.openxmlformats.org/drawingml/2006/main" w="0">
+            <a:noFill/>
+          </a:ln>
+        </p:spPr>
+        <p:txBody>
+          <a:bodyPr xmlns:a="http://schemas.openxmlformats.org/drawingml/2006/main">
+            <a:noAutofit/>
+          </a:bodyPr>
+          <a:lstStyle xmlns:a="http://schemas.openxmlformats.org/drawingml/2006/main"/>
+          <a:p xmlns:a="http://schemas.openxmlformats.org/drawingml/2006/main">
+            <a:pPr>
+              <a:defRPr sz="2175" b="1">
+                <a:solidFill>
+                  <a:srgbClr val="227C83"/>
+                </a:solidFill>
+                <a:latin typeface="Arial"/>
+                <a:ea typeface="Arial"/>
+                <a:cs typeface="Arial"/>
+              </a:defRPr>
+            </a:pPr>
+            <a:r>
+              <a:rPr sz="2175" b="1">
+                <a:solidFill>
+                  <a:srgbClr val="227C83"/>
+                </a:solidFill>
+                <a:latin typeface="Arial"/>
+                <a:ea typeface="Arial"/>
+                <a:cs typeface="Arial"/>
+              </a:rPr>
+              <a:t>Limites e evolução</a:t>
+            </a:r>
+          </a:p>
+        </p:txBody>
+      </p:sp>
+      <p:sp>
+        <p:nvSpPr>
+          <p:cNvPr id="7" name="">
+            <a:extLst xmlns:a="http://schemas.openxmlformats.org/drawingml/2006/main">
+              <a:ext uri="{FF2B5EF4-FFF2-40B4-BE49-F238E27FC236}">
+                <a16:creationId xmlns:a16="http://schemas.microsoft.com/office/drawing/2014/main" id="{8BAAB0A3-3CCB-4F8D-BA72-82B6FC2CB0CD}"/>
+              </a:ext>
+            </a:extLst>
+          </p:cNvPr>
+          <p:cNvSpPr>
+            <a:spLocks xmlns:a="http://schemas.openxmlformats.org/drawingml/2006/main" noGrp="1"/>
+          </p:cNvSpPr>
+          <p:nvPr/>
+        </p:nvSpPr>
+        <p:spPr>
+          <a:xfrm xmlns:a="http://schemas.openxmlformats.org/drawingml/2006/main">
+            <a:off x="6619875" y="2047875"/>
+            <a:ext cx="4762500" cy="2428875"/>
+          </a:xfrm>
+          <a:prstGeom xmlns:a="http://schemas.openxmlformats.org/drawingml/2006/main" prst="rect">
+            <a:avLst/>
+          </a:prstGeom>
+          <a:noFill xmlns:a="http://schemas.openxmlformats.org/drawingml/2006/main"/>
+          <a:ln xmlns:a="http://schemas.openxmlformats.org/drawingml/2006/main" w="0">
+            <a:noFill/>
+          </a:ln>
+        </p:spPr>
+        <p:txBody>
+          <a:bodyPr xmlns:a="http://schemas.openxmlformats.org/drawingml/2006/main">
+            <a:noAutofit/>
+          </a:bodyPr>
+          <a:lstStyle xmlns:a="http://schemas.openxmlformats.org/drawingml/2006/main"/>
+          <a:p xmlns:a="http://schemas.openxmlformats.org/drawingml/2006/main">
+            <a:pPr marL="254000" indent="-127000">
+              <a:spcAft>
+                <a:spcPts val="1000"/>
+              </a:spcAft>
+              <a:buChar char="•"/>
+              <a:defRPr sz="1800">
+                <a:solidFill>
+                  <a:srgbClr val="17212B"/>
+                </a:solidFill>
+                <a:latin typeface="Arial"/>
+                <a:ea typeface="Arial"/>
+                <a:cs typeface="Arial"/>
+              </a:defRPr>
+            </a:pPr>
+            <a:r>
+              <a:rPr sz="1800">
+                <a:solidFill>
+                  <a:srgbClr val="17212B"/>
+                </a:solidFill>
+                <a:latin typeface="Arial"/>
+                <a:ea typeface="Arial"/>
+                <a:cs typeface="Arial"/>
+              </a:rPr>
+              <a:t>Validar premissas e interfaces do AS IS</a:t>
+            </a:r>
+          </a:p>
+          <a:p xmlns:a="http://schemas.openxmlformats.org/drawingml/2006/main">
+            <a:pPr marL="254000" indent="-127000">
+              <a:spcAft>
+                <a:spcPts val="1000"/>
+              </a:spcAft>
+              <a:buChar char="•"/>
+              <a:defRPr sz="1800">
+                <a:solidFill>
+                  <a:srgbClr val="17212B"/>
+                </a:solidFill>
+                <a:latin typeface="Arial"/>
+                <a:ea typeface="Arial"/>
+                <a:cs typeface="Arial"/>
+              </a:defRPr>
+            </a:pPr>
+            <a:r>
+              <a:rPr sz="1800">
+                <a:solidFill>
+                  <a:srgbClr val="17212B"/>
+                </a:solidFill>
+                <a:latin typeface="Arial"/>
+                <a:ea typeface="Arial"/>
+                <a:cs typeface="Arial"/>
+              </a:rPr>
+              <a:t>Conectar OIDC, TLS e sistemas reais por adaptadores</a:t>
+            </a:r>
+          </a:p>
+          <a:p xmlns:a="http://schemas.openxmlformats.org/drawingml/2006/main">
+            <a:pPr marL="254000" indent="-127000">
+              <a:spcAft>
+                <a:spcPts val="1000"/>
+              </a:spcAft>
+              <a:buChar char="•"/>
+              <a:defRPr sz="1800">
+                <a:solidFill>
+                  <a:srgbClr val="17212B"/>
+                </a:solidFill>
+                <a:latin typeface="Arial"/>
+                <a:ea typeface="Arial"/>
+                <a:cs typeface="Arial"/>
+              </a:defRPr>
+            </a:pPr>
+            <a:r>
+              <a:rPr sz="1800">
+                <a:solidFill>
+                  <a:srgbClr val="17212B"/>
+                </a:solidFill>
+                <a:latin typeface="Arial"/>
+                <a:ea typeface="Arial"/>
+                <a:cs typeface="Arial"/>
+              </a:rPr>
+              <a:t>Automatizar retentativas e sincronizar o prazo do Workflow</a:t>
+            </a:r>
+          </a:p>
+        </p:txBody>
+      </p:sp>
+      <p:sp>
+        <p:nvSpPr>
+          <p:cNvPr id="8" name="">
+            <a:extLst xmlns:a="http://schemas.openxmlformats.org/drawingml/2006/main">
+              <a:ext uri="{FF2B5EF4-FFF2-40B4-BE49-F238E27FC236}">
+                <a16:creationId xmlns:a16="http://schemas.microsoft.com/office/drawing/2014/main" id="{8E9B745B-FA09-4220-B9CE-76EBD9BB1ABE}"/>
+              </a:ext>
+            </a:extLst>
+          </p:cNvPr>
+          <p:cNvSpPr>
+            <a:spLocks xmlns:a="http://schemas.openxmlformats.org/drawingml/2006/main" noGrp="1"/>
+          </p:cNvSpPr>
+          <p:nvPr/>
+        </p:nvSpPr>
+        <p:spPr>
+          <a:xfrm xmlns:a="http://schemas.openxmlformats.org/drawingml/2006/main">
+            <a:off x="1571625" y="5191125"/>
+            <a:ext cx="9048750" cy="590550"/>
+          </a:xfrm>
+          <a:prstGeom xmlns:a="http://schemas.openxmlformats.org/drawingml/2006/main" prst="rect">
+            <a:avLst/>
+          </a:prstGeom>
+          <a:noFill xmlns:a="http://schemas.openxmlformats.org/drawingml/2006/main"/>
+          <a:ln xmlns:a="http://schemas.openxmlformats.org/drawingml/2006/main" w="0">
+            <a:noFill/>
+          </a:ln>
+        </p:spPr>
+        <p:txBody>
+          <a:bodyPr xmlns:a="http://schemas.openxmlformats.org/drawingml/2006/main">
+            <a:noAutofit/>
+          </a:bodyPr>
+          <a:lstStyle xmlns:a="http://schemas.openxmlformats.org/drawingml/2006/main"/>
+          <a:p xmlns:a="http://schemas.openxmlformats.org/drawingml/2006/main">
+            <a:pPr>
+              <a:defRPr sz="1875" b="1">
+                <a:solidFill>
+                  <a:srgbClr val="C65D3A"/>
+                </a:solidFill>
+                <a:latin typeface="Arial"/>
+                <a:ea typeface="Arial"/>
+                <a:cs typeface="Arial"/>
+              </a:defRPr>
+            </a:pPr>
+            <a:r>
+              <a:rPr sz="1875" b="1">
+                <a:solidFill>
+                  <a:srgbClr val="C65D3A"/>
+                </a:solidFill>
+                <a:latin typeface="Arial"/>
+                <a:ea typeface="Arial"/>
+                <a:cs typeface="Arial"/>
+              </a:rPr>
+              <a:t>Próxima ação: validar a solução com dados, volumes e responsáveis reais</a:t>
+            </a:r>
+          </a:p>
+        </p:txBody>
+      </p:sp>
+    </p:spTree>
+    <p:extLst>
+      <p:ext uri="{BB962C8B-B14F-4D97-AF65-F5344CB8AC3E}">
+        <p14:creationId xmlns:p14="http://schemas.microsoft.com/office/powerpoint/2010/main" val="1778988182"/>
       </p:ext>
     </p:extLst>
   </p:cSld>
@@ -5369,7 +6014,7 @@
           <p:cNvPr id="10" name="">
             <a:extLst xmlns:a="http://schemas.openxmlformats.org/drawingml/2006/main">
               <a:ext uri="{FF2B5EF4-FFF2-40B4-BE49-F238E27FC236}">
-                <a16:creationId xmlns:a16="http://schemas.microsoft.com/office/drawing/2014/main" id="{BB8DB50B-8884-43A3-A625-E095244B1C55}"/>
+                <a16:creationId xmlns:a16="http://schemas.microsoft.com/office/drawing/2014/main" id="{982663FC-8245-4AF0-8BFF-655BD36BFECE}"/>
               </a:ext>
             </a:extLst>
           </p:cNvPr>
@@ -5399,7 +6044,7 @@
           <p:cNvPr id="2" name="">
             <a:extLst xmlns:a="http://schemas.openxmlformats.org/drawingml/2006/main">
               <a:ext uri="{FF2B5EF4-FFF2-40B4-BE49-F238E27FC236}">
-                <a16:creationId xmlns:a16="http://schemas.microsoft.com/office/drawing/2014/main" id="{D6242845-A3EC-464E-99FC-F40EBF227B44}"/>
+                <a16:creationId xmlns:a16="http://schemas.microsoft.com/office/drawing/2014/main" id="{C820D04F-795B-4439-AF64-B54F3FA6F5E3}"/>
               </a:ext>
             </a:extLst>
           </p:cNvPr>
@@ -5456,7 +6101,7 @@
           <p:cNvPr id="3" name="">
             <a:extLst xmlns:a="http://schemas.openxmlformats.org/drawingml/2006/main">
               <a:ext uri="{FF2B5EF4-FFF2-40B4-BE49-F238E27FC236}">
-                <a16:creationId xmlns:a16="http://schemas.microsoft.com/office/drawing/2014/main" id="{E1FDB689-93E4-4031-9582-A01DDC71E16D}"/>
+                <a16:creationId xmlns:a16="http://schemas.microsoft.com/office/drawing/2014/main" id="{6586CD46-0F1C-4C90-B12C-055A006D7BD5}"/>
               </a:ext>
             </a:extLst>
           </p:cNvPr>
@@ -5513,7 +6158,7 @@
           <p:cNvPr id="4" name="">
             <a:extLst xmlns:a="http://schemas.openxmlformats.org/drawingml/2006/main">
               <a:ext uri="{FF2B5EF4-FFF2-40B4-BE49-F238E27FC236}">
-                <a16:creationId xmlns:a16="http://schemas.microsoft.com/office/drawing/2014/main" id="{CC9DC972-6FE8-439F-B139-4C771D68BE0A}"/>
+                <a16:creationId xmlns:a16="http://schemas.microsoft.com/office/drawing/2014/main" id="{DF142390-F118-4A71-B6C1-F20E73CCAFB6}"/>
               </a:ext>
             </a:extLst>
           </p:cNvPr>
@@ -5655,7 +6300,7 @@
           <p:cNvPr id="5" name="">
             <a:extLst xmlns:a="http://schemas.openxmlformats.org/drawingml/2006/main">
               <a:ext uri="{FF2B5EF4-FFF2-40B4-BE49-F238E27FC236}">
-                <a16:creationId xmlns:a16="http://schemas.microsoft.com/office/drawing/2014/main" id="{29E434D3-B1D3-409F-8B77-60F741C36F13}"/>
+                <a16:creationId xmlns:a16="http://schemas.microsoft.com/office/drawing/2014/main" id="{7AD3B4AA-CECE-476B-B198-77539FD47B27}"/>
               </a:ext>
             </a:extLst>
           </p:cNvPr>
@@ -5719,7 +6364,7 @@
           <p:cNvPr id="6" name="">
             <a:extLst xmlns:a="http://schemas.openxmlformats.org/drawingml/2006/main">
               <a:ext uri="{FF2B5EF4-FFF2-40B4-BE49-F238E27FC236}">
-                <a16:creationId xmlns:a16="http://schemas.microsoft.com/office/drawing/2014/main" id="{7C8BE992-C8B2-4BFC-A547-BA1EA6B60906}"/>
+                <a16:creationId xmlns:a16="http://schemas.microsoft.com/office/drawing/2014/main" id="{0A08C6DC-FBC0-4217-A361-692B39F35F1B}"/>
               </a:ext>
             </a:extLst>
           </p:cNvPr>
@@ -5783,7 +6428,7 @@
           <p:cNvPr id="7" name="">
             <a:extLst xmlns:a="http://schemas.openxmlformats.org/drawingml/2006/main">
               <a:ext uri="{FF2B5EF4-FFF2-40B4-BE49-F238E27FC236}">
-                <a16:creationId xmlns:a16="http://schemas.microsoft.com/office/drawing/2014/main" id="{4FC1EE43-3353-44AF-A262-8E3D4D9707AF}"/>
+                <a16:creationId xmlns:a16="http://schemas.microsoft.com/office/drawing/2014/main" id="{D7DD277D-49B1-4A47-A87F-201023C3A1EC}"/>
               </a:ext>
             </a:extLst>
           </p:cNvPr>
@@ -5847,7 +6492,7 @@
           <p:cNvPr id="8" name="">
             <a:extLst xmlns:a="http://schemas.openxmlformats.org/drawingml/2006/main">
               <a:ext uri="{FF2B5EF4-FFF2-40B4-BE49-F238E27FC236}">
-                <a16:creationId xmlns:a16="http://schemas.microsoft.com/office/drawing/2014/main" id="{A3C185A9-DDD8-4715-821F-CA69B48667CA}"/>
+                <a16:creationId xmlns:a16="http://schemas.microsoft.com/office/drawing/2014/main" id="{5F3DED01-0476-45A9-8374-D327549C81F8}"/>
               </a:ext>
             </a:extLst>
           </p:cNvPr>
@@ -5911,7 +6556,7 @@
           <p:cNvPr id="9" name="">
             <a:extLst xmlns:a="http://schemas.openxmlformats.org/drawingml/2006/main">
               <a:ext uri="{FF2B5EF4-FFF2-40B4-BE49-F238E27FC236}">
-                <a16:creationId xmlns:a16="http://schemas.microsoft.com/office/drawing/2014/main" id="{CD57E46F-A483-4724-9912-6891AA655C5D}"/>
+                <a16:creationId xmlns:a16="http://schemas.microsoft.com/office/drawing/2014/main" id="{29CE4070-313D-42C1-8E2B-29B92F45C1B4}"/>
               </a:ext>
             </a:extLst>
           </p:cNvPr>
@@ -5973,7 +6618,7 @@
     </p:spTree>
     <p:extLst>
       <p:ext uri="{BB962C8B-B14F-4D97-AF65-F5344CB8AC3E}">
-        <p14:creationId xmlns:p14="http://schemas.microsoft.com/office/powerpoint/2010/main" val="1523331498"/>
+        <p14:creationId xmlns:p14="http://schemas.microsoft.com/office/powerpoint/2010/main" val="1944841708"/>
       </p:ext>
     </p:extLst>
   </p:cSld>
@@ -6004,7 +6649,7 @@
           <p:cNvPr id="15" name="">
             <a:extLst xmlns:a="http://schemas.openxmlformats.org/drawingml/2006/main">
               <a:ext uri="{FF2B5EF4-FFF2-40B4-BE49-F238E27FC236}">
-                <a16:creationId xmlns:a16="http://schemas.microsoft.com/office/drawing/2014/main" id="{EDCFE254-6337-4F15-8D7E-73B8561CFF83}"/>
+                <a16:creationId xmlns:a16="http://schemas.microsoft.com/office/drawing/2014/main" id="{41E679AE-97B3-4E3C-979B-906AEFE2DFCE}"/>
               </a:ext>
             </a:extLst>
           </p:cNvPr>
@@ -6034,7 +6679,7 @@
           <p:cNvPr id="2" name="">
             <a:extLst xmlns:a="http://schemas.openxmlformats.org/drawingml/2006/main">
               <a:ext uri="{FF2B5EF4-FFF2-40B4-BE49-F238E27FC236}">
-                <a16:creationId xmlns:a16="http://schemas.microsoft.com/office/drawing/2014/main" id="{C1B7C58D-83D5-48B9-BFA7-18DC406B1D97}"/>
+                <a16:creationId xmlns:a16="http://schemas.microsoft.com/office/drawing/2014/main" id="{61B765A9-FC84-4832-9800-8810B05264EA}"/>
               </a:ext>
             </a:extLst>
           </p:cNvPr>
@@ -6091,7 +6736,7 @@
           <p:cNvPr id="3" name="">
             <a:extLst xmlns:a="http://schemas.openxmlformats.org/drawingml/2006/main">
               <a:ext uri="{FF2B5EF4-FFF2-40B4-BE49-F238E27FC236}">
-                <a16:creationId xmlns:a16="http://schemas.microsoft.com/office/drawing/2014/main" id="{B9E07B49-D5E4-45E7-8A5F-386453F4FC49}"/>
+                <a16:creationId xmlns:a16="http://schemas.microsoft.com/office/drawing/2014/main" id="{4D11D342-C96F-4AF6-9D7B-57040A226FF0}"/>
               </a:ext>
             </a:extLst>
           </p:cNvPr>
@@ -6148,7 +6793,7 @@
           <p:cNvPr id="4" name="">
             <a:extLst xmlns:a="http://schemas.openxmlformats.org/drawingml/2006/main">
               <a:ext uri="{FF2B5EF4-FFF2-40B4-BE49-F238E27FC236}">
-                <a16:creationId xmlns:a16="http://schemas.microsoft.com/office/drawing/2014/main" id="{EB4A17BB-5C9B-4E72-B373-79FD8DB61C30}"/>
+                <a16:creationId xmlns:a16="http://schemas.microsoft.com/office/drawing/2014/main" id="{56E0B2CD-BC48-4D9F-A90B-A906D5685089}"/>
               </a:ext>
             </a:extLst>
           </p:cNvPr>
@@ -6212,7 +6857,7 @@
           <p:cNvPr id="5" name="">
             <a:extLst xmlns:a="http://schemas.openxmlformats.org/drawingml/2006/main">
               <a:ext uri="{FF2B5EF4-FFF2-40B4-BE49-F238E27FC236}">
-                <a16:creationId xmlns:a16="http://schemas.microsoft.com/office/drawing/2014/main" id="{92C070E5-17C4-41B9-80BC-B8E72021F6D6}"/>
+                <a16:creationId xmlns:a16="http://schemas.microsoft.com/office/drawing/2014/main" id="{03D2561F-FABE-43E6-B767-B8D6D50A1670}"/>
               </a:ext>
             </a:extLst>
           </p:cNvPr>
@@ -6276,7 +6921,7 @@
           <p:cNvPr id="6" name="">
             <a:extLst xmlns:a="http://schemas.openxmlformats.org/drawingml/2006/main">
               <a:ext uri="{FF2B5EF4-FFF2-40B4-BE49-F238E27FC236}">
-                <a16:creationId xmlns:a16="http://schemas.microsoft.com/office/drawing/2014/main" id="{87328F7A-EDCB-44AF-9062-9E3418603535}"/>
+                <a16:creationId xmlns:a16="http://schemas.microsoft.com/office/drawing/2014/main" id="{1B1B509D-12C2-443C-8161-24EB84575323}"/>
               </a:ext>
             </a:extLst>
           </p:cNvPr>
@@ -6340,7 +6985,7 @@
           <p:cNvPr id="7" name="">
             <a:extLst xmlns:a="http://schemas.openxmlformats.org/drawingml/2006/main">
               <a:ext uri="{FF2B5EF4-FFF2-40B4-BE49-F238E27FC236}">
-                <a16:creationId xmlns:a16="http://schemas.microsoft.com/office/drawing/2014/main" id="{FFE5E49D-28B0-4ECD-867E-645FEBA994A1}"/>
+                <a16:creationId xmlns:a16="http://schemas.microsoft.com/office/drawing/2014/main" id="{15EB86CC-65FD-4A2C-87C8-EC4A37AB67F7}"/>
               </a:ext>
             </a:extLst>
           </p:cNvPr>
@@ -6404,7 +7049,7 @@
           <p:cNvPr id="8" name="">
             <a:extLst xmlns:a="http://schemas.openxmlformats.org/drawingml/2006/main">
               <a:ext uri="{FF2B5EF4-FFF2-40B4-BE49-F238E27FC236}">
-                <a16:creationId xmlns:a16="http://schemas.microsoft.com/office/drawing/2014/main" id="{0EBB8D74-4427-4AC9-A13F-2C0BC83000D3}"/>
+                <a16:creationId xmlns:a16="http://schemas.microsoft.com/office/drawing/2014/main" id="{0F5EF93F-FA3B-4A08-BF1B-C87E044A3AD5}"/>
               </a:ext>
             </a:extLst>
           </p:cNvPr>
@@ -6572,7 +7217,7 @@
           <p:cNvPr id="13" name="">
             <a:extLst xmlns:a="http://schemas.openxmlformats.org/drawingml/2006/main">
               <a:ext uri="{FF2B5EF4-FFF2-40B4-BE49-F238E27FC236}">
-                <a16:creationId xmlns:a16="http://schemas.microsoft.com/office/drawing/2014/main" id="{20B9745C-A9F8-4EB4-B649-CAB52A1CA959}"/>
+                <a16:creationId xmlns:a16="http://schemas.microsoft.com/office/drawing/2014/main" id="{1283FDF2-3635-4F63-908A-9A77DA878B99}"/>
               </a:ext>
             </a:extLst>
           </p:cNvPr>
@@ -6629,7 +7274,7 @@
           <p:cNvPr id="14" name="">
             <a:extLst xmlns:a="http://schemas.openxmlformats.org/drawingml/2006/main">
               <a:ext uri="{FF2B5EF4-FFF2-40B4-BE49-F238E27FC236}">
-                <a16:creationId xmlns:a16="http://schemas.microsoft.com/office/drawing/2014/main" id="{EBC42B1E-0459-4AC2-B186-31A5A4187372}"/>
+                <a16:creationId xmlns:a16="http://schemas.microsoft.com/office/drawing/2014/main" id="{1CC68571-79F7-427C-99B3-F7D055DBE385}"/>
               </a:ext>
             </a:extLst>
           </p:cNvPr>
@@ -6684,7 +7329,7 @@
     </p:spTree>
     <p:extLst>
       <p:ext uri="{BB962C8B-B14F-4D97-AF65-F5344CB8AC3E}">
-        <p14:creationId xmlns:p14="http://schemas.microsoft.com/office/powerpoint/2010/main" val="1054622914"/>
+        <p14:creationId xmlns:p14="http://schemas.microsoft.com/office/powerpoint/2010/main" val="411669418"/>
       </p:ext>
     </p:extLst>
   </p:cSld>
@@ -6715,7 +7360,7 @@
           <p:cNvPr id="7" name="">
             <a:extLst xmlns:a="http://schemas.openxmlformats.org/drawingml/2006/main">
               <a:ext uri="{FF2B5EF4-FFF2-40B4-BE49-F238E27FC236}">
-                <a16:creationId xmlns:a16="http://schemas.microsoft.com/office/drawing/2014/main" id="{083A1856-C7A0-41CD-8280-F94B2B0D74F4}"/>
+                <a16:creationId xmlns:a16="http://schemas.microsoft.com/office/drawing/2014/main" id="{FEF02A03-4DED-40E4-A042-EB532A8EEBA8}"/>
               </a:ext>
             </a:extLst>
           </p:cNvPr>
@@ -6745,7 +7390,7 @@
           <p:cNvPr id="2" name="">
             <a:extLst xmlns:a="http://schemas.openxmlformats.org/drawingml/2006/main">
               <a:ext uri="{FF2B5EF4-FFF2-40B4-BE49-F238E27FC236}">
-                <a16:creationId xmlns:a16="http://schemas.microsoft.com/office/drawing/2014/main" id="{949A5CD7-F700-4BD0-A520-72A659B597CD}"/>
+                <a16:creationId xmlns:a16="http://schemas.microsoft.com/office/drawing/2014/main" id="{1527EFD1-7AD5-44F3-898E-A13E71CE3AEC}"/>
               </a:ext>
             </a:extLst>
           </p:cNvPr>
@@ -6802,7 +7447,7 @@
           <p:cNvPr id="3" name="">
             <a:extLst xmlns:a="http://schemas.openxmlformats.org/drawingml/2006/main">
               <a:ext uri="{FF2B5EF4-FFF2-40B4-BE49-F238E27FC236}">
-                <a16:creationId xmlns:a16="http://schemas.microsoft.com/office/drawing/2014/main" id="{47A3E926-DECD-4079-8D65-1F0C15C03FC8}"/>
+                <a16:creationId xmlns:a16="http://schemas.microsoft.com/office/drawing/2014/main" id="{A275A6EE-9353-4B37-8B4B-60851B2B62A7}"/>
               </a:ext>
             </a:extLst>
           </p:cNvPr>
@@ -6859,7 +7504,7 @@
           <p:cNvPr id="4" name="">
             <a:extLst xmlns:a="http://schemas.openxmlformats.org/drawingml/2006/main">
               <a:ext uri="{FF2B5EF4-FFF2-40B4-BE49-F238E27FC236}">
-                <a16:creationId xmlns:a16="http://schemas.microsoft.com/office/drawing/2014/main" id="{4868C779-1A18-4860-92A9-FB67A29F8BA5}"/>
+                <a16:creationId xmlns:a16="http://schemas.microsoft.com/office/drawing/2014/main" id="{6517AB7B-C552-4502-89B7-A328B8BE6CC4}"/>
               </a:ext>
             </a:extLst>
           </p:cNvPr>
@@ -7001,7 +7646,7 @@
           <p:cNvPr id="5" name="">
             <a:extLst xmlns:a="http://schemas.openxmlformats.org/drawingml/2006/main">
               <a:ext uri="{FF2B5EF4-FFF2-40B4-BE49-F238E27FC236}">
-                <a16:creationId xmlns:a16="http://schemas.microsoft.com/office/drawing/2014/main" id="{BDD2DC78-A9F6-4EB8-BC92-38AB34448E06}"/>
+                <a16:creationId xmlns:a16="http://schemas.microsoft.com/office/drawing/2014/main" id="{ADE64035-7337-48A8-AD75-F693A2F0F9AB}"/>
               </a:ext>
             </a:extLst>
           </p:cNvPr>
@@ -7058,7 +7703,7 @@
           <p:cNvPr id="6" name="">
             <a:extLst xmlns:a="http://schemas.openxmlformats.org/drawingml/2006/main">
               <a:ext uri="{FF2B5EF4-FFF2-40B4-BE49-F238E27FC236}">
-                <a16:creationId xmlns:a16="http://schemas.microsoft.com/office/drawing/2014/main" id="{30375CDE-6019-4E37-83CC-72B712D2550E}"/>
+                <a16:creationId xmlns:a16="http://schemas.microsoft.com/office/drawing/2014/main" id="{5967F4A3-3D04-45B9-8DE2-B6E96834BF9E}"/>
               </a:ext>
             </a:extLst>
           </p:cNvPr>
@@ -7279,7 +7924,7 @@
     </p:spTree>
     <p:extLst>
       <p:ext uri="{BB962C8B-B14F-4D97-AF65-F5344CB8AC3E}">
-        <p14:creationId xmlns:p14="http://schemas.microsoft.com/office/powerpoint/2010/main" val="188463070"/>
+        <p14:creationId xmlns:p14="http://schemas.microsoft.com/office/powerpoint/2010/main" val="1900986163"/>
       </p:ext>
     </p:extLst>
   </p:cSld>
@@ -7310,7 +7955,7 @@
           <p:cNvPr id="7" name="">
             <a:extLst xmlns:a="http://schemas.openxmlformats.org/drawingml/2006/main">
               <a:ext uri="{FF2B5EF4-FFF2-40B4-BE49-F238E27FC236}">
-                <a16:creationId xmlns:a16="http://schemas.microsoft.com/office/drawing/2014/main" id="{C73B8B6A-82F0-4D28-9A80-0059267C7663}"/>
+                <a16:creationId xmlns:a16="http://schemas.microsoft.com/office/drawing/2014/main" id="{FAF953D6-269B-4C4C-A84F-4082F7F96FB6}"/>
               </a:ext>
             </a:extLst>
           </p:cNvPr>
@@ -7340,7 +7985,7 @@
           <p:cNvPr id="2" name="">
             <a:extLst xmlns:a="http://schemas.openxmlformats.org/drawingml/2006/main">
               <a:ext uri="{FF2B5EF4-FFF2-40B4-BE49-F238E27FC236}">
-                <a16:creationId xmlns:a16="http://schemas.microsoft.com/office/drawing/2014/main" id="{B55A2EAE-810F-45BF-B6C3-9364AFE503B2}"/>
+                <a16:creationId xmlns:a16="http://schemas.microsoft.com/office/drawing/2014/main" id="{08BCAAC4-D28B-4857-AE80-5867F0CD680C}"/>
               </a:ext>
             </a:extLst>
           </p:cNvPr>
@@ -7397,7 +8042,7 @@
           <p:cNvPr id="3" name="">
             <a:extLst xmlns:a="http://schemas.openxmlformats.org/drawingml/2006/main">
               <a:ext uri="{FF2B5EF4-FFF2-40B4-BE49-F238E27FC236}">
-                <a16:creationId xmlns:a16="http://schemas.microsoft.com/office/drawing/2014/main" id="{1ED89B7A-0D4F-4005-9263-3E4A62A9ED8B}"/>
+                <a16:creationId xmlns:a16="http://schemas.microsoft.com/office/drawing/2014/main" id="{ED551D20-730C-4B78-8FD5-2BE89D89A06A}"/>
               </a:ext>
             </a:extLst>
           </p:cNvPr>
@@ -7454,7 +8099,7 @@
           <p:cNvPr id="4" name="">
             <a:extLst xmlns:a="http://schemas.openxmlformats.org/drawingml/2006/main">
               <a:ext uri="{FF2B5EF4-FFF2-40B4-BE49-F238E27FC236}">
-                <a16:creationId xmlns:a16="http://schemas.microsoft.com/office/drawing/2014/main" id="{07BFC69A-D98B-441C-9C3C-360A7E274EFF}"/>
+                <a16:creationId xmlns:a16="http://schemas.microsoft.com/office/drawing/2014/main" id="{1C1F47C2-05FF-409B-BD15-544A98B65C72}"/>
               </a:ext>
             </a:extLst>
           </p:cNvPr>
@@ -7511,7 +8156,7 @@
           <p:cNvPr id="5" name="">
             <a:extLst xmlns:a="http://schemas.openxmlformats.org/drawingml/2006/main">
               <a:ext uri="{FF2B5EF4-FFF2-40B4-BE49-F238E27FC236}">
-                <a16:creationId xmlns:a16="http://schemas.microsoft.com/office/drawing/2014/main" id="{F821DE38-A5A9-4403-A04C-9019A7606A43}"/>
+                <a16:creationId xmlns:a16="http://schemas.microsoft.com/office/drawing/2014/main" id="{ACBBFA1A-1EDB-4EBF-B9AA-AF9D3E452963}"/>
               </a:ext>
             </a:extLst>
           </p:cNvPr>
@@ -7653,7 +8298,7 @@
           <p:cNvPr id="6" name="">
             <a:extLst xmlns:a="http://schemas.openxmlformats.org/drawingml/2006/main">
               <a:ext uri="{FF2B5EF4-FFF2-40B4-BE49-F238E27FC236}">
-                <a16:creationId xmlns:a16="http://schemas.microsoft.com/office/drawing/2014/main" id="{40056131-A520-48DE-AD27-59A543F429FA}"/>
+                <a16:creationId xmlns:a16="http://schemas.microsoft.com/office/drawing/2014/main" id="{04CB2DB7-BDAF-4547-9843-64A266CFF13D}"/>
               </a:ext>
             </a:extLst>
           </p:cNvPr>
@@ -7708,7 +8353,7 @@
     </p:spTree>
     <p:extLst>
       <p:ext uri="{BB962C8B-B14F-4D97-AF65-F5344CB8AC3E}">
-        <p14:creationId xmlns:p14="http://schemas.microsoft.com/office/powerpoint/2010/main" val="1471140803"/>
+        <p14:creationId xmlns:p14="http://schemas.microsoft.com/office/powerpoint/2010/main" val="464319204"/>
       </p:ext>
     </p:extLst>
   </p:cSld>
@@ -7739,7 +8384,7 @@
           <p:cNvPr id="22" name="">
             <a:extLst xmlns:a="http://schemas.openxmlformats.org/drawingml/2006/main">
               <a:ext uri="{FF2B5EF4-FFF2-40B4-BE49-F238E27FC236}">
-                <a16:creationId xmlns:a16="http://schemas.microsoft.com/office/drawing/2014/main" id="{3BCE1C99-0A43-4975-B77D-EA62ECACF466}"/>
+                <a16:creationId xmlns:a16="http://schemas.microsoft.com/office/drawing/2014/main" id="{07AC01C7-2326-4C04-9089-13BDB1031054}"/>
               </a:ext>
             </a:extLst>
           </p:cNvPr>
@@ -7769,7 +8414,7 @@
           <p:cNvPr id="2" name="">
             <a:extLst xmlns:a="http://schemas.openxmlformats.org/drawingml/2006/main">
               <a:ext uri="{FF2B5EF4-FFF2-40B4-BE49-F238E27FC236}">
-                <a16:creationId xmlns:a16="http://schemas.microsoft.com/office/drawing/2014/main" id="{BEF0C37E-AF9C-4D63-85FB-96ED3A308F29}"/>
+                <a16:creationId xmlns:a16="http://schemas.microsoft.com/office/drawing/2014/main" id="{D7C5029A-CA15-472F-8E80-C69783D17B97}"/>
               </a:ext>
             </a:extLst>
           </p:cNvPr>
@@ -7826,7 +8471,7 @@
           <p:cNvPr id="3" name="">
             <a:extLst xmlns:a="http://schemas.openxmlformats.org/drawingml/2006/main">
               <a:ext uri="{FF2B5EF4-FFF2-40B4-BE49-F238E27FC236}">
-                <a16:creationId xmlns:a16="http://schemas.microsoft.com/office/drawing/2014/main" id="{5A05763B-20C5-4255-8E00-350D59BB9820}"/>
+                <a16:creationId xmlns:a16="http://schemas.microsoft.com/office/drawing/2014/main" id="{F8009FDE-080B-4B08-A414-A5BD17E8868A}"/>
               </a:ext>
             </a:extLst>
           </p:cNvPr>
@@ -7883,7 +8528,7 @@
           <p:cNvPr id="4" name="">
             <a:extLst xmlns:a="http://schemas.openxmlformats.org/drawingml/2006/main">
               <a:ext uri="{FF2B5EF4-FFF2-40B4-BE49-F238E27FC236}">
-                <a16:creationId xmlns:a16="http://schemas.microsoft.com/office/drawing/2014/main" id="{000492D4-3CAB-499A-AA60-29E902519CEA}"/>
+                <a16:creationId xmlns:a16="http://schemas.microsoft.com/office/drawing/2014/main" id="{7A599CEF-2799-4B9E-AAA4-9CA9BB548F04}"/>
               </a:ext>
             </a:extLst>
           </p:cNvPr>
@@ -7947,7 +8592,7 @@
           <p:cNvPr id="5" name="">
             <a:extLst xmlns:a="http://schemas.openxmlformats.org/drawingml/2006/main">
               <a:ext uri="{FF2B5EF4-FFF2-40B4-BE49-F238E27FC236}">
-                <a16:creationId xmlns:a16="http://schemas.microsoft.com/office/drawing/2014/main" id="{C632784C-120B-4959-80E7-E97E3811EBCE}"/>
+                <a16:creationId xmlns:a16="http://schemas.microsoft.com/office/drawing/2014/main" id="{9400B269-1750-48D9-9AB3-6B13A13EBEB7}"/>
               </a:ext>
             </a:extLst>
           </p:cNvPr>
@@ -8011,7 +8656,7 @@
           <p:cNvPr id="6" name="">
             <a:extLst xmlns:a="http://schemas.openxmlformats.org/drawingml/2006/main">
               <a:ext uri="{FF2B5EF4-FFF2-40B4-BE49-F238E27FC236}">
-                <a16:creationId xmlns:a16="http://schemas.microsoft.com/office/drawing/2014/main" id="{9909C1C7-F2E5-4D68-96C5-BC5099143332}"/>
+                <a16:creationId xmlns:a16="http://schemas.microsoft.com/office/drawing/2014/main" id="{25011410-8BCD-41BE-B97D-3635C088D9DA}"/>
               </a:ext>
             </a:extLst>
           </p:cNvPr>
@@ -8075,7 +8720,7 @@
           <p:cNvPr id="7" name="">
             <a:extLst xmlns:a="http://schemas.openxmlformats.org/drawingml/2006/main">
               <a:ext uri="{FF2B5EF4-FFF2-40B4-BE49-F238E27FC236}">
-                <a16:creationId xmlns:a16="http://schemas.microsoft.com/office/drawing/2014/main" id="{9FD59F1D-F7D2-4CB7-ABD2-8737C2700602}"/>
+                <a16:creationId xmlns:a16="http://schemas.microsoft.com/office/drawing/2014/main" id="{6E5BA304-14AF-4E4F-98B4-F6897D34A9A0}"/>
               </a:ext>
             </a:extLst>
           </p:cNvPr>
@@ -8139,7 +8784,7 @@
           <p:cNvPr id="8" name="">
             <a:extLst xmlns:a="http://schemas.openxmlformats.org/drawingml/2006/main">
               <a:ext uri="{FF2B5EF4-FFF2-40B4-BE49-F238E27FC236}">
-                <a16:creationId xmlns:a16="http://schemas.microsoft.com/office/drawing/2014/main" id="{450142FF-F058-49E4-ADA4-6F9C7BA87ADA}"/>
+                <a16:creationId xmlns:a16="http://schemas.microsoft.com/office/drawing/2014/main" id="{B0153EA3-E36F-4161-870D-14C98F3B14AC}"/>
               </a:ext>
             </a:extLst>
           </p:cNvPr>
@@ -8203,7 +8848,7 @@
           <p:cNvPr id="9" name="">
             <a:extLst xmlns:a="http://schemas.openxmlformats.org/drawingml/2006/main">
               <a:ext uri="{FF2B5EF4-FFF2-40B4-BE49-F238E27FC236}">
-                <a16:creationId xmlns:a16="http://schemas.microsoft.com/office/drawing/2014/main" id="{C9E13A0F-280B-4FB3-B884-7781CB6E0591}"/>
+                <a16:creationId xmlns:a16="http://schemas.microsoft.com/office/drawing/2014/main" id="{6D2DFF6C-D5EB-4133-960F-7B2EF32AB7BE}"/>
               </a:ext>
             </a:extLst>
           </p:cNvPr>
@@ -8409,7 +9054,7 @@
           <p:cNvPr id="15" name="">
             <a:extLst xmlns:a="http://schemas.openxmlformats.org/drawingml/2006/main">
               <a:ext uri="{FF2B5EF4-FFF2-40B4-BE49-F238E27FC236}">
-                <a16:creationId xmlns:a16="http://schemas.microsoft.com/office/drawing/2014/main" id="{110D404C-2960-4F4D-B9A3-6F23D5C05E4F}"/>
+                <a16:creationId xmlns:a16="http://schemas.microsoft.com/office/drawing/2014/main" id="{D27AB34C-2AD2-4495-94FA-A6547CE0EE84}"/>
               </a:ext>
             </a:extLst>
           </p:cNvPr>
@@ -8633,7 +9278,7 @@
           <p:cNvPr id="21" name="">
             <a:extLst xmlns:a="http://schemas.openxmlformats.org/drawingml/2006/main">
               <a:ext uri="{FF2B5EF4-FFF2-40B4-BE49-F238E27FC236}">
-                <a16:creationId xmlns:a16="http://schemas.microsoft.com/office/drawing/2014/main" id="{E0B03D74-A28E-4DBF-AE69-664B9BA7FD8F}"/>
+                <a16:creationId xmlns:a16="http://schemas.microsoft.com/office/drawing/2014/main" id="{ECB58850-6941-4913-A74B-7903338E62DD}"/>
               </a:ext>
             </a:extLst>
           </p:cNvPr>
@@ -8688,7 +9333,7 @@
     </p:spTree>
     <p:extLst>
       <p:ext uri="{BB962C8B-B14F-4D97-AF65-F5344CB8AC3E}">
-        <p14:creationId xmlns:p14="http://schemas.microsoft.com/office/powerpoint/2010/main" val="800697317"/>
+        <p14:creationId xmlns:p14="http://schemas.microsoft.com/office/powerpoint/2010/main" val="1555247467"/>
       </p:ext>
     </p:extLst>
   </p:cSld>
@@ -8719,7 +9364,7 @@
           <p:cNvPr id="16" name="">
             <a:extLst xmlns:a="http://schemas.openxmlformats.org/drawingml/2006/main">
               <a:ext uri="{FF2B5EF4-FFF2-40B4-BE49-F238E27FC236}">
-                <a16:creationId xmlns:a16="http://schemas.microsoft.com/office/drawing/2014/main" id="{1199B5B4-57D5-4DD9-B184-B695E921A896}"/>
+                <a16:creationId xmlns:a16="http://schemas.microsoft.com/office/drawing/2014/main" id="{1DD6C975-4BFB-494E-8A6E-7572442F3CC9}"/>
               </a:ext>
             </a:extLst>
           </p:cNvPr>
@@ -8749,7 +9394,7 @@
           <p:cNvPr id="2" name="">
             <a:extLst xmlns:a="http://schemas.openxmlformats.org/drawingml/2006/main">
               <a:ext uri="{FF2B5EF4-FFF2-40B4-BE49-F238E27FC236}">
-                <a16:creationId xmlns:a16="http://schemas.microsoft.com/office/drawing/2014/main" id="{11CF0CD4-B21A-4A88-99C2-E121886E852E}"/>
+                <a16:creationId xmlns:a16="http://schemas.microsoft.com/office/drawing/2014/main" id="{DB1BFB9A-F731-409E-92D5-D2FC5C5B27B1}"/>
               </a:ext>
             </a:extLst>
           </p:cNvPr>
@@ -8806,7 +9451,7 @@
           <p:cNvPr id="3" name="">
             <a:extLst xmlns:a="http://schemas.openxmlformats.org/drawingml/2006/main">
               <a:ext uri="{FF2B5EF4-FFF2-40B4-BE49-F238E27FC236}">
-                <a16:creationId xmlns:a16="http://schemas.microsoft.com/office/drawing/2014/main" id="{E13AA869-956F-43CE-B39D-2DF9C64517AA}"/>
+                <a16:creationId xmlns:a16="http://schemas.microsoft.com/office/drawing/2014/main" id="{BD5A08D8-43EE-48FE-A98C-874C2252DC78}"/>
               </a:ext>
             </a:extLst>
           </p:cNvPr>
@@ -8863,7 +9508,7 @@
           <p:cNvPr id="4" name="">
             <a:extLst xmlns:a="http://schemas.openxmlformats.org/drawingml/2006/main">
               <a:ext uri="{FF2B5EF4-FFF2-40B4-BE49-F238E27FC236}">
-                <a16:creationId xmlns:a16="http://schemas.microsoft.com/office/drawing/2014/main" id="{A21364B0-3D6D-4233-9F57-BF7703D49290}"/>
+                <a16:creationId xmlns:a16="http://schemas.microsoft.com/office/drawing/2014/main" id="{6E248127-7B79-4B5D-B0DC-9A545F447280}"/>
               </a:ext>
             </a:extLst>
           </p:cNvPr>
@@ -8920,7 +9565,7 @@
           <p:cNvPr id="5" name="">
             <a:extLst xmlns:a="http://schemas.openxmlformats.org/drawingml/2006/main">
               <a:ext uri="{FF2B5EF4-FFF2-40B4-BE49-F238E27FC236}">
-                <a16:creationId xmlns:a16="http://schemas.microsoft.com/office/drawing/2014/main" id="{64B206F1-4D69-495F-AC17-222895815B9A}"/>
+                <a16:creationId xmlns:a16="http://schemas.microsoft.com/office/drawing/2014/main" id="{3F137B24-F9CD-495A-93F9-52F77F7A579D}"/>
               </a:ext>
             </a:extLst>
           </p:cNvPr>
@@ -8977,7 +9622,7 @@
           <p:cNvPr id="6" name="">
             <a:extLst xmlns:a="http://schemas.openxmlformats.org/drawingml/2006/main">
               <a:ext uri="{FF2B5EF4-FFF2-40B4-BE49-F238E27FC236}">
-                <a16:creationId xmlns:a16="http://schemas.microsoft.com/office/drawing/2014/main" id="{CDDB17A6-94B6-4DA4-BCFE-F7192E9BD0CC}"/>
+                <a16:creationId xmlns:a16="http://schemas.microsoft.com/office/drawing/2014/main" id="{5EE0CEA6-5B54-4919-8D9B-45AC4BE47857}"/>
               </a:ext>
             </a:extLst>
           </p:cNvPr>
@@ -9034,7 +9679,7 @@
           <p:cNvPr id="7" name="">
             <a:extLst xmlns:a="http://schemas.openxmlformats.org/drawingml/2006/main">
               <a:ext uri="{FF2B5EF4-FFF2-40B4-BE49-F238E27FC236}">
-                <a16:creationId xmlns:a16="http://schemas.microsoft.com/office/drawing/2014/main" id="{BCC9BF7E-2396-4DED-8DA0-9706C7F37EA0}"/>
+                <a16:creationId xmlns:a16="http://schemas.microsoft.com/office/drawing/2014/main" id="{C51A315E-0894-42FB-9852-85CEB4AE73E8}"/>
               </a:ext>
             </a:extLst>
           </p:cNvPr>
@@ -9091,7 +9736,7 @@
           <p:cNvPr id="8" name="">
             <a:extLst xmlns:a="http://schemas.openxmlformats.org/drawingml/2006/main">
               <a:ext uri="{FF2B5EF4-FFF2-40B4-BE49-F238E27FC236}">
-                <a16:creationId xmlns:a16="http://schemas.microsoft.com/office/drawing/2014/main" id="{A9A7202A-AE82-49C4-BDA0-4D45DC96434D}"/>
+                <a16:creationId xmlns:a16="http://schemas.microsoft.com/office/drawing/2014/main" id="{19892472-56DB-4264-9CB3-904F62B20DAE}"/>
               </a:ext>
             </a:extLst>
           </p:cNvPr>
@@ -9148,7 +9793,7 @@
           <p:cNvPr id="9" name="">
             <a:extLst xmlns:a="http://schemas.openxmlformats.org/drawingml/2006/main">
               <a:ext uri="{FF2B5EF4-FFF2-40B4-BE49-F238E27FC236}">
-                <a16:creationId xmlns:a16="http://schemas.microsoft.com/office/drawing/2014/main" id="{B6DFBDF6-17FD-4F9A-BA99-468EBC391695}"/>
+                <a16:creationId xmlns:a16="http://schemas.microsoft.com/office/drawing/2014/main" id="{5CD7A8A0-75CB-4E62-87B1-49E62AF78A45}"/>
               </a:ext>
             </a:extLst>
           </p:cNvPr>
@@ -9205,7 +9850,7 @@
           <p:cNvPr id="10" name="">
             <a:extLst xmlns:a="http://schemas.openxmlformats.org/drawingml/2006/main">
               <a:ext uri="{FF2B5EF4-FFF2-40B4-BE49-F238E27FC236}">
-                <a16:creationId xmlns:a16="http://schemas.microsoft.com/office/drawing/2014/main" id="{6C298992-D9E2-43D4-81FA-345842C9E9A7}"/>
+                <a16:creationId xmlns:a16="http://schemas.microsoft.com/office/drawing/2014/main" id="{96C20F3E-944C-4D7C-92CD-440188A1D8E3}"/>
               </a:ext>
             </a:extLst>
           </p:cNvPr>
@@ -9262,7 +9907,7 @@
           <p:cNvPr id="11" name="">
             <a:extLst xmlns:a="http://schemas.openxmlformats.org/drawingml/2006/main">
               <a:ext uri="{FF2B5EF4-FFF2-40B4-BE49-F238E27FC236}">
-                <a16:creationId xmlns:a16="http://schemas.microsoft.com/office/drawing/2014/main" id="{CE619DF6-8ACF-4B29-9204-AFC1491C897D}"/>
+                <a16:creationId xmlns:a16="http://schemas.microsoft.com/office/drawing/2014/main" id="{F40A19AB-2851-40EB-8ABD-6718B69BCDA8}"/>
               </a:ext>
             </a:extLst>
           </p:cNvPr>
@@ -9319,7 +9964,7 @@
           <p:cNvPr id="12" name="">
             <a:extLst xmlns:a="http://schemas.openxmlformats.org/drawingml/2006/main">
               <a:ext uri="{FF2B5EF4-FFF2-40B4-BE49-F238E27FC236}">
-                <a16:creationId xmlns:a16="http://schemas.microsoft.com/office/drawing/2014/main" id="{4F459BE6-0A7D-4380-8A9E-49DA8690170B}"/>
+                <a16:creationId xmlns:a16="http://schemas.microsoft.com/office/drawing/2014/main" id="{E92ABE92-8ED0-4AE2-9FDF-26D0F463DD93}"/>
               </a:ext>
             </a:extLst>
           </p:cNvPr>
@@ -9376,7 +10021,7 @@
           <p:cNvPr id="13" name="">
             <a:extLst xmlns:a="http://schemas.openxmlformats.org/drawingml/2006/main">
               <a:ext uri="{FF2B5EF4-FFF2-40B4-BE49-F238E27FC236}">
-                <a16:creationId xmlns:a16="http://schemas.microsoft.com/office/drawing/2014/main" id="{7231D201-E436-4686-AF30-836E316B50FD}"/>
+                <a16:creationId xmlns:a16="http://schemas.microsoft.com/office/drawing/2014/main" id="{ABAF28C8-CAA0-497B-B633-ECCF82D79E13}"/>
               </a:ext>
             </a:extLst>
           </p:cNvPr>
@@ -9433,7 +10078,7 @@
           <p:cNvPr id="14" name="">
             <a:extLst xmlns:a="http://schemas.openxmlformats.org/drawingml/2006/main">
               <a:ext uri="{FF2B5EF4-FFF2-40B4-BE49-F238E27FC236}">
-                <a16:creationId xmlns:a16="http://schemas.microsoft.com/office/drawing/2014/main" id="{0BA7CDEE-FAE1-409B-92C9-7C56DFDC4BA1}"/>
+                <a16:creationId xmlns:a16="http://schemas.microsoft.com/office/drawing/2014/main" id="{1242F425-B88F-4137-BA56-548732F3F66D}"/>
               </a:ext>
             </a:extLst>
           </p:cNvPr>
@@ -9490,7 +10135,7 @@
           <p:cNvPr id="15" name="">
             <a:extLst xmlns:a="http://schemas.openxmlformats.org/drawingml/2006/main">
               <a:ext uri="{FF2B5EF4-FFF2-40B4-BE49-F238E27FC236}">
-                <a16:creationId xmlns:a16="http://schemas.microsoft.com/office/drawing/2014/main" id="{0B813162-8D3B-400E-AB1A-1D7E7DD3C4E3}"/>
+                <a16:creationId xmlns:a16="http://schemas.microsoft.com/office/drawing/2014/main" id="{4EE43609-9C62-40B6-8656-92F123AA4F33}"/>
               </a:ext>
             </a:extLst>
           </p:cNvPr>
@@ -9545,7 +10190,7 @@
     </p:spTree>
     <p:extLst>
       <p:ext uri="{BB962C8B-B14F-4D97-AF65-F5344CB8AC3E}">
-        <p14:creationId xmlns:p14="http://schemas.microsoft.com/office/powerpoint/2010/main" val="1387823700"/>
+        <p14:creationId xmlns:p14="http://schemas.microsoft.com/office/powerpoint/2010/main" val="1802019160"/>
       </p:ext>
     </p:extLst>
   </p:cSld>
@@ -9576,7 +10221,7 @@
           <p:cNvPr id="11" name="">
             <a:extLst xmlns:a="http://schemas.openxmlformats.org/drawingml/2006/main">
               <a:ext uri="{FF2B5EF4-FFF2-40B4-BE49-F238E27FC236}">
-                <a16:creationId xmlns:a16="http://schemas.microsoft.com/office/drawing/2014/main" id="{FB90C2AF-50A2-4380-A8E4-CA301C8343AB}"/>
+                <a16:creationId xmlns:a16="http://schemas.microsoft.com/office/drawing/2014/main" id="{6D7ED57A-21DD-455F-A1FD-78163D3D6957}"/>
               </a:ext>
             </a:extLst>
           </p:cNvPr>
@@ -9606,7 +10251,7 @@
           <p:cNvPr id="2" name="">
             <a:extLst xmlns:a="http://schemas.openxmlformats.org/drawingml/2006/main">
               <a:ext uri="{FF2B5EF4-FFF2-40B4-BE49-F238E27FC236}">
-                <a16:creationId xmlns:a16="http://schemas.microsoft.com/office/drawing/2014/main" id="{123E34D7-85F6-4A21-80CD-9790D363001E}"/>
+                <a16:creationId xmlns:a16="http://schemas.microsoft.com/office/drawing/2014/main" id="{DFED6BF7-D173-441E-9335-0C00D21806EE}"/>
               </a:ext>
             </a:extLst>
           </p:cNvPr>
@@ -9663,7 +10308,7 @@
           <p:cNvPr id="3" name="">
             <a:extLst xmlns:a="http://schemas.openxmlformats.org/drawingml/2006/main">
               <a:ext uri="{FF2B5EF4-FFF2-40B4-BE49-F238E27FC236}">
-                <a16:creationId xmlns:a16="http://schemas.microsoft.com/office/drawing/2014/main" id="{557A7E04-8CE5-40CD-B7D3-E6E270FD0595}"/>
+                <a16:creationId xmlns:a16="http://schemas.microsoft.com/office/drawing/2014/main" id="{07A3455B-B701-42C8-9C88-993C069AC72D}"/>
               </a:ext>
             </a:extLst>
           </p:cNvPr>
@@ -9720,7 +10365,7 @@
           <p:cNvPr id="4" name="">
             <a:extLst xmlns:a="http://schemas.openxmlformats.org/drawingml/2006/main">
               <a:ext uri="{FF2B5EF4-FFF2-40B4-BE49-F238E27FC236}">
-                <a16:creationId xmlns:a16="http://schemas.microsoft.com/office/drawing/2014/main" id="{A4832D48-ECF0-4FE8-8136-DDAB4981D74F}"/>
+                <a16:creationId xmlns:a16="http://schemas.microsoft.com/office/drawing/2014/main" id="{5E5792B6-15B3-4B1D-973E-FF411F70361D}"/>
               </a:ext>
             </a:extLst>
           </p:cNvPr>
@@ -9807,7 +10452,7 @@
           <p:cNvPr id="5" name="">
             <a:extLst xmlns:a="http://schemas.openxmlformats.org/drawingml/2006/main">
               <a:ext uri="{FF2B5EF4-FFF2-40B4-BE49-F238E27FC236}">
-                <a16:creationId xmlns:a16="http://schemas.microsoft.com/office/drawing/2014/main" id="{E087F9BD-6403-43E8-867E-28B03CA8219B}"/>
+                <a16:creationId xmlns:a16="http://schemas.microsoft.com/office/drawing/2014/main" id="{41A0A42A-584B-474B-9637-FB7FA2030B4E}"/>
               </a:ext>
             </a:extLst>
           </p:cNvPr>
@@ -9894,7 +10539,7 @@
           <p:cNvPr id="6" name="">
             <a:extLst xmlns:a="http://schemas.openxmlformats.org/drawingml/2006/main">
               <a:ext uri="{FF2B5EF4-FFF2-40B4-BE49-F238E27FC236}">
-                <a16:creationId xmlns:a16="http://schemas.microsoft.com/office/drawing/2014/main" id="{E9E42AA0-5DB0-41BB-9B5B-6738ABE96FFC}"/>
+                <a16:creationId xmlns:a16="http://schemas.microsoft.com/office/drawing/2014/main" id="{810BB848-67E7-4D3E-87E8-E7BFCC7F1AF1}"/>
               </a:ext>
             </a:extLst>
           </p:cNvPr>
@@ -10033,7 +10678,7 @@
           <p:cNvPr id="9" name="">
             <a:extLst xmlns:a="http://schemas.openxmlformats.org/drawingml/2006/main">
               <a:ext uri="{FF2B5EF4-FFF2-40B4-BE49-F238E27FC236}">
-                <a16:creationId xmlns:a16="http://schemas.microsoft.com/office/drawing/2014/main" id="{58DE44CD-E42E-4062-9561-42F66BF6F64D}"/>
+                <a16:creationId xmlns:a16="http://schemas.microsoft.com/office/drawing/2014/main" id="{30A3BB40-27C9-42B2-BD53-E7A2ADC162F0}"/>
               </a:ext>
             </a:extLst>
           </p:cNvPr>
@@ -10090,7 +10735,7 @@
           <p:cNvPr id="10" name="">
             <a:extLst xmlns:a="http://schemas.openxmlformats.org/drawingml/2006/main">
               <a:ext uri="{FF2B5EF4-FFF2-40B4-BE49-F238E27FC236}">
-                <a16:creationId xmlns:a16="http://schemas.microsoft.com/office/drawing/2014/main" id="{E5D53B3D-07DC-43B5-9B18-B106ED3BA1F1}"/>
+                <a16:creationId xmlns:a16="http://schemas.microsoft.com/office/drawing/2014/main" id="{C51318F9-A87C-4AB3-822F-74ED3B375346}"/>
               </a:ext>
             </a:extLst>
           </p:cNvPr>
@@ -10145,7 +10790,7 @@
     </p:spTree>
     <p:extLst>
       <p:ext uri="{BB962C8B-B14F-4D97-AF65-F5344CB8AC3E}">
-        <p14:creationId xmlns:p14="http://schemas.microsoft.com/office/powerpoint/2010/main" val="1170131312"/>
+        <p14:creationId xmlns:p14="http://schemas.microsoft.com/office/powerpoint/2010/main" val="1750722494"/>
       </p:ext>
     </p:extLst>
   </p:cSld>
@@ -10176,7 +10821,7 @@
           <p:cNvPr id="12" name="">
             <a:extLst xmlns:a="http://schemas.openxmlformats.org/drawingml/2006/main">
               <a:ext uri="{FF2B5EF4-FFF2-40B4-BE49-F238E27FC236}">
-                <a16:creationId xmlns:a16="http://schemas.microsoft.com/office/drawing/2014/main" id="{085575D7-70B7-4B3B-9057-E057CEA8F22D}"/>
+                <a16:creationId xmlns:a16="http://schemas.microsoft.com/office/drawing/2014/main" id="{CA503FC6-FA3E-44C9-A6DB-268FE6E74CF0}"/>
               </a:ext>
             </a:extLst>
           </p:cNvPr>
@@ -10206,7 +10851,7 @@
           <p:cNvPr id="2" name="">
             <a:extLst xmlns:a="http://schemas.openxmlformats.org/drawingml/2006/main">
               <a:ext uri="{FF2B5EF4-FFF2-40B4-BE49-F238E27FC236}">
-                <a16:creationId xmlns:a16="http://schemas.microsoft.com/office/drawing/2014/main" id="{16DFC777-67BC-4F60-8EE7-D68510CA048A}"/>
+                <a16:creationId xmlns:a16="http://schemas.microsoft.com/office/drawing/2014/main" id="{390473F1-8A68-4CDE-9913-8AF8FD36FD97}"/>
               </a:ext>
             </a:extLst>
           </p:cNvPr>
@@ -10263,7 +10908,7 @@
           <p:cNvPr id="3" name="">
             <a:extLst xmlns:a="http://schemas.openxmlformats.org/drawingml/2006/main">
               <a:ext uri="{FF2B5EF4-FFF2-40B4-BE49-F238E27FC236}">
-                <a16:creationId xmlns:a16="http://schemas.microsoft.com/office/drawing/2014/main" id="{23C008E6-F57B-4888-9FA6-48F035B164DC}"/>
+                <a16:creationId xmlns:a16="http://schemas.microsoft.com/office/drawing/2014/main" id="{21469B64-6DFA-44E2-8192-3F62CFEF6D46}"/>
               </a:ext>
             </a:extLst>
           </p:cNvPr>
@@ -10320,7 +10965,7 @@
           <p:cNvPr id="4" name="">
             <a:extLst xmlns:a="http://schemas.openxmlformats.org/drawingml/2006/main">
               <a:ext uri="{FF2B5EF4-FFF2-40B4-BE49-F238E27FC236}">
-                <a16:creationId xmlns:a16="http://schemas.microsoft.com/office/drawing/2014/main" id="{8779159F-03AB-462D-A19C-B0328B8E44A6}"/>
+                <a16:creationId xmlns:a16="http://schemas.microsoft.com/office/drawing/2014/main" id="{196FE4BF-20C9-4108-AEA5-70D4497F92AA}"/>
               </a:ext>
             </a:extLst>
           </p:cNvPr>
@@ -10407,7 +11052,7 @@
           <p:cNvPr id="5" name="">
             <a:extLst xmlns:a="http://schemas.openxmlformats.org/drawingml/2006/main">
               <a:ext uri="{FF2B5EF4-FFF2-40B4-BE49-F238E27FC236}">
-                <a16:creationId xmlns:a16="http://schemas.microsoft.com/office/drawing/2014/main" id="{2CAB1BF9-2835-47D9-90EB-ADE2BF27F6C8}"/>
+                <a16:creationId xmlns:a16="http://schemas.microsoft.com/office/drawing/2014/main" id="{D5A8B667-4588-47EA-B3DF-B1BB22B6FD00}"/>
               </a:ext>
             </a:extLst>
           </p:cNvPr>
@@ -10494,7 +11139,7 @@
           <p:cNvPr id="6" name="">
             <a:extLst xmlns:a="http://schemas.openxmlformats.org/drawingml/2006/main">
               <a:ext uri="{FF2B5EF4-FFF2-40B4-BE49-F238E27FC236}">
-                <a16:creationId xmlns:a16="http://schemas.microsoft.com/office/drawing/2014/main" id="{B892400D-5236-41C2-9285-D65104B2A865}"/>
+                <a16:creationId xmlns:a16="http://schemas.microsoft.com/office/drawing/2014/main" id="{D0A63839-4580-48C5-A679-28907424AB0A}"/>
               </a:ext>
             </a:extLst>
           </p:cNvPr>
@@ -10581,7 +11226,7 @@
           <p:cNvPr id="7" name="">
             <a:extLst xmlns:a="http://schemas.openxmlformats.org/drawingml/2006/main">
               <a:ext uri="{FF2B5EF4-FFF2-40B4-BE49-F238E27FC236}">
-                <a16:creationId xmlns:a16="http://schemas.microsoft.com/office/drawing/2014/main" id="{9131F575-2668-4C41-9410-4B854F5DEF4A}"/>
+                <a16:creationId xmlns:a16="http://schemas.microsoft.com/office/drawing/2014/main" id="{0E9F3CED-D2E4-48BA-9949-212B1EA69606}"/>
               </a:ext>
             </a:extLst>
           </p:cNvPr>
@@ -10750,7 +11395,7 @@
           <p:cNvPr id="11" name="">
             <a:extLst xmlns:a="http://schemas.openxmlformats.org/drawingml/2006/main">
               <a:ext uri="{FF2B5EF4-FFF2-40B4-BE49-F238E27FC236}">
-                <a16:creationId xmlns:a16="http://schemas.microsoft.com/office/drawing/2014/main" id="{D45D2537-D9D7-4652-BF63-3027A84CDAF2}"/>
+                <a16:creationId xmlns:a16="http://schemas.microsoft.com/office/drawing/2014/main" id="{371649F5-7A46-44E1-A847-EC7BF5482F2C}"/>
               </a:ext>
             </a:extLst>
           </p:cNvPr>
@@ -10805,7 +11450,7 @@
     </p:spTree>
     <p:extLst>
       <p:ext uri="{BB962C8B-B14F-4D97-AF65-F5344CB8AC3E}">
-        <p14:creationId xmlns:p14="http://schemas.microsoft.com/office/powerpoint/2010/main" val="102722594"/>
+        <p14:creationId xmlns:p14="http://schemas.microsoft.com/office/powerpoint/2010/main" val="2073358320"/>
       </p:ext>
     </p:extLst>
   </p:cSld>

</xml_diff>

<commit_message>
feat: implementa módulos ArchCorp e cronograma integrado
</commit_message>
<xml_diff>
--- a/output/Apresentacao_Cenario_4.pptx
+++ b/output/Apresentacao_Cenario_4.pptx
@@ -2,27 +2,27 @@
 <file path=ppt/presentation.xml><?xml version="1.0" encoding="utf-8"?>
 <p:presentation xmlns:p="http://schemas.openxmlformats.org/presentationml/2006/main">
   <p:sldMasterIdLst>
-    <p:sldMasterId xmlns:r="http://schemas.openxmlformats.org/officeDocument/2006/relationships" id="2147483648" r:id="Rb7d2d25d8e514389"/>
+    <p:sldMasterId xmlns:r="http://schemas.openxmlformats.org/officeDocument/2006/relationships" id="2147483648" r:id="R33dbe10fc2fb45a7"/>
   </p:sldMasterIdLst>
   <p:notesMasterIdLst>
-    <p:notesMasterId xmlns:r="http://schemas.openxmlformats.org/officeDocument/2006/relationships" r:id="Racffacf50a134154"/>
+    <p:notesMasterId xmlns:r="http://schemas.openxmlformats.org/officeDocument/2006/relationships" r:id="R2c7684a86d3d4103"/>
   </p:notesMasterIdLst>
   <p:sldIdLst>
-    <p:sldId xmlns:r="http://schemas.openxmlformats.org/officeDocument/2006/relationships" id="256" r:id="R5d876cba77b64cd3"/>
-    <p:sldId xmlns:r="http://schemas.openxmlformats.org/officeDocument/2006/relationships" id="257" r:id="R18a8d225f8fa4e6c"/>
-    <p:sldId xmlns:r="http://schemas.openxmlformats.org/officeDocument/2006/relationships" id="258" r:id="Rd7a9fc273593449f"/>
-    <p:sldId xmlns:r="http://schemas.openxmlformats.org/officeDocument/2006/relationships" id="259" r:id="R1273e750469e4a55"/>
-    <p:sldId xmlns:r="http://schemas.openxmlformats.org/officeDocument/2006/relationships" id="260" r:id="R160a2cfa026f4bcd"/>
-    <p:sldId xmlns:r="http://schemas.openxmlformats.org/officeDocument/2006/relationships" id="261" r:id="Rf6d302c7173b4c55"/>
-    <p:sldId xmlns:r="http://schemas.openxmlformats.org/officeDocument/2006/relationships" id="262" r:id="R0584fdfbcca44af9"/>
-    <p:sldId xmlns:r="http://schemas.openxmlformats.org/officeDocument/2006/relationships" id="263" r:id="R458b4f597fb345d8"/>
-    <p:sldId xmlns:r="http://schemas.openxmlformats.org/officeDocument/2006/relationships" id="264" r:id="Raf43d392ae2149f9"/>
-    <p:sldId xmlns:r="http://schemas.openxmlformats.org/officeDocument/2006/relationships" id="265" r:id="R478b15ef94f645e2"/>
-    <p:sldId xmlns:r="http://schemas.openxmlformats.org/officeDocument/2006/relationships" id="266" r:id="Rfe1c7ae7d9fd4089"/>
-    <p:sldId xmlns:r="http://schemas.openxmlformats.org/officeDocument/2006/relationships" id="267" r:id="Ra20154a06f8642c5"/>
-    <p:sldId xmlns:r="http://schemas.openxmlformats.org/officeDocument/2006/relationships" id="268" r:id="R1721cd0d0aab4f8c"/>
-    <p:sldId xmlns:r="http://schemas.openxmlformats.org/officeDocument/2006/relationships" id="269" r:id="R8c8d77527fc343ef"/>
-    <p:sldId xmlns:r="http://schemas.openxmlformats.org/officeDocument/2006/relationships" id="270" r:id="R8469018e84304197"/>
+    <p:sldId xmlns:r="http://schemas.openxmlformats.org/officeDocument/2006/relationships" id="256" r:id="Ra7e059f5afeb45b1"/>
+    <p:sldId xmlns:r="http://schemas.openxmlformats.org/officeDocument/2006/relationships" id="257" r:id="R89e9ee3f737a49ba"/>
+    <p:sldId xmlns:r="http://schemas.openxmlformats.org/officeDocument/2006/relationships" id="258" r:id="Rd3a846d83a344509"/>
+    <p:sldId xmlns:r="http://schemas.openxmlformats.org/officeDocument/2006/relationships" id="259" r:id="R418e239e82004a1d"/>
+    <p:sldId xmlns:r="http://schemas.openxmlformats.org/officeDocument/2006/relationships" id="260" r:id="Rbf4f7a639fd248fb"/>
+    <p:sldId xmlns:r="http://schemas.openxmlformats.org/officeDocument/2006/relationships" id="261" r:id="Rbcbff4ba0ef24e43"/>
+    <p:sldId xmlns:r="http://schemas.openxmlformats.org/officeDocument/2006/relationships" id="262" r:id="R51a9053fc1c64e20"/>
+    <p:sldId xmlns:r="http://schemas.openxmlformats.org/officeDocument/2006/relationships" id="263" r:id="R1afb59d3eb5b4d61"/>
+    <p:sldId xmlns:r="http://schemas.openxmlformats.org/officeDocument/2006/relationships" id="264" r:id="R9cf837c3df98471a"/>
+    <p:sldId xmlns:r="http://schemas.openxmlformats.org/officeDocument/2006/relationships" id="265" r:id="Rb4c322c0fa964d40"/>
+    <p:sldId xmlns:r="http://schemas.openxmlformats.org/officeDocument/2006/relationships" id="266" r:id="R6de035de01d74cf5"/>
+    <p:sldId xmlns:r="http://schemas.openxmlformats.org/officeDocument/2006/relationships" id="267" r:id="Rf6304cf18b29416d"/>
+    <p:sldId xmlns:r="http://schemas.openxmlformats.org/officeDocument/2006/relationships" id="268" r:id="R977f7391e79b4f64"/>
+    <p:sldId xmlns:r="http://schemas.openxmlformats.org/officeDocument/2006/relationships" id="269" r:id="R74d6c326570d4a96"/>
+    <p:sldId xmlns:r="http://schemas.openxmlformats.org/officeDocument/2006/relationships" id="270" r:id="R703be5d6d8d24c30"/>
   </p:sldIdLst>
   <p:sldSz cx="12192000" cy="6858000"/>
   <p:notesSz cx="6858000" cy="9144000"/>
@@ -456,7 +456,7 @@
           <a:lstStyle xmlns:a="http://schemas.openxmlformats.org/drawingml/2006/main"/>
           <a:p xmlns:a="http://schemas.openxmlformats.org/drawingml/2006/main">
             <a:r>
-              <a:t>Fonte principal: Projeto Aplicado ArchCorp, enunciado acadêmico fornecido ao projeto, 2026.</a:t>
+              <a:t>Fonte principal: Projeto Aplicado Localiza, enunciado acadêmico fornecido ao projeto, 2026.</a:t>
             </a:r>
           </a:p>
         </p:txBody>
@@ -1436,7 +1436,7 @@
           <a:lstStyle xmlns:a="http://schemas.openxmlformats.org/drawingml/2006/main"/>
           <a:p xmlns:a="http://schemas.openxmlformats.org/drawingml/2006/main">
             <a:r>
-              <a:t>Fonte: docs/INTEGRACOES.md e teste test_f2_ativacao_cria_uma_cobranca_e_um_onboarding.</a:t>
+              <a:t>Fonte: docs/INTEGRACOES.md e teste test_f2_ativacao_cria_uma_cobranca_e_uma_preparacao_de_retirada.</a:t>
             </a:r>
           </a:p>
         </p:txBody>
@@ -1504,7 +1504,7 @@
   </p:cSld>
   <p:clrMap bg1="lt1" tx1="dk1" bg2="lt2" tx2="dk2" accent1="accent1" accent2="accent2" accent3="accent3" accent4="accent4" accent5="accent5" accent6="accent6" hlink="hlink" folHlink="folHlink"/>
   <p:sldLayoutIdLst>
-    <p:sldLayoutId xmlns:r="http://schemas.openxmlformats.org/officeDocument/2006/relationships" id="2147483649" r:id="Rb4e71fcbe3b840b3"/>
+    <p:sldLayoutId xmlns:r="http://schemas.openxmlformats.org/officeDocument/2006/relationships" id="2147483649" r:id="Rd4b7f50e9a3149df"/>
   </p:sldLayoutIdLst>
   <p:txStyles>
     <p:titleStyle>
@@ -2055,7 +2055,7 @@
           <p:cNvPr id="5" name="">
             <a:extLst xmlns:a="http://schemas.openxmlformats.org/drawingml/2006/main">
               <a:ext uri="{FF2B5EF4-FFF2-40B4-BE49-F238E27FC236}">
-                <a16:creationId xmlns:a16="http://schemas.microsoft.com/office/drawing/2014/main" id="{8B7EC844-7FD3-49B5-A6A9-26A7D0742D3D}"/>
+                <a16:creationId xmlns:a16="http://schemas.microsoft.com/office/drawing/2014/main" id="{ECF8D89D-8D78-4C66-9B7E-5F1FFC0FCC8F}"/>
               </a:ext>
             </a:extLst>
           </p:cNvPr>
@@ -2135,7 +2135,7 @@
           <p:cNvPr id="2" name="">
             <a:extLst xmlns:a="http://schemas.openxmlformats.org/drawingml/2006/main">
               <a:ext uri="{FF2B5EF4-FFF2-40B4-BE49-F238E27FC236}">
-                <a16:creationId xmlns:a16="http://schemas.microsoft.com/office/drawing/2014/main" id="{3A097520-940C-42B4-A51F-0BC01E330485}"/>
+                <a16:creationId xmlns:a16="http://schemas.microsoft.com/office/drawing/2014/main" id="{12C04581-8C78-417C-9A3F-404E7D1DC5F5}"/>
               </a:ext>
             </a:extLst>
           </p:cNvPr>
@@ -2192,7 +2192,7 @@
           <p:cNvPr id="3" name="">
             <a:extLst xmlns:a="http://schemas.openxmlformats.org/drawingml/2006/main">
               <a:ext uri="{FF2B5EF4-FFF2-40B4-BE49-F238E27FC236}">
-                <a16:creationId xmlns:a16="http://schemas.microsoft.com/office/drawing/2014/main" id="{8A946333-ADD3-4A8E-A008-3B4E973B75BE}"/>
+                <a16:creationId xmlns:a16="http://schemas.microsoft.com/office/drawing/2014/main" id="{BD9C7C82-0B56-4F1C-893E-7A8988EB6EF9}"/>
               </a:ext>
             </a:extLst>
           </p:cNvPr>
@@ -2222,7 +2222,7 @@
           <p:cNvPr id="4" name="">
             <a:extLst xmlns:a="http://schemas.openxmlformats.org/drawingml/2006/main">
               <a:ext uri="{FF2B5EF4-FFF2-40B4-BE49-F238E27FC236}">
-                <a16:creationId xmlns:a16="http://schemas.microsoft.com/office/drawing/2014/main" id="{46093CB3-0296-4630-987E-76B5302ECFC8}"/>
+                <a16:creationId xmlns:a16="http://schemas.microsoft.com/office/drawing/2014/main" id="{F3BE0682-F7A2-4A27-9F8C-6830C270A1D9}"/>
               </a:ext>
             </a:extLst>
           </p:cNvPr>
@@ -2292,7 +2292,7 @@
                 <a:ea typeface="Arial"/>
                 <a:cs typeface="Arial"/>
               </a:rPr>
-              <a:t>14 de setembro de 2026</a:t>
+              <a:t>27 de setembro de 2026 · em revisão</a:t>
             </a:r>
           </a:p>
         </p:txBody>
@@ -2300,7 +2300,7 @@
     </p:spTree>
     <p:extLst>
       <p:ext uri="{BB962C8B-B14F-4D97-AF65-F5344CB8AC3E}">
-        <p14:creationId xmlns:p14="http://schemas.microsoft.com/office/powerpoint/2010/main" val="1055820119"/>
+        <p14:creationId xmlns:p14="http://schemas.microsoft.com/office/powerpoint/2010/main" val="307143516"/>
       </p:ext>
     </p:extLst>
   </p:cSld>
@@ -2331,7 +2331,7 @@
           <p:cNvPr id="12" name="">
             <a:extLst xmlns:a="http://schemas.openxmlformats.org/drawingml/2006/main">
               <a:ext uri="{FF2B5EF4-FFF2-40B4-BE49-F238E27FC236}">
-                <a16:creationId xmlns:a16="http://schemas.microsoft.com/office/drawing/2014/main" id="{8F6D868E-598B-422C-B511-39AEE4473D9A}"/>
+                <a16:creationId xmlns:a16="http://schemas.microsoft.com/office/drawing/2014/main" id="{B714914E-2E05-41D8-A393-52D7AD167099}"/>
               </a:ext>
             </a:extLst>
           </p:cNvPr>
@@ -2361,7 +2361,7 @@
           <p:cNvPr id="2" name="">
             <a:extLst xmlns:a="http://schemas.openxmlformats.org/drawingml/2006/main">
               <a:ext uri="{FF2B5EF4-FFF2-40B4-BE49-F238E27FC236}">
-                <a16:creationId xmlns:a16="http://schemas.microsoft.com/office/drawing/2014/main" id="{18815DCC-0A74-4B58-A802-AFA78DED594F}"/>
+                <a16:creationId xmlns:a16="http://schemas.microsoft.com/office/drawing/2014/main" id="{0A8B9308-2BD2-4AF0-A8D9-165C917A8C5F}"/>
               </a:ext>
             </a:extLst>
           </p:cNvPr>
@@ -2418,7 +2418,7 @@
           <p:cNvPr id="3" name="">
             <a:extLst xmlns:a="http://schemas.openxmlformats.org/drawingml/2006/main">
               <a:ext uri="{FF2B5EF4-FFF2-40B4-BE49-F238E27FC236}">
-                <a16:creationId xmlns:a16="http://schemas.microsoft.com/office/drawing/2014/main" id="{E46D94BA-E95F-45A6-8A1F-34A6A267E68C}"/>
+                <a16:creationId xmlns:a16="http://schemas.microsoft.com/office/drawing/2014/main" id="{5C2E6229-26E2-44C6-B36F-1C018C078F33}"/>
               </a:ext>
             </a:extLst>
           </p:cNvPr>
@@ -2475,7 +2475,7 @@
           <p:cNvPr id="4" name="">
             <a:extLst xmlns:a="http://schemas.openxmlformats.org/drawingml/2006/main">
               <a:ext uri="{FF2B5EF4-FFF2-40B4-BE49-F238E27FC236}">
-                <a16:creationId xmlns:a16="http://schemas.microsoft.com/office/drawing/2014/main" id="{E81CD4F4-EAAD-4659-BF92-1F26BE14F363}"/>
+                <a16:creationId xmlns:a16="http://schemas.microsoft.com/office/drawing/2014/main" id="{F932F274-2119-4FAF-AA18-587E57F03C27}"/>
               </a:ext>
             </a:extLst>
           </p:cNvPr>
@@ -2562,7 +2562,7 @@
           <p:cNvPr id="5" name="">
             <a:extLst xmlns:a="http://schemas.openxmlformats.org/drawingml/2006/main">
               <a:ext uri="{FF2B5EF4-FFF2-40B4-BE49-F238E27FC236}">
-                <a16:creationId xmlns:a16="http://schemas.microsoft.com/office/drawing/2014/main" id="{68CAC6E9-5EAC-42BA-8629-94132E465F3F}"/>
+                <a16:creationId xmlns:a16="http://schemas.microsoft.com/office/drawing/2014/main" id="{5F6E1D45-366A-46BA-89EA-74717B39AE46}"/>
               </a:ext>
             </a:extLst>
           </p:cNvPr>
@@ -2649,7 +2649,7 @@
           <p:cNvPr id="6" name="">
             <a:extLst xmlns:a="http://schemas.openxmlformats.org/drawingml/2006/main">
               <a:ext uri="{FF2B5EF4-FFF2-40B4-BE49-F238E27FC236}">
-                <a16:creationId xmlns:a16="http://schemas.microsoft.com/office/drawing/2014/main" id="{1554CDC8-00F5-4EA7-902C-2550593E5693}"/>
+                <a16:creationId xmlns:a16="http://schemas.microsoft.com/office/drawing/2014/main" id="{FF093D4D-0DA4-4BF5-8132-482AA6580AA4}"/>
               </a:ext>
             </a:extLst>
           </p:cNvPr>
@@ -2736,7 +2736,7 @@
           <p:cNvPr id="7" name="">
             <a:extLst xmlns:a="http://schemas.openxmlformats.org/drawingml/2006/main">
               <a:ext uri="{FF2B5EF4-FFF2-40B4-BE49-F238E27FC236}">
-                <a16:creationId xmlns:a16="http://schemas.microsoft.com/office/drawing/2014/main" id="{1407F8AC-2A20-4765-AD41-79CEB9737C87}"/>
+                <a16:creationId xmlns:a16="http://schemas.microsoft.com/office/drawing/2014/main" id="{9708A891-312B-4D37-8BDA-926CF5D08069}"/>
               </a:ext>
             </a:extLst>
           </p:cNvPr>
@@ -2903,7 +2903,7 @@
           <p:cNvPr id="11" name="">
             <a:extLst xmlns:a="http://schemas.openxmlformats.org/drawingml/2006/main">
               <a:ext uri="{FF2B5EF4-FFF2-40B4-BE49-F238E27FC236}">
-                <a16:creationId xmlns:a16="http://schemas.microsoft.com/office/drawing/2014/main" id="{DFFF0E23-98B0-48DA-A7D1-B3FA2BB97D34}"/>
+                <a16:creationId xmlns:a16="http://schemas.microsoft.com/office/drawing/2014/main" id="{D61CF9C1-DD21-4504-914A-E38093B0AB13}"/>
               </a:ext>
             </a:extLst>
           </p:cNvPr>
@@ -2958,7 +2958,7 @@
     </p:spTree>
     <p:extLst>
       <p:ext uri="{BB962C8B-B14F-4D97-AF65-F5344CB8AC3E}">
-        <p14:creationId xmlns:p14="http://schemas.microsoft.com/office/powerpoint/2010/main" val="111170858"/>
+        <p14:creationId xmlns:p14="http://schemas.microsoft.com/office/powerpoint/2010/main" val="1608770694"/>
       </p:ext>
     </p:extLst>
   </p:cSld>
@@ -2989,7 +2989,7 @@
           <p:cNvPr id="7" name="">
             <a:extLst xmlns:a="http://schemas.openxmlformats.org/drawingml/2006/main">
               <a:ext uri="{FF2B5EF4-FFF2-40B4-BE49-F238E27FC236}">
-                <a16:creationId xmlns:a16="http://schemas.microsoft.com/office/drawing/2014/main" id="{9E25CF97-6FF6-4391-AAEB-B30EB9DCEA4B}"/>
+                <a16:creationId xmlns:a16="http://schemas.microsoft.com/office/drawing/2014/main" id="{472E9C05-849B-4A94-A11F-D8A7D8E48983}"/>
               </a:ext>
             </a:extLst>
           </p:cNvPr>
@@ -3019,7 +3019,7 @@
           <p:cNvPr id="2" name="">
             <a:extLst xmlns:a="http://schemas.openxmlformats.org/drawingml/2006/main">
               <a:ext uri="{FF2B5EF4-FFF2-40B4-BE49-F238E27FC236}">
-                <a16:creationId xmlns:a16="http://schemas.microsoft.com/office/drawing/2014/main" id="{FE892535-8698-4343-A55E-FFE72B7FFCCD}"/>
+                <a16:creationId xmlns:a16="http://schemas.microsoft.com/office/drawing/2014/main" id="{DBA0FC4B-E4E5-4F44-9A1D-FD7D215784E5}"/>
               </a:ext>
             </a:extLst>
           </p:cNvPr>
@@ -3066,7 +3066,7 @@
                 <a:ea typeface="Arial"/>
                 <a:cs typeface="Arial"/>
               </a:rPr>
-              <a:t>Interoperabilidade e contratos</a:t>
+              <a:t>Interoperabilidade e reservas e contratos</a:t>
             </a:r>
           </a:p>
         </p:txBody>
@@ -3076,7 +3076,7 @@
           <p:cNvPr id="3" name="">
             <a:extLst xmlns:a="http://schemas.openxmlformats.org/drawingml/2006/main">
               <a:ext uri="{FF2B5EF4-FFF2-40B4-BE49-F238E27FC236}">
-                <a16:creationId xmlns:a16="http://schemas.microsoft.com/office/drawing/2014/main" id="{490DCCB2-0523-47E9-818A-FBB45A6D9F8F}"/>
+                <a16:creationId xmlns:a16="http://schemas.microsoft.com/office/drawing/2014/main" id="{507AF1EB-2CB8-4520-89F1-35D413A5AAC3}"/>
               </a:ext>
             </a:extLst>
           </p:cNvPr>
@@ -3133,7 +3133,7 @@
           <p:cNvPr id="4" name="">
             <a:extLst xmlns:a="http://schemas.openxmlformats.org/drawingml/2006/main">
               <a:ext uri="{FF2B5EF4-FFF2-40B4-BE49-F238E27FC236}">
-                <a16:creationId xmlns:a16="http://schemas.microsoft.com/office/drawing/2014/main" id="{177F3C2C-F3B3-401D-AFDF-9C3E9E9B397D}"/>
+                <a16:creationId xmlns:a16="http://schemas.microsoft.com/office/drawing/2014/main" id="{137F3AB1-9ACF-45F0-AF52-8B9DBCCA1BFA}"/>
               </a:ext>
             </a:extLst>
           </p:cNvPr>
@@ -3302,7 +3302,7 @@
           <p:cNvPr id="5" name="">
             <a:extLst xmlns:a="http://schemas.openxmlformats.org/drawingml/2006/main">
               <a:ext uri="{FF2B5EF4-FFF2-40B4-BE49-F238E27FC236}">
-                <a16:creationId xmlns:a16="http://schemas.microsoft.com/office/drawing/2014/main" id="{6AB42629-17A4-400D-BA09-776E48743ED5}"/>
+                <a16:creationId xmlns:a16="http://schemas.microsoft.com/office/drawing/2014/main" id="{B9D71854-40E6-46FF-BB7D-467111BC3997}"/>
               </a:ext>
             </a:extLst>
           </p:cNvPr>
@@ -3527,7 +3527,7 @@
           <p:cNvPr id="6" name="">
             <a:extLst xmlns:a="http://schemas.openxmlformats.org/drawingml/2006/main">
               <a:ext uri="{FF2B5EF4-FFF2-40B4-BE49-F238E27FC236}">
-                <a16:creationId xmlns:a16="http://schemas.microsoft.com/office/drawing/2014/main" id="{2C5BEF2B-7203-4FFA-B415-F0BB8B935864}"/>
+                <a16:creationId xmlns:a16="http://schemas.microsoft.com/office/drawing/2014/main" id="{7BDAD26A-4EA9-4CC2-AA06-7FB68994DAFD}"/>
               </a:ext>
             </a:extLst>
           </p:cNvPr>
@@ -3582,7 +3582,7 @@
     </p:spTree>
     <p:extLst>
       <p:ext uri="{BB962C8B-B14F-4D97-AF65-F5344CB8AC3E}">
-        <p14:creationId xmlns:p14="http://schemas.microsoft.com/office/powerpoint/2010/main" val="78602995"/>
+        <p14:creationId xmlns:p14="http://schemas.microsoft.com/office/powerpoint/2010/main" val="842548739"/>
       </p:ext>
     </p:extLst>
   </p:cSld>
@@ -3613,7 +3613,7 @@
           <p:cNvPr id="11" name="">
             <a:extLst xmlns:a="http://schemas.openxmlformats.org/drawingml/2006/main">
               <a:ext uri="{FF2B5EF4-FFF2-40B4-BE49-F238E27FC236}">
-                <a16:creationId xmlns:a16="http://schemas.microsoft.com/office/drawing/2014/main" id="{B3E4E630-6F9B-48A9-A933-B458A2EC1C3C}"/>
+                <a16:creationId xmlns:a16="http://schemas.microsoft.com/office/drawing/2014/main" id="{72E64FDC-5BA0-434F-90BB-446CC292F834}"/>
               </a:ext>
             </a:extLst>
           </p:cNvPr>
@@ -3643,7 +3643,7 @@
           <p:cNvPr id="2" name="">
             <a:extLst xmlns:a="http://schemas.openxmlformats.org/drawingml/2006/main">
               <a:ext uri="{FF2B5EF4-FFF2-40B4-BE49-F238E27FC236}">
-                <a16:creationId xmlns:a16="http://schemas.microsoft.com/office/drawing/2014/main" id="{2F3F4352-BC8A-4ACB-B405-41924EF31064}"/>
+                <a16:creationId xmlns:a16="http://schemas.microsoft.com/office/drawing/2014/main" id="{B2D0E5FC-47F3-460B-B57B-CDABC95C44DA}"/>
               </a:ext>
             </a:extLst>
           </p:cNvPr>
@@ -3700,7 +3700,7 @@
           <p:cNvPr id="3" name="">
             <a:extLst xmlns:a="http://schemas.openxmlformats.org/drawingml/2006/main">
               <a:ext uri="{FF2B5EF4-FFF2-40B4-BE49-F238E27FC236}">
-                <a16:creationId xmlns:a16="http://schemas.microsoft.com/office/drawing/2014/main" id="{B65A4CB1-0A9E-4ACE-822A-B7BF471F5222}"/>
+                <a16:creationId xmlns:a16="http://schemas.microsoft.com/office/drawing/2014/main" id="{1FB67539-D1E2-4D59-9EC6-CC575CFA4881}"/>
               </a:ext>
             </a:extLst>
           </p:cNvPr>
@@ -3757,7 +3757,7 @@
           <p:cNvPr id="4" name="">
             <a:extLst xmlns:a="http://schemas.openxmlformats.org/drawingml/2006/main">
               <a:ext uri="{FF2B5EF4-FFF2-40B4-BE49-F238E27FC236}">
-                <a16:creationId xmlns:a16="http://schemas.microsoft.com/office/drawing/2014/main" id="{7414B718-760F-465E-8204-D4FEE96428A5}"/>
+                <a16:creationId xmlns:a16="http://schemas.microsoft.com/office/drawing/2014/main" id="{D69D29F6-5F5A-4B59-BAFF-16441422EBEE}"/>
               </a:ext>
             </a:extLst>
           </p:cNvPr>
@@ -3814,7 +3814,7 @@
           <p:cNvPr id="5" name="">
             <a:extLst xmlns:a="http://schemas.openxmlformats.org/drawingml/2006/main">
               <a:ext uri="{FF2B5EF4-FFF2-40B4-BE49-F238E27FC236}">
-                <a16:creationId xmlns:a16="http://schemas.microsoft.com/office/drawing/2014/main" id="{3B17E4E0-13CE-4218-9C4F-8CA492C74A57}"/>
+                <a16:creationId xmlns:a16="http://schemas.microsoft.com/office/drawing/2014/main" id="{CABDA462-3F88-4CD7-AD6B-7DC820F5DCC1}"/>
               </a:ext>
             </a:extLst>
           </p:cNvPr>
@@ -3929,7 +3929,7 @@
           <p:cNvPr id="6" name="">
             <a:extLst xmlns:a="http://schemas.openxmlformats.org/drawingml/2006/main">
               <a:ext uri="{FF2B5EF4-FFF2-40B4-BE49-F238E27FC236}">
-                <a16:creationId xmlns:a16="http://schemas.microsoft.com/office/drawing/2014/main" id="{B4EB9413-3749-4AE2-AEF3-05B863978CFB}"/>
+                <a16:creationId xmlns:a16="http://schemas.microsoft.com/office/drawing/2014/main" id="{C2182C35-5D1F-46F9-95B6-F5F13777E2A9}"/>
               </a:ext>
             </a:extLst>
           </p:cNvPr>
@@ -3986,7 +3986,7 @@
           <p:cNvPr id="7" name="">
             <a:extLst xmlns:a="http://schemas.openxmlformats.org/drawingml/2006/main">
               <a:ext uri="{FF2B5EF4-FFF2-40B4-BE49-F238E27FC236}">
-                <a16:creationId xmlns:a16="http://schemas.microsoft.com/office/drawing/2014/main" id="{48339A7C-B609-484C-964D-D31B9674DC99}"/>
+                <a16:creationId xmlns:a16="http://schemas.microsoft.com/office/drawing/2014/main" id="{B31037BF-4E53-4A3D-9CE3-DCE2D6F45820}"/>
               </a:ext>
             </a:extLst>
           </p:cNvPr>
@@ -4037,7 +4037,7 @@
                 <a:ea typeface="Arial"/>
                 <a:cs typeface="Arial"/>
               </a:rPr>
-              <a:t>OIDC simulado e RBAC</a:t>
+              <a:t>Tokens locais ou segredo público e RBAC</a:t>
             </a:r>
           </a:p>
           <a:p xmlns:a="http://schemas.openxmlformats.org/drawingml/2006/main">
@@ -4101,7 +4101,7 @@
           <p:cNvPr id="8" name="">
             <a:extLst xmlns:a="http://schemas.openxmlformats.org/drawingml/2006/main">
               <a:ext uri="{FF2B5EF4-FFF2-40B4-BE49-F238E27FC236}">
-                <a16:creationId xmlns:a16="http://schemas.microsoft.com/office/drawing/2014/main" id="{312B5B1B-FD0E-49B5-87FD-5C02437067DE}"/>
+                <a16:creationId xmlns:a16="http://schemas.microsoft.com/office/drawing/2014/main" id="{1755BD98-A25B-4B2C-ADAA-81291DAF7920}"/>
               </a:ext>
             </a:extLst>
           </p:cNvPr>
@@ -4158,7 +4158,7 @@
           <p:cNvPr id="9" name="">
             <a:extLst xmlns:a="http://schemas.openxmlformats.org/drawingml/2006/main">
               <a:ext uri="{FF2B5EF4-FFF2-40B4-BE49-F238E27FC236}">
-                <a16:creationId xmlns:a16="http://schemas.microsoft.com/office/drawing/2014/main" id="{A8E2385D-6982-4021-999D-4B3D6FD1314D}"/>
+                <a16:creationId xmlns:a16="http://schemas.microsoft.com/office/drawing/2014/main" id="{51A2780A-39CF-4E59-963A-94636BDA4A7B}"/>
               </a:ext>
             </a:extLst>
           </p:cNvPr>
@@ -4273,7 +4273,7 @@
           <p:cNvPr id="10" name="">
             <a:extLst xmlns:a="http://schemas.openxmlformats.org/drawingml/2006/main">
               <a:ext uri="{FF2B5EF4-FFF2-40B4-BE49-F238E27FC236}">
-                <a16:creationId xmlns:a16="http://schemas.microsoft.com/office/drawing/2014/main" id="{9F5DCB19-E889-4B0D-9864-12D70E0661ED}"/>
+                <a16:creationId xmlns:a16="http://schemas.microsoft.com/office/drawing/2014/main" id="{A8E04844-2031-4E0B-B7A4-5C892758995A}"/>
               </a:ext>
             </a:extLst>
           </p:cNvPr>
@@ -4328,7 +4328,7 @@
     </p:spTree>
     <p:extLst>
       <p:ext uri="{BB962C8B-B14F-4D97-AF65-F5344CB8AC3E}">
-        <p14:creationId xmlns:p14="http://schemas.microsoft.com/office/powerpoint/2010/main" val="1056358265"/>
+        <p14:creationId xmlns:p14="http://schemas.microsoft.com/office/powerpoint/2010/main" val="1544054370"/>
       </p:ext>
     </p:extLst>
   </p:cSld>
@@ -4359,7 +4359,7 @@
           <p:cNvPr id="7" name="">
             <a:extLst xmlns:a="http://schemas.openxmlformats.org/drawingml/2006/main">
               <a:ext uri="{FF2B5EF4-FFF2-40B4-BE49-F238E27FC236}">
-                <a16:creationId xmlns:a16="http://schemas.microsoft.com/office/drawing/2014/main" id="{6A97583C-D029-4A23-AE52-87E1C32B394D}"/>
+                <a16:creationId xmlns:a16="http://schemas.microsoft.com/office/drawing/2014/main" id="{F129BE8D-78DD-4B0B-ACA1-94529DC9B925}"/>
               </a:ext>
             </a:extLst>
           </p:cNvPr>
@@ -4389,7 +4389,7 @@
           <p:cNvPr id="2" name="">
             <a:extLst xmlns:a="http://schemas.openxmlformats.org/drawingml/2006/main">
               <a:ext uri="{FF2B5EF4-FFF2-40B4-BE49-F238E27FC236}">
-                <a16:creationId xmlns:a16="http://schemas.microsoft.com/office/drawing/2014/main" id="{51D90636-08A3-4D80-A46E-FEBC7D8BCF64}"/>
+                <a16:creationId xmlns:a16="http://schemas.microsoft.com/office/drawing/2014/main" id="{1260FAFC-4623-4EBE-AB42-9C0E253B83FF}"/>
               </a:ext>
             </a:extLst>
           </p:cNvPr>
@@ -4446,7 +4446,7 @@
           <p:cNvPr id="3" name="">
             <a:extLst xmlns:a="http://schemas.openxmlformats.org/drawingml/2006/main">
               <a:ext uri="{FF2B5EF4-FFF2-40B4-BE49-F238E27FC236}">
-                <a16:creationId xmlns:a16="http://schemas.microsoft.com/office/drawing/2014/main" id="{2370F074-A5E7-4AE9-966D-D111F3CE6A1A}"/>
+                <a16:creationId xmlns:a16="http://schemas.microsoft.com/office/drawing/2014/main" id="{35213F5A-0C39-490A-9A2F-38758962C0B0}"/>
               </a:ext>
             </a:extLst>
           </p:cNvPr>
@@ -4503,7 +4503,7 @@
           <p:cNvPr id="4" name="">
             <a:extLst xmlns:a="http://schemas.openxmlformats.org/drawingml/2006/main">
               <a:ext uri="{FF2B5EF4-FFF2-40B4-BE49-F238E27FC236}">
-                <a16:creationId xmlns:a16="http://schemas.microsoft.com/office/drawing/2014/main" id="{E7B73979-387F-4331-923E-35F197050D41}"/>
+                <a16:creationId xmlns:a16="http://schemas.microsoft.com/office/drawing/2014/main" id="{DBC10599-94D6-462A-8E9D-949C69509144}"/>
               </a:ext>
             </a:extLst>
           </p:cNvPr>
@@ -4672,7 +4672,7 @@
           <p:cNvPr id="5" name="">
             <a:extLst xmlns:a="http://schemas.openxmlformats.org/drawingml/2006/main">
               <a:ext uri="{FF2B5EF4-FFF2-40B4-BE49-F238E27FC236}">
-                <a16:creationId xmlns:a16="http://schemas.microsoft.com/office/drawing/2014/main" id="{841AF3FF-7DF9-4970-9667-710E315C3DB3}"/>
+                <a16:creationId xmlns:a16="http://schemas.microsoft.com/office/drawing/2014/main" id="{3258FF70-9D28-410F-9B6A-CE6BC028392C}"/>
               </a:ext>
             </a:extLst>
           </p:cNvPr>
@@ -4729,7 +4729,7 @@
           <p:cNvPr id="6" name="">
             <a:extLst xmlns:a="http://schemas.openxmlformats.org/drawingml/2006/main">
               <a:ext uri="{FF2B5EF4-FFF2-40B4-BE49-F238E27FC236}">
-                <a16:creationId xmlns:a16="http://schemas.microsoft.com/office/drawing/2014/main" id="{09FC565B-9A33-49D0-A4B8-D4B6C82E5E9A}"/>
+                <a16:creationId xmlns:a16="http://schemas.microsoft.com/office/drawing/2014/main" id="{AACFD907-FC7D-41DB-B993-BD5097246073}"/>
               </a:ext>
             </a:extLst>
           </p:cNvPr>
@@ -4896,7 +4896,7 @@
     </p:spTree>
     <p:extLst>
       <p:ext uri="{BB962C8B-B14F-4D97-AF65-F5344CB8AC3E}">
-        <p14:creationId xmlns:p14="http://schemas.microsoft.com/office/powerpoint/2010/main" val="551531060"/>
+        <p14:creationId xmlns:p14="http://schemas.microsoft.com/office/powerpoint/2010/main" val="2116175135"/>
       </p:ext>
     </p:extLst>
   </p:cSld>
@@ -4927,7 +4927,7 @@
           <p:cNvPr id="8" name="">
             <a:extLst xmlns:a="http://schemas.openxmlformats.org/drawingml/2006/main">
               <a:ext uri="{FF2B5EF4-FFF2-40B4-BE49-F238E27FC236}">
-                <a16:creationId xmlns:a16="http://schemas.microsoft.com/office/drawing/2014/main" id="{6A4F77D3-1911-4D99-A523-E26207620F6D}"/>
+                <a16:creationId xmlns:a16="http://schemas.microsoft.com/office/drawing/2014/main" id="{E10DDF92-BBB3-46F6-9BEB-2B6C39BE03E9}"/>
               </a:ext>
             </a:extLst>
           </p:cNvPr>
@@ -4957,7 +4957,7 @@
           <p:cNvPr id="2" name="">
             <a:extLst xmlns:a="http://schemas.openxmlformats.org/drawingml/2006/main">
               <a:ext uri="{FF2B5EF4-FFF2-40B4-BE49-F238E27FC236}">
-                <a16:creationId xmlns:a16="http://schemas.microsoft.com/office/drawing/2014/main" id="{19F080F1-3C8B-4A64-B66E-830A906AA835}"/>
+                <a16:creationId xmlns:a16="http://schemas.microsoft.com/office/drawing/2014/main" id="{CB60ECA1-641C-4D1D-90A6-9F6C2F467CDF}"/>
               </a:ext>
             </a:extLst>
           </p:cNvPr>
@@ -5014,7 +5014,7 @@
           <p:cNvPr id="3" name="">
             <a:extLst xmlns:a="http://schemas.openxmlformats.org/drawingml/2006/main">
               <a:ext uri="{FF2B5EF4-FFF2-40B4-BE49-F238E27FC236}">
-                <a16:creationId xmlns:a16="http://schemas.microsoft.com/office/drawing/2014/main" id="{9C6FC782-3E0B-4970-8B7C-BCA2E4A9BFDB}"/>
+                <a16:creationId xmlns:a16="http://schemas.microsoft.com/office/drawing/2014/main" id="{82DD81FE-E835-4D40-9970-1EDF71E77CAB}"/>
               </a:ext>
             </a:extLst>
           </p:cNvPr>
@@ -5071,7 +5071,7 @@
           <p:cNvPr id="4" name="">
             <a:extLst xmlns:a="http://schemas.openxmlformats.org/drawingml/2006/main">
               <a:ext uri="{FF2B5EF4-FFF2-40B4-BE49-F238E27FC236}">
-                <a16:creationId xmlns:a16="http://schemas.microsoft.com/office/drawing/2014/main" id="{74A062A0-463F-4F62-8CF9-27886F05E6CD}"/>
+                <a16:creationId xmlns:a16="http://schemas.microsoft.com/office/drawing/2014/main" id="{C50855FC-A732-4472-8FA9-71096AF523C3}"/>
               </a:ext>
             </a:extLst>
           </p:cNvPr>
@@ -5118,7 +5118,7 @@
                 <a:ea typeface="Arial"/>
                 <a:cs typeface="Arial"/>
               </a:rPr>
-              <a:t>13 testes aprovados</a:t>
+              <a:t>Suíte ampliada</a:t>
             </a:r>
           </a:p>
         </p:txBody>
@@ -5128,7 +5128,7 @@
           <p:cNvPr id="5" name="">
             <a:extLst xmlns:a="http://schemas.openxmlformats.org/drawingml/2006/main">
               <a:ext uri="{FF2B5EF4-FFF2-40B4-BE49-F238E27FC236}">
-                <a16:creationId xmlns:a16="http://schemas.microsoft.com/office/drawing/2014/main" id="{30495FDD-4C09-4094-B721-9545E3602A27}"/>
+                <a16:creationId xmlns:a16="http://schemas.microsoft.com/office/drawing/2014/main" id="{D3CF62FB-884E-4931-8C53-19E230BCD834}"/>
               </a:ext>
             </a:extLst>
           </p:cNvPr>
@@ -5185,7 +5185,7 @@
           <p:cNvPr id="6" name="">
             <a:extLst xmlns:a="http://schemas.openxmlformats.org/drawingml/2006/main">
               <a:ext uri="{FF2B5EF4-FFF2-40B4-BE49-F238E27FC236}">
-                <a16:creationId xmlns:a16="http://schemas.microsoft.com/office/drawing/2014/main" id="{5D0B36EB-D99E-4EF9-8494-C7BC3B8DC507}"/>
+                <a16:creationId xmlns:a16="http://schemas.microsoft.com/office/drawing/2014/main" id="{97144759-BE11-4160-99BE-756A014DF7B2}"/>
               </a:ext>
             </a:extLst>
           </p:cNvPr>
@@ -5263,7 +5263,7 @@
                 <a:ea typeface="Arial"/>
                 <a:cs typeface="Arial"/>
               </a:rPr>
-              <a:t>F2 cria uma cobrança e um onboarding</a:t>
+              <a:t>F2 cria uma cobrança e uma preparação de retirada</a:t>
             </a:r>
           </a:p>
           <a:p xmlns:a="http://schemas.openxmlformats.org/drawingml/2006/main">
@@ -5354,7 +5354,7 @@
           <p:cNvPr id="7" name="">
             <a:extLst xmlns:a="http://schemas.openxmlformats.org/drawingml/2006/main">
               <a:ext uri="{FF2B5EF4-FFF2-40B4-BE49-F238E27FC236}">
-                <a16:creationId xmlns:a16="http://schemas.microsoft.com/office/drawing/2014/main" id="{3C7B0C12-4443-49E1-A05C-0AE7BC4D3408}"/>
+                <a16:creationId xmlns:a16="http://schemas.microsoft.com/office/drawing/2014/main" id="{9532E3C5-3FD4-4C7C-8EF4-DE9F90D35EF3}"/>
               </a:ext>
             </a:extLst>
           </p:cNvPr>
@@ -5409,7 +5409,7 @@
     </p:spTree>
     <p:extLst>
       <p:ext uri="{BB962C8B-B14F-4D97-AF65-F5344CB8AC3E}">
-        <p14:creationId xmlns:p14="http://schemas.microsoft.com/office/powerpoint/2010/main" val="23501630"/>
+        <p14:creationId xmlns:p14="http://schemas.microsoft.com/office/powerpoint/2010/main" val="1376782559"/>
       </p:ext>
     </p:extLst>
   </p:cSld>
@@ -5440,7 +5440,7 @@
           <p:cNvPr id="9" name="">
             <a:extLst xmlns:a="http://schemas.openxmlformats.org/drawingml/2006/main">
               <a:ext uri="{FF2B5EF4-FFF2-40B4-BE49-F238E27FC236}">
-                <a16:creationId xmlns:a16="http://schemas.microsoft.com/office/drawing/2014/main" id="{8F83F70E-DFC2-4C78-9586-119844439363}"/>
+                <a16:creationId xmlns:a16="http://schemas.microsoft.com/office/drawing/2014/main" id="{2B0C307D-7D84-4E8E-B6C9-0371BF9D1E93}"/>
               </a:ext>
             </a:extLst>
           </p:cNvPr>
@@ -5470,7 +5470,7 @@
           <p:cNvPr id="2" name="">
             <a:extLst xmlns:a="http://schemas.openxmlformats.org/drawingml/2006/main">
               <a:ext uri="{FF2B5EF4-FFF2-40B4-BE49-F238E27FC236}">
-                <a16:creationId xmlns:a16="http://schemas.microsoft.com/office/drawing/2014/main" id="{73535231-CEC4-4593-A874-727B4744E617}"/>
+                <a16:creationId xmlns:a16="http://schemas.microsoft.com/office/drawing/2014/main" id="{F3CA43A3-6EC9-4F9B-AB67-7728075217A6}"/>
               </a:ext>
             </a:extLst>
           </p:cNvPr>
@@ -5527,7 +5527,7 @@
           <p:cNvPr id="3" name="">
             <a:extLst xmlns:a="http://schemas.openxmlformats.org/drawingml/2006/main">
               <a:ext uri="{FF2B5EF4-FFF2-40B4-BE49-F238E27FC236}">
-                <a16:creationId xmlns:a16="http://schemas.microsoft.com/office/drawing/2014/main" id="{62411538-AAA3-4F14-9FF3-3C348D0368D7}"/>
+                <a16:creationId xmlns:a16="http://schemas.microsoft.com/office/drawing/2014/main" id="{8D07A0E5-BB80-4C4A-A530-6892AA727B52}"/>
               </a:ext>
             </a:extLst>
           </p:cNvPr>
@@ -5584,7 +5584,7 @@
           <p:cNvPr id="4" name="">
             <a:extLst xmlns:a="http://schemas.openxmlformats.org/drawingml/2006/main">
               <a:ext uri="{FF2B5EF4-FFF2-40B4-BE49-F238E27FC236}">
-                <a16:creationId xmlns:a16="http://schemas.microsoft.com/office/drawing/2014/main" id="{0812F851-A153-4CC7-BE65-C28196B1CB6F}"/>
+                <a16:creationId xmlns:a16="http://schemas.microsoft.com/office/drawing/2014/main" id="{6602A080-2761-45DC-A2B5-3C86FEE86B96}"/>
               </a:ext>
             </a:extLst>
           </p:cNvPr>
@@ -5641,7 +5641,7 @@
           <p:cNvPr id="5" name="">
             <a:extLst xmlns:a="http://schemas.openxmlformats.org/drawingml/2006/main">
               <a:ext uri="{FF2B5EF4-FFF2-40B4-BE49-F238E27FC236}">
-                <a16:creationId xmlns:a16="http://schemas.microsoft.com/office/drawing/2014/main" id="{CD63A25C-AAB1-46B9-ACA6-5E64FFB9B19E}"/>
+                <a16:creationId xmlns:a16="http://schemas.microsoft.com/office/drawing/2014/main" id="{AD5CA2ED-DAD3-435C-A190-EC63B7965496}"/>
               </a:ext>
             </a:extLst>
           </p:cNvPr>
@@ -5719,7 +5719,7 @@
                 <a:ea typeface="Arial"/>
                 <a:cs typeface="Arial"/>
               </a:rPr>
-              <a:t>Contratos e fronteiras permitem evolução incremental</a:t>
+              <a:t>Reservas e contratos e fronteiras permitem evolução incremental</a:t>
             </a:r>
           </a:p>
           <a:p xmlns:a="http://schemas.openxmlformats.org/drawingml/2006/main">
@@ -5756,7 +5756,7 @@
           <p:cNvPr id="6" name="">
             <a:extLst xmlns:a="http://schemas.openxmlformats.org/drawingml/2006/main">
               <a:ext uri="{FF2B5EF4-FFF2-40B4-BE49-F238E27FC236}">
-                <a16:creationId xmlns:a16="http://schemas.microsoft.com/office/drawing/2014/main" id="{2062EC0C-2003-4F5F-BE8D-360BC5359D8A}"/>
+                <a16:creationId xmlns:a16="http://schemas.microsoft.com/office/drawing/2014/main" id="{E8DBA59B-B0EC-4D2B-9206-5658E30BD6A6}"/>
               </a:ext>
             </a:extLst>
           </p:cNvPr>
@@ -5813,7 +5813,7 @@
           <p:cNvPr id="7" name="">
             <a:extLst xmlns:a="http://schemas.openxmlformats.org/drawingml/2006/main">
               <a:ext uri="{FF2B5EF4-FFF2-40B4-BE49-F238E27FC236}">
-                <a16:creationId xmlns:a16="http://schemas.microsoft.com/office/drawing/2014/main" id="{8BAAB0A3-3CCB-4F8D-BA72-82B6FC2CB0CD}"/>
+                <a16:creationId xmlns:a16="http://schemas.microsoft.com/office/drawing/2014/main" id="{42407139-145E-49D4-A447-4A1E51DC2008}"/>
               </a:ext>
             </a:extLst>
           </p:cNvPr>
@@ -5891,7 +5891,7 @@
                 <a:ea typeface="Arial"/>
                 <a:cs typeface="Arial"/>
               </a:rPr>
-              <a:t>Conectar OIDC, TLS e sistemas reais por adaptadores</a:t>
+              <a:t>Publicar e testar a demo gratuita com dados sintéticos</a:t>
             </a:r>
           </a:p>
           <a:p xmlns:a="http://schemas.openxmlformats.org/drawingml/2006/main">
@@ -5918,7 +5918,7 @@
                 <a:ea typeface="Arial"/>
                 <a:cs typeface="Arial"/>
               </a:rPr>
-              <a:t>Automatizar retentativas e sincronizar o prazo do Workflow</a:t>
+              <a:t>Adicionar identidade individual e retentativas com atraso</a:t>
             </a:r>
           </a:p>
         </p:txBody>
@@ -5928,7 +5928,7 @@
           <p:cNvPr id="8" name="">
             <a:extLst xmlns:a="http://schemas.openxmlformats.org/drawingml/2006/main">
               <a:ext uri="{FF2B5EF4-FFF2-40B4-BE49-F238E27FC236}">
-                <a16:creationId xmlns:a16="http://schemas.microsoft.com/office/drawing/2014/main" id="{8E9B745B-FA09-4220-B9CE-76EBD9BB1ABE}"/>
+                <a16:creationId xmlns:a16="http://schemas.microsoft.com/office/drawing/2014/main" id="{9202A3CB-4B2E-4D40-9224-12BBE93DBFF7}"/>
               </a:ext>
             </a:extLst>
           </p:cNvPr>
@@ -5983,7 +5983,7 @@
     </p:spTree>
     <p:extLst>
       <p:ext uri="{BB962C8B-B14F-4D97-AF65-F5344CB8AC3E}">
-        <p14:creationId xmlns:p14="http://schemas.microsoft.com/office/powerpoint/2010/main" val="1778988182"/>
+        <p14:creationId xmlns:p14="http://schemas.microsoft.com/office/powerpoint/2010/main" val="149471561"/>
       </p:ext>
     </p:extLst>
   </p:cSld>
@@ -6014,7 +6014,7 @@
           <p:cNvPr id="10" name="">
             <a:extLst xmlns:a="http://schemas.openxmlformats.org/drawingml/2006/main">
               <a:ext uri="{FF2B5EF4-FFF2-40B4-BE49-F238E27FC236}">
-                <a16:creationId xmlns:a16="http://schemas.microsoft.com/office/drawing/2014/main" id="{982663FC-8245-4AF0-8BFF-655BD36BFECE}"/>
+                <a16:creationId xmlns:a16="http://schemas.microsoft.com/office/drawing/2014/main" id="{B3AA9406-4916-4AE1-81A9-C7319E2068F2}"/>
               </a:ext>
             </a:extLst>
           </p:cNvPr>
@@ -6044,7 +6044,7 @@
           <p:cNvPr id="2" name="">
             <a:extLst xmlns:a="http://schemas.openxmlformats.org/drawingml/2006/main">
               <a:ext uri="{FF2B5EF4-FFF2-40B4-BE49-F238E27FC236}">
-                <a16:creationId xmlns:a16="http://schemas.microsoft.com/office/drawing/2014/main" id="{C820D04F-795B-4439-AF64-B54F3FA6F5E3}"/>
+                <a16:creationId xmlns:a16="http://schemas.microsoft.com/office/drawing/2014/main" id="{165EF7B9-E16B-4E91-8CF7-A4E6EF208282}"/>
               </a:ext>
             </a:extLst>
           </p:cNvPr>
@@ -6101,7 +6101,7 @@
           <p:cNvPr id="3" name="">
             <a:extLst xmlns:a="http://schemas.openxmlformats.org/drawingml/2006/main">
               <a:ext uri="{FF2B5EF4-FFF2-40B4-BE49-F238E27FC236}">
-                <a16:creationId xmlns:a16="http://schemas.microsoft.com/office/drawing/2014/main" id="{6586CD46-0F1C-4C90-B12C-055A006D7BD5}"/>
+                <a16:creationId xmlns:a16="http://schemas.microsoft.com/office/drawing/2014/main" id="{2D3FF770-E2BF-4356-8D32-2CC8A0D5BD74}"/>
               </a:ext>
             </a:extLst>
           </p:cNvPr>
@@ -6158,7 +6158,7 @@
           <p:cNvPr id="4" name="">
             <a:extLst xmlns:a="http://schemas.openxmlformats.org/drawingml/2006/main">
               <a:ext uri="{FF2B5EF4-FFF2-40B4-BE49-F238E27FC236}">
-                <a16:creationId xmlns:a16="http://schemas.microsoft.com/office/drawing/2014/main" id="{DF142390-F118-4A71-B6C1-F20E73CCAFB6}"/>
+                <a16:creationId xmlns:a16="http://schemas.microsoft.com/office/drawing/2014/main" id="{C4F54B3B-23A9-44B4-8A23-DCAF4B03E51E}"/>
               </a:ext>
             </a:extLst>
           </p:cNvPr>
@@ -6300,7 +6300,7 @@
           <p:cNvPr id="5" name="">
             <a:extLst xmlns:a="http://schemas.openxmlformats.org/drawingml/2006/main">
               <a:ext uri="{FF2B5EF4-FFF2-40B4-BE49-F238E27FC236}">
-                <a16:creationId xmlns:a16="http://schemas.microsoft.com/office/drawing/2014/main" id="{7AD3B4AA-CECE-476B-B198-77539FD47B27}"/>
+                <a16:creationId xmlns:a16="http://schemas.microsoft.com/office/drawing/2014/main" id="{B774D312-BE0D-489C-9D07-DD9489B9A22D}"/>
               </a:ext>
             </a:extLst>
           </p:cNvPr>
@@ -6364,7 +6364,7 @@
           <p:cNvPr id="6" name="">
             <a:extLst xmlns:a="http://schemas.openxmlformats.org/drawingml/2006/main">
               <a:ext uri="{FF2B5EF4-FFF2-40B4-BE49-F238E27FC236}">
-                <a16:creationId xmlns:a16="http://schemas.microsoft.com/office/drawing/2014/main" id="{0A08C6DC-FBC0-4217-A361-692B39F35F1B}"/>
+                <a16:creationId xmlns:a16="http://schemas.microsoft.com/office/drawing/2014/main" id="{89FB6779-E762-4DBC-99F2-08FCF3A10B0F}"/>
               </a:ext>
             </a:extLst>
           </p:cNvPr>
@@ -6418,7 +6418,7 @@
                 <a:ea typeface="Arial"/>
                 <a:cs typeface="Arial"/>
               </a:rPr>
-              <a:t>Contratos</a:t>
+              <a:t>Reservas e contratos</a:t>
             </a:r>
           </a:p>
         </p:txBody>
@@ -6428,7 +6428,7 @@
           <p:cNvPr id="7" name="">
             <a:extLst xmlns:a="http://schemas.openxmlformats.org/drawingml/2006/main">
               <a:ext uri="{FF2B5EF4-FFF2-40B4-BE49-F238E27FC236}">
-                <a16:creationId xmlns:a16="http://schemas.microsoft.com/office/drawing/2014/main" id="{D7DD277D-49B1-4A47-A87F-201023C3A1EC}"/>
+                <a16:creationId xmlns:a16="http://schemas.microsoft.com/office/drawing/2014/main" id="{EF961145-11D5-4657-B96A-7ADF092CA0C4}"/>
               </a:ext>
             </a:extLst>
           </p:cNvPr>
@@ -6482,7 +6482,7 @@
                 <a:ea typeface="Arial"/>
                 <a:cs typeface="Arial"/>
               </a:rPr>
-              <a:t>Financeiro</a:t>
+              <a:t>Financeiro e faturamento</a:t>
             </a:r>
           </a:p>
         </p:txBody>
@@ -6492,7 +6492,7 @@
           <p:cNvPr id="8" name="">
             <a:extLst xmlns:a="http://schemas.openxmlformats.org/drawingml/2006/main">
               <a:ext uri="{FF2B5EF4-FFF2-40B4-BE49-F238E27FC236}">
-                <a16:creationId xmlns:a16="http://schemas.microsoft.com/office/drawing/2014/main" id="{5F3DED01-0476-45A9-8374-D327549C81F8}"/>
+                <a16:creationId xmlns:a16="http://schemas.microsoft.com/office/drawing/2014/main" id="{7BB511BE-011C-4538-99FB-4FEA07A63B37}"/>
               </a:ext>
             </a:extLst>
           </p:cNvPr>
@@ -6546,7 +6546,7 @@
                 <a:ea typeface="Arial"/>
                 <a:cs typeface="Arial"/>
               </a:rPr>
-              <a:t>Atendimento</a:t>
+              <a:t>Atendimento e assistência 24h</a:t>
             </a:r>
           </a:p>
         </p:txBody>
@@ -6556,7 +6556,7 @@
           <p:cNvPr id="9" name="">
             <a:extLst xmlns:a="http://schemas.openxmlformats.org/drawingml/2006/main">
               <a:ext uri="{FF2B5EF4-FFF2-40B4-BE49-F238E27FC236}">
-                <a16:creationId xmlns:a16="http://schemas.microsoft.com/office/drawing/2014/main" id="{29CE4070-313D-42C1-8E2B-29B92F45C1B4}"/>
+                <a16:creationId xmlns:a16="http://schemas.microsoft.com/office/drawing/2014/main" id="{E8886A59-46B1-40A6-BCB8-814E7896FD26}"/>
               </a:ext>
             </a:extLst>
           </p:cNvPr>
@@ -6618,7 +6618,7 @@
     </p:spTree>
     <p:extLst>
       <p:ext uri="{BB962C8B-B14F-4D97-AF65-F5344CB8AC3E}">
-        <p14:creationId xmlns:p14="http://schemas.microsoft.com/office/powerpoint/2010/main" val="1944841708"/>
+        <p14:creationId xmlns:p14="http://schemas.microsoft.com/office/powerpoint/2010/main" val="2003958931"/>
       </p:ext>
     </p:extLst>
   </p:cSld>
@@ -6649,7 +6649,7 @@
           <p:cNvPr id="15" name="">
             <a:extLst xmlns:a="http://schemas.openxmlformats.org/drawingml/2006/main">
               <a:ext uri="{FF2B5EF4-FFF2-40B4-BE49-F238E27FC236}">
-                <a16:creationId xmlns:a16="http://schemas.microsoft.com/office/drawing/2014/main" id="{41E679AE-97B3-4E3C-979B-906AEFE2DFCE}"/>
+                <a16:creationId xmlns:a16="http://schemas.microsoft.com/office/drawing/2014/main" id="{40D8657A-6BE9-486D-A312-5E342A5461A4}"/>
               </a:ext>
             </a:extLst>
           </p:cNvPr>
@@ -6679,7 +6679,7 @@
           <p:cNvPr id="2" name="">
             <a:extLst xmlns:a="http://schemas.openxmlformats.org/drawingml/2006/main">
               <a:ext uri="{FF2B5EF4-FFF2-40B4-BE49-F238E27FC236}">
-                <a16:creationId xmlns:a16="http://schemas.microsoft.com/office/drawing/2014/main" id="{61B765A9-FC84-4832-9800-8810B05264EA}"/>
+                <a16:creationId xmlns:a16="http://schemas.microsoft.com/office/drawing/2014/main" id="{416E001C-29EA-4DEF-BE52-5DA1501ADC46}"/>
               </a:ext>
             </a:extLst>
           </p:cNvPr>
@@ -6736,7 +6736,7 @@
           <p:cNvPr id="3" name="">
             <a:extLst xmlns:a="http://schemas.openxmlformats.org/drawingml/2006/main">
               <a:ext uri="{FF2B5EF4-FFF2-40B4-BE49-F238E27FC236}">
-                <a16:creationId xmlns:a16="http://schemas.microsoft.com/office/drawing/2014/main" id="{4D11D342-C96F-4AF6-9D7B-57040A226FF0}"/>
+                <a16:creationId xmlns:a16="http://schemas.microsoft.com/office/drawing/2014/main" id="{965D33C0-AB26-4D1B-8B58-C29A2FFA6D93}"/>
               </a:ext>
             </a:extLst>
           </p:cNvPr>
@@ -6793,7 +6793,7 @@
           <p:cNvPr id="4" name="">
             <a:extLst xmlns:a="http://schemas.openxmlformats.org/drawingml/2006/main">
               <a:ext uri="{FF2B5EF4-FFF2-40B4-BE49-F238E27FC236}">
-                <a16:creationId xmlns:a16="http://schemas.microsoft.com/office/drawing/2014/main" id="{56E0B2CD-BC48-4D9F-A90B-A906D5685089}"/>
+                <a16:creationId xmlns:a16="http://schemas.microsoft.com/office/drawing/2014/main" id="{D8EBD275-18E4-4A49-A023-2DD3DC217279}"/>
               </a:ext>
             </a:extLst>
           </p:cNvPr>
@@ -6857,7 +6857,7 @@
           <p:cNvPr id="5" name="">
             <a:extLst xmlns:a="http://schemas.openxmlformats.org/drawingml/2006/main">
               <a:ext uri="{FF2B5EF4-FFF2-40B4-BE49-F238E27FC236}">
-                <a16:creationId xmlns:a16="http://schemas.microsoft.com/office/drawing/2014/main" id="{03D2561F-FABE-43E6-B767-B8D6D50A1670}"/>
+                <a16:creationId xmlns:a16="http://schemas.microsoft.com/office/drawing/2014/main" id="{6A0E79E3-BCC5-44C8-A9B1-D7E06A2B9697}"/>
               </a:ext>
             </a:extLst>
           </p:cNvPr>
@@ -6911,7 +6911,7 @@
                 <a:ea typeface="Arial"/>
                 <a:cs typeface="Arial"/>
               </a:rPr>
-              <a:t>Contratos</a:t>
+              <a:t>Reservas e contratos</a:t>
             </a:r>
           </a:p>
         </p:txBody>
@@ -6921,7 +6921,7 @@
           <p:cNvPr id="6" name="">
             <a:extLst xmlns:a="http://schemas.openxmlformats.org/drawingml/2006/main">
               <a:ext uri="{FF2B5EF4-FFF2-40B4-BE49-F238E27FC236}">
-                <a16:creationId xmlns:a16="http://schemas.microsoft.com/office/drawing/2014/main" id="{1B1B509D-12C2-443C-8161-24EB84575323}"/>
+                <a16:creationId xmlns:a16="http://schemas.microsoft.com/office/drawing/2014/main" id="{A735392E-8AB2-422D-9397-5B9C611AC270}"/>
               </a:ext>
             </a:extLst>
           </p:cNvPr>
@@ -6975,7 +6975,7 @@
                 <a:ea typeface="Arial"/>
                 <a:cs typeface="Arial"/>
               </a:rPr>
-              <a:t>Financeiro</a:t>
+              <a:t>Financeiro e faturamento</a:t>
             </a:r>
           </a:p>
         </p:txBody>
@@ -6985,7 +6985,7 @@
           <p:cNvPr id="7" name="">
             <a:extLst xmlns:a="http://schemas.openxmlformats.org/drawingml/2006/main">
               <a:ext uri="{FF2B5EF4-FFF2-40B4-BE49-F238E27FC236}">
-                <a16:creationId xmlns:a16="http://schemas.microsoft.com/office/drawing/2014/main" id="{15EB86CC-65FD-4A2C-87C8-EC4A37AB67F7}"/>
+                <a16:creationId xmlns:a16="http://schemas.microsoft.com/office/drawing/2014/main" id="{F5039A25-8AF5-4645-94E5-8F6EBD53158F}"/>
               </a:ext>
             </a:extLst>
           </p:cNvPr>
@@ -7039,7 +7039,7 @@
                 <a:ea typeface="Arial"/>
                 <a:cs typeface="Arial"/>
               </a:rPr>
-              <a:t>Atendimento</a:t>
+              <a:t>Atendimento e assistência 24h</a:t>
             </a:r>
           </a:p>
         </p:txBody>
@@ -7049,7 +7049,7 @@
           <p:cNvPr id="8" name="">
             <a:extLst xmlns:a="http://schemas.openxmlformats.org/drawingml/2006/main">
               <a:ext uri="{FF2B5EF4-FFF2-40B4-BE49-F238E27FC236}">
-                <a16:creationId xmlns:a16="http://schemas.microsoft.com/office/drawing/2014/main" id="{0F5EF93F-FA3B-4A08-BF1B-C87E044A3AD5}"/>
+                <a16:creationId xmlns:a16="http://schemas.microsoft.com/office/drawing/2014/main" id="{65D56AB9-5A64-43D3-9414-F4C26D1E56AC}"/>
               </a:ext>
             </a:extLst>
           </p:cNvPr>
@@ -7217,7 +7217,7 @@
           <p:cNvPr id="13" name="">
             <a:extLst xmlns:a="http://schemas.openxmlformats.org/drawingml/2006/main">
               <a:ext uri="{FF2B5EF4-FFF2-40B4-BE49-F238E27FC236}">
-                <a16:creationId xmlns:a16="http://schemas.microsoft.com/office/drawing/2014/main" id="{1283FDF2-3635-4F63-908A-9A77DA878B99}"/>
+                <a16:creationId xmlns:a16="http://schemas.microsoft.com/office/drawing/2014/main" id="{83EFE4F1-89C9-4D29-B8F7-9CCEAC4F8EFB}"/>
               </a:ext>
             </a:extLst>
           </p:cNvPr>
@@ -7274,7 +7274,7 @@
           <p:cNvPr id="14" name="">
             <a:extLst xmlns:a="http://schemas.openxmlformats.org/drawingml/2006/main">
               <a:ext uri="{FF2B5EF4-FFF2-40B4-BE49-F238E27FC236}">
-                <a16:creationId xmlns:a16="http://schemas.microsoft.com/office/drawing/2014/main" id="{1CC68571-79F7-427C-99B3-F7D055DBE385}"/>
+                <a16:creationId xmlns:a16="http://schemas.microsoft.com/office/drawing/2014/main" id="{DD7BBCC7-8B38-43AE-8EFE-753C8CE58369}"/>
               </a:ext>
             </a:extLst>
           </p:cNvPr>
@@ -7329,7 +7329,7 @@
     </p:spTree>
     <p:extLst>
       <p:ext uri="{BB962C8B-B14F-4D97-AF65-F5344CB8AC3E}">
-        <p14:creationId xmlns:p14="http://schemas.microsoft.com/office/powerpoint/2010/main" val="411669418"/>
+        <p14:creationId xmlns:p14="http://schemas.microsoft.com/office/powerpoint/2010/main" val="176095454"/>
       </p:ext>
     </p:extLst>
   </p:cSld>
@@ -7360,7 +7360,7 @@
           <p:cNvPr id="7" name="">
             <a:extLst xmlns:a="http://schemas.openxmlformats.org/drawingml/2006/main">
               <a:ext uri="{FF2B5EF4-FFF2-40B4-BE49-F238E27FC236}">
-                <a16:creationId xmlns:a16="http://schemas.microsoft.com/office/drawing/2014/main" id="{FEF02A03-4DED-40E4-A042-EB532A8EEBA8}"/>
+                <a16:creationId xmlns:a16="http://schemas.microsoft.com/office/drawing/2014/main" id="{F3F5FB4E-857F-442E-A5B3-38DD2065F4A4}"/>
               </a:ext>
             </a:extLst>
           </p:cNvPr>
@@ -7390,7 +7390,7 @@
           <p:cNvPr id="2" name="">
             <a:extLst xmlns:a="http://schemas.openxmlformats.org/drawingml/2006/main">
               <a:ext uri="{FF2B5EF4-FFF2-40B4-BE49-F238E27FC236}">
-                <a16:creationId xmlns:a16="http://schemas.microsoft.com/office/drawing/2014/main" id="{1527EFD1-7AD5-44F3-898E-A13E71CE3AEC}"/>
+                <a16:creationId xmlns:a16="http://schemas.microsoft.com/office/drawing/2014/main" id="{8E3D115A-65F8-44B6-9B35-4E1BF62FD7B9}"/>
               </a:ext>
             </a:extLst>
           </p:cNvPr>
@@ -7447,7 +7447,7 @@
           <p:cNvPr id="3" name="">
             <a:extLst xmlns:a="http://schemas.openxmlformats.org/drawingml/2006/main">
               <a:ext uri="{FF2B5EF4-FFF2-40B4-BE49-F238E27FC236}">
-                <a16:creationId xmlns:a16="http://schemas.microsoft.com/office/drawing/2014/main" id="{A275A6EE-9353-4B37-8B4B-60851B2B62A7}"/>
+                <a16:creationId xmlns:a16="http://schemas.microsoft.com/office/drawing/2014/main" id="{B6BE9CBD-8978-49BE-8D19-FFAE8BE8B920}"/>
               </a:ext>
             </a:extLst>
           </p:cNvPr>
@@ -7504,7 +7504,7 @@
           <p:cNvPr id="4" name="">
             <a:extLst xmlns:a="http://schemas.openxmlformats.org/drawingml/2006/main">
               <a:ext uri="{FF2B5EF4-FFF2-40B4-BE49-F238E27FC236}">
-                <a16:creationId xmlns:a16="http://schemas.microsoft.com/office/drawing/2014/main" id="{6517AB7B-C552-4502-89B7-A328B8BE6CC4}"/>
+                <a16:creationId xmlns:a16="http://schemas.microsoft.com/office/drawing/2014/main" id="{A8E21D15-5318-47B1-8240-BEC5D652A8DE}"/>
               </a:ext>
             </a:extLst>
           </p:cNvPr>
@@ -7582,7 +7582,7 @@
                 <a:ea typeface="Arial"/>
                 <a:cs typeface="Arial"/>
               </a:rPr>
-              <a:t>RF 03: ativação cria cobrança e onboarding sem duplicidade</a:t>
+              <a:t>RF 03: ativação cria cobrança e preparação de retirada sem duplicidade</a:t>
             </a:r>
           </a:p>
           <a:p xmlns:a="http://schemas.openxmlformats.org/drawingml/2006/main">
@@ -7609,7 +7609,7 @@
                 <a:ea typeface="Arial"/>
                 <a:cs typeface="Arial"/>
               </a:rPr>
-              <a:t>RF 04: chamado consulta contrato, serviço e SLA</a:t>
+              <a:t>RF 04: chamado consulta contrato, grupo de veículo e SLA</a:t>
             </a:r>
           </a:p>
           <a:p xmlns:a="http://schemas.openxmlformats.org/drawingml/2006/main">
@@ -7646,7 +7646,7 @@
           <p:cNvPr id="5" name="">
             <a:extLst xmlns:a="http://schemas.openxmlformats.org/drawingml/2006/main">
               <a:ext uri="{FF2B5EF4-FFF2-40B4-BE49-F238E27FC236}">
-                <a16:creationId xmlns:a16="http://schemas.microsoft.com/office/drawing/2014/main" id="{ADE64035-7337-48A8-AD75-F693A2F0F9AB}"/>
+                <a16:creationId xmlns:a16="http://schemas.microsoft.com/office/drawing/2014/main" id="{02B21AF9-88B9-460A-BCF5-50BF594C8C38}"/>
               </a:ext>
             </a:extLst>
           </p:cNvPr>
@@ -7703,7 +7703,7 @@
           <p:cNvPr id="6" name="">
             <a:extLst xmlns:a="http://schemas.openxmlformats.org/drawingml/2006/main">
               <a:ext uri="{FF2B5EF4-FFF2-40B4-BE49-F238E27FC236}">
-                <a16:creationId xmlns:a16="http://schemas.microsoft.com/office/drawing/2014/main" id="{5967F4A3-3D04-45B9-8DE2-B6E96834BF9E}"/>
+                <a16:creationId xmlns:a16="http://schemas.microsoft.com/office/drawing/2014/main" id="{052461D8-E809-4B10-A7E1-CCA0DE6299C3}"/>
               </a:ext>
             </a:extLst>
           </p:cNvPr>
@@ -7924,7 +7924,7 @@
     </p:spTree>
     <p:extLst>
       <p:ext uri="{BB962C8B-B14F-4D97-AF65-F5344CB8AC3E}">
-        <p14:creationId xmlns:p14="http://schemas.microsoft.com/office/powerpoint/2010/main" val="1900986163"/>
+        <p14:creationId xmlns:p14="http://schemas.microsoft.com/office/powerpoint/2010/main" val="1858787110"/>
       </p:ext>
     </p:extLst>
   </p:cSld>
@@ -7955,7 +7955,7 @@
           <p:cNvPr id="7" name="">
             <a:extLst xmlns:a="http://schemas.openxmlformats.org/drawingml/2006/main">
               <a:ext uri="{FF2B5EF4-FFF2-40B4-BE49-F238E27FC236}">
-                <a16:creationId xmlns:a16="http://schemas.microsoft.com/office/drawing/2014/main" id="{FAF953D6-269B-4C4C-A84F-4082F7F96FB6}"/>
+                <a16:creationId xmlns:a16="http://schemas.microsoft.com/office/drawing/2014/main" id="{4A4C5124-0CD9-4D60-B5FB-21C331D565C3}"/>
               </a:ext>
             </a:extLst>
           </p:cNvPr>
@@ -7985,7 +7985,7 @@
           <p:cNvPr id="2" name="">
             <a:extLst xmlns:a="http://schemas.openxmlformats.org/drawingml/2006/main">
               <a:ext uri="{FF2B5EF4-FFF2-40B4-BE49-F238E27FC236}">
-                <a16:creationId xmlns:a16="http://schemas.microsoft.com/office/drawing/2014/main" id="{08BCAAC4-D28B-4857-AE80-5867F0CD680C}"/>
+                <a16:creationId xmlns:a16="http://schemas.microsoft.com/office/drawing/2014/main" id="{107703B7-B29B-43B5-A795-A65887E37B3F}"/>
               </a:ext>
             </a:extLst>
           </p:cNvPr>
@@ -8042,7 +8042,7 @@
           <p:cNvPr id="3" name="">
             <a:extLst xmlns:a="http://schemas.openxmlformats.org/drawingml/2006/main">
               <a:ext uri="{FF2B5EF4-FFF2-40B4-BE49-F238E27FC236}">
-                <a16:creationId xmlns:a16="http://schemas.microsoft.com/office/drawing/2014/main" id="{ED551D20-730C-4B78-8FD5-2BE89D89A06A}"/>
+                <a16:creationId xmlns:a16="http://schemas.microsoft.com/office/drawing/2014/main" id="{A55D4F55-6399-408F-A912-260B90C74F61}"/>
               </a:ext>
             </a:extLst>
           </p:cNvPr>
@@ -8099,7 +8099,7 @@
           <p:cNvPr id="4" name="">
             <a:extLst xmlns:a="http://schemas.openxmlformats.org/drawingml/2006/main">
               <a:ext uri="{FF2B5EF4-FFF2-40B4-BE49-F238E27FC236}">
-                <a16:creationId xmlns:a16="http://schemas.microsoft.com/office/drawing/2014/main" id="{1C1F47C2-05FF-409B-BD15-544A98B65C72}"/>
+                <a16:creationId xmlns:a16="http://schemas.microsoft.com/office/drawing/2014/main" id="{181020DF-8FF1-4009-8B77-4BCBA5EC4F37}"/>
               </a:ext>
             </a:extLst>
           </p:cNvPr>
@@ -8156,7 +8156,7 @@
           <p:cNvPr id="5" name="">
             <a:extLst xmlns:a="http://schemas.openxmlformats.org/drawingml/2006/main">
               <a:ext uri="{FF2B5EF4-FFF2-40B4-BE49-F238E27FC236}">
-                <a16:creationId xmlns:a16="http://schemas.microsoft.com/office/drawing/2014/main" id="{ACBBFA1A-1EDB-4EBF-B9AA-AF9D3E452963}"/>
+                <a16:creationId xmlns:a16="http://schemas.microsoft.com/office/drawing/2014/main" id="{4049AB19-2502-4963-935E-BE062730CAE5}"/>
               </a:ext>
             </a:extLst>
           </p:cNvPr>
@@ -8298,7 +8298,7 @@
           <p:cNvPr id="6" name="">
             <a:extLst xmlns:a="http://schemas.openxmlformats.org/drawingml/2006/main">
               <a:ext uri="{FF2B5EF4-FFF2-40B4-BE49-F238E27FC236}">
-                <a16:creationId xmlns:a16="http://schemas.microsoft.com/office/drawing/2014/main" id="{04CB2DB7-BDAF-4547-9843-64A266CFF13D}"/>
+                <a16:creationId xmlns:a16="http://schemas.microsoft.com/office/drawing/2014/main" id="{4971E268-CAB5-4497-9D66-C67B035ECF62}"/>
               </a:ext>
             </a:extLst>
           </p:cNvPr>
@@ -8353,7 +8353,7 @@
     </p:spTree>
     <p:extLst>
       <p:ext uri="{BB962C8B-B14F-4D97-AF65-F5344CB8AC3E}">
-        <p14:creationId xmlns:p14="http://schemas.microsoft.com/office/powerpoint/2010/main" val="464319204"/>
+        <p14:creationId xmlns:p14="http://schemas.microsoft.com/office/powerpoint/2010/main" val="2109065521"/>
       </p:ext>
     </p:extLst>
   </p:cSld>
@@ -8384,7 +8384,7 @@
           <p:cNvPr id="22" name="">
             <a:extLst xmlns:a="http://schemas.openxmlformats.org/drawingml/2006/main">
               <a:ext uri="{FF2B5EF4-FFF2-40B4-BE49-F238E27FC236}">
-                <a16:creationId xmlns:a16="http://schemas.microsoft.com/office/drawing/2014/main" id="{07AC01C7-2326-4C04-9089-13BDB1031054}"/>
+                <a16:creationId xmlns:a16="http://schemas.microsoft.com/office/drawing/2014/main" id="{CCF9FFE5-6BFA-48EF-A004-896C664408B0}"/>
               </a:ext>
             </a:extLst>
           </p:cNvPr>
@@ -8414,7 +8414,7 @@
           <p:cNvPr id="2" name="">
             <a:extLst xmlns:a="http://schemas.openxmlformats.org/drawingml/2006/main">
               <a:ext uri="{FF2B5EF4-FFF2-40B4-BE49-F238E27FC236}">
-                <a16:creationId xmlns:a16="http://schemas.microsoft.com/office/drawing/2014/main" id="{D7C5029A-CA15-472F-8E80-C69783D17B97}"/>
+                <a16:creationId xmlns:a16="http://schemas.microsoft.com/office/drawing/2014/main" id="{2DA61072-61C2-498B-A7D3-42895B12E4E0}"/>
               </a:ext>
             </a:extLst>
           </p:cNvPr>
@@ -8471,7 +8471,7 @@
           <p:cNvPr id="3" name="">
             <a:extLst xmlns:a="http://schemas.openxmlformats.org/drawingml/2006/main">
               <a:ext uri="{FF2B5EF4-FFF2-40B4-BE49-F238E27FC236}">
-                <a16:creationId xmlns:a16="http://schemas.microsoft.com/office/drawing/2014/main" id="{F8009FDE-080B-4B08-A414-A5BD17E8868A}"/>
+                <a16:creationId xmlns:a16="http://schemas.microsoft.com/office/drawing/2014/main" id="{928AE838-68C6-453C-8B21-D1A538BF6E61}"/>
               </a:ext>
             </a:extLst>
           </p:cNvPr>
@@ -8528,7 +8528,7 @@
           <p:cNvPr id="4" name="">
             <a:extLst xmlns:a="http://schemas.openxmlformats.org/drawingml/2006/main">
               <a:ext uri="{FF2B5EF4-FFF2-40B4-BE49-F238E27FC236}">
-                <a16:creationId xmlns:a16="http://schemas.microsoft.com/office/drawing/2014/main" id="{7A599CEF-2799-4B9E-AAA4-9CA9BB548F04}"/>
+                <a16:creationId xmlns:a16="http://schemas.microsoft.com/office/drawing/2014/main" id="{459FACC6-58D5-4240-8919-1D4BA7F71207}"/>
               </a:ext>
             </a:extLst>
           </p:cNvPr>
@@ -8592,7 +8592,7 @@
           <p:cNvPr id="5" name="">
             <a:extLst xmlns:a="http://schemas.openxmlformats.org/drawingml/2006/main">
               <a:ext uri="{FF2B5EF4-FFF2-40B4-BE49-F238E27FC236}">
-                <a16:creationId xmlns:a16="http://schemas.microsoft.com/office/drawing/2014/main" id="{9400B269-1750-48D9-9AB3-6B13A13EBEB7}"/>
+                <a16:creationId xmlns:a16="http://schemas.microsoft.com/office/drawing/2014/main" id="{52DC1C2B-564C-40B2-A3D9-46B75DAFC005}"/>
               </a:ext>
             </a:extLst>
           </p:cNvPr>
@@ -8656,7 +8656,7 @@
           <p:cNvPr id="6" name="">
             <a:extLst xmlns:a="http://schemas.openxmlformats.org/drawingml/2006/main">
               <a:ext uri="{FF2B5EF4-FFF2-40B4-BE49-F238E27FC236}">
-                <a16:creationId xmlns:a16="http://schemas.microsoft.com/office/drawing/2014/main" id="{25011410-8BCD-41BE-B97D-3635C088D9DA}"/>
+                <a16:creationId xmlns:a16="http://schemas.microsoft.com/office/drawing/2014/main" id="{CEE6E2B8-7B22-400A-B72C-C0AAB2EAA6D6}"/>
               </a:ext>
             </a:extLst>
           </p:cNvPr>
@@ -8720,7 +8720,7 @@
           <p:cNvPr id="7" name="">
             <a:extLst xmlns:a="http://schemas.openxmlformats.org/drawingml/2006/main">
               <a:ext uri="{FF2B5EF4-FFF2-40B4-BE49-F238E27FC236}">
-                <a16:creationId xmlns:a16="http://schemas.microsoft.com/office/drawing/2014/main" id="{6E5BA304-14AF-4E4F-98B4-F6897D34A9A0}"/>
+                <a16:creationId xmlns:a16="http://schemas.microsoft.com/office/drawing/2014/main" id="{61B0F455-940B-4BB3-BDA3-CE20FFF2653E}"/>
               </a:ext>
             </a:extLst>
           </p:cNvPr>
@@ -8784,7 +8784,7 @@
           <p:cNvPr id="8" name="">
             <a:extLst xmlns:a="http://schemas.openxmlformats.org/drawingml/2006/main">
               <a:ext uri="{FF2B5EF4-FFF2-40B4-BE49-F238E27FC236}">
-                <a16:creationId xmlns:a16="http://schemas.microsoft.com/office/drawing/2014/main" id="{B0153EA3-E36F-4161-870D-14C98F3B14AC}"/>
+                <a16:creationId xmlns:a16="http://schemas.microsoft.com/office/drawing/2014/main" id="{CB012C30-C5F7-4F04-BD02-C45A2F250E44}"/>
               </a:ext>
             </a:extLst>
           </p:cNvPr>
@@ -8848,7 +8848,7 @@
           <p:cNvPr id="9" name="">
             <a:extLst xmlns:a="http://schemas.openxmlformats.org/drawingml/2006/main">
               <a:ext uri="{FF2B5EF4-FFF2-40B4-BE49-F238E27FC236}">
-                <a16:creationId xmlns:a16="http://schemas.microsoft.com/office/drawing/2014/main" id="{6D2DFF6C-D5EB-4133-960F-7B2EF32AB7BE}"/>
+                <a16:creationId xmlns:a16="http://schemas.microsoft.com/office/drawing/2014/main" id="{33D11E89-EDF2-4FA9-92BC-6E5F876333A7}"/>
               </a:ext>
             </a:extLst>
           </p:cNvPr>
@@ -9054,7 +9054,7 @@
           <p:cNvPr id="15" name="">
             <a:extLst xmlns:a="http://schemas.openxmlformats.org/drawingml/2006/main">
               <a:ext uri="{FF2B5EF4-FFF2-40B4-BE49-F238E27FC236}">
-                <a16:creationId xmlns:a16="http://schemas.microsoft.com/office/drawing/2014/main" id="{D27AB34C-2AD2-4495-94FA-A6547CE0EE84}"/>
+                <a16:creationId xmlns:a16="http://schemas.microsoft.com/office/drawing/2014/main" id="{021C2975-F8F1-497D-B480-468C55F6FE56}"/>
               </a:ext>
             </a:extLst>
           </p:cNvPr>
@@ -9278,7 +9278,7 @@
           <p:cNvPr id="21" name="">
             <a:extLst xmlns:a="http://schemas.openxmlformats.org/drawingml/2006/main">
               <a:ext uri="{FF2B5EF4-FFF2-40B4-BE49-F238E27FC236}">
-                <a16:creationId xmlns:a16="http://schemas.microsoft.com/office/drawing/2014/main" id="{ECB58850-6941-4913-A74B-7903338E62DD}"/>
+                <a16:creationId xmlns:a16="http://schemas.microsoft.com/office/drawing/2014/main" id="{0212001B-6C10-4390-B1F1-C3417DBF2ED7}"/>
               </a:ext>
             </a:extLst>
           </p:cNvPr>
@@ -9333,7 +9333,7 @@
     </p:spTree>
     <p:extLst>
       <p:ext uri="{BB962C8B-B14F-4D97-AF65-F5344CB8AC3E}">
-        <p14:creationId xmlns:p14="http://schemas.microsoft.com/office/powerpoint/2010/main" val="1555247467"/>
+        <p14:creationId xmlns:p14="http://schemas.microsoft.com/office/powerpoint/2010/main" val="1181809321"/>
       </p:ext>
     </p:extLst>
   </p:cSld>
@@ -9364,7 +9364,7 @@
           <p:cNvPr id="16" name="">
             <a:extLst xmlns:a="http://schemas.openxmlformats.org/drawingml/2006/main">
               <a:ext uri="{FF2B5EF4-FFF2-40B4-BE49-F238E27FC236}">
-                <a16:creationId xmlns:a16="http://schemas.microsoft.com/office/drawing/2014/main" id="{1DD6C975-4BFB-494E-8A6E-7572442F3CC9}"/>
+                <a16:creationId xmlns:a16="http://schemas.microsoft.com/office/drawing/2014/main" id="{68B12370-1680-44BA-B033-C308FB7E95A0}"/>
               </a:ext>
             </a:extLst>
           </p:cNvPr>
@@ -9394,7 +9394,7 @@
           <p:cNvPr id="2" name="">
             <a:extLst xmlns:a="http://schemas.openxmlformats.org/drawingml/2006/main">
               <a:ext uri="{FF2B5EF4-FFF2-40B4-BE49-F238E27FC236}">
-                <a16:creationId xmlns:a16="http://schemas.microsoft.com/office/drawing/2014/main" id="{DB1BFB9A-F731-409E-92D5-D2FC5C5B27B1}"/>
+                <a16:creationId xmlns:a16="http://schemas.microsoft.com/office/drawing/2014/main" id="{C42B77CF-F30A-4369-80C0-48C857FEF520}"/>
               </a:ext>
             </a:extLst>
           </p:cNvPr>
@@ -9451,7 +9451,7 @@
           <p:cNvPr id="3" name="">
             <a:extLst xmlns:a="http://schemas.openxmlformats.org/drawingml/2006/main">
               <a:ext uri="{FF2B5EF4-FFF2-40B4-BE49-F238E27FC236}">
-                <a16:creationId xmlns:a16="http://schemas.microsoft.com/office/drawing/2014/main" id="{BD5A08D8-43EE-48FE-A98C-874C2252DC78}"/>
+                <a16:creationId xmlns:a16="http://schemas.microsoft.com/office/drawing/2014/main" id="{728856EB-DE2B-44C2-B80E-3E8F0808E185}"/>
               </a:ext>
             </a:extLst>
           </p:cNvPr>
@@ -9508,7 +9508,7 @@
           <p:cNvPr id="4" name="">
             <a:extLst xmlns:a="http://schemas.openxmlformats.org/drawingml/2006/main">
               <a:ext uri="{FF2B5EF4-FFF2-40B4-BE49-F238E27FC236}">
-                <a16:creationId xmlns:a16="http://schemas.microsoft.com/office/drawing/2014/main" id="{6E248127-7B79-4B5D-B0DC-9A545F447280}"/>
+                <a16:creationId xmlns:a16="http://schemas.microsoft.com/office/drawing/2014/main" id="{7927E7CE-39BA-4C04-B27C-F204CC2BFFBC}"/>
               </a:ext>
             </a:extLst>
           </p:cNvPr>
@@ -9565,7 +9565,7 @@
           <p:cNvPr id="5" name="">
             <a:extLst xmlns:a="http://schemas.openxmlformats.org/drawingml/2006/main">
               <a:ext uri="{FF2B5EF4-FFF2-40B4-BE49-F238E27FC236}">
-                <a16:creationId xmlns:a16="http://schemas.microsoft.com/office/drawing/2014/main" id="{3F137B24-F9CD-495A-93F9-52F77F7A579D}"/>
+                <a16:creationId xmlns:a16="http://schemas.microsoft.com/office/drawing/2014/main" id="{16B298A5-2AAE-423B-B004-5073AE05AD98}"/>
               </a:ext>
             </a:extLst>
           </p:cNvPr>
@@ -9612,7 +9612,7 @@
                 <a:ea typeface="Arial"/>
                 <a:cs typeface="Arial"/>
               </a:rPr>
-              <a:t>Cliente, contato, consentimento e oportunidade</a:t>
+              <a:t>Cliente, contato, consentimento, perfil de locação e oportunidade corporativa</a:t>
             </a:r>
           </a:p>
         </p:txBody>
@@ -9622,7 +9622,7 @@
           <p:cNvPr id="6" name="">
             <a:extLst xmlns:a="http://schemas.openxmlformats.org/drawingml/2006/main">
               <a:ext uri="{FF2B5EF4-FFF2-40B4-BE49-F238E27FC236}">
-                <a16:creationId xmlns:a16="http://schemas.microsoft.com/office/drawing/2014/main" id="{5EE0CEA6-5B54-4919-8D9B-45AC4BE47857}"/>
+                <a16:creationId xmlns:a16="http://schemas.microsoft.com/office/drawing/2014/main" id="{49B66D9F-D684-42C6-92BB-089A1D555706}"/>
               </a:ext>
             </a:extLst>
           </p:cNvPr>
@@ -9679,7 +9679,7 @@
           <p:cNvPr id="7" name="">
             <a:extLst xmlns:a="http://schemas.openxmlformats.org/drawingml/2006/main">
               <a:ext uri="{FF2B5EF4-FFF2-40B4-BE49-F238E27FC236}">
-                <a16:creationId xmlns:a16="http://schemas.microsoft.com/office/drawing/2014/main" id="{C51A315E-0894-42FB-9852-85CEB4AE73E8}"/>
+                <a16:creationId xmlns:a16="http://schemas.microsoft.com/office/drawing/2014/main" id="{382A2FB9-990C-4BC4-B3D9-EF85F854507C}"/>
               </a:ext>
             </a:extLst>
           </p:cNvPr>
@@ -9726,7 +9726,7 @@
                 <a:ea typeface="Arial"/>
                 <a:cs typeface="Arial"/>
               </a:rPr>
-              <a:t>Contrato, itens, vigência, plano e SLA</a:t>
+              <a:t>Reserva, contrato de locação, grupo de veículo, vigência, proteções e SLA</a:t>
             </a:r>
           </a:p>
         </p:txBody>
@@ -9736,7 +9736,7 @@
           <p:cNvPr id="8" name="">
             <a:extLst xmlns:a="http://schemas.openxmlformats.org/drawingml/2006/main">
               <a:ext uri="{FF2B5EF4-FFF2-40B4-BE49-F238E27FC236}">
-                <a16:creationId xmlns:a16="http://schemas.microsoft.com/office/drawing/2014/main" id="{19892472-56DB-4264-9CB3-904F62B20DAE}"/>
+                <a16:creationId xmlns:a16="http://schemas.microsoft.com/office/drawing/2014/main" id="{0E8211DE-5794-41EF-AC47-4A75CFDF0901}"/>
               </a:ext>
             </a:extLst>
           </p:cNvPr>
@@ -9793,7 +9793,7 @@
           <p:cNvPr id="9" name="">
             <a:extLst xmlns:a="http://schemas.openxmlformats.org/drawingml/2006/main">
               <a:ext uri="{FF2B5EF4-FFF2-40B4-BE49-F238E27FC236}">
-                <a16:creationId xmlns:a16="http://schemas.microsoft.com/office/drawing/2014/main" id="{5CD7A8A0-75CB-4E62-87B1-49E62AF78A45}"/>
+                <a16:creationId xmlns:a16="http://schemas.microsoft.com/office/drawing/2014/main" id="{42B1A65A-B4F1-450A-A558-BB69E6521417}"/>
               </a:ext>
             </a:extLst>
           </p:cNvPr>
@@ -9840,7 +9840,7 @@
                 <a:ea typeface="Arial"/>
                 <a:cs typeface="Arial"/>
               </a:rPr>
-              <a:t>Cobrança, vencimento, pagamento e inadimplência</a:t>
+              <a:t>Pré-autorização, cobrança, fatura, pagamento, caução, multa e inadimplência</a:t>
             </a:r>
           </a:p>
         </p:txBody>
@@ -9850,7 +9850,7 @@
           <p:cNvPr id="10" name="">
             <a:extLst xmlns:a="http://schemas.openxmlformats.org/drawingml/2006/main">
               <a:ext uri="{FF2B5EF4-FFF2-40B4-BE49-F238E27FC236}">
-                <a16:creationId xmlns:a16="http://schemas.microsoft.com/office/drawing/2014/main" id="{96C20F3E-944C-4D7C-92CD-440188A1D8E3}"/>
+                <a16:creationId xmlns:a16="http://schemas.microsoft.com/office/drawing/2014/main" id="{FA27152C-AD06-4643-A905-A1B2B86E87DB}"/>
               </a:ext>
             </a:extLst>
           </p:cNvPr>
@@ -9907,7 +9907,7 @@
           <p:cNvPr id="11" name="">
             <a:extLst xmlns:a="http://schemas.openxmlformats.org/drawingml/2006/main">
               <a:ext uri="{FF2B5EF4-FFF2-40B4-BE49-F238E27FC236}">
-                <a16:creationId xmlns:a16="http://schemas.microsoft.com/office/drawing/2014/main" id="{F40A19AB-2851-40EB-8ABD-6718B69BCDA8}"/>
+                <a16:creationId xmlns:a16="http://schemas.microsoft.com/office/drawing/2014/main" id="{51CC7187-7745-4EBF-84B5-AD8A52756B9A}"/>
               </a:ext>
             </a:extLst>
           </p:cNvPr>
@@ -9954,7 +9954,7 @@
                 <a:ea typeface="Arial"/>
                 <a:cs typeface="Arial"/>
               </a:rPr>
-              <a:t>Chamado, prioridade, histórico e resolução</a:t>
+              <a:t>Chamado, assistência, prioridade, histórico e resolução</a:t>
             </a:r>
           </a:p>
         </p:txBody>
@@ -9964,7 +9964,7 @@
           <p:cNvPr id="12" name="">
             <a:extLst xmlns:a="http://schemas.openxmlformats.org/drawingml/2006/main">
               <a:ext uri="{FF2B5EF4-FFF2-40B4-BE49-F238E27FC236}">
-                <a16:creationId xmlns:a16="http://schemas.microsoft.com/office/drawing/2014/main" id="{E92ABE92-8ED0-4AE2-9FDF-26D0F463DD93}"/>
+                <a16:creationId xmlns:a16="http://schemas.microsoft.com/office/drawing/2014/main" id="{7C294C67-962D-48CA-AAEB-CD62452DE316}"/>
               </a:ext>
             </a:extLst>
           </p:cNvPr>
@@ -10021,7 +10021,7 @@
           <p:cNvPr id="13" name="">
             <a:extLst xmlns:a="http://schemas.openxmlformats.org/drawingml/2006/main">
               <a:ext uri="{FF2B5EF4-FFF2-40B4-BE49-F238E27FC236}">
-                <a16:creationId xmlns:a16="http://schemas.microsoft.com/office/drawing/2014/main" id="{ABAF28C8-CAA0-497B-B633-ECCF82D79E13}"/>
+                <a16:creationId xmlns:a16="http://schemas.microsoft.com/office/drawing/2014/main" id="{89297E5D-14D2-48BA-9F23-DBFEBA73890C}"/>
               </a:ext>
             </a:extLst>
           </p:cNvPr>
@@ -10068,7 +10068,7 @@
                 <a:ea typeface="Arial"/>
                 <a:cs typeface="Arial"/>
               </a:rPr>
-              <a:t>Instância, tarefa, responsável, prazo e estado</a:t>
+              <a:t>Instância, tarefa, responsável, prazo e estado operacional</a:t>
             </a:r>
           </a:p>
         </p:txBody>
@@ -10078,7 +10078,7 @@
           <p:cNvPr id="14" name="">
             <a:extLst xmlns:a="http://schemas.openxmlformats.org/drawingml/2006/main">
               <a:ext uri="{FF2B5EF4-FFF2-40B4-BE49-F238E27FC236}">
-                <a16:creationId xmlns:a16="http://schemas.microsoft.com/office/drawing/2014/main" id="{1242F425-B88F-4137-BA56-548732F3F66D}"/>
+                <a16:creationId xmlns:a16="http://schemas.microsoft.com/office/drawing/2014/main" id="{99725D28-A884-4F60-A174-FE77E19FAF67}"/>
               </a:ext>
             </a:extLst>
           </p:cNvPr>
@@ -10135,7 +10135,7 @@
           <p:cNvPr id="15" name="">
             <a:extLst xmlns:a="http://schemas.openxmlformats.org/drawingml/2006/main">
               <a:ext uri="{FF2B5EF4-FFF2-40B4-BE49-F238E27FC236}">
-                <a16:creationId xmlns:a16="http://schemas.microsoft.com/office/drawing/2014/main" id="{4EE43609-9C62-40B6-8656-92F123AA4F33}"/>
+                <a16:creationId xmlns:a16="http://schemas.microsoft.com/office/drawing/2014/main" id="{D29F6C12-761B-42C9-9C96-B48DBF5C3428}"/>
               </a:ext>
             </a:extLst>
           </p:cNvPr>
@@ -10190,7 +10190,7 @@
     </p:spTree>
     <p:extLst>
       <p:ext uri="{BB962C8B-B14F-4D97-AF65-F5344CB8AC3E}">
-        <p14:creationId xmlns:p14="http://schemas.microsoft.com/office/powerpoint/2010/main" val="1802019160"/>
+        <p14:creationId xmlns:p14="http://schemas.microsoft.com/office/powerpoint/2010/main" val="216230510"/>
       </p:ext>
     </p:extLst>
   </p:cSld>
@@ -10221,7 +10221,7 @@
           <p:cNvPr id="11" name="">
             <a:extLst xmlns:a="http://schemas.openxmlformats.org/drawingml/2006/main">
               <a:ext uri="{FF2B5EF4-FFF2-40B4-BE49-F238E27FC236}">
-                <a16:creationId xmlns:a16="http://schemas.microsoft.com/office/drawing/2014/main" id="{6D7ED57A-21DD-455F-A1FD-78163D3D6957}"/>
+                <a16:creationId xmlns:a16="http://schemas.microsoft.com/office/drawing/2014/main" id="{F87F9366-E495-48EA-9E5A-DF10DD5FFB3F}"/>
               </a:ext>
             </a:extLst>
           </p:cNvPr>
@@ -10251,7 +10251,7 @@
           <p:cNvPr id="2" name="">
             <a:extLst xmlns:a="http://schemas.openxmlformats.org/drawingml/2006/main">
               <a:ext uri="{FF2B5EF4-FFF2-40B4-BE49-F238E27FC236}">
-                <a16:creationId xmlns:a16="http://schemas.microsoft.com/office/drawing/2014/main" id="{DFED6BF7-D173-441E-9335-0C00D21806EE}"/>
+                <a16:creationId xmlns:a16="http://schemas.microsoft.com/office/drawing/2014/main" id="{E8BAFA79-2921-40C9-BD28-063EA24367AE}"/>
               </a:ext>
             </a:extLst>
           </p:cNvPr>
@@ -10298,7 +10298,7 @@
                 <a:ea typeface="Arial"/>
                 <a:cs typeface="Arial"/>
               </a:rPr>
-              <a:t>Fluxo F1 Cliente para contrato</a:t>
+              <a:t>Fluxo F1 Cliente para reserva/contrato</a:t>
             </a:r>
           </a:p>
         </p:txBody>
@@ -10308,7 +10308,7 @@
           <p:cNvPr id="3" name="">
             <a:extLst xmlns:a="http://schemas.openxmlformats.org/drawingml/2006/main">
               <a:ext uri="{FF2B5EF4-FFF2-40B4-BE49-F238E27FC236}">
-                <a16:creationId xmlns:a16="http://schemas.microsoft.com/office/drawing/2014/main" id="{07A3455B-B701-42C8-9C88-993C069AC72D}"/>
+                <a16:creationId xmlns:a16="http://schemas.microsoft.com/office/drawing/2014/main" id="{ED2E51D2-E5C2-4F85-A279-813927EBD54D}"/>
               </a:ext>
             </a:extLst>
           </p:cNvPr>
@@ -10365,7 +10365,7 @@
           <p:cNvPr id="4" name="">
             <a:extLst xmlns:a="http://schemas.openxmlformats.org/drawingml/2006/main">
               <a:ext uri="{FF2B5EF4-FFF2-40B4-BE49-F238E27FC236}">
-                <a16:creationId xmlns:a16="http://schemas.microsoft.com/office/drawing/2014/main" id="{5E5792B6-15B3-4B1D-973E-FF411F70361D}"/>
+                <a16:creationId xmlns:a16="http://schemas.microsoft.com/office/drawing/2014/main" id="{84832920-096A-4696-A811-E81813204E03}"/>
               </a:ext>
             </a:extLst>
           </p:cNvPr>
@@ -10452,7 +10452,7 @@
           <p:cNvPr id="5" name="">
             <a:extLst xmlns:a="http://schemas.openxmlformats.org/drawingml/2006/main">
               <a:ext uri="{FF2B5EF4-FFF2-40B4-BE49-F238E27FC236}">
-                <a16:creationId xmlns:a16="http://schemas.microsoft.com/office/drawing/2014/main" id="{41A0A42A-584B-474B-9637-FB7FA2030B4E}"/>
+                <a16:creationId xmlns:a16="http://schemas.microsoft.com/office/drawing/2014/main" id="{AE39B181-B378-469E-99C0-E496B57AB6D5}"/>
               </a:ext>
             </a:extLst>
           </p:cNvPr>
@@ -10539,7 +10539,7 @@
           <p:cNvPr id="6" name="">
             <a:extLst xmlns:a="http://schemas.openxmlformats.org/drawingml/2006/main">
               <a:ext uri="{FF2B5EF4-FFF2-40B4-BE49-F238E27FC236}">
-                <a16:creationId xmlns:a16="http://schemas.microsoft.com/office/drawing/2014/main" id="{810BB848-67E7-4D3E-87E8-E7BFCC7F1AF1}"/>
+                <a16:creationId xmlns:a16="http://schemas.microsoft.com/office/drawing/2014/main" id="{687EC76E-169D-4843-951B-CAAF1C3769DC}"/>
               </a:ext>
             </a:extLst>
           </p:cNvPr>
@@ -10678,7 +10678,7 @@
           <p:cNvPr id="9" name="">
             <a:extLst xmlns:a="http://schemas.openxmlformats.org/drawingml/2006/main">
               <a:ext uri="{FF2B5EF4-FFF2-40B4-BE49-F238E27FC236}">
-                <a16:creationId xmlns:a16="http://schemas.microsoft.com/office/drawing/2014/main" id="{30A3BB40-27C9-42B2-BD53-E7A2ADC162F0}"/>
+                <a16:creationId xmlns:a16="http://schemas.microsoft.com/office/drawing/2014/main" id="{4AD393B7-7F87-4BC6-AF3C-4F414A6397DE}"/>
               </a:ext>
             </a:extLst>
           </p:cNvPr>
@@ -10735,7 +10735,7 @@
           <p:cNvPr id="10" name="">
             <a:extLst xmlns:a="http://schemas.openxmlformats.org/drawingml/2006/main">
               <a:ext uri="{FF2B5EF4-FFF2-40B4-BE49-F238E27FC236}">
-                <a16:creationId xmlns:a16="http://schemas.microsoft.com/office/drawing/2014/main" id="{C51318F9-A87C-4AB3-822F-74ED3B375346}"/>
+                <a16:creationId xmlns:a16="http://schemas.microsoft.com/office/drawing/2014/main" id="{C49E9140-878D-4E9B-ACFF-906741B80F28}"/>
               </a:ext>
             </a:extLst>
           </p:cNvPr>
@@ -10790,7 +10790,7 @@
     </p:spTree>
     <p:extLst>
       <p:ext uri="{BB962C8B-B14F-4D97-AF65-F5344CB8AC3E}">
-        <p14:creationId xmlns:p14="http://schemas.microsoft.com/office/powerpoint/2010/main" val="1750722494"/>
+        <p14:creationId xmlns:p14="http://schemas.microsoft.com/office/powerpoint/2010/main" val="1880273524"/>
       </p:ext>
     </p:extLst>
   </p:cSld>
@@ -10821,7 +10821,7 @@
           <p:cNvPr id="12" name="">
             <a:extLst xmlns:a="http://schemas.openxmlformats.org/drawingml/2006/main">
               <a:ext uri="{FF2B5EF4-FFF2-40B4-BE49-F238E27FC236}">
-                <a16:creationId xmlns:a16="http://schemas.microsoft.com/office/drawing/2014/main" id="{CA503FC6-FA3E-44C9-A6DB-268FE6E74CF0}"/>
+                <a16:creationId xmlns:a16="http://schemas.microsoft.com/office/drawing/2014/main" id="{6D58DEEF-FDF7-4696-AA8C-5D32501BEA2C}"/>
               </a:ext>
             </a:extLst>
           </p:cNvPr>
@@ -10851,7 +10851,7 @@
           <p:cNvPr id="2" name="">
             <a:extLst xmlns:a="http://schemas.openxmlformats.org/drawingml/2006/main">
               <a:ext uri="{FF2B5EF4-FFF2-40B4-BE49-F238E27FC236}">
-                <a16:creationId xmlns:a16="http://schemas.microsoft.com/office/drawing/2014/main" id="{390473F1-8A68-4CDE-9913-8AF8FD36FD97}"/>
+                <a16:creationId xmlns:a16="http://schemas.microsoft.com/office/drawing/2014/main" id="{F4114B2B-1C7B-4457-BBED-7D2109602C52}"/>
               </a:ext>
             </a:extLst>
           </p:cNvPr>
@@ -10898,7 +10898,7 @@
                 <a:ea typeface="Arial"/>
                 <a:cs typeface="Arial"/>
               </a:rPr>
-              <a:t>Fluxo F2 Ativação cobrança e onboarding</a:t>
+              <a:t>Fluxo F2 Ativação cobrança e preparação de retirada</a:t>
             </a:r>
           </a:p>
         </p:txBody>
@@ -10908,7 +10908,7 @@
           <p:cNvPr id="3" name="">
             <a:extLst xmlns:a="http://schemas.openxmlformats.org/drawingml/2006/main">
               <a:ext uri="{FF2B5EF4-FFF2-40B4-BE49-F238E27FC236}">
-                <a16:creationId xmlns:a16="http://schemas.microsoft.com/office/drawing/2014/main" id="{21469B64-6DFA-44E2-8192-3F62CFEF6D46}"/>
+                <a16:creationId xmlns:a16="http://schemas.microsoft.com/office/drawing/2014/main" id="{C7010A5F-2D65-435F-8CAE-22A198B377C0}"/>
               </a:ext>
             </a:extLst>
           </p:cNvPr>
@@ -10965,7 +10965,7 @@
           <p:cNvPr id="4" name="">
             <a:extLst xmlns:a="http://schemas.openxmlformats.org/drawingml/2006/main">
               <a:ext uri="{FF2B5EF4-FFF2-40B4-BE49-F238E27FC236}">
-                <a16:creationId xmlns:a16="http://schemas.microsoft.com/office/drawing/2014/main" id="{196FE4BF-20C9-4108-AEA5-70D4497F92AA}"/>
+                <a16:creationId xmlns:a16="http://schemas.microsoft.com/office/drawing/2014/main" id="{B528E920-9475-4033-9C8C-CD03AA670F7F}"/>
               </a:ext>
             </a:extLst>
           </p:cNvPr>
@@ -11052,7 +11052,7 @@
           <p:cNvPr id="5" name="">
             <a:extLst xmlns:a="http://schemas.openxmlformats.org/drawingml/2006/main">
               <a:ext uri="{FF2B5EF4-FFF2-40B4-BE49-F238E27FC236}">
-                <a16:creationId xmlns:a16="http://schemas.microsoft.com/office/drawing/2014/main" id="{D5A8B667-4588-47EA-B3DF-B1BB22B6FD00}"/>
+                <a16:creationId xmlns:a16="http://schemas.microsoft.com/office/drawing/2014/main" id="{593FBED0-58E5-423C-ABC8-8192228E3CEB}"/>
               </a:ext>
             </a:extLst>
           </p:cNvPr>
@@ -11139,7 +11139,7 @@
           <p:cNvPr id="6" name="">
             <a:extLst xmlns:a="http://schemas.openxmlformats.org/drawingml/2006/main">
               <a:ext uri="{FF2B5EF4-FFF2-40B4-BE49-F238E27FC236}">
-                <a16:creationId xmlns:a16="http://schemas.microsoft.com/office/drawing/2014/main" id="{D0A63839-4580-48C5-A679-28907424AB0A}"/>
+                <a16:creationId xmlns:a16="http://schemas.microsoft.com/office/drawing/2014/main" id="{16DBF88D-75DC-462F-BCC4-C5FE24AE74D2}"/>
               </a:ext>
             </a:extLst>
           </p:cNvPr>
@@ -11226,7 +11226,7 @@
           <p:cNvPr id="7" name="">
             <a:extLst xmlns:a="http://schemas.openxmlformats.org/drawingml/2006/main">
               <a:ext uri="{FF2B5EF4-FFF2-40B4-BE49-F238E27FC236}">
-                <a16:creationId xmlns:a16="http://schemas.microsoft.com/office/drawing/2014/main" id="{0E9F3CED-D2E4-48BA-9949-212B1EA69606}"/>
+                <a16:creationId xmlns:a16="http://schemas.microsoft.com/office/drawing/2014/main" id="{BE4B8A44-434D-4098-A095-5D1F8EE02F21}"/>
               </a:ext>
             </a:extLst>
           </p:cNvPr>
@@ -11303,7 +11303,7 @@
                 <a:ea typeface="Arial"/>
                 <a:cs typeface="Arial"/>
               </a:rPr>
-              <a:t>1 onboarding</a:t>
+              <a:t>1 preparação de retirada</a:t>
             </a:r>
           </a:p>
         </p:txBody>
@@ -11395,7 +11395,7 @@
           <p:cNvPr id="11" name="">
             <a:extLst xmlns:a="http://schemas.openxmlformats.org/drawingml/2006/main">
               <a:ext uri="{FF2B5EF4-FFF2-40B4-BE49-F238E27FC236}">
-                <a16:creationId xmlns:a16="http://schemas.microsoft.com/office/drawing/2014/main" id="{371649F5-7A46-44E1-A847-EC7BF5482F2C}"/>
+                <a16:creationId xmlns:a16="http://schemas.microsoft.com/office/drawing/2014/main" id="{E4E2F332-636B-410B-A66D-C85F02288BD7}"/>
               </a:ext>
             </a:extLst>
           </p:cNvPr>
@@ -11450,7 +11450,7 @@
     </p:spTree>
     <p:extLst>
       <p:ext uri="{BB962C8B-B14F-4D97-AF65-F5344CB8AC3E}">
-        <p14:creationId xmlns:p14="http://schemas.microsoft.com/office/powerpoint/2010/main" val="2073358320"/>
+        <p14:creationId xmlns:p14="http://schemas.microsoft.com/office/powerpoint/2010/main" val="1814719520"/>
       </p:ext>
     </p:extLst>
   </p:cSld>

</xml_diff>

<commit_message>
docs(T19): alinha relatorio e slides as evidencias atuais
</commit_message>
<xml_diff>
--- a/output/Apresentacao_Cenario_4.pptx
+++ b/output/Apresentacao_Cenario_4.pptx
@@ -2,27 +2,27 @@
 <file path=ppt/presentation.xml><?xml version="1.0" encoding="utf-8"?>
 <p:presentation xmlns:p="http://schemas.openxmlformats.org/presentationml/2006/main">
   <p:sldMasterIdLst>
-    <p:sldMasterId xmlns:r="http://schemas.openxmlformats.org/officeDocument/2006/relationships" id="2147483648" r:id="R33dbe10fc2fb45a7"/>
+    <p:sldMasterId xmlns:r="http://schemas.openxmlformats.org/officeDocument/2006/relationships" id="2147483648" r:id="R627acbd1a8344d65"/>
   </p:sldMasterIdLst>
   <p:notesMasterIdLst>
-    <p:notesMasterId xmlns:r="http://schemas.openxmlformats.org/officeDocument/2006/relationships" r:id="R2c7684a86d3d4103"/>
+    <p:notesMasterId xmlns:r="http://schemas.openxmlformats.org/officeDocument/2006/relationships" r:id="R34ee62f438ae401c"/>
   </p:notesMasterIdLst>
   <p:sldIdLst>
-    <p:sldId xmlns:r="http://schemas.openxmlformats.org/officeDocument/2006/relationships" id="256" r:id="Ra7e059f5afeb45b1"/>
-    <p:sldId xmlns:r="http://schemas.openxmlformats.org/officeDocument/2006/relationships" id="257" r:id="R89e9ee3f737a49ba"/>
-    <p:sldId xmlns:r="http://schemas.openxmlformats.org/officeDocument/2006/relationships" id="258" r:id="Rd3a846d83a344509"/>
-    <p:sldId xmlns:r="http://schemas.openxmlformats.org/officeDocument/2006/relationships" id="259" r:id="R418e239e82004a1d"/>
-    <p:sldId xmlns:r="http://schemas.openxmlformats.org/officeDocument/2006/relationships" id="260" r:id="Rbf4f7a639fd248fb"/>
-    <p:sldId xmlns:r="http://schemas.openxmlformats.org/officeDocument/2006/relationships" id="261" r:id="Rbcbff4ba0ef24e43"/>
-    <p:sldId xmlns:r="http://schemas.openxmlformats.org/officeDocument/2006/relationships" id="262" r:id="R51a9053fc1c64e20"/>
-    <p:sldId xmlns:r="http://schemas.openxmlformats.org/officeDocument/2006/relationships" id="263" r:id="R1afb59d3eb5b4d61"/>
-    <p:sldId xmlns:r="http://schemas.openxmlformats.org/officeDocument/2006/relationships" id="264" r:id="R9cf837c3df98471a"/>
-    <p:sldId xmlns:r="http://schemas.openxmlformats.org/officeDocument/2006/relationships" id="265" r:id="Rb4c322c0fa964d40"/>
-    <p:sldId xmlns:r="http://schemas.openxmlformats.org/officeDocument/2006/relationships" id="266" r:id="R6de035de01d74cf5"/>
-    <p:sldId xmlns:r="http://schemas.openxmlformats.org/officeDocument/2006/relationships" id="267" r:id="Rf6304cf18b29416d"/>
-    <p:sldId xmlns:r="http://schemas.openxmlformats.org/officeDocument/2006/relationships" id="268" r:id="R977f7391e79b4f64"/>
-    <p:sldId xmlns:r="http://schemas.openxmlformats.org/officeDocument/2006/relationships" id="269" r:id="R74d6c326570d4a96"/>
-    <p:sldId xmlns:r="http://schemas.openxmlformats.org/officeDocument/2006/relationships" id="270" r:id="R703be5d6d8d24c30"/>
+    <p:sldId xmlns:r="http://schemas.openxmlformats.org/officeDocument/2006/relationships" id="256" r:id="R7af63b94af104dbc"/>
+    <p:sldId xmlns:r="http://schemas.openxmlformats.org/officeDocument/2006/relationships" id="257" r:id="R6764901b17a0438b"/>
+    <p:sldId xmlns:r="http://schemas.openxmlformats.org/officeDocument/2006/relationships" id="258" r:id="R9b61c7ff444f46f9"/>
+    <p:sldId xmlns:r="http://schemas.openxmlformats.org/officeDocument/2006/relationships" id="259" r:id="R661ef91ce75446de"/>
+    <p:sldId xmlns:r="http://schemas.openxmlformats.org/officeDocument/2006/relationships" id="260" r:id="R3da5d776c4ef48bc"/>
+    <p:sldId xmlns:r="http://schemas.openxmlformats.org/officeDocument/2006/relationships" id="261" r:id="R3e7d76c7c6af4a2e"/>
+    <p:sldId xmlns:r="http://schemas.openxmlformats.org/officeDocument/2006/relationships" id="262" r:id="Ra64baa93a00c44f9"/>
+    <p:sldId xmlns:r="http://schemas.openxmlformats.org/officeDocument/2006/relationships" id="263" r:id="R35544a58d25b4c86"/>
+    <p:sldId xmlns:r="http://schemas.openxmlformats.org/officeDocument/2006/relationships" id="264" r:id="R37788af337ca4a21"/>
+    <p:sldId xmlns:r="http://schemas.openxmlformats.org/officeDocument/2006/relationships" id="265" r:id="Rff7ad3688b324bec"/>
+    <p:sldId xmlns:r="http://schemas.openxmlformats.org/officeDocument/2006/relationships" id="266" r:id="R61c09d3c93c645c4"/>
+    <p:sldId xmlns:r="http://schemas.openxmlformats.org/officeDocument/2006/relationships" id="267" r:id="R18d4f5a63d0b4e58"/>
+    <p:sldId xmlns:r="http://schemas.openxmlformats.org/officeDocument/2006/relationships" id="268" r:id="R4d5550782e294668"/>
+    <p:sldId xmlns:r="http://schemas.openxmlformats.org/officeDocument/2006/relationships" id="269" r:id="R7ca8f20f2bd84c87"/>
+    <p:sldId xmlns:r="http://schemas.openxmlformats.org/officeDocument/2006/relationships" id="270" r:id="Rf0a634f3fd854b76"/>
   </p:sldIdLst>
   <p:sldSz cx="12192000" cy="6858000"/>
   <p:notesSz cx="6858000" cy="9144000"/>
@@ -456,7 +456,7 @@
           <a:lstStyle xmlns:a="http://schemas.openxmlformats.org/drawingml/2006/main"/>
           <a:p xmlns:a="http://schemas.openxmlformats.org/drawingml/2006/main">
             <a:r>
-              <a:t>Fonte principal: Projeto Aplicado Localiza, enunciado acadêmico fornecido ao projeto, 2026.</a:t>
+              <a:t>Fonte: Guia.pdf e plano local. Enunciado específico Localiza não localizado no checkout. Projeto conceitual, sem acesso aos sistemas da organização.</a:t>
             </a:r>
           </a:p>
         </p:txBody>
@@ -806,7 +806,7 @@
           <a:lstStyle xmlns:a="http://schemas.openxmlformats.org/drawingml/2006/main"/>
           <a:p xmlns:a="http://schemas.openxmlformats.org/drawingml/2006/main">
             <a:r>
-              <a:t>Fonte: docs/EVIDENCIAS_VALIDACAO.md. Medição local em 13 de setembro de 2026 com 200 consultas de prontidão.</a:t>
+              <a:t>Fonte: docs/EVIDENCIAS_VALIDACAO.md, 30/09/2026. p95 de /health/ready em 200 consultas SQLite, sem concorrência. Axe em sete telas com dados sintéticos não comprova WCAG completa.</a:t>
             </a:r>
           </a:p>
         </p:txBody>
@@ -1504,7 +1504,7 @@
   </p:cSld>
   <p:clrMap bg1="lt1" tx1="dk1" bg2="lt2" tx2="dk2" accent1="accent1" accent2="accent2" accent3="accent3" accent4="accent4" accent5="accent5" accent6="accent6" hlink="hlink" folHlink="folHlink"/>
   <p:sldLayoutIdLst>
-    <p:sldLayoutId xmlns:r="http://schemas.openxmlformats.org/officeDocument/2006/relationships" id="2147483649" r:id="Rd4b7f50e9a3149df"/>
+    <p:sldLayoutId xmlns:r="http://schemas.openxmlformats.org/officeDocument/2006/relationships" id="2147483649" r:id="Rbe77084cc0ef46ad"/>
   </p:sldLayoutIdLst>
   <p:txStyles>
     <p:titleStyle>
@@ -2055,7 +2055,7 @@
           <p:cNvPr id="5" name="">
             <a:extLst xmlns:a="http://schemas.openxmlformats.org/drawingml/2006/main">
               <a:ext uri="{FF2B5EF4-FFF2-40B4-BE49-F238E27FC236}">
-                <a16:creationId xmlns:a16="http://schemas.microsoft.com/office/drawing/2014/main" id="{ECF8D89D-8D78-4C66-9B7E-5F1FFC0FCC8F}"/>
+                <a16:creationId xmlns:a16="http://schemas.microsoft.com/office/drawing/2014/main" id="{89FBA803-F5F2-4A9D-BCFD-79D70885FCEB}"/>
               </a:ext>
             </a:extLst>
           </p:cNvPr>
@@ -2125,7 +2125,7 @@
                 <a:ea typeface="Arial"/>
                 <a:cs typeface="Arial"/>
               </a:rPr>
-              <a:t>para Empresa de Serviços</a:t>
+              <a:t>no Cenário Localiza</a:t>
             </a:r>
           </a:p>
         </p:txBody>
@@ -2135,7 +2135,7 @@
           <p:cNvPr id="2" name="">
             <a:extLst xmlns:a="http://schemas.openxmlformats.org/drawingml/2006/main">
               <a:ext uri="{FF2B5EF4-FFF2-40B4-BE49-F238E27FC236}">
-                <a16:creationId xmlns:a16="http://schemas.microsoft.com/office/drawing/2014/main" id="{12C04581-8C78-417C-9A3F-404E7D1DC5F5}"/>
+                <a16:creationId xmlns:a16="http://schemas.microsoft.com/office/drawing/2014/main" id="{EF3B52BF-1A8E-40C8-B2F4-DD0460165422}"/>
               </a:ext>
             </a:extLst>
           </p:cNvPr>
@@ -2192,7 +2192,7 @@
           <p:cNvPr id="3" name="">
             <a:extLst xmlns:a="http://schemas.openxmlformats.org/drawingml/2006/main">
               <a:ext uri="{FF2B5EF4-FFF2-40B4-BE49-F238E27FC236}">
-                <a16:creationId xmlns:a16="http://schemas.microsoft.com/office/drawing/2014/main" id="{BD9C7C82-0B56-4F1C-893E-7A8988EB6EF9}"/>
+                <a16:creationId xmlns:a16="http://schemas.microsoft.com/office/drawing/2014/main" id="{78217D8B-289C-4398-8F47-EC803C6903B1}"/>
               </a:ext>
             </a:extLst>
           </p:cNvPr>
@@ -2222,7 +2222,7 @@
           <p:cNvPr id="4" name="">
             <a:extLst xmlns:a="http://schemas.openxmlformats.org/drawingml/2006/main">
               <a:ext uri="{FF2B5EF4-FFF2-40B4-BE49-F238E27FC236}">
-                <a16:creationId xmlns:a16="http://schemas.microsoft.com/office/drawing/2014/main" id="{F3BE0682-F7A2-4A27-9F8C-6830C270A1D9}"/>
+                <a16:creationId xmlns:a16="http://schemas.microsoft.com/office/drawing/2014/main" id="{21F822B5-4251-4566-9FE1-197AA586E1F5}"/>
               </a:ext>
             </a:extLst>
           </p:cNvPr>
@@ -2292,7 +2292,7 @@
                 <a:ea typeface="Arial"/>
                 <a:cs typeface="Arial"/>
               </a:rPr>
-              <a:t>27 de setembro de 2026 · em revisão</a:t>
+              <a:t>30 de setembro de 2026 · em revisão</a:t>
             </a:r>
           </a:p>
         </p:txBody>
@@ -2300,7 +2300,7 @@
     </p:spTree>
     <p:extLst>
       <p:ext uri="{BB962C8B-B14F-4D97-AF65-F5344CB8AC3E}">
-        <p14:creationId xmlns:p14="http://schemas.microsoft.com/office/powerpoint/2010/main" val="307143516"/>
+        <p14:creationId xmlns:p14="http://schemas.microsoft.com/office/powerpoint/2010/main" val="1061768267"/>
       </p:ext>
     </p:extLst>
   </p:cSld>
@@ -2331,7 +2331,7 @@
           <p:cNvPr id="12" name="">
             <a:extLst xmlns:a="http://schemas.openxmlformats.org/drawingml/2006/main">
               <a:ext uri="{FF2B5EF4-FFF2-40B4-BE49-F238E27FC236}">
-                <a16:creationId xmlns:a16="http://schemas.microsoft.com/office/drawing/2014/main" id="{B714914E-2E05-41D8-A393-52D7AD167099}"/>
+                <a16:creationId xmlns:a16="http://schemas.microsoft.com/office/drawing/2014/main" id="{EF525EC1-6BC4-4EEF-9C4F-3804A5D70355}"/>
               </a:ext>
             </a:extLst>
           </p:cNvPr>
@@ -2361,7 +2361,7 @@
           <p:cNvPr id="2" name="">
             <a:extLst xmlns:a="http://schemas.openxmlformats.org/drawingml/2006/main">
               <a:ext uri="{FF2B5EF4-FFF2-40B4-BE49-F238E27FC236}">
-                <a16:creationId xmlns:a16="http://schemas.microsoft.com/office/drawing/2014/main" id="{0A8B9308-2BD2-4AF0-A8D9-165C917A8C5F}"/>
+                <a16:creationId xmlns:a16="http://schemas.microsoft.com/office/drawing/2014/main" id="{E3F380C8-5988-41FC-9CD3-E6FCAFC19147}"/>
               </a:ext>
             </a:extLst>
           </p:cNvPr>
@@ -2418,7 +2418,7 @@
           <p:cNvPr id="3" name="">
             <a:extLst xmlns:a="http://schemas.openxmlformats.org/drawingml/2006/main">
               <a:ext uri="{FF2B5EF4-FFF2-40B4-BE49-F238E27FC236}">
-                <a16:creationId xmlns:a16="http://schemas.microsoft.com/office/drawing/2014/main" id="{5C2E6229-26E2-44C6-B36F-1C018C078F33}"/>
+                <a16:creationId xmlns:a16="http://schemas.microsoft.com/office/drawing/2014/main" id="{4C664614-BB05-4AEB-8BA0-55DDD132020C}"/>
               </a:ext>
             </a:extLst>
           </p:cNvPr>
@@ -2475,7 +2475,7 @@
           <p:cNvPr id="4" name="">
             <a:extLst xmlns:a="http://schemas.openxmlformats.org/drawingml/2006/main">
               <a:ext uri="{FF2B5EF4-FFF2-40B4-BE49-F238E27FC236}">
-                <a16:creationId xmlns:a16="http://schemas.microsoft.com/office/drawing/2014/main" id="{F932F274-2119-4FAF-AA18-587E57F03C27}"/>
+                <a16:creationId xmlns:a16="http://schemas.microsoft.com/office/drawing/2014/main" id="{060CE0AF-B6D6-4B8C-B700-01755325C22E}"/>
               </a:ext>
             </a:extLst>
           </p:cNvPr>
@@ -2562,7 +2562,7 @@
           <p:cNvPr id="5" name="">
             <a:extLst xmlns:a="http://schemas.openxmlformats.org/drawingml/2006/main">
               <a:ext uri="{FF2B5EF4-FFF2-40B4-BE49-F238E27FC236}">
-                <a16:creationId xmlns:a16="http://schemas.microsoft.com/office/drawing/2014/main" id="{5F6E1D45-366A-46BA-89EA-74717B39AE46}"/>
+                <a16:creationId xmlns:a16="http://schemas.microsoft.com/office/drawing/2014/main" id="{23853F95-C561-4D37-A346-A3C7F7A3A024}"/>
               </a:ext>
             </a:extLst>
           </p:cNvPr>
@@ -2649,7 +2649,7 @@
           <p:cNvPr id="6" name="">
             <a:extLst xmlns:a="http://schemas.openxmlformats.org/drawingml/2006/main">
               <a:ext uri="{FF2B5EF4-FFF2-40B4-BE49-F238E27FC236}">
-                <a16:creationId xmlns:a16="http://schemas.microsoft.com/office/drawing/2014/main" id="{FF093D4D-0DA4-4BF5-8132-482AA6580AA4}"/>
+                <a16:creationId xmlns:a16="http://schemas.microsoft.com/office/drawing/2014/main" id="{AF878A60-C084-4E60-97FE-362166F33A7E}"/>
               </a:ext>
             </a:extLst>
           </p:cNvPr>
@@ -2736,7 +2736,7 @@
           <p:cNvPr id="7" name="">
             <a:extLst xmlns:a="http://schemas.openxmlformats.org/drawingml/2006/main">
               <a:ext uri="{FF2B5EF4-FFF2-40B4-BE49-F238E27FC236}">
-                <a16:creationId xmlns:a16="http://schemas.microsoft.com/office/drawing/2014/main" id="{9708A891-312B-4D37-8BDA-926CF5D08069}"/>
+                <a16:creationId xmlns:a16="http://schemas.microsoft.com/office/drawing/2014/main" id="{CB9DFEF4-93B7-49EF-A09D-68CE8780F4B0}"/>
               </a:ext>
             </a:extLst>
           </p:cNvPr>
@@ -2903,7 +2903,7 @@
           <p:cNvPr id="11" name="">
             <a:extLst xmlns:a="http://schemas.openxmlformats.org/drawingml/2006/main">
               <a:ext uri="{FF2B5EF4-FFF2-40B4-BE49-F238E27FC236}">
-                <a16:creationId xmlns:a16="http://schemas.microsoft.com/office/drawing/2014/main" id="{D61CF9C1-DD21-4504-914A-E38093B0AB13}"/>
+                <a16:creationId xmlns:a16="http://schemas.microsoft.com/office/drawing/2014/main" id="{5EDC53D8-11D2-4497-8492-89CCDCC8B200}"/>
               </a:ext>
             </a:extLst>
           </p:cNvPr>
@@ -2958,7 +2958,7 @@
     </p:spTree>
     <p:extLst>
       <p:ext uri="{BB962C8B-B14F-4D97-AF65-F5344CB8AC3E}">
-        <p14:creationId xmlns:p14="http://schemas.microsoft.com/office/powerpoint/2010/main" val="1608770694"/>
+        <p14:creationId xmlns:p14="http://schemas.microsoft.com/office/powerpoint/2010/main" val="729499131"/>
       </p:ext>
     </p:extLst>
   </p:cSld>
@@ -2989,7 +2989,7 @@
           <p:cNvPr id="7" name="">
             <a:extLst xmlns:a="http://schemas.openxmlformats.org/drawingml/2006/main">
               <a:ext uri="{FF2B5EF4-FFF2-40B4-BE49-F238E27FC236}">
-                <a16:creationId xmlns:a16="http://schemas.microsoft.com/office/drawing/2014/main" id="{472E9C05-849B-4A94-A11F-D8A7D8E48983}"/>
+                <a16:creationId xmlns:a16="http://schemas.microsoft.com/office/drawing/2014/main" id="{C52ED6C4-DFEF-4BCB-B385-8CADDBAB82E3}"/>
               </a:ext>
             </a:extLst>
           </p:cNvPr>
@@ -3019,7 +3019,7 @@
           <p:cNvPr id="2" name="">
             <a:extLst xmlns:a="http://schemas.openxmlformats.org/drawingml/2006/main">
               <a:ext uri="{FF2B5EF4-FFF2-40B4-BE49-F238E27FC236}">
-                <a16:creationId xmlns:a16="http://schemas.microsoft.com/office/drawing/2014/main" id="{DBA0FC4B-E4E5-4F44-9A1D-FD7D215784E5}"/>
+                <a16:creationId xmlns:a16="http://schemas.microsoft.com/office/drawing/2014/main" id="{C6F3E3CE-F549-41A9-9351-ED53354BF763}"/>
               </a:ext>
             </a:extLst>
           </p:cNvPr>
@@ -3066,7 +3066,7 @@
                 <a:ea typeface="Arial"/>
                 <a:cs typeface="Arial"/>
               </a:rPr>
-              <a:t>Interoperabilidade e reservas e contratos</a:t>
+              <a:t>Interoperabilidade e contratos técnicos</a:t>
             </a:r>
           </a:p>
         </p:txBody>
@@ -3076,7 +3076,7 @@
           <p:cNvPr id="3" name="">
             <a:extLst xmlns:a="http://schemas.openxmlformats.org/drawingml/2006/main">
               <a:ext uri="{FF2B5EF4-FFF2-40B4-BE49-F238E27FC236}">
-                <a16:creationId xmlns:a16="http://schemas.microsoft.com/office/drawing/2014/main" id="{507AF1EB-2CB8-4520-89F1-35D413A5AAC3}"/>
+                <a16:creationId xmlns:a16="http://schemas.microsoft.com/office/drawing/2014/main" id="{5240111E-57E1-4667-9456-CBB4C6795481}"/>
               </a:ext>
             </a:extLst>
           </p:cNvPr>
@@ -3133,7 +3133,7 @@
           <p:cNvPr id="4" name="">
             <a:extLst xmlns:a="http://schemas.openxmlformats.org/drawingml/2006/main">
               <a:ext uri="{FF2B5EF4-FFF2-40B4-BE49-F238E27FC236}">
-                <a16:creationId xmlns:a16="http://schemas.microsoft.com/office/drawing/2014/main" id="{137F3AB1-9ACF-45F0-AF52-8B9DBCCA1BFA}"/>
+                <a16:creationId xmlns:a16="http://schemas.microsoft.com/office/drawing/2014/main" id="{783CEA3C-5F5A-45F7-9F8A-B9BF86984685}"/>
               </a:ext>
             </a:extLst>
           </p:cNvPr>
@@ -3302,7 +3302,7 @@
           <p:cNvPr id="5" name="">
             <a:extLst xmlns:a="http://schemas.openxmlformats.org/drawingml/2006/main">
               <a:ext uri="{FF2B5EF4-FFF2-40B4-BE49-F238E27FC236}">
-                <a16:creationId xmlns:a16="http://schemas.microsoft.com/office/drawing/2014/main" id="{B9D71854-40E6-46FF-BB7D-467111BC3997}"/>
+                <a16:creationId xmlns:a16="http://schemas.microsoft.com/office/drawing/2014/main" id="{3AD1ACE2-3EEB-407C-A480-9E2A199D476B}"/>
               </a:ext>
             </a:extLst>
           </p:cNvPr>
@@ -3527,7 +3527,7 @@
           <p:cNvPr id="6" name="">
             <a:extLst xmlns:a="http://schemas.openxmlformats.org/drawingml/2006/main">
               <a:ext uri="{FF2B5EF4-FFF2-40B4-BE49-F238E27FC236}">
-                <a16:creationId xmlns:a16="http://schemas.microsoft.com/office/drawing/2014/main" id="{7BDAD26A-4EA9-4CC2-AA06-7FB68994DAFD}"/>
+                <a16:creationId xmlns:a16="http://schemas.microsoft.com/office/drawing/2014/main" id="{81A8685F-759F-47C6-9E68-86269CE7837A}"/>
               </a:ext>
             </a:extLst>
           </p:cNvPr>
@@ -3582,7 +3582,7 @@
     </p:spTree>
     <p:extLst>
       <p:ext uri="{BB962C8B-B14F-4D97-AF65-F5344CB8AC3E}">
-        <p14:creationId xmlns:p14="http://schemas.microsoft.com/office/powerpoint/2010/main" val="842548739"/>
+        <p14:creationId xmlns:p14="http://schemas.microsoft.com/office/powerpoint/2010/main" val="720046207"/>
       </p:ext>
     </p:extLst>
   </p:cSld>
@@ -3613,7 +3613,7 @@
           <p:cNvPr id="11" name="">
             <a:extLst xmlns:a="http://schemas.openxmlformats.org/drawingml/2006/main">
               <a:ext uri="{FF2B5EF4-FFF2-40B4-BE49-F238E27FC236}">
-                <a16:creationId xmlns:a16="http://schemas.microsoft.com/office/drawing/2014/main" id="{72E64FDC-5BA0-434F-90BB-446CC292F834}"/>
+                <a16:creationId xmlns:a16="http://schemas.microsoft.com/office/drawing/2014/main" id="{99B2B1F5-87AE-452D-9383-DBA317EA1142}"/>
               </a:ext>
             </a:extLst>
           </p:cNvPr>
@@ -3643,7 +3643,7 @@
           <p:cNvPr id="2" name="">
             <a:extLst xmlns:a="http://schemas.openxmlformats.org/drawingml/2006/main">
               <a:ext uri="{FF2B5EF4-FFF2-40B4-BE49-F238E27FC236}">
-                <a16:creationId xmlns:a16="http://schemas.microsoft.com/office/drawing/2014/main" id="{B2D0E5FC-47F3-460B-B57B-CDABC95C44DA}"/>
+                <a16:creationId xmlns:a16="http://schemas.microsoft.com/office/drawing/2014/main" id="{4D14374D-3250-4C6D-87DA-FB967F7539A1}"/>
               </a:ext>
             </a:extLst>
           </p:cNvPr>
@@ -3700,7 +3700,7 @@
           <p:cNvPr id="3" name="">
             <a:extLst xmlns:a="http://schemas.openxmlformats.org/drawingml/2006/main">
               <a:ext uri="{FF2B5EF4-FFF2-40B4-BE49-F238E27FC236}">
-                <a16:creationId xmlns:a16="http://schemas.microsoft.com/office/drawing/2014/main" id="{1FB67539-D1E2-4D59-9EC6-CC575CFA4881}"/>
+                <a16:creationId xmlns:a16="http://schemas.microsoft.com/office/drawing/2014/main" id="{5013116D-F645-486E-82BF-72E626BFEEC3}"/>
               </a:ext>
             </a:extLst>
           </p:cNvPr>
@@ -3757,7 +3757,7 @@
           <p:cNvPr id="4" name="">
             <a:extLst xmlns:a="http://schemas.openxmlformats.org/drawingml/2006/main">
               <a:ext uri="{FF2B5EF4-FFF2-40B4-BE49-F238E27FC236}">
-                <a16:creationId xmlns:a16="http://schemas.microsoft.com/office/drawing/2014/main" id="{D69D29F6-5F5A-4B59-BAFF-16441422EBEE}"/>
+                <a16:creationId xmlns:a16="http://schemas.microsoft.com/office/drawing/2014/main" id="{F2E39900-C4C2-47E4-9F83-14A812A92EBD}"/>
               </a:ext>
             </a:extLst>
           </p:cNvPr>
@@ -3814,7 +3814,7 @@
           <p:cNvPr id="5" name="">
             <a:extLst xmlns:a="http://schemas.openxmlformats.org/drawingml/2006/main">
               <a:ext uri="{FF2B5EF4-FFF2-40B4-BE49-F238E27FC236}">
-                <a16:creationId xmlns:a16="http://schemas.microsoft.com/office/drawing/2014/main" id="{CABDA462-3F88-4CD7-AD6B-7DC820F5DCC1}"/>
+                <a16:creationId xmlns:a16="http://schemas.microsoft.com/office/drawing/2014/main" id="{D8ACF01C-D242-4703-A494-27BC1D61A5E7}"/>
               </a:ext>
             </a:extLst>
           </p:cNvPr>
@@ -3919,7 +3919,7 @@
                 <a:ea typeface="Arial"/>
                 <a:cs typeface="Arial"/>
               </a:rPr>
-              <a:t>Fila de falha e reprocessamento</a:t>
+              <a:t>Rollback local e reprocessamento auditado</a:t>
             </a:r>
           </a:p>
         </p:txBody>
@@ -3929,7 +3929,7 @@
           <p:cNvPr id="6" name="">
             <a:extLst xmlns:a="http://schemas.openxmlformats.org/drawingml/2006/main">
               <a:ext uri="{FF2B5EF4-FFF2-40B4-BE49-F238E27FC236}">
-                <a16:creationId xmlns:a16="http://schemas.microsoft.com/office/drawing/2014/main" id="{C2182C35-5D1F-46F9-95B6-F5F13777E2A9}"/>
+                <a16:creationId xmlns:a16="http://schemas.microsoft.com/office/drawing/2014/main" id="{AB9407B7-6FC4-4C49-A28A-8D28CCD7D61D}"/>
               </a:ext>
             </a:extLst>
           </p:cNvPr>
@@ -3986,7 +3986,7 @@
           <p:cNvPr id="7" name="">
             <a:extLst xmlns:a="http://schemas.openxmlformats.org/drawingml/2006/main">
               <a:ext uri="{FF2B5EF4-FFF2-40B4-BE49-F238E27FC236}">
-                <a16:creationId xmlns:a16="http://schemas.microsoft.com/office/drawing/2014/main" id="{B31037BF-4E53-4A3D-9CE3-DCE2D6F45820}"/>
+                <a16:creationId xmlns:a16="http://schemas.microsoft.com/office/drawing/2014/main" id="{EF14D69A-D904-41C3-9F5E-C49ED9DE9428}"/>
               </a:ext>
             </a:extLst>
           </p:cNvPr>
@@ -4091,7 +4091,7 @@
                 <a:ea typeface="Arial"/>
                 <a:cs typeface="Arial"/>
               </a:rPr>
-              <a:t>Dados mínimos em logs e eventos</a:t>
+              <a:t>Exceções sem texto livre em logs e fila</a:t>
             </a:r>
           </a:p>
         </p:txBody>
@@ -4101,7 +4101,7 @@
           <p:cNvPr id="8" name="">
             <a:extLst xmlns:a="http://schemas.openxmlformats.org/drawingml/2006/main">
               <a:ext uri="{FF2B5EF4-FFF2-40B4-BE49-F238E27FC236}">
-                <a16:creationId xmlns:a16="http://schemas.microsoft.com/office/drawing/2014/main" id="{1755BD98-A25B-4B2C-ADAA-81291DAF7920}"/>
+                <a16:creationId xmlns:a16="http://schemas.microsoft.com/office/drawing/2014/main" id="{FC0A64D3-4DD4-4439-989B-6B7DA2B2BE95}"/>
               </a:ext>
             </a:extLst>
           </p:cNvPr>
@@ -4158,7 +4158,7 @@
           <p:cNvPr id="9" name="">
             <a:extLst xmlns:a="http://schemas.openxmlformats.org/drawingml/2006/main">
               <a:ext uri="{FF2B5EF4-FFF2-40B4-BE49-F238E27FC236}">
-                <a16:creationId xmlns:a16="http://schemas.microsoft.com/office/drawing/2014/main" id="{51A2780A-39CF-4E59-963A-94636BDA4A7B}"/>
+                <a16:creationId xmlns:a16="http://schemas.microsoft.com/office/drawing/2014/main" id="{FC728AC8-13AF-4CF7-B698-6DD3D18BA9C9}"/>
               </a:ext>
             </a:extLst>
           </p:cNvPr>
@@ -4273,7 +4273,7 @@
           <p:cNvPr id="10" name="">
             <a:extLst xmlns:a="http://schemas.openxmlformats.org/drawingml/2006/main">
               <a:ext uri="{FF2B5EF4-FFF2-40B4-BE49-F238E27FC236}">
-                <a16:creationId xmlns:a16="http://schemas.microsoft.com/office/drawing/2014/main" id="{A8E04844-2031-4E0B-B7A4-5C892758995A}"/>
+                <a16:creationId xmlns:a16="http://schemas.microsoft.com/office/drawing/2014/main" id="{B41BACF3-598C-42F8-9BA4-FA980607DEB0}"/>
               </a:ext>
             </a:extLst>
           </p:cNvPr>
@@ -4328,7 +4328,7 @@
     </p:spTree>
     <p:extLst>
       <p:ext uri="{BB962C8B-B14F-4D97-AF65-F5344CB8AC3E}">
-        <p14:creationId xmlns:p14="http://schemas.microsoft.com/office/powerpoint/2010/main" val="1544054370"/>
+        <p14:creationId xmlns:p14="http://schemas.microsoft.com/office/powerpoint/2010/main" val="501338936"/>
       </p:ext>
     </p:extLst>
   </p:cSld>
@@ -4359,7 +4359,7 @@
           <p:cNvPr id="7" name="">
             <a:extLst xmlns:a="http://schemas.openxmlformats.org/drawingml/2006/main">
               <a:ext uri="{FF2B5EF4-FFF2-40B4-BE49-F238E27FC236}">
-                <a16:creationId xmlns:a16="http://schemas.microsoft.com/office/drawing/2014/main" id="{F129BE8D-78DD-4B0B-ACA1-94529DC9B925}"/>
+                <a16:creationId xmlns:a16="http://schemas.microsoft.com/office/drawing/2014/main" id="{7DE3C02A-4940-4647-9482-73B93B994F88}"/>
               </a:ext>
             </a:extLst>
           </p:cNvPr>
@@ -4389,7 +4389,7 @@
           <p:cNvPr id="2" name="">
             <a:extLst xmlns:a="http://schemas.openxmlformats.org/drawingml/2006/main">
               <a:ext uri="{FF2B5EF4-FFF2-40B4-BE49-F238E27FC236}">
-                <a16:creationId xmlns:a16="http://schemas.microsoft.com/office/drawing/2014/main" id="{1260FAFC-4623-4EBE-AB42-9C0E253B83FF}"/>
+                <a16:creationId xmlns:a16="http://schemas.microsoft.com/office/drawing/2014/main" id="{65A3825B-6F13-4003-B540-0030FEC3A6EA}"/>
               </a:ext>
             </a:extLst>
           </p:cNvPr>
@@ -4446,7 +4446,7 @@
           <p:cNvPr id="3" name="">
             <a:extLst xmlns:a="http://schemas.openxmlformats.org/drawingml/2006/main">
               <a:ext uri="{FF2B5EF4-FFF2-40B4-BE49-F238E27FC236}">
-                <a16:creationId xmlns:a16="http://schemas.microsoft.com/office/drawing/2014/main" id="{35213F5A-0C39-490A-9A2F-38758962C0B0}"/>
+                <a16:creationId xmlns:a16="http://schemas.microsoft.com/office/drawing/2014/main" id="{7C82F0EF-277E-4158-A10D-5835082F9E3D}"/>
               </a:ext>
             </a:extLst>
           </p:cNvPr>
@@ -4503,7 +4503,7 @@
           <p:cNvPr id="4" name="">
             <a:extLst xmlns:a="http://schemas.openxmlformats.org/drawingml/2006/main">
               <a:ext uri="{FF2B5EF4-FFF2-40B4-BE49-F238E27FC236}">
-                <a16:creationId xmlns:a16="http://schemas.microsoft.com/office/drawing/2014/main" id="{DBC10599-94D6-462A-8E9D-949C69509144}"/>
+                <a16:creationId xmlns:a16="http://schemas.microsoft.com/office/drawing/2014/main" id="{C6C0AC93-A2C3-4688-B9B7-E01EBEC49E7F}"/>
               </a:ext>
             </a:extLst>
           </p:cNvPr>
@@ -4608,7 +4608,7 @@
                 <a:ea typeface="Arial"/>
                 <a:cs typeface="Arial"/>
               </a:rPr>
-              <a:t>API sem estado e consumidores por fila permitem escala</a:t>
+              <a:t>Escala por réplicas/fila é uma evolução futura</a:t>
             </a:r>
           </a:p>
           <a:p xmlns:a="http://schemas.openxmlformats.org/drawingml/2006/main">
@@ -4672,7 +4672,7 @@
           <p:cNvPr id="5" name="">
             <a:extLst xmlns:a="http://schemas.openxmlformats.org/drawingml/2006/main">
               <a:ext uri="{FF2B5EF4-FFF2-40B4-BE49-F238E27FC236}">
-                <a16:creationId xmlns:a16="http://schemas.microsoft.com/office/drawing/2014/main" id="{3258FF70-9D28-410F-9B6A-CE6BC028392C}"/>
+                <a16:creationId xmlns:a16="http://schemas.microsoft.com/office/drawing/2014/main" id="{927E9992-6F4C-44E6-9ACF-9A6DD1AE0FBF}"/>
               </a:ext>
             </a:extLst>
           </p:cNvPr>
@@ -4729,7 +4729,7 @@
           <p:cNvPr id="6" name="">
             <a:extLst xmlns:a="http://schemas.openxmlformats.org/drawingml/2006/main">
               <a:ext uri="{FF2B5EF4-FFF2-40B4-BE49-F238E27FC236}">
-                <a16:creationId xmlns:a16="http://schemas.microsoft.com/office/drawing/2014/main" id="{AACFD907-FC7D-41DB-B993-BD5097246073}"/>
+                <a16:creationId xmlns:a16="http://schemas.microsoft.com/office/drawing/2014/main" id="{BEFC6174-5930-48E4-87DB-BFDA9212313F}"/>
               </a:ext>
             </a:extLst>
           </p:cNvPr>
@@ -4896,7 +4896,7 @@
     </p:spTree>
     <p:extLst>
       <p:ext uri="{BB962C8B-B14F-4D97-AF65-F5344CB8AC3E}">
-        <p14:creationId xmlns:p14="http://schemas.microsoft.com/office/powerpoint/2010/main" val="2116175135"/>
+        <p14:creationId xmlns:p14="http://schemas.microsoft.com/office/powerpoint/2010/main" val="1198218464"/>
       </p:ext>
     </p:extLst>
   </p:cSld>
@@ -4927,7 +4927,7 @@
           <p:cNvPr id="8" name="">
             <a:extLst xmlns:a="http://schemas.openxmlformats.org/drawingml/2006/main">
               <a:ext uri="{FF2B5EF4-FFF2-40B4-BE49-F238E27FC236}">
-                <a16:creationId xmlns:a16="http://schemas.microsoft.com/office/drawing/2014/main" id="{E10DDF92-BBB3-46F6-9BEB-2B6C39BE03E9}"/>
+                <a16:creationId xmlns:a16="http://schemas.microsoft.com/office/drawing/2014/main" id="{47C7913E-CEC3-442F-8DAB-C3C5D3CEA029}"/>
               </a:ext>
             </a:extLst>
           </p:cNvPr>
@@ -4957,7 +4957,7 @@
           <p:cNvPr id="2" name="">
             <a:extLst xmlns:a="http://schemas.openxmlformats.org/drawingml/2006/main">
               <a:ext uri="{FF2B5EF4-FFF2-40B4-BE49-F238E27FC236}">
-                <a16:creationId xmlns:a16="http://schemas.microsoft.com/office/drawing/2014/main" id="{CB60ECA1-641C-4D1D-90A6-9F6C2F467CDF}"/>
+                <a16:creationId xmlns:a16="http://schemas.microsoft.com/office/drawing/2014/main" id="{7E733654-0399-4F72-B55B-D005A7A56803}"/>
               </a:ext>
             </a:extLst>
           </p:cNvPr>
@@ -5014,7 +5014,7 @@
           <p:cNvPr id="3" name="">
             <a:extLst xmlns:a="http://schemas.openxmlformats.org/drawingml/2006/main">
               <a:ext uri="{FF2B5EF4-FFF2-40B4-BE49-F238E27FC236}">
-                <a16:creationId xmlns:a16="http://schemas.microsoft.com/office/drawing/2014/main" id="{82DD81FE-E835-4D40-9970-1EDF71E77CAB}"/>
+                <a16:creationId xmlns:a16="http://schemas.microsoft.com/office/drawing/2014/main" id="{33B8A00C-48DA-43EB-8BD8-1B8D40B39C59}"/>
               </a:ext>
             </a:extLst>
           </p:cNvPr>
@@ -5071,7 +5071,7 @@
           <p:cNvPr id="4" name="">
             <a:extLst xmlns:a="http://schemas.openxmlformats.org/drawingml/2006/main">
               <a:ext uri="{FF2B5EF4-FFF2-40B4-BE49-F238E27FC236}">
-                <a16:creationId xmlns:a16="http://schemas.microsoft.com/office/drawing/2014/main" id="{C50855FC-A732-4472-8FA9-71096AF523C3}"/>
+                <a16:creationId xmlns:a16="http://schemas.microsoft.com/office/drawing/2014/main" id="{7E4F3CD0-CA0D-41B9-A379-6A3E6324B53B}"/>
               </a:ext>
             </a:extLst>
           </p:cNvPr>
@@ -5118,7 +5118,7 @@
                 <a:ea typeface="Arial"/>
                 <a:cs typeface="Arial"/>
               </a:rPr>
-              <a:t>Suíte ampliada</a:t>
+              <a:t>84 testes Python</a:t>
             </a:r>
           </a:p>
         </p:txBody>
@@ -5128,7 +5128,7 @@
           <p:cNvPr id="5" name="">
             <a:extLst xmlns:a="http://schemas.openxmlformats.org/drawingml/2006/main">
               <a:ext uri="{FF2B5EF4-FFF2-40B4-BE49-F238E27FC236}">
-                <a16:creationId xmlns:a16="http://schemas.microsoft.com/office/drawing/2014/main" id="{D3CF62FB-884E-4931-8C53-19E230BCD834}"/>
+                <a16:creationId xmlns:a16="http://schemas.microsoft.com/office/drawing/2014/main" id="{F936E3E8-873D-4B3C-AE49-41B8E152AA63}"/>
               </a:ext>
             </a:extLst>
           </p:cNvPr>
@@ -5175,7 +5175,7 @@
                 <a:ea typeface="Arial"/>
                 <a:cs typeface="Arial"/>
               </a:rPr>
-              <a:t>p95  6,36 ms</a:t>
+              <a:t>p95  3,68 ms</a:t>
             </a:r>
           </a:p>
         </p:txBody>
@@ -5185,7 +5185,7 @@
           <p:cNvPr id="6" name="">
             <a:extLst xmlns:a="http://schemas.openxmlformats.org/drawingml/2006/main">
               <a:ext uri="{FF2B5EF4-FFF2-40B4-BE49-F238E27FC236}">
-                <a16:creationId xmlns:a16="http://schemas.microsoft.com/office/drawing/2014/main" id="{97144759-BE11-4160-99BE-756A014DF7B2}"/>
+                <a16:creationId xmlns:a16="http://schemas.microsoft.com/office/drawing/2014/main" id="{0396E188-02A6-4A9F-8A86-431C0643AE89}"/>
               </a:ext>
             </a:extLst>
           </p:cNvPr>
@@ -5317,7 +5317,7 @@
                 <a:ea typeface="Arial"/>
                 <a:cs typeface="Arial"/>
               </a:rPr>
-              <a:t>Falha controlada preserva e reconcilia o chamado</a:t>
+              <a:t>11 testes de navegador, incluindo axe e teclado</a:t>
             </a:r>
           </a:p>
           <a:p xmlns:a="http://schemas.openxmlformats.org/drawingml/2006/main">
@@ -5344,7 +5344,7 @@
                 <a:ea typeface="Arial"/>
                 <a:cs typeface="Arial"/>
               </a:rPr>
-              <a:t>Rastreabilidade reúne auditoria e eventos</a:t>
+              <a:t>Falha SQL desfeita e pagamentos auditados</a:t>
             </a:r>
           </a:p>
         </p:txBody>
@@ -5354,7 +5354,7 @@
           <p:cNvPr id="7" name="">
             <a:extLst xmlns:a="http://schemas.openxmlformats.org/drawingml/2006/main">
               <a:ext uri="{FF2B5EF4-FFF2-40B4-BE49-F238E27FC236}">
-                <a16:creationId xmlns:a16="http://schemas.microsoft.com/office/drawing/2014/main" id="{9532E3C5-3FD4-4C7C-8EF4-DE9F90D35EF3}"/>
+                <a16:creationId xmlns:a16="http://schemas.microsoft.com/office/drawing/2014/main" id="{2C34A320-FE26-4B7D-B60C-FAFBC6F536C8}"/>
               </a:ext>
             </a:extLst>
           </p:cNvPr>
@@ -5401,7 +5401,7 @@
                 <a:ea typeface="Arial"/>
                 <a:cs typeface="Arial"/>
               </a:rPr>
-              <a:t>Premissas do AS IS seguem para validação com a organização</a:t>
+              <a:t>Verificação local; HTTPS e infraestrutura externa pendentes</a:t>
             </a:r>
           </a:p>
         </p:txBody>
@@ -5409,7 +5409,7 @@
     </p:spTree>
     <p:extLst>
       <p:ext uri="{BB962C8B-B14F-4D97-AF65-F5344CB8AC3E}">
-        <p14:creationId xmlns:p14="http://schemas.microsoft.com/office/powerpoint/2010/main" val="1376782559"/>
+        <p14:creationId xmlns:p14="http://schemas.microsoft.com/office/powerpoint/2010/main" val="1785481312"/>
       </p:ext>
     </p:extLst>
   </p:cSld>
@@ -5440,7 +5440,7 @@
           <p:cNvPr id="9" name="">
             <a:extLst xmlns:a="http://schemas.openxmlformats.org/drawingml/2006/main">
               <a:ext uri="{FF2B5EF4-FFF2-40B4-BE49-F238E27FC236}">
-                <a16:creationId xmlns:a16="http://schemas.microsoft.com/office/drawing/2014/main" id="{2B0C307D-7D84-4E8E-B6C9-0371BF9D1E93}"/>
+                <a16:creationId xmlns:a16="http://schemas.microsoft.com/office/drawing/2014/main" id="{E3BF2307-CE78-4C8A-854A-3FDF261D317F}"/>
               </a:ext>
             </a:extLst>
           </p:cNvPr>
@@ -5470,7 +5470,7 @@
           <p:cNvPr id="2" name="">
             <a:extLst xmlns:a="http://schemas.openxmlformats.org/drawingml/2006/main">
               <a:ext uri="{FF2B5EF4-FFF2-40B4-BE49-F238E27FC236}">
-                <a16:creationId xmlns:a16="http://schemas.microsoft.com/office/drawing/2014/main" id="{F3CA43A3-6EC9-4F9B-AB67-7728075217A6}"/>
+                <a16:creationId xmlns:a16="http://schemas.microsoft.com/office/drawing/2014/main" id="{E44C8391-C47A-425A-A1FC-A960616ACDCE}"/>
               </a:ext>
             </a:extLst>
           </p:cNvPr>
@@ -5527,7 +5527,7 @@
           <p:cNvPr id="3" name="">
             <a:extLst xmlns:a="http://schemas.openxmlformats.org/drawingml/2006/main">
               <a:ext uri="{FF2B5EF4-FFF2-40B4-BE49-F238E27FC236}">
-                <a16:creationId xmlns:a16="http://schemas.microsoft.com/office/drawing/2014/main" id="{8D07A0E5-BB80-4C4A-A530-6892AA727B52}"/>
+                <a16:creationId xmlns:a16="http://schemas.microsoft.com/office/drawing/2014/main" id="{3FD4F647-7605-4131-8E72-6FCE77BAC3A0}"/>
               </a:ext>
             </a:extLst>
           </p:cNvPr>
@@ -5584,7 +5584,7 @@
           <p:cNvPr id="4" name="">
             <a:extLst xmlns:a="http://schemas.openxmlformats.org/drawingml/2006/main">
               <a:ext uri="{FF2B5EF4-FFF2-40B4-BE49-F238E27FC236}">
-                <a16:creationId xmlns:a16="http://schemas.microsoft.com/office/drawing/2014/main" id="{6602A080-2761-45DC-A2B5-3C86FEE86B96}"/>
+                <a16:creationId xmlns:a16="http://schemas.microsoft.com/office/drawing/2014/main" id="{287BF352-9EE7-4732-A9BF-EAECAC28CEB6}"/>
               </a:ext>
             </a:extLst>
           </p:cNvPr>
@@ -5641,7 +5641,7 @@
           <p:cNvPr id="5" name="">
             <a:extLst xmlns:a="http://schemas.openxmlformats.org/drawingml/2006/main">
               <a:ext uri="{FF2B5EF4-FFF2-40B4-BE49-F238E27FC236}">
-                <a16:creationId xmlns:a16="http://schemas.microsoft.com/office/drawing/2014/main" id="{AD5CA2ED-DAD3-435C-A190-EC63B7965496}"/>
+                <a16:creationId xmlns:a16="http://schemas.microsoft.com/office/drawing/2014/main" id="{8093916B-85FC-4579-9981-B75BC4A94FF8}"/>
               </a:ext>
             </a:extLst>
           </p:cNvPr>
@@ -5719,7 +5719,7 @@
                 <a:ea typeface="Arial"/>
                 <a:cs typeface="Arial"/>
               </a:rPr>
-              <a:t>Reservas e contratos e fronteiras permitem evolução incremental</a:t>
+              <a:t>Contratos técnicos e fronteiras permitem evolução incremental</a:t>
             </a:r>
           </a:p>
           <a:p xmlns:a="http://schemas.openxmlformats.org/drawingml/2006/main">
@@ -5756,7 +5756,7 @@
           <p:cNvPr id="6" name="">
             <a:extLst xmlns:a="http://schemas.openxmlformats.org/drawingml/2006/main">
               <a:ext uri="{FF2B5EF4-FFF2-40B4-BE49-F238E27FC236}">
-                <a16:creationId xmlns:a16="http://schemas.microsoft.com/office/drawing/2014/main" id="{E8DBA59B-B0EC-4D2B-9206-5658E30BD6A6}"/>
+                <a16:creationId xmlns:a16="http://schemas.microsoft.com/office/drawing/2014/main" id="{9544247A-19B2-41AA-A14C-A889D61973CC}"/>
               </a:ext>
             </a:extLst>
           </p:cNvPr>
@@ -5813,7 +5813,7 @@
           <p:cNvPr id="7" name="">
             <a:extLst xmlns:a="http://schemas.openxmlformats.org/drawingml/2006/main">
               <a:ext uri="{FF2B5EF4-FFF2-40B4-BE49-F238E27FC236}">
-                <a16:creationId xmlns:a16="http://schemas.microsoft.com/office/drawing/2014/main" id="{42407139-145E-49D4-A447-4A1E51DC2008}"/>
+                <a16:creationId xmlns:a16="http://schemas.microsoft.com/office/drawing/2014/main" id="{02BA6FA8-E36B-428A-9B3B-579278876A6D}"/>
               </a:ext>
             </a:extLst>
           </p:cNvPr>
@@ -5928,7 +5928,7 @@
           <p:cNvPr id="8" name="">
             <a:extLst xmlns:a="http://schemas.openxmlformats.org/drawingml/2006/main">
               <a:ext uri="{FF2B5EF4-FFF2-40B4-BE49-F238E27FC236}">
-                <a16:creationId xmlns:a16="http://schemas.microsoft.com/office/drawing/2014/main" id="{9202A3CB-4B2E-4D40-9224-12BBE93DBFF7}"/>
+                <a16:creationId xmlns:a16="http://schemas.microsoft.com/office/drawing/2014/main" id="{D7066C3F-3B51-4BBA-8CE0-5C4E55A808D1}"/>
               </a:ext>
             </a:extLst>
           </p:cNvPr>
@@ -5983,7 +5983,7 @@
     </p:spTree>
     <p:extLst>
       <p:ext uri="{BB962C8B-B14F-4D97-AF65-F5344CB8AC3E}">
-        <p14:creationId xmlns:p14="http://schemas.microsoft.com/office/powerpoint/2010/main" val="149471561"/>
+        <p14:creationId xmlns:p14="http://schemas.microsoft.com/office/powerpoint/2010/main" val="1105091545"/>
       </p:ext>
     </p:extLst>
   </p:cSld>
@@ -6014,7 +6014,7 @@
           <p:cNvPr id="10" name="">
             <a:extLst xmlns:a="http://schemas.openxmlformats.org/drawingml/2006/main">
               <a:ext uri="{FF2B5EF4-FFF2-40B4-BE49-F238E27FC236}">
-                <a16:creationId xmlns:a16="http://schemas.microsoft.com/office/drawing/2014/main" id="{B3AA9406-4916-4AE1-81A9-C7319E2068F2}"/>
+                <a16:creationId xmlns:a16="http://schemas.microsoft.com/office/drawing/2014/main" id="{6CF8FDEB-7751-4408-ADB9-DF6282F1A988}"/>
               </a:ext>
             </a:extLst>
           </p:cNvPr>
@@ -6044,7 +6044,7 @@
           <p:cNvPr id="2" name="">
             <a:extLst xmlns:a="http://schemas.openxmlformats.org/drawingml/2006/main">
               <a:ext uri="{FF2B5EF4-FFF2-40B4-BE49-F238E27FC236}">
-                <a16:creationId xmlns:a16="http://schemas.microsoft.com/office/drawing/2014/main" id="{165EF7B9-E16B-4E91-8CF7-A4E6EF208282}"/>
+                <a16:creationId xmlns:a16="http://schemas.microsoft.com/office/drawing/2014/main" id="{6D876B0F-DF8B-41E1-9CB5-4C0F336832A4}"/>
               </a:ext>
             </a:extLst>
           </p:cNvPr>
@@ -6101,7 +6101,7 @@
           <p:cNvPr id="3" name="">
             <a:extLst xmlns:a="http://schemas.openxmlformats.org/drawingml/2006/main">
               <a:ext uri="{FF2B5EF4-FFF2-40B4-BE49-F238E27FC236}">
-                <a16:creationId xmlns:a16="http://schemas.microsoft.com/office/drawing/2014/main" id="{2D3FF770-E2BF-4356-8D32-2CC8A0D5BD74}"/>
+                <a16:creationId xmlns:a16="http://schemas.microsoft.com/office/drawing/2014/main" id="{DB655A57-0395-4314-B345-CDF4BF203AD8}"/>
               </a:ext>
             </a:extLst>
           </p:cNvPr>
@@ -6158,7 +6158,7 @@
           <p:cNvPr id="4" name="">
             <a:extLst xmlns:a="http://schemas.openxmlformats.org/drawingml/2006/main">
               <a:ext uri="{FF2B5EF4-FFF2-40B4-BE49-F238E27FC236}">
-                <a16:creationId xmlns:a16="http://schemas.microsoft.com/office/drawing/2014/main" id="{C4F54B3B-23A9-44B4-8A23-DCAF4B03E51E}"/>
+                <a16:creationId xmlns:a16="http://schemas.microsoft.com/office/drawing/2014/main" id="{3FAFB443-8FA1-4559-B4C1-DC8AA8768948}"/>
               </a:ext>
             </a:extLst>
           </p:cNvPr>
@@ -6300,7 +6300,7 @@
           <p:cNvPr id="5" name="">
             <a:extLst xmlns:a="http://schemas.openxmlformats.org/drawingml/2006/main">
               <a:ext uri="{FF2B5EF4-FFF2-40B4-BE49-F238E27FC236}">
-                <a16:creationId xmlns:a16="http://schemas.microsoft.com/office/drawing/2014/main" id="{B774D312-BE0D-489C-9D07-DD9489B9A22D}"/>
+                <a16:creationId xmlns:a16="http://schemas.microsoft.com/office/drawing/2014/main" id="{8042F112-9DE3-4884-922D-E81727D68E37}"/>
               </a:ext>
             </a:extLst>
           </p:cNvPr>
@@ -6364,7 +6364,7 @@
           <p:cNvPr id="6" name="">
             <a:extLst xmlns:a="http://schemas.openxmlformats.org/drawingml/2006/main">
               <a:ext uri="{FF2B5EF4-FFF2-40B4-BE49-F238E27FC236}">
-                <a16:creationId xmlns:a16="http://schemas.microsoft.com/office/drawing/2014/main" id="{89FB6779-E762-4DBC-99F2-08FCF3A10B0F}"/>
+                <a16:creationId xmlns:a16="http://schemas.microsoft.com/office/drawing/2014/main" id="{60F4D356-2378-4EA0-9E4B-BF52372645B5}"/>
               </a:ext>
             </a:extLst>
           </p:cNvPr>
@@ -6428,7 +6428,7 @@
           <p:cNvPr id="7" name="">
             <a:extLst xmlns:a="http://schemas.openxmlformats.org/drawingml/2006/main">
               <a:ext uri="{FF2B5EF4-FFF2-40B4-BE49-F238E27FC236}">
-                <a16:creationId xmlns:a16="http://schemas.microsoft.com/office/drawing/2014/main" id="{EF961145-11D5-4657-B96A-7ADF092CA0C4}"/>
+                <a16:creationId xmlns:a16="http://schemas.microsoft.com/office/drawing/2014/main" id="{19FB20FF-9CFD-4F7B-A192-48BF3D64CA1B}"/>
               </a:ext>
             </a:extLst>
           </p:cNvPr>
@@ -6492,7 +6492,7 @@
           <p:cNvPr id="8" name="">
             <a:extLst xmlns:a="http://schemas.openxmlformats.org/drawingml/2006/main">
               <a:ext uri="{FF2B5EF4-FFF2-40B4-BE49-F238E27FC236}">
-                <a16:creationId xmlns:a16="http://schemas.microsoft.com/office/drawing/2014/main" id="{7BB511BE-011C-4538-99FB-4FEA07A63B37}"/>
+                <a16:creationId xmlns:a16="http://schemas.microsoft.com/office/drawing/2014/main" id="{13A66F67-B962-4673-AD7B-D4F09C903189}"/>
               </a:ext>
             </a:extLst>
           </p:cNvPr>
@@ -6556,7 +6556,7 @@
           <p:cNvPr id="9" name="">
             <a:extLst xmlns:a="http://schemas.openxmlformats.org/drawingml/2006/main">
               <a:ext uri="{FF2B5EF4-FFF2-40B4-BE49-F238E27FC236}">
-                <a16:creationId xmlns:a16="http://schemas.microsoft.com/office/drawing/2014/main" id="{E8886A59-46B1-40A6-BCB8-814E7896FD26}"/>
+                <a16:creationId xmlns:a16="http://schemas.microsoft.com/office/drawing/2014/main" id="{69431324-36F5-40DA-8F5D-D801A07496C4}"/>
               </a:ext>
             </a:extLst>
           </p:cNvPr>
@@ -6618,7 +6618,7 @@
     </p:spTree>
     <p:extLst>
       <p:ext uri="{BB962C8B-B14F-4D97-AF65-F5344CB8AC3E}">
-        <p14:creationId xmlns:p14="http://schemas.microsoft.com/office/powerpoint/2010/main" val="2003958931"/>
+        <p14:creationId xmlns:p14="http://schemas.microsoft.com/office/powerpoint/2010/main" val="87489788"/>
       </p:ext>
     </p:extLst>
   </p:cSld>
@@ -6649,7 +6649,7 @@
           <p:cNvPr id="15" name="">
             <a:extLst xmlns:a="http://schemas.openxmlformats.org/drawingml/2006/main">
               <a:ext uri="{FF2B5EF4-FFF2-40B4-BE49-F238E27FC236}">
-                <a16:creationId xmlns:a16="http://schemas.microsoft.com/office/drawing/2014/main" id="{40D8657A-6BE9-486D-A312-5E342A5461A4}"/>
+                <a16:creationId xmlns:a16="http://schemas.microsoft.com/office/drawing/2014/main" id="{07487F87-A418-476B-B98C-DCA95835F0D3}"/>
               </a:ext>
             </a:extLst>
           </p:cNvPr>
@@ -6679,7 +6679,7 @@
           <p:cNvPr id="2" name="">
             <a:extLst xmlns:a="http://schemas.openxmlformats.org/drawingml/2006/main">
               <a:ext uri="{FF2B5EF4-FFF2-40B4-BE49-F238E27FC236}">
-                <a16:creationId xmlns:a16="http://schemas.microsoft.com/office/drawing/2014/main" id="{416E001C-29EA-4DEF-BE52-5DA1501ADC46}"/>
+                <a16:creationId xmlns:a16="http://schemas.microsoft.com/office/drawing/2014/main" id="{25806127-81BD-469A-94FF-18F28220A2B5}"/>
               </a:ext>
             </a:extLst>
           </p:cNvPr>
@@ -6736,7 +6736,7 @@
           <p:cNvPr id="3" name="">
             <a:extLst xmlns:a="http://schemas.openxmlformats.org/drawingml/2006/main">
               <a:ext uri="{FF2B5EF4-FFF2-40B4-BE49-F238E27FC236}">
-                <a16:creationId xmlns:a16="http://schemas.microsoft.com/office/drawing/2014/main" id="{965D33C0-AB26-4D1B-8B58-C29A2FFA6D93}"/>
+                <a16:creationId xmlns:a16="http://schemas.microsoft.com/office/drawing/2014/main" id="{F5E2C2DE-0EA4-4412-9CB6-E2807943094F}"/>
               </a:ext>
             </a:extLst>
           </p:cNvPr>
@@ -6793,7 +6793,7 @@
           <p:cNvPr id="4" name="">
             <a:extLst xmlns:a="http://schemas.openxmlformats.org/drawingml/2006/main">
               <a:ext uri="{FF2B5EF4-FFF2-40B4-BE49-F238E27FC236}">
-                <a16:creationId xmlns:a16="http://schemas.microsoft.com/office/drawing/2014/main" id="{D8EBD275-18E4-4A49-A023-2DD3DC217279}"/>
+                <a16:creationId xmlns:a16="http://schemas.microsoft.com/office/drawing/2014/main" id="{3982D17E-EDBF-4FF8-BB81-DBC5C58D8253}"/>
               </a:ext>
             </a:extLst>
           </p:cNvPr>
@@ -6805,11 +6805,11 @@
         <p:spPr>
           <a:xfrm xmlns:a="http://schemas.openxmlformats.org/drawingml/2006/main">
             <a:off x="762000" y="2000250"/>
-            <a:ext cx="1619250" cy="809625"/>
+            <a:ext cx="1619250" cy="1047750"/>
           </a:xfrm>
           <a:prstGeom xmlns:a="http://schemas.openxmlformats.org/drawingml/2006/main" prst="roundRect">
             <a:avLst>
-              <a:gd name="adj" fmla="val 16471"/>
+              <a:gd name="adj" fmla="val 12727"/>
             </a:avLst>
           </a:prstGeom>
           <a:solidFill xmlns:a="http://schemas.openxmlformats.org/drawingml/2006/main">
@@ -6857,7 +6857,7 @@
           <p:cNvPr id="5" name="">
             <a:extLst xmlns:a="http://schemas.openxmlformats.org/drawingml/2006/main">
               <a:ext uri="{FF2B5EF4-FFF2-40B4-BE49-F238E27FC236}">
-                <a16:creationId xmlns:a16="http://schemas.microsoft.com/office/drawing/2014/main" id="{6A0E79E3-BCC5-44C8-A9B1-D7E06A2B9697}"/>
+                <a16:creationId xmlns:a16="http://schemas.microsoft.com/office/drawing/2014/main" id="{208B661C-0939-43A1-89C7-32489441DFBA}"/>
               </a:ext>
             </a:extLst>
           </p:cNvPr>
@@ -6869,11 +6869,11 @@
         <p:spPr>
           <a:xfrm xmlns:a="http://schemas.openxmlformats.org/drawingml/2006/main">
             <a:off x="3048000" y="2000250"/>
-            <a:ext cx="1714500" cy="809625"/>
+            <a:ext cx="1714500" cy="1047750"/>
           </a:xfrm>
           <a:prstGeom xmlns:a="http://schemas.openxmlformats.org/drawingml/2006/main" prst="roundRect">
             <a:avLst>
-              <a:gd name="adj" fmla="val 16471"/>
+              <a:gd name="adj" fmla="val 12727"/>
             </a:avLst>
           </a:prstGeom>
           <a:solidFill xmlns:a="http://schemas.openxmlformats.org/drawingml/2006/main">
@@ -6921,7 +6921,7 @@
           <p:cNvPr id="6" name="">
             <a:extLst xmlns:a="http://schemas.openxmlformats.org/drawingml/2006/main">
               <a:ext uri="{FF2B5EF4-FFF2-40B4-BE49-F238E27FC236}">
-                <a16:creationId xmlns:a16="http://schemas.microsoft.com/office/drawing/2014/main" id="{A735392E-8AB2-422D-9397-5B9C611AC270}"/>
+                <a16:creationId xmlns:a16="http://schemas.microsoft.com/office/drawing/2014/main" id="{AA842277-9B14-4B3A-A3C1-61DA3101F699}"/>
               </a:ext>
             </a:extLst>
           </p:cNvPr>
@@ -6933,11 +6933,11 @@
         <p:spPr>
           <a:xfrm xmlns:a="http://schemas.openxmlformats.org/drawingml/2006/main">
             <a:off x="5429250" y="2000250"/>
-            <a:ext cx="1714500" cy="809625"/>
+            <a:ext cx="1714500" cy="1047750"/>
           </a:xfrm>
           <a:prstGeom xmlns:a="http://schemas.openxmlformats.org/drawingml/2006/main" prst="roundRect">
             <a:avLst>
-              <a:gd name="adj" fmla="val 16471"/>
+              <a:gd name="adj" fmla="val 12727"/>
             </a:avLst>
           </a:prstGeom>
           <a:solidFill xmlns:a="http://schemas.openxmlformats.org/drawingml/2006/main">
@@ -6985,7 +6985,7 @@
           <p:cNvPr id="7" name="">
             <a:extLst xmlns:a="http://schemas.openxmlformats.org/drawingml/2006/main">
               <a:ext uri="{FF2B5EF4-FFF2-40B4-BE49-F238E27FC236}">
-                <a16:creationId xmlns:a16="http://schemas.microsoft.com/office/drawing/2014/main" id="{F5039A25-8AF5-4645-94E5-8F6EBD53158F}"/>
+                <a16:creationId xmlns:a16="http://schemas.microsoft.com/office/drawing/2014/main" id="{EFD5B854-3C7D-402B-86DA-8C2306ED93A7}"/>
               </a:ext>
             </a:extLst>
           </p:cNvPr>
@@ -6997,11 +6997,11 @@
         <p:spPr>
           <a:xfrm xmlns:a="http://schemas.openxmlformats.org/drawingml/2006/main">
             <a:off x="7810500" y="2000250"/>
-            <a:ext cx="1714500" cy="809625"/>
+            <a:ext cx="1714500" cy="1047750"/>
           </a:xfrm>
           <a:prstGeom xmlns:a="http://schemas.openxmlformats.org/drawingml/2006/main" prst="roundRect">
             <a:avLst>
-              <a:gd name="adj" fmla="val 16471"/>
+              <a:gd name="adj" fmla="val 12727"/>
             </a:avLst>
           </a:prstGeom>
           <a:solidFill xmlns:a="http://schemas.openxmlformats.org/drawingml/2006/main">
@@ -7049,7 +7049,7 @@
           <p:cNvPr id="8" name="">
             <a:extLst xmlns:a="http://schemas.openxmlformats.org/drawingml/2006/main">
               <a:ext uri="{FF2B5EF4-FFF2-40B4-BE49-F238E27FC236}">
-                <a16:creationId xmlns:a16="http://schemas.microsoft.com/office/drawing/2014/main" id="{65D56AB9-5A64-43D3-9414-F4C26D1E56AC}"/>
+                <a16:creationId xmlns:a16="http://schemas.microsoft.com/office/drawing/2014/main" id="{2B961341-D3BD-4F28-BE90-A492638627F6}"/>
               </a:ext>
             </a:extLst>
           </p:cNvPr>
@@ -7061,11 +7061,11 @@
         <p:spPr>
           <a:xfrm xmlns:a="http://schemas.openxmlformats.org/drawingml/2006/main">
             <a:off x="10191750" y="2000250"/>
-            <a:ext cx="1428750" cy="809625"/>
+            <a:ext cx="1428750" cy="1047750"/>
           </a:xfrm>
           <a:prstGeom xmlns:a="http://schemas.openxmlformats.org/drawingml/2006/main" prst="roundRect">
             <a:avLst>
-              <a:gd name="adj" fmla="val 16471"/>
+              <a:gd name="adj" fmla="val 12727"/>
             </a:avLst>
           </a:prstGeom>
           <a:solidFill xmlns:a="http://schemas.openxmlformats.org/drawingml/2006/main">
@@ -7119,7 +7119,7 @@
         </p:nvCxnSpPr>
         <p:spPr>
           <a:xfrm xmlns:a="http://schemas.openxmlformats.org/drawingml/2006/main">
-            <a:off x="2381250" y="2405063"/>
+            <a:off x="2381250" y="2524125"/>
             <a:ext cx="666750" cy="0"/>
           </a:xfrm>
           <a:prstGeom xmlns:a="http://schemas.openxmlformats.org/drawingml/2006/main" prst="straightConnector1">
@@ -7145,7 +7145,7 @@
         </p:nvCxnSpPr>
         <p:spPr>
           <a:xfrm xmlns:a="http://schemas.openxmlformats.org/drawingml/2006/main">
-            <a:off x="4762500" y="2405063"/>
+            <a:off x="4762500" y="2524125"/>
             <a:ext cx="666750" cy="0"/>
           </a:xfrm>
           <a:prstGeom xmlns:a="http://schemas.openxmlformats.org/drawingml/2006/main" prst="straightConnector1">
@@ -7171,7 +7171,7 @@
         </p:nvCxnSpPr>
         <p:spPr>
           <a:xfrm xmlns:a="http://schemas.openxmlformats.org/drawingml/2006/main">
-            <a:off x="7143750" y="2405063"/>
+            <a:off x="7143750" y="2524125"/>
             <a:ext cx="666750" cy="0"/>
           </a:xfrm>
           <a:prstGeom xmlns:a="http://schemas.openxmlformats.org/drawingml/2006/main" prst="straightConnector1">
@@ -7197,7 +7197,7 @@
         </p:nvCxnSpPr>
         <p:spPr>
           <a:xfrm xmlns:a="http://schemas.openxmlformats.org/drawingml/2006/main">
-            <a:off x="9525000" y="2405063"/>
+            <a:off x="9525000" y="2524125"/>
             <a:ext cx="666750" cy="0"/>
           </a:xfrm>
           <a:prstGeom xmlns:a="http://schemas.openxmlformats.org/drawingml/2006/main" prst="straightConnector1">
@@ -7217,7 +7217,7 @@
           <p:cNvPr id="13" name="">
             <a:extLst xmlns:a="http://schemas.openxmlformats.org/drawingml/2006/main">
               <a:ext uri="{FF2B5EF4-FFF2-40B4-BE49-F238E27FC236}">
-                <a16:creationId xmlns:a16="http://schemas.microsoft.com/office/drawing/2014/main" id="{83EFE4F1-89C9-4D29-B8F7-9CCEAC4F8EFB}"/>
+                <a16:creationId xmlns:a16="http://schemas.microsoft.com/office/drawing/2014/main" id="{A829EEF4-9B67-4FBE-B09F-173A04988FCF}"/>
               </a:ext>
             </a:extLst>
           </p:cNvPr>
@@ -7274,7 +7274,7 @@
           <p:cNvPr id="14" name="">
             <a:extLst xmlns:a="http://schemas.openxmlformats.org/drawingml/2006/main">
               <a:ext uri="{FF2B5EF4-FFF2-40B4-BE49-F238E27FC236}">
-                <a16:creationId xmlns:a16="http://schemas.microsoft.com/office/drawing/2014/main" id="{DD7BBCC7-8B38-43AE-8EFE-753C8CE58369}"/>
+                <a16:creationId xmlns:a16="http://schemas.microsoft.com/office/drawing/2014/main" id="{120681B0-EDA5-4274-83A2-70E67C6F9FA0}"/>
               </a:ext>
             </a:extLst>
           </p:cNvPr>
@@ -7329,7 +7329,7 @@
     </p:spTree>
     <p:extLst>
       <p:ext uri="{BB962C8B-B14F-4D97-AF65-F5344CB8AC3E}">
-        <p14:creationId xmlns:p14="http://schemas.microsoft.com/office/powerpoint/2010/main" val="176095454"/>
+        <p14:creationId xmlns:p14="http://schemas.microsoft.com/office/powerpoint/2010/main" val="1059297290"/>
       </p:ext>
     </p:extLst>
   </p:cSld>
@@ -7360,7 +7360,7 @@
           <p:cNvPr id="7" name="">
             <a:extLst xmlns:a="http://schemas.openxmlformats.org/drawingml/2006/main">
               <a:ext uri="{FF2B5EF4-FFF2-40B4-BE49-F238E27FC236}">
-                <a16:creationId xmlns:a16="http://schemas.microsoft.com/office/drawing/2014/main" id="{F3F5FB4E-857F-442E-A5B3-38DD2065F4A4}"/>
+                <a16:creationId xmlns:a16="http://schemas.microsoft.com/office/drawing/2014/main" id="{32BAAF7A-12C9-41EE-9582-10A4C051BFF8}"/>
               </a:ext>
             </a:extLst>
           </p:cNvPr>
@@ -7390,7 +7390,7 @@
           <p:cNvPr id="2" name="">
             <a:extLst xmlns:a="http://schemas.openxmlformats.org/drawingml/2006/main">
               <a:ext uri="{FF2B5EF4-FFF2-40B4-BE49-F238E27FC236}">
-                <a16:creationId xmlns:a16="http://schemas.microsoft.com/office/drawing/2014/main" id="{8E3D115A-65F8-44B6-9B35-4E1BF62FD7B9}"/>
+                <a16:creationId xmlns:a16="http://schemas.microsoft.com/office/drawing/2014/main" id="{FF583FA2-347E-4EC5-8B86-5AFF93F0215D}"/>
               </a:ext>
             </a:extLst>
           </p:cNvPr>
@@ -7447,7 +7447,7 @@
           <p:cNvPr id="3" name="">
             <a:extLst xmlns:a="http://schemas.openxmlformats.org/drawingml/2006/main">
               <a:ext uri="{FF2B5EF4-FFF2-40B4-BE49-F238E27FC236}">
-                <a16:creationId xmlns:a16="http://schemas.microsoft.com/office/drawing/2014/main" id="{B6BE9CBD-8978-49BE-8D19-FFAE8BE8B920}"/>
+                <a16:creationId xmlns:a16="http://schemas.microsoft.com/office/drawing/2014/main" id="{13A863C3-A863-4FC3-B28D-BD84EE096078}"/>
               </a:ext>
             </a:extLst>
           </p:cNvPr>
@@ -7504,7 +7504,7 @@
           <p:cNvPr id="4" name="">
             <a:extLst xmlns:a="http://schemas.openxmlformats.org/drawingml/2006/main">
               <a:ext uri="{FF2B5EF4-FFF2-40B4-BE49-F238E27FC236}">
-                <a16:creationId xmlns:a16="http://schemas.microsoft.com/office/drawing/2014/main" id="{A8E21D15-5318-47B1-8240-BEC5D652A8DE}"/>
+                <a16:creationId xmlns:a16="http://schemas.microsoft.com/office/drawing/2014/main" id="{B8ADB77C-B0B7-42F2-8F5B-BE2B504ED5BA}"/>
               </a:ext>
             </a:extLst>
           </p:cNvPr>
@@ -7646,7 +7646,7 @@
           <p:cNvPr id="5" name="">
             <a:extLst xmlns:a="http://schemas.openxmlformats.org/drawingml/2006/main">
               <a:ext uri="{FF2B5EF4-FFF2-40B4-BE49-F238E27FC236}">
-                <a16:creationId xmlns:a16="http://schemas.microsoft.com/office/drawing/2014/main" id="{02B21AF9-88B9-460A-BCF5-50BF594C8C38}"/>
+                <a16:creationId xmlns:a16="http://schemas.microsoft.com/office/drawing/2014/main" id="{A3D8C3C2-0116-4C08-A4E7-FB3DC50661C6}"/>
               </a:ext>
             </a:extLst>
           </p:cNvPr>
@@ -7703,7 +7703,7 @@
           <p:cNvPr id="6" name="">
             <a:extLst xmlns:a="http://schemas.openxmlformats.org/drawingml/2006/main">
               <a:ext uri="{FF2B5EF4-FFF2-40B4-BE49-F238E27FC236}">
-                <a16:creationId xmlns:a16="http://schemas.microsoft.com/office/drawing/2014/main" id="{052461D8-E809-4B10-A7E1-CCA0DE6299C3}"/>
+                <a16:creationId xmlns:a16="http://schemas.microsoft.com/office/drawing/2014/main" id="{3DBF25D0-6E8F-409E-BAC9-219025C3394E}"/>
               </a:ext>
             </a:extLst>
           </p:cNvPr>
@@ -7924,7 +7924,7 @@
     </p:spTree>
     <p:extLst>
       <p:ext uri="{BB962C8B-B14F-4D97-AF65-F5344CB8AC3E}">
-        <p14:creationId xmlns:p14="http://schemas.microsoft.com/office/powerpoint/2010/main" val="1858787110"/>
+        <p14:creationId xmlns:p14="http://schemas.microsoft.com/office/powerpoint/2010/main" val="805756691"/>
       </p:ext>
     </p:extLst>
   </p:cSld>
@@ -7955,7 +7955,7 @@
           <p:cNvPr id="7" name="">
             <a:extLst xmlns:a="http://schemas.openxmlformats.org/drawingml/2006/main">
               <a:ext uri="{FF2B5EF4-FFF2-40B4-BE49-F238E27FC236}">
-                <a16:creationId xmlns:a16="http://schemas.microsoft.com/office/drawing/2014/main" id="{4A4C5124-0CD9-4D60-B5FB-21C331D565C3}"/>
+                <a16:creationId xmlns:a16="http://schemas.microsoft.com/office/drawing/2014/main" id="{FAB60652-E1B1-4B7B-AB72-4B4379D4F9A0}"/>
               </a:ext>
             </a:extLst>
           </p:cNvPr>
@@ -7985,7 +7985,7 @@
           <p:cNvPr id="2" name="">
             <a:extLst xmlns:a="http://schemas.openxmlformats.org/drawingml/2006/main">
               <a:ext uri="{FF2B5EF4-FFF2-40B4-BE49-F238E27FC236}">
-                <a16:creationId xmlns:a16="http://schemas.microsoft.com/office/drawing/2014/main" id="{107703B7-B29B-43B5-A795-A65887E37B3F}"/>
+                <a16:creationId xmlns:a16="http://schemas.microsoft.com/office/drawing/2014/main" id="{7FA3A109-27E7-4C80-AB4C-C721561EC275}"/>
               </a:ext>
             </a:extLst>
           </p:cNvPr>
@@ -8042,7 +8042,7 @@
           <p:cNvPr id="3" name="">
             <a:extLst xmlns:a="http://schemas.openxmlformats.org/drawingml/2006/main">
               <a:ext uri="{FF2B5EF4-FFF2-40B4-BE49-F238E27FC236}">
-                <a16:creationId xmlns:a16="http://schemas.microsoft.com/office/drawing/2014/main" id="{A55D4F55-6399-408F-A912-260B90C74F61}"/>
+                <a16:creationId xmlns:a16="http://schemas.microsoft.com/office/drawing/2014/main" id="{3F384225-3249-465E-B02A-6DF6A3BFEBDC}"/>
               </a:ext>
             </a:extLst>
           </p:cNvPr>
@@ -8099,7 +8099,7 @@
           <p:cNvPr id="4" name="">
             <a:extLst xmlns:a="http://schemas.openxmlformats.org/drawingml/2006/main">
               <a:ext uri="{FF2B5EF4-FFF2-40B4-BE49-F238E27FC236}">
-                <a16:creationId xmlns:a16="http://schemas.microsoft.com/office/drawing/2014/main" id="{181020DF-8FF1-4009-8B77-4BCBA5EC4F37}"/>
+                <a16:creationId xmlns:a16="http://schemas.microsoft.com/office/drawing/2014/main" id="{88768D56-AC8D-480C-B9D8-A1905854BB32}"/>
               </a:ext>
             </a:extLst>
           </p:cNvPr>
@@ -8156,7 +8156,7 @@
           <p:cNvPr id="5" name="">
             <a:extLst xmlns:a="http://schemas.openxmlformats.org/drawingml/2006/main">
               <a:ext uri="{FF2B5EF4-FFF2-40B4-BE49-F238E27FC236}">
-                <a16:creationId xmlns:a16="http://schemas.microsoft.com/office/drawing/2014/main" id="{4049AB19-2502-4963-935E-BE062730CAE5}"/>
+                <a16:creationId xmlns:a16="http://schemas.microsoft.com/office/drawing/2014/main" id="{747C4CEF-63E2-498B-9A67-94F650A9045C}"/>
               </a:ext>
             </a:extLst>
           </p:cNvPr>
@@ -8261,7 +8261,7 @@
                 <a:ea typeface="Arial"/>
                 <a:cs typeface="Arial"/>
               </a:rPr>
-              <a:t>PostgreSQL e RabbitMQ sustentam a demonstração local</a:t>
+              <a:t>SQLite verificado; PostgreSQL e RabbitMQ previstos no Compose</a:t>
             </a:r>
           </a:p>
           <a:p xmlns:a="http://schemas.openxmlformats.org/drawingml/2006/main">
@@ -8298,7 +8298,7 @@
           <p:cNvPr id="6" name="">
             <a:extLst xmlns:a="http://schemas.openxmlformats.org/drawingml/2006/main">
               <a:ext uri="{FF2B5EF4-FFF2-40B4-BE49-F238E27FC236}">
-                <a16:creationId xmlns:a16="http://schemas.microsoft.com/office/drawing/2014/main" id="{4971E268-CAB5-4497-9D66-C67B035ECF62}"/>
+                <a16:creationId xmlns:a16="http://schemas.microsoft.com/office/drawing/2014/main" id="{835E7058-0261-4376-9F9E-4417392BD301}"/>
               </a:ext>
             </a:extLst>
           </p:cNvPr>
@@ -8353,7 +8353,7 @@
     </p:spTree>
     <p:extLst>
       <p:ext uri="{BB962C8B-B14F-4D97-AF65-F5344CB8AC3E}">
-        <p14:creationId xmlns:p14="http://schemas.microsoft.com/office/powerpoint/2010/main" val="2109065521"/>
+        <p14:creationId xmlns:p14="http://schemas.microsoft.com/office/powerpoint/2010/main" val="138749966"/>
       </p:ext>
     </p:extLst>
   </p:cSld>
@@ -8384,7 +8384,7 @@
           <p:cNvPr id="22" name="">
             <a:extLst xmlns:a="http://schemas.openxmlformats.org/drawingml/2006/main">
               <a:ext uri="{FF2B5EF4-FFF2-40B4-BE49-F238E27FC236}">
-                <a16:creationId xmlns:a16="http://schemas.microsoft.com/office/drawing/2014/main" id="{CCF9FFE5-6BFA-48EF-A004-896C664408B0}"/>
+                <a16:creationId xmlns:a16="http://schemas.microsoft.com/office/drawing/2014/main" id="{5DE4805A-697C-476D-9A4A-0E0F8CE85CB4}"/>
               </a:ext>
             </a:extLst>
           </p:cNvPr>
@@ -8414,7 +8414,7 @@
           <p:cNvPr id="2" name="">
             <a:extLst xmlns:a="http://schemas.openxmlformats.org/drawingml/2006/main">
               <a:ext uri="{FF2B5EF4-FFF2-40B4-BE49-F238E27FC236}">
-                <a16:creationId xmlns:a16="http://schemas.microsoft.com/office/drawing/2014/main" id="{2DA61072-61C2-498B-A7D3-42895B12E4E0}"/>
+                <a16:creationId xmlns:a16="http://schemas.microsoft.com/office/drawing/2014/main" id="{D70F02F9-3CC6-40B6-8A35-85AC4325DC2D}"/>
               </a:ext>
             </a:extLst>
           </p:cNvPr>
@@ -8471,7 +8471,7 @@
           <p:cNvPr id="3" name="">
             <a:extLst xmlns:a="http://schemas.openxmlformats.org/drawingml/2006/main">
               <a:ext uri="{FF2B5EF4-FFF2-40B4-BE49-F238E27FC236}">
-                <a16:creationId xmlns:a16="http://schemas.microsoft.com/office/drawing/2014/main" id="{928AE838-68C6-453C-8B21-D1A538BF6E61}"/>
+                <a16:creationId xmlns:a16="http://schemas.microsoft.com/office/drawing/2014/main" id="{6805DD65-7BD9-4DA3-9D67-EAA790363005}"/>
               </a:ext>
             </a:extLst>
           </p:cNvPr>
@@ -8528,7 +8528,7 @@
           <p:cNvPr id="4" name="">
             <a:extLst xmlns:a="http://schemas.openxmlformats.org/drawingml/2006/main">
               <a:ext uri="{FF2B5EF4-FFF2-40B4-BE49-F238E27FC236}">
-                <a16:creationId xmlns:a16="http://schemas.microsoft.com/office/drawing/2014/main" id="{459FACC6-58D5-4240-8919-1D4BA7F71207}"/>
+                <a16:creationId xmlns:a16="http://schemas.microsoft.com/office/drawing/2014/main" id="{21CE8C05-F882-44B8-9B80-8F6E51E41CBA}"/>
               </a:ext>
             </a:extLst>
           </p:cNvPr>
@@ -8592,7 +8592,7 @@
           <p:cNvPr id="5" name="">
             <a:extLst xmlns:a="http://schemas.openxmlformats.org/drawingml/2006/main">
               <a:ext uri="{FF2B5EF4-FFF2-40B4-BE49-F238E27FC236}">
-                <a16:creationId xmlns:a16="http://schemas.microsoft.com/office/drawing/2014/main" id="{52DC1C2B-564C-40B2-A3D9-46B75DAFC005}"/>
+                <a16:creationId xmlns:a16="http://schemas.microsoft.com/office/drawing/2014/main" id="{1B664C12-7142-4D4A-9EE2-F018F9D1CADA}"/>
               </a:ext>
             </a:extLst>
           </p:cNvPr>
@@ -8656,7 +8656,7 @@
           <p:cNvPr id="6" name="">
             <a:extLst xmlns:a="http://schemas.openxmlformats.org/drawingml/2006/main">
               <a:ext uri="{FF2B5EF4-FFF2-40B4-BE49-F238E27FC236}">
-                <a16:creationId xmlns:a16="http://schemas.microsoft.com/office/drawing/2014/main" id="{CEE6E2B8-7B22-400A-B72C-C0AAB2EAA6D6}"/>
+                <a16:creationId xmlns:a16="http://schemas.microsoft.com/office/drawing/2014/main" id="{DCC71DE4-832A-4F1D-886B-F9055C8859B8}"/>
               </a:ext>
             </a:extLst>
           </p:cNvPr>
@@ -8720,7 +8720,7 @@
           <p:cNvPr id="7" name="">
             <a:extLst xmlns:a="http://schemas.openxmlformats.org/drawingml/2006/main">
               <a:ext uri="{FF2B5EF4-FFF2-40B4-BE49-F238E27FC236}">
-                <a16:creationId xmlns:a16="http://schemas.microsoft.com/office/drawing/2014/main" id="{61B0F455-940B-4BB3-BDA3-CE20FFF2653E}"/>
+                <a16:creationId xmlns:a16="http://schemas.microsoft.com/office/drawing/2014/main" id="{C07D39AC-814F-4AF2-82BF-BA6C230813FC}"/>
               </a:ext>
             </a:extLst>
           </p:cNvPr>
@@ -8784,7 +8784,7 @@
           <p:cNvPr id="8" name="">
             <a:extLst xmlns:a="http://schemas.openxmlformats.org/drawingml/2006/main">
               <a:ext uri="{FF2B5EF4-FFF2-40B4-BE49-F238E27FC236}">
-                <a16:creationId xmlns:a16="http://schemas.microsoft.com/office/drawing/2014/main" id="{CB012C30-C5F7-4F04-BD02-C45A2F250E44}"/>
+                <a16:creationId xmlns:a16="http://schemas.microsoft.com/office/drawing/2014/main" id="{A1DA69C6-2C96-4B8C-A276-D1F886F86FC8}"/>
               </a:ext>
             </a:extLst>
           </p:cNvPr>
@@ -8848,7 +8848,7 @@
           <p:cNvPr id="9" name="">
             <a:extLst xmlns:a="http://schemas.openxmlformats.org/drawingml/2006/main">
               <a:ext uri="{FF2B5EF4-FFF2-40B4-BE49-F238E27FC236}">
-                <a16:creationId xmlns:a16="http://schemas.microsoft.com/office/drawing/2014/main" id="{33D11E89-EDF2-4FA9-92BC-6E5F876333A7}"/>
+                <a16:creationId xmlns:a16="http://schemas.microsoft.com/office/drawing/2014/main" id="{1B9FE18B-068E-4C91-A81A-FE0552E1323E}"/>
               </a:ext>
             </a:extLst>
           </p:cNvPr>
@@ -9054,7 +9054,7 @@
           <p:cNvPr id="15" name="">
             <a:extLst xmlns:a="http://schemas.openxmlformats.org/drawingml/2006/main">
               <a:ext uri="{FF2B5EF4-FFF2-40B4-BE49-F238E27FC236}">
-                <a16:creationId xmlns:a16="http://schemas.microsoft.com/office/drawing/2014/main" id="{021C2975-F8F1-497D-B480-468C55F6FE56}"/>
+                <a16:creationId xmlns:a16="http://schemas.microsoft.com/office/drawing/2014/main" id="{66C5598E-6C80-4CDD-AE34-1BD1B3C8DA94}"/>
               </a:ext>
             </a:extLst>
           </p:cNvPr>
@@ -9278,7 +9278,7 @@
           <p:cNvPr id="21" name="">
             <a:extLst xmlns:a="http://schemas.openxmlformats.org/drawingml/2006/main">
               <a:ext uri="{FF2B5EF4-FFF2-40B4-BE49-F238E27FC236}">
-                <a16:creationId xmlns:a16="http://schemas.microsoft.com/office/drawing/2014/main" id="{0212001B-6C10-4390-B1F1-C3417DBF2ED7}"/>
+                <a16:creationId xmlns:a16="http://schemas.microsoft.com/office/drawing/2014/main" id="{B4110C87-7B9A-45CD-AB13-CA478F2E0A0D}"/>
               </a:ext>
             </a:extLst>
           </p:cNvPr>
@@ -9333,7 +9333,7 @@
     </p:spTree>
     <p:extLst>
       <p:ext uri="{BB962C8B-B14F-4D97-AF65-F5344CB8AC3E}">
-        <p14:creationId xmlns:p14="http://schemas.microsoft.com/office/powerpoint/2010/main" val="1181809321"/>
+        <p14:creationId xmlns:p14="http://schemas.microsoft.com/office/powerpoint/2010/main" val="820399632"/>
       </p:ext>
     </p:extLst>
   </p:cSld>
@@ -9364,7 +9364,7 @@
           <p:cNvPr id="16" name="">
             <a:extLst xmlns:a="http://schemas.openxmlformats.org/drawingml/2006/main">
               <a:ext uri="{FF2B5EF4-FFF2-40B4-BE49-F238E27FC236}">
-                <a16:creationId xmlns:a16="http://schemas.microsoft.com/office/drawing/2014/main" id="{68B12370-1680-44BA-B033-C308FB7E95A0}"/>
+                <a16:creationId xmlns:a16="http://schemas.microsoft.com/office/drawing/2014/main" id="{AACA5879-FB5E-48C1-8945-B66DFD155501}"/>
               </a:ext>
             </a:extLst>
           </p:cNvPr>
@@ -9394,7 +9394,7 @@
           <p:cNvPr id="2" name="">
             <a:extLst xmlns:a="http://schemas.openxmlformats.org/drawingml/2006/main">
               <a:ext uri="{FF2B5EF4-FFF2-40B4-BE49-F238E27FC236}">
-                <a16:creationId xmlns:a16="http://schemas.microsoft.com/office/drawing/2014/main" id="{C42B77CF-F30A-4369-80C0-48C857FEF520}"/>
+                <a16:creationId xmlns:a16="http://schemas.microsoft.com/office/drawing/2014/main" id="{E08011AD-E3AA-487B-8F8F-B7F7AFDC21DC}"/>
               </a:ext>
             </a:extLst>
           </p:cNvPr>
@@ -9451,7 +9451,7 @@
           <p:cNvPr id="3" name="">
             <a:extLst xmlns:a="http://schemas.openxmlformats.org/drawingml/2006/main">
               <a:ext uri="{FF2B5EF4-FFF2-40B4-BE49-F238E27FC236}">
-                <a16:creationId xmlns:a16="http://schemas.microsoft.com/office/drawing/2014/main" id="{728856EB-DE2B-44C2-B80E-3E8F0808E185}"/>
+                <a16:creationId xmlns:a16="http://schemas.microsoft.com/office/drawing/2014/main" id="{F4B32DC5-ACE9-40DF-A45E-AAB4E968CA5B}"/>
               </a:ext>
             </a:extLst>
           </p:cNvPr>
@@ -9508,7 +9508,7 @@
           <p:cNvPr id="4" name="">
             <a:extLst xmlns:a="http://schemas.openxmlformats.org/drawingml/2006/main">
               <a:ext uri="{FF2B5EF4-FFF2-40B4-BE49-F238E27FC236}">
-                <a16:creationId xmlns:a16="http://schemas.microsoft.com/office/drawing/2014/main" id="{7927E7CE-39BA-4C04-B27C-F204CC2BFFBC}"/>
+                <a16:creationId xmlns:a16="http://schemas.microsoft.com/office/drawing/2014/main" id="{6F93914C-052D-4D5B-92C5-3FC838AEB000}"/>
               </a:ext>
             </a:extLst>
           </p:cNvPr>
@@ -9565,7 +9565,7 @@
           <p:cNvPr id="5" name="">
             <a:extLst xmlns:a="http://schemas.openxmlformats.org/drawingml/2006/main">
               <a:ext uri="{FF2B5EF4-FFF2-40B4-BE49-F238E27FC236}">
-                <a16:creationId xmlns:a16="http://schemas.microsoft.com/office/drawing/2014/main" id="{16B298A5-2AAE-423B-B004-5073AE05AD98}"/>
+                <a16:creationId xmlns:a16="http://schemas.microsoft.com/office/drawing/2014/main" id="{6CFD8117-600B-49EC-B31C-1686ABE248F9}"/>
               </a:ext>
             </a:extLst>
           </p:cNvPr>
@@ -9622,7 +9622,7 @@
           <p:cNvPr id="6" name="">
             <a:extLst xmlns:a="http://schemas.openxmlformats.org/drawingml/2006/main">
               <a:ext uri="{FF2B5EF4-FFF2-40B4-BE49-F238E27FC236}">
-                <a16:creationId xmlns:a16="http://schemas.microsoft.com/office/drawing/2014/main" id="{49B66D9F-D684-42C6-92BB-089A1D555706}"/>
+                <a16:creationId xmlns:a16="http://schemas.microsoft.com/office/drawing/2014/main" id="{D4FB3C8F-1C39-4D2F-8686-33C166D3D13C}"/>
               </a:ext>
             </a:extLst>
           </p:cNvPr>
@@ -9679,7 +9679,7 @@
           <p:cNvPr id="7" name="">
             <a:extLst xmlns:a="http://schemas.openxmlformats.org/drawingml/2006/main">
               <a:ext uri="{FF2B5EF4-FFF2-40B4-BE49-F238E27FC236}">
-                <a16:creationId xmlns:a16="http://schemas.microsoft.com/office/drawing/2014/main" id="{382A2FB9-990C-4BC4-B3D9-EF85F854507C}"/>
+                <a16:creationId xmlns:a16="http://schemas.microsoft.com/office/drawing/2014/main" id="{BAEC3A43-2580-428E-964F-8042B81A9656}"/>
               </a:ext>
             </a:extLst>
           </p:cNvPr>
@@ -9736,7 +9736,7 @@
           <p:cNvPr id="8" name="">
             <a:extLst xmlns:a="http://schemas.openxmlformats.org/drawingml/2006/main">
               <a:ext uri="{FF2B5EF4-FFF2-40B4-BE49-F238E27FC236}">
-                <a16:creationId xmlns:a16="http://schemas.microsoft.com/office/drawing/2014/main" id="{0E8211DE-5794-41EF-AC47-4A75CFDF0901}"/>
+                <a16:creationId xmlns:a16="http://schemas.microsoft.com/office/drawing/2014/main" id="{3CE46B31-1E68-4430-AC50-4474B84C6321}"/>
               </a:ext>
             </a:extLst>
           </p:cNvPr>
@@ -9793,7 +9793,7 @@
           <p:cNvPr id="9" name="">
             <a:extLst xmlns:a="http://schemas.openxmlformats.org/drawingml/2006/main">
               <a:ext uri="{FF2B5EF4-FFF2-40B4-BE49-F238E27FC236}">
-                <a16:creationId xmlns:a16="http://schemas.microsoft.com/office/drawing/2014/main" id="{42B1A65A-B4F1-450A-A558-BB69E6521417}"/>
+                <a16:creationId xmlns:a16="http://schemas.microsoft.com/office/drawing/2014/main" id="{4A9960EC-C33F-4EC1-B1CB-5B60EB280C7F}"/>
               </a:ext>
             </a:extLst>
           </p:cNvPr>
@@ -9850,7 +9850,7 @@
           <p:cNvPr id="10" name="">
             <a:extLst xmlns:a="http://schemas.openxmlformats.org/drawingml/2006/main">
               <a:ext uri="{FF2B5EF4-FFF2-40B4-BE49-F238E27FC236}">
-                <a16:creationId xmlns:a16="http://schemas.microsoft.com/office/drawing/2014/main" id="{FA27152C-AD06-4643-A905-A1B2B86E87DB}"/>
+                <a16:creationId xmlns:a16="http://schemas.microsoft.com/office/drawing/2014/main" id="{AFDAFC6D-A90A-4512-98A8-0329B610841B}"/>
               </a:ext>
             </a:extLst>
           </p:cNvPr>
@@ -9907,7 +9907,7 @@
           <p:cNvPr id="11" name="">
             <a:extLst xmlns:a="http://schemas.openxmlformats.org/drawingml/2006/main">
               <a:ext uri="{FF2B5EF4-FFF2-40B4-BE49-F238E27FC236}">
-                <a16:creationId xmlns:a16="http://schemas.microsoft.com/office/drawing/2014/main" id="{51CC7187-7745-4EBF-84B5-AD8A52756B9A}"/>
+                <a16:creationId xmlns:a16="http://schemas.microsoft.com/office/drawing/2014/main" id="{7A0261D0-69E8-4E28-9BE2-23670560370D}"/>
               </a:ext>
             </a:extLst>
           </p:cNvPr>
@@ -9964,7 +9964,7 @@
           <p:cNvPr id="12" name="">
             <a:extLst xmlns:a="http://schemas.openxmlformats.org/drawingml/2006/main">
               <a:ext uri="{FF2B5EF4-FFF2-40B4-BE49-F238E27FC236}">
-                <a16:creationId xmlns:a16="http://schemas.microsoft.com/office/drawing/2014/main" id="{7C294C67-962D-48CA-AAEB-CD62452DE316}"/>
+                <a16:creationId xmlns:a16="http://schemas.microsoft.com/office/drawing/2014/main" id="{25B6F7E2-CD39-4306-A37D-0883C7D15C73}"/>
               </a:ext>
             </a:extLst>
           </p:cNvPr>
@@ -10021,7 +10021,7 @@
           <p:cNvPr id="13" name="">
             <a:extLst xmlns:a="http://schemas.openxmlformats.org/drawingml/2006/main">
               <a:ext uri="{FF2B5EF4-FFF2-40B4-BE49-F238E27FC236}">
-                <a16:creationId xmlns:a16="http://schemas.microsoft.com/office/drawing/2014/main" id="{89297E5D-14D2-48BA-9F23-DBFEBA73890C}"/>
+                <a16:creationId xmlns:a16="http://schemas.microsoft.com/office/drawing/2014/main" id="{02BB9959-2E66-403D-9358-3B4E39A8C6B0}"/>
               </a:ext>
             </a:extLst>
           </p:cNvPr>
@@ -10078,7 +10078,7 @@
           <p:cNvPr id="14" name="">
             <a:extLst xmlns:a="http://schemas.openxmlformats.org/drawingml/2006/main">
               <a:ext uri="{FF2B5EF4-FFF2-40B4-BE49-F238E27FC236}">
-                <a16:creationId xmlns:a16="http://schemas.microsoft.com/office/drawing/2014/main" id="{99725D28-A884-4F60-A174-FE77E19FAF67}"/>
+                <a16:creationId xmlns:a16="http://schemas.microsoft.com/office/drawing/2014/main" id="{76751E8E-23D3-4DF5-9840-16F02DDDE1FC}"/>
               </a:ext>
             </a:extLst>
           </p:cNvPr>
@@ -10135,7 +10135,7 @@
           <p:cNvPr id="15" name="">
             <a:extLst xmlns:a="http://schemas.openxmlformats.org/drawingml/2006/main">
               <a:ext uri="{FF2B5EF4-FFF2-40B4-BE49-F238E27FC236}">
-                <a16:creationId xmlns:a16="http://schemas.microsoft.com/office/drawing/2014/main" id="{D29F6C12-761B-42C9-9C96-B48DBF5C3428}"/>
+                <a16:creationId xmlns:a16="http://schemas.microsoft.com/office/drawing/2014/main" id="{761C6B6E-6D6E-40E3-A5ED-9E6BAE4295AB}"/>
               </a:ext>
             </a:extLst>
           </p:cNvPr>
@@ -10190,7 +10190,7 @@
     </p:spTree>
     <p:extLst>
       <p:ext uri="{BB962C8B-B14F-4D97-AF65-F5344CB8AC3E}">
-        <p14:creationId xmlns:p14="http://schemas.microsoft.com/office/powerpoint/2010/main" val="216230510"/>
+        <p14:creationId xmlns:p14="http://schemas.microsoft.com/office/powerpoint/2010/main" val="1779330724"/>
       </p:ext>
     </p:extLst>
   </p:cSld>
@@ -10221,7 +10221,7 @@
           <p:cNvPr id="11" name="">
             <a:extLst xmlns:a="http://schemas.openxmlformats.org/drawingml/2006/main">
               <a:ext uri="{FF2B5EF4-FFF2-40B4-BE49-F238E27FC236}">
-                <a16:creationId xmlns:a16="http://schemas.microsoft.com/office/drawing/2014/main" id="{F87F9366-E495-48EA-9E5A-DF10DD5FFB3F}"/>
+                <a16:creationId xmlns:a16="http://schemas.microsoft.com/office/drawing/2014/main" id="{D95C1E9C-B1D3-4A41-B4EB-4B265CA3CA42}"/>
               </a:ext>
             </a:extLst>
           </p:cNvPr>
@@ -10251,7 +10251,7 @@
           <p:cNvPr id="2" name="">
             <a:extLst xmlns:a="http://schemas.openxmlformats.org/drawingml/2006/main">
               <a:ext uri="{FF2B5EF4-FFF2-40B4-BE49-F238E27FC236}">
-                <a16:creationId xmlns:a16="http://schemas.microsoft.com/office/drawing/2014/main" id="{E8BAFA79-2921-40C9-BD28-063EA24367AE}"/>
+                <a16:creationId xmlns:a16="http://schemas.microsoft.com/office/drawing/2014/main" id="{5B522ED5-2112-4AF0-BC4D-C9F154D5E8F8}"/>
               </a:ext>
             </a:extLst>
           </p:cNvPr>
@@ -10308,7 +10308,7 @@
           <p:cNvPr id="3" name="">
             <a:extLst xmlns:a="http://schemas.openxmlformats.org/drawingml/2006/main">
               <a:ext uri="{FF2B5EF4-FFF2-40B4-BE49-F238E27FC236}">
-                <a16:creationId xmlns:a16="http://schemas.microsoft.com/office/drawing/2014/main" id="{ED2E51D2-E5C2-4F85-A279-813927EBD54D}"/>
+                <a16:creationId xmlns:a16="http://schemas.microsoft.com/office/drawing/2014/main" id="{858B9433-6729-4B7A-B3E7-9E28378549F6}"/>
               </a:ext>
             </a:extLst>
           </p:cNvPr>
@@ -10365,7 +10365,7 @@
           <p:cNvPr id="4" name="">
             <a:extLst xmlns:a="http://schemas.openxmlformats.org/drawingml/2006/main">
               <a:ext uri="{FF2B5EF4-FFF2-40B4-BE49-F238E27FC236}">
-                <a16:creationId xmlns:a16="http://schemas.microsoft.com/office/drawing/2014/main" id="{84832920-096A-4696-A811-E81813204E03}"/>
+                <a16:creationId xmlns:a16="http://schemas.microsoft.com/office/drawing/2014/main" id="{B2D22FF1-DBF9-4FC9-A46F-7246708068C8}"/>
               </a:ext>
             </a:extLst>
           </p:cNvPr>
@@ -10452,7 +10452,7 @@
           <p:cNvPr id="5" name="">
             <a:extLst xmlns:a="http://schemas.openxmlformats.org/drawingml/2006/main">
               <a:ext uri="{FF2B5EF4-FFF2-40B4-BE49-F238E27FC236}">
-                <a16:creationId xmlns:a16="http://schemas.microsoft.com/office/drawing/2014/main" id="{AE39B181-B378-469E-99C0-E496B57AB6D5}"/>
+                <a16:creationId xmlns:a16="http://schemas.microsoft.com/office/drawing/2014/main" id="{7EB76FD0-A4DC-478C-A6E7-60D9558EA206}"/>
               </a:ext>
             </a:extLst>
           </p:cNvPr>
@@ -10539,7 +10539,7 @@
           <p:cNvPr id="6" name="">
             <a:extLst xmlns:a="http://schemas.openxmlformats.org/drawingml/2006/main">
               <a:ext uri="{FF2B5EF4-FFF2-40B4-BE49-F238E27FC236}">
-                <a16:creationId xmlns:a16="http://schemas.microsoft.com/office/drawing/2014/main" id="{687EC76E-169D-4843-951B-CAAF1C3769DC}"/>
+                <a16:creationId xmlns:a16="http://schemas.microsoft.com/office/drawing/2014/main" id="{591C5312-67D4-42AB-940B-9823EA1BB378}"/>
               </a:ext>
             </a:extLst>
           </p:cNvPr>
@@ -10678,7 +10678,7 @@
           <p:cNvPr id="9" name="">
             <a:extLst xmlns:a="http://schemas.openxmlformats.org/drawingml/2006/main">
               <a:ext uri="{FF2B5EF4-FFF2-40B4-BE49-F238E27FC236}">
-                <a16:creationId xmlns:a16="http://schemas.microsoft.com/office/drawing/2014/main" id="{4AD393B7-7F87-4BC6-AF3C-4F414A6397DE}"/>
+                <a16:creationId xmlns:a16="http://schemas.microsoft.com/office/drawing/2014/main" id="{D0B45B80-3E45-485F-A15B-5CC969E5E7AC}"/>
               </a:ext>
             </a:extLst>
           </p:cNvPr>
@@ -10735,7 +10735,7 @@
           <p:cNvPr id="10" name="">
             <a:extLst xmlns:a="http://schemas.openxmlformats.org/drawingml/2006/main">
               <a:ext uri="{FF2B5EF4-FFF2-40B4-BE49-F238E27FC236}">
-                <a16:creationId xmlns:a16="http://schemas.microsoft.com/office/drawing/2014/main" id="{C49E9140-878D-4E9B-ACFF-906741B80F28}"/>
+                <a16:creationId xmlns:a16="http://schemas.microsoft.com/office/drawing/2014/main" id="{9142F618-E4FD-4187-BDEB-BBD34C4C7007}"/>
               </a:ext>
             </a:extLst>
           </p:cNvPr>
@@ -10790,7 +10790,7 @@
     </p:spTree>
     <p:extLst>
       <p:ext uri="{BB962C8B-B14F-4D97-AF65-F5344CB8AC3E}">
-        <p14:creationId xmlns:p14="http://schemas.microsoft.com/office/powerpoint/2010/main" val="1880273524"/>
+        <p14:creationId xmlns:p14="http://schemas.microsoft.com/office/powerpoint/2010/main" val="1761314659"/>
       </p:ext>
     </p:extLst>
   </p:cSld>
@@ -10821,7 +10821,7 @@
           <p:cNvPr id="12" name="">
             <a:extLst xmlns:a="http://schemas.openxmlformats.org/drawingml/2006/main">
               <a:ext uri="{FF2B5EF4-FFF2-40B4-BE49-F238E27FC236}">
-                <a16:creationId xmlns:a16="http://schemas.microsoft.com/office/drawing/2014/main" id="{6D58DEEF-FDF7-4696-AA8C-5D32501BEA2C}"/>
+                <a16:creationId xmlns:a16="http://schemas.microsoft.com/office/drawing/2014/main" id="{05B1E945-C56C-4C2D-A219-9CD8FD3D588E}"/>
               </a:ext>
             </a:extLst>
           </p:cNvPr>
@@ -10851,7 +10851,7 @@
           <p:cNvPr id="2" name="">
             <a:extLst xmlns:a="http://schemas.openxmlformats.org/drawingml/2006/main">
               <a:ext uri="{FF2B5EF4-FFF2-40B4-BE49-F238E27FC236}">
-                <a16:creationId xmlns:a16="http://schemas.microsoft.com/office/drawing/2014/main" id="{F4114B2B-1C7B-4457-BBED-7D2109602C52}"/>
+                <a16:creationId xmlns:a16="http://schemas.microsoft.com/office/drawing/2014/main" id="{4E9CF62A-1211-4DEE-96C7-9A964F677504}"/>
               </a:ext>
             </a:extLst>
           </p:cNvPr>
@@ -10908,7 +10908,7 @@
           <p:cNvPr id="3" name="">
             <a:extLst xmlns:a="http://schemas.openxmlformats.org/drawingml/2006/main">
               <a:ext uri="{FF2B5EF4-FFF2-40B4-BE49-F238E27FC236}">
-                <a16:creationId xmlns:a16="http://schemas.microsoft.com/office/drawing/2014/main" id="{C7010A5F-2D65-435F-8CAE-22A198B377C0}"/>
+                <a16:creationId xmlns:a16="http://schemas.microsoft.com/office/drawing/2014/main" id="{56E080EE-0864-4100-8870-85F9441C7C1F}"/>
               </a:ext>
             </a:extLst>
           </p:cNvPr>
@@ -10965,7 +10965,7 @@
           <p:cNvPr id="4" name="">
             <a:extLst xmlns:a="http://schemas.openxmlformats.org/drawingml/2006/main">
               <a:ext uri="{FF2B5EF4-FFF2-40B4-BE49-F238E27FC236}">
-                <a16:creationId xmlns:a16="http://schemas.microsoft.com/office/drawing/2014/main" id="{B528E920-9475-4033-9C8C-CD03AA670F7F}"/>
+                <a16:creationId xmlns:a16="http://schemas.microsoft.com/office/drawing/2014/main" id="{A2538623-40DD-4F14-97A2-A716DF13588A}"/>
               </a:ext>
             </a:extLst>
           </p:cNvPr>
@@ -11052,7 +11052,7 @@
           <p:cNvPr id="5" name="">
             <a:extLst xmlns:a="http://schemas.openxmlformats.org/drawingml/2006/main">
               <a:ext uri="{FF2B5EF4-FFF2-40B4-BE49-F238E27FC236}">
-                <a16:creationId xmlns:a16="http://schemas.microsoft.com/office/drawing/2014/main" id="{593FBED0-58E5-423C-ABC8-8192228E3CEB}"/>
+                <a16:creationId xmlns:a16="http://schemas.microsoft.com/office/drawing/2014/main" id="{6D7020B9-3B5D-49E7-B5FA-8B69A42F2E75}"/>
               </a:ext>
             </a:extLst>
           </p:cNvPr>
@@ -11139,7 +11139,7 @@
           <p:cNvPr id="6" name="">
             <a:extLst xmlns:a="http://schemas.openxmlformats.org/drawingml/2006/main">
               <a:ext uri="{FF2B5EF4-FFF2-40B4-BE49-F238E27FC236}">
-                <a16:creationId xmlns:a16="http://schemas.microsoft.com/office/drawing/2014/main" id="{16DBF88D-75DC-462F-BCC4-C5FE24AE74D2}"/>
+                <a16:creationId xmlns:a16="http://schemas.microsoft.com/office/drawing/2014/main" id="{2FF0B7E8-50C7-4C21-8160-581554DEB44F}"/>
               </a:ext>
             </a:extLst>
           </p:cNvPr>
@@ -11226,7 +11226,7 @@
           <p:cNvPr id="7" name="">
             <a:extLst xmlns:a="http://schemas.openxmlformats.org/drawingml/2006/main">
               <a:ext uri="{FF2B5EF4-FFF2-40B4-BE49-F238E27FC236}">
-                <a16:creationId xmlns:a16="http://schemas.microsoft.com/office/drawing/2014/main" id="{BE4B8A44-434D-4098-A095-5D1F8EE02F21}"/>
+                <a16:creationId xmlns:a16="http://schemas.microsoft.com/office/drawing/2014/main" id="{48013CE8-F278-441A-A20A-C6EDD343269F}"/>
               </a:ext>
             </a:extLst>
           </p:cNvPr>
@@ -11238,11 +11238,11 @@
         <p:spPr>
           <a:xfrm xmlns:a="http://schemas.openxmlformats.org/drawingml/2006/main">
             <a:off x="7334250" y="3429000"/>
-            <a:ext cx="2095500" cy="857250"/>
+            <a:ext cx="2095500" cy="1047750"/>
           </a:xfrm>
           <a:prstGeom xmlns:a="http://schemas.openxmlformats.org/drawingml/2006/main" prst="roundRect">
             <a:avLst>
-              <a:gd name="adj" fmla="val 15556"/>
+              <a:gd name="adj" fmla="val 12727"/>
             </a:avLst>
           </a:prstGeom>
           <a:solidFill xmlns:a="http://schemas.openxmlformats.org/drawingml/2006/main">
@@ -11374,7 +11374,7 @@
         <p:spPr>
           <a:xfrm xmlns:a="http://schemas.openxmlformats.org/drawingml/2006/main">
             <a:off x="6000750" y="2952750"/>
-            <a:ext cx="1333500" cy="904875"/>
+            <a:ext cx="1333500" cy="1000125"/>
           </a:xfrm>
           <a:prstGeom xmlns:a="http://schemas.openxmlformats.org/drawingml/2006/main" prst="bentConnector3">
             <a:avLst>
@@ -11395,7 +11395,7 @@
           <p:cNvPr id="11" name="">
             <a:extLst xmlns:a="http://schemas.openxmlformats.org/drawingml/2006/main">
               <a:ext uri="{FF2B5EF4-FFF2-40B4-BE49-F238E27FC236}">
-                <a16:creationId xmlns:a16="http://schemas.microsoft.com/office/drawing/2014/main" id="{E4E2F332-636B-410B-A66D-C85F02288BD7}"/>
+                <a16:creationId xmlns:a16="http://schemas.microsoft.com/office/drawing/2014/main" id="{2BA9E0A6-3DE8-4DFC-8CE2-6FC1E0C62E96}"/>
               </a:ext>
             </a:extLst>
           </p:cNvPr>
@@ -11450,7 +11450,7 @@
     </p:spTree>
     <p:extLst>
       <p:ext uri="{BB962C8B-B14F-4D97-AF65-F5344CB8AC3E}">
-        <p14:creationId xmlns:p14="http://schemas.microsoft.com/office/powerpoint/2010/main" val="1814719520"/>
+        <p14:creationId xmlns:p14="http://schemas.microsoft.com/office/powerpoint/2010/main" val="1047457400"/>
       </p:ext>
     </p:extLst>
   </p:cSld>

</xml_diff>

<commit_message>
docs: alinha entrega ao guia e aos marcos de novembro
</commit_message>
<xml_diff>
--- a/output/Apresentacao_Cenario_4.pptx
+++ b/output/Apresentacao_Cenario_4.pptx
@@ -2,30 +2,30 @@
 <file path=ppt/presentation.xml><?xml version="1.0" encoding="utf-8"?>
 <p:presentation xmlns:p="http://schemas.openxmlformats.org/presentationml/2006/main">
   <p:sldMasterIdLst>
-    <p:sldMasterId xmlns:r="http://schemas.openxmlformats.org/officeDocument/2006/relationships" id="2147483648" r:id="R6fca8afdb6824539"/>
+    <p:sldMasterId xmlns:r="http://schemas.openxmlformats.org/officeDocument/2006/relationships" id="2147483648" r:id="Rcffed83e686440b7"/>
   </p:sldMasterIdLst>
   <p:notesMasterIdLst>
-    <p:notesMasterId xmlns:r="http://schemas.openxmlformats.org/officeDocument/2006/relationships" r:id="R7ca66f6d40a4440c"/>
+    <p:notesMasterId xmlns:r="http://schemas.openxmlformats.org/officeDocument/2006/relationships" r:id="Rec5116ca5b6d4406"/>
   </p:notesMasterIdLst>
   <p:sldIdLst>
-    <p:sldId xmlns:r="http://schemas.openxmlformats.org/officeDocument/2006/relationships" id="256" r:id="R071185443a0d4dc9"/>
-    <p:sldId xmlns:r="http://schemas.openxmlformats.org/officeDocument/2006/relationships" id="257" r:id="Ra1cac1bf3e5a443c"/>
-    <p:sldId xmlns:r="http://schemas.openxmlformats.org/officeDocument/2006/relationships" id="258" r:id="Recbe8cb03b464ef0"/>
-    <p:sldId xmlns:r="http://schemas.openxmlformats.org/officeDocument/2006/relationships" id="259" r:id="R5967fdacdc2c43d3"/>
-    <p:sldId xmlns:r="http://schemas.openxmlformats.org/officeDocument/2006/relationships" id="260" r:id="R0266d84eced943bf"/>
-    <p:sldId xmlns:r="http://schemas.openxmlformats.org/officeDocument/2006/relationships" id="261" r:id="R6967d862dfc84338"/>
-    <p:sldId xmlns:r="http://schemas.openxmlformats.org/officeDocument/2006/relationships" id="262" r:id="R88abd5c3b1e54cc6"/>
-    <p:sldId xmlns:r="http://schemas.openxmlformats.org/officeDocument/2006/relationships" id="263" r:id="R78c7142ffc4f481b"/>
-    <p:sldId xmlns:r="http://schemas.openxmlformats.org/officeDocument/2006/relationships" id="264" r:id="R753bb430fcfb4baf"/>
-    <p:sldId xmlns:r="http://schemas.openxmlformats.org/officeDocument/2006/relationships" id="265" r:id="Rf7dfcbc5a0e542f7"/>
-    <p:sldId xmlns:r="http://schemas.openxmlformats.org/officeDocument/2006/relationships" id="266" r:id="Re21c362acffc4b0f"/>
-    <p:sldId xmlns:r="http://schemas.openxmlformats.org/officeDocument/2006/relationships" id="267" r:id="Re9eaf8dcf90d4414"/>
-    <p:sldId xmlns:r="http://schemas.openxmlformats.org/officeDocument/2006/relationships" id="268" r:id="R5d46dfa8cb9c47d1"/>
-    <p:sldId xmlns:r="http://schemas.openxmlformats.org/officeDocument/2006/relationships" id="269" r:id="R712e55b3022c4a61"/>
-    <p:sldId xmlns:r="http://schemas.openxmlformats.org/officeDocument/2006/relationships" id="270" r:id="Rd26d67b40fe7446b"/>
-    <p:sldId xmlns:r="http://schemas.openxmlformats.org/officeDocument/2006/relationships" id="271" r:id="Rfa05c6175e60456a"/>
-    <p:sldId xmlns:r="http://schemas.openxmlformats.org/officeDocument/2006/relationships" id="272" r:id="Ra34050f536f84071"/>
-    <p:sldId xmlns:r="http://schemas.openxmlformats.org/officeDocument/2006/relationships" id="273" r:id="Rc4c876d3b865479e"/>
+    <p:sldId xmlns:r="http://schemas.openxmlformats.org/officeDocument/2006/relationships" id="256" r:id="R70f2fb8122a143e3"/>
+    <p:sldId xmlns:r="http://schemas.openxmlformats.org/officeDocument/2006/relationships" id="257" r:id="R2b8105c23204438c"/>
+    <p:sldId xmlns:r="http://schemas.openxmlformats.org/officeDocument/2006/relationships" id="258" r:id="R7363dd76906e44b6"/>
+    <p:sldId xmlns:r="http://schemas.openxmlformats.org/officeDocument/2006/relationships" id="259" r:id="R3bbe767dbc964fbe"/>
+    <p:sldId xmlns:r="http://schemas.openxmlformats.org/officeDocument/2006/relationships" id="260" r:id="R76d7ecbf96f64751"/>
+    <p:sldId xmlns:r="http://schemas.openxmlformats.org/officeDocument/2006/relationships" id="261" r:id="Ra64731bf21ca4775"/>
+    <p:sldId xmlns:r="http://schemas.openxmlformats.org/officeDocument/2006/relationships" id="262" r:id="Rfd4991d09e5c4c83"/>
+    <p:sldId xmlns:r="http://schemas.openxmlformats.org/officeDocument/2006/relationships" id="263" r:id="R2f1bbfb9e5794c92"/>
+    <p:sldId xmlns:r="http://schemas.openxmlformats.org/officeDocument/2006/relationships" id="264" r:id="R25282741b1fc49b8"/>
+    <p:sldId xmlns:r="http://schemas.openxmlformats.org/officeDocument/2006/relationships" id="265" r:id="Rb581c503e40f4d0c"/>
+    <p:sldId xmlns:r="http://schemas.openxmlformats.org/officeDocument/2006/relationships" id="266" r:id="R22f5705bcf55436d"/>
+    <p:sldId xmlns:r="http://schemas.openxmlformats.org/officeDocument/2006/relationships" id="267" r:id="Rd38aa7207c77460a"/>
+    <p:sldId xmlns:r="http://schemas.openxmlformats.org/officeDocument/2006/relationships" id="268" r:id="Rf558f02d4c144158"/>
+    <p:sldId xmlns:r="http://schemas.openxmlformats.org/officeDocument/2006/relationships" id="269" r:id="R7c93be25e1bb42db"/>
+    <p:sldId xmlns:r="http://schemas.openxmlformats.org/officeDocument/2006/relationships" id="270" r:id="Rcc4ed3db59194c39"/>
+    <p:sldId xmlns:r="http://schemas.openxmlformats.org/officeDocument/2006/relationships" id="271" r:id="R8d1bd44f480847ed"/>
+    <p:sldId xmlns:r="http://schemas.openxmlformats.org/officeDocument/2006/relationships" id="272" r:id="R65a23ba236764be3"/>
+    <p:sldId xmlns:r="http://schemas.openxmlformats.org/officeDocument/2006/relationships" id="273" r:id="Ra5737860e902456d"/>
   </p:sldIdLst>
   <p:sldSz cx="12192000" cy="6858000"/>
   <p:notesSz cx="6858000" cy="9144000"/>
@@ -459,7 +459,7 @@
           <a:lstStyle xmlns:a="http://schemas.openxmlformats.org/drawingml/2006/main"/>
           <a:p xmlns:a="http://schemas.openxmlformats.org/drawingml/2006/main">
             <a:r>
-              <a:t>Fonte principal: Projeto Aplicado ArchCorp, enunciado acadêmico, 2026. Cenário 4 aplicado a uma locadora fictícia inspirada na Localiza, com dados sintéticos.</a:t>
+              <a:t>Fonte principal: Guia.pdf, enunciado acadêmico ArchCorp, 2026, 13 páginas. Cenário 4 aplicado a uma locadora fictícia inspirada na Localiza, com dados sintéticos. Referência técnica: main f1669d78f01e2d279b3de60a999ed778e6c9916e, PR #75 de 25/10/2026, https://github.com/Roger-Quinelato/projetoAplicado7/pull/75, commit consultado localmente. Marcos previstos conforme orientação da entrega. Autoria e contribuições aguardam informação da equipe. Não há declaração de aceite docente.</a:t>
             </a:r>
           </a:p>
         </p:txBody>
@@ -529,7 +529,7 @@
           <a:lstStyle xmlns:a="http://schemas.openxmlformats.org/drawingml/2006/main"/>
           <a:p xmlns:a="http://schemas.openxmlformats.org/drawingml/2006/main">
             <a:r>
-              <a:t>Fonte: docs/INTEGRACOES.md, ADR-006 e scripts/demo_f1.py executado contra a API local em 17/10/2026.</a:t>
+              <a:t>Fonte: docs/INTEGRACOES.md, scripts/demo_f1.py e evidência histórica consolidada em docs/EVIDENCIAS_VALIDACAO.md (20/10/2026). Não reexecutado em 28/10. ADR-006 permanece Proposto, aguardando aceite do responsável. A chamada no mesmo processo não tem interrupção por timeout de rede.</a:t>
             </a:r>
           </a:p>
         </p:txBody>
@@ -599,7 +599,7 @@
           <a:lstStyle xmlns:a="http://schemas.openxmlformats.org/drawingml/2006/main"/>
           <a:p xmlns:a="http://schemas.openxmlformats.org/drawingml/2006/main">
             <a:r>
-              <a:t>Fonte: docs/INTEGRACOES.md, teste test_f2_ativacao_cria_uma_cobranca_e_uma_preparacao_de_retirada e scripts/demo_f2.py.</a:t>
+              <a:t>Fonte: docs/INTEGRACOES.md, scripts/demo_f2.py e evidência histórica consolidada em docs/EVIDENCIAS_VALIDACAO.md (20/10/2026). Não reexecutado em 28/10. O despachante invoca os consumidores internos; RabbitMQ recebe uma cópia opcional e não executa esses consumidores.</a:t>
             </a:r>
           </a:p>
         </p:txBody>
@@ -669,7 +669,7 @@
           <a:lstStyle xmlns:a="http://schemas.openxmlformats.org/drawingml/2006/main"/>
           <a:p xmlns:a="http://schemas.openxmlformats.org/drawingml/2006/main">
             <a:r>
-              <a:t>Fonte: docs/INTEGRACOES.md, testes de F3 e indisponibilidade e scripts/demo_f3.py.</a:t>
+              <a:t>Fonte: docs/INTEGRACOES.md, scripts/demo_f3.py e evidência histórica consolidada em docs/EVIDENCIAS_VALIDACAO.md (20/10/2026). Revisão de código e reprodução informadas pela equipe em 28/10: se TicketOpened falha e TicketResolved é consumido antes da recuperação, handle_ticket_resolved retorna sem processo; a abertura reprocessada depois cria STARTED embora o chamado esteja RESOLVED, sem pendências restantes que assegurem a convergência (src/archcorp/workflow/service.py, handle_ticket_resolved). Defeito não corrigido nesta revisão documental. A reconciliação de elegibilidade depende de ação explícita, sem agendador. Os resultados históricos não comprovam todos os casos de ordenação de eventos.</a:t>
             </a:r>
           </a:p>
         </p:txBody>
@@ -809,7 +809,7 @@
           <a:lstStyle xmlns:a="http://schemas.openxmlformats.org/drawingml/2006/main"/>
           <a:p xmlns:a="http://schemas.openxmlformats.org/drawingml/2006/main">
             <a:r>
-              <a:t>Fonte: docs/ATRIBUTOS_QUALIDADE.md (nove atributos com necessidade, risco, estratégia, resultado e evidência) e relatório, seção 4.8.</a:t>
+              <a:t>Fonte: docs/ATRIBUTOS_QUALIDADE.md (nove atributos com necessidade, risco, estratégia, resultado e evidência) e relatório, seção 4.8. Desempenho histórico de 20/10, local, PostgreSQL 16, 60 clientes e 100 amostras por consulta em 10 consultas de negócio. Não representa hospedagem pública nem medição na main f1669d7.</a:t>
             </a:r>
           </a:p>
         </p:txBody>
@@ -879,7 +879,7 @@
           <a:lstStyle xmlns:a="http://schemas.openxmlformats.org/drawingml/2006/main"/>
           <a:p xmlns:a="http://schemas.openxmlformats.org/drawingml/2006/main">
             <a:r>
-              <a:t>Fonte: docs/ATRIBUTOS_QUALIDADE.md e docs/EVIDENCIAS_VALIDACAO.md.</a:t>
+              <a:t>Fonte: docs/ATRIBUTOS_QUALIDADE.md e docs/EVIDENCIAS_VALIDACAO.md. Correções de segurança: main f1669d7, PR #75, 25/10/2026, https://github.com/Roger-Quinelato/projetoAplicado7/pull/75, registro local do commit. Credencial com caracteres não ASCII comparada em bytes, exceção inesperada registra só errorType. FAILED é estado persistido da aplicação, não fila de erro RabbitMQ. Sem OIDC e sem tracing distribuído.</a:t>
             </a:r>
           </a:p>
         </p:txBody>
@@ -1019,7 +1019,7 @@
           <a:lstStyle xmlns:a="http://schemas.openxmlformats.org/drawingml/2006/main"/>
           <a:p xmlns:a="http://schemas.openxmlformats.org/drawingml/2006/main">
             <a:r>
-              <a:t>Fonte: docs/EVIDENCIAS_VALIDACAO.md. Em 17/10/2026: 211 testes aprovados e 10 ignorados (PostgreSQL/RabbitMQ reais); roteiros demo_f1/f2/f3 contra uvicorn local; p95 de 200 consultas de prontidão em Windows 11, Python 3.12, SQLite.</a:t>
+              <a:t>Fontes: docs/EVIDENCIAS_VALIDACAO.md, seções históricas de 20/10/2026; registro local do commit f1669d78f01e2d279b3de60a999ed778e6c9916e, PR #75, 25/10/2026, https://github.com/Roger-Quinelato/projetoAplicado7/pull/75; logs da CI Verify 40199072801, https://github.com/Roger-Quinelato/projetoAplicado7/actions/runs/40199072801, executada em 25/10 sobre essa main, consultados no GitHub Actions em 28/10/2026. Quatro jobs success: application 252 passed/14 skipped; postgresql 262 passed/4 skipped; rabbitmq 22 passed; e2e 25 passed e axe separado 1 passed. Suítes sobrepostas, sem total agregado. Histórico de 20/10: PostgreSQL 16/RabbitMQ 3.12 locais, contêiner Linux, Python 3.13, 60 clientes, 100 amostras por consulta em 10 consultas de negócio, p95 máximo de 45,1 ms, 22 roteiros de navegador, F1 20/20, F2 14/14 e F3 15/15. O p95 não foi medido novamente na main f1669d7. Verificação local de 28/10: Python 252 aprovados e 14 ignorados, frontend 19 aprovados, TypeScript e OpenAPI check aprovados. Hospedagem pública e PostgreSQL gerenciado sem comprovação.</a:t>
             </a:r>
           </a:p>
         </p:txBody>
@@ -1089,7 +1089,7 @@
           <a:lstStyle xmlns:a="http://schemas.openxmlformats.org/drawingml/2006/main"/>
           <a:p xmlns:a="http://schemas.openxmlformats.org/drawingml/2006/main">
             <a:r>
-              <a:t>Fonte: relatório técnico, seções 4.10 e 5, e docs/EVOLUCAO_MANUTENCAO.md. Inserir nomes e contribuições individuais antes da submissão.</a:t>
+              <a:t>Fontes: relatório técnico, seções 3.1, 3.4, 4.10 e 5, docs/EVOLUCAO_MANUTENCAO.md e ADR-006 (Proposto). Revisão e reproduções informadas em 28/10/2026: F3 perde a convergência se TicketResolved é consumido antes de recuperar TicketOpened; encerramento de contrato pode deixar processo COMPLETED com tarefa CANCELLED; leitura financeira calcula OVERDUE enquanto o comando de cancelamento usa OPEN persistido. Conferência: src/archcorp/workflow/service.py (handle_ticket_resolved e handle_contract_closed), src/archcorp/finance/service.py (cancel) e domain.py. Defeitos conhecidos não corrigidos nesta revisão documental. Verificação local de 28/10 informada: Python 252 aprovados/14 ignorados, frontend 19 aprovados, TypeScript e OpenAPI check aprovados. Não somar suítes. Marcos previstos conforme orientação da entrega. Nomes e contribuições individuais necessários para a submissão. Premissas e ADR-006 aguardam validação ou aceite. Publicação, OIDC e agendador são evolução. O merge do PR #75 não equivale a aceite docente nem à validação das premissas.</a:t>
             </a:r>
           </a:p>
         </p:txBody>
@@ -1579,7 +1579,7 @@
           <a:lstStyle xmlns:a="http://schemas.openxmlformats.org/drawingml/2006/main"/>
           <a:p xmlns:a="http://schemas.openxmlformats.org/drawingml/2006/main">
             <a:r>
-              <a:t>Fonte: AGENT.md, tabela de propriedade dos dados, e plano de implementação, seção 6.</a:t>
+              <a:t>Fonte: AGENTS.md, tabela de propriedade dos dados, e plano de implementação, seção 6.</a:t>
             </a:r>
           </a:p>
         </p:txBody>
@@ -1696,7 +1696,7 @@
           <p:cNvPr id="3" name="Title">
             <a:extLst xmlns:a="http://schemas.openxmlformats.org/drawingml/2006/main">
               <a:ext uri="{FF2B5EF4-FFF2-40B4-BE49-F238E27FC236}">
-                <a16:creationId xmlns:a16="http://schemas.microsoft.com/office/drawing/2014/main" id="{8EF60EC6-5F39-45BC-AE31-66CB0272E883}"/>
+                <a16:creationId xmlns:a16="http://schemas.microsoft.com/office/drawing/2014/main" id="{52F22302-607E-4512-BF2F-35012247082E}"/>
               </a:ext>
             </a:extLst>
           </p:cNvPr>
@@ -1925,7 +1925,7 @@
           <p:cNvPr id="2" name="Subtitle">
             <a:extLst xmlns:a="http://schemas.openxmlformats.org/drawingml/2006/main">
               <a:ext uri="{FF2B5EF4-FFF2-40B4-BE49-F238E27FC236}">
-                <a16:creationId xmlns:a16="http://schemas.microsoft.com/office/drawing/2014/main" id="{5939D9FA-5325-4842-8309-D5085AA9C149}"/>
+                <a16:creationId xmlns:a16="http://schemas.microsoft.com/office/drawing/2014/main" id="{E14BB22B-78CA-4208-9251-2A613260C8CF}"/>
               </a:ext>
             </a:extLst>
           </p:cNvPr>
@@ -2171,7 +2171,7 @@
           <p:cNvPr id="2" name="Section title">
             <a:extLst xmlns:a="http://schemas.openxmlformats.org/drawingml/2006/main">
               <a:ext uri="{FF2B5EF4-FFF2-40B4-BE49-F238E27FC236}">
-                <a16:creationId xmlns:a16="http://schemas.microsoft.com/office/drawing/2014/main" id="{EC74F1F8-AE8B-4EA3-A0F7-63F7D8AEA5F8}"/>
+                <a16:creationId xmlns:a16="http://schemas.microsoft.com/office/drawing/2014/main" id="{3CF94330-2524-4EBB-AEF8-E29845BE2AF3}"/>
               </a:ext>
             </a:extLst>
           </p:cNvPr>
@@ -2417,7 +2417,7 @@
           <p:cNvPr id="3" name="Title">
             <a:extLst xmlns:a="http://schemas.openxmlformats.org/drawingml/2006/main">
               <a:ext uri="{FF2B5EF4-FFF2-40B4-BE49-F238E27FC236}">
-                <a16:creationId xmlns:a16="http://schemas.microsoft.com/office/drawing/2014/main" id="{B0FA8B7B-6501-49CE-9553-5BC9A29F03E2}"/>
+                <a16:creationId xmlns:a16="http://schemas.microsoft.com/office/drawing/2014/main" id="{721AE563-DBC9-42F5-B80D-C607DCB7F038}"/>
               </a:ext>
             </a:extLst>
           </p:cNvPr>
@@ -2646,7 +2646,7 @@
           <p:cNvPr id="2" name="Body">
             <a:extLst xmlns:a="http://schemas.openxmlformats.org/drawingml/2006/main">
               <a:ext uri="{FF2B5EF4-FFF2-40B4-BE49-F238E27FC236}">
-                <a16:creationId xmlns:a16="http://schemas.microsoft.com/office/drawing/2014/main" id="{DD0B66D0-CB67-49F2-B934-680A5892B159}"/>
+                <a16:creationId xmlns:a16="http://schemas.microsoft.com/office/drawing/2014/main" id="{BA95F0B2-2A24-40EB-9361-5E15DDDF2149}"/>
               </a:ext>
             </a:extLst>
           </p:cNvPr>
@@ -2892,7 +2892,7 @@
           <p:cNvPr id="4" name="Title">
             <a:extLst xmlns:a="http://schemas.openxmlformats.org/drawingml/2006/main">
               <a:ext uri="{FF2B5EF4-FFF2-40B4-BE49-F238E27FC236}">
-                <a16:creationId xmlns:a16="http://schemas.microsoft.com/office/drawing/2014/main" id="{746B2D54-1727-4DD0-AF15-C68FE27395AB}"/>
+                <a16:creationId xmlns:a16="http://schemas.microsoft.com/office/drawing/2014/main" id="{78E8EB24-8293-4430-875A-5C7748B62647}"/>
               </a:ext>
             </a:extLst>
           </p:cNvPr>
@@ -3121,7 +3121,7 @@
           <p:cNvPr id="2" name="Left column">
             <a:extLst xmlns:a="http://schemas.openxmlformats.org/drawingml/2006/main">
               <a:ext uri="{FF2B5EF4-FFF2-40B4-BE49-F238E27FC236}">
-                <a16:creationId xmlns:a16="http://schemas.microsoft.com/office/drawing/2014/main" id="{AB86D2AE-70EA-42E2-B307-0548152C1E98}"/>
+                <a16:creationId xmlns:a16="http://schemas.microsoft.com/office/drawing/2014/main" id="{919CB7B3-A0DB-46DC-B133-293C706F676F}"/>
               </a:ext>
             </a:extLst>
           </p:cNvPr>
@@ -3350,7 +3350,7 @@
           <p:cNvPr id="3" name="Right column">
             <a:extLst xmlns:a="http://schemas.openxmlformats.org/drawingml/2006/main">
               <a:ext uri="{FF2B5EF4-FFF2-40B4-BE49-F238E27FC236}">
-                <a16:creationId xmlns:a16="http://schemas.microsoft.com/office/drawing/2014/main" id="{3B8D108E-8D22-4418-A6EC-3929487F46F8}"/>
+                <a16:creationId xmlns:a16="http://schemas.microsoft.com/office/drawing/2014/main" id="{DA6BEEC1-7019-4639-8343-154E984ED655}"/>
               </a:ext>
             </a:extLst>
           </p:cNvPr>
@@ -3596,7 +3596,7 @@
           <p:cNvPr id="3" name="Title">
             <a:extLst xmlns:a="http://schemas.openxmlformats.org/drawingml/2006/main">
               <a:ext uri="{FF2B5EF4-FFF2-40B4-BE49-F238E27FC236}">
-                <a16:creationId xmlns:a16="http://schemas.microsoft.com/office/drawing/2014/main" id="{AFA95225-DDF9-4C0B-A99D-BC8A5468198A}"/>
+                <a16:creationId xmlns:a16="http://schemas.microsoft.com/office/drawing/2014/main" id="{86A42B9C-010B-43A0-B4B9-1357D249C352}"/>
               </a:ext>
             </a:extLst>
           </p:cNvPr>
@@ -3825,7 +3825,7 @@
           <p:cNvPr id="2" name="Left column">
             <a:extLst xmlns:a="http://schemas.openxmlformats.org/drawingml/2006/main">
               <a:ext uri="{FF2B5EF4-FFF2-40B4-BE49-F238E27FC236}">
-                <a16:creationId xmlns:a16="http://schemas.microsoft.com/office/drawing/2014/main" id="{7857505B-0AC6-4251-A20D-36C84D9F3983}"/>
+                <a16:creationId xmlns:a16="http://schemas.microsoft.com/office/drawing/2014/main" id="{8C42A9B8-8B44-4C2D-BC31-948054B892B0}"/>
               </a:ext>
             </a:extLst>
           </p:cNvPr>
@@ -4092,12 +4092,12 @@
   </p:cSld>
   <p:clrMap bg1="lt1" tx1="dk1" bg2="lt2" tx2="dk2" accent1="accent1" accent2="accent2" accent3="accent3" accent4="accent4" accent5="accent5" accent6="accent6" hlink="hlink" folHlink="folHlink"/>
   <p:sldLayoutIdLst>
-    <p:sldLayoutId xmlns:r="http://schemas.openxmlformats.org/officeDocument/2006/relationships" id="2147483649" r:id="Rde6f38cf631f41c3"/>
-    <p:sldLayoutId xmlns:r="http://schemas.openxmlformats.org/officeDocument/2006/relationships" id="2147483650" r:id="R0ac39e635ff24be1"/>
-    <p:sldLayoutId xmlns:r="http://schemas.openxmlformats.org/officeDocument/2006/relationships" id="2147483651" r:id="R5781e1fd1ea64c6b"/>
-    <p:sldLayoutId xmlns:r="http://schemas.openxmlformats.org/officeDocument/2006/relationships" id="2147483652" r:id="Rc5a35a0954fc4d81"/>
-    <p:sldLayoutId xmlns:r="http://schemas.openxmlformats.org/officeDocument/2006/relationships" id="2147483653" r:id="R2b23f75af8064e2f"/>
-    <p:sldLayoutId xmlns:r="http://schemas.openxmlformats.org/officeDocument/2006/relationships" id="2147483654" r:id="R75a9ee88cbf84394"/>
+    <p:sldLayoutId xmlns:r="http://schemas.openxmlformats.org/officeDocument/2006/relationships" id="2147483649" r:id="Rb41eaf8d157d4840"/>
+    <p:sldLayoutId xmlns:r="http://schemas.openxmlformats.org/officeDocument/2006/relationships" id="2147483650" r:id="Raa6cf94ebf6942d2"/>
+    <p:sldLayoutId xmlns:r="http://schemas.openxmlformats.org/officeDocument/2006/relationships" id="2147483651" r:id="R8dbe8aacf4104f9c"/>
+    <p:sldLayoutId xmlns:r="http://schemas.openxmlformats.org/officeDocument/2006/relationships" id="2147483652" r:id="R3743a4b4ce024896"/>
+    <p:sldLayoutId xmlns:r="http://schemas.openxmlformats.org/officeDocument/2006/relationships" id="2147483653" r:id="R0da1412da5ec4cf7"/>
+    <p:sldLayoutId xmlns:r="http://schemas.openxmlformats.org/officeDocument/2006/relationships" id="2147483654" r:id="R2655f55d261a4ac3"/>
   </p:sldLayoutIdLst>
   <p:txStyles>
     <p:titleStyle>
@@ -4648,7 +4648,7 @@
           <p:cNvPr id="5" name="">
             <a:extLst xmlns:a="http://schemas.openxmlformats.org/drawingml/2006/main">
               <a:ext uri="{FF2B5EF4-FFF2-40B4-BE49-F238E27FC236}">
-                <a16:creationId xmlns:a16="http://schemas.microsoft.com/office/drawing/2014/main" id="{00276C65-42C0-49EE-9A6C-931B971B1AE3}"/>
+                <a16:creationId xmlns:a16="http://schemas.microsoft.com/office/drawing/2014/main" id="{94A34BB2-6415-4ED6-9749-A783D475E966}"/>
               </a:ext>
             </a:extLst>
           </p:cNvPr>
@@ -4829,7 +4829,7 @@
           <p:cNvPr id="2" name="">
             <a:extLst xmlns:a="http://schemas.openxmlformats.org/drawingml/2006/main">
               <a:ext uri="{FF2B5EF4-FFF2-40B4-BE49-F238E27FC236}">
-                <a16:creationId xmlns:a16="http://schemas.microsoft.com/office/drawing/2014/main" id="{D9BFA065-CA24-46EC-A634-5ACF46E0E1FE}"/>
+                <a16:creationId xmlns:a16="http://schemas.microsoft.com/office/drawing/2014/main" id="{1734B3C5-A2A6-4F48-8C53-8BA55A626BA1}"/>
               </a:ext>
             </a:extLst>
           </p:cNvPr>
@@ -4987,7 +4987,7 @@
           <p:cNvPr id="3" name="">
             <a:extLst xmlns:a="http://schemas.openxmlformats.org/drawingml/2006/main">
               <a:ext uri="{FF2B5EF4-FFF2-40B4-BE49-F238E27FC236}">
-                <a16:creationId xmlns:a16="http://schemas.microsoft.com/office/drawing/2014/main" id="{585E523D-F5F0-4DA9-BB30-852252C58740}"/>
+                <a16:creationId xmlns:a16="http://schemas.microsoft.com/office/drawing/2014/main" id="{8178BC73-9D93-4172-B43E-38C2B5247D65}"/>
               </a:ext>
             </a:extLst>
           </p:cNvPr>
@@ -5017,7 +5017,7 @@
           <p:cNvPr id="4" name="">
             <a:extLst xmlns:a="http://schemas.openxmlformats.org/drawingml/2006/main">
               <a:ext uri="{FF2B5EF4-FFF2-40B4-BE49-F238E27FC236}">
-                <a16:creationId xmlns:a16="http://schemas.microsoft.com/office/drawing/2014/main" id="{7FBCD117-F74D-47B8-A001-3DD20767D78D}"/>
+                <a16:creationId xmlns:a16="http://schemas.microsoft.com/office/drawing/2014/main" id="{65E67ADC-C81A-48E3-B0D4-7FAFD883C512}"/>
               </a:ext>
             </a:extLst>
           </p:cNvPr>
@@ -5028,8 +5028,8 @@
         </p:nvSpPr>
         <p:spPr>
           <a:xfrm xmlns:a="http://schemas.openxmlformats.org/drawingml/2006/main">
-            <a:off x="895350" y="5334000"/>
-            <a:ext cx="9525000" cy="666750"/>
+            <a:off x="895350" y="5191125"/>
+            <a:ext cx="10477500" cy="1047750"/>
           </a:xfrm>
           <a:prstGeom xmlns:a="http://schemas.openxmlformats.org/drawingml/2006/main" prst="rect">
             <a:avLst/>
@@ -5165,7 +5165,7 @@
                 <a:ea typeface="Arial"/>
                 <a:cs typeface="Arial"/>
               </a:rPr>
-              <a:t>Equipe do Projeto Aplicado (nomes a preencher)</a:t>
+              <a:t>Nomes e contribuições individuais ainda não informados</a:t>
             </a:r>
           </a:p>
           <a:p xmlns:a="http://schemas.openxmlformats.org/drawingml/2006/main">
@@ -5188,7 +5188,30 @@
                 <a:ea typeface="Arial"/>
                 <a:cs typeface="Arial"/>
               </a:rPr>
-              <a:t>Outubro de 2026</a:t>
+              <a:t>Versão 28/10/2026  ·  Base main f1669d7</a:t>
+            </a:r>
+          </a:p>
+          <a:p xmlns:a="http://schemas.openxmlformats.org/drawingml/2006/main">
+            <a:pPr>
+              <a:defRPr sz="1500" b="0">
+                <a:solidFill>
+                  <a:srgbClr val="FFFFFF"/>
+                </a:solidFill>
+                <a:latin typeface="Arial"/>
+                <a:ea typeface="Arial"/>
+                <a:cs typeface="Arial"/>
+              </a:defRPr>
+            </a:pPr>
+            <a:r>
+              <a:rPr sz="1500" b="0">
+                <a:solidFill>
+                  <a:srgbClr val="FFFFFF"/>
+                </a:solidFill>
+                <a:latin typeface="Arial"/>
+                <a:ea typeface="Arial"/>
+                <a:cs typeface="Arial"/>
+              </a:rPr>
+              <a:t>Entrega pronta 09/11/2026  ·  Apresentação 23/11/2026 (previstas)</a:t>
             </a:r>
           </a:p>
         </p:txBody>
@@ -5196,7 +5219,7 @@
     </p:spTree>
     <p:extLst>
       <p:ext uri="{BB962C8B-B14F-4D97-AF65-F5344CB8AC3E}">
-        <p14:creationId xmlns:p14="http://schemas.microsoft.com/office/powerpoint/2010/main" val="194760433"/>
+        <p14:creationId xmlns:p14="http://schemas.microsoft.com/office/powerpoint/2010/main" val="1661073413"/>
       </p:ext>
     </p:extLst>
   </p:cSld>
@@ -5227,7 +5250,7 @@
           <p:cNvPr id="8" name="">
             <a:extLst xmlns:a="http://schemas.openxmlformats.org/drawingml/2006/main">
               <a:ext uri="{FF2B5EF4-FFF2-40B4-BE49-F238E27FC236}">
-                <a16:creationId xmlns:a16="http://schemas.microsoft.com/office/drawing/2014/main" id="{D69FC8EA-85CA-4E39-804C-89E3BB589468}"/>
+                <a16:creationId xmlns:a16="http://schemas.microsoft.com/office/drawing/2014/main" id="{87652935-0135-447D-B292-4723B1163553}"/>
               </a:ext>
             </a:extLst>
           </p:cNvPr>
@@ -5259,7 +5282,7 @@
           <p:cNvPr id="7" name="">
             <a:extLst xmlns:a="http://schemas.openxmlformats.org/drawingml/2006/main">
               <a:ext uri="{FF2B5EF4-FFF2-40B4-BE49-F238E27FC236}">
-                <a16:creationId xmlns:a16="http://schemas.microsoft.com/office/drawing/2014/main" id="{2B04E3CD-759E-4584-B213-BC4DC1FF1AA5}"/>
+                <a16:creationId xmlns:a16="http://schemas.microsoft.com/office/drawing/2014/main" id="{CE5C28A6-4EFD-4F08-BA19-46F874BA5766}"/>
               </a:ext>
             </a:extLst>
           </p:cNvPr>
@@ -5291,7 +5314,7 @@
           <p:cNvPr id="12" name="">
             <a:extLst xmlns:a="http://schemas.openxmlformats.org/drawingml/2006/main">
               <a:ext uri="{FF2B5EF4-FFF2-40B4-BE49-F238E27FC236}">
-                <a16:creationId xmlns:a16="http://schemas.microsoft.com/office/drawing/2014/main" id="{267A6288-A3EC-4D3B-B4A5-661A84F2C08F}"/>
+                <a16:creationId xmlns:a16="http://schemas.microsoft.com/office/drawing/2014/main" id="{008BB7EB-F761-4D4C-B6F1-CE014F37662D}"/>
               </a:ext>
             </a:extLst>
           </p:cNvPr>
@@ -5321,7 +5344,7 @@
           <p:cNvPr id="2" name="">
             <a:extLst xmlns:a="http://schemas.openxmlformats.org/drawingml/2006/main">
               <a:ext uri="{FF2B5EF4-FFF2-40B4-BE49-F238E27FC236}">
-                <a16:creationId xmlns:a16="http://schemas.microsoft.com/office/drawing/2014/main" id="{6571B931-0797-427B-9AB9-1141DD24FF81}"/>
+                <a16:creationId xmlns:a16="http://schemas.microsoft.com/office/drawing/2014/main" id="{34ED6DCB-7A5F-45C0-A38F-4B20609D5000}"/>
               </a:ext>
             </a:extLst>
           </p:cNvPr>
@@ -5479,7 +5502,7 @@
           <p:cNvPr id="3" name="">
             <a:extLst xmlns:a="http://schemas.openxmlformats.org/drawingml/2006/main">
               <a:ext uri="{FF2B5EF4-FFF2-40B4-BE49-F238E27FC236}">
-                <a16:creationId xmlns:a16="http://schemas.microsoft.com/office/drawing/2014/main" id="{4F775BBB-AD87-42D5-B6CD-5A91A039ECC3}"/>
+                <a16:creationId xmlns:a16="http://schemas.microsoft.com/office/drawing/2014/main" id="{912CA445-9B14-4DB6-91C9-4DF9F3D96E0D}"/>
               </a:ext>
             </a:extLst>
           </p:cNvPr>
@@ -5627,7 +5650,7 @@
                 <a:ea typeface="Arial"/>
                 <a:cs typeface="Arial"/>
               </a:rPr>
-              <a:t>Projeto Aplicado Cenário 4</a:t>
+              <a:t>Projeto Aplicado Cenário 4  ·  Versão 28/10/2026</a:t>
             </a:r>
           </a:p>
         </p:txBody>
@@ -5637,7 +5660,7 @@
           <p:cNvPr id="4" name="">
             <a:extLst xmlns:a="http://schemas.openxmlformats.org/drawingml/2006/main">
               <a:ext uri="{FF2B5EF4-FFF2-40B4-BE49-F238E27FC236}">
-                <a16:creationId xmlns:a16="http://schemas.microsoft.com/office/drawing/2014/main" id="{C9DEEF79-F400-42A5-BDFB-E85A270728C2}"/>
+                <a16:creationId xmlns:a16="http://schemas.microsoft.com/office/drawing/2014/main" id="{96D2DA12-A3E2-4140-8AD4-EF7BEE12FDD8}"/>
               </a:ext>
             </a:extLst>
           </p:cNvPr>
@@ -5825,7 +5848,7 @@
           <p:cNvPr id="5" name="">
             <a:extLst xmlns:a="http://schemas.openxmlformats.org/drawingml/2006/main">
               <a:ext uri="{FF2B5EF4-FFF2-40B4-BE49-F238E27FC236}">
-                <a16:creationId xmlns:a16="http://schemas.microsoft.com/office/drawing/2014/main" id="{7399D4E1-F6DC-49FA-B726-08CA9353DD41}"/>
+                <a16:creationId xmlns:a16="http://schemas.microsoft.com/office/drawing/2014/main" id="{BC0D5546-0889-49AF-A3BA-BAFAC8B4469E}"/>
               </a:ext>
             </a:extLst>
           </p:cNvPr>
@@ -6013,7 +6036,7 @@
           <p:cNvPr id="6" name="">
             <a:extLst xmlns:a="http://schemas.openxmlformats.org/drawingml/2006/main">
               <a:ext uri="{FF2B5EF4-FFF2-40B4-BE49-F238E27FC236}">
-                <a16:creationId xmlns:a16="http://schemas.microsoft.com/office/drawing/2014/main" id="{2997F763-71F8-4254-9B92-5062BA2C5CEF}"/>
+                <a16:creationId xmlns:a16="http://schemas.microsoft.com/office/drawing/2014/main" id="{B299E4EA-7702-4808-8D75-25D6CE596CE0}"/>
               </a:ext>
             </a:extLst>
           </p:cNvPr>
@@ -6201,7 +6224,7 @@
           <p:cNvPr id="9" name="">
             <a:extLst xmlns:a="http://schemas.openxmlformats.org/drawingml/2006/main">
               <a:ext uri="{FF2B5EF4-FFF2-40B4-BE49-F238E27FC236}">
-                <a16:creationId xmlns:a16="http://schemas.microsoft.com/office/drawing/2014/main" id="{8CDC309C-F0BA-4802-B6D0-D471ABE843E4}"/>
+                <a16:creationId xmlns:a16="http://schemas.microsoft.com/office/drawing/2014/main" id="{BA509EA9-6C3C-4504-ABE6-05CD19AA8CF5}"/>
               </a:ext>
             </a:extLst>
           </p:cNvPr>
@@ -6359,7 +6382,7 @@
           <p:cNvPr id="10" name="">
             <a:extLst xmlns:a="http://schemas.openxmlformats.org/drawingml/2006/main">
               <a:ext uri="{FF2B5EF4-FFF2-40B4-BE49-F238E27FC236}">
-                <a16:creationId xmlns:a16="http://schemas.microsoft.com/office/drawing/2014/main" id="{29C27F61-E025-4D76-9601-06208EF8F288}"/>
+                <a16:creationId xmlns:a16="http://schemas.microsoft.com/office/drawing/2014/main" id="{D01A5814-3094-4A3D-9320-C8263F29903A}"/>
               </a:ext>
             </a:extLst>
           </p:cNvPr>
@@ -6517,7 +6540,7 @@
           <p:cNvPr id="11" name="">
             <a:extLst xmlns:a="http://schemas.openxmlformats.org/drawingml/2006/main">
               <a:ext uri="{FF2B5EF4-FFF2-40B4-BE49-F238E27FC236}">
-                <a16:creationId xmlns:a16="http://schemas.microsoft.com/office/drawing/2014/main" id="{E62FB4BE-641F-4074-B7D5-AE2F96A4C990}"/>
+                <a16:creationId xmlns:a16="http://schemas.microsoft.com/office/drawing/2014/main" id="{D483107D-F279-4A8A-9BE0-B7D92DE082E5}"/>
               </a:ext>
             </a:extLst>
           </p:cNvPr>
@@ -6529,7 +6552,7 @@
         <p:spPr>
           <a:xfrm xmlns:a="http://schemas.openxmlformats.org/drawingml/2006/main">
             <a:off x="3333750" y="5429250"/>
-            <a:ext cx="5905500" cy="476250"/>
+            <a:ext cx="6858000" cy="476250"/>
           </a:xfrm>
           <a:prstGeom xmlns:a="http://schemas.openxmlformats.org/drawingml/2006/main" prst="rect">
             <a:avLst/>
@@ -6665,7 +6688,7 @@
                 <a:ea typeface="Arial"/>
                 <a:cs typeface="Arial"/>
               </a:rPr>
-              <a:t>Roteiro demo_f1.py: 20 de 20 checagens</a:t>
+              <a:t>F1 histórico: 20/20 checagens (20/10)</a:t>
             </a:r>
           </a:p>
         </p:txBody>
@@ -6673,7 +6696,7 @@
     </p:spTree>
     <p:extLst>
       <p:ext uri="{BB962C8B-B14F-4D97-AF65-F5344CB8AC3E}">
-        <p14:creationId xmlns:p14="http://schemas.microsoft.com/office/powerpoint/2010/main" val="1400606809"/>
+        <p14:creationId xmlns:p14="http://schemas.microsoft.com/office/powerpoint/2010/main" val="45429468"/>
       </p:ext>
     </p:extLst>
   </p:cSld>
@@ -6704,7 +6727,7 @@
           <p:cNvPr id="10" name="">
             <a:extLst xmlns:a="http://schemas.openxmlformats.org/drawingml/2006/main">
               <a:ext uri="{FF2B5EF4-FFF2-40B4-BE49-F238E27FC236}">
-                <a16:creationId xmlns:a16="http://schemas.microsoft.com/office/drawing/2014/main" id="{549D19A2-AEA2-48A4-BB68-A348D212D05A}"/>
+                <a16:creationId xmlns:a16="http://schemas.microsoft.com/office/drawing/2014/main" id="{C56036B1-CA3A-4E3D-AF9A-EF5B504039C5}"/>
               </a:ext>
             </a:extLst>
           </p:cNvPr>
@@ -6738,7 +6761,7 @@
           <p:cNvPr id="9" name="">
             <a:extLst xmlns:a="http://schemas.openxmlformats.org/drawingml/2006/main">
               <a:ext uri="{FF2B5EF4-FFF2-40B4-BE49-F238E27FC236}">
-                <a16:creationId xmlns:a16="http://schemas.microsoft.com/office/drawing/2014/main" id="{9FF64383-CE4D-4D4D-A044-A5FCEAD4E59F}"/>
+                <a16:creationId xmlns:a16="http://schemas.microsoft.com/office/drawing/2014/main" id="{27738231-D583-42BD-ABF9-A4C8B7F27237}"/>
               </a:ext>
             </a:extLst>
           </p:cNvPr>
@@ -6772,7 +6795,7 @@
           <p:cNvPr id="8" name="">
             <a:extLst xmlns:a="http://schemas.openxmlformats.org/drawingml/2006/main">
               <a:ext uri="{FF2B5EF4-FFF2-40B4-BE49-F238E27FC236}">
-                <a16:creationId xmlns:a16="http://schemas.microsoft.com/office/drawing/2014/main" id="{A556129D-197D-4EC0-B4ED-1E1EF3DE2D89}"/>
+                <a16:creationId xmlns:a16="http://schemas.microsoft.com/office/drawing/2014/main" id="{B8158F6A-DD21-4D59-941D-39AFE2763E4A}"/>
               </a:ext>
             </a:extLst>
           </p:cNvPr>
@@ -6804,7 +6827,7 @@
           <p:cNvPr id="13" name="">
             <a:extLst xmlns:a="http://schemas.openxmlformats.org/drawingml/2006/main">
               <a:ext uri="{FF2B5EF4-FFF2-40B4-BE49-F238E27FC236}">
-                <a16:creationId xmlns:a16="http://schemas.microsoft.com/office/drawing/2014/main" id="{E1DC582F-158B-4CE3-9323-250979695271}"/>
+                <a16:creationId xmlns:a16="http://schemas.microsoft.com/office/drawing/2014/main" id="{34C8D0C5-198D-4B22-86BC-88689B1CA833}"/>
               </a:ext>
             </a:extLst>
           </p:cNvPr>
@@ -6834,7 +6857,7 @@
           <p:cNvPr id="2" name="">
             <a:extLst xmlns:a="http://schemas.openxmlformats.org/drawingml/2006/main">
               <a:ext uri="{FF2B5EF4-FFF2-40B4-BE49-F238E27FC236}">
-                <a16:creationId xmlns:a16="http://schemas.microsoft.com/office/drawing/2014/main" id="{1A39A942-ACAA-4920-A90D-65A58C458D6D}"/>
+                <a16:creationId xmlns:a16="http://schemas.microsoft.com/office/drawing/2014/main" id="{E423AF2C-704C-4B0D-90C2-F4E0631AF13A}"/>
               </a:ext>
             </a:extLst>
           </p:cNvPr>
@@ -6992,7 +7015,7 @@
           <p:cNvPr id="3" name="">
             <a:extLst xmlns:a="http://schemas.openxmlformats.org/drawingml/2006/main">
               <a:ext uri="{FF2B5EF4-FFF2-40B4-BE49-F238E27FC236}">
-                <a16:creationId xmlns:a16="http://schemas.microsoft.com/office/drawing/2014/main" id="{BFF7BB9E-124C-4E33-8D14-4A8E9A51D6E7}"/>
+                <a16:creationId xmlns:a16="http://schemas.microsoft.com/office/drawing/2014/main" id="{083B975A-CF8D-413E-9DC1-A782B88AD140}"/>
               </a:ext>
             </a:extLst>
           </p:cNvPr>
@@ -7140,7 +7163,7 @@
                 <a:ea typeface="Arial"/>
                 <a:cs typeface="Arial"/>
               </a:rPr>
-              <a:t>Projeto Aplicado Cenário 4</a:t>
+              <a:t>Projeto Aplicado Cenário 4  ·  Versão 28/10/2026</a:t>
             </a:r>
           </a:p>
         </p:txBody>
@@ -7150,7 +7173,7 @@
           <p:cNvPr id="4" name="">
             <a:extLst xmlns:a="http://schemas.openxmlformats.org/drawingml/2006/main">
               <a:ext uri="{FF2B5EF4-FFF2-40B4-BE49-F238E27FC236}">
-                <a16:creationId xmlns:a16="http://schemas.microsoft.com/office/drawing/2014/main" id="{704C899A-9458-428E-879E-AE4735213756}"/>
+                <a16:creationId xmlns:a16="http://schemas.microsoft.com/office/drawing/2014/main" id="{3F521CF9-78BE-4A25-AFBD-A80BE9335A23}"/>
               </a:ext>
             </a:extLst>
           </p:cNvPr>
@@ -7338,7 +7361,7 @@
           <p:cNvPr id="5" name="">
             <a:extLst xmlns:a="http://schemas.openxmlformats.org/drawingml/2006/main">
               <a:ext uri="{FF2B5EF4-FFF2-40B4-BE49-F238E27FC236}">
-                <a16:creationId xmlns:a16="http://schemas.microsoft.com/office/drawing/2014/main" id="{CF04164A-2CAA-4723-A5B3-8477FECC8A67}"/>
+                <a16:creationId xmlns:a16="http://schemas.microsoft.com/office/drawing/2014/main" id="{A903E73B-96E9-4CEA-AA5D-EE3B42F6CC6A}"/>
               </a:ext>
             </a:extLst>
           </p:cNvPr>
@@ -7526,7 +7549,7 @@
           <p:cNvPr id="6" name="">
             <a:extLst xmlns:a="http://schemas.openxmlformats.org/drawingml/2006/main">
               <a:ext uri="{FF2B5EF4-FFF2-40B4-BE49-F238E27FC236}">
-                <a16:creationId xmlns:a16="http://schemas.microsoft.com/office/drawing/2014/main" id="{E15C5733-A9EE-418F-9991-4914B5CD3A75}"/>
+                <a16:creationId xmlns:a16="http://schemas.microsoft.com/office/drawing/2014/main" id="{B8603890-0CC4-4483-B63F-BF4BD491F460}"/>
               </a:ext>
             </a:extLst>
           </p:cNvPr>
@@ -7714,7 +7737,7 @@
           <p:cNvPr id="7" name="">
             <a:extLst xmlns:a="http://schemas.openxmlformats.org/drawingml/2006/main">
               <a:ext uri="{FF2B5EF4-FFF2-40B4-BE49-F238E27FC236}">
-                <a16:creationId xmlns:a16="http://schemas.microsoft.com/office/drawing/2014/main" id="{33B0ACE6-778A-4084-A8DB-D6FBC37D0D82}"/>
+                <a16:creationId xmlns:a16="http://schemas.microsoft.com/office/drawing/2014/main" id="{1E3DEC25-5603-4F28-8DEE-69898B48FEDA}"/>
               </a:ext>
             </a:extLst>
           </p:cNvPr>
@@ -7902,7 +7925,7 @@
           <p:cNvPr id="11" name="">
             <a:extLst xmlns:a="http://schemas.openxmlformats.org/drawingml/2006/main">
               <a:ext uri="{FF2B5EF4-FFF2-40B4-BE49-F238E27FC236}">
-                <a16:creationId xmlns:a16="http://schemas.microsoft.com/office/drawing/2014/main" id="{0353201E-FB9F-42E3-83A9-C51814753460}"/>
+                <a16:creationId xmlns:a16="http://schemas.microsoft.com/office/drawing/2014/main" id="{0B676A44-4AB3-47BC-8E1E-88982A542B29}"/>
               </a:ext>
             </a:extLst>
           </p:cNvPr>
@@ -8060,7 +8083,7 @@
           <p:cNvPr id="12" name="">
             <a:extLst xmlns:a="http://schemas.openxmlformats.org/drawingml/2006/main">
               <a:ext uri="{FF2B5EF4-FFF2-40B4-BE49-F238E27FC236}">
-                <a16:creationId xmlns:a16="http://schemas.microsoft.com/office/drawing/2014/main" id="{D2B4AB19-AD25-4E3D-87C1-4C5C99DE021D}"/>
+                <a16:creationId xmlns:a16="http://schemas.microsoft.com/office/drawing/2014/main" id="{55B42EC4-F1F3-44A5-A1D5-606C2DE8CB4B}"/>
               </a:ext>
             </a:extLst>
           </p:cNvPr>
@@ -8072,7 +8095,7 @@
         <p:spPr>
           <a:xfrm xmlns:a="http://schemas.openxmlformats.org/drawingml/2006/main">
             <a:off x="3619500" y="5524500"/>
-            <a:ext cx="5905500" cy="476250"/>
+            <a:ext cx="6858000" cy="476250"/>
           </a:xfrm>
           <a:prstGeom xmlns:a="http://schemas.openxmlformats.org/drawingml/2006/main" prst="rect">
             <a:avLst/>
@@ -8208,7 +8231,7 @@
                 <a:ea typeface="Arial"/>
                 <a:cs typeface="Arial"/>
               </a:rPr>
-              <a:t>Roteiro demo_f2.py: 14 de 14 checagens</a:t>
+              <a:t>F2 histórico: 14/14 checagens (20/10)</a:t>
             </a:r>
           </a:p>
         </p:txBody>
@@ -8216,7 +8239,7 @@
     </p:spTree>
     <p:extLst>
       <p:ext uri="{BB962C8B-B14F-4D97-AF65-F5344CB8AC3E}">
-        <p14:creationId xmlns:p14="http://schemas.microsoft.com/office/powerpoint/2010/main" val="1159329385"/>
+        <p14:creationId xmlns:p14="http://schemas.microsoft.com/office/powerpoint/2010/main" val="1379234653"/>
       </p:ext>
     </p:extLst>
   </p:cSld>
@@ -8247,7 +8270,7 @@
           <p:cNvPr id="10" name="">
             <a:extLst xmlns:a="http://schemas.openxmlformats.org/drawingml/2006/main">
               <a:ext uri="{FF2B5EF4-FFF2-40B4-BE49-F238E27FC236}">
-                <a16:creationId xmlns:a16="http://schemas.microsoft.com/office/drawing/2014/main" id="{8E9C209A-1984-4FE3-BB0B-CDD56DD8D31B}"/>
+                <a16:creationId xmlns:a16="http://schemas.microsoft.com/office/drawing/2014/main" id="{384D1B37-5662-46CD-8DB9-5ADD6656C63D}"/>
               </a:ext>
             </a:extLst>
           </p:cNvPr>
@@ -8279,7 +8302,7 @@
           <p:cNvPr id="9" name="">
             <a:extLst xmlns:a="http://schemas.openxmlformats.org/drawingml/2006/main">
               <a:ext uri="{FF2B5EF4-FFF2-40B4-BE49-F238E27FC236}">
-                <a16:creationId xmlns:a16="http://schemas.microsoft.com/office/drawing/2014/main" id="{C040A0E5-2618-47B4-B3F4-46882C0992E4}"/>
+                <a16:creationId xmlns:a16="http://schemas.microsoft.com/office/drawing/2014/main" id="{01BCB684-519F-4B51-8762-EFE8CA70AC2D}"/>
               </a:ext>
             </a:extLst>
           </p:cNvPr>
@@ -8311,7 +8334,7 @@
           <p:cNvPr id="8" name="">
             <a:extLst xmlns:a="http://schemas.openxmlformats.org/drawingml/2006/main">
               <a:ext uri="{FF2B5EF4-FFF2-40B4-BE49-F238E27FC236}">
-                <a16:creationId xmlns:a16="http://schemas.microsoft.com/office/drawing/2014/main" id="{B3577A52-AC6A-4618-8C11-0A6B8319586F}"/>
+                <a16:creationId xmlns:a16="http://schemas.microsoft.com/office/drawing/2014/main" id="{2B3D7872-3BA7-4465-874A-1199C8D6FBF7}"/>
               </a:ext>
             </a:extLst>
           </p:cNvPr>
@@ -8345,7 +8368,7 @@
           <p:cNvPr id="13" name="">
             <a:extLst xmlns:a="http://schemas.openxmlformats.org/drawingml/2006/main">
               <a:ext uri="{FF2B5EF4-FFF2-40B4-BE49-F238E27FC236}">
-                <a16:creationId xmlns:a16="http://schemas.microsoft.com/office/drawing/2014/main" id="{6E21FF86-2D30-4889-9FEE-71EB8E19D1F8}"/>
+                <a16:creationId xmlns:a16="http://schemas.microsoft.com/office/drawing/2014/main" id="{3DADAE7B-8064-47DD-B8F4-F495A010F978}"/>
               </a:ext>
             </a:extLst>
           </p:cNvPr>
@@ -8375,7 +8398,7 @@
           <p:cNvPr id="2" name="">
             <a:extLst xmlns:a="http://schemas.openxmlformats.org/drawingml/2006/main">
               <a:ext uri="{FF2B5EF4-FFF2-40B4-BE49-F238E27FC236}">
-                <a16:creationId xmlns:a16="http://schemas.microsoft.com/office/drawing/2014/main" id="{EDE3B909-74D8-49E6-BE28-697953CF52D4}"/>
+                <a16:creationId xmlns:a16="http://schemas.microsoft.com/office/drawing/2014/main" id="{B29A95D3-9A76-4F54-B0DD-D09D9EEF5C70}"/>
               </a:ext>
             </a:extLst>
           </p:cNvPr>
@@ -8533,7 +8556,7 @@
           <p:cNvPr id="3" name="">
             <a:extLst xmlns:a="http://schemas.openxmlformats.org/drawingml/2006/main">
               <a:ext uri="{FF2B5EF4-FFF2-40B4-BE49-F238E27FC236}">
-                <a16:creationId xmlns:a16="http://schemas.microsoft.com/office/drawing/2014/main" id="{66CC6E28-E9B4-4130-9A25-C5D97C0F4B0D}"/>
+                <a16:creationId xmlns:a16="http://schemas.microsoft.com/office/drawing/2014/main" id="{1018CF2B-47E2-4446-B6A0-F386F3EF6E06}"/>
               </a:ext>
             </a:extLst>
           </p:cNvPr>
@@ -8681,7 +8704,7 @@
                 <a:ea typeface="Arial"/>
                 <a:cs typeface="Arial"/>
               </a:rPr>
-              <a:t>Projeto Aplicado Cenário 4</a:t>
+              <a:t>Projeto Aplicado Cenário 4  ·  Versão 28/10/2026</a:t>
             </a:r>
           </a:p>
         </p:txBody>
@@ -8691,7 +8714,7 @@
           <p:cNvPr id="4" name="">
             <a:extLst xmlns:a="http://schemas.openxmlformats.org/drawingml/2006/main">
               <a:ext uri="{FF2B5EF4-FFF2-40B4-BE49-F238E27FC236}">
-                <a16:creationId xmlns:a16="http://schemas.microsoft.com/office/drawing/2014/main" id="{20FA18DF-2C2C-4F0E-9566-0139448815E4}"/>
+                <a16:creationId xmlns:a16="http://schemas.microsoft.com/office/drawing/2014/main" id="{BA24B3F7-A897-4856-87DA-19D1C982B29D}"/>
               </a:ext>
             </a:extLst>
           </p:cNvPr>
@@ -8879,7 +8902,7 @@
           <p:cNvPr id="5" name="">
             <a:extLst xmlns:a="http://schemas.openxmlformats.org/drawingml/2006/main">
               <a:ext uri="{FF2B5EF4-FFF2-40B4-BE49-F238E27FC236}">
-                <a16:creationId xmlns:a16="http://schemas.microsoft.com/office/drawing/2014/main" id="{ABC8F3A2-92EE-4F16-9FEC-D5AFCED3B81F}"/>
+                <a16:creationId xmlns:a16="http://schemas.microsoft.com/office/drawing/2014/main" id="{3B1478A5-36FE-4406-B8F3-A103032BE71C}"/>
               </a:ext>
             </a:extLst>
           </p:cNvPr>
@@ -9067,7 +9090,7 @@
           <p:cNvPr id="6" name="">
             <a:extLst xmlns:a="http://schemas.openxmlformats.org/drawingml/2006/main">
               <a:ext uri="{FF2B5EF4-FFF2-40B4-BE49-F238E27FC236}">
-                <a16:creationId xmlns:a16="http://schemas.microsoft.com/office/drawing/2014/main" id="{4878ECF3-7359-4AF4-9E05-5CC7BD83587B}"/>
+                <a16:creationId xmlns:a16="http://schemas.microsoft.com/office/drawing/2014/main" id="{3EC9F2C2-7DB5-4F65-AC94-DB5475925726}"/>
               </a:ext>
             </a:extLst>
           </p:cNvPr>
@@ -9255,7 +9278,7 @@
           <p:cNvPr id="7" name="">
             <a:extLst xmlns:a="http://schemas.openxmlformats.org/drawingml/2006/main">
               <a:ext uri="{FF2B5EF4-FFF2-40B4-BE49-F238E27FC236}">
-                <a16:creationId xmlns:a16="http://schemas.microsoft.com/office/drawing/2014/main" id="{D380EDEC-A92F-4326-9FAA-6EA640EE6FE8}"/>
+                <a16:creationId xmlns:a16="http://schemas.microsoft.com/office/drawing/2014/main" id="{954F0393-D46D-4116-A904-4085402A22EF}"/>
               </a:ext>
             </a:extLst>
           </p:cNvPr>
@@ -9443,7 +9466,7 @@
           <p:cNvPr id="11" name="">
             <a:extLst xmlns:a="http://schemas.openxmlformats.org/drawingml/2006/main">
               <a:ext uri="{FF2B5EF4-FFF2-40B4-BE49-F238E27FC236}">
-                <a16:creationId xmlns:a16="http://schemas.microsoft.com/office/drawing/2014/main" id="{0A1BCAD7-EB31-49D5-9898-ED8354DA8C7C}"/>
+                <a16:creationId xmlns:a16="http://schemas.microsoft.com/office/drawing/2014/main" id="{C5043FCE-642B-468D-AD09-5B6B143F9231}"/>
               </a:ext>
             </a:extLst>
           </p:cNvPr>
@@ -9454,166 +9477,8 @@
         </p:nvSpPr>
         <p:spPr>
           <a:xfrm xmlns:a="http://schemas.openxmlformats.org/drawingml/2006/main">
-            <a:off x="2095500" y="4953000"/>
-            <a:ext cx="7810500" cy="476250"/>
-          </a:xfrm>
-          <a:prstGeom xmlns:a="http://schemas.openxmlformats.org/drawingml/2006/main" prst="rect">
-            <a:avLst/>
-          </a:prstGeom>
-          <a:noFill xmlns:a="http://schemas.openxmlformats.org/drawingml/2006/main"/>
-          <a:ln xmlns:a="http://schemas.openxmlformats.org/drawingml/2006/main" w="0">
-            <a:noFill/>
-          </a:ln>
-        </p:spPr>
-        <p:txBody>
-          <a:bodyPr xmlns:a="http://schemas.openxmlformats.org/drawingml/2006/main">
-            <a:noAutofit/>
-          </a:bodyPr>
-          <a:lstStyle xmlns:a="http://schemas.openxmlformats.org/drawingml/2006/main">
-            <a:defPPr>
-              <a:defRPr sz="1875" b="1">
-                <a:solidFill>
-                  <a:srgbClr val="C65D3A"/>
-                </a:solidFill>
-                <a:latin typeface="Arial"/>
-                <a:ea typeface="Arial"/>
-                <a:cs typeface="Arial"/>
-              </a:defRPr>
-            </a:defPPr>
-            <a:lvl1pPr>
-              <a:defRPr sz="1875" b="1">
-                <a:solidFill>
-                  <a:srgbClr val="C65D3A"/>
-                </a:solidFill>
-                <a:latin typeface="Arial"/>
-                <a:ea typeface="Arial"/>
-                <a:cs typeface="Arial"/>
-              </a:defRPr>
-            </a:lvl1pPr>
-            <a:lvl2pPr>
-              <a:defRPr sz="1875" b="1">
-                <a:solidFill>
-                  <a:srgbClr val="C65D3A"/>
-                </a:solidFill>
-                <a:latin typeface="Arial"/>
-                <a:ea typeface="Arial"/>
-                <a:cs typeface="Arial"/>
-              </a:defRPr>
-            </a:lvl2pPr>
-            <a:lvl3pPr>
-              <a:defRPr sz="1875" b="1">
-                <a:solidFill>
-                  <a:srgbClr val="C65D3A"/>
-                </a:solidFill>
-                <a:latin typeface="Arial"/>
-                <a:ea typeface="Arial"/>
-                <a:cs typeface="Arial"/>
-              </a:defRPr>
-            </a:lvl3pPr>
-            <a:lvl4pPr>
-              <a:defRPr sz="1875" b="1">
-                <a:solidFill>
-                  <a:srgbClr val="C65D3A"/>
-                </a:solidFill>
-                <a:latin typeface="Arial"/>
-                <a:ea typeface="Arial"/>
-                <a:cs typeface="Arial"/>
-              </a:defRPr>
-            </a:lvl4pPr>
-            <a:lvl5pPr>
-              <a:defRPr sz="1875" b="1">
-                <a:solidFill>
-                  <a:srgbClr val="C65D3A"/>
-                </a:solidFill>
-                <a:latin typeface="Arial"/>
-                <a:ea typeface="Arial"/>
-                <a:cs typeface="Arial"/>
-              </a:defRPr>
-            </a:lvl5pPr>
-            <a:lvl6pPr>
-              <a:defRPr sz="1875" b="1">
-                <a:solidFill>
-                  <a:srgbClr val="C65D3A"/>
-                </a:solidFill>
-                <a:latin typeface="Arial"/>
-                <a:ea typeface="Arial"/>
-                <a:cs typeface="Arial"/>
-              </a:defRPr>
-            </a:lvl6pPr>
-            <a:lvl7pPr>
-              <a:defRPr sz="1875" b="1">
-                <a:solidFill>
-                  <a:srgbClr val="C65D3A"/>
-                </a:solidFill>
-                <a:latin typeface="Arial"/>
-                <a:ea typeface="Arial"/>
-                <a:cs typeface="Arial"/>
-              </a:defRPr>
-            </a:lvl7pPr>
-            <a:lvl8pPr>
-              <a:defRPr sz="1875" b="1">
-                <a:solidFill>
-                  <a:srgbClr val="C65D3A"/>
-                </a:solidFill>
-                <a:latin typeface="Arial"/>
-                <a:ea typeface="Arial"/>
-                <a:cs typeface="Arial"/>
-              </a:defRPr>
-            </a:lvl8pPr>
-            <a:lvl9pPr>
-              <a:defRPr sz="1875" b="1">
-                <a:solidFill>
-                  <a:srgbClr val="C65D3A"/>
-                </a:solidFill>
-                <a:latin typeface="Arial"/>
-                <a:ea typeface="Arial"/>
-                <a:cs typeface="Arial"/>
-              </a:defRPr>
-            </a:lvl9pPr>
-          </a:lstStyle>
-          <a:p xmlns:a="http://schemas.openxmlformats.org/drawingml/2006/main">
-            <a:pPr>
-              <a:defRPr sz="1875" b="1">
-                <a:solidFill>
-                  <a:srgbClr val="C65D3A"/>
-                </a:solidFill>
-                <a:latin typeface="Arial"/>
-                <a:ea typeface="Arial"/>
-                <a:cs typeface="Arial"/>
-              </a:defRPr>
-            </a:pPr>
-            <a:r>
-              <a:rPr sz="1875" b="1">
-                <a:solidFill>
-                  <a:srgbClr val="C65D3A"/>
-                </a:solidFill>
-                <a:latin typeface="Arial"/>
-                <a:ea typeface="Arial"/>
-                <a:cs typeface="Arial"/>
-              </a:rPr>
-              <a:t>Indisponibilidade preserva a solicitação para reconciliação</a:t>
-            </a:r>
-          </a:p>
-        </p:txBody>
-      </p:sp>
-      <p:sp>
-        <p:nvSpPr>
-          <p:cNvPr id="12" name="">
-            <a:extLst xmlns:a="http://schemas.openxmlformats.org/drawingml/2006/main">
-              <a:ext uri="{FF2B5EF4-FFF2-40B4-BE49-F238E27FC236}">
-                <a16:creationId xmlns:a16="http://schemas.microsoft.com/office/drawing/2014/main" id="{3174C428-7F85-46E6-851A-A3AC4D3CD2B4}"/>
-              </a:ext>
-            </a:extLst>
-          </p:cNvPr>
-          <p:cNvSpPr>
-            <a:spLocks xmlns:a="http://schemas.openxmlformats.org/drawingml/2006/main" noGrp="1"/>
-          </p:cNvSpPr>
-          <p:nvPr/>
-        </p:nvSpPr>
-        <p:spPr>
-          <a:xfrm xmlns:a="http://schemas.openxmlformats.org/drawingml/2006/main">
-            <a:off x="3619500" y="5619750"/>
-            <a:ext cx="5905500" cy="476250"/>
+            <a:off x="1143000" y="4953000"/>
+            <a:ext cx="10096500" cy="571500"/>
           </a:xfrm>
           <a:prstGeom xmlns:a="http://schemas.openxmlformats.org/drawingml/2006/main" prst="rect">
             <a:avLst/>
@@ -9631,7 +9496,7 @@
             <a:defPPr>
               <a:defRPr sz="1800" b="1">
                 <a:solidFill>
-                  <a:srgbClr val="2E7D5B"/>
+                  <a:srgbClr val="C65D3A"/>
                 </a:solidFill>
                 <a:latin typeface="Arial"/>
                 <a:ea typeface="Arial"/>
@@ -9641,7 +9506,7 @@
             <a:lvl1pPr>
               <a:defRPr sz="1800" b="1">
                 <a:solidFill>
-                  <a:srgbClr val="2E7D5B"/>
+                  <a:srgbClr val="C65D3A"/>
                 </a:solidFill>
                 <a:latin typeface="Arial"/>
                 <a:ea typeface="Arial"/>
@@ -9651,7 +9516,7 @@
             <a:lvl2pPr>
               <a:defRPr sz="1800" b="1">
                 <a:solidFill>
-                  <a:srgbClr val="2E7D5B"/>
+                  <a:srgbClr val="C65D3A"/>
                 </a:solidFill>
                 <a:latin typeface="Arial"/>
                 <a:ea typeface="Arial"/>
@@ -9661,7 +9526,7 @@
             <a:lvl3pPr>
               <a:defRPr sz="1800" b="1">
                 <a:solidFill>
-                  <a:srgbClr val="2E7D5B"/>
+                  <a:srgbClr val="C65D3A"/>
                 </a:solidFill>
                 <a:latin typeface="Arial"/>
                 <a:ea typeface="Arial"/>
@@ -9671,7 +9536,7 @@
             <a:lvl4pPr>
               <a:defRPr sz="1800" b="1">
                 <a:solidFill>
-                  <a:srgbClr val="2E7D5B"/>
+                  <a:srgbClr val="C65D3A"/>
                 </a:solidFill>
                 <a:latin typeface="Arial"/>
                 <a:ea typeface="Arial"/>
@@ -9681,7 +9546,7 @@
             <a:lvl5pPr>
               <a:defRPr sz="1800" b="1">
                 <a:solidFill>
-                  <a:srgbClr val="2E7D5B"/>
+                  <a:srgbClr val="C65D3A"/>
                 </a:solidFill>
                 <a:latin typeface="Arial"/>
                 <a:ea typeface="Arial"/>
@@ -9691,7 +9556,7 @@
             <a:lvl6pPr>
               <a:defRPr sz="1800" b="1">
                 <a:solidFill>
-                  <a:srgbClr val="2E7D5B"/>
+                  <a:srgbClr val="C65D3A"/>
                 </a:solidFill>
                 <a:latin typeface="Arial"/>
                 <a:ea typeface="Arial"/>
@@ -9701,7 +9566,7 @@
             <a:lvl7pPr>
               <a:defRPr sz="1800" b="1">
                 <a:solidFill>
-                  <a:srgbClr val="2E7D5B"/>
+                  <a:srgbClr val="C65D3A"/>
                 </a:solidFill>
                 <a:latin typeface="Arial"/>
                 <a:ea typeface="Arial"/>
@@ -9711,7 +9576,7 @@
             <a:lvl8pPr>
               <a:defRPr sz="1800" b="1">
                 <a:solidFill>
-                  <a:srgbClr val="2E7D5B"/>
+                  <a:srgbClr val="C65D3A"/>
                 </a:solidFill>
                 <a:latin typeface="Arial"/>
                 <a:ea typeface="Arial"/>
@@ -9721,7 +9586,7 @@
             <a:lvl9pPr>
               <a:defRPr sz="1800" b="1">
                 <a:solidFill>
-                  <a:srgbClr val="2E7D5B"/>
+                  <a:srgbClr val="C65D3A"/>
                 </a:solidFill>
                 <a:latin typeface="Arial"/>
                 <a:ea typeface="Arial"/>
@@ -9733,7 +9598,7 @@
             <a:pPr>
               <a:defRPr sz="1800" b="1">
                 <a:solidFill>
-                  <a:srgbClr val="2E7D5B"/>
+                  <a:srgbClr val="C65D3A"/>
                 </a:solidFill>
                 <a:latin typeface="Arial"/>
                 <a:ea typeface="Arial"/>
@@ -9743,13 +9608,171 @@
             <a:r>
               <a:rPr sz="1800" b="1">
                 <a:solidFill>
+                  <a:srgbClr val="C65D3A"/>
+                </a:solidFill>
+                <a:latin typeface="Arial"/>
+                <a:ea typeface="Arial"/>
+                <a:cs typeface="Arial"/>
+              </a:rPr>
+              <a:t>Limite conhecido: resolução antes da abertura pode deixar processo STARTED</a:t>
+            </a:r>
+          </a:p>
+        </p:txBody>
+      </p:sp>
+      <p:sp>
+        <p:nvSpPr>
+          <p:cNvPr id="12" name="">
+            <a:extLst xmlns:a="http://schemas.openxmlformats.org/drawingml/2006/main">
+              <a:ext uri="{FF2B5EF4-FFF2-40B4-BE49-F238E27FC236}">
+                <a16:creationId xmlns:a16="http://schemas.microsoft.com/office/drawing/2014/main" id="{494840C9-4C87-472C-A1D7-CD4C82544ECB}"/>
+              </a:ext>
+            </a:extLst>
+          </p:cNvPr>
+          <p:cNvSpPr>
+            <a:spLocks xmlns:a="http://schemas.openxmlformats.org/drawingml/2006/main" noGrp="1"/>
+          </p:cNvSpPr>
+          <p:nvPr/>
+        </p:nvSpPr>
+        <p:spPr>
+          <a:xfrm xmlns:a="http://schemas.openxmlformats.org/drawingml/2006/main">
+            <a:off x="3619500" y="5619750"/>
+            <a:ext cx="6858000" cy="476250"/>
+          </a:xfrm>
+          <a:prstGeom xmlns:a="http://schemas.openxmlformats.org/drawingml/2006/main" prst="rect">
+            <a:avLst/>
+          </a:prstGeom>
+          <a:noFill xmlns:a="http://schemas.openxmlformats.org/drawingml/2006/main"/>
+          <a:ln xmlns:a="http://schemas.openxmlformats.org/drawingml/2006/main" w="0">
+            <a:noFill/>
+          </a:ln>
+        </p:spPr>
+        <p:txBody>
+          <a:bodyPr xmlns:a="http://schemas.openxmlformats.org/drawingml/2006/main">
+            <a:noAutofit/>
+          </a:bodyPr>
+          <a:lstStyle xmlns:a="http://schemas.openxmlformats.org/drawingml/2006/main">
+            <a:defPPr>
+              <a:defRPr sz="1800" b="1">
+                <a:solidFill>
                   <a:srgbClr val="2E7D5B"/>
                 </a:solidFill>
                 <a:latin typeface="Arial"/>
                 <a:ea typeface="Arial"/>
                 <a:cs typeface="Arial"/>
+              </a:defRPr>
+            </a:defPPr>
+            <a:lvl1pPr>
+              <a:defRPr sz="1800" b="1">
+                <a:solidFill>
+                  <a:srgbClr val="2E7D5B"/>
+                </a:solidFill>
+                <a:latin typeface="Arial"/>
+                <a:ea typeface="Arial"/>
+                <a:cs typeface="Arial"/>
+              </a:defRPr>
+            </a:lvl1pPr>
+            <a:lvl2pPr>
+              <a:defRPr sz="1800" b="1">
+                <a:solidFill>
+                  <a:srgbClr val="2E7D5B"/>
+                </a:solidFill>
+                <a:latin typeface="Arial"/>
+                <a:ea typeface="Arial"/>
+                <a:cs typeface="Arial"/>
+              </a:defRPr>
+            </a:lvl2pPr>
+            <a:lvl3pPr>
+              <a:defRPr sz="1800" b="1">
+                <a:solidFill>
+                  <a:srgbClr val="2E7D5B"/>
+                </a:solidFill>
+                <a:latin typeface="Arial"/>
+                <a:ea typeface="Arial"/>
+                <a:cs typeface="Arial"/>
+              </a:defRPr>
+            </a:lvl3pPr>
+            <a:lvl4pPr>
+              <a:defRPr sz="1800" b="1">
+                <a:solidFill>
+                  <a:srgbClr val="2E7D5B"/>
+                </a:solidFill>
+                <a:latin typeface="Arial"/>
+                <a:ea typeface="Arial"/>
+                <a:cs typeface="Arial"/>
+              </a:defRPr>
+            </a:lvl4pPr>
+            <a:lvl5pPr>
+              <a:defRPr sz="1800" b="1">
+                <a:solidFill>
+                  <a:srgbClr val="2E7D5B"/>
+                </a:solidFill>
+                <a:latin typeface="Arial"/>
+                <a:ea typeface="Arial"/>
+                <a:cs typeface="Arial"/>
+              </a:defRPr>
+            </a:lvl5pPr>
+            <a:lvl6pPr>
+              <a:defRPr sz="1800" b="1">
+                <a:solidFill>
+                  <a:srgbClr val="2E7D5B"/>
+                </a:solidFill>
+                <a:latin typeface="Arial"/>
+                <a:ea typeface="Arial"/>
+                <a:cs typeface="Arial"/>
+              </a:defRPr>
+            </a:lvl6pPr>
+            <a:lvl7pPr>
+              <a:defRPr sz="1800" b="1">
+                <a:solidFill>
+                  <a:srgbClr val="2E7D5B"/>
+                </a:solidFill>
+                <a:latin typeface="Arial"/>
+                <a:ea typeface="Arial"/>
+                <a:cs typeface="Arial"/>
+              </a:defRPr>
+            </a:lvl7pPr>
+            <a:lvl8pPr>
+              <a:defRPr sz="1800" b="1">
+                <a:solidFill>
+                  <a:srgbClr val="2E7D5B"/>
+                </a:solidFill>
+                <a:latin typeface="Arial"/>
+                <a:ea typeface="Arial"/>
+                <a:cs typeface="Arial"/>
+              </a:defRPr>
+            </a:lvl8pPr>
+            <a:lvl9pPr>
+              <a:defRPr sz="1800" b="1">
+                <a:solidFill>
+                  <a:srgbClr val="2E7D5B"/>
+                </a:solidFill>
+                <a:latin typeface="Arial"/>
+                <a:ea typeface="Arial"/>
+                <a:cs typeface="Arial"/>
+              </a:defRPr>
+            </a:lvl9pPr>
+          </a:lstStyle>
+          <a:p xmlns:a="http://schemas.openxmlformats.org/drawingml/2006/main">
+            <a:pPr>
+              <a:defRPr sz="1800" b="1">
+                <a:solidFill>
+                  <a:srgbClr val="2E7D5B"/>
+                </a:solidFill>
+                <a:latin typeface="Arial"/>
+                <a:ea typeface="Arial"/>
+                <a:cs typeface="Arial"/>
+              </a:defRPr>
+            </a:pPr>
+            <a:r>
+              <a:rPr sz="1800" b="1">
+                <a:solidFill>
+                  <a:srgbClr val="2E7D5B"/>
+                </a:solidFill>
+                <a:latin typeface="Arial"/>
+                <a:ea typeface="Arial"/>
+                <a:cs typeface="Arial"/>
               </a:rPr>
-              <a:t>Roteiro demo_f3.py: 15 de 15 checagens</a:t>
+              <a:t>F3 histórico: 15/15 checagens (20/10)</a:t>
             </a:r>
           </a:p>
         </p:txBody>
@@ -9757,7 +9780,7 @@
     </p:spTree>
     <p:extLst>
       <p:ext uri="{BB962C8B-B14F-4D97-AF65-F5344CB8AC3E}">
-        <p14:creationId xmlns:p14="http://schemas.microsoft.com/office/powerpoint/2010/main" val="1771030527"/>
+        <p14:creationId xmlns:p14="http://schemas.microsoft.com/office/powerpoint/2010/main" val="1168916265"/>
       </p:ext>
     </p:extLst>
   </p:cSld>
@@ -9788,7 +9811,7 @@
           <p:cNvPr id="7" name="">
             <a:extLst xmlns:a="http://schemas.openxmlformats.org/drawingml/2006/main">
               <a:ext uri="{FF2B5EF4-FFF2-40B4-BE49-F238E27FC236}">
-                <a16:creationId xmlns:a16="http://schemas.microsoft.com/office/drawing/2014/main" id="{3D36192D-7EE9-4F96-BA21-8A26038A6FBB}"/>
+                <a16:creationId xmlns:a16="http://schemas.microsoft.com/office/drawing/2014/main" id="{4BC00EFB-94EA-4F1F-85FA-BAD205487A8B}"/>
               </a:ext>
             </a:extLst>
           </p:cNvPr>
@@ -9818,7 +9841,7 @@
           <p:cNvPr id="2" name="">
             <a:extLst xmlns:a="http://schemas.openxmlformats.org/drawingml/2006/main">
               <a:ext uri="{FF2B5EF4-FFF2-40B4-BE49-F238E27FC236}">
-                <a16:creationId xmlns:a16="http://schemas.microsoft.com/office/drawing/2014/main" id="{DBF0006F-3E23-4AC0-93F5-6B74F2570F07}"/>
+                <a16:creationId xmlns:a16="http://schemas.microsoft.com/office/drawing/2014/main" id="{CA81F471-ADA9-49F4-A031-D194DB3637BB}"/>
               </a:ext>
             </a:extLst>
           </p:cNvPr>
@@ -9976,7 +9999,7 @@
           <p:cNvPr id="3" name="">
             <a:extLst xmlns:a="http://schemas.openxmlformats.org/drawingml/2006/main">
               <a:ext uri="{FF2B5EF4-FFF2-40B4-BE49-F238E27FC236}">
-                <a16:creationId xmlns:a16="http://schemas.microsoft.com/office/drawing/2014/main" id="{80877DF2-1640-40F4-A20B-66E1166FCCBF}"/>
+                <a16:creationId xmlns:a16="http://schemas.microsoft.com/office/drawing/2014/main" id="{3273A162-FCBE-417F-AA42-FF9B808EA685}"/>
               </a:ext>
             </a:extLst>
           </p:cNvPr>
@@ -10124,7 +10147,7 @@
                 <a:ea typeface="Arial"/>
                 <a:cs typeface="Arial"/>
               </a:rPr>
-              <a:t>Projeto Aplicado Cenário 4</a:t>
+              <a:t>Projeto Aplicado Cenário 4  ·  Versão 28/10/2026</a:t>
             </a:r>
           </a:p>
         </p:txBody>
@@ -10134,7 +10157,7 @@
           <p:cNvPr id="4" name="">
             <a:extLst xmlns:a="http://schemas.openxmlformats.org/drawingml/2006/main">
               <a:ext uri="{FF2B5EF4-FFF2-40B4-BE49-F238E27FC236}">
-                <a16:creationId xmlns:a16="http://schemas.microsoft.com/office/drawing/2014/main" id="{27810EA0-8CF1-488C-B662-FB4744E9F56C}"/>
+                <a16:creationId xmlns:a16="http://schemas.microsoft.com/office/drawing/2014/main" id="{1F3E39E4-E9EB-43C3-BC19-E354C7FC580F}"/>
               </a:ext>
             </a:extLst>
           </p:cNvPr>
@@ -10404,7 +10427,7 @@
           <p:cNvPr id="5" name="">
             <a:extLst xmlns:a="http://schemas.openxmlformats.org/drawingml/2006/main">
               <a:ext uri="{FF2B5EF4-FFF2-40B4-BE49-F238E27FC236}">
-                <a16:creationId xmlns:a16="http://schemas.microsoft.com/office/drawing/2014/main" id="{19188E1D-B1DA-4EA5-9E81-4B14C25B104F}"/>
+                <a16:creationId xmlns:a16="http://schemas.microsoft.com/office/drawing/2014/main" id="{1289B5DF-54EA-483C-916D-B2C298B14D6E}"/>
               </a:ext>
             </a:extLst>
           </p:cNvPr>
@@ -10730,7 +10753,7 @@
           <p:cNvPr id="6" name="">
             <a:extLst xmlns:a="http://schemas.openxmlformats.org/drawingml/2006/main">
               <a:ext uri="{FF2B5EF4-FFF2-40B4-BE49-F238E27FC236}">
-                <a16:creationId xmlns:a16="http://schemas.microsoft.com/office/drawing/2014/main" id="{B2294ADC-4FF0-4C7E-81CE-14F1FE18AC0B}"/>
+                <a16:creationId xmlns:a16="http://schemas.microsoft.com/office/drawing/2014/main" id="{4E66D15B-4CD3-42C6-801D-F9C0C7949A31}"/>
               </a:ext>
             </a:extLst>
           </p:cNvPr>
@@ -10886,7 +10909,7 @@
     </p:spTree>
     <p:extLst>
       <p:ext uri="{BB962C8B-B14F-4D97-AF65-F5344CB8AC3E}">
-        <p14:creationId xmlns:p14="http://schemas.microsoft.com/office/powerpoint/2010/main" val="2136084134"/>
+        <p14:creationId xmlns:p14="http://schemas.microsoft.com/office/powerpoint/2010/main" val="214609718"/>
       </p:ext>
     </p:extLst>
   </p:cSld>
@@ -10917,7 +10940,7 @@
           <p:cNvPr id="28" name="">
             <a:extLst xmlns:a="http://schemas.openxmlformats.org/drawingml/2006/main">
               <a:ext uri="{FF2B5EF4-FFF2-40B4-BE49-F238E27FC236}">
-                <a16:creationId xmlns:a16="http://schemas.microsoft.com/office/drawing/2014/main" id="{8D0C23B8-C33F-443D-9DEB-1B4C8222BB0F}"/>
+                <a16:creationId xmlns:a16="http://schemas.microsoft.com/office/drawing/2014/main" id="{7140E2A3-3214-4957-88CB-F00F2627CC03}"/>
               </a:ext>
             </a:extLst>
           </p:cNvPr>
@@ -10947,7 +10970,7 @@
           <p:cNvPr id="2" name="">
             <a:extLst xmlns:a="http://schemas.openxmlformats.org/drawingml/2006/main">
               <a:ext uri="{FF2B5EF4-FFF2-40B4-BE49-F238E27FC236}">
-                <a16:creationId xmlns:a16="http://schemas.microsoft.com/office/drawing/2014/main" id="{56CB15C8-FED7-43CE-808D-909BF89A3DAA}"/>
+                <a16:creationId xmlns:a16="http://schemas.microsoft.com/office/drawing/2014/main" id="{44ADAA69-384E-474F-A19A-FA4D9789E293}"/>
               </a:ext>
             </a:extLst>
           </p:cNvPr>
@@ -11105,7 +11128,7 @@
           <p:cNvPr id="3" name="">
             <a:extLst xmlns:a="http://schemas.openxmlformats.org/drawingml/2006/main">
               <a:ext uri="{FF2B5EF4-FFF2-40B4-BE49-F238E27FC236}">
-                <a16:creationId xmlns:a16="http://schemas.microsoft.com/office/drawing/2014/main" id="{CB0A090C-1547-40C5-BEBA-56590763404B}"/>
+                <a16:creationId xmlns:a16="http://schemas.microsoft.com/office/drawing/2014/main" id="{9A3C599B-ADFB-437D-9279-984F112CF3B2}"/>
               </a:ext>
             </a:extLst>
           </p:cNvPr>
@@ -11253,7 +11276,7 @@
                 <a:ea typeface="Arial"/>
                 <a:cs typeface="Arial"/>
               </a:rPr>
-              <a:t>Projeto Aplicado Cenário 4</a:t>
+              <a:t>Projeto Aplicado Cenário 4  ·  Versão 28/10/2026</a:t>
             </a:r>
           </a:p>
         </p:txBody>
@@ -11263,7 +11286,7 @@
           <p:cNvPr id="4" name="">
             <a:extLst xmlns:a="http://schemas.openxmlformats.org/drawingml/2006/main">
               <a:ext uri="{FF2B5EF4-FFF2-40B4-BE49-F238E27FC236}">
-                <a16:creationId xmlns:a16="http://schemas.microsoft.com/office/drawing/2014/main" id="{14C2CFD7-3A24-4CA2-A88C-F2BD42D0505C}"/>
+                <a16:creationId xmlns:a16="http://schemas.microsoft.com/office/drawing/2014/main" id="{086571E3-518C-4A8B-8793-94D1A2C06ACF}"/>
               </a:ext>
             </a:extLst>
           </p:cNvPr>
@@ -11421,7 +11444,7 @@
           <p:cNvPr id="5" name="">
             <a:extLst xmlns:a="http://schemas.openxmlformats.org/drawingml/2006/main">
               <a:ext uri="{FF2B5EF4-FFF2-40B4-BE49-F238E27FC236}">
-                <a16:creationId xmlns:a16="http://schemas.microsoft.com/office/drawing/2014/main" id="{8AAD841A-9ECB-47E3-8C66-06E65122729A}"/>
+                <a16:creationId xmlns:a16="http://schemas.microsoft.com/office/drawing/2014/main" id="{97AA7B8A-8A27-425D-BDFC-FF4D89A08C4E}"/>
               </a:ext>
             </a:extLst>
           </p:cNvPr>
@@ -11579,7 +11602,7 @@
           <p:cNvPr id="6" name="">
             <a:extLst xmlns:a="http://schemas.openxmlformats.org/drawingml/2006/main">
               <a:ext uri="{FF2B5EF4-FFF2-40B4-BE49-F238E27FC236}">
-                <a16:creationId xmlns:a16="http://schemas.microsoft.com/office/drawing/2014/main" id="{72EC9F97-0AC7-4ABF-ABEC-526ED475D39B}"/>
+                <a16:creationId xmlns:a16="http://schemas.microsoft.com/office/drawing/2014/main" id="{2E2B6648-B831-47F3-A80A-D4057D97CEC8}"/>
               </a:ext>
             </a:extLst>
           </p:cNvPr>
@@ -11737,7 +11760,7 @@
           <p:cNvPr id="7" name="">
             <a:extLst xmlns:a="http://schemas.openxmlformats.org/drawingml/2006/main">
               <a:ext uri="{FF2B5EF4-FFF2-40B4-BE49-F238E27FC236}">
-                <a16:creationId xmlns:a16="http://schemas.microsoft.com/office/drawing/2014/main" id="{EC6C682C-1D9D-4186-A8C1-CD8682A9C702}"/>
+                <a16:creationId xmlns:a16="http://schemas.microsoft.com/office/drawing/2014/main" id="{EC5999FB-EFF2-42EE-A55C-B3E71AAA929C}"/>
               </a:ext>
             </a:extLst>
           </p:cNvPr>
@@ -11895,7 +11918,7 @@
           <p:cNvPr id="8" name="">
             <a:extLst xmlns:a="http://schemas.openxmlformats.org/drawingml/2006/main">
               <a:ext uri="{FF2B5EF4-FFF2-40B4-BE49-F238E27FC236}">
-                <a16:creationId xmlns:a16="http://schemas.microsoft.com/office/drawing/2014/main" id="{A6AAD7A6-3A56-4B4B-9822-22E8E22FA182}"/>
+                <a16:creationId xmlns:a16="http://schemas.microsoft.com/office/drawing/2014/main" id="{7A6D258C-C2CA-420F-B3E2-B2E9E45D4545}"/>
               </a:ext>
             </a:extLst>
           </p:cNvPr>
@@ -12053,7 +12076,7 @@
           <p:cNvPr id="9" name="">
             <a:extLst xmlns:a="http://schemas.openxmlformats.org/drawingml/2006/main">
               <a:ext uri="{FF2B5EF4-FFF2-40B4-BE49-F238E27FC236}">
-                <a16:creationId xmlns:a16="http://schemas.microsoft.com/office/drawing/2014/main" id="{963B907B-17C4-4E0A-87F1-59B58F0421BF}"/>
+                <a16:creationId xmlns:a16="http://schemas.microsoft.com/office/drawing/2014/main" id="{8E7A4886-79BE-4F6E-96C5-BBCE800C32D8}"/>
               </a:ext>
             </a:extLst>
           </p:cNvPr>
@@ -12211,7 +12234,7 @@
           <p:cNvPr id="10" name="">
             <a:extLst xmlns:a="http://schemas.openxmlformats.org/drawingml/2006/main">
               <a:ext uri="{FF2B5EF4-FFF2-40B4-BE49-F238E27FC236}">
-                <a16:creationId xmlns:a16="http://schemas.microsoft.com/office/drawing/2014/main" id="{F5E13AA8-68F7-42F7-B037-24EC2ED7ECED}"/>
+                <a16:creationId xmlns:a16="http://schemas.microsoft.com/office/drawing/2014/main" id="{2B165131-128A-45F2-BE5B-ED54140B4414}"/>
               </a:ext>
             </a:extLst>
           </p:cNvPr>
@@ -12369,7 +12392,7 @@
           <p:cNvPr id="11" name="">
             <a:extLst xmlns:a="http://schemas.openxmlformats.org/drawingml/2006/main">
               <a:ext uri="{FF2B5EF4-FFF2-40B4-BE49-F238E27FC236}">
-                <a16:creationId xmlns:a16="http://schemas.microsoft.com/office/drawing/2014/main" id="{7C04610B-7F92-4B9C-89C2-E1AF9FC70379}"/>
+                <a16:creationId xmlns:a16="http://schemas.microsoft.com/office/drawing/2014/main" id="{4F76F2AF-89E9-42EC-B6E2-F4D0FC35E3A2}"/>
               </a:ext>
             </a:extLst>
           </p:cNvPr>
@@ -12527,7 +12550,7 @@
           <p:cNvPr id="12" name="">
             <a:extLst xmlns:a="http://schemas.openxmlformats.org/drawingml/2006/main">
               <a:ext uri="{FF2B5EF4-FFF2-40B4-BE49-F238E27FC236}">
-                <a16:creationId xmlns:a16="http://schemas.microsoft.com/office/drawing/2014/main" id="{51F65B12-6C92-4D83-89DB-CA049AE79410}"/>
+                <a16:creationId xmlns:a16="http://schemas.microsoft.com/office/drawing/2014/main" id="{D78A216F-3BB8-4139-B3F2-D1D773584DF7}"/>
               </a:ext>
             </a:extLst>
           </p:cNvPr>
@@ -12685,7 +12708,7 @@
           <p:cNvPr id="13" name="">
             <a:extLst xmlns:a="http://schemas.openxmlformats.org/drawingml/2006/main">
               <a:ext uri="{FF2B5EF4-FFF2-40B4-BE49-F238E27FC236}">
-                <a16:creationId xmlns:a16="http://schemas.microsoft.com/office/drawing/2014/main" id="{E8718F2C-1621-416B-BAEE-7FC86DC8BD5A}"/>
+                <a16:creationId xmlns:a16="http://schemas.microsoft.com/office/drawing/2014/main" id="{A11789D9-A58A-474F-94A8-3659B6283E27}"/>
               </a:ext>
             </a:extLst>
           </p:cNvPr>
@@ -12843,7 +12866,7 @@
           <p:cNvPr id="14" name="">
             <a:extLst xmlns:a="http://schemas.openxmlformats.org/drawingml/2006/main">
               <a:ext uri="{FF2B5EF4-FFF2-40B4-BE49-F238E27FC236}">
-                <a16:creationId xmlns:a16="http://schemas.microsoft.com/office/drawing/2014/main" id="{77771A8C-40C3-4B77-8449-F9E2F482B080}"/>
+                <a16:creationId xmlns:a16="http://schemas.microsoft.com/office/drawing/2014/main" id="{5E542756-C59C-4EE5-925E-624EEE86552E}"/>
               </a:ext>
             </a:extLst>
           </p:cNvPr>
@@ -13001,7 +13024,7 @@
           <p:cNvPr id="15" name="">
             <a:extLst xmlns:a="http://schemas.openxmlformats.org/drawingml/2006/main">
               <a:ext uri="{FF2B5EF4-FFF2-40B4-BE49-F238E27FC236}">
-                <a16:creationId xmlns:a16="http://schemas.microsoft.com/office/drawing/2014/main" id="{E96E0B60-9DE0-4EFD-A58D-809E47E352CA}"/>
+                <a16:creationId xmlns:a16="http://schemas.microsoft.com/office/drawing/2014/main" id="{FB0205C3-307C-4898-A7C9-A20BD9A65F46}"/>
               </a:ext>
             </a:extLst>
           </p:cNvPr>
@@ -13159,7 +13182,7 @@
           <p:cNvPr id="16" name="">
             <a:extLst xmlns:a="http://schemas.openxmlformats.org/drawingml/2006/main">
               <a:ext uri="{FF2B5EF4-FFF2-40B4-BE49-F238E27FC236}">
-                <a16:creationId xmlns:a16="http://schemas.microsoft.com/office/drawing/2014/main" id="{8B543790-225B-4E58-A2AB-2A57286A98F6}"/>
+                <a16:creationId xmlns:a16="http://schemas.microsoft.com/office/drawing/2014/main" id="{7BFB5338-B332-4E34-9F66-318B049F03FD}"/>
               </a:ext>
             </a:extLst>
           </p:cNvPr>
@@ -13317,7 +13340,7 @@
           <p:cNvPr id="17" name="">
             <a:extLst xmlns:a="http://schemas.openxmlformats.org/drawingml/2006/main">
               <a:ext uri="{FF2B5EF4-FFF2-40B4-BE49-F238E27FC236}">
-                <a16:creationId xmlns:a16="http://schemas.microsoft.com/office/drawing/2014/main" id="{D71FFDF5-AD1B-4C7A-B961-A73CFD1FDA25}"/>
+                <a16:creationId xmlns:a16="http://schemas.microsoft.com/office/drawing/2014/main" id="{6299F6D8-3E62-4641-94DF-5B6A1F22FDE3}"/>
               </a:ext>
             </a:extLst>
           </p:cNvPr>
@@ -13475,7 +13498,7 @@
           <p:cNvPr id="18" name="">
             <a:extLst xmlns:a="http://schemas.openxmlformats.org/drawingml/2006/main">
               <a:ext uri="{FF2B5EF4-FFF2-40B4-BE49-F238E27FC236}">
-                <a16:creationId xmlns:a16="http://schemas.microsoft.com/office/drawing/2014/main" id="{DBE86A1F-B9ED-45F1-BCB9-B6C8B13BE74D}"/>
+                <a16:creationId xmlns:a16="http://schemas.microsoft.com/office/drawing/2014/main" id="{046EBB68-A5D8-4D4C-9452-14B2FEBBFD8B}"/>
               </a:ext>
             </a:extLst>
           </p:cNvPr>
@@ -13633,7 +13656,7 @@
           <p:cNvPr id="19" name="">
             <a:extLst xmlns:a="http://schemas.openxmlformats.org/drawingml/2006/main">
               <a:ext uri="{FF2B5EF4-FFF2-40B4-BE49-F238E27FC236}">
-                <a16:creationId xmlns:a16="http://schemas.microsoft.com/office/drawing/2014/main" id="{2C79FEE8-4B5B-47E6-96D6-C3CDCD51E00D}"/>
+                <a16:creationId xmlns:a16="http://schemas.microsoft.com/office/drawing/2014/main" id="{5C1D1334-B793-4A89-B5E0-669310C25502}"/>
               </a:ext>
             </a:extLst>
           </p:cNvPr>
@@ -13791,7 +13814,7 @@
           <p:cNvPr id="20" name="">
             <a:extLst xmlns:a="http://schemas.openxmlformats.org/drawingml/2006/main">
               <a:ext uri="{FF2B5EF4-FFF2-40B4-BE49-F238E27FC236}">
-                <a16:creationId xmlns:a16="http://schemas.microsoft.com/office/drawing/2014/main" id="{CB802BE9-2985-4EEF-A680-DA4B16B6866B}"/>
+                <a16:creationId xmlns:a16="http://schemas.microsoft.com/office/drawing/2014/main" id="{2A954D60-5361-4DCD-941B-49886A924FB1}"/>
               </a:ext>
             </a:extLst>
           </p:cNvPr>
@@ -13949,7 +13972,7 @@
           <p:cNvPr id="21" name="">
             <a:extLst xmlns:a="http://schemas.openxmlformats.org/drawingml/2006/main">
               <a:ext uri="{FF2B5EF4-FFF2-40B4-BE49-F238E27FC236}">
-                <a16:creationId xmlns:a16="http://schemas.microsoft.com/office/drawing/2014/main" id="{34A71A8E-2135-4A81-910D-8AF59FB964C4}"/>
+                <a16:creationId xmlns:a16="http://schemas.microsoft.com/office/drawing/2014/main" id="{FF973B10-FF55-456D-ADFD-CDD0499ABB01}"/>
               </a:ext>
             </a:extLst>
           </p:cNvPr>
@@ -14107,7 +14130,7 @@
           <p:cNvPr id="22" name="">
             <a:extLst xmlns:a="http://schemas.openxmlformats.org/drawingml/2006/main">
               <a:ext uri="{FF2B5EF4-FFF2-40B4-BE49-F238E27FC236}">
-                <a16:creationId xmlns:a16="http://schemas.microsoft.com/office/drawing/2014/main" id="{6D750D08-BA57-40BA-961E-E7FBB59D1BDB}"/>
+                <a16:creationId xmlns:a16="http://schemas.microsoft.com/office/drawing/2014/main" id="{D7BF26E9-6A75-4576-8062-404A21AF5B91}"/>
               </a:ext>
             </a:extLst>
           </p:cNvPr>
@@ -14265,7 +14288,7 @@
           <p:cNvPr id="23" name="">
             <a:extLst xmlns:a="http://schemas.openxmlformats.org/drawingml/2006/main">
               <a:ext uri="{FF2B5EF4-FFF2-40B4-BE49-F238E27FC236}">
-                <a16:creationId xmlns:a16="http://schemas.microsoft.com/office/drawing/2014/main" id="{4AB36BCA-97C7-4774-995E-F9129BBF5ADA}"/>
+                <a16:creationId xmlns:a16="http://schemas.microsoft.com/office/drawing/2014/main" id="{9B1C19E2-8CE6-4E15-A24A-DED706DB1FA2}"/>
               </a:ext>
             </a:extLst>
           </p:cNvPr>
@@ -14423,7 +14446,7 @@
           <p:cNvPr id="24" name="">
             <a:extLst xmlns:a="http://schemas.openxmlformats.org/drawingml/2006/main">
               <a:ext uri="{FF2B5EF4-FFF2-40B4-BE49-F238E27FC236}">
-                <a16:creationId xmlns:a16="http://schemas.microsoft.com/office/drawing/2014/main" id="{46EA4641-9717-4777-A007-E73E22701804}"/>
+                <a16:creationId xmlns:a16="http://schemas.microsoft.com/office/drawing/2014/main" id="{0EFE2E2C-0E63-4819-B98E-66CE4C5BD503}"/>
               </a:ext>
             </a:extLst>
           </p:cNvPr>
@@ -14581,7 +14604,7 @@
           <p:cNvPr id="25" name="">
             <a:extLst xmlns:a="http://schemas.openxmlformats.org/drawingml/2006/main">
               <a:ext uri="{FF2B5EF4-FFF2-40B4-BE49-F238E27FC236}">
-                <a16:creationId xmlns:a16="http://schemas.microsoft.com/office/drawing/2014/main" id="{685A05C6-6D22-4EDE-BE77-0DB748F8B244}"/>
+                <a16:creationId xmlns:a16="http://schemas.microsoft.com/office/drawing/2014/main" id="{DD91793F-8854-43F7-AD4E-70A2DCB8ECC9}"/>
               </a:ext>
             </a:extLst>
           </p:cNvPr>
@@ -14739,7 +14762,7 @@
           <p:cNvPr id="26" name="">
             <a:extLst xmlns:a="http://schemas.openxmlformats.org/drawingml/2006/main">
               <a:ext uri="{FF2B5EF4-FFF2-40B4-BE49-F238E27FC236}">
-                <a16:creationId xmlns:a16="http://schemas.microsoft.com/office/drawing/2014/main" id="{46DDCFE2-85C1-45E1-8D63-6E8920460602}"/>
+                <a16:creationId xmlns:a16="http://schemas.microsoft.com/office/drawing/2014/main" id="{D1955FE3-F33C-423E-BA42-C3E6D27BDCD6}"/>
               </a:ext>
             </a:extLst>
           </p:cNvPr>
@@ -14897,7 +14920,7 @@
           <p:cNvPr id="27" name="">
             <a:extLst xmlns:a="http://schemas.openxmlformats.org/drawingml/2006/main">
               <a:ext uri="{FF2B5EF4-FFF2-40B4-BE49-F238E27FC236}">
-                <a16:creationId xmlns:a16="http://schemas.microsoft.com/office/drawing/2014/main" id="{96414F7A-24D7-4DD9-A8FA-D0D4BEB58790}"/>
+                <a16:creationId xmlns:a16="http://schemas.microsoft.com/office/drawing/2014/main" id="{5C2B91F2-EC0F-436C-B1FB-8C9DC0015477}"/>
               </a:ext>
             </a:extLst>
           </p:cNvPr>
@@ -15045,7 +15068,7 @@
                 <a:ea typeface="Arial"/>
                 <a:cs typeface="Arial"/>
               </a:rPr>
-              <a:t>p95 local 4,22 ms</a:t>
+              <a:t>p95 45,1 ms (20/10)</a:t>
             </a:r>
           </a:p>
         </p:txBody>
@@ -15053,7 +15076,7 @@
     </p:spTree>
     <p:extLst>
       <p:ext uri="{BB962C8B-B14F-4D97-AF65-F5344CB8AC3E}">
-        <p14:creationId xmlns:p14="http://schemas.microsoft.com/office/powerpoint/2010/main" val="56330795"/>
+        <p14:creationId xmlns:p14="http://schemas.microsoft.com/office/powerpoint/2010/main" val="1339888652"/>
       </p:ext>
     </p:extLst>
   </p:cSld>
@@ -15084,7 +15107,7 @@
           <p:cNvPr id="11" name="">
             <a:extLst xmlns:a="http://schemas.openxmlformats.org/drawingml/2006/main">
               <a:ext uri="{FF2B5EF4-FFF2-40B4-BE49-F238E27FC236}">
-                <a16:creationId xmlns:a16="http://schemas.microsoft.com/office/drawing/2014/main" id="{D1333AC8-0C6D-4C3D-B948-91374D8708C7}"/>
+                <a16:creationId xmlns:a16="http://schemas.microsoft.com/office/drawing/2014/main" id="{0970811A-325D-46F4-854D-FC1F8AA1034D}"/>
               </a:ext>
             </a:extLst>
           </p:cNvPr>
@@ -15114,7 +15137,7 @@
           <p:cNvPr id="2" name="">
             <a:extLst xmlns:a="http://schemas.openxmlformats.org/drawingml/2006/main">
               <a:ext uri="{FF2B5EF4-FFF2-40B4-BE49-F238E27FC236}">
-                <a16:creationId xmlns:a16="http://schemas.microsoft.com/office/drawing/2014/main" id="{C0A3DD73-749D-4E7F-9947-3BAF7F25CE93}"/>
+                <a16:creationId xmlns:a16="http://schemas.microsoft.com/office/drawing/2014/main" id="{12387ED7-4C79-4D86-98C7-91911E15DA77}"/>
               </a:ext>
             </a:extLst>
           </p:cNvPr>
@@ -15272,7 +15295,7 @@
           <p:cNvPr id="3" name="">
             <a:extLst xmlns:a="http://schemas.openxmlformats.org/drawingml/2006/main">
               <a:ext uri="{FF2B5EF4-FFF2-40B4-BE49-F238E27FC236}">
-                <a16:creationId xmlns:a16="http://schemas.microsoft.com/office/drawing/2014/main" id="{00D68420-5A49-4592-8A5A-110C1466D9CA}"/>
+                <a16:creationId xmlns:a16="http://schemas.microsoft.com/office/drawing/2014/main" id="{1F2DC33A-7E19-4EA0-81FD-D6216D6B7C81}"/>
               </a:ext>
             </a:extLst>
           </p:cNvPr>
@@ -15420,7 +15443,7 @@
                 <a:ea typeface="Arial"/>
                 <a:cs typeface="Arial"/>
               </a:rPr>
-              <a:t>Projeto Aplicado Cenário 4</a:t>
+              <a:t>Projeto Aplicado Cenário 4  ·  Versão 28/10/2026</a:t>
             </a:r>
           </a:p>
         </p:txBody>
@@ -15430,7 +15453,7 @@
           <p:cNvPr id="4" name="">
             <a:extLst xmlns:a="http://schemas.openxmlformats.org/drawingml/2006/main">
               <a:ext uri="{FF2B5EF4-FFF2-40B4-BE49-F238E27FC236}">
-                <a16:creationId xmlns:a16="http://schemas.microsoft.com/office/drawing/2014/main" id="{BB3C8D46-08EA-439B-AD77-E70A81AABD2D}"/>
+                <a16:creationId xmlns:a16="http://schemas.microsoft.com/office/drawing/2014/main" id="{2AA8F1C7-4EBB-45D2-BE8D-18DDFE6DDADE}"/>
               </a:ext>
             </a:extLst>
           </p:cNvPr>
@@ -15588,7 +15611,7 @@
           <p:cNvPr id="5" name="">
             <a:extLst xmlns:a="http://schemas.openxmlformats.org/drawingml/2006/main">
               <a:ext uri="{FF2B5EF4-FFF2-40B4-BE49-F238E27FC236}">
-                <a16:creationId xmlns:a16="http://schemas.microsoft.com/office/drawing/2014/main" id="{36F93639-6D62-4B1A-A2F3-45BF91E0FD72}"/>
+                <a16:creationId xmlns:a16="http://schemas.microsoft.com/office/drawing/2014/main" id="{42F003F3-5DB7-42E3-9634-80520A8526EB}"/>
               </a:ext>
             </a:extLst>
           </p:cNvPr>
@@ -15794,7 +15817,7 @@
                 <a:ea typeface="Arial"/>
                 <a:cs typeface="Arial"/>
               </a:rPr>
-              <a:t>Fila de falha e reprocessamento</a:t>
+              <a:t>Estado FAILED e reprocessamento</a:t>
             </a:r>
           </a:p>
         </p:txBody>
@@ -15804,7 +15827,7 @@
           <p:cNvPr id="6" name="">
             <a:extLst xmlns:a="http://schemas.openxmlformats.org/drawingml/2006/main">
               <a:ext uri="{FF2B5EF4-FFF2-40B4-BE49-F238E27FC236}">
-                <a16:creationId xmlns:a16="http://schemas.microsoft.com/office/drawing/2014/main" id="{18A90EB7-F87B-43C9-81C5-137B595D1DDF}"/>
+                <a16:creationId xmlns:a16="http://schemas.microsoft.com/office/drawing/2014/main" id="{CB846D04-72F4-48E7-B920-56A23F99B273}"/>
               </a:ext>
             </a:extLst>
           </p:cNvPr>
@@ -15962,7 +15985,7 @@
           <p:cNvPr id="7" name="">
             <a:extLst xmlns:a="http://schemas.openxmlformats.org/drawingml/2006/main">
               <a:ext uri="{FF2B5EF4-FFF2-40B4-BE49-F238E27FC236}">
-                <a16:creationId xmlns:a16="http://schemas.microsoft.com/office/drawing/2014/main" id="{B2F8D4CA-B758-4028-91AA-1D4D3B89E4E5}"/>
+                <a16:creationId xmlns:a16="http://schemas.microsoft.com/office/drawing/2014/main" id="{6807BED9-FDA1-4A58-892F-A6EA6A97175C}"/>
               </a:ext>
             </a:extLst>
           </p:cNvPr>
@@ -16114,7 +16137,7 @@
                 <a:ea typeface="Arial"/>
                 <a:cs typeface="Arial"/>
               </a:rPr>
-              <a:t>Tokens locais ou segredo público e RBAC</a:t>
+              <a:t>Tokens locais ou segredo compartilhado e RBAC</a:t>
             </a:r>
           </a:p>
           <a:p xmlns:a="http://schemas.openxmlformats.org/drawingml/2006/main">
@@ -16141,7 +16164,7 @@
                 <a:ea typeface="Arial"/>
                 <a:cs typeface="Arial"/>
               </a:rPr>
-              <a:t>Validação na fronteira</a:t>
+              <a:t>Credenciais comparadas em bytes</a:t>
             </a:r>
           </a:p>
           <a:p xmlns:a="http://schemas.openxmlformats.org/drawingml/2006/main">
@@ -16168,7 +16191,7 @@
                 <a:ea typeface="Arial"/>
                 <a:cs typeface="Arial"/>
               </a:rPr>
-              <a:t>Dados mínimos em logs e eventos</a:t>
+              <a:t>Erros sem mensagem sensível nos logs</a:t>
             </a:r>
           </a:p>
         </p:txBody>
@@ -16178,7 +16201,7 @@
           <p:cNvPr id="8" name="">
             <a:extLst xmlns:a="http://schemas.openxmlformats.org/drawingml/2006/main">
               <a:ext uri="{FF2B5EF4-FFF2-40B4-BE49-F238E27FC236}">
-                <a16:creationId xmlns:a16="http://schemas.microsoft.com/office/drawing/2014/main" id="{3B2A7758-88DA-42A1-9AD9-C94698BC30A5}"/>
+                <a16:creationId xmlns:a16="http://schemas.microsoft.com/office/drawing/2014/main" id="{A44AA109-EE20-4BEE-9E39-89568EDCCAA7}"/>
               </a:ext>
             </a:extLst>
           </p:cNvPr>
@@ -16336,7 +16359,7 @@
           <p:cNvPr id="9" name="">
             <a:extLst xmlns:a="http://schemas.openxmlformats.org/drawingml/2006/main">
               <a:ext uri="{FF2B5EF4-FFF2-40B4-BE49-F238E27FC236}">
-                <a16:creationId xmlns:a16="http://schemas.microsoft.com/office/drawing/2014/main" id="{F6FD0D95-0BA1-4CA3-9992-530077EA9070}"/>
+                <a16:creationId xmlns:a16="http://schemas.microsoft.com/office/drawing/2014/main" id="{94896AA7-67D0-4366-B9D2-3A2C823C0620}"/>
               </a:ext>
             </a:extLst>
           </p:cNvPr>
@@ -16552,7 +16575,7 @@
           <p:cNvPr id="10" name="">
             <a:extLst xmlns:a="http://schemas.openxmlformats.org/drawingml/2006/main">
               <a:ext uri="{FF2B5EF4-FFF2-40B4-BE49-F238E27FC236}">
-                <a16:creationId xmlns:a16="http://schemas.microsoft.com/office/drawing/2014/main" id="{79A3F484-7D0D-4C96-A48A-301F3B3AB4C0}"/>
+                <a16:creationId xmlns:a16="http://schemas.microsoft.com/office/drawing/2014/main" id="{AE3ABF47-1BC5-41FB-91C3-B22C85AB67CA}"/>
               </a:ext>
             </a:extLst>
           </p:cNvPr>
@@ -16563,8 +16586,8 @@
         </p:nvSpPr>
         <p:spPr>
           <a:xfrm xmlns:a="http://schemas.openxmlformats.org/drawingml/2006/main">
-            <a:off x="1619250" y="4810125"/>
-            <a:ext cx="8858250" cy="666750"/>
+            <a:off x="1047750" y="4810125"/>
+            <a:ext cx="10287000" cy="809625"/>
           </a:xfrm>
           <a:prstGeom xmlns:a="http://schemas.openxmlformats.org/drawingml/2006/main" prst="rect">
             <a:avLst/>
@@ -16580,7 +16603,7 @@
           </a:bodyPr>
           <a:lstStyle xmlns:a="http://schemas.openxmlformats.org/drawingml/2006/main">
             <a:defPPr>
-              <a:defRPr sz="1950" b="1">
+              <a:defRPr sz="1875" b="1">
                 <a:solidFill>
                   <a:srgbClr val="C65D3A"/>
                 </a:solidFill>
@@ -16590,7 +16613,7 @@
               </a:defRPr>
             </a:defPPr>
             <a:lvl1pPr>
-              <a:defRPr sz="1950" b="1">
+              <a:defRPr sz="1875" b="1">
                 <a:solidFill>
                   <a:srgbClr val="C65D3A"/>
                 </a:solidFill>
@@ -16600,7 +16623,7 @@
               </a:defRPr>
             </a:lvl1pPr>
             <a:lvl2pPr>
-              <a:defRPr sz="1950" b="1">
+              <a:defRPr sz="1875" b="1">
                 <a:solidFill>
                   <a:srgbClr val="C65D3A"/>
                 </a:solidFill>
@@ -16610,7 +16633,7 @@
               </a:defRPr>
             </a:lvl2pPr>
             <a:lvl3pPr>
-              <a:defRPr sz="1950" b="1">
+              <a:defRPr sz="1875" b="1">
                 <a:solidFill>
                   <a:srgbClr val="C65D3A"/>
                 </a:solidFill>
@@ -16620,7 +16643,7 @@
               </a:defRPr>
             </a:lvl3pPr>
             <a:lvl4pPr>
-              <a:defRPr sz="1950" b="1">
+              <a:defRPr sz="1875" b="1">
                 <a:solidFill>
                   <a:srgbClr val="C65D3A"/>
                 </a:solidFill>
@@ -16630,7 +16653,7 @@
               </a:defRPr>
             </a:lvl4pPr>
             <a:lvl5pPr>
-              <a:defRPr sz="1950" b="1">
+              <a:defRPr sz="1875" b="1">
                 <a:solidFill>
                   <a:srgbClr val="C65D3A"/>
                 </a:solidFill>
@@ -16640,7 +16663,7 @@
               </a:defRPr>
             </a:lvl5pPr>
             <a:lvl6pPr>
-              <a:defRPr sz="1950" b="1">
+              <a:defRPr sz="1875" b="1">
                 <a:solidFill>
                   <a:srgbClr val="C65D3A"/>
                 </a:solidFill>
@@ -16650,7 +16673,7 @@
               </a:defRPr>
             </a:lvl6pPr>
             <a:lvl7pPr>
-              <a:defRPr sz="1950" b="1">
+              <a:defRPr sz="1875" b="1">
                 <a:solidFill>
                   <a:srgbClr val="C65D3A"/>
                 </a:solidFill>
@@ -16660,7 +16683,7 @@
               </a:defRPr>
             </a:lvl7pPr>
             <a:lvl8pPr>
-              <a:defRPr sz="1950" b="1">
+              <a:defRPr sz="1875" b="1">
                 <a:solidFill>
                   <a:srgbClr val="C65D3A"/>
                 </a:solidFill>
@@ -16670,7 +16693,7 @@
               </a:defRPr>
             </a:lvl8pPr>
             <a:lvl9pPr>
-              <a:defRPr sz="1950" b="1">
+              <a:defRPr sz="1875" b="1">
                 <a:solidFill>
                   <a:srgbClr val="C65D3A"/>
                 </a:solidFill>
@@ -16682,7 +16705,7 @@
           </a:lstStyle>
           <a:p xmlns:a="http://schemas.openxmlformats.org/drawingml/2006/main">
             <a:pPr>
-              <a:defRPr sz="1950" b="1">
+              <a:defRPr sz="1875" b="1">
                 <a:solidFill>
                   <a:srgbClr val="C65D3A"/>
                 </a:solidFill>
@@ -16692,7 +16715,7 @@
               </a:defRPr>
             </a:pPr>
             <a:r>
-              <a:rPr sz="1950" b="1">
+              <a:rPr sz="1875" b="1">
                 <a:solidFill>
                   <a:srgbClr val="C65D3A"/>
                 </a:solidFill>
@@ -16700,7 +16723,30 @@
                 <a:ea typeface="Arial"/>
                 <a:cs typeface="Arial"/>
               </a:rPr>
-              <a:t>Falha permanente testada após três tentativas e reprocessamento auditado</a:t>
+              <a:t>Testes de reprocessamento cobrem cenários específicos.</a:t>
+            </a:r>
+          </a:p>
+          <a:p xmlns:a="http://schemas.openxmlformats.org/drawingml/2006/main">
+            <a:pPr>
+              <a:defRPr sz="1875" b="1">
+                <a:solidFill>
+                  <a:srgbClr val="C65D3A"/>
+                </a:solidFill>
+                <a:latin typeface="Arial"/>
+                <a:ea typeface="Arial"/>
+                <a:cs typeface="Arial"/>
+              </a:defRPr>
+            </a:pPr>
+            <a:r>
+              <a:rPr sz="1875" b="1">
+                <a:solidFill>
+                  <a:srgbClr val="C65D3A"/>
+                </a:solidFill>
+                <a:latin typeface="Arial"/>
+                <a:ea typeface="Arial"/>
+                <a:cs typeface="Arial"/>
+              </a:rPr>
+              <a:t>Convergência de eventos e coerência de estados têm defeitos conhecidos.</a:t>
             </a:r>
           </a:p>
         </p:txBody>
@@ -16708,7 +16754,7 @@
     </p:spTree>
     <p:extLst>
       <p:ext uri="{BB962C8B-B14F-4D97-AF65-F5344CB8AC3E}">
-        <p14:creationId xmlns:p14="http://schemas.microsoft.com/office/powerpoint/2010/main" val="981026956"/>
+        <p14:creationId xmlns:p14="http://schemas.microsoft.com/office/powerpoint/2010/main" val="810531046"/>
       </p:ext>
     </p:extLst>
   </p:cSld>
@@ -16739,7 +16785,7 @@
           <p:cNvPr id="11" name="">
             <a:extLst xmlns:a="http://schemas.openxmlformats.org/drawingml/2006/main">
               <a:ext uri="{FF2B5EF4-FFF2-40B4-BE49-F238E27FC236}">
-                <a16:creationId xmlns:a16="http://schemas.microsoft.com/office/drawing/2014/main" id="{29053730-ED0D-430F-BC95-FA1C36F4F986}"/>
+                <a16:creationId xmlns:a16="http://schemas.microsoft.com/office/drawing/2014/main" id="{CD6D9C80-FAC1-4C4A-9374-1DB790868F1A}"/>
               </a:ext>
             </a:extLst>
           </p:cNvPr>
@@ -16769,7 +16815,7 @@
           <p:cNvPr id="2" name="">
             <a:extLst xmlns:a="http://schemas.openxmlformats.org/drawingml/2006/main">
               <a:ext uri="{FF2B5EF4-FFF2-40B4-BE49-F238E27FC236}">
-                <a16:creationId xmlns:a16="http://schemas.microsoft.com/office/drawing/2014/main" id="{3693B760-AE78-4BA1-9191-869B3FD2C688}"/>
+                <a16:creationId xmlns:a16="http://schemas.microsoft.com/office/drawing/2014/main" id="{2329900D-2D89-4580-AFB5-01899407E497}"/>
               </a:ext>
             </a:extLst>
           </p:cNvPr>
@@ -16927,7 +16973,7 @@
           <p:cNvPr id="3" name="">
             <a:extLst xmlns:a="http://schemas.openxmlformats.org/drawingml/2006/main">
               <a:ext uri="{FF2B5EF4-FFF2-40B4-BE49-F238E27FC236}">
-                <a16:creationId xmlns:a16="http://schemas.microsoft.com/office/drawing/2014/main" id="{AB60A3FE-3F3A-495A-86EC-0ABDC747FC38}"/>
+                <a16:creationId xmlns:a16="http://schemas.microsoft.com/office/drawing/2014/main" id="{7A903CAF-104F-4B97-A567-100FEA7FA3A6}"/>
               </a:ext>
             </a:extLst>
           </p:cNvPr>
@@ -17075,7 +17121,7 @@
                 <a:ea typeface="Arial"/>
                 <a:cs typeface="Arial"/>
               </a:rPr>
-              <a:t>Projeto Aplicado Cenário 4</a:t>
+              <a:t>Projeto Aplicado Cenário 4  ·  Versão 28/10/2026</a:t>
             </a:r>
           </a:p>
         </p:txBody>
@@ -17085,7 +17131,7 @@
           <p:cNvPr id="4" name="">
             <a:extLst xmlns:a="http://schemas.openxmlformats.org/drawingml/2006/main">
               <a:ext uri="{FF2B5EF4-FFF2-40B4-BE49-F238E27FC236}">
-                <a16:creationId xmlns:a16="http://schemas.microsoft.com/office/drawing/2014/main" id="{71E1C671-1673-4989-8ED6-DAC6A91E3F97}"/>
+                <a16:creationId xmlns:a16="http://schemas.microsoft.com/office/drawing/2014/main" id="{66668094-FD7C-4058-BA05-44207BDBE898}"/>
               </a:ext>
             </a:extLst>
           </p:cNvPr>
@@ -17243,7 +17289,7 @@
           <p:cNvPr id="5" name="">
             <a:extLst xmlns:a="http://schemas.openxmlformats.org/drawingml/2006/main">
               <a:ext uri="{FF2B5EF4-FFF2-40B4-BE49-F238E27FC236}">
-                <a16:creationId xmlns:a16="http://schemas.microsoft.com/office/drawing/2014/main" id="{BB4DC70E-350E-4706-8498-98AD05E11696}"/>
+                <a16:creationId xmlns:a16="http://schemas.microsoft.com/office/drawing/2014/main" id="{70AEF803-B012-4005-B3C3-1323DB2E0010}"/>
               </a:ext>
             </a:extLst>
           </p:cNvPr>
@@ -17459,7 +17505,7 @@
           <p:cNvPr id="6" name="">
             <a:extLst xmlns:a="http://schemas.openxmlformats.org/drawingml/2006/main">
               <a:ext uri="{FF2B5EF4-FFF2-40B4-BE49-F238E27FC236}">
-                <a16:creationId xmlns:a16="http://schemas.microsoft.com/office/drawing/2014/main" id="{9542B702-AF60-4609-8BFE-21D6A2CCCCE3}"/>
+                <a16:creationId xmlns:a16="http://schemas.microsoft.com/office/drawing/2014/main" id="{3F2440A0-BC19-40B7-BBAF-B0E6CB39CE93}"/>
               </a:ext>
             </a:extLst>
           </p:cNvPr>
@@ -17617,7 +17663,7 @@
           <p:cNvPr id="7" name="">
             <a:extLst xmlns:a="http://schemas.openxmlformats.org/drawingml/2006/main">
               <a:ext uri="{FF2B5EF4-FFF2-40B4-BE49-F238E27FC236}">
-                <a16:creationId xmlns:a16="http://schemas.microsoft.com/office/drawing/2014/main" id="{776407D8-B5D0-40C4-8421-7F469F6FF710}"/>
+                <a16:creationId xmlns:a16="http://schemas.microsoft.com/office/drawing/2014/main" id="{4481CC70-6981-49C6-A081-35D65C527CB3}"/>
               </a:ext>
             </a:extLst>
           </p:cNvPr>
@@ -17833,7 +17879,7 @@
           <p:cNvPr id="8" name="">
             <a:extLst xmlns:a="http://schemas.openxmlformats.org/drawingml/2006/main">
               <a:ext uri="{FF2B5EF4-FFF2-40B4-BE49-F238E27FC236}">
-                <a16:creationId xmlns:a16="http://schemas.microsoft.com/office/drawing/2014/main" id="{FDBD5745-700B-426E-AC04-C80433A7F987}"/>
+                <a16:creationId xmlns:a16="http://schemas.microsoft.com/office/drawing/2014/main" id="{3DF71525-0691-4737-95D1-44DC446DACF0}"/>
               </a:ext>
             </a:extLst>
           </p:cNvPr>
@@ -17991,7 +18037,7 @@
           <p:cNvPr id="9" name="">
             <a:extLst xmlns:a="http://schemas.openxmlformats.org/drawingml/2006/main">
               <a:ext uri="{FF2B5EF4-FFF2-40B4-BE49-F238E27FC236}">
-                <a16:creationId xmlns:a16="http://schemas.microsoft.com/office/drawing/2014/main" id="{299A2482-44E8-462F-909B-8A6178AA68C7}"/>
+                <a16:creationId xmlns:a16="http://schemas.microsoft.com/office/drawing/2014/main" id="{12F842B8-BF31-494B-93EC-E9222FC76F17}"/>
               </a:ext>
             </a:extLst>
           </p:cNvPr>
@@ -18207,7 +18253,7 @@
           <p:cNvPr id="10" name="">
             <a:extLst xmlns:a="http://schemas.openxmlformats.org/drawingml/2006/main">
               <a:ext uri="{FF2B5EF4-FFF2-40B4-BE49-F238E27FC236}">
-                <a16:creationId xmlns:a16="http://schemas.microsoft.com/office/drawing/2014/main" id="{0676D30E-6BF1-4A03-8DE0-7D8280D7084C}"/>
+                <a16:creationId xmlns:a16="http://schemas.microsoft.com/office/drawing/2014/main" id="{FE9C2E4E-6BDD-4238-A24B-B9C8A3AD16FF}"/>
               </a:ext>
             </a:extLst>
           </p:cNvPr>
@@ -18355,7 +18401,7 @@
                 <a:ea typeface="Arial"/>
                 <a:cs typeface="Arial"/>
               </a:rPr>
-              <a:t>Viabilidade: um implantável, componentes gratuitos e equipe júnior; custos reais a levantar</a:t>
+              <a:t>Viabilidade: um implantável, serviços gratuitos (não custo zero) e equipe júnior; custos reais a levantar</a:t>
             </a:r>
           </a:p>
         </p:txBody>
@@ -18363,7 +18409,7 @@
     </p:spTree>
     <p:extLst>
       <p:ext uri="{BB962C8B-B14F-4D97-AF65-F5344CB8AC3E}">
-        <p14:creationId xmlns:p14="http://schemas.microsoft.com/office/powerpoint/2010/main" val="2132754436"/>
+        <p14:creationId xmlns:p14="http://schemas.microsoft.com/office/powerpoint/2010/main" val="1195748721"/>
       </p:ext>
     </p:extLst>
   </p:cSld>
@@ -18391,10 +18437,10 @@
       </p:grpSpPr>
       <p:sp>
         <p:nvSpPr>
-          <p:cNvPr id="8" name="">
+          <p:cNvPr id="9" name="">
             <a:extLst xmlns:a="http://schemas.openxmlformats.org/drawingml/2006/main">
               <a:ext uri="{FF2B5EF4-FFF2-40B4-BE49-F238E27FC236}">
-                <a16:creationId xmlns:a16="http://schemas.microsoft.com/office/drawing/2014/main" id="{8E57705D-A972-44AF-B7B7-9ABF5CF19392}"/>
+                <a16:creationId xmlns:a16="http://schemas.microsoft.com/office/drawing/2014/main" id="{FE56AEB4-1D95-48E9-8CA2-867DAF29CB58}"/>
               </a:ext>
             </a:extLst>
           </p:cNvPr>
@@ -18424,7 +18470,7 @@
           <p:cNvPr id="2" name="">
             <a:extLst xmlns:a="http://schemas.openxmlformats.org/drawingml/2006/main">
               <a:ext uri="{FF2B5EF4-FFF2-40B4-BE49-F238E27FC236}">
-                <a16:creationId xmlns:a16="http://schemas.microsoft.com/office/drawing/2014/main" id="{A74C5062-FBE7-4513-B665-CBE126FB3FC4}"/>
+                <a16:creationId xmlns:a16="http://schemas.microsoft.com/office/drawing/2014/main" id="{ABD19A29-E102-4215-A00A-B1CB8E48D7F6}"/>
               </a:ext>
             </a:extLst>
           </p:cNvPr>
@@ -18572,7 +18618,7 @@
                 <a:ea typeface="Arial"/>
                 <a:cs typeface="Arial"/>
               </a:rPr>
-              <a:t>Demonstração e resultados</a:t>
+              <a:t>Evidências e versão de referência</a:t>
             </a:r>
           </a:p>
         </p:txBody>
@@ -18582,7 +18628,7 @@
           <p:cNvPr id="3" name="">
             <a:extLst xmlns:a="http://schemas.openxmlformats.org/drawingml/2006/main">
               <a:ext uri="{FF2B5EF4-FFF2-40B4-BE49-F238E27FC236}">
-                <a16:creationId xmlns:a16="http://schemas.microsoft.com/office/drawing/2014/main" id="{72A507D2-37F5-472C-A281-5C32CEB2FA8F}"/>
+                <a16:creationId xmlns:a16="http://schemas.microsoft.com/office/drawing/2014/main" id="{2F5C8602-8FD5-4279-B47A-3E9724A608E0}"/>
               </a:ext>
             </a:extLst>
           </p:cNvPr>
@@ -18730,7 +18776,7 @@
                 <a:ea typeface="Arial"/>
                 <a:cs typeface="Arial"/>
               </a:rPr>
-              <a:t>Projeto Aplicado Cenário 4</a:t>
+              <a:t>Projeto Aplicado Cenário 4  ·  Versão 28/10/2026</a:t>
             </a:r>
           </a:p>
         </p:txBody>
@@ -18740,7 +18786,7 @@
           <p:cNvPr id="4" name="">
             <a:extLst xmlns:a="http://schemas.openxmlformats.org/drawingml/2006/main">
               <a:ext uri="{FF2B5EF4-FFF2-40B4-BE49-F238E27FC236}">
-                <a16:creationId xmlns:a16="http://schemas.microsoft.com/office/drawing/2014/main" id="{55CC9F6E-0009-49F0-BF7F-4BC283424DE6}"/>
+                <a16:creationId xmlns:a16="http://schemas.microsoft.com/office/drawing/2014/main" id="{096A8522-EE7B-42CB-A0E1-88D83B2ACA35}"/>
               </a:ext>
             </a:extLst>
           </p:cNvPr>
@@ -18751,8 +18797,8 @@
         </p:nvSpPr>
         <p:spPr>
           <a:xfrm xmlns:a="http://schemas.openxmlformats.org/drawingml/2006/main">
-            <a:off x="1000125" y="1381125"/>
-            <a:ext cx="4953000" cy="571500"/>
+            <a:off x="809625" y="1333500"/>
+            <a:ext cx="5143500" cy="476250"/>
           </a:xfrm>
           <a:prstGeom xmlns:a="http://schemas.openxmlformats.org/drawingml/2006/main" prst="rect">
             <a:avLst/>
@@ -18768,9 +18814,9 @@
           </a:bodyPr>
           <a:lstStyle xmlns:a="http://schemas.openxmlformats.org/drawingml/2006/main">
             <a:defPPr>
-              <a:defRPr sz="2550" b="1">
-                <a:solidFill>
-                  <a:srgbClr val="2E7D5B"/>
+              <a:defRPr sz="2250" b="1">
+                <a:solidFill>
+                  <a:srgbClr val="227C83"/>
                 </a:solidFill>
                 <a:latin typeface="Arial"/>
                 <a:ea typeface="Arial"/>
@@ -18778,9 +18824,9 @@
               </a:defRPr>
             </a:defPPr>
             <a:lvl1pPr>
-              <a:defRPr sz="2550" b="1">
-                <a:solidFill>
-                  <a:srgbClr val="2E7D5B"/>
+              <a:defRPr sz="2250" b="1">
+                <a:solidFill>
+                  <a:srgbClr val="227C83"/>
                 </a:solidFill>
                 <a:latin typeface="Arial"/>
                 <a:ea typeface="Arial"/>
@@ -18788,9 +18834,9 @@
               </a:defRPr>
             </a:lvl1pPr>
             <a:lvl2pPr>
-              <a:defRPr sz="2550" b="1">
-                <a:solidFill>
-                  <a:srgbClr val="2E7D5B"/>
+              <a:defRPr sz="2250" b="1">
+                <a:solidFill>
+                  <a:srgbClr val="227C83"/>
                 </a:solidFill>
                 <a:latin typeface="Arial"/>
                 <a:ea typeface="Arial"/>
@@ -18798,9 +18844,9 @@
               </a:defRPr>
             </a:lvl2pPr>
             <a:lvl3pPr>
-              <a:defRPr sz="2550" b="1">
-                <a:solidFill>
-                  <a:srgbClr val="2E7D5B"/>
+              <a:defRPr sz="2250" b="1">
+                <a:solidFill>
+                  <a:srgbClr val="227C83"/>
                 </a:solidFill>
                 <a:latin typeface="Arial"/>
                 <a:ea typeface="Arial"/>
@@ -18808,9 +18854,9 @@
               </a:defRPr>
             </a:lvl3pPr>
             <a:lvl4pPr>
-              <a:defRPr sz="2550" b="1">
-                <a:solidFill>
-                  <a:srgbClr val="2E7D5B"/>
+              <a:defRPr sz="2250" b="1">
+                <a:solidFill>
+                  <a:srgbClr val="227C83"/>
                 </a:solidFill>
                 <a:latin typeface="Arial"/>
                 <a:ea typeface="Arial"/>
@@ -18818,9 +18864,9 @@
               </a:defRPr>
             </a:lvl4pPr>
             <a:lvl5pPr>
-              <a:defRPr sz="2550" b="1">
-                <a:solidFill>
-                  <a:srgbClr val="2E7D5B"/>
+              <a:defRPr sz="2250" b="1">
+                <a:solidFill>
+                  <a:srgbClr val="227C83"/>
                 </a:solidFill>
                 <a:latin typeface="Arial"/>
                 <a:ea typeface="Arial"/>
@@ -18828,9 +18874,9 @@
               </a:defRPr>
             </a:lvl5pPr>
             <a:lvl6pPr>
-              <a:defRPr sz="2550" b="1">
-                <a:solidFill>
-                  <a:srgbClr val="2E7D5B"/>
+              <a:defRPr sz="2250" b="1">
+                <a:solidFill>
+                  <a:srgbClr val="227C83"/>
                 </a:solidFill>
                 <a:latin typeface="Arial"/>
                 <a:ea typeface="Arial"/>
@@ -18838,9 +18884,9 @@
               </a:defRPr>
             </a:lvl6pPr>
             <a:lvl7pPr>
-              <a:defRPr sz="2550" b="1">
-                <a:solidFill>
-                  <a:srgbClr val="2E7D5B"/>
+              <a:defRPr sz="2250" b="1">
+                <a:solidFill>
+                  <a:srgbClr val="227C83"/>
                 </a:solidFill>
                 <a:latin typeface="Arial"/>
                 <a:ea typeface="Arial"/>
@@ -18848,9 +18894,9 @@
               </a:defRPr>
             </a:lvl7pPr>
             <a:lvl8pPr>
-              <a:defRPr sz="2550" b="1">
-                <a:solidFill>
-                  <a:srgbClr val="2E7D5B"/>
+              <a:defRPr sz="2250" b="1">
+                <a:solidFill>
+                  <a:srgbClr val="227C83"/>
                 </a:solidFill>
                 <a:latin typeface="Arial"/>
                 <a:ea typeface="Arial"/>
@@ -18858,9 +18904,9 @@
               </a:defRPr>
             </a:lvl8pPr>
             <a:lvl9pPr>
-              <a:defRPr sz="2550" b="1">
-                <a:solidFill>
-                  <a:srgbClr val="2E7D5B"/>
+              <a:defRPr sz="2250" b="1">
+                <a:solidFill>
+                  <a:srgbClr val="227C83"/>
                 </a:solidFill>
                 <a:latin typeface="Arial"/>
                 <a:ea typeface="Arial"/>
@@ -18870,9 +18916,9 @@
           </a:lstStyle>
           <a:p xmlns:a="http://schemas.openxmlformats.org/drawingml/2006/main">
             <a:pPr>
-              <a:defRPr sz="2550" b="1">
-                <a:solidFill>
-                  <a:srgbClr val="2E7D5B"/>
+              <a:defRPr sz="2250" b="1">
+                <a:solidFill>
+                  <a:srgbClr val="227C83"/>
                 </a:solidFill>
                 <a:latin typeface="Arial"/>
                 <a:ea typeface="Arial"/>
@@ -18880,15 +18926,15 @@
               </a:defRPr>
             </a:pPr>
             <a:r>
-              <a:rPr sz="2550" b="1">
-                <a:solidFill>
-                  <a:srgbClr val="2E7D5B"/>
+              <a:rPr sz="2250" b="1">
+                <a:solidFill>
+                  <a:srgbClr val="227C83"/>
                 </a:solidFill>
                 <a:latin typeface="Arial"/>
                 <a:ea typeface="Arial"/>
                 <a:cs typeface="Arial"/>
               </a:rPr>
-              <a:t>211 testes aprovados</a:t>
+              <a:t>Histórico de 20/10/2026</a:t>
             </a:r>
           </a:p>
         </p:txBody>
@@ -18898,7 +18944,7 @@
           <p:cNvPr id="5" name="">
             <a:extLst xmlns:a="http://schemas.openxmlformats.org/drawingml/2006/main">
               <a:ext uri="{FF2B5EF4-FFF2-40B4-BE49-F238E27FC236}">
-                <a16:creationId xmlns:a16="http://schemas.microsoft.com/office/drawing/2014/main" id="{55304C4A-D156-48DC-84FB-5A939D26FAA7}"/>
+                <a16:creationId xmlns:a16="http://schemas.microsoft.com/office/drawing/2014/main" id="{CEDC8CAC-8ABF-40B3-BE0C-BFBBFE821317}"/>
               </a:ext>
             </a:extLst>
           </p:cNvPr>
@@ -18909,8 +18955,8 @@
         </p:nvSpPr>
         <p:spPr>
           <a:xfrm xmlns:a="http://schemas.openxmlformats.org/drawingml/2006/main">
-            <a:off x="7620000" y="1381125"/>
-            <a:ext cx="3143250" cy="571500"/>
+            <a:off x="762000" y="2047875"/>
+            <a:ext cx="5191125" cy="2905125"/>
           </a:xfrm>
           <a:prstGeom xmlns:a="http://schemas.openxmlformats.org/drawingml/2006/main" prst="rect">
             <a:avLst/>
@@ -18926,9 +18972,9 @@
           </a:bodyPr>
           <a:lstStyle xmlns:a="http://schemas.openxmlformats.org/drawingml/2006/main">
             <a:defPPr>
-              <a:defRPr sz="2550" b="1">
-                <a:solidFill>
-                  <a:srgbClr val="2E7D5B"/>
+              <a:defRPr sz="1800">
+                <a:solidFill>
+                  <a:srgbClr val="17212B"/>
                 </a:solidFill>
                 <a:latin typeface="Arial"/>
                 <a:ea typeface="Arial"/>
@@ -18936,9 +18982,9 @@
               </a:defRPr>
             </a:defPPr>
             <a:lvl1pPr>
-              <a:defRPr sz="2550" b="1">
-                <a:solidFill>
-                  <a:srgbClr val="2E7D5B"/>
+              <a:defRPr sz="1800">
+                <a:solidFill>
+                  <a:srgbClr val="17212B"/>
                 </a:solidFill>
                 <a:latin typeface="Arial"/>
                 <a:ea typeface="Arial"/>
@@ -18946,9 +18992,9 @@
               </a:defRPr>
             </a:lvl1pPr>
             <a:lvl2pPr>
-              <a:defRPr sz="2550" b="1">
-                <a:solidFill>
-                  <a:srgbClr val="2E7D5B"/>
+              <a:defRPr sz="1800">
+                <a:solidFill>
+                  <a:srgbClr val="17212B"/>
                 </a:solidFill>
                 <a:latin typeface="Arial"/>
                 <a:ea typeface="Arial"/>
@@ -18956,9 +19002,9 @@
               </a:defRPr>
             </a:lvl2pPr>
             <a:lvl3pPr>
-              <a:defRPr sz="2550" b="1">
-                <a:solidFill>
-                  <a:srgbClr val="2E7D5B"/>
+              <a:defRPr sz="1800">
+                <a:solidFill>
+                  <a:srgbClr val="17212B"/>
                 </a:solidFill>
                 <a:latin typeface="Arial"/>
                 <a:ea typeface="Arial"/>
@@ -18966,9 +19012,9 @@
               </a:defRPr>
             </a:lvl3pPr>
             <a:lvl4pPr>
-              <a:defRPr sz="2550" b="1">
-                <a:solidFill>
-                  <a:srgbClr val="2E7D5B"/>
+              <a:defRPr sz="1800">
+                <a:solidFill>
+                  <a:srgbClr val="17212B"/>
                 </a:solidFill>
                 <a:latin typeface="Arial"/>
                 <a:ea typeface="Arial"/>
@@ -18976,9 +19022,9 @@
               </a:defRPr>
             </a:lvl4pPr>
             <a:lvl5pPr>
-              <a:defRPr sz="2550" b="1">
-                <a:solidFill>
-                  <a:srgbClr val="2E7D5B"/>
+              <a:defRPr sz="1800">
+                <a:solidFill>
+                  <a:srgbClr val="17212B"/>
                 </a:solidFill>
                 <a:latin typeface="Arial"/>
                 <a:ea typeface="Arial"/>
@@ -18986,9 +19032,9 @@
               </a:defRPr>
             </a:lvl5pPr>
             <a:lvl6pPr>
-              <a:defRPr sz="2550" b="1">
-                <a:solidFill>
-                  <a:srgbClr val="2E7D5B"/>
+              <a:defRPr sz="1800">
+                <a:solidFill>
+                  <a:srgbClr val="17212B"/>
                 </a:solidFill>
                 <a:latin typeface="Arial"/>
                 <a:ea typeface="Arial"/>
@@ -18996,9 +19042,9 @@
               </a:defRPr>
             </a:lvl6pPr>
             <a:lvl7pPr>
-              <a:defRPr sz="2550" b="1">
-                <a:solidFill>
-                  <a:srgbClr val="2E7D5B"/>
+              <a:defRPr sz="1800">
+                <a:solidFill>
+                  <a:srgbClr val="17212B"/>
                 </a:solidFill>
                 <a:latin typeface="Arial"/>
                 <a:ea typeface="Arial"/>
@@ -19006,9 +19052,9 @@
               </a:defRPr>
             </a:lvl7pPr>
             <a:lvl8pPr>
-              <a:defRPr sz="2550" b="1">
-                <a:solidFill>
-                  <a:srgbClr val="2E7D5B"/>
+              <a:defRPr sz="1800">
+                <a:solidFill>
+                  <a:srgbClr val="17212B"/>
                 </a:solidFill>
                 <a:latin typeface="Arial"/>
                 <a:ea typeface="Arial"/>
@@ -19016,9 +19062,9 @@
               </a:defRPr>
             </a:lvl8pPr>
             <a:lvl9pPr>
-              <a:defRPr sz="2550" b="1">
-                <a:solidFill>
-                  <a:srgbClr val="2E7D5B"/>
+              <a:defRPr sz="1800">
+                <a:solidFill>
+                  <a:srgbClr val="17212B"/>
                 </a:solidFill>
                 <a:latin typeface="Arial"/>
                 <a:ea typeface="Arial"/>
@@ -19027,10 +19073,14 @@
             </a:lvl9pPr>
           </a:lstStyle>
           <a:p xmlns:a="http://schemas.openxmlformats.org/drawingml/2006/main">
-            <a:pPr>
-              <a:defRPr sz="2550" b="1">
-                <a:solidFill>
-                  <a:srgbClr val="2E7D5B"/>
+            <a:pPr marL="254000" indent="-127000">
+              <a:spcAft>
+                <a:spcPts val="1000"/>
+              </a:spcAft>
+              <a:buChar char="•"/>
+              <a:defRPr sz="1800">
+                <a:solidFill>
+                  <a:srgbClr val="17212B"/>
                 </a:solidFill>
                 <a:latin typeface="Arial"/>
                 <a:ea typeface="Arial"/>
@@ -19038,15 +19088,96 @@
               </a:defRPr>
             </a:pPr>
             <a:r>
-              <a:rPr sz="2550" b="1">
-                <a:solidFill>
-                  <a:srgbClr val="2E7D5B"/>
+              <a:rPr sz="1800">
+                <a:solidFill>
+                  <a:srgbClr val="17212B"/>
                 </a:solidFill>
                 <a:latin typeface="Arial"/>
                 <a:ea typeface="Arial"/>
                 <a:cs typeface="Arial"/>
               </a:rPr>
-              <a:t>p95  4,22 ms</a:t>
+              <a:t>246 testes com PostgreSQL e RabbitMQ</a:t>
+            </a:r>
+          </a:p>
+          <a:p xmlns:a="http://schemas.openxmlformats.org/drawingml/2006/main">
+            <a:pPr marL="254000" indent="-127000">
+              <a:spcAft>
+                <a:spcPts val="1000"/>
+              </a:spcAft>
+              <a:buChar char="•"/>
+              <a:defRPr sz="1800">
+                <a:solidFill>
+                  <a:srgbClr val="17212B"/>
+                </a:solidFill>
+                <a:latin typeface="Arial"/>
+                <a:ea typeface="Arial"/>
+                <a:cs typeface="Arial"/>
+              </a:defRPr>
+            </a:pPr>
+            <a:r>
+              <a:rPr sz="1800">
+                <a:solidFill>
+                  <a:srgbClr val="17212B"/>
+                </a:solidFill>
+                <a:latin typeface="Arial"/>
+                <a:ea typeface="Arial"/>
+                <a:cs typeface="Arial"/>
+              </a:rPr>
+              <a:t>232 aprovados e 14 ignorados em SQLite</a:t>
+            </a:r>
+          </a:p>
+          <a:p xmlns:a="http://schemas.openxmlformats.org/drawingml/2006/main">
+            <a:pPr marL="254000" indent="-127000">
+              <a:spcAft>
+                <a:spcPts val="1000"/>
+              </a:spcAft>
+              <a:buChar char="•"/>
+              <a:defRPr sz="1800">
+                <a:solidFill>
+                  <a:srgbClr val="17212B"/>
+                </a:solidFill>
+                <a:latin typeface="Arial"/>
+                <a:ea typeface="Arial"/>
+                <a:cs typeface="Arial"/>
+              </a:defRPr>
+            </a:pPr>
+            <a:r>
+              <a:rPr sz="1800">
+                <a:solidFill>
+                  <a:srgbClr val="17212B"/>
+                </a:solidFill>
+                <a:latin typeface="Arial"/>
+                <a:ea typeface="Arial"/>
+                <a:cs typeface="Arial"/>
+              </a:rPr>
+              <a:t>22 roteiros de navegador aprovados</a:t>
+            </a:r>
+          </a:p>
+          <a:p xmlns:a="http://schemas.openxmlformats.org/drawingml/2006/main">
+            <a:pPr marL="254000" indent="-127000">
+              <a:spcAft>
+                <a:spcPts val="1000"/>
+              </a:spcAft>
+              <a:buChar char="•"/>
+              <a:defRPr sz="1800">
+                <a:solidFill>
+                  <a:srgbClr val="17212B"/>
+                </a:solidFill>
+                <a:latin typeface="Arial"/>
+                <a:ea typeface="Arial"/>
+                <a:cs typeface="Arial"/>
+              </a:defRPr>
+            </a:pPr>
+            <a:r>
+              <a:rPr sz="1800">
+                <a:solidFill>
+                  <a:srgbClr val="17212B"/>
+                </a:solidFill>
+                <a:latin typeface="Arial"/>
+                <a:ea typeface="Arial"/>
+                <a:cs typeface="Arial"/>
+              </a:rPr>
+              <a:t>p95 máximo de 45,1 ms em consultas locais</a:t>
             </a:r>
           </a:p>
         </p:txBody>
@@ -19056,7 +19187,7 @@
           <p:cNvPr id="6" name="">
             <a:extLst xmlns:a="http://schemas.openxmlformats.org/drawingml/2006/main">
               <a:ext uri="{FF2B5EF4-FFF2-40B4-BE49-F238E27FC236}">
-                <a16:creationId xmlns:a16="http://schemas.microsoft.com/office/drawing/2014/main" id="{AA3789A5-D973-4441-9DAD-61441710FFE1}"/>
+                <a16:creationId xmlns:a16="http://schemas.microsoft.com/office/drawing/2014/main" id="{56B6FD06-3FC3-4C94-9568-DE1E8F49B809}"/>
               </a:ext>
             </a:extLst>
           </p:cNvPr>
@@ -19067,8 +19198,8 @@
         </p:nvSpPr>
         <p:spPr>
           <a:xfrm xmlns:a="http://schemas.openxmlformats.org/drawingml/2006/main">
-            <a:off x="1619250" y="2381250"/>
-            <a:ext cx="9144000" cy="2857500"/>
+            <a:off x="6477000" y="1333500"/>
+            <a:ext cx="5143500" cy="476250"/>
           </a:xfrm>
           <a:prstGeom xmlns:a="http://schemas.openxmlformats.org/drawingml/2006/main" prst="rect">
             <a:avLst/>
@@ -19084,9 +19215,9 @@
           </a:bodyPr>
           <a:lstStyle xmlns:a="http://schemas.openxmlformats.org/drawingml/2006/main">
             <a:defPPr>
-              <a:defRPr sz="1950">
-                <a:solidFill>
-                  <a:srgbClr val="17212B"/>
+              <a:defRPr sz="2175" b="1">
+                <a:solidFill>
+                  <a:srgbClr val="227C83"/>
                 </a:solidFill>
                 <a:latin typeface="Arial"/>
                 <a:ea typeface="Arial"/>
@@ -19094,9 +19225,9 @@
               </a:defRPr>
             </a:defPPr>
             <a:lvl1pPr>
-              <a:defRPr sz="1950">
-                <a:solidFill>
-                  <a:srgbClr val="17212B"/>
+              <a:defRPr sz="2175" b="1">
+                <a:solidFill>
+                  <a:srgbClr val="227C83"/>
                 </a:solidFill>
                 <a:latin typeface="Arial"/>
                 <a:ea typeface="Arial"/>
@@ -19104,9 +19235,9 @@
               </a:defRPr>
             </a:lvl1pPr>
             <a:lvl2pPr>
-              <a:defRPr sz="1950">
-                <a:solidFill>
-                  <a:srgbClr val="17212B"/>
+              <a:defRPr sz="2175" b="1">
+                <a:solidFill>
+                  <a:srgbClr val="227C83"/>
                 </a:solidFill>
                 <a:latin typeface="Arial"/>
                 <a:ea typeface="Arial"/>
@@ -19114,9 +19245,9 @@
               </a:defRPr>
             </a:lvl2pPr>
             <a:lvl3pPr>
-              <a:defRPr sz="1950">
-                <a:solidFill>
-                  <a:srgbClr val="17212B"/>
+              <a:defRPr sz="2175" b="1">
+                <a:solidFill>
+                  <a:srgbClr val="227C83"/>
                 </a:solidFill>
                 <a:latin typeface="Arial"/>
                 <a:ea typeface="Arial"/>
@@ -19124,9 +19255,9 @@
               </a:defRPr>
             </a:lvl3pPr>
             <a:lvl4pPr>
-              <a:defRPr sz="1950">
-                <a:solidFill>
-                  <a:srgbClr val="17212B"/>
+              <a:defRPr sz="2175" b="1">
+                <a:solidFill>
+                  <a:srgbClr val="227C83"/>
                 </a:solidFill>
                 <a:latin typeface="Arial"/>
                 <a:ea typeface="Arial"/>
@@ -19134,9 +19265,9 @@
               </a:defRPr>
             </a:lvl4pPr>
             <a:lvl5pPr>
-              <a:defRPr sz="1950">
-                <a:solidFill>
-                  <a:srgbClr val="17212B"/>
+              <a:defRPr sz="2175" b="1">
+                <a:solidFill>
+                  <a:srgbClr val="227C83"/>
                 </a:solidFill>
                 <a:latin typeface="Arial"/>
                 <a:ea typeface="Arial"/>
@@ -19144,9 +19275,9 @@
               </a:defRPr>
             </a:lvl5pPr>
             <a:lvl6pPr>
-              <a:defRPr sz="1950">
-                <a:solidFill>
-                  <a:srgbClr val="17212B"/>
+              <a:defRPr sz="2175" b="1">
+                <a:solidFill>
+                  <a:srgbClr val="227C83"/>
                 </a:solidFill>
                 <a:latin typeface="Arial"/>
                 <a:ea typeface="Arial"/>
@@ -19154,9 +19285,9 @@
               </a:defRPr>
             </a:lvl6pPr>
             <a:lvl7pPr>
-              <a:defRPr sz="1950">
-                <a:solidFill>
-                  <a:srgbClr val="17212B"/>
+              <a:defRPr sz="2175" b="1">
+                <a:solidFill>
+                  <a:srgbClr val="227C83"/>
                 </a:solidFill>
                 <a:latin typeface="Arial"/>
                 <a:ea typeface="Arial"/>
@@ -19164,9 +19295,9 @@
               </a:defRPr>
             </a:lvl7pPr>
             <a:lvl8pPr>
-              <a:defRPr sz="1950">
-                <a:solidFill>
-                  <a:srgbClr val="17212B"/>
+              <a:defRPr sz="2175" b="1">
+                <a:solidFill>
+                  <a:srgbClr val="227C83"/>
                 </a:solidFill>
                 <a:latin typeface="Arial"/>
                 <a:ea typeface="Arial"/>
@@ -19174,9 +19305,9 @@
               </a:defRPr>
             </a:lvl8pPr>
             <a:lvl9pPr>
-              <a:defRPr sz="1950">
-                <a:solidFill>
-                  <a:srgbClr val="17212B"/>
+              <a:defRPr sz="2175" b="1">
+                <a:solidFill>
+                  <a:srgbClr val="227C83"/>
                 </a:solidFill>
                 <a:latin typeface="Arial"/>
                 <a:ea typeface="Arial"/>
@@ -19185,14 +19316,10 @@
             </a:lvl9pPr>
           </a:lstStyle>
           <a:p xmlns:a="http://schemas.openxmlformats.org/drawingml/2006/main">
-            <a:pPr marL="254000" indent="-127000">
-              <a:spcAft>
-                <a:spcPts val="1000"/>
-              </a:spcAft>
-              <a:buChar char="•"/>
-              <a:defRPr sz="1950">
-                <a:solidFill>
-                  <a:srgbClr val="17212B"/>
+            <a:pPr>
+              <a:defRPr sz="2175" b="1">
+                <a:solidFill>
+                  <a:srgbClr val="227C83"/>
                 </a:solidFill>
                 <a:latin typeface="Arial"/>
                 <a:ea typeface="Arial"/>
@@ -19200,123 +19327,15 @@
               </a:defRPr>
             </a:pPr>
             <a:r>
-              <a:rPr sz="1950">
-                <a:solidFill>
-                  <a:srgbClr val="17212B"/>
+              <a:rPr sz="2175" b="1">
+                <a:solidFill>
+                  <a:srgbClr val="227C83"/>
                 </a:solidFill>
                 <a:latin typeface="Arial"/>
                 <a:ea typeface="Arial"/>
                 <a:cs typeface="Arial"/>
               </a:rPr>
-              <a:t>F1 cria rascunho sem recadastro: 20 de 20</a:t>
-            </a:r>
-          </a:p>
-          <a:p xmlns:a="http://schemas.openxmlformats.org/drawingml/2006/main">
-            <a:pPr marL="254000" indent="-127000">
-              <a:spcAft>
-                <a:spcPts val="1000"/>
-              </a:spcAft>
-              <a:buChar char="•"/>
-              <a:defRPr sz="1950">
-                <a:solidFill>
-                  <a:srgbClr val="17212B"/>
-                </a:solidFill>
-                <a:latin typeface="Arial"/>
-                <a:ea typeface="Arial"/>
-                <a:cs typeface="Arial"/>
-              </a:defRPr>
-            </a:pPr>
-            <a:r>
-              <a:rPr sz="1950">
-                <a:solidFill>
-                  <a:srgbClr val="17212B"/>
-                </a:solidFill>
-                <a:latin typeface="Arial"/>
-                <a:ea typeface="Arial"/>
-                <a:cs typeface="Arial"/>
-              </a:rPr>
-              <a:t>F2 cria uma cobrança e uma preparação de retirada: 14 de 14</a:t>
-            </a:r>
-          </a:p>
-          <a:p xmlns:a="http://schemas.openxmlformats.org/drawingml/2006/main">
-            <a:pPr marL="254000" indent="-127000">
-              <a:spcAft>
-                <a:spcPts val="1000"/>
-              </a:spcAft>
-              <a:buChar char="•"/>
-              <a:defRPr sz="1950">
-                <a:solidFill>
-                  <a:srgbClr val="17212B"/>
-                </a:solidFill>
-                <a:latin typeface="Arial"/>
-                <a:ea typeface="Arial"/>
-                <a:cs typeface="Arial"/>
-              </a:defRPr>
-            </a:pPr>
-            <a:r>
-              <a:rPr sz="1950">
-                <a:solidFill>
-                  <a:srgbClr val="17212B"/>
-                </a:solidFill>
-                <a:latin typeface="Arial"/>
-                <a:ea typeface="Arial"/>
-                <a:cs typeface="Arial"/>
-              </a:rPr>
-              <a:t>F3 registra SLA, resolve e conclui o processo: 15 de 15</a:t>
-            </a:r>
-          </a:p>
-          <a:p xmlns:a="http://schemas.openxmlformats.org/drawingml/2006/main">
-            <a:pPr marL="254000" indent="-127000">
-              <a:spcAft>
-                <a:spcPts val="1000"/>
-              </a:spcAft>
-              <a:buChar char="•"/>
-              <a:defRPr sz="1950">
-                <a:solidFill>
-                  <a:srgbClr val="17212B"/>
-                </a:solidFill>
-                <a:latin typeface="Arial"/>
-                <a:ea typeface="Arial"/>
-                <a:cs typeface="Arial"/>
-              </a:defRPr>
-            </a:pPr>
-            <a:r>
-              <a:rPr sz="1950">
-                <a:solidFill>
-                  <a:srgbClr val="17212B"/>
-                </a:solidFill>
-                <a:latin typeface="Arial"/>
-                <a:ea typeface="Arial"/>
-                <a:cs typeface="Arial"/>
-              </a:rPr>
-              <a:t>Falha controlada preserva e reconcilia o chamado</a:t>
-            </a:r>
-          </a:p>
-          <a:p xmlns:a="http://schemas.openxmlformats.org/drawingml/2006/main">
-            <a:pPr marL="254000" indent="-127000">
-              <a:spcAft>
-                <a:spcPts val="1000"/>
-              </a:spcAft>
-              <a:buChar char="•"/>
-              <a:defRPr sz="1950">
-                <a:solidFill>
-                  <a:srgbClr val="17212B"/>
-                </a:solidFill>
-                <a:latin typeface="Arial"/>
-                <a:ea typeface="Arial"/>
-                <a:cs typeface="Arial"/>
-              </a:defRPr>
-            </a:pPr>
-            <a:r>
-              <a:rPr sz="1950">
-                <a:solidFill>
-                  <a:srgbClr val="17212B"/>
-                </a:solidFill>
-                <a:latin typeface="Arial"/>
-                <a:ea typeface="Arial"/>
-                <a:cs typeface="Arial"/>
-              </a:rPr>
-              <a:t>Rastreabilidade reúne auditoria e eventos</a:t>
+              <a:t>CI da main f1669d7 em 25/10</a:t>
             </a:r>
           </a:p>
         </p:txBody>
@@ -19326,7 +19345,7 @@
           <p:cNvPr id="7" name="">
             <a:extLst xmlns:a="http://schemas.openxmlformats.org/drawingml/2006/main">
               <a:ext uri="{FF2B5EF4-FFF2-40B4-BE49-F238E27FC236}">
-                <a16:creationId xmlns:a16="http://schemas.microsoft.com/office/drawing/2014/main" id="{947E0B12-AF28-4C6C-9463-F5B562F145B5}"/>
+                <a16:creationId xmlns:a16="http://schemas.microsoft.com/office/drawing/2014/main" id="{54AC997F-A0FE-4F3D-8624-65F01D7AB2A8}"/>
               </a:ext>
             </a:extLst>
           </p:cNvPr>
@@ -19337,8 +19356,251 @@
         </p:nvSpPr>
         <p:spPr>
           <a:xfrm xmlns:a="http://schemas.openxmlformats.org/drawingml/2006/main">
-            <a:off x="2381250" y="5619750"/>
-            <a:ext cx="7620000" cy="400050"/>
+            <a:off x="6429375" y="2047875"/>
+            <a:ext cx="5048250" cy="2905125"/>
+          </a:xfrm>
+          <a:prstGeom xmlns:a="http://schemas.openxmlformats.org/drawingml/2006/main" prst="rect">
+            <a:avLst/>
+          </a:prstGeom>
+          <a:noFill xmlns:a="http://schemas.openxmlformats.org/drawingml/2006/main"/>
+          <a:ln xmlns:a="http://schemas.openxmlformats.org/drawingml/2006/main" w="0">
+            <a:noFill/>
+          </a:ln>
+        </p:spPr>
+        <p:txBody>
+          <a:bodyPr xmlns:a="http://schemas.openxmlformats.org/drawingml/2006/main">
+            <a:noAutofit/>
+          </a:bodyPr>
+          <a:lstStyle xmlns:a="http://schemas.openxmlformats.org/drawingml/2006/main">
+            <a:defPPr>
+              <a:defRPr sz="1800">
+                <a:solidFill>
+                  <a:srgbClr val="17212B"/>
+                </a:solidFill>
+                <a:latin typeface="Arial"/>
+                <a:ea typeface="Arial"/>
+                <a:cs typeface="Arial"/>
+              </a:defRPr>
+            </a:defPPr>
+            <a:lvl1pPr>
+              <a:defRPr sz="1800">
+                <a:solidFill>
+                  <a:srgbClr val="17212B"/>
+                </a:solidFill>
+                <a:latin typeface="Arial"/>
+                <a:ea typeface="Arial"/>
+                <a:cs typeface="Arial"/>
+              </a:defRPr>
+            </a:lvl1pPr>
+            <a:lvl2pPr>
+              <a:defRPr sz="1800">
+                <a:solidFill>
+                  <a:srgbClr val="17212B"/>
+                </a:solidFill>
+                <a:latin typeface="Arial"/>
+                <a:ea typeface="Arial"/>
+                <a:cs typeface="Arial"/>
+              </a:defRPr>
+            </a:lvl2pPr>
+            <a:lvl3pPr>
+              <a:defRPr sz="1800">
+                <a:solidFill>
+                  <a:srgbClr val="17212B"/>
+                </a:solidFill>
+                <a:latin typeface="Arial"/>
+                <a:ea typeface="Arial"/>
+                <a:cs typeface="Arial"/>
+              </a:defRPr>
+            </a:lvl3pPr>
+            <a:lvl4pPr>
+              <a:defRPr sz="1800">
+                <a:solidFill>
+                  <a:srgbClr val="17212B"/>
+                </a:solidFill>
+                <a:latin typeface="Arial"/>
+                <a:ea typeface="Arial"/>
+                <a:cs typeface="Arial"/>
+              </a:defRPr>
+            </a:lvl4pPr>
+            <a:lvl5pPr>
+              <a:defRPr sz="1800">
+                <a:solidFill>
+                  <a:srgbClr val="17212B"/>
+                </a:solidFill>
+                <a:latin typeface="Arial"/>
+                <a:ea typeface="Arial"/>
+                <a:cs typeface="Arial"/>
+              </a:defRPr>
+            </a:lvl5pPr>
+            <a:lvl6pPr>
+              <a:defRPr sz="1800">
+                <a:solidFill>
+                  <a:srgbClr val="17212B"/>
+                </a:solidFill>
+                <a:latin typeface="Arial"/>
+                <a:ea typeface="Arial"/>
+                <a:cs typeface="Arial"/>
+              </a:defRPr>
+            </a:lvl6pPr>
+            <a:lvl7pPr>
+              <a:defRPr sz="1800">
+                <a:solidFill>
+                  <a:srgbClr val="17212B"/>
+                </a:solidFill>
+                <a:latin typeface="Arial"/>
+                <a:ea typeface="Arial"/>
+                <a:cs typeface="Arial"/>
+              </a:defRPr>
+            </a:lvl7pPr>
+            <a:lvl8pPr>
+              <a:defRPr sz="1800">
+                <a:solidFill>
+                  <a:srgbClr val="17212B"/>
+                </a:solidFill>
+                <a:latin typeface="Arial"/>
+                <a:ea typeface="Arial"/>
+                <a:cs typeface="Arial"/>
+              </a:defRPr>
+            </a:lvl8pPr>
+            <a:lvl9pPr>
+              <a:defRPr sz="1800">
+                <a:solidFill>
+                  <a:srgbClr val="17212B"/>
+                </a:solidFill>
+                <a:latin typeface="Arial"/>
+                <a:ea typeface="Arial"/>
+                <a:cs typeface="Arial"/>
+              </a:defRPr>
+            </a:lvl9pPr>
+          </a:lstStyle>
+          <a:p xmlns:a="http://schemas.openxmlformats.org/drawingml/2006/main">
+            <a:pPr marL="254000" indent="-127000">
+              <a:spcAft>
+                <a:spcPts val="1000"/>
+              </a:spcAft>
+              <a:buChar char="•"/>
+              <a:defRPr sz="1800">
+                <a:solidFill>
+                  <a:srgbClr val="17212B"/>
+                </a:solidFill>
+                <a:latin typeface="Arial"/>
+                <a:ea typeface="Arial"/>
+                <a:cs typeface="Arial"/>
+              </a:defRPr>
+            </a:pPr>
+            <a:r>
+              <a:rPr sz="1800">
+                <a:solidFill>
+                  <a:srgbClr val="17212B"/>
+                </a:solidFill>
+                <a:latin typeface="Arial"/>
+                <a:ea typeface="Arial"/>
+                <a:cs typeface="Arial"/>
+              </a:rPr>
+              <a:t>application: 252 aprovados, 14 ignorados</a:t>
+            </a:r>
+          </a:p>
+          <a:p xmlns:a="http://schemas.openxmlformats.org/drawingml/2006/main">
+            <a:pPr marL="254000" indent="-127000">
+              <a:spcAft>
+                <a:spcPts val="1000"/>
+              </a:spcAft>
+              <a:buChar char="•"/>
+              <a:defRPr sz="1800">
+                <a:solidFill>
+                  <a:srgbClr val="17212B"/>
+                </a:solidFill>
+                <a:latin typeface="Arial"/>
+                <a:ea typeface="Arial"/>
+                <a:cs typeface="Arial"/>
+              </a:defRPr>
+            </a:pPr>
+            <a:r>
+              <a:rPr sz="1800">
+                <a:solidFill>
+                  <a:srgbClr val="17212B"/>
+                </a:solidFill>
+                <a:latin typeface="Arial"/>
+                <a:ea typeface="Arial"/>
+                <a:cs typeface="Arial"/>
+              </a:rPr>
+              <a:t>postgresql: 262 aprovados, 4 ignorados</a:t>
+            </a:r>
+          </a:p>
+          <a:p xmlns:a="http://schemas.openxmlformats.org/drawingml/2006/main">
+            <a:pPr marL="254000" indent="-127000">
+              <a:spcAft>
+                <a:spcPts val="1000"/>
+              </a:spcAft>
+              <a:buChar char="•"/>
+              <a:defRPr sz="1800">
+                <a:solidFill>
+                  <a:srgbClr val="17212B"/>
+                </a:solidFill>
+                <a:latin typeface="Arial"/>
+                <a:ea typeface="Arial"/>
+                <a:cs typeface="Arial"/>
+              </a:defRPr>
+            </a:pPr>
+            <a:r>
+              <a:rPr sz="1800">
+                <a:solidFill>
+                  <a:srgbClr val="17212B"/>
+                </a:solidFill>
+                <a:latin typeface="Arial"/>
+                <a:ea typeface="Arial"/>
+                <a:cs typeface="Arial"/>
+              </a:rPr>
+              <a:t>rabbitmq: 22 aprovados</a:t>
+            </a:r>
+          </a:p>
+          <a:p xmlns:a="http://schemas.openxmlformats.org/drawingml/2006/main">
+            <a:pPr marL="254000" indent="-127000">
+              <a:spcAft>
+                <a:spcPts val="1000"/>
+              </a:spcAft>
+              <a:buChar char="•"/>
+              <a:defRPr sz="1800">
+                <a:solidFill>
+                  <a:srgbClr val="17212B"/>
+                </a:solidFill>
+                <a:latin typeface="Arial"/>
+                <a:ea typeface="Arial"/>
+                <a:cs typeface="Arial"/>
+              </a:defRPr>
+            </a:pPr>
+            <a:r>
+              <a:rPr sz="1800">
+                <a:solidFill>
+                  <a:srgbClr val="17212B"/>
+                </a:solidFill>
+                <a:latin typeface="Arial"/>
+                <a:ea typeface="Arial"/>
+                <a:cs typeface="Arial"/>
+              </a:rPr>
+              <a:t>e2e: 25 aprovados; axe: 1 aprovado</a:t>
+            </a:r>
+          </a:p>
+        </p:txBody>
+      </p:sp>
+      <p:sp>
+        <p:nvSpPr>
+          <p:cNvPr id="8" name="">
+            <a:extLst xmlns:a="http://schemas.openxmlformats.org/drawingml/2006/main">
+              <a:ext uri="{FF2B5EF4-FFF2-40B4-BE49-F238E27FC236}">
+                <a16:creationId xmlns:a16="http://schemas.microsoft.com/office/drawing/2014/main" id="{39CEC7AE-EFE3-444B-BDE1-C1E42862ABD4}"/>
+              </a:ext>
+            </a:extLst>
+          </p:cNvPr>
+          <p:cNvSpPr>
+            <a:spLocks xmlns:a="http://schemas.openxmlformats.org/drawingml/2006/main" noGrp="1"/>
+          </p:cNvSpPr>
+          <p:nvPr/>
+        </p:nvSpPr>
+        <p:spPr>
+          <a:xfrm xmlns:a="http://schemas.openxmlformats.org/drawingml/2006/main">
+            <a:off x="952500" y="5286375"/>
+            <a:ext cx="10477500" cy="762000"/>
           </a:xfrm>
           <a:prstGeom xmlns:a="http://schemas.openxmlformats.org/drawingml/2006/main" prst="rect">
             <a:avLst/>
@@ -19474,7 +19736,30 @@
                 <a:ea typeface="Arial"/>
                 <a:cs typeface="Arial"/>
               </a:rPr>
-              <a:t>Premissas do AS IS seguem para validação com a organização</a:t>
+              <a:t>CI 40199072801 com quatro jobs concluídos com sucesso.</a:t>
+            </a:r>
+          </a:p>
+          <a:p xmlns:a="http://schemas.openxmlformats.org/drawingml/2006/main">
+            <a:pPr>
+              <a:defRPr sz="1725" b="1">
+                <a:solidFill>
+                  <a:srgbClr val="C65D3A"/>
+                </a:solidFill>
+                <a:latin typeface="Arial"/>
+                <a:ea typeface="Arial"/>
+                <a:cs typeface="Arial"/>
+              </a:defRPr>
+            </a:pPr>
+            <a:r>
+              <a:rPr sz="1725" b="1">
+                <a:solidFill>
+                  <a:srgbClr val="C65D3A"/>
+                </a:solidFill>
+                <a:latin typeface="Arial"/>
+                <a:ea typeface="Arial"/>
+                <a:cs typeface="Arial"/>
+              </a:rPr>
+              <a:t>As suítes se sobrepõem. Não somar as contagens. p95 histórico de 20/10.</a:t>
             </a:r>
           </a:p>
         </p:txBody>
@@ -19482,7 +19767,7 @@
     </p:spTree>
     <p:extLst>
       <p:ext uri="{BB962C8B-B14F-4D97-AF65-F5344CB8AC3E}">
-        <p14:creationId xmlns:p14="http://schemas.microsoft.com/office/powerpoint/2010/main" val="672559567"/>
+        <p14:creationId xmlns:p14="http://schemas.microsoft.com/office/powerpoint/2010/main" val="1472350016"/>
       </p:ext>
     </p:extLst>
   </p:cSld>
@@ -19513,7 +19798,7 @@
           <p:cNvPr id="9" name="">
             <a:extLst xmlns:a="http://schemas.openxmlformats.org/drawingml/2006/main">
               <a:ext uri="{FF2B5EF4-FFF2-40B4-BE49-F238E27FC236}">
-                <a16:creationId xmlns:a16="http://schemas.microsoft.com/office/drawing/2014/main" id="{38A59B64-499B-47A0-83BD-5292DB25EA45}"/>
+                <a16:creationId xmlns:a16="http://schemas.microsoft.com/office/drawing/2014/main" id="{CF2092BF-7F5C-4EB3-A6CB-C54E9500F867}"/>
               </a:ext>
             </a:extLst>
           </p:cNvPr>
@@ -19543,7 +19828,7 @@
           <p:cNvPr id="2" name="">
             <a:extLst xmlns:a="http://schemas.openxmlformats.org/drawingml/2006/main">
               <a:ext uri="{FF2B5EF4-FFF2-40B4-BE49-F238E27FC236}">
-                <a16:creationId xmlns:a16="http://schemas.microsoft.com/office/drawing/2014/main" id="{7283F30C-44DB-4690-AE4C-FA950D9F7CBF}"/>
+                <a16:creationId xmlns:a16="http://schemas.microsoft.com/office/drawing/2014/main" id="{9CAC1357-2E17-4B9C-98F1-8509340D4DCB}"/>
               </a:ext>
             </a:extLst>
           </p:cNvPr>
@@ -19691,7 +19976,7 @@
                 <a:ea typeface="Arial"/>
                 <a:cs typeface="Arial"/>
               </a:rPr>
-              <a:t>Conclusões e próximos passos</a:t>
+              <a:t>Conclusões e marcos da entrega</a:t>
             </a:r>
           </a:p>
         </p:txBody>
@@ -19701,7 +19986,7 @@
           <p:cNvPr id="3" name="">
             <a:extLst xmlns:a="http://schemas.openxmlformats.org/drawingml/2006/main">
               <a:ext uri="{FF2B5EF4-FFF2-40B4-BE49-F238E27FC236}">
-                <a16:creationId xmlns:a16="http://schemas.microsoft.com/office/drawing/2014/main" id="{E68CA92A-ED5C-44F2-9CB5-6D153DA17F2C}"/>
+                <a16:creationId xmlns:a16="http://schemas.microsoft.com/office/drawing/2014/main" id="{D62E6A57-4F2E-413D-973A-1B59182B0E36}"/>
               </a:ext>
             </a:extLst>
           </p:cNvPr>
@@ -19849,7 +20134,7 @@
                 <a:ea typeface="Arial"/>
                 <a:cs typeface="Arial"/>
               </a:rPr>
-              <a:t>Projeto Aplicado Cenário 4</a:t>
+              <a:t>Projeto Aplicado Cenário 4  ·  Versão 28/10/2026</a:t>
             </a:r>
           </a:p>
         </p:txBody>
@@ -19859,7 +20144,7 @@
           <p:cNvPr id="4" name="">
             <a:extLst xmlns:a="http://schemas.openxmlformats.org/drawingml/2006/main">
               <a:ext uri="{FF2B5EF4-FFF2-40B4-BE49-F238E27FC236}">
-                <a16:creationId xmlns:a16="http://schemas.microsoft.com/office/drawing/2014/main" id="{C603A488-C1D3-4FA1-9761-D940F3878A17}"/>
+                <a16:creationId xmlns:a16="http://schemas.microsoft.com/office/drawing/2014/main" id="{B86D6615-E61F-4043-ACD3-074A7E299C2D}"/>
               </a:ext>
             </a:extLst>
           </p:cNvPr>
@@ -20017,7 +20302,7 @@
           <p:cNvPr id="5" name="">
             <a:extLst xmlns:a="http://schemas.openxmlformats.org/drawingml/2006/main">
               <a:ext uri="{FF2B5EF4-FFF2-40B4-BE49-F238E27FC236}">
-                <a16:creationId xmlns:a16="http://schemas.microsoft.com/office/drawing/2014/main" id="{78515946-BA38-4725-96CC-E112DBC50AF5}"/>
+                <a16:creationId xmlns:a16="http://schemas.microsoft.com/office/drawing/2014/main" id="{70064C00-D92A-4F6E-B267-CBC13773D03A}"/>
               </a:ext>
             </a:extLst>
           </p:cNvPr>
@@ -20029,7 +20314,7 @@
         <p:spPr>
           <a:xfrm xmlns:a="http://schemas.openxmlformats.org/drawingml/2006/main">
             <a:off x="809625" y="2047875"/>
-            <a:ext cx="4953000" cy="2428875"/>
+            <a:ext cx="4953000" cy="2571750"/>
           </a:xfrm>
           <a:prstGeom xmlns:a="http://schemas.openxmlformats.org/drawingml/2006/main" prst="rect">
             <a:avLst/>
@@ -20169,7 +20454,7 @@
                 <a:ea typeface="Arial"/>
                 <a:cs typeface="Arial"/>
               </a:rPr>
-              <a:t>A arquitetura integrou os três fluxos obrigatórios</a:t>
+              <a:t>Os três fluxos têm evidências no protótipo acadêmico</a:t>
             </a:r>
           </a:p>
           <a:p xmlns:a="http://schemas.openxmlformats.org/drawingml/2006/main">
@@ -20196,7 +20481,7 @@
                 <a:ea typeface="Arial"/>
                 <a:cs typeface="Arial"/>
               </a:rPr>
-              <a:t>Reservas e contratos e fronteiras permitem evolução incremental</a:t>
+              <a:t>Contratos e fronteiras permitem evolução incremental</a:t>
             </a:r>
           </a:p>
           <a:p xmlns:a="http://schemas.openxmlformats.org/drawingml/2006/main">
@@ -20223,7 +20508,7 @@
                 <a:ea typeface="Arial"/>
                 <a:cs typeface="Arial"/>
               </a:rPr>
-              <a:t>Outbox, inbox e correlação tornam falhas recuperáveis</a:t>
+              <a:t>Testes aprovados não garantem convergência em todos os casos</a:t>
             </a:r>
           </a:p>
         </p:txBody>
@@ -20233,7 +20518,7 @@
           <p:cNvPr id="6" name="">
             <a:extLst xmlns:a="http://schemas.openxmlformats.org/drawingml/2006/main">
               <a:ext uri="{FF2B5EF4-FFF2-40B4-BE49-F238E27FC236}">
-                <a16:creationId xmlns:a16="http://schemas.microsoft.com/office/drawing/2014/main" id="{AC1AC050-8E27-4800-9006-D5ABCB9F9E06}"/>
+                <a16:creationId xmlns:a16="http://schemas.microsoft.com/office/drawing/2014/main" id="{3385B796-BD95-4023-8DB6-C1B76F8EF958}"/>
               </a:ext>
             </a:extLst>
           </p:cNvPr>
@@ -20391,7 +20676,7 @@
           <p:cNvPr id="7" name="">
             <a:extLst xmlns:a="http://schemas.openxmlformats.org/drawingml/2006/main">
               <a:ext uri="{FF2B5EF4-FFF2-40B4-BE49-F238E27FC236}">
-                <a16:creationId xmlns:a16="http://schemas.microsoft.com/office/drawing/2014/main" id="{5AB21D06-8B51-41EE-B4FD-F2DE7C8C8D79}"/>
+                <a16:creationId xmlns:a16="http://schemas.microsoft.com/office/drawing/2014/main" id="{6133BBD3-E51D-4D0A-9296-0FB6F0DD9D00}"/>
               </a:ext>
             </a:extLst>
           </p:cNvPr>
@@ -20402,8 +20687,8 @@
         </p:nvSpPr>
         <p:spPr>
           <a:xfrm xmlns:a="http://schemas.openxmlformats.org/drawingml/2006/main">
-            <a:off x="6619875" y="2047875"/>
-            <a:ext cx="4762500" cy="2428875"/>
+            <a:off x="6619875" y="1952625"/>
+            <a:ext cx="4762500" cy="2952750"/>
           </a:xfrm>
           <a:prstGeom xmlns:a="http://schemas.openxmlformats.org/drawingml/2006/main" prst="rect">
             <a:avLst/>
@@ -20419,7 +20704,7 @@
           </a:bodyPr>
           <a:lstStyle xmlns:a="http://schemas.openxmlformats.org/drawingml/2006/main">
             <a:defPPr>
-              <a:defRPr sz="1800">
+              <a:defRPr sz="1725">
                 <a:solidFill>
                   <a:srgbClr val="17212B"/>
                 </a:solidFill>
@@ -20429,7 +20714,7 @@
               </a:defRPr>
             </a:defPPr>
             <a:lvl1pPr>
-              <a:defRPr sz="1800">
+              <a:defRPr sz="1725">
                 <a:solidFill>
                   <a:srgbClr val="17212B"/>
                 </a:solidFill>
@@ -20439,7 +20724,7 @@
               </a:defRPr>
             </a:lvl1pPr>
             <a:lvl2pPr>
-              <a:defRPr sz="1800">
+              <a:defRPr sz="1725">
                 <a:solidFill>
                   <a:srgbClr val="17212B"/>
                 </a:solidFill>
@@ -20449,7 +20734,7 @@
               </a:defRPr>
             </a:lvl2pPr>
             <a:lvl3pPr>
-              <a:defRPr sz="1800">
+              <a:defRPr sz="1725">
                 <a:solidFill>
                   <a:srgbClr val="17212B"/>
                 </a:solidFill>
@@ -20459,7 +20744,7 @@
               </a:defRPr>
             </a:lvl3pPr>
             <a:lvl4pPr>
-              <a:defRPr sz="1800">
+              <a:defRPr sz="1725">
                 <a:solidFill>
                   <a:srgbClr val="17212B"/>
                 </a:solidFill>
@@ -20469,7 +20754,7 @@
               </a:defRPr>
             </a:lvl4pPr>
             <a:lvl5pPr>
-              <a:defRPr sz="1800">
+              <a:defRPr sz="1725">
                 <a:solidFill>
                   <a:srgbClr val="17212B"/>
                 </a:solidFill>
@@ -20479,7 +20764,7 @@
               </a:defRPr>
             </a:lvl5pPr>
             <a:lvl6pPr>
-              <a:defRPr sz="1800">
+              <a:defRPr sz="1725">
                 <a:solidFill>
                   <a:srgbClr val="17212B"/>
                 </a:solidFill>
@@ -20489,7 +20774,7 @@
               </a:defRPr>
             </a:lvl6pPr>
             <a:lvl7pPr>
-              <a:defRPr sz="1800">
+              <a:defRPr sz="1725">
                 <a:solidFill>
                   <a:srgbClr val="17212B"/>
                 </a:solidFill>
@@ -20499,7 +20784,7 @@
               </a:defRPr>
             </a:lvl7pPr>
             <a:lvl8pPr>
-              <a:defRPr sz="1800">
+              <a:defRPr sz="1725">
                 <a:solidFill>
                   <a:srgbClr val="17212B"/>
                 </a:solidFill>
@@ -20509,7 +20794,7 @@
               </a:defRPr>
             </a:lvl8pPr>
             <a:lvl9pPr>
-              <a:defRPr sz="1800">
+              <a:defRPr sz="1725">
                 <a:solidFill>
                   <a:srgbClr val="17212B"/>
                 </a:solidFill>
@@ -20525,7 +20810,7 @@
                 <a:spcPts val="1000"/>
               </a:spcAft>
               <a:buChar char="•"/>
-              <a:defRPr sz="1800">
+              <a:defRPr sz="1725">
                 <a:solidFill>
                   <a:srgbClr val="17212B"/>
                 </a:solidFill>
@@ -20535,7 +20820,7 @@
               </a:defRPr>
             </a:pPr>
             <a:r>
-              <a:rPr sz="1800">
+              <a:rPr sz="1725">
                 <a:solidFill>
                   <a:srgbClr val="17212B"/>
                 </a:solidFill>
@@ -20543,7 +20828,7 @@
                 <a:ea typeface="Arial"/>
                 <a:cs typeface="Arial"/>
               </a:rPr>
-              <a:t>Validar premissas e interfaces do AS IS</a:t>
+              <a:t>F3 pode permanecer STARTED após resolução</a:t>
             </a:r>
           </a:p>
           <a:p xmlns:a="http://schemas.openxmlformats.org/drawingml/2006/main">
@@ -20552,7 +20837,7 @@
                 <a:spcPts val="1000"/>
               </a:spcAft>
               <a:buChar char="•"/>
-              <a:defRPr sz="1800">
+              <a:defRPr sz="1725">
                 <a:solidFill>
                   <a:srgbClr val="17212B"/>
                 </a:solidFill>
@@ -20562,7 +20847,7 @@
               </a:defRPr>
             </a:pPr>
             <a:r>
-              <a:rPr sz="1800">
+              <a:rPr sz="1725">
                 <a:solidFill>
                   <a:srgbClr val="17212B"/>
                 </a:solidFill>
@@ -20570,7 +20855,7 @@
                 <a:ea typeface="Arial"/>
                 <a:cs typeface="Arial"/>
               </a:rPr>
-              <a:t>Publicar e testar a demo gratuita com dados sintéticos</a:t>
+              <a:t>Processo COMPLETED pode ter tarefa CANCELLED</a:t>
             </a:r>
           </a:p>
           <a:p xmlns:a="http://schemas.openxmlformats.org/drawingml/2006/main">
@@ -20579,7 +20864,7 @@
                 <a:spcPts val="1000"/>
               </a:spcAft>
               <a:buChar char="•"/>
-              <a:defRPr sz="1800">
+              <a:defRPr sz="1725">
                 <a:solidFill>
                   <a:srgbClr val="17212B"/>
                 </a:solidFill>
@@ -20589,7 +20874,7 @@
               </a:defRPr>
             </a:pPr>
             <a:r>
-              <a:rPr sz="1800">
+              <a:rPr sz="1725">
                 <a:solidFill>
                   <a:srgbClr val="17212B"/>
                 </a:solidFill>
@@ -20597,7 +20882,34 @@
                 <a:ea typeface="Arial"/>
                 <a:cs typeface="Arial"/>
               </a:rPr>
-              <a:t>Adicionar identidade individual e agendador de vencimentos</a:t>
+              <a:t>Fatura exibida OVERDUE pode ser cancelada</a:t>
+            </a:r>
+          </a:p>
+          <a:p xmlns:a="http://schemas.openxmlformats.org/drawingml/2006/main">
+            <a:pPr marL="254000" indent="-127000">
+              <a:spcAft>
+                <a:spcPts val="1000"/>
+              </a:spcAft>
+              <a:buChar char="•"/>
+              <a:defRPr sz="1725">
+                <a:solidFill>
+                  <a:srgbClr val="17212B"/>
+                </a:solidFill>
+                <a:latin typeface="Arial"/>
+                <a:ea typeface="Arial"/>
+                <a:cs typeface="Arial"/>
+              </a:defRPr>
+            </a:pPr>
+            <a:r>
+              <a:rPr sz="1725">
+                <a:solidFill>
+                  <a:srgbClr val="17212B"/>
+                </a:solidFill>
+                <a:latin typeface="Arial"/>
+                <a:ea typeface="Arial"/>
+                <a:cs typeface="Arial"/>
+              </a:rPr>
+              <a:t>Nomes e contribuições individuais pendentes</a:t>
             </a:r>
           </a:p>
         </p:txBody>
@@ -20607,7 +20919,7 @@
           <p:cNvPr id="8" name="">
             <a:extLst xmlns:a="http://schemas.openxmlformats.org/drawingml/2006/main">
               <a:ext uri="{FF2B5EF4-FFF2-40B4-BE49-F238E27FC236}">
-                <a16:creationId xmlns:a16="http://schemas.microsoft.com/office/drawing/2014/main" id="{20327035-BD1B-4456-B7EF-80AC1E387450}"/>
+                <a16:creationId xmlns:a16="http://schemas.microsoft.com/office/drawing/2014/main" id="{15A0E840-E4C6-48A6-BC48-5C42CCB5A79F}"/>
               </a:ext>
             </a:extLst>
           </p:cNvPr>
@@ -20618,8 +20930,8 @@
         </p:nvSpPr>
         <p:spPr>
           <a:xfrm xmlns:a="http://schemas.openxmlformats.org/drawingml/2006/main">
-            <a:off x="1571625" y="5191125"/>
-            <a:ext cx="9048750" cy="590550"/>
+            <a:off x="1571625" y="5143500"/>
+            <a:ext cx="9048750" cy="781050"/>
           </a:xfrm>
           <a:prstGeom xmlns:a="http://schemas.openxmlformats.org/drawingml/2006/main" prst="rect">
             <a:avLst/>
@@ -20635,7 +20947,7 @@
           </a:bodyPr>
           <a:lstStyle xmlns:a="http://schemas.openxmlformats.org/drawingml/2006/main">
             <a:defPPr>
-              <a:defRPr sz="1875" b="1">
+              <a:defRPr sz="2025" b="1">
                 <a:solidFill>
                   <a:srgbClr val="C65D3A"/>
                 </a:solidFill>
@@ -20645,7 +20957,7 @@
               </a:defRPr>
             </a:defPPr>
             <a:lvl1pPr>
-              <a:defRPr sz="1875" b="1">
+              <a:defRPr sz="2025" b="1">
                 <a:solidFill>
                   <a:srgbClr val="C65D3A"/>
                 </a:solidFill>
@@ -20655,7 +20967,7 @@
               </a:defRPr>
             </a:lvl1pPr>
             <a:lvl2pPr>
-              <a:defRPr sz="1875" b="1">
+              <a:defRPr sz="2025" b="1">
                 <a:solidFill>
                   <a:srgbClr val="C65D3A"/>
                 </a:solidFill>
@@ -20665,7 +20977,7 @@
               </a:defRPr>
             </a:lvl2pPr>
             <a:lvl3pPr>
-              <a:defRPr sz="1875" b="1">
+              <a:defRPr sz="2025" b="1">
                 <a:solidFill>
                   <a:srgbClr val="C65D3A"/>
                 </a:solidFill>
@@ -20675,7 +20987,7 @@
               </a:defRPr>
             </a:lvl3pPr>
             <a:lvl4pPr>
-              <a:defRPr sz="1875" b="1">
+              <a:defRPr sz="2025" b="1">
                 <a:solidFill>
                   <a:srgbClr val="C65D3A"/>
                 </a:solidFill>
@@ -20685,7 +20997,7 @@
               </a:defRPr>
             </a:lvl4pPr>
             <a:lvl5pPr>
-              <a:defRPr sz="1875" b="1">
+              <a:defRPr sz="2025" b="1">
                 <a:solidFill>
                   <a:srgbClr val="C65D3A"/>
                 </a:solidFill>
@@ -20695,7 +21007,7 @@
               </a:defRPr>
             </a:lvl5pPr>
             <a:lvl6pPr>
-              <a:defRPr sz="1875" b="1">
+              <a:defRPr sz="2025" b="1">
                 <a:solidFill>
                   <a:srgbClr val="C65D3A"/>
                 </a:solidFill>
@@ -20705,7 +21017,7 @@
               </a:defRPr>
             </a:lvl6pPr>
             <a:lvl7pPr>
-              <a:defRPr sz="1875" b="1">
+              <a:defRPr sz="2025" b="1">
                 <a:solidFill>
                   <a:srgbClr val="C65D3A"/>
                 </a:solidFill>
@@ -20715,7 +21027,7 @@
               </a:defRPr>
             </a:lvl7pPr>
             <a:lvl8pPr>
-              <a:defRPr sz="1875" b="1">
+              <a:defRPr sz="2025" b="1">
                 <a:solidFill>
                   <a:srgbClr val="C65D3A"/>
                 </a:solidFill>
@@ -20725,7 +21037,7 @@
               </a:defRPr>
             </a:lvl8pPr>
             <a:lvl9pPr>
-              <a:defRPr sz="1875" b="1">
+              <a:defRPr sz="2025" b="1">
                 <a:solidFill>
                   <a:srgbClr val="C65D3A"/>
                 </a:solidFill>
@@ -20737,7 +21049,7 @@
           </a:lstStyle>
           <a:p xmlns:a="http://schemas.openxmlformats.org/drawingml/2006/main">
             <a:pPr>
-              <a:defRPr sz="1875" b="1">
+              <a:defRPr sz="2025" b="1">
                 <a:solidFill>
                   <a:srgbClr val="C65D3A"/>
                 </a:solidFill>
@@ -20747,7 +21059,7 @@
               </a:defRPr>
             </a:pPr>
             <a:r>
-              <a:rPr sz="1875" b="1">
+              <a:rPr sz="2025" b="1">
                 <a:solidFill>
                   <a:srgbClr val="C65D3A"/>
                 </a:solidFill>
@@ -20755,7 +21067,30 @@
                 <a:ea typeface="Arial"/>
                 <a:cs typeface="Arial"/>
               </a:rPr>
-              <a:t>Próxima ação: validar a solução com dados, volumes e responsáveis reais</a:t>
+              <a:t>Entrega pronta prevista para 09/11/2026</a:t>
+            </a:r>
+          </a:p>
+          <a:p xmlns:a="http://schemas.openxmlformats.org/drawingml/2006/main">
+            <a:pPr>
+              <a:defRPr sz="2025" b="1">
+                <a:solidFill>
+                  <a:srgbClr val="C65D3A"/>
+                </a:solidFill>
+                <a:latin typeface="Arial"/>
+                <a:ea typeface="Arial"/>
+                <a:cs typeface="Arial"/>
+              </a:defRPr>
+            </a:pPr>
+            <a:r>
+              <a:rPr sz="2025" b="1">
+                <a:solidFill>
+                  <a:srgbClr val="C65D3A"/>
+                </a:solidFill>
+                <a:latin typeface="Arial"/>
+                <a:ea typeface="Arial"/>
+                <a:cs typeface="Arial"/>
+              </a:rPr>
+              <a:t>Apresentação prevista para 23/11/2026</a:t>
             </a:r>
           </a:p>
         </p:txBody>
@@ -20763,7 +21098,7 @@
     </p:spTree>
     <p:extLst>
       <p:ext uri="{BB962C8B-B14F-4D97-AF65-F5344CB8AC3E}">
-        <p14:creationId xmlns:p14="http://schemas.microsoft.com/office/powerpoint/2010/main" val="1024749011"/>
+        <p14:creationId xmlns:p14="http://schemas.microsoft.com/office/powerpoint/2010/main" val="517809180"/>
       </p:ext>
     </p:extLst>
   </p:cSld>
@@ -20794,7 +21129,7 @@
           <p:cNvPr id="10" name="">
             <a:extLst xmlns:a="http://schemas.openxmlformats.org/drawingml/2006/main">
               <a:ext uri="{FF2B5EF4-FFF2-40B4-BE49-F238E27FC236}">
-                <a16:creationId xmlns:a16="http://schemas.microsoft.com/office/drawing/2014/main" id="{46692518-B5B4-4220-8D54-E8B495E6F4D9}"/>
+                <a16:creationId xmlns:a16="http://schemas.microsoft.com/office/drawing/2014/main" id="{E0335C8B-E43F-4222-8607-B6FC71731678}"/>
               </a:ext>
             </a:extLst>
           </p:cNvPr>
@@ -20824,7 +21159,7 @@
           <p:cNvPr id="2" name="">
             <a:extLst xmlns:a="http://schemas.openxmlformats.org/drawingml/2006/main">
               <a:ext uri="{FF2B5EF4-FFF2-40B4-BE49-F238E27FC236}">
-                <a16:creationId xmlns:a16="http://schemas.microsoft.com/office/drawing/2014/main" id="{51F981FB-6EB4-4E3C-9DD6-4C5D714CAD23}"/>
+                <a16:creationId xmlns:a16="http://schemas.microsoft.com/office/drawing/2014/main" id="{C5EBA234-595C-4C62-9105-C2D34E56C00D}"/>
               </a:ext>
             </a:extLst>
           </p:cNvPr>
@@ -20982,7 +21317,7 @@
           <p:cNvPr id="3" name="">
             <a:extLst xmlns:a="http://schemas.openxmlformats.org/drawingml/2006/main">
               <a:ext uri="{FF2B5EF4-FFF2-40B4-BE49-F238E27FC236}">
-                <a16:creationId xmlns:a16="http://schemas.microsoft.com/office/drawing/2014/main" id="{78B910B8-8614-4F73-AC24-71C73928F4B7}"/>
+                <a16:creationId xmlns:a16="http://schemas.microsoft.com/office/drawing/2014/main" id="{237B0CFB-0788-4324-9A8E-0C06F85229D8}"/>
               </a:ext>
             </a:extLst>
           </p:cNvPr>
@@ -21130,7 +21465,7 @@
                 <a:ea typeface="Arial"/>
                 <a:cs typeface="Arial"/>
               </a:rPr>
-              <a:t>Projeto Aplicado Cenário 4</a:t>
+              <a:t>Projeto Aplicado Cenário 4  ·  Versão 28/10/2026</a:t>
             </a:r>
           </a:p>
         </p:txBody>
@@ -21140,7 +21475,7 @@
           <p:cNvPr id="4" name="">
             <a:extLst xmlns:a="http://schemas.openxmlformats.org/drawingml/2006/main">
               <a:ext uri="{FF2B5EF4-FFF2-40B4-BE49-F238E27FC236}">
-                <a16:creationId xmlns:a16="http://schemas.microsoft.com/office/drawing/2014/main" id="{C05E4B4B-4F87-40DB-98D6-155A662AE9EA}"/>
+                <a16:creationId xmlns:a16="http://schemas.microsoft.com/office/drawing/2014/main" id="{CBD8D149-7B95-4B7F-9D93-C2BAB1795A67}"/>
               </a:ext>
             </a:extLst>
           </p:cNvPr>
@@ -21383,7 +21718,7 @@
           <p:cNvPr id="5" name="">
             <a:extLst xmlns:a="http://schemas.openxmlformats.org/drawingml/2006/main">
               <a:ext uri="{FF2B5EF4-FFF2-40B4-BE49-F238E27FC236}">
-                <a16:creationId xmlns:a16="http://schemas.microsoft.com/office/drawing/2014/main" id="{38E7450E-FF81-42FE-A3A6-535B3C05B711}"/>
+                <a16:creationId xmlns:a16="http://schemas.microsoft.com/office/drawing/2014/main" id="{3AD8A57F-039E-4B1F-8F5C-94452F937C79}"/>
               </a:ext>
             </a:extLst>
           </p:cNvPr>
@@ -21548,7 +21883,7 @@
           <p:cNvPr id="6" name="">
             <a:extLst xmlns:a="http://schemas.openxmlformats.org/drawingml/2006/main">
               <a:ext uri="{FF2B5EF4-FFF2-40B4-BE49-F238E27FC236}">
-                <a16:creationId xmlns:a16="http://schemas.microsoft.com/office/drawing/2014/main" id="{19800428-4C36-4F79-9857-4EB799562F0A}"/>
+                <a16:creationId xmlns:a16="http://schemas.microsoft.com/office/drawing/2014/main" id="{B3691AFD-7A20-48DE-A2C0-C9B2AAC6B88E}"/>
               </a:ext>
             </a:extLst>
           </p:cNvPr>
@@ -21713,7 +22048,7 @@
           <p:cNvPr id="7" name="">
             <a:extLst xmlns:a="http://schemas.openxmlformats.org/drawingml/2006/main">
               <a:ext uri="{FF2B5EF4-FFF2-40B4-BE49-F238E27FC236}">
-                <a16:creationId xmlns:a16="http://schemas.microsoft.com/office/drawing/2014/main" id="{16CC61DA-5A80-4951-8F7E-557566394142}"/>
+                <a16:creationId xmlns:a16="http://schemas.microsoft.com/office/drawing/2014/main" id="{DB38D867-BDD1-40A3-92D2-BB67F4BC18B5}"/>
               </a:ext>
             </a:extLst>
           </p:cNvPr>
@@ -21878,7 +22213,7 @@
           <p:cNvPr id="8" name="">
             <a:extLst xmlns:a="http://schemas.openxmlformats.org/drawingml/2006/main">
               <a:ext uri="{FF2B5EF4-FFF2-40B4-BE49-F238E27FC236}">
-                <a16:creationId xmlns:a16="http://schemas.microsoft.com/office/drawing/2014/main" id="{306576D9-B00D-4467-A0EB-1D37731ECABF}"/>
+                <a16:creationId xmlns:a16="http://schemas.microsoft.com/office/drawing/2014/main" id="{7F72EE14-BE14-459F-9105-FEDDA616AA61}"/>
               </a:ext>
             </a:extLst>
           </p:cNvPr>
@@ -22043,7 +22378,7 @@
           <p:cNvPr id="9" name="">
             <a:extLst xmlns:a="http://schemas.openxmlformats.org/drawingml/2006/main">
               <a:ext uri="{FF2B5EF4-FFF2-40B4-BE49-F238E27FC236}">
-                <a16:creationId xmlns:a16="http://schemas.microsoft.com/office/drawing/2014/main" id="{A6E3A105-7687-43DE-B6BA-7967A6C1C2B1}"/>
+                <a16:creationId xmlns:a16="http://schemas.microsoft.com/office/drawing/2014/main" id="{FC3228AD-4249-46D3-876B-907D36D323CD}"/>
               </a:ext>
             </a:extLst>
           </p:cNvPr>
@@ -22206,7 +22541,7 @@
     </p:spTree>
     <p:extLst>
       <p:ext uri="{BB962C8B-B14F-4D97-AF65-F5344CB8AC3E}">
-        <p14:creationId xmlns:p14="http://schemas.microsoft.com/office/powerpoint/2010/main" val="2033026072"/>
+        <p14:creationId xmlns:p14="http://schemas.microsoft.com/office/powerpoint/2010/main" val="1337664166"/>
       </p:ext>
     </p:extLst>
   </p:cSld>
@@ -22237,7 +22572,7 @@
           <p:cNvPr id="7" name="">
             <a:extLst xmlns:a="http://schemas.openxmlformats.org/drawingml/2006/main">
               <a:ext uri="{FF2B5EF4-FFF2-40B4-BE49-F238E27FC236}">
-                <a16:creationId xmlns:a16="http://schemas.microsoft.com/office/drawing/2014/main" id="{F3D886F3-4BA7-4B99-8306-A1367FA148F9}"/>
+                <a16:creationId xmlns:a16="http://schemas.microsoft.com/office/drawing/2014/main" id="{97EA82A6-C1DB-4580-B3C3-DEB9ECEF3B19}"/>
               </a:ext>
             </a:extLst>
           </p:cNvPr>
@@ -22267,7 +22602,7 @@
           <p:cNvPr id="2" name="">
             <a:extLst xmlns:a="http://schemas.openxmlformats.org/drawingml/2006/main">
               <a:ext uri="{FF2B5EF4-FFF2-40B4-BE49-F238E27FC236}">
-                <a16:creationId xmlns:a16="http://schemas.microsoft.com/office/drawing/2014/main" id="{8C2F060B-CD0F-411F-AA9F-D60C2AE08399}"/>
+                <a16:creationId xmlns:a16="http://schemas.microsoft.com/office/drawing/2014/main" id="{F0414E2E-8BD6-45BC-8A82-AFF47486FD88}"/>
               </a:ext>
             </a:extLst>
           </p:cNvPr>
@@ -22425,7 +22760,7 @@
           <p:cNvPr id="3" name="">
             <a:extLst xmlns:a="http://schemas.openxmlformats.org/drawingml/2006/main">
               <a:ext uri="{FF2B5EF4-FFF2-40B4-BE49-F238E27FC236}">
-                <a16:creationId xmlns:a16="http://schemas.microsoft.com/office/drawing/2014/main" id="{54FF6899-0F91-4AD4-B2A2-B35AF5CD7E9C}"/>
+                <a16:creationId xmlns:a16="http://schemas.microsoft.com/office/drawing/2014/main" id="{B420374A-252C-4EF7-87E4-71DB9AB896C8}"/>
               </a:ext>
             </a:extLst>
           </p:cNvPr>
@@ -22573,7 +22908,7 @@
                 <a:ea typeface="Arial"/>
                 <a:cs typeface="Arial"/>
               </a:rPr>
-              <a:t>Projeto Aplicado Cenário 4</a:t>
+              <a:t>Projeto Aplicado Cenário 4  ·  Versão 28/10/2026</a:t>
             </a:r>
           </a:p>
         </p:txBody>
@@ -22583,7 +22918,7 @@
           <p:cNvPr id="4" name="">
             <a:extLst xmlns:a="http://schemas.openxmlformats.org/drawingml/2006/main">
               <a:ext uri="{FF2B5EF4-FFF2-40B4-BE49-F238E27FC236}">
-                <a16:creationId xmlns:a16="http://schemas.microsoft.com/office/drawing/2014/main" id="{32FE8014-FDBF-4A2A-AF4C-AF2BE1746740}"/>
+                <a16:creationId xmlns:a16="http://schemas.microsoft.com/office/drawing/2014/main" id="{AF232A1D-FF4C-4CA8-8D80-1CA9A92C296B}"/>
               </a:ext>
             </a:extLst>
           </p:cNvPr>
@@ -22741,7 +23076,7 @@
           <p:cNvPr id="5" name="">
             <a:extLst xmlns:a="http://schemas.openxmlformats.org/drawingml/2006/main">
               <a:ext uri="{FF2B5EF4-FFF2-40B4-BE49-F238E27FC236}">
-                <a16:creationId xmlns:a16="http://schemas.microsoft.com/office/drawing/2014/main" id="{0552E73D-8D88-4F19-BE3A-E3C453C8D840}"/>
+                <a16:creationId xmlns:a16="http://schemas.microsoft.com/office/drawing/2014/main" id="{C8E56E33-948A-4F71-8B17-343D6C500A58}"/>
               </a:ext>
             </a:extLst>
           </p:cNvPr>
@@ -22751,7 +23086,7 @@
           <p:nvPr/>
         </p:nvPicPr>
         <p:blipFill>
-          <a:blip xmlns:r="http://schemas.openxmlformats.org/officeDocument/2006/relationships" xmlns:a="http://schemas.openxmlformats.org/drawingml/2006/main" r:embed="R5f24c57f261a4ae6"/>
+          <a:blip xmlns:r="http://schemas.openxmlformats.org/officeDocument/2006/relationships" xmlns:a="http://schemas.openxmlformats.org/drawingml/2006/main" r:embed="R442d3fdbdb804d02"/>
           <a:stretch xmlns:a="http://schemas.openxmlformats.org/drawingml/2006/main"/>
         </p:blipFill>
         <p:spPr>
@@ -22769,7 +23104,7 @@
           <p:cNvPr id="6" name="">
             <a:extLst xmlns:a="http://schemas.openxmlformats.org/drawingml/2006/main">
               <a:ext uri="{FF2B5EF4-FFF2-40B4-BE49-F238E27FC236}">
-                <a16:creationId xmlns:a16="http://schemas.microsoft.com/office/drawing/2014/main" id="{49ACA00B-B42E-47AE-AA44-8A6F6A234C73}"/>
+                <a16:creationId xmlns:a16="http://schemas.microsoft.com/office/drawing/2014/main" id="{F79936A9-56F9-4FD1-8DFA-DF65F8218652}"/>
               </a:ext>
             </a:extLst>
           </p:cNvPr>
@@ -22925,7 +23260,7 @@
     </p:spTree>
     <p:extLst>
       <p:ext uri="{BB962C8B-B14F-4D97-AF65-F5344CB8AC3E}">
-        <p14:creationId xmlns:p14="http://schemas.microsoft.com/office/powerpoint/2010/main" val="1279118972"/>
+        <p14:creationId xmlns:p14="http://schemas.microsoft.com/office/powerpoint/2010/main" val="398864758"/>
       </p:ext>
     </p:extLst>
   </p:cSld>
@@ -22956,7 +23291,7 @@
           <p:cNvPr id="7" name="">
             <a:extLst xmlns:a="http://schemas.openxmlformats.org/drawingml/2006/main">
               <a:ext uri="{FF2B5EF4-FFF2-40B4-BE49-F238E27FC236}">
-                <a16:creationId xmlns:a16="http://schemas.microsoft.com/office/drawing/2014/main" id="{3FEE1E41-F07A-4D9F-B55E-BF58F10416CD}"/>
+                <a16:creationId xmlns:a16="http://schemas.microsoft.com/office/drawing/2014/main" id="{886102EE-96FA-47D9-BF09-9BD7449EDD21}"/>
               </a:ext>
             </a:extLst>
           </p:cNvPr>
@@ -22986,7 +23321,7 @@
           <p:cNvPr id="2" name="">
             <a:extLst xmlns:a="http://schemas.openxmlformats.org/drawingml/2006/main">
               <a:ext uri="{FF2B5EF4-FFF2-40B4-BE49-F238E27FC236}">
-                <a16:creationId xmlns:a16="http://schemas.microsoft.com/office/drawing/2014/main" id="{72D80791-2564-48BA-AC77-9231AAAEED6E}"/>
+                <a16:creationId xmlns:a16="http://schemas.microsoft.com/office/drawing/2014/main" id="{11F66293-8AC4-47BB-8278-AC6C4A3B8603}"/>
               </a:ext>
             </a:extLst>
           </p:cNvPr>
@@ -23144,7 +23479,7 @@
           <p:cNvPr id="3" name="">
             <a:extLst xmlns:a="http://schemas.openxmlformats.org/drawingml/2006/main">
               <a:ext uri="{FF2B5EF4-FFF2-40B4-BE49-F238E27FC236}">
-                <a16:creationId xmlns:a16="http://schemas.microsoft.com/office/drawing/2014/main" id="{03F54981-5AD1-436F-8B3D-40FBFFABC384}"/>
+                <a16:creationId xmlns:a16="http://schemas.microsoft.com/office/drawing/2014/main" id="{1D65ABC2-F1CF-4333-9E0F-4525A0C298E5}"/>
               </a:ext>
             </a:extLst>
           </p:cNvPr>
@@ -23292,7 +23627,7 @@
                 <a:ea typeface="Arial"/>
                 <a:cs typeface="Arial"/>
               </a:rPr>
-              <a:t>Projeto Aplicado Cenário 4</a:t>
+              <a:t>Projeto Aplicado Cenário 4  ·  Versão 28/10/2026</a:t>
             </a:r>
           </a:p>
         </p:txBody>
@@ -23302,7 +23637,7 @@
           <p:cNvPr id="4" name="">
             <a:extLst xmlns:a="http://schemas.openxmlformats.org/drawingml/2006/main">
               <a:ext uri="{FF2B5EF4-FFF2-40B4-BE49-F238E27FC236}">
-                <a16:creationId xmlns:a16="http://schemas.microsoft.com/office/drawing/2014/main" id="{8F3F1E45-DA63-4F9F-AA6A-8D715EF7613F}"/>
+                <a16:creationId xmlns:a16="http://schemas.microsoft.com/office/drawing/2014/main" id="{1A3CCC3A-2B2C-4FD9-8649-6105A43A7074}"/>
               </a:ext>
             </a:extLst>
           </p:cNvPr>
@@ -23545,7 +23880,7 @@
           <p:cNvPr id="5" name="">
             <a:extLst xmlns:a="http://schemas.openxmlformats.org/drawingml/2006/main">
               <a:ext uri="{FF2B5EF4-FFF2-40B4-BE49-F238E27FC236}">
-                <a16:creationId xmlns:a16="http://schemas.microsoft.com/office/drawing/2014/main" id="{94F76EF3-2159-4747-BFA7-11F9FB4515B4}"/>
+                <a16:creationId xmlns:a16="http://schemas.microsoft.com/office/drawing/2014/main" id="{9A06A441-3A0B-4F27-B487-EC4C56DF340D}"/>
               </a:ext>
             </a:extLst>
           </p:cNvPr>
@@ -23703,7 +24038,7 @@
           <p:cNvPr id="6" name="">
             <a:extLst xmlns:a="http://schemas.openxmlformats.org/drawingml/2006/main">
               <a:ext uri="{FF2B5EF4-FFF2-40B4-BE49-F238E27FC236}">
-                <a16:creationId xmlns:a16="http://schemas.microsoft.com/office/drawing/2014/main" id="{99C5FA0B-C8A1-4C8A-B9F3-0569CE0C258B}"/>
+                <a16:creationId xmlns:a16="http://schemas.microsoft.com/office/drawing/2014/main" id="{44F76592-ACF6-4AC4-91BA-1F2B40EE488E}"/>
               </a:ext>
             </a:extLst>
           </p:cNvPr>
@@ -24025,7 +24360,7 @@
     </p:spTree>
     <p:extLst>
       <p:ext uri="{BB962C8B-B14F-4D97-AF65-F5344CB8AC3E}">
-        <p14:creationId xmlns:p14="http://schemas.microsoft.com/office/powerpoint/2010/main" val="2001583491"/>
+        <p14:creationId xmlns:p14="http://schemas.microsoft.com/office/powerpoint/2010/main" val="2047447363"/>
       </p:ext>
     </p:extLst>
   </p:cSld>
@@ -24056,7 +24391,7 @@
           <p:cNvPr id="7" name="">
             <a:extLst xmlns:a="http://schemas.openxmlformats.org/drawingml/2006/main">
               <a:ext uri="{FF2B5EF4-FFF2-40B4-BE49-F238E27FC236}">
-                <a16:creationId xmlns:a16="http://schemas.microsoft.com/office/drawing/2014/main" id="{E393E905-08F9-4353-B02E-264B69E70B4C}"/>
+                <a16:creationId xmlns:a16="http://schemas.microsoft.com/office/drawing/2014/main" id="{98F2F754-873C-4104-965B-B9EE8B65EFB2}"/>
               </a:ext>
             </a:extLst>
           </p:cNvPr>
@@ -24086,7 +24421,7 @@
           <p:cNvPr id="2" name="">
             <a:extLst xmlns:a="http://schemas.openxmlformats.org/drawingml/2006/main">
               <a:ext uri="{FF2B5EF4-FFF2-40B4-BE49-F238E27FC236}">
-                <a16:creationId xmlns:a16="http://schemas.microsoft.com/office/drawing/2014/main" id="{8EF53911-FCDC-4B9C-909E-0F637951097B}"/>
+                <a16:creationId xmlns:a16="http://schemas.microsoft.com/office/drawing/2014/main" id="{5CFD0B6F-563E-4F01-A384-71ABC8ACADCD}"/>
               </a:ext>
             </a:extLst>
           </p:cNvPr>
@@ -24244,7 +24579,7 @@
           <p:cNvPr id="3" name="">
             <a:extLst xmlns:a="http://schemas.openxmlformats.org/drawingml/2006/main">
               <a:ext uri="{FF2B5EF4-FFF2-40B4-BE49-F238E27FC236}">
-                <a16:creationId xmlns:a16="http://schemas.microsoft.com/office/drawing/2014/main" id="{1BDE2170-3AB4-4291-B2CB-81800B705A05}"/>
+                <a16:creationId xmlns:a16="http://schemas.microsoft.com/office/drawing/2014/main" id="{D2A3E201-D138-45B4-BA58-FA3A0A108947}"/>
               </a:ext>
             </a:extLst>
           </p:cNvPr>
@@ -24392,7 +24727,7 @@
                 <a:ea typeface="Arial"/>
                 <a:cs typeface="Arial"/>
               </a:rPr>
-              <a:t>Projeto Aplicado Cenário 4</a:t>
+              <a:t>Projeto Aplicado Cenário 4  ·  Versão 28/10/2026</a:t>
             </a:r>
           </a:p>
         </p:txBody>
@@ -24402,7 +24737,7 @@
           <p:cNvPr id="4" name="">
             <a:extLst xmlns:a="http://schemas.openxmlformats.org/drawingml/2006/main">
               <a:ext uri="{FF2B5EF4-FFF2-40B4-BE49-F238E27FC236}">
-                <a16:creationId xmlns:a16="http://schemas.microsoft.com/office/drawing/2014/main" id="{2EB26866-35F3-46CF-8C39-F9F59F262B8E}"/>
+                <a16:creationId xmlns:a16="http://schemas.microsoft.com/office/drawing/2014/main" id="{C51D28E8-35E4-44C3-9D29-EFE2F708EC51}"/>
               </a:ext>
             </a:extLst>
           </p:cNvPr>
@@ -24560,7 +24895,7 @@
           <p:cNvPr id="5" name="">
             <a:extLst xmlns:a="http://schemas.openxmlformats.org/drawingml/2006/main">
               <a:ext uri="{FF2B5EF4-FFF2-40B4-BE49-F238E27FC236}">
-                <a16:creationId xmlns:a16="http://schemas.microsoft.com/office/drawing/2014/main" id="{42861581-42F6-485D-A65A-13036D629ADA}"/>
+                <a16:creationId xmlns:a16="http://schemas.microsoft.com/office/drawing/2014/main" id="{15A8E860-985A-403F-A180-FCE25F533246}"/>
               </a:ext>
             </a:extLst>
           </p:cNvPr>
@@ -24803,7 +25138,7 @@
           <p:cNvPr id="6" name="">
             <a:extLst xmlns:a="http://schemas.openxmlformats.org/drawingml/2006/main">
               <a:ext uri="{FF2B5EF4-FFF2-40B4-BE49-F238E27FC236}">
-                <a16:creationId xmlns:a16="http://schemas.microsoft.com/office/drawing/2014/main" id="{A368221C-38AA-4684-92D1-86F73A4AE534}"/>
+                <a16:creationId xmlns:a16="http://schemas.microsoft.com/office/drawing/2014/main" id="{4E71C85D-3A8E-43E3-A60F-4ADFF978E94F}"/>
               </a:ext>
             </a:extLst>
           </p:cNvPr>
@@ -24959,7 +25294,7 @@
     </p:spTree>
     <p:extLst>
       <p:ext uri="{BB962C8B-B14F-4D97-AF65-F5344CB8AC3E}">
-        <p14:creationId xmlns:p14="http://schemas.microsoft.com/office/powerpoint/2010/main" val="301702740"/>
+        <p14:creationId xmlns:p14="http://schemas.microsoft.com/office/powerpoint/2010/main" val="1820411137"/>
       </p:ext>
     </p:extLst>
   </p:cSld>
@@ -24990,7 +25325,7 @@
           <p:cNvPr id="7" name="">
             <a:extLst xmlns:a="http://schemas.openxmlformats.org/drawingml/2006/main">
               <a:ext uri="{FF2B5EF4-FFF2-40B4-BE49-F238E27FC236}">
-                <a16:creationId xmlns:a16="http://schemas.microsoft.com/office/drawing/2014/main" id="{A5100763-6956-485B-BEFF-580A21DC5F9E}"/>
+                <a16:creationId xmlns:a16="http://schemas.microsoft.com/office/drawing/2014/main" id="{30AD806D-C1E8-4518-9AFD-173078EA6FF9}"/>
               </a:ext>
             </a:extLst>
           </p:cNvPr>
@@ -25020,7 +25355,7 @@
           <p:cNvPr id="2" name="">
             <a:extLst xmlns:a="http://schemas.openxmlformats.org/drawingml/2006/main">
               <a:ext uri="{FF2B5EF4-FFF2-40B4-BE49-F238E27FC236}">
-                <a16:creationId xmlns:a16="http://schemas.microsoft.com/office/drawing/2014/main" id="{023C0A2F-E1B4-489A-A35C-004947AE40F9}"/>
+                <a16:creationId xmlns:a16="http://schemas.microsoft.com/office/drawing/2014/main" id="{B266E570-FEDC-47B1-A6E2-D3A5D28613F6}"/>
               </a:ext>
             </a:extLst>
           </p:cNvPr>
@@ -25178,7 +25513,7 @@
           <p:cNvPr id="3" name="">
             <a:extLst xmlns:a="http://schemas.openxmlformats.org/drawingml/2006/main">
               <a:ext uri="{FF2B5EF4-FFF2-40B4-BE49-F238E27FC236}">
-                <a16:creationId xmlns:a16="http://schemas.microsoft.com/office/drawing/2014/main" id="{64A2E80F-7AEB-4B95-B7FD-1238424F8F3B}"/>
+                <a16:creationId xmlns:a16="http://schemas.microsoft.com/office/drawing/2014/main" id="{83CCC297-26DE-41E5-972F-65BC252AEFA9}"/>
               </a:ext>
             </a:extLst>
           </p:cNvPr>
@@ -25326,7 +25661,7 @@
                 <a:ea typeface="Arial"/>
                 <a:cs typeface="Arial"/>
               </a:rPr>
-              <a:t>Projeto Aplicado Cenário 4</a:t>
+              <a:t>Projeto Aplicado Cenário 4  ·  Versão 28/10/2026</a:t>
             </a:r>
           </a:p>
         </p:txBody>
@@ -25336,7 +25671,7 @@
           <p:cNvPr id="4" name="">
             <a:extLst xmlns:a="http://schemas.openxmlformats.org/drawingml/2006/main">
               <a:ext uri="{FF2B5EF4-FFF2-40B4-BE49-F238E27FC236}">
-                <a16:creationId xmlns:a16="http://schemas.microsoft.com/office/drawing/2014/main" id="{67FABE38-D401-4459-A4BA-0B3A9688F7E1}"/>
+                <a16:creationId xmlns:a16="http://schemas.microsoft.com/office/drawing/2014/main" id="{295DD83C-2377-48CE-8D4A-73D4261260DA}"/>
               </a:ext>
             </a:extLst>
           </p:cNvPr>
@@ -25346,7 +25681,7 @@
           <p:nvPr/>
         </p:nvPicPr>
         <p:blipFill>
-          <a:blip xmlns:r="http://schemas.openxmlformats.org/officeDocument/2006/relationships" xmlns:a="http://schemas.openxmlformats.org/drawingml/2006/main" r:embed="R7ba2c40846854e44"/>
+          <a:blip xmlns:r="http://schemas.openxmlformats.org/officeDocument/2006/relationships" xmlns:a="http://schemas.openxmlformats.org/drawingml/2006/main" r:embed="Redaf8f5dac99459a"/>
           <a:stretch xmlns:a="http://schemas.openxmlformats.org/drawingml/2006/main"/>
         </p:blipFill>
         <p:spPr>
@@ -25364,7 +25699,7 @@
           <p:cNvPr id="5" name="">
             <a:extLst xmlns:a="http://schemas.openxmlformats.org/drawingml/2006/main">
               <a:ext uri="{FF2B5EF4-FFF2-40B4-BE49-F238E27FC236}">
-                <a16:creationId xmlns:a16="http://schemas.microsoft.com/office/drawing/2014/main" id="{80A029D4-2393-4D8B-A7BC-5FC3ED59B364}"/>
+                <a16:creationId xmlns:a16="http://schemas.microsoft.com/office/drawing/2014/main" id="{AE0653C6-0CA9-43D4-910A-2BA305974C66}"/>
               </a:ext>
             </a:extLst>
           </p:cNvPr>
@@ -25607,7 +25942,7 @@
           <p:cNvPr id="6" name="">
             <a:extLst xmlns:a="http://schemas.openxmlformats.org/drawingml/2006/main">
               <a:ext uri="{FF2B5EF4-FFF2-40B4-BE49-F238E27FC236}">
-                <a16:creationId xmlns:a16="http://schemas.microsoft.com/office/drawing/2014/main" id="{ABC5EA8B-9E75-4F91-AAE7-8FB11FF4F5E6}"/>
+                <a16:creationId xmlns:a16="http://schemas.microsoft.com/office/drawing/2014/main" id="{C7603FDF-F0D7-470A-8294-756D630D83F3}"/>
               </a:ext>
             </a:extLst>
           </p:cNvPr>
@@ -25763,7 +26098,7 @@
     </p:spTree>
     <p:extLst>
       <p:ext uri="{BB962C8B-B14F-4D97-AF65-F5344CB8AC3E}">
-        <p14:creationId xmlns:p14="http://schemas.microsoft.com/office/powerpoint/2010/main" val="646684032"/>
+        <p14:creationId xmlns:p14="http://schemas.microsoft.com/office/powerpoint/2010/main" val="1583082640"/>
       </p:ext>
     </p:extLst>
   </p:cSld>
@@ -25794,7 +26129,7 @@
           <p:cNvPr id="19" name="">
             <a:extLst xmlns:a="http://schemas.openxmlformats.org/drawingml/2006/main">
               <a:ext uri="{FF2B5EF4-FFF2-40B4-BE49-F238E27FC236}">
-                <a16:creationId xmlns:a16="http://schemas.microsoft.com/office/drawing/2014/main" id="{E08321A8-9333-4500-AD20-29391595C1B4}"/>
+                <a16:creationId xmlns:a16="http://schemas.microsoft.com/office/drawing/2014/main" id="{E0409CBA-4961-4347-87E7-025E85F66025}"/>
               </a:ext>
             </a:extLst>
           </p:cNvPr>
@@ -25824,7 +26159,7 @@
           <p:cNvPr id="2" name="">
             <a:extLst xmlns:a="http://schemas.openxmlformats.org/drawingml/2006/main">
               <a:ext uri="{FF2B5EF4-FFF2-40B4-BE49-F238E27FC236}">
-                <a16:creationId xmlns:a16="http://schemas.microsoft.com/office/drawing/2014/main" id="{99CD0C5C-D162-4556-86ED-5AB348519E1C}"/>
+                <a16:creationId xmlns:a16="http://schemas.microsoft.com/office/drawing/2014/main" id="{D2DFCB02-AB6C-4AC5-A13B-18034DE4C6A8}"/>
               </a:ext>
             </a:extLst>
           </p:cNvPr>
@@ -25982,7 +26317,7 @@
           <p:cNvPr id="3" name="">
             <a:extLst xmlns:a="http://schemas.openxmlformats.org/drawingml/2006/main">
               <a:ext uri="{FF2B5EF4-FFF2-40B4-BE49-F238E27FC236}">
-                <a16:creationId xmlns:a16="http://schemas.microsoft.com/office/drawing/2014/main" id="{BB34A784-E2DF-4BCE-833E-1A1F2DB90F1C}"/>
+                <a16:creationId xmlns:a16="http://schemas.microsoft.com/office/drawing/2014/main" id="{4F0C9736-0B23-40C4-B25F-EC89F8496781}"/>
               </a:ext>
             </a:extLst>
           </p:cNvPr>
@@ -26130,7 +26465,7 @@
                 <a:ea typeface="Arial"/>
                 <a:cs typeface="Arial"/>
               </a:rPr>
-              <a:t>Projeto Aplicado Cenário 4</a:t>
+              <a:t>Projeto Aplicado Cenário 4  ·  Versão 28/10/2026</a:t>
             </a:r>
           </a:p>
         </p:txBody>
@@ -26140,7 +26475,7 @@
           <p:cNvPr id="4" name="">
             <a:extLst xmlns:a="http://schemas.openxmlformats.org/drawingml/2006/main">
               <a:ext uri="{FF2B5EF4-FFF2-40B4-BE49-F238E27FC236}">
-                <a16:creationId xmlns:a16="http://schemas.microsoft.com/office/drawing/2014/main" id="{DC383B24-7B7F-47EE-81C0-60B0B59DF05E}"/>
+                <a16:creationId xmlns:a16="http://schemas.microsoft.com/office/drawing/2014/main" id="{C7C61B60-5036-4BC4-9840-4FF31B42F823}"/>
               </a:ext>
             </a:extLst>
           </p:cNvPr>
@@ -26305,7 +26640,7 @@
           <p:cNvPr id="5" name="">
             <a:extLst xmlns:a="http://schemas.openxmlformats.org/drawingml/2006/main">
               <a:ext uri="{FF2B5EF4-FFF2-40B4-BE49-F238E27FC236}">
-                <a16:creationId xmlns:a16="http://schemas.microsoft.com/office/drawing/2014/main" id="{495D5FB4-C76C-47EB-87ED-83EA68A0F138}"/>
+                <a16:creationId xmlns:a16="http://schemas.microsoft.com/office/drawing/2014/main" id="{084CD303-1A40-4E24-9815-5EFBEFDB05BE}"/>
               </a:ext>
             </a:extLst>
           </p:cNvPr>
@@ -26463,7 +26798,7 @@
           <p:cNvPr id="6" name="">
             <a:extLst xmlns:a="http://schemas.openxmlformats.org/drawingml/2006/main">
               <a:ext uri="{FF2B5EF4-FFF2-40B4-BE49-F238E27FC236}">
-                <a16:creationId xmlns:a16="http://schemas.microsoft.com/office/drawing/2014/main" id="{1ADA156C-F976-45C0-9658-8ED2053766CA}"/>
+                <a16:creationId xmlns:a16="http://schemas.microsoft.com/office/drawing/2014/main" id="{34E3E8ED-50AA-443A-B3D1-AC840FCFC425}"/>
               </a:ext>
             </a:extLst>
           </p:cNvPr>
@@ -26621,7 +26956,7 @@
           <p:cNvPr id="7" name="">
             <a:extLst xmlns:a="http://schemas.openxmlformats.org/drawingml/2006/main">
               <a:ext uri="{FF2B5EF4-FFF2-40B4-BE49-F238E27FC236}">
-                <a16:creationId xmlns:a16="http://schemas.microsoft.com/office/drawing/2014/main" id="{BBCD95F0-36FE-4159-8C3A-464EF6E18EE5}"/>
+                <a16:creationId xmlns:a16="http://schemas.microsoft.com/office/drawing/2014/main" id="{8CC777C9-8A3B-41B7-902A-F217F9F8FF0E}"/>
               </a:ext>
             </a:extLst>
           </p:cNvPr>
@@ -26786,7 +27121,7 @@
           <p:cNvPr id="8" name="">
             <a:extLst xmlns:a="http://schemas.openxmlformats.org/drawingml/2006/main">
               <a:ext uri="{FF2B5EF4-FFF2-40B4-BE49-F238E27FC236}">
-                <a16:creationId xmlns:a16="http://schemas.microsoft.com/office/drawing/2014/main" id="{CD0EA44B-E600-4838-BE92-620182535B2F}"/>
+                <a16:creationId xmlns:a16="http://schemas.microsoft.com/office/drawing/2014/main" id="{1D1701FF-33BB-4F68-9BC5-653A11C9A3E7}"/>
               </a:ext>
             </a:extLst>
           </p:cNvPr>
@@ -26944,7 +27279,7 @@
           <p:cNvPr id="9" name="">
             <a:extLst xmlns:a="http://schemas.openxmlformats.org/drawingml/2006/main">
               <a:ext uri="{FF2B5EF4-FFF2-40B4-BE49-F238E27FC236}">
-                <a16:creationId xmlns:a16="http://schemas.microsoft.com/office/drawing/2014/main" id="{53D600BD-EB77-440E-87E4-C39068538787}"/>
+                <a16:creationId xmlns:a16="http://schemas.microsoft.com/office/drawing/2014/main" id="{BEF67298-0A01-4FAA-99F6-486446D08C80}"/>
               </a:ext>
             </a:extLst>
           </p:cNvPr>
@@ -27102,7 +27437,7 @@
           <p:cNvPr id="10" name="">
             <a:extLst xmlns:a="http://schemas.openxmlformats.org/drawingml/2006/main">
               <a:ext uri="{FF2B5EF4-FFF2-40B4-BE49-F238E27FC236}">
-                <a16:creationId xmlns:a16="http://schemas.microsoft.com/office/drawing/2014/main" id="{FD8B58CC-2832-4065-9145-6E2ECA792A9B}"/>
+                <a16:creationId xmlns:a16="http://schemas.microsoft.com/office/drawing/2014/main" id="{82D60308-7599-4175-B791-828D547D68F0}"/>
               </a:ext>
             </a:extLst>
           </p:cNvPr>
@@ -27267,7 +27602,7 @@
           <p:cNvPr id="11" name="">
             <a:extLst xmlns:a="http://schemas.openxmlformats.org/drawingml/2006/main">
               <a:ext uri="{FF2B5EF4-FFF2-40B4-BE49-F238E27FC236}">
-                <a16:creationId xmlns:a16="http://schemas.microsoft.com/office/drawing/2014/main" id="{D5F0BA3D-0328-4333-A0B0-3BC99A3E0683}"/>
+                <a16:creationId xmlns:a16="http://schemas.microsoft.com/office/drawing/2014/main" id="{DC338644-66D7-4D93-A5E0-8094F7E13F6A}"/>
               </a:ext>
             </a:extLst>
           </p:cNvPr>
@@ -27425,7 +27760,7 @@
           <p:cNvPr id="12" name="">
             <a:extLst xmlns:a="http://schemas.openxmlformats.org/drawingml/2006/main">
               <a:ext uri="{FF2B5EF4-FFF2-40B4-BE49-F238E27FC236}">
-                <a16:creationId xmlns:a16="http://schemas.microsoft.com/office/drawing/2014/main" id="{1FCFBFD8-5AEB-4BCB-9883-13FC847CA058}"/>
+                <a16:creationId xmlns:a16="http://schemas.microsoft.com/office/drawing/2014/main" id="{8A305D72-2909-4CEB-9DF6-82ABD60C5E19}"/>
               </a:ext>
             </a:extLst>
           </p:cNvPr>
@@ -27583,7 +27918,7 @@
           <p:cNvPr id="13" name="">
             <a:extLst xmlns:a="http://schemas.openxmlformats.org/drawingml/2006/main">
               <a:ext uri="{FF2B5EF4-FFF2-40B4-BE49-F238E27FC236}">
-                <a16:creationId xmlns:a16="http://schemas.microsoft.com/office/drawing/2014/main" id="{CB919B67-58ED-432C-BCB4-15FACFBE9B66}"/>
+                <a16:creationId xmlns:a16="http://schemas.microsoft.com/office/drawing/2014/main" id="{7D29FEC2-7533-495C-AB3C-FEAD13FA31CF}"/>
               </a:ext>
             </a:extLst>
           </p:cNvPr>
@@ -27748,7 +28083,7 @@
           <p:cNvPr id="14" name="">
             <a:extLst xmlns:a="http://schemas.openxmlformats.org/drawingml/2006/main">
               <a:ext uri="{FF2B5EF4-FFF2-40B4-BE49-F238E27FC236}">
-                <a16:creationId xmlns:a16="http://schemas.microsoft.com/office/drawing/2014/main" id="{00F7EE1F-2C6C-410A-B7C0-577D10010ED6}"/>
+                <a16:creationId xmlns:a16="http://schemas.microsoft.com/office/drawing/2014/main" id="{8C9FAAE1-5F74-4127-AB04-08778AFF83FE}"/>
               </a:ext>
             </a:extLst>
           </p:cNvPr>
@@ -27906,7 +28241,7 @@
           <p:cNvPr id="15" name="">
             <a:extLst xmlns:a="http://schemas.openxmlformats.org/drawingml/2006/main">
               <a:ext uri="{FF2B5EF4-FFF2-40B4-BE49-F238E27FC236}">
-                <a16:creationId xmlns:a16="http://schemas.microsoft.com/office/drawing/2014/main" id="{D3112E00-8AAE-484B-BF97-553267CCD582}"/>
+                <a16:creationId xmlns:a16="http://schemas.microsoft.com/office/drawing/2014/main" id="{1D457411-D8AE-4650-B633-D91D8C5E21FD}"/>
               </a:ext>
             </a:extLst>
           </p:cNvPr>
@@ -28064,7 +28399,7 @@
           <p:cNvPr id="16" name="">
             <a:extLst xmlns:a="http://schemas.openxmlformats.org/drawingml/2006/main">
               <a:ext uri="{FF2B5EF4-FFF2-40B4-BE49-F238E27FC236}">
-                <a16:creationId xmlns:a16="http://schemas.microsoft.com/office/drawing/2014/main" id="{53651466-7504-4430-A440-058905E1B630}"/>
+                <a16:creationId xmlns:a16="http://schemas.microsoft.com/office/drawing/2014/main" id="{2B9D7817-564C-4FB7-AD80-C8439F2073E0}"/>
               </a:ext>
             </a:extLst>
           </p:cNvPr>
@@ -28229,7 +28564,7 @@
           <p:cNvPr id="17" name="">
             <a:extLst xmlns:a="http://schemas.openxmlformats.org/drawingml/2006/main">
               <a:ext uri="{FF2B5EF4-FFF2-40B4-BE49-F238E27FC236}">
-                <a16:creationId xmlns:a16="http://schemas.microsoft.com/office/drawing/2014/main" id="{E6CF5F64-C195-4854-AB32-F989EC538517}"/>
+                <a16:creationId xmlns:a16="http://schemas.microsoft.com/office/drawing/2014/main" id="{5A4B0896-9D4D-4D5C-8752-6D7C68EF02FE}"/>
               </a:ext>
             </a:extLst>
           </p:cNvPr>
@@ -28387,7 +28722,7 @@
           <p:cNvPr id="18" name="">
             <a:extLst xmlns:a="http://schemas.openxmlformats.org/drawingml/2006/main">
               <a:ext uri="{FF2B5EF4-FFF2-40B4-BE49-F238E27FC236}">
-                <a16:creationId xmlns:a16="http://schemas.microsoft.com/office/drawing/2014/main" id="{6646368D-D945-4FFE-9F3E-E5D44545EECD}"/>
+                <a16:creationId xmlns:a16="http://schemas.microsoft.com/office/drawing/2014/main" id="{87B2AB50-E4F2-4E81-88ED-9EBCDFDC1AD6}"/>
               </a:ext>
             </a:extLst>
           </p:cNvPr>
@@ -28543,7 +28878,7 @@
     </p:spTree>
     <p:extLst>
       <p:ext uri="{BB962C8B-B14F-4D97-AF65-F5344CB8AC3E}">
-        <p14:creationId xmlns:p14="http://schemas.microsoft.com/office/powerpoint/2010/main" val="1185681379"/>
+        <p14:creationId xmlns:p14="http://schemas.microsoft.com/office/powerpoint/2010/main" val="289355591"/>
       </p:ext>
     </p:extLst>
   </p:cSld>
@@ -28574,7 +28909,7 @@
           <p:cNvPr id="16" name="">
             <a:extLst xmlns:a="http://schemas.openxmlformats.org/drawingml/2006/main">
               <a:ext uri="{FF2B5EF4-FFF2-40B4-BE49-F238E27FC236}">
-                <a16:creationId xmlns:a16="http://schemas.microsoft.com/office/drawing/2014/main" id="{16536538-AFCD-464B-861A-B72D62729F7C}"/>
+                <a16:creationId xmlns:a16="http://schemas.microsoft.com/office/drawing/2014/main" id="{F0BED1FE-7BFD-43D8-824A-7ED81E844D80}"/>
               </a:ext>
             </a:extLst>
           </p:cNvPr>
@@ -28604,7 +28939,7 @@
           <p:cNvPr id="2" name="">
             <a:extLst xmlns:a="http://schemas.openxmlformats.org/drawingml/2006/main">
               <a:ext uri="{FF2B5EF4-FFF2-40B4-BE49-F238E27FC236}">
-                <a16:creationId xmlns:a16="http://schemas.microsoft.com/office/drawing/2014/main" id="{1D041BB9-9161-41A3-A907-2640CB1152A8}"/>
+                <a16:creationId xmlns:a16="http://schemas.microsoft.com/office/drawing/2014/main" id="{76E52E5D-C938-4E04-A0B8-C0540BBFDDF3}"/>
               </a:ext>
             </a:extLst>
           </p:cNvPr>
@@ -28762,7 +29097,7 @@
           <p:cNvPr id="3" name="">
             <a:extLst xmlns:a="http://schemas.openxmlformats.org/drawingml/2006/main">
               <a:ext uri="{FF2B5EF4-FFF2-40B4-BE49-F238E27FC236}">
-                <a16:creationId xmlns:a16="http://schemas.microsoft.com/office/drawing/2014/main" id="{5C85FAF3-2957-425C-878D-AF06B2F07D10}"/>
+                <a16:creationId xmlns:a16="http://schemas.microsoft.com/office/drawing/2014/main" id="{0F8FDC1A-2226-4932-AC79-DE0E39281508}"/>
               </a:ext>
             </a:extLst>
           </p:cNvPr>
@@ -28910,7 +29245,7 @@
                 <a:ea typeface="Arial"/>
                 <a:cs typeface="Arial"/>
               </a:rPr>
-              <a:t>Projeto Aplicado Cenário 4</a:t>
+              <a:t>Projeto Aplicado Cenário 4  ·  Versão 28/10/2026</a:t>
             </a:r>
           </a:p>
         </p:txBody>
@@ -28920,7 +29255,7 @@
           <p:cNvPr id="4" name="">
             <a:extLst xmlns:a="http://schemas.openxmlformats.org/drawingml/2006/main">
               <a:ext uri="{FF2B5EF4-FFF2-40B4-BE49-F238E27FC236}">
-                <a16:creationId xmlns:a16="http://schemas.microsoft.com/office/drawing/2014/main" id="{BE813EE2-53AA-4E07-AB66-1A4FB92B770D}"/>
+                <a16:creationId xmlns:a16="http://schemas.microsoft.com/office/drawing/2014/main" id="{04B565D3-DE61-4994-9EDF-11549C5F63C9}"/>
               </a:ext>
             </a:extLst>
           </p:cNvPr>
@@ -29078,7 +29413,7 @@
           <p:cNvPr id="5" name="">
             <a:extLst xmlns:a="http://schemas.openxmlformats.org/drawingml/2006/main">
               <a:ext uri="{FF2B5EF4-FFF2-40B4-BE49-F238E27FC236}">
-                <a16:creationId xmlns:a16="http://schemas.microsoft.com/office/drawing/2014/main" id="{66CD1496-A15A-4EBF-B47E-8C4801DED033}"/>
+                <a16:creationId xmlns:a16="http://schemas.microsoft.com/office/drawing/2014/main" id="{069B7356-2ECD-4FFA-A23E-197EA0E476B1}"/>
               </a:ext>
             </a:extLst>
           </p:cNvPr>
@@ -29236,7 +29571,7 @@
           <p:cNvPr id="6" name="">
             <a:extLst xmlns:a="http://schemas.openxmlformats.org/drawingml/2006/main">
               <a:ext uri="{FF2B5EF4-FFF2-40B4-BE49-F238E27FC236}">
-                <a16:creationId xmlns:a16="http://schemas.microsoft.com/office/drawing/2014/main" id="{A5EB4C1C-9DDF-4CA4-A1D2-23068C741252}"/>
+                <a16:creationId xmlns:a16="http://schemas.microsoft.com/office/drawing/2014/main" id="{CC0B3C58-EE1C-4534-8D8D-23B7E8362735}"/>
               </a:ext>
             </a:extLst>
           </p:cNvPr>
@@ -29394,7 +29729,7 @@
           <p:cNvPr id="7" name="">
             <a:extLst xmlns:a="http://schemas.openxmlformats.org/drawingml/2006/main">
               <a:ext uri="{FF2B5EF4-FFF2-40B4-BE49-F238E27FC236}">
-                <a16:creationId xmlns:a16="http://schemas.microsoft.com/office/drawing/2014/main" id="{6690A9CB-5861-4481-8DE0-140860DA7B3E}"/>
+                <a16:creationId xmlns:a16="http://schemas.microsoft.com/office/drawing/2014/main" id="{4EE51E81-809E-4898-B854-F7E30919F058}"/>
               </a:ext>
             </a:extLst>
           </p:cNvPr>
@@ -29552,7 +29887,7 @@
           <p:cNvPr id="8" name="">
             <a:extLst xmlns:a="http://schemas.openxmlformats.org/drawingml/2006/main">
               <a:ext uri="{FF2B5EF4-FFF2-40B4-BE49-F238E27FC236}">
-                <a16:creationId xmlns:a16="http://schemas.microsoft.com/office/drawing/2014/main" id="{B4C73DD7-3D91-4C95-B623-B7FB0189241D}"/>
+                <a16:creationId xmlns:a16="http://schemas.microsoft.com/office/drawing/2014/main" id="{727E234D-AE82-4F74-862D-7C3615E1AEBE}"/>
               </a:ext>
             </a:extLst>
           </p:cNvPr>
@@ -29710,7 +30045,7 @@
           <p:cNvPr id="9" name="">
             <a:extLst xmlns:a="http://schemas.openxmlformats.org/drawingml/2006/main">
               <a:ext uri="{FF2B5EF4-FFF2-40B4-BE49-F238E27FC236}">
-                <a16:creationId xmlns:a16="http://schemas.microsoft.com/office/drawing/2014/main" id="{5E8F8250-B823-42EE-93B3-5E6F2866531E}"/>
+                <a16:creationId xmlns:a16="http://schemas.microsoft.com/office/drawing/2014/main" id="{97A761F8-2495-468D-A9D7-B442A5479C82}"/>
               </a:ext>
             </a:extLst>
           </p:cNvPr>
@@ -29868,7 +30203,7 @@
           <p:cNvPr id="10" name="">
             <a:extLst xmlns:a="http://schemas.openxmlformats.org/drawingml/2006/main">
               <a:ext uri="{FF2B5EF4-FFF2-40B4-BE49-F238E27FC236}">
-                <a16:creationId xmlns:a16="http://schemas.microsoft.com/office/drawing/2014/main" id="{4F421842-4C56-43BA-9461-4102EFE49F19}"/>
+                <a16:creationId xmlns:a16="http://schemas.microsoft.com/office/drawing/2014/main" id="{F9CEAACD-A8F9-471D-B25B-59BB8CEAF801}"/>
               </a:ext>
             </a:extLst>
           </p:cNvPr>
@@ -30026,7 +30361,7 @@
           <p:cNvPr id="11" name="">
             <a:extLst xmlns:a="http://schemas.openxmlformats.org/drawingml/2006/main">
               <a:ext uri="{FF2B5EF4-FFF2-40B4-BE49-F238E27FC236}">
-                <a16:creationId xmlns:a16="http://schemas.microsoft.com/office/drawing/2014/main" id="{295CA136-A53A-4EC1-999C-6FE6C0105C6E}"/>
+                <a16:creationId xmlns:a16="http://schemas.microsoft.com/office/drawing/2014/main" id="{CC7BC676-C41F-4038-9516-5CF7DA23F2E6}"/>
               </a:ext>
             </a:extLst>
           </p:cNvPr>
@@ -30184,7 +30519,7 @@
           <p:cNvPr id="12" name="">
             <a:extLst xmlns:a="http://schemas.openxmlformats.org/drawingml/2006/main">
               <a:ext uri="{FF2B5EF4-FFF2-40B4-BE49-F238E27FC236}">
-                <a16:creationId xmlns:a16="http://schemas.microsoft.com/office/drawing/2014/main" id="{7AD9F545-F7D2-4B50-956B-5AB67451EA84}"/>
+                <a16:creationId xmlns:a16="http://schemas.microsoft.com/office/drawing/2014/main" id="{4E1664C6-24D8-4702-9F1D-B6B5A1B9A3F7}"/>
               </a:ext>
             </a:extLst>
           </p:cNvPr>
@@ -30342,7 +30677,7 @@
           <p:cNvPr id="13" name="">
             <a:extLst xmlns:a="http://schemas.openxmlformats.org/drawingml/2006/main">
               <a:ext uri="{FF2B5EF4-FFF2-40B4-BE49-F238E27FC236}">
-                <a16:creationId xmlns:a16="http://schemas.microsoft.com/office/drawing/2014/main" id="{DD1556CC-1C02-4952-AC07-3856D48B2391}"/>
+                <a16:creationId xmlns:a16="http://schemas.microsoft.com/office/drawing/2014/main" id="{B673505E-9AF5-4EFC-B1E1-A28EBA3891DF}"/>
               </a:ext>
             </a:extLst>
           </p:cNvPr>
@@ -30500,7 +30835,7 @@
           <p:cNvPr id="14" name="">
             <a:extLst xmlns:a="http://schemas.openxmlformats.org/drawingml/2006/main">
               <a:ext uri="{FF2B5EF4-FFF2-40B4-BE49-F238E27FC236}">
-                <a16:creationId xmlns:a16="http://schemas.microsoft.com/office/drawing/2014/main" id="{F4A9522B-5466-40D2-9E1B-69D81A0E9FFF}"/>
+                <a16:creationId xmlns:a16="http://schemas.microsoft.com/office/drawing/2014/main" id="{E1E53C14-CD57-47FC-9DE1-6E12D1D202E7}"/>
               </a:ext>
             </a:extLst>
           </p:cNvPr>
@@ -30658,7 +30993,7 @@
           <p:cNvPr id="15" name="">
             <a:extLst xmlns:a="http://schemas.openxmlformats.org/drawingml/2006/main">
               <a:ext uri="{FF2B5EF4-FFF2-40B4-BE49-F238E27FC236}">
-                <a16:creationId xmlns:a16="http://schemas.microsoft.com/office/drawing/2014/main" id="{0601A111-EF2C-4B36-AF4F-45794B665FE3}"/>
+                <a16:creationId xmlns:a16="http://schemas.microsoft.com/office/drawing/2014/main" id="{F3E5B7E9-0A68-40B9-A874-A46BA01BA9A1}"/>
               </a:ext>
             </a:extLst>
           </p:cNvPr>
@@ -30814,7 +31149,7 @@
     </p:spTree>
     <p:extLst>
       <p:ext uri="{BB962C8B-B14F-4D97-AF65-F5344CB8AC3E}">
-        <p14:creationId xmlns:p14="http://schemas.microsoft.com/office/powerpoint/2010/main" val="1561174393"/>
+        <p14:creationId xmlns:p14="http://schemas.microsoft.com/office/powerpoint/2010/main" val="334837432"/>
       </p:ext>
     </p:extLst>
   </p:cSld>
@@ -30845,7 +31180,7 @@
           <p:cNvPr id="9" name="">
             <a:extLst xmlns:a="http://schemas.openxmlformats.org/drawingml/2006/main">
               <a:ext uri="{FF2B5EF4-FFF2-40B4-BE49-F238E27FC236}">
-                <a16:creationId xmlns:a16="http://schemas.microsoft.com/office/drawing/2014/main" id="{779DE8AB-9E68-4A4F-8B5A-035C65A3EB09}"/>
+                <a16:creationId xmlns:a16="http://schemas.microsoft.com/office/drawing/2014/main" id="{679E70A1-65C8-4B33-BFE3-6E03D4579892}"/>
               </a:ext>
             </a:extLst>
           </p:cNvPr>
@@ -30875,7 +31210,7 @@
           <p:cNvPr id="2" name="">
             <a:extLst xmlns:a="http://schemas.openxmlformats.org/drawingml/2006/main">
               <a:ext uri="{FF2B5EF4-FFF2-40B4-BE49-F238E27FC236}">
-                <a16:creationId xmlns:a16="http://schemas.microsoft.com/office/drawing/2014/main" id="{97C8D749-F7A7-4D27-BCED-8532F1383954}"/>
+                <a16:creationId xmlns:a16="http://schemas.microsoft.com/office/drawing/2014/main" id="{09C87233-1984-4983-B8EE-B2ED28A4EAB6}"/>
               </a:ext>
             </a:extLst>
           </p:cNvPr>
@@ -31033,7 +31368,7 @@
           <p:cNvPr id="3" name="">
             <a:extLst xmlns:a="http://schemas.openxmlformats.org/drawingml/2006/main">
               <a:ext uri="{FF2B5EF4-FFF2-40B4-BE49-F238E27FC236}">
-                <a16:creationId xmlns:a16="http://schemas.microsoft.com/office/drawing/2014/main" id="{40C232EC-D08E-43E7-8C64-1AFF12DE5760}"/>
+                <a16:creationId xmlns:a16="http://schemas.microsoft.com/office/drawing/2014/main" id="{EB1469C1-131F-4A54-ACF3-6094BB65085A}"/>
               </a:ext>
             </a:extLst>
           </p:cNvPr>
@@ -31181,7 +31516,7 @@
                 <a:ea typeface="Arial"/>
                 <a:cs typeface="Arial"/>
               </a:rPr>
-              <a:t>Projeto Aplicado Cenário 4</a:t>
+              <a:t>Projeto Aplicado Cenário 4  ·  Versão 28/10/2026</a:t>
             </a:r>
           </a:p>
         </p:txBody>
@@ -31191,7 +31526,7 @@
           <p:cNvPr id="4" name="">
             <a:extLst xmlns:a="http://schemas.openxmlformats.org/drawingml/2006/main">
               <a:ext uri="{FF2B5EF4-FFF2-40B4-BE49-F238E27FC236}">
-                <a16:creationId xmlns:a16="http://schemas.microsoft.com/office/drawing/2014/main" id="{8F42CF82-DD46-405C-A105-6C6053BF1047}"/>
+                <a16:creationId xmlns:a16="http://schemas.microsoft.com/office/drawing/2014/main" id="{E852323D-D9B0-4E3D-9C4B-3B4870DABB3E}"/>
               </a:ext>
             </a:extLst>
           </p:cNvPr>
@@ -31461,7 +31796,7 @@
           <p:cNvPr id="5" name="">
             <a:extLst xmlns:a="http://schemas.openxmlformats.org/drawingml/2006/main">
               <a:ext uri="{FF2B5EF4-FFF2-40B4-BE49-F238E27FC236}">
-                <a16:creationId xmlns:a16="http://schemas.microsoft.com/office/drawing/2014/main" id="{F9EE705E-30F0-44E1-9F30-B20B031D1641}"/>
+                <a16:creationId xmlns:a16="http://schemas.microsoft.com/office/drawing/2014/main" id="{37406DDB-A2DF-4173-AF41-1A7D47B9BC29}"/>
               </a:ext>
             </a:extLst>
           </p:cNvPr>
@@ -31649,7 +31984,7 @@
           <p:cNvPr id="6" name="">
             <a:extLst xmlns:a="http://schemas.openxmlformats.org/drawingml/2006/main">
               <a:ext uri="{FF2B5EF4-FFF2-40B4-BE49-F238E27FC236}">
-                <a16:creationId xmlns:a16="http://schemas.microsoft.com/office/drawing/2014/main" id="{33CB46A5-CEC1-4A9F-A354-D656A874556F}"/>
+                <a16:creationId xmlns:a16="http://schemas.microsoft.com/office/drawing/2014/main" id="{327A070F-D4C3-4DB2-8D11-C4DAB06410FD}"/>
               </a:ext>
             </a:extLst>
           </p:cNvPr>
@@ -31837,7 +32172,7 @@
           <p:cNvPr id="7" name="">
             <a:extLst xmlns:a="http://schemas.openxmlformats.org/drawingml/2006/main">
               <a:ext uri="{FF2B5EF4-FFF2-40B4-BE49-F238E27FC236}">
-                <a16:creationId xmlns:a16="http://schemas.microsoft.com/office/drawing/2014/main" id="{18267CD3-BE43-4164-B98D-3AC16F07FD9D}"/>
+                <a16:creationId xmlns:a16="http://schemas.microsoft.com/office/drawing/2014/main" id="{9E854349-887C-4C80-938B-8F179D81850C}"/>
               </a:ext>
             </a:extLst>
           </p:cNvPr>
@@ -32025,7 +32360,7 @@
           <p:cNvPr id="8" name="">
             <a:extLst xmlns:a="http://schemas.openxmlformats.org/drawingml/2006/main">
               <a:ext uri="{FF2B5EF4-FFF2-40B4-BE49-F238E27FC236}">
-                <a16:creationId xmlns:a16="http://schemas.microsoft.com/office/drawing/2014/main" id="{41C98C30-3776-4722-BB27-A667004E61CF}"/>
+                <a16:creationId xmlns:a16="http://schemas.microsoft.com/office/drawing/2014/main" id="{DECA67F3-6154-45FB-AB0E-1F0DA66902A1}"/>
               </a:ext>
             </a:extLst>
           </p:cNvPr>
@@ -32181,7 +32516,7 @@
     </p:spTree>
     <p:extLst>
       <p:ext uri="{BB962C8B-B14F-4D97-AF65-F5344CB8AC3E}">
-        <p14:creationId xmlns:p14="http://schemas.microsoft.com/office/powerpoint/2010/main" val="581817457"/>
+        <p14:creationId xmlns:p14="http://schemas.microsoft.com/office/powerpoint/2010/main" val="2143374585"/>
       </p:ext>
     </p:extLst>
   </p:cSld>

</xml_diff>

<commit_message>
docs: alinha entrega ao guia e aos marcos de novembro (#77)
</commit_message>
<xml_diff>
--- a/output/Apresentacao_Cenario_4.pptx
+++ b/output/Apresentacao_Cenario_4.pptx
@@ -2,30 +2,30 @@
 <file path=ppt/presentation.xml><?xml version="1.0" encoding="utf-8"?>
 <p:presentation xmlns:p="http://schemas.openxmlformats.org/presentationml/2006/main">
   <p:sldMasterIdLst>
-    <p:sldMasterId xmlns:r="http://schemas.openxmlformats.org/officeDocument/2006/relationships" id="2147483648" r:id="R6fca8afdb6824539"/>
+    <p:sldMasterId xmlns:r="http://schemas.openxmlformats.org/officeDocument/2006/relationships" id="2147483648" r:id="Rcffed83e686440b7"/>
   </p:sldMasterIdLst>
   <p:notesMasterIdLst>
-    <p:notesMasterId xmlns:r="http://schemas.openxmlformats.org/officeDocument/2006/relationships" r:id="R7ca66f6d40a4440c"/>
+    <p:notesMasterId xmlns:r="http://schemas.openxmlformats.org/officeDocument/2006/relationships" r:id="Rec5116ca5b6d4406"/>
   </p:notesMasterIdLst>
   <p:sldIdLst>
-    <p:sldId xmlns:r="http://schemas.openxmlformats.org/officeDocument/2006/relationships" id="256" r:id="R071185443a0d4dc9"/>
-    <p:sldId xmlns:r="http://schemas.openxmlformats.org/officeDocument/2006/relationships" id="257" r:id="Ra1cac1bf3e5a443c"/>
-    <p:sldId xmlns:r="http://schemas.openxmlformats.org/officeDocument/2006/relationships" id="258" r:id="Recbe8cb03b464ef0"/>
-    <p:sldId xmlns:r="http://schemas.openxmlformats.org/officeDocument/2006/relationships" id="259" r:id="R5967fdacdc2c43d3"/>
-    <p:sldId xmlns:r="http://schemas.openxmlformats.org/officeDocument/2006/relationships" id="260" r:id="R0266d84eced943bf"/>
-    <p:sldId xmlns:r="http://schemas.openxmlformats.org/officeDocument/2006/relationships" id="261" r:id="R6967d862dfc84338"/>
-    <p:sldId xmlns:r="http://schemas.openxmlformats.org/officeDocument/2006/relationships" id="262" r:id="R88abd5c3b1e54cc6"/>
-    <p:sldId xmlns:r="http://schemas.openxmlformats.org/officeDocument/2006/relationships" id="263" r:id="R78c7142ffc4f481b"/>
-    <p:sldId xmlns:r="http://schemas.openxmlformats.org/officeDocument/2006/relationships" id="264" r:id="R753bb430fcfb4baf"/>
-    <p:sldId xmlns:r="http://schemas.openxmlformats.org/officeDocument/2006/relationships" id="265" r:id="Rf7dfcbc5a0e542f7"/>
-    <p:sldId xmlns:r="http://schemas.openxmlformats.org/officeDocument/2006/relationships" id="266" r:id="Re21c362acffc4b0f"/>
-    <p:sldId xmlns:r="http://schemas.openxmlformats.org/officeDocument/2006/relationships" id="267" r:id="Re9eaf8dcf90d4414"/>
-    <p:sldId xmlns:r="http://schemas.openxmlformats.org/officeDocument/2006/relationships" id="268" r:id="R5d46dfa8cb9c47d1"/>
-    <p:sldId xmlns:r="http://schemas.openxmlformats.org/officeDocument/2006/relationships" id="269" r:id="R712e55b3022c4a61"/>
-    <p:sldId xmlns:r="http://schemas.openxmlformats.org/officeDocument/2006/relationships" id="270" r:id="Rd26d67b40fe7446b"/>
-    <p:sldId xmlns:r="http://schemas.openxmlformats.org/officeDocument/2006/relationships" id="271" r:id="Rfa05c6175e60456a"/>
-    <p:sldId xmlns:r="http://schemas.openxmlformats.org/officeDocument/2006/relationships" id="272" r:id="Ra34050f536f84071"/>
-    <p:sldId xmlns:r="http://schemas.openxmlformats.org/officeDocument/2006/relationships" id="273" r:id="Rc4c876d3b865479e"/>
+    <p:sldId xmlns:r="http://schemas.openxmlformats.org/officeDocument/2006/relationships" id="256" r:id="R70f2fb8122a143e3"/>
+    <p:sldId xmlns:r="http://schemas.openxmlformats.org/officeDocument/2006/relationships" id="257" r:id="R2b8105c23204438c"/>
+    <p:sldId xmlns:r="http://schemas.openxmlformats.org/officeDocument/2006/relationships" id="258" r:id="R7363dd76906e44b6"/>
+    <p:sldId xmlns:r="http://schemas.openxmlformats.org/officeDocument/2006/relationships" id="259" r:id="R3bbe767dbc964fbe"/>
+    <p:sldId xmlns:r="http://schemas.openxmlformats.org/officeDocument/2006/relationships" id="260" r:id="R76d7ecbf96f64751"/>
+    <p:sldId xmlns:r="http://schemas.openxmlformats.org/officeDocument/2006/relationships" id="261" r:id="Ra64731bf21ca4775"/>
+    <p:sldId xmlns:r="http://schemas.openxmlformats.org/officeDocument/2006/relationships" id="262" r:id="Rfd4991d09e5c4c83"/>
+    <p:sldId xmlns:r="http://schemas.openxmlformats.org/officeDocument/2006/relationships" id="263" r:id="R2f1bbfb9e5794c92"/>
+    <p:sldId xmlns:r="http://schemas.openxmlformats.org/officeDocument/2006/relationships" id="264" r:id="R25282741b1fc49b8"/>
+    <p:sldId xmlns:r="http://schemas.openxmlformats.org/officeDocument/2006/relationships" id="265" r:id="Rb581c503e40f4d0c"/>
+    <p:sldId xmlns:r="http://schemas.openxmlformats.org/officeDocument/2006/relationships" id="266" r:id="R22f5705bcf55436d"/>
+    <p:sldId xmlns:r="http://schemas.openxmlformats.org/officeDocument/2006/relationships" id="267" r:id="Rd38aa7207c77460a"/>
+    <p:sldId xmlns:r="http://schemas.openxmlformats.org/officeDocument/2006/relationships" id="268" r:id="Rf558f02d4c144158"/>
+    <p:sldId xmlns:r="http://schemas.openxmlformats.org/officeDocument/2006/relationships" id="269" r:id="R7c93be25e1bb42db"/>
+    <p:sldId xmlns:r="http://schemas.openxmlformats.org/officeDocument/2006/relationships" id="270" r:id="Rcc4ed3db59194c39"/>
+    <p:sldId xmlns:r="http://schemas.openxmlformats.org/officeDocument/2006/relationships" id="271" r:id="R8d1bd44f480847ed"/>
+    <p:sldId xmlns:r="http://schemas.openxmlformats.org/officeDocument/2006/relationships" id="272" r:id="R65a23ba236764be3"/>
+    <p:sldId xmlns:r="http://schemas.openxmlformats.org/officeDocument/2006/relationships" id="273" r:id="Ra5737860e902456d"/>
   </p:sldIdLst>
   <p:sldSz cx="12192000" cy="6858000"/>
   <p:notesSz cx="6858000" cy="9144000"/>
@@ -459,7 +459,7 @@
           <a:lstStyle xmlns:a="http://schemas.openxmlformats.org/drawingml/2006/main"/>
           <a:p xmlns:a="http://schemas.openxmlformats.org/drawingml/2006/main">
             <a:r>
-              <a:t>Fonte principal: Projeto Aplicado ArchCorp, enunciado acadêmico, 2026. Cenário 4 aplicado a uma locadora fictícia inspirada na Localiza, com dados sintéticos.</a:t>
+              <a:t>Fonte principal: Guia.pdf, enunciado acadêmico ArchCorp, 2026, 13 páginas. Cenário 4 aplicado a uma locadora fictícia inspirada na Localiza, com dados sintéticos. Referência técnica: main f1669d78f01e2d279b3de60a999ed778e6c9916e, PR #75 de 25/10/2026, https://github.com/Roger-Quinelato/projetoAplicado7/pull/75, commit consultado localmente. Marcos previstos conforme orientação da entrega. Autoria e contribuições aguardam informação da equipe. Não há declaração de aceite docente.</a:t>
             </a:r>
           </a:p>
         </p:txBody>
@@ -529,7 +529,7 @@
           <a:lstStyle xmlns:a="http://schemas.openxmlformats.org/drawingml/2006/main"/>
           <a:p xmlns:a="http://schemas.openxmlformats.org/drawingml/2006/main">
             <a:r>
-              <a:t>Fonte: docs/INTEGRACOES.md, ADR-006 e scripts/demo_f1.py executado contra a API local em 17/10/2026.</a:t>
+              <a:t>Fonte: docs/INTEGRACOES.md, scripts/demo_f1.py e evidência histórica consolidada em docs/EVIDENCIAS_VALIDACAO.md (20/10/2026). Não reexecutado em 28/10. ADR-006 permanece Proposto, aguardando aceite do responsável. A chamada no mesmo processo não tem interrupção por timeout de rede.</a:t>
             </a:r>
           </a:p>
         </p:txBody>
@@ -599,7 +599,7 @@
           <a:lstStyle xmlns:a="http://schemas.openxmlformats.org/drawingml/2006/main"/>
           <a:p xmlns:a="http://schemas.openxmlformats.org/drawingml/2006/main">
             <a:r>
-              <a:t>Fonte: docs/INTEGRACOES.md, teste test_f2_ativacao_cria_uma_cobranca_e_uma_preparacao_de_retirada e scripts/demo_f2.py.</a:t>
+              <a:t>Fonte: docs/INTEGRACOES.md, scripts/demo_f2.py e evidência histórica consolidada em docs/EVIDENCIAS_VALIDACAO.md (20/10/2026). Não reexecutado em 28/10. O despachante invoca os consumidores internos; RabbitMQ recebe uma cópia opcional e não executa esses consumidores.</a:t>
             </a:r>
           </a:p>
         </p:txBody>
@@ -669,7 +669,7 @@
           <a:lstStyle xmlns:a="http://schemas.openxmlformats.org/drawingml/2006/main"/>
           <a:p xmlns:a="http://schemas.openxmlformats.org/drawingml/2006/main">
             <a:r>
-              <a:t>Fonte: docs/INTEGRACOES.md, testes de F3 e indisponibilidade e scripts/demo_f3.py.</a:t>
+              <a:t>Fonte: docs/INTEGRACOES.md, scripts/demo_f3.py e evidência histórica consolidada em docs/EVIDENCIAS_VALIDACAO.md (20/10/2026). Revisão de código e reprodução informadas pela equipe em 28/10: se TicketOpened falha e TicketResolved é consumido antes da recuperação, handle_ticket_resolved retorna sem processo; a abertura reprocessada depois cria STARTED embora o chamado esteja RESOLVED, sem pendências restantes que assegurem a convergência (src/archcorp/workflow/service.py, handle_ticket_resolved). Defeito não corrigido nesta revisão documental. A reconciliação de elegibilidade depende de ação explícita, sem agendador. Os resultados históricos não comprovam todos os casos de ordenação de eventos.</a:t>
             </a:r>
           </a:p>
         </p:txBody>
@@ -809,7 +809,7 @@
           <a:lstStyle xmlns:a="http://schemas.openxmlformats.org/drawingml/2006/main"/>
           <a:p xmlns:a="http://schemas.openxmlformats.org/drawingml/2006/main">
             <a:r>
-              <a:t>Fonte: docs/ATRIBUTOS_QUALIDADE.md (nove atributos com necessidade, risco, estratégia, resultado e evidência) e relatório, seção 4.8.</a:t>
+              <a:t>Fonte: docs/ATRIBUTOS_QUALIDADE.md (nove atributos com necessidade, risco, estratégia, resultado e evidência) e relatório, seção 4.8. Desempenho histórico de 20/10, local, PostgreSQL 16, 60 clientes e 100 amostras por consulta em 10 consultas de negócio. Não representa hospedagem pública nem medição na main f1669d7.</a:t>
             </a:r>
           </a:p>
         </p:txBody>
@@ -879,7 +879,7 @@
           <a:lstStyle xmlns:a="http://schemas.openxmlformats.org/drawingml/2006/main"/>
           <a:p xmlns:a="http://schemas.openxmlformats.org/drawingml/2006/main">
             <a:r>
-              <a:t>Fonte: docs/ATRIBUTOS_QUALIDADE.md e docs/EVIDENCIAS_VALIDACAO.md.</a:t>
+              <a:t>Fonte: docs/ATRIBUTOS_QUALIDADE.md e docs/EVIDENCIAS_VALIDACAO.md. Correções de segurança: main f1669d7, PR #75, 25/10/2026, https://github.com/Roger-Quinelato/projetoAplicado7/pull/75, registro local do commit. Credencial com caracteres não ASCII comparada em bytes, exceção inesperada registra só errorType. FAILED é estado persistido da aplicação, não fila de erro RabbitMQ. Sem OIDC e sem tracing distribuído.</a:t>
             </a:r>
           </a:p>
         </p:txBody>
@@ -1019,7 +1019,7 @@
           <a:lstStyle xmlns:a="http://schemas.openxmlformats.org/drawingml/2006/main"/>
           <a:p xmlns:a="http://schemas.openxmlformats.org/drawingml/2006/main">
             <a:r>
-              <a:t>Fonte: docs/EVIDENCIAS_VALIDACAO.md. Em 17/10/2026: 211 testes aprovados e 10 ignorados (PostgreSQL/RabbitMQ reais); roteiros demo_f1/f2/f3 contra uvicorn local; p95 de 200 consultas de prontidão em Windows 11, Python 3.12, SQLite.</a:t>
+              <a:t>Fontes: docs/EVIDENCIAS_VALIDACAO.md, seções históricas de 20/10/2026; registro local do commit f1669d78f01e2d279b3de60a999ed778e6c9916e, PR #75, 25/10/2026, https://github.com/Roger-Quinelato/projetoAplicado7/pull/75; logs da CI Verify 40199072801, https://github.com/Roger-Quinelato/projetoAplicado7/actions/runs/40199072801, executada em 25/10 sobre essa main, consultados no GitHub Actions em 28/10/2026. Quatro jobs success: application 252 passed/14 skipped; postgresql 262 passed/4 skipped; rabbitmq 22 passed; e2e 25 passed e axe separado 1 passed. Suítes sobrepostas, sem total agregado. Histórico de 20/10: PostgreSQL 16/RabbitMQ 3.12 locais, contêiner Linux, Python 3.13, 60 clientes, 100 amostras por consulta em 10 consultas de negócio, p95 máximo de 45,1 ms, 22 roteiros de navegador, F1 20/20, F2 14/14 e F3 15/15. O p95 não foi medido novamente na main f1669d7. Verificação local de 28/10: Python 252 aprovados e 14 ignorados, frontend 19 aprovados, TypeScript e OpenAPI check aprovados. Hospedagem pública e PostgreSQL gerenciado sem comprovação.</a:t>
             </a:r>
           </a:p>
         </p:txBody>
@@ -1089,7 +1089,7 @@
           <a:lstStyle xmlns:a="http://schemas.openxmlformats.org/drawingml/2006/main"/>
           <a:p xmlns:a="http://schemas.openxmlformats.org/drawingml/2006/main">
             <a:r>
-              <a:t>Fonte: relatório técnico, seções 4.10 e 5, e docs/EVOLUCAO_MANUTENCAO.md. Inserir nomes e contribuições individuais antes da submissão.</a:t>
+              <a:t>Fontes: relatório técnico, seções 3.1, 3.4, 4.10 e 5, docs/EVOLUCAO_MANUTENCAO.md e ADR-006 (Proposto). Revisão e reproduções informadas em 28/10/2026: F3 perde a convergência se TicketResolved é consumido antes de recuperar TicketOpened; encerramento de contrato pode deixar processo COMPLETED com tarefa CANCELLED; leitura financeira calcula OVERDUE enquanto o comando de cancelamento usa OPEN persistido. Conferência: src/archcorp/workflow/service.py (handle_ticket_resolved e handle_contract_closed), src/archcorp/finance/service.py (cancel) e domain.py. Defeitos conhecidos não corrigidos nesta revisão documental. Verificação local de 28/10 informada: Python 252 aprovados/14 ignorados, frontend 19 aprovados, TypeScript e OpenAPI check aprovados. Não somar suítes. Marcos previstos conforme orientação da entrega. Nomes e contribuições individuais necessários para a submissão. Premissas e ADR-006 aguardam validação ou aceite. Publicação, OIDC e agendador são evolução. O merge do PR #75 não equivale a aceite docente nem à validação das premissas.</a:t>
             </a:r>
           </a:p>
         </p:txBody>
@@ -1579,7 +1579,7 @@
           <a:lstStyle xmlns:a="http://schemas.openxmlformats.org/drawingml/2006/main"/>
           <a:p xmlns:a="http://schemas.openxmlformats.org/drawingml/2006/main">
             <a:r>
-              <a:t>Fonte: AGENT.md, tabela de propriedade dos dados, e plano de implementação, seção 6.</a:t>
+              <a:t>Fonte: AGENTS.md, tabela de propriedade dos dados, e plano de implementação, seção 6.</a:t>
             </a:r>
           </a:p>
         </p:txBody>
@@ -1696,7 +1696,7 @@
           <p:cNvPr id="3" name="Title">
             <a:extLst xmlns:a="http://schemas.openxmlformats.org/drawingml/2006/main">
               <a:ext uri="{FF2B5EF4-FFF2-40B4-BE49-F238E27FC236}">
-                <a16:creationId xmlns:a16="http://schemas.microsoft.com/office/drawing/2014/main" id="{8EF60EC6-5F39-45BC-AE31-66CB0272E883}"/>
+                <a16:creationId xmlns:a16="http://schemas.microsoft.com/office/drawing/2014/main" id="{52F22302-607E-4512-BF2F-35012247082E}"/>
               </a:ext>
             </a:extLst>
           </p:cNvPr>
@@ -1925,7 +1925,7 @@
           <p:cNvPr id="2" name="Subtitle">
             <a:extLst xmlns:a="http://schemas.openxmlformats.org/drawingml/2006/main">
               <a:ext uri="{FF2B5EF4-FFF2-40B4-BE49-F238E27FC236}">
-                <a16:creationId xmlns:a16="http://schemas.microsoft.com/office/drawing/2014/main" id="{5939D9FA-5325-4842-8309-D5085AA9C149}"/>
+                <a16:creationId xmlns:a16="http://schemas.microsoft.com/office/drawing/2014/main" id="{E14BB22B-78CA-4208-9251-2A613260C8CF}"/>
               </a:ext>
             </a:extLst>
           </p:cNvPr>
@@ -2171,7 +2171,7 @@
           <p:cNvPr id="2" name="Section title">
             <a:extLst xmlns:a="http://schemas.openxmlformats.org/drawingml/2006/main">
               <a:ext uri="{FF2B5EF4-FFF2-40B4-BE49-F238E27FC236}">
-                <a16:creationId xmlns:a16="http://schemas.microsoft.com/office/drawing/2014/main" id="{EC74F1F8-AE8B-4EA3-A0F7-63F7D8AEA5F8}"/>
+                <a16:creationId xmlns:a16="http://schemas.microsoft.com/office/drawing/2014/main" id="{3CF94330-2524-4EBB-AEF8-E29845BE2AF3}"/>
               </a:ext>
             </a:extLst>
           </p:cNvPr>
@@ -2417,7 +2417,7 @@
           <p:cNvPr id="3" name="Title">
             <a:extLst xmlns:a="http://schemas.openxmlformats.org/drawingml/2006/main">
               <a:ext uri="{FF2B5EF4-FFF2-40B4-BE49-F238E27FC236}">
-                <a16:creationId xmlns:a16="http://schemas.microsoft.com/office/drawing/2014/main" id="{B0FA8B7B-6501-49CE-9553-5BC9A29F03E2}"/>
+                <a16:creationId xmlns:a16="http://schemas.microsoft.com/office/drawing/2014/main" id="{721AE563-DBC9-42F5-B80D-C607DCB7F038}"/>
               </a:ext>
             </a:extLst>
           </p:cNvPr>
@@ -2646,7 +2646,7 @@
           <p:cNvPr id="2" name="Body">
             <a:extLst xmlns:a="http://schemas.openxmlformats.org/drawingml/2006/main">
               <a:ext uri="{FF2B5EF4-FFF2-40B4-BE49-F238E27FC236}">
-                <a16:creationId xmlns:a16="http://schemas.microsoft.com/office/drawing/2014/main" id="{DD0B66D0-CB67-49F2-B934-680A5892B159}"/>
+                <a16:creationId xmlns:a16="http://schemas.microsoft.com/office/drawing/2014/main" id="{BA95F0B2-2A24-40EB-9361-5E15DDDF2149}"/>
               </a:ext>
             </a:extLst>
           </p:cNvPr>
@@ -2892,7 +2892,7 @@
           <p:cNvPr id="4" name="Title">
             <a:extLst xmlns:a="http://schemas.openxmlformats.org/drawingml/2006/main">
               <a:ext uri="{FF2B5EF4-FFF2-40B4-BE49-F238E27FC236}">
-                <a16:creationId xmlns:a16="http://schemas.microsoft.com/office/drawing/2014/main" id="{746B2D54-1727-4DD0-AF15-C68FE27395AB}"/>
+                <a16:creationId xmlns:a16="http://schemas.microsoft.com/office/drawing/2014/main" id="{78E8EB24-8293-4430-875A-5C7748B62647}"/>
               </a:ext>
             </a:extLst>
           </p:cNvPr>
@@ -3121,7 +3121,7 @@
           <p:cNvPr id="2" name="Left column">
             <a:extLst xmlns:a="http://schemas.openxmlformats.org/drawingml/2006/main">
               <a:ext uri="{FF2B5EF4-FFF2-40B4-BE49-F238E27FC236}">
-                <a16:creationId xmlns:a16="http://schemas.microsoft.com/office/drawing/2014/main" id="{AB86D2AE-70EA-42E2-B307-0548152C1E98}"/>
+                <a16:creationId xmlns:a16="http://schemas.microsoft.com/office/drawing/2014/main" id="{919CB7B3-A0DB-46DC-B133-293C706F676F}"/>
               </a:ext>
             </a:extLst>
           </p:cNvPr>
@@ -3350,7 +3350,7 @@
           <p:cNvPr id="3" name="Right column">
             <a:extLst xmlns:a="http://schemas.openxmlformats.org/drawingml/2006/main">
               <a:ext uri="{FF2B5EF4-FFF2-40B4-BE49-F238E27FC236}">
-                <a16:creationId xmlns:a16="http://schemas.microsoft.com/office/drawing/2014/main" id="{3B8D108E-8D22-4418-A6EC-3929487F46F8}"/>
+                <a16:creationId xmlns:a16="http://schemas.microsoft.com/office/drawing/2014/main" id="{DA6BEEC1-7019-4639-8343-154E984ED655}"/>
               </a:ext>
             </a:extLst>
           </p:cNvPr>
@@ -3596,7 +3596,7 @@
           <p:cNvPr id="3" name="Title">
             <a:extLst xmlns:a="http://schemas.openxmlformats.org/drawingml/2006/main">
               <a:ext uri="{FF2B5EF4-FFF2-40B4-BE49-F238E27FC236}">
-                <a16:creationId xmlns:a16="http://schemas.microsoft.com/office/drawing/2014/main" id="{AFA95225-DDF9-4C0B-A99D-BC8A5468198A}"/>
+                <a16:creationId xmlns:a16="http://schemas.microsoft.com/office/drawing/2014/main" id="{86A42B9C-010B-43A0-B4B9-1357D249C352}"/>
               </a:ext>
             </a:extLst>
           </p:cNvPr>
@@ -3825,7 +3825,7 @@
           <p:cNvPr id="2" name="Left column">
             <a:extLst xmlns:a="http://schemas.openxmlformats.org/drawingml/2006/main">
               <a:ext uri="{FF2B5EF4-FFF2-40B4-BE49-F238E27FC236}">
-                <a16:creationId xmlns:a16="http://schemas.microsoft.com/office/drawing/2014/main" id="{7857505B-0AC6-4251-A20D-36C84D9F3983}"/>
+                <a16:creationId xmlns:a16="http://schemas.microsoft.com/office/drawing/2014/main" id="{8C42A9B8-8B44-4C2D-BC31-948054B892B0}"/>
               </a:ext>
             </a:extLst>
           </p:cNvPr>
@@ -4092,12 +4092,12 @@
   </p:cSld>
   <p:clrMap bg1="lt1" tx1="dk1" bg2="lt2" tx2="dk2" accent1="accent1" accent2="accent2" accent3="accent3" accent4="accent4" accent5="accent5" accent6="accent6" hlink="hlink" folHlink="folHlink"/>
   <p:sldLayoutIdLst>
-    <p:sldLayoutId xmlns:r="http://schemas.openxmlformats.org/officeDocument/2006/relationships" id="2147483649" r:id="Rde6f38cf631f41c3"/>
-    <p:sldLayoutId xmlns:r="http://schemas.openxmlformats.org/officeDocument/2006/relationships" id="2147483650" r:id="R0ac39e635ff24be1"/>
-    <p:sldLayoutId xmlns:r="http://schemas.openxmlformats.org/officeDocument/2006/relationships" id="2147483651" r:id="R5781e1fd1ea64c6b"/>
-    <p:sldLayoutId xmlns:r="http://schemas.openxmlformats.org/officeDocument/2006/relationships" id="2147483652" r:id="Rc5a35a0954fc4d81"/>
-    <p:sldLayoutId xmlns:r="http://schemas.openxmlformats.org/officeDocument/2006/relationships" id="2147483653" r:id="R2b23f75af8064e2f"/>
-    <p:sldLayoutId xmlns:r="http://schemas.openxmlformats.org/officeDocument/2006/relationships" id="2147483654" r:id="R75a9ee88cbf84394"/>
+    <p:sldLayoutId xmlns:r="http://schemas.openxmlformats.org/officeDocument/2006/relationships" id="2147483649" r:id="Rb41eaf8d157d4840"/>
+    <p:sldLayoutId xmlns:r="http://schemas.openxmlformats.org/officeDocument/2006/relationships" id="2147483650" r:id="Raa6cf94ebf6942d2"/>
+    <p:sldLayoutId xmlns:r="http://schemas.openxmlformats.org/officeDocument/2006/relationships" id="2147483651" r:id="R8dbe8aacf4104f9c"/>
+    <p:sldLayoutId xmlns:r="http://schemas.openxmlformats.org/officeDocument/2006/relationships" id="2147483652" r:id="R3743a4b4ce024896"/>
+    <p:sldLayoutId xmlns:r="http://schemas.openxmlformats.org/officeDocument/2006/relationships" id="2147483653" r:id="R0da1412da5ec4cf7"/>
+    <p:sldLayoutId xmlns:r="http://schemas.openxmlformats.org/officeDocument/2006/relationships" id="2147483654" r:id="R2655f55d261a4ac3"/>
   </p:sldLayoutIdLst>
   <p:txStyles>
     <p:titleStyle>
@@ -4648,7 +4648,7 @@
           <p:cNvPr id="5" name="">
             <a:extLst xmlns:a="http://schemas.openxmlformats.org/drawingml/2006/main">
               <a:ext uri="{FF2B5EF4-FFF2-40B4-BE49-F238E27FC236}">
-                <a16:creationId xmlns:a16="http://schemas.microsoft.com/office/drawing/2014/main" id="{00276C65-42C0-49EE-9A6C-931B971B1AE3}"/>
+                <a16:creationId xmlns:a16="http://schemas.microsoft.com/office/drawing/2014/main" id="{94A34BB2-6415-4ED6-9749-A783D475E966}"/>
               </a:ext>
             </a:extLst>
           </p:cNvPr>
@@ -4829,7 +4829,7 @@
           <p:cNvPr id="2" name="">
             <a:extLst xmlns:a="http://schemas.openxmlformats.org/drawingml/2006/main">
               <a:ext uri="{FF2B5EF4-FFF2-40B4-BE49-F238E27FC236}">
-                <a16:creationId xmlns:a16="http://schemas.microsoft.com/office/drawing/2014/main" id="{D9BFA065-CA24-46EC-A634-5ACF46E0E1FE}"/>
+                <a16:creationId xmlns:a16="http://schemas.microsoft.com/office/drawing/2014/main" id="{1734B3C5-A2A6-4F48-8C53-8BA55A626BA1}"/>
               </a:ext>
             </a:extLst>
           </p:cNvPr>
@@ -4987,7 +4987,7 @@
           <p:cNvPr id="3" name="">
             <a:extLst xmlns:a="http://schemas.openxmlformats.org/drawingml/2006/main">
               <a:ext uri="{FF2B5EF4-FFF2-40B4-BE49-F238E27FC236}">
-                <a16:creationId xmlns:a16="http://schemas.microsoft.com/office/drawing/2014/main" id="{585E523D-F5F0-4DA9-BB30-852252C58740}"/>
+                <a16:creationId xmlns:a16="http://schemas.microsoft.com/office/drawing/2014/main" id="{8178BC73-9D93-4172-B43E-38C2B5247D65}"/>
               </a:ext>
             </a:extLst>
           </p:cNvPr>
@@ -5017,7 +5017,7 @@
           <p:cNvPr id="4" name="">
             <a:extLst xmlns:a="http://schemas.openxmlformats.org/drawingml/2006/main">
               <a:ext uri="{FF2B5EF4-FFF2-40B4-BE49-F238E27FC236}">
-                <a16:creationId xmlns:a16="http://schemas.microsoft.com/office/drawing/2014/main" id="{7FBCD117-F74D-47B8-A001-3DD20767D78D}"/>
+                <a16:creationId xmlns:a16="http://schemas.microsoft.com/office/drawing/2014/main" id="{65E67ADC-C81A-48E3-B0D4-7FAFD883C512}"/>
               </a:ext>
             </a:extLst>
           </p:cNvPr>
@@ -5028,8 +5028,8 @@
         </p:nvSpPr>
         <p:spPr>
           <a:xfrm xmlns:a="http://schemas.openxmlformats.org/drawingml/2006/main">
-            <a:off x="895350" y="5334000"/>
-            <a:ext cx="9525000" cy="666750"/>
+            <a:off x="895350" y="5191125"/>
+            <a:ext cx="10477500" cy="1047750"/>
           </a:xfrm>
           <a:prstGeom xmlns:a="http://schemas.openxmlformats.org/drawingml/2006/main" prst="rect">
             <a:avLst/>
@@ -5165,7 +5165,7 @@
                 <a:ea typeface="Arial"/>
                 <a:cs typeface="Arial"/>
               </a:rPr>
-              <a:t>Equipe do Projeto Aplicado (nomes a preencher)</a:t>
+              <a:t>Nomes e contribuições individuais ainda não informados</a:t>
             </a:r>
           </a:p>
           <a:p xmlns:a="http://schemas.openxmlformats.org/drawingml/2006/main">
@@ -5188,7 +5188,30 @@
                 <a:ea typeface="Arial"/>
                 <a:cs typeface="Arial"/>
               </a:rPr>
-              <a:t>Outubro de 2026</a:t>
+              <a:t>Versão 28/10/2026  ·  Base main f1669d7</a:t>
+            </a:r>
+          </a:p>
+          <a:p xmlns:a="http://schemas.openxmlformats.org/drawingml/2006/main">
+            <a:pPr>
+              <a:defRPr sz="1500" b="0">
+                <a:solidFill>
+                  <a:srgbClr val="FFFFFF"/>
+                </a:solidFill>
+                <a:latin typeface="Arial"/>
+                <a:ea typeface="Arial"/>
+                <a:cs typeface="Arial"/>
+              </a:defRPr>
+            </a:pPr>
+            <a:r>
+              <a:rPr sz="1500" b="0">
+                <a:solidFill>
+                  <a:srgbClr val="FFFFFF"/>
+                </a:solidFill>
+                <a:latin typeface="Arial"/>
+                <a:ea typeface="Arial"/>
+                <a:cs typeface="Arial"/>
+              </a:rPr>
+              <a:t>Entrega pronta 09/11/2026  ·  Apresentação 23/11/2026 (previstas)</a:t>
             </a:r>
           </a:p>
         </p:txBody>
@@ -5196,7 +5219,7 @@
     </p:spTree>
     <p:extLst>
       <p:ext uri="{BB962C8B-B14F-4D97-AF65-F5344CB8AC3E}">
-        <p14:creationId xmlns:p14="http://schemas.microsoft.com/office/powerpoint/2010/main" val="194760433"/>
+        <p14:creationId xmlns:p14="http://schemas.microsoft.com/office/powerpoint/2010/main" val="1661073413"/>
       </p:ext>
     </p:extLst>
   </p:cSld>
@@ -5227,7 +5250,7 @@
           <p:cNvPr id="8" name="">
             <a:extLst xmlns:a="http://schemas.openxmlformats.org/drawingml/2006/main">
               <a:ext uri="{FF2B5EF4-FFF2-40B4-BE49-F238E27FC236}">
-                <a16:creationId xmlns:a16="http://schemas.microsoft.com/office/drawing/2014/main" id="{D69FC8EA-85CA-4E39-804C-89E3BB589468}"/>
+                <a16:creationId xmlns:a16="http://schemas.microsoft.com/office/drawing/2014/main" id="{87652935-0135-447D-B292-4723B1163553}"/>
               </a:ext>
             </a:extLst>
           </p:cNvPr>
@@ -5259,7 +5282,7 @@
           <p:cNvPr id="7" name="">
             <a:extLst xmlns:a="http://schemas.openxmlformats.org/drawingml/2006/main">
               <a:ext uri="{FF2B5EF4-FFF2-40B4-BE49-F238E27FC236}">
-                <a16:creationId xmlns:a16="http://schemas.microsoft.com/office/drawing/2014/main" id="{2B04E3CD-759E-4584-B213-BC4DC1FF1AA5}"/>
+                <a16:creationId xmlns:a16="http://schemas.microsoft.com/office/drawing/2014/main" id="{CE5C28A6-4EFD-4F08-BA19-46F874BA5766}"/>
               </a:ext>
             </a:extLst>
           </p:cNvPr>
@@ -5291,7 +5314,7 @@
           <p:cNvPr id="12" name="">
             <a:extLst xmlns:a="http://schemas.openxmlformats.org/drawingml/2006/main">
               <a:ext uri="{FF2B5EF4-FFF2-40B4-BE49-F238E27FC236}">
-                <a16:creationId xmlns:a16="http://schemas.microsoft.com/office/drawing/2014/main" id="{267A6288-A3EC-4D3B-B4A5-661A84F2C08F}"/>
+                <a16:creationId xmlns:a16="http://schemas.microsoft.com/office/drawing/2014/main" id="{008BB7EB-F761-4D4C-B6F1-CE014F37662D}"/>
               </a:ext>
             </a:extLst>
           </p:cNvPr>
@@ -5321,7 +5344,7 @@
           <p:cNvPr id="2" name="">
             <a:extLst xmlns:a="http://schemas.openxmlformats.org/drawingml/2006/main">
               <a:ext uri="{FF2B5EF4-FFF2-40B4-BE49-F238E27FC236}">
-                <a16:creationId xmlns:a16="http://schemas.microsoft.com/office/drawing/2014/main" id="{6571B931-0797-427B-9AB9-1141DD24FF81}"/>
+                <a16:creationId xmlns:a16="http://schemas.microsoft.com/office/drawing/2014/main" id="{34ED6DCB-7A5F-45C0-A38F-4B20609D5000}"/>
               </a:ext>
             </a:extLst>
           </p:cNvPr>
@@ -5479,7 +5502,7 @@
           <p:cNvPr id="3" name="">
             <a:extLst xmlns:a="http://schemas.openxmlformats.org/drawingml/2006/main">
               <a:ext uri="{FF2B5EF4-FFF2-40B4-BE49-F238E27FC236}">
-                <a16:creationId xmlns:a16="http://schemas.microsoft.com/office/drawing/2014/main" id="{4F775BBB-AD87-42D5-B6CD-5A91A039ECC3}"/>
+                <a16:creationId xmlns:a16="http://schemas.microsoft.com/office/drawing/2014/main" id="{912CA445-9B14-4DB6-91C9-4DF9F3D96E0D}"/>
               </a:ext>
             </a:extLst>
           </p:cNvPr>
@@ -5627,7 +5650,7 @@
                 <a:ea typeface="Arial"/>
                 <a:cs typeface="Arial"/>
               </a:rPr>
-              <a:t>Projeto Aplicado Cenário 4</a:t>
+              <a:t>Projeto Aplicado Cenário 4  ·  Versão 28/10/2026</a:t>
             </a:r>
           </a:p>
         </p:txBody>
@@ -5637,7 +5660,7 @@
           <p:cNvPr id="4" name="">
             <a:extLst xmlns:a="http://schemas.openxmlformats.org/drawingml/2006/main">
               <a:ext uri="{FF2B5EF4-FFF2-40B4-BE49-F238E27FC236}">
-                <a16:creationId xmlns:a16="http://schemas.microsoft.com/office/drawing/2014/main" id="{C9DEEF79-F400-42A5-BDFB-E85A270728C2}"/>
+                <a16:creationId xmlns:a16="http://schemas.microsoft.com/office/drawing/2014/main" id="{96D2DA12-A3E2-4140-8AD4-EF7BEE12FDD8}"/>
               </a:ext>
             </a:extLst>
           </p:cNvPr>
@@ -5825,7 +5848,7 @@
           <p:cNvPr id="5" name="">
             <a:extLst xmlns:a="http://schemas.openxmlformats.org/drawingml/2006/main">
               <a:ext uri="{FF2B5EF4-FFF2-40B4-BE49-F238E27FC236}">
-                <a16:creationId xmlns:a16="http://schemas.microsoft.com/office/drawing/2014/main" id="{7399D4E1-F6DC-49FA-B726-08CA9353DD41}"/>
+                <a16:creationId xmlns:a16="http://schemas.microsoft.com/office/drawing/2014/main" id="{BC0D5546-0889-49AF-A3BA-BAFAC8B4469E}"/>
               </a:ext>
             </a:extLst>
           </p:cNvPr>
@@ -6013,7 +6036,7 @@
           <p:cNvPr id="6" name="">
             <a:extLst xmlns:a="http://schemas.openxmlformats.org/drawingml/2006/main">
               <a:ext uri="{FF2B5EF4-FFF2-40B4-BE49-F238E27FC236}">
-                <a16:creationId xmlns:a16="http://schemas.microsoft.com/office/drawing/2014/main" id="{2997F763-71F8-4254-9B92-5062BA2C5CEF}"/>
+                <a16:creationId xmlns:a16="http://schemas.microsoft.com/office/drawing/2014/main" id="{B299E4EA-7702-4808-8D75-25D6CE596CE0}"/>
               </a:ext>
             </a:extLst>
           </p:cNvPr>
@@ -6201,7 +6224,7 @@
           <p:cNvPr id="9" name="">
             <a:extLst xmlns:a="http://schemas.openxmlformats.org/drawingml/2006/main">
               <a:ext uri="{FF2B5EF4-FFF2-40B4-BE49-F238E27FC236}">
-                <a16:creationId xmlns:a16="http://schemas.microsoft.com/office/drawing/2014/main" id="{8CDC309C-F0BA-4802-B6D0-D471ABE843E4}"/>
+                <a16:creationId xmlns:a16="http://schemas.microsoft.com/office/drawing/2014/main" id="{BA509EA9-6C3C-4504-ABE6-05CD19AA8CF5}"/>
               </a:ext>
             </a:extLst>
           </p:cNvPr>
@@ -6359,7 +6382,7 @@
           <p:cNvPr id="10" name="">
             <a:extLst xmlns:a="http://schemas.openxmlformats.org/drawingml/2006/main">
               <a:ext uri="{FF2B5EF4-FFF2-40B4-BE49-F238E27FC236}">
-                <a16:creationId xmlns:a16="http://schemas.microsoft.com/office/drawing/2014/main" id="{29C27F61-E025-4D76-9601-06208EF8F288}"/>
+                <a16:creationId xmlns:a16="http://schemas.microsoft.com/office/drawing/2014/main" id="{D01A5814-3094-4A3D-9320-C8263F29903A}"/>
               </a:ext>
             </a:extLst>
           </p:cNvPr>
@@ -6517,7 +6540,7 @@
           <p:cNvPr id="11" name="">
             <a:extLst xmlns:a="http://schemas.openxmlformats.org/drawingml/2006/main">
               <a:ext uri="{FF2B5EF4-FFF2-40B4-BE49-F238E27FC236}">
-                <a16:creationId xmlns:a16="http://schemas.microsoft.com/office/drawing/2014/main" id="{E62FB4BE-641F-4074-B7D5-AE2F96A4C990}"/>
+                <a16:creationId xmlns:a16="http://schemas.microsoft.com/office/drawing/2014/main" id="{D483107D-F279-4A8A-9BE0-B7D92DE082E5}"/>
               </a:ext>
             </a:extLst>
           </p:cNvPr>
@@ -6529,7 +6552,7 @@
         <p:spPr>
           <a:xfrm xmlns:a="http://schemas.openxmlformats.org/drawingml/2006/main">
             <a:off x="3333750" y="5429250"/>
-            <a:ext cx="5905500" cy="476250"/>
+            <a:ext cx="6858000" cy="476250"/>
           </a:xfrm>
           <a:prstGeom xmlns:a="http://schemas.openxmlformats.org/drawingml/2006/main" prst="rect">
             <a:avLst/>
@@ -6665,7 +6688,7 @@
                 <a:ea typeface="Arial"/>
                 <a:cs typeface="Arial"/>
               </a:rPr>
-              <a:t>Roteiro demo_f1.py: 20 de 20 checagens</a:t>
+              <a:t>F1 histórico: 20/20 checagens (20/10)</a:t>
             </a:r>
           </a:p>
         </p:txBody>
@@ -6673,7 +6696,7 @@
     </p:spTree>
     <p:extLst>
       <p:ext uri="{BB962C8B-B14F-4D97-AF65-F5344CB8AC3E}">
-        <p14:creationId xmlns:p14="http://schemas.microsoft.com/office/powerpoint/2010/main" val="1400606809"/>
+        <p14:creationId xmlns:p14="http://schemas.microsoft.com/office/powerpoint/2010/main" val="45429468"/>
       </p:ext>
     </p:extLst>
   </p:cSld>
@@ -6704,7 +6727,7 @@
           <p:cNvPr id="10" name="">
             <a:extLst xmlns:a="http://schemas.openxmlformats.org/drawingml/2006/main">
               <a:ext uri="{FF2B5EF4-FFF2-40B4-BE49-F238E27FC236}">
-                <a16:creationId xmlns:a16="http://schemas.microsoft.com/office/drawing/2014/main" id="{549D19A2-AEA2-48A4-BB68-A348D212D05A}"/>
+                <a16:creationId xmlns:a16="http://schemas.microsoft.com/office/drawing/2014/main" id="{C56036B1-CA3A-4E3D-AF9A-EF5B504039C5}"/>
               </a:ext>
             </a:extLst>
           </p:cNvPr>
@@ -6738,7 +6761,7 @@
           <p:cNvPr id="9" name="">
             <a:extLst xmlns:a="http://schemas.openxmlformats.org/drawingml/2006/main">
               <a:ext uri="{FF2B5EF4-FFF2-40B4-BE49-F238E27FC236}">
-                <a16:creationId xmlns:a16="http://schemas.microsoft.com/office/drawing/2014/main" id="{9FF64383-CE4D-4D4D-A044-A5FCEAD4E59F}"/>
+                <a16:creationId xmlns:a16="http://schemas.microsoft.com/office/drawing/2014/main" id="{27738231-D583-42BD-ABF9-A4C8B7F27237}"/>
               </a:ext>
             </a:extLst>
           </p:cNvPr>
@@ -6772,7 +6795,7 @@
           <p:cNvPr id="8" name="">
             <a:extLst xmlns:a="http://schemas.openxmlformats.org/drawingml/2006/main">
               <a:ext uri="{FF2B5EF4-FFF2-40B4-BE49-F238E27FC236}">
-                <a16:creationId xmlns:a16="http://schemas.microsoft.com/office/drawing/2014/main" id="{A556129D-197D-4EC0-B4ED-1E1EF3DE2D89}"/>
+                <a16:creationId xmlns:a16="http://schemas.microsoft.com/office/drawing/2014/main" id="{B8158F6A-DD21-4D59-941D-39AFE2763E4A}"/>
               </a:ext>
             </a:extLst>
           </p:cNvPr>
@@ -6804,7 +6827,7 @@
           <p:cNvPr id="13" name="">
             <a:extLst xmlns:a="http://schemas.openxmlformats.org/drawingml/2006/main">
               <a:ext uri="{FF2B5EF4-FFF2-40B4-BE49-F238E27FC236}">
-                <a16:creationId xmlns:a16="http://schemas.microsoft.com/office/drawing/2014/main" id="{E1DC582F-158B-4CE3-9323-250979695271}"/>
+                <a16:creationId xmlns:a16="http://schemas.microsoft.com/office/drawing/2014/main" id="{34C8D0C5-198D-4B22-86BC-88689B1CA833}"/>
               </a:ext>
             </a:extLst>
           </p:cNvPr>
@@ -6834,7 +6857,7 @@
           <p:cNvPr id="2" name="">
             <a:extLst xmlns:a="http://schemas.openxmlformats.org/drawingml/2006/main">
               <a:ext uri="{FF2B5EF4-FFF2-40B4-BE49-F238E27FC236}">
-                <a16:creationId xmlns:a16="http://schemas.microsoft.com/office/drawing/2014/main" id="{1A39A942-ACAA-4920-A90D-65A58C458D6D}"/>
+                <a16:creationId xmlns:a16="http://schemas.microsoft.com/office/drawing/2014/main" id="{E423AF2C-704C-4B0D-90C2-F4E0631AF13A}"/>
               </a:ext>
             </a:extLst>
           </p:cNvPr>
@@ -6992,7 +7015,7 @@
           <p:cNvPr id="3" name="">
             <a:extLst xmlns:a="http://schemas.openxmlformats.org/drawingml/2006/main">
               <a:ext uri="{FF2B5EF4-FFF2-40B4-BE49-F238E27FC236}">
-                <a16:creationId xmlns:a16="http://schemas.microsoft.com/office/drawing/2014/main" id="{BFF7BB9E-124C-4E33-8D14-4A8E9A51D6E7}"/>
+                <a16:creationId xmlns:a16="http://schemas.microsoft.com/office/drawing/2014/main" id="{083B975A-CF8D-413E-9DC1-A782B88AD140}"/>
               </a:ext>
             </a:extLst>
           </p:cNvPr>
@@ -7140,7 +7163,7 @@
                 <a:ea typeface="Arial"/>
                 <a:cs typeface="Arial"/>
               </a:rPr>
-              <a:t>Projeto Aplicado Cenário 4</a:t>
+              <a:t>Projeto Aplicado Cenário 4  ·  Versão 28/10/2026</a:t>
             </a:r>
           </a:p>
         </p:txBody>
@@ -7150,7 +7173,7 @@
           <p:cNvPr id="4" name="">
             <a:extLst xmlns:a="http://schemas.openxmlformats.org/drawingml/2006/main">
               <a:ext uri="{FF2B5EF4-FFF2-40B4-BE49-F238E27FC236}">
-                <a16:creationId xmlns:a16="http://schemas.microsoft.com/office/drawing/2014/main" id="{704C899A-9458-428E-879E-AE4735213756}"/>
+                <a16:creationId xmlns:a16="http://schemas.microsoft.com/office/drawing/2014/main" id="{3F521CF9-78BE-4A25-AFBD-A80BE9335A23}"/>
               </a:ext>
             </a:extLst>
           </p:cNvPr>
@@ -7338,7 +7361,7 @@
           <p:cNvPr id="5" name="">
             <a:extLst xmlns:a="http://schemas.openxmlformats.org/drawingml/2006/main">
               <a:ext uri="{FF2B5EF4-FFF2-40B4-BE49-F238E27FC236}">
-                <a16:creationId xmlns:a16="http://schemas.microsoft.com/office/drawing/2014/main" id="{CF04164A-2CAA-4723-A5B3-8477FECC8A67}"/>
+                <a16:creationId xmlns:a16="http://schemas.microsoft.com/office/drawing/2014/main" id="{A903E73B-96E9-4CEA-AA5D-EE3B42F6CC6A}"/>
               </a:ext>
             </a:extLst>
           </p:cNvPr>
@@ -7526,7 +7549,7 @@
           <p:cNvPr id="6" name="">
             <a:extLst xmlns:a="http://schemas.openxmlformats.org/drawingml/2006/main">
               <a:ext uri="{FF2B5EF4-FFF2-40B4-BE49-F238E27FC236}">
-                <a16:creationId xmlns:a16="http://schemas.microsoft.com/office/drawing/2014/main" id="{E15C5733-A9EE-418F-9991-4914B5CD3A75}"/>
+                <a16:creationId xmlns:a16="http://schemas.microsoft.com/office/drawing/2014/main" id="{B8603890-0CC4-4483-B63F-BF4BD491F460}"/>
               </a:ext>
             </a:extLst>
           </p:cNvPr>
@@ -7714,7 +7737,7 @@
           <p:cNvPr id="7" name="">
             <a:extLst xmlns:a="http://schemas.openxmlformats.org/drawingml/2006/main">
               <a:ext uri="{FF2B5EF4-FFF2-40B4-BE49-F238E27FC236}">
-                <a16:creationId xmlns:a16="http://schemas.microsoft.com/office/drawing/2014/main" id="{33B0ACE6-778A-4084-A8DB-D6FBC37D0D82}"/>
+                <a16:creationId xmlns:a16="http://schemas.microsoft.com/office/drawing/2014/main" id="{1E3DEC25-5603-4F28-8DEE-69898B48FEDA}"/>
               </a:ext>
             </a:extLst>
           </p:cNvPr>
@@ -7902,7 +7925,7 @@
           <p:cNvPr id="11" name="">
             <a:extLst xmlns:a="http://schemas.openxmlformats.org/drawingml/2006/main">
               <a:ext uri="{FF2B5EF4-FFF2-40B4-BE49-F238E27FC236}">
-                <a16:creationId xmlns:a16="http://schemas.microsoft.com/office/drawing/2014/main" id="{0353201E-FB9F-42E3-83A9-C51814753460}"/>
+                <a16:creationId xmlns:a16="http://schemas.microsoft.com/office/drawing/2014/main" id="{0B676A44-4AB3-47BC-8E1E-88982A542B29}"/>
               </a:ext>
             </a:extLst>
           </p:cNvPr>
@@ -8060,7 +8083,7 @@
           <p:cNvPr id="12" name="">
             <a:extLst xmlns:a="http://schemas.openxmlformats.org/drawingml/2006/main">
               <a:ext uri="{FF2B5EF4-FFF2-40B4-BE49-F238E27FC236}">
-                <a16:creationId xmlns:a16="http://schemas.microsoft.com/office/drawing/2014/main" id="{D2B4AB19-AD25-4E3D-87C1-4C5C99DE021D}"/>
+                <a16:creationId xmlns:a16="http://schemas.microsoft.com/office/drawing/2014/main" id="{55B42EC4-F1F3-44A5-A1D5-606C2DE8CB4B}"/>
               </a:ext>
             </a:extLst>
           </p:cNvPr>
@@ -8072,7 +8095,7 @@
         <p:spPr>
           <a:xfrm xmlns:a="http://schemas.openxmlformats.org/drawingml/2006/main">
             <a:off x="3619500" y="5524500"/>
-            <a:ext cx="5905500" cy="476250"/>
+            <a:ext cx="6858000" cy="476250"/>
           </a:xfrm>
           <a:prstGeom xmlns:a="http://schemas.openxmlformats.org/drawingml/2006/main" prst="rect">
             <a:avLst/>
@@ -8208,7 +8231,7 @@
                 <a:ea typeface="Arial"/>
                 <a:cs typeface="Arial"/>
               </a:rPr>
-              <a:t>Roteiro demo_f2.py: 14 de 14 checagens</a:t>
+              <a:t>F2 histórico: 14/14 checagens (20/10)</a:t>
             </a:r>
           </a:p>
         </p:txBody>
@@ -8216,7 +8239,7 @@
     </p:spTree>
     <p:extLst>
       <p:ext uri="{BB962C8B-B14F-4D97-AF65-F5344CB8AC3E}">
-        <p14:creationId xmlns:p14="http://schemas.microsoft.com/office/powerpoint/2010/main" val="1159329385"/>
+        <p14:creationId xmlns:p14="http://schemas.microsoft.com/office/powerpoint/2010/main" val="1379234653"/>
       </p:ext>
     </p:extLst>
   </p:cSld>
@@ -8247,7 +8270,7 @@
           <p:cNvPr id="10" name="">
             <a:extLst xmlns:a="http://schemas.openxmlformats.org/drawingml/2006/main">
               <a:ext uri="{FF2B5EF4-FFF2-40B4-BE49-F238E27FC236}">
-                <a16:creationId xmlns:a16="http://schemas.microsoft.com/office/drawing/2014/main" id="{8E9C209A-1984-4FE3-BB0B-CDD56DD8D31B}"/>
+                <a16:creationId xmlns:a16="http://schemas.microsoft.com/office/drawing/2014/main" id="{384D1B37-5662-46CD-8DB9-5ADD6656C63D}"/>
               </a:ext>
             </a:extLst>
           </p:cNvPr>
@@ -8279,7 +8302,7 @@
           <p:cNvPr id="9" name="">
             <a:extLst xmlns:a="http://schemas.openxmlformats.org/drawingml/2006/main">
               <a:ext uri="{FF2B5EF4-FFF2-40B4-BE49-F238E27FC236}">
-                <a16:creationId xmlns:a16="http://schemas.microsoft.com/office/drawing/2014/main" id="{C040A0E5-2618-47B4-B3F4-46882C0992E4}"/>
+                <a16:creationId xmlns:a16="http://schemas.microsoft.com/office/drawing/2014/main" id="{01BCB684-519F-4B51-8762-EFE8CA70AC2D}"/>
               </a:ext>
             </a:extLst>
           </p:cNvPr>
@@ -8311,7 +8334,7 @@
           <p:cNvPr id="8" name="">
             <a:extLst xmlns:a="http://schemas.openxmlformats.org/drawingml/2006/main">
               <a:ext uri="{FF2B5EF4-FFF2-40B4-BE49-F238E27FC236}">
-                <a16:creationId xmlns:a16="http://schemas.microsoft.com/office/drawing/2014/main" id="{B3577A52-AC6A-4618-8C11-0A6B8319586F}"/>
+                <a16:creationId xmlns:a16="http://schemas.microsoft.com/office/drawing/2014/main" id="{2B3D7872-3BA7-4465-874A-1199C8D6FBF7}"/>
               </a:ext>
             </a:extLst>
           </p:cNvPr>
@@ -8345,7 +8368,7 @@
           <p:cNvPr id="13" name="">
             <a:extLst xmlns:a="http://schemas.openxmlformats.org/drawingml/2006/main">
               <a:ext uri="{FF2B5EF4-FFF2-40B4-BE49-F238E27FC236}">
-                <a16:creationId xmlns:a16="http://schemas.microsoft.com/office/drawing/2014/main" id="{6E21FF86-2D30-4889-9FEE-71EB8E19D1F8}"/>
+                <a16:creationId xmlns:a16="http://schemas.microsoft.com/office/drawing/2014/main" id="{3DADAE7B-8064-47DD-B8F4-F495A010F978}"/>
               </a:ext>
             </a:extLst>
           </p:cNvPr>
@@ -8375,7 +8398,7 @@
           <p:cNvPr id="2" name="">
             <a:extLst xmlns:a="http://schemas.openxmlformats.org/drawingml/2006/main">
               <a:ext uri="{FF2B5EF4-FFF2-40B4-BE49-F238E27FC236}">
-                <a16:creationId xmlns:a16="http://schemas.microsoft.com/office/drawing/2014/main" id="{EDE3B909-74D8-49E6-BE28-697953CF52D4}"/>
+                <a16:creationId xmlns:a16="http://schemas.microsoft.com/office/drawing/2014/main" id="{B29A95D3-9A76-4F54-B0DD-D09D9EEF5C70}"/>
               </a:ext>
             </a:extLst>
           </p:cNvPr>
@@ -8533,7 +8556,7 @@
           <p:cNvPr id="3" name="">
             <a:extLst xmlns:a="http://schemas.openxmlformats.org/drawingml/2006/main">
               <a:ext uri="{FF2B5EF4-FFF2-40B4-BE49-F238E27FC236}">
-                <a16:creationId xmlns:a16="http://schemas.microsoft.com/office/drawing/2014/main" id="{66CC6E28-E9B4-4130-9A25-C5D97C0F4B0D}"/>
+                <a16:creationId xmlns:a16="http://schemas.microsoft.com/office/drawing/2014/main" id="{1018CF2B-47E2-4446-B6A0-F386F3EF6E06}"/>
               </a:ext>
             </a:extLst>
           </p:cNvPr>
@@ -8681,7 +8704,7 @@
                 <a:ea typeface="Arial"/>
                 <a:cs typeface="Arial"/>
               </a:rPr>
-              <a:t>Projeto Aplicado Cenário 4</a:t>
+              <a:t>Projeto Aplicado Cenário 4  ·  Versão 28/10/2026</a:t>
             </a:r>
           </a:p>
         </p:txBody>
@@ -8691,7 +8714,7 @@
           <p:cNvPr id="4" name="">
             <a:extLst xmlns:a="http://schemas.openxmlformats.org/drawingml/2006/main">
               <a:ext uri="{FF2B5EF4-FFF2-40B4-BE49-F238E27FC236}">
-                <a16:creationId xmlns:a16="http://schemas.microsoft.com/office/drawing/2014/main" id="{20FA18DF-2C2C-4F0E-9566-0139448815E4}"/>
+                <a16:creationId xmlns:a16="http://schemas.microsoft.com/office/drawing/2014/main" id="{BA24B3F7-A897-4856-87DA-19D1C982B29D}"/>
               </a:ext>
             </a:extLst>
           </p:cNvPr>
@@ -8879,7 +8902,7 @@
           <p:cNvPr id="5" name="">
             <a:extLst xmlns:a="http://schemas.openxmlformats.org/drawingml/2006/main">
               <a:ext uri="{FF2B5EF4-FFF2-40B4-BE49-F238E27FC236}">
-                <a16:creationId xmlns:a16="http://schemas.microsoft.com/office/drawing/2014/main" id="{ABC8F3A2-92EE-4F16-9FEC-D5AFCED3B81F}"/>
+                <a16:creationId xmlns:a16="http://schemas.microsoft.com/office/drawing/2014/main" id="{3B1478A5-36FE-4406-B8F3-A103032BE71C}"/>
               </a:ext>
             </a:extLst>
           </p:cNvPr>
@@ -9067,7 +9090,7 @@
           <p:cNvPr id="6" name="">
             <a:extLst xmlns:a="http://schemas.openxmlformats.org/drawingml/2006/main">
               <a:ext uri="{FF2B5EF4-FFF2-40B4-BE49-F238E27FC236}">
-                <a16:creationId xmlns:a16="http://schemas.microsoft.com/office/drawing/2014/main" id="{4878ECF3-7359-4AF4-9E05-5CC7BD83587B}"/>
+                <a16:creationId xmlns:a16="http://schemas.microsoft.com/office/drawing/2014/main" id="{3EC9F2C2-7DB5-4F65-AC94-DB5475925726}"/>
               </a:ext>
             </a:extLst>
           </p:cNvPr>
@@ -9255,7 +9278,7 @@
           <p:cNvPr id="7" name="">
             <a:extLst xmlns:a="http://schemas.openxmlformats.org/drawingml/2006/main">
               <a:ext uri="{FF2B5EF4-FFF2-40B4-BE49-F238E27FC236}">
-                <a16:creationId xmlns:a16="http://schemas.microsoft.com/office/drawing/2014/main" id="{D380EDEC-A92F-4326-9FAA-6EA640EE6FE8}"/>
+                <a16:creationId xmlns:a16="http://schemas.microsoft.com/office/drawing/2014/main" id="{954F0393-D46D-4116-A904-4085402A22EF}"/>
               </a:ext>
             </a:extLst>
           </p:cNvPr>
@@ -9443,7 +9466,7 @@
           <p:cNvPr id="11" name="">
             <a:extLst xmlns:a="http://schemas.openxmlformats.org/drawingml/2006/main">
               <a:ext uri="{FF2B5EF4-FFF2-40B4-BE49-F238E27FC236}">
-                <a16:creationId xmlns:a16="http://schemas.microsoft.com/office/drawing/2014/main" id="{0A1BCAD7-EB31-49D5-9898-ED8354DA8C7C}"/>
+                <a16:creationId xmlns:a16="http://schemas.microsoft.com/office/drawing/2014/main" id="{C5043FCE-642B-468D-AD09-5B6B143F9231}"/>
               </a:ext>
             </a:extLst>
           </p:cNvPr>
@@ -9454,166 +9477,8 @@
         </p:nvSpPr>
         <p:spPr>
           <a:xfrm xmlns:a="http://schemas.openxmlformats.org/drawingml/2006/main">
-            <a:off x="2095500" y="4953000"/>
-            <a:ext cx="7810500" cy="476250"/>
-          </a:xfrm>
-          <a:prstGeom xmlns:a="http://schemas.openxmlformats.org/drawingml/2006/main" prst="rect">
-            <a:avLst/>
-          </a:prstGeom>
-          <a:noFill xmlns:a="http://schemas.openxmlformats.org/drawingml/2006/main"/>
-          <a:ln xmlns:a="http://schemas.openxmlformats.org/drawingml/2006/main" w="0">
-            <a:noFill/>
-          </a:ln>
-        </p:spPr>
-        <p:txBody>
-          <a:bodyPr xmlns:a="http://schemas.openxmlformats.org/drawingml/2006/main">
-            <a:noAutofit/>
-          </a:bodyPr>
-          <a:lstStyle xmlns:a="http://schemas.openxmlformats.org/drawingml/2006/main">
-            <a:defPPr>
-              <a:defRPr sz="1875" b="1">
-                <a:solidFill>
-                  <a:srgbClr val="C65D3A"/>
-                </a:solidFill>
-                <a:latin typeface="Arial"/>
-                <a:ea typeface="Arial"/>
-                <a:cs typeface="Arial"/>
-              </a:defRPr>
-            </a:defPPr>
-            <a:lvl1pPr>
-              <a:defRPr sz="1875" b="1">
-                <a:solidFill>
-                  <a:srgbClr val="C65D3A"/>
-                </a:solidFill>
-                <a:latin typeface="Arial"/>
-                <a:ea typeface="Arial"/>
-                <a:cs typeface="Arial"/>
-              </a:defRPr>
-            </a:lvl1pPr>
-            <a:lvl2pPr>
-              <a:defRPr sz="1875" b="1">
-                <a:solidFill>
-                  <a:srgbClr val="C65D3A"/>
-                </a:solidFill>
-                <a:latin typeface="Arial"/>
-                <a:ea typeface="Arial"/>
-                <a:cs typeface="Arial"/>
-              </a:defRPr>
-            </a:lvl2pPr>
-            <a:lvl3pPr>
-              <a:defRPr sz="1875" b="1">
-                <a:solidFill>
-                  <a:srgbClr val="C65D3A"/>
-                </a:solidFill>
-                <a:latin typeface="Arial"/>
-                <a:ea typeface="Arial"/>
-                <a:cs typeface="Arial"/>
-              </a:defRPr>
-            </a:lvl3pPr>
-            <a:lvl4pPr>
-              <a:defRPr sz="1875" b="1">
-                <a:solidFill>
-                  <a:srgbClr val="C65D3A"/>
-                </a:solidFill>
-                <a:latin typeface="Arial"/>
-                <a:ea typeface="Arial"/>
-                <a:cs typeface="Arial"/>
-              </a:defRPr>
-            </a:lvl4pPr>
-            <a:lvl5pPr>
-              <a:defRPr sz="1875" b="1">
-                <a:solidFill>
-                  <a:srgbClr val="C65D3A"/>
-                </a:solidFill>
-                <a:latin typeface="Arial"/>
-                <a:ea typeface="Arial"/>
-                <a:cs typeface="Arial"/>
-              </a:defRPr>
-            </a:lvl5pPr>
-            <a:lvl6pPr>
-              <a:defRPr sz="1875" b="1">
-                <a:solidFill>
-                  <a:srgbClr val="C65D3A"/>
-                </a:solidFill>
-                <a:latin typeface="Arial"/>
-                <a:ea typeface="Arial"/>
-                <a:cs typeface="Arial"/>
-              </a:defRPr>
-            </a:lvl6pPr>
-            <a:lvl7pPr>
-              <a:defRPr sz="1875" b="1">
-                <a:solidFill>
-                  <a:srgbClr val="C65D3A"/>
-                </a:solidFill>
-                <a:latin typeface="Arial"/>
-                <a:ea typeface="Arial"/>
-                <a:cs typeface="Arial"/>
-              </a:defRPr>
-            </a:lvl7pPr>
-            <a:lvl8pPr>
-              <a:defRPr sz="1875" b="1">
-                <a:solidFill>
-                  <a:srgbClr val="C65D3A"/>
-                </a:solidFill>
-                <a:latin typeface="Arial"/>
-                <a:ea typeface="Arial"/>
-                <a:cs typeface="Arial"/>
-              </a:defRPr>
-            </a:lvl8pPr>
-            <a:lvl9pPr>
-              <a:defRPr sz="1875" b="1">
-                <a:solidFill>
-                  <a:srgbClr val="C65D3A"/>
-                </a:solidFill>
-                <a:latin typeface="Arial"/>
-                <a:ea typeface="Arial"/>
-                <a:cs typeface="Arial"/>
-              </a:defRPr>
-            </a:lvl9pPr>
-          </a:lstStyle>
-          <a:p xmlns:a="http://schemas.openxmlformats.org/drawingml/2006/main">
-            <a:pPr>
-              <a:defRPr sz="1875" b="1">
-                <a:solidFill>
-                  <a:srgbClr val="C65D3A"/>
-                </a:solidFill>
-                <a:latin typeface="Arial"/>
-                <a:ea typeface="Arial"/>
-                <a:cs typeface="Arial"/>
-              </a:defRPr>
-            </a:pPr>
-            <a:r>
-              <a:rPr sz="1875" b="1">
-                <a:solidFill>
-                  <a:srgbClr val="C65D3A"/>
-                </a:solidFill>
-                <a:latin typeface="Arial"/>
-                <a:ea typeface="Arial"/>
-                <a:cs typeface="Arial"/>
-              </a:rPr>
-              <a:t>Indisponibilidade preserva a solicitação para reconciliação</a:t>
-            </a:r>
-          </a:p>
-        </p:txBody>
-      </p:sp>
-      <p:sp>
-        <p:nvSpPr>
-          <p:cNvPr id="12" name="">
-            <a:extLst xmlns:a="http://schemas.openxmlformats.org/drawingml/2006/main">
-              <a:ext uri="{FF2B5EF4-FFF2-40B4-BE49-F238E27FC236}">
-                <a16:creationId xmlns:a16="http://schemas.microsoft.com/office/drawing/2014/main" id="{3174C428-7F85-46E6-851A-A3AC4D3CD2B4}"/>
-              </a:ext>
-            </a:extLst>
-          </p:cNvPr>
-          <p:cNvSpPr>
-            <a:spLocks xmlns:a="http://schemas.openxmlformats.org/drawingml/2006/main" noGrp="1"/>
-          </p:cNvSpPr>
-          <p:nvPr/>
-        </p:nvSpPr>
-        <p:spPr>
-          <a:xfrm xmlns:a="http://schemas.openxmlformats.org/drawingml/2006/main">
-            <a:off x="3619500" y="5619750"/>
-            <a:ext cx="5905500" cy="476250"/>
+            <a:off x="1143000" y="4953000"/>
+            <a:ext cx="10096500" cy="571500"/>
           </a:xfrm>
           <a:prstGeom xmlns:a="http://schemas.openxmlformats.org/drawingml/2006/main" prst="rect">
             <a:avLst/>
@@ -9631,7 +9496,7 @@
             <a:defPPr>
               <a:defRPr sz="1800" b="1">
                 <a:solidFill>
-                  <a:srgbClr val="2E7D5B"/>
+                  <a:srgbClr val="C65D3A"/>
                 </a:solidFill>
                 <a:latin typeface="Arial"/>
                 <a:ea typeface="Arial"/>
@@ -9641,7 +9506,7 @@
             <a:lvl1pPr>
               <a:defRPr sz="1800" b="1">
                 <a:solidFill>
-                  <a:srgbClr val="2E7D5B"/>
+                  <a:srgbClr val="C65D3A"/>
                 </a:solidFill>
                 <a:latin typeface="Arial"/>
                 <a:ea typeface="Arial"/>
@@ -9651,7 +9516,7 @@
             <a:lvl2pPr>
               <a:defRPr sz="1800" b="1">
                 <a:solidFill>
-                  <a:srgbClr val="2E7D5B"/>
+                  <a:srgbClr val="C65D3A"/>
                 </a:solidFill>
                 <a:latin typeface="Arial"/>
                 <a:ea typeface="Arial"/>
@@ -9661,7 +9526,7 @@
             <a:lvl3pPr>
               <a:defRPr sz="1800" b="1">
                 <a:solidFill>
-                  <a:srgbClr val="2E7D5B"/>
+                  <a:srgbClr val="C65D3A"/>
                 </a:solidFill>
                 <a:latin typeface="Arial"/>
                 <a:ea typeface="Arial"/>
@@ -9671,7 +9536,7 @@
             <a:lvl4pPr>
               <a:defRPr sz="1800" b="1">
                 <a:solidFill>
-                  <a:srgbClr val="2E7D5B"/>
+                  <a:srgbClr val="C65D3A"/>
                 </a:solidFill>
                 <a:latin typeface="Arial"/>
                 <a:ea typeface="Arial"/>
@@ -9681,7 +9546,7 @@
             <a:lvl5pPr>
               <a:defRPr sz="1800" b="1">
                 <a:solidFill>
-                  <a:srgbClr val="2E7D5B"/>
+                  <a:srgbClr val="C65D3A"/>
                 </a:solidFill>
                 <a:latin typeface="Arial"/>
                 <a:ea typeface="Arial"/>
@@ -9691,7 +9556,7 @@
             <a:lvl6pPr>
               <a:defRPr sz="1800" b="1">
                 <a:solidFill>
-                  <a:srgbClr val="2E7D5B"/>
+                  <a:srgbClr val="C65D3A"/>
                 </a:solidFill>
                 <a:latin typeface="Arial"/>
                 <a:ea typeface="Arial"/>
@@ -9701,7 +9566,7 @@
             <a:lvl7pPr>
               <a:defRPr sz="1800" b="1">
                 <a:solidFill>
-                  <a:srgbClr val="2E7D5B"/>
+                  <a:srgbClr val="C65D3A"/>
                 </a:solidFill>
                 <a:latin typeface="Arial"/>
                 <a:ea typeface="Arial"/>
@@ -9711,7 +9576,7 @@
             <a:lvl8pPr>
               <a:defRPr sz="1800" b="1">
                 <a:solidFill>
-                  <a:srgbClr val="2E7D5B"/>
+                  <a:srgbClr val="C65D3A"/>
                 </a:solidFill>
                 <a:latin typeface="Arial"/>
                 <a:ea typeface="Arial"/>
@@ -9721,7 +9586,7 @@
             <a:lvl9pPr>
               <a:defRPr sz="1800" b="1">
                 <a:solidFill>
-                  <a:srgbClr val="2E7D5B"/>
+                  <a:srgbClr val="C65D3A"/>
                 </a:solidFill>
                 <a:latin typeface="Arial"/>
                 <a:ea typeface="Arial"/>
@@ -9733,7 +9598,7 @@
             <a:pPr>
               <a:defRPr sz="1800" b="1">
                 <a:solidFill>
-                  <a:srgbClr val="2E7D5B"/>
+                  <a:srgbClr val="C65D3A"/>
                 </a:solidFill>
                 <a:latin typeface="Arial"/>
                 <a:ea typeface="Arial"/>
@@ -9743,13 +9608,171 @@
             <a:r>
               <a:rPr sz="1800" b="1">
                 <a:solidFill>
+                  <a:srgbClr val="C65D3A"/>
+                </a:solidFill>
+                <a:latin typeface="Arial"/>
+                <a:ea typeface="Arial"/>
+                <a:cs typeface="Arial"/>
+              </a:rPr>
+              <a:t>Limite conhecido: resolução antes da abertura pode deixar processo STARTED</a:t>
+            </a:r>
+          </a:p>
+        </p:txBody>
+      </p:sp>
+      <p:sp>
+        <p:nvSpPr>
+          <p:cNvPr id="12" name="">
+            <a:extLst xmlns:a="http://schemas.openxmlformats.org/drawingml/2006/main">
+              <a:ext uri="{FF2B5EF4-FFF2-40B4-BE49-F238E27FC236}">
+                <a16:creationId xmlns:a16="http://schemas.microsoft.com/office/drawing/2014/main" id="{494840C9-4C87-472C-A1D7-CD4C82544ECB}"/>
+              </a:ext>
+            </a:extLst>
+          </p:cNvPr>
+          <p:cNvSpPr>
+            <a:spLocks xmlns:a="http://schemas.openxmlformats.org/drawingml/2006/main" noGrp="1"/>
+          </p:cNvSpPr>
+          <p:nvPr/>
+        </p:nvSpPr>
+        <p:spPr>
+          <a:xfrm xmlns:a="http://schemas.openxmlformats.org/drawingml/2006/main">
+            <a:off x="3619500" y="5619750"/>
+            <a:ext cx="6858000" cy="476250"/>
+          </a:xfrm>
+          <a:prstGeom xmlns:a="http://schemas.openxmlformats.org/drawingml/2006/main" prst="rect">
+            <a:avLst/>
+          </a:prstGeom>
+          <a:noFill xmlns:a="http://schemas.openxmlformats.org/drawingml/2006/main"/>
+          <a:ln xmlns:a="http://schemas.openxmlformats.org/drawingml/2006/main" w="0">
+            <a:noFill/>
+          </a:ln>
+        </p:spPr>
+        <p:txBody>
+          <a:bodyPr xmlns:a="http://schemas.openxmlformats.org/drawingml/2006/main">
+            <a:noAutofit/>
+          </a:bodyPr>
+          <a:lstStyle xmlns:a="http://schemas.openxmlformats.org/drawingml/2006/main">
+            <a:defPPr>
+              <a:defRPr sz="1800" b="1">
+                <a:solidFill>
                   <a:srgbClr val="2E7D5B"/>
                 </a:solidFill>
                 <a:latin typeface="Arial"/>
                 <a:ea typeface="Arial"/>
                 <a:cs typeface="Arial"/>
+              </a:defRPr>
+            </a:defPPr>
+            <a:lvl1pPr>
+              <a:defRPr sz="1800" b="1">
+                <a:solidFill>
+                  <a:srgbClr val="2E7D5B"/>
+                </a:solidFill>
+                <a:latin typeface="Arial"/>
+                <a:ea typeface="Arial"/>
+                <a:cs typeface="Arial"/>
+              </a:defRPr>
+            </a:lvl1pPr>
+            <a:lvl2pPr>
+              <a:defRPr sz="1800" b="1">
+                <a:solidFill>
+                  <a:srgbClr val="2E7D5B"/>
+                </a:solidFill>
+                <a:latin typeface="Arial"/>
+                <a:ea typeface="Arial"/>
+                <a:cs typeface="Arial"/>
+              </a:defRPr>
+            </a:lvl2pPr>
+            <a:lvl3pPr>
+              <a:defRPr sz="1800" b="1">
+                <a:solidFill>
+                  <a:srgbClr val="2E7D5B"/>
+                </a:solidFill>
+                <a:latin typeface="Arial"/>
+                <a:ea typeface="Arial"/>
+                <a:cs typeface="Arial"/>
+              </a:defRPr>
+            </a:lvl3pPr>
+            <a:lvl4pPr>
+              <a:defRPr sz="1800" b="1">
+                <a:solidFill>
+                  <a:srgbClr val="2E7D5B"/>
+                </a:solidFill>
+                <a:latin typeface="Arial"/>
+                <a:ea typeface="Arial"/>
+                <a:cs typeface="Arial"/>
+              </a:defRPr>
+            </a:lvl4pPr>
+            <a:lvl5pPr>
+              <a:defRPr sz="1800" b="1">
+                <a:solidFill>
+                  <a:srgbClr val="2E7D5B"/>
+                </a:solidFill>
+                <a:latin typeface="Arial"/>
+                <a:ea typeface="Arial"/>
+                <a:cs typeface="Arial"/>
+              </a:defRPr>
+            </a:lvl5pPr>
+            <a:lvl6pPr>
+              <a:defRPr sz="1800" b="1">
+                <a:solidFill>
+                  <a:srgbClr val="2E7D5B"/>
+                </a:solidFill>
+                <a:latin typeface="Arial"/>
+                <a:ea typeface="Arial"/>
+                <a:cs typeface="Arial"/>
+              </a:defRPr>
+            </a:lvl6pPr>
+            <a:lvl7pPr>
+              <a:defRPr sz="1800" b="1">
+                <a:solidFill>
+                  <a:srgbClr val="2E7D5B"/>
+                </a:solidFill>
+                <a:latin typeface="Arial"/>
+                <a:ea typeface="Arial"/>
+                <a:cs typeface="Arial"/>
+              </a:defRPr>
+            </a:lvl7pPr>
+            <a:lvl8pPr>
+              <a:defRPr sz="1800" b="1">
+                <a:solidFill>
+                  <a:srgbClr val="2E7D5B"/>
+                </a:solidFill>
+                <a:latin typeface="Arial"/>
+                <a:ea typeface="Arial"/>
+                <a:cs typeface="Arial"/>
+              </a:defRPr>
+            </a:lvl8pPr>
+            <a:lvl9pPr>
+              <a:defRPr sz="1800" b="1">
+                <a:solidFill>
+                  <a:srgbClr val="2E7D5B"/>
+                </a:solidFill>
+                <a:latin typeface="Arial"/>
+                <a:ea typeface="Arial"/>
+                <a:cs typeface="Arial"/>
+              </a:defRPr>
+            </a:lvl9pPr>
+          </a:lstStyle>
+          <a:p xmlns:a="http://schemas.openxmlformats.org/drawingml/2006/main">
+            <a:pPr>
+              <a:defRPr sz="1800" b="1">
+                <a:solidFill>
+                  <a:srgbClr val="2E7D5B"/>
+                </a:solidFill>
+                <a:latin typeface="Arial"/>
+                <a:ea typeface="Arial"/>
+                <a:cs typeface="Arial"/>
+              </a:defRPr>
+            </a:pPr>
+            <a:r>
+              <a:rPr sz="1800" b="1">
+                <a:solidFill>
+                  <a:srgbClr val="2E7D5B"/>
+                </a:solidFill>
+                <a:latin typeface="Arial"/>
+                <a:ea typeface="Arial"/>
+                <a:cs typeface="Arial"/>
               </a:rPr>
-              <a:t>Roteiro demo_f3.py: 15 de 15 checagens</a:t>
+              <a:t>F3 histórico: 15/15 checagens (20/10)</a:t>
             </a:r>
           </a:p>
         </p:txBody>
@@ -9757,7 +9780,7 @@
     </p:spTree>
     <p:extLst>
       <p:ext uri="{BB962C8B-B14F-4D97-AF65-F5344CB8AC3E}">
-        <p14:creationId xmlns:p14="http://schemas.microsoft.com/office/powerpoint/2010/main" val="1771030527"/>
+        <p14:creationId xmlns:p14="http://schemas.microsoft.com/office/powerpoint/2010/main" val="1168916265"/>
       </p:ext>
     </p:extLst>
   </p:cSld>
@@ -9788,7 +9811,7 @@
           <p:cNvPr id="7" name="">
             <a:extLst xmlns:a="http://schemas.openxmlformats.org/drawingml/2006/main">
               <a:ext uri="{FF2B5EF4-FFF2-40B4-BE49-F238E27FC236}">
-                <a16:creationId xmlns:a16="http://schemas.microsoft.com/office/drawing/2014/main" id="{3D36192D-7EE9-4F96-BA21-8A26038A6FBB}"/>
+                <a16:creationId xmlns:a16="http://schemas.microsoft.com/office/drawing/2014/main" id="{4BC00EFB-94EA-4F1F-85FA-BAD205487A8B}"/>
               </a:ext>
             </a:extLst>
           </p:cNvPr>
@@ -9818,7 +9841,7 @@
           <p:cNvPr id="2" name="">
             <a:extLst xmlns:a="http://schemas.openxmlformats.org/drawingml/2006/main">
               <a:ext uri="{FF2B5EF4-FFF2-40B4-BE49-F238E27FC236}">
-                <a16:creationId xmlns:a16="http://schemas.microsoft.com/office/drawing/2014/main" id="{DBF0006F-3E23-4AC0-93F5-6B74F2570F07}"/>
+                <a16:creationId xmlns:a16="http://schemas.microsoft.com/office/drawing/2014/main" id="{CA81F471-ADA9-49F4-A031-D194DB3637BB}"/>
               </a:ext>
             </a:extLst>
           </p:cNvPr>
@@ -9976,7 +9999,7 @@
           <p:cNvPr id="3" name="">
             <a:extLst xmlns:a="http://schemas.openxmlformats.org/drawingml/2006/main">
               <a:ext uri="{FF2B5EF4-FFF2-40B4-BE49-F238E27FC236}">
-                <a16:creationId xmlns:a16="http://schemas.microsoft.com/office/drawing/2014/main" id="{80877DF2-1640-40F4-A20B-66E1166FCCBF}"/>
+                <a16:creationId xmlns:a16="http://schemas.microsoft.com/office/drawing/2014/main" id="{3273A162-FCBE-417F-AA42-FF9B808EA685}"/>
               </a:ext>
             </a:extLst>
           </p:cNvPr>
@@ -10124,7 +10147,7 @@
                 <a:ea typeface="Arial"/>
                 <a:cs typeface="Arial"/>
               </a:rPr>
-              <a:t>Projeto Aplicado Cenário 4</a:t>
+              <a:t>Projeto Aplicado Cenário 4  ·  Versão 28/10/2026</a:t>
             </a:r>
           </a:p>
         </p:txBody>
@@ -10134,7 +10157,7 @@
           <p:cNvPr id="4" name="">
             <a:extLst xmlns:a="http://schemas.openxmlformats.org/drawingml/2006/main">
               <a:ext uri="{FF2B5EF4-FFF2-40B4-BE49-F238E27FC236}">
-                <a16:creationId xmlns:a16="http://schemas.microsoft.com/office/drawing/2014/main" id="{27810EA0-8CF1-488C-B662-FB4744E9F56C}"/>
+                <a16:creationId xmlns:a16="http://schemas.microsoft.com/office/drawing/2014/main" id="{1F3E39E4-E9EB-43C3-BC19-E354C7FC580F}"/>
               </a:ext>
             </a:extLst>
           </p:cNvPr>
@@ -10404,7 +10427,7 @@
           <p:cNvPr id="5" name="">
             <a:extLst xmlns:a="http://schemas.openxmlformats.org/drawingml/2006/main">
               <a:ext uri="{FF2B5EF4-FFF2-40B4-BE49-F238E27FC236}">
-                <a16:creationId xmlns:a16="http://schemas.microsoft.com/office/drawing/2014/main" id="{19188E1D-B1DA-4EA5-9E81-4B14C25B104F}"/>
+                <a16:creationId xmlns:a16="http://schemas.microsoft.com/office/drawing/2014/main" id="{1289B5DF-54EA-483C-916D-B2C298B14D6E}"/>
               </a:ext>
             </a:extLst>
           </p:cNvPr>
@@ -10730,7 +10753,7 @@
           <p:cNvPr id="6" name="">
             <a:extLst xmlns:a="http://schemas.openxmlformats.org/drawingml/2006/main">
               <a:ext uri="{FF2B5EF4-FFF2-40B4-BE49-F238E27FC236}">
-                <a16:creationId xmlns:a16="http://schemas.microsoft.com/office/drawing/2014/main" id="{B2294ADC-4FF0-4C7E-81CE-14F1FE18AC0B}"/>
+                <a16:creationId xmlns:a16="http://schemas.microsoft.com/office/drawing/2014/main" id="{4E66D15B-4CD3-42C6-801D-F9C0C7949A31}"/>
               </a:ext>
             </a:extLst>
           </p:cNvPr>
@@ -10886,7 +10909,7 @@
     </p:spTree>
     <p:extLst>
       <p:ext uri="{BB962C8B-B14F-4D97-AF65-F5344CB8AC3E}">
-        <p14:creationId xmlns:p14="http://schemas.microsoft.com/office/powerpoint/2010/main" val="2136084134"/>
+        <p14:creationId xmlns:p14="http://schemas.microsoft.com/office/powerpoint/2010/main" val="214609718"/>
       </p:ext>
     </p:extLst>
   </p:cSld>
@@ -10917,7 +10940,7 @@
           <p:cNvPr id="28" name="">
             <a:extLst xmlns:a="http://schemas.openxmlformats.org/drawingml/2006/main">
               <a:ext uri="{FF2B5EF4-FFF2-40B4-BE49-F238E27FC236}">
-                <a16:creationId xmlns:a16="http://schemas.microsoft.com/office/drawing/2014/main" id="{8D0C23B8-C33F-443D-9DEB-1B4C8222BB0F}"/>
+                <a16:creationId xmlns:a16="http://schemas.microsoft.com/office/drawing/2014/main" id="{7140E2A3-3214-4957-88CB-F00F2627CC03}"/>
               </a:ext>
             </a:extLst>
           </p:cNvPr>
@@ -10947,7 +10970,7 @@
           <p:cNvPr id="2" name="">
             <a:extLst xmlns:a="http://schemas.openxmlformats.org/drawingml/2006/main">
               <a:ext uri="{FF2B5EF4-FFF2-40B4-BE49-F238E27FC236}">
-                <a16:creationId xmlns:a16="http://schemas.microsoft.com/office/drawing/2014/main" id="{56CB15C8-FED7-43CE-808D-909BF89A3DAA}"/>
+                <a16:creationId xmlns:a16="http://schemas.microsoft.com/office/drawing/2014/main" id="{44ADAA69-384E-474F-A19A-FA4D9789E293}"/>
               </a:ext>
             </a:extLst>
           </p:cNvPr>
@@ -11105,7 +11128,7 @@
           <p:cNvPr id="3" name="">
             <a:extLst xmlns:a="http://schemas.openxmlformats.org/drawingml/2006/main">
               <a:ext uri="{FF2B5EF4-FFF2-40B4-BE49-F238E27FC236}">
-                <a16:creationId xmlns:a16="http://schemas.microsoft.com/office/drawing/2014/main" id="{CB0A090C-1547-40C5-BEBA-56590763404B}"/>
+                <a16:creationId xmlns:a16="http://schemas.microsoft.com/office/drawing/2014/main" id="{9A3C599B-ADFB-437D-9279-984F112CF3B2}"/>
               </a:ext>
             </a:extLst>
           </p:cNvPr>
@@ -11253,7 +11276,7 @@
                 <a:ea typeface="Arial"/>
                 <a:cs typeface="Arial"/>
               </a:rPr>
-              <a:t>Projeto Aplicado Cenário 4</a:t>
+              <a:t>Projeto Aplicado Cenário 4  ·  Versão 28/10/2026</a:t>
             </a:r>
           </a:p>
         </p:txBody>
@@ -11263,7 +11286,7 @@
           <p:cNvPr id="4" name="">
             <a:extLst xmlns:a="http://schemas.openxmlformats.org/drawingml/2006/main">
               <a:ext uri="{FF2B5EF4-FFF2-40B4-BE49-F238E27FC236}">
-                <a16:creationId xmlns:a16="http://schemas.microsoft.com/office/drawing/2014/main" id="{14C2CFD7-3A24-4CA2-A88C-F2BD42D0505C}"/>
+                <a16:creationId xmlns:a16="http://schemas.microsoft.com/office/drawing/2014/main" id="{086571E3-518C-4A8B-8793-94D1A2C06ACF}"/>
               </a:ext>
             </a:extLst>
           </p:cNvPr>
@@ -11421,7 +11444,7 @@
           <p:cNvPr id="5" name="">
             <a:extLst xmlns:a="http://schemas.openxmlformats.org/drawingml/2006/main">
               <a:ext uri="{FF2B5EF4-FFF2-40B4-BE49-F238E27FC236}">
-                <a16:creationId xmlns:a16="http://schemas.microsoft.com/office/drawing/2014/main" id="{8AAD841A-9ECB-47E3-8C66-06E65122729A}"/>
+                <a16:creationId xmlns:a16="http://schemas.microsoft.com/office/drawing/2014/main" id="{97AA7B8A-8A27-425D-BDFC-FF4D89A08C4E}"/>
               </a:ext>
             </a:extLst>
           </p:cNvPr>
@@ -11579,7 +11602,7 @@
           <p:cNvPr id="6" name="">
             <a:extLst xmlns:a="http://schemas.openxmlformats.org/drawingml/2006/main">
               <a:ext uri="{FF2B5EF4-FFF2-40B4-BE49-F238E27FC236}">
-                <a16:creationId xmlns:a16="http://schemas.microsoft.com/office/drawing/2014/main" id="{72EC9F97-0AC7-4ABF-ABEC-526ED475D39B}"/>
+                <a16:creationId xmlns:a16="http://schemas.microsoft.com/office/drawing/2014/main" id="{2E2B6648-B831-47F3-A80A-D4057D97CEC8}"/>
               </a:ext>
             </a:extLst>
           </p:cNvPr>
@@ -11737,7 +11760,7 @@
           <p:cNvPr id="7" name="">
             <a:extLst xmlns:a="http://schemas.openxmlformats.org/drawingml/2006/main">
               <a:ext uri="{FF2B5EF4-FFF2-40B4-BE49-F238E27FC236}">
-                <a16:creationId xmlns:a16="http://schemas.microsoft.com/office/drawing/2014/main" id="{EC6C682C-1D9D-4186-A8C1-CD8682A9C702}"/>
+                <a16:creationId xmlns:a16="http://schemas.microsoft.com/office/drawing/2014/main" id="{EC5999FB-EFF2-42EE-A55C-B3E71AAA929C}"/>
               </a:ext>
             </a:extLst>
           </p:cNvPr>
@@ -11895,7 +11918,7 @@
           <p:cNvPr id="8" name="">
             <a:extLst xmlns:a="http://schemas.openxmlformats.org/drawingml/2006/main">
               <a:ext uri="{FF2B5EF4-FFF2-40B4-BE49-F238E27FC236}">
-                <a16:creationId xmlns:a16="http://schemas.microsoft.com/office/drawing/2014/main" id="{A6AAD7A6-3A56-4B4B-9822-22E8E22FA182}"/>
+                <a16:creationId xmlns:a16="http://schemas.microsoft.com/office/drawing/2014/main" id="{7A6D258C-C2CA-420F-B3E2-B2E9E45D4545}"/>
               </a:ext>
             </a:extLst>
           </p:cNvPr>
@@ -12053,7 +12076,7 @@
           <p:cNvPr id="9" name="">
             <a:extLst xmlns:a="http://schemas.openxmlformats.org/drawingml/2006/main">
               <a:ext uri="{FF2B5EF4-FFF2-40B4-BE49-F238E27FC236}">
-                <a16:creationId xmlns:a16="http://schemas.microsoft.com/office/drawing/2014/main" id="{963B907B-17C4-4E0A-87F1-59B58F0421BF}"/>
+                <a16:creationId xmlns:a16="http://schemas.microsoft.com/office/drawing/2014/main" id="{8E7A4886-79BE-4F6E-96C5-BBCE800C32D8}"/>
               </a:ext>
             </a:extLst>
           </p:cNvPr>
@@ -12211,7 +12234,7 @@
           <p:cNvPr id="10" name="">
             <a:extLst xmlns:a="http://schemas.openxmlformats.org/drawingml/2006/main">
               <a:ext uri="{FF2B5EF4-FFF2-40B4-BE49-F238E27FC236}">
-                <a16:creationId xmlns:a16="http://schemas.microsoft.com/office/drawing/2014/main" id="{F5E13AA8-68F7-42F7-B037-24EC2ED7ECED}"/>
+                <a16:creationId xmlns:a16="http://schemas.microsoft.com/office/drawing/2014/main" id="{2B165131-128A-45F2-BE5B-ED54140B4414}"/>
               </a:ext>
             </a:extLst>
           </p:cNvPr>
@@ -12369,7 +12392,7 @@
           <p:cNvPr id="11" name="">
             <a:extLst xmlns:a="http://schemas.openxmlformats.org/drawingml/2006/main">
               <a:ext uri="{FF2B5EF4-FFF2-40B4-BE49-F238E27FC236}">
-                <a16:creationId xmlns:a16="http://schemas.microsoft.com/office/drawing/2014/main" id="{7C04610B-7F92-4B9C-89C2-E1AF9FC70379}"/>
+                <a16:creationId xmlns:a16="http://schemas.microsoft.com/office/drawing/2014/main" id="{4F76F2AF-89E9-42EC-B6E2-F4D0FC35E3A2}"/>
               </a:ext>
             </a:extLst>
           </p:cNvPr>
@@ -12527,7 +12550,7 @@
           <p:cNvPr id="12" name="">
             <a:extLst xmlns:a="http://schemas.openxmlformats.org/drawingml/2006/main">
               <a:ext uri="{FF2B5EF4-FFF2-40B4-BE49-F238E27FC236}">
-                <a16:creationId xmlns:a16="http://schemas.microsoft.com/office/drawing/2014/main" id="{51F65B12-6C92-4D83-89DB-CA049AE79410}"/>
+                <a16:creationId xmlns:a16="http://schemas.microsoft.com/office/drawing/2014/main" id="{D78A216F-3BB8-4139-B3F2-D1D773584DF7}"/>
               </a:ext>
             </a:extLst>
           </p:cNvPr>
@@ -12685,7 +12708,7 @@
           <p:cNvPr id="13" name="">
             <a:extLst xmlns:a="http://schemas.openxmlformats.org/drawingml/2006/main">
               <a:ext uri="{FF2B5EF4-FFF2-40B4-BE49-F238E27FC236}">
-                <a16:creationId xmlns:a16="http://schemas.microsoft.com/office/drawing/2014/main" id="{E8718F2C-1621-416B-BAEE-7FC86DC8BD5A}"/>
+                <a16:creationId xmlns:a16="http://schemas.microsoft.com/office/drawing/2014/main" id="{A11789D9-A58A-474F-94A8-3659B6283E27}"/>
               </a:ext>
             </a:extLst>
           </p:cNvPr>
@@ -12843,7 +12866,7 @@
           <p:cNvPr id="14" name="">
             <a:extLst xmlns:a="http://schemas.openxmlformats.org/drawingml/2006/main">
               <a:ext uri="{FF2B5EF4-FFF2-40B4-BE49-F238E27FC236}">
-                <a16:creationId xmlns:a16="http://schemas.microsoft.com/office/drawing/2014/main" id="{77771A8C-40C3-4B77-8449-F9E2F482B080}"/>
+                <a16:creationId xmlns:a16="http://schemas.microsoft.com/office/drawing/2014/main" id="{5E542756-C59C-4EE5-925E-624EEE86552E}"/>
               </a:ext>
             </a:extLst>
           </p:cNvPr>
@@ -13001,7 +13024,7 @@
           <p:cNvPr id="15" name="">
             <a:extLst xmlns:a="http://schemas.openxmlformats.org/drawingml/2006/main">
               <a:ext uri="{FF2B5EF4-FFF2-40B4-BE49-F238E27FC236}">
-                <a16:creationId xmlns:a16="http://schemas.microsoft.com/office/drawing/2014/main" id="{E96E0B60-9DE0-4EFD-A58D-809E47E352CA}"/>
+                <a16:creationId xmlns:a16="http://schemas.microsoft.com/office/drawing/2014/main" id="{FB0205C3-307C-4898-A7C9-A20BD9A65F46}"/>
               </a:ext>
             </a:extLst>
           </p:cNvPr>
@@ -13159,7 +13182,7 @@
           <p:cNvPr id="16" name="">
             <a:extLst xmlns:a="http://schemas.openxmlformats.org/drawingml/2006/main">
               <a:ext uri="{FF2B5EF4-FFF2-40B4-BE49-F238E27FC236}">
-                <a16:creationId xmlns:a16="http://schemas.microsoft.com/office/drawing/2014/main" id="{8B543790-225B-4E58-A2AB-2A57286A98F6}"/>
+                <a16:creationId xmlns:a16="http://schemas.microsoft.com/office/drawing/2014/main" id="{7BFB5338-B332-4E34-9F66-318B049F03FD}"/>
               </a:ext>
             </a:extLst>
           </p:cNvPr>
@@ -13317,7 +13340,7 @@
           <p:cNvPr id="17" name="">
             <a:extLst xmlns:a="http://schemas.openxmlformats.org/drawingml/2006/main">
               <a:ext uri="{FF2B5EF4-FFF2-40B4-BE49-F238E27FC236}">
-                <a16:creationId xmlns:a16="http://schemas.microsoft.com/office/drawing/2014/main" id="{D71FFDF5-AD1B-4C7A-B961-A73CFD1FDA25}"/>
+                <a16:creationId xmlns:a16="http://schemas.microsoft.com/office/drawing/2014/main" id="{6299F6D8-3E62-4641-94DF-5B6A1F22FDE3}"/>
               </a:ext>
             </a:extLst>
           </p:cNvPr>
@@ -13475,7 +13498,7 @@
           <p:cNvPr id="18" name="">
             <a:extLst xmlns:a="http://schemas.openxmlformats.org/drawingml/2006/main">
               <a:ext uri="{FF2B5EF4-FFF2-40B4-BE49-F238E27FC236}">
-                <a16:creationId xmlns:a16="http://schemas.microsoft.com/office/drawing/2014/main" id="{DBE86A1F-B9ED-45F1-BCB9-B6C8B13BE74D}"/>
+                <a16:creationId xmlns:a16="http://schemas.microsoft.com/office/drawing/2014/main" id="{046EBB68-A5D8-4D4C-9452-14B2FEBBFD8B}"/>
               </a:ext>
             </a:extLst>
           </p:cNvPr>
@@ -13633,7 +13656,7 @@
           <p:cNvPr id="19" name="">
             <a:extLst xmlns:a="http://schemas.openxmlformats.org/drawingml/2006/main">
               <a:ext uri="{FF2B5EF4-FFF2-40B4-BE49-F238E27FC236}">
-                <a16:creationId xmlns:a16="http://schemas.microsoft.com/office/drawing/2014/main" id="{2C79FEE8-4B5B-47E6-96D6-C3CDCD51E00D}"/>
+                <a16:creationId xmlns:a16="http://schemas.microsoft.com/office/drawing/2014/main" id="{5C1D1334-B793-4A89-B5E0-669310C25502}"/>
               </a:ext>
             </a:extLst>
           </p:cNvPr>
@@ -13791,7 +13814,7 @@
           <p:cNvPr id="20" name="">
             <a:extLst xmlns:a="http://schemas.openxmlformats.org/drawingml/2006/main">
               <a:ext uri="{FF2B5EF4-FFF2-40B4-BE49-F238E27FC236}">
-                <a16:creationId xmlns:a16="http://schemas.microsoft.com/office/drawing/2014/main" id="{CB802BE9-2985-4EEF-A680-DA4B16B6866B}"/>
+                <a16:creationId xmlns:a16="http://schemas.microsoft.com/office/drawing/2014/main" id="{2A954D60-5361-4DCD-941B-49886A924FB1}"/>
               </a:ext>
             </a:extLst>
           </p:cNvPr>
@@ -13949,7 +13972,7 @@
           <p:cNvPr id="21" name="">
             <a:extLst xmlns:a="http://schemas.openxmlformats.org/drawingml/2006/main">
               <a:ext uri="{FF2B5EF4-FFF2-40B4-BE49-F238E27FC236}">
-                <a16:creationId xmlns:a16="http://schemas.microsoft.com/office/drawing/2014/main" id="{34A71A8E-2135-4A81-910D-8AF59FB964C4}"/>
+                <a16:creationId xmlns:a16="http://schemas.microsoft.com/office/drawing/2014/main" id="{FF973B10-FF55-456D-ADFD-CDD0499ABB01}"/>
               </a:ext>
             </a:extLst>
           </p:cNvPr>
@@ -14107,7 +14130,7 @@
           <p:cNvPr id="22" name="">
             <a:extLst xmlns:a="http://schemas.openxmlformats.org/drawingml/2006/main">
               <a:ext uri="{FF2B5EF4-FFF2-40B4-BE49-F238E27FC236}">
-                <a16:creationId xmlns:a16="http://schemas.microsoft.com/office/drawing/2014/main" id="{6D750D08-BA57-40BA-961E-E7FBB59D1BDB}"/>
+                <a16:creationId xmlns:a16="http://schemas.microsoft.com/office/drawing/2014/main" id="{D7BF26E9-6A75-4576-8062-404A21AF5B91}"/>
               </a:ext>
             </a:extLst>
           </p:cNvPr>
@@ -14265,7 +14288,7 @@
           <p:cNvPr id="23" name="">
             <a:extLst xmlns:a="http://schemas.openxmlformats.org/drawingml/2006/main">
               <a:ext uri="{FF2B5EF4-FFF2-40B4-BE49-F238E27FC236}">
-                <a16:creationId xmlns:a16="http://schemas.microsoft.com/office/drawing/2014/main" id="{4AB36BCA-97C7-4774-995E-F9129BBF5ADA}"/>
+                <a16:creationId xmlns:a16="http://schemas.microsoft.com/office/drawing/2014/main" id="{9B1C19E2-8CE6-4E15-A24A-DED706DB1FA2}"/>
               </a:ext>
             </a:extLst>
           </p:cNvPr>
@@ -14423,7 +14446,7 @@
           <p:cNvPr id="24" name="">
             <a:extLst xmlns:a="http://schemas.openxmlformats.org/drawingml/2006/main">
               <a:ext uri="{FF2B5EF4-FFF2-40B4-BE49-F238E27FC236}">
-                <a16:creationId xmlns:a16="http://schemas.microsoft.com/office/drawing/2014/main" id="{46EA4641-9717-4777-A007-E73E22701804}"/>
+                <a16:creationId xmlns:a16="http://schemas.microsoft.com/office/drawing/2014/main" id="{0EFE2E2C-0E63-4819-B98E-66CE4C5BD503}"/>
               </a:ext>
             </a:extLst>
           </p:cNvPr>
@@ -14581,7 +14604,7 @@
           <p:cNvPr id="25" name="">
             <a:extLst xmlns:a="http://schemas.openxmlformats.org/drawingml/2006/main">
               <a:ext uri="{FF2B5EF4-FFF2-40B4-BE49-F238E27FC236}">
-                <a16:creationId xmlns:a16="http://schemas.microsoft.com/office/drawing/2014/main" id="{685A05C6-6D22-4EDE-BE77-0DB748F8B244}"/>
+                <a16:creationId xmlns:a16="http://schemas.microsoft.com/office/drawing/2014/main" id="{DD91793F-8854-43F7-AD4E-70A2DCB8ECC9}"/>
               </a:ext>
             </a:extLst>
           </p:cNvPr>
@@ -14739,7 +14762,7 @@
           <p:cNvPr id="26" name="">
             <a:extLst xmlns:a="http://schemas.openxmlformats.org/drawingml/2006/main">
               <a:ext uri="{FF2B5EF4-FFF2-40B4-BE49-F238E27FC236}">
-                <a16:creationId xmlns:a16="http://schemas.microsoft.com/office/drawing/2014/main" id="{46DDCFE2-85C1-45E1-8D63-6E8920460602}"/>
+                <a16:creationId xmlns:a16="http://schemas.microsoft.com/office/drawing/2014/main" id="{D1955FE3-F33C-423E-BA42-C3E6D27BDCD6}"/>
               </a:ext>
             </a:extLst>
           </p:cNvPr>
@@ -14897,7 +14920,7 @@
           <p:cNvPr id="27" name="">
             <a:extLst xmlns:a="http://schemas.openxmlformats.org/drawingml/2006/main">
               <a:ext uri="{FF2B5EF4-FFF2-40B4-BE49-F238E27FC236}">
-                <a16:creationId xmlns:a16="http://schemas.microsoft.com/office/drawing/2014/main" id="{96414F7A-24D7-4DD9-A8FA-D0D4BEB58790}"/>
+                <a16:creationId xmlns:a16="http://schemas.microsoft.com/office/drawing/2014/main" id="{5C2B91F2-EC0F-436C-B1FB-8C9DC0015477}"/>
               </a:ext>
             </a:extLst>
           </p:cNvPr>
@@ -15045,7 +15068,7 @@
                 <a:ea typeface="Arial"/>
                 <a:cs typeface="Arial"/>
               </a:rPr>
-              <a:t>p95 local 4,22 ms</a:t>
+              <a:t>p95 45,1 ms (20/10)</a:t>
             </a:r>
           </a:p>
         </p:txBody>
@@ -15053,7 +15076,7 @@
     </p:spTree>
     <p:extLst>
       <p:ext uri="{BB962C8B-B14F-4D97-AF65-F5344CB8AC3E}">
-        <p14:creationId xmlns:p14="http://schemas.microsoft.com/office/powerpoint/2010/main" val="56330795"/>
+        <p14:creationId xmlns:p14="http://schemas.microsoft.com/office/powerpoint/2010/main" val="1339888652"/>
       </p:ext>
     </p:extLst>
   </p:cSld>
@@ -15084,7 +15107,7 @@
           <p:cNvPr id="11" name="">
             <a:extLst xmlns:a="http://schemas.openxmlformats.org/drawingml/2006/main">
               <a:ext uri="{FF2B5EF4-FFF2-40B4-BE49-F238E27FC236}">
-                <a16:creationId xmlns:a16="http://schemas.microsoft.com/office/drawing/2014/main" id="{D1333AC8-0C6D-4C3D-B948-91374D8708C7}"/>
+                <a16:creationId xmlns:a16="http://schemas.microsoft.com/office/drawing/2014/main" id="{0970811A-325D-46F4-854D-FC1F8AA1034D}"/>
               </a:ext>
             </a:extLst>
           </p:cNvPr>
@@ -15114,7 +15137,7 @@
           <p:cNvPr id="2" name="">
             <a:extLst xmlns:a="http://schemas.openxmlformats.org/drawingml/2006/main">
               <a:ext uri="{FF2B5EF4-FFF2-40B4-BE49-F238E27FC236}">
-                <a16:creationId xmlns:a16="http://schemas.microsoft.com/office/drawing/2014/main" id="{C0A3DD73-749D-4E7F-9947-3BAF7F25CE93}"/>
+                <a16:creationId xmlns:a16="http://schemas.microsoft.com/office/drawing/2014/main" id="{12387ED7-4C79-4D86-98C7-91911E15DA77}"/>
               </a:ext>
             </a:extLst>
           </p:cNvPr>
@@ -15272,7 +15295,7 @@
           <p:cNvPr id="3" name="">
             <a:extLst xmlns:a="http://schemas.openxmlformats.org/drawingml/2006/main">
               <a:ext uri="{FF2B5EF4-FFF2-40B4-BE49-F238E27FC236}">
-                <a16:creationId xmlns:a16="http://schemas.microsoft.com/office/drawing/2014/main" id="{00D68420-5A49-4592-8A5A-110C1466D9CA}"/>
+                <a16:creationId xmlns:a16="http://schemas.microsoft.com/office/drawing/2014/main" id="{1F2DC33A-7E19-4EA0-81FD-D6216D6B7C81}"/>
               </a:ext>
             </a:extLst>
           </p:cNvPr>
@@ -15420,7 +15443,7 @@
                 <a:ea typeface="Arial"/>
                 <a:cs typeface="Arial"/>
               </a:rPr>
-              <a:t>Projeto Aplicado Cenário 4</a:t>
+              <a:t>Projeto Aplicado Cenário 4  ·  Versão 28/10/2026</a:t>
             </a:r>
           </a:p>
         </p:txBody>
@@ -15430,7 +15453,7 @@
           <p:cNvPr id="4" name="">
             <a:extLst xmlns:a="http://schemas.openxmlformats.org/drawingml/2006/main">
               <a:ext uri="{FF2B5EF4-FFF2-40B4-BE49-F238E27FC236}">
-                <a16:creationId xmlns:a16="http://schemas.microsoft.com/office/drawing/2014/main" id="{BB3C8D46-08EA-439B-AD77-E70A81AABD2D}"/>
+                <a16:creationId xmlns:a16="http://schemas.microsoft.com/office/drawing/2014/main" id="{2AA8F1C7-4EBB-45D2-BE8D-18DDFE6DDADE}"/>
               </a:ext>
             </a:extLst>
           </p:cNvPr>
@@ -15588,7 +15611,7 @@
           <p:cNvPr id="5" name="">
             <a:extLst xmlns:a="http://schemas.openxmlformats.org/drawingml/2006/main">
               <a:ext uri="{FF2B5EF4-FFF2-40B4-BE49-F238E27FC236}">
-                <a16:creationId xmlns:a16="http://schemas.microsoft.com/office/drawing/2014/main" id="{36F93639-6D62-4B1A-A2F3-45BF91E0FD72}"/>
+                <a16:creationId xmlns:a16="http://schemas.microsoft.com/office/drawing/2014/main" id="{42F003F3-5DB7-42E3-9634-80520A8526EB}"/>
               </a:ext>
             </a:extLst>
           </p:cNvPr>
@@ -15794,7 +15817,7 @@
                 <a:ea typeface="Arial"/>
                 <a:cs typeface="Arial"/>
               </a:rPr>
-              <a:t>Fila de falha e reprocessamento</a:t>
+              <a:t>Estado FAILED e reprocessamento</a:t>
             </a:r>
           </a:p>
         </p:txBody>
@@ -15804,7 +15827,7 @@
           <p:cNvPr id="6" name="">
             <a:extLst xmlns:a="http://schemas.openxmlformats.org/drawingml/2006/main">
               <a:ext uri="{FF2B5EF4-FFF2-40B4-BE49-F238E27FC236}">
-                <a16:creationId xmlns:a16="http://schemas.microsoft.com/office/drawing/2014/main" id="{18A90EB7-F87B-43C9-81C5-137B595D1DDF}"/>
+                <a16:creationId xmlns:a16="http://schemas.microsoft.com/office/drawing/2014/main" id="{CB846D04-72F4-48E7-B920-56A23F99B273}"/>
               </a:ext>
             </a:extLst>
           </p:cNvPr>
@@ -15962,7 +15985,7 @@
           <p:cNvPr id="7" name="">
             <a:extLst xmlns:a="http://schemas.openxmlformats.org/drawingml/2006/main">
               <a:ext uri="{FF2B5EF4-FFF2-40B4-BE49-F238E27FC236}">
-                <a16:creationId xmlns:a16="http://schemas.microsoft.com/office/drawing/2014/main" id="{B2F8D4CA-B758-4028-91AA-1D4D3B89E4E5}"/>
+                <a16:creationId xmlns:a16="http://schemas.microsoft.com/office/drawing/2014/main" id="{6807BED9-FDA1-4A58-892F-A6EA6A97175C}"/>
               </a:ext>
             </a:extLst>
           </p:cNvPr>
@@ -16114,7 +16137,7 @@
                 <a:ea typeface="Arial"/>
                 <a:cs typeface="Arial"/>
               </a:rPr>
-              <a:t>Tokens locais ou segredo público e RBAC</a:t>
+              <a:t>Tokens locais ou segredo compartilhado e RBAC</a:t>
             </a:r>
           </a:p>
           <a:p xmlns:a="http://schemas.openxmlformats.org/drawingml/2006/main">
@@ -16141,7 +16164,7 @@
                 <a:ea typeface="Arial"/>
                 <a:cs typeface="Arial"/>
               </a:rPr>
-              <a:t>Validação na fronteira</a:t>
+              <a:t>Credenciais comparadas em bytes</a:t>
             </a:r>
           </a:p>
           <a:p xmlns:a="http://schemas.openxmlformats.org/drawingml/2006/main">
@@ -16168,7 +16191,7 @@
                 <a:ea typeface="Arial"/>
                 <a:cs typeface="Arial"/>
               </a:rPr>
-              <a:t>Dados mínimos em logs e eventos</a:t>
+              <a:t>Erros sem mensagem sensível nos logs</a:t>
             </a:r>
           </a:p>
         </p:txBody>
@@ -16178,7 +16201,7 @@
           <p:cNvPr id="8" name="">
             <a:extLst xmlns:a="http://schemas.openxmlformats.org/drawingml/2006/main">
               <a:ext uri="{FF2B5EF4-FFF2-40B4-BE49-F238E27FC236}">
-                <a16:creationId xmlns:a16="http://schemas.microsoft.com/office/drawing/2014/main" id="{3B2A7758-88DA-42A1-9AD9-C94698BC30A5}"/>
+                <a16:creationId xmlns:a16="http://schemas.microsoft.com/office/drawing/2014/main" id="{A44AA109-EE20-4BEE-9E39-89568EDCCAA7}"/>
               </a:ext>
             </a:extLst>
           </p:cNvPr>
@@ -16336,7 +16359,7 @@
           <p:cNvPr id="9" name="">
             <a:extLst xmlns:a="http://schemas.openxmlformats.org/drawingml/2006/main">
               <a:ext uri="{FF2B5EF4-FFF2-40B4-BE49-F238E27FC236}">
-                <a16:creationId xmlns:a16="http://schemas.microsoft.com/office/drawing/2014/main" id="{F6FD0D95-0BA1-4CA3-9992-530077EA9070}"/>
+                <a16:creationId xmlns:a16="http://schemas.microsoft.com/office/drawing/2014/main" id="{94896AA7-67D0-4366-B9D2-3A2C823C0620}"/>
               </a:ext>
             </a:extLst>
           </p:cNvPr>
@@ -16552,7 +16575,7 @@
           <p:cNvPr id="10" name="">
             <a:extLst xmlns:a="http://schemas.openxmlformats.org/drawingml/2006/main">
               <a:ext uri="{FF2B5EF4-FFF2-40B4-BE49-F238E27FC236}">
-                <a16:creationId xmlns:a16="http://schemas.microsoft.com/office/drawing/2014/main" id="{79A3F484-7D0D-4C96-A48A-301F3B3AB4C0}"/>
+                <a16:creationId xmlns:a16="http://schemas.microsoft.com/office/drawing/2014/main" id="{AE3ABF47-1BC5-41FB-91C3-B22C85AB67CA}"/>
               </a:ext>
             </a:extLst>
           </p:cNvPr>
@@ -16563,8 +16586,8 @@
         </p:nvSpPr>
         <p:spPr>
           <a:xfrm xmlns:a="http://schemas.openxmlformats.org/drawingml/2006/main">
-            <a:off x="1619250" y="4810125"/>
-            <a:ext cx="8858250" cy="666750"/>
+            <a:off x="1047750" y="4810125"/>
+            <a:ext cx="10287000" cy="809625"/>
           </a:xfrm>
           <a:prstGeom xmlns:a="http://schemas.openxmlformats.org/drawingml/2006/main" prst="rect">
             <a:avLst/>
@@ -16580,7 +16603,7 @@
           </a:bodyPr>
           <a:lstStyle xmlns:a="http://schemas.openxmlformats.org/drawingml/2006/main">
             <a:defPPr>
-              <a:defRPr sz="1950" b="1">
+              <a:defRPr sz="1875" b="1">
                 <a:solidFill>
                   <a:srgbClr val="C65D3A"/>
                 </a:solidFill>
@@ -16590,7 +16613,7 @@
               </a:defRPr>
             </a:defPPr>
             <a:lvl1pPr>
-              <a:defRPr sz="1950" b="1">
+              <a:defRPr sz="1875" b="1">
                 <a:solidFill>
                   <a:srgbClr val="C65D3A"/>
                 </a:solidFill>
@@ -16600,7 +16623,7 @@
               </a:defRPr>
             </a:lvl1pPr>
             <a:lvl2pPr>
-              <a:defRPr sz="1950" b="1">
+              <a:defRPr sz="1875" b="1">
                 <a:solidFill>
                   <a:srgbClr val="C65D3A"/>
                 </a:solidFill>
@@ -16610,7 +16633,7 @@
               </a:defRPr>
             </a:lvl2pPr>
             <a:lvl3pPr>
-              <a:defRPr sz="1950" b="1">
+              <a:defRPr sz="1875" b="1">
                 <a:solidFill>
                   <a:srgbClr val="C65D3A"/>
                 </a:solidFill>
@@ -16620,7 +16643,7 @@
               </a:defRPr>
             </a:lvl3pPr>
             <a:lvl4pPr>
-              <a:defRPr sz="1950" b="1">
+              <a:defRPr sz="1875" b="1">
                 <a:solidFill>
                   <a:srgbClr val="C65D3A"/>
                 </a:solidFill>
@@ -16630,7 +16653,7 @@
               </a:defRPr>
             </a:lvl4pPr>
             <a:lvl5pPr>
-              <a:defRPr sz="1950" b="1">
+              <a:defRPr sz="1875" b="1">
                 <a:solidFill>
                   <a:srgbClr val="C65D3A"/>
                 </a:solidFill>
@@ -16640,7 +16663,7 @@
               </a:defRPr>
             </a:lvl5pPr>
             <a:lvl6pPr>
-              <a:defRPr sz="1950" b="1">
+              <a:defRPr sz="1875" b="1">
                 <a:solidFill>
                   <a:srgbClr val="C65D3A"/>
                 </a:solidFill>
@@ -16650,7 +16673,7 @@
               </a:defRPr>
             </a:lvl6pPr>
             <a:lvl7pPr>
-              <a:defRPr sz="1950" b="1">
+              <a:defRPr sz="1875" b="1">
                 <a:solidFill>
                   <a:srgbClr val="C65D3A"/>
                 </a:solidFill>
@@ -16660,7 +16683,7 @@
               </a:defRPr>
             </a:lvl7pPr>
             <a:lvl8pPr>
-              <a:defRPr sz="1950" b="1">
+              <a:defRPr sz="1875" b="1">
                 <a:solidFill>
                   <a:srgbClr val="C65D3A"/>
                 </a:solidFill>
@@ -16670,7 +16693,7 @@
               </a:defRPr>
             </a:lvl8pPr>
             <a:lvl9pPr>
-              <a:defRPr sz="1950" b="1">
+              <a:defRPr sz="1875" b="1">
                 <a:solidFill>
                   <a:srgbClr val="C65D3A"/>
                 </a:solidFill>
@@ -16682,7 +16705,7 @@
           </a:lstStyle>
           <a:p xmlns:a="http://schemas.openxmlformats.org/drawingml/2006/main">
             <a:pPr>
-              <a:defRPr sz="1950" b="1">
+              <a:defRPr sz="1875" b="1">
                 <a:solidFill>
                   <a:srgbClr val="C65D3A"/>
                 </a:solidFill>
@@ -16692,7 +16715,7 @@
               </a:defRPr>
             </a:pPr>
             <a:r>
-              <a:rPr sz="1950" b="1">
+              <a:rPr sz="1875" b="1">
                 <a:solidFill>
                   <a:srgbClr val="C65D3A"/>
                 </a:solidFill>
@@ -16700,7 +16723,30 @@
                 <a:ea typeface="Arial"/>
                 <a:cs typeface="Arial"/>
               </a:rPr>
-              <a:t>Falha permanente testada após três tentativas e reprocessamento auditado</a:t>
+              <a:t>Testes de reprocessamento cobrem cenários específicos.</a:t>
+            </a:r>
+          </a:p>
+          <a:p xmlns:a="http://schemas.openxmlformats.org/drawingml/2006/main">
+            <a:pPr>
+              <a:defRPr sz="1875" b="1">
+                <a:solidFill>
+                  <a:srgbClr val="C65D3A"/>
+                </a:solidFill>
+                <a:latin typeface="Arial"/>
+                <a:ea typeface="Arial"/>
+                <a:cs typeface="Arial"/>
+              </a:defRPr>
+            </a:pPr>
+            <a:r>
+              <a:rPr sz="1875" b="1">
+                <a:solidFill>
+                  <a:srgbClr val="C65D3A"/>
+                </a:solidFill>
+                <a:latin typeface="Arial"/>
+                <a:ea typeface="Arial"/>
+                <a:cs typeface="Arial"/>
+              </a:rPr>
+              <a:t>Convergência de eventos e coerência de estados têm defeitos conhecidos.</a:t>
             </a:r>
           </a:p>
         </p:txBody>
@@ -16708,7 +16754,7 @@
     </p:spTree>
     <p:extLst>
       <p:ext uri="{BB962C8B-B14F-4D97-AF65-F5344CB8AC3E}">
-        <p14:creationId xmlns:p14="http://schemas.microsoft.com/office/powerpoint/2010/main" val="981026956"/>
+        <p14:creationId xmlns:p14="http://schemas.microsoft.com/office/powerpoint/2010/main" val="810531046"/>
       </p:ext>
     </p:extLst>
   </p:cSld>
@@ -16739,7 +16785,7 @@
           <p:cNvPr id="11" name="">
             <a:extLst xmlns:a="http://schemas.openxmlformats.org/drawingml/2006/main">
               <a:ext uri="{FF2B5EF4-FFF2-40B4-BE49-F238E27FC236}">
-                <a16:creationId xmlns:a16="http://schemas.microsoft.com/office/drawing/2014/main" id="{29053730-ED0D-430F-BC95-FA1C36F4F986}"/>
+                <a16:creationId xmlns:a16="http://schemas.microsoft.com/office/drawing/2014/main" id="{CD6D9C80-FAC1-4C4A-9374-1DB790868F1A}"/>
               </a:ext>
             </a:extLst>
           </p:cNvPr>
@@ -16769,7 +16815,7 @@
           <p:cNvPr id="2" name="">
             <a:extLst xmlns:a="http://schemas.openxmlformats.org/drawingml/2006/main">
               <a:ext uri="{FF2B5EF4-FFF2-40B4-BE49-F238E27FC236}">
-                <a16:creationId xmlns:a16="http://schemas.microsoft.com/office/drawing/2014/main" id="{3693B760-AE78-4BA1-9191-869B3FD2C688}"/>
+                <a16:creationId xmlns:a16="http://schemas.microsoft.com/office/drawing/2014/main" id="{2329900D-2D89-4580-AFB5-01899407E497}"/>
               </a:ext>
             </a:extLst>
           </p:cNvPr>
@@ -16927,7 +16973,7 @@
           <p:cNvPr id="3" name="">
             <a:extLst xmlns:a="http://schemas.openxmlformats.org/drawingml/2006/main">
               <a:ext uri="{FF2B5EF4-FFF2-40B4-BE49-F238E27FC236}">
-                <a16:creationId xmlns:a16="http://schemas.microsoft.com/office/drawing/2014/main" id="{AB60A3FE-3F3A-495A-86EC-0ABDC747FC38}"/>
+                <a16:creationId xmlns:a16="http://schemas.microsoft.com/office/drawing/2014/main" id="{7A903CAF-104F-4B97-A567-100FEA7FA3A6}"/>
               </a:ext>
             </a:extLst>
           </p:cNvPr>
@@ -17075,7 +17121,7 @@
                 <a:ea typeface="Arial"/>
                 <a:cs typeface="Arial"/>
               </a:rPr>
-              <a:t>Projeto Aplicado Cenário 4</a:t>
+              <a:t>Projeto Aplicado Cenário 4  ·  Versão 28/10/2026</a:t>
             </a:r>
           </a:p>
         </p:txBody>
@@ -17085,7 +17131,7 @@
           <p:cNvPr id="4" name="">
             <a:extLst xmlns:a="http://schemas.openxmlformats.org/drawingml/2006/main">
               <a:ext uri="{FF2B5EF4-FFF2-40B4-BE49-F238E27FC236}">
-                <a16:creationId xmlns:a16="http://schemas.microsoft.com/office/drawing/2014/main" id="{71E1C671-1673-4989-8ED6-DAC6A91E3F97}"/>
+                <a16:creationId xmlns:a16="http://schemas.microsoft.com/office/drawing/2014/main" id="{66668094-FD7C-4058-BA05-44207BDBE898}"/>
               </a:ext>
             </a:extLst>
           </p:cNvPr>
@@ -17243,7 +17289,7 @@
           <p:cNvPr id="5" name="">
             <a:extLst xmlns:a="http://schemas.openxmlformats.org/drawingml/2006/main">
               <a:ext uri="{FF2B5EF4-FFF2-40B4-BE49-F238E27FC236}">
-                <a16:creationId xmlns:a16="http://schemas.microsoft.com/office/drawing/2014/main" id="{BB4DC70E-350E-4706-8498-98AD05E11696}"/>
+                <a16:creationId xmlns:a16="http://schemas.microsoft.com/office/drawing/2014/main" id="{70AEF803-B012-4005-B3C3-1323DB2E0010}"/>
               </a:ext>
             </a:extLst>
           </p:cNvPr>
@@ -17459,7 +17505,7 @@
           <p:cNvPr id="6" name="">
             <a:extLst xmlns:a="http://schemas.openxmlformats.org/drawingml/2006/main">
               <a:ext uri="{FF2B5EF4-FFF2-40B4-BE49-F238E27FC236}">
-                <a16:creationId xmlns:a16="http://schemas.microsoft.com/office/drawing/2014/main" id="{9542B702-AF60-4609-8BFE-21D6A2CCCCE3}"/>
+                <a16:creationId xmlns:a16="http://schemas.microsoft.com/office/drawing/2014/main" id="{3F2440A0-BC19-40B7-BBAF-B0E6CB39CE93}"/>
               </a:ext>
             </a:extLst>
           </p:cNvPr>
@@ -17617,7 +17663,7 @@
           <p:cNvPr id="7" name="">
             <a:extLst xmlns:a="http://schemas.openxmlformats.org/drawingml/2006/main">
               <a:ext uri="{FF2B5EF4-FFF2-40B4-BE49-F238E27FC236}">
-                <a16:creationId xmlns:a16="http://schemas.microsoft.com/office/drawing/2014/main" id="{776407D8-B5D0-40C4-8421-7F469F6FF710}"/>
+                <a16:creationId xmlns:a16="http://schemas.microsoft.com/office/drawing/2014/main" id="{4481CC70-6981-49C6-A081-35D65C527CB3}"/>
               </a:ext>
             </a:extLst>
           </p:cNvPr>
@@ -17833,7 +17879,7 @@
           <p:cNvPr id="8" name="">
             <a:extLst xmlns:a="http://schemas.openxmlformats.org/drawingml/2006/main">
               <a:ext uri="{FF2B5EF4-FFF2-40B4-BE49-F238E27FC236}">
-                <a16:creationId xmlns:a16="http://schemas.microsoft.com/office/drawing/2014/main" id="{FDBD5745-700B-426E-AC04-C80433A7F987}"/>
+                <a16:creationId xmlns:a16="http://schemas.microsoft.com/office/drawing/2014/main" id="{3DF71525-0691-4737-95D1-44DC446DACF0}"/>
               </a:ext>
             </a:extLst>
           </p:cNvPr>
@@ -17991,7 +18037,7 @@
           <p:cNvPr id="9" name="">
             <a:extLst xmlns:a="http://schemas.openxmlformats.org/drawingml/2006/main">
               <a:ext uri="{FF2B5EF4-FFF2-40B4-BE49-F238E27FC236}">
-                <a16:creationId xmlns:a16="http://schemas.microsoft.com/office/drawing/2014/main" id="{299A2482-44E8-462F-909B-8A6178AA68C7}"/>
+                <a16:creationId xmlns:a16="http://schemas.microsoft.com/office/drawing/2014/main" id="{12F842B8-BF31-494B-93EC-E9222FC76F17}"/>
               </a:ext>
             </a:extLst>
           </p:cNvPr>
@@ -18207,7 +18253,7 @@
           <p:cNvPr id="10" name="">
             <a:extLst xmlns:a="http://schemas.openxmlformats.org/drawingml/2006/main">
               <a:ext uri="{FF2B5EF4-FFF2-40B4-BE49-F238E27FC236}">
-                <a16:creationId xmlns:a16="http://schemas.microsoft.com/office/drawing/2014/main" id="{0676D30E-6BF1-4A03-8DE0-7D8280D7084C}"/>
+                <a16:creationId xmlns:a16="http://schemas.microsoft.com/office/drawing/2014/main" id="{FE9C2E4E-6BDD-4238-A24B-B9C8A3AD16FF}"/>
               </a:ext>
             </a:extLst>
           </p:cNvPr>
@@ -18355,7 +18401,7 @@
                 <a:ea typeface="Arial"/>
                 <a:cs typeface="Arial"/>
               </a:rPr>
-              <a:t>Viabilidade: um implantável, componentes gratuitos e equipe júnior; custos reais a levantar</a:t>
+              <a:t>Viabilidade: um implantável, serviços gratuitos (não custo zero) e equipe júnior; custos reais a levantar</a:t>
             </a:r>
           </a:p>
         </p:txBody>
@@ -18363,7 +18409,7 @@
     </p:spTree>
     <p:extLst>
       <p:ext uri="{BB962C8B-B14F-4D97-AF65-F5344CB8AC3E}">
-        <p14:creationId xmlns:p14="http://schemas.microsoft.com/office/powerpoint/2010/main" val="2132754436"/>
+        <p14:creationId xmlns:p14="http://schemas.microsoft.com/office/powerpoint/2010/main" val="1195748721"/>
       </p:ext>
     </p:extLst>
   </p:cSld>
@@ -18391,10 +18437,10 @@
       </p:grpSpPr>
       <p:sp>
         <p:nvSpPr>
-          <p:cNvPr id="8" name="">
+          <p:cNvPr id="9" name="">
             <a:extLst xmlns:a="http://schemas.openxmlformats.org/drawingml/2006/main">
               <a:ext uri="{FF2B5EF4-FFF2-40B4-BE49-F238E27FC236}">
-                <a16:creationId xmlns:a16="http://schemas.microsoft.com/office/drawing/2014/main" id="{8E57705D-A972-44AF-B7B7-9ABF5CF19392}"/>
+                <a16:creationId xmlns:a16="http://schemas.microsoft.com/office/drawing/2014/main" id="{FE56AEB4-1D95-48E9-8CA2-867DAF29CB58}"/>
               </a:ext>
             </a:extLst>
           </p:cNvPr>
@@ -18424,7 +18470,7 @@
           <p:cNvPr id="2" name="">
             <a:extLst xmlns:a="http://schemas.openxmlformats.org/drawingml/2006/main">
               <a:ext uri="{FF2B5EF4-FFF2-40B4-BE49-F238E27FC236}">
-                <a16:creationId xmlns:a16="http://schemas.microsoft.com/office/drawing/2014/main" id="{A74C5062-FBE7-4513-B665-CBE126FB3FC4}"/>
+                <a16:creationId xmlns:a16="http://schemas.microsoft.com/office/drawing/2014/main" id="{ABD19A29-E102-4215-A00A-B1CB8E48D7F6}"/>
               </a:ext>
             </a:extLst>
           </p:cNvPr>
@@ -18572,7 +18618,7 @@
                 <a:ea typeface="Arial"/>
                 <a:cs typeface="Arial"/>
               </a:rPr>
-              <a:t>Demonstração e resultados</a:t>
+              <a:t>Evidências e versão de referência</a:t>
             </a:r>
           </a:p>
         </p:txBody>
@@ -18582,7 +18628,7 @@
           <p:cNvPr id="3" name="">
             <a:extLst xmlns:a="http://schemas.openxmlformats.org/drawingml/2006/main">
               <a:ext uri="{FF2B5EF4-FFF2-40B4-BE49-F238E27FC236}">
-                <a16:creationId xmlns:a16="http://schemas.microsoft.com/office/drawing/2014/main" id="{72A507D2-37F5-472C-A281-5C32CEB2FA8F}"/>
+                <a16:creationId xmlns:a16="http://schemas.microsoft.com/office/drawing/2014/main" id="{2F5C8602-8FD5-4279-B47A-3E9724A608E0}"/>
               </a:ext>
             </a:extLst>
           </p:cNvPr>
@@ -18730,7 +18776,7 @@
                 <a:ea typeface="Arial"/>
                 <a:cs typeface="Arial"/>
               </a:rPr>
-              <a:t>Projeto Aplicado Cenário 4</a:t>
+              <a:t>Projeto Aplicado Cenário 4  ·  Versão 28/10/2026</a:t>
             </a:r>
           </a:p>
         </p:txBody>
@@ -18740,7 +18786,7 @@
           <p:cNvPr id="4" name="">
             <a:extLst xmlns:a="http://schemas.openxmlformats.org/drawingml/2006/main">
               <a:ext uri="{FF2B5EF4-FFF2-40B4-BE49-F238E27FC236}">
-                <a16:creationId xmlns:a16="http://schemas.microsoft.com/office/drawing/2014/main" id="{55CC9F6E-0009-49F0-BF7F-4BC283424DE6}"/>
+                <a16:creationId xmlns:a16="http://schemas.microsoft.com/office/drawing/2014/main" id="{096A8522-EE7B-42CB-A0E1-88D83B2ACA35}"/>
               </a:ext>
             </a:extLst>
           </p:cNvPr>
@@ -18751,8 +18797,8 @@
         </p:nvSpPr>
         <p:spPr>
           <a:xfrm xmlns:a="http://schemas.openxmlformats.org/drawingml/2006/main">
-            <a:off x="1000125" y="1381125"/>
-            <a:ext cx="4953000" cy="571500"/>
+            <a:off x="809625" y="1333500"/>
+            <a:ext cx="5143500" cy="476250"/>
           </a:xfrm>
           <a:prstGeom xmlns:a="http://schemas.openxmlformats.org/drawingml/2006/main" prst="rect">
             <a:avLst/>
@@ -18768,9 +18814,9 @@
           </a:bodyPr>
           <a:lstStyle xmlns:a="http://schemas.openxmlformats.org/drawingml/2006/main">
             <a:defPPr>
-              <a:defRPr sz="2550" b="1">
-                <a:solidFill>
-                  <a:srgbClr val="2E7D5B"/>
+              <a:defRPr sz="2250" b="1">
+                <a:solidFill>
+                  <a:srgbClr val="227C83"/>
                 </a:solidFill>
                 <a:latin typeface="Arial"/>
                 <a:ea typeface="Arial"/>
@@ -18778,9 +18824,9 @@
               </a:defRPr>
             </a:defPPr>
             <a:lvl1pPr>
-              <a:defRPr sz="2550" b="1">
-                <a:solidFill>
-                  <a:srgbClr val="2E7D5B"/>
+              <a:defRPr sz="2250" b="1">
+                <a:solidFill>
+                  <a:srgbClr val="227C83"/>
                 </a:solidFill>
                 <a:latin typeface="Arial"/>
                 <a:ea typeface="Arial"/>
@@ -18788,9 +18834,9 @@
               </a:defRPr>
             </a:lvl1pPr>
             <a:lvl2pPr>
-              <a:defRPr sz="2550" b="1">
-                <a:solidFill>
-                  <a:srgbClr val="2E7D5B"/>
+              <a:defRPr sz="2250" b="1">
+                <a:solidFill>
+                  <a:srgbClr val="227C83"/>
                 </a:solidFill>
                 <a:latin typeface="Arial"/>
                 <a:ea typeface="Arial"/>
@@ -18798,9 +18844,9 @@
               </a:defRPr>
             </a:lvl2pPr>
             <a:lvl3pPr>
-              <a:defRPr sz="2550" b="1">
-                <a:solidFill>
-                  <a:srgbClr val="2E7D5B"/>
+              <a:defRPr sz="2250" b="1">
+                <a:solidFill>
+                  <a:srgbClr val="227C83"/>
                 </a:solidFill>
                 <a:latin typeface="Arial"/>
                 <a:ea typeface="Arial"/>
@@ -18808,9 +18854,9 @@
               </a:defRPr>
             </a:lvl3pPr>
             <a:lvl4pPr>
-              <a:defRPr sz="2550" b="1">
-                <a:solidFill>
-                  <a:srgbClr val="2E7D5B"/>
+              <a:defRPr sz="2250" b="1">
+                <a:solidFill>
+                  <a:srgbClr val="227C83"/>
                 </a:solidFill>
                 <a:latin typeface="Arial"/>
                 <a:ea typeface="Arial"/>
@@ -18818,9 +18864,9 @@
               </a:defRPr>
             </a:lvl4pPr>
             <a:lvl5pPr>
-              <a:defRPr sz="2550" b="1">
-                <a:solidFill>
-                  <a:srgbClr val="2E7D5B"/>
+              <a:defRPr sz="2250" b="1">
+                <a:solidFill>
+                  <a:srgbClr val="227C83"/>
                 </a:solidFill>
                 <a:latin typeface="Arial"/>
                 <a:ea typeface="Arial"/>
@@ -18828,9 +18874,9 @@
               </a:defRPr>
             </a:lvl5pPr>
             <a:lvl6pPr>
-              <a:defRPr sz="2550" b="1">
-                <a:solidFill>
-                  <a:srgbClr val="2E7D5B"/>
+              <a:defRPr sz="2250" b="1">
+                <a:solidFill>
+                  <a:srgbClr val="227C83"/>
                 </a:solidFill>
                 <a:latin typeface="Arial"/>
                 <a:ea typeface="Arial"/>
@@ -18838,9 +18884,9 @@
               </a:defRPr>
             </a:lvl6pPr>
             <a:lvl7pPr>
-              <a:defRPr sz="2550" b="1">
-                <a:solidFill>
-                  <a:srgbClr val="2E7D5B"/>
+              <a:defRPr sz="2250" b="1">
+                <a:solidFill>
+                  <a:srgbClr val="227C83"/>
                 </a:solidFill>
                 <a:latin typeface="Arial"/>
                 <a:ea typeface="Arial"/>
@@ -18848,9 +18894,9 @@
               </a:defRPr>
             </a:lvl7pPr>
             <a:lvl8pPr>
-              <a:defRPr sz="2550" b="1">
-                <a:solidFill>
-                  <a:srgbClr val="2E7D5B"/>
+              <a:defRPr sz="2250" b="1">
+                <a:solidFill>
+                  <a:srgbClr val="227C83"/>
                 </a:solidFill>
                 <a:latin typeface="Arial"/>
                 <a:ea typeface="Arial"/>
@@ -18858,9 +18904,9 @@
               </a:defRPr>
             </a:lvl8pPr>
             <a:lvl9pPr>
-              <a:defRPr sz="2550" b="1">
-                <a:solidFill>
-                  <a:srgbClr val="2E7D5B"/>
+              <a:defRPr sz="2250" b="1">
+                <a:solidFill>
+                  <a:srgbClr val="227C83"/>
                 </a:solidFill>
                 <a:latin typeface="Arial"/>
                 <a:ea typeface="Arial"/>
@@ -18870,9 +18916,9 @@
           </a:lstStyle>
           <a:p xmlns:a="http://schemas.openxmlformats.org/drawingml/2006/main">
             <a:pPr>
-              <a:defRPr sz="2550" b="1">
-                <a:solidFill>
-                  <a:srgbClr val="2E7D5B"/>
+              <a:defRPr sz="2250" b="1">
+                <a:solidFill>
+                  <a:srgbClr val="227C83"/>
                 </a:solidFill>
                 <a:latin typeface="Arial"/>
                 <a:ea typeface="Arial"/>
@@ -18880,15 +18926,15 @@
               </a:defRPr>
             </a:pPr>
             <a:r>
-              <a:rPr sz="2550" b="1">
-                <a:solidFill>
-                  <a:srgbClr val="2E7D5B"/>
+              <a:rPr sz="2250" b="1">
+                <a:solidFill>
+                  <a:srgbClr val="227C83"/>
                 </a:solidFill>
                 <a:latin typeface="Arial"/>
                 <a:ea typeface="Arial"/>
                 <a:cs typeface="Arial"/>
               </a:rPr>
-              <a:t>211 testes aprovados</a:t>
+              <a:t>Histórico de 20/10/2026</a:t>
             </a:r>
           </a:p>
         </p:txBody>
@@ -18898,7 +18944,7 @@
           <p:cNvPr id="5" name="">
             <a:extLst xmlns:a="http://schemas.openxmlformats.org/drawingml/2006/main">
               <a:ext uri="{FF2B5EF4-FFF2-40B4-BE49-F238E27FC236}">
-                <a16:creationId xmlns:a16="http://schemas.microsoft.com/office/drawing/2014/main" id="{55304C4A-D156-48DC-84FB-5A939D26FAA7}"/>
+                <a16:creationId xmlns:a16="http://schemas.microsoft.com/office/drawing/2014/main" id="{CEDC8CAC-8ABF-40B3-BE0C-BFBBFE821317}"/>
               </a:ext>
             </a:extLst>
           </p:cNvPr>
@@ -18909,8 +18955,8 @@
         </p:nvSpPr>
         <p:spPr>
           <a:xfrm xmlns:a="http://schemas.openxmlformats.org/drawingml/2006/main">
-            <a:off x="7620000" y="1381125"/>
-            <a:ext cx="3143250" cy="571500"/>
+            <a:off x="762000" y="2047875"/>
+            <a:ext cx="5191125" cy="2905125"/>
           </a:xfrm>
           <a:prstGeom xmlns:a="http://schemas.openxmlformats.org/drawingml/2006/main" prst="rect">
             <a:avLst/>
@@ -18926,9 +18972,9 @@
           </a:bodyPr>
           <a:lstStyle xmlns:a="http://schemas.openxmlformats.org/drawingml/2006/main">
             <a:defPPr>
-              <a:defRPr sz="2550" b="1">
-                <a:solidFill>
-                  <a:srgbClr val="2E7D5B"/>
+              <a:defRPr sz="1800">
+                <a:solidFill>
+                  <a:srgbClr val="17212B"/>
                 </a:solidFill>
                 <a:latin typeface="Arial"/>
                 <a:ea typeface="Arial"/>
@@ -18936,9 +18982,9 @@
               </a:defRPr>
             </a:defPPr>
             <a:lvl1pPr>
-              <a:defRPr sz="2550" b="1">
-                <a:solidFill>
-                  <a:srgbClr val="2E7D5B"/>
+              <a:defRPr sz="1800">
+                <a:solidFill>
+                  <a:srgbClr val="17212B"/>
                 </a:solidFill>
                 <a:latin typeface="Arial"/>
                 <a:ea typeface="Arial"/>
@@ -18946,9 +18992,9 @@
               </a:defRPr>
             </a:lvl1pPr>
             <a:lvl2pPr>
-              <a:defRPr sz="2550" b="1">
-                <a:solidFill>
-                  <a:srgbClr val="2E7D5B"/>
+              <a:defRPr sz="1800">
+                <a:solidFill>
+                  <a:srgbClr val="17212B"/>
                 </a:solidFill>
                 <a:latin typeface="Arial"/>
                 <a:ea typeface="Arial"/>
@@ -18956,9 +19002,9 @@
               </a:defRPr>
             </a:lvl2pPr>
             <a:lvl3pPr>
-              <a:defRPr sz="2550" b="1">
-                <a:solidFill>
-                  <a:srgbClr val="2E7D5B"/>
+              <a:defRPr sz="1800">
+                <a:solidFill>
+                  <a:srgbClr val="17212B"/>
                 </a:solidFill>
                 <a:latin typeface="Arial"/>
                 <a:ea typeface="Arial"/>
@@ -18966,9 +19012,9 @@
               </a:defRPr>
             </a:lvl3pPr>
             <a:lvl4pPr>
-              <a:defRPr sz="2550" b="1">
-                <a:solidFill>
-                  <a:srgbClr val="2E7D5B"/>
+              <a:defRPr sz="1800">
+                <a:solidFill>
+                  <a:srgbClr val="17212B"/>
                 </a:solidFill>
                 <a:latin typeface="Arial"/>
                 <a:ea typeface="Arial"/>
@@ -18976,9 +19022,9 @@
               </a:defRPr>
             </a:lvl4pPr>
             <a:lvl5pPr>
-              <a:defRPr sz="2550" b="1">
-                <a:solidFill>
-                  <a:srgbClr val="2E7D5B"/>
+              <a:defRPr sz="1800">
+                <a:solidFill>
+                  <a:srgbClr val="17212B"/>
                 </a:solidFill>
                 <a:latin typeface="Arial"/>
                 <a:ea typeface="Arial"/>
@@ -18986,9 +19032,9 @@
               </a:defRPr>
             </a:lvl5pPr>
             <a:lvl6pPr>
-              <a:defRPr sz="2550" b="1">
-                <a:solidFill>
-                  <a:srgbClr val="2E7D5B"/>
+              <a:defRPr sz="1800">
+                <a:solidFill>
+                  <a:srgbClr val="17212B"/>
                 </a:solidFill>
                 <a:latin typeface="Arial"/>
                 <a:ea typeface="Arial"/>
@@ -18996,9 +19042,9 @@
               </a:defRPr>
             </a:lvl6pPr>
             <a:lvl7pPr>
-              <a:defRPr sz="2550" b="1">
-                <a:solidFill>
-                  <a:srgbClr val="2E7D5B"/>
+              <a:defRPr sz="1800">
+                <a:solidFill>
+                  <a:srgbClr val="17212B"/>
                 </a:solidFill>
                 <a:latin typeface="Arial"/>
                 <a:ea typeface="Arial"/>
@@ -19006,9 +19052,9 @@
               </a:defRPr>
             </a:lvl7pPr>
             <a:lvl8pPr>
-              <a:defRPr sz="2550" b="1">
-                <a:solidFill>
-                  <a:srgbClr val="2E7D5B"/>
+              <a:defRPr sz="1800">
+                <a:solidFill>
+                  <a:srgbClr val="17212B"/>
                 </a:solidFill>
                 <a:latin typeface="Arial"/>
                 <a:ea typeface="Arial"/>
@@ -19016,9 +19062,9 @@
               </a:defRPr>
             </a:lvl8pPr>
             <a:lvl9pPr>
-              <a:defRPr sz="2550" b="1">
-                <a:solidFill>
-                  <a:srgbClr val="2E7D5B"/>
+              <a:defRPr sz="1800">
+                <a:solidFill>
+                  <a:srgbClr val="17212B"/>
                 </a:solidFill>
                 <a:latin typeface="Arial"/>
                 <a:ea typeface="Arial"/>
@@ -19027,10 +19073,14 @@
             </a:lvl9pPr>
           </a:lstStyle>
           <a:p xmlns:a="http://schemas.openxmlformats.org/drawingml/2006/main">
-            <a:pPr>
-              <a:defRPr sz="2550" b="1">
-                <a:solidFill>
-                  <a:srgbClr val="2E7D5B"/>
+            <a:pPr marL="254000" indent="-127000">
+              <a:spcAft>
+                <a:spcPts val="1000"/>
+              </a:spcAft>
+              <a:buChar char="•"/>
+              <a:defRPr sz="1800">
+                <a:solidFill>
+                  <a:srgbClr val="17212B"/>
                 </a:solidFill>
                 <a:latin typeface="Arial"/>
                 <a:ea typeface="Arial"/>
@@ -19038,15 +19088,96 @@
               </a:defRPr>
             </a:pPr>
             <a:r>
-              <a:rPr sz="2550" b="1">
-                <a:solidFill>
-                  <a:srgbClr val="2E7D5B"/>
+              <a:rPr sz="1800">
+                <a:solidFill>
+                  <a:srgbClr val="17212B"/>
                 </a:solidFill>
                 <a:latin typeface="Arial"/>
                 <a:ea typeface="Arial"/>
                 <a:cs typeface="Arial"/>
               </a:rPr>
-              <a:t>p95  4,22 ms</a:t>
+              <a:t>246 testes com PostgreSQL e RabbitMQ</a:t>
+            </a:r>
+          </a:p>
+          <a:p xmlns:a="http://schemas.openxmlformats.org/drawingml/2006/main">
+            <a:pPr marL="254000" indent="-127000">
+              <a:spcAft>
+                <a:spcPts val="1000"/>
+              </a:spcAft>
+              <a:buChar char="•"/>
+              <a:defRPr sz="1800">
+                <a:solidFill>
+                  <a:srgbClr val="17212B"/>
+                </a:solidFill>
+                <a:latin typeface="Arial"/>
+                <a:ea typeface="Arial"/>
+                <a:cs typeface="Arial"/>
+              </a:defRPr>
+            </a:pPr>
+            <a:r>
+              <a:rPr sz="1800">
+                <a:solidFill>
+                  <a:srgbClr val="17212B"/>
+                </a:solidFill>
+                <a:latin typeface="Arial"/>
+                <a:ea typeface="Arial"/>
+                <a:cs typeface="Arial"/>
+              </a:rPr>
+              <a:t>232 aprovados e 14 ignorados em SQLite</a:t>
+            </a:r>
+          </a:p>
+          <a:p xmlns:a="http://schemas.openxmlformats.org/drawingml/2006/main">
+            <a:pPr marL="254000" indent="-127000">
+              <a:spcAft>
+                <a:spcPts val="1000"/>
+              </a:spcAft>
+              <a:buChar char="•"/>
+              <a:defRPr sz="1800">
+                <a:solidFill>
+                  <a:srgbClr val="17212B"/>
+                </a:solidFill>
+                <a:latin typeface="Arial"/>
+                <a:ea typeface="Arial"/>
+                <a:cs typeface="Arial"/>
+              </a:defRPr>
+            </a:pPr>
+            <a:r>
+              <a:rPr sz="1800">
+                <a:solidFill>
+                  <a:srgbClr val="17212B"/>
+                </a:solidFill>
+                <a:latin typeface="Arial"/>
+                <a:ea typeface="Arial"/>
+                <a:cs typeface="Arial"/>
+              </a:rPr>
+              <a:t>22 roteiros de navegador aprovados</a:t>
+            </a:r>
+          </a:p>
+          <a:p xmlns:a="http://schemas.openxmlformats.org/drawingml/2006/main">
+            <a:pPr marL="254000" indent="-127000">
+              <a:spcAft>
+                <a:spcPts val="1000"/>
+              </a:spcAft>
+              <a:buChar char="•"/>
+              <a:defRPr sz="1800">
+                <a:solidFill>
+                  <a:srgbClr val="17212B"/>
+                </a:solidFill>
+                <a:latin typeface="Arial"/>
+                <a:ea typeface="Arial"/>
+                <a:cs typeface="Arial"/>
+              </a:defRPr>
+            </a:pPr>
+            <a:r>
+              <a:rPr sz="1800">
+                <a:solidFill>
+                  <a:srgbClr val="17212B"/>
+                </a:solidFill>
+                <a:latin typeface="Arial"/>
+                <a:ea typeface="Arial"/>
+                <a:cs typeface="Arial"/>
+              </a:rPr>
+              <a:t>p95 máximo de 45,1 ms em consultas locais</a:t>
             </a:r>
           </a:p>
         </p:txBody>
@@ -19056,7 +19187,7 @@
           <p:cNvPr id="6" name="">
             <a:extLst xmlns:a="http://schemas.openxmlformats.org/drawingml/2006/main">
               <a:ext uri="{FF2B5EF4-FFF2-40B4-BE49-F238E27FC236}">
-                <a16:creationId xmlns:a16="http://schemas.microsoft.com/office/drawing/2014/main" id="{AA3789A5-D973-4441-9DAD-61441710FFE1}"/>
+                <a16:creationId xmlns:a16="http://schemas.microsoft.com/office/drawing/2014/main" id="{56B6FD06-3FC3-4C94-9568-DE1E8F49B809}"/>
               </a:ext>
             </a:extLst>
           </p:cNvPr>
@@ -19067,8 +19198,8 @@
         </p:nvSpPr>
         <p:spPr>
           <a:xfrm xmlns:a="http://schemas.openxmlformats.org/drawingml/2006/main">
-            <a:off x="1619250" y="2381250"/>
-            <a:ext cx="9144000" cy="2857500"/>
+            <a:off x="6477000" y="1333500"/>
+            <a:ext cx="5143500" cy="476250"/>
           </a:xfrm>
           <a:prstGeom xmlns:a="http://schemas.openxmlformats.org/drawingml/2006/main" prst="rect">
             <a:avLst/>
@@ -19084,9 +19215,9 @@
           </a:bodyPr>
           <a:lstStyle xmlns:a="http://schemas.openxmlformats.org/drawingml/2006/main">
             <a:defPPr>
-              <a:defRPr sz="1950">
-                <a:solidFill>
-                  <a:srgbClr val="17212B"/>
+              <a:defRPr sz="2175" b="1">
+                <a:solidFill>
+                  <a:srgbClr val="227C83"/>
                 </a:solidFill>
                 <a:latin typeface="Arial"/>
                 <a:ea typeface="Arial"/>
@@ -19094,9 +19225,9 @@
               </a:defRPr>
             </a:defPPr>
             <a:lvl1pPr>
-              <a:defRPr sz="1950">
-                <a:solidFill>
-                  <a:srgbClr val="17212B"/>
+              <a:defRPr sz="2175" b="1">
+                <a:solidFill>
+                  <a:srgbClr val="227C83"/>
                 </a:solidFill>
                 <a:latin typeface="Arial"/>
                 <a:ea typeface="Arial"/>
@@ -19104,9 +19235,9 @@
               </a:defRPr>
             </a:lvl1pPr>
             <a:lvl2pPr>
-              <a:defRPr sz="1950">
-                <a:solidFill>
-                  <a:srgbClr val="17212B"/>
+              <a:defRPr sz="2175" b="1">
+                <a:solidFill>
+                  <a:srgbClr val="227C83"/>
                 </a:solidFill>
                 <a:latin typeface="Arial"/>
                 <a:ea typeface="Arial"/>
@@ -19114,9 +19245,9 @@
               </a:defRPr>
             </a:lvl2pPr>
             <a:lvl3pPr>
-              <a:defRPr sz="1950">
-                <a:solidFill>
-                  <a:srgbClr val="17212B"/>
+              <a:defRPr sz="2175" b="1">
+                <a:solidFill>
+                  <a:srgbClr val="227C83"/>
                 </a:solidFill>
                 <a:latin typeface="Arial"/>
                 <a:ea typeface="Arial"/>
@@ -19124,9 +19255,9 @@
               </a:defRPr>
             </a:lvl3pPr>
             <a:lvl4pPr>
-              <a:defRPr sz="1950">
-                <a:solidFill>
-                  <a:srgbClr val="17212B"/>
+              <a:defRPr sz="2175" b="1">
+                <a:solidFill>
+                  <a:srgbClr val="227C83"/>
                 </a:solidFill>
                 <a:latin typeface="Arial"/>
                 <a:ea typeface="Arial"/>
@@ -19134,9 +19265,9 @@
               </a:defRPr>
             </a:lvl4pPr>
             <a:lvl5pPr>
-              <a:defRPr sz="1950">
-                <a:solidFill>
-                  <a:srgbClr val="17212B"/>
+              <a:defRPr sz="2175" b="1">
+                <a:solidFill>
+                  <a:srgbClr val="227C83"/>
                 </a:solidFill>
                 <a:latin typeface="Arial"/>
                 <a:ea typeface="Arial"/>
@@ -19144,9 +19275,9 @@
               </a:defRPr>
             </a:lvl5pPr>
             <a:lvl6pPr>
-              <a:defRPr sz="1950">
-                <a:solidFill>
-                  <a:srgbClr val="17212B"/>
+              <a:defRPr sz="2175" b="1">
+                <a:solidFill>
+                  <a:srgbClr val="227C83"/>
                 </a:solidFill>
                 <a:latin typeface="Arial"/>
                 <a:ea typeface="Arial"/>
@@ -19154,9 +19285,9 @@
               </a:defRPr>
             </a:lvl6pPr>
             <a:lvl7pPr>
-              <a:defRPr sz="1950">
-                <a:solidFill>
-                  <a:srgbClr val="17212B"/>
+              <a:defRPr sz="2175" b="1">
+                <a:solidFill>
+                  <a:srgbClr val="227C83"/>
                 </a:solidFill>
                 <a:latin typeface="Arial"/>
                 <a:ea typeface="Arial"/>
@@ -19164,9 +19295,9 @@
               </a:defRPr>
             </a:lvl7pPr>
             <a:lvl8pPr>
-              <a:defRPr sz="1950">
-                <a:solidFill>
-                  <a:srgbClr val="17212B"/>
+              <a:defRPr sz="2175" b="1">
+                <a:solidFill>
+                  <a:srgbClr val="227C83"/>
                 </a:solidFill>
                 <a:latin typeface="Arial"/>
                 <a:ea typeface="Arial"/>
@@ -19174,9 +19305,9 @@
               </a:defRPr>
             </a:lvl8pPr>
             <a:lvl9pPr>
-              <a:defRPr sz="1950">
-                <a:solidFill>
-                  <a:srgbClr val="17212B"/>
+              <a:defRPr sz="2175" b="1">
+                <a:solidFill>
+                  <a:srgbClr val="227C83"/>
                 </a:solidFill>
                 <a:latin typeface="Arial"/>
                 <a:ea typeface="Arial"/>
@@ -19185,14 +19316,10 @@
             </a:lvl9pPr>
           </a:lstStyle>
           <a:p xmlns:a="http://schemas.openxmlformats.org/drawingml/2006/main">
-            <a:pPr marL="254000" indent="-127000">
-              <a:spcAft>
-                <a:spcPts val="1000"/>
-              </a:spcAft>
-              <a:buChar char="•"/>
-              <a:defRPr sz="1950">
-                <a:solidFill>
-                  <a:srgbClr val="17212B"/>
+            <a:pPr>
+              <a:defRPr sz="2175" b="1">
+                <a:solidFill>
+                  <a:srgbClr val="227C83"/>
                 </a:solidFill>
                 <a:latin typeface="Arial"/>
                 <a:ea typeface="Arial"/>
@@ -19200,123 +19327,15 @@
               </a:defRPr>
             </a:pPr>
             <a:r>
-              <a:rPr sz="1950">
-                <a:solidFill>
-                  <a:srgbClr val="17212B"/>
+              <a:rPr sz="2175" b="1">
+                <a:solidFill>
+                  <a:srgbClr val="227C83"/>
                 </a:solidFill>
                 <a:latin typeface="Arial"/>
                 <a:ea typeface="Arial"/>
                 <a:cs typeface="Arial"/>
               </a:rPr>
-              <a:t>F1 cria rascunho sem recadastro: 20 de 20</a:t>
-            </a:r>
-          </a:p>
-          <a:p xmlns:a="http://schemas.openxmlformats.org/drawingml/2006/main">
-            <a:pPr marL="254000" indent="-127000">
-              <a:spcAft>
-                <a:spcPts val="1000"/>
-              </a:spcAft>
-              <a:buChar char="•"/>
-              <a:defRPr sz="1950">
-                <a:solidFill>
-                  <a:srgbClr val="17212B"/>
-                </a:solidFill>
-                <a:latin typeface="Arial"/>
-                <a:ea typeface="Arial"/>
-                <a:cs typeface="Arial"/>
-              </a:defRPr>
-            </a:pPr>
-            <a:r>
-              <a:rPr sz="1950">
-                <a:solidFill>
-                  <a:srgbClr val="17212B"/>
-                </a:solidFill>
-                <a:latin typeface="Arial"/>
-                <a:ea typeface="Arial"/>
-                <a:cs typeface="Arial"/>
-              </a:rPr>
-              <a:t>F2 cria uma cobrança e uma preparação de retirada: 14 de 14</a:t>
-            </a:r>
-          </a:p>
-          <a:p xmlns:a="http://schemas.openxmlformats.org/drawingml/2006/main">
-            <a:pPr marL="254000" indent="-127000">
-              <a:spcAft>
-                <a:spcPts val="1000"/>
-              </a:spcAft>
-              <a:buChar char="•"/>
-              <a:defRPr sz="1950">
-                <a:solidFill>
-                  <a:srgbClr val="17212B"/>
-                </a:solidFill>
-                <a:latin typeface="Arial"/>
-                <a:ea typeface="Arial"/>
-                <a:cs typeface="Arial"/>
-              </a:defRPr>
-            </a:pPr>
-            <a:r>
-              <a:rPr sz="1950">
-                <a:solidFill>
-                  <a:srgbClr val="17212B"/>
-                </a:solidFill>
-                <a:latin typeface="Arial"/>
-                <a:ea typeface="Arial"/>
-                <a:cs typeface="Arial"/>
-              </a:rPr>
-              <a:t>F3 registra SLA, resolve e conclui o processo: 15 de 15</a:t>
-            </a:r>
-          </a:p>
-          <a:p xmlns:a="http://schemas.openxmlformats.org/drawingml/2006/main">
-            <a:pPr marL="254000" indent="-127000">
-              <a:spcAft>
-                <a:spcPts val="1000"/>
-              </a:spcAft>
-              <a:buChar char="•"/>
-              <a:defRPr sz="1950">
-                <a:solidFill>
-                  <a:srgbClr val="17212B"/>
-                </a:solidFill>
-                <a:latin typeface="Arial"/>
-                <a:ea typeface="Arial"/>
-                <a:cs typeface="Arial"/>
-              </a:defRPr>
-            </a:pPr>
-            <a:r>
-              <a:rPr sz="1950">
-                <a:solidFill>
-                  <a:srgbClr val="17212B"/>
-                </a:solidFill>
-                <a:latin typeface="Arial"/>
-                <a:ea typeface="Arial"/>
-                <a:cs typeface="Arial"/>
-              </a:rPr>
-              <a:t>Falha controlada preserva e reconcilia o chamado</a:t>
-            </a:r>
-          </a:p>
-          <a:p xmlns:a="http://schemas.openxmlformats.org/drawingml/2006/main">
-            <a:pPr marL="254000" indent="-127000">
-              <a:spcAft>
-                <a:spcPts val="1000"/>
-              </a:spcAft>
-              <a:buChar char="•"/>
-              <a:defRPr sz="1950">
-                <a:solidFill>
-                  <a:srgbClr val="17212B"/>
-                </a:solidFill>
-                <a:latin typeface="Arial"/>
-                <a:ea typeface="Arial"/>
-                <a:cs typeface="Arial"/>
-              </a:defRPr>
-            </a:pPr>
-            <a:r>
-              <a:rPr sz="1950">
-                <a:solidFill>
-                  <a:srgbClr val="17212B"/>
-                </a:solidFill>
-                <a:latin typeface="Arial"/>
-                <a:ea typeface="Arial"/>
-                <a:cs typeface="Arial"/>
-              </a:rPr>
-              <a:t>Rastreabilidade reúne auditoria e eventos</a:t>
+              <a:t>CI da main f1669d7 em 25/10</a:t>
             </a:r>
           </a:p>
         </p:txBody>
@@ -19326,7 +19345,7 @@
           <p:cNvPr id="7" name="">
             <a:extLst xmlns:a="http://schemas.openxmlformats.org/drawingml/2006/main">
               <a:ext uri="{FF2B5EF4-FFF2-40B4-BE49-F238E27FC236}">
-                <a16:creationId xmlns:a16="http://schemas.microsoft.com/office/drawing/2014/main" id="{947E0B12-AF28-4C6C-9463-F5B562F145B5}"/>
+                <a16:creationId xmlns:a16="http://schemas.microsoft.com/office/drawing/2014/main" id="{54AC997F-A0FE-4F3D-8624-65F01D7AB2A8}"/>
               </a:ext>
             </a:extLst>
           </p:cNvPr>
@@ -19337,8 +19356,251 @@
         </p:nvSpPr>
         <p:spPr>
           <a:xfrm xmlns:a="http://schemas.openxmlformats.org/drawingml/2006/main">
-            <a:off x="2381250" y="5619750"/>
-            <a:ext cx="7620000" cy="400050"/>
+            <a:off x="6429375" y="2047875"/>
+            <a:ext cx="5048250" cy="2905125"/>
+          </a:xfrm>
+          <a:prstGeom xmlns:a="http://schemas.openxmlformats.org/drawingml/2006/main" prst="rect">
+            <a:avLst/>
+          </a:prstGeom>
+          <a:noFill xmlns:a="http://schemas.openxmlformats.org/drawingml/2006/main"/>
+          <a:ln xmlns:a="http://schemas.openxmlformats.org/drawingml/2006/main" w="0">
+            <a:noFill/>
+          </a:ln>
+        </p:spPr>
+        <p:txBody>
+          <a:bodyPr xmlns:a="http://schemas.openxmlformats.org/drawingml/2006/main">
+            <a:noAutofit/>
+          </a:bodyPr>
+          <a:lstStyle xmlns:a="http://schemas.openxmlformats.org/drawingml/2006/main">
+            <a:defPPr>
+              <a:defRPr sz="1800">
+                <a:solidFill>
+                  <a:srgbClr val="17212B"/>
+                </a:solidFill>
+                <a:latin typeface="Arial"/>
+                <a:ea typeface="Arial"/>
+                <a:cs typeface="Arial"/>
+              </a:defRPr>
+            </a:defPPr>
+            <a:lvl1pPr>
+              <a:defRPr sz="1800">
+                <a:solidFill>
+                  <a:srgbClr val="17212B"/>
+                </a:solidFill>
+                <a:latin typeface="Arial"/>
+                <a:ea typeface="Arial"/>
+                <a:cs typeface="Arial"/>
+              </a:defRPr>
+            </a:lvl1pPr>
+            <a:lvl2pPr>
+              <a:defRPr sz="1800">
+                <a:solidFill>
+                  <a:srgbClr val="17212B"/>
+                </a:solidFill>
+                <a:latin typeface="Arial"/>
+                <a:ea typeface="Arial"/>
+                <a:cs typeface="Arial"/>
+              </a:defRPr>
+            </a:lvl2pPr>
+            <a:lvl3pPr>
+              <a:defRPr sz="1800">
+                <a:solidFill>
+                  <a:srgbClr val="17212B"/>
+                </a:solidFill>
+                <a:latin typeface="Arial"/>
+                <a:ea typeface="Arial"/>
+                <a:cs typeface="Arial"/>
+              </a:defRPr>
+            </a:lvl3pPr>
+            <a:lvl4pPr>
+              <a:defRPr sz="1800">
+                <a:solidFill>
+                  <a:srgbClr val="17212B"/>
+                </a:solidFill>
+                <a:latin typeface="Arial"/>
+                <a:ea typeface="Arial"/>
+                <a:cs typeface="Arial"/>
+              </a:defRPr>
+            </a:lvl4pPr>
+            <a:lvl5pPr>
+              <a:defRPr sz="1800">
+                <a:solidFill>
+                  <a:srgbClr val="17212B"/>
+                </a:solidFill>
+                <a:latin typeface="Arial"/>
+                <a:ea typeface="Arial"/>
+                <a:cs typeface="Arial"/>
+              </a:defRPr>
+            </a:lvl5pPr>
+            <a:lvl6pPr>
+              <a:defRPr sz="1800">
+                <a:solidFill>
+                  <a:srgbClr val="17212B"/>
+                </a:solidFill>
+                <a:latin typeface="Arial"/>
+                <a:ea typeface="Arial"/>
+                <a:cs typeface="Arial"/>
+              </a:defRPr>
+            </a:lvl6pPr>
+            <a:lvl7pPr>
+              <a:defRPr sz="1800">
+                <a:solidFill>
+                  <a:srgbClr val="17212B"/>
+                </a:solidFill>
+                <a:latin typeface="Arial"/>
+                <a:ea typeface="Arial"/>
+                <a:cs typeface="Arial"/>
+              </a:defRPr>
+            </a:lvl7pPr>
+            <a:lvl8pPr>
+              <a:defRPr sz="1800">
+                <a:solidFill>
+                  <a:srgbClr val="17212B"/>
+                </a:solidFill>
+                <a:latin typeface="Arial"/>
+                <a:ea typeface="Arial"/>
+                <a:cs typeface="Arial"/>
+              </a:defRPr>
+            </a:lvl8pPr>
+            <a:lvl9pPr>
+              <a:defRPr sz="1800">
+                <a:solidFill>
+                  <a:srgbClr val="17212B"/>
+                </a:solidFill>
+                <a:latin typeface="Arial"/>
+                <a:ea typeface="Arial"/>
+                <a:cs typeface="Arial"/>
+              </a:defRPr>
+            </a:lvl9pPr>
+          </a:lstStyle>
+          <a:p xmlns:a="http://schemas.openxmlformats.org/drawingml/2006/main">
+            <a:pPr marL="254000" indent="-127000">
+              <a:spcAft>
+                <a:spcPts val="1000"/>
+              </a:spcAft>
+              <a:buChar char="•"/>
+              <a:defRPr sz="1800">
+                <a:solidFill>
+                  <a:srgbClr val="17212B"/>
+                </a:solidFill>
+                <a:latin typeface="Arial"/>
+                <a:ea typeface="Arial"/>
+                <a:cs typeface="Arial"/>
+              </a:defRPr>
+            </a:pPr>
+            <a:r>
+              <a:rPr sz="1800">
+                <a:solidFill>
+                  <a:srgbClr val="17212B"/>
+                </a:solidFill>
+                <a:latin typeface="Arial"/>
+                <a:ea typeface="Arial"/>
+                <a:cs typeface="Arial"/>
+              </a:rPr>
+              <a:t>application: 252 aprovados, 14 ignorados</a:t>
+            </a:r>
+          </a:p>
+          <a:p xmlns:a="http://schemas.openxmlformats.org/drawingml/2006/main">
+            <a:pPr marL="254000" indent="-127000">
+              <a:spcAft>
+                <a:spcPts val="1000"/>
+              </a:spcAft>
+              <a:buChar char="•"/>
+              <a:defRPr sz="1800">
+                <a:solidFill>
+                  <a:srgbClr val="17212B"/>
+                </a:solidFill>
+                <a:latin typeface="Arial"/>
+                <a:ea typeface="Arial"/>
+                <a:cs typeface="Arial"/>
+              </a:defRPr>
+            </a:pPr>
+            <a:r>
+              <a:rPr sz="1800">
+                <a:solidFill>
+                  <a:srgbClr val="17212B"/>
+                </a:solidFill>
+                <a:latin typeface="Arial"/>
+                <a:ea typeface="Arial"/>
+                <a:cs typeface="Arial"/>
+              </a:rPr>
+              <a:t>postgresql: 262 aprovados, 4 ignorados</a:t>
+            </a:r>
+          </a:p>
+          <a:p xmlns:a="http://schemas.openxmlformats.org/drawingml/2006/main">
+            <a:pPr marL="254000" indent="-127000">
+              <a:spcAft>
+                <a:spcPts val="1000"/>
+              </a:spcAft>
+              <a:buChar char="•"/>
+              <a:defRPr sz="1800">
+                <a:solidFill>
+                  <a:srgbClr val="17212B"/>
+                </a:solidFill>
+                <a:latin typeface="Arial"/>
+                <a:ea typeface="Arial"/>
+                <a:cs typeface="Arial"/>
+              </a:defRPr>
+            </a:pPr>
+            <a:r>
+              <a:rPr sz="1800">
+                <a:solidFill>
+                  <a:srgbClr val="17212B"/>
+                </a:solidFill>
+                <a:latin typeface="Arial"/>
+                <a:ea typeface="Arial"/>
+                <a:cs typeface="Arial"/>
+              </a:rPr>
+              <a:t>rabbitmq: 22 aprovados</a:t>
+            </a:r>
+          </a:p>
+          <a:p xmlns:a="http://schemas.openxmlformats.org/drawingml/2006/main">
+            <a:pPr marL="254000" indent="-127000">
+              <a:spcAft>
+                <a:spcPts val="1000"/>
+              </a:spcAft>
+              <a:buChar char="•"/>
+              <a:defRPr sz="1800">
+                <a:solidFill>
+                  <a:srgbClr val="17212B"/>
+                </a:solidFill>
+                <a:latin typeface="Arial"/>
+                <a:ea typeface="Arial"/>
+                <a:cs typeface="Arial"/>
+              </a:defRPr>
+            </a:pPr>
+            <a:r>
+              <a:rPr sz="1800">
+                <a:solidFill>
+                  <a:srgbClr val="17212B"/>
+                </a:solidFill>
+                <a:latin typeface="Arial"/>
+                <a:ea typeface="Arial"/>
+                <a:cs typeface="Arial"/>
+              </a:rPr>
+              <a:t>e2e: 25 aprovados; axe: 1 aprovado</a:t>
+            </a:r>
+          </a:p>
+        </p:txBody>
+      </p:sp>
+      <p:sp>
+        <p:nvSpPr>
+          <p:cNvPr id="8" name="">
+            <a:extLst xmlns:a="http://schemas.openxmlformats.org/drawingml/2006/main">
+              <a:ext uri="{FF2B5EF4-FFF2-40B4-BE49-F238E27FC236}">
+                <a16:creationId xmlns:a16="http://schemas.microsoft.com/office/drawing/2014/main" id="{39CEC7AE-EFE3-444B-BDE1-C1E42862ABD4}"/>
+              </a:ext>
+            </a:extLst>
+          </p:cNvPr>
+          <p:cNvSpPr>
+            <a:spLocks xmlns:a="http://schemas.openxmlformats.org/drawingml/2006/main" noGrp="1"/>
+          </p:cNvSpPr>
+          <p:nvPr/>
+        </p:nvSpPr>
+        <p:spPr>
+          <a:xfrm xmlns:a="http://schemas.openxmlformats.org/drawingml/2006/main">
+            <a:off x="952500" y="5286375"/>
+            <a:ext cx="10477500" cy="762000"/>
           </a:xfrm>
           <a:prstGeom xmlns:a="http://schemas.openxmlformats.org/drawingml/2006/main" prst="rect">
             <a:avLst/>
@@ -19474,7 +19736,30 @@
                 <a:ea typeface="Arial"/>
                 <a:cs typeface="Arial"/>
               </a:rPr>
-              <a:t>Premissas do AS IS seguem para validação com a organização</a:t>
+              <a:t>CI 40199072801 com quatro jobs concluídos com sucesso.</a:t>
+            </a:r>
+          </a:p>
+          <a:p xmlns:a="http://schemas.openxmlformats.org/drawingml/2006/main">
+            <a:pPr>
+              <a:defRPr sz="1725" b="1">
+                <a:solidFill>
+                  <a:srgbClr val="C65D3A"/>
+                </a:solidFill>
+                <a:latin typeface="Arial"/>
+                <a:ea typeface="Arial"/>
+                <a:cs typeface="Arial"/>
+              </a:defRPr>
+            </a:pPr>
+            <a:r>
+              <a:rPr sz="1725" b="1">
+                <a:solidFill>
+                  <a:srgbClr val="C65D3A"/>
+                </a:solidFill>
+                <a:latin typeface="Arial"/>
+                <a:ea typeface="Arial"/>
+                <a:cs typeface="Arial"/>
+              </a:rPr>
+              <a:t>As suítes se sobrepõem. Não somar as contagens. p95 histórico de 20/10.</a:t>
             </a:r>
           </a:p>
         </p:txBody>
@@ -19482,7 +19767,7 @@
     </p:spTree>
     <p:extLst>
       <p:ext uri="{BB962C8B-B14F-4D97-AF65-F5344CB8AC3E}">
-        <p14:creationId xmlns:p14="http://schemas.microsoft.com/office/powerpoint/2010/main" val="672559567"/>
+        <p14:creationId xmlns:p14="http://schemas.microsoft.com/office/powerpoint/2010/main" val="1472350016"/>
       </p:ext>
     </p:extLst>
   </p:cSld>
@@ -19513,7 +19798,7 @@
           <p:cNvPr id="9" name="">
             <a:extLst xmlns:a="http://schemas.openxmlformats.org/drawingml/2006/main">
               <a:ext uri="{FF2B5EF4-FFF2-40B4-BE49-F238E27FC236}">
-                <a16:creationId xmlns:a16="http://schemas.microsoft.com/office/drawing/2014/main" id="{38A59B64-499B-47A0-83BD-5292DB25EA45}"/>
+                <a16:creationId xmlns:a16="http://schemas.microsoft.com/office/drawing/2014/main" id="{CF2092BF-7F5C-4EB3-A6CB-C54E9500F867}"/>
               </a:ext>
             </a:extLst>
           </p:cNvPr>
@@ -19543,7 +19828,7 @@
           <p:cNvPr id="2" name="">
             <a:extLst xmlns:a="http://schemas.openxmlformats.org/drawingml/2006/main">
               <a:ext uri="{FF2B5EF4-FFF2-40B4-BE49-F238E27FC236}">
-                <a16:creationId xmlns:a16="http://schemas.microsoft.com/office/drawing/2014/main" id="{7283F30C-44DB-4690-AE4C-FA950D9F7CBF}"/>
+                <a16:creationId xmlns:a16="http://schemas.microsoft.com/office/drawing/2014/main" id="{9CAC1357-2E17-4B9C-98F1-8509340D4DCB}"/>
               </a:ext>
             </a:extLst>
           </p:cNvPr>
@@ -19691,7 +19976,7 @@
                 <a:ea typeface="Arial"/>
                 <a:cs typeface="Arial"/>
               </a:rPr>
-              <a:t>Conclusões e próximos passos</a:t>
+              <a:t>Conclusões e marcos da entrega</a:t>
             </a:r>
           </a:p>
         </p:txBody>
@@ -19701,7 +19986,7 @@
           <p:cNvPr id="3" name="">
             <a:extLst xmlns:a="http://schemas.openxmlformats.org/drawingml/2006/main">
               <a:ext uri="{FF2B5EF4-FFF2-40B4-BE49-F238E27FC236}">
-                <a16:creationId xmlns:a16="http://schemas.microsoft.com/office/drawing/2014/main" id="{E68CA92A-ED5C-44F2-9CB5-6D153DA17F2C}"/>
+                <a16:creationId xmlns:a16="http://schemas.microsoft.com/office/drawing/2014/main" id="{D62E6A57-4F2E-413D-973A-1B59182B0E36}"/>
               </a:ext>
             </a:extLst>
           </p:cNvPr>
@@ -19849,7 +20134,7 @@
                 <a:ea typeface="Arial"/>
                 <a:cs typeface="Arial"/>
               </a:rPr>
-              <a:t>Projeto Aplicado Cenário 4</a:t>
+              <a:t>Projeto Aplicado Cenário 4  ·  Versão 28/10/2026</a:t>
             </a:r>
           </a:p>
         </p:txBody>
@@ -19859,7 +20144,7 @@
           <p:cNvPr id="4" name="">
             <a:extLst xmlns:a="http://schemas.openxmlformats.org/drawingml/2006/main">
               <a:ext uri="{FF2B5EF4-FFF2-40B4-BE49-F238E27FC236}">
-                <a16:creationId xmlns:a16="http://schemas.microsoft.com/office/drawing/2014/main" id="{C603A488-C1D3-4FA1-9761-D940F3878A17}"/>
+                <a16:creationId xmlns:a16="http://schemas.microsoft.com/office/drawing/2014/main" id="{B86D6615-E61F-4043-ACD3-074A7E299C2D}"/>
               </a:ext>
             </a:extLst>
           </p:cNvPr>
@@ -20017,7 +20302,7 @@
           <p:cNvPr id="5" name="">
             <a:extLst xmlns:a="http://schemas.openxmlformats.org/drawingml/2006/main">
               <a:ext uri="{FF2B5EF4-FFF2-40B4-BE49-F238E27FC236}">
-                <a16:creationId xmlns:a16="http://schemas.microsoft.com/office/drawing/2014/main" id="{78515946-BA38-4725-96CC-E112DBC50AF5}"/>
+                <a16:creationId xmlns:a16="http://schemas.microsoft.com/office/drawing/2014/main" id="{70064C00-D92A-4F6E-B267-CBC13773D03A}"/>
               </a:ext>
             </a:extLst>
           </p:cNvPr>
@@ -20029,7 +20314,7 @@
         <p:spPr>
           <a:xfrm xmlns:a="http://schemas.openxmlformats.org/drawingml/2006/main">
             <a:off x="809625" y="2047875"/>
-            <a:ext cx="4953000" cy="2428875"/>
+            <a:ext cx="4953000" cy="2571750"/>
           </a:xfrm>
           <a:prstGeom xmlns:a="http://schemas.openxmlformats.org/drawingml/2006/main" prst="rect">
             <a:avLst/>
@@ -20169,7 +20454,7 @@
                 <a:ea typeface="Arial"/>
                 <a:cs typeface="Arial"/>
               </a:rPr>
-              <a:t>A arquitetura integrou os três fluxos obrigatórios</a:t>
+              <a:t>Os três fluxos têm evidências no protótipo acadêmico</a:t>
             </a:r>
           </a:p>
           <a:p xmlns:a="http://schemas.openxmlformats.org/drawingml/2006/main">
@@ -20196,7 +20481,7 @@
                 <a:ea typeface="Arial"/>
                 <a:cs typeface="Arial"/>
               </a:rPr>
-              <a:t>Reservas e contratos e fronteiras permitem evolução incremental</a:t>
+              <a:t>Contratos e fronteiras permitem evolução incremental</a:t>
             </a:r>
           </a:p>
           <a:p xmlns:a="http://schemas.openxmlformats.org/drawingml/2006/main">
@@ -20223,7 +20508,7 @@
                 <a:ea typeface="Arial"/>
                 <a:cs typeface="Arial"/>
               </a:rPr>
-              <a:t>Outbox, inbox e correlação tornam falhas recuperáveis</a:t>
+              <a:t>Testes aprovados não garantem convergência em todos os casos</a:t>
             </a:r>
           </a:p>
         </p:txBody>
@@ -20233,7 +20518,7 @@
           <p:cNvPr id="6" name="">
             <a:extLst xmlns:a="http://schemas.openxmlformats.org/drawingml/2006/main">
               <a:ext uri="{FF2B5EF4-FFF2-40B4-BE49-F238E27FC236}">
-                <a16:creationId xmlns:a16="http://schemas.microsoft.com/office/drawing/2014/main" id="{AC1AC050-8E27-4800-9006-D5ABCB9F9E06}"/>
+                <a16:creationId xmlns:a16="http://schemas.microsoft.com/office/drawing/2014/main" id="{3385B796-BD95-4023-8DB6-C1B76F8EF958}"/>
               </a:ext>
             </a:extLst>
           </p:cNvPr>
@@ -20391,7 +20676,7 @@
           <p:cNvPr id="7" name="">
             <a:extLst xmlns:a="http://schemas.openxmlformats.org/drawingml/2006/main">
               <a:ext uri="{FF2B5EF4-FFF2-40B4-BE49-F238E27FC236}">
-                <a16:creationId xmlns:a16="http://schemas.microsoft.com/office/drawing/2014/main" id="{5AB21D06-8B51-41EE-B4FD-F2DE7C8C8D79}"/>
+                <a16:creationId xmlns:a16="http://schemas.microsoft.com/office/drawing/2014/main" id="{6133BBD3-E51D-4D0A-9296-0FB6F0DD9D00}"/>
               </a:ext>
             </a:extLst>
           </p:cNvPr>
@@ -20402,8 +20687,8 @@
         </p:nvSpPr>
         <p:spPr>
           <a:xfrm xmlns:a="http://schemas.openxmlformats.org/drawingml/2006/main">
-            <a:off x="6619875" y="2047875"/>
-            <a:ext cx="4762500" cy="2428875"/>
+            <a:off x="6619875" y="1952625"/>
+            <a:ext cx="4762500" cy="2952750"/>
           </a:xfrm>
           <a:prstGeom xmlns:a="http://schemas.openxmlformats.org/drawingml/2006/main" prst="rect">
             <a:avLst/>
@@ -20419,7 +20704,7 @@
           </a:bodyPr>
           <a:lstStyle xmlns:a="http://schemas.openxmlformats.org/drawingml/2006/main">
             <a:defPPr>
-              <a:defRPr sz="1800">
+              <a:defRPr sz="1725">
                 <a:solidFill>
                   <a:srgbClr val="17212B"/>
                 </a:solidFill>
@@ -20429,7 +20714,7 @@
               </a:defRPr>
             </a:defPPr>
             <a:lvl1pPr>
-              <a:defRPr sz="1800">
+              <a:defRPr sz="1725">
                 <a:solidFill>
                   <a:srgbClr val="17212B"/>
                 </a:solidFill>
@@ -20439,7 +20724,7 @@
               </a:defRPr>
             </a:lvl1pPr>
             <a:lvl2pPr>
-              <a:defRPr sz="1800">
+              <a:defRPr sz="1725">
                 <a:solidFill>
                   <a:srgbClr val="17212B"/>
                 </a:solidFill>
@@ -20449,7 +20734,7 @@
               </a:defRPr>
             </a:lvl2pPr>
             <a:lvl3pPr>
-              <a:defRPr sz="1800">
+              <a:defRPr sz="1725">
                 <a:solidFill>
                   <a:srgbClr val="17212B"/>
                 </a:solidFill>
@@ -20459,7 +20744,7 @@
               </a:defRPr>
             </a:lvl3pPr>
             <a:lvl4pPr>
-              <a:defRPr sz="1800">
+              <a:defRPr sz="1725">
                 <a:solidFill>
                   <a:srgbClr val="17212B"/>
                 </a:solidFill>
@@ -20469,7 +20754,7 @@
               </a:defRPr>
             </a:lvl4pPr>
             <a:lvl5pPr>
-              <a:defRPr sz="1800">
+              <a:defRPr sz="1725">
                 <a:solidFill>
                   <a:srgbClr val="17212B"/>
                 </a:solidFill>
@@ -20479,7 +20764,7 @@
               </a:defRPr>
             </a:lvl5pPr>
             <a:lvl6pPr>
-              <a:defRPr sz="1800">
+              <a:defRPr sz="1725">
                 <a:solidFill>
                   <a:srgbClr val="17212B"/>
                 </a:solidFill>
@@ -20489,7 +20774,7 @@
               </a:defRPr>
             </a:lvl6pPr>
             <a:lvl7pPr>
-              <a:defRPr sz="1800">
+              <a:defRPr sz="1725">
                 <a:solidFill>
                   <a:srgbClr val="17212B"/>
                 </a:solidFill>
@@ -20499,7 +20784,7 @@
               </a:defRPr>
             </a:lvl7pPr>
             <a:lvl8pPr>
-              <a:defRPr sz="1800">
+              <a:defRPr sz="1725">
                 <a:solidFill>
                   <a:srgbClr val="17212B"/>
                 </a:solidFill>
@@ -20509,7 +20794,7 @@
               </a:defRPr>
             </a:lvl8pPr>
             <a:lvl9pPr>
-              <a:defRPr sz="1800">
+              <a:defRPr sz="1725">
                 <a:solidFill>
                   <a:srgbClr val="17212B"/>
                 </a:solidFill>
@@ -20525,7 +20810,7 @@
                 <a:spcPts val="1000"/>
               </a:spcAft>
               <a:buChar char="•"/>
-              <a:defRPr sz="1800">
+              <a:defRPr sz="1725">
                 <a:solidFill>
                   <a:srgbClr val="17212B"/>
                 </a:solidFill>
@@ -20535,7 +20820,7 @@
               </a:defRPr>
             </a:pPr>
             <a:r>
-              <a:rPr sz="1800">
+              <a:rPr sz="1725">
                 <a:solidFill>
                   <a:srgbClr val="17212B"/>
                 </a:solidFill>
@@ -20543,7 +20828,7 @@
                 <a:ea typeface="Arial"/>
                 <a:cs typeface="Arial"/>
               </a:rPr>
-              <a:t>Validar premissas e interfaces do AS IS</a:t>
+              <a:t>F3 pode permanecer STARTED após resolução</a:t>
             </a:r>
           </a:p>
           <a:p xmlns:a="http://schemas.openxmlformats.org/drawingml/2006/main">
@@ -20552,7 +20837,7 @@
                 <a:spcPts val="1000"/>
               </a:spcAft>
               <a:buChar char="•"/>
-              <a:defRPr sz="1800">
+              <a:defRPr sz="1725">
                 <a:solidFill>
                   <a:srgbClr val="17212B"/>
                 </a:solidFill>
@@ -20562,7 +20847,7 @@
               </a:defRPr>
             </a:pPr>
             <a:r>
-              <a:rPr sz="1800">
+              <a:rPr sz="1725">
                 <a:solidFill>
                   <a:srgbClr val="17212B"/>
                 </a:solidFill>
@@ -20570,7 +20855,7 @@
                 <a:ea typeface="Arial"/>
                 <a:cs typeface="Arial"/>
               </a:rPr>
-              <a:t>Publicar e testar a demo gratuita com dados sintéticos</a:t>
+              <a:t>Processo COMPLETED pode ter tarefa CANCELLED</a:t>
             </a:r>
           </a:p>
           <a:p xmlns:a="http://schemas.openxmlformats.org/drawingml/2006/main">
@@ -20579,7 +20864,7 @@
                 <a:spcPts val="1000"/>
               </a:spcAft>
               <a:buChar char="•"/>
-              <a:defRPr sz="1800">
+              <a:defRPr sz="1725">
                 <a:solidFill>
                   <a:srgbClr val="17212B"/>
                 </a:solidFill>
@@ -20589,7 +20874,7 @@
               </a:defRPr>
             </a:pPr>
             <a:r>
-              <a:rPr sz="1800">
+              <a:rPr sz="1725">
                 <a:solidFill>
                   <a:srgbClr val="17212B"/>
                 </a:solidFill>
@@ -20597,7 +20882,34 @@
                 <a:ea typeface="Arial"/>
                 <a:cs typeface="Arial"/>
               </a:rPr>
-              <a:t>Adicionar identidade individual e agendador de vencimentos</a:t>
+              <a:t>Fatura exibida OVERDUE pode ser cancelada</a:t>
+            </a:r>
+          </a:p>
+          <a:p xmlns:a="http://schemas.openxmlformats.org/drawingml/2006/main">
+            <a:pPr marL="254000" indent="-127000">
+              <a:spcAft>
+                <a:spcPts val="1000"/>
+              </a:spcAft>
+              <a:buChar char="•"/>
+              <a:defRPr sz="1725">
+                <a:solidFill>
+                  <a:srgbClr val="17212B"/>
+                </a:solidFill>
+                <a:latin typeface="Arial"/>
+                <a:ea typeface="Arial"/>
+                <a:cs typeface="Arial"/>
+              </a:defRPr>
+            </a:pPr>
+            <a:r>
+              <a:rPr sz="1725">
+                <a:solidFill>
+                  <a:srgbClr val="17212B"/>
+                </a:solidFill>
+                <a:latin typeface="Arial"/>
+                <a:ea typeface="Arial"/>
+                <a:cs typeface="Arial"/>
+              </a:rPr>
+              <a:t>Nomes e contribuições individuais pendentes</a:t>
             </a:r>
           </a:p>
         </p:txBody>
@@ -20607,7 +20919,7 @@
           <p:cNvPr id="8" name="">
             <a:extLst xmlns:a="http://schemas.openxmlformats.org/drawingml/2006/main">
               <a:ext uri="{FF2B5EF4-FFF2-40B4-BE49-F238E27FC236}">
-                <a16:creationId xmlns:a16="http://schemas.microsoft.com/office/drawing/2014/main" id="{20327035-BD1B-4456-B7EF-80AC1E387450}"/>
+                <a16:creationId xmlns:a16="http://schemas.microsoft.com/office/drawing/2014/main" id="{15A0E840-E4C6-48A6-BC48-5C42CCB5A79F}"/>
               </a:ext>
             </a:extLst>
           </p:cNvPr>
@@ -20618,8 +20930,8 @@
         </p:nvSpPr>
         <p:spPr>
           <a:xfrm xmlns:a="http://schemas.openxmlformats.org/drawingml/2006/main">
-            <a:off x="1571625" y="5191125"/>
-            <a:ext cx="9048750" cy="590550"/>
+            <a:off x="1571625" y="5143500"/>
+            <a:ext cx="9048750" cy="781050"/>
           </a:xfrm>
           <a:prstGeom xmlns:a="http://schemas.openxmlformats.org/drawingml/2006/main" prst="rect">
             <a:avLst/>
@@ -20635,7 +20947,7 @@
           </a:bodyPr>
           <a:lstStyle xmlns:a="http://schemas.openxmlformats.org/drawingml/2006/main">
             <a:defPPr>
-              <a:defRPr sz="1875" b="1">
+              <a:defRPr sz="2025" b="1">
                 <a:solidFill>
                   <a:srgbClr val="C65D3A"/>
                 </a:solidFill>
@@ -20645,7 +20957,7 @@
               </a:defRPr>
             </a:defPPr>
             <a:lvl1pPr>
-              <a:defRPr sz="1875" b="1">
+              <a:defRPr sz="2025" b="1">
                 <a:solidFill>
                   <a:srgbClr val="C65D3A"/>
                 </a:solidFill>
@@ -20655,7 +20967,7 @@
               </a:defRPr>
             </a:lvl1pPr>
             <a:lvl2pPr>
-              <a:defRPr sz="1875" b="1">
+              <a:defRPr sz="2025" b="1">
                 <a:solidFill>
                   <a:srgbClr val="C65D3A"/>
                 </a:solidFill>
@@ -20665,7 +20977,7 @@
               </a:defRPr>
             </a:lvl2pPr>
             <a:lvl3pPr>
-              <a:defRPr sz="1875" b="1">
+              <a:defRPr sz="2025" b="1">
                 <a:solidFill>
                   <a:srgbClr val="C65D3A"/>
                 </a:solidFill>
@@ -20675,7 +20987,7 @@
               </a:defRPr>
             </a:lvl3pPr>
             <a:lvl4pPr>
-              <a:defRPr sz="1875" b="1">
+              <a:defRPr sz="2025" b="1">
                 <a:solidFill>
                   <a:srgbClr val="C65D3A"/>
                 </a:solidFill>
@@ -20685,7 +20997,7 @@
               </a:defRPr>
             </a:lvl4pPr>
             <a:lvl5pPr>
-              <a:defRPr sz="1875" b="1">
+              <a:defRPr sz="2025" b="1">
                 <a:solidFill>
                   <a:srgbClr val="C65D3A"/>
                 </a:solidFill>
@@ -20695,7 +21007,7 @@
               </a:defRPr>
             </a:lvl5pPr>
             <a:lvl6pPr>
-              <a:defRPr sz="1875" b="1">
+              <a:defRPr sz="2025" b="1">
                 <a:solidFill>
                   <a:srgbClr val="C65D3A"/>
                 </a:solidFill>
@@ -20705,7 +21017,7 @@
               </a:defRPr>
             </a:lvl6pPr>
             <a:lvl7pPr>
-              <a:defRPr sz="1875" b="1">
+              <a:defRPr sz="2025" b="1">
                 <a:solidFill>
                   <a:srgbClr val="C65D3A"/>
                 </a:solidFill>
@@ -20715,7 +21027,7 @@
               </a:defRPr>
             </a:lvl7pPr>
             <a:lvl8pPr>
-              <a:defRPr sz="1875" b="1">
+              <a:defRPr sz="2025" b="1">
                 <a:solidFill>
                   <a:srgbClr val="C65D3A"/>
                 </a:solidFill>
@@ -20725,7 +21037,7 @@
               </a:defRPr>
             </a:lvl8pPr>
             <a:lvl9pPr>
-              <a:defRPr sz="1875" b="1">
+              <a:defRPr sz="2025" b="1">
                 <a:solidFill>
                   <a:srgbClr val="C65D3A"/>
                 </a:solidFill>
@@ -20737,7 +21049,7 @@
           </a:lstStyle>
           <a:p xmlns:a="http://schemas.openxmlformats.org/drawingml/2006/main">
             <a:pPr>
-              <a:defRPr sz="1875" b="1">
+              <a:defRPr sz="2025" b="1">
                 <a:solidFill>
                   <a:srgbClr val="C65D3A"/>
                 </a:solidFill>
@@ -20747,7 +21059,7 @@
               </a:defRPr>
             </a:pPr>
             <a:r>
-              <a:rPr sz="1875" b="1">
+              <a:rPr sz="2025" b="1">
                 <a:solidFill>
                   <a:srgbClr val="C65D3A"/>
                 </a:solidFill>
@@ -20755,7 +21067,30 @@
                 <a:ea typeface="Arial"/>
                 <a:cs typeface="Arial"/>
               </a:rPr>
-              <a:t>Próxima ação: validar a solução com dados, volumes e responsáveis reais</a:t>
+              <a:t>Entrega pronta prevista para 09/11/2026</a:t>
+            </a:r>
+          </a:p>
+          <a:p xmlns:a="http://schemas.openxmlformats.org/drawingml/2006/main">
+            <a:pPr>
+              <a:defRPr sz="2025" b="1">
+                <a:solidFill>
+                  <a:srgbClr val="C65D3A"/>
+                </a:solidFill>
+                <a:latin typeface="Arial"/>
+                <a:ea typeface="Arial"/>
+                <a:cs typeface="Arial"/>
+              </a:defRPr>
+            </a:pPr>
+            <a:r>
+              <a:rPr sz="2025" b="1">
+                <a:solidFill>
+                  <a:srgbClr val="C65D3A"/>
+                </a:solidFill>
+                <a:latin typeface="Arial"/>
+                <a:ea typeface="Arial"/>
+                <a:cs typeface="Arial"/>
+              </a:rPr>
+              <a:t>Apresentação prevista para 23/11/2026</a:t>
             </a:r>
           </a:p>
         </p:txBody>
@@ -20763,7 +21098,7 @@
     </p:spTree>
     <p:extLst>
       <p:ext uri="{BB962C8B-B14F-4D97-AF65-F5344CB8AC3E}">
-        <p14:creationId xmlns:p14="http://schemas.microsoft.com/office/powerpoint/2010/main" val="1024749011"/>
+        <p14:creationId xmlns:p14="http://schemas.microsoft.com/office/powerpoint/2010/main" val="517809180"/>
       </p:ext>
     </p:extLst>
   </p:cSld>
@@ -20794,7 +21129,7 @@
           <p:cNvPr id="10" name="">
             <a:extLst xmlns:a="http://schemas.openxmlformats.org/drawingml/2006/main">
               <a:ext uri="{FF2B5EF4-FFF2-40B4-BE49-F238E27FC236}">
-                <a16:creationId xmlns:a16="http://schemas.microsoft.com/office/drawing/2014/main" id="{46692518-B5B4-4220-8D54-E8B495E6F4D9}"/>
+                <a16:creationId xmlns:a16="http://schemas.microsoft.com/office/drawing/2014/main" id="{E0335C8B-E43F-4222-8607-B6FC71731678}"/>
               </a:ext>
             </a:extLst>
           </p:cNvPr>
@@ -20824,7 +21159,7 @@
           <p:cNvPr id="2" name="">
             <a:extLst xmlns:a="http://schemas.openxmlformats.org/drawingml/2006/main">
               <a:ext uri="{FF2B5EF4-FFF2-40B4-BE49-F238E27FC236}">
-                <a16:creationId xmlns:a16="http://schemas.microsoft.com/office/drawing/2014/main" id="{51F981FB-6EB4-4E3C-9DD6-4C5D714CAD23}"/>
+                <a16:creationId xmlns:a16="http://schemas.microsoft.com/office/drawing/2014/main" id="{C5EBA234-595C-4C62-9105-C2D34E56C00D}"/>
               </a:ext>
             </a:extLst>
           </p:cNvPr>
@@ -20982,7 +21317,7 @@
           <p:cNvPr id="3" name="">
             <a:extLst xmlns:a="http://schemas.openxmlformats.org/drawingml/2006/main">
               <a:ext uri="{FF2B5EF4-FFF2-40B4-BE49-F238E27FC236}">
-                <a16:creationId xmlns:a16="http://schemas.microsoft.com/office/drawing/2014/main" id="{78B910B8-8614-4F73-AC24-71C73928F4B7}"/>
+                <a16:creationId xmlns:a16="http://schemas.microsoft.com/office/drawing/2014/main" id="{237B0CFB-0788-4324-9A8E-0C06F85229D8}"/>
               </a:ext>
             </a:extLst>
           </p:cNvPr>
@@ -21130,7 +21465,7 @@
                 <a:ea typeface="Arial"/>
                 <a:cs typeface="Arial"/>
               </a:rPr>
-              <a:t>Projeto Aplicado Cenário 4</a:t>
+              <a:t>Projeto Aplicado Cenário 4  ·  Versão 28/10/2026</a:t>
             </a:r>
           </a:p>
         </p:txBody>
@@ -21140,7 +21475,7 @@
           <p:cNvPr id="4" name="">
             <a:extLst xmlns:a="http://schemas.openxmlformats.org/drawingml/2006/main">
               <a:ext uri="{FF2B5EF4-FFF2-40B4-BE49-F238E27FC236}">
-                <a16:creationId xmlns:a16="http://schemas.microsoft.com/office/drawing/2014/main" id="{C05E4B4B-4F87-40DB-98D6-155A662AE9EA}"/>
+                <a16:creationId xmlns:a16="http://schemas.microsoft.com/office/drawing/2014/main" id="{CBD8D149-7B95-4B7F-9D93-C2BAB1795A67}"/>
               </a:ext>
             </a:extLst>
           </p:cNvPr>
@@ -21383,7 +21718,7 @@
           <p:cNvPr id="5" name="">
             <a:extLst xmlns:a="http://schemas.openxmlformats.org/drawingml/2006/main">
               <a:ext uri="{FF2B5EF4-FFF2-40B4-BE49-F238E27FC236}">
-                <a16:creationId xmlns:a16="http://schemas.microsoft.com/office/drawing/2014/main" id="{38E7450E-FF81-42FE-A3A6-535B3C05B711}"/>
+                <a16:creationId xmlns:a16="http://schemas.microsoft.com/office/drawing/2014/main" id="{3AD8A57F-039E-4B1F-8F5C-94452F937C79}"/>
               </a:ext>
             </a:extLst>
           </p:cNvPr>
@@ -21548,7 +21883,7 @@
           <p:cNvPr id="6" name="">
             <a:extLst xmlns:a="http://schemas.openxmlformats.org/drawingml/2006/main">
               <a:ext uri="{FF2B5EF4-FFF2-40B4-BE49-F238E27FC236}">
-                <a16:creationId xmlns:a16="http://schemas.microsoft.com/office/drawing/2014/main" id="{19800428-4C36-4F79-9857-4EB799562F0A}"/>
+                <a16:creationId xmlns:a16="http://schemas.microsoft.com/office/drawing/2014/main" id="{B3691AFD-7A20-48DE-A2C0-C9B2AAC6B88E}"/>
               </a:ext>
             </a:extLst>
           </p:cNvPr>
@@ -21713,7 +22048,7 @@
           <p:cNvPr id="7" name="">
             <a:extLst xmlns:a="http://schemas.openxmlformats.org/drawingml/2006/main">
               <a:ext uri="{FF2B5EF4-FFF2-40B4-BE49-F238E27FC236}">
-                <a16:creationId xmlns:a16="http://schemas.microsoft.com/office/drawing/2014/main" id="{16CC61DA-5A80-4951-8F7E-557566394142}"/>
+                <a16:creationId xmlns:a16="http://schemas.microsoft.com/office/drawing/2014/main" id="{DB38D867-BDD1-40A3-92D2-BB67F4BC18B5}"/>
               </a:ext>
             </a:extLst>
           </p:cNvPr>
@@ -21878,7 +22213,7 @@
           <p:cNvPr id="8" name="">
             <a:extLst xmlns:a="http://schemas.openxmlformats.org/drawingml/2006/main">
               <a:ext uri="{FF2B5EF4-FFF2-40B4-BE49-F238E27FC236}">
-                <a16:creationId xmlns:a16="http://schemas.microsoft.com/office/drawing/2014/main" id="{306576D9-B00D-4467-A0EB-1D37731ECABF}"/>
+                <a16:creationId xmlns:a16="http://schemas.microsoft.com/office/drawing/2014/main" id="{7F72EE14-BE14-459F-9105-FEDDA616AA61}"/>
               </a:ext>
             </a:extLst>
           </p:cNvPr>
@@ -22043,7 +22378,7 @@
           <p:cNvPr id="9" name="">
             <a:extLst xmlns:a="http://schemas.openxmlformats.org/drawingml/2006/main">
               <a:ext uri="{FF2B5EF4-FFF2-40B4-BE49-F238E27FC236}">
-                <a16:creationId xmlns:a16="http://schemas.microsoft.com/office/drawing/2014/main" id="{A6E3A105-7687-43DE-B6BA-7967A6C1C2B1}"/>
+                <a16:creationId xmlns:a16="http://schemas.microsoft.com/office/drawing/2014/main" id="{FC3228AD-4249-46D3-876B-907D36D323CD}"/>
               </a:ext>
             </a:extLst>
           </p:cNvPr>
@@ -22206,7 +22541,7 @@
     </p:spTree>
     <p:extLst>
       <p:ext uri="{BB962C8B-B14F-4D97-AF65-F5344CB8AC3E}">
-        <p14:creationId xmlns:p14="http://schemas.microsoft.com/office/powerpoint/2010/main" val="2033026072"/>
+        <p14:creationId xmlns:p14="http://schemas.microsoft.com/office/powerpoint/2010/main" val="1337664166"/>
       </p:ext>
     </p:extLst>
   </p:cSld>
@@ -22237,7 +22572,7 @@
           <p:cNvPr id="7" name="">
             <a:extLst xmlns:a="http://schemas.openxmlformats.org/drawingml/2006/main">
               <a:ext uri="{FF2B5EF4-FFF2-40B4-BE49-F238E27FC236}">
-                <a16:creationId xmlns:a16="http://schemas.microsoft.com/office/drawing/2014/main" id="{F3D886F3-4BA7-4B99-8306-A1367FA148F9}"/>
+                <a16:creationId xmlns:a16="http://schemas.microsoft.com/office/drawing/2014/main" id="{97EA82A6-C1DB-4580-B3C3-DEB9ECEF3B19}"/>
               </a:ext>
             </a:extLst>
           </p:cNvPr>
@@ -22267,7 +22602,7 @@
           <p:cNvPr id="2" name="">
             <a:extLst xmlns:a="http://schemas.openxmlformats.org/drawingml/2006/main">
               <a:ext uri="{FF2B5EF4-FFF2-40B4-BE49-F238E27FC236}">
-                <a16:creationId xmlns:a16="http://schemas.microsoft.com/office/drawing/2014/main" id="{8C2F060B-CD0F-411F-AA9F-D60C2AE08399}"/>
+                <a16:creationId xmlns:a16="http://schemas.microsoft.com/office/drawing/2014/main" id="{F0414E2E-8BD6-45BC-8A82-AFF47486FD88}"/>
               </a:ext>
             </a:extLst>
           </p:cNvPr>
@@ -22425,7 +22760,7 @@
           <p:cNvPr id="3" name="">
             <a:extLst xmlns:a="http://schemas.openxmlformats.org/drawingml/2006/main">
               <a:ext uri="{FF2B5EF4-FFF2-40B4-BE49-F238E27FC236}">
-                <a16:creationId xmlns:a16="http://schemas.microsoft.com/office/drawing/2014/main" id="{54FF6899-0F91-4AD4-B2A2-B35AF5CD7E9C}"/>
+                <a16:creationId xmlns:a16="http://schemas.microsoft.com/office/drawing/2014/main" id="{B420374A-252C-4EF7-87E4-71DB9AB896C8}"/>
               </a:ext>
             </a:extLst>
           </p:cNvPr>
@@ -22573,7 +22908,7 @@
                 <a:ea typeface="Arial"/>
                 <a:cs typeface="Arial"/>
               </a:rPr>
-              <a:t>Projeto Aplicado Cenário 4</a:t>
+              <a:t>Projeto Aplicado Cenário 4  ·  Versão 28/10/2026</a:t>
             </a:r>
           </a:p>
         </p:txBody>
@@ -22583,7 +22918,7 @@
           <p:cNvPr id="4" name="">
             <a:extLst xmlns:a="http://schemas.openxmlformats.org/drawingml/2006/main">
               <a:ext uri="{FF2B5EF4-FFF2-40B4-BE49-F238E27FC236}">
-                <a16:creationId xmlns:a16="http://schemas.microsoft.com/office/drawing/2014/main" id="{32FE8014-FDBF-4A2A-AF4C-AF2BE1746740}"/>
+                <a16:creationId xmlns:a16="http://schemas.microsoft.com/office/drawing/2014/main" id="{AF232A1D-FF4C-4CA8-8D80-1CA9A92C296B}"/>
               </a:ext>
             </a:extLst>
           </p:cNvPr>
@@ -22741,7 +23076,7 @@
           <p:cNvPr id="5" name="">
             <a:extLst xmlns:a="http://schemas.openxmlformats.org/drawingml/2006/main">
               <a:ext uri="{FF2B5EF4-FFF2-40B4-BE49-F238E27FC236}">
-                <a16:creationId xmlns:a16="http://schemas.microsoft.com/office/drawing/2014/main" id="{0552E73D-8D88-4F19-BE3A-E3C453C8D840}"/>
+                <a16:creationId xmlns:a16="http://schemas.microsoft.com/office/drawing/2014/main" id="{C8E56E33-948A-4F71-8B17-343D6C500A58}"/>
               </a:ext>
             </a:extLst>
           </p:cNvPr>
@@ -22751,7 +23086,7 @@
           <p:nvPr/>
         </p:nvPicPr>
         <p:blipFill>
-          <a:blip xmlns:r="http://schemas.openxmlformats.org/officeDocument/2006/relationships" xmlns:a="http://schemas.openxmlformats.org/drawingml/2006/main" r:embed="R5f24c57f261a4ae6"/>
+          <a:blip xmlns:r="http://schemas.openxmlformats.org/officeDocument/2006/relationships" xmlns:a="http://schemas.openxmlformats.org/drawingml/2006/main" r:embed="R442d3fdbdb804d02"/>
           <a:stretch xmlns:a="http://schemas.openxmlformats.org/drawingml/2006/main"/>
         </p:blipFill>
         <p:spPr>
@@ -22769,7 +23104,7 @@
           <p:cNvPr id="6" name="">
             <a:extLst xmlns:a="http://schemas.openxmlformats.org/drawingml/2006/main">
               <a:ext uri="{FF2B5EF4-FFF2-40B4-BE49-F238E27FC236}">
-                <a16:creationId xmlns:a16="http://schemas.microsoft.com/office/drawing/2014/main" id="{49ACA00B-B42E-47AE-AA44-8A6F6A234C73}"/>
+                <a16:creationId xmlns:a16="http://schemas.microsoft.com/office/drawing/2014/main" id="{F79936A9-56F9-4FD1-8DFA-DF65F8218652}"/>
               </a:ext>
             </a:extLst>
           </p:cNvPr>
@@ -22925,7 +23260,7 @@
     </p:spTree>
     <p:extLst>
       <p:ext uri="{BB962C8B-B14F-4D97-AF65-F5344CB8AC3E}">
-        <p14:creationId xmlns:p14="http://schemas.microsoft.com/office/powerpoint/2010/main" val="1279118972"/>
+        <p14:creationId xmlns:p14="http://schemas.microsoft.com/office/powerpoint/2010/main" val="398864758"/>
       </p:ext>
     </p:extLst>
   </p:cSld>
@@ -22956,7 +23291,7 @@
           <p:cNvPr id="7" name="">
             <a:extLst xmlns:a="http://schemas.openxmlformats.org/drawingml/2006/main">
               <a:ext uri="{FF2B5EF4-FFF2-40B4-BE49-F238E27FC236}">
-                <a16:creationId xmlns:a16="http://schemas.microsoft.com/office/drawing/2014/main" id="{3FEE1E41-F07A-4D9F-B55E-BF58F10416CD}"/>
+                <a16:creationId xmlns:a16="http://schemas.microsoft.com/office/drawing/2014/main" id="{886102EE-96FA-47D9-BF09-9BD7449EDD21}"/>
               </a:ext>
             </a:extLst>
           </p:cNvPr>
@@ -22986,7 +23321,7 @@
           <p:cNvPr id="2" name="">
             <a:extLst xmlns:a="http://schemas.openxmlformats.org/drawingml/2006/main">
               <a:ext uri="{FF2B5EF4-FFF2-40B4-BE49-F238E27FC236}">
-                <a16:creationId xmlns:a16="http://schemas.microsoft.com/office/drawing/2014/main" id="{72D80791-2564-48BA-AC77-9231AAAEED6E}"/>
+                <a16:creationId xmlns:a16="http://schemas.microsoft.com/office/drawing/2014/main" id="{11F66293-8AC4-47BB-8278-AC6C4A3B8603}"/>
               </a:ext>
             </a:extLst>
           </p:cNvPr>
@@ -23144,7 +23479,7 @@
           <p:cNvPr id="3" name="">
             <a:extLst xmlns:a="http://schemas.openxmlformats.org/drawingml/2006/main">
               <a:ext uri="{FF2B5EF4-FFF2-40B4-BE49-F238E27FC236}">
-                <a16:creationId xmlns:a16="http://schemas.microsoft.com/office/drawing/2014/main" id="{03F54981-5AD1-436F-8B3D-40FBFFABC384}"/>
+                <a16:creationId xmlns:a16="http://schemas.microsoft.com/office/drawing/2014/main" id="{1D65ABC2-F1CF-4333-9E0F-4525A0C298E5}"/>
               </a:ext>
             </a:extLst>
           </p:cNvPr>
@@ -23292,7 +23627,7 @@
                 <a:ea typeface="Arial"/>
                 <a:cs typeface="Arial"/>
               </a:rPr>
-              <a:t>Projeto Aplicado Cenário 4</a:t>
+              <a:t>Projeto Aplicado Cenário 4  ·  Versão 28/10/2026</a:t>
             </a:r>
           </a:p>
         </p:txBody>
@@ -23302,7 +23637,7 @@
           <p:cNvPr id="4" name="">
             <a:extLst xmlns:a="http://schemas.openxmlformats.org/drawingml/2006/main">
               <a:ext uri="{FF2B5EF4-FFF2-40B4-BE49-F238E27FC236}">
-                <a16:creationId xmlns:a16="http://schemas.microsoft.com/office/drawing/2014/main" id="{8F3F1E45-DA63-4F9F-AA6A-8D715EF7613F}"/>
+                <a16:creationId xmlns:a16="http://schemas.microsoft.com/office/drawing/2014/main" id="{1A3CCC3A-2B2C-4FD9-8649-6105A43A7074}"/>
               </a:ext>
             </a:extLst>
           </p:cNvPr>
@@ -23545,7 +23880,7 @@
           <p:cNvPr id="5" name="">
             <a:extLst xmlns:a="http://schemas.openxmlformats.org/drawingml/2006/main">
               <a:ext uri="{FF2B5EF4-FFF2-40B4-BE49-F238E27FC236}">
-                <a16:creationId xmlns:a16="http://schemas.microsoft.com/office/drawing/2014/main" id="{94F76EF3-2159-4747-BFA7-11F9FB4515B4}"/>
+                <a16:creationId xmlns:a16="http://schemas.microsoft.com/office/drawing/2014/main" id="{9A06A441-3A0B-4F27-B487-EC4C56DF340D}"/>
               </a:ext>
             </a:extLst>
           </p:cNvPr>
@@ -23703,7 +24038,7 @@
           <p:cNvPr id="6" name="">
             <a:extLst xmlns:a="http://schemas.openxmlformats.org/drawingml/2006/main">
               <a:ext uri="{FF2B5EF4-FFF2-40B4-BE49-F238E27FC236}">
-                <a16:creationId xmlns:a16="http://schemas.microsoft.com/office/drawing/2014/main" id="{99C5FA0B-C8A1-4C8A-B9F3-0569CE0C258B}"/>
+                <a16:creationId xmlns:a16="http://schemas.microsoft.com/office/drawing/2014/main" id="{44F76592-ACF6-4AC4-91BA-1F2B40EE488E}"/>
               </a:ext>
             </a:extLst>
           </p:cNvPr>
@@ -24025,7 +24360,7 @@
     </p:spTree>
     <p:extLst>
       <p:ext uri="{BB962C8B-B14F-4D97-AF65-F5344CB8AC3E}">
-        <p14:creationId xmlns:p14="http://schemas.microsoft.com/office/powerpoint/2010/main" val="2001583491"/>
+        <p14:creationId xmlns:p14="http://schemas.microsoft.com/office/powerpoint/2010/main" val="2047447363"/>
       </p:ext>
     </p:extLst>
   </p:cSld>
@@ -24056,7 +24391,7 @@
           <p:cNvPr id="7" name="">
             <a:extLst xmlns:a="http://schemas.openxmlformats.org/drawingml/2006/main">
               <a:ext uri="{FF2B5EF4-FFF2-40B4-BE49-F238E27FC236}">
-                <a16:creationId xmlns:a16="http://schemas.microsoft.com/office/drawing/2014/main" id="{E393E905-08F9-4353-B02E-264B69E70B4C}"/>
+                <a16:creationId xmlns:a16="http://schemas.microsoft.com/office/drawing/2014/main" id="{98F2F754-873C-4104-965B-B9EE8B65EFB2}"/>
               </a:ext>
             </a:extLst>
           </p:cNvPr>
@@ -24086,7 +24421,7 @@
           <p:cNvPr id="2" name="">
             <a:extLst xmlns:a="http://schemas.openxmlformats.org/drawingml/2006/main">
               <a:ext uri="{FF2B5EF4-FFF2-40B4-BE49-F238E27FC236}">
-                <a16:creationId xmlns:a16="http://schemas.microsoft.com/office/drawing/2014/main" id="{8EF53911-FCDC-4B9C-909E-0F637951097B}"/>
+                <a16:creationId xmlns:a16="http://schemas.microsoft.com/office/drawing/2014/main" id="{5CFD0B6F-563E-4F01-A384-71ABC8ACADCD}"/>
               </a:ext>
             </a:extLst>
           </p:cNvPr>
@@ -24244,7 +24579,7 @@
           <p:cNvPr id="3" name="">
             <a:extLst xmlns:a="http://schemas.openxmlformats.org/drawingml/2006/main">
               <a:ext uri="{FF2B5EF4-FFF2-40B4-BE49-F238E27FC236}">
-                <a16:creationId xmlns:a16="http://schemas.microsoft.com/office/drawing/2014/main" id="{1BDE2170-3AB4-4291-B2CB-81800B705A05}"/>
+                <a16:creationId xmlns:a16="http://schemas.microsoft.com/office/drawing/2014/main" id="{D2A3E201-D138-45B4-BA58-FA3A0A108947}"/>
               </a:ext>
             </a:extLst>
           </p:cNvPr>
@@ -24392,7 +24727,7 @@
                 <a:ea typeface="Arial"/>
                 <a:cs typeface="Arial"/>
               </a:rPr>
-              <a:t>Projeto Aplicado Cenário 4</a:t>
+              <a:t>Projeto Aplicado Cenário 4  ·  Versão 28/10/2026</a:t>
             </a:r>
           </a:p>
         </p:txBody>
@@ -24402,7 +24737,7 @@
           <p:cNvPr id="4" name="">
             <a:extLst xmlns:a="http://schemas.openxmlformats.org/drawingml/2006/main">
               <a:ext uri="{FF2B5EF4-FFF2-40B4-BE49-F238E27FC236}">
-                <a16:creationId xmlns:a16="http://schemas.microsoft.com/office/drawing/2014/main" id="{2EB26866-35F3-46CF-8C39-F9F59F262B8E}"/>
+                <a16:creationId xmlns:a16="http://schemas.microsoft.com/office/drawing/2014/main" id="{C51D28E8-35E4-44C3-9D29-EFE2F708EC51}"/>
               </a:ext>
             </a:extLst>
           </p:cNvPr>
@@ -24560,7 +24895,7 @@
           <p:cNvPr id="5" name="">
             <a:extLst xmlns:a="http://schemas.openxmlformats.org/drawingml/2006/main">
               <a:ext uri="{FF2B5EF4-FFF2-40B4-BE49-F238E27FC236}">
-                <a16:creationId xmlns:a16="http://schemas.microsoft.com/office/drawing/2014/main" id="{42861581-42F6-485D-A65A-13036D629ADA}"/>
+                <a16:creationId xmlns:a16="http://schemas.microsoft.com/office/drawing/2014/main" id="{15A8E860-985A-403F-A180-FCE25F533246}"/>
               </a:ext>
             </a:extLst>
           </p:cNvPr>
@@ -24803,7 +25138,7 @@
           <p:cNvPr id="6" name="">
             <a:extLst xmlns:a="http://schemas.openxmlformats.org/drawingml/2006/main">
               <a:ext uri="{FF2B5EF4-FFF2-40B4-BE49-F238E27FC236}">
-                <a16:creationId xmlns:a16="http://schemas.microsoft.com/office/drawing/2014/main" id="{A368221C-38AA-4684-92D1-86F73A4AE534}"/>
+                <a16:creationId xmlns:a16="http://schemas.microsoft.com/office/drawing/2014/main" id="{4E71C85D-3A8E-43E3-A60F-4ADFF978E94F}"/>
               </a:ext>
             </a:extLst>
           </p:cNvPr>
@@ -24959,7 +25294,7 @@
     </p:spTree>
     <p:extLst>
       <p:ext uri="{BB962C8B-B14F-4D97-AF65-F5344CB8AC3E}">
-        <p14:creationId xmlns:p14="http://schemas.microsoft.com/office/powerpoint/2010/main" val="301702740"/>
+        <p14:creationId xmlns:p14="http://schemas.microsoft.com/office/powerpoint/2010/main" val="1820411137"/>
       </p:ext>
     </p:extLst>
   </p:cSld>
@@ -24990,7 +25325,7 @@
           <p:cNvPr id="7" name="">
             <a:extLst xmlns:a="http://schemas.openxmlformats.org/drawingml/2006/main">
               <a:ext uri="{FF2B5EF4-FFF2-40B4-BE49-F238E27FC236}">
-                <a16:creationId xmlns:a16="http://schemas.microsoft.com/office/drawing/2014/main" id="{A5100763-6956-485B-BEFF-580A21DC5F9E}"/>
+                <a16:creationId xmlns:a16="http://schemas.microsoft.com/office/drawing/2014/main" id="{30AD806D-C1E8-4518-9AFD-173078EA6FF9}"/>
               </a:ext>
             </a:extLst>
           </p:cNvPr>
@@ -25020,7 +25355,7 @@
           <p:cNvPr id="2" name="">
             <a:extLst xmlns:a="http://schemas.openxmlformats.org/drawingml/2006/main">
               <a:ext uri="{FF2B5EF4-FFF2-40B4-BE49-F238E27FC236}">
-                <a16:creationId xmlns:a16="http://schemas.microsoft.com/office/drawing/2014/main" id="{023C0A2F-E1B4-489A-A35C-004947AE40F9}"/>
+                <a16:creationId xmlns:a16="http://schemas.microsoft.com/office/drawing/2014/main" id="{B266E570-FEDC-47B1-A6E2-D3A5D28613F6}"/>
               </a:ext>
             </a:extLst>
           </p:cNvPr>
@@ -25178,7 +25513,7 @@
           <p:cNvPr id="3" name="">
             <a:extLst xmlns:a="http://schemas.openxmlformats.org/drawingml/2006/main">
               <a:ext uri="{FF2B5EF4-FFF2-40B4-BE49-F238E27FC236}">
-                <a16:creationId xmlns:a16="http://schemas.microsoft.com/office/drawing/2014/main" id="{64A2E80F-7AEB-4B95-B7FD-1238424F8F3B}"/>
+                <a16:creationId xmlns:a16="http://schemas.microsoft.com/office/drawing/2014/main" id="{83CCC297-26DE-41E5-972F-65BC252AEFA9}"/>
               </a:ext>
             </a:extLst>
           </p:cNvPr>
@@ -25326,7 +25661,7 @@
                 <a:ea typeface="Arial"/>
                 <a:cs typeface="Arial"/>
               </a:rPr>
-              <a:t>Projeto Aplicado Cenário 4</a:t>
+              <a:t>Projeto Aplicado Cenário 4  ·  Versão 28/10/2026</a:t>
             </a:r>
           </a:p>
         </p:txBody>
@@ -25336,7 +25671,7 @@
           <p:cNvPr id="4" name="">
             <a:extLst xmlns:a="http://schemas.openxmlformats.org/drawingml/2006/main">
               <a:ext uri="{FF2B5EF4-FFF2-40B4-BE49-F238E27FC236}">
-                <a16:creationId xmlns:a16="http://schemas.microsoft.com/office/drawing/2014/main" id="{67FABE38-D401-4459-A4BA-0B3A9688F7E1}"/>
+                <a16:creationId xmlns:a16="http://schemas.microsoft.com/office/drawing/2014/main" id="{295DD83C-2377-48CE-8D4A-73D4261260DA}"/>
               </a:ext>
             </a:extLst>
           </p:cNvPr>
@@ -25346,7 +25681,7 @@
           <p:nvPr/>
         </p:nvPicPr>
         <p:blipFill>
-          <a:blip xmlns:r="http://schemas.openxmlformats.org/officeDocument/2006/relationships" xmlns:a="http://schemas.openxmlformats.org/drawingml/2006/main" r:embed="R7ba2c40846854e44"/>
+          <a:blip xmlns:r="http://schemas.openxmlformats.org/officeDocument/2006/relationships" xmlns:a="http://schemas.openxmlformats.org/drawingml/2006/main" r:embed="Redaf8f5dac99459a"/>
           <a:stretch xmlns:a="http://schemas.openxmlformats.org/drawingml/2006/main"/>
         </p:blipFill>
         <p:spPr>
@@ -25364,7 +25699,7 @@
           <p:cNvPr id="5" name="">
             <a:extLst xmlns:a="http://schemas.openxmlformats.org/drawingml/2006/main">
               <a:ext uri="{FF2B5EF4-FFF2-40B4-BE49-F238E27FC236}">
-                <a16:creationId xmlns:a16="http://schemas.microsoft.com/office/drawing/2014/main" id="{80A029D4-2393-4D8B-A7BC-5FC3ED59B364}"/>
+                <a16:creationId xmlns:a16="http://schemas.microsoft.com/office/drawing/2014/main" id="{AE0653C6-0CA9-43D4-910A-2BA305974C66}"/>
               </a:ext>
             </a:extLst>
           </p:cNvPr>
@@ -25607,7 +25942,7 @@
           <p:cNvPr id="6" name="">
             <a:extLst xmlns:a="http://schemas.openxmlformats.org/drawingml/2006/main">
               <a:ext uri="{FF2B5EF4-FFF2-40B4-BE49-F238E27FC236}">
-                <a16:creationId xmlns:a16="http://schemas.microsoft.com/office/drawing/2014/main" id="{ABC5EA8B-9E75-4F91-AAE7-8FB11FF4F5E6}"/>
+                <a16:creationId xmlns:a16="http://schemas.microsoft.com/office/drawing/2014/main" id="{C7603FDF-F0D7-470A-8294-756D630D83F3}"/>
               </a:ext>
             </a:extLst>
           </p:cNvPr>
@@ -25763,7 +26098,7 @@
     </p:spTree>
     <p:extLst>
       <p:ext uri="{BB962C8B-B14F-4D97-AF65-F5344CB8AC3E}">
-        <p14:creationId xmlns:p14="http://schemas.microsoft.com/office/powerpoint/2010/main" val="646684032"/>
+        <p14:creationId xmlns:p14="http://schemas.microsoft.com/office/powerpoint/2010/main" val="1583082640"/>
       </p:ext>
     </p:extLst>
   </p:cSld>
@@ -25794,7 +26129,7 @@
           <p:cNvPr id="19" name="">
             <a:extLst xmlns:a="http://schemas.openxmlformats.org/drawingml/2006/main">
               <a:ext uri="{FF2B5EF4-FFF2-40B4-BE49-F238E27FC236}">
-                <a16:creationId xmlns:a16="http://schemas.microsoft.com/office/drawing/2014/main" id="{E08321A8-9333-4500-AD20-29391595C1B4}"/>
+                <a16:creationId xmlns:a16="http://schemas.microsoft.com/office/drawing/2014/main" id="{E0409CBA-4961-4347-87E7-025E85F66025}"/>
               </a:ext>
             </a:extLst>
           </p:cNvPr>
@@ -25824,7 +26159,7 @@
           <p:cNvPr id="2" name="">
             <a:extLst xmlns:a="http://schemas.openxmlformats.org/drawingml/2006/main">
               <a:ext uri="{FF2B5EF4-FFF2-40B4-BE49-F238E27FC236}">
-                <a16:creationId xmlns:a16="http://schemas.microsoft.com/office/drawing/2014/main" id="{99CD0C5C-D162-4556-86ED-5AB348519E1C}"/>
+                <a16:creationId xmlns:a16="http://schemas.microsoft.com/office/drawing/2014/main" id="{D2DFCB02-AB6C-4AC5-A13B-18034DE4C6A8}"/>
               </a:ext>
             </a:extLst>
           </p:cNvPr>
@@ -25982,7 +26317,7 @@
           <p:cNvPr id="3" name="">
             <a:extLst xmlns:a="http://schemas.openxmlformats.org/drawingml/2006/main">
               <a:ext uri="{FF2B5EF4-FFF2-40B4-BE49-F238E27FC236}">
-                <a16:creationId xmlns:a16="http://schemas.microsoft.com/office/drawing/2014/main" id="{BB34A784-E2DF-4BCE-833E-1A1F2DB90F1C}"/>
+                <a16:creationId xmlns:a16="http://schemas.microsoft.com/office/drawing/2014/main" id="{4F0C9736-0B23-40C4-B25F-EC89F8496781}"/>
               </a:ext>
             </a:extLst>
           </p:cNvPr>
@@ -26130,7 +26465,7 @@
                 <a:ea typeface="Arial"/>
                 <a:cs typeface="Arial"/>
               </a:rPr>
-              <a:t>Projeto Aplicado Cenário 4</a:t>
+              <a:t>Projeto Aplicado Cenário 4  ·  Versão 28/10/2026</a:t>
             </a:r>
           </a:p>
         </p:txBody>
@@ -26140,7 +26475,7 @@
           <p:cNvPr id="4" name="">
             <a:extLst xmlns:a="http://schemas.openxmlformats.org/drawingml/2006/main">
               <a:ext uri="{FF2B5EF4-FFF2-40B4-BE49-F238E27FC236}">
-                <a16:creationId xmlns:a16="http://schemas.microsoft.com/office/drawing/2014/main" id="{DC383B24-7B7F-47EE-81C0-60B0B59DF05E}"/>
+                <a16:creationId xmlns:a16="http://schemas.microsoft.com/office/drawing/2014/main" id="{C7C61B60-5036-4BC4-9840-4FF31B42F823}"/>
               </a:ext>
             </a:extLst>
           </p:cNvPr>
@@ -26305,7 +26640,7 @@
           <p:cNvPr id="5" name="">
             <a:extLst xmlns:a="http://schemas.openxmlformats.org/drawingml/2006/main">
               <a:ext uri="{FF2B5EF4-FFF2-40B4-BE49-F238E27FC236}">
-                <a16:creationId xmlns:a16="http://schemas.microsoft.com/office/drawing/2014/main" id="{495D5FB4-C76C-47EB-87ED-83EA68A0F138}"/>
+                <a16:creationId xmlns:a16="http://schemas.microsoft.com/office/drawing/2014/main" id="{084CD303-1A40-4E24-9815-5EFBEFDB05BE}"/>
               </a:ext>
             </a:extLst>
           </p:cNvPr>
@@ -26463,7 +26798,7 @@
           <p:cNvPr id="6" name="">
             <a:extLst xmlns:a="http://schemas.openxmlformats.org/drawingml/2006/main">
               <a:ext uri="{FF2B5EF4-FFF2-40B4-BE49-F238E27FC236}">
-                <a16:creationId xmlns:a16="http://schemas.microsoft.com/office/drawing/2014/main" id="{1ADA156C-F976-45C0-9658-8ED2053766CA}"/>
+                <a16:creationId xmlns:a16="http://schemas.microsoft.com/office/drawing/2014/main" id="{34E3E8ED-50AA-443A-B3D1-AC840FCFC425}"/>
               </a:ext>
             </a:extLst>
           </p:cNvPr>
@@ -26621,7 +26956,7 @@
           <p:cNvPr id="7" name="">
             <a:extLst xmlns:a="http://schemas.openxmlformats.org/drawingml/2006/main">
               <a:ext uri="{FF2B5EF4-FFF2-40B4-BE49-F238E27FC236}">
-                <a16:creationId xmlns:a16="http://schemas.microsoft.com/office/drawing/2014/main" id="{BBCD95F0-36FE-4159-8C3A-464EF6E18EE5}"/>
+                <a16:creationId xmlns:a16="http://schemas.microsoft.com/office/drawing/2014/main" id="{8CC777C9-8A3B-41B7-902A-F217F9F8FF0E}"/>
               </a:ext>
             </a:extLst>
           </p:cNvPr>
@@ -26786,7 +27121,7 @@
           <p:cNvPr id="8" name="">
             <a:extLst xmlns:a="http://schemas.openxmlformats.org/drawingml/2006/main">
               <a:ext uri="{FF2B5EF4-FFF2-40B4-BE49-F238E27FC236}">
-                <a16:creationId xmlns:a16="http://schemas.microsoft.com/office/drawing/2014/main" id="{CD0EA44B-E600-4838-BE92-620182535B2F}"/>
+                <a16:creationId xmlns:a16="http://schemas.microsoft.com/office/drawing/2014/main" id="{1D1701FF-33BB-4F68-9BC5-653A11C9A3E7}"/>
               </a:ext>
             </a:extLst>
           </p:cNvPr>
@@ -26944,7 +27279,7 @@
           <p:cNvPr id="9" name="">
             <a:extLst xmlns:a="http://schemas.openxmlformats.org/drawingml/2006/main">
               <a:ext uri="{FF2B5EF4-FFF2-40B4-BE49-F238E27FC236}">
-                <a16:creationId xmlns:a16="http://schemas.microsoft.com/office/drawing/2014/main" id="{53D600BD-EB77-440E-87E4-C39068538787}"/>
+                <a16:creationId xmlns:a16="http://schemas.microsoft.com/office/drawing/2014/main" id="{BEF67298-0A01-4FAA-99F6-486446D08C80}"/>
               </a:ext>
             </a:extLst>
           </p:cNvPr>
@@ -27102,7 +27437,7 @@
           <p:cNvPr id="10" name="">
             <a:extLst xmlns:a="http://schemas.openxmlformats.org/drawingml/2006/main">
               <a:ext uri="{FF2B5EF4-FFF2-40B4-BE49-F238E27FC236}">
-                <a16:creationId xmlns:a16="http://schemas.microsoft.com/office/drawing/2014/main" id="{FD8B58CC-2832-4065-9145-6E2ECA792A9B}"/>
+                <a16:creationId xmlns:a16="http://schemas.microsoft.com/office/drawing/2014/main" id="{82D60308-7599-4175-B791-828D547D68F0}"/>
               </a:ext>
             </a:extLst>
           </p:cNvPr>
@@ -27267,7 +27602,7 @@
           <p:cNvPr id="11" name="">
             <a:extLst xmlns:a="http://schemas.openxmlformats.org/drawingml/2006/main">
               <a:ext uri="{FF2B5EF4-FFF2-40B4-BE49-F238E27FC236}">
-                <a16:creationId xmlns:a16="http://schemas.microsoft.com/office/drawing/2014/main" id="{D5F0BA3D-0328-4333-A0B0-3BC99A3E0683}"/>
+                <a16:creationId xmlns:a16="http://schemas.microsoft.com/office/drawing/2014/main" id="{DC338644-66D7-4D93-A5E0-8094F7E13F6A}"/>
               </a:ext>
             </a:extLst>
           </p:cNvPr>
@@ -27425,7 +27760,7 @@
           <p:cNvPr id="12" name="">
             <a:extLst xmlns:a="http://schemas.openxmlformats.org/drawingml/2006/main">
               <a:ext uri="{FF2B5EF4-FFF2-40B4-BE49-F238E27FC236}">
-                <a16:creationId xmlns:a16="http://schemas.microsoft.com/office/drawing/2014/main" id="{1FCFBFD8-5AEB-4BCB-9883-13FC847CA058}"/>
+                <a16:creationId xmlns:a16="http://schemas.microsoft.com/office/drawing/2014/main" id="{8A305D72-2909-4CEB-9DF6-82ABD60C5E19}"/>
               </a:ext>
             </a:extLst>
           </p:cNvPr>
@@ -27583,7 +27918,7 @@
           <p:cNvPr id="13" name="">
             <a:extLst xmlns:a="http://schemas.openxmlformats.org/drawingml/2006/main">
               <a:ext uri="{FF2B5EF4-FFF2-40B4-BE49-F238E27FC236}">
-                <a16:creationId xmlns:a16="http://schemas.microsoft.com/office/drawing/2014/main" id="{CB919B67-58ED-432C-BCB4-15FACFBE9B66}"/>
+                <a16:creationId xmlns:a16="http://schemas.microsoft.com/office/drawing/2014/main" id="{7D29FEC2-7533-495C-AB3C-FEAD13FA31CF}"/>
               </a:ext>
             </a:extLst>
           </p:cNvPr>
@@ -27748,7 +28083,7 @@
           <p:cNvPr id="14" name="">
             <a:extLst xmlns:a="http://schemas.openxmlformats.org/drawingml/2006/main">
               <a:ext uri="{FF2B5EF4-FFF2-40B4-BE49-F238E27FC236}">
-                <a16:creationId xmlns:a16="http://schemas.microsoft.com/office/drawing/2014/main" id="{00F7EE1F-2C6C-410A-B7C0-577D10010ED6}"/>
+                <a16:creationId xmlns:a16="http://schemas.microsoft.com/office/drawing/2014/main" id="{8C9FAAE1-5F74-4127-AB04-08778AFF83FE}"/>
               </a:ext>
             </a:extLst>
           </p:cNvPr>
@@ -27906,7 +28241,7 @@
           <p:cNvPr id="15" name="">
             <a:extLst xmlns:a="http://schemas.openxmlformats.org/drawingml/2006/main">
               <a:ext uri="{FF2B5EF4-FFF2-40B4-BE49-F238E27FC236}">
-                <a16:creationId xmlns:a16="http://schemas.microsoft.com/office/drawing/2014/main" id="{D3112E00-8AAE-484B-BF97-553267CCD582}"/>
+                <a16:creationId xmlns:a16="http://schemas.microsoft.com/office/drawing/2014/main" id="{1D457411-D8AE-4650-B633-D91D8C5E21FD}"/>
               </a:ext>
             </a:extLst>
           </p:cNvPr>
@@ -28064,7 +28399,7 @@
           <p:cNvPr id="16" name="">
             <a:extLst xmlns:a="http://schemas.openxmlformats.org/drawingml/2006/main">
               <a:ext uri="{FF2B5EF4-FFF2-40B4-BE49-F238E27FC236}">
-                <a16:creationId xmlns:a16="http://schemas.microsoft.com/office/drawing/2014/main" id="{53651466-7504-4430-A440-058905E1B630}"/>
+                <a16:creationId xmlns:a16="http://schemas.microsoft.com/office/drawing/2014/main" id="{2B9D7817-564C-4FB7-AD80-C8439F2073E0}"/>
               </a:ext>
             </a:extLst>
           </p:cNvPr>
@@ -28229,7 +28564,7 @@
           <p:cNvPr id="17" name="">
             <a:extLst xmlns:a="http://schemas.openxmlformats.org/drawingml/2006/main">
               <a:ext uri="{FF2B5EF4-FFF2-40B4-BE49-F238E27FC236}">
-                <a16:creationId xmlns:a16="http://schemas.microsoft.com/office/drawing/2014/main" id="{E6CF5F64-C195-4854-AB32-F989EC538517}"/>
+                <a16:creationId xmlns:a16="http://schemas.microsoft.com/office/drawing/2014/main" id="{5A4B0896-9D4D-4D5C-8752-6D7C68EF02FE}"/>
               </a:ext>
             </a:extLst>
           </p:cNvPr>
@@ -28387,7 +28722,7 @@
           <p:cNvPr id="18" name="">
             <a:extLst xmlns:a="http://schemas.openxmlformats.org/drawingml/2006/main">
               <a:ext uri="{FF2B5EF4-FFF2-40B4-BE49-F238E27FC236}">
-                <a16:creationId xmlns:a16="http://schemas.microsoft.com/office/drawing/2014/main" id="{6646368D-D945-4FFE-9F3E-E5D44545EECD}"/>
+                <a16:creationId xmlns:a16="http://schemas.microsoft.com/office/drawing/2014/main" id="{87B2AB50-E4F2-4E81-88ED-9EBCDFDC1AD6}"/>
               </a:ext>
             </a:extLst>
           </p:cNvPr>
@@ -28543,7 +28878,7 @@
     </p:spTree>
     <p:extLst>
       <p:ext uri="{BB962C8B-B14F-4D97-AF65-F5344CB8AC3E}">
-        <p14:creationId xmlns:p14="http://schemas.microsoft.com/office/powerpoint/2010/main" val="1185681379"/>
+        <p14:creationId xmlns:p14="http://schemas.microsoft.com/office/powerpoint/2010/main" val="289355591"/>
       </p:ext>
     </p:extLst>
   </p:cSld>
@@ -28574,7 +28909,7 @@
           <p:cNvPr id="16" name="">
             <a:extLst xmlns:a="http://schemas.openxmlformats.org/drawingml/2006/main">
               <a:ext uri="{FF2B5EF4-FFF2-40B4-BE49-F238E27FC236}">
-                <a16:creationId xmlns:a16="http://schemas.microsoft.com/office/drawing/2014/main" id="{16536538-AFCD-464B-861A-B72D62729F7C}"/>
+                <a16:creationId xmlns:a16="http://schemas.microsoft.com/office/drawing/2014/main" id="{F0BED1FE-7BFD-43D8-824A-7ED81E844D80}"/>
               </a:ext>
             </a:extLst>
           </p:cNvPr>
@@ -28604,7 +28939,7 @@
           <p:cNvPr id="2" name="">
             <a:extLst xmlns:a="http://schemas.openxmlformats.org/drawingml/2006/main">
               <a:ext uri="{FF2B5EF4-FFF2-40B4-BE49-F238E27FC236}">
-                <a16:creationId xmlns:a16="http://schemas.microsoft.com/office/drawing/2014/main" id="{1D041BB9-9161-41A3-A907-2640CB1152A8}"/>
+                <a16:creationId xmlns:a16="http://schemas.microsoft.com/office/drawing/2014/main" id="{76E52E5D-C938-4E04-A0B8-C0540BBFDDF3}"/>
               </a:ext>
             </a:extLst>
           </p:cNvPr>
@@ -28762,7 +29097,7 @@
           <p:cNvPr id="3" name="">
             <a:extLst xmlns:a="http://schemas.openxmlformats.org/drawingml/2006/main">
               <a:ext uri="{FF2B5EF4-FFF2-40B4-BE49-F238E27FC236}">
-                <a16:creationId xmlns:a16="http://schemas.microsoft.com/office/drawing/2014/main" id="{5C85FAF3-2957-425C-878D-AF06B2F07D10}"/>
+                <a16:creationId xmlns:a16="http://schemas.microsoft.com/office/drawing/2014/main" id="{0F8FDC1A-2226-4932-AC79-DE0E39281508}"/>
               </a:ext>
             </a:extLst>
           </p:cNvPr>
@@ -28910,7 +29245,7 @@
                 <a:ea typeface="Arial"/>
                 <a:cs typeface="Arial"/>
               </a:rPr>
-              <a:t>Projeto Aplicado Cenário 4</a:t>
+              <a:t>Projeto Aplicado Cenário 4  ·  Versão 28/10/2026</a:t>
             </a:r>
           </a:p>
         </p:txBody>
@@ -28920,7 +29255,7 @@
           <p:cNvPr id="4" name="">
             <a:extLst xmlns:a="http://schemas.openxmlformats.org/drawingml/2006/main">
               <a:ext uri="{FF2B5EF4-FFF2-40B4-BE49-F238E27FC236}">
-                <a16:creationId xmlns:a16="http://schemas.microsoft.com/office/drawing/2014/main" id="{BE813EE2-53AA-4E07-AB66-1A4FB92B770D}"/>
+                <a16:creationId xmlns:a16="http://schemas.microsoft.com/office/drawing/2014/main" id="{04B565D3-DE61-4994-9EDF-11549C5F63C9}"/>
               </a:ext>
             </a:extLst>
           </p:cNvPr>
@@ -29078,7 +29413,7 @@
           <p:cNvPr id="5" name="">
             <a:extLst xmlns:a="http://schemas.openxmlformats.org/drawingml/2006/main">
               <a:ext uri="{FF2B5EF4-FFF2-40B4-BE49-F238E27FC236}">
-                <a16:creationId xmlns:a16="http://schemas.microsoft.com/office/drawing/2014/main" id="{66CD1496-A15A-4EBF-B47E-8C4801DED033}"/>
+                <a16:creationId xmlns:a16="http://schemas.microsoft.com/office/drawing/2014/main" id="{069B7356-2ECD-4FFA-A23E-197EA0E476B1}"/>
               </a:ext>
             </a:extLst>
           </p:cNvPr>
@@ -29236,7 +29571,7 @@
           <p:cNvPr id="6" name="">
             <a:extLst xmlns:a="http://schemas.openxmlformats.org/drawingml/2006/main">
               <a:ext uri="{FF2B5EF4-FFF2-40B4-BE49-F238E27FC236}">
-                <a16:creationId xmlns:a16="http://schemas.microsoft.com/office/drawing/2014/main" id="{A5EB4C1C-9DDF-4CA4-A1D2-23068C741252}"/>
+                <a16:creationId xmlns:a16="http://schemas.microsoft.com/office/drawing/2014/main" id="{CC0B3C58-EE1C-4534-8D8D-23B7E8362735}"/>
               </a:ext>
             </a:extLst>
           </p:cNvPr>
@@ -29394,7 +29729,7 @@
           <p:cNvPr id="7" name="">
             <a:extLst xmlns:a="http://schemas.openxmlformats.org/drawingml/2006/main">
               <a:ext uri="{FF2B5EF4-FFF2-40B4-BE49-F238E27FC236}">
-                <a16:creationId xmlns:a16="http://schemas.microsoft.com/office/drawing/2014/main" id="{6690A9CB-5861-4481-8DE0-140860DA7B3E}"/>
+                <a16:creationId xmlns:a16="http://schemas.microsoft.com/office/drawing/2014/main" id="{4EE51E81-809E-4898-B854-F7E30919F058}"/>
               </a:ext>
             </a:extLst>
           </p:cNvPr>
@@ -29552,7 +29887,7 @@
           <p:cNvPr id="8" name="">
             <a:extLst xmlns:a="http://schemas.openxmlformats.org/drawingml/2006/main">
               <a:ext uri="{FF2B5EF4-FFF2-40B4-BE49-F238E27FC236}">
-                <a16:creationId xmlns:a16="http://schemas.microsoft.com/office/drawing/2014/main" id="{B4C73DD7-3D91-4C95-B623-B7FB0189241D}"/>
+                <a16:creationId xmlns:a16="http://schemas.microsoft.com/office/drawing/2014/main" id="{727E234D-AE82-4F74-862D-7C3615E1AEBE}"/>
               </a:ext>
             </a:extLst>
           </p:cNvPr>
@@ -29710,7 +30045,7 @@
           <p:cNvPr id="9" name="">
             <a:extLst xmlns:a="http://schemas.openxmlformats.org/drawingml/2006/main">
               <a:ext uri="{FF2B5EF4-FFF2-40B4-BE49-F238E27FC236}">
-                <a16:creationId xmlns:a16="http://schemas.microsoft.com/office/drawing/2014/main" id="{5E8F8250-B823-42EE-93B3-5E6F2866531E}"/>
+                <a16:creationId xmlns:a16="http://schemas.microsoft.com/office/drawing/2014/main" id="{97A761F8-2495-468D-A9D7-B442A5479C82}"/>
               </a:ext>
             </a:extLst>
           </p:cNvPr>
@@ -29868,7 +30203,7 @@
           <p:cNvPr id="10" name="">
             <a:extLst xmlns:a="http://schemas.openxmlformats.org/drawingml/2006/main">
               <a:ext uri="{FF2B5EF4-FFF2-40B4-BE49-F238E27FC236}">
-                <a16:creationId xmlns:a16="http://schemas.microsoft.com/office/drawing/2014/main" id="{4F421842-4C56-43BA-9461-4102EFE49F19}"/>
+                <a16:creationId xmlns:a16="http://schemas.microsoft.com/office/drawing/2014/main" id="{F9CEAACD-A8F9-471D-B25B-59BB8CEAF801}"/>
               </a:ext>
             </a:extLst>
           </p:cNvPr>
@@ -30026,7 +30361,7 @@
           <p:cNvPr id="11" name="">
             <a:extLst xmlns:a="http://schemas.openxmlformats.org/drawingml/2006/main">
               <a:ext uri="{FF2B5EF4-FFF2-40B4-BE49-F238E27FC236}">
-                <a16:creationId xmlns:a16="http://schemas.microsoft.com/office/drawing/2014/main" id="{295CA136-A53A-4EC1-999C-6FE6C0105C6E}"/>
+                <a16:creationId xmlns:a16="http://schemas.microsoft.com/office/drawing/2014/main" id="{CC7BC676-C41F-4038-9516-5CF7DA23F2E6}"/>
               </a:ext>
             </a:extLst>
           </p:cNvPr>
@@ -30184,7 +30519,7 @@
           <p:cNvPr id="12" name="">
             <a:extLst xmlns:a="http://schemas.openxmlformats.org/drawingml/2006/main">
               <a:ext uri="{FF2B5EF4-FFF2-40B4-BE49-F238E27FC236}">
-                <a16:creationId xmlns:a16="http://schemas.microsoft.com/office/drawing/2014/main" id="{7AD9F545-F7D2-4B50-956B-5AB67451EA84}"/>
+                <a16:creationId xmlns:a16="http://schemas.microsoft.com/office/drawing/2014/main" id="{4E1664C6-24D8-4702-9F1D-B6B5A1B9A3F7}"/>
               </a:ext>
             </a:extLst>
           </p:cNvPr>
@@ -30342,7 +30677,7 @@
           <p:cNvPr id="13" name="">
             <a:extLst xmlns:a="http://schemas.openxmlformats.org/drawingml/2006/main">
               <a:ext uri="{FF2B5EF4-FFF2-40B4-BE49-F238E27FC236}">
-                <a16:creationId xmlns:a16="http://schemas.microsoft.com/office/drawing/2014/main" id="{DD1556CC-1C02-4952-AC07-3856D48B2391}"/>
+                <a16:creationId xmlns:a16="http://schemas.microsoft.com/office/drawing/2014/main" id="{B673505E-9AF5-4EFC-B1E1-A28EBA3891DF}"/>
               </a:ext>
             </a:extLst>
           </p:cNvPr>
@@ -30500,7 +30835,7 @@
           <p:cNvPr id="14" name="">
             <a:extLst xmlns:a="http://schemas.openxmlformats.org/drawingml/2006/main">
               <a:ext uri="{FF2B5EF4-FFF2-40B4-BE49-F238E27FC236}">
-                <a16:creationId xmlns:a16="http://schemas.microsoft.com/office/drawing/2014/main" id="{F4A9522B-5466-40D2-9E1B-69D81A0E9FFF}"/>
+                <a16:creationId xmlns:a16="http://schemas.microsoft.com/office/drawing/2014/main" id="{E1E53C14-CD57-47FC-9DE1-6E12D1D202E7}"/>
               </a:ext>
             </a:extLst>
           </p:cNvPr>
@@ -30658,7 +30993,7 @@
           <p:cNvPr id="15" name="">
             <a:extLst xmlns:a="http://schemas.openxmlformats.org/drawingml/2006/main">
               <a:ext uri="{FF2B5EF4-FFF2-40B4-BE49-F238E27FC236}">
-                <a16:creationId xmlns:a16="http://schemas.microsoft.com/office/drawing/2014/main" id="{0601A111-EF2C-4B36-AF4F-45794B665FE3}"/>
+                <a16:creationId xmlns:a16="http://schemas.microsoft.com/office/drawing/2014/main" id="{F3E5B7E9-0A68-40B9-A874-A46BA01BA9A1}"/>
               </a:ext>
             </a:extLst>
           </p:cNvPr>
@@ -30814,7 +31149,7 @@
     </p:spTree>
     <p:extLst>
       <p:ext uri="{BB962C8B-B14F-4D97-AF65-F5344CB8AC3E}">
-        <p14:creationId xmlns:p14="http://schemas.microsoft.com/office/powerpoint/2010/main" val="1561174393"/>
+        <p14:creationId xmlns:p14="http://schemas.microsoft.com/office/powerpoint/2010/main" val="334837432"/>
       </p:ext>
     </p:extLst>
   </p:cSld>
@@ -30845,7 +31180,7 @@
           <p:cNvPr id="9" name="">
             <a:extLst xmlns:a="http://schemas.openxmlformats.org/drawingml/2006/main">
               <a:ext uri="{FF2B5EF4-FFF2-40B4-BE49-F238E27FC236}">
-                <a16:creationId xmlns:a16="http://schemas.microsoft.com/office/drawing/2014/main" id="{779DE8AB-9E68-4A4F-8B5A-035C65A3EB09}"/>
+                <a16:creationId xmlns:a16="http://schemas.microsoft.com/office/drawing/2014/main" id="{679E70A1-65C8-4B33-BFE3-6E03D4579892}"/>
               </a:ext>
             </a:extLst>
           </p:cNvPr>
@@ -30875,7 +31210,7 @@
           <p:cNvPr id="2" name="">
             <a:extLst xmlns:a="http://schemas.openxmlformats.org/drawingml/2006/main">
               <a:ext uri="{FF2B5EF4-FFF2-40B4-BE49-F238E27FC236}">
-                <a16:creationId xmlns:a16="http://schemas.microsoft.com/office/drawing/2014/main" id="{97C8D749-F7A7-4D27-BCED-8532F1383954}"/>
+                <a16:creationId xmlns:a16="http://schemas.microsoft.com/office/drawing/2014/main" id="{09C87233-1984-4983-B8EE-B2ED28A4EAB6}"/>
               </a:ext>
             </a:extLst>
           </p:cNvPr>
@@ -31033,7 +31368,7 @@
           <p:cNvPr id="3" name="">
             <a:extLst xmlns:a="http://schemas.openxmlformats.org/drawingml/2006/main">
               <a:ext uri="{FF2B5EF4-FFF2-40B4-BE49-F238E27FC236}">
-                <a16:creationId xmlns:a16="http://schemas.microsoft.com/office/drawing/2014/main" id="{40C232EC-D08E-43E7-8C64-1AFF12DE5760}"/>
+                <a16:creationId xmlns:a16="http://schemas.microsoft.com/office/drawing/2014/main" id="{EB1469C1-131F-4A54-ACF3-6094BB65085A}"/>
               </a:ext>
             </a:extLst>
           </p:cNvPr>
@@ -31181,7 +31516,7 @@
                 <a:ea typeface="Arial"/>
                 <a:cs typeface="Arial"/>
               </a:rPr>
-              <a:t>Projeto Aplicado Cenário 4</a:t>
+              <a:t>Projeto Aplicado Cenário 4  ·  Versão 28/10/2026</a:t>
             </a:r>
           </a:p>
         </p:txBody>
@@ -31191,7 +31526,7 @@
           <p:cNvPr id="4" name="">
             <a:extLst xmlns:a="http://schemas.openxmlformats.org/drawingml/2006/main">
               <a:ext uri="{FF2B5EF4-FFF2-40B4-BE49-F238E27FC236}">
-                <a16:creationId xmlns:a16="http://schemas.microsoft.com/office/drawing/2014/main" id="{8F42CF82-DD46-405C-A105-6C6053BF1047}"/>
+                <a16:creationId xmlns:a16="http://schemas.microsoft.com/office/drawing/2014/main" id="{E852323D-D9B0-4E3D-9C4B-3B4870DABB3E}"/>
               </a:ext>
             </a:extLst>
           </p:cNvPr>
@@ -31461,7 +31796,7 @@
           <p:cNvPr id="5" name="">
             <a:extLst xmlns:a="http://schemas.openxmlformats.org/drawingml/2006/main">
               <a:ext uri="{FF2B5EF4-FFF2-40B4-BE49-F238E27FC236}">
-                <a16:creationId xmlns:a16="http://schemas.microsoft.com/office/drawing/2014/main" id="{F9EE705E-30F0-44E1-9F30-B20B031D1641}"/>
+                <a16:creationId xmlns:a16="http://schemas.microsoft.com/office/drawing/2014/main" id="{37406DDB-A2DF-4173-AF41-1A7D47B9BC29}"/>
               </a:ext>
             </a:extLst>
           </p:cNvPr>
@@ -31649,7 +31984,7 @@
           <p:cNvPr id="6" name="">
             <a:extLst xmlns:a="http://schemas.openxmlformats.org/drawingml/2006/main">
               <a:ext uri="{FF2B5EF4-FFF2-40B4-BE49-F238E27FC236}">
-                <a16:creationId xmlns:a16="http://schemas.microsoft.com/office/drawing/2014/main" id="{33CB46A5-CEC1-4A9F-A354-D656A874556F}"/>
+                <a16:creationId xmlns:a16="http://schemas.microsoft.com/office/drawing/2014/main" id="{327A070F-D4C3-4DB2-8D11-C4DAB06410FD}"/>
               </a:ext>
             </a:extLst>
           </p:cNvPr>
@@ -31837,7 +32172,7 @@
           <p:cNvPr id="7" name="">
             <a:extLst xmlns:a="http://schemas.openxmlformats.org/drawingml/2006/main">
               <a:ext uri="{FF2B5EF4-FFF2-40B4-BE49-F238E27FC236}">
-                <a16:creationId xmlns:a16="http://schemas.microsoft.com/office/drawing/2014/main" id="{18267CD3-BE43-4164-B98D-3AC16F07FD9D}"/>
+                <a16:creationId xmlns:a16="http://schemas.microsoft.com/office/drawing/2014/main" id="{9E854349-887C-4C80-938B-8F179D81850C}"/>
               </a:ext>
             </a:extLst>
           </p:cNvPr>
@@ -32025,7 +32360,7 @@
           <p:cNvPr id="8" name="">
             <a:extLst xmlns:a="http://schemas.openxmlformats.org/drawingml/2006/main">
               <a:ext uri="{FF2B5EF4-FFF2-40B4-BE49-F238E27FC236}">
-                <a16:creationId xmlns:a16="http://schemas.microsoft.com/office/drawing/2014/main" id="{41C98C30-3776-4722-BB27-A667004E61CF}"/>
+                <a16:creationId xmlns:a16="http://schemas.microsoft.com/office/drawing/2014/main" id="{DECA67F3-6154-45FB-AB0E-1F0DA66902A1}"/>
               </a:ext>
             </a:extLst>
           </p:cNvPr>
@@ -32181,7 +32516,7 @@
     </p:spTree>
     <p:extLst>
       <p:ext uri="{BB962C8B-B14F-4D97-AF65-F5344CB8AC3E}">
-        <p14:creationId xmlns:p14="http://schemas.microsoft.com/office/powerpoint/2010/main" val="581817457"/>
+        <p14:creationId xmlns:p14="http://schemas.microsoft.com/office/powerpoint/2010/main" val="2143374585"/>
       </p:ext>
     </p:extLst>
   </p:cSld>

</xml_diff>

<commit_message>
fix: recupera F3 e alinha estados de fechamento e autoria
</commit_message>
<xml_diff>
--- a/output/Apresentacao_Cenario_4.pptx
+++ b/output/Apresentacao_Cenario_4.pptx
@@ -2,30 +2,30 @@
 <file path=ppt/presentation.xml><?xml version="1.0" encoding="utf-8"?>
 <p:presentation xmlns:p="http://schemas.openxmlformats.org/presentationml/2006/main">
   <p:sldMasterIdLst>
-    <p:sldMasterId xmlns:r="http://schemas.openxmlformats.org/officeDocument/2006/relationships" id="2147483648" r:id="Rcffed83e686440b7"/>
+    <p:sldMasterId xmlns:r="http://schemas.openxmlformats.org/officeDocument/2006/relationships" id="2147483648" r:id="R263f44df8d6f4c4e"/>
   </p:sldMasterIdLst>
   <p:notesMasterIdLst>
-    <p:notesMasterId xmlns:r="http://schemas.openxmlformats.org/officeDocument/2006/relationships" r:id="Rec5116ca5b6d4406"/>
+    <p:notesMasterId xmlns:r="http://schemas.openxmlformats.org/officeDocument/2006/relationships" r:id="Rf8cfd4963b8a45ca"/>
   </p:notesMasterIdLst>
   <p:sldIdLst>
-    <p:sldId xmlns:r="http://schemas.openxmlformats.org/officeDocument/2006/relationships" id="256" r:id="R70f2fb8122a143e3"/>
-    <p:sldId xmlns:r="http://schemas.openxmlformats.org/officeDocument/2006/relationships" id="257" r:id="R2b8105c23204438c"/>
-    <p:sldId xmlns:r="http://schemas.openxmlformats.org/officeDocument/2006/relationships" id="258" r:id="R7363dd76906e44b6"/>
-    <p:sldId xmlns:r="http://schemas.openxmlformats.org/officeDocument/2006/relationships" id="259" r:id="R3bbe767dbc964fbe"/>
-    <p:sldId xmlns:r="http://schemas.openxmlformats.org/officeDocument/2006/relationships" id="260" r:id="R76d7ecbf96f64751"/>
-    <p:sldId xmlns:r="http://schemas.openxmlformats.org/officeDocument/2006/relationships" id="261" r:id="Ra64731bf21ca4775"/>
-    <p:sldId xmlns:r="http://schemas.openxmlformats.org/officeDocument/2006/relationships" id="262" r:id="Rfd4991d09e5c4c83"/>
-    <p:sldId xmlns:r="http://schemas.openxmlformats.org/officeDocument/2006/relationships" id="263" r:id="R2f1bbfb9e5794c92"/>
-    <p:sldId xmlns:r="http://schemas.openxmlformats.org/officeDocument/2006/relationships" id="264" r:id="R25282741b1fc49b8"/>
-    <p:sldId xmlns:r="http://schemas.openxmlformats.org/officeDocument/2006/relationships" id="265" r:id="Rb581c503e40f4d0c"/>
-    <p:sldId xmlns:r="http://schemas.openxmlformats.org/officeDocument/2006/relationships" id="266" r:id="R22f5705bcf55436d"/>
-    <p:sldId xmlns:r="http://schemas.openxmlformats.org/officeDocument/2006/relationships" id="267" r:id="Rd38aa7207c77460a"/>
-    <p:sldId xmlns:r="http://schemas.openxmlformats.org/officeDocument/2006/relationships" id="268" r:id="Rf558f02d4c144158"/>
-    <p:sldId xmlns:r="http://schemas.openxmlformats.org/officeDocument/2006/relationships" id="269" r:id="R7c93be25e1bb42db"/>
-    <p:sldId xmlns:r="http://schemas.openxmlformats.org/officeDocument/2006/relationships" id="270" r:id="Rcc4ed3db59194c39"/>
-    <p:sldId xmlns:r="http://schemas.openxmlformats.org/officeDocument/2006/relationships" id="271" r:id="R8d1bd44f480847ed"/>
-    <p:sldId xmlns:r="http://schemas.openxmlformats.org/officeDocument/2006/relationships" id="272" r:id="R65a23ba236764be3"/>
-    <p:sldId xmlns:r="http://schemas.openxmlformats.org/officeDocument/2006/relationships" id="273" r:id="Ra5737860e902456d"/>
+    <p:sldId xmlns:r="http://schemas.openxmlformats.org/officeDocument/2006/relationships" id="256" r:id="Re7c9cf294a264bc1"/>
+    <p:sldId xmlns:r="http://schemas.openxmlformats.org/officeDocument/2006/relationships" id="257" r:id="Rd3d6e4fe658f4c95"/>
+    <p:sldId xmlns:r="http://schemas.openxmlformats.org/officeDocument/2006/relationships" id="258" r:id="R2169a7e178ea4d48"/>
+    <p:sldId xmlns:r="http://schemas.openxmlformats.org/officeDocument/2006/relationships" id="259" r:id="R32f447573b8a4dfc"/>
+    <p:sldId xmlns:r="http://schemas.openxmlformats.org/officeDocument/2006/relationships" id="260" r:id="R9db968c9b8c94926"/>
+    <p:sldId xmlns:r="http://schemas.openxmlformats.org/officeDocument/2006/relationships" id="261" r:id="R1aab3598c49e4f24"/>
+    <p:sldId xmlns:r="http://schemas.openxmlformats.org/officeDocument/2006/relationships" id="262" r:id="Re8a91494c6db4cfd"/>
+    <p:sldId xmlns:r="http://schemas.openxmlformats.org/officeDocument/2006/relationships" id="263" r:id="Rd659c453e0724367"/>
+    <p:sldId xmlns:r="http://schemas.openxmlformats.org/officeDocument/2006/relationships" id="264" r:id="Rd2119e7162274914"/>
+    <p:sldId xmlns:r="http://schemas.openxmlformats.org/officeDocument/2006/relationships" id="265" r:id="Reb22938acc004214"/>
+    <p:sldId xmlns:r="http://schemas.openxmlformats.org/officeDocument/2006/relationships" id="266" r:id="R691430c9ab894f10"/>
+    <p:sldId xmlns:r="http://schemas.openxmlformats.org/officeDocument/2006/relationships" id="267" r:id="R6f4ac0c400ef4c1d"/>
+    <p:sldId xmlns:r="http://schemas.openxmlformats.org/officeDocument/2006/relationships" id="268" r:id="Rc938d41a64fe45df"/>
+    <p:sldId xmlns:r="http://schemas.openxmlformats.org/officeDocument/2006/relationships" id="269" r:id="R09c2cbc452a74418"/>
+    <p:sldId xmlns:r="http://schemas.openxmlformats.org/officeDocument/2006/relationships" id="270" r:id="R07e8c9cad4d545d2"/>
+    <p:sldId xmlns:r="http://schemas.openxmlformats.org/officeDocument/2006/relationships" id="271" r:id="R3094759e80e54edf"/>
+    <p:sldId xmlns:r="http://schemas.openxmlformats.org/officeDocument/2006/relationships" id="272" r:id="Rf6e57369b710496a"/>
+    <p:sldId xmlns:r="http://schemas.openxmlformats.org/officeDocument/2006/relationships" id="273" r:id="Rd34e40abb03e4d21"/>
   </p:sldIdLst>
   <p:sldSz cx="12192000" cy="6858000"/>
   <p:notesSz cx="6858000" cy="9144000"/>
@@ -459,7 +459,7 @@
           <a:lstStyle xmlns:a="http://schemas.openxmlformats.org/drawingml/2006/main"/>
           <a:p xmlns:a="http://schemas.openxmlformats.org/drawingml/2006/main">
             <a:r>
-              <a:t>Fonte principal: Guia.pdf, enunciado acadêmico ArchCorp, 2026, 13 páginas. Cenário 4 aplicado a uma locadora fictícia inspirada na Localiza, com dados sintéticos. Referência técnica: main f1669d78f01e2d279b3de60a999ed778e6c9916e, PR #75 de 25/10/2026, https://github.com/Roger-Quinelato/projetoAplicado7/pull/75, commit consultado localmente. Marcos previstos conforme orientação da entrega. Autoria e contribuições aguardam informação da equipe. Não há declaração de aceite docente.</a:t>
+              <a:t>Fonte principal: Guia.pdf, enunciado acadêmico ArchCorp, 2026, 13 páginas. Cenário 4 aplicado a uma locadora fictícia inspirada na Localiza, com dados sintéticos. Referência técnica: main f1669d78f01e2d279b3de60a999ed778e6c9916e, PR #75 de 25/10/2026, https://github.com/Roger-Quinelato/projetoAplicado7/pull/75, commit consultado localmente. Marcos previstos conforme orientação da entrega. Autoria: Rodrigo Nenato — backend, produto e negócio; Raquel — frontend e levantamento de requisitos. Não há declaração de aceite docente.</a:t>
             </a:r>
           </a:p>
         </p:txBody>
@@ -669,7 +669,7 @@
           <a:lstStyle xmlns:a="http://schemas.openxmlformats.org/drawingml/2006/main"/>
           <a:p xmlns:a="http://schemas.openxmlformats.org/drawingml/2006/main">
             <a:r>
-              <a:t>Fonte: docs/INTEGRACOES.md, scripts/demo_f3.py e evidência histórica consolidada em docs/EVIDENCIAS_VALIDACAO.md (20/10/2026). Revisão de código e reprodução informadas pela equipe em 28/10: se TicketOpened falha e TicketResolved é consumido antes da recuperação, handle_ticket_resolved retorna sem processo; a abertura reprocessada depois cria STARTED embora o chamado esteja RESOLVED, sem pendências restantes que assegurem a convergência (src/archcorp/workflow/service.py, handle_ticket_resolved). Defeito não corrigido nesta revisão documental. A reconciliação de elegibilidade depende de ação explícita, sem agendador. Os resultados históricos não comprovam todos os casos de ordenação de eventos.</a:t>
+              <a:t>F3: quando o processo ainda não existe, resolução e reconciliação levantam uma falha recuperável. O dispatcher não confirma a inbox e mantém a tentativa disponível; se atingir FAILED, reprocessar explicitamente após recuperar a abertura. Regressões em tests/test_regressoes_fechamento.py cobrem falha temporária, limite de tentativas e reprocessamento, sem duplicação. A resolução preserva estados finais e usa o agregado das tarefas. Não há agendador: o despacho é explícito.</a:t>
             </a:r>
           </a:p>
         </p:txBody>
@@ -1019,7 +1019,7 @@
           <a:lstStyle xmlns:a="http://schemas.openxmlformats.org/drawingml/2006/main"/>
           <a:p xmlns:a="http://schemas.openxmlformats.org/drawingml/2006/main">
             <a:r>
-              <a:t>Fontes: docs/EVIDENCIAS_VALIDACAO.md, seções históricas de 20/10/2026; registro local do commit f1669d78f01e2d279b3de60a999ed778e6c9916e, PR #75, 25/10/2026, https://github.com/Roger-Quinelato/projetoAplicado7/pull/75; logs da CI Verify 40199072801, https://github.com/Roger-Quinelato/projetoAplicado7/actions/runs/40199072801, executada em 25/10 sobre essa main, consultados no GitHub Actions em 28/10/2026. Quatro jobs success: application 252 passed/14 skipped; postgresql 262 passed/4 skipped; rabbitmq 22 passed; e2e 25 passed e axe separado 1 passed. Suítes sobrepostas, sem total agregado. Histórico de 20/10: PostgreSQL 16/RabbitMQ 3.12 locais, contêiner Linux, Python 3.13, 60 clientes, 100 amostras por consulta em 10 consultas de negócio, p95 máximo de 45,1 ms, 22 roteiros de navegador, F1 20/20, F2 14/14 e F3 15/15. O p95 não foi medido novamente na main f1669d7. Verificação local de 28/10: Python 252 aprovados e 14 ignorados, frontend 19 aprovados, TypeScript e OpenAPI check aprovados. Hospedagem pública e PostgreSQL gerenciado sem comprovação.</a:t>
+              <a:t>Fontes: docs/EVIDENCIAS_VALIDACAO.md, seções históricas de 20/10/2026; registro local do commit f1669d78f01e2d279b3de60a999ed778e6c9916e, PR #75, 25/10/2026, https://github.com/Roger-Quinelato/projetoAplicado7/pull/75; logs da CI Verify 40199072801, https://github.com/Roger-Quinelato/projetoAplicado7/actions/runs/40199072801, executada em 25/10 sobre essa main, consultados no GitHub Actions em 28/10/2026. Quatro jobs success: application 252 passed/14 skipped; postgresql 262 passed/4 skipped; rabbitmq 22 passed; e2e 25 passed e axe separado 1 passed. Suítes sobrepostas, sem total agregado. Histórico de 20/10: PostgreSQL 16/RabbitMQ 3.12 locais, contêiner Linux, Python 3.13, 60 clientes, 100 amostras por consulta em 10 consultas de negócio, p95 máximo de 45,1 ms, 22 roteiros de navegador, F1 20/20, F2 14/14 e F3 15/15. O p95 não foi medido novamente na main f1669d7. Verificação local após correções em 28/10: Python 264 aprovados e 14 ignorados, frontend 19 aprovados, TypeScript e OpenAPI check aprovados. Hospedagem pública e PostgreSQL gerenciado sem comprovação.</a:t>
             </a:r>
           </a:p>
         </p:txBody>
@@ -1089,7 +1089,7 @@
           <a:lstStyle xmlns:a="http://schemas.openxmlformats.org/drawingml/2006/main"/>
           <a:p xmlns:a="http://schemas.openxmlformats.org/drawingml/2006/main">
             <a:r>
-              <a:t>Fontes: relatório técnico, seções 3.1, 3.4, 4.10 e 5, docs/EVOLUCAO_MANUTENCAO.md e ADR-006 (Proposto). Revisão e reproduções informadas em 28/10/2026: F3 perde a convergência se TicketResolved é consumido antes de recuperar TicketOpened; encerramento de contrato pode deixar processo COMPLETED com tarefa CANCELLED; leitura financeira calcula OVERDUE enquanto o comando de cancelamento usa OPEN persistido. Conferência: src/archcorp/workflow/service.py (handle_ticket_resolved e handle_contract_closed), src/archcorp/finance/service.py (cancel) e domain.py. Defeitos conhecidos não corrigidos nesta revisão documental. Verificação local de 28/10 informada: Python 252 aprovados/14 ignorados, frontend 19 aprovados, TypeScript e OpenAPI check aprovados. Não somar suítes. Marcos previstos conforme orientação da entrega. Nomes e contribuições individuais necessários para a submissão. Premissas e ADR-006 aguardam validação ou aceite. Publicação, OIDC e agendador são evolução. O merge do PR #75 não equivale a aceite docente nem à validação das premissas.</a:t>
+              <a:t>Correções de fechamento: F3 não confirma resolução/reconciliação sem processo; eventos mantêm retentativa e reprocessamento explícito. Encerramento do contrato cancela tarefas pendentes e deriva o estado agregado, preservando tarefas finais. Cancelamento financeiro usa a data UTC e o estado efetivo da consulta; vencida recebe 409. As correções não alteram registros antigos já consumidos. Autoria declarada: Rodrigo Nenato — backend, produto e negócio; Raquel — frontend e levantamento de requisitos. Permanecem ensaio, aceite docente e comprovação da hospedagem prevista no plano. OIDC, tracing distribuído e consumo pelo broker são evoluções.</a:t>
             </a:r>
           </a:p>
         </p:txBody>
@@ -1696,7 +1696,7 @@
           <p:cNvPr id="3" name="Title">
             <a:extLst xmlns:a="http://schemas.openxmlformats.org/drawingml/2006/main">
               <a:ext uri="{FF2B5EF4-FFF2-40B4-BE49-F238E27FC236}">
-                <a16:creationId xmlns:a16="http://schemas.microsoft.com/office/drawing/2014/main" id="{52F22302-607E-4512-BF2F-35012247082E}"/>
+                <a16:creationId xmlns:a16="http://schemas.microsoft.com/office/drawing/2014/main" id="{BA0B2BB4-7244-478E-9A22-4F0FEB1ED1D4}"/>
               </a:ext>
             </a:extLst>
           </p:cNvPr>
@@ -1925,7 +1925,7 @@
           <p:cNvPr id="2" name="Subtitle">
             <a:extLst xmlns:a="http://schemas.openxmlformats.org/drawingml/2006/main">
               <a:ext uri="{FF2B5EF4-FFF2-40B4-BE49-F238E27FC236}">
-                <a16:creationId xmlns:a16="http://schemas.microsoft.com/office/drawing/2014/main" id="{E14BB22B-78CA-4208-9251-2A613260C8CF}"/>
+                <a16:creationId xmlns:a16="http://schemas.microsoft.com/office/drawing/2014/main" id="{B0BED536-0E84-47CF-9BFF-A736444B7DE6}"/>
               </a:ext>
             </a:extLst>
           </p:cNvPr>
@@ -2171,7 +2171,7 @@
           <p:cNvPr id="2" name="Section title">
             <a:extLst xmlns:a="http://schemas.openxmlformats.org/drawingml/2006/main">
               <a:ext uri="{FF2B5EF4-FFF2-40B4-BE49-F238E27FC236}">
-                <a16:creationId xmlns:a16="http://schemas.microsoft.com/office/drawing/2014/main" id="{3CF94330-2524-4EBB-AEF8-E29845BE2AF3}"/>
+                <a16:creationId xmlns:a16="http://schemas.microsoft.com/office/drawing/2014/main" id="{5D12B58F-3AA3-45D0-90E1-5FCBFD0CC049}"/>
               </a:ext>
             </a:extLst>
           </p:cNvPr>
@@ -2417,7 +2417,7 @@
           <p:cNvPr id="3" name="Title">
             <a:extLst xmlns:a="http://schemas.openxmlformats.org/drawingml/2006/main">
               <a:ext uri="{FF2B5EF4-FFF2-40B4-BE49-F238E27FC236}">
-                <a16:creationId xmlns:a16="http://schemas.microsoft.com/office/drawing/2014/main" id="{721AE563-DBC9-42F5-B80D-C607DCB7F038}"/>
+                <a16:creationId xmlns:a16="http://schemas.microsoft.com/office/drawing/2014/main" id="{0CD1FB1A-6B73-4879-ADE7-86A173BCC463}"/>
               </a:ext>
             </a:extLst>
           </p:cNvPr>
@@ -2646,7 +2646,7 @@
           <p:cNvPr id="2" name="Body">
             <a:extLst xmlns:a="http://schemas.openxmlformats.org/drawingml/2006/main">
               <a:ext uri="{FF2B5EF4-FFF2-40B4-BE49-F238E27FC236}">
-                <a16:creationId xmlns:a16="http://schemas.microsoft.com/office/drawing/2014/main" id="{BA95F0B2-2A24-40EB-9361-5E15DDDF2149}"/>
+                <a16:creationId xmlns:a16="http://schemas.microsoft.com/office/drawing/2014/main" id="{D057DEEB-7C4E-4183-831C-52DAF578A70F}"/>
               </a:ext>
             </a:extLst>
           </p:cNvPr>
@@ -2892,7 +2892,7 @@
           <p:cNvPr id="4" name="Title">
             <a:extLst xmlns:a="http://schemas.openxmlformats.org/drawingml/2006/main">
               <a:ext uri="{FF2B5EF4-FFF2-40B4-BE49-F238E27FC236}">
-                <a16:creationId xmlns:a16="http://schemas.microsoft.com/office/drawing/2014/main" id="{78E8EB24-8293-4430-875A-5C7748B62647}"/>
+                <a16:creationId xmlns:a16="http://schemas.microsoft.com/office/drawing/2014/main" id="{2E3CC9A2-2C94-40CE-A388-15450A3A9FD4}"/>
               </a:ext>
             </a:extLst>
           </p:cNvPr>
@@ -3121,7 +3121,7 @@
           <p:cNvPr id="2" name="Left column">
             <a:extLst xmlns:a="http://schemas.openxmlformats.org/drawingml/2006/main">
               <a:ext uri="{FF2B5EF4-FFF2-40B4-BE49-F238E27FC236}">
-                <a16:creationId xmlns:a16="http://schemas.microsoft.com/office/drawing/2014/main" id="{919CB7B3-A0DB-46DC-B133-293C706F676F}"/>
+                <a16:creationId xmlns:a16="http://schemas.microsoft.com/office/drawing/2014/main" id="{0A2E2781-3032-4026-8F18-F3424ABF6636}"/>
               </a:ext>
             </a:extLst>
           </p:cNvPr>
@@ -3350,7 +3350,7 @@
           <p:cNvPr id="3" name="Right column">
             <a:extLst xmlns:a="http://schemas.openxmlformats.org/drawingml/2006/main">
               <a:ext uri="{FF2B5EF4-FFF2-40B4-BE49-F238E27FC236}">
-                <a16:creationId xmlns:a16="http://schemas.microsoft.com/office/drawing/2014/main" id="{DA6BEEC1-7019-4639-8343-154E984ED655}"/>
+                <a16:creationId xmlns:a16="http://schemas.microsoft.com/office/drawing/2014/main" id="{20E20029-0D81-49EE-AC93-18BAA0CA9F22}"/>
               </a:ext>
             </a:extLst>
           </p:cNvPr>
@@ -3596,7 +3596,7 @@
           <p:cNvPr id="3" name="Title">
             <a:extLst xmlns:a="http://schemas.openxmlformats.org/drawingml/2006/main">
               <a:ext uri="{FF2B5EF4-FFF2-40B4-BE49-F238E27FC236}">
-                <a16:creationId xmlns:a16="http://schemas.microsoft.com/office/drawing/2014/main" id="{86A42B9C-010B-43A0-B4B9-1357D249C352}"/>
+                <a16:creationId xmlns:a16="http://schemas.microsoft.com/office/drawing/2014/main" id="{76B5DCD2-7D14-43D9-8C73-064C74E36620}"/>
               </a:ext>
             </a:extLst>
           </p:cNvPr>
@@ -3825,7 +3825,7 @@
           <p:cNvPr id="2" name="Left column">
             <a:extLst xmlns:a="http://schemas.openxmlformats.org/drawingml/2006/main">
               <a:ext uri="{FF2B5EF4-FFF2-40B4-BE49-F238E27FC236}">
-                <a16:creationId xmlns:a16="http://schemas.microsoft.com/office/drawing/2014/main" id="{8C42A9B8-8B44-4C2D-BC31-948054B892B0}"/>
+                <a16:creationId xmlns:a16="http://schemas.microsoft.com/office/drawing/2014/main" id="{B0DA4D31-73BA-4649-B98D-C97B4D84B10E}"/>
               </a:ext>
             </a:extLst>
           </p:cNvPr>
@@ -4092,12 +4092,12 @@
   </p:cSld>
   <p:clrMap bg1="lt1" tx1="dk1" bg2="lt2" tx2="dk2" accent1="accent1" accent2="accent2" accent3="accent3" accent4="accent4" accent5="accent5" accent6="accent6" hlink="hlink" folHlink="folHlink"/>
   <p:sldLayoutIdLst>
-    <p:sldLayoutId xmlns:r="http://schemas.openxmlformats.org/officeDocument/2006/relationships" id="2147483649" r:id="Rb41eaf8d157d4840"/>
-    <p:sldLayoutId xmlns:r="http://schemas.openxmlformats.org/officeDocument/2006/relationships" id="2147483650" r:id="Raa6cf94ebf6942d2"/>
-    <p:sldLayoutId xmlns:r="http://schemas.openxmlformats.org/officeDocument/2006/relationships" id="2147483651" r:id="R8dbe8aacf4104f9c"/>
-    <p:sldLayoutId xmlns:r="http://schemas.openxmlformats.org/officeDocument/2006/relationships" id="2147483652" r:id="R3743a4b4ce024896"/>
-    <p:sldLayoutId xmlns:r="http://schemas.openxmlformats.org/officeDocument/2006/relationships" id="2147483653" r:id="R0da1412da5ec4cf7"/>
-    <p:sldLayoutId xmlns:r="http://schemas.openxmlformats.org/officeDocument/2006/relationships" id="2147483654" r:id="R2655f55d261a4ac3"/>
+    <p:sldLayoutId xmlns:r="http://schemas.openxmlformats.org/officeDocument/2006/relationships" id="2147483649" r:id="R084c054ab8264d07"/>
+    <p:sldLayoutId xmlns:r="http://schemas.openxmlformats.org/officeDocument/2006/relationships" id="2147483650" r:id="R964daba3d9324441"/>
+    <p:sldLayoutId xmlns:r="http://schemas.openxmlformats.org/officeDocument/2006/relationships" id="2147483651" r:id="R3276124c2d8145c5"/>
+    <p:sldLayoutId xmlns:r="http://schemas.openxmlformats.org/officeDocument/2006/relationships" id="2147483652" r:id="R5ee089717fc940b5"/>
+    <p:sldLayoutId xmlns:r="http://schemas.openxmlformats.org/officeDocument/2006/relationships" id="2147483653" r:id="Ra6aceb5927eb4788"/>
+    <p:sldLayoutId xmlns:r="http://schemas.openxmlformats.org/officeDocument/2006/relationships" id="2147483654" r:id="Rf09e96a51af44460"/>
   </p:sldLayoutIdLst>
   <p:txStyles>
     <p:titleStyle>
@@ -4648,7 +4648,7 @@
           <p:cNvPr id="5" name="">
             <a:extLst xmlns:a="http://schemas.openxmlformats.org/drawingml/2006/main">
               <a:ext uri="{FF2B5EF4-FFF2-40B4-BE49-F238E27FC236}">
-                <a16:creationId xmlns:a16="http://schemas.microsoft.com/office/drawing/2014/main" id="{94A34BB2-6415-4ED6-9749-A783D475E966}"/>
+                <a16:creationId xmlns:a16="http://schemas.microsoft.com/office/drawing/2014/main" id="{0BEC27C4-84C4-47AF-9942-2D46F314F688}"/>
               </a:ext>
             </a:extLst>
           </p:cNvPr>
@@ -4829,7 +4829,7 @@
           <p:cNvPr id="2" name="">
             <a:extLst xmlns:a="http://schemas.openxmlformats.org/drawingml/2006/main">
               <a:ext uri="{FF2B5EF4-FFF2-40B4-BE49-F238E27FC236}">
-                <a16:creationId xmlns:a16="http://schemas.microsoft.com/office/drawing/2014/main" id="{1734B3C5-A2A6-4F48-8C53-8BA55A626BA1}"/>
+                <a16:creationId xmlns:a16="http://schemas.microsoft.com/office/drawing/2014/main" id="{78486A8B-47B0-4215-AAB8-6CCF4B69FBEA}"/>
               </a:ext>
             </a:extLst>
           </p:cNvPr>
@@ -4987,7 +4987,7 @@
           <p:cNvPr id="3" name="">
             <a:extLst xmlns:a="http://schemas.openxmlformats.org/drawingml/2006/main">
               <a:ext uri="{FF2B5EF4-FFF2-40B4-BE49-F238E27FC236}">
-                <a16:creationId xmlns:a16="http://schemas.microsoft.com/office/drawing/2014/main" id="{8178BC73-9D93-4172-B43E-38C2B5247D65}"/>
+                <a16:creationId xmlns:a16="http://schemas.microsoft.com/office/drawing/2014/main" id="{009C5590-A2C6-44EC-865A-F10E290D15D0}"/>
               </a:ext>
             </a:extLst>
           </p:cNvPr>
@@ -5017,7 +5017,7 @@
           <p:cNvPr id="4" name="">
             <a:extLst xmlns:a="http://schemas.openxmlformats.org/drawingml/2006/main">
               <a:ext uri="{FF2B5EF4-FFF2-40B4-BE49-F238E27FC236}">
-                <a16:creationId xmlns:a16="http://schemas.microsoft.com/office/drawing/2014/main" id="{65E67ADC-C81A-48E3-B0D4-7FAFD883C512}"/>
+                <a16:creationId xmlns:a16="http://schemas.microsoft.com/office/drawing/2014/main" id="{A120F43E-6AE8-4DAF-A387-FBFDA468E16D}"/>
               </a:ext>
             </a:extLst>
           </p:cNvPr>
@@ -5165,7 +5165,30 @@
                 <a:ea typeface="Arial"/>
                 <a:cs typeface="Arial"/>
               </a:rPr>
-              <a:t>Nomes e contribuições individuais ainda não informados</a:t>
+              <a:t>Rodrigo Nenato — backend, produto e negócio</a:t>
+            </a:r>
+          </a:p>
+          <a:p xmlns:a="http://schemas.openxmlformats.org/drawingml/2006/main">
+            <a:pPr>
+              <a:defRPr sz="1500" b="0">
+                <a:solidFill>
+                  <a:srgbClr val="FFFFFF"/>
+                </a:solidFill>
+                <a:latin typeface="Arial"/>
+                <a:ea typeface="Arial"/>
+                <a:cs typeface="Arial"/>
+              </a:defRPr>
+            </a:pPr>
+            <a:r>
+              <a:rPr sz="1500" b="0">
+                <a:solidFill>
+                  <a:srgbClr val="FFFFFF"/>
+                </a:solidFill>
+                <a:latin typeface="Arial"/>
+                <a:ea typeface="Arial"/>
+                <a:cs typeface="Arial"/>
+              </a:rPr>
+              <a:t>Raquel — frontend e levantamento de requisitos</a:t>
             </a:r>
           </a:p>
           <a:p xmlns:a="http://schemas.openxmlformats.org/drawingml/2006/main">
@@ -5219,7 +5242,7 @@
     </p:spTree>
     <p:extLst>
       <p:ext uri="{BB962C8B-B14F-4D97-AF65-F5344CB8AC3E}">
-        <p14:creationId xmlns:p14="http://schemas.microsoft.com/office/powerpoint/2010/main" val="1661073413"/>
+        <p14:creationId xmlns:p14="http://schemas.microsoft.com/office/powerpoint/2010/main" val="321175279"/>
       </p:ext>
     </p:extLst>
   </p:cSld>
@@ -5250,7 +5273,7 @@
           <p:cNvPr id="8" name="">
             <a:extLst xmlns:a="http://schemas.openxmlformats.org/drawingml/2006/main">
               <a:ext uri="{FF2B5EF4-FFF2-40B4-BE49-F238E27FC236}">
-                <a16:creationId xmlns:a16="http://schemas.microsoft.com/office/drawing/2014/main" id="{87652935-0135-447D-B292-4723B1163553}"/>
+                <a16:creationId xmlns:a16="http://schemas.microsoft.com/office/drawing/2014/main" id="{13B97BC0-232A-4C2B-A19D-7D696C467CB7}"/>
               </a:ext>
             </a:extLst>
           </p:cNvPr>
@@ -5282,7 +5305,7 @@
           <p:cNvPr id="7" name="">
             <a:extLst xmlns:a="http://schemas.openxmlformats.org/drawingml/2006/main">
               <a:ext uri="{FF2B5EF4-FFF2-40B4-BE49-F238E27FC236}">
-                <a16:creationId xmlns:a16="http://schemas.microsoft.com/office/drawing/2014/main" id="{CE5C28A6-4EFD-4F08-BA19-46F874BA5766}"/>
+                <a16:creationId xmlns:a16="http://schemas.microsoft.com/office/drawing/2014/main" id="{54136C9E-F0F8-4BDB-AB75-4279950F8491}"/>
               </a:ext>
             </a:extLst>
           </p:cNvPr>
@@ -5314,7 +5337,7 @@
           <p:cNvPr id="12" name="">
             <a:extLst xmlns:a="http://schemas.openxmlformats.org/drawingml/2006/main">
               <a:ext uri="{FF2B5EF4-FFF2-40B4-BE49-F238E27FC236}">
-                <a16:creationId xmlns:a16="http://schemas.microsoft.com/office/drawing/2014/main" id="{008BB7EB-F761-4D4C-B6F1-CE014F37662D}"/>
+                <a16:creationId xmlns:a16="http://schemas.microsoft.com/office/drawing/2014/main" id="{401E513E-008F-4994-A21C-C8B01A81B5B4}"/>
               </a:ext>
             </a:extLst>
           </p:cNvPr>
@@ -5344,7 +5367,7 @@
           <p:cNvPr id="2" name="">
             <a:extLst xmlns:a="http://schemas.openxmlformats.org/drawingml/2006/main">
               <a:ext uri="{FF2B5EF4-FFF2-40B4-BE49-F238E27FC236}">
-                <a16:creationId xmlns:a16="http://schemas.microsoft.com/office/drawing/2014/main" id="{34ED6DCB-7A5F-45C0-A38F-4B20609D5000}"/>
+                <a16:creationId xmlns:a16="http://schemas.microsoft.com/office/drawing/2014/main" id="{20B74C03-5111-4452-992D-C8BE751DB905}"/>
               </a:ext>
             </a:extLst>
           </p:cNvPr>
@@ -5502,7 +5525,7 @@
           <p:cNvPr id="3" name="">
             <a:extLst xmlns:a="http://schemas.openxmlformats.org/drawingml/2006/main">
               <a:ext uri="{FF2B5EF4-FFF2-40B4-BE49-F238E27FC236}">
-                <a16:creationId xmlns:a16="http://schemas.microsoft.com/office/drawing/2014/main" id="{912CA445-9B14-4DB6-91C9-4DF9F3D96E0D}"/>
+                <a16:creationId xmlns:a16="http://schemas.microsoft.com/office/drawing/2014/main" id="{E524790C-DF12-43FD-B2C5-D5F059A8387B}"/>
               </a:ext>
             </a:extLst>
           </p:cNvPr>
@@ -5660,7 +5683,7 @@
           <p:cNvPr id="4" name="">
             <a:extLst xmlns:a="http://schemas.openxmlformats.org/drawingml/2006/main">
               <a:ext uri="{FF2B5EF4-FFF2-40B4-BE49-F238E27FC236}">
-                <a16:creationId xmlns:a16="http://schemas.microsoft.com/office/drawing/2014/main" id="{96D2DA12-A3E2-4140-8AD4-EF7BEE12FDD8}"/>
+                <a16:creationId xmlns:a16="http://schemas.microsoft.com/office/drawing/2014/main" id="{5BFB74E5-9C69-4807-B452-F8DD4304E463}"/>
               </a:ext>
             </a:extLst>
           </p:cNvPr>
@@ -5848,7 +5871,7 @@
           <p:cNvPr id="5" name="">
             <a:extLst xmlns:a="http://schemas.openxmlformats.org/drawingml/2006/main">
               <a:ext uri="{FF2B5EF4-FFF2-40B4-BE49-F238E27FC236}">
-                <a16:creationId xmlns:a16="http://schemas.microsoft.com/office/drawing/2014/main" id="{BC0D5546-0889-49AF-A3BA-BAFAC8B4469E}"/>
+                <a16:creationId xmlns:a16="http://schemas.microsoft.com/office/drawing/2014/main" id="{0937EF6C-B898-4F07-A3B8-7BFC1A2EBC90}"/>
               </a:ext>
             </a:extLst>
           </p:cNvPr>
@@ -6036,7 +6059,7 @@
           <p:cNvPr id="6" name="">
             <a:extLst xmlns:a="http://schemas.openxmlformats.org/drawingml/2006/main">
               <a:ext uri="{FF2B5EF4-FFF2-40B4-BE49-F238E27FC236}">
-                <a16:creationId xmlns:a16="http://schemas.microsoft.com/office/drawing/2014/main" id="{B299E4EA-7702-4808-8D75-25D6CE596CE0}"/>
+                <a16:creationId xmlns:a16="http://schemas.microsoft.com/office/drawing/2014/main" id="{D4033466-2891-4FE3-8DB1-D5D63C3A3D9F}"/>
               </a:ext>
             </a:extLst>
           </p:cNvPr>
@@ -6224,7 +6247,7 @@
           <p:cNvPr id="9" name="">
             <a:extLst xmlns:a="http://schemas.openxmlformats.org/drawingml/2006/main">
               <a:ext uri="{FF2B5EF4-FFF2-40B4-BE49-F238E27FC236}">
-                <a16:creationId xmlns:a16="http://schemas.microsoft.com/office/drawing/2014/main" id="{BA509EA9-6C3C-4504-ABE6-05CD19AA8CF5}"/>
+                <a16:creationId xmlns:a16="http://schemas.microsoft.com/office/drawing/2014/main" id="{AF16BF74-BA20-4F59-BC31-6B01C07CC152}"/>
               </a:ext>
             </a:extLst>
           </p:cNvPr>
@@ -6382,7 +6405,7 @@
           <p:cNvPr id="10" name="">
             <a:extLst xmlns:a="http://schemas.openxmlformats.org/drawingml/2006/main">
               <a:ext uri="{FF2B5EF4-FFF2-40B4-BE49-F238E27FC236}">
-                <a16:creationId xmlns:a16="http://schemas.microsoft.com/office/drawing/2014/main" id="{D01A5814-3094-4A3D-9320-C8263F29903A}"/>
+                <a16:creationId xmlns:a16="http://schemas.microsoft.com/office/drawing/2014/main" id="{56575D22-3547-42EF-82AF-F63520CA8D15}"/>
               </a:ext>
             </a:extLst>
           </p:cNvPr>
@@ -6540,7 +6563,7 @@
           <p:cNvPr id="11" name="">
             <a:extLst xmlns:a="http://schemas.openxmlformats.org/drawingml/2006/main">
               <a:ext uri="{FF2B5EF4-FFF2-40B4-BE49-F238E27FC236}">
-                <a16:creationId xmlns:a16="http://schemas.microsoft.com/office/drawing/2014/main" id="{D483107D-F279-4A8A-9BE0-B7D92DE082E5}"/>
+                <a16:creationId xmlns:a16="http://schemas.microsoft.com/office/drawing/2014/main" id="{3C04CB50-6172-49D9-80C9-EC972A77B704}"/>
               </a:ext>
             </a:extLst>
           </p:cNvPr>
@@ -6696,7 +6719,7 @@
     </p:spTree>
     <p:extLst>
       <p:ext uri="{BB962C8B-B14F-4D97-AF65-F5344CB8AC3E}">
-        <p14:creationId xmlns:p14="http://schemas.microsoft.com/office/powerpoint/2010/main" val="45429468"/>
+        <p14:creationId xmlns:p14="http://schemas.microsoft.com/office/powerpoint/2010/main" val="188665233"/>
       </p:ext>
     </p:extLst>
   </p:cSld>
@@ -6727,7 +6750,7 @@
           <p:cNvPr id="10" name="">
             <a:extLst xmlns:a="http://schemas.openxmlformats.org/drawingml/2006/main">
               <a:ext uri="{FF2B5EF4-FFF2-40B4-BE49-F238E27FC236}">
-                <a16:creationId xmlns:a16="http://schemas.microsoft.com/office/drawing/2014/main" id="{C56036B1-CA3A-4E3D-AF9A-EF5B504039C5}"/>
+                <a16:creationId xmlns:a16="http://schemas.microsoft.com/office/drawing/2014/main" id="{C52D0663-994A-4A30-97F6-1B02F8C1DDCD}"/>
               </a:ext>
             </a:extLst>
           </p:cNvPr>
@@ -6761,7 +6784,7 @@
           <p:cNvPr id="9" name="">
             <a:extLst xmlns:a="http://schemas.openxmlformats.org/drawingml/2006/main">
               <a:ext uri="{FF2B5EF4-FFF2-40B4-BE49-F238E27FC236}">
-                <a16:creationId xmlns:a16="http://schemas.microsoft.com/office/drawing/2014/main" id="{27738231-D583-42BD-ABF9-A4C8B7F27237}"/>
+                <a16:creationId xmlns:a16="http://schemas.microsoft.com/office/drawing/2014/main" id="{971068AA-B663-4570-BC07-7AB313B6FF58}"/>
               </a:ext>
             </a:extLst>
           </p:cNvPr>
@@ -6795,7 +6818,7 @@
           <p:cNvPr id="8" name="">
             <a:extLst xmlns:a="http://schemas.openxmlformats.org/drawingml/2006/main">
               <a:ext uri="{FF2B5EF4-FFF2-40B4-BE49-F238E27FC236}">
-                <a16:creationId xmlns:a16="http://schemas.microsoft.com/office/drawing/2014/main" id="{B8158F6A-DD21-4D59-941D-39AFE2763E4A}"/>
+                <a16:creationId xmlns:a16="http://schemas.microsoft.com/office/drawing/2014/main" id="{DED54A40-72EE-42AF-B944-A44FFA8AABCB}"/>
               </a:ext>
             </a:extLst>
           </p:cNvPr>
@@ -6827,7 +6850,7 @@
           <p:cNvPr id="13" name="">
             <a:extLst xmlns:a="http://schemas.openxmlformats.org/drawingml/2006/main">
               <a:ext uri="{FF2B5EF4-FFF2-40B4-BE49-F238E27FC236}">
-                <a16:creationId xmlns:a16="http://schemas.microsoft.com/office/drawing/2014/main" id="{34C8D0C5-198D-4B22-86BC-88689B1CA833}"/>
+                <a16:creationId xmlns:a16="http://schemas.microsoft.com/office/drawing/2014/main" id="{78030D89-0390-4C9A-BFB7-5A220A006913}"/>
               </a:ext>
             </a:extLst>
           </p:cNvPr>
@@ -6857,7 +6880,7 @@
           <p:cNvPr id="2" name="">
             <a:extLst xmlns:a="http://schemas.openxmlformats.org/drawingml/2006/main">
               <a:ext uri="{FF2B5EF4-FFF2-40B4-BE49-F238E27FC236}">
-                <a16:creationId xmlns:a16="http://schemas.microsoft.com/office/drawing/2014/main" id="{E423AF2C-704C-4B0D-90C2-F4E0631AF13A}"/>
+                <a16:creationId xmlns:a16="http://schemas.microsoft.com/office/drawing/2014/main" id="{3B2E59E6-EA69-4DC2-85A7-CD80E09FF954}"/>
               </a:ext>
             </a:extLst>
           </p:cNvPr>
@@ -7015,7 +7038,7 @@
           <p:cNvPr id="3" name="">
             <a:extLst xmlns:a="http://schemas.openxmlformats.org/drawingml/2006/main">
               <a:ext uri="{FF2B5EF4-FFF2-40B4-BE49-F238E27FC236}">
-                <a16:creationId xmlns:a16="http://schemas.microsoft.com/office/drawing/2014/main" id="{083B975A-CF8D-413E-9DC1-A782B88AD140}"/>
+                <a16:creationId xmlns:a16="http://schemas.microsoft.com/office/drawing/2014/main" id="{D636352F-EB34-49F0-A0C9-45A234C5E329}"/>
               </a:ext>
             </a:extLst>
           </p:cNvPr>
@@ -7173,7 +7196,7 @@
           <p:cNvPr id="4" name="">
             <a:extLst xmlns:a="http://schemas.openxmlformats.org/drawingml/2006/main">
               <a:ext uri="{FF2B5EF4-FFF2-40B4-BE49-F238E27FC236}">
-                <a16:creationId xmlns:a16="http://schemas.microsoft.com/office/drawing/2014/main" id="{3F521CF9-78BE-4A25-AFBD-A80BE9335A23}"/>
+                <a16:creationId xmlns:a16="http://schemas.microsoft.com/office/drawing/2014/main" id="{53975614-DECA-4EC0-A94F-23714780D214}"/>
               </a:ext>
             </a:extLst>
           </p:cNvPr>
@@ -7361,7 +7384,7 @@
           <p:cNvPr id="5" name="">
             <a:extLst xmlns:a="http://schemas.openxmlformats.org/drawingml/2006/main">
               <a:ext uri="{FF2B5EF4-FFF2-40B4-BE49-F238E27FC236}">
-                <a16:creationId xmlns:a16="http://schemas.microsoft.com/office/drawing/2014/main" id="{A903E73B-96E9-4CEA-AA5D-EE3B42F6CC6A}"/>
+                <a16:creationId xmlns:a16="http://schemas.microsoft.com/office/drawing/2014/main" id="{ED866979-D392-4D0C-883D-0892E08EFA09}"/>
               </a:ext>
             </a:extLst>
           </p:cNvPr>
@@ -7549,7 +7572,7 @@
           <p:cNvPr id="6" name="">
             <a:extLst xmlns:a="http://schemas.openxmlformats.org/drawingml/2006/main">
               <a:ext uri="{FF2B5EF4-FFF2-40B4-BE49-F238E27FC236}">
-                <a16:creationId xmlns:a16="http://schemas.microsoft.com/office/drawing/2014/main" id="{B8603890-0CC4-4483-B63F-BF4BD491F460}"/>
+                <a16:creationId xmlns:a16="http://schemas.microsoft.com/office/drawing/2014/main" id="{03CB2C27-39BC-4B2A-932A-1B5C4081AEF2}"/>
               </a:ext>
             </a:extLst>
           </p:cNvPr>
@@ -7737,7 +7760,7 @@
           <p:cNvPr id="7" name="">
             <a:extLst xmlns:a="http://schemas.openxmlformats.org/drawingml/2006/main">
               <a:ext uri="{FF2B5EF4-FFF2-40B4-BE49-F238E27FC236}">
-                <a16:creationId xmlns:a16="http://schemas.microsoft.com/office/drawing/2014/main" id="{1E3DEC25-5603-4F28-8DEE-69898B48FEDA}"/>
+                <a16:creationId xmlns:a16="http://schemas.microsoft.com/office/drawing/2014/main" id="{3452FF20-FEB2-4F1E-8745-DEDDA6C9F5D8}"/>
               </a:ext>
             </a:extLst>
           </p:cNvPr>
@@ -7925,7 +7948,7 @@
           <p:cNvPr id="11" name="">
             <a:extLst xmlns:a="http://schemas.openxmlformats.org/drawingml/2006/main">
               <a:ext uri="{FF2B5EF4-FFF2-40B4-BE49-F238E27FC236}">
-                <a16:creationId xmlns:a16="http://schemas.microsoft.com/office/drawing/2014/main" id="{0B676A44-4AB3-47BC-8E1E-88982A542B29}"/>
+                <a16:creationId xmlns:a16="http://schemas.microsoft.com/office/drawing/2014/main" id="{C57E248B-A7C2-4C3F-A1BC-9D7C03393747}"/>
               </a:ext>
             </a:extLst>
           </p:cNvPr>
@@ -8083,7 +8106,7 @@
           <p:cNvPr id="12" name="">
             <a:extLst xmlns:a="http://schemas.openxmlformats.org/drawingml/2006/main">
               <a:ext uri="{FF2B5EF4-FFF2-40B4-BE49-F238E27FC236}">
-                <a16:creationId xmlns:a16="http://schemas.microsoft.com/office/drawing/2014/main" id="{55B42EC4-F1F3-44A5-A1D5-606C2DE8CB4B}"/>
+                <a16:creationId xmlns:a16="http://schemas.microsoft.com/office/drawing/2014/main" id="{933EEBBD-91E4-44E5-BCFF-3925997AC8E8}"/>
               </a:ext>
             </a:extLst>
           </p:cNvPr>
@@ -8239,7 +8262,7 @@
     </p:spTree>
     <p:extLst>
       <p:ext uri="{BB962C8B-B14F-4D97-AF65-F5344CB8AC3E}">
-        <p14:creationId xmlns:p14="http://schemas.microsoft.com/office/powerpoint/2010/main" val="1379234653"/>
+        <p14:creationId xmlns:p14="http://schemas.microsoft.com/office/powerpoint/2010/main" val="1064481190"/>
       </p:ext>
     </p:extLst>
   </p:cSld>
@@ -8270,7 +8293,7 @@
           <p:cNvPr id="10" name="">
             <a:extLst xmlns:a="http://schemas.openxmlformats.org/drawingml/2006/main">
               <a:ext uri="{FF2B5EF4-FFF2-40B4-BE49-F238E27FC236}">
-                <a16:creationId xmlns:a16="http://schemas.microsoft.com/office/drawing/2014/main" id="{384D1B37-5662-46CD-8DB9-5ADD6656C63D}"/>
+                <a16:creationId xmlns:a16="http://schemas.microsoft.com/office/drawing/2014/main" id="{8CCA31DF-DCE8-4E13-96EE-34B0BB8E40C8}"/>
               </a:ext>
             </a:extLst>
           </p:cNvPr>
@@ -8302,7 +8325,7 @@
           <p:cNvPr id="9" name="">
             <a:extLst xmlns:a="http://schemas.openxmlformats.org/drawingml/2006/main">
               <a:ext uri="{FF2B5EF4-FFF2-40B4-BE49-F238E27FC236}">
-                <a16:creationId xmlns:a16="http://schemas.microsoft.com/office/drawing/2014/main" id="{01BCB684-519F-4B51-8762-EFE8CA70AC2D}"/>
+                <a16:creationId xmlns:a16="http://schemas.microsoft.com/office/drawing/2014/main" id="{E4A4159A-4E8D-4E4C-A4E2-607B52C173A5}"/>
               </a:ext>
             </a:extLst>
           </p:cNvPr>
@@ -8334,7 +8357,7 @@
           <p:cNvPr id="8" name="">
             <a:extLst xmlns:a="http://schemas.openxmlformats.org/drawingml/2006/main">
               <a:ext uri="{FF2B5EF4-FFF2-40B4-BE49-F238E27FC236}">
-                <a16:creationId xmlns:a16="http://schemas.microsoft.com/office/drawing/2014/main" id="{2B3D7872-3BA7-4465-874A-1199C8D6FBF7}"/>
+                <a16:creationId xmlns:a16="http://schemas.microsoft.com/office/drawing/2014/main" id="{38DDB58B-16A7-4071-954B-2C478CDB32E3}"/>
               </a:ext>
             </a:extLst>
           </p:cNvPr>
@@ -8368,7 +8391,7 @@
           <p:cNvPr id="13" name="">
             <a:extLst xmlns:a="http://schemas.openxmlformats.org/drawingml/2006/main">
               <a:ext uri="{FF2B5EF4-FFF2-40B4-BE49-F238E27FC236}">
-                <a16:creationId xmlns:a16="http://schemas.microsoft.com/office/drawing/2014/main" id="{3DADAE7B-8064-47DD-B8F4-F495A010F978}"/>
+                <a16:creationId xmlns:a16="http://schemas.microsoft.com/office/drawing/2014/main" id="{53C0CC52-6FC3-4B17-93D9-C608EE36F82E}"/>
               </a:ext>
             </a:extLst>
           </p:cNvPr>
@@ -8398,7 +8421,7 @@
           <p:cNvPr id="2" name="">
             <a:extLst xmlns:a="http://schemas.openxmlformats.org/drawingml/2006/main">
               <a:ext uri="{FF2B5EF4-FFF2-40B4-BE49-F238E27FC236}">
-                <a16:creationId xmlns:a16="http://schemas.microsoft.com/office/drawing/2014/main" id="{B29A95D3-9A76-4F54-B0DD-D09D9EEF5C70}"/>
+                <a16:creationId xmlns:a16="http://schemas.microsoft.com/office/drawing/2014/main" id="{579D7207-3D75-4F79-9BCB-3A59067F109C}"/>
               </a:ext>
             </a:extLst>
           </p:cNvPr>
@@ -8556,7 +8579,7 @@
           <p:cNvPr id="3" name="">
             <a:extLst xmlns:a="http://schemas.openxmlformats.org/drawingml/2006/main">
               <a:ext uri="{FF2B5EF4-FFF2-40B4-BE49-F238E27FC236}">
-                <a16:creationId xmlns:a16="http://schemas.microsoft.com/office/drawing/2014/main" id="{1018CF2B-47E2-4446-B6A0-F386F3EF6E06}"/>
+                <a16:creationId xmlns:a16="http://schemas.microsoft.com/office/drawing/2014/main" id="{9F7F6C1E-0132-4BC1-945A-206B2D72656C}"/>
               </a:ext>
             </a:extLst>
           </p:cNvPr>
@@ -8714,7 +8737,7 @@
           <p:cNvPr id="4" name="">
             <a:extLst xmlns:a="http://schemas.openxmlformats.org/drawingml/2006/main">
               <a:ext uri="{FF2B5EF4-FFF2-40B4-BE49-F238E27FC236}">
-                <a16:creationId xmlns:a16="http://schemas.microsoft.com/office/drawing/2014/main" id="{BA24B3F7-A897-4856-87DA-19D1C982B29D}"/>
+                <a16:creationId xmlns:a16="http://schemas.microsoft.com/office/drawing/2014/main" id="{8BD4CF26-DB5C-4649-BAD8-B911CE47747B}"/>
               </a:ext>
             </a:extLst>
           </p:cNvPr>
@@ -8902,7 +8925,7 @@
           <p:cNvPr id="5" name="">
             <a:extLst xmlns:a="http://schemas.openxmlformats.org/drawingml/2006/main">
               <a:ext uri="{FF2B5EF4-FFF2-40B4-BE49-F238E27FC236}">
-                <a16:creationId xmlns:a16="http://schemas.microsoft.com/office/drawing/2014/main" id="{3B1478A5-36FE-4406-B8F3-A103032BE71C}"/>
+                <a16:creationId xmlns:a16="http://schemas.microsoft.com/office/drawing/2014/main" id="{987B0952-EB39-4C13-8D79-00319A3E8558}"/>
               </a:ext>
             </a:extLst>
           </p:cNvPr>
@@ -9090,7 +9113,7 @@
           <p:cNvPr id="6" name="">
             <a:extLst xmlns:a="http://schemas.openxmlformats.org/drawingml/2006/main">
               <a:ext uri="{FF2B5EF4-FFF2-40B4-BE49-F238E27FC236}">
-                <a16:creationId xmlns:a16="http://schemas.microsoft.com/office/drawing/2014/main" id="{3EC9F2C2-7DB5-4F65-AC94-DB5475925726}"/>
+                <a16:creationId xmlns:a16="http://schemas.microsoft.com/office/drawing/2014/main" id="{53A9A494-C286-48F8-AB9F-3F210405D7B8}"/>
               </a:ext>
             </a:extLst>
           </p:cNvPr>
@@ -9278,7 +9301,7 @@
           <p:cNvPr id="7" name="">
             <a:extLst xmlns:a="http://schemas.openxmlformats.org/drawingml/2006/main">
               <a:ext uri="{FF2B5EF4-FFF2-40B4-BE49-F238E27FC236}">
-                <a16:creationId xmlns:a16="http://schemas.microsoft.com/office/drawing/2014/main" id="{954F0393-D46D-4116-A904-4085402A22EF}"/>
+                <a16:creationId xmlns:a16="http://schemas.microsoft.com/office/drawing/2014/main" id="{F9B72CE4-B04E-4793-8905-7D694A767356}"/>
               </a:ext>
             </a:extLst>
           </p:cNvPr>
@@ -9466,7 +9489,7 @@
           <p:cNvPr id="11" name="">
             <a:extLst xmlns:a="http://schemas.openxmlformats.org/drawingml/2006/main">
               <a:ext uri="{FF2B5EF4-FFF2-40B4-BE49-F238E27FC236}">
-                <a16:creationId xmlns:a16="http://schemas.microsoft.com/office/drawing/2014/main" id="{C5043FCE-642B-468D-AD09-5B6B143F9231}"/>
+                <a16:creationId xmlns:a16="http://schemas.microsoft.com/office/drawing/2014/main" id="{CB91D0D2-63CC-40BC-B2E8-7A2BD3704780}"/>
               </a:ext>
             </a:extLst>
           </p:cNvPr>
@@ -9614,7 +9637,7 @@
                 <a:ea typeface="Arial"/>
                 <a:cs typeface="Arial"/>
               </a:rPr>
-              <a:t>Limite conhecido: resolução antes da abertura pode deixar processo STARTED</a:t>
+              <a:t>Recuperação: resolução aguarda a abertura, sem confirmar a inbox</a:t>
             </a:r>
           </a:p>
         </p:txBody>
@@ -9624,7 +9647,7 @@
           <p:cNvPr id="12" name="">
             <a:extLst xmlns:a="http://schemas.openxmlformats.org/drawingml/2006/main">
               <a:ext uri="{FF2B5EF4-FFF2-40B4-BE49-F238E27FC236}">
-                <a16:creationId xmlns:a16="http://schemas.microsoft.com/office/drawing/2014/main" id="{494840C9-4C87-472C-A1D7-CD4C82544ECB}"/>
+                <a16:creationId xmlns:a16="http://schemas.microsoft.com/office/drawing/2014/main" id="{3C7A5639-968F-4ADA-A8B2-BB17BBF70D6A}"/>
               </a:ext>
             </a:extLst>
           </p:cNvPr>
@@ -9780,7 +9803,7 @@
     </p:spTree>
     <p:extLst>
       <p:ext uri="{BB962C8B-B14F-4D97-AF65-F5344CB8AC3E}">
-        <p14:creationId xmlns:p14="http://schemas.microsoft.com/office/powerpoint/2010/main" val="1168916265"/>
+        <p14:creationId xmlns:p14="http://schemas.microsoft.com/office/powerpoint/2010/main" val="1964591233"/>
       </p:ext>
     </p:extLst>
   </p:cSld>
@@ -9811,7 +9834,7 @@
           <p:cNvPr id="7" name="">
             <a:extLst xmlns:a="http://schemas.openxmlformats.org/drawingml/2006/main">
               <a:ext uri="{FF2B5EF4-FFF2-40B4-BE49-F238E27FC236}">
-                <a16:creationId xmlns:a16="http://schemas.microsoft.com/office/drawing/2014/main" id="{4BC00EFB-94EA-4F1F-85FA-BAD205487A8B}"/>
+                <a16:creationId xmlns:a16="http://schemas.microsoft.com/office/drawing/2014/main" id="{29D8DA79-B880-4F9F-B4AA-6E7DEBCA1B3E}"/>
               </a:ext>
             </a:extLst>
           </p:cNvPr>
@@ -9841,7 +9864,7 @@
           <p:cNvPr id="2" name="">
             <a:extLst xmlns:a="http://schemas.openxmlformats.org/drawingml/2006/main">
               <a:ext uri="{FF2B5EF4-FFF2-40B4-BE49-F238E27FC236}">
-                <a16:creationId xmlns:a16="http://schemas.microsoft.com/office/drawing/2014/main" id="{CA81F471-ADA9-49F4-A031-D194DB3637BB}"/>
+                <a16:creationId xmlns:a16="http://schemas.microsoft.com/office/drawing/2014/main" id="{51944E6A-24A4-40A4-AFFF-A854242E168E}"/>
               </a:ext>
             </a:extLst>
           </p:cNvPr>
@@ -9989,7 +10012,7 @@
                 <a:ea typeface="Arial"/>
                 <a:cs typeface="Arial"/>
               </a:rPr>
-              <a:t>Interoperabilidade e reservas e contratos</a:t>
+              <a:t>Interoperabilidade e contratos técnicos</a:t>
             </a:r>
           </a:p>
         </p:txBody>
@@ -9999,7 +10022,7 @@
           <p:cNvPr id="3" name="">
             <a:extLst xmlns:a="http://schemas.openxmlformats.org/drawingml/2006/main">
               <a:ext uri="{FF2B5EF4-FFF2-40B4-BE49-F238E27FC236}">
-                <a16:creationId xmlns:a16="http://schemas.microsoft.com/office/drawing/2014/main" id="{3273A162-FCBE-417F-AA42-FF9B808EA685}"/>
+                <a16:creationId xmlns:a16="http://schemas.microsoft.com/office/drawing/2014/main" id="{580D54C9-B762-46C8-AA7A-F8DA5A7B4B24}"/>
               </a:ext>
             </a:extLst>
           </p:cNvPr>
@@ -10157,7 +10180,7 @@
           <p:cNvPr id="4" name="">
             <a:extLst xmlns:a="http://schemas.openxmlformats.org/drawingml/2006/main">
               <a:ext uri="{FF2B5EF4-FFF2-40B4-BE49-F238E27FC236}">
-                <a16:creationId xmlns:a16="http://schemas.microsoft.com/office/drawing/2014/main" id="{1F3E39E4-E9EB-43C3-BC19-E354C7FC580F}"/>
+                <a16:creationId xmlns:a16="http://schemas.microsoft.com/office/drawing/2014/main" id="{FC9CAA2F-2233-4DA5-B876-D789340132B1}"/>
               </a:ext>
             </a:extLst>
           </p:cNvPr>
@@ -10427,7 +10450,7 @@
           <p:cNvPr id="5" name="">
             <a:extLst xmlns:a="http://schemas.openxmlformats.org/drawingml/2006/main">
               <a:ext uri="{FF2B5EF4-FFF2-40B4-BE49-F238E27FC236}">
-                <a16:creationId xmlns:a16="http://schemas.microsoft.com/office/drawing/2014/main" id="{1289B5DF-54EA-483C-916D-B2C298B14D6E}"/>
+                <a16:creationId xmlns:a16="http://schemas.microsoft.com/office/drawing/2014/main" id="{4AC8774F-B364-4E20-ACF7-BD7F9CB869F1}"/>
               </a:ext>
             </a:extLst>
           </p:cNvPr>
@@ -10753,7 +10776,7 @@
           <p:cNvPr id="6" name="">
             <a:extLst xmlns:a="http://schemas.openxmlformats.org/drawingml/2006/main">
               <a:ext uri="{FF2B5EF4-FFF2-40B4-BE49-F238E27FC236}">
-                <a16:creationId xmlns:a16="http://schemas.microsoft.com/office/drawing/2014/main" id="{4E66D15B-4CD3-42C6-801D-F9C0C7949A31}"/>
+                <a16:creationId xmlns:a16="http://schemas.microsoft.com/office/drawing/2014/main" id="{097583B4-E341-420D-BA93-50FF8597B0F3}"/>
               </a:ext>
             </a:extLst>
           </p:cNvPr>
@@ -10909,7 +10932,7 @@
     </p:spTree>
     <p:extLst>
       <p:ext uri="{BB962C8B-B14F-4D97-AF65-F5344CB8AC3E}">
-        <p14:creationId xmlns:p14="http://schemas.microsoft.com/office/powerpoint/2010/main" val="214609718"/>
+        <p14:creationId xmlns:p14="http://schemas.microsoft.com/office/powerpoint/2010/main" val="735718339"/>
       </p:ext>
     </p:extLst>
   </p:cSld>
@@ -10940,7 +10963,7 @@
           <p:cNvPr id="28" name="">
             <a:extLst xmlns:a="http://schemas.openxmlformats.org/drawingml/2006/main">
               <a:ext uri="{FF2B5EF4-FFF2-40B4-BE49-F238E27FC236}">
-                <a16:creationId xmlns:a16="http://schemas.microsoft.com/office/drawing/2014/main" id="{7140E2A3-3214-4957-88CB-F00F2627CC03}"/>
+                <a16:creationId xmlns:a16="http://schemas.microsoft.com/office/drawing/2014/main" id="{EE47CED4-38FC-42C8-B3CE-9857BF0074B1}"/>
               </a:ext>
             </a:extLst>
           </p:cNvPr>
@@ -10970,7 +10993,7 @@
           <p:cNvPr id="2" name="">
             <a:extLst xmlns:a="http://schemas.openxmlformats.org/drawingml/2006/main">
               <a:ext uri="{FF2B5EF4-FFF2-40B4-BE49-F238E27FC236}">
-                <a16:creationId xmlns:a16="http://schemas.microsoft.com/office/drawing/2014/main" id="{44ADAA69-384E-474F-A19A-FA4D9789E293}"/>
+                <a16:creationId xmlns:a16="http://schemas.microsoft.com/office/drawing/2014/main" id="{24BFA92C-0D47-48D3-A864-AC090F83FF04}"/>
               </a:ext>
             </a:extLst>
           </p:cNvPr>
@@ -11128,7 +11151,7 @@
           <p:cNvPr id="3" name="">
             <a:extLst xmlns:a="http://schemas.openxmlformats.org/drawingml/2006/main">
               <a:ext uri="{FF2B5EF4-FFF2-40B4-BE49-F238E27FC236}">
-                <a16:creationId xmlns:a16="http://schemas.microsoft.com/office/drawing/2014/main" id="{9A3C599B-ADFB-437D-9279-984F112CF3B2}"/>
+                <a16:creationId xmlns:a16="http://schemas.microsoft.com/office/drawing/2014/main" id="{B07D79F4-D40C-49F1-8DC9-213DFCE04798}"/>
               </a:ext>
             </a:extLst>
           </p:cNvPr>
@@ -11286,7 +11309,7 @@
           <p:cNvPr id="4" name="">
             <a:extLst xmlns:a="http://schemas.openxmlformats.org/drawingml/2006/main">
               <a:ext uri="{FF2B5EF4-FFF2-40B4-BE49-F238E27FC236}">
-                <a16:creationId xmlns:a16="http://schemas.microsoft.com/office/drawing/2014/main" id="{086571E3-518C-4A8B-8793-94D1A2C06ACF}"/>
+                <a16:creationId xmlns:a16="http://schemas.microsoft.com/office/drawing/2014/main" id="{BB926976-9C53-4FEE-B93F-986B19EBAFAE}"/>
               </a:ext>
             </a:extLst>
           </p:cNvPr>
@@ -11444,7 +11467,7 @@
           <p:cNvPr id="5" name="">
             <a:extLst xmlns:a="http://schemas.openxmlformats.org/drawingml/2006/main">
               <a:ext uri="{FF2B5EF4-FFF2-40B4-BE49-F238E27FC236}">
-                <a16:creationId xmlns:a16="http://schemas.microsoft.com/office/drawing/2014/main" id="{97AA7B8A-8A27-425D-BDFC-FF4D89A08C4E}"/>
+                <a16:creationId xmlns:a16="http://schemas.microsoft.com/office/drawing/2014/main" id="{6C990A13-9899-441A-BEFE-61D9BDDA53A8}"/>
               </a:ext>
             </a:extLst>
           </p:cNvPr>
@@ -11602,7 +11625,7 @@
           <p:cNvPr id="6" name="">
             <a:extLst xmlns:a="http://schemas.openxmlformats.org/drawingml/2006/main">
               <a:ext uri="{FF2B5EF4-FFF2-40B4-BE49-F238E27FC236}">
-                <a16:creationId xmlns:a16="http://schemas.microsoft.com/office/drawing/2014/main" id="{2E2B6648-B831-47F3-A80A-D4057D97CEC8}"/>
+                <a16:creationId xmlns:a16="http://schemas.microsoft.com/office/drawing/2014/main" id="{C682FB87-C8A1-4C0C-A390-D1469DAA54A6}"/>
               </a:ext>
             </a:extLst>
           </p:cNvPr>
@@ -11760,7 +11783,7 @@
           <p:cNvPr id="7" name="">
             <a:extLst xmlns:a="http://schemas.openxmlformats.org/drawingml/2006/main">
               <a:ext uri="{FF2B5EF4-FFF2-40B4-BE49-F238E27FC236}">
-                <a16:creationId xmlns:a16="http://schemas.microsoft.com/office/drawing/2014/main" id="{EC5999FB-EFF2-42EE-A55C-B3E71AAA929C}"/>
+                <a16:creationId xmlns:a16="http://schemas.microsoft.com/office/drawing/2014/main" id="{6A2619C3-2D6E-492A-91D4-D4F0B9AC003B}"/>
               </a:ext>
             </a:extLst>
           </p:cNvPr>
@@ -11918,7 +11941,7 @@
           <p:cNvPr id="8" name="">
             <a:extLst xmlns:a="http://schemas.openxmlformats.org/drawingml/2006/main">
               <a:ext uri="{FF2B5EF4-FFF2-40B4-BE49-F238E27FC236}">
-                <a16:creationId xmlns:a16="http://schemas.microsoft.com/office/drawing/2014/main" id="{7A6D258C-C2CA-420F-B3E2-B2E9E45D4545}"/>
+                <a16:creationId xmlns:a16="http://schemas.microsoft.com/office/drawing/2014/main" id="{66973762-A88C-4913-AAA0-ED063C1F5174}"/>
               </a:ext>
             </a:extLst>
           </p:cNvPr>
@@ -12076,7 +12099,7 @@
           <p:cNvPr id="9" name="">
             <a:extLst xmlns:a="http://schemas.openxmlformats.org/drawingml/2006/main">
               <a:ext uri="{FF2B5EF4-FFF2-40B4-BE49-F238E27FC236}">
-                <a16:creationId xmlns:a16="http://schemas.microsoft.com/office/drawing/2014/main" id="{8E7A4886-79BE-4F6E-96C5-BBCE800C32D8}"/>
+                <a16:creationId xmlns:a16="http://schemas.microsoft.com/office/drawing/2014/main" id="{22DCE2ED-8DAB-4AC2-9249-9388FA4A4123}"/>
               </a:ext>
             </a:extLst>
           </p:cNvPr>
@@ -12234,7 +12257,7 @@
           <p:cNvPr id="10" name="">
             <a:extLst xmlns:a="http://schemas.openxmlformats.org/drawingml/2006/main">
               <a:ext uri="{FF2B5EF4-FFF2-40B4-BE49-F238E27FC236}">
-                <a16:creationId xmlns:a16="http://schemas.microsoft.com/office/drawing/2014/main" id="{2B165131-128A-45F2-BE5B-ED54140B4414}"/>
+                <a16:creationId xmlns:a16="http://schemas.microsoft.com/office/drawing/2014/main" id="{76D74BCD-CE3C-4445-B6E4-660FDC35EEC1}"/>
               </a:ext>
             </a:extLst>
           </p:cNvPr>
@@ -12392,7 +12415,7 @@
           <p:cNvPr id="11" name="">
             <a:extLst xmlns:a="http://schemas.openxmlformats.org/drawingml/2006/main">
               <a:ext uri="{FF2B5EF4-FFF2-40B4-BE49-F238E27FC236}">
-                <a16:creationId xmlns:a16="http://schemas.microsoft.com/office/drawing/2014/main" id="{4F76F2AF-89E9-42EC-B6E2-F4D0FC35E3A2}"/>
+                <a16:creationId xmlns:a16="http://schemas.microsoft.com/office/drawing/2014/main" id="{5DE02B8E-A145-4D7D-8FE4-7CFC1FB40D51}"/>
               </a:ext>
             </a:extLst>
           </p:cNvPr>
@@ -12550,7 +12573,7 @@
           <p:cNvPr id="12" name="">
             <a:extLst xmlns:a="http://schemas.openxmlformats.org/drawingml/2006/main">
               <a:ext uri="{FF2B5EF4-FFF2-40B4-BE49-F238E27FC236}">
-                <a16:creationId xmlns:a16="http://schemas.microsoft.com/office/drawing/2014/main" id="{D78A216F-3BB8-4139-B3F2-D1D773584DF7}"/>
+                <a16:creationId xmlns:a16="http://schemas.microsoft.com/office/drawing/2014/main" id="{29DF320C-D9CB-47D7-A1C9-D1D4FCF6F551}"/>
               </a:ext>
             </a:extLst>
           </p:cNvPr>
@@ -12708,7 +12731,7 @@
           <p:cNvPr id="13" name="">
             <a:extLst xmlns:a="http://schemas.openxmlformats.org/drawingml/2006/main">
               <a:ext uri="{FF2B5EF4-FFF2-40B4-BE49-F238E27FC236}">
-                <a16:creationId xmlns:a16="http://schemas.microsoft.com/office/drawing/2014/main" id="{A11789D9-A58A-474F-94A8-3659B6283E27}"/>
+                <a16:creationId xmlns:a16="http://schemas.microsoft.com/office/drawing/2014/main" id="{9F2651F3-545B-449A-BCA3-DDCF73170C0D}"/>
               </a:ext>
             </a:extLst>
           </p:cNvPr>
@@ -12866,7 +12889,7 @@
           <p:cNvPr id="14" name="">
             <a:extLst xmlns:a="http://schemas.openxmlformats.org/drawingml/2006/main">
               <a:ext uri="{FF2B5EF4-FFF2-40B4-BE49-F238E27FC236}">
-                <a16:creationId xmlns:a16="http://schemas.microsoft.com/office/drawing/2014/main" id="{5E542756-C59C-4EE5-925E-624EEE86552E}"/>
+                <a16:creationId xmlns:a16="http://schemas.microsoft.com/office/drawing/2014/main" id="{2453E694-342C-4CF4-8346-3CB79D25390D}"/>
               </a:ext>
             </a:extLst>
           </p:cNvPr>
@@ -13024,7 +13047,7 @@
           <p:cNvPr id="15" name="">
             <a:extLst xmlns:a="http://schemas.openxmlformats.org/drawingml/2006/main">
               <a:ext uri="{FF2B5EF4-FFF2-40B4-BE49-F238E27FC236}">
-                <a16:creationId xmlns:a16="http://schemas.microsoft.com/office/drawing/2014/main" id="{FB0205C3-307C-4898-A7C9-A20BD9A65F46}"/>
+                <a16:creationId xmlns:a16="http://schemas.microsoft.com/office/drawing/2014/main" id="{88C85F37-86B4-4B1B-9A7C-571BE19CF7D7}"/>
               </a:ext>
             </a:extLst>
           </p:cNvPr>
@@ -13182,7 +13205,7 @@
           <p:cNvPr id="16" name="">
             <a:extLst xmlns:a="http://schemas.openxmlformats.org/drawingml/2006/main">
               <a:ext uri="{FF2B5EF4-FFF2-40B4-BE49-F238E27FC236}">
-                <a16:creationId xmlns:a16="http://schemas.microsoft.com/office/drawing/2014/main" id="{7BFB5338-B332-4E34-9F66-318B049F03FD}"/>
+                <a16:creationId xmlns:a16="http://schemas.microsoft.com/office/drawing/2014/main" id="{2F85F49C-D438-4AAC-B790-560F0C001A2B}"/>
               </a:ext>
             </a:extLst>
           </p:cNvPr>
@@ -13340,7 +13363,7 @@
           <p:cNvPr id="17" name="">
             <a:extLst xmlns:a="http://schemas.openxmlformats.org/drawingml/2006/main">
               <a:ext uri="{FF2B5EF4-FFF2-40B4-BE49-F238E27FC236}">
-                <a16:creationId xmlns:a16="http://schemas.microsoft.com/office/drawing/2014/main" id="{6299F6D8-3E62-4641-94DF-5B6A1F22FDE3}"/>
+                <a16:creationId xmlns:a16="http://schemas.microsoft.com/office/drawing/2014/main" id="{439BBA55-FCE6-4F8C-BF2D-F73E07D07060}"/>
               </a:ext>
             </a:extLst>
           </p:cNvPr>
@@ -13498,7 +13521,7 @@
           <p:cNvPr id="18" name="">
             <a:extLst xmlns:a="http://schemas.openxmlformats.org/drawingml/2006/main">
               <a:ext uri="{FF2B5EF4-FFF2-40B4-BE49-F238E27FC236}">
-                <a16:creationId xmlns:a16="http://schemas.microsoft.com/office/drawing/2014/main" id="{046EBB68-A5D8-4D4C-9452-14B2FEBBFD8B}"/>
+                <a16:creationId xmlns:a16="http://schemas.microsoft.com/office/drawing/2014/main" id="{E4DFBB7E-F426-453F-ACA5-5E4C7DCD6F4A}"/>
               </a:ext>
             </a:extLst>
           </p:cNvPr>
@@ -13656,7 +13679,7 @@
           <p:cNvPr id="19" name="">
             <a:extLst xmlns:a="http://schemas.openxmlformats.org/drawingml/2006/main">
               <a:ext uri="{FF2B5EF4-FFF2-40B4-BE49-F238E27FC236}">
-                <a16:creationId xmlns:a16="http://schemas.microsoft.com/office/drawing/2014/main" id="{5C1D1334-B793-4A89-B5E0-669310C25502}"/>
+                <a16:creationId xmlns:a16="http://schemas.microsoft.com/office/drawing/2014/main" id="{FEC687E4-CE58-4622-A012-08C370545FFE}"/>
               </a:ext>
             </a:extLst>
           </p:cNvPr>
@@ -13814,7 +13837,7 @@
           <p:cNvPr id="20" name="">
             <a:extLst xmlns:a="http://schemas.openxmlformats.org/drawingml/2006/main">
               <a:ext uri="{FF2B5EF4-FFF2-40B4-BE49-F238E27FC236}">
-                <a16:creationId xmlns:a16="http://schemas.microsoft.com/office/drawing/2014/main" id="{2A954D60-5361-4DCD-941B-49886A924FB1}"/>
+                <a16:creationId xmlns:a16="http://schemas.microsoft.com/office/drawing/2014/main" id="{55EE6B98-8AF4-4ED1-B950-72BE69B119F5}"/>
               </a:ext>
             </a:extLst>
           </p:cNvPr>
@@ -13972,7 +13995,7 @@
           <p:cNvPr id="21" name="">
             <a:extLst xmlns:a="http://schemas.openxmlformats.org/drawingml/2006/main">
               <a:ext uri="{FF2B5EF4-FFF2-40B4-BE49-F238E27FC236}">
-                <a16:creationId xmlns:a16="http://schemas.microsoft.com/office/drawing/2014/main" id="{FF973B10-FF55-456D-ADFD-CDD0499ABB01}"/>
+                <a16:creationId xmlns:a16="http://schemas.microsoft.com/office/drawing/2014/main" id="{930E0312-7A59-4BEE-AD27-5F11F7AEF9DB}"/>
               </a:ext>
             </a:extLst>
           </p:cNvPr>
@@ -14130,7 +14153,7 @@
           <p:cNvPr id="22" name="">
             <a:extLst xmlns:a="http://schemas.openxmlformats.org/drawingml/2006/main">
               <a:ext uri="{FF2B5EF4-FFF2-40B4-BE49-F238E27FC236}">
-                <a16:creationId xmlns:a16="http://schemas.microsoft.com/office/drawing/2014/main" id="{D7BF26E9-6A75-4576-8062-404A21AF5B91}"/>
+                <a16:creationId xmlns:a16="http://schemas.microsoft.com/office/drawing/2014/main" id="{EF2B5335-1DC1-4161-A120-0BD7B61D1EB1}"/>
               </a:ext>
             </a:extLst>
           </p:cNvPr>
@@ -14288,7 +14311,7 @@
           <p:cNvPr id="23" name="">
             <a:extLst xmlns:a="http://schemas.openxmlformats.org/drawingml/2006/main">
               <a:ext uri="{FF2B5EF4-FFF2-40B4-BE49-F238E27FC236}">
-                <a16:creationId xmlns:a16="http://schemas.microsoft.com/office/drawing/2014/main" id="{9B1C19E2-8CE6-4E15-A24A-DED706DB1FA2}"/>
+                <a16:creationId xmlns:a16="http://schemas.microsoft.com/office/drawing/2014/main" id="{BA6569AA-E656-4858-9074-B4B92C3EFD22}"/>
               </a:ext>
             </a:extLst>
           </p:cNvPr>
@@ -14446,7 +14469,7 @@
           <p:cNvPr id="24" name="">
             <a:extLst xmlns:a="http://schemas.openxmlformats.org/drawingml/2006/main">
               <a:ext uri="{FF2B5EF4-FFF2-40B4-BE49-F238E27FC236}">
-                <a16:creationId xmlns:a16="http://schemas.microsoft.com/office/drawing/2014/main" id="{0EFE2E2C-0E63-4819-B98E-66CE4C5BD503}"/>
+                <a16:creationId xmlns:a16="http://schemas.microsoft.com/office/drawing/2014/main" id="{5438F5D1-A061-4EB9-B892-F7AA17DA0C78}"/>
               </a:ext>
             </a:extLst>
           </p:cNvPr>
@@ -14604,7 +14627,7 @@
           <p:cNvPr id="25" name="">
             <a:extLst xmlns:a="http://schemas.openxmlformats.org/drawingml/2006/main">
               <a:ext uri="{FF2B5EF4-FFF2-40B4-BE49-F238E27FC236}">
-                <a16:creationId xmlns:a16="http://schemas.microsoft.com/office/drawing/2014/main" id="{DD91793F-8854-43F7-AD4E-70A2DCB8ECC9}"/>
+                <a16:creationId xmlns:a16="http://schemas.microsoft.com/office/drawing/2014/main" id="{932557DA-1C14-4F9B-B036-172617C65642}"/>
               </a:ext>
             </a:extLst>
           </p:cNvPr>
@@ -14762,7 +14785,7 @@
           <p:cNvPr id="26" name="">
             <a:extLst xmlns:a="http://schemas.openxmlformats.org/drawingml/2006/main">
               <a:ext uri="{FF2B5EF4-FFF2-40B4-BE49-F238E27FC236}">
-                <a16:creationId xmlns:a16="http://schemas.microsoft.com/office/drawing/2014/main" id="{D1955FE3-F33C-423E-BA42-C3E6D27BDCD6}"/>
+                <a16:creationId xmlns:a16="http://schemas.microsoft.com/office/drawing/2014/main" id="{5C8DD27A-9B16-441B-9847-32195E10B07E}"/>
               </a:ext>
             </a:extLst>
           </p:cNvPr>
@@ -14920,7 +14943,7 @@
           <p:cNvPr id="27" name="">
             <a:extLst xmlns:a="http://schemas.openxmlformats.org/drawingml/2006/main">
               <a:ext uri="{FF2B5EF4-FFF2-40B4-BE49-F238E27FC236}">
-                <a16:creationId xmlns:a16="http://schemas.microsoft.com/office/drawing/2014/main" id="{5C2B91F2-EC0F-436C-B1FB-8C9DC0015477}"/>
+                <a16:creationId xmlns:a16="http://schemas.microsoft.com/office/drawing/2014/main" id="{55E98EB8-F55A-4041-A7E8-244F3D2F222D}"/>
               </a:ext>
             </a:extLst>
           </p:cNvPr>
@@ -15076,7 +15099,7 @@
     </p:spTree>
     <p:extLst>
       <p:ext uri="{BB962C8B-B14F-4D97-AF65-F5344CB8AC3E}">
-        <p14:creationId xmlns:p14="http://schemas.microsoft.com/office/powerpoint/2010/main" val="1339888652"/>
+        <p14:creationId xmlns:p14="http://schemas.microsoft.com/office/powerpoint/2010/main" val="224303783"/>
       </p:ext>
     </p:extLst>
   </p:cSld>
@@ -15107,7 +15130,7 @@
           <p:cNvPr id="11" name="">
             <a:extLst xmlns:a="http://schemas.openxmlformats.org/drawingml/2006/main">
               <a:ext uri="{FF2B5EF4-FFF2-40B4-BE49-F238E27FC236}">
-                <a16:creationId xmlns:a16="http://schemas.microsoft.com/office/drawing/2014/main" id="{0970811A-325D-46F4-854D-FC1F8AA1034D}"/>
+                <a16:creationId xmlns:a16="http://schemas.microsoft.com/office/drawing/2014/main" id="{66E43796-3E72-4580-9411-E9E53FC7C684}"/>
               </a:ext>
             </a:extLst>
           </p:cNvPr>
@@ -15137,7 +15160,7 @@
           <p:cNvPr id="2" name="">
             <a:extLst xmlns:a="http://schemas.openxmlformats.org/drawingml/2006/main">
               <a:ext uri="{FF2B5EF4-FFF2-40B4-BE49-F238E27FC236}">
-                <a16:creationId xmlns:a16="http://schemas.microsoft.com/office/drawing/2014/main" id="{12387ED7-4C79-4D86-98C7-91911E15DA77}"/>
+                <a16:creationId xmlns:a16="http://schemas.microsoft.com/office/drawing/2014/main" id="{3A770A98-667D-4993-895A-A6C5C88FCA15}"/>
               </a:ext>
             </a:extLst>
           </p:cNvPr>
@@ -15295,7 +15318,7 @@
           <p:cNvPr id="3" name="">
             <a:extLst xmlns:a="http://schemas.openxmlformats.org/drawingml/2006/main">
               <a:ext uri="{FF2B5EF4-FFF2-40B4-BE49-F238E27FC236}">
-                <a16:creationId xmlns:a16="http://schemas.microsoft.com/office/drawing/2014/main" id="{1F2DC33A-7E19-4EA0-81FD-D6216D6B7C81}"/>
+                <a16:creationId xmlns:a16="http://schemas.microsoft.com/office/drawing/2014/main" id="{64DFF8E2-03C4-40CB-9DB6-79D1C15B05E6}"/>
               </a:ext>
             </a:extLst>
           </p:cNvPr>
@@ -15453,7 +15476,7 @@
           <p:cNvPr id="4" name="">
             <a:extLst xmlns:a="http://schemas.openxmlformats.org/drawingml/2006/main">
               <a:ext uri="{FF2B5EF4-FFF2-40B4-BE49-F238E27FC236}">
-                <a16:creationId xmlns:a16="http://schemas.microsoft.com/office/drawing/2014/main" id="{2AA8F1C7-4EBB-45D2-BE8D-18DDFE6DDADE}"/>
+                <a16:creationId xmlns:a16="http://schemas.microsoft.com/office/drawing/2014/main" id="{470D4A8B-B7BA-4C03-A706-8E8F198F010E}"/>
               </a:ext>
             </a:extLst>
           </p:cNvPr>
@@ -15611,7 +15634,7 @@
           <p:cNvPr id="5" name="">
             <a:extLst xmlns:a="http://schemas.openxmlformats.org/drawingml/2006/main">
               <a:ext uri="{FF2B5EF4-FFF2-40B4-BE49-F238E27FC236}">
-                <a16:creationId xmlns:a16="http://schemas.microsoft.com/office/drawing/2014/main" id="{42F003F3-5DB7-42E3-9634-80520A8526EB}"/>
+                <a16:creationId xmlns:a16="http://schemas.microsoft.com/office/drawing/2014/main" id="{4FED675C-65FF-4C25-985E-35F74604D4EC}"/>
               </a:ext>
             </a:extLst>
           </p:cNvPr>
@@ -15827,7 +15850,7 @@
           <p:cNvPr id="6" name="">
             <a:extLst xmlns:a="http://schemas.openxmlformats.org/drawingml/2006/main">
               <a:ext uri="{FF2B5EF4-FFF2-40B4-BE49-F238E27FC236}">
-                <a16:creationId xmlns:a16="http://schemas.microsoft.com/office/drawing/2014/main" id="{CB846D04-72F4-48E7-B920-56A23F99B273}"/>
+                <a16:creationId xmlns:a16="http://schemas.microsoft.com/office/drawing/2014/main" id="{8FF9BAC3-809B-434C-860B-B2A65330614B}"/>
               </a:ext>
             </a:extLst>
           </p:cNvPr>
@@ -15985,7 +16008,7 @@
           <p:cNvPr id="7" name="">
             <a:extLst xmlns:a="http://schemas.openxmlformats.org/drawingml/2006/main">
               <a:ext uri="{FF2B5EF4-FFF2-40B4-BE49-F238E27FC236}">
-                <a16:creationId xmlns:a16="http://schemas.microsoft.com/office/drawing/2014/main" id="{6807BED9-FDA1-4A58-892F-A6EA6A97175C}"/>
+                <a16:creationId xmlns:a16="http://schemas.microsoft.com/office/drawing/2014/main" id="{D9614D96-2225-46AF-B49B-54E211F8EBBB}"/>
               </a:ext>
             </a:extLst>
           </p:cNvPr>
@@ -16201,7 +16224,7 @@
           <p:cNvPr id="8" name="">
             <a:extLst xmlns:a="http://schemas.openxmlformats.org/drawingml/2006/main">
               <a:ext uri="{FF2B5EF4-FFF2-40B4-BE49-F238E27FC236}">
-                <a16:creationId xmlns:a16="http://schemas.microsoft.com/office/drawing/2014/main" id="{A44AA109-EE20-4BEE-9E39-89568EDCCAA7}"/>
+                <a16:creationId xmlns:a16="http://schemas.microsoft.com/office/drawing/2014/main" id="{C3B805EC-37BF-4A5B-A163-6C5696A716EF}"/>
               </a:ext>
             </a:extLst>
           </p:cNvPr>
@@ -16359,7 +16382,7 @@
           <p:cNvPr id="9" name="">
             <a:extLst xmlns:a="http://schemas.openxmlformats.org/drawingml/2006/main">
               <a:ext uri="{FF2B5EF4-FFF2-40B4-BE49-F238E27FC236}">
-                <a16:creationId xmlns:a16="http://schemas.microsoft.com/office/drawing/2014/main" id="{94896AA7-67D0-4366-B9D2-3A2C823C0620}"/>
+                <a16:creationId xmlns:a16="http://schemas.microsoft.com/office/drawing/2014/main" id="{92981B97-79C1-4959-BE27-398663AD2CFD}"/>
               </a:ext>
             </a:extLst>
           </p:cNvPr>
@@ -16575,7 +16598,7 @@
           <p:cNvPr id="10" name="">
             <a:extLst xmlns:a="http://schemas.openxmlformats.org/drawingml/2006/main">
               <a:ext uri="{FF2B5EF4-FFF2-40B4-BE49-F238E27FC236}">
-                <a16:creationId xmlns:a16="http://schemas.microsoft.com/office/drawing/2014/main" id="{AE3ABF47-1BC5-41FB-91C3-B22C85AB67CA}"/>
+                <a16:creationId xmlns:a16="http://schemas.microsoft.com/office/drawing/2014/main" id="{2CB6FD01-B877-49B6-8DE6-F43C963D158B}"/>
               </a:ext>
             </a:extLst>
           </p:cNvPr>
@@ -16723,7 +16746,7 @@
                 <a:ea typeface="Arial"/>
                 <a:cs typeface="Arial"/>
               </a:rPr>
-              <a:t>Testes de reprocessamento cobrem cenários específicos.</a:t>
+              <a:t>Regressões cobrem recuperação fora de ordem e estados finais.</a:t>
             </a:r>
           </a:p>
           <a:p xmlns:a="http://schemas.openxmlformats.org/drawingml/2006/main">
@@ -16746,7 +16769,7 @@
                 <a:ea typeface="Arial"/>
                 <a:cs typeface="Arial"/>
               </a:rPr>
-              <a:t>Convergência de eventos e coerência de estados têm defeitos conhecidos.</a:t>
+              <a:t>Falhas permanecem recuperáveis por retentativa ou reprocessamento explícito.</a:t>
             </a:r>
           </a:p>
         </p:txBody>
@@ -16754,7 +16777,7 @@
     </p:spTree>
     <p:extLst>
       <p:ext uri="{BB962C8B-B14F-4D97-AF65-F5344CB8AC3E}">
-        <p14:creationId xmlns:p14="http://schemas.microsoft.com/office/powerpoint/2010/main" val="810531046"/>
+        <p14:creationId xmlns:p14="http://schemas.microsoft.com/office/powerpoint/2010/main" val="343087461"/>
       </p:ext>
     </p:extLst>
   </p:cSld>
@@ -16785,7 +16808,7 @@
           <p:cNvPr id="11" name="">
             <a:extLst xmlns:a="http://schemas.openxmlformats.org/drawingml/2006/main">
               <a:ext uri="{FF2B5EF4-FFF2-40B4-BE49-F238E27FC236}">
-                <a16:creationId xmlns:a16="http://schemas.microsoft.com/office/drawing/2014/main" id="{CD6D9C80-FAC1-4C4A-9374-1DB790868F1A}"/>
+                <a16:creationId xmlns:a16="http://schemas.microsoft.com/office/drawing/2014/main" id="{3864A285-9D91-4B58-82EF-F2347050F85F}"/>
               </a:ext>
             </a:extLst>
           </p:cNvPr>
@@ -16815,7 +16838,7 @@
           <p:cNvPr id="2" name="">
             <a:extLst xmlns:a="http://schemas.openxmlformats.org/drawingml/2006/main">
               <a:ext uri="{FF2B5EF4-FFF2-40B4-BE49-F238E27FC236}">
-                <a16:creationId xmlns:a16="http://schemas.microsoft.com/office/drawing/2014/main" id="{2329900D-2D89-4580-AFB5-01899407E497}"/>
+                <a16:creationId xmlns:a16="http://schemas.microsoft.com/office/drawing/2014/main" id="{07A4C0E2-F635-4475-BFFD-0B0EAA31668F}"/>
               </a:ext>
             </a:extLst>
           </p:cNvPr>
@@ -16973,7 +16996,7 @@
           <p:cNvPr id="3" name="">
             <a:extLst xmlns:a="http://schemas.openxmlformats.org/drawingml/2006/main">
               <a:ext uri="{FF2B5EF4-FFF2-40B4-BE49-F238E27FC236}">
-                <a16:creationId xmlns:a16="http://schemas.microsoft.com/office/drawing/2014/main" id="{7A903CAF-104F-4B97-A567-100FEA7FA3A6}"/>
+                <a16:creationId xmlns:a16="http://schemas.microsoft.com/office/drawing/2014/main" id="{C1BAC8BA-546C-40CC-B036-64C8A91DD53A}"/>
               </a:ext>
             </a:extLst>
           </p:cNvPr>
@@ -17131,7 +17154,7 @@
           <p:cNvPr id="4" name="">
             <a:extLst xmlns:a="http://schemas.openxmlformats.org/drawingml/2006/main">
               <a:ext uri="{FF2B5EF4-FFF2-40B4-BE49-F238E27FC236}">
-                <a16:creationId xmlns:a16="http://schemas.microsoft.com/office/drawing/2014/main" id="{66668094-FD7C-4058-BA05-44207BDBE898}"/>
+                <a16:creationId xmlns:a16="http://schemas.microsoft.com/office/drawing/2014/main" id="{CF21ABCA-8D98-4AF4-88F9-6635AE12D92E}"/>
               </a:ext>
             </a:extLst>
           </p:cNvPr>
@@ -17289,7 +17312,7 @@
           <p:cNvPr id="5" name="">
             <a:extLst xmlns:a="http://schemas.openxmlformats.org/drawingml/2006/main">
               <a:ext uri="{FF2B5EF4-FFF2-40B4-BE49-F238E27FC236}">
-                <a16:creationId xmlns:a16="http://schemas.microsoft.com/office/drawing/2014/main" id="{70AEF803-B012-4005-B3C3-1323DB2E0010}"/>
+                <a16:creationId xmlns:a16="http://schemas.microsoft.com/office/drawing/2014/main" id="{99C1A8E0-9D7E-4180-B90B-28A569041622}"/>
               </a:ext>
             </a:extLst>
           </p:cNvPr>
@@ -17505,7 +17528,7 @@
           <p:cNvPr id="6" name="">
             <a:extLst xmlns:a="http://schemas.openxmlformats.org/drawingml/2006/main">
               <a:ext uri="{FF2B5EF4-FFF2-40B4-BE49-F238E27FC236}">
-                <a16:creationId xmlns:a16="http://schemas.microsoft.com/office/drawing/2014/main" id="{3F2440A0-BC19-40B7-BBAF-B0E6CB39CE93}"/>
+                <a16:creationId xmlns:a16="http://schemas.microsoft.com/office/drawing/2014/main" id="{6C6311C6-172E-439A-8803-6255177B915A}"/>
               </a:ext>
             </a:extLst>
           </p:cNvPr>
@@ -17663,7 +17686,7 @@
           <p:cNvPr id="7" name="">
             <a:extLst xmlns:a="http://schemas.openxmlformats.org/drawingml/2006/main">
               <a:ext uri="{FF2B5EF4-FFF2-40B4-BE49-F238E27FC236}">
-                <a16:creationId xmlns:a16="http://schemas.microsoft.com/office/drawing/2014/main" id="{4481CC70-6981-49C6-A081-35D65C527CB3}"/>
+                <a16:creationId xmlns:a16="http://schemas.microsoft.com/office/drawing/2014/main" id="{81FEB653-8E5C-4D01-9D69-E7676049C6C9}"/>
               </a:ext>
             </a:extLst>
           </p:cNvPr>
@@ -17879,7 +17902,7 @@
           <p:cNvPr id="8" name="">
             <a:extLst xmlns:a="http://schemas.openxmlformats.org/drawingml/2006/main">
               <a:ext uri="{FF2B5EF4-FFF2-40B4-BE49-F238E27FC236}">
-                <a16:creationId xmlns:a16="http://schemas.microsoft.com/office/drawing/2014/main" id="{3DF71525-0691-4737-95D1-44DC446DACF0}"/>
+                <a16:creationId xmlns:a16="http://schemas.microsoft.com/office/drawing/2014/main" id="{7290EE69-1055-4836-BAB8-75878D92AE2E}"/>
               </a:ext>
             </a:extLst>
           </p:cNvPr>
@@ -18037,7 +18060,7 @@
           <p:cNvPr id="9" name="">
             <a:extLst xmlns:a="http://schemas.openxmlformats.org/drawingml/2006/main">
               <a:ext uri="{FF2B5EF4-FFF2-40B4-BE49-F238E27FC236}">
-                <a16:creationId xmlns:a16="http://schemas.microsoft.com/office/drawing/2014/main" id="{12F842B8-BF31-494B-93EC-E9222FC76F17}"/>
+                <a16:creationId xmlns:a16="http://schemas.microsoft.com/office/drawing/2014/main" id="{6A2BF504-1D41-49FD-BBC2-5306164D4AC0}"/>
               </a:ext>
             </a:extLst>
           </p:cNvPr>
@@ -18253,7 +18276,7 @@
           <p:cNvPr id="10" name="">
             <a:extLst xmlns:a="http://schemas.openxmlformats.org/drawingml/2006/main">
               <a:ext uri="{FF2B5EF4-FFF2-40B4-BE49-F238E27FC236}">
-                <a16:creationId xmlns:a16="http://schemas.microsoft.com/office/drawing/2014/main" id="{FE9C2E4E-6BDD-4238-A24B-B9C8A3AD16FF}"/>
+                <a16:creationId xmlns:a16="http://schemas.microsoft.com/office/drawing/2014/main" id="{5B4354CE-77FD-4756-A625-4795B93A40A7}"/>
               </a:ext>
             </a:extLst>
           </p:cNvPr>
@@ -18409,7 +18432,7 @@
     </p:spTree>
     <p:extLst>
       <p:ext uri="{BB962C8B-B14F-4D97-AF65-F5344CB8AC3E}">
-        <p14:creationId xmlns:p14="http://schemas.microsoft.com/office/powerpoint/2010/main" val="1195748721"/>
+        <p14:creationId xmlns:p14="http://schemas.microsoft.com/office/powerpoint/2010/main" val="1619760626"/>
       </p:ext>
     </p:extLst>
   </p:cSld>
@@ -18440,7 +18463,7 @@
           <p:cNvPr id="9" name="">
             <a:extLst xmlns:a="http://schemas.openxmlformats.org/drawingml/2006/main">
               <a:ext uri="{FF2B5EF4-FFF2-40B4-BE49-F238E27FC236}">
-                <a16:creationId xmlns:a16="http://schemas.microsoft.com/office/drawing/2014/main" id="{FE56AEB4-1D95-48E9-8CA2-867DAF29CB58}"/>
+                <a16:creationId xmlns:a16="http://schemas.microsoft.com/office/drawing/2014/main" id="{6E516552-E89A-42DD-8E48-AF0468A29B55}"/>
               </a:ext>
             </a:extLst>
           </p:cNvPr>
@@ -18470,7 +18493,7 @@
           <p:cNvPr id="2" name="">
             <a:extLst xmlns:a="http://schemas.openxmlformats.org/drawingml/2006/main">
               <a:ext uri="{FF2B5EF4-FFF2-40B4-BE49-F238E27FC236}">
-                <a16:creationId xmlns:a16="http://schemas.microsoft.com/office/drawing/2014/main" id="{ABD19A29-E102-4215-A00A-B1CB8E48D7F6}"/>
+                <a16:creationId xmlns:a16="http://schemas.microsoft.com/office/drawing/2014/main" id="{1C12246B-15EF-4571-A9D8-94F96C8879CF}"/>
               </a:ext>
             </a:extLst>
           </p:cNvPr>
@@ -18628,7 +18651,7 @@
           <p:cNvPr id="3" name="">
             <a:extLst xmlns:a="http://schemas.openxmlformats.org/drawingml/2006/main">
               <a:ext uri="{FF2B5EF4-FFF2-40B4-BE49-F238E27FC236}">
-                <a16:creationId xmlns:a16="http://schemas.microsoft.com/office/drawing/2014/main" id="{2F5C8602-8FD5-4279-B47A-3E9724A608E0}"/>
+                <a16:creationId xmlns:a16="http://schemas.microsoft.com/office/drawing/2014/main" id="{72E8746C-E3F7-40C9-A93A-5E7A387AF58E}"/>
               </a:ext>
             </a:extLst>
           </p:cNvPr>
@@ -18786,7 +18809,7 @@
           <p:cNvPr id="4" name="">
             <a:extLst xmlns:a="http://schemas.openxmlformats.org/drawingml/2006/main">
               <a:ext uri="{FF2B5EF4-FFF2-40B4-BE49-F238E27FC236}">
-                <a16:creationId xmlns:a16="http://schemas.microsoft.com/office/drawing/2014/main" id="{096A8522-EE7B-42CB-A0E1-88D83B2ACA35}"/>
+                <a16:creationId xmlns:a16="http://schemas.microsoft.com/office/drawing/2014/main" id="{A793943E-EB44-4297-A4E4-FBABA6025209}"/>
               </a:ext>
             </a:extLst>
           </p:cNvPr>
@@ -18944,7 +18967,7 @@
           <p:cNvPr id="5" name="">
             <a:extLst xmlns:a="http://schemas.openxmlformats.org/drawingml/2006/main">
               <a:ext uri="{FF2B5EF4-FFF2-40B4-BE49-F238E27FC236}">
-                <a16:creationId xmlns:a16="http://schemas.microsoft.com/office/drawing/2014/main" id="{CEDC8CAC-8ABF-40B3-BE0C-BFBBFE821317}"/>
+                <a16:creationId xmlns:a16="http://schemas.microsoft.com/office/drawing/2014/main" id="{C7755F35-680E-4E4C-8538-349A11253B90}"/>
               </a:ext>
             </a:extLst>
           </p:cNvPr>
@@ -19187,7 +19210,7 @@
           <p:cNvPr id="6" name="">
             <a:extLst xmlns:a="http://schemas.openxmlformats.org/drawingml/2006/main">
               <a:ext uri="{FF2B5EF4-FFF2-40B4-BE49-F238E27FC236}">
-                <a16:creationId xmlns:a16="http://schemas.microsoft.com/office/drawing/2014/main" id="{56B6FD06-3FC3-4C94-9568-DE1E8F49B809}"/>
+                <a16:creationId xmlns:a16="http://schemas.microsoft.com/office/drawing/2014/main" id="{E4A55976-49C6-414D-B56A-07D75B68CBFE}"/>
               </a:ext>
             </a:extLst>
           </p:cNvPr>
@@ -19345,7 +19368,7 @@
           <p:cNvPr id="7" name="">
             <a:extLst xmlns:a="http://schemas.openxmlformats.org/drawingml/2006/main">
               <a:ext uri="{FF2B5EF4-FFF2-40B4-BE49-F238E27FC236}">
-                <a16:creationId xmlns:a16="http://schemas.microsoft.com/office/drawing/2014/main" id="{54AC997F-A0FE-4F3D-8624-65F01D7AB2A8}"/>
+                <a16:creationId xmlns:a16="http://schemas.microsoft.com/office/drawing/2014/main" id="{13A3CB7F-4F46-4D4B-AA2E-764ABAA8C2F8}"/>
               </a:ext>
             </a:extLst>
           </p:cNvPr>
@@ -19588,7 +19611,7 @@
           <p:cNvPr id="8" name="">
             <a:extLst xmlns:a="http://schemas.openxmlformats.org/drawingml/2006/main">
               <a:ext uri="{FF2B5EF4-FFF2-40B4-BE49-F238E27FC236}">
-                <a16:creationId xmlns:a16="http://schemas.microsoft.com/office/drawing/2014/main" id="{39CEC7AE-EFE3-444B-BDE1-C1E42862ABD4}"/>
+                <a16:creationId xmlns:a16="http://schemas.microsoft.com/office/drawing/2014/main" id="{67DFF504-3A84-4409-A3F4-30309556511B}"/>
               </a:ext>
             </a:extLst>
           </p:cNvPr>
@@ -19767,7 +19790,7 @@
     </p:spTree>
     <p:extLst>
       <p:ext uri="{BB962C8B-B14F-4D97-AF65-F5344CB8AC3E}">
-        <p14:creationId xmlns:p14="http://schemas.microsoft.com/office/powerpoint/2010/main" val="1472350016"/>
+        <p14:creationId xmlns:p14="http://schemas.microsoft.com/office/powerpoint/2010/main" val="2021914904"/>
       </p:ext>
     </p:extLst>
   </p:cSld>
@@ -19798,7 +19821,7 @@
           <p:cNvPr id="9" name="">
             <a:extLst xmlns:a="http://schemas.openxmlformats.org/drawingml/2006/main">
               <a:ext uri="{FF2B5EF4-FFF2-40B4-BE49-F238E27FC236}">
-                <a16:creationId xmlns:a16="http://schemas.microsoft.com/office/drawing/2014/main" id="{CF2092BF-7F5C-4EB3-A6CB-C54E9500F867}"/>
+                <a16:creationId xmlns:a16="http://schemas.microsoft.com/office/drawing/2014/main" id="{7DE11216-FBDF-4DF9-8DB0-3432E0AEBA8F}"/>
               </a:ext>
             </a:extLst>
           </p:cNvPr>
@@ -19828,7 +19851,7 @@
           <p:cNvPr id="2" name="">
             <a:extLst xmlns:a="http://schemas.openxmlformats.org/drawingml/2006/main">
               <a:ext uri="{FF2B5EF4-FFF2-40B4-BE49-F238E27FC236}">
-                <a16:creationId xmlns:a16="http://schemas.microsoft.com/office/drawing/2014/main" id="{9CAC1357-2E17-4B9C-98F1-8509340D4DCB}"/>
+                <a16:creationId xmlns:a16="http://schemas.microsoft.com/office/drawing/2014/main" id="{2986FE55-3BF2-44C2-8CEA-353601E9481B}"/>
               </a:ext>
             </a:extLst>
           </p:cNvPr>
@@ -19986,7 +20009,7 @@
           <p:cNvPr id="3" name="">
             <a:extLst xmlns:a="http://schemas.openxmlformats.org/drawingml/2006/main">
               <a:ext uri="{FF2B5EF4-FFF2-40B4-BE49-F238E27FC236}">
-                <a16:creationId xmlns:a16="http://schemas.microsoft.com/office/drawing/2014/main" id="{D62E6A57-4F2E-413D-973A-1B59182B0E36}"/>
+                <a16:creationId xmlns:a16="http://schemas.microsoft.com/office/drawing/2014/main" id="{CAB1A2A6-F4AB-4FC2-9593-E6B971CB52DB}"/>
               </a:ext>
             </a:extLst>
           </p:cNvPr>
@@ -20144,7 +20167,7 @@
           <p:cNvPr id="4" name="">
             <a:extLst xmlns:a="http://schemas.openxmlformats.org/drawingml/2006/main">
               <a:ext uri="{FF2B5EF4-FFF2-40B4-BE49-F238E27FC236}">
-                <a16:creationId xmlns:a16="http://schemas.microsoft.com/office/drawing/2014/main" id="{B86D6615-E61F-4043-ACD3-074A7E299C2D}"/>
+                <a16:creationId xmlns:a16="http://schemas.microsoft.com/office/drawing/2014/main" id="{F9A84899-08CF-4DC1-B27D-D62D9B179198}"/>
               </a:ext>
             </a:extLst>
           </p:cNvPr>
@@ -20302,7 +20325,7 @@
           <p:cNvPr id="5" name="">
             <a:extLst xmlns:a="http://schemas.openxmlformats.org/drawingml/2006/main">
               <a:ext uri="{FF2B5EF4-FFF2-40B4-BE49-F238E27FC236}">
-                <a16:creationId xmlns:a16="http://schemas.microsoft.com/office/drawing/2014/main" id="{70064C00-D92A-4F6E-B267-CBC13773D03A}"/>
+                <a16:creationId xmlns:a16="http://schemas.microsoft.com/office/drawing/2014/main" id="{7EED2B27-6B53-449E-8944-4F0FDC3650BC}"/>
               </a:ext>
             </a:extLst>
           </p:cNvPr>
@@ -20508,7 +20531,7 @@
                 <a:ea typeface="Arial"/>
                 <a:cs typeface="Arial"/>
               </a:rPr>
-              <a:t>Testes aprovados não garantem convergência em todos os casos</a:t>
+              <a:t>Regressões cobrem recuperação e estados finais</a:t>
             </a:r>
           </a:p>
         </p:txBody>
@@ -20518,7 +20541,7 @@
           <p:cNvPr id="6" name="">
             <a:extLst xmlns:a="http://schemas.openxmlformats.org/drawingml/2006/main">
               <a:ext uri="{FF2B5EF4-FFF2-40B4-BE49-F238E27FC236}">
-                <a16:creationId xmlns:a16="http://schemas.microsoft.com/office/drawing/2014/main" id="{3385B796-BD95-4023-8DB6-C1B76F8EF958}"/>
+                <a16:creationId xmlns:a16="http://schemas.microsoft.com/office/drawing/2014/main" id="{DF076522-687E-4A9A-8CBC-DDECD02A2852}"/>
               </a:ext>
             </a:extLst>
           </p:cNvPr>
@@ -20676,7 +20699,7 @@
           <p:cNvPr id="7" name="">
             <a:extLst xmlns:a="http://schemas.openxmlformats.org/drawingml/2006/main">
               <a:ext uri="{FF2B5EF4-FFF2-40B4-BE49-F238E27FC236}">
-                <a16:creationId xmlns:a16="http://schemas.microsoft.com/office/drawing/2014/main" id="{6133BBD3-E51D-4D0A-9296-0FB6F0DD9D00}"/>
+                <a16:creationId xmlns:a16="http://schemas.microsoft.com/office/drawing/2014/main" id="{CD2B1CD0-36B8-4A69-A9D2-BAE0FE3A135D}"/>
               </a:ext>
             </a:extLst>
           </p:cNvPr>
@@ -20828,7 +20851,7 @@
                 <a:ea typeface="Arial"/>
                 <a:cs typeface="Arial"/>
               </a:rPr>
-              <a:t>F3 pode permanecer STARTED após resolução</a:t>
+              <a:t>F3 aguarda a abertura e permite reprocessamento</a:t>
             </a:r>
           </a:p>
           <a:p xmlns:a="http://schemas.openxmlformats.org/drawingml/2006/main">
@@ -20855,7 +20878,7 @@
                 <a:ea typeface="Arial"/>
                 <a:cs typeface="Arial"/>
               </a:rPr>
-              <a:t>Processo COMPLETED pode ter tarefa CANCELLED</a:t>
+              <a:t>Processo respeita o agregado das tarefas</a:t>
             </a:r>
           </a:p>
           <a:p xmlns:a="http://schemas.openxmlformats.org/drawingml/2006/main">
@@ -20882,7 +20905,7 @@
                 <a:ea typeface="Arial"/>
                 <a:cs typeface="Arial"/>
               </a:rPr>
-              <a:t>Fatura exibida OVERDUE pode ser cancelada</a:t>
+              <a:t>Fatura vencida não aceita cancelamento</a:t>
             </a:r>
           </a:p>
           <a:p xmlns:a="http://schemas.openxmlformats.org/drawingml/2006/main">
@@ -20909,7 +20932,7 @@
                 <a:ea typeface="Arial"/>
                 <a:cs typeface="Arial"/>
               </a:rPr>
-              <a:t>Nomes e contribuições individuais pendentes</a:t>
+              <a:t>Rodrigo Nenato e Raquel: autoria preenchida</a:t>
             </a:r>
           </a:p>
         </p:txBody>
@@ -20919,7 +20942,7 @@
           <p:cNvPr id="8" name="">
             <a:extLst xmlns:a="http://schemas.openxmlformats.org/drawingml/2006/main">
               <a:ext uri="{FF2B5EF4-FFF2-40B4-BE49-F238E27FC236}">
-                <a16:creationId xmlns:a16="http://schemas.microsoft.com/office/drawing/2014/main" id="{15A0E840-E4C6-48A6-BC48-5C42CCB5A79F}"/>
+                <a16:creationId xmlns:a16="http://schemas.microsoft.com/office/drawing/2014/main" id="{6C93E6A3-61F0-4DF3-9DF8-F7900B288572}"/>
               </a:ext>
             </a:extLst>
           </p:cNvPr>
@@ -21098,7 +21121,7 @@
     </p:spTree>
     <p:extLst>
       <p:ext uri="{BB962C8B-B14F-4D97-AF65-F5344CB8AC3E}">
-        <p14:creationId xmlns:p14="http://schemas.microsoft.com/office/powerpoint/2010/main" val="517809180"/>
+        <p14:creationId xmlns:p14="http://schemas.microsoft.com/office/powerpoint/2010/main" val="1612740335"/>
       </p:ext>
     </p:extLst>
   </p:cSld>
@@ -21129,7 +21152,7 @@
           <p:cNvPr id="10" name="">
             <a:extLst xmlns:a="http://schemas.openxmlformats.org/drawingml/2006/main">
               <a:ext uri="{FF2B5EF4-FFF2-40B4-BE49-F238E27FC236}">
-                <a16:creationId xmlns:a16="http://schemas.microsoft.com/office/drawing/2014/main" id="{E0335C8B-E43F-4222-8607-B6FC71731678}"/>
+                <a16:creationId xmlns:a16="http://schemas.microsoft.com/office/drawing/2014/main" id="{E7A77448-D129-4FB0-AFA1-3ADE8F85F7FD}"/>
               </a:ext>
             </a:extLst>
           </p:cNvPr>
@@ -21159,7 +21182,7 @@
           <p:cNvPr id="2" name="">
             <a:extLst xmlns:a="http://schemas.openxmlformats.org/drawingml/2006/main">
               <a:ext uri="{FF2B5EF4-FFF2-40B4-BE49-F238E27FC236}">
-                <a16:creationId xmlns:a16="http://schemas.microsoft.com/office/drawing/2014/main" id="{C5EBA234-595C-4C62-9105-C2D34E56C00D}"/>
+                <a16:creationId xmlns:a16="http://schemas.microsoft.com/office/drawing/2014/main" id="{C2C3006D-BDF9-47AB-97C0-82B073D8684F}"/>
               </a:ext>
             </a:extLst>
           </p:cNvPr>
@@ -21317,7 +21340,7 @@
           <p:cNvPr id="3" name="">
             <a:extLst xmlns:a="http://schemas.openxmlformats.org/drawingml/2006/main">
               <a:ext uri="{FF2B5EF4-FFF2-40B4-BE49-F238E27FC236}">
-                <a16:creationId xmlns:a16="http://schemas.microsoft.com/office/drawing/2014/main" id="{237B0CFB-0788-4324-9A8E-0C06F85229D8}"/>
+                <a16:creationId xmlns:a16="http://schemas.microsoft.com/office/drawing/2014/main" id="{F089ADCB-2E35-4F99-8F87-FAF89F404FAD}"/>
               </a:ext>
             </a:extLst>
           </p:cNvPr>
@@ -21475,7 +21498,7 @@
           <p:cNvPr id="4" name="">
             <a:extLst xmlns:a="http://schemas.openxmlformats.org/drawingml/2006/main">
               <a:ext uri="{FF2B5EF4-FFF2-40B4-BE49-F238E27FC236}">
-                <a16:creationId xmlns:a16="http://schemas.microsoft.com/office/drawing/2014/main" id="{CBD8D149-7B95-4B7F-9D93-C2BAB1795A67}"/>
+                <a16:creationId xmlns:a16="http://schemas.microsoft.com/office/drawing/2014/main" id="{DFC71942-2E96-498E-AE7E-56570E586299}"/>
               </a:ext>
             </a:extLst>
           </p:cNvPr>
@@ -21718,7 +21741,7 @@
           <p:cNvPr id="5" name="">
             <a:extLst xmlns:a="http://schemas.openxmlformats.org/drawingml/2006/main">
               <a:ext uri="{FF2B5EF4-FFF2-40B4-BE49-F238E27FC236}">
-                <a16:creationId xmlns:a16="http://schemas.microsoft.com/office/drawing/2014/main" id="{3AD8A57F-039E-4B1F-8F5C-94452F937C79}"/>
+                <a16:creationId xmlns:a16="http://schemas.microsoft.com/office/drawing/2014/main" id="{012F5941-4012-4CCA-9219-18F413FDE365}"/>
               </a:ext>
             </a:extLst>
           </p:cNvPr>
@@ -21883,7 +21906,7 @@
           <p:cNvPr id="6" name="">
             <a:extLst xmlns:a="http://schemas.openxmlformats.org/drawingml/2006/main">
               <a:ext uri="{FF2B5EF4-FFF2-40B4-BE49-F238E27FC236}">
-                <a16:creationId xmlns:a16="http://schemas.microsoft.com/office/drawing/2014/main" id="{B3691AFD-7A20-48DE-A2C0-C9B2AAC6B88E}"/>
+                <a16:creationId xmlns:a16="http://schemas.microsoft.com/office/drawing/2014/main" id="{0577D115-C128-48F8-AE5A-0CA75881F84F}"/>
               </a:ext>
             </a:extLst>
           </p:cNvPr>
@@ -22048,7 +22071,7 @@
           <p:cNvPr id="7" name="">
             <a:extLst xmlns:a="http://schemas.openxmlformats.org/drawingml/2006/main">
               <a:ext uri="{FF2B5EF4-FFF2-40B4-BE49-F238E27FC236}">
-                <a16:creationId xmlns:a16="http://schemas.microsoft.com/office/drawing/2014/main" id="{DB38D867-BDD1-40A3-92D2-BB67F4BC18B5}"/>
+                <a16:creationId xmlns:a16="http://schemas.microsoft.com/office/drawing/2014/main" id="{84459E7E-8EBE-43BC-909F-79C05DCB9BA9}"/>
               </a:ext>
             </a:extLst>
           </p:cNvPr>
@@ -22213,7 +22236,7 @@
           <p:cNvPr id="8" name="">
             <a:extLst xmlns:a="http://schemas.openxmlformats.org/drawingml/2006/main">
               <a:ext uri="{FF2B5EF4-FFF2-40B4-BE49-F238E27FC236}">
-                <a16:creationId xmlns:a16="http://schemas.microsoft.com/office/drawing/2014/main" id="{7F72EE14-BE14-459F-9105-FEDDA616AA61}"/>
+                <a16:creationId xmlns:a16="http://schemas.microsoft.com/office/drawing/2014/main" id="{69A5CE3A-8EBB-435C-9AF3-BB5F30D2211D}"/>
               </a:ext>
             </a:extLst>
           </p:cNvPr>
@@ -22378,7 +22401,7 @@
           <p:cNvPr id="9" name="">
             <a:extLst xmlns:a="http://schemas.openxmlformats.org/drawingml/2006/main">
               <a:ext uri="{FF2B5EF4-FFF2-40B4-BE49-F238E27FC236}">
-                <a16:creationId xmlns:a16="http://schemas.microsoft.com/office/drawing/2014/main" id="{FC3228AD-4249-46D3-876B-907D36D323CD}"/>
+                <a16:creationId xmlns:a16="http://schemas.microsoft.com/office/drawing/2014/main" id="{620C75AF-6EAD-428F-9C19-5641B0D8F409}"/>
               </a:ext>
             </a:extLst>
           </p:cNvPr>
@@ -22541,7 +22564,7 @@
     </p:spTree>
     <p:extLst>
       <p:ext uri="{BB962C8B-B14F-4D97-AF65-F5344CB8AC3E}">
-        <p14:creationId xmlns:p14="http://schemas.microsoft.com/office/powerpoint/2010/main" val="1337664166"/>
+        <p14:creationId xmlns:p14="http://schemas.microsoft.com/office/powerpoint/2010/main" val="390930540"/>
       </p:ext>
     </p:extLst>
   </p:cSld>
@@ -22572,7 +22595,7 @@
           <p:cNvPr id="7" name="">
             <a:extLst xmlns:a="http://schemas.openxmlformats.org/drawingml/2006/main">
               <a:ext uri="{FF2B5EF4-FFF2-40B4-BE49-F238E27FC236}">
-                <a16:creationId xmlns:a16="http://schemas.microsoft.com/office/drawing/2014/main" id="{97EA82A6-C1DB-4580-B3C3-DEB9ECEF3B19}"/>
+                <a16:creationId xmlns:a16="http://schemas.microsoft.com/office/drawing/2014/main" id="{8DEAABE5-076A-4681-BEDA-E28AEC5E545E}"/>
               </a:ext>
             </a:extLst>
           </p:cNvPr>
@@ -22602,7 +22625,7 @@
           <p:cNvPr id="2" name="">
             <a:extLst xmlns:a="http://schemas.openxmlformats.org/drawingml/2006/main">
               <a:ext uri="{FF2B5EF4-FFF2-40B4-BE49-F238E27FC236}">
-                <a16:creationId xmlns:a16="http://schemas.microsoft.com/office/drawing/2014/main" id="{F0414E2E-8BD6-45BC-8A82-AFF47486FD88}"/>
+                <a16:creationId xmlns:a16="http://schemas.microsoft.com/office/drawing/2014/main" id="{AACE7BBD-9CA6-458C-A760-A1555EACF54C}"/>
               </a:ext>
             </a:extLst>
           </p:cNvPr>
@@ -22760,7 +22783,7 @@
           <p:cNvPr id="3" name="">
             <a:extLst xmlns:a="http://schemas.openxmlformats.org/drawingml/2006/main">
               <a:ext uri="{FF2B5EF4-FFF2-40B4-BE49-F238E27FC236}">
-                <a16:creationId xmlns:a16="http://schemas.microsoft.com/office/drawing/2014/main" id="{B420374A-252C-4EF7-87E4-71DB9AB896C8}"/>
+                <a16:creationId xmlns:a16="http://schemas.microsoft.com/office/drawing/2014/main" id="{2A1CD59F-B665-4529-B910-D900B185B1E8}"/>
               </a:ext>
             </a:extLst>
           </p:cNvPr>
@@ -22918,7 +22941,7 @@
           <p:cNvPr id="4" name="">
             <a:extLst xmlns:a="http://schemas.openxmlformats.org/drawingml/2006/main">
               <a:ext uri="{FF2B5EF4-FFF2-40B4-BE49-F238E27FC236}">
-                <a16:creationId xmlns:a16="http://schemas.microsoft.com/office/drawing/2014/main" id="{AF232A1D-FF4C-4CA8-8D80-1CA9A92C296B}"/>
+                <a16:creationId xmlns:a16="http://schemas.microsoft.com/office/drawing/2014/main" id="{A1EFB56E-E2D2-47EE-A108-EFAD88C3039F}"/>
               </a:ext>
             </a:extLst>
           </p:cNvPr>
@@ -23076,7 +23099,7 @@
           <p:cNvPr id="5" name="">
             <a:extLst xmlns:a="http://schemas.openxmlformats.org/drawingml/2006/main">
               <a:ext uri="{FF2B5EF4-FFF2-40B4-BE49-F238E27FC236}">
-                <a16:creationId xmlns:a16="http://schemas.microsoft.com/office/drawing/2014/main" id="{C8E56E33-948A-4F71-8B17-343D6C500A58}"/>
+                <a16:creationId xmlns:a16="http://schemas.microsoft.com/office/drawing/2014/main" id="{C63B3DD1-C222-4069-AE4B-8C134F2788E1}"/>
               </a:ext>
             </a:extLst>
           </p:cNvPr>
@@ -23086,7 +23109,7 @@
           <p:nvPr/>
         </p:nvPicPr>
         <p:blipFill>
-          <a:blip xmlns:r="http://schemas.openxmlformats.org/officeDocument/2006/relationships" xmlns:a="http://schemas.openxmlformats.org/drawingml/2006/main" r:embed="R442d3fdbdb804d02"/>
+          <a:blip xmlns:r="http://schemas.openxmlformats.org/officeDocument/2006/relationships" xmlns:a="http://schemas.openxmlformats.org/drawingml/2006/main" r:embed="R00597fbca7ba4e53"/>
           <a:stretch xmlns:a="http://schemas.openxmlformats.org/drawingml/2006/main"/>
         </p:blipFill>
         <p:spPr>
@@ -23104,7 +23127,7 @@
           <p:cNvPr id="6" name="">
             <a:extLst xmlns:a="http://schemas.openxmlformats.org/drawingml/2006/main">
               <a:ext uri="{FF2B5EF4-FFF2-40B4-BE49-F238E27FC236}">
-                <a16:creationId xmlns:a16="http://schemas.microsoft.com/office/drawing/2014/main" id="{F79936A9-56F9-4FD1-8DFA-DF65F8218652}"/>
+                <a16:creationId xmlns:a16="http://schemas.microsoft.com/office/drawing/2014/main" id="{CD15E2B0-E84E-45D8-BC0D-E3AF944C04E4}"/>
               </a:ext>
             </a:extLst>
           </p:cNvPr>
@@ -23260,7 +23283,7 @@
     </p:spTree>
     <p:extLst>
       <p:ext uri="{BB962C8B-B14F-4D97-AF65-F5344CB8AC3E}">
-        <p14:creationId xmlns:p14="http://schemas.microsoft.com/office/powerpoint/2010/main" val="398864758"/>
+        <p14:creationId xmlns:p14="http://schemas.microsoft.com/office/powerpoint/2010/main" val="541421640"/>
       </p:ext>
     </p:extLst>
   </p:cSld>
@@ -23291,7 +23314,7 @@
           <p:cNvPr id="7" name="">
             <a:extLst xmlns:a="http://schemas.openxmlformats.org/drawingml/2006/main">
               <a:ext uri="{FF2B5EF4-FFF2-40B4-BE49-F238E27FC236}">
-                <a16:creationId xmlns:a16="http://schemas.microsoft.com/office/drawing/2014/main" id="{886102EE-96FA-47D9-BF09-9BD7449EDD21}"/>
+                <a16:creationId xmlns:a16="http://schemas.microsoft.com/office/drawing/2014/main" id="{FF6188FE-2CC5-4A9D-8E92-ADD122FA1F02}"/>
               </a:ext>
             </a:extLst>
           </p:cNvPr>
@@ -23321,7 +23344,7 @@
           <p:cNvPr id="2" name="">
             <a:extLst xmlns:a="http://schemas.openxmlformats.org/drawingml/2006/main">
               <a:ext uri="{FF2B5EF4-FFF2-40B4-BE49-F238E27FC236}">
-                <a16:creationId xmlns:a16="http://schemas.microsoft.com/office/drawing/2014/main" id="{11F66293-8AC4-47BB-8278-AC6C4A3B8603}"/>
+                <a16:creationId xmlns:a16="http://schemas.microsoft.com/office/drawing/2014/main" id="{CA964D7C-4680-44B3-8382-37DC7CF6DE51}"/>
               </a:ext>
             </a:extLst>
           </p:cNvPr>
@@ -23479,7 +23502,7 @@
           <p:cNvPr id="3" name="">
             <a:extLst xmlns:a="http://schemas.openxmlformats.org/drawingml/2006/main">
               <a:ext uri="{FF2B5EF4-FFF2-40B4-BE49-F238E27FC236}">
-                <a16:creationId xmlns:a16="http://schemas.microsoft.com/office/drawing/2014/main" id="{1D65ABC2-F1CF-4333-9E0F-4525A0C298E5}"/>
+                <a16:creationId xmlns:a16="http://schemas.microsoft.com/office/drawing/2014/main" id="{B25E8B3F-65E2-46D0-9E26-D6FD8F170AA7}"/>
               </a:ext>
             </a:extLst>
           </p:cNvPr>
@@ -23637,7 +23660,7 @@
           <p:cNvPr id="4" name="">
             <a:extLst xmlns:a="http://schemas.openxmlformats.org/drawingml/2006/main">
               <a:ext uri="{FF2B5EF4-FFF2-40B4-BE49-F238E27FC236}">
-                <a16:creationId xmlns:a16="http://schemas.microsoft.com/office/drawing/2014/main" id="{1A3CCC3A-2B2C-4FD9-8649-6105A43A7074}"/>
+                <a16:creationId xmlns:a16="http://schemas.microsoft.com/office/drawing/2014/main" id="{1211133D-5770-424D-894D-82BF65B5075D}"/>
               </a:ext>
             </a:extLst>
           </p:cNvPr>
@@ -23880,7 +23903,7 @@
           <p:cNvPr id="5" name="">
             <a:extLst xmlns:a="http://schemas.openxmlformats.org/drawingml/2006/main">
               <a:ext uri="{FF2B5EF4-FFF2-40B4-BE49-F238E27FC236}">
-                <a16:creationId xmlns:a16="http://schemas.microsoft.com/office/drawing/2014/main" id="{9A06A441-3A0B-4F27-B487-EC4C56DF340D}"/>
+                <a16:creationId xmlns:a16="http://schemas.microsoft.com/office/drawing/2014/main" id="{C5DB6BCE-6CDB-4BE2-9666-02BF7129FF56}"/>
               </a:ext>
             </a:extLst>
           </p:cNvPr>
@@ -24038,7 +24061,7 @@
           <p:cNvPr id="6" name="">
             <a:extLst xmlns:a="http://schemas.openxmlformats.org/drawingml/2006/main">
               <a:ext uri="{FF2B5EF4-FFF2-40B4-BE49-F238E27FC236}">
-                <a16:creationId xmlns:a16="http://schemas.microsoft.com/office/drawing/2014/main" id="{44F76592-ACF6-4AC4-91BA-1F2B40EE488E}"/>
+                <a16:creationId xmlns:a16="http://schemas.microsoft.com/office/drawing/2014/main" id="{2D2D2631-3E43-476A-8824-6A12C48D3263}"/>
               </a:ext>
             </a:extLst>
           </p:cNvPr>
@@ -24360,7 +24383,7 @@
     </p:spTree>
     <p:extLst>
       <p:ext uri="{BB962C8B-B14F-4D97-AF65-F5344CB8AC3E}">
-        <p14:creationId xmlns:p14="http://schemas.microsoft.com/office/powerpoint/2010/main" val="2047447363"/>
+        <p14:creationId xmlns:p14="http://schemas.microsoft.com/office/powerpoint/2010/main" val="1373173452"/>
       </p:ext>
     </p:extLst>
   </p:cSld>
@@ -24391,7 +24414,7 @@
           <p:cNvPr id="7" name="">
             <a:extLst xmlns:a="http://schemas.openxmlformats.org/drawingml/2006/main">
               <a:ext uri="{FF2B5EF4-FFF2-40B4-BE49-F238E27FC236}">
-                <a16:creationId xmlns:a16="http://schemas.microsoft.com/office/drawing/2014/main" id="{98F2F754-873C-4104-965B-B9EE8B65EFB2}"/>
+                <a16:creationId xmlns:a16="http://schemas.microsoft.com/office/drawing/2014/main" id="{B0B7DF4D-F362-41EF-8103-DF4723628F1E}"/>
               </a:ext>
             </a:extLst>
           </p:cNvPr>
@@ -24421,7 +24444,7 @@
           <p:cNvPr id="2" name="">
             <a:extLst xmlns:a="http://schemas.openxmlformats.org/drawingml/2006/main">
               <a:ext uri="{FF2B5EF4-FFF2-40B4-BE49-F238E27FC236}">
-                <a16:creationId xmlns:a16="http://schemas.microsoft.com/office/drawing/2014/main" id="{5CFD0B6F-563E-4F01-A384-71ABC8ACADCD}"/>
+                <a16:creationId xmlns:a16="http://schemas.microsoft.com/office/drawing/2014/main" id="{A995A89A-C901-462B-8156-E0D7BD720F1E}"/>
               </a:ext>
             </a:extLst>
           </p:cNvPr>
@@ -24579,7 +24602,7 @@
           <p:cNvPr id="3" name="">
             <a:extLst xmlns:a="http://schemas.openxmlformats.org/drawingml/2006/main">
               <a:ext uri="{FF2B5EF4-FFF2-40B4-BE49-F238E27FC236}">
-                <a16:creationId xmlns:a16="http://schemas.microsoft.com/office/drawing/2014/main" id="{D2A3E201-D138-45B4-BA58-FA3A0A108947}"/>
+                <a16:creationId xmlns:a16="http://schemas.microsoft.com/office/drawing/2014/main" id="{083A2076-4661-4804-BB7B-68B2B8F36082}"/>
               </a:ext>
             </a:extLst>
           </p:cNvPr>
@@ -24737,7 +24760,7 @@
           <p:cNvPr id="4" name="">
             <a:extLst xmlns:a="http://schemas.openxmlformats.org/drawingml/2006/main">
               <a:ext uri="{FF2B5EF4-FFF2-40B4-BE49-F238E27FC236}">
-                <a16:creationId xmlns:a16="http://schemas.microsoft.com/office/drawing/2014/main" id="{C51D28E8-35E4-44C3-9D29-EFE2F708EC51}"/>
+                <a16:creationId xmlns:a16="http://schemas.microsoft.com/office/drawing/2014/main" id="{F482C684-B6F2-4347-A502-AE1EC4DBC2B2}"/>
               </a:ext>
             </a:extLst>
           </p:cNvPr>
@@ -24895,7 +24918,7 @@
           <p:cNvPr id="5" name="">
             <a:extLst xmlns:a="http://schemas.openxmlformats.org/drawingml/2006/main">
               <a:ext uri="{FF2B5EF4-FFF2-40B4-BE49-F238E27FC236}">
-                <a16:creationId xmlns:a16="http://schemas.microsoft.com/office/drawing/2014/main" id="{15A8E860-985A-403F-A180-FCE25F533246}"/>
+                <a16:creationId xmlns:a16="http://schemas.microsoft.com/office/drawing/2014/main" id="{1777EF93-79CF-41C5-9361-9AFA1B6119B9}"/>
               </a:ext>
             </a:extLst>
           </p:cNvPr>
@@ -25138,7 +25161,7 @@
           <p:cNvPr id="6" name="">
             <a:extLst xmlns:a="http://schemas.openxmlformats.org/drawingml/2006/main">
               <a:ext uri="{FF2B5EF4-FFF2-40B4-BE49-F238E27FC236}">
-                <a16:creationId xmlns:a16="http://schemas.microsoft.com/office/drawing/2014/main" id="{4E71C85D-3A8E-43E3-A60F-4ADFF978E94F}"/>
+                <a16:creationId xmlns:a16="http://schemas.microsoft.com/office/drawing/2014/main" id="{05CBA4DB-2E4A-4C2A-ABCC-94640DCA660C}"/>
               </a:ext>
             </a:extLst>
           </p:cNvPr>
@@ -25294,7 +25317,7 @@
     </p:spTree>
     <p:extLst>
       <p:ext uri="{BB962C8B-B14F-4D97-AF65-F5344CB8AC3E}">
-        <p14:creationId xmlns:p14="http://schemas.microsoft.com/office/powerpoint/2010/main" val="1820411137"/>
+        <p14:creationId xmlns:p14="http://schemas.microsoft.com/office/powerpoint/2010/main" val="388130509"/>
       </p:ext>
     </p:extLst>
   </p:cSld>
@@ -25325,7 +25348,7 @@
           <p:cNvPr id="7" name="">
             <a:extLst xmlns:a="http://schemas.openxmlformats.org/drawingml/2006/main">
               <a:ext uri="{FF2B5EF4-FFF2-40B4-BE49-F238E27FC236}">
-                <a16:creationId xmlns:a16="http://schemas.microsoft.com/office/drawing/2014/main" id="{30AD806D-C1E8-4518-9AFD-173078EA6FF9}"/>
+                <a16:creationId xmlns:a16="http://schemas.microsoft.com/office/drawing/2014/main" id="{AC94F414-CC72-4E6F-BA5D-C5E0812A9D3A}"/>
               </a:ext>
             </a:extLst>
           </p:cNvPr>
@@ -25355,7 +25378,7 @@
           <p:cNvPr id="2" name="">
             <a:extLst xmlns:a="http://schemas.openxmlformats.org/drawingml/2006/main">
               <a:ext uri="{FF2B5EF4-FFF2-40B4-BE49-F238E27FC236}">
-                <a16:creationId xmlns:a16="http://schemas.microsoft.com/office/drawing/2014/main" id="{B266E570-FEDC-47B1-A6E2-D3A5D28613F6}"/>
+                <a16:creationId xmlns:a16="http://schemas.microsoft.com/office/drawing/2014/main" id="{24E620F5-3418-4CB7-A7FA-22D0FE3AB234}"/>
               </a:ext>
             </a:extLst>
           </p:cNvPr>
@@ -25513,7 +25536,7 @@
           <p:cNvPr id="3" name="">
             <a:extLst xmlns:a="http://schemas.openxmlformats.org/drawingml/2006/main">
               <a:ext uri="{FF2B5EF4-FFF2-40B4-BE49-F238E27FC236}">
-                <a16:creationId xmlns:a16="http://schemas.microsoft.com/office/drawing/2014/main" id="{83CCC297-26DE-41E5-972F-65BC252AEFA9}"/>
+                <a16:creationId xmlns:a16="http://schemas.microsoft.com/office/drawing/2014/main" id="{B156B0F5-BA73-46B7-AD9D-694CC70BE468}"/>
               </a:ext>
             </a:extLst>
           </p:cNvPr>
@@ -25671,7 +25694,7 @@
           <p:cNvPr id="4" name="">
             <a:extLst xmlns:a="http://schemas.openxmlformats.org/drawingml/2006/main">
               <a:ext uri="{FF2B5EF4-FFF2-40B4-BE49-F238E27FC236}">
-                <a16:creationId xmlns:a16="http://schemas.microsoft.com/office/drawing/2014/main" id="{295DD83C-2377-48CE-8D4A-73D4261260DA}"/>
+                <a16:creationId xmlns:a16="http://schemas.microsoft.com/office/drawing/2014/main" id="{BFDB6BE7-33C5-406A-8B6B-BD5F1A2C6CB9}"/>
               </a:ext>
             </a:extLst>
           </p:cNvPr>
@@ -25681,7 +25704,7 @@
           <p:nvPr/>
         </p:nvPicPr>
         <p:blipFill>
-          <a:blip xmlns:r="http://schemas.openxmlformats.org/officeDocument/2006/relationships" xmlns:a="http://schemas.openxmlformats.org/drawingml/2006/main" r:embed="Redaf8f5dac99459a"/>
+          <a:blip xmlns:r="http://schemas.openxmlformats.org/officeDocument/2006/relationships" xmlns:a="http://schemas.openxmlformats.org/drawingml/2006/main" r:embed="Rfe53bc55bb5c4c46"/>
           <a:stretch xmlns:a="http://schemas.openxmlformats.org/drawingml/2006/main"/>
         </p:blipFill>
         <p:spPr>
@@ -25699,7 +25722,7 @@
           <p:cNvPr id="5" name="">
             <a:extLst xmlns:a="http://schemas.openxmlformats.org/drawingml/2006/main">
               <a:ext uri="{FF2B5EF4-FFF2-40B4-BE49-F238E27FC236}">
-                <a16:creationId xmlns:a16="http://schemas.microsoft.com/office/drawing/2014/main" id="{AE0653C6-0CA9-43D4-910A-2BA305974C66}"/>
+                <a16:creationId xmlns:a16="http://schemas.microsoft.com/office/drawing/2014/main" id="{48A1F0D1-A325-4D0D-937A-8D83ACD47AEA}"/>
               </a:ext>
             </a:extLst>
           </p:cNvPr>
@@ -25942,7 +25965,7 @@
           <p:cNvPr id="6" name="">
             <a:extLst xmlns:a="http://schemas.openxmlformats.org/drawingml/2006/main">
               <a:ext uri="{FF2B5EF4-FFF2-40B4-BE49-F238E27FC236}">
-                <a16:creationId xmlns:a16="http://schemas.microsoft.com/office/drawing/2014/main" id="{C7603FDF-F0D7-470A-8294-756D630D83F3}"/>
+                <a16:creationId xmlns:a16="http://schemas.microsoft.com/office/drawing/2014/main" id="{A8179A96-3A00-45D9-8361-A2AF901E128A}"/>
               </a:ext>
             </a:extLst>
           </p:cNvPr>
@@ -26098,7 +26121,7 @@
     </p:spTree>
     <p:extLst>
       <p:ext uri="{BB962C8B-B14F-4D97-AF65-F5344CB8AC3E}">
-        <p14:creationId xmlns:p14="http://schemas.microsoft.com/office/powerpoint/2010/main" val="1583082640"/>
+        <p14:creationId xmlns:p14="http://schemas.microsoft.com/office/powerpoint/2010/main" val="1686717508"/>
       </p:ext>
     </p:extLst>
   </p:cSld>
@@ -26129,7 +26152,7 @@
           <p:cNvPr id="19" name="">
             <a:extLst xmlns:a="http://schemas.openxmlformats.org/drawingml/2006/main">
               <a:ext uri="{FF2B5EF4-FFF2-40B4-BE49-F238E27FC236}">
-                <a16:creationId xmlns:a16="http://schemas.microsoft.com/office/drawing/2014/main" id="{E0409CBA-4961-4347-87E7-025E85F66025}"/>
+                <a16:creationId xmlns:a16="http://schemas.microsoft.com/office/drawing/2014/main" id="{C4885B50-95C0-4FCB-BA17-525DC21D7C68}"/>
               </a:ext>
             </a:extLst>
           </p:cNvPr>
@@ -26159,7 +26182,7 @@
           <p:cNvPr id="2" name="">
             <a:extLst xmlns:a="http://schemas.openxmlformats.org/drawingml/2006/main">
               <a:ext uri="{FF2B5EF4-FFF2-40B4-BE49-F238E27FC236}">
-                <a16:creationId xmlns:a16="http://schemas.microsoft.com/office/drawing/2014/main" id="{D2DFCB02-AB6C-4AC5-A13B-18034DE4C6A8}"/>
+                <a16:creationId xmlns:a16="http://schemas.microsoft.com/office/drawing/2014/main" id="{00F22B0E-E950-46DF-8102-1FC2F8DA5834}"/>
               </a:ext>
             </a:extLst>
           </p:cNvPr>
@@ -26317,7 +26340,7 @@
           <p:cNvPr id="3" name="">
             <a:extLst xmlns:a="http://schemas.openxmlformats.org/drawingml/2006/main">
               <a:ext uri="{FF2B5EF4-FFF2-40B4-BE49-F238E27FC236}">
-                <a16:creationId xmlns:a16="http://schemas.microsoft.com/office/drawing/2014/main" id="{4F0C9736-0B23-40C4-B25F-EC89F8496781}"/>
+                <a16:creationId xmlns:a16="http://schemas.microsoft.com/office/drawing/2014/main" id="{F5E37194-EE30-4AE0-8D2B-7D60CBF8C393}"/>
               </a:ext>
             </a:extLst>
           </p:cNvPr>
@@ -26475,7 +26498,7 @@
           <p:cNvPr id="4" name="">
             <a:extLst xmlns:a="http://schemas.openxmlformats.org/drawingml/2006/main">
               <a:ext uri="{FF2B5EF4-FFF2-40B4-BE49-F238E27FC236}">
-                <a16:creationId xmlns:a16="http://schemas.microsoft.com/office/drawing/2014/main" id="{C7C61B60-5036-4BC4-9840-4FF31B42F823}"/>
+                <a16:creationId xmlns:a16="http://schemas.microsoft.com/office/drawing/2014/main" id="{DC9B3D8D-EEBB-4ED0-B9F2-FE8D3D6F4744}"/>
               </a:ext>
             </a:extLst>
           </p:cNvPr>
@@ -26640,7 +26663,7 @@
           <p:cNvPr id="5" name="">
             <a:extLst xmlns:a="http://schemas.openxmlformats.org/drawingml/2006/main">
               <a:ext uri="{FF2B5EF4-FFF2-40B4-BE49-F238E27FC236}">
-                <a16:creationId xmlns:a16="http://schemas.microsoft.com/office/drawing/2014/main" id="{084CD303-1A40-4E24-9815-5EFBEFDB05BE}"/>
+                <a16:creationId xmlns:a16="http://schemas.microsoft.com/office/drawing/2014/main" id="{66ADE6B7-439A-4355-9DBD-F998B348E452}"/>
               </a:ext>
             </a:extLst>
           </p:cNvPr>
@@ -26798,7 +26821,7 @@
           <p:cNvPr id="6" name="">
             <a:extLst xmlns:a="http://schemas.openxmlformats.org/drawingml/2006/main">
               <a:ext uri="{FF2B5EF4-FFF2-40B4-BE49-F238E27FC236}">
-                <a16:creationId xmlns:a16="http://schemas.microsoft.com/office/drawing/2014/main" id="{34E3E8ED-50AA-443A-B3D1-AC840FCFC425}"/>
+                <a16:creationId xmlns:a16="http://schemas.microsoft.com/office/drawing/2014/main" id="{66624EC8-D2A3-4847-9292-E87BAF92BE91}"/>
               </a:ext>
             </a:extLst>
           </p:cNvPr>
@@ -26956,7 +26979,7 @@
           <p:cNvPr id="7" name="">
             <a:extLst xmlns:a="http://schemas.openxmlformats.org/drawingml/2006/main">
               <a:ext uri="{FF2B5EF4-FFF2-40B4-BE49-F238E27FC236}">
-                <a16:creationId xmlns:a16="http://schemas.microsoft.com/office/drawing/2014/main" id="{8CC777C9-8A3B-41B7-902A-F217F9F8FF0E}"/>
+                <a16:creationId xmlns:a16="http://schemas.microsoft.com/office/drawing/2014/main" id="{EB78C3C1-F54F-403F-98D1-3850F19D430B}"/>
               </a:ext>
             </a:extLst>
           </p:cNvPr>
@@ -27121,7 +27144,7 @@
           <p:cNvPr id="8" name="">
             <a:extLst xmlns:a="http://schemas.openxmlformats.org/drawingml/2006/main">
               <a:ext uri="{FF2B5EF4-FFF2-40B4-BE49-F238E27FC236}">
-                <a16:creationId xmlns:a16="http://schemas.microsoft.com/office/drawing/2014/main" id="{1D1701FF-33BB-4F68-9BC5-653A11C9A3E7}"/>
+                <a16:creationId xmlns:a16="http://schemas.microsoft.com/office/drawing/2014/main" id="{EC6F1251-FD0A-4307-8D35-A22A605D7DC1}"/>
               </a:ext>
             </a:extLst>
           </p:cNvPr>
@@ -27279,7 +27302,7 @@
           <p:cNvPr id="9" name="">
             <a:extLst xmlns:a="http://schemas.openxmlformats.org/drawingml/2006/main">
               <a:ext uri="{FF2B5EF4-FFF2-40B4-BE49-F238E27FC236}">
-                <a16:creationId xmlns:a16="http://schemas.microsoft.com/office/drawing/2014/main" id="{BEF67298-0A01-4FAA-99F6-486446D08C80}"/>
+                <a16:creationId xmlns:a16="http://schemas.microsoft.com/office/drawing/2014/main" id="{F2ADAFE7-178C-45E2-8CDA-0B9CA64B1C61}"/>
               </a:ext>
             </a:extLst>
           </p:cNvPr>
@@ -27437,7 +27460,7 @@
           <p:cNvPr id="10" name="">
             <a:extLst xmlns:a="http://schemas.openxmlformats.org/drawingml/2006/main">
               <a:ext uri="{FF2B5EF4-FFF2-40B4-BE49-F238E27FC236}">
-                <a16:creationId xmlns:a16="http://schemas.microsoft.com/office/drawing/2014/main" id="{82D60308-7599-4175-B791-828D547D68F0}"/>
+                <a16:creationId xmlns:a16="http://schemas.microsoft.com/office/drawing/2014/main" id="{0DFF39E4-95DF-4B35-AC3A-EF69E3A8EA05}"/>
               </a:ext>
             </a:extLst>
           </p:cNvPr>
@@ -27602,7 +27625,7 @@
           <p:cNvPr id="11" name="">
             <a:extLst xmlns:a="http://schemas.openxmlformats.org/drawingml/2006/main">
               <a:ext uri="{FF2B5EF4-FFF2-40B4-BE49-F238E27FC236}">
-                <a16:creationId xmlns:a16="http://schemas.microsoft.com/office/drawing/2014/main" id="{DC338644-66D7-4D93-A5E0-8094F7E13F6A}"/>
+                <a16:creationId xmlns:a16="http://schemas.microsoft.com/office/drawing/2014/main" id="{EC89FE72-8553-4E17-8903-83B4B66C9983}"/>
               </a:ext>
             </a:extLst>
           </p:cNvPr>
@@ -27760,7 +27783,7 @@
           <p:cNvPr id="12" name="">
             <a:extLst xmlns:a="http://schemas.openxmlformats.org/drawingml/2006/main">
               <a:ext uri="{FF2B5EF4-FFF2-40B4-BE49-F238E27FC236}">
-                <a16:creationId xmlns:a16="http://schemas.microsoft.com/office/drawing/2014/main" id="{8A305D72-2909-4CEB-9DF6-82ABD60C5E19}"/>
+                <a16:creationId xmlns:a16="http://schemas.microsoft.com/office/drawing/2014/main" id="{6AE7846F-E65D-40EE-8206-A25D61B69E24}"/>
               </a:ext>
             </a:extLst>
           </p:cNvPr>
@@ -27918,7 +27941,7 @@
           <p:cNvPr id="13" name="">
             <a:extLst xmlns:a="http://schemas.openxmlformats.org/drawingml/2006/main">
               <a:ext uri="{FF2B5EF4-FFF2-40B4-BE49-F238E27FC236}">
-                <a16:creationId xmlns:a16="http://schemas.microsoft.com/office/drawing/2014/main" id="{7D29FEC2-7533-495C-AB3C-FEAD13FA31CF}"/>
+                <a16:creationId xmlns:a16="http://schemas.microsoft.com/office/drawing/2014/main" id="{8AA61C1E-50AB-4F11-A1BB-E1FF313036DE}"/>
               </a:ext>
             </a:extLst>
           </p:cNvPr>
@@ -28083,7 +28106,7 @@
           <p:cNvPr id="14" name="">
             <a:extLst xmlns:a="http://schemas.openxmlformats.org/drawingml/2006/main">
               <a:ext uri="{FF2B5EF4-FFF2-40B4-BE49-F238E27FC236}">
-                <a16:creationId xmlns:a16="http://schemas.microsoft.com/office/drawing/2014/main" id="{8C9FAAE1-5F74-4127-AB04-08778AFF83FE}"/>
+                <a16:creationId xmlns:a16="http://schemas.microsoft.com/office/drawing/2014/main" id="{E0BF4BCE-29C8-4F0E-8D42-582496CD2DFC}"/>
               </a:ext>
             </a:extLst>
           </p:cNvPr>
@@ -28241,7 +28264,7 @@
           <p:cNvPr id="15" name="">
             <a:extLst xmlns:a="http://schemas.openxmlformats.org/drawingml/2006/main">
               <a:ext uri="{FF2B5EF4-FFF2-40B4-BE49-F238E27FC236}">
-                <a16:creationId xmlns:a16="http://schemas.microsoft.com/office/drawing/2014/main" id="{1D457411-D8AE-4650-B633-D91D8C5E21FD}"/>
+                <a16:creationId xmlns:a16="http://schemas.microsoft.com/office/drawing/2014/main" id="{65015C2A-C3F0-44CD-B27D-9D8D530454B3}"/>
               </a:ext>
             </a:extLst>
           </p:cNvPr>
@@ -28399,7 +28422,7 @@
           <p:cNvPr id="16" name="">
             <a:extLst xmlns:a="http://schemas.openxmlformats.org/drawingml/2006/main">
               <a:ext uri="{FF2B5EF4-FFF2-40B4-BE49-F238E27FC236}">
-                <a16:creationId xmlns:a16="http://schemas.microsoft.com/office/drawing/2014/main" id="{2B9D7817-564C-4FB7-AD80-C8439F2073E0}"/>
+                <a16:creationId xmlns:a16="http://schemas.microsoft.com/office/drawing/2014/main" id="{7F565FB8-33CA-4B1E-ACC3-B18ABC61AC42}"/>
               </a:ext>
             </a:extLst>
           </p:cNvPr>
@@ -28564,7 +28587,7 @@
           <p:cNvPr id="17" name="">
             <a:extLst xmlns:a="http://schemas.openxmlformats.org/drawingml/2006/main">
               <a:ext uri="{FF2B5EF4-FFF2-40B4-BE49-F238E27FC236}">
-                <a16:creationId xmlns:a16="http://schemas.microsoft.com/office/drawing/2014/main" id="{5A4B0896-9D4D-4D5C-8752-6D7C68EF02FE}"/>
+                <a16:creationId xmlns:a16="http://schemas.microsoft.com/office/drawing/2014/main" id="{A0C2DD0B-C9EC-4A46-B5BB-DB5E99280D83}"/>
               </a:ext>
             </a:extLst>
           </p:cNvPr>
@@ -28722,7 +28745,7 @@
           <p:cNvPr id="18" name="">
             <a:extLst xmlns:a="http://schemas.openxmlformats.org/drawingml/2006/main">
               <a:ext uri="{FF2B5EF4-FFF2-40B4-BE49-F238E27FC236}">
-                <a16:creationId xmlns:a16="http://schemas.microsoft.com/office/drawing/2014/main" id="{87B2AB50-E4F2-4E81-88ED-9EBCDFDC1AD6}"/>
+                <a16:creationId xmlns:a16="http://schemas.microsoft.com/office/drawing/2014/main" id="{A8670CE3-6F04-4F26-BA4A-D14EBBB3BA6B}"/>
               </a:ext>
             </a:extLst>
           </p:cNvPr>
@@ -28878,7 +28901,7 @@
     </p:spTree>
     <p:extLst>
       <p:ext uri="{BB962C8B-B14F-4D97-AF65-F5344CB8AC3E}">
-        <p14:creationId xmlns:p14="http://schemas.microsoft.com/office/powerpoint/2010/main" val="289355591"/>
+        <p14:creationId xmlns:p14="http://schemas.microsoft.com/office/powerpoint/2010/main" val="1690840365"/>
       </p:ext>
     </p:extLst>
   </p:cSld>
@@ -28909,7 +28932,7 @@
           <p:cNvPr id="16" name="">
             <a:extLst xmlns:a="http://schemas.openxmlformats.org/drawingml/2006/main">
               <a:ext uri="{FF2B5EF4-FFF2-40B4-BE49-F238E27FC236}">
-                <a16:creationId xmlns:a16="http://schemas.microsoft.com/office/drawing/2014/main" id="{F0BED1FE-7BFD-43D8-824A-7ED81E844D80}"/>
+                <a16:creationId xmlns:a16="http://schemas.microsoft.com/office/drawing/2014/main" id="{D966E575-8626-4609-B303-A89D72BCB057}"/>
               </a:ext>
             </a:extLst>
           </p:cNvPr>
@@ -28939,7 +28962,7 @@
           <p:cNvPr id="2" name="">
             <a:extLst xmlns:a="http://schemas.openxmlformats.org/drawingml/2006/main">
               <a:ext uri="{FF2B5EF4-FFF2-40B4-BE49-F238E27FC236}">
-                <a16:creationId xmlns:a16="http://schemas.microsoft.com/office/drawing/2014/main" id="{76E52E5D-C938-4E04-A0B8-C0540BBFDDF3}"/>
+                <a16:creationId xmlns:a16="http://schemas.microsoft.com/office/drawing/2014/main" id="{99A58F8D-C44B-483D-A6F7-C92F3F143B10}"/>
               </a:ext>
             </a:extLst>
           </p:cNvPr>
@@ -29097,7 +29120,7 @@
           <p:cNvPr id="3" name="">
             <a:extLst xmlns:a="http://schemas.openxmlformats.org/drawingml/2006/main">
               <a:ext uri="{FF2B5EF4-FFF2-40B4-BE49-F238E27FC236}">
-                <a16:creationId xmlns:a16="http://schemas.microsoft.com/office/drawing/2014/main" id="{0F8FDC1A-2226-4932-AC79-DE0E39281508}"/>
+                <a16:creationId xmlns:a16="http://schemas.microsoft.com/office/drawing/2014/main" id="{656411FE-7353-4459-9A91-0BB947174BC9}"/>
               </a:ext>
             </a:extLst>
           </p:cNvPr>
@@ -29255,7 +29278,7 @@
           <p:cNvPr id="4" name="">
             <a:extLst xmlns:a="http://schemas.openxmlformats.org/drawingml/2006/main">
               <a:ext uri="{FF2B5EF4-FFF2-40B4-BE49-F238E27FC236}">
-                <a16:creationId xmlns:a16="http://schemas.microsoft.com/office/drawing/2014/main" id="{04B565D3-DE61-4994-9EDF-11549C5F63C9}"/>
+                <a16:creationId xmlns:a16="http://schemas.microsoft.com/office/drawing/2014/main" id="{C2596B0E-A4A3-4D75-8302-C0A77BA87E7A}"/>
               </a:ext>
             </a:extLst>
           </p:cNvPr>
@@ -29413,7 +29436,7 @@
           <p:cNvPr id="5" name="">
             <a:extLst xmlns:a="http://schemas.openxmlformats.org/drawingml/2006/main">
               <a:ext uri="{FF2B5EF4-FFF2-40B4-BE49-F238E27FC236}">
-                <a16:creationId xmlns:a16="http://schemas.microsoft.com/office/drawing/2014/main" id="{069B7356-2ECD-4FFA-A23E-197EA0E476B1}"/>
+                <a16:creationId xmlns:a16="http://schemas.microsoft.com/office/drawing/2014/main" id="{340E8D48-0C92-4B11-98F9-3728929D3ECB}"/>
               </a:ext>
             </a:extLst>
           </p:cNvPr>
@@ -29571,7 +29594,7 @@
           <p:cNvPr id="6" name="">
             <a:extLst xmlns:a="http://schemas.openxmlformats.org/drawingml/2006/main">
               <a:ext uri="{FF2B5EF4-FFF2-40B4-BE49-F238E27FC236}">
-                <a16:creationId xmlns:a16="http://schemas.microsoft.com/office/drawing/2014/main" id="{CC0B3C58-EE1C-4534-8D8D-23B7E8362735}"/>
+                <a16:creationId xmlns:a16="http://schemas.microsoft.com/office/drawing/2014/main" id="{AE15E547-94FA-4BC4-AC99-5F627C700237}"/>
               </a:ext>
             </a:extLst>
           </p:cNvPr>
@@ -29729,7 +29752,7 @@
           <p:cNvPr id="7" name="">
             <a:extLst xmlns:a="http://schemas.openxmlformats.org/drawingml/2006/main">
               <a:ext uri="{FF2B5EF4-FFF2-40B4-BE49-F238E27FC236}">
-                <a16:creationId xmlns:a16="http://schemas.microsoft.com/office/drawing/2014/main" id="{4EE51E81-809E-4898-B854-F7E30919F058}"/>
+                <a16:creationId xmlns:a16="http://schemas.microsoft.com/office/drawing/2014/main" id="{9B69D5E5-2ECE-4E41-A90B-C3AB4EA5D24D}"/>
               </a:ext>
             </a:extLst>
           </p:cNvPr>
@@ -29887,7 +29910,7 @@
           <p:cNvPr id="8" name="">
             <a:extLst xmlns:a="http://schemas.openxmlformats.org/drawingml/2006/main">
               <a:ext uri="{FF2B5EF4-FFF2-40B4-BE49-F238E27FC236}">
-                <a16:creationId xmlns:a16="http://schemas.microsoft.com/office/drawing/2014/main" id="{727E234D-AE82-4F74-862D-7C3615E1AEBE}"/>
+                <a16:creationId xmlns:a16="http://schemas.microsoft.com/office/drawing/2014/main" id="{67E011F3-A959-4FD0-89CE-BA14406E777E}"/>
               </a:ext>
             </a:extLst>
           </p:cNvPr>
@@ -30045,7 +30068,7 @@
           <p:cNvPr id="9" name="">
             <a:extLst xmlns:a="http://schemas.openxmlformats.org/drawingml/2006/main">
               <a:ext uri="{FF2B5EF4-FFF2-40B4-BE49-F238E27FC236}">
-                <a16:creationId xmlns:a16="http://schemas.microsoft.com/office/drawing/2014/main" id="{97A761F8-2495-468D-A9D7-B442A5479C82}"/>
+                <a16:creationId xmlns:a16="http://schemas.microsoft.com/office/drawing/2014/main" id="{606DBB31-35F0-4186-9549-C8CB9795B101}"/>
               </a:ext>
             </a:extLst>
           </p:cNvPr>
@@ -30203,7 +30226,7 @@
           <p:cNvPr id="10" name="">
             <a:extLst xmlns:a="http://schemas.openxmlformats.org/drawingml/2006/main">
               <a:ext uri="{FF2B5EF4-FFF2-40B4-BE49-F238E27FC236}">
-                <a16:creationId xmlns:a16="http://schemas.microsoft.com/office/drawing/2014/main" id="{F9CEAACD-A8F9-471D-B25B-59BB8CEAF801}"/>
+                <a16:creationId xmlns:a16="http://schemas.microsoft.com/office/drawing/2014/main" id="{E17C2F58-DC7A-4272-AF84-F03F57FF9D35}"/>
               </a:ext>
             </a:extLst>
           </p:cNvPr>
@@ -30361,7 +30384,7 @@
           <p:cNvPr id="11" name="">
             <a:extLst xmlns:a="http://schemas.openxmlformats.org/drawingml/2006/main">
               <a:ext uri="{FF2B5EF4-FFF2-40B4-BE49-F238E27FC236}">
-                <a16:creationId xmlns:a16="http://schemas.microsoft.com/office/drawing/2014/main" id="{CC7BC676-C41F-4038-9516-5CF7DA23F2E6}"/>
+                <a16:creationId xmlns:a16="http://schemas.microsoft.com/office/drawing/2014/main" id="{D4DC1B8C-343B-4890-AF04-9B3C86E3CAC8}"/>
               </a:ext>
             </a:extLst>
           </p:cNvPr>
@@ -30519,7 +30542,7 @@
           <p:cNvPr id="12" name="">
             <a:extLst xmlns:a="http://schemas.openxmlformats.org/drawingml/2006/main">
               <a:ext uri="{FF2B5EF4-FFF2-40B4-BE49-F238E27FC236}">
-                <a16:creationId xmlns:a16="http://schemas.microsoft.com/office/drawing/2014/main" id="{4E1664C6-24D8-4702-9F1D-B6B5A1B9A3F7}"/>
+                <a16:creationId xmlns:a16="http://schemas.microsoft.com/office/drawing/2014/main" id="{99446A95-983D-40A5-9F17-D6D52C49D07B}"/>
               </a:ext>
             </a:extLst>
           </p:cNvPr>
@@ -30677,7 +30700,7 @@
           <p:cNvPr id="13" name="">
             <a:extLst xmlns:a="http://schemas.openxmlformats.org/drawingml/2006/main">
               <a:ext uri="{FF2B5EF4-FFF2-40B4-BE49-F238E27FC236}">
-                <a16:creationId xmlns:a16="http://schemas.microsoft.com/office/drawing/2014/main" id="{B673505E-9AF5-4EFC-B1E1-A28EBA3891DF}"/>
+                <a16:creationId xmlns:a16="http://schemas.microsoft.com/office/drawing/2014/main" id="{1F070B79-2B19-4E38-A315-6EDE4EB2C084}"/>
               </a:ext>
             </a:extLst>
           </p:cNvPr>
@@ -30835,7 +30858,7 @@
           <p:cNvPr id="14" name="">
             <a:extLst xmlns:a="http://schemas.openxmlformats.org/drawingml/2006/main">
               <a:ext uri="{FF2B5EF4-FFF2-40B4-BE49-F238E27FC236}">
-                <a16:creationId xmlns:a16="http://schemas.microsoft.com/office/drawing/2014/main" id="{E1E53C14-CD57-47FC-9DE1-6E12D1D202E7}"/>
+                <a16:creationId xmlns:a16="http://schemas.microsoft.com/office/drawing/2014/main" id="{95DED94B-5EEF-4E03-8A6A-C37CBD55EC57}"/>
               </a:ext>
             </a:extLst>
           </p:cNvPr>
@@ -30993,7 +31016,7 @@
           <p:cNvPr id="15" name="">
             <a:extLst xmlns:a="http://schemas.openxmlformats.org/drawingml/2006/main">
               <a:ext uri="{FF2B5EF4-FFF2-40B4-BE49-F238E27FC236}">
-                <a16:creationId xmlns:a16="http://schemas.microsoft.com/office/drawing/2014/main" id="{F3E5B7E9-0A68-40B9-A874-A46BA01BA9A1}"/>
+                <a16:creationId xmlns:a16="http://schemas.microsoft.com/office/drawing/2014/main" id="{E15270A1-40B9-4CF1-989D-3692BAF6EBE7}"/>
               </a:ext>
             </a:extLst>
           </p:cNvPr>
@@ -31149,7 +31172,7 @@
     </p:spTree>
     <p:extLst>
       <p:ext uri="{BB962C8B-B14F-4D97-AF65-F5344CB8AC3E}">
-        <p14:creationId xmlns:p14="http://schemas.microsoft.com/office/powerpoint/2010/main" val="334837432"/>
+        <p14:creationId xmlns:p14="http://schemas.microsoft.com/office/powerpoint/2010/main" val="607549768"/>
       </p:ext>
     </p:extLst>
   </p:cSld>
@@ -31180,7 +31203,7 @@
           <p:cNvPr id="9" name="">
             <a:extLst xmlns:a="http://schemas.openxmlformats.org/drawingml/2006/main">
               <a:ext uri="{FF2B5EF4-FFF2-40B4-BE49-F238E27FC236}">
-                <a16:creationId xmlns:a16="http://schemas.microsoft.com/office/drawing/2014/main" id="{679E70A1-65C8-4B33-BFE3-6E03D4579892}"/>
+                <a16:creationId xmlns:a16="http://schemas.microsoft.com/office/drawing/2014/main" id="{F1C6E235-D020-41DE-993D-A453B969D22F}"/>
               </a:ext>
             </a:extLst>
           </p:cNvPr>
@@ -31210,7 +31233,7 @@
           <p:cNvPr id="2" name="">
             <a:extLst xmlns:a="http://schemas.openxmlformats.org/drawingml/2006/main">
               <a:ext uri="{FF2B5EF4-FFF2-40B4-BE49-F238E27FC236}">
-                <a16:creationId xmlns:a16="http://schemas.microsoft.com/office/drawing/2014/main" id="{09C87233-1984-4983-B8EE-B2ED28A4EAB6}"/>
+                <a16:creationId xmlns:a16="http://schemas.microsoft.com/office/drawing/2014/main" id="{F59D68F6-07B3-48D9-B5E9-072F4836C55B}"/>
               </a:ext>
             </a:extLst>
           </p:cNvPr>
@@ -31368,7 +31391,7 @@
           <p:cNvPr id="3" name="">
             <a:extLst xmlns:a="http://schemas.openxmlformats.org/drawingml/2006/main">
               <a:ext uri="{FF2B5EF4-FFF2-40B4-BE49-F238E27FC236}">
-                <a16:creationId xmlns:a16="http://schemas.microsoft.com/office/drawing/2014/main" id="{EB1469C1-131F-4A54-ACF3-6094BB65085A}"/>
+                <a16:creationId xmlns:a16="http://schemas.microsoft.com/office/drawing/2014/main" id="{ABB4DB3F-0D2F-45FC-A2ED-7967263420E6}"/>
               </a:ext>
             </a:extLst>
           </p:cNvPr>
@@ -31526,7 +31549,7 @@
           <p:cNvPr id="4" name="">
             <a:extLst xmlns:a="http://schemas.openxmlformats.org/drawingml/2006/main">
               <a:ext uri="{FF2B5EF4-FFF2-40B4-BE49-F238E27FC236}">
-                <a16:creationId xmlns:a16="http://schemas.microsoft.com/office/drawing/2014/main" id="{E852323D-D9B0-4E3D-9C4B-3B4870DABB3E}"/>
+                <a16:creationId xmlns:a16="http://schemas.microsoft.com/office/drawing/2014/main" id="{4B5EB6A3-CB77-4E10-B392-C04F01DE86E5}"/>
               </a:ext>
             </a:extLst>
           </p:cNvPr>
@@ -31796,7 +31819,7 @@
           <p:cNvPr id="5" name="">
             <a:extLst xmlns:a="http://schemas.openxmlformats.org/drawingml/2006/main">
               <a:ext uri="{FF2B5EF4-FFF2-40B4-BE49-F238E27FC236}">
-                <a16:creationId xmlns:a16="http://schemas.microsoft.com/office/drawing/2014/main" id="{37406DDB-A2DF-4173-AF41-1A7D47B9BC29}"/>
+                <a16:creationId xmlns:a16="http://schemas.microsoft.com/office/drawing/2014/main" id="{2ADC9111-5CF1-4EF1-A911-96E22B327F03}"/>
               </a:ext>
             </a:extLst>
           </p:cNvPr>
@@ -31984,7 +32007,7 @@
           <p:cNvPr id="6" name="">
             <a:extLst xmlns:a="http://schemas.openxmlformats.org/drawingml/2006/main">
               <a:ext uri="{FF2B5EF4-FFF2-40B4-BE49-F238E27FC236}">
-                <a16:creationId xmlns:a16="http://schemas.microsoft.com/office/drawing/2014/main" id="{327A070F-D4C3-4DB2-8D11-C4DAB06410FD}"/>
+                <a16:creationId xmlns:a16="http://schemas.microsoft.com/office/drawing/2014/main" id="{BF6AA0F7-2B29-4E1C-8510-B78E0CB8DAFE}"/>
               </a:ext>
             </a:extLst>
           </p:cNvPr>
@@ -32172,7 +32195,7 @@
           <p:cNvPr id="7" name="">
             <a:extLst xmlns:a="http://schemas.openxmlformats.org/drawingml/2006/main">
               <a:ext uri="{FF2B5EF4-FFF2-40B4-BE49-F238E27FC236}">
-                <a16:creationId xmlns:a16="http://schemas.microsoft.com/office/drawing/2014/main" id="{9E854349-887C-4C80-938B-8F179D81850C}"/>
+                <a16:creationId xmlns:a16="http://schemas.microsoft.com/office/drawing/2014/main" id="{346E31AD-DBC5-49FD-A33F-D9D5D2B94AFB}"/>
               </a:ext>
             </a:extLst>
           </p:cNvPr>
@@ -32360,7 +32383,7 @@
           <p:cNvPr id="8" name="">
             <a:extLst xmlns:a="http://schemas.openxmlformats.org/drawingml/2006/main">
               <a:ext uri="{FF2B5EF4-FFF2-40B4-BE49-F238E27FC236}">
-                <a16:creationId xmlns:a16="http://schemas.microsoft.com/office/drawing/2014/main" id="{DECA67F3-6154-45FB-AB0E-1F0DA66902A1}"/>
+                <a16:creationId xmlns:a16="http://schemas.microsoft.com/office/drawing/2014/main" id="{91CA0FFD-D1D8-49D1-8FD1-426C0BA0C393}"/>
               </a:ext>
             </a:extLst>
           </p:cNvPr>
@@ -32516,7 +32539,7 @@
     </p:spTree>
     <p:extLst>
       <p:ext uri="{BB962C8B-B14F-4D97-AF65-F5344CB8AC3E}">
-        <p14:creationId xmlns:p14="http://schemas.microsoft.com/office/powerpoint/2010/main" val="2143374585"/>
+        <p14:creationId xmlns:p14="http://schemas.microsoft.com/office/powerpoint/2010/main" val="1742231885"/>
       </p:ext>
     </p:extLst>
   </p:cSld>

</xml_diff>

<commit_message>
docs: corrige autoria para Roger Quinelato
</commit_message>
<xml_diff>
--- a/output/Apresentacao_Cenario_4.pptx
+++ b/output/Apresentacao_Cenario_4.pptx
@@ -2,30 +2,30 @@
 <file path=ppt/presentation.xml><?xml version="1.0" encoding="utf-8"?>
 <p:presentation xmlns:p="http://schemas.openxmlformats.org/presentationml/2006/main">
   <p:sldMasterIdLst>
-    <p:sldMasterId xmlns:r="http://schemas.openxmlformats.org/officeDocument/2006/relationships" id="2147483648" r:id="R263f44df8d6f4c4e"/>
+    <p:sldMasterId xmlns:r="http://schemas.openxmlformats.org/officeDocument/2006/relationships" id="2147483648" r:id="Rae7307d456dd468c"/>
   </p:sldMasterIdLst>
   <p:notesMasterIdLst>
-    <p:notesMasterId xmlns:r="http://schemas.openxmlformats.org/officeDocument/2006/relationships" r:id="Rf8cfd4963b8a45ca"/>
+    <p:notesMasterId xmlns:r="http://schemas.openxmlformats.org/officeDocument/2006/relationships" r:id="Rf449ba9f92d94996"/>
   </p:notesMasterIdLst>
   <p:sldIdLst>
-    <p:sldId xmlns:r="http://schemas.openxmlformats.org/officeDocument/2006/relationships" id="256" r:id="Re7c9cf294a264bc1"/>
-    <p:sldId xmlns:r="http://schemas.openxmlformats.org/officeDocument/2006/relationships" id="257" r:id="Rd3d6e4fe658f4c95"/>
-    <p:sldId xmlns:r="http://schemas.openxmlformats.org/officeDocument/2006/relationships" id="258" r:id="R2169a7e178ea4d48"/>
-    <p:sldId xmlns:r="http://schemas.openxmlformats.org/officeDocument/2006/relationships" id="259" r:id="R32f447573b8a4dfc"/>
-    <p:sldId xmlns:r="http://schemas.openxmlformats.org/officeDocument/2006/relationships" id="260" r:id="R9db968c9b8c94926"/>
-    <p:sldId xmlns:r="http://schemas.openxmlformats.org/officeDocument/2006/relationships" id="261" r:id="R1aab3598c49e4f24"/>
-    <p:sldId xmlns:r="http://schemas.openxmlformats.org/officeDocument/2006/relationships" id="262" r:id="Re8a91494c6db4cfd"/>
-    <p:sldId xmlns:r="http://schemas.openxmlformats.org/officeDocument/2006/relationships" id="263" r:id="Rd659c453e0724367"/>
-    <p:sldId xmlns:r="http://schemas.openxmlformats.org/officeDocument/2006/relationships" id="264" r:id="Rd2119e7162274914"/>
-    <p:sldId xmlns:r="http://schemas.openxmlformats.org/officeDocument/2006/relationships" id="265" r:id="Reb22938acc004214"/>
-    <p:sldId xmlns:r="http://schemas.openxmlformats.org/officeDocument/2006/relationships" id="266" r:id="R691430c9ab894f10"/>
-    <p:sldId xmlns:r="http://schemas.openxmlformats.org/officeDocument/2006/relationships" id="267" r:id="R6f4ac0c400ef4c1d"/>
-    <p:sldId xmlns:r="http://schemas.openxmlformats.org/officeDocument/2006/relationships" id="268" r:id="Rc938d41a64fe45df"/>
-    <p:sldId xmlns:r="http://schemas.openxmlformats.org/officeDocument/2006/relationships" id="269" r:id="R09c2cbc452a74418"/>
-    <p:sldId xmlns:r="http://schemas.openxmlformats.org/officeDocument/2006/relationships" id="270" r:id="R07e8c9cad4d545d2"/>
-    <p:sldId xmlns:r="http://schemas.openxmlformats.org/officeDocument/2006/relationships" id="271" r:id="R3094759e80e54edf"/>
-    <p:sldId xmlns:r="http://schemas.openxmlformats.org/officeDocument/2006/relationships" id="272" r:id="Rf6e57369b710496a"/>
-    <p:sldId xmlns:r="http://schemas.openxmlformats.org/officeDocument/2006/relationships" id="273" r:id="Rd34e40abb03e4d21"/>
+    <p:sldId xmlns:r="http://schemas.openxmlformats.org/officeDocument/2006/relationships" id="256" r:id="R4ab5ae0954e14746"/>
+    <p:sldId xmlns:r="http://schemas.openxmlformats.org/officeDocument/2006/relationships" id="257" r:id="R35e9d005f8784510"/>
+    <p:sldId xmlns:r="http://schemas.openxmlformats.org/officeDocument/2006/relationships" id="258" r:id="R501776224dd343de"/>
+    <p:sldId xmlns:r="http://schemas.openxmlformats.org/officeDocument/2006/relationships" id="259" r:id="R1fc09c484ade4540"/>
+    <p:sldId xmlns:r="http://schemas.openxmlformats.org/officeDocument/2006/relationships" id="260" r:id="R9047bfc93c8d4a96"/>
+    <p:sldId xmlns:r="http://schemas.openxmlformats.org/officeDocument/2006/relationships" id="261" r:id="R4cb5ec138c054304"/>
+    <p:sldId xmlns:r="http://schemas.openxmlformats.org/officeDocument/2006/relationships" id="262" r:id="Ra5328b6e023b4101"/>
+    <p:sldId xmlns:r="http://schemas.openxmlformats.org/officeDocument/2006/relationships" id="263" r:id="Rebdf725b57bf42d3"/>
+    <p:sldId xmlns:r="http://schemas.openxmlformats.org/officeDocument/2006/relationships" id="264" r:id="Rc4f3c41e504c4b83"/>
+    <p:sldId xmlns:r="http://schemas.openxmlformats.org/officeDocument/2006/relationships" id="265" r:id="R4c168aa1c6664e92"/>
+    <p:sldId xmlns:r="http://schemas.openxmlformats.org/officeDocument/2006/relationships" id="266" r:id="R0cfd92ed67be4b5e"/>
+    <p:sldId xmlns:r="http://schemas.openxmlformats.org/officeDocument/2006/relationships" id="267" r:id="Rc42f8239c0ab474f"/>
+    <p:sldId xmlns:r="http://schemas.openxmlformats.org/officeDocument/2006/relationships" id="268" r:id="R639d58921a40473f"/>
+    <p:sldId xmlns:r="http://schemas.openxmlformats.org/officeDocument/2006/relationships" id="269" r:id="Raafa89758f3648b2"/>
+    <p:sldId xmlns:r="http://schemas.openxmlformats.org/officeDocument/2006/relationships" id="270" r:id="Rf22a3c7131e5425e"/>
+    <p:sldId xmlns:r="http://schemas.openxmlformats.org/officeDocument/2006/relationships" id="271" r:id="R5a489f66a40a4306"/>
+    <p:sldId xmlns:r="http://schemas.openxmlformats.org/officeDocument/2006/relationships" id="272" r:id="R208bdb58be6d472e"/>
+    <p:sldId xmlns:r="http://schemas.openxmlformats.org/officeDocument/2006/relationships" id="273" r:id="Ra694979cc49d421c"/>
   </p:sldIdLst>
   <p:sldSz cx="12192000" cy="6858000"/>
   <p:notesSz cx="6858000" cy="9144000"/>
@@ -459,7 +459,7 @@
           <a:lstStyle xmlns:a="http://schemas.openxmlformats.org/drawingml/2006/main"/>
           <a:p xmlns:a="http://schemas.openxmlformats.org/drawingml/2006/main">
             <a:r>
-              <a:t>Fonte principal: Guia.pdf, enunciado acadêmico ArchCorp, 2026, 13 páginas. Cenário 4 aplicado a uma locadora fictícia inspirada na Localiza, com dados sintéticos. Referência técnica: main f1669d78f01e2d279b3de60a999ed778e6c9916e, PR #75 de 25/10/2026, https://github.com/Roger-Quinelato/projetoAplicado7/pull/75, commit consultado localmente. Marcos previstos conforme orientação da entrega. Autoria: Rodrigo Nenato — backend, produto e negócio; Raquel — frontend e levantamento de requisitos. Não há declaração de aceite docente.</a:t>
+              <a:t>Fonte principal: Guia.pdf, enunciado acadêmico ArchCorp, 2026, 13 páginas. Cenário 4 aplicado a uma locadora fictícia inspirada na Localiza, com dados sintéticos. Referência técnica: main f1669d78f01e2d279b3de60a999ed778e6c9916e, PR #75 de 25/10/2026, https://github.com/Roger-Quinelato/projetoAplicado7/pull/75, commit consultado localmente. Marcos previstos conforme orientação da entrega. Autoria: Roger Quinelato — backend, produto e negócio; Raquel — frontend e levantamento de requisitos. Não há declaração de aceite docente.</a:t>
             </a:r>
           </a:p>
         </p:txBody>
@@ -1089,7 +1089,7 @@
           <a:lstStyle xmlns:a="http://schemas.openxmlformats.org/drawingml/2006/main"/>
           <a:p xmlns:a="http://schemas.openxmlformats.org/drawingml/2006/main">
             <a:r>
-              <a:t>Correções de fechamento: F3 não confirma resolução/reconciliação sem processo; eventos mantêm retentativa e reprocessamento explícito. Encerramento do contrato cancela tarefas pendentes e deriva o estado agregado, preservando tarefas finais. Cancelamento financeiro usa a data UTC e o estado efetivo da consulta; vencida recebe 409. As correções não alteram registros antigos já consumidos. Autoria declarada: Rodrigo Nenato — backend, produto e negócio; Raquel — frontend e levantamento de requisitos. Permanecem ensaio, aceite docente e comprovação da hospedagem prevista no plano. OIDC, tracing distribuído e consumo pelo broker são evoluções.</a:t>
+              <a:t>Correções de fechamento: F3 não confirma resolução/reconciliação sem processo; eventos mantêm retentativa e reprocessamento explícito. Encerramento do contrato cancela tarefas pendentes e deriva o estado agregado, preservando tarefas finais. Cancelamento financeiro usa a data UTC e o estado efetivo da consulta; vencida recebe 409. As correções não alteram registros antigos já consumidos. Autoria declarada: Roger Quinelato — backend, produto e negócio; Raquel — frontend e levantamento de requisitos. Permanecem ensaio, aceite docente e comprovação da hospedagem prevista no plano. OIDC, tracing distribuído e consumo pelo broker são evoluções.</a:t>
             </a:r>
           </a:p>
         </p:txBody>
@@ -1696,7 +1696,7 @@
           <p:cNvPr id="3" name="Title">
             <a:extLst xmlns:a="http://schemas.openxmlformats.org/drawingml/2006/main">
               <a:ext uri="{FF2B5EF4-FFF2-40B4-BE49-F238E27FC236}">
-                <a16:creationId xmlns:a16="http://schemas.microsoft.com/office/drawing/2014/main" id="{BA0B2BB4-7244-478E-9A22-4F0FEB1ED1D4}"/>
+                <a16:creationId xmlns:a16="http://schemas.microsoft.com/office/drawing/2014/main" id="{CEE593D6-F72B-43BE-9AC4-77BEFBAB9C63}"/>
               </a:ext>
             </a:extLst>
           </p:cNvPr>
@@ -1925,7 +1925,7 @@
           <p:cNvPr id="2" name="Subtitle">
             <a:extLst xmlns:a="http://schemas.openxmlformats.org/drawingml/2006/main">
               <a:ext uri="{FF2B5EF4-FFF2-40B4-BE49-F238E27FC236}">
-                <a16:creationId xmlns:a16="http://schemas.microsoft.com/office/drawing/2014/main" id="{B0BED536-0E84-47CF-9BFF-A736444B7DE6}"/>
+                <a16:creationId xmlns:a16="http://schemas.microsoft.com/office/drawing/2014/main" id="{3724803F-9AAA-44BE-990D-F488C48E5230}"/>
               </a:ext>
             </a:extLst>
           </p:cNvPr>
@@ -2171,7 +2171,7 @@
           <p:cNvPr id="2" name="Section title">
             <a:extLst xmlns:a="http://schemas.openxmlformats.org/drawingml/2006/main">
               <a:ext uri="{FF2B5EF4-FFF2-40B4-BE49-F238E27FC236}">
-                <a16:creationId xmlns:a16="http://schemas.microsoft.com/office/drawing/2014/main" id="{5D12B58F-3AA3-45D0-90E1-5FCBFD0CC049}"/>
+                <a16:creationId xmlns:a16="http://schemas.microsoft.com/office/drawing/2014/main" id="{C012BA3A-20E3-4570-BCE9-EADBED3A76C3}"/>
               </a:ext>
             </a:extLst>
           </p:cNvPr>
@@ -2417,7 +2417,7 @@
           <p:cNvPr id="3" name="Title">
             <a:extLst xmlns:a="http://schemas.openxmlformats.org/drawingml/2006/main">
               <a:ext uri="{FF2B5EF4-FFF2-40B4-BE49-F238E27FC236}">
-                <a16:creationId xmlns:a16="http://schemas.microsoft.com/office/drawing/2014/main" id="{0CD1FB1A-6B73-4879-ADE7-86A173BCC463}"/>
+                <a16:creationId xmlns:a16="http://schemas.microsoft.com/office/drawing/2014/main" id="{7033B1B7-8AA5-481A-950F-F755C50D4F9F}"/>
               </a:ext>
             </a:extLst>
           </p:cNvPr>
@@ -2646,7 +2646,7 @@
           <p:cNvPr id="2" name="Body">
             <a:extLst xmlns:a="http://schemas.openxmlformats.org/drawingml/2006/main">
               <a:ext uri="{FF2B5EF4-FFF2-40B4-BE49-F238E27FC236}">
-                <a16:creationId xmlns:a16="http://schemas.microsoft.com/office/drawing/2014/main" id="{D057DEEB-7C4E-4183-831C-52DAF578A70F}"/>
+                <a16:creationId xmlns:a16="http://schemas.microsoft.com/office/drawing/2014/main" id="{AAF78521-657A-422A-B4FE-C5FFF8F32695}"/>
               </a:ext>
             </a:extLst>
           </p:cNvPr>
@@ -2892,7 +2892,7 @@
           <p:cNvPr id="4" name="Title">
             <a:extLst xmlns:a="http://schemas.openxmlformats.org/drawingml/2006/main">
               <a:ext uri="{FF2B5EF4-FFF2-40B4-BE49-F238E27FC236}">
-                <a16:creationId xmlns:a16="http://schemas.microsoft.com/office/drawing/2014/main" id="{2E3CC9A2-2C94-40CE-A388-15450A3A9FD4}"/>
+                <a16:creationId xmlns:a16="http://schemas.microsoft.com/office/drawing/2014/main" id="{A7BC370B-34D0-451D-AE94-5E81F0ED2455}"/>
               </a:ext>
             </a:extLst>
           </p:cNvPr>
@@ -3121,7 +3121,7 @@
           <p:cNvPr id="2" name="Left column">
             <a:extLst xmlns:a="http://schemas.openxmlformats.org/drawingml/2006/main">
               <a:ext uri="{FF2B5EF4-FFF2-40B4-BE49-F238E27FC236}">
-                <a16:creationId xmlns:a16="http://schemas.microsoft.com/office/drawing/2014/main" id="{0A2E2781-3032-4026-8F18-F3424ABF6636}"/>
+                <a16:creationId xmlns:a16="http://schemas.microsoft.com/office/drawing/2014/main" id="{4E7BA3BD-838A-4DE0-87C0-F04DAD564D1B}"/>
               </a:ext>
             </a:extLst>
           </p:cNvPr>
@@ -3350,7 +3350,7 @@
           <p:cNvPr id="3" name="Right column">
             <a:extLst xmlns:a="http://schemas.openxmlformats.org/drawingml/2006/main">
               <a:ext uri="{FF2B5EF4-FFF2-40B4-BE49-F238E27FC236}">
-                <a16:creationId xmlns:a16="http://schemas.microsoft.com/office/drawing/2014/main" id="{20E20029-0D81-49EE-AC93-18BAA0CA9F22}"/>
+                <a16:creationId xmlns:a16="http://schemas.microsoft.com/office/drawing/2014/main" id="{F85DE391-5210-4C50-BC51-8E74EF8A2E7B}"/>
               </a:ext>
             </a:extLst>
           </p:cNvPr>
@@ -3596,7 +3596,7 @@
           <p:cNvPr id="3" name="Title">
             <a:extLst xmlns:a="http://schemas.openxmlformats.org/drawingml/2006/main">
               <a:ext uri="{FF2B5EF4-FFF2-40B4-BE49-F238E27FC236}">
-                <a16:creationId xmlns:a16="http://schemas.microsoft.com/office/drawing/2014/main" id="{76B5DCD2-7D14-43D9-8C73-064C74E36620}"/>
+                <a16:creationId xmlns:a16="http://schemas.microsoft.com/office/drawing/2014/main" id="{AE762BA5-AF84-400C-BB56-1F66DBD205DC}"/>
               </a:ext>
             </a:extLst>
           </p:cNvPr>
@@ -3825,7 +3825,7 @@
           <p:cNvPr id="2" name="Left column">
             <a:extLst xmlns:a="http://schemas.openxmlformats.org/drawingml/2006/main">
               <a:ext uri="{FF2B5EF4-FFF2-40B4-BE49-F238E27FC236}">
-                <a16:creationId xmlns:a16="http://schemas.microsoft.com/office/drawing/2014/main" id="{B0DA4D31-73BA-4649-B98D-C97B4D84B10E}"/>
+                <a16:creationId xmlns:a16="http://schemas.microsoft.com/office/drawing/2014/main" id="{EFD41CB0-1A43-40DB-89C3-7BF57DC7C842}"/>
               </a:ext>
             </a:extLst>
           </p:cNvPr>
@@ -4092,12 +4092,12 @@
   </p:cSld>
   <p:clrMap bg1="lt1" tx1="dk1" bg2="lt2" tx2="dk2" accent1="accent1" accent2="accent2" accent3="accent3" accent4="accent4" accent5="accent5" accent6="accent6" hlink="hlink" folHlink="folHlink"/>
   <p:sldLayoutIdLst>
-    <p:sldLayoutId xmlns:r="http://schemas.openxmlformats.org/officeDocument/2006/relationships" id="2147483649" r:id="R084c054ab8264d07"/>
-    <p:sldLayoutId xmlns:r="http://schemas.openxmlformats.org/officeDocument/2006/relationships" id="2147483650" r:id="R964daba3d9324441"/>
-    <p:sldLayoutId xmlns:r="http://schemas.openxmlformats.org/officeDocument/2006/relationships" id="2147483651" r:id="R3276124c2d8145c5"/>
-    <p:sldLayoutId xmlns:r="http://schemas.openxmlformats.org/officeDocument/2006/relationships" id="2147483652" r:id="R5ee089717fc940b5"/>
-    <p:sldLayoutId xmlns:r="http://schemas.openxmlformats.org/officeDocument/2006/relationships" id="2147483653" r:id="Ra6aceb5927eb4788"/>
-    <p:sldLayoutId xmlns:r="http://schemas.openxmlformats.org/officeDocument/2006/relationships" id="2147483654" r:id="Rf09e96a51af44460"/>
+    <p:sldLayoutId xmlns:r="http://schemas.openxmlformats.org/officeDocument/2006/relationships" id="2147483649" r:id="Rcf4242fc289b4761"/>
+    <p:sldLayoutId xmlns:r="http://schemas.openxmlformats.org/officeDocument/2006/relationships" id="2147483650" r:id="R37ad38a59baa40d6"/>
+    <p:sldLayoutId xmlns:r="http://schemas.openxmlformats.org/officeDocument/2006/relationships" id="2147483651" r:id="R28b31ef2446e4d08"/>
+    <p:sldLayoutId xmlns:r="http://schemas.openxmlformats.org/officeDocument/2006/relationships" id="2147483652" r:id="R4c38481493bf4911"/>
+    <p:sldLayoutId xmlns:r="http://schemas.openxmlformats.org/officeDocument/2006/relationships" id="2147483653" r:id="R4e47be286a5f4d82"/>
+    <p:sldLayoutId xmlns:r="http://schemas.openxmlformats.org/officeDocument/2006/relationships" id="2147483654" r:id="R19167ebe19734fdb"/>
   </p:sldLayoutIdLst>
   <p:txStyles>
     <p:titleStyle>
@@ -4648,7 +4648,7 @@
           <p:cNvPr id="5" name="">
             <a:extLst xmlns:a="http://schemas.openxmlformats.org/drawingml/2006/main">
               <a:ext uri="{FF2B5EF4-FFF2-40B4-BE49-F238E27FC236}">
-                <a16:creationId xmlns:a16="http://schemas.microsoft.com/office/drawing/2014/main" id="{0BEC27C4-84C4-47AF-9942-2D46F314F688}"/>
+                <a16:creationId xmlns:a16="http://schemas.microsoft.com/office/drawing/2014/main" id="{987BA7BF-0FC3-42F5-BEDD-56D0F88CBE37}"/>
               </a:ext>
             </a:extLst>
           </p:cNvPr>
@@ -4829,7 +4829,7 @@
           <p:cNvPr id="2" name="">
             <a:extLst xmlns:a="http://schemas.openxmlformats.org/drawingml/2006/main">
               <a:ext uri="{FF2B5EF4-FFF2-40B4-BE49-F238E27FC236}">
-                <a16:creationId xmlns:a16="http://schemas.microsoft.com/office/drawing/2014/main" id="{78486A8B-47B0-4215-AAB8-6CCF4B69FBEA}"/>
+                <a16:creationId xmlns:a16="http://schemas.microsoft.com/office/drawing/2014/main" id="{76123F34-9206-44F9-873E-D8CE77E13921}"/>
               </a:ext>
             </a:extLst>
           </p:cNvPr>
@@ -4987,7 +4987,7 @@
           <p:cNvPr id="3" name="">
             <a:extLst xmlns:a="http://schemas.openxmlformats.org/drawingml/2006/main">
               <a:ext uri="{FF2B5EF4-FFF2-40B4-BE49-F238E27FC236}">
-                <a16:creationId xmlns:a16="http://schemas.microsoft.com/office/drawing/2014/main" id="{009C5590-A2C6-44EC-865A-F10E290D15D0}"/>
+                <a16:creationId xmlns:a16="http://schemas.microsoft.com/office/drawing/2014/main" id="{18A8A6F4-153E-4098-9BFA-1F94814AB763}"/>
               </a:ext>
             </a:extLst>
           </p:cNvPr>
@@ -5017,7 +5017,7 @@
           <p:cNvPr id="4" name="">
             <a:extLst xmlns:a="http://schemas.openxmlformats.org/drawingml/2006/main">
               <a:ext uri="{FF2B5EF4-FFF2-40B4-BE49-F238E27FC236}">
-                <a16:creationId xmlns:a16="http://schemas.microsoft.com/office/drawing/2014/main" id="{A120F43E-6AE8-4DAF-A387-FBFDA468E16D}"/>
+                <a16:creationId xmlns:a16="http://schemas.microsoft.com/office/drawing/2014/main" id="{2D1C11C2-D764-4258-BF41-94F5B3CC20D6}"/>
               </a:ext>
             </a:extLst>
           </p:cNvPr>
@@ -5165,7 +5165,7 @@
                 <a:ea typeface="Arial"/>
                 <a:cs typeface="Arial"/>
               </a:rPr>
-              <a:t>Rodrigo Nenato — backend, produto e negócio</a:t>
+              <a:t>Roger Quinelato — backend, produto e negócio</a:t>
             </a:r>
           </a:p>
           <a:p xmlns:a="http://schemas.openxmlformats.org/drawingml/2006/main">
@@ -5242,7 +5242,7 @@
     </p:spTree>
     <p:extLst>
       <p:ext uri="{BB962C8B-B14F-4D97-AF65-F5344CB8AC3E}">
-        <p14:creationId xmlns:p14="http://schemas.microsoft.com/office/powerpoint/2010/main" val="321175279"/>
+        <p14:creationId xmlns:p14="http://schemas.microsoft.com/office/powerpoint/2010/main" val="1715833366"/>
       </p:ext>
     </p:extLst>
   </p:cSld>
@@ -5273,7 +5273,7 @@
           <p:cNvPr id="8" name="">
             <a:extLst xmlns:a="http://schemas.openxmlformats.org/drawingml/2006/main">
               <a:ext uri="{FF2B5EF4-FFF2-40B4-BE49-F238E27FC236}">
-                <a16:creationId xmlns:a16="http://schemas.microsoft.com/office/drawing/2014/main" id="{13B97BC0-232A-4C2B-A19D-7D696C467CB7}"/>
+                <a16:creationId xmlns:a16="http://schemas.microsoft.com/office/drawing/2014/main" id="{F4340F95-C2FD-43D6-AC0E-75A5BE08FD12}"/>
               </a:ext>
             </a:extLst>
           </p:cNvPr>
@@ -5305,7 +5305,7 @@
           <p:cNvPr id="7" name="">
             <a:extLst xmlns:a="http://schemas.openxmlformats.org/drawingml/2006/main">
               <a:ext uri="{FF2B5EF4-FFF2-40B4-BE49-F238E27FC236}">
-                <a16:creationId xmlns:a16="http://schemas.microsoft.com/office/drawing/2014/main" id="{54136C9E-F0F8-4BDB-AB75-4279950F8491}"/>
+                <a16:creationId xmlns:a16="http://schemas.microsoft.com/office/drawing/2014/main" id="{290953B0-AFF9-42BC-AAD0-E4C0CB082878}"/>
               </a:ext>
             </a:extLst>
           </p:cNvPr>
@@ -5337,7 +5337,7 @@
           <p:cNvPr id="12" name="">
             <a:extLst xmlns:a="http://schemas.openxmlformats.org/drawingml/2006/main">
               <a:ext uri="{FF2B5EF4-FFF2-40B4-BE49-F238E27FC236}">
-                <a16:creationId xmlns:a16="http://schemas.microsoft.com/office/drawing/2014/main" id="{401E513E-008F-4994-A21C-C8B01A81B5B4}"/>
+                <a16:creationId xmlns:a16="http://schemas.microsoft.com/office/drawing/2014/main" id="{B82F13E3-7D5F-4DC1-8451-AF0FF40249EA}"/>
               </a:ext>
             </a:extLst>
           </p:cNvPr>
@@ -5367,7 +5367,7 @@
           <p:cNvPr id="2" name="">
             <a:extLst xmlns:a="http://schemas.openxmlformats.org/drawingml/2006/main">
               <a:ext uri="{FF2B5EF4-FFF2-40B4-BE49-F238E27FC236}">
-                <a16:creationId xmlns:a16="http://schemas.microsoft.com/office/drawing/2014/main" id="{20B74C03-5111-4452-992D-C8BE751DB905}"/>
+                <a16:creationId xmlns:a16="http://schemas.microsoft.com/office/drawing/2014/main" id="{16167645-8593-414A-8792-967363AA1605}"/>
               </a:ext>
             </a:extLst>
           </p:cNvPr>
@@ -5525,7 +5525,7 @@
           <p:cNvPr id="3" name="">
             <a:extLst xmlns:a="http://schemas.openxmlformats.org/drawingml/2006/main">
               <a:ext uri="{FF2B5EF4-FFF2-40B4-BE49-F238E27FC236}">
-                <a16:creationId xmlns:a16="http://schemas.microsoft.com/office/drawing/2014/main" id="{E524790C-DF12-43FD-B2C5-D5F059A8387B}"/>
+                <a16:creationId xmlns:a16="http://schemas.microsoft.com/office/drawing/2014/main" id="{6A289B18-A401-4FE9-B1EF-F2ABFA04B86D}"/>
               </a:ext>
             </a:extLst>
           </p:cNvPr>
@@ -5683,7 +5683,7 @@
           <p:cNvPr id="4" name="">
             <a:extLst xmlns:a="http://schemas.openxmlformats.org/drawingml/2006/main">
               <a:ext uri="{FF2B5EF4-FFF2-40B4-BE49-F238E27FC236}">
-                <a16:creationId xmlns:a16="http://schemas.microsoft.com/office/drawing/2014/main" id="{5BFB74E5-9C69-4807-B452-F8DD4304E463}"/>
+                <a16:creationId xmlns:a16="http://schemas.microsoft.com/office/drawing/2014/main" id="{2BF395EF-1D18-48D1-B4E5-C7F4015A3DCA}"/>
               </a:ext>
             </a:extLst>
           </p:cNvPr>
@@ -5871,7 +5871,7 @@
           <p:cNvPr id="5" name="">
             <a:extLst xmlns:a="http://schemas.openxmlformats.org/drawingml/2006/main">
               <a:ext uri="{FF2B5EF4-FFF2-40B4-BE49-F238E27FC236}">
-                <a16:creationId xmlns:a16="http://schemas.microsoft.com/office/drawing/2014/main" id="{0937EF6C-B898-4F07-A3B8-7BFC1A2EBC90}"/>
+                <a16:creationId xmlns:a16="http://schemas.microsoft.com/office/drawing/2014/main" id="{A8602A70-E0EB-45AD-AFFD-503B494A1922}"/>
               </a:ext>
             </a:extLst>
           </p:cNvPr>
@@ -6059,7 +6059,7 @@
           <p:cNvPr id="6" name="">
             <a:extLst xmlns:a="http://schemas.openxmlformats.org/drawingml/2006/main">
               <a:ext uri="{FF2B5EF4-FFF2-40B4-BE49-F238E27FC236}">
-                <a16:creationId xmlns:a16="http://schemas.microsoft.com/office/drawing/2014/main" id="{D4033466-2891-4FE3-8DB1-D5D63C3A3D9F}"/>
+                <a16:creationId xmlns:a16="http://schemas.microsoft.com/office/drawing/2014/main" id="{CDD117A8-CBA2-4A38-BB28-78C271E5B39D}"/>
               </a:ext>
             </a:extLst>
           </p:cNvPr>
@@ -6247,7 +6247,7 @@
           <p:cNvPr id="9" name="">
             <a:extLst xmlns:a="http://schemas.openxmlformats.org/drawingml/2006/main">
               <a:ext uri="{FF2B5EF4-FFF2-40B4-BE49-F238E27FC236}">
-                <a16:creationId xmlns:a16="http://schemas.microsoft.com/office/drawing/2014/main" id="{AF16BF74-BA20-4F59-BC31-6B01C07CC152}"/>
+                <a16:creationId xmlns:a16="http://schemas.microsoft.com/office/drawing/2014/main" id="{06950075-DB97-46C0-A69F-39E64DD29B5B}"/>
               </a:ext>
             </a:extLst>
           </p:cNvPr>
@@ -6405,7 +6405,7 @@
           <p:cNvPr id="10" name="">
             <a:extLst xmlns:a="http://schemas.openxmlformats.org/drawingml/2006/main">
               <a:ext uri="{FF2B5EF4-FFF2-40B4-BE49-F238E27FC236}">
-                <a16:creationId xmlns:a16="http://schemas.microsoft.com/office/drawing/2014/main" id="{56575D22-3547-42EF-82AF-F63520CA8D15}"/>
+                <a16:creationId xmlns:a16="http://schemas.microsoft.com/office/drawing/2014/main" id="{A77F34D2-41C4-4F3E-970F-5BD0C97A99CB}"/>
               </a:ext>
             </a:extLst>
           </p:cNvPr>
@@ -6563,7 +6563,7 @@
           <p:cNvPr id="11" name="">
             <a:extLst xmlns:a="http://schemas.openxmlformats.org/drawingml/2006/main">
               <a:ext uri="{FF2B5EF4-FFF2-40B4-BE49-F238E27FC236}">
-                <a16:creationId xmlns:a16="http://schemas.microsoft.com/office/drawing/2014/main" id="{3C04CB50-6172-49D9-80C9-EC972A77B704}"/>
+                <a16:creationId xmlns:a16="http://schemas.microsoft.com/office/drawing/2014/main" id="{A78C98D4-DDD9-4A4C-B071-EDE7E735E8D5}"/>
               </a:ext>
             </a:extLst>
           </p:cNvPr>
@@ -6719,7 +6719,7 @@
     </p:spTree>
     <p:extLst>
       <p:ext uri="{BB962C8B-B14F-4D97-AF65-F5344CB8AC3E}">
-        <p14:creationId xmlns:p14="http://schemas.microsoft.com/office/powerpoint/2010/main" val="188665233"/>
+        <p14:creationId xmlns:p14="http://schemas.microsoft.com/office/powerpoint/2010/main" val="890944476"/>
       </p:ext>
     </p:extLst>
   </p:cSld>
@@ -6750,7 +6750,7 @@
           <p:cNvPr id="10" name="">
             <a:extLst xmlns:a="http://schemas.openxmlformats.org/drawingml/2006/main">
               <a:ext uri="{FF2B5EF4-FFF2-40B4-BE49-F238E27FC236}">
-                <a16:creationId xmlns:a16="http://schemas.microsoft.com/office/drawing/2014/main" id="{C52D0663-994A-4A30-97F6-1B02F8C1DDCD}"/>
+                <a16:creationId xmlns:a16="http://schemas.microsoft.com/office/drawing/2014/main" id="{1E89D90C-7176-491F-97E0-556268202BC1}"/>
               </a:ext>
             </a:extLst>
           </p:cNvPr>
@@ -6784,7 +6784,7 @@
           <p:cNvPr id="9" name="">
             <a:extLst xmlns:a="http://schemas.openxmlformats.org/drawingml/2006/main">
               <a:ext uri="{FF2B5EF4-FFF2-40B4-BE49-F238E27FC236}">
-                <a16:creationId xmlns:a16="http://schemas.microsoft.com/office/drawing/2014/main" id="{971068AA-B663-4570-BC07-7AB313B6FF58}"/>
+                <a16:creationId xmlns:a16="http://schemas.microsoft.com/office/drawing/2014/main" id="{8AC28AD2-0A05-4345-AA0E-F7DC0BC11448}"/>
               </a:ext>
             </a:extLst>
           </p:cNvPr>
@@ -6818,7 +6818,7 @@
           <p:cNvPr id="8" name="">
             <a:extLst xmlns:a="http://schemas.openxmlformats.org/drawingml/2006/main">
               <a:ext uri="{FF2B5EF4-FFF2-40B4-BE49-F238E27FC236}">
-                <a16:creationId xmlns:a16="http://schemas.microsoft.com/office/drawing/2014/main" id="{DED54A40-72EE-42AF-B944-A44FFA8AABCB}"/>
+                <a16:creationId xmlns:a16="http://schemas.microsoft.com/office/drawing/2014/main" id="{47C2A792-1E08-4C39-BE29-B100E648C53D}"/>
               </a:ext>
             </a:extLst>
           </p:cNvPr>
@@ -6850,7 +6850,7 @@
           <p:cNvPr id="13" name="">
             <a:extLst xmlns:a="http://schemas.openxmlformats.org/drawingml/2006/main">
               <a:ext uri="{FF2B5EF4-FFF2-40B4-BE49-F238E27FC236}">
-                <a16:creationId xmlns:a16="http://schemas.microsoft.com/office/drawing/2014/main" id="{78030D89-0390-4C9A-BFB7-5A220A006913}"/>
+                <a16:creationId xmlns:a16="http://schemas.microsoft.com/office/drawing/2014/main" id="{EA7E3721-7FDC-46F4-9F81-D2BC6EA8AD09}"/>
               </a:ext>
             </a:extLst>
           </p:cNvPr>
@@ -6880,7 +6880,7 @@
           <p:cNvPr id="2" name="">
             <a:extLst xmlns:a="http://schemas.openxmlformats.org/drawingml/2006/main">
               <a:ext uri="{FF2B5EF4-FFF2-40B4-BE49-F238E27FC236}">
-                <a16:creationId xmlns:a16="http://schemas.microsoft.com/office/drawing/2014/main" id="{3B2E59E6-EA69-4DC2-85A7-CD80E09FF954}"/>
+                <a16:creationId xmlns:a16="http://schemas.microsoft.com/office/drawing/2014/main" id="{014D9F2B-4B42-4412-A15A-C0E9AC76FFD2}"/>
               </a:ext>
             </a:extLst>
           </p:cNvPr>
@@ -7038,7 +7038,7 @@
           <p:cNvPr id="3" name="">
             <a:extLst xmlns:a="http://schemas.openxmlformats.org/drawingml/2006/main">
               <a:ext uri="{FF2B5EF4-FFF2-40B4-BE49-F238E27FC236}">
-                <a16:creationId xmlns:a16="http://schemas.microsoft.com/office/drawing/2014/main" id="{D636352F-EB34-49F0-A0C9-45A234C5E329}"/>
+                <a16:creationId xmlns:a16="http://schemas.microsoft.com/office/drawing/2014/main" id="{F4E6950C-272C-4D8C-BBD0-D5177ACBE8F0}"/>
               </a:ext>
             </a:extLst>
           </p:cNvPr>
@@ -7196,7 +7196,7 @@
           <p:cNvPr id="4" name="">
             <a:extLst xmlns:a="http://schemas.openxmlformats.org/drawingml/2006/main">
               <a:ext uri="{FF2B5EF4-FFF2-40B4-BE49-F238E27FC236}">
-                <a16:creationId xmlns:a16="http://schemas.microsoft.com/office/drawing/2014/main" id="{53975614-DECA-4EC0-A94F-23714780D214}"/>
+                <a16:creationId xmlns:a16="http://schemas.microsoft.com/office/drawing/2014/main" id="{47C3A952-48B4-4BC4-B950-F8E432EF3A0D}"/>
               </a:ext>
             </a:extLst>
           </p:cNvPr>
@@ -7384,7 +7384,7 @@
           <p:cNvPr id="5" name="">
             <a:extLst xmlns:a="http://schemas.openxmlformats.org/drawingml/2006/main">
               <a:ext uri="{FF2B5EF4-FFF2-40B4-BE49-F238E27FC236}">
-                <a16:creationId xmlns:a16="http://schemas.microsoft.com/office/drawing/2014/main" id="{ED866979-D392-4D0C-883D-0892E08EFA09}"/>
+                <a16:creationId xmlns:a16="http://schemas.microsoft.com/office/drawing/2014/main" id="{9781F7D2-F3CD-4B84-94AC-25820256BCD2}"/>
               </a:ext>
             </a:extLst>
           </p:cNvPr>
@@ -7572,7 +7572,7 @@
           <p:cNvPr id="6" name="">
             <a:extLst xmlns:a="http://schemas.openxmlformats.org/drawingml/2006/main">
               <a:ext uri="{FF2B5EF4-FFF2-40B4-BE49-F238E27FC236}">
-                <a16:creationId xmlns:a16="http://schemas.microsoft.com/office/drawing/2014/main" id="{03CB2C27-39BC-4B2A-932A-1B5C4081AEF2}"/>
+                <a16:creationId xmlns:a16="http://schemas.microsoft.com/office/drawing/2014/main" id="{0BEB7B8A-C81A-4FA4-8059-C41E7ABB649F}"/>
               </a:ext>
             </a:extLst>
           </p:cNvPr>
@@ -7760,7 +7760,7 @@
           <p:cNvPr id="7" name="">
             <a:extLst xmlns:a="http://schemas.openxmlformats.org/drawingml/2006/main">
               <a:ext uri="{FF2B5EF4-FFF2-40B4-BE49-F238E27FC236}">
-                <a16:creationId xmlns:a16="http://schemas.microsoft.com/office/drawing/2014/main" id="{3452FF20-FEB2-4F1E-8745-DEDDA6C9F5D8}"/>
+                <a16:creationId xmlns:a16="http://schemas.microsoft.com/office/drawing/2014/main" id="{9D0919A4-AB28-4234-8C3D-5008F443207F}"/>
               </a:ext>
             </a:extLst>
           </p:cNvPr>
@@ -7948,7 +7948,7 @@
           <p:cNvPr id="11" name="">
             <a:extLst xmlns:a="http://schemas.openxmlformats.org/drawingml/2006/main">
               <a:ext uri="{FF2B5EF4-FFF2-40B4-BE49-F238E27FC236}">
-                <a16:creationId xmlns:a16="http://schemas.microsoft.com/office/drawing/2014/main" id="{C57E248B-A7C2-4C3F-A1BC-9D7C03393747}"/>
+                <a16:creationId xmlns:a16="http://schemas.microsoft.com/office/drawing/2014/main" id="{6A0CBF89-ECE9-4060-8946-E8848A38186F}"/>
               </a:ext>
             </a:extLst>
           </p:cNvPr>
@@ -8106,7 +8106,7 @@
           <p:cNvPr id="12" name="">
             <a:extLst xmlns:a="http://schemas.openxmlformats.org/drawingml/2006/main">
               <a:ext uri="{FF2B5EF4-FFF2-40B4-BE49-F238E27FC236}">
-                <a16:creationId xmlns:a16="http://schemas.microsoft.com/office/drawing/2014/main" id="{933EEBBD-91E4-44E5-BCFF-3925997AC8E8}"/>
+                <a16:creationId xmlns:a16="http://schemas.microsoft.com/office/drawing/2014/main" id="{33F2A241-8FE6-42C2-B275-929E15CE69C0}"/>
               </a:ext>
             </a:extLst>
           </p:cNvPr>
@@ -8262,7 +8262,7 @@
     </p:spTree>
     <p:extLst>
       <p:ext uri="{BB962C8B-B14F-4D97-AF65-F5344CB8AC3E}">
-        <p14:creationId xmlns:p14="http://schemas.microsoft.com/office/powerpoint/2010/main" val="1064481190"/>
+        <p14:creationId xmlns:p14="http://schemas.microsoft.com/office/powerpoint/2010/main" val="1218121198"/>
       </p:ext>
     </p:extLst>
   </p:cSld>
@@ -8293,7 +8293,7 @@
           <p:cNvPr id="10" name="">
             <a:extLst xmlns:a="http://schemas.openxmlformats.org/drawingml/2006/main">
               <a:ext uri="{FF2B5EF4-FFF2-40B4-BE49-F238E27FC236}">
-                <a16:creationId xmlns:a16="http://schemas.microsoft.com/office/drawing/2014/main" id="{8CCA31DF-DCE8-4E13-96EE-34B0BB8E40C8}"/>
+                <a16:creationId xmlns:a16="http://schemas.microsoft.com/office/drawing/2014/main" id="{315AFB7D-BE6C-4CD3-9503-47969409EE92}"/>
               </a:ext>
             </a:extLst>
           </p:cNvPr>
@@ -8325,7 +8325,7 @@
           <p:cNvPr id="9" name="">
             <a:extLst xmlns:a="http://schemas.openxmlformats.org/drawingml/2006/main">
               <a:ext uri="{FF2B5EF4-FFF2-40B4-BE49-F238E27FC236}">
-                <a16:creationId xmlns:a16="http://schemas.microsoft.com/office/drawing/2014/main" id="{E4A4159A-4E8D-4E4C-A4E2-607B52C173A5}"/>
+                <a16:creationId xmlns:a16="http://schemas.microsoft.com/office/drawing/2014/main" id="{A6F2292E-3616-430E-9B13-4373841738AB}"/>
               </a:ext>
             </a:extLst>
           </p:cNvPr>
@@ -8357,7 +8357,7 @@
           <p:cNvPr id="8" name="">
             <a:extLst xmlns:a="http://schemas.openxmlformats.org/drawingml/2006/main">
               <a:ext uri="{FF2B5EF4-FFF2-40B4-BE49-F238E27FC236}">
-                <a16:creationId xmlns:a16="http://schemas.microsoft.com/office/drawing/2014/main" id="{38DDB58B-16A7-4071-954B-2C478CDB32E3}"/>
+                <a16:creationId xmlns:a16="http://schemas.microsoft.com/office/drawing/2014/main" id="{BECEB873-C258-4577-A8D4-E33A5AB08AF3}"/>
               </a:ext>
             </a:extLst>
           </p:cNvPr>
@@ -8391,7 +8391,7 @@
           <p:cNvPr id="13" name="">
             <a:extLst xmlns:a="http://schemas.openxmlformats.org/drawingml/2006/main">
               <a:ext uri="{FF2B5EF4-FFF2-40B4-BE49-F238E27FC236}">
-                <a16:creationId xmlns:a16="http://schemas.microsoft.com/office/drawing/2014/main" id="{53C0CC52-6FC3-4B17-93D9-C608EE36F82E}"/>
+                <a16:creationId xmlns:a16="http://schemas.microsoft.com/office/drawing/2014/main" id="{9ED38835-D701-44D0-B376-F0D6860D81BF}"/>
               </a:ext>
             </a:extLst>
           </p:cNvPr>
@@ -8421,7 +8421,7 @@
           <p:cNvPr id="2" name="">
             <a:extLst xmlns:a="http://schemas.openxmlformats.org/drawingml/2006/main">
               <a:ext uri="{FF2B5EF4-FFF2-40B4-BE49-F238E27FC236}">
-                <a16:creationId xmlns:a16="http://schemas.microsoft.com/office/drawing/2014/main" id="{579D7207-3D75-4F79-9BCB-3A59067F109C}"/>
+                <a16:creationId xmlns:a16="http://schemas.microsoft.com/office/drawing/2014/main" id="{1D6AD531-A881-4430-98B7-7282EB355112}"/>
               </a:ext>
             </a:extLst>
           </p:cNvPr>
@@ -8579,7 +8579,7 @@
           <p:cNvPr id="3" name="">
             <a:extLst xmlns:a="http://schemas.openxmlformats.org/drawingml/2006/main">
               <a:ext uri="{FF2B5EF4-FFF2-40B4-BE49-F238E27FC236}">
-                <a16:creationId xmlns:a16="http://schemas.microsoft.com/office/drawing/2014/main" id="{9F7F6C1E-0132-4BC1-945A-206B2D72656C}"/>
+                <a16:creationId xmlns:a16="http://schemas.microsoft.com/office/drawing/2014/main" id="{ED5F12ED-C70B-4BE2-952E-64629CCD6DF7}"/>
               </a:ext>
             </a:extLst>
           </p:cNvPr>
@@ -8737,7 +8737,7 @@
           <p:cNvPr id="4" name="">
             <a:extLst xmlns:a="http://schemas.openxmlformats.org/drawingml/2006/main">
               <a:ext uri="{FF2B5EF4-FFF2-40B4-BE49-F238E27FC236}">
-                <a16:creationId xmlns:a16="http://schemas.microsoft.com/office/drawing/2014/main" id="{8BD4CF26-DB5C-4649-BAD8-B911CE47747B}"/>
+                <a16:creationId xmlns:a16="http://schemas.microsoft.com/office/drawing/2014/main" id="{60EA2A85-1424-4361-9E85-98CF621FA2A6}"/>
               </a:ext>
             </a:extLst>
           </p:cNvPr>
@@ -8925,7 +8925,7 @@
           <p:cNvPr id="5" name="">
             <a:extLst xmlns:a="http://schemas.openxmlformats.org/drawingml/2006/main">
               <a:ext uri="{FF2B5EF4-FFF2-40B4-BE49-F238E27FC236}">
-                <a16:creationId xmlns:a16="http://schemas.microsoft.com/office/drawing/2014/main" id="{987B0952-EB39-4C13-8D79-00319A3E8558}"/>
+                <a16:creationId xmlns:a16="http://schemas.microsoft.com/office/drawing/2014/main" id="{BC75E7CE-1FF9-4E15-921D-2E73F425FC0D}"/>
               </a:ext>
             </a:extLst>
           </p:cNvPr>
@@ -9113,7 +9113,7 @@
           <p:cNvPr id="6" name="">
             <a:extLst xmlns:a="http://schemas.openxmlformats.org/drawingml/2006/main">
               <a:ext uri="{FF2B5EF4-FFF2-40B4-BE49-F238E27FC236}">
-                <a16:creationId xmlns:a16="http://schemas.microsoft.com/office/drawing/2014/main" id="{53A9A494-C286-48F8-AB9F-3F210405D7B8}"/>
+                <a16:creationId xmlns:a16="http://schemas.microsoft.com/office/drawing/2014/main" id="{14A9BAC1-A06E-4470-90D9-B633A04AD719}"/>
               </a:ext>
             </a:extLst>
           </p:cNvPr>
@@ -9301,7 +9301,7 @@
           <p:cNvPr id="7" name="">
             <a:extLst xmlns:a="http://schemas.openxmlformats.org/drawingml/2006/main">
               <a:ext uri="{FF2B5EF4-FFF2-40B4-BE49-F238E27FC236}">
-                <a16:creationId xmlns:a16="http://schemas.microsoft.com/office/drawing/2014/main" id="{F9B72CE4-B04E-4793-8905-7D694A767356}"/>
+                <a16:creationId xmlns:a16="http://schemas.microsoft.com/office/drawing/2014/main" id="{BD4822A7-388D-4488-9664-796739AF1209}"/>
               </a:ext>
             </a:extLst>
           </p:cNvPr>
@@ -9489,7 +9489,7 @@
           <p:cNvPr id="11" name="">
             <a:extLst xmlns:a="http://schemas.openxmlformats.org/drawingml/2006/main">
               <a:ext uri="{FF2B5EF4-FFF2-40B4-BE49-F238E27FC236}">
-                <a16:creationId xmlns:a16="http://schemas.microsoft.com/office/drawing/2014/main" id="{CB91D0D2-63CC-40BC-B2E8-7A2BD3704780}"/>
+                <a16:creationId xmlns:a16="http://schemas.microsoft.com/office/drawing/2014/main" id="{A0D1F238-0F08-4B79-9804-A68BDD978AA7}"/>
               </a:ext>
             </a:extLst>
           </p:cNvPr>
@@ -9647,7 +9647,7 @@
           <p:cNvPr id="12" name="">
             <a:extLst xmlns:a="http://schemas.openxmlformats.org/drawingml/2006/main">
               <a:ext uri="{FF2B5EF4-FFF2-40B4-BE49-F238E27FC236}">
-                <a16:creationId xmlns:a16="http://schemas.microsoft.com/office/drawing/2014/main" id="{3C7A5639-968F-4ADA-A8B2-BB17BBF70D6A}"/>
+                <a16:creationId xmlns:a16="http://schemas.microsoft.com/office/drawing/2014/main" id="{7B98C94D-10F6-4672-8832-FEDE57A70779}"/>
               </a:ext>
             </a:extLst>
           </p:cNvPr>
@@ -9803,7 +9803,7 @@
     </p:spTree>
     <p:extLst>
       <p:ext uri="{BB962C8B-B14F-4D97-AF65-F5344CB8AC3E}">
-        <p14:creationId xmlns:p14="http://schemas.microsoft.com/office/powerpoint/2010/main" val="1964591233"/>
+        <p14:creationId xmlns:p14="http://schemas.microsoft.com/office/powerpoint/2010/main" val="617087666"/>
       </p:ext>
     </p:extLst>
   </p:cSld>
@@ -9834,7 +9834,7 @@
           <p:cNvPr id="7" name="">
             <a:extLst xmlns:a="http://schemas.openxmlformats.org/drawingml/2006/main">
               <a:ext uri="{FF2B5EF4-FFF2-40B4-BE49-F238E27FC236}">
-                <a16:creationId xmlns:a16="http://schemas.microsoft.com/office/drawing/2014/main" id="{29D8DA79-B880-4F9F-B4AA-6E7DEBCA1B3E}"/>
+                <a16:creationId xmlns:a16="http://schemas.microsoft.com/office/drawing/2014/main" id="{4BE97FB6-73A2-4C75-9E9D-DD562EDF8235}"/>
               </a:ext>
             </a:extLst>
           </p:cNvPr>
@@ -9864,7 +9864,7 @@
           <p:cNvPr id="2" name="">
             <a:extLst xmlns:a="http://schemas.openxmlformats.org/drawingml/2006/main">
               <a:ext uri="{FF2B5EF4-FFF2-40B4-BE49-F238E27FC236}">
-                <a16:creationId xmlns:a16="http://schemas.microsoft.com/office/drawing/2014/main" id="{51944E6A-24A4-40A4-AFFF-A854242E168E}"/>
+                <a16:creationId xmlns:a16="http://schemas.microsoft.com/office/drawing/2014/main" id="{D2BE12BB-23C4-454F-BE00-88E55A01133A}"/>
               </a:ext>
             </a:extLst>
           </p:cNvPr>
@@ -10022,7 +10022,7 @@
           <p:cNvPr id="3" name="">
             <a:extLst xmlns:a="http://schemas.openxmlformats.org/drawingml/2006/main">
               <a:ext uri="{FF2B5EF4-FFF2-40B4-BE49-F238E27FC236}">
-                <a16:creationId xmlns:a16="http://schemas.microsoft.com/office/drawing/2014/main" id="{580D54C9-B762-46C8-AA7A-F8DA5A7B4B24}"/>
+                <a16:creationId xmlns:a16="http://schemas.microsoft.com/office/drawing/2014/main" id="{5A811759-5B24-4FD5-9FD5-BC1B5DB1B626}"/>
               </a:ext>
             </a:extLst>
           </p:cNvPr>
@@ -10180,7 +10180,7 @@
           <p:cNvPr id="4" name="">
             <a:extLst xmlns:a="http://schemas.openxmlformats.org/drawingml/2006/main">
               <a:ext uri="{FF2B5EF4-FFF2-40B4-BE49-F238E27FC236}">
-                <a16:creationId xmlns:a16="http://schemas.microsoft.com/office/drawing/2014/main" id="{FC9CAA2F-2233-4DA5-B876-D789340132B1}"/>
+                <a16:creationId xmlns:a16="http://schemas.microsoft.com/office/drawing/2014/main" id="{1B44B4FC-A9BA-41B6-9213-7BBB7411CB58}"/>
               </a:ext>
             </a:extLst>
           </p:cNvPr>
@@ -10450,7 +10450,7 @@
           <p:cNvPr id="5" name="">
             <a:extLst xmlns:a="http://schemas.openxmlformats.org/drawingml/2006/main">
               <a:ext uri="{FF2B5EF4-FFF2-40B4-BE49-F238E27FC236}">
-                <a16:creationId xmlns:a16="http://schemas.microsoft.com/office/drawing/2014/main" id="{4AC8774F-B364-4E20-ACF7-BD7F9CB869F1}"/>
+                <a16:creationId xmlns:a16="http://schemas.microsoft.com/office/drawing/2014/main" id="{8031529D-6954-44A0-BAF1-A5677DC4AF33}"/>
               </a:ext>
             </a:extLst>
           </p:cNvPr>
@@ -10776,7 +10776,7 @@
           <p:cNvPr id="6" name="">
             <a:extLst xmlns:a="http://schemas.openxmlformats.org/drawingml/2006/main">
               <a:ext uri="{FF2B5EF4-FFF2-40B4-BE49-F238E27FC236}">
-                <a16:creationId xmlns:a16="http://schemas.microsoft.com/office/drawing/2014/main" id="{097583B4-E341-420D-BA93-50FF8597B0F3}"/>
+                <a16:creationId xmlns:a16="http://schemas.microsoft.com/office/drawing/2014/main" id="{6FD98FCF-DFD4-41BD-B77D-0F4D0BA7FD06}"/>
               </a:ext>
             </a:extLst>
           </p:cNvPr>
@@ -10932,7 +10932,7 @@
     </p:spTree>
     <p:extLst>
       <p:ext uri="{BB962C8B-B14F-4D97-AF65-F5344CB8AC3E}">
-        <p14:creationId xmlns:p14="http://schemas.microsoft.com/office/powerpoint/2010/main" val="735718339"/>
+        <p14:creationId xmlns:p14="http://schemas.microsoft.com/office/powerpoint/2010/main" val="2055433004"/>
       </p:ext>
     </p:extLst>
   </p:cSld>
@@ -10963,7 +10963,7 @@
           <p:cNvPr id="28" name="">
             <a:extLst xmlns:a="http://schemas.openxmlformats.org/drawingml/2006/main">
               <a:ext uri="{FF2B5EF4-FFF2-40B4-BE49-F238E27FC236}">
-                <a16:creationId xmlns:a16="http://schemas.microsoft.com/office/drawing/2014/main" id="{EE47CED4-38FC-42C8-B3CE-9857BF0074B1}"/>
+                <a16:creationId xmlns:a16="http://schemas.microsoft.com/office/drawing/2014/main" id="{78945D96-974F-43BF-927C-F496C5ADEACC}"/>
               </a:ext>
             </a:extLst>
           </p:cNvPr>
@@ -10993,7 +10993,7 @@
           <p:cNvPr id="2" name="">
             <a:extLst xmlns:a="http://schemas.openxmlformats.org/drawingml/2006/main">
               <a:ext uri="{FF2B5EF4-FFF2-40B4-BE49-F238E27FC236}">
-                <a16:creationId xmlns:a16="http://schemas.microsoft.com/office/drawing/2014/main" id="{24BFA92C-0D47-48D3-A864-AC090F83FF04}"/>
+                <a16:creationId xmlns:a16="http://schemas.microsoft.com/office/drawing/2014/main" id="{AA754AE8-80AC-47D6-A94A-C3C145B8B9CE}"/>
               </a:ext>
             </a:extLst>
           </p:cNvPr>
@@ -11151,7 +11151,7 @@
           <p:cNvPr id="3" name="">
             <a:extLst xmlns:a="http://schemas.openxmlformats.org/drawingml/2006/main">
               <a:ext uri="{FF2B5EF4-FFF2-40B4-BE49-F238E27FC236}">
-                <a16:creationId xmlns:a16="http://schemas.microsoft.com/office/drawing/2014/main" id="{B07D79F4-D40C-49F1-8DC9-213DFCE04798}"/>
+                <a16:creationId xmlns:a16="http://schemas.microsoft.com/office/drawing/2014/main" id="{15FF0C93-4DAA-4FD1-8744-CEC991833752}"/>
               </a:ext>
             </a:extLst>
           </p:cNvPr>
@@ -11309,7 +11309,7 @@
           <p:cNvPr id="4" name="">
             <a:extLst xmlns:a="http://schemas.openxmlformats.org/drawingml/2006/main">
               <a:ext uri="{FF2B5EF4-FFF2-40B4-BE49-F238E27FC236}">
-                <a16:creationId xmlns:a16="http://schemas.microsoft.com/office/drawing/2014/main" id="{BB926976-9C53-4FEE-B93F-986B19EBAFAE}"/>
+                <a16:creationId xmlns:a16="http://schemas.microsoft.com/office/drawing/2014/main" id="{85DCC13F-8673-4A3D-BFEE-800188FCE277}"/>
               </a:ext>
             </a:extLst>
           </p:cNvPr>
@@ -11467,7 +11467,7 @@
           <p:cNvPr id="5" name="">
             <a:extLst xmlns:a="http://schemas.openxmlformats.org/drawingml/2006/main">
               <a:ext uri="{FF2B5EF4-FFF2-40B4-BE49-F238E27FC236}">
-                <a16:creationId xmlns:a16="http://schemas.microsoft.com/office/drawing/2014/main" id="{6C990A13-9899-441A-BEFE-61D9BDDA53A8}"/>
+                <a16:creationId xmlns:a16="http://schemas.microsoft.com/office/drawing/2014/main" id="{18EC15F2-ABC3-447C-A629-61C6AB904110}"/>
               </a:ext>
             </a:extLst>
           </p:cNvPr>
@@ -11625,7 +11625,7 @@
           <p:cNvPr id="6" name="">
             <a:extLst xmlns:a="http://schemas.openxmlformats.org/drawingml/2006/main">
               <a:ext uri="{FF2B5EF4-FFF2-40B4-BE49-F238E27FC236}">
-                <a16:creationId xmlns:a16="http://schemas.microsoft.com/office/drawing/2014/main" id="{C682FB87-C8A1-4C0C-A390-D1469DAA54A6}"/>
+                <a16:creationId xmlns:a16="http://schemas.microsoft.com/office/drawing/2014/main" id="{B6845FCC-8AB5-407D-8532-593E2FEEB6E4}"/>
               </a:ext>
             </a:extLst>
           </p:cNvPr>
@@ -11783,7 +11783,7 @@
           <p:cNvPr id="7" name="">
             <a:extLst xmlns:a="http://schemas.openxmlformats.org/drawingml/2006/main">
               <a:ext uri="{FF2B5EF4-FFF2-40B4-BE49-F238E27FC236}">
-                <a16:creationId xmlns:a16="http://schemas.microsoft.com/office/drawing/2014/main" id="{6A2619C3-2D6E-492A-91D4-D4F0B9AC003B}"/>
+                <a16:creationId xmlns:a16="http://schemas.microsoft.com/office/drawing/2014/main" id="{75060652-2873-47A4-B40B-0A697FE3BD31}"/>
               </a:ext>
             </a:extLst>
           </p:cNvPr>
@@ -11941,7 +11941,7 @@
           <p:cNvPr id="8" name="">
             <a:extLst xmlns:a="http://schemas.openxmlformats.org/drawingml/2006/main">
               <a:ext uri="{FF2B5EF4-FFF2-40B4-BE49-F238E27FC236}">
-                <a16:creationId xmlns:a16="http://schemas.microsoft.com/office/drawing/2014/main" id="{66973762-A88C-4913-AAA0-ED063C1F5174}"/>
+                <a16:creationId xmlns:a16="http://schemas.microsoft.com/office/drawing/2014/main" id="{325D7F0D-31B3-45B0-B734-1C9441EEF08D}"/>
               </a:ext>
             </a:extLst>
           </p:cNvPr>
@@ -12099,7 +12099,7 @@
           <p:cNvPr id="9" name="">
             <a:extLst xmlns:a="http://schemas.openxmlformats.org/drawingml/2006/main">
               <a:ext uri="{FF2B5EF4-FFF2-40B4-BE49-F238E27FC236}">
-                <a16:creationId xmlns:a16="http://schemas.microsoft.com/office/drawing/2014/main" id="{22DCE2ED-8DAB-4AC2-9249-9388FA4A4123}"/>
+                <a16:creationId xmlns:a16="http://schemas.microsoft.com/office/drawing/2014/main" id="{8C5AA0FF-AA79-45C7-A84C-076998372343}"/>
               </a:ext>
             </a:extLst>
           </p:cNvPr>
@@ -12257,7 +12257,7 @@
           <p:cNvPr id="10" name="">
             <a:extLst xmlns:a="http://schemas.openxmlformats.org/drawingml/2006/main">
               <a:ext uri="{FF2B5EF4-FFF2-40B4-BE49-F238E27FC236}">
-                <a16:creationId xmlns:a16="http://schemas.microsoft.com/office/drawing/2014/main" id="{76D74BCD-CE3C-4445-B6E4-660FDC35EEC1}"/>
+                <a16:creationId xmlns:a16="http://schemas.microsoft.com/office/drawing/2014/main" id="{CB51BD74-1436-45AF-95A3-07D25B0287DE}"/>
               </a:ext>
             </a:extLst>
           </p:cNvPr>
@@ -12415,7 +12415,7 @@
           <p:cNvPr id="11" name="">
             <a:extLst xmlns:a="http://schemas.openxmlformats.org/drawingml/2006/main">
               <a:ext uri="{FF2B5EF4-FFF2-40B4-BE49-F238E27FC236}">
-                <a16:creationId xmlns:a16="http://schemas.microsoft.com/office/drawing/2014/main" id="{5DE02B8E-A145-4D7D-8FE4-7CFC1FB40D51}"/>
+                <a16:creationId xmlns:a16="http://schemas.microsoft.com/office/drawing/2014/main" id="{871A7976-6585-4995-938B-C345C313F779}"/>
               </a:ext>
             </a:extLst>
           </p:cNvPr>
@@ -12573,7 +12573,7 @@
           <p:cNvPr id="12" name="">
             <a:extLst xmlns:a="http://schemas.openxmlformats.org/drawingml/2006/main">
               <a:ext uri="{FF2B5EF4-FFF2-40B4-BE49-F238E27FC236}">
-                <a16:creationId xmlns:a16="http://schemas.microsoft.com/office/drawing/2014/main" id="{29DF320C-D9CB-47D7-A1C9-D1D4FCF6F551}"/>
+                <a16:creationId xmlns:a16="http://schemas.microsoft.com/office/drawing/2014/main" id="{E8875676-F3EE-46BD-B1F1-2C9C0A1F1BD7}"/>
               </a:ext>
             </a:extLst>
           </p:cNvPr>
@@ -12731,7 +12731,7 @@
           <p:cNvPr id="13" name="">
             <a:extLst xmlns:a="http://schemas.openxmlformats.org/drawingml/2006/main">
               <a:ext uri="{FF2B5EF4-FFF2-40B4-BE49-F238E27FC236}">
-                <a16:creationId xmlns:a16="http://schemas.microsoft.com/office/drawing/2014/main" id="{9F2651F3-545B-449A-BCA3-DDCF73170C0D}"/>
+                <a16:creationId xmlns:a16="http://schemas.microsoft.com/office/drawing/2014/main" id="{09D1AFDC-3163-4C8A-B7B6-31652E77F670}"/>
               </a:ext>
             </a:extLst>
           </p:cNvPr>
@@ -12889,7 +12889,7 @@
           <p:cNvPr id="14" name="">
             <a:extLst xmlns:a="http://schemas.openxmlformats.org/drawingml/2006/main">
               <a:ext uri="{FF2B5EF4-FFF2-40B4-BE49-F238E27FC236}">
-                <a16:creationId xmlns:a16="http://schemas.microsoft.com/office/drawing/2014/main" id="{2453E694-342C-4CF4-8346-3CB79D25390D}"/>
+                <a16:creationId xmlns:a16="http://schemas.microsoft.com/office/drawing/2014/main" id="{B8D16312-28FA-4952-8381-973C2B9A06A7}"/>
               </a:ext>
             </a:extLst>
           </p:cNvPr>
@@ -13047,7 +13047,7 @@
           <p:cNvPr id="15" name="">
             <a:extLst xmlns:a="http://schemas.openxmlformats.org/drawingml/2006/main">
               <a:ext uri="{FF2B5EF4-FFF2-40B4-BE49-F238E27FC236}">
-                <a16:creationId xmlns:a16="http://schemas.microsoft.com/office/drawing/2014/main" id="{88C85F37-86B4-4B1B-9A7C-571BE19CF7D7}"/>
+                <a16:creationId xmlns:a16="http://schemas.microsoft.com/office/drawing/2014/main" id="{BDC967B5-40E3-4EDF-B968-EA63B0703AE5}"/>
               </a:ext>
             </a:extLst>
           </p:cNvPr>
@@ -13205,7 +13205,7 @@
           <p:cNvPr id="16" name="">
             <a:extLst xmlns:a="http://schemas.openxmlformats.org/drawingml/2006/main">
               <a:ext uri="{FF2B5EF4-FFF2-40B4-BE49-F238E27FC236}">
-                <a16:creationId xmlns:a16="http://schemas.microsoft.com/office/drawing/2014/main" id="{2F85F49C-D438-4AAC-B790-560F0C001A2B}"/>
+                <a16:creationId xmlns:a16="http://schemas.microsoft.com/office/drawing/2014/main" id="{F146CB0F-DC9D-44B7-BB03-97B00EB9C3CA}"/>
               </a:ext>
             </a:extLst>
           </p:cNvPr>
@@ -13363,7 +13363,7 @@
           <p:cNvPr id="17" name="">
             <a:extLst xmlns:a="http://schemas.openxmlformats.org/drawingml/2006/main">
               <a:ext uri="{FF2B5EF4-FFF2-40B4-BE49-F238E27FC236}">
-                <a16:creationId xmlns:a16="http://schemas.microsoft.com/office/drawing/2014/main" id="{439BBA55-FCE6-4F8C-BF2D-F73E07D07060}"/>
+                <a16:creationId xmlns:a16="http://schemas.microsoft.com/office/drawing/2014/main" id="{5E36741A-C92A-4F20-A2C8-1396C1DC8730}"/>
               </a:ext>
             </a:extLst>
           </p:cNvPr>
@@ -13521,7 +13521,7 @@
           <p:cNvPr id="18" name="">
             <a:extLst xmlns:a="http://schemas.openxmlformats.org/drawingml/2006/main">
               <a:ext uri="{FF2B5EF4-FFF2-40B4-BE49-F238E27FC236}">
-                <a16:creationId xmlns:a16="http://schemas.microsoft.com/office/drawing/2014/main" id="{E4DFBB7E-F426-453F-ACA5-5E4C7DCD6F4A}"/>
+                <a16:creationId xmlns:a16="http://schemas.microsoft.com/office/drawing/2014/main" id="{5F5DA5B6-9479-4D87-82E1-2F3D3A67F1DE}"/>
               </a:ext>
             </a:extLst>
           </p:cNvPr>
@@ -13679,7 +13679,7 @@
           <p:cNvPr id="19" name="">
             <a:extLst xmlns:a="http://schemas.openxmlformats.org/drawingml/2006/main">
               <a:ext uri="{FF2B5EF4-FFF2-40B4-BE49-F238E27FC236}">
-                <a16:creationId xmlns:a16="http://schemas.microsoft.com/office/drawing/2014/main" id="{FEC687E4-CE58-4622-A012-08C370545FFE}"/>
+                <a16:creationId xmlns:a16="http://schemas.microsoft.com/office/drawing/2014/main" id="{9216B858-B6AF-4340-A718-9128E4148838}"/>
               </a:ext>
             </a:extLst>
           </p:cNvPr>
@@ -13837,7 +13837,7 @@
           <p:cNvPr id="20" name="">
             <a:extLst xmlns:a="http://schemas.openxmlformats.org/drawingml/2006/main">
               <a:ext uri="{FF2B5EF4-FFF2-40B4-BE49-F238E27FC236}">
-                <a16:creationId xmlns:a16="http://schemas.microsoft.com/office/drawing/2014/main" id="{55EE6B98-8AF4-4ED1-B950-72BE69B119F5}"/>
+                <a16:creationId xmlns:a16="http://schemas.microsoft.com/office/drawing/2014/main" id="{A224C6E2-0A87-4750-963E-A4CED4A6AC2D}"/>
               </a:ext>
             </a:extLst>
           </p:cNvPr>
@@ -13995,7 +13995,7 @@
           <p:cNvPr id="21" name="">
             <a:extLst xmlns:a="http://schemas.openxmlformats.org/drawingml/2006/main">
               <a:ext uri="{FF2B5EF4-FFF2-40B4-BE49-F238E27FC236}">
-                <a16:creationId xmlns:a16="http://schemas.microsoft.com/office/drawing/2014/main" id="{930E0312-7A59-4BEE-AD27-5F11F7AEF9DB}"/>
+                <a16:creationId xmlns:a16="http://schemas.microsoft.com/office/drawing/2014/main" id="{CA5F01C0-DE76-4819-B31D-A8B1B7ECB006}"/>
               </a:ext>
             </a:extLst>
           </p:cNvPr>
@@ -14153,7 +14153,7 @@
           <p:cNvPr id="22" name="">
             <a:extLst xmlns:a="http://schemas.openxmlformats.org/drawingml/2006/main">
               <a:ext uri="{FF2B5EF4-FFF2-40B4-BE49-F238E27FC236}">
-                <a16:creationId xmlns:a16="http://schemas.microsoft.com/office/drawing/2014/main" id="{EF2B5335-1DC1-4161-A120-0BD7B61D1EB1}"/>
+                <a16:creationId xmlns:a16="http://schemas.microsoft.com/office/drawing/2014/main" id="{75056AAA-A703-497D-B27E-1F8A54F2B2E3}"/>
               </a:ext>
             </a:extLst>
           </p:cNvPr>
@@ -14311,7 +14311,7 @@
           <p:cNvPr id="23" name="">
             <a:extLst xmlns:a="http://schemas.openxmlformats.org/drawingml/2006/main">
               <a:ext uri="{FF2B5EF4-FFF2-40B4-BE49-F238E27FC236}">
-                <a16:creationId xmlns:a16="http://schemas.microsoft.com/office/drawing/2014/main" id="{BA6569AA-E656-4858-9074-B4B92C3EFD22}"/>
+                <a16:creationId xmlns:a16="http://schemas.microsoft.com/office/drawing/2014/main" id="{D0638B88-97E1-4026-9571-5ECCE02B3F01}"/>
               </a:ext>
             </a:extLst>
           </p:cNvPr>
@@ -14469,7 +14469,7 @@
           <p:cNvPr id="24" name="">
             <a:extLst xmlns:a="http://schemas.openxmlformats.org/drawingml/2006/main">
               <a:ext uri="{FF2B5EF4-FFF2-40B4-BE49-F238E27FC236}">
-                <a16:creationId xmlns:a16="http://schemas.microsoft.com/office/drawing/2014/main" id="{5438F5D1-A061-4EB9-B892-F7AA17DA0C78}"/>
+                <a16:creationId xmlns:a16="http://schemas.microsoft.com/office/drawing/2014/main" id="{B29B8CA0-D1E6-411A-93E5-1353267FDE71}"/>
               </a:ext>
             </a:extLst>
           </p:cNvPr>
@@ -14627,7 +14627,7 @@
           <p:cNvPr id="25" name="">
             <a:extLst xmlns:a="http://schemas.openxmlformats.org/drawingml/2006/main">
               <a:ext uri="{FF2B5EF4-FFF2-40B4-BE49-F238E27FC236}">
-                <a16:creationId xmlns:a16="http://schemas.microsoft.com/office/drawing/2014/main" id="{932557DA-1C14-4F9B-B036-172617C65642}"/>
+                <a16:creationId xmlns:a16="http://schemas.microsoft.com/office/drawing/2014/main" id="{C168216A-47B0-49C6-A622-84E1CCE43F41}"/>
               </a:ext>
             </a:extLst>
           </p:cNvPr>
@@ -14785,7 +14785,7 @@
           <p:cNvPr id="26" name="">
             <a:extLst xmlns:a="http://schemas.openxmlformats.org/drawingml/2006/main">
               <a:ext uri="{FF2B5EF4-FFF2-40B4-BE49-F238E27FC236}">
-                <a16:creationId xmlns:a16="http://schemas.microsoft.com/office/drawing/2014/main" id="{5C8DD27A-9B16-441B-9847-32195E10B07E}"/>
+                <a16:creationId xmlns:a16="http://schemas.microsoft.com/office/drawing/2014/main" id="{254A164B-AFB5-4866-B578-4FAF1D74C5D9}"/>
               </a:ext>
             </a:extLst>
           </p:cNvPr>
@@ -14943,7 +14943,7 @@
           <p:cNvPr id="27" name="">
             <a:extLst xmlns:a="http://schemas.openxmlformats.org/drawingml/2006/main">
               <a:ext uri="{FF2B5EF4-FFF2-40B4-BE49-F238E27FC236}">
-                <a16:creationId xmlns:a16="http://schemas.microsoft.com/office/drawing/2014/main" id="{55E98EB8-F55A-4041-A7E8-244F3D2F222D}"/>
+                <a16:creationId xmlns:a16="http://schemas.microsoft.com/office/drawing/2014/main" id="{A1CA3584-0656-4FDD-A020-FC709CF05C50}"/>
               </a:ext>
             </a:extLst>
           </p:cNvPr>
@@ -15099,7 +15099,7 @@
     </p:spTree>
     <p:extLst>
       <p:ext uri="{BB962C8B-B14F-4D97-AF65-F5344CB8AC3E}">
-        <p14:creationId xmlns:p14="http://schemas.microsoft.com/office/powerpoint/2010/main" val="224303783"/>
+        <p14:creationId xmlns:p14="http://schemas.microsoft.com/office/powerpoint/2010/main" val="971053774"/>
       </p:ext>
     </p:extLst>
   </p:cSld>
@@ -15130,7 +15130,7 @@
           <p:cNvPr id="11" name="">
             <a:extLst xmlns:a="http://schemas.openxmlformats.org/drawingml/2006/main">
               <a:ext uri="{FF2B5EF4-FFF2-40B4-BE49-F238E27FC236}">
-                <a16:creationId xmlns:a16="http://schemas.microsoft.com/office/drawing/2014/main" id="{66E43796-3E72-4580-9411-E9E53FC7C684}"/>
+                <a16:creationId xmlns:a16="http://schemas.microsoft.com/office/drawing/2014/main" id="{8C542366-CA75-40AD-B27E-29E765C35190}"/>
               </a:ext>
             </a:extLst>
           </p:cNvPr>
@@ -15160,7 +15160,7 @@
           <p:cNvPr id="2" name="">
             <a:extLst xmlns:a="http://schemas.openxmlformats.org/drawingml/2006/main">
               <a:ext uri="{FF2B5EF4-FFF2-40B4-BE49-F238E27FC236}">
-                <a16:creationId xmlns:a16="http://schemas.microsoft.com/office/drawing/2014/main" id="{3A770A98-667D-4993-895A-A6C5C88FCA15}"/>
+                <a16:creationId xmlns:a16="http://schemas.microsoft.com/office/drawing/2014/main" id="{B8322954-7812-4FB8-A503-E7410A092F15}"/>
               </a:ext>
             </a:extLst>
           </p:cNvPr>
@@ -15318,7 +15318,7 @@
           <p:cNvPr id="3" name="">
             <a:extLst xmlns:a="http://schemas.openxmlformats.org/drawingml/2006/main">
               <a:ext uri="{FF2B5EF4-FFF2-40B4-BE49-F238E27FC236}">
-                <a16:creationId xmlns:a16="http://schemas.microsoft.com/office/drawing/2014/main" id="{64DFF8E2-03C4-40CB-9DB6-79D1C15B05E6}"/>
+                <a16:creationId xmlns:a16="http://schemas.microsoft.com/office/drawing/2014/main" id="{5AE1C8F2-E859-4806-AF07-D74512DC14B4}"/>
               </a:ext>
             </a:extLst>
           </p:cNvPr>
@@ -15476,7 +15476,7 @@
           <p:cNvPr id="4" name="">
             <a:extLst xmlns:a="http://schemas.openxmlformats.org/drawingml/2006/main">
               <a:ext uri="{FF2B5EF4-FFF2-40B4-BE49-F238E27FC236}">
-                <a16:creationId xmlns:a16="http://schemas.microsoft.com/office/drawing/2014/main" id="{470D4A8B-B7BA-4C03-A706-8E8F198F010E}"/>
+                <a16:creationId xmlns:a16="http://schemas.microsoft.com/office/drawing/2014/main" id="{B5F59320-B910-4DDF-8591-FE654D42B29A}"/>
               </a:ext>
             </a:extLst>
           </p:cNvPr>
@@ -15634,7 +15634,7 @@
           <p:cNvPr id="5" name="">
             <a:extLst xmlns:a="http://schemas.openxmlformats.org/drawingml/2006/main">
               <a:ext uri="{FF2B5EF4-FFF2-40B4-BE49-F238E27FC236}">
-                <a16:creationId xmlns:a16="http://schemas.microsoft.com/office/drawing/2014/main" id="{4FED675C-65FF-4C25-985E-35F74604D4EC}"/>
+                <a16:creationId xmlns:a16="http://schemas.microsoft.com/office/drawing/2014/main" id="{57F67159-FB52-4BEA-B2F0-11D1394F5906}"/>
               </a:ext>
             </a:extLst>
           </p:cNvPr>
@@ -15850,7 +15850,7 @@
           <p:cNvPr id="6" name="">
             <a:extLst xmlns:a="http://schemas.openxmlformats.org/drawingml/2006/main">
               <a:ext uri="{FF2B5EF4-FFF2-40B4-BE49-F238E27FC236}">
-                <a16:creationId xmlns:a16="http://schemas.microsoft.com/office/drawing/2014/main" id="{8FF9BAC3-809B-434C-860B-B2A65330614B}"/>
+                <a16:creationId xmlns:a16="http://schemas.microsoft.com/office/drawing/2014/main" id="{A9C85F56-5C37-4B69-BFD1-F0AB660A264A}"/>
               </a:ext>
             </a:extLst>
           </p:cNvPr>
@@ -16008,7 +16008,7 @@
           <p:cNvPr id="7" name="">
             <a:extLst xmlns:a="http://schemas.openxmlformats.org/drawingml/2006/main">
               <a:ext uri="{FF2B5EF4-FFF2-40B4-BE49-F238E27FC236}">
-                <a16:creationId xmlns:a16="http://schemas.microsoft.com/office/drawing/2014/main" id="{D9614D96-2225-46AF-B49B-54E211F8EBBB}"/>
+                <a16:creationId xmlns:a16="http://schemas.microsoft.com/office/drawing/2014/main" id="{DC8112E6-8B2B-4385-AF3A-9EBE7A3A3911}"/>
               </a:ext>
             </a:extLst>
           </p:cNvPr>
@@ -16224,7 +16224,7 @@
           <p:cNvPr id="8" name="">
             <a:extLst xmlns:a="http://schemas.openxmlformats.org/drawingml/2006/main">
               <a:ext uri="{FF2B5EF4-FFF2-40B4-BE49-F238E27FC236}">
-                <a16:creationId xmlns:a16="http://schemas.microsoft.com/office/drawing/2014/main" id="{C3B805EC-37BF-4A5B-A163-6C5696A716EF}"/>
+                <a16:creationId xmlns:a16="http://schemas.microsoft.com/office/drawing/2014/main" id="{8177BD21-64BF-48F3-A288-0AE7726B573F}"/>
               </a:ext>
             </a:extLst>
           </p:cNvPr>
@@ -16382,7 +16382,7 @@
           <p:cNvPr id="9" name="">
             <a:extLst xmlns:a="http://schemas.openxmlformats.org/drawingml/2006/main">
               <a:ext uri="{FF2B5EF4-FFF2-40B4-BE49-F238E27FC236}">
-                <a16:creationId xmlns:a16="http://schemas.microsoft.com/office/drawing/2014/main" id="{92981B97-79C1-4959-BE27-398663AD2CFD}"/>
+                <a16:creationId xmlns:a16="http://schemas.microsoft.com/office/drawing/2014/main" id="{F3663902-A695-454C-B33E-4F4874AF0784}"/>
               </a:ext>
             </a:extLst>
           </p:cNvPr>
@@ -16598,7 +16598,7 @@
           <p:cNvPr id="10" name="">
             <a:extLst xmlns:a="http://schemas.openxmlformats.org/drawingml/2006/main">
               <a:ext uri="{FF2B5EF4-FFF2-40B4-BE49-F238E27FC236}">
-                <a16:creationId xmlns:a16="http://schemas.microsoft.com/office/drawing/2014/main" id="{2CB6FD01-B877-49B6-8DE6-F43C963D158B}"/>
+                <a16:creationId xmlns:a16="http://schemas.microsoft.com/office/drawing/2014/main" id="{018077F5-96CC-44AF-9280-E3D196D91679}"/>
               </a:ext>
             </a:extLst>
           </p:cNvPr>
@@ -16777,7 +16777,7 @@
     </p:spTree>
     <p:extLst>
       <p:ext uri="{BB962C8B-B14F-4D97-AF65-F5344CB8AC3E}">
-        <p14:creationId xmlns:p14="http://schemas.microsoft.com/office/powerpoint/2010/main" val="343087461"/>
+        <p14:creationId xmlns:p14="http://schemas.microsoft.com/office/powerpoint/2010/main" val="1747552853"/>
       </p:ext>
     </p:extLst>
   </p:cSld>
@@ -16808,7 +16808,7 @@
           <p:cNvPr id="11" name="">
             <a:extLst xmlns:a="http://schemas.openxmlformats.org/drawingml/2006/main">
               <a:ext uri="{FF2B5EF4-FFF2-40B4-BE49-F238E27FC236}">
-                <a16:creationId xmlns:a16="http://schemas.microsoft.com/office/drawing/2014/main" id="{3864A285-9D91-4B58-82EF-F2347050F85F}"/>
+                <a16:creationId xmlns:a16="http://schemas.microsoft.com/office/drawing/2014/main" id="{73B3B64C-A103-4000-9F25-C2376DA44B6D}"/>
               </a:ext>
             </a:extLst>
           </p:cNvPr>
@@ -16838,7 +16838,7 @@
           <p:cNvPr id="2" name="">
             <a:extLst xmlns:a="http://schemas.openxmlformats.org/drawingml/2006/main">
               <a:ext uri="{FF2B5EF4-FFF2-40B4-BE49-F238E27FC236}">
-                <a16:creationId xmlns:a16="http://schemas.microsoft.com/office/drawing/2014/main" id="{07A4C0E2-F635-4475-BFFD-0B0EAA31668F}"/>
+                <a16:creationId xmlns:a16="http://schemas.microsoft.com/office/drawing/2014/main" id="{0EF988D9-1C71-429D-A050-E4F3B584C6C5}"/>
               </a:ext>
             </a:extLst>
           </p:cNvPr>
@@ -16996,7 +16996,7 @@
           <p:cNvPr id="3" name="">
             <a:extLst xmlns:a="http://schemas.openxmlformats.org/drawingml/2006/main">
               <a:ext uri="{FF2B5EF4-FFF2-40B4-BE49-F238E27FC236}">
-                <a16:creationId xmlns:a16="http://schemas.microsoft.com/office/drawing/2014/main" id="{C1BAC8BA-546C-40CC-B036-64C8A91DD53A}"/>
+                <a16:creationId xmlns:a16="http://schemas.microsoft.com/office/drawing/2014/main" id="{2AF86A2C-E851-487B-B0D9-B056993A2DBE}"/>
               </a:ext>
             </a:extLst>
           </p:cNvPr>
@@ -17154,7 +17154,7 @@
           <p:cNvPr id="4" name="">
             <a:extLst xmlns:a="http://schemas.openxmlformats.org/drawingml/2006/main">
               <a:ext uri="{FF2B5EF4-FFF2-40B4-BE49-F238E27FC236}">
-                <a16:creationId xmlns:a16="http://schemas.microsoft.com/office/drawing/2014/main" id="{CF21ABCA-8D98-4AF4-88F9-6635AE12D92E}"/>
+                <a16:creationId xmlns:a16="http://schemas.microsoft.com/office/drawing/2014/main" id="{181A78B9-F96D-4426-AB51-29062316FDE6}"/>
               </a:ext>
             </a:extLst>
           </p:cNvPr>
@@ -17312,7 +17312,7 @@
           <p:cNvPr id="5" name="">
             <a:extLst xmlns:a="http://schemas.openxmlformats.org/drawingml/2006/main">
               <a:ext uri="{FF2B5EF4-FFF2-40B4-BE49-F238E27FC236}">
-                <a16:creationId xmlns:a16="http://schemas.microsoft.com/office/drawing/2014/main" id="{99C1A8E0-9D7E-4180-B90B-28A569041622}"/>
+                <a16:creationId xmlns:a16="http://schemas.microsoft.com/office/drawing/2014/main" id="{AF15E67D-BC30-4DBD-9F5F-644DC4DC0C9A}"/>
               </a:ext>
             </a:extLst>
           </p:cNvPr>
@@ -17528,7 +17528,7 @@
           <p:cNvPr id="6" name="">
             <a:extLst xmlns:a="http://schemas.openxmlformats.org/drawingml/2006/main">
               <a:ext uri="{FF2B5EF4-FFF2-40B4-BE49-F238E27FC236}">
-                <a16:creationId xmlns:a16="http://schemas.microsoft.com/office/drawing/2014/main" id="{6C6311C6-172E-439A-8803-6255177B915A}"/>
+                <a16:creationId xmlns:a16="http://schemas.microsoft.com/office/drawing/2014/main" id="{DDD9D129-5A0E-46A7-9390-19B4074527C0}"/>
               </a:ext>
             </a:extLst>
           </p:cNvPr>
@@ -17686,7 +17686,7 @@
           <p:cNvPr id="7" name="">
             <a:extLst xmlns:a="http://schemas.openxmlformats.org/drawingml/2006/main">
               <a:ext uri="{FF2B5EF4-FFF2-40B4-BE49-F238E27FC236}">
-                <a16:creationId xmlns:a16="http://schemas.microsoft.com/office/drawing/2014/main" id="{81FEB653-8E5C-4D01-9D69-E7676049C6C9}"/>
+                <a16:creationId xmlns:a16="http://schemas.microsoft.com/office/drawing/2014/main" id="{9545B7CE-17E1-46E4-8CE1-CB5BBE11AB80}"/>
               </a:ext>
             </a:extLst>
           </p:cNvPr>
@@ -17902,7 +17902,7 @@
           <p:cNvPr id="8" name="">
             <a:extLst xmlns:a="http://schemas.openxmlformats.org/drawingml/2006/main">
               <a:ext uri="{FF2B5EF4-FFF2-40B4-BE49-F238E27FC236}">
-                <a16:creationId xmlns:a16="http://schemas.microsoft.com/office/drawing/2014/main" id="{7290EE69-1055-4836-BAB8-75878D92AE2E}"/>
+                <a16:creationId xmlns:a16="http://schemas.microsoft.com/office/drawing/2014/main" id="{B3F191DB-5BFF-478C-B51B-E16BE158283E}"/>
               </a:ext>
             </a:extLst>
           </p:cNvPr>
@@ -18060,7 +18060,7 @@
           <p:cNvPr id="9" name="">
             <a:extLst xmlns:a="http://schemas.openxmlformats.org/drawingml/2006/main">
               <a:ext uri="{FF2B5EF4-FFF2-40B4-BE49-F238E27FC236}">
-                <a16:creationId xmlns:a16="http://schemas.microsoft.com/office/drawing/2014/main" id="{6A2BF504-1D41-49FD-BBC2-5306164D4AC0}"/>
+                <a16:creationId xmlns:a16="http://schemas.microsoft.com/office/drawing/2014/main" id="{A07ED06C-C097-4D11-BF85-F0A49CCC4B0F}"/>
               </a:ext>
             </a:extLst>
           </p:cNvPr>
@@ -18276,7 +18276,7 @@
           <p:cNvPr id="10" name="">
             <a:extLst xmlns:a="http://schemas.openxmlformats.org/drawingml/2006/main">
               <a:ext uri="{FF2B5EF4-FFF2-40B4-BE49-F238E27FC236}">
-                <a16:creationId xmlns:a16="http://schemas.microsoft.com/office/drawing/2014/main" id="{5B4354CE-77FD-4756-A625-4795B93A40A7}"/>
+                <a16:creationId xmlns:a16="http://schemas.microsoft.com/office/drawing/2014/main" id="{9BD83306-7D93-4192-B2BE-B834AE5EECBD}"/>
               </a:ext>
             </a:extLst>
           </p:cNvPr>
@@ -18432,7 +18432,7 @@
     </p:spTree>
     <p:extLst>
       <p:ext uri="{BB962C8B-B14F-4D97-AF65-F5344CB8AC3E}">
-        <p14:creationId xmlns:p14="http://schemas.microsoft.com/office/powerpoint/2010/main" val="1619760626"/>
+        <p14:creationId xmlns:p14="http://schemas.microsoft.com/office/powerpoint/2010/main" val="99317416"/>
       </p:ext>
     </p:extLst>
   </p:cSld>
@@ -18463,7 +18463,7 @@
           <p:cNvPr id="9" name="">
             <a:extLst xmlns:a="http://schemas.openxmlformats.org/drawingml/2006/main">
               <a:ext uri="{FF2B5EF4-FFF2-40B4-BE49-F238E27FC236}">
-                <a16:creationId xmlns:a16="http://schemas.microsoft.com/office/drawing/2014/main" id="{6E516552-E89A-42DD-8E48-AF0468A29B55}"/>
+                <a16:creationId xmlns:a16="http://schemas.microsoft.com/office/drawing/2014/main" id="{B2B64A3A-2B20-4ED0-A3BC-36BA44FEE1ED}"/>
               </a:ext>
             </a:extLst>
           </p:cNvPr>
@@ -18493,7 +18493,7 @@
           <p:cNvPr id="2" name="">
             <a:extLst xmlns:a="http://schemas.openxmlformats.org/drawingml/2006/main">
               <a:ext uri="{FF2B5EF4-FFF2-40B4-BE49-F238E27FC236}">
-                <a16:creationId xmlns:a16="http://schemas.microsoft.com/office/drawing/2014/main" id="{1C12246B-15EF-4571-A9D8-94F96C8879CF}"/>
+                <a16:creationId xmlns:a16="http://schemas.microsoft.com/office/drawing/2014/main" id="{38FFCB0E-04B5-43FC-B171-CEAF8EDB9A32}"/>
               </a:ext>
             </a:extLst>
           </p:cNvPr>
@@ -18651,7 +18651,7 @@
           <p:cNvPr id="3" name="">
             <a:extLst xmlns:a="http://schemas.openxmlformats.org/drawingml/2006/main">
               <a:ext uri="{FF2B5EF4-FFF2-40B4-BE49-F238E27FC236}">
-                <a16:creationId xmlns:a16="http://schemas.microsoft.com/office/drawing/2014/main" id="{72E8746C-E3F7-40C9-A93A-5E7A387AF58E}"/>
+                <a16:creationId xmlns:a16="http://schemas.microsoft.com/office/drawing/2014/main" id="{42B8CF28-8A4E-4602-A9F2-1517702BD67F}"/>
               </a:ext>
             </a:extLst>
           </p:cNvPr>
@@ -18809,7 +18809,7 @@
           <p:cNvPr id="4" name="">
             <a:extLst xmlns:a="http://schemas.openxmlformats.org/drawingml/2006/main">
               <a:ext uri="{FF2B5EF4-FFF2-40B4-BE49-F238E27FC236}">
-                <a16:creationId xmlns:a16="http://schemas.microsoft.com/office/drawing/2014/main" id="{A793943E-EB44-4297-A4E4-FBABA6025209}"/>
+                <a16:creationId xmlns:a16="http://schemas.microsoft.com/office/drawing/2014/main" id="{F1BD19F4-5EE3-4D8E-BE37-97124E62DD4C}"/>
               </a:ext>
             </a:extLst>
           </p:cNvPr>
@@ -18967,7 +18967,7 @@
           <p:cNvPr id="5" name="">
             <a:extLst xmlns:a="http://schemas.openxmlformats.org/drawingml/2006/main">
               <a:ext uri="{FF2B5EF4-FFF2-40B4-BE49-F238E27FC236}">
-                <a16:creationId xmlns:a16="http://schemas.microsoft.com/office/drawing/2014/main" id="{C7755F35-680E-4E4C-8538-349A11253B90}"/>
+                <a16:creationId xmlns:a16="http://schemas.microsoft.com/office/drawing/2014/main" id="{691BA3B1-3BC9-4C95-8AA8-71BCA979535C}"/>
               </a:ext>
             </a:extLst>
           </p:cNvPr>
@@ -19210,7 +19210,7 @@
           <p:cNvPr id="6" name="">
             <a:extLst xmlns:a="http://schemas.openxmlformats.org/drawingml/2006/main">
               <a:ext uri="{FF2B5EF4-FFF2-40B4-BE49-F238E27FC236}">
-                <a16:creationId xmlns:a16="http://schemas.microsoft.com/office/drawing/2014/main" id="{E4A55976-49C6-414D-B56A-07D75B68CBFE}"/>
+                <a16:creationId xmlns:a16="http://schemas.microsoft.com/office/drawing/2014/main" id="{B5D025E3-5987-4703-80BB-45C427C3EFA3}"/>
               </a:ext>
             </a:extLst>
           </p:cNvPr>
@@ -19368,7 +19368,7 @@
           <p:cNvPr id="7" name="">
             <a:extLst xmlns:a="http://schemas.openxmlformats.org/drawingml/2006/main">
               <a:ext uri="{FF2B5EF4-FFF2-40B4-BE49-F238E27FC236}">
-                <a16:creationId xmlns:a16="http://schemas.microsoft.com/office/drawing/2014/main" id="{13A3CB7F-4F46-4D4B-AA2E-764ABAA8C2F8}"/>
+                <a16:creationId xmlns:a16="http://schemas.microsoft.com/office/drawing/2014/main" id="{0E132C86-FC6E-40A9-86F0-7F9DF98086AE}"/>
               </a:ext>
             </a:extLst>
           </p:cNvPr>
@@ -19611,7 +19611,7 @@
           <p:cNvPr id="8" name="">
             <a:extLst xmlns:a="http://schemas.openxmlformats.org/drawingml/2006/main">
               <a:ext uri="{FF2B5EF4-FFF2-40B4-BE49-F238E27FC236}">
-                <a16:creationId xmlns:a16="http://schemas.microsoft.com/office/drawing/2014/main" id="{67DFF504-3A84-4409-A3F4-30309556511B}"/>
+                <a16:creationId xmlns:a16="http://schemas.microsoft.com/office/drawing/2014/main" id="{4824ED5F-873C-443C-9EB1-ED45EE453488}"/>
               </a:ext>
             </a:extLst>
           </p:cNvPr>
@@ -19790,7 +19790,7 @@
     </p:spTree>
     <p:extLst>
       <p:ext uri="{BB962C8B-B14F-4D97-AF65-F5344CB8AC3E}">
-        <p14:creationId xmlns:p14="http://schemas.microsoft.com/office/powerpoint/2010/main" val="2021914904"/>
+        <p14:creationId xmlns:p14="http://schemas.microsoft.com/office/powerpoint/2010/main" val="867088316"/>
       </p:ext>
     </p:extLst>
   </p:cSld>
@@ -19821,7 +19821,7 @@
           <p:cNvPr id="9" name="">
             <a:extLst xmlns:a="http://schemas.openxmlformats.org/drawingml/2006/main">
               <a:ext uri="{FF2B5EF4-FFF2-40B4-BE49-F238E27FC236}">
-                <a16:creationId xmlns:a16="http://schemas.microsoft.com/office/drawing/2014/main" id="{7DE11216-FBDF-4DF9-8DB0-3432E0AEBA8F}"/>
+                <a16:creationId xmlns:a16="http://schemas.microsoft.com/office/drawing/2014/main" id="{A281C31D-F9DF-4CBF-8BC7-5F64E4F4103E}"/>
               </a:ext>
             </a:extLst>
           </p:cNvPr>
@@ -19851,7 +19851,7 @@
           <p:cNvPr id="2" name="">
             <a:extLst xmlns:a="http://schemas.openxmlformats.org/drawingml/2006/main">
               <a:ext uri="{FF2B5EF4-FFF2-40B4-BE49-F238E27FC236}">
-                <a16:creationId xmlns:a16="http://schemas.microsoft.com/office/drawing/2014/main" id="{2986FE55-3BF2-44C2-8CEA-353601E9481B}"/>
+                <a16:creationId xmlns:a16="http://schemas.microsoft.com/office/drawing/2014/main" id="{8145D540-06F8-440C-A193-761B38997B4A}"/>
               </a:ext>
             </a:extLst>
           </p:cNvPr>
@@ -20009,7 +20009,7 @@
           <p:cNvPr id="3" name="">
             <a:extLst xmlns:a="http://schemas.openxmlformats.org/drawingml/2006/main">
               <a:ext uri="{FF2B5EF4-FFF2-40B4-BE49-F238E27FC236}">
-                <a16:creationId xmlns:a16="http://schemas.microsoft.com/office/drawing/2014/main" id="{CAB1A2A6-F4AB-4FC2-9593-E6B971CB52DB}"/>
+                <a16:creationId xmlns:a16="http://schemas.microsoft.com/office/drawing/2014/main" id="{F6F40B37-7B7A-4651-BEC1-3956C19FB131}"/>
               </a:ext>
             </a:extLst>
           </p:cNvPr>
@@ -20167,7 +20167,7 @@
           <p:cNvPr id="4" name="">
             <a:extLst xmlns:a="http://schemas.openxmlformats.org/drawingml/2006/main">
               <a:ext uri="{FF2B5EF4-FFF2-40B4-BE49-F238E27FC236}">
-                <a16:creationId xmlns:a16="http://schemas.microsoft.com/office/drawing/2014/main" id="{F9A84899-08CF-4DC1-B27D-D62D9B179198}"/>
+                <a16:creationId xmlns:a16="http://schemas.microsoft.com/office/drawing/2014/main" id="{7E368321-6D83-42E4-A7E7-755A6F8DF465}"/>
               </a:ext>
             </a:extLst>
           </p:cNvPr>
@@ -20325,7 +20325,7 @@
           <p:cNvPr id="5" name="">
             <a:extLst xmlns:a="http://schemas.openxmlformats.org/drawingml/2006/main">
               <a:ext uri="{FF2B5EF4-FFF2-40B4-BE49-F238E27FC236}">
-                <a16:creationId xmlns:a16="http://schemas.microsoft.com/office/drawing/2014/main" id="{7EED2B27-6B53-449E-8944-4F0FDC3650BC}"/>
+                <a16:creationId xmlns:a16="http://schemas.microsoft.com/office/drawing/2014/main" id="{9D773938-6CD3-4CC2-BC19-5ABC67646DE9}"/>
               </a:ext>
             </a:extLst>
           </p:cNvPr>
@@ -20541,7 +20541,7 @@
           <p:cNvPr id="6" name="">
             <a:extLst xmlns:a="http://schemas.openxmlformats.org/drawingml/2006/main">
               <a:ext uri="{FF2B5EF4-FFF2-40B4-BE49-F238E27FC236}">
-                <a16:creationId xmlns:a16="http://schemas.microsoft.com/office/drawing/2014/main" id="{DF076522-687E-4A9A-8CBC-DDECD02A2852}"/>
+                <a16:creationId xmlns:a16="http://schemas.microsoft.com/office/drawing/2014/main" id="{1041FD32-59BE-4494-9646-7FBE10560535}"/>
               </a:ext>
             </a:extLst>
           </p:cNvPr>
@@ -20699,7 +20699,7 @@
           <p:cNvPr id="7" name="">
             <a:extLst xmlns:a="http://schemas.openxmlformats.org/drawingml/2006/main">
               <a:ext uri="{FF2B5EF4-FFF2-40B4-BE49-F238E27FC236}">
-                <a16:creationId xmlns:a16="http://schemas.microsoft.com/office/drawing/2014/main" id="{CD2B1CD0-36B8-4A69-A9D2-BAE0FE3A135D}"/>
+                <a16:creationId xmlns:a16="http://schemas.microsoft.com/office/drawing/2014/main" id="{B8BB2A3B-77AE-4AA2-91D4-19B704E563FC}"/>
               </a:ext>
             </a:extLst>
           </p:cNvPr>
@@ -20932,7 +20932,7 @@
                 <a:ea typeface="Arial"/>
                 <a:cs typeface="Arial"/>
               </a:rPr>
-              <a:t>Rodrigo Nenato e Raquel: autoria preenchida</a:t>
+              <a:t>Roger Quinelato e Raquel: autoria preenchida</a:t>
             </a:r>
           </a:p>
         </p:txBody>
@@ -20942,7 +20942,7 @@
           <p:cNvPr id="8" name="">
             <a:extLst xmlns:a="http://schemas.openxmlformats.org/drawingml/2006/main">
               <a:ext uri="{FF2B5EF4-FFF2-40B4-BE49-F238E27FC236}">
-                <a16:creationId xmlns:a16="http://schemas.microsoft.com/office/drawing/2014/main" id="{6C93E6A3-61F0-4DF3-9DF8-F7900B288572}"/>
+                <a16:creationId xmlns:a16="http://schemas.microsoft.com/office/drawing/2014/main" id="{D01B77BF-31C0-45F1-8C3C-2FDDB8C2AA3E}"/>
               </a:ext>
             </a:extLst>
           </p:cNvPr>
@@ -21121,7 +21121,7 @@
     </p:spTree>
     <p:extLst>
       <p:ext uri="{BB962C8B-B14F-4D97-AF65-F5344CB8AC3E}">
-        <p14:creationId xmlns:p14="http://schemas.microsoft.com/office/powerpoint/2010/main" val="1612740335"/>
+        <p14:creationId xmlns:p14="http://schemas.microsoft.com/office/powerpoint/2010/main" val="891064582"/>
       </p:ext>
     </p:extLst>
   </p:cSld>
@@ -21152,7 +21152,7 @@
           <p:cNvPr id="10" name="">
             <a:extLst xmlns:a="http://schemas.openxmlformats.org/drawingml/2006/main">
               <a:ext uri="{FF2B5EF4-FFF2-40B4-BE49-F238E27FC236}">
-                <a16:creationId xmlns:a16="http://schemas.microsoft.com/office/drawing/2014/main" id="{E7A77448-D129-4FB0-AFA1-3ADE8F85F7FD}"/>
+                <a16:creationId xmlns:a16="http://schemas.microsoft.com/office/drawing/2014/main" id="{A729199B-0D7C-4073-BE01-5316BD5DB9E8}"/>
               </a:ext>
             </a:extLst>
           </p:cNvPr>
@@ -21182,7 +21182,7 @@
           <p:cNvPr id="2" name="">
             <a:extLst xmlns:a="http://schemas.openxmlformats.org/drawingml/2006/main">
               <a:ext uri="{FF2B5EF4-FFF2-40B4-BE49-F238E27FC236}">
-                <a16:creationId xmlns:a16="http://schemas.microsoft.com/office/drawing/2014/main" id="{C2C3006D-BDF9-47AB-97C0-82B073D8684F}"/>
+                <a16:creationId xmlns:a16="http://schemas.microsoft.com/office/drawing/2014/main" id="{8FF22229-C8DA-4D79-B152-407D4B5823EC}"/>
               </a:ext>
             </a:extLst>
           </p:cNvPr>
@@ -21340,7 +21340,7 @@
           <p:cNvPr id="3" name="">
             <a:extLst xmlns:a="http://schemas.openxmlformats.org/drawingml/2006/main">
               <a:ext uri="{FF2B5EF4-FFF2-40B4-BE49-F238E27FC236}">
-                <a16:creationId xmlns:a16="http://schemas.microsoft.com/office/drawing/2014/main" id="{F089ADCB-2E35-4F99-8F87-FAF89F404FAD}"/>
+                <a16:creationId xmlns:a16="http://schemas.microsoft.com/office/drawing/2014/main" id="{D9756849-E03C-4BF5-9ED1-FF68DF236A01}"/>
               </a:ext>
             </a:extLst>
           </p:cNvPr>
@@ -21498,7 +21498,7 @@
           <p:cNvPr id="4" name="">
             <a:extLst xmlns:a="http://schemas.openxmlformats.org/drawingml/2006/main">
               <a:ext uri="{FF2B5EF4-FFF2-40B4-BE49-F238E27FC236}">
-                <a16:creationId xmlns:a16="http://schemas.microsoft.com/office/drawing/2014/main" id="{DFC71942-2E96-498E-AE7E-56570E586299}"/>
+                <a16:creationId xmlns:a16="http://schemas.microsoft.com/office/drawing/2014/main" id="{AECC6C73-1ABE-482C-8F6F-8F790D6F81E7}"/>
               </a:ext>
             </a:extLst>
           </p:cNvPr>
@@ -21741,7 +21741,7 @@
           <p:cNvPr id="5" name="">
             <a:extLst xmlns:a="http://schemas.openxmlformats.org/drawingml/2006/main">
               <a:ext uri="{FF2B5EF4-FFF2-40B4-BE49-F238E27FC236}">
-                <a16:creationId xmlns:a16="http://schemas.microsoft.com/office/drawing/2014/main" id="{012F5941-4012-4CCA-9219-18F413FDE365}"/>
+                <a16:creationId xmlns:a16="http://schemas.microsoft.com/office/drawing/2014/main" id="{E4AD27AF-29AE-413B-8E63-4879CE4426E2}"/>
               </a:ext>
             </a:extLst>
           </p:cNvPr>
@@ -21906,7 +21906,7 @@
           <p:cNvPr id="6" name="">
             <a:extLst xmlns:a="http://schemas.openxmlformats.org/drawingml/2006/main">
               <a:ext uri="{FF2B5EF4-FFF2-40B4-BE49-F238E27FC236}">
-                <a16:creationId xmlns:a16="http://schemas.microsoft.com/office/drawing/2014/main" id="{0577D115-C128-48F8-AE5A-0CA75881F84F}"/>
+                <a16:creationId xmlns:a16="http://schemas.microsoft.com/office/drawing/2014/main" id="{4F5E2B0E-B3E7-4C6E-B3A3-F5C1F2FF3F08}"/>
               </a:ext>
             </a:extLst>
           </p:cNvPr>
@@ -22071,7 +22071,7 @@
           <p:cNvPr id="7" name="">
             <a:extLst xmlns:a="http://schemas.openxmlformats.org/drawingml/2006/main">
               <a:ext uri="{FF2B5EF4-FFF2-40B4-BE49-F238E27FC236}">
-                <a16:creationId xmlns:a16="http://schemas.microsoft.com/office/drawing/2014/main" id="{84459E7E-8EBE-43BC-909F-79C05DCB9BA9}"/>
+                <a16:creationId xmlns:a16="http://schemas.microsoft.com/office/drawing/2014/main" id="{E416FCEC-C2A3-4B05-BBE5-BE2208A1362A}"/>
               </a:ext>
             </a:extLst>
           </p:cNvPr>
@@ -22236,7 +22236,7 @@
           <p:cNvPr id="8" name="">
             <a:extLst xmlns:a="http://schemas.openxmlformats.org/drawingml/2006/main">
               <a:ext uri="{FF2B5EF4-FFF2-40B4-BE49-F238E27FC236}">
-                <a16:creationId xmlns:a16="http://schemas.microsoft.com/office/drawing/2014/main" id="{69A5CE3A-8EBB-435C-9AF3-BB5F30D2211D}"/>
+                <a16:creationId xmlns:a16="http://schemas.microsoft.com/office/drawing/2014/main" id="{B8CCA3AD-1FB4-45C0-A919-8930A0F30DDE}"/>
               </a:ext>
             </a:extLst>
           </p:cNvPr>
@@ -22401,7 +22401,7 @@
           <p:cNvPr id="9" name="">
             <a:extLst xmlns:a="http://schemas.openxmlformats.org/drawingml/2006/main">
               <a:ext uri="{FF2B5EF4-FFF2-40B4-BE49-F238E27FC236}">
-                <a16:creationId xmlns:a16="http://schemas.microsoft.com/office/drawing/2014/main" id="{620C75AF-6EAD-428F-9C19-5641B0D8F409}"/>
+                <a16:creationId xmlns:a16="http://schemas.microsoft.com/office/drawing/2014/main" id="{7153BF96-D821-4DCF-AAA1-86B5EE2E72BA}"/>
               </a:ext>
             </a:extLst>
           </p:cNvPr>
@@ -22564,7 +22564,7 @@
     </p:spTree>
     <p:extLst>
       <p:ext uri="{BB962C8B-B14F-4D97-AF65-F5344CB8AC3E}">
-        <p14:creationId xmlns:p14="http://schemas.microsoft.com/office/powerpoint/2010/main" val="390930540"/>
+        <p14:creationId xmlns:p14="http://schemas.microsoft.com/office/powerpoint/2010/main" val="2110506220"/>
       </p:ext>
     </p:extLst>
   </p:cSld>
@@ -22595,7 +22595,7 @@
           <p:cNvPr id="7" name="">
             <a:extLst xmlns:a="http://schemas.openxmlformats.org/drawingml/2006/main">
               <a:ext uri="{FF2B5EF4-FFF2-40B4-BE49-F238E27FC236}">
-                <a16:creationId xmlns:a16="http://schemas.microsoft.com/office/drawing/2014/main" id="{8DEAABE5-076A-4681-BEDA-E28AEC5E545E}"/>
+                <a16:creationId xmlns:a16="http://schemas.microsoft.com/office/drawing/2014/main" id="{81CA6177-A006-46AA-833F-32CFA53A57EA}"/>
               </a:ext>
             </a:extLst>
           </p:cNvPr>
@@ -22625,7 +22625,7 @@
           <p:cNvPr id="2" name="">
             <a:extLst xmlns:a="http://schemas.openxmlformats.org/drawingml/2006/main">
               <a:ext uri="{FF2B5EF4-FFF2-40B4-BE49-F238E27FC236}">
-                <a16:creationId xmlns:a16="http://schemas.microsoft.com/office/drawing/2014/main" id="{AACE7BBD-9CA6-458C-A760-A1555EACF54C}"/>
+                <a16:creationId xmlns:a16="http://schemas.microsoft.com/office/drawing/2014/main" id="{1584A404-D6ED-48E3-BE90-F45C36303AEE}"/>
               </a:ext>
             </a:extLst>
           </p:cNvPr>
@@ -22783,7 +22783,7 @@
           <p:cNvPr id="3" name="">
             <a:extLst xmlns:a="http://schemas.openxmlformats.org/drawingml/2006/main">
               <a:ext uri="{FF2B5EF4-FFF2-40B4-BE49-F238E27FC236}">
-                <a16:creationId xmlns:a16="http://schemas.microsoft.com/office/drawing/2014/main" id="{2A1CD59F-B665-4529-B910-D900B185B1E8}"/>
+                <a16:creationId xmlns:a16="http://schemas.microsoft.com/office/drawing/2014/main" id="{D25D91BD-9C20-4987-A3F7-E6FB362DDB80}"/>
               </a:ext>
             </a:extLst>
           </p:cNvPr>
@@ -22941,7 +22941,7 @@
           <p:cNvPr id="4" name="">
             <a:extLst xmlns:a="http://schemas.openxmlformats.org/drawingml/2006/main">
               <a:ext uri="{FF2B5EF4-FFF2-40B4-BE49-F238E27FC236}">
-                <a16:creationId xmlns:a16="http://schemas.microsoft.com/office/drawing/2014/main" id="{A1EFB56E-E2D2-47EE-A108-EFAD88C3039F}"/>
+                <a16:creationId xmlns:a16="http://schemas.microsoft.com/office/drawing/2014/main" id="{D4A54234-01ED-4877-BCF7-82154F223D79}"/>
               </a:ext>
             </a:extLst>
           </p:cNvPr>
@@ -23099,7 +23099,7 @@
           <p:cNvPr id="5" name="">
             <a:extLst xmlns:a="http://schemas.openxmlformats.org/drawingml/2006/main">
               <a:ext uri="{FF2B5EF4-FFF2-40B4-BE49-F238E27FC236}">
-                <a16:creationId xmlns:a16="http://schemas.microsoft.com/office/drawing/2014/main" id="{C63B3DD1-C222-4069-AE4B-8C134F2788E1}"/>
+                <a16:creationId xmlns:a16="http://schemas.microsoft.com/office/drawing/2014/main" id="{3C6EAD13-2D80-48D0-8BED-BE04AEE04B65}"/>
               </a:ext>
             </a:extLst>
           </p:cNvPr>
@@ -23109,7 +23109,7 @@
           <p:nvPr/>
         </p:nvPicPr>
         <p:blipFill>
-          <a:blip xmlns:r="http://schemas.openxmlformats.org/officeDocument/2006/relationships" xmlns:a="http://schemas.openxmlformats.org/drawingml/2006/main" r:embed="R00597fbca7ba4e53"/>
+          <a:blip xmlns:r="http://schemas.openxmlformats.org/officeDocument/2006/relationships" xmlns:a="http://schemas.openxmlformats.org/drawingml/2006/main" r:embed="R5d559bf6cc6a4ef0"/>
           <a:stretch xmlns:a="http://schemas.openxmlformats.org/drawingml/2006/main"/>
         </p:blipFill>
         <p:spPr>
@@ -23127,7 +23127,7 @@
           <p:cNvPr id="6" name="">
             <a:extLst xmlns:a="http://schemas.openxmlformats.org/drawingml/2006/main">
               <a:ext uri="{FF2B5EF4-FFF2-40B4-BE49-F238E27FC236}">
-                <a16:creationId xmlns:a16="http://schemas.microsoft.com/office/drawing/2014/main" id="{CD15E2B0-E84E-45D8-BC0D-E3AF944C04E4}"/>
+                <a16:creationId xmlns:a16="http://schemas.microsoft.com/office/drawing/2014/main" id="{1FFABC91-902C-4359-8DB3-2D2FCDB7E7C8}"/>
               </a:ext>
             </a:extLst>
           </p:cNvPr>
@@ -23283,7 +23283,7 @@
     </p:spTree>
     <p:extLst>
       <p:ext uri="{BB962C8B-B14F-4D97-AF65-F5344CB8AC3E}">
-        <p14:creationId xmlns:p14="http://schemas.microsoft.com/office/powerpoint/2010/main" val="541421640"/>
+        <p14:creationId xmlns:p14="http://schemas.microsoft.com/office/powerpoint/2010/main" val="2085770446"/>
       </p:ext>
     </p:extLst>
   </p:cSld>
@@ -23314,7 +23314,7 @@
           <p:cNvPr id="7" name="">
             <a:extLst xmlns:a="http://schemas.openxmlformats.org/drawingml/2006/main">
               <a:ext uri="{FF2B5EF4-FFF2-40B4-BE49-F238E27FC236}">
-                <a16:creationId xmlns:a16="http://schemas.microsoft.com/office/drawing/2014/main" id="{FF6188FE-2CC5-4A9D-8E92-ADD122FA1F02}"/>
+                <a16:creationId xmlns:a16="http://schemas.microsoft.com/office/drawing/2014/main" id="{72D0320C-A6B9-404F-8BA9-46C98C0AB942}"/>
               </a:ext>
             </a:extLst>
           </p:cNvPr>
@@ -23344,7 +23344,7 @@
           <p:cNvPr id="2" name="">
             <a:extLst xmlns:a="http://schemas.openxmlformats.org/drawingml/2006/main">
               <a:ext uri="{FF2B5EF4-FFF2-40B4-BE49-F238E27FC236}">
-                <a16:creationId xmlns:a16="http://schemas.microsoft.com/office/drawing/2014/main" id="{CA964D7C-4680-44B3-8382-37DC7CF6DE51}"/>
+                <a16:creationId xmlns:a16="http://schemas.microsoft.com/office/drawing/2014/main" id="{8C462DDC-9C83-4269-9B70-492403B6DB03}"/>
               </a:ext>
             </a:extLst>
           </p:cNvPr>
@@ -23502,7 +23502,7 @@
           <p:cNvPr id="3" name="">
             <a:extLst xmlns:a="http://schemas.openxmlformats.org/drawingml/2006/main">
               <a:ext uri="{FF2B5EF4-FFF2-40B4-BE49-F238E27FC236}">
-                <a16:creationId xmlns:a16="http://schemas.microsoft.com/office/drawing/2014/main" id="{B25E8B3F-65E2-46D0-9E26-D6FD8F170AA7}"/>
+                <a16:creationId xmlns:a16="http://schemas.microsoft.com/office/drawing/2014/main" id="{72B20F14-E47C-496B-BFDC-F11B5EEB2D5B}"/>
               </a:ext>
             </a:extLst>
           </p:cNvPr>
@@ -23660,7 +23660,7 @@
           <p:cNvPr id="4" name="">
             <a:extLst xmlns:a="http://schemas.openxmlformats.org/drawingml/2006/main">
               <a:ext uri="{FF2B5EF4-FFF2-40B4-BE49-F238E27FC236}">
-                <a16:creationId xmlns:a16="http://schemas.microsoft.com/office/drawing/2014/main" id="{1211133D-5770-424D-894D-82BF65B5075D}"/>
+                <a16:creationId xmlns:a16="http://schemas.microsoft.com/office/drawing/2014/main" id="{163874C6-71A9-4EF5-9075-49B1C2631A71}"/>
               </a:ext>
             </a:extLst>
           </p:cNvPr>
@@ -23903,7 +23903,7 @@
           <p:cNvPr id="5" name="">
             <a:extLst xmlns:a="http://schemas.openxmlformats.org/drawingml/2006/main">
               <a:ext uri="{FF2B5EF4-FFF2-40B4-BE49-F238E27FC236}">
-                <a16:creationId xmlns:a16="http://schemas.microsoft.com/office/drawing/2014/main" id="{C5DB6BCE-6CDB-4BE2-9666-02BF7129FF56}"/>
+                <a16:creationId xmlns:a16="http://schemas.microsoft.com/office/drawing/2014/main" id="{8B143341-4D39-42B1-951D-4531190DD204}"/>
               </a:ext>
             </a:extLst>
           </p:cNvPr>
@@ -24061,7 +24061,7 @@
           <p:cNvPr id="6" name="">
             <a:extLst xmlns:a="http://schemas.openxmlformats.org/drawingml/2006/main">
               <a:ext uri="{FF2B5EF4-FFF2-40B4-BE49-F238E27FC236}">
-                <a16:creationId xmlns:a16="http://schemas.microsoft.com/office/drawing/2014/main" id="{2D2D2631-3E43-476A-8824-6A12C48D3263}"/>
+                <a16:creationId xmlns:a16="http://schemas.microsoft.com/office/drawing/2014/main" id="{531E5E86-2D21-48AD-B285-A724B860E7B2}"/>
               </a:ext>
             </a:extLst>
           </p:cNvPr>
@@ -24383,7 +24383,7 @@
     </p:spTree>
     <p:extLst>
       <p:ext uri="{BB962C8B-B14F-4D97-AF65-F5344CB8AC3E}">
-        <p14:creationId xmlns:p14="http://schemas.microsoft.com/office/powerpoint/2010/main" val="1373173452"/>
+        <p14:creationId xmlns:p14="http://schemas.microsoft.com/office/powerpoint/2010/main" val="896559721"/>
       </p:ext>
     </p:extLst>
   </p:cSld>
@@ -24414,7 +24414,7 @@
           <p:cNvPr id="7" name="">
             <a:extLst xmlns:a="http://schemas.openxmlformats.org/drawingml/2006/main">
               <a:ext uri="{FF2B5EF4-FFF2-40B4-BE49-F238E27FC236}">
-                <a16:creationId xmlns:a16="http://schemas.microsoft.com/office/drawing/2014/main" id="{B0B7DF4D-F362-41EF-8103-DF4723628F1E}"/>
+                <a16:creationId xmlns:a16="http://schemas.microsoft.com/office/drawing/2014/main" id="{6E5F427D-5927-414D-80C3-76B25A95D7BF}"/>
               </a:ext>
             </a:extLst>
           </p:cNvPr>
@@ -24444,7 +24444,7 @@
           <p:cNvPr id="2" name="">
             <a:extLst xmlns:a="http://schemas.openxmlformats.org/drawingml/2006/main">
               <a:ext uri="{FF2B5EF4-FFF2-40B4-BE49-F238E27FC236}">
-                <a16:creationId xmlns:a16="http://schemas.microsoft.com/office/drawing/2014/main" id="{A995A89A-C901-462B-8156-E0D7BD720F1E}"/>
+                <a16:creationId xmlns:a16="http://schemas.microsoft.com/office/drawing/2014/main" id="{2B6A41D9-2755-47FC-8005-25D4EAA2067D}"/>
               </a:ext>
             </a:extLst>
           </p:cNvPr>
@@ -24602,7 +24602,7 @@
           <p:cNvPr id="3" name="">
             <a:extLst xmlns:a="http://schemas.openxmlformats.org/drawingml/2006/main">
               <a:ext uri="{FF2B5EF4-FFF2-40B4-BE49-F238E27FC236}">
-                <a16:creationId xmlns:a16="http://schemas.microsoft.com/office/drawing/2014/main" id="{083A2076-4661-4804-BB7B-68B2B8F36082}"/>
+                <a16:creationId xmlns:a16="http://schemas.microsoft.com/office/drawing/2014/main" id="{9F2DEE94-107F-4B13-8DEB-8ADA938EDED9}"/>
               </a:ext>
             </a:extLst>
           </p:cNvPr>
@@ -24760,7 +24760,7 @@
           <p:cNvPr id="4" name="">
             <a:extLst xmlns:a="http://schemas.openxmlformats.org/drawingml/2006/main">
               <a:ext uri="{FF2B5EF4-FFF2-40B4-BE49-F238E27FC236}">
-                <a16:creationId xmlns:a16="http://schemas.microsoft.com/office/drawing/2014/main" id="{F482C684-B6F2-4347-A502-AE1EC4DBC2B2}"/>
+                <a16:creationId xmlns:a16="http://schemas.microsoft.com/office/drawing/2014/main" id="{96A8B86E-480C-4FB3-8A69-04EA121512FB}"/>
               </a:ext>
             </a:extLst>
           </p:cNvPr>
@@ -24918,7 +24918,7 @@
           <p:cNvPr id="5" name="">
             <a:extLst xmlns:a="http://schemas.openxmlformats.org/drawingml/2006/main">
               <a:ext uri="{FF2B5EF4-FFF2-40B4-BE49-F238E27FC236}">
-                <a16:creationId xmlns:a16="http://schemas.microsoft.com/office/drawing/2014/main" id="{1777EF93-79CF-41C5-9361-9AFA1B6119B9}"/>
+                <a16:creationId xmlns:a16="http://schemas.microsoft.com/office/drawing/2014/main" id="{75A8626A-1C6C-462C-A021-FA390929457C}"/>
               </a:ext>
             </a:extLst>
           </p:cNvPr>
@@ -25161,7 +25161,7 @@
           <p:cNvPr id="6" name="">
             <a:extLst xmlns:a="http://schemas.openxmlformats.org/drawingml/2006/main">
               <a:ext uri="{FF2B5EF4-FFF2-40B4-BE49-F238E27FC236}">
-                <a16:creationId xmlns:a16="http://schemas.microsoft.com/office/drawing/2014/main" id="{05CBA4DB-2E4A-4C2A-ABCC-94640DCA660C}"/>
+                <a16:creationId xmlns:a16="http://schemas.microsoft.com/office/drawing/2014/main" id="{D27420BE-A591-4776-B9BB-0869875C1696}"/>
               </a:ext>
             </a:extLst>
           </p:cNvPr>
@@ -25317,7 +25317,7 @@
     </p:spTree>
     <p:extLst>
       <p:ext uri="{BB962C8B-B14F-4D97-AF65-F5344CB8AC3E}">
-        <p14:creationId xmlns:p14="http://schemas.microsoft.com/office/powerpoint/2010/main" val="388130509"/>
+        <p14:creationId xmlns:p14="http://schemas.microsoft.com/office/powerpoint/2010/main" val="258086028"/>
       </p:ext>
     </p:extLst>
   </p:cSld>
@@ -25348,7 +25348,7 @@
           <p:cNvPr id="7" name="">
             <a:extLst xmlns:a="http://schemas.openxmlformats.org/drawingml/2006/main">
               <a:ext uri="{FF2B5EF4-FFF2-40B4-BE49-F238E27FC236}">
-                <a16:creationId xmlns:a16="http://schemas.microsoft.com/office/drawing/2014/main" id="{AC94F414-CC72-4E6F-BA5D-C5E0812A9D3A}"/>
+                <a16:creationId xmlns:a16="http://schemas.microsoft.com/office/drawing/2014/main" id="{F906B4C5-3BA7-447D-B518-B1875DF04C4E}"/>
               </a:ext>
             </a:extLst>
           </p:cNvPr>
@@ -25378,7 +25378,7 @@
           <p:cNvPr id="2" name="">
             <a:extLst xmlns:a="http://schemas.openxmlformats.org/drawingml/2006/main">
               <a:ext uri="{FF2B5EF4-FFF2-40B4-BE49-F238E27FC236}">
-                <a16:creationId xmlns:a16="http://schemas.microsoft.com/office/drawing/2014/main" id="{24E620F5-3418-4CB7-A7FA-22D0FE3AB234}"/>
+                <a16:creationId xmlns:a16="http://schemas.microsoft.com/office/drawing/2014/main" id="{D9278438-CD38-40E9-97C4-60A82AB1633E}"/>
               </a:ext>
             </a:extLst>
           </p:cNvPr>
@@ -25536,7 +25536,7 @@
           <p:cNvPr id="3" name="">
             <a:extLst xmlns:a="http://schemas.openxmlformats.org/drawingml/2006/main">
               <a:ext uri="{FF2B5EF4-FFF2-40B4-BE49-F238E27FC236}">
-                <a16:creationId xmlns:a16="http://schemas.microsoft.com/office/drawing/2014/main" id="{B156B0F5-BA73-46B7-AD9D-694CC70BE468}"/>
+                <a16:creationId xmlns:a16="http://schemas.microsoft.com/office/drawing/2014/main" id="{D54ECF8E-004B-45A6-BBA7-97E86262A636}"/>
               </a:ext>
             </a:extLst>
           </p:cNvPr>
@@ -25694,7 +25694,7 @@
           <p:cNvPr id="4" name="">
             <a:extLst xmlns:a="http://schemas.openxmlformats.org/drawingml/2006/main">
               <a:ext uri="{FF2B5EF4-FFF2-40B4-BE49-F238E27FC236}">
-                <a16:creationId xmlns:a16="http://schemas.microsoft.com/office/drawing/2014/main" id="{BFDB6BE7-33C5-406A-8B6B-BD5F1A2C6CB9}"/>
+                <a16:creationId xmlns:a16="http://schemas.microsoft.com/office/drawing/2014/main" id="{9F3924FC-730F-4034-B385-F0B13F7AF0DD}"/>
               </a:ext>
             </a:extLst>
           </p:cNvPr>
@@ -25704,7 +25704,7 @@
           <p:nvPr/>
         </p:nvPicPr>
         <p:blipFill>
-          <a:blip xmlns:r="http://schemas.openxmlformats.org/officeDocument/2006/relationships" xmlns:a="http://schemas.openxmlformats.org/drawingml/2006/main" r:embed="Rfe53bc55bb5c4c46"/>
+          <a:blip xmlns:r="http://schemas.openxmlformats.org/officeDocument/2006/relationships" xmlns:a="http://schemas.openxmlformats.org/drawingml/2006/main" r:embed="Rfc50d45d6e07439c"/>
           <a:stretch xmlns:a="http://schemas.openxmlformats.org/drawingml/2006/main"/>
         </p:blipFill>
         <p:spPr>
@@ -25722,7 +25722,7 @@
           <p:cNvPr id="5" name="">
             <a:extLst xmlns:a="http://schemas.openxmlformats.org/drawingml/2006/main">
               <a:ext uri="{FF2B5EF4-FFF2-40B4-BE49-F238E27FC236}">
-                <a16:creationId xmlns:a16="http://schemas.microsoft.com/office/drawing/2014/main" id="{48A1F0D1-A325-4D0D-937A-8D83ACD47AEA}"/>
+                <a16:creationId xmlns:a16="http://schemas.microsoft.com/office/drawing/2014/main" id="{F151DC41-510B-453B-8D79-38A4708507FD}"/>
               </a:ext>
             </a:extLst>
           </p:cNvPr>
@@ -25965,7 +25965,7 @@
           <p:cNvPr id="6" name="">
             <a:extLst xmlns:a="http://schemas.openxmlformats.org/drawingml/2006/main">
               <a:ext uri="{FF2B5EF4-FFF2-40B4-BE49-F238E27FC236}">
-                <a16:creationId xmlns:a16="http://schemas.microsoft.com/office/drawing/2014/main" id="{A8179A96-3A00-45D9-8361-A2AF901E128A}"/>
+                <a16:creationId xmlns:a16="http://schemas.microsoft.com/office/drawing/2014/main" id="{705AFA24-544B-4EEA-B007-1E860F8A0A79}"/>
               </a:ext>
             </a:extLst>
           </p:cNvPr>
@@ -26121,7 +26121,7 @@
     </p:spTree>
     <p:extLst>
       <p:ext uri="{BB962C8B-B14F-4D97-AF65-F5344CB8AC3E}">
-        <p14:creationId xmlns:p14="http://schemas.microsoft.com/office/powerpoint/2010/main" val="1686717508"/>
+        <p14:creationId xmlns:p14="http://schemas.microsoft.com/office/powerpoint/2010/main" val="1694691005"/>
       </p:ext>
     </p:extLst>
   </p:cSld>
@@ -26152,7 +26152,7 @@
           <p:cNvPr id="19" name="">
             <a:extLst xmlns:a="http://schemas.openxmlformats.org/drawingml/2006/main">
               <a:ext uri="{FF2B5EF4-FFF2-40B4-BE49-F238E27FC236}">
-                <a16:creationId xmlns:a16="http://schemas.microsoft.com/office/drawing/2014/main" id="{C4885B50-95C0-4FCB-BA17-525DC21D7C68}"/>
+                <a16:creationId xmlns:a16="http://schemas.microsoft.com/office/drawing/2014/main" id="{E99A3812-0970-4815-B151-06F8E427FA6B}"/>
               </a:ext>
             </a:extLst>
           </p:cNvPr>
@@ -26182,7 +26182,7 @@
           <p:cNvPr id="2" name="">
             <a:extLst xmlns:a="http://schemas.openxmlformats.org/drawingml/2006/main">
               <a:ext uri="{FF2B5EF4-FFF2-40B4-BE49-F238E27FC236}">
-                <a16:creationId xmlns:a16="http://schemas.microsoft.com/office/drawing/2014/main" id="{00F22B0E-E950-46DF-8102-1FC2F8DA5834}"/>
+                <a16:creationId xmlns:a16="http://schemas.microsoft.com/office/drawing/2014/main" id="{2EC04EDC-23A7-4076-A6B9-385F1B57241B}"/>
               </a:ext>
             </a:extLst>
           </p:cNvPr>
@@ -26340,7 +26340,7 @@
           <p:cNvPr id="3" name="">
             <a:extLst xmlns:a="http://schemas.openxmlformats.org/drawingml/2006/main">
               <a:ext uri="{FF2B5EF4-FFF2-40B4-BE49-F238E27FC236}">
-                <a16:creationId xmlns:a16="http://schemas.microsoft.com/office/drawing/2014/main" id="{F5E37194-EE30-4AE0-8D2B-7D60CBF8C393}"/>
+                <a16:creationId xmlns:a16="http://schemas.microsoft.com/office/drawing/2014/main" id="{A0BD0718-0216-41B6-8C25-EBCBDD163B91}"/>
               </a:ext>
             </a:extLst>
           </p:cNvPr>
@@ -26498,7 +26498,7 @@
           <p:cNvPr id="4" name="">
             <a:extLst xmlns:a="http://schemas.openxmlformats.org/drawingml/2006/main">
               <a:ext uri="{FF2B5EF4-FFF2-40B4-BE49-F238E27FC236}">
-                <a16:creationId xmlns:a16="http://schemas.microsoft.com/office/drawing/2014/main" id="{DC9B3D8D-EEBB-4ED0-B9F2-FE8D3D6F4744}"/>
+                <a16:creationId xmlns:a16="http://schemas.microsoft.com/office/drawing/2014/main" id="{8A53F9B0-D381-46C2-9D21-277656D4C2F5}"/>
               </a:ext>
             </a:extLst>
           </p:cNvPr>
@@ -26663,7 +26663,7 @@
           <p:cNvPr id="5" name="">
             <a:extLst xmlns:a="http://schemas.openxmlformats.org/drawingml/2006/main">
               <a:ext uri="{FF2B5EF4-FFF2-40B4-BE49-F238E27FC236}">
-                <a16:creationId xmlns:a16="http://schemas.microsoft.com/office/drawing/2014/main" id="{66ADE6B7-439A-4355-9DBD-F998B348E452}"/>
+                <a16:creationId xmlns:a16="http://schemas.microsoft.com/office/drawing/2014/main" id="{87A67EA3-88EF-4A0D-8D81-D1E504D9611E}"/>
               </a:ext>
             </a:extLst>
           </p:cNvPr>
@@ -26821,7 +26821,7 @@
           <p:cNvPr id="6" name="">
             <a:extLst xmlns:a="http://schemas.openxmlformats.org/drawingml/2006/main">
               <a:ext uri="{FF2B5EF4-FFF2-40B4-BE49-F238E27FC236}">
-                <a16:creationId xmlns:a16="http://schemas.microsoft.com/office/drawing/2014/main" id="{66624EC8-D2A3-4847-9292-E87BAF92BE91}"/>
+                <a16:creationId xmlns:a16="http://schemas.microsoft.com/office/drawing/2014/main" id="{2B4DCA79-481B-43E3-898E-A257D13DD99F}"/>
               </a:ext>
             </a:extLst>
           </p:cNvPr>
@@ -26979,7 +26979,7 @@
           <p:cNvPr id="7" name="">
             <a:extLst xmlns:a="http://schemas.openxmlformats.org/drawingml/2006/main">
               <a:ext uri="{FF2B5EF4-FFF2-40B4-BE49-F238E27FC236}">
-                <a16:creationId xmlns:a16="http://schemas.microsoft.com/office/drawing/2014/main" id="{EB78C3C1-F54F-403F-98D1-3850F19D430B}"/>
+                <a16:creationId xmlns:a16="http://schemas.microsoft.com/office/drawing/2014/main" id="{6F55CD49-58C2-48FD-9D78-EE2E40D5F267}"/>
               </a:ext>
             </a:extLst>
           </p:cNvPr>
@@ -27144,7 +27144,7 @@
           <p:cNvPr id="8" name="">
             <a:extLst xmlns:a="http://schemas.openxmlformats.org/drawingml/2006/main">
               <a:ext uri="{FF2B5EF4-FFF2-40B4-BE49-F238E27FC236}">
-                <a16:creationId xmlns:a16="http://schemas.microsoft.com/office/drawing/2014/main" id="{EC6F1251-FD0A-4307-8D35-A22A605D7DC1}"/>
+                <a16:creationId xmlns:a16="http://schemas.microsoft.com/office/drawing/2014/main" id="{2097DA58-23C6-483F-954D-2CA5B47FBADB}"/>
               </a:ext>
             </a:extLst>
           </p:cNvPr>
@@ -27302,7 +27302,7 @@
           <p:cNvPr id="9" name="">
             <a:extLst xmlns:a="http://schemas.openxmlformats.org/drawingml/2006/main">
               <a:ext uri="{FF2B5EF4-FFF2-40B4-BE49-F238E27FC236}">
-                <a16:creationId xmlns:a16="http://schemas.microsoft.com/office/drawing/2014/main" id="{F2ADAFE7-178C-45E2-8CDA-0B9CA64B1C61}"/>
+                <a16:creationId xmlns:a16="http://schemas.microsoft.com/office/drawing/2014/main" id="{40E8332B-F9F3-44CB-B9A6-F9C7CA96743C}"/>
               </a:ext>
             </a:extLst>
           </p:cNvPr>
@@ -27460,7 +27460,7 @@
           <p:cNvPr id="10" name="">
             <a:extLst xmlns:a="http://schemas.openxmlformats.org/drawingml/2006/main">
               <a:ext uri="{FF2B5EF4-FFF2-40B4-BE49-F238E27FC236}">
-                <a16:creationId xmlns:a16="http://schemas.microsoft.com/office/drawing/2014/main" id="{0DFF39E4-95DF-4B35-AC3A-EF69E3A8EA05}"/>
+                <a16:creationId xmlns:a16="http://schemas.microsoft.com/office/drawing/2014/main" id="{CD024895-19D0-4815-8296-FBCBD5B51894}"/>
               </a:ext>
             </a:extLst>
           </p:cNvPr>
@@ -27625,7 +27625,7 @@
           <p:cNvPr id="11" name="">
             <a:extLst xmlns:a="http://schemas.openxmlformats.org/drawingml/2006/main">
               <a:ext uri="{FF2B5EF4-FFF2-40B4-BE49-F238E27FC236}">
-                <a16:creationId xmlns:a16="http://schemas.microsoft.com/office/drawing/2014/main" id="{EC89FE72-8553-4E17-8903-83B4B66C9983}"/>
+                <a16:creationId xmlns:a16="http://schemas.microsoft.com/office/drawing/2014/main" id="{AA3D61AD-1854-457B-A734-66DFBA8B170F}"/>
               </a:ext>
             </a:extLst>
           </p:cNvPr>
@@ -27783,7 +27783,7 @@
           <p:cNvPr id="12" name="">
             <a:extLst xmlns:a="http://schemas.openxmlformats.org/drawingml/2006/main">
               <a:ext uri="{FF2B5EF4-FFF2-40B4-BE49-F238E27FC236}">
-                <a16:creationId xmlns:a16="http://schemas.microsoft.com/office/drawing/2014/main" id="{6AE7846F-E65D-40EE-8206-A25D61B69E24}"/>
+                <a16:creationId xmlns:a16="http://schemas.microsoft.com/office/drawing/2014/main" id="{0AB3ABC7-E2E8-4F71-82E3-658391BD63E8}"/>
               </a:ext>
             </a:extLst>
           </p:cNvPr>
@@ -27941,7 +27941,7 @@
           <p:cNvPr id="13" name="">
             <a:extLst xmlns:a="http://schemas.openxmlformats.org/drawingml/2006/main">
               <a:ext uri="{FF2B5EF4-FFF2-40B4-BE49-F238E27FC236}">
-                <a16:creationId xmlns:a16="http://schemas.microsoft.com/office/drawing/2014/main" id="{8AA61C1E-50AB-4F11-A1BB-E1FF313036DE}"/>
+                <a16:creationId xmlns:a16="http://schemas.microsoft.com/office/drawing/2014/main" id="{C72FA73D-C084-48A7-9951-3339A32382E6}"/>
               </a:ext>
             </a:extLst>
           </p:cNvPr>
@@ -28106,7 +28106,7 @@
           <p:cNvPr id="14" name="">
             <a:extLst xmlns:a="http://schemas.openxmlformats.org/drawingml/2006/main">
               <a:ext uri="{FF2B5EF4-FFF2-40B4-BE49-F238E27FC236}">
-                <a16:creationId xmlns:a16="http://schemas.microsoft.com/office/drawing/2014/main" id="{E0BF4BCE-29C8-4F0E-8D42-582496CD2DFC}"/>
+                <a16:creationId xmlns:a16="http://schemas.microsoft.com/office/drawing/2014/main" id="{9AAFABA8-9A78-4768-B270-1370FADB2E2A}"/>
               </a:ext>
             </a:extLst>
           </p:cNvPr>
@@ -28264,7 +28264,7 @@
           <p:cNvPr id="15" name="">
             <a:extLst xmlns:a="http://schemas.openxmlformats.org/drawingml/2006/main">
               <a:ext uri="{FF2B5EF4-FFF2-40B4-BE49-F238E27FC236}">
-                <a16:creationId xmlns:a16="http://schemas.microsoft.com/office/drawing/2014/main" id="{65015C2A-C3F0-44CD-B27D-9D8D530454B3}"/>
+                <a16:creationId xmlns:a16="http://schemas.microsoft.com/office/drawing/2014/main" id="{650FE3BD-87CD-45F4-8032-718369B23AE5}"/>
               </a:ext>
             </a:extLst>
           </p:cNvPr>
@@ -28422,7 +28422,7 @@
           <p:cNvPr id="16" name="">
             <a:extLst xmlns:a="http://schemas.openxmlformats.org/drawingml/2006/main">
               <a:ext uri="{FF2B5EF4-FFF2-40B4-BE49-F238E27FC236}">
-                <a16:creationId xmlns:a16="http://schemas.microsoft.com/office/drawing/2014/main" id="{7F565FB8-33CA-4B1E-ACC3-B18ABC61AC42}"/>
+                <a16:creationId xmlns:a16="http://schemas.microsoft.com/office/drawing/2014/main" id="{8D625F3E-4860-425E-ADEE-16EBD06C4D05}"/>
               </a:ext>
             </a:extLst>
           </p:cNvPr>
@@ -28587,7 +28587,7 @@
           <p:cNvPr id="17" name="">
             <a:extLst xmlns:a="http://schemas.openxmlformats.org/drawingml/2006/main">
               <a:ext uri="{FF2B5EF4-FFF2-40B4-BE49-F238E27FC236}">
-                <a16:creationId xmlns:a16="http://schemas.microsoft.com/office/drawing/2014/main" id="{A0C2DD0B-C9EC-4A46-B5BB-DB5E99280D83}"/>
+                <a16:creationId xmlns:a16="http://schemas.microsoft.com/office/drawing/2014/main" id="{1C7BA545-3E2D-4B91-AAAD-45FFB5A71547}"/>
               </a:ext>
             </a:extLst>
           </p:cNvPr>
@@ -28745,7 +28745,7 @@
           <p:cNvPr id="18" name="">
             <a:extLst xmlns:a="http://schemas.openxmlformats.org/drawingml/2006/main">
               <a:ext uri="{FF2B5EF4-FFF2-40B4-BE49-F238E27FC236}">
-                <a16:creationId xmlns:a16="http://schemas.microsoft.com/office/drawing/2014/main" id="{A8670CE3-6F04-4F26-BA4A-D14EBBB3BA6B}"/>
+                <a16:creationId xmlns:a16="http://schemas.microsoft.com/office/drawing/2014/main" id="{8E2E6204-8F12-48F5-8941-97F82B01186C}"/>
               </a:ext>
             </a:extLst>
           </p:cNvPr>
@@ -28901,7 +28901,7 @@
     </p:spTree>
     <p:extLst>
       <p:ext uri="{BB962C8B-B14F-4D97-AF65-F5344CB8AC3E}">
-        <p14:creationId xmlns:p14="http://schemas.microsoft.com/office/powerpoint/2010/main" val="1690840365"/>
+        <p14:creationId xmlns:p14="http://schemas.microsoft.com/office/powerpoint/2010/main" val="253188042"/>
       </p:ext>
     </p:extLst>
   </p:cSld>
@@ -28932,7 +28932,7 @@
           <p:cNvPr id="16" name="">
             <a:extLst xmlns:a="http://schemas.openxmlformats.org/drawingml/2006/main">
               <a:ext uri="{FF2B5EF4-FFF2-40B4-BE49-F238E27FC236}">
-                <a16:creationId xmlns:a16="http://schemas.microsoft.com/office/drawing/2014/main" id="{D966E575-8626-4609-B303-A89D72BCB057}"/>
+                <a16:creationId xmlns:a16="http://schemas.microsoft.com/office/drawing/2014/main" id="{02BE0C9B-86A4-4F22-8713-A7B9077D0DBA}"/>
               </a:ext>
             </a:extLst>
           </p:cNvPr>
@@ -28962,7 +28962,7 @@
           <p:cNvPr id="2" name="">
             <a:extLst xmlns:a="http://schemas.openxmlformats.org/drawingml/2006/main">
               <a:ext uri="{FF2B5EF4-FFF2-40B4-BE49-F238E27FC236}">
-                <a16:creationId xmlns:a16="http://schemas.microsoft.com/office/drawing/2014/main" id="{99A58F8D-C44B-483D-A6F7-C92F3F143B10}"/>
+                <a16:creationId xmlns:a16="http://schemas.microsoft.com/office/drawing/2014/main" id="{F4396842-A241-4A95-82F6-7080BFBF77B3}"/>
               </a:ext>
             </a:extLst>
           </p:cNvPr>
@@ -29120,7 +29120,7 @@
           <p:cNvPr id="3" name="">
             <a:extLst xmlns:a="http://schemas.openxmlformats.org/drawingml/2006/main">
               <a:ext uri="{FF2B5EF4-FFF2-40B4-BE49-F238E27FC236}">
-                <a16:creationId xmlns:a16="http://schemas.microsoft.com/office/drawing/2014/main" id="{656411FE-7353-4459-9A91-0BB947174BC9}"/>
+                <a16:creationId xmlns:a16="http://schemas.microsoft.com/office/drawing/2014/main" id="{588253B7-6293-4A99-902F-5A60606C9F1C}"/>
               </a:ext>
             </a:extLst>
           </p:cNvPr>
@@ -29278,7 +29278,7 @@
           <p:cNvPr id="4" name="">
             <a:extLst xmlns:a="http://schemas.openxmlformats.org/drawingml/2006/main">
               <a:ext uri="{FF2B5EF4-FFF2-40B4-BE49-F238E27FC236}">
-                <a16:creationId xmlns:a16="http://schemas.microsoft.com/office/drawing/2014/main" id="{C2596B0E-A4A3-4D75-8302-C0A77BA87E7A}"/>
+                <a16:creationId xmlns:a16="http://schemas.microsoft.com/office/drawing/2014/main" id="{623E169B-4D79-469F-AA6E-987639252455}"/>
               </a:ext>
             </a:extLst>
           </p:cNvPr>
@@ -29436,7 +29436,7 @@
           <p:cNvPr id="5" name="">
             <a:extLst xmlns:a="http://schemas.openxmlformats.org/drawingml/2006/main">
               <a:ext uri="{FF2B5EF4-FFF2-40B4-BE49-F238E27FC236}">
-                <a16:creationId xmlns:a16="http://schemas.microsoft.com/office/drawing/2014/main" id="{340E8D48-0C92-4B11-98F9-3728929D3ECB}"/>
+                <a16:creationId xmlns:a16="http://schemas.microsoft.com/office/drawing/2014/main" id="{F18AF2BF-E458-4D9D-B0DF-14FB549328AB}"/>
               </a:ext>
             </a:extLst>
           </p:cNvPr>
@@ -29594,7 +29594,7 @@
           <p:cNvPr id="6" name="">
             <a:extLst xmlns:a="http://schemas.openxmlformats.org/drawingml/2006/main">
               <a:ext uri="{FF2B5EF4-FFF2-40B4-BE49-F238E27FC236}">
-                <a16:creationId xmlns:a16="http://schemas.microsoft.com/office/drawing/2014/main" id="{AE15E547-94FA-4BC4-AC99-5F627C700237}"/>
+                <a16:creationId xmlns:a16="http://schemas.microsoft.com/office/drawing/2014/main" id="{EB83C95D-EC79-4147-B7CB-7609011CD42A}"/>
               </a:ext>
             </a:extLst>
           </p:cNvPr>
@@ -29752,7 +29752,7 @@
           <p:cNvPr id="7" name="">
             <a:extLst xmlns:a="http://schemas.openxmlformats.org/drawingml/2006/main">
               <a:ext uri="{FF2B5EF4-FFF2-40B4-BE49-F238E27FC236}">
-                <a16:creationId xmlns:a16="http://schemas.microsoft.com/office/drawing/2014/main" id="{9B69D5E5-2ECE-4E41-A90B-C3AB4EA5D24D}"/>
+                <a16:creationId xmlns:a16="http://schemas.microsoft.com/office/drawing/2014/main" id="{6613E00B-77D4-4CEC-8BF0-2A3C2372CC66}"/>
               </a:ext>
             </a:extLst>
           </p:cNvPr>
@@ -29910,7 +29910,7 @@
           <p:cNvPr id="8" name="">
             <a:extLst xmlns:a="http://schemas.openxmlformats.org/drawingml/2006/main">
               <a:ext uri="{FF2B5EF4-FFF2-40B4-BE49-F238E27FC236}">
-                <a16:creationId xmlns:a16="http://schemas.microsoft.com/office/drawing/2014/main" id="{67E011F3-A959-4FD0-89CE-BA14406E777E}"/>
+                <a16:creationId xmlns:a16="http://schemas.microsoft.com/office/drawing/2014/main" id="{8D77D24F-7031-4E99-9F91-0050DA026CC0}"/>
               </a:ext>
             </a:extLst>
           </p:cNvPr>
@@ -30068,7 +30068,7 @@
           <p:cNvPr id="9" name="">
             <a:extLst xmlns:a="http://schemas.openxmlformats.org/drawingml/2006/main">
               <a:ext uri="{FF2B5EF4-FFF2-40B4-BE49-F238E27FC236}">
-                <a16:creationId xmlns:a16="http://schemas.microsoft.com/office/drawing/2014/main" id="{606DBB31-35F0-4186-9549-C8CB9795B101}"/>
+                <a16:creationId xmlns:a16="http://schemas.microsoft.com/office/drawing/2014/main" id="{BA6D99B1-EB46-482D-AFE4-CD84FC9C468B}"/>
               </a:ext>
             </a:extLst>
           </p:cNvPr>
@@ -30226,7 +30226,7 @@
           <p:cNvPr id="10" name="">
             <a:extLst xmlns:a="http://schemas.openxmlformats.org/drawingml/2006/main">
               <a:ext uri="{FF2B5EF4-FFF2-40B4-BE49-F238E27FC236}">
-                <a16:creationId xmlns:a16="http://schemas.microsoft.com/office/drawing/2014/main" id="{E17C2F58-DC7A-4272-AF84-F03F57FF9D35}"/>
+                <a16:creationId xmlns:a16="http://schemas.microsoft.com/office/drawing/2014/main" id="{665EF8C1-12EB-4F6C-A839-5D2E4CA4E552}"/>
               </a:ext>
             </a:extLst>
           </p:cNvPr>
@@ -30384,7 +30384,7 @@
           <p:cNvPr id="11" name="">
             <a:extLst xmlns:a="http://schemas.openxmlformats.org/drawingml/2006/main">
               <a:ext uri="{FF2B5EF4-FFF2-40B4-BE49-F238E27FC236}">
-                <a16:creationId xmlns:a16="http://schemas.microsoft.com/office/drawing/2014/main" id="{D4DC1B8C-343B-4890-AF04-9B3C86E3CAC8}"/>
+                <a16:creationId xmlns:a16="http://schemas.microsoft.com/office/drawing/2014/main" id="{3140CD44-B8B9-4AB6-B214-0786B68061CD}"/>
               </a:ext>
             </a:extLst>
           </p:cNvPr>
@@ -30542,7 +30542,7 @@
           <p:cNvPr id="12" name="">
             <a:extLst xmlns:a="http://schemas.openxmlformats.org/drawingml/2006/main">
               <a:ext uri="{FF2B5EF4-FFF2-40B4-BE49-F238E27FC236}">
-                <a16:creationId xmlns:a16="http://schemas.microsoft.com/office/drawing/2014/main" id="{99446A95-983D-40A5-9F17-D6D52C49D07B}"/>
+                <a16:creationId xmlns:a16="http://schemas.microsoft.com/office/drawing/2014/main" id="{0E117F58-37E0-4085-AC9A-56D9568B8356}"/>
               </a:ext>
             </a:extLst>
           </p:cNvPr>
@@ -30700,7 +30700,7 @@
           <p:cNvPr id="13" name="">
             <a:extLst xmlns:a="http://schemas.openxmlformats.org/drawingml/2006/main">
               <a:ext uri="{FF2B5EF4-FFF2-40B4-BE49-F238E27FC236}">
-                <a16:creationId xmlns:a16="http://schemas.microsoft.com/office/drawing/2014/main" id="{1F070B79-2B19-4E38-A315-6EDE4EB2C084}"/>
+                <a16:creationId xmlns:a16="http://schemas.microsoft.com/office/drawing/2014/main" id="{8DB49035-E2CD-404D-98B5-363D6A6BC8A8}"/>
               </a:ext>
             </a:extLst>
           </p:cNvPr>
@@ -30858,7 +30858,7 @@
           <p:cNvPr id="14" name="">
             <a:extLst xmlns:a="http://schemas.openxmlformats.org/drawingml/2006/main">
               <a:ext uri="{FF2B5EF4-FFF2-40B4-BE49-F238E27FC236}">
-                <a16:creationId xmlns:a16="http://schemas.microsoft.com/office/drawing/2014/main" id="{95DED94B-5EEF-4E03-8A6A-C37CBD55EC57}"/>
+                <a16:creationId xmlns:a16="http://schemas.microsoft.com/office/drawing/2014/main" id="{744B909B-FEF9-4756-820E-E78DB10C340E}"/>
               </a:ext>
             </a:extLst>
           </p:cNvPr>
@@ -31016,7 +31016,7 @@
           <p:cNvPr id="15" name="">
             <a:extLst xmlns:a="http://schemas.openxmlformats.org/drawingml/2006/main">
               <a:ext uri="{FF2B5EF4-FFF2-40B4-BE49-F238E27FC236}">
-                <a16:creationId xmlns:a16="http://schemas.microsoft.com/office/drawing/2014/main" id="{E15270A1-40B9-4CF1-989D-3692BAF6EBE7}"/>
+                <a16:creationId xmlns:a16="http://schemas.microsoft.com/office/drawing/2014/main" id="{56CE7D92-C779-486C-9E83-9BD466667256}"/>
               </a:ext>
             </a:extLst>
           </p:cNvPr>
@@ -31172,7 +31172,7 @@
     </p:spTree>
     <p:extLst>
       <p:ext uri="{BB962C8B-B14F-4D97-AF65-F5344CB8AC3E}">
-        <p14:creationId xmlns:p14="http://schemas.microsoft.com/office/powerpoint/2010/main" val="607549768"/>
+        <p14:creationId xmlns:p14="http://schemas.microsoft.com/office/powerpoint/2010/main" val="1369230454"/>
       </p:ext>
     </p:extLst>
   </p:cSld>
@@ -31203,7 +31203,7 @@
           <p:cNvPr id="9" name="">
             <a:extLst xmlns:a="http://schemas.openxmlformats.org/drawingml/2006/main">
               <a:ext uri="{FF2B5EF4-FFF2-40B4-BE49-F238E27FC236}">
-                <a16:creationId xmlns:a16="http://schemas.microsoft.com/office/drawing/2014/main" id="{F1C6E235-D020-41DE-993D-A453B969D22F}"/>
+                <a16:creationId xmlns:a16="http://schemas.microsoft.com/office/drawing/2014/main" id="{2D3F6ADD-F4AB-42A9-BC1D-7628FF00DB1F}"/>
               </a:ext>
             </a:extLst>
           </p:cNvPr>
@@ -31233,7 +31233,7 @@
           <p:cNvPr id="2" name="">
             <a:extLst xmlns:a="http://schemas.openxmlformats.org/drawingml/2006/main">
               <a:ext uri="{FF2B5EF4-FFF2-40B4-BE49-F238E27FC236}">
-                <a16:creationId xmlns:a16="http://schemas.microsoft.com/office/drawing/2014/main" id="{F59D68F6-07B3-48D9-B5E9-072F4836C55B}"/>
+                <a16:creationId xmlns:a16="http://schemas.microsoft.com/office/drawing/2014/main" id="{76D04C20-0358-4811-B453-D63133E84ADD}"/>
               </a:ext>
             </a:extLst>
           </p:cNvPr>
@@ -31391,7 +31391,7 @@
           <p:cNvPr id="3" name="">
             <a:extLst xmlns:a="http://schemas.openxmlformats.org/drawingml/2006/main">
               <a:ext uri="{FF2B5EF4-FFF2-40B4-BE49-F238E27FC236}">
-                <a16:creationId xmlns:a16="http://schemas.microsoft.com/office/drawing/2014/main" id="{ABB4DB3F-0D2F-45FC-A2ED-7967263420E6}"/>
+                <a16:creationId xmlns:a16="http://schemas.microsoft.com/office/drawing/2014/main" id="{F52C1492-7596-4C04-9976-6DBDFCAE3FC0}"/>
               </a:ext>
             </a:extLst>
           </p:cNvPr>
@@ -31549,7 +31549,7 @@
           <p:cNvPr id="4" name="">
             <a:extLst xmlns:a="http://schemas.openxmlformats.org/drawingml/2006/main">
               <a:ext uri="{FF2B5EF4-FFF2-40B4-BE49-F238E27FC236}">
-                <a16:creationId xmlns:a16="http://schemas.microsoft.com/office/drawing/2014/main" id="{4B5EB6A3-CB77-4E10-B392-C04F01DE86E5}"/>
+                <a16:creationId xmlns:a16="http://schemas.microsoft.com/office/drawing/2014/main" id="{BA45F0E4-EF2D-4577-BB4C-38F4D0FD7AAE}"/>
               </a:ext>
             </a:extLst>
           </p:cNvPr>
@@ -31819,7 +31819,7 @@
           <p:cNvPr id="5" name="">
             <a:extLst xmlns:a="http://schemas.openxmlformats.org/drawingml/2006/main">
               <a:ext uri="{FF2B5EF4-FFF2-40B4-BE49-F238E27FC236}">
-                <a16:creationId xmlns:a16="http://schemas.microsoft.com/office/drawing/2014/main" id="{2ADC9111-5CF1-4EF1-A911-96E22B327F03}"/>
+                <a16:creationId xmlns:a16="http://schemas.microsoft.com/office/drawing/2014/main" id="{971BA5F0-80B6-42AF-B889-E6E234906203}"/>
               </a:ext>
             </a:extLst>
           </p:cNvPr>
@@ -32007,7 +32007,7 @@
           <p:cNvPr id="6" name="">
             <a:extLst xmlns:a="http://schemas.openxmlformats.org/drawingml/2006/main">
               <a:ext uri="{FF2B5EF4-FFF2-40B4-BE49-F238E27FC236}">
-                <a16:creationId xmlns:a16="http://schemas.microsoft.com/office/drawing/2014/main" id="{BF6AA0F7-2B29-4E1C-8510-B78E0CB8DAFE}"/>
+                <a16:creationId xmlns:a16="http://schemas.microsoft.com/office/drawing/2014/main" id="{9BC3E2B3-8192-4F15-A9FF-1CB9DBB14BEC}"/>
               </a:ext>
             </a:extLst>
           </p:cNvPr>
@@ -32195,7 +32195,7 @@
           <p:cNvPr id="7" name="">
             <a:extLst xmlns:a="http://schemas.openxmlformats.org/drawingml/2006/main">
               <a:ext uri="{FF2B5EF4-FFF2-40B4-BE49-F238E27FC236}">
-                <a16:creationId xmlns:a16="http://schemas.microsoft.com/office/drawing/2014/main" id="{346E31AD-DBC5-49FD-A33F-D9D5D2B94AFB}"/>
+                <a16:creationId xmlns:a16="http://schemas.microsoft.com/office/drawing/2014/main" id="{735D7432-D8C2-44EC-B6EE-C9D8FF282C8B}"/>
               </a:ext>
             </a:extLst>
           </p:cNvPr>
@@ -32383,7 +32383,7 @@
           <p:cNvPr id="8" name="">
             <a:extLst xmlns:a="http://schemas.openxmlformats.org/drawingml/2006/main">
               <a:ext uri="{FF2B5EF4-FFF2-40B4-BE49-F238E27FC236}">
-                <a16:creationId xmlns:a16="http://schemas.microsoft.com/office/drawing/2014/main" id="{91CA0FFD-D1D8-49D1-8FD1-426C0BA0C393}"/>
+                <a16:creationId xmlns:a16="http://schemas.microsoft.com/office/drawing/2014/main" id="{6A557B02-747B-4504-9677-66620B8CDC27}"/>
               </a:ext>
             </a:extLst>
           </p:cNvPr>
@@ -32539,7 +32539,7 @@
     </p:spTree>
     <p:extLst>
       <p:ext uri="{BB962C8B-B14F-4D97-AF65-F5344CB8AC3E}">
-        <p14:creationId xmlns:p14="http://schemas.microsoft.com/office/powerpoint/2010/main" val="1742231885"/>
+        <p14:creationId xmlns:p14="http://schemas.microsoft.com/office/powerpoint/2010/main" val="169823913"/>
       </p:ext>
     </p:extLst>
   </p:cSld>

</xml_diff>

<commit_message>
Corrige recuperação do F3, estados de fechamento e autoria da entrega (#78)
* fix: recupera F3 e alinha estados de fechamento e autoria

* docs: corrige autoria para Roger Quinelato
</commit_message>
<xml_diff>
--- a/output/Apresentacao_Cenario_4.pptx
+++ b/output/Apresentacao_Cenario_4.pptx
@@ -2,30 +2,30 @@
 <file path=ppt/presentation.xml><?xml version="1.0" encoding="utf-8"?>
 <p:presentation xmlns:p="http://schemas.openxmlformats.org/presentationml/2006/main">
   <p:sldMasterIdLst>
-    <p:sldMasterId xmlns:r="http://schemas.openxmlformats.org/officeDocument/2006/relationships" id="2147483648" r:id="Rcffed83e686440b7"/>
+    <p:sldMasterId xmlns:r="http://schemas.openxmlformats.org/officeDocument/2006/relationships" id="2147483648" r:id="Rae7307d456dd468c"/>
   </p:sldMasterIdLst>
   <p:notesMasterIdLst>
-    <p:notesMasterId xmlns:r="http://schemas.openxmlformats.org/officeDocument/2006/relationships" r:id="Rec5116ca5b6d4406"/>
+    <p:notesMasterId xmlns:r="http://schemas.openxmlformats.org/officeDocument/2006/relationships" r:id="Rf449ba9f92d94996"/>
   </p:notesMasterIdLst>
   <p:sldIdLst>
-    <p:sldId xmlns:r="http://schemas.openxmlformats.org/officeDocument/2006/relationships" id="256" r:id="R70f2fb8122a143e3"/>
-    <p:sldId xmlns:r="http://schemas.openxmlformats.org/officeDocument/2006/relationships" id="257" r:id="R2b8105c23204438c"/>
-    <p:sldId xmlns:r="http://schemas.openxmlformats.org/officeDocument/2006/relationships" id="258" r:id="R7363dd76906e44b6"/>
-    <p:sldId xmlns:r="http://schemas.openxmlformats.org/officeDocument/2006/relationships" id="259" r:id="R3bbe767dbc964fbe"/>
-    <p:sldId xmlns:r="http://schemas.openxmlformats.org/officeDocument/2006/relationships" id="260" r:id="R76d7ecbf96f64751"/>
-    <p:sldId xmlns:r="http://schemas.openxmlformats.org/officeDocument/2006/relationships" id="261" r:id="Ra64731bf21ca4775"/>
-    <p:sldId xmlns:r="http://schemas.openxmlformats.org/officeDocument/2006/relationships" id="262" r:id="Rfd4991d09e5c4c83"/>
-    <p:sldId xmlns:r="http://schemas.openxmlformats.org/officeDocument/2006/relationships" id="263" r:id="R2f1bbfb9e5794c92"/>
-    <p:sldId xmlns:r="http://schemas.openxmlformats.org/officeDocument/2006/relationships" id="264" r:id="R25282741b1fc49b8"/>
-    <p:sldId xmlns:r="http://schemas.openxmlformats.org/officeDocument/2006/relationships" id="265" r:id="Rb581c503e40f4d0c"/>
-    <p:sldId xmlns:r="http://schemas.openxmlformats.org/officeDocument/2006/relationships" id="266" r:id="R22f5705bcf55436d"/>
-    <p:sldId xmlns:r="http://schemas.openxmlformats.org/officeDocument/2006/relationships" id="267" r:id="Rd38aa7207c77460a"/>
-    <p:sldId xmlns:r="http://schemas.openxmlformats.org/officeDocument/2006/relationships" id="268" r:id="Rf558f02d4c144158"/>
-    <p:sldId xmlns:r="http://schemas.openxmlformats.org/officeDocument/2006/relationships" id="269" r:id="R7c93be25e1bb42db"/>
-    <p:sldId xmlns:r="http://schemas.openxmlformats.org/officeDocument/2006/relationships" id="270" r:id="Rcc4ed3db59194c39"/>
-    <p:sldId xmlns:r="http://schemas.openxmlformats.org/officeDocument/2006/relationships" id="271" r:id="R8d1bd44f480847ed"/>
-    <p:sldId xmlns:r="http://schemas.openxmlformats.org/officeDocument/2006/relationships" id="272" r:id="R65a23ba236764be3"/>
-    <p:sldId xmlns:r="http://schemas.openxmlformats.org/officeDocument/2006/relationships" id="273" r:id="Ra5737860e902456d"/>
+    <p:sldId xmlns:r="http://schemas.openxmlformats.org/officeDocument/2006/relationships" id="256" r:id="R4ab5ae0954e14746"/>
+    <p:sldId xmlns:r="http://schemas.openxmlformats.org/officeDocument/2006/relationships" id="257" r:id="R35e9d005f8784510"/>
+    <p:sldId xmlns:r="http://schemas.openxmlformats.org/officeDocument/2006/relationships" id="258" r:id="R501776224dd343de"/>
+    <p:sldId xmlns:r="http://schemas.openxmlformats.org/officeDocument/2006/relationships" id="259" r:id="R1fc09c484ade4540"/>
+    <p:sldId xmlns:r="http://schemas.openxmlformats.org/officeDocument/2006/relationships" id="260" r:id="R9047bfc93c8d4a96"/>
+    <p:sldId xmlns:r="http://schemas.openxmlformats.org/officeDocument/2006/relationships" id="261" r:id="R4cb5ec138c054304"/>
+    <p:sldId xmlns:r="http://schemas.openxmlformats.org/officeDocument/2006/relationships" id="262" r:id="Ra5328b6e023b4101"/>
+    <p:sldId xmlns:r="http://schemas.openxmlformats.org/officeDocument/2006/relationships" id="263" r:id="Rebdf725b57bf42d3"/>
+    <p:sldId xmlns:r="http://schemas.openxmlformats.org/officeDocument/2006/relationships" id="264" r:id="Rc4f3c41e504c4b83"/>
+    <p:sldId xmlns:r="http://schemas.openxmlformats.org/officeDocument/2006/relationships" id="265" r:id="R4c168aa1c6664e92"/>
+    <p:sldId xmlns:r="http://schemas.openxmlformats.org/officeDocument/2006/relationships" id="266" r:id="R0cfd92ed67be4b5e"/>
+    <p:sldId xmlns:r="http://schemas.openxmlformats.org/officeDocument/2006/relationships" id="267" r:id="Rc42f8239c0ab474f"/>
+    <p:sldId xmlns:r="http://schemas.openxmlformats.org/officeDocument/2006/relationships" id="268" r:id="R639d58921a40473f"/>
+    <p:sldId xmlns:r="http://schemas.openxmlformats.org/officeDocument/2006/relationships" id="269" r:id="Raafa89758f3648b2"/>
+    <p:sldId xmlns:r="http://schemas.openxmlformats.org/officeDocument/2006/relationships" id="270" r:id="Rf22a3c7131e5425e"/>
+    <p:sldId xmlns:r="http://schemas.openxmlformats.org/officeDocument/2006/relationships" id="271" r:id="R5a489f66a40a4306"/>
+    <p:sldId xmlns:r="http://schemas.openxmlformats.org/officeDocument/2006/relationships" id="272" r:id="R208bdb58be6d472e"/>
+    <p:sldId xmlns:r="http://schemas.openxmlformats.org/officeDocument/2006/relationships" id="273" r:id="Ra694979cc49d421c"/>
   </p:sldIdLst>
   <p:sldSz cx="12192000" cy="6858000"/>
   <p:notesSz cx="6858000" cy="9144000"/>
@@ -459,7 +459,7 @@
           <a:lstStyle xmlns:a="http://schemas.openxmlformats.org/drawingml/2006/main"/>
           <a:p xmlns:a="http://schemas.openxmlformats.org/drawingml/2006/main">
             <a:r>
-              <a:t>Fonte principal: Guia.pdf, enunciado acadêmico ArchCorp, 2026, 13 páginas. Cenário 4 aplicado a uma locadora fictícia inspirada na Localiza, com dados sintéticos. Referência técnica: main f1669d78f01e2d279b3de60a999ed778e6c9916e, PR #75 de 25/10/2026, https://github.com/Roger-Quinelato/projetoAplicado7/pull/75, commit consultado localmente. Marcos previstos conforme orientação da entrega. Autoria e contribuições aguardam informação da equipe. Não há declaração de aceite docente.</a:t>
+              <a:t>Fonte principal: Guia.pdf, enunciado acadêmico ArchCorp, 2026, 13 páginas. Cenário 4 aplicado a uma locadora fictícia inspirada na Localiza, com dados sintéticos. Referência técnica: main f1669d78f01e2d279b3de60a999ed778e6c9916e, PR #75 de 25/10/2026, https://github.com/Roger-Quinelato/projetoAplicado7/pull/75, commit consultado localmente. Marcos previstos conforme orientação da entrega. Autoria: Roger Quinelato — backend, produto e negócio; Raquel — frontend e levantamento de requisitos. Não há declaração de aceite docente.</a:t>
             </a:r>
           </a:p>
         </p:txBody>
@@ -669,7 +669,7 @@
           <a:lstStyle xmlns:a="http://schemas.openxmlformats.org/drawingml/2006/main"/>
           <a:p xmlns:a="http://schemas.openxmlformats.org/drawingml/2006/main">
             <a:r>
-              <a:t>Fonte: docs/INTEGRACOES.md, scripts/demo_f3.py e evidência histórica consolidada em docs/EVIDENCIAS_VALIDACAO.md (20/10/2026). Revisão de código e reprodução informadas pela equipe em 28/10: se TicketOpened falha e TicketResolved é consumido antes da recuperação, handle_ticket_resolved retorna sem processo; a abertura reprocessada depois cria STARTED embora o chamado esteja RESOLVED, sem pendências restantes que assegurem a convergência (src/archcorp/workflow/service.py, handle_ticket_resolved). Defeito não corrigido nesta revisão documental. A reconciliação de elegibilidade depende de ação explícita, sem agendador. Os resultados históricos não comprovam todos os casos de ordenação de eventos.</a:t>
+              <a:t>F3: quando o processo ainda não existe, resolução e reconciliação levantam uma falha recuperável. O dispatcher não confirma a inbox e mantém a tentativa disponível; se atingir FAILED, reprocessar explicitamente após recuperar a abertura. Regressões em tests/test_regressoes_fechamento.py cobrem falha temporária, limite de tentativas e reprocessamento, sem duplicação. A resolução preserva estados finais e usa o agregado das tarefas. Não há agendador: o despacho é explícito.</a:t>
             </a:r>
           </a:p>
         </p:txBody>
@@ -1019,7 +1019,7 @@
           <a:lstStyle xmlns:a="http://schemas.openxmlformats.org/drawingml/2006/main"/>
           <a:p xmlns:a="http://schemas.openxmlformats.org/drawingml/2006/main">
             <a:r>
-              <a:t>Fontes: docs/EVIDENCIAS_VALIDACAO.md, seções históricas de 20/10/2026; registro local do commit f1669d78f01e2d279b3de60a999ed778e6c9916e, PR #75, 25/10/2026, https://github.com/Roger-Quinelato/projetoAplicado7/pull/75; logs da CI Verify 40199072801, https://github.com/Roger-Quinelato/projetoAplicado7/actions/runs/40199072801, executada em 25/10 sobre essa main, consultados no GitHub Actions em 28/10/2026. Quatro jobs success: application 252 passed/14 skipped; postgresql 262 passed/4 skipped; rabbitmq 22 passed; e2e 25 passed e axe separado 1 passed. Suítes sobrepostas, sem total agregado. Histórico de 20/10: PostgreSQL 16/RabbitMQ 3.12 locais, contêiner Linux, Python 3.13, 60 clientes, 100 amostras por consulta em 10 consultas de negócio, p95 máximo de 45,1 ms, 22 roteiros de navegador, F1 20/20, F2 14/14 e F3 15/15. O p95 não foi medido novamente na main f1669d7. Verificação local de 28/10: Python 252 aprovados e 14 ignorados, frontend 19 aprovados, TypeScript e OpenAPI check aprovados. Hospedagem pública e PostgreSQL gerenciado sem comprovação.</a:t>
+              <a:t>Fontes: docs/EVIDENCIAS_VALIDACAO.md, seções históricas de 20/10/2026; registro local do commit f1669d78f01e2d279b3de60a999ed778e6c9916e, PR #75, 25/10/2026, https://github.com/Roger-Quinelato/projetoAplicado7/pull/75; logs da CI Verify 40199072801, https://github.com/Roger-Quinelato/projetoAplicado7/actions/runs/40199072801, executada em 25/10 sobre essa main, consultados no GitHub Actions em 28/10/2026. Quatro jobs success: application 252 passed/14 skipped; postgresql 262 passed/4 skipped; rabbitmq 22 passed; e2e 25 passed e axe separado 1 passed. Suítes sobrepostas, sem total agregado. Histórico de 20/10: PostgreSQL 16/RabbitMQ 3.12 locais, contêiner Linux, Python 3.13, 60 clientes, 100 amostras por consulta em 10 consultas de negócio, p95 máximo de 45,1 ms, 22 roteiros de navegador, F1 20/20, F2 14/14 e F3 15/15. O p95 não foi medido novamente na main f1669d7. Verificação local após correções em 28/10: Python 264 aprovados e 14 ignorados, frontend 19 aprovados, TypeScript e OpenAPI check aprovados. Hospedagem pública e PostgreSQL gerenciado sem comprovação.</a:t>
             </a:r>
           </a:p>
         </p:txBody>
@@ -1089,7 +1089,7 @@
           <a:lstStyle xmlns:a="http://schemas.openxmlformats.org/drawingml/2006/main"/>
           <a:p xmlns:a="http://schemas.openxmlformats.org/drawingml/2006/main">
             <a:r>
-              <a:t>Fontes: relatório técnico, seções 3.1, 3.4, 4.10 e 5, docs/EVOLUCAO_MANUTENCAO.md e ADR-006 (Proposto). Revisão e reproduções informadas em 28/10/2026: F3 perde a convergência se TicketResolved é consumido antes de recuperar TicketOpened; encerramento de contrato pode deixar processo COMPLETED com tarefa CANCELLED; leitura financeira calcula OVERDUE enquanto o comando de cancelamento usa OPEN persistido. Conferência: src/archcorp/workflow/service.py (handle_ticket_resolved e handle_contract_closed), src/archcorp/finance/service.py (cancel) e domain.py. Defeitos conhecidos não corrigidos nesta revisão documental. Verificação local de 28/10 informada: Python 252 aprovados/14 ignorados, frontend 19 aprovados, TypeScript e OpenAPI check aprovados. Não somar suítes. Marcos previstos conforme orientação da entrega. Nomes e contribuições individuais necessários para a submissão. Premissas e ADR-006 aguardam validação ou aceite. Publicação, OIDC e agendador são evolução. O merge do PR #75 não equivale a aceite docente nem à validação das premissas.</a:t>
+              <a:t>Correções de fechamento: F3 não confirma resolução/reconciliação sem processo; eventos mantêm retentativa e reprocessamento explícito. Encerramento do contrato cancela tarefas pendentes e deriva o estado agregado, preservando tarefas finais. Cancelamento financeiro usa a data UTC e o estado efetivo da consulta; vencida recebe 409. As correções não alteram registros antigos já consumidos. Autoria declarada: Roger Quinelato — backend, produto e negócio; Raquel — frontend e levantamento de requisitos. Permanecem ensaio, aceite docente e comprovação da hospedagem prevista no plano. OIDC, tracing distribuído e consumo pelo broker são evoluções.</a:t>
             </a:r>
           </a:p>
         </p:txBody>
@@ -1696,7 +1696,7 @@
           <p:cNvPr id="3" name="Title">
             <a:extLst xmlns:a="http://schemas.openxmlformats.org/drawingml/2006/main">
               <a:ext uri="{FF2B5EF4-FFF2-40B4-BE49-F238E27FC236}">
-                <a16:creationId xmlns:a16="http://schemas.microsoft.com/office/drawing/2014/main" id="{52F22302-607E-4512-BF2F-35012247082E}"/>
+                <a16:creationId xmlns:a16="http://schemas.microsoft.com/office/drawing/2014/main" id="{CEE593D6-F72B-43BE-9AC4-77BEFBAB9C63}"/>
               </a:ext>
             </a:extLst>
           </p:cNvPr>
@@ -1925,7 +1925,7 @@
           <p:cNvPr id="2" name="Subtitle">
             <a:extLst xmlns:a="http://schemas.openxmlformats.org/drawingml/2006/main">
               <a:ext uri="{FF2B5EF4-FFF2-40B4-BE49-F238E27FC236}">
-                <a16:creationId xmlns:a16="http://schemas.microsoft.com/office/drawing/2014/main" id="{E14BB22B-78CA-4208-9251-2A613260C8CF}"/>
+                <a16:creationId xmlns:a16="http://schemas.microsoft.com/office/drawing/2014/main" id="{3724803F-9AAA-44BE-990D-F488C48E5230}"/>
               </a:ext>
             </a:extLst>
           </p:cNvPr>
@@ -2171,7 +2171,7 @@
           <p:cNvPr id="2" name="Section title">
             <a:extLst xmlns:a="http://schemas.openxmlformats.org/drawingml/2006/main">
               <a:ext uri="{FF2B5EF4-FFF2-40B4-BE49-F238E27FC236}">
-                <a16:creationId xmlns:a16="http://schemas.microsoft.com/office/drawing/2014/main" id="{3CF94330-2524-4EBB-AEF8-E29845BE2AF3}"/>
+                <a16:creationId xmlns:a16="http://schemas.microsoft.com/office/drawing/2014/main" id="{C012BA3A-20E3-4570-BCE9-EADBED3A76C3}"/>
               </a:ext>
             </a:extLst>
           </p:cNvPr>
@@ -2417,7 +2417,7 @@
           <p:cNvPr id="3" name="Title">
             <a:extLst xmlns:a="http://schemas.openxmlformats.org/drawingml/2006/main">
               <a:ext uri="{FF2B5EF4-FFF2-40B4-BE49-F238E27FC236}">
-                <a16:creationId xmlns:a16="http://schemas.microsoft.com/office/drawing/2014/main" id="{721AE563-DBC9-42F5-B80D-C607DCB7F038}"/>
+                <a16:creationId xmlns:a16="http://schemas.microsoft.com/office/drawing/2014/main" id="{7033B1B7-8AA5-481A-950F-F755C50D4F9F}"/>
               </a:ext>
             </a:extLst>
           </p:cNvPr>
@@ -2646,7 +2646,7 @@
           <p:cNvPr id="2" name="Body">
             <a:extLst xmlns:a="http://schemas.openxmlformats.org/drawingml/2006/main">
               <a:ext uri="{FF2B5EF4-FFF2-40B4-BE49-F238E27FC236}">
-                <a16:creationId xmlns:a16="http://schemas.microsoft.com/office/drawing/2014/main" id="{BA95F0B2-2A24-40EB-9361-5E15DDDF2149}"/>
+                <a16:creationId xmlns:a16="http://schemas.microsoft.com/office/drawing/2014/main" id="{AAF78521-657A-422A-B4FE-C5FFF8F32695}"/>
               </a:ext>
             </a:extLst>
           </p:cNvPr>
@@ -2892,7 +2892,7 @@
           <p:cNvPr id="4" name="Title">
             <a:extLst xmlns:a="http://schemas.openxmlformats.org/drawingml/2006/main">
               <a:ext uri="{FF2B5EF4-FFF2-40B4-BE49-F238E27FC236}">
-                <a16:creationId xmlns:a16="http://schemas.microsoft.com/office/drawing/2014/main" id="{78E8EB24-8293-4430-875A-5C7748B62647}"/>
+                <a16:creationId xmlns:a16="http://schemas.microsoft.com/office/drawing/2014/main" id="{A7BC370B-34D0-451D-AE94-5E81F0ED2455}"/>
               </a:ext>
             </a:extLst>
           </p:cNvPr>
@@ -3121,7 +3121,7 @@
           <p:cNvPr id="2" name="Left column">
             <a:extLst xmlns:a="http://schemas.openxmlformats.org/drawingml/2006/main">
               <a:ext uri="{FF2B5EF4-FFF2-40B4-BE49-F238E27FC236}">
-                <a16:creationId xmlns:a16="http://schemas.microsoft.com/office/drawing/2014/main" id="{919CB7B3-A0DB-46DC-B133-293C706F676F}"/>
+                <a16:creationId xmlns:a16="http://schemas.microsoft.com/office/drawing/2014/main" id="{4E7BA3BD-838A-4DE0-87C0-F04DAD564D1B}"/>
               </a:ext>
             </a:extLst>
           </p:cNvPr>
@@ -3350,7 +3350,7 @@
           <p:cNvPr id="3" name="Right column">
             <a:extLst xmlns:a="http://schemas.openxmlformats.org/drawingml/2006/main">
               <a:ext uri="{FF2B5EF4-FFF2-40B4-BE49-F238E27FC236}">
-                <a16:creationId xmlns:a16="http://schemas.microsoft.com/office/drawing/2014/main" id="{DA6BEEC1-7019-4639-8343-154E984ED655}"/>
+                <a16:creationId xmlns:a16="http://schemas.microsoft.com/office/drawing/2014/main" id="{F85DE391-5210-4C50-BC51-8E74EF8A2E7B}"/>
               </a:ext>
             </a:extLst>
           </p:cNvPr>
@@ -3596,7 +3596,7 @@
           <p:cNvPr id="3" name="Title">
             <a:extLst xmlns:a="http://schemas.openxmlformats.org/drawingml/2006/main">
               <a:ext uri="{FF2B5EF4-FFF2-40B4-BE49-F238E27FC236}">
-                <a16:creationId xmlns:a16="http://schemas.microsoft.com/office/drawing/2014/main" id="{86A42B9C-010B-43A0-B4B9-1357D249C352}"/>
+                <a16:creationId xmlns:a16="http://schemas.microsoft.com/office/drawing/2014/main" id="{AE762BA5-AF84-400C-BB56-1F66DBD205DC}"/>
               </a:ext>
             </a:extLst>
           </p:cNvPr>
@@ -3825,7 +3825,7 @@
           <p:cNvPr id="2" name="Left column">
             <a:extLst xmlns:a="http://schemas.openxmlformats.org/drawingml/2006/main">
               <a:ext uri="{FF2B5EF4-FFF2-40B4-BE49-F238E27FC236}">
-                <a16:creationId xmlns:a16="http://schemas.microsoft.com/office/drawing/2014/main" id="{8C42A9B8-8B44-4C2D-BC31-948054B892B0}"/>
+                <a16:creationId xmlns:a16="http://schemas.microsoft.com/office/drawing/2014/main" id="{EFD41CB0-1A43-40DB-89C3-7BF57DC7C842}"/>
               </a:ext>
             </a:extLst>
           </p:cNvPr>
@@ -4092,12 +4092,12 @@
   </p:cSld>
   <p:clrMap bg1="lt1" tx1="dk1" bg2="lt2" tx2="dk2" accent1="accent1" accent2="accent2" accent3="accent3" accent4="accent4" accent5="accent5" accent6="accent6" hlink="hlink" folHlink="folHlink"/>
   <p:sldLayoutIdLst>
-    <p:sldLayoutId xmlns:r="http://schemas.openxmlformats.org/officeDocument/2006/relationships" id="2147483649" r:id="Rb41eaf8d157d4840"/>
-    <p:sldLayoutId xmlns:r="http://schemas.openxmlformats.org/officeDocument/2006/relationships" id="2147483650" r:id="Raa6cf94ebf6942d2"/>
-    <p:sldLayoutId xmlns:r="http://schemas.openxmlformats.org/officeDocument/2006/relationships" id="2147483651" r:id="R8dbe8aacf4104f9c"/>
-    <p:sldLayoutId xmlns:r="http://schemas.openxmlformats.org/officeDocument/2006/relationships" id="2147483652" r:id="R3743a4b4ce024896"/>
-    <p:sldLayoutId xmlns:r="http://schemas.openxmlformats.org/officeDocument/2006/relationships" id="2147483653" r:id="R0da1412da5ec4cf7"/>
-    <p:sldLayoutId xmlns:r="http://schemas.openxmlformats.org/officeDocument/2006/relationships" id="2147483654" r:id="R2655f55d261a4ac3"/>
+    <p:sldLayoutId xmlns:r="http://schemas.openxmlformats.org/officeDocument/2006/relationships" id="2147483649" r:id="Rcf4242fc289b4761"/>
+    <p:sldLayoutId xmlns:r="http://schemas.openxmlformats.org/officeDocument/2006/relationships" id="2147483650" r:id="R37ad38a59baa40d6"/>
+    <p:sldLayoutId xmlns:r="http://schemas.openxmlformats.org/officeDocument/2006/relationships" id="2147483651" r:id="R28b31ef2446e4d08"/>
+    <p:sldLayoutId xmlns:r="http://schemas.openxmlformats.org/officeDocument/2006/relationships" id="2147483652" r:id="R4c38481493bf4911"/>
+    <p:sldLayoutId xmlns:r="http://schemas.openxmlformats.org/officeDocument/2006/relationships" id="2147483653" r:id="R4e47be286a5f4d82"/>
+    <p:sldLayoutId xmlns:r="http://schemas.openxmlformats.org/officeDocument/2006/relationships" id="2147483654" r:id="R19167ebe19734fdb"/>
   </p:sldLayoutIdLst>
   <p:txStyles>
     <p:titleStyle>
@@ -4648,7 +4648,7 @@
           <p:cNvPr id="5" name="">
             <a:extLst xmlns:a="http://schemas.openxmlformats.org/drawingml/2006/main">
               <a:ext uri="{FF2B5EF4-FFF2-40B4-BE49-F238E27FC236}">
-                <a16:creationId xmlns:a16="http://schemas.microsoft.com/office/drawing/2014/main" id="{94A34BB2-6415-4ED6-9749-A783D475E966}"/>
+                <a16:creationId xmlns:a16="http://schemas.microsoft.com/office/drawing/2014/main" id="{987BA7BF-0FC3-42F5-BEDD-56D0F88CBE37}"/>
               </a:ext>
             </a:extLst>
           </p:cNvPr>
@@ -4829,7 +4829,7 @@
           <p:cNvPr id="2" name="">
             <a:extLst xmlns:a="http://schemas.openxmlformats.org/drawingml/2006/main">
               <a:ext uri="{FF2B5EF4-FFF2-40B4-BE49-F238E27FC236}">
-                <a16:creationId xmlns:a16="http://schemas.microsoft.com/office/drawing/2014/main" id="{1734B3C5-A2A6-4F48-8C53-8BA55A626BA1}"/>
+                <a16:creationId xmlns:a16="http://schemas.microsoft.com/office/drawing/2014/main" id="{76123F34-9206-44F9-873E-D8CE77E13921}"/>
               </a:ext>
             </a:extLst>
           </p:cNvPr>
@@ -4987,7 +4987,7 @@
           <p:cNvPr id="3" name="">
             <a:extLst xmlns:a="http://schemas.openxmlformats.org/drawingml/2006/main">
               <a:ext uri="{FF2B5EF4-FFF2-40B4-BE49-F238E27FC236}">
-                <a16:creationId xmlns:a16="http://schemas.microsoft.com/office/drawing/2014/main" id="{8178BC73-9D93-4172-B43E-38C2B5247D65}"/>
+                <a16:creationId xmlns:a16="http://schemas.microsoft.com/office/drawing/2014/main" id="{18A8A6F4-153E-4098-9BFA-1F94814AB763}"/>
               </a:ext>
             </a:extLst>
           </p:cNvPr>
@@ -5017,7 +5017,7 @@
           <p:cNvPr id="4" name="">
             <a:extLst xmlns:a="http://schemas.openxmlformats.org/drawingml/2006/main">
               <a:ext uri="{FF2B5EF4-FFF2-40B4-BE49-F238E27FC236}">
-                <a16:creationId xmlns:a16="http://schemas.microsoft.com/office/drawing/2014/main" id="{65E67ADC-C81A-48E3-B0D4-7FAFD883C512}"/>
+                <a16:creationId xmlns:a16="http://schemas.microsoft.com/office/drawing/2014/main" id="{2D1C11C2-D764-4258-BF41-94F5B3CC20D6}"/>
               </a:ext>
             </a:extLst>
           </p:cNvPr>
@@ -5165,7 +5165,30 @@
                 <a:ea typeface="Arial"/>
                 <a:cs typeface="Arial"/>
               </a:rPr>
-              <a:t>Nomes e contribuições individuais ainda não informados</a:t>
+              <a:t>Roger Quinelato — backend, produto e negócio</a:t>
+            </a:r>
+          </a:p>
+          <a:p xmlns:a="http://schemas.openxmlformats.org/drawingml/2006/main">
+            <a:pPr>
+              <a:defRPr sz="1500" b="0">
+                <a:solidFill>
+                  <a:srgbClr val="FFFFFF"/>
+                </a:solidFill>
+                <a:latin typeface="Arial"/>
+                <a:ea typeface="Arial"/>
+                <a:cs typeface="Arial"/>
+              </a:defRPr>
+            </a:pPr>
+            <a:r>
+              <a:rPr sz="1500" b="0">
+                <a:solidFill>
+                  <a:srgbClr val="FFFFFF"/>
+                </a:solidFill>
+                <a:latin typeface="Arial"/>
+                <a:ea typeface="Arial"/>
+                <a:cs typeface="Arial"/>
+              </a:rPr>
+              <a:t>Raquel — frontend e levantamento de requisitos</a:t>
             </a:r>
           </a:p>
           <a:p xmlns:a="http://schemas.openxmlformats.org/drawingml/2006/main">
@@ -5219,7 +5242,7 @@
     </p:spTree>
     <p:extLst>
       <p:ext uri="{BB962C8B-B14F-4D97-AF65-F5344CB8AC3E}">
-        <p14:creationId xmlns:p14="http://schemas.microsoft.com/office/powerpoint/2010/main" val="1661073413"/>
+        <p14:creationId xmlns:p14="http://schemas.microsoft.com/office/powerpoint/2010/main" val="1715833366"/>
       </p:ext>
     </p:extLst>
   </p:cSld>
@@ -5250,7 +5273,7 @@
           <p:cNvPr id="8" name="">
             <a:extLst xmlns:a="http://schemas.openxmlformats.org/drawingml/2006/main">
               <a:ext uri="{FF2B5EF4-FFF2-40B4-BE49-F238E27FC236}">
-                <a16:creationId xmlns:a16="http://schemas.microsoft.com/office/drawing/2014/main" id="{87652935-0135-447D-B292-4723B1163553}"/>
+                <a16:creationId xmlns:a16="http://schemas.microsoft.com/office/drawing/2014/main" id="{F4340F95-C2FD-43D6-AC0E-75A5BE08FD12}"/>
               </a:ext>
             </a:extLst>
           </p:cNvPr>
@@ -5282,7 +5305,7 @@
           <p:cNvPr id="7" name="">
             <a:extLst xmlns:a="http://schemas.openxmlformats.org/drawingml/2006/main">
               <a:ext uri="{FF2B5EF4-FFF2-40B4-BE49-F238E27FC236}">
-                <a16:creationId xmlns:a16="http://schemas.microsoft.com/office/drawing/2014/main" id="{CE5C28A6-4EFD-4F08-BA19-46F874BA5766}"/>
+                <a16:creationId xmlns:a16="http://schemas.microsoft.com/office/drawing/2014/main" id="{290953B0-AFF9-42BC-AAD0-E4C0CB082878}"/>
               </a:ext>
             </a:extLst>
           </p:cNvPr>
@@ -5314,7 +5337,7 @@
           <p:cNvPr id="12" name="">
             <a:extLst xmlns:a="http://schemas.openxmlformats.org/drawingml/2006/main">
               <a:ext uri="{FF2B5EF4-FFF2-40B4-BE49-F238E27FC236}">
-                <a16:creationId xmlns:a16="http://schemas.microsoft.com/office/drawing/2014/main" id="{008BB7EB-F761-4D4C-B6F1-CE014F37662D}"/>
+                <a16:creationId xmlns:a16="http://schemas.microsoft.com/office/drawing/2014/main" id="{B82F13E3-7D5F-4DC1-8451-AF0FF40249EA}"/>
               </a:ext>
             </a:extLst>
           </p:cNvPr>
@@ -5344,7 +5367,7 @@
           <p:cNvPr id="2" name="">
             <a:extLst xmlns:a="http://schemas.openxmlformats.org/drawingml/2006/main">
               <a:ext uri="{FF2B5EF4-FFF2-40B4-BE49-F238E27FC236}">
-                <a16:creationId xmlns:a16="http://schemas.microsoft.com/office/drawing/2014/main" id="{34ED6DCB-7A5F-45C0-A38F-4B20609D5000}"/>
+                <a16:creationId xmlns:a16="http://schemas.microsoft.com/office/drawing/2014/main" id="{16167645-8593-414A-8792-967363AA1605}"/>
               </a:ext>
             </a:extLst>
           </p:cNvPr>
@@ -5502,7 +5525,7 @@
           <p:cNvPr id="3" name="">
             <a:extLst xmlns:a="http://schemas.openxmlformats.org/drawingml/2006/main">
               <a:ext uri="{FF2B5EF4-FFF2-40B4-BE49-F238E27FC236}">
-                <a16:creationId xmlns:a16="http://schemas.microsoft.com/office/drawing/2014/main" id="{912CA445-9B14-4DB6-91C9-4DF9F3D96E0D}"/>
+                <a16:creationId xmlns:a16="http://schemas.microsoft.com/office/drawing/2014/main" id="{6A289B18-A401-4FE9-B1EF-F2ABFA04B86D}"/>
               </a:ext>
             </a:extLst>
           </p:cNvPr>
@@ -5660,7 +5683,7 @@
           <p:cNvPr id="4" name="">
             <a:extLst xmlns:a="http://schemas.openxmlformats.org/drawingml/2006/main">
               <a:ext uri="{FF2B5EF4-FFF2-40B4-BE49-F238E27FC236}">
-                <a16:creationId xmlns:a16="http://schemas.microsoft.com/office/drawing/2014/main" id="{96D2DA12-A3E2-4140-8AD4-EF7BEE12FDD8}"/>
+                <a16:creationId xmlns:a16="http://schemas.microsoft.com/office/drawing/2014/main" id="{2BF395EF-1D18-48D1-B4E5-C7F4015A3DCA}"/>
               </a:ext>
             </a:extLst>
           </p:cNvPr>
@@ -5848,7 +5871,7 @@
           <p:cNvPr id="5" name="">
             <a:extLst xmlns:a="http://schemas.openxmlformats.org/drawingml/2006/main">
               <a:ext uri="{FF2B5EF4-FFF2-40B4-BE49-F238E27FC236}">
-                <a16:creationId xmlns:a16="http://schemas.microsoft.com/office/drawing/2014/main" id="{BC0D5546-0889-49AF-A3BA-BAFAC8B4469E}"/>
+                <a16:creationId xmlns:a16="http://schemas.microsoft.com/office/drawing/2014/main" id="{A8602A70-E0EB-45AD-AFFD-503B494A1922}"/>
               </a:ext>
             </a:extLst>
           </p:cNvPr>
@@ -6036,7 +6059,7 @@
           <p:cNvPr id="6" name="">
             <a:extLst xmlns:a="http://schemas.openxmlformats.org/drawingml/2006/main">
               <a:ext uri="{FF2B5EF4-FFF2-40B4-BE49-F238E27FC236}">
-                <a16:creationId xmlns:a16="http://schemas.microsoft.com/office/drawing/2014/main" id="{B299E4EA-7702-4808-8D75-25D6CE596CE0}"/>
+                <a16:creationId xmlns:a16="http://schemas.microsoft.com/office/drawing/2014/main" id="{CDD117A8-CBA2-4A38-BB28-78C271E5B39D}"/>
               </a:ext>
             </a:extLst>
           </p:cNvPr>
@@ -6224,7 +6247,7 @@
           <p:cNvPr id="9" name="">
             <a:extLst xmlns:a="http://schemas.openxmlformats.org/drawingml/2006/main">
               <a:ext uri="{FF2B5EF4-FFF2-40B4-BE49-F238E27FC236}">
-                <a16:creationId xmlns:a16="http://schemas.microsoft.com/office/drawing/2014/main" id="{BA509EA9-6C3C-4504-ABE6-05CD19AA8CF5}"/>
+                <a16:creationId xmlns:a16="http://schemas.microsoft.com/office/drawing/2014/main" id="{06950075-DB97-46C0-A69F-39E64DD29B5B}"/>
               </a:ext>
             </a:extLst>
           </p:cNvPr>
@@ -6382,7 +6405,7 @@
           <p:cNvPr id="10" name="">
             <a:extLst xmlns:a="http://schemas.openxmlformats.org/drawingml/2006/main">
               <a:ext uri="{FF2B5EF4-FFF2-40B4-BE49-F238E27FC236}">
-                <a16:creationId xmlns:a16="http://schemas.microsoft.com/office/drawing/2014/main" id="{D01A5814-3094-4A3D-9320-C8263F29903A}"/>
+                <a16:creationId xmlns:a16="http://schemas.microsoft.com/office/drawing/2014/main" id="{A77F34D2-41C4-4F3E-970F-5BD0C97A99CB}"/>
               </a:ext>
             </a:extLst>
           </p:cNvPr>
@@ -6540,7 +6563,7 @@
           <p:cNvPr id="11" name="">
             <a:extLst xmlns:a="http://schemas.openxmlformats.org/drawingml/2006/main">
               <a:ext uri="{FF2B5EF4-FFF2-40B4-BE49-F238E27FC236}">
-                <a16:creationId xmlns:a16="http://schemas.microsoft.com/office/drawing/2014/main" id="{D483107D-F279-4A8A-9BE0-B7D92DE082E5}"/>
+                <a16:creationId xmlns:a16="http://schemas.microsoft.com/office/drawing/2014/main" id="{A78C98D4-DDD9-4A4C-B071-EDE7E735E8D5}"/>
               </a:ext>
             </a:extLst>
           </p:cNvPr>
@@ -6696,7 +6719,7 @@
     </p:spTree>
     <p:extLst>
       <p:ext uri="{BB962C8B-B14F-4D97-AF65-F5344CB8AC3E}">
-        <p14:creationId xmlns:p14="http://schemas.microsoft.com/office/powerpoint/2010/main" val="45429468"/>
+        <p14:creationId xmlns:p14="http://schemas.microsoft.com/office/powerpoint/2010/main" val="890944476"/>
       </p:ext>
     </p:extLst>
   </p:cSld>
@@ -6727,7 +6750,7 @@
           <p:cNvPr id="10" name="">
             <a:extLst xmlns:a="http://schemas.openxmlformats.org/drawingml/2006/main">
               <a:ext uri="{FF2B5EF4-FFF2-40B4-BE49-F238E27FC236}">
-                <a16:creationId xmlns:a16="http://schemas.microsoft.com/office/drawing/2014/main" id="{C56036B1-CA3A-4E3D-AF9A-EF5B504039C5}"/>
+                <a16:creationId xmlns:a16="http://schemas.microsoft.com/office/drawing/2014/main" id="{1E89D90C-7176-491F-97E0-556268202BC1}"/>
               </a:ext>
             </a:extLst>
           </p:cNvPr>
@@ -6761,7 +6784,7 @@
           <p:cNvPr id="9" name="">
             <a:extLst xmlns:a="http://schemas.openxmlformats.org/drawingml/2006/main">
               <a:ext uri="{FF2B5EF4-FFF2-40B4-BE49-F238E27FC236}">
-                <a16:creationId xmlns:a16="http://schemas.microsoft.com/office/drawing/2014/main" id="{27738231-D583-42BD-ABF9-A4C8B7F27237}"/>
+                <a16:creationId xmlns:a16="http://schemas.microsoft.com/office/drawing/2014/main" id="{8AC28AD2-0A05-4345-AA0E-F7DC0BC11448}"/>
               </a:ext>
             </a:extLst>
           </p:cNvPr>
@@ -6795,7 +6818,7 @@
           <p:cNvPr id="8" name="">
             <a:extLst xmlns:a="http://schemas.openxmlformats.org/drawingml/2006/main">
               <a:ext uri="{FF2B5EF4-FFF2-40B4-BE49-F238E27FC236}">
-                <a16:creationId xmlns:a16="http://schemas.microsoft.com/office/drawing/2014/main" id="{B8158F6A-DD21-4D59-941D-39AFE2763E4A}"/>
+                <a16:creationId xmlns:a16="http://schemas.microsoft.com/office/drawing/2014/main" id="{47C2A792-1E08-4C39-BE29-B100E648C53D}"/>
               </a:ext>
             </a:extLst>
           </p:cNvPr>
@@ -6827,7 +6850,7 @@
           <p:cNvPr id="13" name="">
             <a:extLst xmlns:a="http://schemas.openxmlformats.org/drawingml/2006/main">
               <a:ext uri="{FF2B5EF4-FFF2-40B4-BE49-F238E27FC236}">
-                <a16:creationId xmlns:a16="http://schemas.microsoft.com/office/drawing/2014/main" id="{34C8D0C5-198D-4B22-86BC-88689B1CA833}"/>
+                <a16:creationId xmlns:a16="http://schemas.microsoft.com/office/drawing/2014/main" id="{EA7E3721-7FDC-46F4-9F81-D2BC6EA8AD09}"/>
               </a:ext>
             </a:extLst>
           </p:cNvPr>
@@ -6857,7 +6880,7 @@
           <p:cNvPr id="2" name="">
             <a:extLst xmlns:a="http://schemas.openxmlformats.org/drawingml/2006/main">
               <a:ext uri="{FF2B5EF4-FFF2-40B4-BE49-F238E27FC236}">
-                <a16:creationId xmlns:a16="http://schemas.microsoft.com/office/drawing/2014/main" id="{E423AF2C-704C-4B0D-90C2-F4E0631AF13A}"/>
+                <a16:creationId xmlns:a16="http://schemas.microsoft.com/office/drawing/2014/main" id="{014D9F2B-4B42-4412-A15A-C0E9AC76FFD2}"/>
               </a:ext>
             </a:extLst>
           </p:cNvPr>
@@ -7015,7 +7038,7 @@
           <p:cNvPr id="3" name="">
             <a:extLst xmlns:a="http://schemas.openxmlformats.org/drawingml/2006/main">
               <a:ext uri="{FF2B5EF4-FFF2-40B4-BE49-F238E27FC236}">
-                <a16:creationId xmlns:a16="http://schemas.microsoft.com/office/drawing/2014/main" id="{083B975A-CF8D-413E-9DC1-A782B88AD140}"/>
+                <a16:creationId xmlns:a16="http://schemas.microsoft.com/office/drawing/2014/main" id="{F4E6950C-272C-4D8C-BBD0-D5177ACBE8F0}"/>
               </a:ext>
             </a:extLst>
           </p:cNvPr>
@@ -7173,7 +7196,7 @@
           <p:cNvPr id="4" name="">
             <a:extLst xmlns:a="http://schemas.openxmlformats.org/drawingml/2006/main">
               <a:ext uri="{FF2B5EF4-FFF2-40B4-BE49-F238E27FC236}">
-                <a16:creationId xmlns:a16="http://schemas.microsoft.com/office/drawing/2014/main" id="{3F521CF9-78BE-4A25-AFBD-A80BE9335A23}"/>
+                <a16:creationId xmlns:a16="http://schemas.microsoft.com/office/drawing/2014/main" id="{47C3A952-48B4-4BC4-B950-F8E432EF3A0D}"/>
               </a:ext>
             </a:extLst>
           </p:cNvPr>
@@ -7361,7 +7384,7 @@
           <p:cNvPr id="5" name="">
             <a:extLst xmlns:a="http://schemas.openxmlformats.org/drawingml/2006/main">
               <a:ext uri="{FF2B5EF4-FFF2-40B4-BE49-F238E27FC236}">
-                <a16:creationId xmlns:a16="http://schemas.microsoft.com/office/drawing/2014/main" id="{A903E73B-96E9-4CEA-AA5D-EE3B42F6CC6A}"/>
+                <a16:creationId xmlns:a16="http://schemas.microsoft.com/office/drawing/2014/main" id="{9781F7D2-F3CD-4B84-94AC-25820256BCD2}"/>
               </a:ext>
             </a:extLst>
           </p:cNvPr>
@@ -7549,7 +7572,7 @@
           <p:cNvPr id="6" name="">
             <a:extLst xmlns:a="http://schemas.openxmlformats.org/drawingml/2006/main">
               <a:ext uri="{FF2B5EF4-FFF2-40B4-BE49-F238E27FC236}">
-                <a16:creationId xmlns:a16="http://schemas.microsoft.com/office/drawing/2014/main" id="{B8603890-0CC4-4483-B63F-BF4BD491F460}"/>
+                <a16:creationId xmlns:a16="http://schemas.microsoft.com/office/drawing/2014/main" id="{0BEB7B8A-C81A-4FA4-8059-C41E7ABB649F}"/>
               </a:ext>
             </a:extLst>
           </p:cNvPr>
@@ -7737,7 +7760,7 @@
           <p:cNvPr id="7" name="">
             <a:extLst xmlns:a="http://schemas.openxmlformats.org/drawingml/2006/main">
               <a:ext uri="{FF2B5EF4-FFF2-40B4-BE49-F238E27FC236}">
-                <a16:creationId xmlns:a16="http://schemas.microsoft.com/office/drawing/2014/main" id="{1E3DEC25-5603-4F28-8DEE-69898B48FEDA}"/>
+                <a16:creationId xmlns:a16="http://schemas.microsoft.com/office/drawing/2014/main" id="{9D0919A4-AB28-4234-8C3D-5008F443207F}"/>
               </a:ext>
             </a:extLst>
           </p:cNvPr>
@@ -7925,7 +7948,7 @@
           <p:cNvPr id="11" name="">
             <a:extLst xmlns:a="http://schemas.openxmlformats.org/drawingml/2006/main">
               <a:ext uri="{FF2B5EF4-FFF2-40B4-BE49-F238E27FC236}">
-                <a16:creationId xmlns:a16="http://schemas.microsoft.com/office/drawing/2014/main" id="{0B676A44-4AB3-47BC-8E1E-88982A542B29}"/>
+                <a16:creationId xmlns:a16="http://schemas.microsoft.com/office/drawing/2014/main" id="{6A0CBF89-ECE9-4060-8946-E8848A38186F}"/>
               </a:ext>
             </a:extLst>
           </p:cNvPr>
@@ -8083,7 +8106,7 @@
           <p:cNvPr id="12" name="">
             <a:extLst xmlns:a="http://schemas.openxmlformats.org/drawingml/2006/main">
               <a:ext uri="{FF2B5EF4-FFF2-40B4-BE49-F238E27FC236}">
-                <a16:creationId xmlns:a16="http://schemas.microsoft.com/office/drawing/2014/main" id="{55B42EC4-F1F3-44A5-A1D5-606C2DE8CB4B}"/>
+                <a16:creationId xmlns:a16="http://schemas.microsoft.com/office/drawing/2014/main" id="{33F2A241-8FE6-42C2-B275-929E15CE69C0}"/>
               </a:ext>
             </a:extLst>
           </p:cNvPr>
@@ -8239,7 +8262,7 @@
     </p:spTree>
     <p:extLst>
       <p:ext uri="{BB962C8B-B14F-4D97-AF65-F5344CB8AC3E}">
-        <p14:creationId xmlns:p14="http://schemas.microsoft.com/office/powerpoint/2010/main" val="1379234653"/>
+        <p14:creationId xmlns:p14="http://schemas.microsoft.com/office/powerpoint/2010/main" val="1218121198"/>
       </p:ext>
     </p:extLst>
   </p:cSld>
@@ -8270,7 +8293,7 @@
           <p:cNvPr id="10" name="">
             <a:extLst xmlns:a="http://schemas.openxmlformats.org/drawingml/2006/main">
               <a:ext uri="{FF2B5EF4-FFF2-40B4-BE49-F238E27FC236}">
-                <a16:creationId xmlns:a16="http://schemas.microsoft.com/office/drawing/2014/main" id="{384D1B37-5662-46CD-8DB9-5ADD6656C63D}"/>
+                <a16:creationId xmlns:a16="http://schemas.microsoft.com/office/drawing/2014/main" id="{315AFB7D-BE6C-4CD3-9503-47969409EE92}"/>
               </a:ext>
             </a:extLst>
           </p:cNvPr>
@@ -8302,7 +8325,7 @@
           <p:cNvPr id="9" name="">
             <a:extLst xmlns:a="http://schemas.openxmlformats.org/drawingml/2006/main">
               <a:ext uri="{FF2B5EF4-FFF2-40B4-BE49-F238E27FC236}">
-                <a16:creationId xmlns:a16="http://schemas.microsoft.com/office/drawing/2014/main" id="{01BCB684-519F-4B51-8762-EFE8CA70AC2D}"/>
+                <a16:creationId xmlns:a16="http://schemas.microsoft.com/office/drawing/2014/main" id="{A6F2292E-3616-430E-9B13-4373841738AB}"/>
               </a:ext>
             </a:extLst>
           </p:cNvPr>
@@ -8334,7 +8357,7 @@
           <p:cNvPr id="8" name="">
             <a:extLst xmlns:a="http://schemas.openxmlformats.org/drawingml/2006/main">
               <a:ext uri="{FF2B5EF4-FFF2-40B4-BE49-F238E27FC236}">
-                <a16:creationId xmlns:a16="http://schemas.microsoft.com/office/drawing/2014/main" id="{2B3D7872-3BA7-4465-874A-1199C8D6FBF7}"/>
+                <a16:creationId xmlns:a16="http://schemas.microsoft.com/office/drawing/2014/main" id="{BECEB873-C258-4577-A8D4-E33A5AB08AF3}"/>
               </a:ext>
             </a:extLst>
           </p:cNvPr>
@@ -8368,7 +8391,7 @@
           <p:cNvPr id="13" name="">
             <a:extLst xmlns:a="http://schemas.openxmlformats.org/drawingml/2006/main">
               <a:ext uri="{FF2B5EF4-FFF2-40B4-BE49-F238E27FC236}">
-                <a16:creationId xmlns:a16="http://schemas.microsoft.com/office/drawing/2014/main" id="{3DADAE7B-8064-47DD-B8F4-F495A010F978}"/>
+                <a16:creationId xmlns:a16="http://schemas.microsoft.com/office/drawing/2014/main" id="{9ED38835-D701-44D0-B376-F0D6860D81BF}"/>
               </a:ext>
             </a:extLst>
           </p:cNvPr>
@@ -8398,7 +8421,7 @@
           <p:cNvPr id="2" name="">
             <a:extLst xmlns:a="http://schemas.openxmlformats.org/drawingml/2006/main">
               <a:ext uri="{FF2B5EF4-FFF2-40B4-BE49-F238E27FC236}">
-                <a16:creationId xmlns:a16="http://schemas.microsoft.com/office/drawing/2014/main" id="{B29A95D3-9A76-4F54-B0DD-D09D9EEF5C70}"/>
+                <a16:creationId xmlns:a16="http://schemas.microsoft.com/office/drawing/2014/main" id="{1D6AD531-A881-4430-98B7-7282EB355112}"/>
               </a:ext>
             </a:extLst>
           </p:cNvPr>
@@ -8556,7 +8579,7 @@
           <p:cNvPr id="3" name="">
             <a:extLst xmlns:a="http://schemas.openxmlformats.org/drawingml/2006/main">
               <a:ext uri="{FF2B5EF4-FFF2-40B4-BE49-F238E27FC236}">
-                <a16:creationId xmlns:a16="http://schemas.microsoft.com/office/drawing/2014/main" id="{1018CF2B-47E2-4446-B6A0-F386F3EF6E06}"/>
+                <a16:creationId xmlns:a16="http://schemas.microsoft.com/office/drawing/2014/main" id="{ED5F12ED-C70B-4BE2-952E-64629CCD6DF7}"/>
               </a:ext>
             </a:extLst>
           </p:cNvPr>
@@ -8714,7 +8737,7 @@
           <p:cNvPr id="4" name="">
             <a:extLst xmlns:a="http://schemas.openxmlformats.org/drawingml/2006/main">
               <a:ext uri="{FF2B5EF4-FFF2-40B4-BE49-F238E27FC236}">
-                <a16:creationId xmlns:a16="http://schemas.microsoft.com/office/drawing/2014/main" id="{BA24B3F7-A897-4856-87DA-19D1C982B29D}"/>
+                <a16:creationId xmlns:a16="http://schemas.microsoft.com/office/drawing/2014/main" id="{60EA2A85-1424-4361-9E85-98CF621FA2A6}"/>
               </a:ext>
             </a:extLst>
           </p:cNvPr>
@@ -8902,7 +8925,7 @@
           <p:cNvPr id="5" name="">
             <a:extLst xmlns:a="http://schemas.openxmlformats.org/drawingml/2006/main">
               <a:ext uri="{FF2B5EF4-FFF2-40B4-BE49-F238E27FC236}">
-                <a16:creationId xmlns:a16="http://schemas.microsoft.com/office/drawing/2014/main" id="{3B1478A5-36FE-4406-B8F3-A103032BE71C}"/>
+                <a16:creationId xmlns:a16="http://schemas.microsoft.com/office/drawing/2014/main" id="{BC75E7CE-1FF9-4E15-921D-2E73F425FC0D}"/>
               </a:ext>
             </a:extLst>
           </p:cNvPr>
@@ -9090,7 +9113,7 @@
           <p:cNvPr id="6" name="">
             <a:extLst xmlns:a="http://schemas.openxmlformats.org/drawingml/2006/main">
               <a:ext uri="{FF2B5EF4-FFF2-40B4-BE49-F238E27FC236}">
-                <a16:creationId xmlns:a16="http://schemas.microsoft.com/office/drawing/2014/main" id="{3EC9F2C2-7DB5-4F65-AC94-DB5475925726}"/>
+                <a16:creationId xmlns:a16="http://schemas.microsoft.com/office/drawing/2014/main" id="{14A9BAC1-A06E-4470-90D9-B633A04AD719}"/>
               </a:ext>
             </a:extLst>
           </p:cNvPr>
@@ -9278,7 +9301,7 @@
           <p:cNvPr id="7" name="">
             <a:extLst xmlns:a="http://schemas.openxmlformats.org/drawingml/2006/main">
               <a:ext uri="{FF2B5EF4-FFF2-40B4-BE49-F238E27FC236}">
-                <a16:creationId xmlns:a16="http://schemas.microsoft.com/office/drawing/2014/main" id="{954F0393-D46D-4116-A904-4085402A22EF}"/>
+                <a16:creationId xmlns:a16="http://schemas.microsoft.com/office/drawing/2014/main" id="{BD4822A7-388D-4488-9664-796739AF1209}"/>
               </a:ext>
             </a:extLst>
           </p:cNvPr>
@@ -9466,7 +9489,7 @@
           <p:cNvPr id="11" name="">
             <a:extLst xmlns:a="http://schemas.openxmlformats.org/drawingml/2006/main">
               <a:ext uri="{FF2B5EF4-FFF2-40B4-BE49-F238E27FC236}">
-                <a16:creationId xmlns:a16="http://schemas.microsoft.com/office/drawing/2014/main" id="{C5043FCE-642B-468D-AD09-5B6B143F9231}"/>
+                <a16:creationId xmlns:a16="http://schemas.microsoft.com/office/drawing/2014/main" id="{A0D1F238-0F08-4B79-9804-A68BDD978AA7}"/>
               </a:ext>
             </a:extLst>
           </p:cNvPr>
@@ -9614,7 +9637,7 @@
                 <a:ea typeface="Arial"/>
                 <a:cs typeface="Arial"/>
               </a:rPr>
-              <a:t>Limite conhecido: resolução antes da abertura pode deixar processo STARTED</a:t>
+              <a:t>Recuperação: resolução aguarda a abertura, sem confirmar a inbox</a:t>
             </a:r>
           </a:p>
         </p:txBody>
@@ -9624,7 +9647,7 @@
           <p:cNvPr id="12" name="">
             <a:extLst xmlns:a="http://schemas.openxmlformats.org/drawingml/2006/main">
               <a:ext uri="{FF2B5EF4-FFF2-40B4-BE49-F238E27FC236}">
-                <a16:creationId xmlns:a16="http://schemas.microsoft.com/office/drawing/2014/main" id="{494840C9-4C87-472C-A1D7-CD4C82544ECB}"/>
+                <a16:creationId xmlns:a16="http://schemas.microsoft.com/office/drawing/2014/main" id="{7B98C94D-10F6-4672-8832-FEDE57A70779}"/>
               </a:ext>
             </a:extLst>
           </p:cNvPr>
@@ -9780,7 +9803,7 @@
     </p:spTree>
     <p:extLst>
       <p:ext uri="{BB962C8B-B14F-4D97-AF65-F5344CB8AC3E}">
-        <p14:creationId xmlns:p14="http://schemas.microsoft.com/office/powerpoint/2010/main" val="1168916265"/>
+        <p14:creationId xmlns:p14="http://schemas.microsoft.com/office/powerpoint/2010/main" val="617087666"/>
       </p:ext>
     </p:extLst>
   </p:cSld>
@@ -9811,7 +9834,7 @@
           <p:cNvPr id="7" name="">
             <a:extLst xmlns:a="http://schemas.openxmlformats.org/drawingml/2006/main">
               <a:ext uri="{FF2B5EF4-FFF2-40B4-BE49-F238E27FC236}">
-                <a16:creationId xmlns:a16="http://schemas.microsoft.com/office/drawing/2014/main" id="{4BC00EFB-94EA-4F1F-85FA-BAD205487A8B}"/>
+                <a16:creationId xmlns:a16="http://schemas.microsoft.com/office/drawing/2014/main" id="{4BE97FB6-73A2-4C75-9E9D-DD562EDF8235}"/>
               </a:ext>
             </a:extLst>
           </p:cNvPr>
@@ -9841,7 +9864,7 @@
           <p:cNvPr id="2" name="">
             <a:extLst xmlns:a="http://schemas.openxmlformats.org/drawingml/2006/main">
               <a:ext uri="{FF2B5EF4-FFF2-40B4-BE49-F238E27FC236}">
-                <a16:creationId xmlns:a16="http://schemas.microsoft.com/office/drawing/2014/main" id="{CA81F471-ADA9-49F4-A031-D194DB3637BB}"/>
+                <a16:creationId xmlns:a16="http://schemas.microsoft.com/office/drawing/2014/main" id="{D2BE12BB-23C4-454F-BE00-88E55A01133A}"/>
               </a:ext>
             </a:extLst>
           </p:cNvPr>
@@ -9989,7 +10012,7 @@
                 <a:ea typeface="Arial"/>
                 <a:cs typeface="Arial"/>
               </a:rPr>
-              <a:t>Interoperabilidade e reservas e contratos</a:t>
+              <a:t>Interoperabilidade e contratos técnicos</a:t>
             </a:r>
           </a:p>
         </p:txBody>
@@ -9999,7 +10022,7 @@
           <p:cNvPr id="3" name="">
             <a:extLst xmlns:a="http://schemas.openxmlformats.org/drawingml/2006/main">
               <a:ext uri="{FF2B5EF4-FFF2-40B4-BE49-F238E27FC236}">
-                <a16:creationId xmlns:a16="http://schemas.microsoft.com/office/drawing/2014/main" id="{3273A162-FCBE-417F-AA42-FF9B808EA685}"/>
+                <a16:creationId xmlns:a16="http://schemas.microsoft.com/office/drawing/2014/main" id="{5A811759-5B24-4FD5-9FD5-BC1B5DB1B626}"/>
               </a:ext>
             </a:extLst>
           </p:cNvPr>
@@ -10157,7 +10180,7 @@
           <p:cNvPr id="4" name="">
             <a:extLst xmlns:a="http://schemas.openxmlformats.org/drawingml/2006/main">
               <a:ext uri="{FF2B5EF4-FFF2-40B4-BE49-F238E27FC236}">
-                <a16:creationId xmlns:a16="http://schemas.microsoft.com/office/drawing/2014/main" id="{1F3E39E4-E9EB-43C3-BC19-E354C7FC580F}"/>
+                <a16:creationId xmlns:a16="http://schemas.microsoft.com/office/drawing/2014/main" id="{1B44B4FC-A9BA-41B6-9213-7BBB7411CB58}"/>
               </a:ext>
             </a:extLst>
           </p:cNvPr>
@@ -10427,7 +10450,7 @@
           <p:cNvPr id="5" name="">
             <a:extLst xmlns:a="http://schemas.openxmlformats.org/drawingml/2006/main">
               <a:ext uri="{FF2B5EF4-FFF2-40B4-BE49-F238E27FC236}">
-                <a16:creationId xmlns:a16="http://schemas.microsoft.com/office/drawing/2014/main" id="{1289B5DF-54EA-483C-916D-B2C298B14D6E}"/>
+                <a16:creationId xmlns:a16="http://schemas.microsoft.com/office/drawing/2014/main" id="{8031529D-6954-44A0-BAF1-A5677DC4AF33}"/>
               </a:ext>
             </a:extLst>
           </p:cNvPr>
@@ -10753,7 +10776,7 @@
           <p:cNvPr id="6" name="">
             <a:extLst xmlns:a="http://schemas.openxmlformats.org/drawingml/2006/main">
               <a:ext uri="{FF2B5EF4-FFF2-40B4-BE49-F238E27FC236}">
-                <a16:creationId xmlns:a16="http://schemas.microsoft.com/office/drawing/2014/main" id="{4E66D15B-4CD3-42C6-801D-F9C0C7949A31}"/>
+                <a16:creationId xmlns:a16="http://schemas.microsoft.com/office/drawing/2014/main" id="{6FD98FCF-DFD4-41BD-B77D-0F4D0BA7FD06}"/>
               </a:ext>
             </a:extLst>
           </p:cNvPr>
@@ -10909,7 +10932,7 @@
     </p:spTree>
     <p:extLst>
       <p:ext uri="{BB962C8B-B14F-4D97-AF65-F5344CB8AC3E}">
-        <p14:creationId xmlns:p14="http://schemas.microsoft.com/office/powerpoint/2010/main" val="214609718"/>
+        <p14:creationId xmlns:p14="http://schemas.microsoft.com/office/powerpoint/2010/main" val="2055433004"/>
       </p:ext>
     </p:extLst>
   </p:cSld>
@@ -10940,7 +10963,7 @@
           <p:cNvPr id="28" name="">
             <a:extLst xmlns:a="http://schemas.openxmlformats.org/drawingml/2006/main">
               <a:ext uri="{FF2B5EF4-FFF2-40B4-BE49-F238E27FC236}">
-                <a16:creationId xmlns:a16="http://schemas.microsoft.com/office/drawing/2014/main" id="{7140E2A3-3214-4957-88CB-F00F2627CC03}"/>
+                <a16:creationId xmlns:a16="http://schemas.microsoft.com/office/drawing/2014/main" id="{78945D96-974F-43BF-927C-F496C5ADEACC}"/>
               </a:ext>
             </a:extLst>
           </p:cNvPr>
@@ -10970,7 +10993,7 @@
           <p:cNvPr id="2" name="">
             <a:extLst xmlns:a="http://schemas.openxmlformats.org/drawingml/2006/main">
               <a:ext uri="{FF2B5EF4-FFF2-40B4-BE49-F238E27FC236}">
-                <a16:creationId xmlns:a16="http://schemas.microsoft.com/office/drawing/2014/main" id="{44ADAA69-384E-474F-A19A-FA4D9789E293}"/>
+                <a16:creationId xmlns:a16="http://schemas.microsoft.com/office/drawing/2014/main" id="{AA754AE8-80AC-47D6-A94A-C3C145B8B9CE}"/>
               </a:ext>
             </a:extLst>
           </p:cNvPr>
@@ -11128,7 +11151,7 @@
           <p:cNvPr id="3" name="">
             <a:extLst xmlns:a="http://schemas.openxmlformats.org/drawingml/2006/main">
               <a:ext uri="{FF2B5EF4-FFF2-40B4-BE49-F238E27FC236}">
-                <a16:creationId xmlns:a16="http://schemas.microsoft.com/office/drawing/2014/main" id="{9A3C599B-ADFB-437D-9279-984F112CF3B2}"/>
+                <a16:creationId xmlns:a16="http://schemas.microsoft.com/office/drawing/2014/main" id="{15FF0C93-4DAA-4FD1-8744-CEC991833752}"/>
               </a:ext>
             </a:extLst>
           </p:cNvPr>
@@ -11286,7 +11309,7 @@
           <p:cNvPr id="4" name="">
             <a:extLst xmlns:a="http://schemas.openxmlformats.org/drawingml/2006/main">
               <a:ext uri="{FF2B5EF4-FFF2-40B4-BE49-F238E27FC236}">
-                <a16:creationId xmlns:a16="http://schemas.microsoft.com/office/drawing/2014/main" id="{086571E3-518C-4A8B-8793-94D1A2C06ACF}"/>
+                <a16:creationId xmlns:a16="http://schemas.microsoft.com/office/drawing/2014/main" id="{85DCC13F-8673-4A3D-BFEE-800188FCE277}"/>
               </a:ext>
             </a:extLst>
           </p:cNvPr>
@@ -11444,7 +11467,7 @@
           <p:cNvPr id="5" name="">
             <a:extLst xmlns:a="http://schemas.openxmlformats.org/drawingml/2006/main">
               <a:ext uri="{FF2B5EF4-FFF2-40B4-BE49-F238E27FC236}">
-                <a16:creationId xmlns:a16="http://schemas.microsoft.com/office/drawing/2014/main" id="{97AA7B8A-8A27-425D-BDFC-FF4D89A08C4E}"/>
+                <a16:creationId xmlns:a16="http://schemas.microsoft.com/office/drawing/2014/main" id="{18EC15F2-ABC3-447C-A629-61C6AB904110}"/>
               </a:ext>
             </a:extLst>
           </p:cNvPr>
@@ -11602,7 +11625,7 @@
           <p:cNvPr id="6" name="">
             <a:extLst xmlns:a="http://schemas.openxmlformats.org/drawingml/2006/main">
               <a:ext uri="{FF2B5EF4-FFF2-40B4-BE49-F238E27FC236}">
-                <a16:creationId xmlns:a16="http://schemas.microsoft.com/office/drawing/2014/main" id="{2E2B6648-B831-47F3-A80A-D4057D97CEC8}"/>
+                <a16:creationId xmlns:a16="http://schemas.microsoft.com/office/drawing/2014/main" id="{B6845FCC-8AB5-407D-8532-593E2FEEB6E4}"/>
               </a:ext>
             </a:extLst>
           </p:cNvPr>
@@ -11760,7 +11783,7 @@
           <p:cNvPr id="7" name="">
             <a:extLst xmlns:a="http://schemas.openxmlformats.org/drawingml/2006/main">
               <a:ext uri="{FF2B5EF4-FFF2-40B4-BE49-F238E27FC236}">
-                <a16:creationId xmlns:a16="http://schemas.microsoft.com/office/drawing/2014/main" id="{EC5999FB-EFF2-42EE-A55C-B3E71AAA929C}"/>
+                <a16:creationId xmlns:a16="http://schemas.microsoft.com/office/drawing/2014/main" id="{75060652-2873-47A4-B40B-0A697FE3BD31}"/>
               </a:ext>
             </a:extLst>
           </p:cNvPr>
@@ -11918,7 +11941,7 @@
           <p:cNvPr id="8" name="">
             <a:extLst xmlns:a="http://schemas.openxmlformats.org/drawingml/2006/main">
               <a:ext uri="{FF2B5EF4-FFF2-40B4-BE49-F238E27FC236}">
-                <a16:creationId xmlns:a16="http://schemas.microsoft.com/office/drawing/2014/main" id="{7A6D258C-C2CA-420F-B3E2-B2E9E45D4545}"/>
+                <a16:creationId xmlns:a16="http://schemas.microsoft.com/office/drawing/2014/main" id="{325D7F0D-31B3-45B0-B734-1C9441EEF08D}"/>
               </a:ext>
             </a:extLst>
           </p:cNvPr>
@@ -12076,7 +12099,7 @@
           <p:cNvPr id="9" name="">
             <a:extLst xmlns:a="http://schemas.openxmlformats.org/drawingml/2006/main">
               <a:ext uri="{FF2B5EF4-FFF2-40B4-BE49-F238E27FC236}">
-                <a16:creationId xmlns:a16="http://schemas.microsoft.com/office/drawing/2014/main" id="{8E7A4886-79BE-4F6E-96C5-BBCE800C32D8}"/>
+                <a16:creationId xmlns:a16="http://schemas.microsoft.com/office/drawing/2014/main" id="{8C5AA0FF-AA79-45C7-A84C-076998372343}"/>
               </a:ext>
             </a:extLst>
           </p:cNvPr>
@@ -12234,7 +12257,7 @@
           <p:cNvPr id="10" name="">
             <a:extLst xmlns:a="http://schemas.openxmlformats.org/drawingml/2006/main">
               <a:ext uri="{FF2B5EF4-FFF2-40B4-BE49-F238E27FC236}">
-                <a16:creationId xmlns:a16="http://schemas.microsoft.com/office/drawing/2014/main" id="{2B165131-128A-45F2-BE5B-ED54140B4414}"/>
+                <a16:creationId xmlns:a16="http://schemas.microsoft.com/office/drawing/2014/main" id="{CB51BD74-1436-45AF-95A3-07D25B0287DE}"/>
               </a:ext>
             </a:extLst>
           </p:cNvPr>
@@ -12392,7 +12415,7 @@
           <p:cNvPr id="11" name="">
             <a:extLst xmlns:a="http://schemas.openxmlformats.org/drawingml/2006/main">
               <a:ext uri="{FF2B5EF4-FFF2-40B4-BE49-F238E27FC236}">
-                <a16:creationId xmlns:a16="http://schemas.microsoft.com/office/drawing/2014/main" id="{4F76F2AF-89E9-42EC-B6E2-F4D0FC35E3A2}"/>
+                <a16:creationId xmlns:a16="http://schemas.microsoft.com/office/drawing/2014/main" id="{871A7976-6585-4995-938B-C345C313F779}"/>
               </a:ext>
             </a:extLst>
           </p:cNvPr>
@@ -12550,7 +12573,7 @@
           <p:cNvPr id="12" name="">
             <a:extLst xmlns:a="http://schemas.openxmlformats.org/drawingml/2006/main">
               <a:ext uri="{FF2B5EF4-FFF2-40B4-BE49-F238E27FC236}">
-                <a16:creationId xmlns:a16="http://schemas.microsoft.com/office/drawing/2014/main" id="{D78A216F-3BB8-4139-B3F2-D1D773584DF7}"/>
+                <a16:creationId xmlns:a16="http://schemas.microsoft.com/office/drawing/2014/main" id="{E8875676-F3EE-46BD-B1F1-2C9C0A1F1BD7}"/>
               </a:ext>
             </a:extLst>
           </p:cNvPr>
@@ -12708,7 +12731,7 @@
           <p:cNvPr id="13" name="">
             <a:extLst xmlns:a="http://schemas.openxmlformats.org/drawingml/2006/main">
               <a:ext uri="{FF2B5EF4-FFF2-40B4-BE49-F238E27FC236}">
-                <a16:creationId xmlns:a16="http://schemas.microsoft.com/office/drawing/2014/main" id="{A11789D9-A58A-474F-94A8-3659B6283E27}"/>
+                <a16:creationId xmlns:a16="http://schemas.microsoft.com/office/drawing/2014/main" id="{09D1AFDC-3163-4C8A-B7B6-31652E77F670}"/>
               </a:ext>
             </a:extLst>
           </p:cNvPr>
@@ -12866,7 +12889,7 @@
           <p:cNvPr id="14" name="">
             <a:extLst xmlns:a="http://schemas.openxmlformats.org/drawingml/2006/main">
               <a:ext uri="{FF2B5EF4-FFF2-40B4-BE49-F238E27FC236}">
-                <a16:creationId xmlns:a16="http://schemas.microsoft.com/office/drawing/2014/main" id="{5E542756-C59C-4EE5-925E-624EEE86552E}"/>
+                <a16:creationId xmlns:a16="http://schemas.microsoft.com/office/drawing/2014/main" id="{B8D16312-28FA-4952-8381-973C2B9A06A7}"/>
               </a:ext>
             </a:extLst>
           </p:cNvPr>
@@ -13024,7 +13047,7 @@
           <p:cNvPr id="15" name="">
             <a:extLst xmlns:a="http://schemas.openxmlformats.org/drawingml/2006/main">
               <a:ext uri="{FF2B5EF4-FFF2-40B4-BE49-F238E27FC236}">
-                <a16:creationId xmlns:a16="http://schemas.microsoft.com/office/drawing/2014/main" id="{FB0205C3-307C-4898-A7C9-A20BD9A65F46}"/>
+                <a16:creationId xmlns:a16="http://schemas.microsoft.com/office/drawing/2014/main" id="{BDC967B5-40E3-4EDF-B968-EA63B0703AE5}"/>
               </a:ext>
             </a:extLst>
           </p:cNvPr>
@@ -13182,7 +13205,7 @@
           <p:cNvPr id="16" name="">
             <a:extLst xmlns:a="http://schemas.openxmlformats.org/drawingml/2006/main">
               <a:ext uri="{FF2B5EF4-FFF2-40B4-BE49-F238E27FC236}">
-                <a16:creationId xmlns:a16="http://schemas.microsoft.com/office/drawing/2014/main" id="{7BFB5338-B332-4E34-9F66-318B049F03FD}"/>
+                <a16:creationId xmlns:a16="http://schemas.microsoft.com/office/drawing/2014/main" id="{F146CB0F-DC9D-44B7-BB03-97B00EB9C3CA}"/>
               </a:ext>
             </a:extLst>
           </p:cNvPr>
@@ -13340,7 +13363,7 @@
           <p:cNvPr id="17" name="">
             <a:extLst xmlns:a="http://schemas.openxmlformats.org/drawingml/2006/main">
               <a:ext uri="{FF2B5EF4-FFF2-40B4-BE49-F238E27FC236}">
-                <a16:creationId xmlns:a16="http://schemas.microsoft.com/office/drawing/2014/main" id="{6299F6D8-3E62-4641-94DF-5B6A1F22FDE3}"/>
+                <a16:creationId xmlns:a16="http://schemas.microsoft.com/office/drawing/2014/main" id="{5E36741A-C92A-4F20-A2C8-1396C1DC8730}"/>
               </a:ext>
             </a:extLst>
           </p:cNvPr>
@@ -13498,7 +13521,7 @@
           <p:cNvPr id="18" name="">
             <a:extLst xmlns:a="http://schemas.openxmlformats.org/drawingml/2006/main">
               <a:ext uri="{FF2B5EF4-FFF2-40B4-BE49-F238E27FC236}">
-                <a16:creationId xmlns:a16="http://schemas.microsoft.com/office/drawing/2014/main" id="{046EBB68-A5D8-4D4C-9452-14B2FEBBFD8B}"/>
+                <a16:creationId xmlns:a16="http://schemas.microsoft.com/office/drawing/2014/main" id="{5F5DA5B6-9479-4D87-82E1-2F3D3A67F1DE}"/>
               </a:ext>
             </a:extLst>
           </p:cNvPr>
@@ -13656,7 +13679,7 @@
           <p:cNvPr id="19" name="">
             <a:extLst xmlns:a="http://schemas.openxmlformats.org/drawingml/2006/main">
               <a:ext uri="{FF2B5EF4-FFF2-40B4-BE49-F238E27FC236}">
-                <a16:creationId xmlns:a16="http://schemas.microsoft.com/office/drawing/2014/main" id="{5C1D1334-B793-4A89-B5E0-669310C25502}"/>
+                <a16:creationId xmlns:a16="http://schemas.microsoft.com/office/drawing/2014/main" id="{9216B858-B6AF-4340-A718-9128E4148838}"/>
               </a:ext>
             </a:extLst>
           </p:cNvPr>
@@ -13814,7 +13837,7 @@
           <p:cNvPr id="20" name="">
             <a:extLst xmlns:a="http://schemas.openxmlformats.org/drawingml/2006/main">
               <a:ext uri="{FF2B5EF4-FFF2-40B4-BE49-F238E27FC236}">
-                <a16:creationId xmlns:a16="http://schemas.microsoft.com/office/drawing/2014/main" id="{2A954D60-5361-4DCD-941B-49886A924FB1}"/>
+                <a16:creationId xmlns:a16="http://schemas.microsoft.com/office/drawing/2014/main" id="{A224C6E2-0A87-4750-963E-A4CED4A6AC2D}"/>
               </a:ext>
             </a:extLst>
           </p:cNvPr>
@@ -13972,7 +13995,7 @@
           <p:cNvPr id="21" name="">
             <a:extLst xmlns:a="http://schemas.openxmlformats.org/drawingml/2006/main">
               <a:ext uri="{FF2B5EF4-FFF2-40B4-BE49-F238E27FC236}">
-                <a16:creationId xmlns:a16="http://schemas.microsoft.com/office/drawing/2014/main" id="{FF973B10-FF55-456D-ADFD-CDD0499ABB01}"/>
+                <a16:creationId xmlns:a16="http://schemas.microsoft.com/office/drawing/2014/main" id="{CA5F01C0-DE76-4819-B31D-A8B1B7ECB006}"/>
               </a:ext>
             </a:extLst>
           </p:cNvPr>
@@ -14130,7 +14153,7 @@
           <p:cNvPr id="22" name="">
             <a:extLst xmlns:a="http://schemas.openxmlformats.org/drawingml/2006/main">
               <a:ext uri="{FF2B5EF4-FFF2-40B4-BE49-F238E27FC236}">
-                <a16:creationId xmlns:a16="http://schemas.microsoft.com/office/drawing/2014/main" id="{D7BF26E9-6A75-4576-8062-404A21AF5B91}"/>
+                <a16:creationId xmlns:a16="http://schemas.microsoft.com/office/drawing/2014/main" id="{75056AAA-A703-497D-B27E-1F8A54F2B2E3}"/>
               </a:ext>
             </a:extLst>
           </p:cNvPr>
@@ -14288,7 +14311,7 @@
           <p:cNvPr id="23" name="">
             <a:extLst xmlns:a="http://schemas.openxmlformats.org/drawingml/2006/main">
               <a:ext uri="{FF2B5EF4-FFF2-40B4-BE49-F238E27FC236}">
-                <a16:creationId xmlns:a16="http://schemas.microsoft.com/office/drawing/2014/main" id="{9B1C19E2-8CE6-4E15-A24A-DED706DB1FA2}"/>
+                <a16:creationId xmlns:a16="http://schemas.microsoft.com/office/drawing/2014/main" id="{D0638B88-97E1-4026-9571-5ECCE02B3F01}"/>
               </a:ext>
             </a:extLst>
           </p:cNvPr>
@@ -14446,7 +14469,7 @@
           <p:cNvPr id="24" name="">
             <a:extLst xmlns:a="http://schemas.openxmlformats.org/drawingml/2006/main">
               <a:ext uri="{FF2B5EF4-FFF2-40B4-BE49-F238E27FC236}">
-                <a16:creationId xmlns:a16="http://schemas.microsoft.com/office/drawing/2014/main" id="{0EFE2E2C-0E63-4819-B98E-66CE4C5BD503}"/>
+                <a16:creationId xmlns:a16="http://schemas.microsoft.com/office/drawing/2014/main" id="{B29B8CA0-D1E6-411A-93E5-1353267FDE71}"/>
               </a:ext>
             </a:extLst>
           </p:cNvPr>
@@ -14604,7 +14627,7 @@
           <p:cNvPr id="25" name="">
             <a:extLst xmlns:a="http://schemas.openxmlformats.org/drawingml/2006/main">
               <a:ext uri="{FF2B5EF4-FFF2-40B4-BE49-F238E27FC236}">
-                <a16:creationId xmlns:a16="http://schemas.microsoft.com/office/drawing/2014/main" id="{DD91793F-8854-43F7-AD4E-70A2DCB8ECC9}"/>
+                <a16:creationId xmlns:a16="http://schemas.microsoft.com/office/drawing/2014/main" id="{C168216A-47B0-49C6-A622-84E1CCE43F41}"/>
               </a:ext>
             </a:extLst>
           </p:cNvPr>
@@ -14762,7 +14785,7 @@
           <p:cNvPr id="26" name="">
             <a:extLst xmlns:a="http://schemas.openxmlformats.org/drawingml/2006/main">
               <a:ext uri="{FF2B5EF4-FFF2-40B4-BE49-F238E27FC236}">
-                <a16:creationId xmlns:a16="http://schemas.microsoft.com/office/drawing/2014/main" id="{D1955FE3-F33C-423E-BA42-C3E6D27BDCD6}"/>
+                <a16:creationId xmlns:a16="http://schemas.microsoft.com/office/drawing/2014/main" id="{254A164B-AFB5-4866-B578-4FAF1D74C5D9}"/>
               </a:ext>
             </a:extLst>
           </p:cNvPr>
@@ -14920,7 +14943,7 @@
           <p:cNvPr id="27" name="">
             <a:extLst xmlns:a="http://schemas.openxmlformats.org/drawingml/2006/main">
               <a:ext uri="{FF2B5EF4-FFF2-40B4-BE49-F238E27FC236}">
-                <a16:creationId xmlns:a16="http://schemas.microsoft.com/office/drawing/2014/main" id="{5C2B91F2-EC0F-436C-B1FB-8C9DC0015477}"/>
+                <a16:creationId xmlns:a16="http://schemas.microsoft.com/office/drawing/2014/main" id="{A1CA3584-0656-4FDD-A020-FC709CF05C50}"/>
               </a:ext>
             </a:extLst>
           </p:cNvPr>
@@ -15076,7 +15099,7 @@
     </p:spTree>
     <p:extLst>
       <p:ext uri="{BB962C8B-B14F-4D97-AF65-F5344CB8AC3E}">
-        <p14:creationId xmlns:p14="http://schemas.microsoft.com/office/powerpoint/2010/main" val="1339888652"/>
+        <p14:creationId xmlns:p14="http://schemas.microsoft.com/office/powerpoint/2010/main" val="971053774"/>
       </p:ext>
     </p:extLst>
   </p:cSld>
@@ -15107,7 +15130,7 @@
           <p:cNvPr id="11" name="">
             <a:extLst xmlns:a="http://schemas.openxmlformats.org/drawingml/2006/main">
               <a:ext uri="{FF2B5EF4-FFF2-40B4-BE49-F238E27FC236}">
-                <a16:creationId xmlns:a16="http://schemas.microsoft.com/office/drawing/2014/main" id="{0970811A-325D-46F4-854D-FC1F8AA1034D}"/>
+                <a16:creationId xmlns:a16="http://schemas.microsoft.com/office/drawing/2014/main" id="{8C542366-CA75-40AD-B27E-29E765C35190}"/>
               </a:ext>
             </a:extLst>
           </p:cNvPr>
@@ -15137,7 +15160,7 @@
           <p:cNvPr id="2" name="">
             <a:extLst xmlns:a="http://schemas.openxmlformats.org/drawingml/2006/main">
               <a:ext uri="{FF2B5EF4-FFF2-40B4-BE49-F238E27FC236}">
-                <a16:creationId xmlns:a16="http://schemas.microsoft.com/office/drawing/2014/main" id="{12387ED7-4C79-4D86-98C7-91911E15DA77}"/>
+                <a16:creationId xmlns:a16="http://schemas.microsoft.com/office/drawing/2014/main" id="{B8322954-7812-4FB8-A503-E7410A092F15}"/>
               </a:ext>
             </a:extLst>
           </p:cNvPr>
@@ -15295,7 +15318,7 @@
           <p:cNvPr id="3" name="">
             <a:extLst xmlns:a="http://schemas.openxmlformats.org/drawingml/2006/main">
               <a:ext uri="{FF2B5EF4-FFF2-40B4-BE49-F238E27FC236}">
-                <a16:creationId xmlns:a16="http://schemas.microsoft.com/office/drawing/2014/main" id="{1F2DC33A-7E19-4EA0-81FD-D6216D6B7C81}"/>
+                <a16:creationId xmlns:a16="http://schemas.microsoft.com/office/drawing/2014/main" id="{5AE1C8F2-E859-4806-AF07-D74512DC14B4}"/>
               </a:ext>
             </a:extLst>
           </p:cNvPr>
@@ -15453,7 +15476,7 @@
           <p:cNvPr id="4" name="">
             <a:extLst xmlns:a="http://schemas.openxmlformats.org/drawingml/2006/main">
               <a:ext uri="{FF2B5EF4-FFF2-40B4-BE49-F238E27FC236}">
-                <a16:creationId xmlns:a16="http://schemas.microsoft.com/office/drawing/2014/main" id="{2AA8F1C7-4EBB-45D2-BE8D-18DDFE6DDADE}"/>
+                <a16:creationId xmlns:a16="http://schemas.microsoft.com/office/drawing/2014/main" id="{B5F59320-B910-4DDF-8591-FE654D42B29A}"/>
               </a:ext>
             </a:extLst>
           </p:cNvPr>
@@ -15611,7 +15634,7 @@
           <p:cNvPr id="5" name="">
             <a:extLst xmlns:a="http://schemas.openxmlformats.org/drawingml/2006/main">
               <a:ext uri="{FF2B5EF4-FFF2-40B4-BE49-F238E27FC236}">
-                <a16:creationId xmlns:a16="http://schemas.microsoft.com/office/drawing/2014/main" id="{42F003F3-5DB7-42E3-9634-80520A8526EB}"/>
+                <a16:creationId xmlns:a16="http://schemas.microsoft.com/office/drawing/2014/main" id="{57F67159-FB52-4BEA-B2F0-11D1394F5906}"/>
               </a:ext>
             </a:extLst>
           </p:cNvPr>
@@ -15827,7 +15850,7 @@
           <p:cNvPr id="6" name="">
             <a:extLst xmlns:a="http://schemas.openxmlformats.org/drawingml/2006/main">
               <a:ext uri="{FF2B5EF4-FFF2-40B4-BE49-F238E27FC236}">
-                <a16:creationId xmlns:a16="http://schemas.microsoft.com/office/drawing/2014/main" id="{CB846D04-72F4-48E7-B920-56A23F99B273}"/>
+                <a16:creationId xmlns:a16="http://schemas.microsoft.com/office/drawing/2014/main" id="{A9C85F56-5C37-4B69-BFD1-F0AB660A264A}"/>
               </a:ext>
             </a:extLst>
           </p:cNvPr>
@@ -15985,7 +16008,7 @@
           <p:cNvPr id="7" name="">
             <a:extLst xmlns:a="http://schemas.openxmlformats.org/drawingml/2006/main">
               <a:ext uri="{FF2B5EF4-FFF2-40B4-BE49-F238E27FC236}">
-                <a16:creationId xmlns:a16="http://schemas.microsoft.com/office/drawing/2014/main" id="{6807BED9-FDA1-4A58-892F-A6EA6A97175C}"/>
+                <a16:creationId xmlns:a16="http://schemas.microsoft.com/office/drawing/2014/main" id="{DC8112E6-8B2B-4385-AF3A-9EBE7A3A3911}"/>
               </a:ext>
             </a:extLst>
           </p:cNvPr>
@@ -16201,7 +16224,7 @@
           <p:cNvPr id="8" name="">
             <a:extLst xmlns:a="http://schemas.openxmlformats.org/drawingml/2006/main">
               <a:ext uri="{FF2B5EF4-FFF2-40B4-BE49-F238E27FC236}">
-                <a16:creationId xmlns:a16="http://schemas.microsoft.com/office/drawing/2014/main" id="{A44AA109-EE20-4BEE-9E39-89568EDCCAA7}"/>
+                <a16:creationId xmlns:a16="http://schemas.microsoft.com/office/drawing/2014/main" id="{8177BD21-64BF-48F3-A288-0AE7726B573F}"/>
               </a:ext>
             </a:extLst>
           </p:cNvPr>
@@ -16359,7 +16382,7 @@
           <p:cNvPr id="9" name="">
             <a:extLst xmlns:a="http://schemas.openxmlformats.org/drawingml/2006/main">
               <a:ext uri="{FF2B5EF4-FFF2-40B4-BE49-F238E27FC236}">
-                <a16:creationId xmlns:a16="http://schemas.microsoft.com/office/drawing/2014/main" id="{94896AA7-67D0-4366-B9D2-3A2C823C0620}"/>
+                <a16:creationId xmlns:a16="http://schemas.microsoft.com/office/drawing/2014/main" id="{F3663902-A695-454C-B33E-4F4874AF0784}"/>
               </a:ext>
             </a:extLst>
           </p:cNvPr>
@@ -16575,7 +16598,7 @@
           <p:cNvPr id="10" name="">
             <a:extLst xmlns:a="http://schemas.openxmlformats.org/drawingml/2006/main">
               <a:ext uri="{FF2B5EF4-FFF2-40B4-BE49-F238E27FC236}">
-                <a16:creationId xmlns:a16="http://schemas.microsoft.com/office/drawing/2014/main" id="{AE3ABF47-1BC5-41FB-91C3-B22C85AB67CA}"/>
+                <a16:creationId xmlns:a16="http://schemas.microsoft.com/office/drawing/2014/main" id="{018077F5-96CC-44AF-9280-E3D196D91679}"/>
               </a:ext>
             </a:extLst>
           </p:cNvPr>
@@ -16723,7 +16746,7 @@
                 <a:ea typeface="Arial"/>
                 <a:cs typeface="Arial"/>
               </a:rPr>
-              <a:t>Testes de reprocessamento cobrem cenários específicos.</a:t>
+              <a:t>Regressões cobrem recuperação fora de ordem e estados finais.</a:t>
             </a:r>
           </a:p>
           <a:p xmlns:a="http://schemas.openxmlformats.org/drawingml/2006/main">
@@ -16746,7 +16769,7 @@
                 <a:ea typeface="Arial"/>
                 <a:cs typeface="Arial"/>
               </a:rPr>
-              <a:t>Convergência de eventos e coerência de estados têm defeitos conhecidos.</a:t>
+              <a:t>Falhas permanecem recuperáveis por retentativa ou reprocessamento explícito.</a:t>
             </a:r>
           </a:p>
         </p:txBody>
@@ -16754,7 +16777,7 @@
     </p:spTree>
     <p:extLst>
       <p:ext uri="{BB962C8B-B14F-4D97-AF65-F5344CB8AC3E}">
-        <p14:creationId xmlns:p14="http://schemas.microsoft.com/office/powerpoint/2010/main" val="810531046"/>
+        <p14:creationId xmlns:p14="http://schemas.microsoft.com/office/powerpoint/2010/main" val="1747552853"/>
       </p:ext>
     </p:extLst>
   </p:cSld>
@@ -16785,7 +16808,7 @@
           <p:cNvPr id="11" name="">
             <a:extLst xmlns:a="http://schemas.openxmlformats.org/drawingml/2006/main">
               <a:ext uri="{FF2B5EF4-FFF2-40B4-BE49-F238E27FC236}">
-                <a16:creationId xmlns:a16="http://schemas.microsoft.com/office/drawing/2014/main" id="{CD6D9C80-FAC1-4C4A-9374-1DB790868F1A}"/>
+                <a16:creationId xmlns:a16="http://schemas.microsoft.com/office/drawing/2014/main" id="{73B3B64C-A103-4000-9F25-C2376DA44B6D}"/>
               </a:ext>
             </a:extLst>
           </p:cNvPr>
@@ -16815,7 +16838,7 @@
           <p:cNvPr id="2" name="">
             <a:extLst xmlns:a="http://schemas.openxmlformats.org/drawingml/2006/main">
               <a:ext uri="{FF2B5EF4-FFF2-40B4-BE49-F238E27FC236}">
-                <a16:creationId xmlns:a16="http://schemas.microsoft.com/office/drawing/2014/main" id="{2329900D-2D89-4580-AFB5-01899407E497}"/>
+                <a16:creationId xmlns:a16="http://schemas.microsoft.com/office/drawing/2014/main" id="{0EF988D9-1C71-429D-A050-E4F3B584C6C5}"/>
               </a:ext>
             </a:extLst>
           </p:cNvPr>
@@ -16973,7 +16996,7 @@
           <p:cNvPr id="3" name="">
             <a:extLst xmlns:a="http://schemas.openxmlformats.org/drawingml/2006/main">
               <a:ext uri="{FF2B5EF4-FFF2-40B4-BE49-F238E27FC236}">
-                <a16:creationId xmlns:a16="http://schemas.microsoft.com/office/drawing/2014/main" id="{7A903CAF-104F-4B97-A567-100FEA7FA3A6}"/>
+                <a16:creationId xmlns:a16="http://schemas.microsoft.com/office/drawing/2014/main" id="{2AF86A2C-E851-487B-B0D9-B056993A2DBE}"/>
               </a:ext>
             </a:extLst>
           </p:cNvPr>
@@ -17131,7 +17154,7 @@
           <p:cNvPr id="4" name="">
             <a:extLst xmlns:a="http://schemas.openxmlformats.org/drawingml/2006/main">
               <a:ext uri="{FF2B5EF4-FFF2-40B4-BE49-F238E27FC236}">
-                <a16:creationId xmlns:a16="http://schemas.microsoft.com/office/drawing/2014/main" id="{66668094-FD7C-4058-BA05-44207BDBE898}"/>
+                <a16:creationId xmlns:a16="http://schemas.microsoft.com/office/drawing/2014/main" id="{181A78B9-F96D-4426-AB51-29062316FDE6}"/>
               </a:ext>
             </a:extLst>
           </p:cNvPr>
@@ -17289,7 +17312,7 @@
           <p:cNvPr id="5" name="">
             <a:extLst xmlns:a="http://schemas.openxmlformats.org/drawingml/2006/main">
               <a:ext uri="{FF2B5EF4-FFF2-40B4-BE49-F238E27FC236}">
-                <a16:creationId xmlns:a16="http://schemas.microsoft.com/office/drawing/2014/main" id="{70AEF803-B012-4005-B3C3-1323DB2E0010}"/>
+                <a16:creationId xmlns:a16="http://schemas.microsoft.com/office/drawing/2014/main" id="{AF15E67D-BC30-4DBD-9F5F-644DC4DC0C9A}"/>
               </a:ext>
             </a:extLst>
           </p:cNvPr>
@@ -17505,7 +17528,7 @@
           <p:cNvPr id="6" name="">
             <a:extLst xmlns:a="http://schemas.openxmlformats.org/drawingml/2006/main">
               <a:ext uri="{FF2B5EF4-FFF2-40B4-BE49-F238E27FC236}">
-                <a16:creationId xmlns:a16="http://schemas.microsoft.com/office/drawing/2014/main" id="{3F2440A0-BC19-40B7-BBAF-B0E6CB39CE93}"/>
+                <a16:creationId xmlns:a16="http://schemas.microsoft.com/office/drawing/2014/main" id="{DDD9D129-5A0E-46A7-9390-19B4074527C0}"/>
               </a:ext>
             </a:extLst>
           </p:cNvPr>
@@ -17663,7 +17686,7 @@
           <p:cNvPr id="7" name="">
             <a:extLst xmlns:a="http://schemas.openxmlformats.org/drawingml/2006/main">
               <a:ext uri="{FF2B5EF4-FFF2-40B4-BE49-F238E27FC236}">
-                <a16:creationId xmlns:a16="http://schemas.microsoft.com/office/drawing/2014/main" id="{4481CC70-6981-49C6-A081-35D65C527CB3}"/>
+                <a16:creationId xmlns:a16="http://schemas.microsoft.com/office/drawing/2014/main" id="{9545B7CE-17E1-46E4-8CE1-CB5BBE11AB80}"/>
               </a:ext>
             </a:extLst>
           </p:cNvPr>
@@ -17879,7 +17902,7 @@
           <p:cNvPr id="8" name="">
             <a:extLst xmlns:a="http://schemas.openxmlformats.org/drawingml/2006/main">
               <a:ext uri="{FF2B5EF4-FFF2-40B4-BE49-F238E27FC236}">
-                <a16:creationId xmlns:a16="http://schemas.microsoft.com/office/drawing/2014/main" id="{3DF71525-0691-4737-95D1-44DC446DACF0}"/>
+                <a16:creationId xmlns:a16="http://schemas.microsoft.com/office/drawing/2014/main" id="{B3F191DB-5BFF-478C-B51B-E16BE158283E}"/>
               </a:ext>
             </a:extLst>
           </p:cNvPr>
@@ -18037,7 +18060,7 @@
           <p:cNvPr id="9" name="">
             <a:extLst xmlns:a="http://schemas.openxmlformats.org/drawingml/2006/main">
               <a:ext uri="{FF2B5EF4-FFF2-40B4-BE49-F238E27FC236}">
-                <a16:creationId xmlns:a16="http://schemas.microsoft.com/office/drawing/2014/main" id="{12F842B8-BF31-494B-93EC-E9222FC76F17}"/>
+                <a16:creationId xmlns:a16="http://schemas.microsoft.com/office/drawing/2014/main" id="{A07ED06C-C097-4D11-BF85-F0A49CCC4B0F}"/>
               </a:ext>
             </a:extLst>
           </p:cNvPr>
@@ -18253,7 +18276,7 @@
           <p:cNvPr id="10" name="">
             <a:extLst xmlns:a="http://schemas.openxmlformats.org/drawingml/2006/main">
               <a:ext uri="{FF2B5EF4-FFF2-40B4-BE49-F238E27FC236}">
-                <a16:creationId xmlns:a16="http://schemas.microsoft.com/office/drawing/2014/main" id="{FE9C2E4E-6BDD-4238-A24B-B9C8A3AD16FF}"/>
+                <a16:creationId xmlns:a16="http://schemas.microsoft.com/office/drawing/2014/main" id="{9BD83306-7D93-4192-B2BE-B834AE5EECBD}"/>
               </a:ext>
             </a:extLst>
           </p:cNvPr>
@@ -18409,7 +18432,7 @@
     </p:spTree>
     <p:extLst>
       <p:ext uri="{BB962C8B-B14F-4D97-AF65-F5344CB8AC3E}">
-        <p14:creationId xmlns:p14="http://schemas.microsoft.com/office/powerpoint/2010/main" val="1195748721"/>
+        <p14:creationId xmlns:p14="http://schemas.microsoft.com/office/powerpoint/2010/main" val="99317416"/>
       </p:ext>
     </p:extLst>
   </p:cSld>
@@ -18440,7 +18463,7 @@
           <p:cNvPr id="9" name="">
             <a:extLst xmlns:a="http://schemas.openxmlformats.org/drawingml/2006/main">
               <a:ext uri="{FF2B5EF4-FFF2-40B4-BE49-F238E27FC236}">
-                <a16:creationId xmlns:a16="http://schemas.microsoft.com/office/drawing/2014/main" id="{FE56AEB4-1D95-48E9-8CA2-867DAF29CB58}"/>
+                <a16:creationId xmlns:a16="http://schemas.microsoft.com/office/drawing/2014/main" id="{B2B64A3A-2B20-4ED0-A3BC-36BA44FEE1ED}"/>
               </a:ext>
             </a:extLst>
           </p:cNvPr>
@@ -18470,7 +18493,7 @@
           <p:cNvPr id="2" name="">
             <a:extLst xmlns:a="http://schemas.openxmlformats.org/drawingml/2006/main">
               <a:ext uri="{FF2B5EF4-FFF2-40B4-BE49-F238E27FC236}">
-                <a16:creationId xmlns:a16="http://schemas.microsoft.com/office/drawing/2014/main" id="{ABD19A29-E102-4215-A00A-B1CB8E48D7F6}"/>
+                <a16:creationId xmlns:a16="http://schemas.microsoft.com/office/drawing/2014/main" id="{38FFCB0E-04B5-43FC-B171-CEAF8EDB9A32}"/>
               </a:ext>
             </a:extLst>
           </p:cNvPr>
@@ -18628,7 +18651,7 @@
           <p:cNvPr id="3" name="">
             <a:extLst xmlns:a="http://schemas.openxmlformats.org/drawingml/2006/main">
               <a:ext uri="{FF2B5EF4-FFF2-40B4-BE49-F238E27FC236}">
-                <a16:creationId xmlns:a16="http://schemas.microsoft.com/office/drawing/2014/main" id="{2F5C8602-8FD5-4279-B47A-3E9724A608E0}"/>
+                <a16:creationId xmlns:a16="http://schemas.microsoft.com/office/drawing/2014/main" id="{42B8CF28-8A4E-4602-A9F2-1517702BD67F}"/>
               </a:ext>
             </a:extLst>
           </p:cNvPr>
@@ -18786,7 +18809,7 @@
           <p:cNvPr id="4" name="">
             <a:extLst xmlns:a="http://schemas.openxmlformats.org/drawingml/2006/main">
               <a:ext uri="{FF2B5EF4-FFF2-40B4-BE49-F238E27FC236}">
-                <a16:creationId xmlns:a16="http://schemas.microsoft.com/office/drawing/2014/main" id="{096A8522-EE7B-42CB-A0E1-88D83B2ACA35}"/>
+                <a16:creationId xmlns:a16="http://schemas.microsoft.com/office/drawing/2014/main" id="{F1BD19F4-5EE3-4D8E-BE37-97124E62DD4C}"/>
               </a:ext>
             </a:extLst>
           </p:cNvPr>
@@ -18944,7 +18967,7 @@
           <p:cNvPr id="5" name="">
             <a:extLst xmlns:a="http://schemas.openxmlformats.org/drawingml/2006/main">
               <a:ext uri="{FF2B5EF4-FFF2-40B4-BE49-F238E27FC236}">
-                <a16:creationId xmlns:a16="http://schemas.microsoft.com/office/drawing/2014/main" id="{CEDC8CAC-8ABF-40B3-BE0C-BFBBFE821317}"/>
+                <a16:creationId xmlns:a16="http://schemas.microsoft.com/office/drawing/2014/main" id="{691BA3B1-3BC9-4C95-8AA8-71BCA979535C}"/>
               </a:ext>
             </a:extLst>
           </p:cNvPr>
@@ -19187,7 +19210,7 @@
           <p:cNvPr id="6" name="">
             <a:extLst xmlns:a="http://schemas.openxmlformats.org/drawingml/2006/main">
               <a:ext uri="{FF2B5EF4-FFF2-40B4-BE49-F238E27FC236}">
-                <a16:creationId xmlns:a16="http://schemas.microsoft.com/office/drawing/2014/main" id="{56B6FD06-3FC3-4C94-9568-DE1E8F49B809}"/>
+                <a16:creationId xmlns:a16="http://schemas.microsoft.com/office/drawing/2014/main" id="{B5D025E3-5987-4703-80BB-45C427C3EFA3}"/>
               </a:ext>
             </a:extLst>
           </p:cNvPr>
@@ -19345,7 +19368,7 @@
           <p:cNvPr id="7" name="">
             <a:extLst xmlns:a="http://schemas.openxmlformats.org/drawingml/2006/main">
               <a:ext uri="{FF2B5EF4-FFF2-40B4-BE49-F238E27FC236}">
-                <a16:creationId xmlns:a16="http://schemas.microsoft.com/office/drawing/2014/main" id="{54AC997F-A0FE-4F3D-8624-65F01D7AB2A8}"/>
+                <a16:creationId xmlns:a16="http://schemas.microsoft.com/office/drawing/2014/main" id="{0E132C86-FC6E-40A9-86F0-7F9DF98086AE}"/>
               </a:ext>
             </a:extLst>
           </p:cNvPr>
@@ -19588,7 +19611,7 @@
           <p:cNvPr id="8" name="">
             <a:extLst xmlns:a="http://schemas.openxmlformats.org/drawingml/2006/main">
               <a:ext uri="{FF2B5EF4-FFF2-40B4-BE49-F238E27FC236}">
-                <a16:creationId xmlns:a16="http://schemas.microsoft.com/office/drawing/2014/main" id="{39CEC7AE-EFE3-444B-BDE1-C1E42862ABD4}"/>
+                <a16:creationId xmlns:a16="http://schemas.microsoft.com/office/drawing/2014/main" id="{4824ED5F-873C-443C-9EB1-ED45EE453488}"/>
               </a:ext>
             </a:extLst>
           </p:cNvPr>
@@ -19767,7 +19790,7 @@
     </p:spTree>
     <p:extLst>
       <p:ext uri="{BB962C8B-B14F-4D97-AF65-F5344CB8AC3E}">
-        <p14:creationId xmlns:p14="http://schemas.microsoft.com/office/powerpoint/2010/main" val="1472350016"/>
+        <p14:creationId xmlns:p14="http://schemas.microsoft.com/office/powerpoint/2010/main" val="867088316"/>
       </p:ext>
     </p:extLst>
   </p:cSld>
@@ -19798,7 +19821,7 @@
           <p:cNvPr id="9" name="">
             <a:extLst xmlns:a="http://schemas.openxmlformats.org/drawingml/2006/main">
               <a:ext uri="{FF2B5EF4-FFF2-40B4-BE49-F238E27FC236}">
-                <a16:creationId xmlns:a16="http://schemas.microsoft.com/office/drawing/2014/main" id="{CF2092BF-7F5C-4EB3-A6CB-C54E9500F867}"/>
+                <a16:creationId xmlns:a16="http://schemas.microsoft.com/office/drawing/2014/main" id="{A281C31D-F9DF-4CBF-8BC7-5F64E4F4103E}"/>
               </a:ext>
             </a:extLst>
           </p:cNvPr>
@@ -19828,7 +19851,7 @@
           <p:cNvPr id="2" name="">
             <a:extLst xmlns:a="http://schemas.openxmlformats.org/drawingml/2006/main">
               <a:ext uri="{FF2B5EF4-FFF2-40B4-BE49-F238E27FC236}">
-                <a16:creationId xmlns:a16="http://schemas.microsoft.com/office/drawing/2014/main" id="{9CAC1357-2E17-4B9C-98F1-8509340D4DCB}"/>
+                <a16:creationId xmlns:a16="http://schemas.microsoft.com/office/drawing/2014/main" id="{8145D540-06F8-440C-A193-761B38997B4A}"/>
               </a:ext>
             </a:extLst>
           </p:cNvPr>
@@ -19986,7 +20009,7 @@
           <p:cNvPr id="3" name="">
             <a:extLst xmlns:a="http://schemas.openxmlformats.org/drawingml/2006/main">
               <a:ext uri="{FF2B5EF4-FFF2-40B4-BE49-F238E27FC236}">
-                <a16:creationId xmlns:a16="http://schemas.microsoft.com/office/drawing/2014/main" id="{D62E6A57-4F2E-413D-973A-1B59182B0E36}"/>
+                <a16:creationId xmlns:a16="http://schemas.microsoft.com/office/drawing/2014/main" id="{F6F40B37-7B7A-4651-BEC1-3956C19FB131}"/>
               </a:ext>
             </a:extLst>
           </p:cNvPr>
@@ -20144,7 +20167,7 @@
           <p:cNvPr id="4" name="">
             <a:extLst xmlns:a="http://schemas.openxmlformats.org/drawingml/2006/main">
               <a:ext uri="{FF2B5EF4-FFF2-40B4-BE49-F238E27FC236}">
-                <a16:creationId xmlns:a16="http://schemas.microsoft.com/office/drawing/2014/main" id="{B86D6615-E61F-4043-ACD3-074A7E299C2D}"/>
+                <a16:creationId xmlns:a16="http://schemas.microsoft.com/office/drawing/2014/main" id="{7E368321-6D83-42E4-A7E7-755A6F8DF465}"/>
               </a:ext>
             </a:extLst>
           </p:cNvPr>
@@ -20302,7 +20325,7 @@
           <p:cNvPr id="5" name="">
             <a:extLst xmlns:a="http://schemas.openxmlformats.org/drawingml/2006/main">
               <a:ext uri="{FF2B5EF4-FFF2-40B4-BE49-F238E27FC236}">
-                <a16:creationId xmlns:a16="http://schemas.microsoft.com/office/drawing/2014/main" id="{70064C00-D92A-4F6E-B267-CBC13773D03A}"/>
+                <a16:creationId xmlns:a16="http://schemas.microsoft.com/office/drawing/2014/main" id="{9D773938-6CD3-4CC2-BC19-5ABC67646DE9}"/>
               </a:ext>
             </a:extLst>
           </p:cNvPr>
@@ -20508,7 +20531,7 @@
                 <a:ea typeface="Arial"/>
                 <a:cs typeface="Arial"/>
               </a:rPr>
-              <a:t>Testes aprovados não garantem convergência em todos os casos</a:t>
+              <a:t>Regressões cobrem recuperação e estados finais</a:t>
             </a:r>
           </a:p>
         </p:txBody>
@@ -20518,7 +20541,7 @@
           <p:cNvPr id="6" name="">
             <a:extLst xmlns:a="http://schemas.openxmlformats.org/drawingml/2006/main">
               <a:ext uri="{FF2B5EF4-FFF2-40B4-BE49-F238E27FC236}">
-                <a16:creationId xmlns:a16="http://schemas.microsoft.com/office/drawing/2014/main" id="{3385B796-BD95-4023-8DB6-C1B76F8EF958}"/>
+                <a16:creationId xmlns:a16="http://schemas.microsoft.com/office/drawing/2014/main" id="{1041FD32-59BE-4494-9646-7FBE10560535}"/>
               </a:ext>
             </a:extLst>
           </p:cNvPr>
@@ -20676,7 +20699,7 @@
           <p:cNvPr id="7" name="">
             <a:extLst xmlns:a="http://schemas.openxmlformats.org/drawingml/2006/main">
               <a:ext uri="{FF2B5EF4-FFF2-40B4-BE49-F238E27FC236}">
-                <a16:creationId xmlns:a16="http://schemas.microsoft.com/office/drawing/2014/main" id="{6133BBD3-E51D-4D0A-9296-0FB6F0DD9D00}"/>
+                <a16:creationId xmlns:a16="http://schemas.microsoft.com/office/drawing/2014/main" id="{B8BB2A3B-77AE-4AA2-91D4-19B704E563FC}"/>
               </a:ext>
             </a:extLst>
           </p:cNvPr>
@@ -20828,7 +20851,7 @@
                 <a:ea typeface="Arial"/>
                 <a:cs typeface="Arial"/>
               </a:rPr>
-              <a:t>F3 pode permanecer STARTED após resolução</a:t>
+              <a:t>F3 aguarda a abertura e permite reprocessamento</a:t>
             </a:r>
           </a:p>
           <a:p xmlns:a="http://schemas.openxmlformats.org/drawingml/2006/main">
@@ -20855,7 +20878,7 @@
                 <a:ea typeface="Arial"/>
                 <a:cs typeface="Arial"/>
               </a:rPr>
-              <a:t>Processo COMPLETED pode ter tarefa CANCELLED</a:t>
+              <a:t>Processo respeita o agregado das tarefas</a:t>
             </a:r>
           </a:p>
           <a:p xmlns:a="http://schemas.openxmlformats.org/drawingml/2006/main">
@@ -20882,7 +20905,7 @@
                 <a:ea typeface="Arial"/>
                 <a:cs typeface="Arial"/>
               </a:rPr>
-              <a:t>Fatura exibida OVERDUE pode ser cancelada</a:t>
+              <a:t>Fatura vencida não aceita cancelamento</a:t>
             </a:r>
           </a:p>
           <a:p xmlns:a="http://schemas.openxmlformats.org/drawingml/2006/main">
@@ -20909,7 +20932,7 @@
                 <a:ea typeface="Arial"/>
                 <a:cs typeface="Arial"/>
               </a:rPr>
-              <a:t>Nomes e contribuições individuais pendentes</a:t>
+              <a:t>Roger Quinelato e Raquel: autoria preenchida</a:t>
             </a:r>
           </a:p>
         </p:txBody>
@@ -20919,7 +20942,7 @@
           <p:cNvPr id="8" name="">
             <a:extLst xmlns:a="http://schemas.openxmlformats.org/drawingml/2006/main">
               <a:ext uri="{FF2B5EF4-FFF2-40B4-BE49-F238E27FC236}">
-                <a16:creationId xmlns:a16="http://schemas.microsoft.com/office/drawing/2014/main" id="{15A0E840-E4C6-48A6-BC48-5C42CCB5A79F}"/>
+                <a16:creationId xmlns:a16="http://schemas.microsoft.com/office/drawing/2014/main" id="{D01B77BF-31C0-45F1-8C3C-2FDDB8C2AA3E}"/>
               </a:ext>
             </a:extLst>
           </p:cNvPr>
@@ -21098,7 +21121,7 @@
     </p:spTree>
     <p:extLst>
       <p:ext uri="{BB962C8B-B14F-4D97-AF65-F5344CB8AC3E}">
-        <p14:creationId xmlns:p14="http://schemas.microsoft.com/office/powerpoint/2010/main" val="517809180"/>
+        <p14:creationId xmlns:p14="http://schemas.microsoft.com/office/powerpoint/2010/main" val="891064582"/>
       </p:ext>
     </p:extLst>
   </p:cSld>
@@ -21129,7 +21152,7 @@
           <p:cNvPr id="10" name="">
             <a:extLst xmlns:a="http://schemas.openxmlformats.org/drawingml/2006/main">
               <a:ext uri="{FF2B5EF4-FFF2-40B4-BE49-F238E27FC236}">
-                <a16:creationId xmlns:a16="http://schemas.microsoft.com/office/drawing/2014/main" id="{E0335C8B-E43F-4222-8607-B6FC71731678}"/>
+                <a16:creationId xmlns:a16="http://schemas.microsoft.com/office/drawing/2014/main" id="{A729199B-0D7C-4073-BE01-5316BD5DB9E8}"/>
               </a:ext>
             </a:extLst>
           </p:cNvPr>
@@ -21159,7 +21182,7 @@
           <p:cNvPr id="2" name="">
             <a:extLst xmlns:a="http://schemas.openxmlformats.org/drawingml/2006/main">
               <a:ext uri="{FF2B5EF4-FFF2-40B4-BE49-F238E27FC236}">
-                <a16:creationId xmlns:a16="http://schemas.microsoft.com/office/drawing/2014/main" id="{C5EBA234-595C-4C62-9105-C2D34E56C00D}"/>
+                <a16:creationId xmlns:a16="http://schemas.microsoft.com/office/drawing/2014/main" id="{8FF22229-C8DA-4D79-B152-407D4B5823EC}"/>
               </a:ext>
             </a:extLst>
           </p:cNvPr>
@@ -21317,7 +21340,7 @@
           <p:cNvPr id="3" name="">
             <a:extLst xmlns:a="http://schemas.openxmlformats.org/drawingml/2006/main">
               <a:ext uri="{FF2B5EF4-FFF2-40B4-BE49-F238E27FC236}">
-                <a16:creationId xmlns:a16="http://schemas.microsoft.com/office/drawing/2014/main" id="{237B0CFB-0788-4324-9A8E-0C06F85229D8}"/>
+                <a16:creationId xmlns:a16="http://schemas.microsoft.com/office/drawing/2014/main" id="{D9756849-E03C-4BF5-9ED1-FF68DF236A01}"/>
               </a:ext>
             </a:extLst>
           </p:cNvPr>
@@ -21475,7 +21498,7 @@
           <p:cNvPr id="4" name="">
             <a:extLst xmlns:a="http://schemas.openxmlformats.org/drawingml/2006/main">
               <a:ext uri="{FF2B5EF4-FFF2-40B4-BE49-F238E27FC236}">
-                <a16:creationId xmlns:a16="http://schemas.microsoft.com/office/drawing/2014/main" id="{CBD8D149-7B95-4B7F-9D93-C2BAB1795A67}"/>
+                <a16:creationId xmlns:a16="http://schemas.microsoft.com/office/drawing/2014/main" id="{AECC6C73-1ABE-482C-8F6F-8F790D6F81E7}"/>
               </a:ext>
             </a:extLst>
           </p:cNvPr>
@@ -21718,7 +21741,7 @@
           <p:cNvPr id="5" name="">
             <a:extLst xmlns:a="http://schemas.openxmlformats.org/drawingml/2006/main">
               <a:ext uri="{FF2B5EF4-FFF2-40B4-BE49-F238E27FC236}">
-                <a16:creationId xmlns:a16="http://schemas.microsoft.com/office/drawing/2014/main" id="{3AD8A57F-039E-4B1F-8F5C-94452F937C79}"/>
+                <a16:creationId xmlns:a16="http://schemas.microsoft.com/office/drawing/2014/main" id="{E4AD27AF-29AE-413B-8E63-4879CE4426E2}"/>
               </a:ext>
             </a:extLst>
           </p:cNvPr>
@@ -21883,7 +21906,7 @@
           <p:cNvPr id="6" name="">
             <a:extLst xmlns:a="http://schemas.openxmlformats.org/drawingml/2006/main">
               <a:ext uri="{FF2B5EF4-FFF2-40B4-BE49-F238E27FC236}">
-                <a16:creationId xmlns:a16="http://schemas.microsoft.com/office/drawing/2014/main" id="{B3691AFD-7A20-48DE-A2C0-C9B2AAC6B88E}"/>
+                <a16:creationId xmlns:a16="http://schemas.microsoft.com/office/drawing/2014/main" id="{4F5E2B0E-B3E7-4C6E-B3A3-F5C1F2FF3F08}"/>
               </a:ext>
             </a:extLst>
           </p:cNvPr>
@@ -22048,7 +22071,7 @@
           <p:cNvPr id="7" name="">
             <a:extLst xmlns:a="http://schemas.openxmlformats.org/drawingml/2006/main">
               <a:ext uri="{FF2B5EF4-FFF2-40B4-BE49-F238E27FC236}">
-                <a16:creationId xmlns:a16="http://schemas.microsoft.com/office/drawing/2014/main" id="{DB38D867-BDD1-40A3-92D2-BB67F4BC18B5}"/>
+                <a16:creationId xmlns:a16="http://schemas.microsoft.com/office/drawing/2014/main" id="{E416FCEC-C2A3-4B05-BBE5-BE2208A1362A}"/>
               </a:ext>
             </a:extLst>
           </p:cNvPr>
@@ -22213,7 +22236,7 @@
           <p:cNvPr id="8" name="">
             <a:extLst xmlns:a="http://schemas.openxmlformats.org/drawingml/2006/main">
               <a:ext uri="{FF2B5EF4-FFF2-40B4-BE49-F238E27FC236}">
-                <a16:creationId xmlns:a16="http://schemas.microsoft.com/office/drawing/2014/main" id="{7F72EE14-BE14-459F-9105-FEDDA616AA61}"/>
+                <a16:creationId xmlns:a16="http://schemas.microsoft.com/office/drawing/2014/main" id="{B8CCA3AD-1FB4-45C0-A919-8930A0F30DDE}"/>
               </a:ext>
             </a:extLst>
           </p:cNvPr>
@@ -22378,7 +22401,7 @@
           <p:cNvPr id="9" name="">
             <a:extLst xmlns:a="http://schemas.openxmlformats.org/drawingml/2006/main">
               <a:ext uri="{FF2B5EF4-FFF2-40B4-BE49-F238E27FC236}">
-                <a16:creationId xmlns:a16="http://schemas.microsoft.com/office/drawing/2014/main" id="{FC3228AD-4249-46D3-876B-907D36D323CD}"/>
+                <a16:creationId xmlns:a16="http://schemas.microsoft.com/office/drawing/2014/main" id="{7153BF96-D821-4DCF-AAA1-86B5EE2E72BA}"/>
               </a:ext>
             </a:extLst>
           </p:cNvPr>
@@ -22541,7 +22564,7 @@
     </p:spTree>
     <p:extLst>
       <p:ext uri="{BB962C8B-B14F-4D97-AF65-F5344CB8AC3E}">
-        <p14:creationId xmlns:p14="http://schemas.microsoft.com/office/powerpoint/2010/main" val="1337664166"/>
+        <p14:creationId xmlns:p14="http://schemas.microsoft.com/office/powerpoint/2010/main" val="2110506220"/>
       </p:ext>
     </p:extLst>
   </p:cSld>
@@ -22572,7 +22595,7 @@
           <p:cNvPr id="7" name="">
             <a:extLst xmlns:a="http://schemas.openxmlformats.org/drawingml/2006/main">
               <a:ext uri="{FF2B5EF4-FFF2-40B4-BE49-F238E27FC236}">
-                <a16:creationId xmlns:a16="http://schemas.microsoft.com/office/drawing/2014/main" id="{97EA82A6-C1DB-4580-B3C3-DEB9ECEF3B19}"/>
+                <a16:creationId xmlns:a16="http://schemas.microsoft.com/office/drawing/2014/main" id="{81CA6177-A006-46AA-833F-32CFA53A57EA}"/>
               </a:ext>
             </a:extLst>
           </p:cNvPr>
@@ -22602,7 +22625,7 @@
           <p:cNvPr id="2" name="">
             <a:extLst xmlns:a="http://schemas.openxmlformats.org/drawingml/2006/main">
               <a:ext uri="{FF2B5EF4-FFF2-40B4-BE49-F238E27FC236}">
-                <a16:creationId xmlns:a16="http://schemas.microsoft.com/office/drawing/2014/main" id="{F0414E2E-8BD6-45BC-8A82-AFF47486FD88}"/>
+                <a16:creationId xmlns:a16="http://schemas.microsoft.com/office/drawing/2014/main" id="{1584A404-D6ED-48E3-BE90-F45C36303AEE}"/>
               </a:ext>
             </a:extLst>
           </p:cNvPr>
@@ -22760,7 +22783,7 @@
           <p:cNvPr id="3" name="">
             <a:extLst xmlns:a="http://schemas.openxmlformats.org/drawingml/2006/main">
               <a:ext uri="{FF2B5EF4-FFF2-40B4-BE49-F238E27FC236}">
-                <a16:creationId xmlns:a16="http://schemas.microsoft.com/office/drawing/2014/main" id="{B420374A-252C-4EF7-87E4-71DB9AB896C8}"/>
+                <a16:creationId xmlns:a16="http://schemas.microsoft.com/office/drawing/2014/main" id="{D25D91BD-9C20-4987-A3F7-E6FB362DDB80}"/>
               </a:ext>
             </a:extLst>
           </p:cNvPr>
@@ -22918,7 +22941,7 @@
           <p:cNvPr id="4" name="">
             <a:extLst xmlns:a="http://schemas.openxmlformats.org/drawingml/2006/main">
               <a:ext uri="{FF2B5EF4-FFF2-40B4-BE49-F238E27FC236}">
-                <a16:creationId xmlns:a16="http://schemas.microsoft.com/office/drawing/2014/main" id="{AF232A1D-FF4C-4CA8-8D80-1CA9A92C296B}"/>
+                <a16:creationId xmlns:a16="http://schemas.microsoft.com/office/drawing/2014/main" id="{D4A54234-01ED-4877-BCF7-82154F223D79}"/>
               </a:ext>
             </a:extLst>
           </p:cNvPr>
@@ -23076,7 +23099,7 @@
           <p:cNvPr id="5" name="">
             <a:extLst xmlns:a="http://schemas.openxmlformats.org/drawingml/2006/main">
               <a:ext uri="{FF2B5EF4-FFF2-40B4-BE49-F238E27FC236}">
-                <a16:creationId xmlns:a16="http://schemas.microsoft.com/office/drawing/2014/main" id="{C8E56E33-948A-4F71-8B17-343D6C500A58}"/>
+                <a16:creationId xmlns:a16="http://schemas.microsoft.com/office/drawing/2014/main" id="{3C6EAD13-2D80-48D0-8BED-BE04AEE04B65}"/>
               </a:ext>
             </a:extLst>
           </p:cNvPr>
@@ -23086,7 +23109,7 @@
           <p:nvPr/>
         </p:nvPicPr>
         <p:blipFill>
-          <a:blip xmlns:r="http://schemas.openxmlformats.org/officeDocument/2006/relationships" xmlns:a="http://schemas.openxmlformats.org/drawingml/2006/main" r:embed="R442d3fdbdb804d02"/>
+          <a:blip xmlns:r="http://schemas.openxmlformats.org/officeDocument/2006/relationships" xmlns:a="http://schemas.openxmlformats.org/drawingml/2006/main" r:embed="R5d559bf6cc6a4ef0"/>
           <a:stretch xmlns:a="http://schemas.openxmlformats.org/drawingml/2006/main"/>
         </p:blipFill>
         <p:spPr>
@@ -23104,7 +23127,7 @@
           <p:cNvPr id="6" name="">
             <a:extLst xmlns:a="http://schemas.openxmlformats.org/drawingml/2006/main">
               <a:ext uri="{FF2B5EF4-FFF2-40B4-BE49-F238E27FC236}">
-                <a16:creationId xmlns:a16="http://schemas.microsoft.com/office/drawing/2014/main" id="{F79936A9-56F9-4FD1-8DFA-DF65F8218652}"/>
+                <a16:creationId xmlns:a16="http://schemas.microsoft.com/office/drawing/2014/main" id="{1FFABC91-902C-4359-8DB3-2D2FCDB7E7C8}"/>
               </a:ext>
             </a:extLst>
           </p:cNvPr>
@@ -23260,7 +23283,7 @@
     </p:spTree>
     <p:extLst>
       <p:ext uri="{BB962C8B-B14F-4D97-AF65-F5344CB8AC3E}">
-        <p14:creationId xmlns:p14="http://schemas.microsoft.com/office/powerpoint/2010/main" val="398864758"/>
+        <p14:creationId xmlns:p14="http://schemas.microsoft.com/office/powerpoint/2010/main" val="2085770446"/>
       </p:ext>
     </p:extLst>
   </p:cSld>
@@ -23291,7 +23314,7 @@
           <p:cNvPr id="7" name="">
             <a:extLst xmlns:a="http://schemas.openxmlformats.org/drawingml/2006/main">
               <a:ext uri="{FF2B5EF4-FFF2-40B4-BE49-F238E27FC236}">
-                <a16:creationId xmlns:a16="http://schemas.microsoft.com/office/drawing/2014/main" id="{886102EE-96FA-47D9-BF09-9BD7449EDD21}"/>
+                <a16:creationId xmlns:a16="http://schemas.microsoft.com/office/drawing/2014/main" id="{72D0320C-A6B9-404F-8BA9-46C98C0AB942}"/>
               </a:ext>
             </a:extLst>
           </p:cNvPr>
@@ -23321,7 +23344,7 @@
           <p:cNvPr id="2" name="">
             <a:extLst xmlns:a="http://schemas.openxmlformats.org/drawingml/2006/main">
               <a:ext uri="{FF2B5EF4-FFF2-40B4-BE49-F238E27FC236}">
-                <a16:creationId xmlns:a16="http://schemas.microsoft.com/office/drawing/2014/main" id="{11F66293-8AC4-47BB-8278-AC6C4A3B8603}"/>
+                <a16:creationId xmlns:a16="http://schemas.microsoft.com/office/drawing/2014/main" id="{8C462DDC-9C83-4269-9B70-492403B6DB03}"/>
               </a:ext>
             </a:extLst>
           </p:cNvPr>
@@ -23479,7 +23502,7 @@
           <p:cNvPr id="3" name="">
             <a:extLst xmlns:a="http://schemas.openxmlformats.org/drawingml/2006/main">
               <a:ext uri="{FF2B5EF4-FFF2-40B4-BE49-F238E27FC236}">
-                <a16:creationId xmlns:a16="http://schemas.microsoft.com/office/drawing/2014/main" id="{1D65ABC2-F1CF-4333-9E0F-4525A0C298E5}"/>
+                <a16:creationId xmlns:a16="http://schemas.microsoft.com/office/drawing/2014/main" id="{72B20F14-E47C-496B-BFDC-F11B5EEB2D5B}"/>
               </a:ext>
             </a:extLst>
           </p:cNvPr>
@@ -23637,7 +23660,7 @@
           <p:cNvPr id="4" name="">
             <a:extLst xmlns:a="http://schemas.openxmlformats.org/drawingml/2006/main">
               <a:ext uri="{FF2B5EF4-FFF2-40B4-BE49-F238E27FC236}">
-                <a16:creationId xmlns:a16="http://schemas.microsoft.com/office/drawing/2014/main" id="{1A3CCC3A-2B2C-4FD9-8649-6105A43A7074}"/>
+                <a16:creationId xmlns:a16="http://schemas.microsoft.com/office/drawing/2014/main" id="{163874C6-71A9-4EF5-9075-49B1C2631A71}"/>
               </a:ext>
             </a:extLst>
           </p:cNvPr>
@@ -23880,7 +23903,7 @@
           <p:cNvPr id="5" name="">
             <a:extLst xmlns:a="http://schemas.openxmlformats.org/drawingml/2006/main">
               <a:ext uri="{FF2B5EF4-FFF2-40B4-BE49-F238E27FC236}">
-                <a16:creationId xmlns:a16="http://schemas.microsoft.com/office/drawing/2014/main" id="{9A06A441-3A0B-4F27-B487-EC4C56DF340D}"/>
+                <a16:creationId xmlns:a16="http://schemas.microsoft.com/office/drawing/2014/main" id="{8B143341-4D39-42B1-951D-4531190DD204}"/>
               </a:ext>
             </a:extLst>
           </p:cNvPr>
@@ -24038,7 +24061,7 @@
           <p:cNvPr id="6" name="">
             <a:extLst xmlns:a="http://schemas.openxmlformats.org/drawingml/2006/main">
               <a:ext uri="{FF2B5EF4-FFF2-40B4-BE49-F238E27FC236}">
-                <a16:creationId xmlns:a16="http://schemas.microsoft.com/office/drawing/2014/main" id="{44F76592-ACF6-4AC4-91BA-1F2B40EE488E}"/>
+                <a16:creationId xmlns:a16="http://schemas.microsoft.com/office/drawing/2014/main" id="{531E5E86-2D21-48AD-B285-A724B860E7B2}"/>
               </a:ext>
             </a:extLst>
           </p:cNvPr>
@@ -24360,7 +24383,7 @@
     </p:spTree>
     <p:extLst>
       <p:ext uri="{BB962C8B-B14F-4D97-AF65-F5344CB8AC3E}">
-        <p14:creationId xmlns:p14="http://schemas.microsoft.com/office/powerpoint/2010/main" val="2047447363"/>
+        <p14:creationId xmlns:p14="http://schemas.microsoft.com/office/powerpoint/2010/main" val="896559721"/>
       </p:ext>
     </p:extLst>
   </p:cSld>
@@ -24391,7 +24414,7 @@
           <p:cNvPr id="7" name="">
             <a:extLst xmlns:a="http://schemas.openxmlformats.org/drawingml/2006/main">
               <a:ext uri="{FF2B5EF4-FFF2-40B4-BE49-F238E27FC236}">
-                <a16:creationId xmlns:a16="http://schemas.microsoft.com/office/drawing/2014/main" id="{98F2F754-873C-4104-965B-B9EE8B65EFB2}"/>
+                <a16:creationId xmlns:a16="http://schemas.microsoft.com/office/drawing/2014/main" id="{6E5F427D-5927-414D-80C3-76B25A95D7BF}"/>
               </a:ext>
             </a:extLst>
           </p:cNvPr>
@@ -24421,7 +24444,7 @@
           <p:cNvPr id="2" name="">
             <a:extLst xmlns:a="http://schemas.openxmlformats.org/drawingml/2006/main">
               <a:ext uri="{FF2B5EF4-FFF2-40B4-BE49-F238E27FC236}">
-                <a16:creationId xmlns:a16="http://schemas.microsoft.com/office/drawing/2014/main" id="{5CFD0B6F-563E-4F01-A384-71ABC8ACADCD}"/>
+                <a16:creationId xmlns:a16="http://schemas.microsoft.com/office/drawing/2014/main" id="{2B6A41D9-2755-47FC-8005-25D4EAA2067D}"/>
               </a:ext>
             </a:extLst>
           </p:cNvPr>
@@ -24579,7 +24602,7 @@
           <p:cNvPr id="3" name="">
             <a:extLst xmlns:a="http://schemas.openxmlformats.org/drawingml/2006/main">
               <a:ext uri="{FF2B5EF4-FFF2-40B4-BE49-F238E27FC236}">
-                <a16:creationId xmlns:a16="http://schemas.microsoft.com/office/drawing/2014/main" id="{D2A3E201-D138-45B4-BA58-FA3A0A108947}"/>
+                <a16:creationId xmlns:a16="http://schemas.microsoft.com/office/drawing/2014/main" id="{9F2DEE94-107F-4B13-8DEB-8ADA938EDED9}"/>
               </a:ext>
             </a:extLst>
           </p:cNvPr>
@@ -24737,7 +24760,7 @@
           <p:cNvPr id="4" name="">
             <a:extLst xmlns:a="http://schemas.openxmlformats.org/drawingml/2006/main">
               <a:ext uri="{FF2B5EF4-FFF2-40B4-BE49-F238E27FC236}">
-                <a16:creationId xmlns:a16="http://schemas.microsoft.com/office/drawing/2014/main" id="{C51D28E8-35E4-44C3-9D29-EFE2F708EC51}"/>
+                <a16:creationId xmlns:a16="http://schemas.microsoft.com/office/drawing/2014/main" id="{96A8B86E-480C-4FB3-8A69-04EA121512FB}"/>
               </a:ext>
             </a:extLst>
           </p:cNvPr>
@@ -24895,7 +24918,7 @@
           <p:cNvPr id="5" name="">
             <a:extLst xmlns:a="http://schemas.openxmlformats.org/drawingml/2006/main">
               <a:ext uri="{FF2B5EF4-FFF2-40B4-BE49-F238E27FC236}">
-                <a16:creationId xmlns:a16="http://schemas.microsoft.com/office/drawing/2014/main" id="{15A8E860-985A-403F-A180-FCE25F533246}"/>
+                <a16:creationId xmlns:a16="http://schemas.microsoft.com/office/drawing/2014/main" id="{75A8626A-1C6C-462C-A021-FA390929457C}"/>
               </a:ext>
             </a:extLst>
           </p:cNvPr>
@@ -25138,7 +25161,7 @@
           <p:cNvPr id="6" name="">
             <a:extLst xmlns:a="http://schemas.openxmlformats.org/drawingml/2006/main">
               <a:ext uri="{FF2B5EF4-FFF2-40B4-BE49-F238E27FC236}">
-                <a16:creationId xmlns:a16="http://schemas.microsoft.com/office/drawing/2014/main" id="{4E71C85D-3A8E-43E3-A60F-4ADFF978E94F}"/>
+                <a16:creationId xmlns:a16="http://schemas.microsoft.com/office/drawing/2014/main" id="{D27420BE-A591-4776-B9BB-0869875C1696}"/>
               </a:ext>
             </a:extLst>
           </p:cNvPr>
@@ -25294,7 +25317,7 @@
     </p:spTree>
     <p:extLst>
       <p:ext uri="{BB962C8B-B14F-4D97-AF65-F5344CB8AC3E}">
-        <p14:creationId xmlns:p14="http://schemas.microsoft.com/office/powerpoint/2010/main" val="1820411137"/>
+        <p14:creationId xmlns:p14="http://schemas.microsoft.com/office/powerpoint/2010/main" val="258086028"/>
       </p:ext>
     </p:extLst>
   </p:cSld>
@@ -25325,7 +25348,7 @@
           <p:cNvPr id="7" name="">
             <a:extLst xmlns:a="http://schemas.openxmlformats.org/drawingml/2006/main">
               <a:ext uri="{FF2B5EF4-FFF2-40B4-BE49-F238E27FC236}">
-                <a16:creationId xmlns:a16="http://schemas.microsoft.com/office/drawing/2014/main" id="{30AD806D-C1E8-4518-9AFD-173078EA6FF9}"/>
+                <a16:creationId xmlns:a16="http://schemas.microsoft.com/office/drawing/2014/main" id="{F906B4C5-3BA7-447D-B518-B1875DF04C4E}"/>
               </a:ext>
             </a:extLst>
           </p:cNvPr>
@@ -25355,7 +25378,7 @@
           <p:cNvPr id="2" name="">
             <a:extLst xmlns:a="http://schemas.openxmlformats.org/drawingml/2006/main">
               <a:ext uri="{FF2B5EF4-FFF2-40B4-BE49-F238E27FC236}">
-                <a16:creationId xmlns:a16="http://schemas.microsoft.com/office/drawing/2014/main" id="{B266E570-FEDC-47B1-A6E2-D3A5D28613F6}"/>
+                <a16:creationId xmlns:a16="http://schemas.microsoft.com/office/drawing/2014/main" id="{D9278438-CD38-40E9-97C4-60A82AB1633E}"/>
               </a:ext>
             </a:extLst>
           </p:cNvPr>
@@ -25513,7 +25536,7 @@
           <p:cNvPr id="3" name="">
             <a:extLst xmlns:a="http://schemas.openxmlformats.org/drawingml/2006/main">
               <a:ext uri="{FF2B5EF4-FFF2-40B4-BE49-F238E27FC236}">
-                <a16:creationId xmlns:a16="http://schemas.microsoft.com/office/drawing/2014/main" id="{83CCC297-26DE-41E5-972F-65BC252AEFA9}"/>
+                <a16:creationId xmlns:a16="http://schemas.microsoft.com/office/drawing/2014/main" id="{D54ECF8E-004B-45A6-BBA7-97E86262A636}"/>
               </a:ext>
             </a:extLst>
           </p:cNvPr>
@@ -25671,7 +25694,7 @@
           <p:cNvPr id="4" name="">
             <a:extLst xmlns:a="http://schemas.openxmlformats.org/drawingml/2006/main">
               <a:ext uri="{FF2B5EF4-FFF2-40B4-BE49-F238E27FC236}">
-                <a16:creationId xmlns:a16="http://schemas.microsoft.com/office/drawing/2014/main" id="{295DD83C-2377-48CE-8D4A-73D4261260DA}"/>
+                <a16:creationId xmlns:a16="http://schemas.microsoft.com/office/drawing/2014/main" id="{9F3924FC-730F-4034-B385-F0B13F7AF0DD}"/>
               </a:ext>
             </a:extLst>
           </p:cNvPr>
@@ -25681,7 +25704,7 @@
           <p:nvPr/>
         </p:nvPicPr>
         <p:blipFill>
-          <a:blip xmlns:r="http://schemas.openxmlformats.org/officeDocument/2006/relationships" xmlns:a="http://schemas.openxmlformats.org/drawingml/2006/main" r:embed="Redaf8f5dac99459a"/>
+          <a:blip xmlns:r="http://schemas.openxmlformats.org/officeDocument/2006/relationships" xmlns:a="http://schemas.openxmlformats.org/drawingml/2006/main" r:embed="Rfc50d45d6e07439c"/>
           <a:stretch xmlns:a="http://schemas.openxmlformats.org/drawingml/2006/main"/>
         </p:blipFill>
         <p:spPr>
@@ -25699,7 +25722,7 @@
           <p:cNvPr id="5" name="">
             <a:extLst xmlns:a="http://schemas.openxmlformats.org/drawingml/2006/main">
               <a:ext uri="{FF2B5EF4-FFF2-40B4-BE49-F238E27FC236}">
-                <a16:creationId xmlns:a16="http://schemas.microsoft.com/office/drawing/2014/main" id="{AE0653C6-0CA9-43D4-910A-2BA305974C66}"/>
+                <a16:creationId xmlns:a16="http://schemas.microsoft.com/office/drawing/2014/main" id="{F151DC41-510B-453B-8D79-38A4708507FD}"/>
               </a:ext>
             </a:extLst>
           </p:cNvPr>
@@ -25942,7 +25965,7 @@
           <p:cNvPr id="6" name="">
             <a:extLst xmlns:a="http://schemas.openxmlformats.org/drawingml/2006/main">
               <a:ext uri="{FF2B5EF4-FFF2-40B4-BE49-F238E27FC236}">
-                <a16:creationId xmlns:a16="http://schemas.microsoft.com/office/drawing/2014/main" id="{C7603FDF-F0D7-470A-8294-756D630D83F3}"/>
+                <a16:creationId xmlns:a16="http://schemas.microsoft.com/office/drawing/2014/main" id="{705AFA24-544B-4EEA-B007-1E860F8A0A79}"/>
               </a:ext>
             </a:extLst>
           </p:cNvPr>
@@ -26098,7 +26121,7 @@
     </p:spTree>
     <p:extLst>
       <p:ext uri="{BB962C8B-B14F-4D97-AF65-F5344CB8AC3E}">
-        <p14:creationId xmlns:p14="http://schemas.microsoft.com/office/powerpoint/2010/main" val="1583082640"/>
+        <p14:creationId xmlns:p14="http://schemas.microsoft.com/office/powerpoint/2010/main" val="1694691005"/>
       </p:ext>
     </p:extLst>
   </p:cSld>
@@ -26129,7 +26152,7 @@
           <p:cNvPr id="19" name="">
             <a:extLst xmlns:a="http://schemas.openxmlformats.org/drawingml/2006/main">
               <a:ext uri="{FF2B5EF4-FFF2-40B4-BE49-F238E27FC236}">
-                <a16:creationId xmlns:a16="http://schemas.microsoft.com/office/drawing/2014/main" id="{E0409CBA-4961-4347-87E7-025E85F66025}"/>
+                <a16:creationId xmlns:a16="http://schemas.microsoft.com/office/drawing/2014/main" id="{E99A3812-0970-4815-B151-06F8E427FA6B}"/>
               </a:ext>
             </a:extLst>
           </p:cNvPr>
@@ -26159,7 +26182,7 @@
           <p:cNvPr id="2" name="">
             <a:extLst xmlns:a="http://schemas.openxmlformats.org/drawingml/2006/main">
               <a:ext uri="{FF2B5EF4-FFF2-40B4-BE49-F238E27FC236}">
-                <a16:creationId xmlns:a16="http://schemas.microsoft.com/office/drawing/2014/main" id="{D2DFCB02-AB6C-4AC5-A13B-18034DE4C6A8}"/>
+                <a16:creationId xmlns:a16="http://schemas.microsoft.com/office/drawing/2014/main" id="{2EC04EDC-23A7-4076-A6B9-385F1B57241B}"/>
               </a:ext>
             </a:extLst>
           </p:cNvPr>
@@ -26317,7 +26340,7 @@
           <p:cNvPr id="3" name="">
             <a:extLst xmlns:a="http://schemas.openxmlformats.org/drawingml/2006/main">
               <a:ext uri="{FF2B5EF4-FFF2-40B4-BE49-F238E27FC236}">
-                <a16:creationId xmlns:a16="http://schemas.microsoft.com/office/drawing/2014/main" id="{4F0C9736-0B23-40C4-B25F-EC89F8496781}"/>
+                <a16:creationId xmlns:a16="http://schemas.microsoft.com/office/drawing/2014/main" id="{A0BD0718-0216-41B6-8C25-EBCBDD163B91}"/>
               </a:ext>
             </a:extLst>
           </p:cNvPr>
@@ -26475,7 +26498,7 @@
           <p:cNvPr id="4" name="">
             <a:extLst xmlns:a="http://schemas.openxmlformats.org/drawingml/2006/main">
               <a:ext uri="{FF2B5EF4-FFF2-40B4-BE49-F238E27FC236}">
-                <a16:creationId xmlns:a16="http://schemas.microsoft.com/office/drawing/2014/main" id="{C7C61B60-5036-4BC4-9840-4FF31B42F823}"/>
+                <a16:creationId xmlns:a16="http://schemas.microsoft.com/office/drawing/2014/main" id="{8A53F9B0-D381-46C2-9D21-277656D4C2F5}"/>
               </a:ext>
             </a:extLst>
           </p:cNvPr>
@@ -26640,7 +26663,7 @@
           <p:cNvPr id="5" name="">
             <a:extLst xmlns:a="http://schemas.openxmlformats.org/drawingml/2006/main">
               <a:ext uri="{FF2B5EF4-FFF2-40B4-BE49-F238E27FC236}">
-                <a16:creationId xmlns:a16="http://schemas.microsoft.com/office/drawing/2014/main" id="{084CD303-1A40-4E24-9815-5EFBEFDB05BE}"/>
+                <a16:creationId xmlns:a16="http://schemas.microsoft.com/office/drawing/2014/main" id="{87A67EA3-88EF-4A0D-8D81-D1E504D9611E}"/>
               </a:ext>
             </a:extLst>
           </p:cNvPr>
@@ -26798,7 +26821,7 @@
           <p:cNvPr id="6" name="">
             <a:extLst xmlns:a="http://schemas.openxmlformats.org/drawingml/2006/main">
               <a:ext uri="{FF2B5EF4-FFF2-40B4-BE49-F238E27FC236}">
-                <a16:creationId xmlns:a16="http://schemas.microsoft.com/office/drawing/2014/main" id="{34E3E8ED-50AA-443A-B3D1-AC840FCFC425}"/>
+                <a16:creationId xmlns:a16="http://schemas.microsoft.com/office/drawing/2014/main" id="{2B4DCA79-481B-43E3-898E-A257D13DD99F}"/>
               </a:ext>
             </a:extLst>
           </p:cNvPr>
@@ -26956,7 +26979,7 @@
           <p:cNvPr id="7" name="">
             <a:extLst xmlns:a="http://schemas.openxmlformats.org/drawingml/2006/main">
               <a:ext uri="{FF2B5EF4-FFF2-40B4-BE49-F238E27FC236}">
-                <a16:creationId xmlns:a16="http://schemas.microsoft.com/office/drawing/2014/main" id="{8CC777C9-8A3B-41B7-902A-F217F9F8FF0E}"/>
+                <a16:creationId xmlns:a16="http://schemas.microsoft.com/office/drawing/2014/main" id="{6F55CD49-58C2-48FD-9D78-EE2E40D5F267}"/>
               </a:ext>
             </a:extLst>
           </p:cNvPr>
@@ -27121,7 +27144,7 @@
           <p:cNvPr id="8" name="">
             <a:extLst xmlns:a="http://schemas.openxmlformats.org/drawingml/2006/main">
               <a:ext uri="{FF2B5EF4-FFF2-40B4-BE49-F238E27FC236}">
-                <a16:creationId xmlns:a16="http://schemas.microsoft.com/office/drawing/2014/main" id="{1D1701FF-33BB-4F68-9BC5-653A11C9A3E7}"/>
+                <a16:creationId xmlns:a16="http://schemas.microsoft.com/office/drawing/2014/main" id="{2097DA58-23C6-483F-954D-2CA5B47FBADB}"/>
               </a:ext>
             </a:extLst>
           </p:cNvPr>
@@ -27279,7 +27302,7 @@
           <p:cNvPr id="9" name="">
             <a:extLst xmlns:a="http://schemas.openxmlformats.org/drawingml/2006/main">
               <a:ext uri="{FF2B5EF4-FFF2-40B4-BE49-F238E27FC236}">
-                <a16:creationId xmlns:a16="http://schemas.microsoft.com/office/drawing/2014/main" id="{BEF67298-0A01-4FAA-99F6-486446D08C80}"/>
+                <a16:creationId xmlns:a16="http://schemas.microsoft.com/office/drawing/2014/main" id="{40E8332B-F9F3-44CB-B9A6-F9C7CA96743C}"/>
               </a:ext>
             </a:extLst>
           </p:cNvPr>
@@ -27437,7 +27460,7 @@
           <p:cNvPr id="10" name="">
             <a:extLst xmlns:a="http://schemas.openxmlformats.org/drawingml/2006/main">
               <a:ext uri="{FF2B5EF4-FFF2-40B4-BE49-F238E27FC236}">
-                <a16:creationId xmlns:a16="http://schemas.microsoft.com/office/drawing/2014/main" id="{82D60308-7599-4175-B791-828D547D68F0}"/>
+                <a16:creationId xmlns:a16="http://schemas.microsoft.com/office/drawing/2014/main" id="{CD024895-19D0-4815-8296-FBCBD5B51894}"/>
               </a:ext>
             </a:extLst>
           </p:cNvPr>
@@ -27602,7 +27625,7 @@
           <p:cNvPr id="11" name="">
             <a:extLst xmlns:a="http://schemas.openxmlformats.org/drawingml/2006/main">
               <a:ext uri="{FF2B5EF4-FFF2-40B4-BE49-F238E27FC236}">
-                <a16:creationId xmlns:a16="http://schemas.microsoft.com/office/drawing/2014/main" id="{DC338644-66D7-4D93-A5E0-8094F7E13F6A}"/>
+                <a16:creationId xmlns:a16="http://schemas.microsoft.com/office/drawing/2014/main" id="{AA3D61AD-1854-457B-A734-66DFBA8B170F}"/>
               </a:ext>
             </a:extLst>
           </p:cNvPr>
@@ -27760,7 +27783,7 @@
           <p:cNvPr id="12" name="">
             <a:extLst xmlns:a="http://schemas.openxmlformats.org/drawingml/2006/main">
               <a:ext uri="{FF2B5EF4-FFF2-40B4-BE49-F238E27FC236}">
-                <a16:creationId xmlns:a16="http://schemas.microsoft.com/office/drawing/2014/main" id="{8A305D72-2909-4CEB-9DF6-82ABD60C5E19}"/>
+                <a16:creationId xmlns:a16="http://schemas.microsoft.com/office/drawing/2014/main" id="{0AB3ABC7-E2E8-4F71-82E3-658391BD63E8}"/>
               </a:ext>
             </a:extLst>
           </p:cNvPr>
@@ -27918,7 +27941,7 @@
           <p:cNvPr id="13" name="">
             <a:extLst xmlns:a="http://schemas.openxmlformats.org/drawingml/2006/main">
               <a:ext uri="{FF2B5EF4-FFF2-40B4-BE49-F238E27FC236}">
-                <a16:creationId xmlns:a16="http://schemas.microsoft.com/office/drawing/2014/main" id="{7D29FEC2-7533-495C-AB3C-FEAD13FA31CF}"/>
+                <a16:creationId xmlns:a16="http://schemas.microsoft.com/office/drawing/2014/main" id="{C72FA73D-C084-48A7-9951-3339A32382E6}"/>
               </a:ext>
             </a:extLst>
           </p:cNvPr>
@@ -28083,7 +28106,7 @@
           <p:cNvPr id="14" name="">
             <a:extLst xmlns:a="http://schemas.openxmlformats.org/drawingml/2006/main">
               <a:ext uri="{FF2B5EF4-FFF2-40B4-BE49-F238E27FC236}">
-                <a16:creationId xmlns:a16="http://schemas.microsoft.com/office/drawing/2014/main" id="{8C9FAAE1-5F74-4127-AB04-08778AFF83FE}"/>
+                <a16:creationId xmlns:a16="http://schemas.microsoft.com/office/drawing/2014/main" id="{9AAFABA8-9A78-4768-B270-1370FADB2E2A}"/>
               </a:ext>
             </a:extLst>
           </p:cNvPr>
@@ -28241,7 +28264,7 @@
           <p:cNvPr id="15" name="">
             <a:extLst xmlns:a="http://schemas.openxmlformats.org/drawingml/2006/main">
               <a:ext uri="{FF2B5EF4-FFF2-40B4-BE49-F238E27FC236}">
-                <a16:creationId xmlns:a16="http://schemas.microsoft.com/office/drawing/2014/main" id="{1D457411-D8AE-4650-B633-D91D8C5E21FD}"/>
+                <a16:creationId xmlns:a16="http://schemas.microsoft.com/office/drawing/2014/main" id="{650FE3BD-87CD-45F4-8032-718369B23AE5}"/>
               </a:ext>
             </a:extLst>
           </p:cNvPr>
@@ -28399,7 +28422,7 @@
           <p:cNvPr id="16" name="">
             <a:extLst xmlns:a="http://schemas.openxmlformats.org/drawingml/2006/main">
               <a:ext uri="{FF2B5EF4-FFF2-40B4-BE49-F238E27FC236}">
-                <a16:creationId xmlns:a16="http://schemas.microsoft.com/office/drawing/2014/main" id="{2B9D7817-564C-4FB7-AD80-C8439F2073E0}"/>
+                <a16:creationId xmlns:a16="http://schemas.microsoft.com/office/drawing/2014/main" id="{8D625F3E-4860-425E-ADEE-16EBD06C4D05}"/>
               </a:ext>
             </a:extLst>
           </p:cNvPr>
@@ -28564,7 +28587,7 @@
           <p:cNvPr id="17" name="">
             <a:extLst xmlns:a="http://schemas.openxmlformats.org/drawingml/2006/main">
               <a:ext uri="{FF2B5EF4-FFF2-40B4-BE49-F238E27FC236}">
-                <a16:creationId xmlns:a16="http://schemas.microsoft.com/office/drawing/2014/main" id="{5A4B0896-9D4D-4D5C-8752-6D7C68EF02FE}"/>
+                <a16:creationId xmlns:a16="http://schemas.microsoft.com/office/drawing/2014/main" id="{1C7BA545-3E2D-4B91-AAAD-45FFB5A71547}"/>
               </a:ext>
             </a:extLst>
           </p:cNvPr>
@@ -28722,7 +28745,7 @@
           <p:cNvPr id="18" name="">
             <a:extLst xmlns:a="http://schemas.openxmlformats.org/drawingml/2006/main">
               <a:ext uri="{FF2B5EF4-FFF2-40B4-BE49-F238E27FC236}">
-                <a16:creationId xmlns:a16="http://schemas.microsoft.com/office/drawing/2014/main" id="{87B2AB50-E4F2-4E81-88ED-9EBCDFDC1AD6}"/>
+                <a16:creationId xmlns:a16="http://schemas.microsoft.com/office/drawing/2014/main" id="{8E2E6204-8F12-48F5-8941-97F82B01186C}"/>
               </a:ext>
             </a:extLst>
           </p:cNvPr>
@@ -28878,7 +28901,7 @@
     </p:spTree>
     <p:extLst>
       <p:ext uri="{BB962C8B-B14F-4D97-AF65-F5344CB8AC3E}">
-        <p14:creationId xmlns:p14="http://schemas.microsoft.com/office/powerpoint/2010/main" val="289355591"/>
+        <p14:creationId xmlns:p14="http://schemas.microsoft.com/office/powerpoint/2010/main" val="253188042"/>
       </p:ext>
     </p:extLst>
   </p:cSld>
@@ -28909,7 +28932,7 @@
           <p:cNvPr id="16" name="">
             <a:extLst xmlns:a="http://schemas.openxmlformats.org/drawingml/2006/main">
               <a:ext uri="{FF2B5EF4-FFF2-40B4-BE49-F238E27FC236}">
-                <a16:creationId xmlns:a16="http://schemas.microsoft.com/office/drawing/2014/main" id="{F0BED1FE-7BFD-43D8-824A-7ED81E844D80}"/>
+                <a16:creationId xmlns:a16="http://schemas.microsoft.com/office/drawing/2014/main" id="{02BE0C9B-86A4-4F22-8713-A7B9077D0DBA}"/>
               </a:ext>
             </a:extLst>
           </p:cNvPr>
@@ -28939,7 +28962,7 @@
           <p:cNvPr id="2" name="">
             <a:extLst xmlns:a="http://schemas.openxmlformats.org/drawingml/2006/main">
               <a:ext uri="{FF2B5EF4-FFF2-40B4-BE49-F238E27FC236}">
-                <a16:creationId xmlns:a16="http://schemas.microsoft.com/office/drawing/2014/main" id="{76E52E5D-C938-4E04-A0B8-C0540BBFDDF3}"/>
+                <a16:creationId xmlns:a16="http://schemas.microsoft.com/office/drawing/2014/main" id="{F4396842-A241-4A95-82F6-7080BFBF77B3}"/>
               </a:ext>
             </a:extLst>
           </p:cNvPr>
@@ -29097,7 +29120,7 @@
           <p:cNvPr id="3" name="">
             <a:extLst xmlns:a="http://schemas.openxmlformats.org/drawingml/2006/main">
               <a:ext uri="{FF2B5EF4-FFF2-40B4-BE49-F238E27FC236}">
-                <a16:creationId xmlns:a16="http://schemas.microsoft.com/office/drawing/2014/main" id="{0F8FDC1A-2226-4932-AC79-DE0E39281508}"/>
+                <a16:creationId xmlns:a16="http://schemas.microsoft.com/office/drawing/2014/main" id="{588253B7-6293-4A99-902F-5A60606C9F1C}"/>
               </a:ext>
             </a:extLst>
           </p:cNvPr>
@@ -29255,7 +29278,7 @@
           <p:cNvPr id="4" name="">
             <a:extLst xmlns:a="http://schemas.openxmlformats.org/drawingml/2006/main">
               <a:ext uri="{FF2B5EF4-FFF2-40B4-BE49-F238E27FC236}">
-                <a16:creationId xmlns:a16="http://schemas.microsoft.com/office/drawing/2014/main" id="{04B565D3-DE61-4994-9EDF-11549C5F63C9}"/>
+                <a16:creationId xmlns:a16="http://schemas.microsoft.com/office/drawing/2014/main" id="{623E169B-4D79-469F-AA6E-987639252455}"/>
               </a:ext>
             </a:extLst>
           </p:cNvPr>
@@ -29413,7 +29436,7 @@
           <p:cNvPr id="5" name="">
             <a:extLst xmlns:a="http://schemas.openxmlformats.org/drawingml/2006/main">
               <a:ext uri="{FF2B5EF4-FFF2-40B4-BE49-F238E27FC236}">
-                <a16:creationId xmlns:a16="http://schemas.microsoft.com/office/drawing/2014/main" id="{069B7356-2ECD-4FFA-A23E-197EA0E476B1}"/>
+                <a16:creationId xmlns:a16="http://schemas.microsoft.com/office/drawing/2014/main" id="{F18AF2BF-E458-4D9D-B0DF-14FB549328AB}"/>
               </a:ext>
             </a:extLst>
           </p:cNvPr>
@@ -29571,7 +29594,7 @@
           <p:cNvPr id="6" name="">
             <a:extLst xmlns:a="http://schemas.openxmlformats.org/drawingml/2006/main">
               <a:ext uri="{FF2B5EF4-FFF2-40B4-BE49-F238E27FC236}">
-                <a16:creationId xmlns:a16="http://schemas.microsoft.com/office/drawing/2014/main" id="{CC0B3C58-EE1C-4534-8D8D-23B7E8362735}"/>
+                <a16:creationId xmlns:a16="http://schemas.microsoft.com/office/drawing/2014/main" id="{EB83C95D-EC79-4147-B7CB-7609011CD42A}"/>
               </a:ext>
             </a:extLst>
           </p:cNvPr>
@@ -29729,7 +29752,7 @@
           <p:cNvPr id="7" name="">
             <a:extLst xmlns:a="http://schemas.openxmlformats.org/drawingml/2006/main">
               <a:ext uri="{FF2B5EF4-FFF2-40B4-BE49-F238E27FC236}">
-                <a16:creationId xmlns:a16="http://schemas.microsoft.com/office/drawing/2014/main" id="{4EE51E81-809E-4898-B854-F7E30919F058}"/>
+                <a16:creationId xmlns:a16="http://schemas.microsoft.com/office/drawing/2014/main" id="{6613E00B-77D4-4CEC-8BF0-2A3C2372CC66}"/>
               </a:ext>
             </a:extLst>
           </p:cNvPr>
@@ -29887,7 +29910,7 @@
           <p:cNvPr id="8" name="">
             <a:extLst xmlns:a="http://schemas.openxmlformats.org/drawingml/2006/main">
               <a:ext uri="{FF2B5EF4-FFF2-40B4-BE49-F238E27FC236}">
-                <a16:creationId xmlns:a16="http://schemas.microsoft.com/office/drawing/2014/main" id="{727E234D-AE82-4F74-862D-7C3615E1AEBE}"/>
+                <a16:creationId xmlns:a16="http://schemas.microsoft.com/office/drawing/2014/main" id="{8D77D24F-7031-4E99-9F91-0050DA026CC0}"/>
               </a:ext>
             </a:extLst>
           </p:cNvPr>
@@ -30045,7 +30068,7 @@
           <p:cNvPr id="9" name="">
             <a:extLst xmlns:a="http://schemas.openxmlformats.org/drawingml/2006/main">
               <a:ext uri="{FF2B5EF4-FFF2-40B4-BE49-F238E27FC236}">
-                <a16:creationId xmlns:a16="http://schemas.microsoft.com/office/drawing/2014/main" id="{97A761F8-2495-468D-A9D7-B442A5479C82}"/>
+                <a16:creationId xmlns:a16="http://schemas.microsoft.com/office/drawing/2014/main" id="{BA6D99B1-EB46-482D-AFE4-CD84FC9C468B}"/>
               </a:ext>
             </a:extLst>
           </p:cNvPr>
@@ -30203,7 +30226,7 @@
           <p:cNvPr id="10" name="">
             <a:extLst xmlns:a="http://schemas.openxmlformats.org/drawingml/2006/main">
               <a:ext uri="{FF2B5EF4-FFF2-40B4-BE49-F238E27FC236}">
-                <a16:creationId xmlns:a16="http://schemas.microsoft.com/office/drawing/2014/main" id="{F9CEAACD-A8F9-471D-B25B-59BB8CEAF801}"/>
+                <a16:creationId xmlns:a16="http://schemas.microsoft.com/office/drawing/2014/main" id="{665EF8C1-12EB-4F6C-A839-5D2E4CA4E552}"/>
               </a:ext>
             </a:extLst>
           </p:cNvPr>
@@ -30361,7 +30384,7 @@
           <p:cNvPr id="11" name="">
             <a:extLst xmlns:a="http://schemas.openxmlformats.org/drawingml/2006/main">
               <a:ext uri="{FF2B5EF4-FFF2-40B4-BE49-F238E27FC236}">
-                <a16:creationId xmlns:a16="http://schemas.microsoft.com/office/drawing/2014/main" id="{CC7BC676-C41F-4038-9516-5CF7DA23F2E6}"/>
+                <a16:creationId xmlns:a16="http://schemas.microsoft.com/office/drawing/2014/main" id="{3140CD44-B8B9-4AB6-B214-0786B68061CD}"/>
               </a:ext>
             </a:extLst>
           </p:cNvPr>
@@ -30519,7 +30542,7 @@
           <p:cNvPr id="12" name="">
             <a:extLst xmlns:a="http://schemas.openxmlformats.org/drawingml/2006/main">
               <a:ext uri="{FF2B5EF4-FFF2-40B4-BE49-F238E27FC236}">
-                <a16:creationId xmlns:a16="http://schemas.microsoft.com/office/drawing/2014/main" id="{4E1664C6-24D8-4702-9F1D-B6B5A1B9A3F7}"/>
+                <a16:creationId xmlns:a16="http://schemas.microsoft.com/office/drawing/2014/main" id="{0E117F58-37E0-4085-AC9A-56D9568B8356}"/>
               </a:ext>
             </a:extLst>
           </p:cNvPr>
@@ -30677,7 +30700,7 @@
           <p:cNvPr id="13" name="">
             <a:extLst xmlns:a="http://schemas.openxmlformats.org/drawingml/2006/main">
               <a:ext uri="{FF2B5EF4-FFF2-40B4-BE49-F238E27FC236}">
-                <a16:creationId xmlns:a16="http://schemas.microsoft.com/office/drawing/2014/main" id="{B673505E-9AF5-4EFC-B1E1-A28EBA3891DF}"/>
+                <a16:creationId xmlns:a16="http://schemas.microsoft.com/office/drawing/2014/main" id="{8DB49035-E2CD-404D-98B5-363D6A6BC8A8}"/>
               </a:ext>
             </a:extLst>
           </p:cNvPr>
@@ -30835,7 +30858,7 @@
           <p:cNvPr id="14" name="">
             <a:extLst xmlns:a="http://schemas.openxmlformats.org/drawingml/2006/main">
               <a:ext uri="{FF2B5EF4-FFF2-40B4-BE49-F238E27FC236}">
-                <a16:creationId xmlns:a16="http://schemas.microsoft.com/office/drawing/2014/main" id="{E1E53C14-CD57-47FC-9DE1-6E12D1D202E7}"/>
+                <a16:creationId xmlns:a16="http://schemas.microsoft.com/office/drawing/2014/main" id="{744B909B-FEF9-4756-820E-E78DB10C340E}"/>
               </a:ext>
             </a:extLst>
           </p:cNvPr>
@@ -30993,7 +31016,7 @@
           <p:cNvPr id="15" name="">
             <a:extLst xmlns:a="http://schemas.openxmlformats.org/drawingml/2006/main">
               <a:ext uri="{FF2B5EF4-FFF2-40B4-BE49-F238E27FC236}">
-                <a16:creationId xmlns:a16="http://schemas.microsoft.com/office/drawing/2014/main" id="{F3E5B7E9-0A68-40B9-A874-A46BA01BA9A1}"/>
+                <a16:creationId xmlns:a16="http://schemas.microsoft.com/office/drawing/2014/main" id="{56CE7D92-C779-486C-9E83-9BD466667256}"/>
               </a:ext>
             </a:extLst>
           </p:cNvPr>
@@ -31149,7 +31172,7 @@
     </p:spTree>
     <p:extLst>
       <p:ext uri="{BB962C8B-B14F-4D97-AF65-F5344CB8AC3E}">
-        <p14:creationId xmlns:p14="http://schemas.microsoft.com/office/powerpoint/2010/main" val="334837432"/>
+        <p14:creationId xmlns:p14="http://schemas.microsoft.com/office/powerpoint/2010/main" val="1369230454"/>
       </p:ext>
     </p:extLst>
   </p:cSld>
@@ -31180,7 +31203,7 @@
           <p:cNvPr id="9" name="">
             <a:extLst xmlns:a="http://schemas.openxmlformats.org/drawingml/2006/main">
               <a:ext uri="{FF2B5EF4-FFF2-40B4-BE49-F238E27FC236}">
-                <a16:creationId xmlns:a16="http://schemas.microsoft.com/office/drawing/2014/main" id="{679E70A1-65C8-4B33-BFE3-6E03D4579892}"/>
+                <a16:creationId xmlns:a16="http://schemas.microsoft.com/office/drawing/2014/main" id="{2D3F6ADD-F4AB-42A9-BC1D-7628FF00DB1F}"/>
               </a:ext>
             </a:extLst>
           </p:cNvPr>
@@ -31210,7 +31233,7 @@
           <p:cNvPr id="2" name="">
             <a:extLst xmlns:a="http://schemas.openxmlformats.org/drawingml/2006/main">
               <a:ext uri="{FF2B5EF4-FFF2-40B4-BE49-F238E27FC236}">
-                <a16:creationId xmlns:a16="http://schemas.microsoft.com/office/drawing/2014/main" id="{09C87233-1984-4983-B8EE-B2ED28A4EAB6}"/>
+                <a16:creationId xmlns:a16="http://schemas.microsoft.com/office/drawing/2014/main" id="{76D04C20-0358-4811-B453-D63133E84ADD}"/>
               </a:ext>
             </a:extLst>
           </p:cNvPr>
@@ -31368,7 +31391,7 @@
           <p:cNvPr id="3" name="">
             <a:extLst xmlns:a="http://schemas.openxmlformats.org/drawingml/2006/main">
               <a:ext uri="{FF2B5EF4-FFF2-40B4-BE49-F238E27FC236}">
-                <a16:creationId xmlns:a16="http://schemas.microsoft.com/office/drawing/2014/main" id="{EB1469C1-131F-4A54-ACF3-6094BB65085A}"/>
+                <a16:creationId xmlns:a16="http://schemas.microsoft.com/office/drawing/2014/main" id="{F52C1492-7596-4C04-9976-6DBDFCAE3FC0}"/>
               </a:ext>
             </a:extLst>
           </p:cNvPr>
@@ -31526,7 +31549,7 @@
           <p:cNvPr id="4" name="">
             <a:extLst xmlns:a="http://schemas.openxmlformats.org/drawingml/2006/main">
               <a:ext uri="{FF2B5EF4-FFF2-40B4-BE49-F238E27FC236}">
-                <a16:creationId xmlns:a16="http://schemas.microsoft.com/office/drawing/2014/main" id="{E852323D-D9B0-4E3D-9C4B-3B4870DABB3E}"/>
+                <a16:creationId xmlns:a16="http://schemas.microsoft.com/office/drawing/2014/main" id="{BA45F0E4-EF2D-4577-BB4C-38F4D0FD7AAE}"/>
               </a:ext>
             </a:extLst>
           </p:cNvPr>
@@ -31796,7 +31819,7 @@
           <p:cNvPr id="5" name="">
             <a:extLst xmlns:a="http://schemas.openxmlformats.org/drawingml/2006/main">
               <a:ext uri="{FF2B5EF4-FFF2-40B4-BE49-F238E27FC236}">
-                <a16:creationId xmlns:a16="http://schemas.microsoft.com/office/drawing/2014/main" id="{37406DDB-A2DF-4173-AF41-1A7D47B9BC29}"/>
+                <a16:creationId xmlns:a16="http://schemas.microsoft.com/office/drawing/2014/main" id="{971BA5F0-80B6-42AF-B889-E6E234906203}"/>
               </a:ext>
             </a:extLst>
           </p:cNvPr>
@@ -31984,7 +32007,7 @@
           <p:cNvPr id="6" name="">
             <a:extLst xmlns:a="http://schemas.openxmlformats.org/drawingml/2006/main">
               <a:ext uri="{FF2B5EF4-FFF2-40B4-BE49-F238E27FC236}">
-                <a16:creationId xmlns:a16="http://schemas.microsoft.com/office/drawing/2014/main" id="{327A070F-D4C3-4DB2-8D11-C4DAB06410FD}"/>
+                <a16:creationId xmlns:a16="http://schemas.microsoft.com/office/drawing/2014/main" id="{9BC3E2B3-8192-4F15-A9FF-1CB9DBB14BEC}"/>
               </a:ext>
             </a:extLst>
           </p:cNvPr>
@@ -32172,7 +32195,7 @@
           <p:cNvPr id="7" name="">
             <a:extLst xmlns:a="http://schemas.openxmlformats.org/drawingml/2006/main">
               <a:ext uri="{FF2B5EF4-FFF2-40B4-BE49-F238E27FC236}">
-                <a16:creationId xmlns:a16="http://schemas.microsoft.com/office/drawing/2014/main" id="{9E854349-887C-4C80-938B-8F179D81850C}"/>
+                <a16:creationId xmlns:a16="http://schemas.microsoft.com/office/drawing/2014/main" id="{735D7432-D8C2-44EC-B6EE-C9D8FF282C8B}"/>
               </a:ext>
             </a:extLst>
           </p:cNvPr>
@@ -32360,7 +32383,7 @@
           <p:cNvPr id="8" name="">
             <a:extLst xmlns:a="http://schemas.openxmlformats.org/drawingml/2006/main">
               <a:ext uri="{FF2B5EF4-FFF2-40B4-BE49-F238E27FC236}">
-                <a16:creationId xmlns:a16="http://schemas.microsoft.com/office/drawing/2014/main" id="{DECA67F3-6154-45FB-AB0E-1F0DA66902A1}"/>
+                <a16:creationId xmlns:a16="http://schemas.microsoft.com/office/drawing/2014/main" id="{6A557B02-747B-4504-9677-66620B8CDC27}"/>
               </a:ext>
             </a:extLst>
           </p:cNvPr>
@@ -32516,7 +32539,7 @@
     </p:spTree>
     <p:extLst>
       <p:ext uri="{BB962C8B-B14F-4D97-AF65-F5344CB8AC3E}">
-        <p14:creationId xmlns:p14="http://schemas.microsoft.com/office/powerpoint/2010/main" val="2143374585"/>
+        <p14:creationId xmlns:p14="http://schemas.microsoft.com/office/powerpoint/2010/main" val="169823913"/>
       </p:ext>
     </p:extLst>
   </p:cSld>

</xml_diff>

<commit_message>
docs: relatório e slides gerados a partir da evidência consolidada (etapa 6)
Os geradores passam a ler output/evidencias/evidencias.json (versão,
testes, p95, interface e CI), sem números transcritos à mão. Retirada a
publicação Supabase/Render (ADR-007), incluídos os agentes de revisão e
o relatório operacional, e corrigidas as referências (2026a-d; removida
a ARCHCORP 2026b, não citada). PDF com 20 páginas; 18 slides.
</commit_message>
<xml_diff>
--- a/output/Apresentacao_Cenario_4.pptx
+++ b/output/Apresentacao_Cenario_4.pptx
@@ -2,30 +2,30 @@
 <file path=ppt/presentation.xml><?xml version="1.0" encoding="utf-8"?>
 <p:presentation xmlns:p="http://schemas.openxmlformats.org/presentationml/2006/main">
   <p:sldMasterIdLst>
-    <p:sldMasterId xmlns:r="http://schemas.openxmlformats.org/officeDocument/2006/relationships" id="2147483648" r:id="Rae7307d456dd468c"/>
+    <p:sldMasterId xmlns:r="http://schemas.openxmlformats.org/officeDocument/2006/relationships" id="2147483648" r:id="Rd41158fea8ef483c"/>
   </p:sldMasterIdLst>
   <p:notesMasterIdLst>
-    <p:notesMasterId xmlns:r="http://schemas.openxmlformats.org/officeDocument/2006/relationships" r:id="Rf449ba9f92d94996"/>
+    <p:notesMasterId xmlns:r="http://schemas.openxmlformats.org/officeDocument/2006/relationships" r:id="R5367f4dd3df14d4a"/>
   </p:notesMasterIdLst>
   <p:sldIdLst>
-    <p:sldId xmlns:r="http://schemas.openxmlformats.org/officeDocument/2006/relationships" id="256" r:id="R4ab5ae0954e14746"/>
-    <p:sldId xmlns:r="http://schemas.openxmlformats.org/officeDocument/2006/relationships" id="257" r:id="R35e9d005f8784510"/>
-    <p:sldId xmlns:r="http://schemas.openxmlformats.org/officeDocument/2006/relationships" id="258" r:id="R501776224dd343de"/>
-    <p:sldId xmlns:r="http://schemas.openxmlformats.org/officeDocument/2006/relationships" id="259" r:id="R1fc09c484ade4540"/>
-    <p:sldId xmlns:r="http://schemas.openxmlformats.org/officeDocument/2006/relationships" id="260" r:id="R9047bfc93c8d4a96"/>
-    <p:sldId xmlns:r="http://schemas.openxmlformats.org/officeDocument/2006/relationships" id="261" r:id="R4cb5ec138c054304"/>
-    <p:sldId xmlns:r="http://schemas.openxmlformats.org/officeDocument/2006/relationships" id="262" r:id="Ra5328b6e023b4101"/>
-    <p:sldId xmlns:r="http://schemas.openxmlformats.org/officeDocument/2006/relationships" id="263" r:id="Rebdf725b57bf42d3"/>
-    <p:sldId xmlns:r="http://schemas.openxmlformats.org/officeDocument/2006/relationships" id="264" r:id="Rc4f3c41e504c4b83"/>
-    <p:sldId xmlns:r="http://schemas.openxmlformats.org/officeDocument/2006/relationships" id="265" r:id="R4c168aa1c6664e92"/>
-    <p:sldId xmlns:r="http://schemas.openxmlformats.org/officeDocument/2006/relationships" id="266" r:id="R0cfd92ed67be4b5e"/>
-    <p:sldId xmlns:r="http://schemas.openxmlformats.org/officeDocument/2006/relationships" id="267" r:id="Rc42f8239c0ab474f"/>
-    <p:sldId xmlns:r="http://schemas.openxmlformats.org/officeDocument/2006/relationships" id="268" r:id="R639d58921a40473f"/>
-    <p:sldId xmlns:r="http://schemas.openxmlformats.org/officeDocument/2006/relationships" id="269" r:id="Raafa89758f3648b2"/>
-    <p:sldId xmlns:r="http://schemas.openxmlformats.org/officeDocument/2006/relationships" id="270" r:id="Rf22a3c7131e5425e"/>
-    <p:sldId xmlns:r="http://schemas.openxmlformats.org/officeDocument/2006/relationships" id="271" r:id="R5a489f66a40a4306"/>
-    <p:sldId xmlns:r="http://schemas.openxmlformats.org/officeDocument/2006/relationships" id="272" r:id="R208bdb58be6d472e"/>
-    <p:sldId xmlns:r="http://schemas.openxmlformats.org/officeDocument/2006/relationships" id="273" r:id="Ra694979cc49d421c"/>
+    <p:sldId xmlns:r="http://schemas.openxmlformats.org/officeDocument/2006/relationships" id="256" r:id="R566469cf66584c9a"/>
+    <p:sldId xmlns:r="http://schemas.openxmlformats.org/officeDocument/2006/relationships" id="257" r:id="Rb810065a080b4ccd"/>
+    <p:sldId xmlns:r="http://schemas.openxmlformats.org/officeDocument/2006/relationships" id="258" r:id="Rd69bee85e6444565"/>
+    <p:sldId xmlns:r="http://schemas.openxmlformats.org/officeDocument/2006/relationships" id="259" r:id="R6802f6c557d748e5"/>
+    <p:sldId xmlns:r="http://schemas.openxmlformats.org/officeDocument/2006/relationships" id="260" r:id="R600c0856ee624af4"/>
+    <p:sldId xmlns:r="http://schemas.openxmlformats.org/officeDocument/2006/relationships" id="261" r:id="R5c1076a1e30d4165"/>
+    <p:sldId xmlns:r="http://schemas.openxmlformats.org/officeDocument/2006/relationships" id="262" r:id="R6d2d7b7a8dd94392"/>
+    <p:sldId xmlns:r="http://schemas.openxmlformats.org/officeDocument/2006/relationships" id="263" r:id="R6fd1a1555291485c"/>
+    <p:sldId xmlns:r="http://schemas.openxmlformats.org/officeDocument/2006/relationships" id="264" r:id="Ra0897982c1ee4259"/>
+    <p:sldId xmlns:r="http://schemas.openxmlformats.org/officeDocument/2006/relationships" id="265" r:id="Rd8088677689e4703"/>
+    <p:sldId xmlns:r="http://schemas.openxmlformats.org/officeDocument/2006/relationships" id="266" r:id="R26e4208e61274c36"/>
+    <p:sldId xmlns:r="http://schemas.openxmlformats.org/officeDocument/2006/relationships" id="267" r:id="R74f01b4d9c4d4eba"/>
+    <p:sldId xmlns:r="http://schemas.openxmlformats.org/officeDocument/2006/relationships" id="268" r:id="Rf49b0efbdc204a1f"/>
+    <p:sldId xmlns:r="http://schemas.openxmlformats.org/officeDocument/2006/relationships" id="269" r:id="Rc0d7e8180f4f41d5"/>
+    <p:sldId xmlns:r="http://schemas.openxmlformats.org/officeDocument/2006/relationships" id="270" r:id="Raf881635198f4112"/>
+    <p:sldId xmlns:r="http://schemas.openxmlformats.org/officeDocument/2006/relationships" id="271" r:id="Re43eb0c434e44aa1"/>
+    <p:sldId xmlns:r="http://schemas.openxmlformats.org/officeDocument/2006/relationships" id="272" r:id="R10ed9c71453c4df0"/>
+    <p:sldId xmlns:r="http://schemas.openxmlformats.org/officeDocument/2006/relationships" id="273" r:id="Reb180658b99f4a58"/>
   </p:sldIdLst>
   <p:sldSz cx="12192000" cy="6858000"/>
   <p:notesSz cx="6858000" cy="9144000"/>
@@ -459,7 +459,7 @@
           <a:lstStyle xmlns:a="http://schemas.openxmlformats.org/drawingml/2006/main"/>
           <a:p xmlns:a="http://schemas.openxmlformats.org/drawingml/2006/main">
             <a:r>
-              <a:t>Fonte principal: Guia.pdf, enunciado acadêmico ArchCorp, 2026, 13 páginas. Cenário 4 aplicado a uma locadora fictícia inspirada na Localiza, com dados sintéticos. Referência técnica: main f1669d78f01e2d279b3de60a999ed778e6c9916e, PR #75 de 25/10/2026, https://github.com/Roger-Quinelato/projetoAplicado7/pull/75, commit consultado localmente. Marcos previstos conforme orientação da entrega. Autoria: Roger Quinelato — backend, produto e negócio; Raquel — frontend e levantamento de requisitos. Não há declaração de aceite docente.</a:t>
+              <a:t>Fonte principal: Guia.pdf, enunciado acadêmico ArchCorp, 2026, 13 páginas. Cenário 4 aplicado a uma locadora fictícia inspirada na Localiza, com dados sintéticos. Referência técnica: versão 534eab2e77363318fedda77509aca0e0031f4e3a, que parte da integração do PR #75 (https://github.com/Roger-Quinelato/projetoAplicado7/pull/75) e inclui as correções do PR #78. Marcos previstos conforme orientação da entrega. Autoria: Roger Quinelato — backend, produto e negócio; Raquel Pereira — frontend e levantamento de requisitos. Não há declaração de aceite docente.</a:t>
             </a:r>
           </a:p>
         </p:txBody>
@@ -809,7 +809,7 @@
           <a:lstStyle xmlns:a="http://schemas.openxmlformats.org/drawingml/2006/main"/>
           <a:p xmlns:a="http://schemas.openxmlformats.org/drawingml/2006/main">
             <a:r>
-              <a:t>Fonte: docs/ATRIBUTOS_QUALIDADE.md (nove atributos com necessidade, risco, estratégia, resultado e evidência) e relatório, seção 4.8. Desempenho histórico de 20/10, local, PostgreSQL 16, 60 clientes e 100 amostras por consulta em 10 consultas de negócio. Não representa hospedagem pública nem medição na main f1669d7.</a:t>
+              <a:t>Fonte: docs/ATRIBUTOS_QUALIDADE.md (nove atributos com necessidade, risco, estratégia, resultado e evidência) e relatório, seção 4.8. Desempenho: 29/10/2026, SQLite local, 60 clientes e 100 amostras por consulta em 10 consultas de negócio, versão 534eab2. Demonstração local; sem publicação pública (ADR-007).</a:t>
             </a:r>
           </a:p>
         </p:txBody>
@@ -1019,7 +1019,7 @@
           <a:lstStyle xmlns:a="http://schemas.openxmlformats.org/drawingml/2006/main"/>
           <a:p xmlns:a="http://schemas.openxmlformats.org/drawingml/2006/main">
             <a:r>
-              <a:t>Fontes: docs/EVIDENCIAS_VALIDACAO.md, seções históricas de 20/10/2026; registro local do commit f1669d78f01e2d279b3de60a999ed778e6c9916e, PR #75, 25/10/2026, https://github.com/Roger-Quinelato/projetoAplicado7/pull/75; logs da CI Verify 40199072801, https://github.com/Roger-Quinelato/projetoAplicado7/actions/runs/40199072801, executada em 25/10 sobre essa main, consultados no GitHub Actions em 28/10/2026. Quatro jobs success: application 252 passed/14 skipped; postgresql 262 passed/4 skipped; rabbitmq 22 passed; e2e 25 passed e axe separado 1 passed. Suítes sobrepostas, sem total agregado. Histórico de 20/10: PostgreSQL 16/RabbitMQ 3.12 locais, contêiner Linux, Python 3.13, 60 clientes, 100 amostras por consulta em 10 consultas de negócio, p95 máximo de 45,1 ms, 22 roteiros de navegador, F1 20/20, F2 14/14 e F3 15/15. O p95 não foi medido novamente na main f1669d7. Verificação local após correções em 28/10: Python 264 aprovados e 14 ignorados, frontend 19 aprovados, TypeScript e OpenAPI check aprovados. Hospedagem pública e PostgreSQL gerenciado sem comprovação.</a:t>
+              <a:t>Fontes: output/evidencias/evidencias.json (tools/consolidar_evidencias.py), gerado em 29/10/2026 sobre a versão 534eab2; docs/EVIDENCIAS_VALIDACAO.md. O relatório operacional (scripts/relatorio_operacional.py) lê GET /api/v1/integration/insights, /metrics e os resumos e propõe uma decisão por indicador. No ensaio, o funil mostrou zero faturas pagas porque os roteiros não exercitam pagamento: a leitura orienta o que demonstrar. Agentes de revisão FDE (cliente e Guia) e QA (portão e código) trabalham somente leitura; a decisão fica com testes, CI e responsável. Demonstração local, sem publicação pública (ADR-007).</a:t>
             </a:r>
           </a:p>
         </p:txBody>
@@ -1089,7 +1089,7 @@
           <a:lstStyle xmlns:a="http://schemas.openxmlformats.org/drawingml/2006/main"/>
           <a:p xmlns:a="http://schemas.openxmlformats.org/drawingml/2006/main">
             <a:r>
-              <a:t>Correções de fechamento: F3 não confirma resolução/reconciliação sem processo; eventos mantêm retentativa e reprocessamento explícito. Encerramento do contrato cancela tarefas pendentes e deriva o estado agregado, preservando tarefas finais. Cancelamento financeiro usa a data UTC e o estado efetivo da consulta; vencida recebe 409. As correções não alteram registros antigos já consumidos. Autoria declarada: Roger Quinelato — backend, produto e negócio; Raquel — frontend e levantamento de requisitos. Permanecem ensaio, aceite docente e comprovação da hospedagem prevista no plano. OIDC, tracing distribuído e consumo pelo broker são evoluções.</a:t>
+              <a:t>Correções de fechamento: F3 não confirma resolução/reconciliação sem processo; eventos mantêm retentativa e reprocessamento explícito. Encerramento do contrato cancela tarefas pendentes e deriva o estado agregado, preservando tarefas finais. Cancelamento financeiro usa a data UTC e o estado efetivo da consulta; vencida recebe 409. As correções não alteram registros antigos já consumidos. Autoria declarada: Roger Quinelato — backend, produto e negócio; Raquel Pereira — frontend e levantamento de requisitos. Permanecem ensaio e aceite docente; a demonstração é local e a publicação pública é evolução (ADR-007). OIDC, tracing distribuído e consumo pelo broker são evoluções.</a:t>
             </a:r>
           </a:p>
         </p:txBody>
@@ -1696,7 +1696,7 @@
           <p:cNvPr id="3" name="Title">
             <a:extLst xmlns:a="http://schemas.openxmlformats.org/drawingml/2006/main">
               <a:ext uri="{FF2B5EF4-FFF2-40B4-BE49-F238E27FC236}">
-                <a16:creationId xmlns:a16="http://schemas.microsoft.com/office/drawing/2014/main" id="{CEE593D6-F72B-43BE-9AC4-77BEFBAB9C63}"/>
+                <a16:creationId xmlns:a16="http://schemas.microsoft.com/office/drawing/2014/main" id="{9AA102E5-F89D-4632-A19A-5A3850669A54}"/>
               </a:ext>
             </a:extLst>
           </p:cNvPr>
@@ -1925,7 +1925,7 @@
           <p:cNvPr id="2" name="Subtitle">
             <a:extLst xmlns:a="http://schemas.openxmlformats.org/drawingml/2006/main">
               <a:ext uri="{FF2B5EF4-FFF2-40B4-BE49-F238E27FC236}">
-                <a16:creationId xmlns:a16="http://schemas.microsoft.com/office/drawing/2014/main" id="{3724803F-9AAA-44BE-990D-F488C48E5230}"/>
+                <a16:creationId xmlns:a16="http://schemas.microsoft.com/office/drawing/2014/main" id="{5F6EA76C-C82F-4CC2-9670-4403FCA916C3}"/>
               </a:ext>
             </a:extLst>
           </p:cNvPr>
@@ -2171,7 +2171,7 @@
           <p:cNvPr id="2" name="Section title">
             <a:extLst xmlns:a="http://schemas.openxmlformats.org/drawingml/2006/main">
               <a:ext uri="{FF2B5EF4-FFF2-40B4-BE49-F238E27FC236}">
-                <a16:creationId xmlns:a16="http://schemas.microsoft.com/office/drawing/2014/main" id="{C012BA3A-20E3-4570-BCE9-EADBED3A76C3}"/>
+                <a16:creationId xmlns:a16="http://schemas.microsoft.com/office/drawing/2014/main" id="{3AD36F8B-7093-4426-9EE1-48C1A7EFC3A1}"/>
               </a:ext>
             </a:extLst>
           </p:cNvPr>
@@ -2417,7 +2417,7 @@
           <p:cNvPr id="3" name="Title">
             <a:extLst xmlns:a="http://schemas.openxmlformats.org/drawingml/2006/main">
               <a:ext uri="{FF2B5EF4-FFF2-40B4-BE49-F238E27FC236}">
-                <a16:creationId xmlns:a16="http://schemas.microsoft.com/office/drawing/2014/main" id="{7033B1B7-8AA5-481A-950F-F755C50D4F9F}"/>
+                <a16:creationId xmlns:a16="http://schemas.microsoft.com/office/drawing/2014/main" id="{90C89FDD-2725-47C4-9A99-C449438B4A9D}"/>
               </a:ext>
             </a:extLst>
           </p:cNvPr>
@@ -2646,7 +2646,7 @@
           <p:cNvPr id="2" name="Body">
             <a:extLst xmlns:a="http://schemas.openxmlformats.org/drawingml/2006/main">
               <a:ext uri="{FF2B5EF4-FFF2-40B4-BE49-F238E27FC236}">
-                <a16:creationId xmlns:a16="http://schemas.microsoft.com/office/drawing/2014/main" id="{AAF78521-657A-422A-B4FE-C5FFF8F32695}"/>
+                <a16:creationId xmlns:a16="http://schemas.microsoft.com/office/drawing/2014/main" id="{6A134C65-B850-42E4-9B3B-8FAFB8847DF7}"/>
               </a:ext>
             </a:extLst>
           </p:cNvPr>
@@ -2892,7 +2892,7 @@
           <p:cNvPr id="4" name="Title">
             <a:extLst xmlns:a="http://schemas.openxmlformats.org/drawingml/2006/main">
               <a:ext uri="{FF2B5EF4-FFF2-40B4-BE49-F238E27FC236}">
-                <a16:creationId xmlns:a16="http://schemas.microsoft.com/office/drawing/2014/main" id="{A7BC370B-34D0-451D-AE94-5E81F0ED2455}"/>
+                <a16:creationId xmlns:a16="http://schemas.microsoft.com/office/drawing/2014/main" id="{A5B52A49-DD2E-417E-81E5-0E8DC5986D0B}"/>
               </a:ext>
             </a:extLst>
           </p:cNvPr>
@@ -3121,7 +3121,7 @@
           <p:cNvPr id="2" name="Left column">
             <a:extLst xmlns:a="http://schemas.openxmlformats.org/drawingml/2006/main">
               <a:ext uri="{FF2B5EF4-FFF2-40B4-BE49-F238E27FC236}">
-                <a16:creationId xmlns:a16="http://schemas.microsoft.com/office/drawing/2014/main" id="{4E7BA3BD-838A-4DE0-87C0-F04DAD564D1B}"/>
+                <a16:creationId xmlns:a16="http://schemas.microsoft.com/office/drawing/2014/main" id="{072D5F21-CB76-4B97-A44C-3E9B8C886E97}"/>
               </a:ext>
             </a:extLst>
           </p:cNvPr>
@@ -3350,7 +3350,7 @@
           <p:cNvPr id="3" name="Right column">
             <a:extLst xmlns:a="http://schemas.openxmlformats.org/drawingml/2006/main">
               <a:ext uri="{FF2B5EF4-FFF2-40B4-BE49-F238E27FC236}">
-                <a16:creationId xmlns:a16="http://schemas.microsoft.com/office/drawing/2014/main" id="{F85DE391-5210-4C50-BC51-8E74EF8A2E7B}"/>
+                <a16:creationId xmlns:a16="http://schemas.microsoft.com/office/drawing/2014/main" id="{210E4041-F794-47C5-A7D6-1A8D161E540C}"/>
               </a:ext>
             </a:extLst>
           </p:cNvPr>
@@ -3596,7 +3596,7 @@
           <p:cNvPr id="3" name="Title">
             <a:extLst xmlns:a="http://schemas.openxmlformats.org/drawingml/2006/main">
               <a:ext uri="{FF2B5EF4-FFF2-40B4-BE49-F238E27FC236}">
-                <a16:creationId xmlns:a16="http://schemas.microsoft.com/office/drawing/2014/main" id="{AE762BA5-AF84-400C-BB56-1F66DBD205DC}"/>
+                <a16:creationId xmlns:a16="http://schemas.microsoft.com/office/drawing/2014/main" id="{84EE5A09-02DF-49A0-83DE-A2E82FAE128B}"/>
               </a:ext>
             </a:extLst>
           </p:cNvPr>
@@ -3825,7 +3825,7 @@
           <p:cNvPr id="2" name="Left column">
             <a:extLst xmlns:a="http://schemas.openxmlformats.org/drawingml/2006/main">
               <a:ext uri="{FF2B5EF4-FFF2-40B4-BE49-F238E27FC236}">
-                <a16:creationId xmlns:a16="http://schemas.microsoft.com/office/drawing/2014/main" id="{EFD41CB0-1A43-40DB-89C3-7BF57DC7C842}"/>
+                <a16:creationId xmlns:a16="http://schemas.microsoft.com/office/drawing/2014/main" id="{4A63F8A7-3B58-4A03-A040-C1D829A8E9C7}"/>
               </a:ext>
             </a:extLst>
           </p:cNvPr>
@@ -4092,12 +4092,12 @@
   </p:cSld>
   <p:clrMap bg1="lt1" tx1="dk1" bg2="lt2" tx2="dk2" accent1="accent1" accent2="accent2" accent3="accent3" accent4="accent4" accent5="accent5" accent6="accent6" hlink="hlink" folHlink="folHlink"/>
   <p:sldLayoutIdLst>
-    <p:sldLayoutId xmlns:r="http://schemas.openxmlformats.org/officeDocument/2006/relationships" id="2147483649" r:id="Rcf4242fc289b4761"/>
-    <p:sldLayoutId xmlns:r="http://schemas.openxmlformats.org/officeDocument/2006/relationships" id="2147483650" r:id="R37ad38a59baa40d6"/>
-    <p:sldLayoutId xmlns:r="http://schemas.openxmlformats.org/officeDocument/2006/relationships" id="2147483651" r:id="R28b31ef2446e4d08"/>
-    <p:sldLayoutId xmlns:r="http://schemas.openxmlformats.org/officeDocument/2006/relationships" id="2147483652" r:id="R4c38481493bf4911"/>
-    <p:sldLayoutId xmlns:r="http://schemas.openxmlformats.org/officeDocument/2006/relationships" id="2147483653" r:id="R4e47be286a5f4d82"/>
-    <p:sldLayoutId xmlns:r="http://schemas.openxmlformats.org/officeDocument/2006/relationships" id="2147483654" r:id="R19167ebe19734fdb"/>
+    <p:sldLayoutId xmlns:r="http://schemas.openxmlformats.org/officeDocument/2006/relationships" id="2147483649" r:id="Rffa414c81f9144e5"/>
+    <p:sldLayoutId xmlns:r="http://schemas.openxmlformats.org/officeDocument/2006/relationships" id="2147483650" r:id="R7c90641b895e41aa"/>
+    <p:sldLayoutId xmlns:r="http://schemas.openxmlformats.org/officeDocument/2006/relationships" id="2147483651" r:id="R5f95b560205c4b28"/>
+    <p:sldLayoutId xmlns:r="http://schemas.openxmlformats.org/officeDocument/2006/relationships" id="2147483652" r:id="R93e37e7dc6de4a3f"/>
+    <p:sldLayoutId xmlns:r="http://schemas.openxmlformats.org/officeDocument/2006/relationships" id="2147483653" r:id="R902f3b9f3e8c45d4"/>
+    <p:sldLayoutId xmlns:r="http://schemas.openxmlformats.org/officeDocument/2006/relationships" id="2147483654" r:id="R0bac7e476ec3465c"/>
   </p:sldLayoutIdLst>
   <p:txStyles>
     <p:titleStyle>
@@ -4648,7 +4648,7 @@
           <p:cNvPr id="5" name="">
             <a:extLst xmlns:a="http://schemas.openxmlformats.org/drawingml/2006/main">
               <a:ext uri="{FF2B5EF4-FFF2-40B4-BE49-F238E27FC236}">
-                <a16:creationId xmlns:a16="http://schemas.microsoft.com/office/drawing/2014/main" id="{987BA7BF-0FC3-42F5-BEDD-56D0F88CBE37}"/>
+                <a16:creationId xmlns:a16="http://schemas.microsoft.com/office/drawing/2014/main" id="{19E902CE-B7DD-48CE-8FF0-9F4715E2AB84}"/>
               </a:ext>
             </a:extLst>
           </p:cNvPr>
@@ -4829,7 +4829,7 @@
           <p:cNvPr id="2" name="">
             <a:extLst xmlns:a="http://schemas.openxmlformats.org/drawingml/2006/main">
               <a:ext uri="{FF2B5EF4-FFF2-40B4-BE49-F238E27FC236}">
-                <a16:creationId xmlns:a16="http://schemas.microsoft.com/office/drawing/2014/main" id="{76123F34-9206-44F9-873E-D8CE77E13921}"/>
+                <a16:creationId xmlns:a16="http://schemas.microsoft.com/office/drawing/2014/main" id="{BCD16174-470A-4163-B158-9EC05DBBCBB9}"/>
               </a:ext>
             </a:extLst>
           </p:cNvPr>
@@ -4987,7 +4987,7 @@
           <p:cNvPr id="3" name="">
             <a:extLst xmlns:a="http://schemas.openxmlformats.org/drawingml/2006/main">
               <a:ext uri="{FF2B5EF4-FFF2-40B4-BE49-F238E27FC236}">
-                <a16:creationId xmlns:a16="http://schemas.microsoft.com/office/drawing/2014/main" id="{18A8A6F4-153E-4098-9BFA-1F94814AB763}"/>
+                <a16:creationId xmlns:a16="http://schemas.microsoft.com/office/drawing/2014/main" id="{D5BD39C5-7B7F-4672-80C8-21E3F59D785E}"/>
               </a:ext>
             </a:extLst>
           </p:cNvPr>
@@ -5017,7 +5017,7 @@
           <p:cNvPr id="4" name="">
             <a:extLst xmlns:a="http://schemas.openxmlformats.org/drawingml/2006/main">
               <a:ext uri="{FF2B5EF4-FFF2-40B4-BE49-F238E27FC236}">
-                <a16:creationId xmlns:a16="http://schemas.microsoft.com/office/drawing/2014/main" id="{2D1C11C2-D764-4258-BF41-94F5B3CC20D6}"/>
+                <a16:creationId xmlns:a16="http://schemas.microsoft.com/office/drawing/2014/main" id="{22175279-7608-49B8-8A1B-076AC60F4162}"/>
               </a:ext>
             </a:extLst>
           </p:cNvPr>
@@ -5188,7 +5188,7 @@
                 <a:ea typeface="Arial"/>
                 <a:cs typeface="Arial"/>
               </a:rPr>
-              <a:t>Raquel — frontend e levantamento de requisitos</a:t>
+              <a:t>Raquel Pereira — frontend e levantamento de requisitos</a:t>
             </a:r>
           </a:p>
           <a:p xmlns:a="http://schemas.openxmlformats.org/drawingml/2006/main">
@@ -5211,7 +5211,7 @@
                 <a:ea typeface="Arial"/>
                 <a:cs typeface="Arial"/>
               </a:rPr>
-              <a:t>Versão 28/10/2026  ·  Base main f1669d7</a:t>
+              <a:t>Versão 29/10/2026  ·  Versão do código 534eab2</a:t>
             </a:r>
           </a:p>
           <a:p xmlns:a="http://schemas.openxmlformats.org/drawingml/2006/main">
@@ -5242,7 +5242,7 @@
     </p:spTree>
     <p:extLst>
       <p:ext uri="{BB962C8B-B14F-4D97-AF65-F5344CB8AC3E}">
-        <p14:creationId xmlns:p14="http://schemas.microsoft.com/office/powerpoint/2010/main" val="1715833366"/>
+        <p14:creationId xmlns:p14="http://schemas.microsoft.com/office/powerpoint/2010/main" val="126891129"/>
       </p:ext>
     </p:extLst>
   </p:cSld>
@@ -5273,7 +5273,7 @@
           <p:cNvPr id="8" name="">
             <a:extLst xmlns:a="http://schemas.openxmlformats.org/drawingml/2006/main">
               <a:ext uri="{FF2B5EF4-FFF2-40B4-BE49-F238E27FC236}">
-                <a16:creationId xmlns:a16="http://schemas.microsoft.com/office/drawing/2014/main" id="{F4340F95-C2FD-43D6-AC0E-75A5BE08FD12}"/>
+                <a16:creationId xmlns:a16="http://schemas.microsoft.com/office/drawing/2014/main" id="{2952DDB7-7237-46B3-A268-B8B42B08CCC9}"/>
               </a:ext>
             </a:extLst>
           </p:cNvPr>
@@ -5305,7 +5305,7 @@
           <p:cNvPr id="7" name="">
             <a:extLst xmlns:a="http://schemas.openxmlformats.org/drawingml/2006/main">
               <a:ext uri="{FF2B5EF4-FFF2-40B4-BE49-F238E27FC236}">
-                <a16:creationId xmlns:a16="http://schemas.microsoft.com/office/drawing/2014/main" id="{290953B0-AFF9-42BC-AAD0-E4C0CB082878}"/>
+                <a16:creationId xmlns:a16="http://schemas.microsoft.com/office/drawing/2014/main" id="{2E80D9D7-70E9-43BC-96AF-A5CBAC461659}"/>
               </a:ext>
             </a:extLst>
           </p:cNvPr>
@@ -5337,7 +5337,7 @@
           <p:cNvPr id="12" name="">
             <a:extLst xmlns:a="http://schemas.openxmlformats.org/drawingml/2006/main">
               <a:ext uri="{FF2B5EF4-FFF2-40B4-BE49-F238E27FC236}">
-                <a16:creationId xmlns:a16="http://schemas.microsoft.com/office/drawing/2014/main" id="{B82F13E3-7D5F-4DC1-8451-AF0FF40249EA}"/>
+                <a16:creationId xmlns:a16="http://schemas.microsoft.com/office/drawing/2014/main" id="{94891469-9D79-4944-BD93-7A673D4AA148}"/>
               </a:ext>
             </a:extLst>
           </p:cNvPr>
@@ -5367,7 +5367,7 @@
           <p:cNvPr id="2" name="">
             <a:extLst xmlns:a="http://schemas.openxmlformats.org/drawingml/2006/main">
               <a:ext uri="{FF2B5EF4-FFF2-40B4-BE49-F238E27FC236}">
-                <a16:creationId xmlns:a16="http://schemas.microsoft.com/office/drawing/2014/main" id="{16167645-8593-414A-8792-967363AA1605}"/>
+                <a16:creationId xmlns:a16="http://schemas.microsoft.com/office/drawing/2014/main" id="{9CCF4DF1-A929-4A33-8616-10E2DFD6F39C}"/>
               </a:ext>
             </a:extLst>
           </p:cNvPr>
@@ -5525,7 +5525,7 @@
           <p:cNvPr id="3" name="">
             <a:extLst xmlns:a="http://schemas.openxmlformats.org/drawingml/2006/main">
               <a:ext uri="{FF2B5EF4-FFF2-40B4-BE49-F238E27FC236}">
-                <a16:creationId xmlns:a16="http://schemas.microsoft.com/office/drawing/2014/main" id="{6A289B18-A401-4FE9-B1EF-F2ABFA04B86D}"/>
+                <a16:creationId xmlns:a16="http://schemas.microsoft.com/office/drawing/2014/main" id="{CDDAC8E6-68F3-44D5-9A06-AA51DA5D35A8}"/>
               </a:ext>
             </a:extLst>
           </p:cNvPr>
@@ -5673,7 +5673,7 @@
                 <a:ea typeface="Arial"/>
                 <a:cs typeface="Arial"/>
               </a:rPr>
-              <a:t>Projeto Aplicado Cenário 4  ·  Versão 28/10/2026</a:t>
+              <a:t>Projeto Aplicado Cenário 4  ·  Versão 29/10/2026</a:t>
             </a:r>
           </a:p>
         </p:txBody>
@@ -5683,7 +5683,7 @@
           <p:cNvPr id="4" name="">
             <a:extLst xmlns:a="http://schemas.openxmlformats.org/drawingml/2006/main">
               <a:ext uri="{FF2B5EF4-FFF2-40B4-BE49-F238E27FC236}">
-                <a16:creationId xmlns:a16="http://schemas.microsoft.com/office/drawing/2014/main" id="{2BF395EF-1D18-48D1-B4E5-C7F4015A3DCA}"/>
+                <a16:creationId xmlns:a16="http://schemas.microsoft.com/office/drawing/2014/main" id="{10BD2622-613A-4195-965B-45C561BB5226}"/>
               </a:ext>
             </a:extLst>
           </p:cNvPr>
@@ -5871,7 +5871,7 @@
           <p:cNvPr id="5" name="">
             <a:extLst xmlns:a="http://schemas.openxmlformats.org/drawingml/2006/main">
               <a:ext uri="{FF2B5EF4-FFF2-40B4-BE49-F238E27FC236}">
-                <a16:creationId xmlns:a16="http://schemas.microsoft.com/office/drawing/2014/main" id="{A8602A70-E0EB-45AD-AFFD-503B494A1922}"/>
+                <a16:creationId xmlns:a16="http://schemas.microsoft.com/office/drawing/2014/main" id="{33C1CFF4-ED2F-4241-8BCB-DAC985BDFD65}"/>
               </a:ext>
             </a:extLst>
           </p:cNvPr>
@@ -6059,7 +6059,7 @@
           <p:cNvPr id="6" name="">
             <a:extLst xmlns:a="http://schemas.openxmlformats.org/drawingml/2006/main">
               <a:ext uri="{FF2B5EF4-FFF2-40B4-BE49-F238E27FC236}">
-                <a16:creationId xmlns:a16="http://schemas.microsoft.com/office/drawing/2014/main" id="{CDD117A8-CBA2-4A38-BB28-78C271E5B39D}"/>
+                <a16:creationId xmlns:a16="http://schemas.microsoft.com/office/drawing/2014/main" id="{9E3609B4-883B-4CF4-99B5-48DD70F5DB94}"/>
               </a:ext>
             </a:extLst>
           </p:cNvPr>
@@ -6247,7 +6247,7 @@
           <p:cNvPr id="9" name="">
             <a:extLst xmlns:a="http://schemas.openxmlformats.org/drawingml/2006/main">
               <a:ext uri="{FF2B5EF4-FFF2-40B4-BE49-F238E27FC236}">
-                <a16:creationId xmlns:a16="http://schemas.microsoft.com/office/drawing/2014/main" id="{06950075-DB97-46C0-A69F-39E64DD29B5B}"/>
+                <a16:creationId xmlns:a16="http://schemas.microsoft.com/office/drawing/2014/main" id="{A842D84A-7F76-4007-841A-7806ED340234}"/>
               </a:ext>
             </a:extLst>
           </p:cNvPr>
@@ -6405,7 +6405,7 @@
           <p:cNvPr id="10" name="">
             <a:extLst xmlns:a="http://schemas.openxmlformats.org/drawingml/2006/main">
               <a:ext uri="{FF2B5EF4-FFF2-40B4-BE49-F238E27FC236}">
-                <a16:creationId xmlns:a16="http://schemas.microsoft.com/office/drawing/2014/main" id="{A77F34D2-41C4-4F3E-970F-5BD0C97A99CB}"/>
+                <a16:creationId xmlns:a16="http://schemas.microsoft.com/office/drawing/2014/main" id="{8B6FC505-313C-4065-A185-F7A2488E9DFA}"/>
               </a:ext>
             </a:extLst>
           </p:cNvPr>
@@ -6563,7 +6563,7 @@
           <p:cNvPr id="11" name="">
             <a:extLst xmlns:a="http://schemas.openxmlformats.org/drawingml/2006/main">
               <a:ext uri="{FF2B5EF4-FFF2-40B4-BE49-F238E27FC236}">
-                <a16:creationId xmlns:a16="http://schemas.microsoft.com/office/drawing/2014/main" id="{A78C98D4-DDD9-4A4C-B071-EDE7E735E8D5}"/>
+                <a16:creationId xmlns:a16="http://schemas.microsoft.com/office/drawing/2014/main" id="{06026431-62B0-42FC-B140-596D9F755245}"/>
               </a:ext>
             </a:extLst>
           </p:cNvPr>
@@ -6719,7 +6719,7 @@
     </p:spTree>
     <p:extLst>
       <p:ext uri="{BB962C8B-B14F-4D97-AF65-F5344CB8AC3E}">
-        <p14:creationId xmlns:p14="http://schemas.microsoft.com/office/powerpoint/2010/main" val="890944476"/>
+        <p14:creationId xmlns:p14="http://schemas.microsoft.com/office/powerpoint/2010/main" val="2015259319"/>
       </p:ext>
     </p:extLst>
   </p:cSld>
@@ -6750,7 +6750,7 @@
           <p:cNvPr id="10" name="">
             <a:extLst xmlns:a="http://schemas.openxmlformats.org/drawingml/2006/main">
               <a:ext uri="{FF2B5EF4-FFF2-40B4-BE49-F238E27FC236}">
-                <a16:creationId xmlns:a16="http://schemas.microsoft.com/office/drawing/2014/main" id="{1E89D90C-7176-491F-97E0-556268202BC1}"/>
+                <a16:creationId xmlns:a16="http://schemas.microsoft.com/office/drawing/2014/main" id="{0354A235-5341-416E-89EB-93072DC01E8A}"/>
               </a:ext>
             </a:extLst>
           </p:cNvPr>
@@ -6784,7 +6784,7 @@
           <p:cNvPr id="9" name="">
             <a:extLst xmlns:a="http://schemas.openxmlformats.org/drawingml/2006/main">
               <a:ext uri="{FF2B5EF4-FFF2-40B4-BE49-F238E27FC236}">
-                <a16:creationId xmlns:a16="http://schemas.microsoft.com/office/drawing/2014/main" id="{8AC28AD2-0A05-4345-AA0E-F7DC0BC11448}"/>
+                <a16:creationId xmlns:a16="http://schemas.microsoft.com/office/drawing/2014/main" id="{29EAEAEE-97EA-448F-970F-F071032CDF4C}"/>
               </a:ext>
             </a:extLst>
           </p:cNvPr>
@@ -6818,7 +6818,7 @@
           <p:cNvPr id="8" name="">
             <a:extLst xmlns:a="http://schemas.openxmlformats.org/drawingml/2006/main">
               <a:ext uri="{FF2B5EF4-FFF2-40B4-BE49-F238E27FC236}">
-                <a16:creationId xmlns:a16="http://schemas.microsoft.com/office/drawing/2014/main" id="{47C2A792-1E08-4C39-BE29-B100E648C53D}"/>
+                <a16:creationId xmlns:a16="http://schemas.microsoft.com/office/drawing/2014/main" id="{EF690F9E-F5CA-4A2D-A3C3-2BAC11159329}"/>
               </a:ext>
             </a:extLst>
           </p:cNvPr>
@@ -6850,7 +6850,7 @@
           <p:cNvPr id="13" name="">
             <a:extLst xmlns:a="http://schemas.openxmlformats.org/drawingml/2006/main">
               <a:ext uri="{FF2B5EF4-FFF2-40B4-BE49-F238E27FC236}">
-                <a16:creationId xmlns:a16="http://schemas.microsoft.com/office/drawing/2014/main" id="{EA7E3721-7FDC-46F4-9F81-D2BC6EA8AD09}"/>
+                <a16:creationId xmlns:a16="http://schemas.microsoft.com/office/drawing/2014/main" id="{4EECBECE-EB96-4143-8E37-B0F3869362EF}"/>
               </a:ext>
             </a:extLst>
           </p:cNvPr>
@@ -6880,7 +6880,7 @@
           <p:cNvPr id="2" name="">
             <a:extLst xmlns:a="http://schemas.openxmlformats.org/drawingml/2006/main">
               <a:ext uri="{FF2B5EF4-FFF2-40B4-BE49-F238E27FC236}">
-                <a16:creationId xmlns:a16="http://schemas.microsoft.com/office/drawing/2014/main" id="{014D9F2B-4B42-4412-A15A-C0E9AC76FFD2}"/>
+                <a16:creationId xmlns:a16="http://schemas.microsoft.com/office/drawing/2014/main" id="{A7D3A45E-F6AD-4F59-96C1-32B7AC0AFED8}"/>
               </a:ext>
             </a:extLst>
           </p:cNvPr>
@@ -7038,7 +7038,7 @@
           <p:cNvPr id="3" name="">
             <a:extLst xmlns:a="http://schemas.openxmlformats.org/drawingml/2006/main">
               <a:ext uri="{FF2B5EF4-FFF2-40B4-BE49-F238E27FC236}">
-                <a16:creationId xmlns:a16="http://schemas.microsoft.com/office/drawing/2014/main" id="{F4E6950C-272C-4D8C-BBD0-D5177ACBE8F0}"/>
+                <a16:creationId xmlns:a16="http://schemas.microsoft.com/office/drawing/2014/main" id="{A291D903-8249-4DFB-8F22-5786C088183A}"/>
               </a:ext>
             </a:extLst>
           </p:cNvPr>
@@ -7186,7 +7186,7 @@
                 <a:ea typeface="Arial"/>
                 <a:cs typeface="Arial"/>
               </a:rPr>
-              <a:t>Projeto Aplicado Cenário 4  ·  Versão 28/10/2026</a:t>
+              <a:t>Projeto Aplicado Cenário 4  ·  Versão 29/10/2026</a:t>
             </a:r>
           </a:p>
         </p:txBody>
@@ -7196,7 +7196,7 @@
           <p:cNvPr id="4" name="">
             <a:extLst xmlns:a="http://schemas.openxmlformats.org/drawingml/2006/main">
               <a:ext uri="{FF2B5EF4-FFF2-40B4-BE49-F238E27FC236}">
-                <a16:creationId xmlns:a16="http://schemas.microsoft.com/office/drawing/2014/main" id="{47C3A952-48B4-4BC4-B950-F8E432EF3A0D}"/>
+                <a16:creationId xmlns:a16="http://schemas.microsoft.com/office/drawing/2014/main" id="{6B253BC4-CE36-4A66-87E9-272D0A7D1DDF}"/>
               </a:ext>
             </a:extLst>
           </p:cNvPr>
@@ -7384,7 +7384,7 @@
           <p:cNvPr id="5" name="">
             <a:extLst xmlns:a="http://schemas.openxmlformats.org/drawingml/2006/main">
               <a:ext uri="{FF2B5EF4-FFF2-40B4-BE49-F238E27FC236}">
-                <a16:creationId xmlns:a16="http://schemas.microsoft.com/office/drawing/2014/main" id="{9781F7D2-F3CD-4B84-94AC-25820256BCD2}"/>
+                <a16:creationId xmlns:a16="http://schemas.microsoft.com/office/drawing/2014/main" id="{F9130336-CB93-4DDB-BFE0-8577D810C70E}"/>
               </a:ext>
             </a:extLst>
           </p:cNvPr>
@@ -7572,7 +7572,7 @@
           <p:cNvPr id="6" name="">
             <a:extLst xmlns:a="http://schemas.openxmlformats.org/drawingml/2006/main">
               <a:ext uri="{FF2B5EF4-FFF2-40B4-BE49-F238E27FC236}">
-                <a16:creationId xmlns:a16="http://schemas.microsoft.com/office/drawing/2014/main" id="{0BEB7B8A-C81A-4FA4-8059-C41E7ABB649F}"/>
+                <a16:creationId xmlns:a16="http://schemas.microsoft.com/office/drawing/2014/main" id="{B2099862-92D3-4D23-B9E4-C5E5962F2994}"/>
               </a:ext>
             </a:extLst>
           </p:cNvPr>
@@ -7760,7 +7760,7 @@
           <p:cNvPr id="7" name="">
             <a:extLst xmlns:a="http://schemas.openxmlformats.org/drawingml/2006/main">
               <a:ext uri="{FF2B5EF4-FFF2-40B4-BE49-F238E27FC236}">
-                <a16:creationId xmlns:a16="http://schemas.microsoft.com/office/drawing/2014/main" id="{9D0919A4-AB28-4234-8C3D-5008F443207F}"/>
+                <a16:creationId xmlns:a16="http://schemas.microsoft.com/office/drawing/2014/main" id="{34137EC9-5A69-40A6-B8BC-5DFF3B1D9346}"/>
               </a:ext>
             </a:extLst>
           </p:cNvPr>
@@ -7948,7 +7948,7 @@
           <p:cNvPr id="11" name="">
             <a:extLst xmlns:a="http://schemas.openxmlformats.org/drawingml/2006/main">
               <a:ext uri="{FF2B5EF4-FFF2-40B4-BE49-F238E27FC236}">
-                <a16:creationId xmlns:a16="http://schemas.microsoft.com/office/drawing/2014/main" id="{6A0CBF89-ECE9-4060-8946-E8848A38186F}"/>
+                <a16:creationId xmlns:a16="http://schemas.microsoft.com/office/drawing/2014/main" id="{7D0E2AA3-4CA6-4FAA-8CEA-08532C059A9B}"/>
               </a:ext>
             </a:extLst>
           </p:cNvPr>
@@ -8106,7 +8106,7 @@
           <p:cNvPr id="12" name="">
             <a:extLst xmlns:a="http://schemas.openxmlformats.org/drawingml/2006/main">
               <a:ext uri="{FF2B5EF4-FFF2-40B4-BE49-F238E27FC236}">
-                <a16:creationId xmlns:a16="http://schemas.microsoft.com/office/drawing/2014/main" id="{33F2A241-8FE6-42C2-B275-929E15CE69C0}"/>
+                <a16:creationId xmlns:a16="http://schemas.microsoft.com/office/drawing/2014/main" id="{68912780-4105-409A-ABA4-18F02EE63187}"/>
               </a:ext>
             </a:extLst>
           </p:cNvPr>
@@ -8262,7 +8262,7 @@
     </p:spTree>
     <p:extLst>
       <p:ext uri="{BB962C8B-B14F-4D97-AF65-F5344CB8AC3E}">
-        <p14:creationId xmlns:p14="http://schemas.microsoft.com/office/powerpoint/2010/main" val="1218121198"/>
+        <p14:creationId xmlns:p14="http://schemas.microsoft.com/office/powerpoint/2010/main" val="667982043"/>
       </p:ext>
     </p:extLst>
   </p:cSld>
@@ -8293,7 +8293,7 @@
           <p:cNvPr id="10" name="">
             <a:extLst xmlns:a="http://schemas.openxmlformats.org/drawingml/2006/main">
               <a:ext uri="{FF2B5EF4-FFF2-40B4-BE49-F238E27FC236}">
-                <a16:creationId xmlns:a16="http://schemas.microsoft.com/office/drawing/2014/main" id="{315AFB7D-BE6C-4CD3-9503-47969409EE92}"/>
+                <a16:creationId xmlns:a16="http://schemas.microsoft.com/office/drawing/2014/main" id="{F3328531-5D41-406A-B694-5CC36FAAAF15}"/>
               </a:ext>
             </a:extLst>
           </p:cNvPr>
@@ -8325,7 +8325,7 @@
           <p:cNvPr id="9" name="">
             <a:extLst xmlns:a="http://schemas.openxmlformats.org/drawingml/2006/main">
               <a:ext uri="{FF2B5EF4-FFF2-40B4-BE49-F238E27FC236}">
-                <a16:creationId xmlns:a16="http://schemas.microsoft.com/office/drawing/2014/main" id="{A6F2292E-3616-430E-9B13-4373841738AB}"/>
+                <a16:creationId xmlns:a16="http://schemas.microsoft.com/office/drawing/2014/main" id="{4E51A862-6184-4970-9EA2-6568322143CE}"/>
               </a:ext>
             </a:extLst>
           </p:cNvPr>
@@ -8357,7 +8357,7 @@
           <p:cNvPr id="8" name="">
             <a:extLst xmlns:a="http://schemas.openxmlformats.org/drawingml/2006/main">
               <a:ext uri="{FF2B5EF4-FFF2-40B4-BE49-F238E27FC236}">
-                <a16:creationId xmlns:a16="http://schemas.microsoft.com/office/drawing/2014/main" id="{BECEB873-C258-4577-A8D4-E33A5AB08AF3}"/>
+                <a16:creationId xmlns:a16="http://schemas.microsoft.com/office/drawing/2014/main" id="{7B3E442D-D6D2-439C-8B50-81388F209CD0}"/>
               </a:ext>
             </a:extLst>
           </p:cNvPr>
@@ -8391,7 +8391,7 @@
           <p:cNvPr id="13" name="">
             <a:extLst xmlns:a="http://schemas.openxmlformats.org/drawingml/2006/main">
               <a:ext uri="{FF2B5EF4-FFF2-40B4-BE49-F238E27FC236}">
-                <a16:creationId xmlns:a16="http://schemas.microsoft.com/office/drawing/2014/main" id="{9ED38835-D701-44D0-B376-F0D6860D81BF}"/>
+                <a16:creationId xmlns:a16="http://schemas.microsoft.com/office/drawing/2014/main" id="{1C2C04D5-20BC-4BF7-8E77-877F95C16317}"/>
               </a:ext>
             </a:extLst>
           </p:cNvPr>
@@ -8421,7 +8421,7 @@
           <p:cNvPr id="2" name="">
             <a:extLst xmlns:a="http://schemas.openxmlformats.org/drawingml/2006/main">
               <a:ext uri="{FF2B5EF4-FFF2-40B4-BE49-F238E27FC236}">
-                <a16:creationId xmlns:a16="http://schemas.microsoft.com/office/drawing/2014/main" id="{1D6AD531-A881-4430-98B7-7282EB355112}"/>
+                <a16:creationId xmlns:a16="http://schemas.microsoft.com/office/drawing/2014/main" id="{32649F3A-C7DB-4874-88D9-7EA19CD40482}"/>
               </a:ext>
             </a:extLst>
           </p:cNvPr>
@@ -8579,7 +8579,7 @@
           <p:cNvPr id="3" name="">
             <a:extLst xmlns:a="http://schemas.openxmlformats.org/drawingml/2006/main">
               <a:ext uri="{FF2B5EF4-FFF2-40B4-BE49-F238E27FC236}">
-                <a16:creationId xmlns:a16="http://schemas.microsoft.com/office/drawing/2014/main" id="{ED5F12ED-C70B-4BE2-952E-64629CCD6DF7}"/>
+                <a16:creationId xmlns:a16="http://schemas.microsoft.com/office/drawing/2014/main" id="{222D795F-0C1F-4C63-B545-14E6E2FF5A85}"/>
               </a:ext>
             </a:extLst>
           </p:cNvPr>
@@ -8727,7 +8727,7 @@
                 <a:ea typeface="Arial"/>
                 <a:cs typeface="Arial"/>
               </a:rPr>
-              <a:t>Projeto Aplicado Cenário 4  ·  Versão 28/10/2026</a:t>
+              <a:t>Projeto Aplicado Cenário 4  ·  Versão 29/10/2026</a:t>
             </a:r>
           </a:p>
         </p:txBody>
@@ -8737,7 +8737,7 @@
           <p:cNvPr id="4" name="">
             <a:extLst xmlns:a="http://schemas.openxmlformats.org/drawingml/2006/main">
               <a:ext uri="{FF2B5EF4-FFF2-40B4-BE49-F238E27FC236}">
-                <a16:creationId xmlns:a16="http://schemas.microsoft.com/office/drawing/2014/main" id="{60EA2A85-1424-4361-9E85-98CF621FA2A6}"/>
+                <a16:creationId xmlns:a16="http://schemas.microsoft.com/office/drawing/2014/main" id="{65AA1E53-0B2E-4F02-B7F5-B263D69D4770}"/>
               </a:ext>
             </a:extLst>
           </p:cNvPr>
@@ -8925,7 +8925,7 @@
           <p:cNvPr id="5" name="">
             <a:extLst xmlns:a="http://schemas.openxmlformats.org/drawingml/2006/main">
               <a:ext uri="{FF2B5EF4-FFF2-40B4-BE49-F238E27FC236}">
-                <a16:creationId xmlns:a16="http://schemas.microsoft.com/office/drawing/2014/main" id="{BC75E7CE-1FF9-4E15-921D-2E73F425FC0D}"/>
+                <a16:creationId xmlns:a16="http://schemas.microsoft.com/office/drawing/2014/main" id="{1C404933-79D3-4193-AF8C-9600120325AE}"/>
               </a:ext>
             </a:extLst>
           </p:cNvPr>
@@ -9113,7 +9113,7 @@
           <p:cNvPr id="6" name="">
             <a:extLst xmlns:a="http://schemas.openxmlformats.org/drawingml/2006/main">
               <a:ext uri="{FF2B5EF4-FFF2-40B4-BE49-F238E27FC236}">
-                <a16:creationId xmlns:a16="http://schemas.microsoft.com/office/drawing/2014/main" id="{14A9BAC1-A06E-4470-90D9-B633A04AD719}"/>
+                <a16:creationId xmlns:a16="http://schemas.microsoft.com/office/drawing/2014/main" id="{1301C448-E507-4350-833B-15C5D6FCCE3D}"/>
               </a:ext>
             </a:extLst>
           </p:cNvPr>
@@ -9301,7 +9301,7 @@
           <p:cNvPr id="7" name="">
             <a:extLst xmlns:a="http://schemas.openxmlformats.org/drawingml/2006/main">
               <a:ext uri="{FF2B5EF4-FFF2-40B4-BE49-F238E27FC236}">
-                <a16:creationId xmlns:a16="http://schemas.microsoft.com/office/drawing/2014/main" id="{BD4822A7-388D-4488-9664-796739AF1209}"/>
+                <a16:creationId xmlns:a16="http://schemas.microsoft.com/office/drawing/2014/main" id="{1351637C-E787-4996-A7AB-93CBA43AB94A}"/>
               </a:ext>
             </a:extLst>
           </p:cNvPr>
@@ -9489,7 +9489,7 @@
           <p:cNvPr id="11" name="">
             <a:extLst xmlns:a="http://schemas.openxmlformats.org/drawingml/2006/main">
               <a:ext uri="{FF2B5EF4-FFF2-40B4-BE49-F238E27FC236}">
-                <a16:creationId xmlns:a16="http://schemas.microsoft.com/office/drawing/2014/main" id="{A0D1F238-0F08-4B79-9804-A68BDD978AA7}"/>
+                <a16:creationId xmlns:a16="http://schemas.microsoft.com/office/drawing/2014/main" id="{C236A9A8-D16B-46FA-A17D-A19BE11C64EE}"/>
               </a:ext>
             </a:extLst>
           </p:cNvPr>
@@ -9647,7 +9647,7 @@
           <p:cNvPr id="12" name="">
             <a:extLst xmlns:a="http://schemas.openxmlformats.org/drawingml/2006/main">
               <a:ext uri="{FF2B5EF4-FFF2-40B4-BE49-F238E27FC236}">
-                <a16:creationId xmlns:a16="http://schemas.microsoft.com/office/drawing/2014/main" id="{7B98C94D-10F6-4672-8832-FEDE57A70779}"/>
+                <a16:creationId xmlns:a16="http://schemas.microsoft.com/office/drawing/2014/main" id="{A4611D56-F9DC-4936-A7AE-171772F30965}"/>
               </a:ext>
             </a:extLst>
           </p:cNvPr>
@@ -9803,7 +9803,7 @@
     </p:spTree>
     <p:extLst>
       <p:ext uri="{BB962C8B-B14F-4D97-AF65-F5344CB8AC3E}">
-        <p14:creationId xmlns:p14="http://schemas.microsoft.com/office/powerpoint/2010/main" val="617087666"/>
+        <p14:creationId xmlns:p14="http://schemas.microsoft.com/office/powerpoint/2010/main" val="1630788221"/>
       </p:ext>
     </p:extLst>
   </p:cSld>
@@ -9834,7 +9834,7 @@
           <p:cNvPr id="7" name="">
             <a:extLst xmlns:a="http://schemas.openxmlformats.org/drawingml/2006/main">
               <a:ext uri="{FF2B5EF4-FFF2-40B4-BE49-F238E27FC236}">
-                <a16:creationId xmlns:a16="http://schemas.microsoft.com/office/drawing/2014/main" id="{4BE97FB6-73A2-4C75-9E9D-DD562EDF8235}"/>
+                <a16:creationId xmlns:a16="http://schemas.microsoft.com/office/drawing/2014/main" id="{C6110F86-7665-4445-A40F-487A785B04C5}"/>
               </a:ext>
             </a:extLst>
           </p:cNvPr>
@@ -9864,7 +9864,7 @@
           <p:cNvPr id="2" name="">
             <a:extLst xmlns:a="http://schemas.openxmlformats.org/drawingml/2006/main">
               <a:ext uri="{FF2B5EF4-FFF2-40B4-BE49-F238E27FC236}">
-                <a16:creationId xmlns:a16="http://schemas.microsoft.com/office/drawing/2014/main" id="{D2BE12BB-23C4-454F-BE00-88E55A01133A}"/>
+                <a16:creationId xmlns:a16="http://schemas.microsoft.com/office/drawing/2014/main" id="{8BDC85AA-98B4-459B-8726-6FCF135BED19}"/>
               </a:ext>
             </a:extLst>
           </p:cNvPr>
@@ -10022,7 +10022,7 @@
           <p:cNvPr id="3" name="">
             <a:extLst xmlns:a="http://schemas.openxmlformats.org/drawingml/2006/main">
               <a:ext uri="{FF2B5EF4-FFF2-40B4-BE49-F238E27FC236}">
-                <a16:creationId xmlns:a16="http://schemas.microsoft.com/office/drawing/2014/main" id="{5A811759-5B24-4FD5-9FD5-BC1B5DB1B626}"/>
+                <a16:creationId xmlns:a16="http://schemas.microsoft.com/office/drawing/2014/main" id="{721B79B4-B5D7-496F-BAFB-94D4658DBB40}"/>
               </a:ext>
             </a:extLst>
           </p:cNvPr>
@@ -10170,7 +10170,7 @@
                 <a:ea typeface="Arial"/>
                 <a:cs typeface="Arial"/>
               </a:rPr>
-              <a:t>Projeto Aplicado Cenário 4  ·  Versão 28/10/2026</a:t>
+              <a:t>Projeto Aplicado Cenário 4  ·  Versão 29/10/2026</a:t>
             </a:r>
           </a:p>
         </p:txBody>
@@ -10180,7 +10180,7 @@
           <p:cNvPr id="4" name="">
             <a:extLst xmlns:a="http://schemas.openxmlformats.org/drawingml/2006/main">
               <a:ext uri="{FF2B5EF4-FFF2-40B4-BE49-F238E27FC236}">
-                <a16:creationId xmlns:a16="http://schemas.microsoft.com/office/drawing/2014/main" id="{1B44B4FC-A9BA-41B6-9213-7BBB7411CB58}"/>
+                <a16:creationId xmlns:a16="http://schemas.microsoft.com/office/drawing/2014/main" id="{FB496CA7-44AD-4957-8549-CA8E8205C22A}"/>
               </a:ext>
             </a:extLst>
           </p:cNvPr>
@@ -10450,7 +10450,7 @@
           <p:cNvPr id="5" name="">
             <a:extLst xmlns:a="http://schemas.openxmlformats.org/drawingml/2006/main">
               <a:ext uri="{FF2B5EF4-FFF2-40B4-BE49-F238E27FC236}">
-                <a16:creationId xmlns:a16="http://schemas.microsoft.com/office/drawing/2014/main" id="{8031529D-6954-44A0-BAF1-A5677DC4AF33}"/>
+                <a16:creationId xmlns:a16="http://schemas.microsoft.com/office/drawing/2014/main" id="{4BF48A46-8CDC-43D9-8ECD-613E785BEFB5}"/>
               </a:ext>
             </a:extLst>
           </p:cNvPr>
@@ -10776,7 +10776,7 @@
           <p:cNvPr id="6" name="">
             <a:extLst xmlns:a="http://schemas.openxmlformats.org/drawingml/2006/main">
               <a:ext uri="{FF2B5EF4-FFF2-40B4-BE49-F238E27FC236}">
-                <a16:creationId xmlns:a16="http://schemas.microsoft.com/office/drawing/2014/main" id="{6FD98FCF-DFD4-41BD-B77D-0F4D0BA7FD06}"/>
+                <a16:creationId xmlns:a16="http://schemas.microsoft.com/office/drawing/2014/main" id="{11DF69DD-5D06-4286-9756-DF220A1EB281}"/>
               </a:ext>
             </a:extLst>
           </p:cNvPr>
@@ -10932,7 +10932,7 @@
     </p:spTree>
     <p:extLst>
       <p:ext uri="{BB962C8B-B14F-4D97-AF65-F5344CB8AC3E}">
-        <p14:creationId xmlns:p14="http://schemas.microsoft.com/office/powerpoint/2010/main" val="2055433004"/>
+        <p14:creationId xmlns:p14="http://schemas.microsoft.com/office/powerpoint/2010/main" val="413238972"/>
       </p:ext>
     </p:extLst>
   </p:cSld>
@@ -10963,7 +10963,7 @@
           <p:cNvPr id="28" name="">
             <a:extLst xmlns:a="http://schemas.openxmlformats.org/drawingml/2006/main">
               <a:ext uri="{FF2B5EF4-FFF2-40B4-BE49-F238E27FC236}">
-                <a16:creationId xmlns:a16="http://schemas.microsoft.com/office/drawing/2014/main" id="{78945D96-974F-43BF-927C-F496C5ADEACC}"/>
+                <a16:creationId xmlns:a16="http://schemas.microsoft.com/office/drawing/2014/main" id="{B5B6C7BB-A6E3-477B-A13F-73F932992821}"/>
               </a:ext>
             </a:extLst>
           </p:cNvPr>
@@ -10993,7 +10993,7 @@
           <p:cNvPr id="2" name="">
             <a:extLst xmlns:a="http://schemas.openxmlformats.org/drawingml/2006/main">
               <a:ext uri="{FF2B5EF4-FFF2-40B4-BE49-F238E27FC236}">
-                <a16:creationId xmlns:a16="http://schemas.microsoft.com/office/drawing/2014/main" id="{AA754AE8-80AC-47D6-A94A-C3C145B8B9CE}"/>
+                <a16:creationId xmlns:a16="http://schemas.microsoft.com/office/drawing/2014/main" id="{F81A125C-C5E9-4408-96C6-7E3212BCE66A}"/>
               </a:ext>
             </a:extLst>
           </p:cNvPr>
@@ -11151,7 +11151,7 @@
           <p:cNvPr id="3" name="">
             <a:extLst xmlns:a="http://schemas.openxmlformats.org/drawingml/2006/main">
               <a:ext uri="{FF2B5EF4-FFF2-40B4-BE49-F238E27FC236}">
-                <a16:creationId xmlns:a16="http://schemas.microsoft.com/office/drawing/2014/main" id="{15FF0C93-4DAA-4FD1-8744-CEC991833752}"/>
+                <a16:creationId xmlns:a16="http://schemas.microsoft.com/office/drawing/2014/main" id="{87D369F5-1E96-4A74-B47C-232A82FDAB75}"/>
               </a:ext>
             </a:extLst>
           </p:cNvPr>
@@ -11299,7 +11299,7 @@
                 <a:ea typeface="Arial"/>
                 <a:cs typeface="Arial"/>
               </a:rPr>
-              <a:t>Projeto Aplicado Cenário 4  ·  Versão 28/10/2026</a:t>
+              <a:t>Projeto Aplicado Cenário 4  ·  Versão 29/10/2026</a:t>
             </a:r>
           </a:p>
         </p:txBody>
@@ -11309,7 +11309,7 @@
           <p:cNvPr id="4" name="">
             <a:extLst xmlns:a="http://schemas.openxmlformats.org/drawingml/2006/main">
               <a:ext uri="{FF2B5EF4-FFF2-40B4-BE49-F238E27FC236}">
-                <a16:creationId xmlns:a16="http://schemas.microsoft.com/office/drawing/2014/main" id="{85DCC13F-8673-4A3D-BFEE-800188FCE277}"/>
+                <a16:creationId xmlns:a16="http://schemas.microsoft.com/office/drawing/2014/main" id="{16D059CF-3824-4765-892A-82917A6F1C80}"/>
               </a:ext>
             </a:extLst>
           </p:cNvPr>
@@ -11467,7 +11467,7 @@
           <p:cNvPr id="5" name="">
             <a:extLst xmlns:a="http://schemas.openxmlformats.org/drawingml/2006/main">
               <a:ext uri="{FF2B5EF4-FFF2-40B4-BE49-F238E27FC236}">
-                <a16:creationId xmlns:a16="http://schemas.microsoft.com/office/drawing/2014/main" id="{18EC15F2-ABC3-447C-A629-61C6AB904110}"/>
+                <a16:creationId xmlns:a16="http://schemas.microsoft.com/office/drawing/2014/main" id="{C7465027-C3D5-4A04-9154-C5E80571AF7E}"/>
               </a:ext>
             </a:extLst>
           </p:cNvPr>
@@ -11625,7 +11625,7 @@
           <p:cNvPr id="6" name="">
             <a:extLst xmlns:a="http://schemas.openxmlformats.org/drawingml/2006/main">
               <a:ext uri="{FF2B5EF4-FFF2-40B4-BE49-F238E27FC236}">
-                <a16:creationId xmlns:a16="http://schemas.microsoft.com/office/drawing/2014/main" id="{B6845FCC-8AB5-407D-8532-593E2FEEB6E4}"/>
+                <a16:creationId xmlns:a16="http://schemas.microsoft.com/office/drawing/2014/main" id="{7FF056F4-906D-4677-BA79-159E34CDFED6}"/>
               </a:ext>
             </a:extLst>
           </p:cNvPr>
@@ -11783,7 +11783,7 @@
           <p:cNvPr id="7" name="">
             <a:extLst xmlns:a="http://schemas.openxmlformats.org/drawingml/2006/main">
               <a:ext uri="{FF2B5EF4-FFF2-40B4-BE49-F238E27FC236}">
-                <a16:creationId xmlns:a16="http://schemas.microsoft.com/office/drawing/2014/main" id="{75060652-2873-47A4-B40B-0A697FE3BD31}"/>
+                <a16:creationId xmlns:a16="http://schemas.microsoft.com/office/drawing/2014/main" id="{CAFF39EF-8F15-4A7B-B632-56EA607AF605}"/>
               </a:ext>
             </a:extLst>
           </p:cNvPr>
@@ -11941,7 +11941,7 @@
           <p:cNvPr id="8" name="">
             <a:extLst xmlns:a="http://schemas.openxmlformats.org/drawingml/2006/main">
               <a:ext uri="{FF2B5EF4-FFF2-40B4-BE49-F238E27FC236}">
-                <a16:creationId xmlns:a16="http://schemas.microsoft.com/office/drawing/2014/main" id="{325D7F0D-31B3-45B0-B734-1C9441EEF08D}"/>
+                <a16:creationId xmlns:a16="http://schemas.microsoft.com/office/drawing/2014/main" id="{5241EAD3-EBA5-4A16-BA00-49972D5C9043}"/>
               </a:ext>
             </a:extLst>
           </p:cNvPr>
@@ -12099,7 +12099,7 @@
           <p:cNvPr id="9" name="">
             <a:extLst xmlns:a="http://schemas.openxmlformats.org/drawingml/2006/main">
               <a:ext uri="{FF2B5EF4-FFF2-40B4-BE49-F238E27FC236}">
-                <a16:creationId xmlns:a16="http://schemas.microsoft.com/office/drawing/2014/main" id="{8C5AA0FF-AA79-45C7-A84C-076998372343}"/>
+                <a16:creationId xmlns:a16="http://schemas.microsoft.com/office/drawing/2014/main" id="{0B902029-035B-41D3-9CCD-1FCD23985E8F}"/>
               </a:ext>
             </a:extLst>
           </p:cNvPr>
@@ -12257,7 +12257,7 @@
           <p:cNvPr id="10" name="">
             <a:extLst xmlns:a="http://schemas.openxmlformats.org/drawingml/2006/main">
               <a:ext uri="{FF2B5EF4-FFF2-40B4-BE49-F238E27FC236}">
-                <a16:creationId xmlns:a16="http://schemas.microsoft.com/office/drawing/2014/main" id="{CB51BD74-1436-45AF-95A3-07D25B0287DE}"/>
+                <a16:creationId xmlns:a16="http://schemas.microsoft.com/office/drawing/2014/main" id="{2DACBABC-008D-41A8-846D-C585EAAA1357}"/>
               </a:ext>
             </a:extLst>
           </p:cNvPr>
@@ -12415,7 +12415,7 @@
           <p:cNvPr id="11" name="">
             <a:extLst xmlns:a="http://schemas.openxmlformats.org/drawingml/2006/main">
               <a:ext uri="{FF2B5EF4-FFF2-40B4-BE49-F238E27FC236}">
-                <a16:creationId xmlns:a16="http://schemas.microsoft.com/office/drawing/2014/main" id="{871A7976-6585-4995-938B-C345C313F779}"/>
+                <a16:creationId xmlns:a16="http://schemas.microsoft.com/office/drawing/2014/main" id="{81034C17-7380-4FE7-BDED-2600F8147454}"/>
               </a:ext>
             </a:extLst>
           </p:cNvPr>
@@ -12573,7 +12573,7 @@
           <p:cNvPr id="12" name="">
             <a:extLst xmlns:a="http://schemas.openxmlformats.org/drawingml/2006/main">
               <a:ext uri="{FF2B5EF4-FFF2-40B4-BE49-F238E27FC236}">
-                <a16:creationId xmlns:a16="http://schemas.microsoft.com/office/drawing/2014/main" id="{E8875676-F3EE-46BD-B1F1-2C9C0A1F1BD7}"/>
+                <a16:creationId xmlns:a16="http://schemas.microsoft.com/office/drawing/2014/main" id="{DAF2CD92-905A-45A9-B838-ED04C4C3E497}"/>
               </a:ext>
             </a:extLst>
           </p:cNvPr>
@@ -12731,7 +12731,7 @@
           <p:cNvPr id="13" name="">
             <a:extLst xmlns:a="http://schemas.openxmlformats.org/drawingml/2006/main">
               <a:ext uri="{FF2B5EF4-FFF2-40B4-BE49-F238E27FC236}">
-                <a16:creationId xmlns:a16="http://schemas.microsoft.com/office/drawing/2014/main" id="{09D1AFDC-3163-4C8A-B7B6-31652E77F670}"/>
+                <a16:creationId xmlns:a16="http://schemas.microsoft.com/office/drawing/2014/main" id="{2EF24851-6272-409E-AEB8-5F34AC8CF7BD}"/>
               </a:ext>
             </a:extLst>
           </p:cNvPr>
@@ -12889,7 +12889,7 @@
           <p:cNvPr id="14" name="">
             <a:extLst xmlns:a="http://schemas.openxmlformats.org/drawingml/2006/main">
               <a:ext uri="{FF2B5EF4-FFF2-40B4-BE49-F238E27FC236}">
-                <a16:creationId xmlns:a16="http://schemas.microsoft.com/office/drawing/2014/main" id="{B8D16312-28FA-4952-8381-973C2B9A06A7}"/>
+                <a16:creationId xmlns:a16="http://schemas.microsoft.com/office/drawing/2014/main" id="{EF12734C-5A80-4142-8E7F-462A83986026}"/>
               </a:ext>
             </a:extLst>
           </p:cNvPr>
@@ -13047,7 +13047,7 @@
           <p:cNvPr id="15" name="">
             <a:extLst xmlns:a="http://schemas.openxmlformats.org/drawingml/2006/main">
               <a:ext uri="{FF2B5EF4-FFF2-40B4-BE49-F238E27FC236}">
-                <a16:creationId xmlns:a16="http://schemas.microsoft.com/office/drawing/2014/main" id="{BDC967B5-40E3-4EDF-B968-EA63B0703AE5}"/>
+                <a16:creationId xmlns:a16="http://schemas.microsoft.com/office/drawing/2014/main" id="{F559049E-16D3-4704-B802-ACE317253D38}"/>
               </a:ext>
             </a:extLst>
           </p:cNvPr>
@@ -13205,7 +13205,7 @@
           <p:cNvPr id="16" name="">
             <a:extLst xmlns:a="http://schemas.openxmlformats.org/drawingml/2006/main">
               <a:ext uri="{FF2B5EF4-FFF2-40B4-BE49-F238E27FC236}">
-                <a16:creationId xmlns:a16="http://schemas.microsoft.com/office/drawing/2014/main" id="{F146CB0F-DC9D-44B7-BB03-97B00EB9C3CA}"/>
+                <a16:creationId xmlns:a16="http://schemas.microsoft.com/office/drawing/2014/main" id="{FB2A4CF6-8452-4C84-BB33-A97B7E645F57}"/>
               </a:ext>
             </a:extLst>
           </p:cNvPr>
@@ -13363,7 +13363,7 @@
           <p:cNvPr id="17" name="">
             <a:extLst xmlns:a="http://schemas.openxmlformats.org/drawingml/2006/main">
               <a:ext uri="{FF2B5EF4-FFF2-40B4-BE49-F238E27FC236}">
-                <a16:creationId xmlns:a16="http://schemas.microsoft.com/office/drawing/2014/main" id="{5E36741A-C92A-4F20-A2C8-1396C1DC8730}"/>
+                <a16:creationId xmlns:a16="http://schemas.microsoft.com/office/drawing/2014/main" id="{3559150F-8180-49EB-9D17-B79198A10E2E}"/>
               </a:ext>
             </a:extLst>
           </p:cNvPr>
@@ -13521,7 +13521,7 @@
           <p:cNvPr id="18" name="">
             <a:extLst xmlns:a="http://schemas.openxmlformats.org/drawingml/2006/main">
               <a:ext uri="{FF2B5EF4-FFF2-40B4-BE49-F238E27FC236}">
-                <a16:creationId xmlns:a16="http://schemas.microsoft.com/office/drawing/2014/main" id="{5F5DA5B6-9479-4D87-82E1-2F3D3A67F1DE}"/>
+                <a16:creationId xmlns:a16="http://schemas.microsoft.com/office/drawing/2014/main" id="{A4003447-5F99-4F3E-838B-09E74CB8D06C}"/>
               </a:ext>
             </a:extLst>
           </p:cNvPr>
@@ -13679,7 +13679,7 @@
           <p:cNvPr id="19" name="">
             <a:extLst xmlns:a="http://schemas.openxmlformats.org/drawingml/2006/main">
               <a:ext uri="{FF2B5EF4-FFF2-40B4-BE49-F238E27FC236}">
-                <a16:creationId xmlns:a16="http://schemas.microsoft.com/office/drawing/2014/main" id="{9216B858-B6AF-4340-A718-9128E4148838}"/>
+                <a16:creationId xmlns:a16="http://schemas.microsoft.com/office/drawing/2014/main" id="{90979CC4-C291-49A5-97A6-6C0A83F44701}"/>
               </a:ext>
             </a:extLst>
           </p:cNvPr>
@@ -13837,7 +13837,7 @@
           <p:cNvPr id="20" name="">
             <a:extLst xmlns:a="http://schemas.openxmlformats.org/drawingml/2006/main">
               <a:ext uri="{FF2B5EF4-FFF2-40B4-BE49-F238E27FC236}">
-                <a16:creationId xmlns:a16="http://schemas.microsoft.com/office/drawing/2014/main" id="{A224C6E2-0A87-4750-963E-A4CED4A6AC2D}"/>
+                <a16:creationId xmlns:a16="http://schemas.microsoft.com/office/drawing/2014/main" id="{F8D47440-523A-4CD8-8530-86A84CBA1EA2}"/>
               </a:ext>
             </a:extLst>
           </p:cNvPr>
@@ -13995,7 +13995,7 @@
           <p:cNvPr id="21" name="">
             <a:extLst xmlns:a="http://schemas.openxmlformats.org/drawingml/2006/main">
               <a:ext uri="{FF2B5EF4-FFF2-40B4-BE49-F238E27FC236}">
-                <a16:creationId xmlns:a16="http://schemas.microsoft.com/office/drawing/2014/main" id="{CA5F01C0-DE76-4819-B31D-A8B1B7ECB006}"/>
+                <a16:creationId xmlns:a16="http://schemas.microsoft.com/office/drawing/2014/main" id="{5E1FAF02-9153-419E-9E1B-2DF9DD271226}"/>
               </a:ext>
             </a:extLst>
           </p:cNvPr>
@@ -14153,7 +14153,7 @@
           <p:cNvPr id="22" name="">
             <a:extLst xmlns:a="http://schemas.openxmlformats.org/drawingml/2006/main">
               <a:ext uri="{FF2B5EF4-FFF2-40B4-BE49-F238E27FC236}">
-                <a16:creationId xmlns:a16="http://schemas.microsoft.com/office/drawing/2014/main" id="{75056AAA-A703-497D-B27E-1F8A54F2B2E3}"/>
+                <a16:creationId xmlns:a16="http://schemas.microsoft.com/office/drawing/2014/main" id="{1A525301-B2ED-476F-834B-B6E552988BA4}"/>
               </a:ext>
             </a:extLst>
           </p:cNvPr>
@@ -14311,7 +14311,7 @@
           <p:cNvPr id="23" name="">
             <a:extLst xmlns:a="http://schemas.openxmlformats.org/drawingml/2006/main">
               <a:ext uri="{FF2B5EF4-FFF2-40B4-BE49-F238E27FC236}">
-                <a16:creationId xmlns:a16="http://schemas.microsoft.com/office/drawing/2014/main" id="{D0638B88-97E1-4026-9571-5ECCE02B3F01}"/>
+                <a16:creationId xmlns:a16="http://schemas.microsoft.com/office/drawing/2014/main" id="{6569C80D-2034-4ABB-9E61-DD50443C29A3}"/>
               </a:ext>
             </a:extLst>
           </p:cNvPr>
@@ -14469,7 +14469,7 @@
           <p:cNvPr id="24" name="">
             <a:extLst xmlns:a="http://schemas.openxmlformats.org/drawingml/2006/main">
               <a:ext uri="{FF2B5EF4-FFF2-40B4-BE49-F238E27FC236}">
-                <a16:creationId xmlns:a16="http://schemas.microsoft.com/office/drawing/2014/main" id="{B29B8CA0-D1E6-411A-93E5-1353267FDE71}"/>
+                <a16:creationId xmlns:a16="http://schemas.microsoft.com/office/drawing/2014/main" id="{767FE549-4C1D-4F92-AFC1-28511AB3BCAA}"/>
               </a:ext>
             </a:extLst>
           </p:cNvPr>
@@ -14627,7 +14627,7 @@
           <p:cNvPr id="25" name="">
             <a:extLst xmlns:a="http://schemas.openxmlformats.org/drawingml/2006/main">
               <a:ext uri="{FF2B5EF4-FFF2-40B4-BE49-F238E27FC236}">
-                <a16:creationId xmlns:a16="http://schemas.microsoft.com/office/drawing/2014/main" id="{C168216A-47B0-49C6-A622-84E1CCE43F41}"/>
+                <a16:creationId xmlns:a16="http://schemas.microsoft.com/office/drawing/2014/main" id="{36A067EB-9D8B-4B23-8838-725306A5F7F5}"/>
               </a:ext>
             </a:extLst>
           </p:cNvPr>
@@ -14785,7 +14785,7 @@
           <p:cNvPr id="26" name="">
             <a:extLst xmlns:a="http://schemas.openxmlformats.org/drawingml/2006/main">
               <a:ext uri="{FF2B5EF4-FFF2-40B4-BE49-F238E27FC236}">
-                <a16:creationId xmlns:a16="http://schemas.microsoft.com/office/drawing/2014/main" id="{254A164B-AFB5-4866-B578-4FAF1D74C5D9}"/>
+                <a16:creationId xmlns:a16="http://schemas.microsoft.com/office/drawing/2014/main" id="{93DABC70-2853-4521-8F68-0CDE2089F70A}"/>
               </a:ext>
             </a:extLst>
           </p:cNvPr>
@@ -14943,7 +14943,7 @@
           <p:cNvPr id="27" name="">
             <a:extLst xmlns:a="http://schemas.openxmlformats.org/drawingml/2006/main">
               <a:ext uri="{FF2B5EF4-FFF2-40B4-BE49-F238E27FC236}">
-                <a16:creationId xmlns:a16="http://schemas.microsoft.com/office/drawing/2014/main" id="{A1CA3584-0656-4FDD-A020-FC709CF05C50}"/>
+                <a16:creationId xmlns:a16="http://schemas.microsoft.com/office/drawing/2014/main" id="{2CC33238-DCA7-4374-B349-D7D535200A03}"/>
               </a:ext>
             </a:extLst>
           </p:cNvPr>
@@ -15091,7 +15091,7 @@
                 <a:ea typeface="Arial"/>
                 <a:cs typeface="Arial"/>
               </a:rPr>
-              <a:t>p95 45,1 ms (20/10)</a:t>
+              <a:t>p95 máximo 21,53 ms</a:t>
             </a:r>
           </a:p>
         </p:txBody>
@@ -15099,7 +15099,7 @@
     </p:spTree>
     <p:extLst>
       <p:ext uri="{BB962C8B-B14F-4D97-AF65-F5344CB8AC3E}">
-        <p14:creationId xmlns:p14="http://schemas.microsoft.com/office/powerpoint/2010/main" val="971053774"/>
+        <p14:creationId xmlns:p14="http://schemas.microsoft.com/office/powerpoint/2010/main" val="405967811"/>
       </p:ext>
     </p:extLst>
   </p:cSld>
@@ -15130,7 +15130,7 @@
           <p:cNvPr id="11" name="">
             <a:extLst xmlns:a="http://schemas.openxmlformats.org/drawingml/2006/main">
               <a:ext uri="{FF2B5EF4-FFF2-40B4-BE49-F238E27FC236}">
-                <a16:creationId xmlns:a16="http://schemas.microsoft.com/office/drawing/2014/main" id="{8C542366-CA75-40AD-B27E-29E765C35190}"/>
+                <a16:creationId xmlns:a16="http://schemas.microsoft.com/office/drawing/2014/main" id="{034851BF-B7EE-4CBE-A125-06C1FE6159F8}"/>
               </a:ext>
             </a:extLst>
           </p:cNvPr>
@@ -15160,7 +15160,7 @@
           <p:cNvPr id="2" name="">
             <a:extLst xmlns:a="http://schemas.openxmlformats.org/drawingml/2006/main">
               <a:ext uri="{FF2B5EF4-FFF2-40B4-BE49-F238E27FC236}">
-                <a16:creationId xmlns:a16="http://schemas.microsoft.com/office/drawing/2014/main" id="{B8322954-7812-4FB8-A503-E7410A092F15}"/>
+                <a16:creationId xmlns:a16="http://schemas.microsoft.com/office/drawing/2014/main" id="{0B5F719E-8EAF-4F90-8ED2-A7A7E599DF68}"/>
               </a:ext>
             </a:extLst>
           </p:cNvPr>
@@ -15318,7 +15318,7 @@
           <p:cNvPr id="3" name="">
             <a:extLst xmlns:a="http://schemas.openxmlformats.org/drawingml/2006/main">
               <a:ext uri="{FF2B5EF4-FFF2-40B4-BE49-F238E27FC236}">
-                <a16:creationId xmlns:a16="http://schemas.microsoft.com/office/drawing/2014/main" id="{5AE1C8F2-E859-4806-AF07-D74512DC14B4}"/>
+                <a16:creationId xmlns:a16="http://schemas.microsoft.com/office/drawing/2014/main" id="{D610CB1C-8BD5-41CF-B9AD-D5D8234C625A}"/>
               </a:ext>
             </a:extLst>
           </p:cNvPr>
@@ -15466,7 +15466,7 @@
                 <a:ea typeface="Arial"/>
                 <a:cs typeface="Arial"/>
               </a:rPr>
-              <a:t>Projeto Aplicado Cenário 4  ·  Versão 28/10/2026</a:t>
+              <a:t>Projeto Aplicado Cenário 4  ·  Versão 29/10/2026</a:t>
             </a:r>
           </a:p>
         </p:txBody>
@@ -15476,7 +15476,7 @@
           <p:cNvPr id="4" name="">
             <a:extLst xmlns:a="http://schemas.openxmlformats.org/drawingml/2006/main">
               <a:ext uri="{FF2B5EF4-FFF2-40B4-BE49-F238E27FC236}">
-                <a16:creationId xmlns:a16="http://schemas.microsoft.com/office/drawing/2014/main" id="{B5F59320-B910-4DDF-8591-FE654D42B29A}"/>
+                <a16:creationId xmlns:a16="http://schemas.microsoft.com/office/drawing/2014/main" id="{A2289252-9834-448D-BED5-7DC6F003431B}"/>
               </a:ext>
             </a:extLst>
           </p:cNvPr>
@@ -15634,7 +15634,7 @@
           <p:cNvPr id="5" name="">
             <a:extLst xmlns:a="http://schemas.openxmlformats.org/drawingml/2006/main">
               <a:ext uri="{FF2B5EF4-FFF2-40B4-BE49-F238E27FC236}">
-                <a16:creationId xmlns:a16="http://schemas.microsoft.com/office/drawing/2014/main" id="{57F67159-FB52-4BEA-B2F0-11D1394F5906}"/>
+                <a16:creationId xmlns:a16="http://schemas.microsoft.com/office/drawing/2014/main" id="{2CD0DC23-7EB3-4CEA-B1F8-EC0670754C4E}"/>
               </a:ext>
             </a:extLst>
           </p:cNvPr>
@@ -15850,7 +15850,7 @@
           <p:cNvPr id="6" name="">
             <a:extLst xmlns:a="http://schemas.openxmlformats.org/drawingml/2006/main">
               <a:ext uri="{FF2B5EF4-FFF2-40B4-BE49-F238E27FC236}">
-                <a16:creationId xmlns:a16="http://schemas.microsoft.com/office/drawing/2014/main" id="{A9C85F56-5C37-4B69-BFD1-F0AB660A264A}"/>
+                <a16:creationId xmlns:a16="http://schemas.microsoft.com/office/drawing/2014/main" id="{C94CD34D-8C21-4AB8-B0C4-64B3868986DD}"/>
               </a:ext>
             </a:extLst>
           </p:cNvPr>
@@ -16008,7 +16008,7 @@
           <p:cNvPr id="7" name="">
             <a:extLst xmlns:a="http://schemas.openxmlformats.org/drawingml/2006/main">
               <a:ext uri="{FF2B5EF4-FFF2-40B4-BE49-F238E27FC236}">
-                <a16:creationId xmlns:a16="http://schemas.microsoft.com/office/drawing/2014/main" id="{DC8112E6-8B2B-4385-AF3A-9EBE7A3A3911}"/>
+                <a16:creationId xmlns:a16="http://schemas.microsoft.com/office/drawing/2014/main" id="{8E237868-2EE3-47F1-9A6E-EC807DF79465}"/>
               </a:ext>
             </a:extLst>
           </p:cNvPr>
@@ -16224,7 +16224,7 @@
           <p:cNvPr id="8" name="">
             <a:extLst xmlns:a="http://schemas.openxmlformats.org/drawingml/2006/main">
               <a:ext uri="{FF2B5EF4-FFF2-40B4-BE49-F238E27FC236}">
-                <a16:creationId xmlns:a16="http://schemas.microsoft.com/office/drawing/2014/main" id="{8177BD21-64BF-48F3-A288-0AE7726B573F}"/>
+                <a16:creationId xmlns:a16="http://schemas.microsoft.com/office/drawing/2014/main" id="{67F053E3-8F22-430A-8882-F4DD3B05D246}"/>
               </a:ext>
             </a:extLst>
           </p:cNvPr>
@@ -16382,7 +16382,7 @@
           <p:cNvPr id="9" name="">
             <a:extLst xmlns:a="http://schemas.openxmlformats.org/drawingml/2006/main">
               <a:ext uri="{FF2B5EF4-FFF2-40B4-BE49-F238E27FC236}">
-                <a16:creationId xmlns:a16="http://schemas.microsoft.com/office/drawing/2014/main" id="{F3663902-A695-454C-B33E-4F4874AF0784}"/>
+                <a16:creationId xmlns:a16="http://schemas.microsoft.com/office/drawing/2014/main" id="{BF57E21A-DEB3-4213-9864-7B9919C68FB2}"/>
               </a:ext>
             </a:extLst>
           </p:cNvPr>
@@ -16598,7 +16598,7 @@
           <p:cNvPr id="10" name="">
             <a:extLst xmlns:a="http://schemas.openxmlformats.org/drawingml/2006/main">
               <a:ext uri="{FF2B5EF4-FFF2-40B4-BE49-F238E27FC236}">
-                <a16:creationId xmlns:a16="http://schemas.microsoft.com/office/drawing/2014/main" id="{018077F5-96CC-44AF-9280-E3D196D91679}"/>
+                <a16:creationId xmlns:a16="http://schemas.microsoft.com/office/drawing/2014/main" id="{80722866-5342-40CD-9129-FF0BB902745E}"/>
               </a:ext>
             </a:extLst>
           </p:cNvPr>
@@ -16777,7 +16777,7 @@
     </p:spTree>
     <p:extLst>
       <p:ext uri="{BB962C8B-B14F-4D97-AF65-F5344CB8AC3E}">
-        <p14:creationId xmlns:p14="http://schemas.microsoft.com/office/powerpoint/2010/main" val="1747552853"/>
+        <p14:creationId xmlns:p14="http://schemas.microsoft.com/office/powerpoint/2010/main" val="1880809440"/>
       </p:ext>
     </p:extLst>
   </p:cSld>
@@ -16808,7 +16808,7 @@
           <p:cNvPr id="11" name="">
             <a:extLst xmlns:a="http://schemas.openxmlformats.org/drawingml/2006/main">
               <a:ext uri="{FF2B5EF4-FFF2-40B4-BE49-F238E27FC236}">
-                <a16:creationId xmlns:a16="http://schemas.microsoft.com/office/drawing/2014/main" id="{73B3B64C-A103-4000-9F25-C2376DA44B6D}"/>
+                <a16:creationId xmlns:a16="http://schemas.microsoft.com/office/drawing/2014/main" id="{309A3EFE-AC24-4FE5-8835-DB733022B30E}"/>
               </a:ext>
             </a:extLst>
           </p:cNvPr>
@@ -16838,7 +16838,7 @@
           <p:cNvPr id="2" name="">
             <a:extLst xmlns:a="http://schemas.openxmlformats.org/drawingml/2006/main">
               <a:ext uri="{FF2B5EF4-FFF2-40B4-BE49-F238E27FC236}">
-                <a16:creationId xmlns:a16="http://schemas.microsoft.com/office/drawing/2014/main" id="{0EF988D9-1C71-429D-A050-E4F3B584C6C5}"/>
+                <a16:creationId xmlns:a16="http://schemas.microsoft.com/office/drawing/2014/main" id="{9FFFE221-5ED7-402F-9968-FBC10542DE25}"/>
               </a:ext>
             </a:extLst>
           </p:cNvPr>
@@ -16996,7 +16996,7 @@
           <p:cNvPr id="3" name="">
             <a:extLst xmlns:a="http://schemas.openxmlformats.org/drawingml/2006/main">
               <a:ext uri="{FF2B5EF4-FFF2-40B4-BE49-F238E27FC236}">
-                <a16:creationId xmlns:a16="http://schemas.microsoft.com/office/drawing/2014/main" id="{2AF86A2C-E851-487B-B0D9-B056993A2DBE}"/>
+                <a16:creationId xmlns:a16="http://schemas.microsoft.com/office/drawing/2014/main" id="{D5A979B8-BCBD-44BF-A877-614CE9523DAB}"/>
               </a:ext>
             </a:extLst>
           </p:cNvPr>
@@ -17144,7 +17144,7 @@
                 <a:ea typeface="Arial"/>
                 <a:cs typeface="Arial"/>
               </a:rPr>
-              <a:t>Projeto Aplicado Cenário 4  ·  Versão 28/10/2026</a:t>
+              <a:t>Projeto Aplicado Cenário 4  ·  Versão 29/10/2026</a:t>
             </a:r>
           </a:p>
         </p:txBody>
@@ -17154,7 +17154,7 @@
           <p:cNvPr id="4" name="">
             <a:extLst xmlns:a="http://schemas.openxmlformats.org/drawingml/2006/main">
               <a:ext uri="{FF2B5EF4-FFF2-40B4-BE49-F238E27FC236}">
-                <a16:creationId xmlns:a16="http://schemas.microsoft.com/office/drawing/2014/main" id="{181A78B9-F96D-4426-AB51-29062316FDE6}"/>
+                <a16:creationId xmlns:a16="http://schemas.microsoft.com/office/drawing/2014/main" id="{1949E378-7F0E-4D09-9F85-57800C1EA0CB}"/>
               </a:ext>
             </a:extLst>
           </p:cNvPr>
@@ -17312,7 +17312,7 @@
           <p:cNvPr id="5" name="">
             <a:extLst xmlns:a="http://schemas.openxmlformats.org/drawingml/2006/main">
               <a:ext uri="{FF2B5EF4-FFF2-40B4-BE49-F238E27FC236}">
-                <a16:creationId xmlns:a16="http://schemas.microsoft.com/office/drawing/2014/main" id="{AF15E67D-BC30-4DBD-9F5F-644DC4DC0C9A}"/>
+                <a16:creationId xmlns:a16="http://schemas.microsoft.com/office/drawing/2014/main" id="{9A9E0E04-91FA-44E6-B685-1F36656AE4EB}"/>
               </a:ext>
             </a:extLst>
           </p:cNvPr>
@@ -17528,7 +17528,7 @@
           <p:cNvPr id="6" name="">
             <a:extLst xmlns:a="http://schemas.openxmlformats.org/drawingml/2006/main">
               <a:ext uri="{FF2B5EF4-FFF2-40B4-BE49-F238E27FC236}">
-                <a16:creationId xmlns:a16="http://schemas.microsoft.com/office/drawing/2014/main" id="{DDD9D129-5A0E-46A7-9390-19B4074527C0}"/>
+                <a16:creationId xmlns:a16="http://schemas.microsoft.com/office/drawing/2014/main" id="{9B11A4B3-7A3E-4472-A918-CC35E4919EA6}"/>
               </a:ext>
             </a:extLst>
           </p:cNvPr>
@@ -17686,7 +17686,7 @@
           <p:cNvPr id="7" name="">
             <a:extLst xmlns:a="http://schemas.openxmlformats.org/drawingml/2006/main">
               <a:ext uri="{FF2B5EF4-FFF2-40B4-BE49-F238E27FC236}">
-                <a16:creationId xmlns:a16="http://schemas.microsoft.com/office/drawing/2014/main" id="{9545B7CE-17E1-46E4-8CE1-CB5BBE11AB80}"/>
+                <a16:creationId xmlns:a16="http://schemas.microsoft.com/office/drawing/2014/main" id="{660EA618-35B7-4546-99A5-C9F6DAD47CFF}"/>
               </a:ext>
             </a:extLst>
           </p:cNvPr>
@@ -17902,7 +17902,7 @@
           <p:cNvPr id="8" name="">
             <a:extLst xmlns:a="http://schemas.openxmlformats.org/drawingml/2006/main">
               <a:ext uri="{FF2B5EF4-FFF2-40B4-BE49-F238E27FC236}">
-                <a16:creationId xmlns:a16="http://schemas.microsoft.com/office/drawing/2014/main" id="{B3F191DB-5BFF-478C-B51B-E16BE158283E}"/>
+                <a16:creationId xmlns:a16="http://schemas.microsoft.com/office/drawing/2014/main" id="{A153A063-E443-45D3-B820-203DE211044F}"/>
               </a:ext>
             </a:extLst>
           </p:cNvPr>
@@ -18060,7 +18060,7 @@
           <p:cNvPr id="9" name="">
             <a:extLst xmlns:a="http://schemas.openxmlformats.org/drawingml/2006/main">
               <a:ext uri="{FF2B5EF4-FFF2-40B4-BE49-F238E27FC236}">
-                <a16:creationId xmlns:a16="http://schemas.microsoft.com/office/drawing/2014/main" id="{A07ED06C-C097-4D11-BF85-F0A49CCC4B0F}"/>
+                <a16:creationId xmlns:a16="http://schemas.microsoft.com/office/drawing/2014/main" id="{348BA83B-F3B8-4F65-B326-B819864C1479}"/>
               </a:ext>
             </a:extLst>
           </p:cNvPr>
@@ -18276,7 +18276,7 @@
           <p:cNvPr id="10" name="">
             <a:extLst xmlns:a="http://schemas.openxmlformats.org/drawingml/2006/main">
               <a:ext uri="{FF2B5EF4-FFF2-40B4-BE49-F238E27FC236}">
-                <a16:creationId xmlns:a16="http://schemas.microsoft.com/office/drawing/2014/main" id="{9BD83306-7D93-4192-B2BE-B834AE5EECBD}"/>
+                <a16:creationId xmlns:a16="http://schemas.microsoft.com/office/drawing/2014/main" id="{A9A6C1E0-F7C7-4798-BF87-B47DDED9A996}"/>
               </a:ext>
             </a:extLst>
           </p:cNvPr>
@@ -18432,7 +18432,7 @@
     </p:spTree>
     <p:extLst>
       <p:ext uri="{BB962C8B-B14F-4D97-AF65-F5344CB8AC3E}">
-        <p14:creationId xmlns:p14="http://schemas.microsoft.com/office/powerpoint/2010/main" val="99317416"/>
+        <p14:creationId xmlns:p14="http://schemas.microsoft.com/office/powerpoint/2010/main" val="1076678735"/>
       </p:ext>
     </p:extLst>
   </p:cSld>
@@ -18463,7 +18463,7 @@
           <p:cNvPr id="9" name="">
             <a:extLst xmlns:a="http://schemas.openxmlformats.org/drawingml/2006/main">
               <a:ext uri="{FF2B5EF4-FFF2-40B4-BE49-F238E27FC236}">
-                <a16:creationId xmlns:a16="http://schemas.microsoft.com/office/drawing/2014/main" id="{B2B64A3A-2B20-4ED0-A3BC-36BA44FEE1ED}"/>
+                <a16:creationId xmlns:a16="http://schemas.microsoft.com/office/drawing/2014/main" id="{EA2C5962-15CC-425B-A7A8-50D1C97E4829}"/>
               </a:ext>
             </a:extLst>
           </p:cNvPr>
@@ -18493,7 +18493,7 @@
           <p:cNvPr id="2" name="">
             <a:extLst xmlns:a="http://schemas.openxmlformats.org/drawingml/2006/main">
               <a:ext uri="{FF2B5EF4-FFF2-40B4-BE49-F238E27FC236}">
-                <a16:creationId xmlns:a16="http://schemas.microsoft.com/office/drawing/2014/main" id="{38FFCB0E-04B5-43FC-B171-CEAF8EDB9A32}"/>
+                <a16:creationId xmlns:a16="http://schemas.microsoft.com/office/drawing/2014/main" id="{48EFFE59-3AE6-497A-89CD-AF8630856697}"/>
               </a:ext>
             </a:extLst>
           </p:cNvPr>
@@ -18641,7 +18641,7 @@
                 <a:ea typeface="Arial"/>
                 <a:cs typeface="Arial"/>
               </a:rPr>
-              <a:t>Evidências e versão de referência</a:t>
+              <a:t>Evidências e informação operacional</a:t>
             </a:r>
           </a:p>
         </p:txBody>
@@ -18651,7 +18651,7 @@
           <p:cNvPr id="3" name="">
             <a:extLst xmlns:a="http://schemas.openxmlformats.org/drawingml/2006/main">
               <a:ext uri="{FF2B5EF4-FFF2-40B4-BE49-F238E27FC236}">
-                <a16:creationId xmlns:a16="http://schemas.microsoft.com/office/drawing/2014/main" id="{42B8CF28-8A4E-4602-A9F2-1517702BD67F}"/>
+                <a16:creationId xmlns:a16="http://schemas.microsoft.com/office/drawing/2014/main" id="{9B12EF14-2E9F-405D-BA65-6AA2731AF321}"/>
               </a:ext>
             </a:extLst>
           </p:cNvPr>
@@ -18799,7 +18799,7 @@
                 <a:ea typeface="Arial"/>
                 <a:cs typeface="Arial"/>
               </a:rPr>
-              <a:t>Projeto Aplicado Cenário 4  ·  Versão 28/10/2026</a:t>
+              <a:t>Projeto Aplicado Cenário 4  ·  Versão 29/10/2026</a:t>
             </a:r>
           </a:p>
         </p:txBody>
@@ -18809,7 +18809,7 @@
           <p:cNvPr id="4" name="">
             <a:extLst xmlns:a="http://schemas.openxmlformats.org/drawingml/2006/main">
               <a:ext uri="{FF2B5EF4-FFF2-40B4-BE49-F238E27FC236}">
-                <a16:creationId xmlns:a16="http://schemas.microsoft.com/office/drawing/2014/main" id="{F1BD19F4-5EE3-4D8E-BE37-97124E62DD4C}"/>
+                <a16:creationId xmlns:a16="http://schemas.microsoft.com/office/drawing/2014/main" id="{8E23279B-3B69-4F76-8EB4-79F4F05A291F}"/>
               </a:ext>
             </a:extLst>
           </p:cNvPr>
@@ -18837,7 +18837,7 @@
           </a:bodyPr>
           <a:lstStyle xmlns:a="http://schemas.openxmlformats.org/drawingml/2006/main">
             <a:defPPr>
-              <a:defRPr sz="2250" b="1">
+              <a:defRPr sz="2175" b="1">
                 <a:solidFill>
                   <a:srgbClr val="227C83"/>
                 </a:solidFill>
@@ -18847,7 +18847,7 @@
               </a:defRPr>
             </a:defPPr>
             <a:lvl1pPr>
-              <a:defRPr sz="2250" b="1">
+              <a:defRPr sz="2175" b="1">
                 <a:solidFill>
                   <a:srgbClr val="227C83"/>
                 </a:solidFill>
@@ -18857,7 +18857,7 @@
               </a:defRPr>
             </a:lvl1pPr>
             <a:lvl2pPr>
-              <a:defRPr sz="2250" b="1">
+              <a:defRPr sz="2175" b="1">
                 <a:solidFill>
                   <a:srgbClr val="227C83"/>
                 </a:solidFill>
@@ -18867,7 +18867,7 @@
               </a:defRPr>
             </a:lvl2pPr>
             <a:lvl3pPr>
-              <a:defRPr sz="2250" b="1">
+              <a:defRPr sz="2175" b="1">
                 <a:solidFill>
                   <a:srgbClr val="227C83"/>
                 </a:solidFill>
@@ -18877,7 +18877,7 @@
               </a:defRPr>
             </a:lvl3pPr>
             <a:lvl4pPr>
-              <a:defRPr sz="2250" b="1">
+              <a:defRPr sz="2175" b="1">
                 <a:solidFill>
                   <a:srgbClr val="227C83"/>
                 </a:solidFill>
@@ -18887,7 +18887,7 @@
               </a:defRPr>
             </a:lvl4pPr>
             <a:lvl5pPr>
-              <a:defRPr sz="2250" b="1">
+              <a:defRPr sz="2175" b="1">
                 <a:solidFill>
                   <a:srgbClr val="227C83"/>
                 </a:solidFill>
@@ -18897,7 +18897,7 @@
               </a:defRPr>
             </a:lvl5pPr>
             <a:lvl6pPr>
-              <a:defRPr sz="2250" b="1">
+              <a:defRPr sz="2175" b="1">
                 <a:solidFill>
                   <a:srgbClr val="227C83"/>
                 </a:solidFill>
@@ -18907,7 +18907,7 @@
               </a:defRPr>
             </a:lvl6pPr>
             <a:lvl7pPr>
-              <a:defRPr sz="2250" b="1">
+              <a:defRPr sz="2175" b="1">
                 <a:solidFill>
                   <a:srgbClr val="227C83"/>
                 </a:solidFill>
@@ -18917,7 +18917,7 @@
               </a:defRPr>
             </a:lvl7pPr>
             <a:lvl8pPr>
-              <a:defRPr sz="2250" b="1">
+              <a:defRPr sz="2175" b="1">
                 <a:solidFill>
                   <a:srgbClr val="227C83"/>
                 </a:solidFill>
@@ -18927,7 +18927,7 @@
               </a:defRPr>
             </a:lvl8pPr>
             <a:lvl9pPr>
-              <a:defRPr sz="2250" b="1">
+              <a:defRPr sz="2175" b="1">
                 <a:solidFill>
                   <a:srgbClr val="227C83"/>
                 </a:solidFill>
@@ -18939,7 +18939,7 @@
           </a:lstStyle>
           <a:p xmlns:a="http://schemas.openxmlformats.org/drawingml/2006/main">
             <a:pPr>
-              <a:defRPr sz="2250" b="1">
+              <a:defRPr sz="2175" b="1">
                 <a:solidFill>
                   <a:srgbClr val="227C83"/>
                 </a:solidFill>
@@ -18949,7 +18949,7 @@
               </a:defRPr>
             </a:pPr>
             <a:r>
-              <a:rPr sz="2250" b="1">
+              <a:rPr sz="2175" b="1">
                 <a:solidFill>
                   <a:srgbClr val="227C83"/>
                 </a:solidFill>
@@ -18957,7 +18957,7 @@
                 <a:ea typeface="Arial"/>
                 <a:cs typeface="Arial"/>
               </a:rPr>
-              <a:t>Histórico de 20/10/2026</a:t>
+              <a:t>Verificação da versão 534eab2</a:t>
             </a:r>
           </a:p>
         </p:txBody>
@@ -18967,7 +18967,7 @@
           <p:cNvPr id="5" name="">
             <a:extLst xmlns:a="http://schemas.openxmlformats.org/drawingml/2006/main">
               <a:ext uri="{FF2B5EF4-FFF2-40B4-BE49-F238E27FC236}">
-                <a16:creationId xmlns:a16="http://schemas.microsoft.com/office/drawing/2014/main" id="{691BA3B1-3BC9-4C95-8AA8-71BCA979535C}"/>
+                <a16:creationId xmlns:a16="http://schemas.microsoft.com/office/drawing/2014/main" id="{898180BB-1C85-496F-B724-1303EEC30CA4}"/>
               </a:ext>
             </a:extLst>
           </p:cNvPr>
@@ -19119,7 +19119,7 @@
                 <a:ea typeface="Arial"/>
                 <a:cs typeface="Arial"/>
               </a:rPr>
-              <a:t>246 testes com PostgreSQL e RabbitMQ</a:t>
+              <a:t>269 testes Python aprovados (14 ignorados)</a:t>
             </a:r>
           </a:p>
           <a:p xmlns:a="http://schemas.openxmlformats.org/drawingml/2006/main">
@@ -19146,7 +19146,7 @@
                 <a:ea typeface="Arial"/>
                 <a:cs typeface="Arial"/>
               </a:rPr>
-              <a:t>232 aprovados e 14 ignorados em SQLite</a:t>
+              <a:t>19 testes da interface aprovados</a:t>
             </a:r>
           </a:p>
           <a:p xmlns:a="http://schemas.openxmlformats.org/drawingml/2006/main">
@@ -19173,7 +19173,7 @@
                 <a:ea typeface="Arial"/>
                 <a:cs typeface="Arial"/>
               </a:rPr>
-              <a:t>22 roteiros de navegador aprovados</a:t>
+              <a:t>F1, F2 e F3 concluídos sem falha</a:t>
             </a:r>
           </a:p>
           <a:p xmlns:a="http://schemas.openxmlformats.org/drawingml/2006/main">
@@ -19200,7 +19200,7 @@
                 <a:ea typeface="Arial"/>
                 <a:cs typeface="Arial"/>
               </a:rPr>
-              <a:t>p95 máximo de 45,1 ms em consultas locais</a:t>
+              <a:t>p95 máximo de 21,53 ms (meta 500 ms)</a:t>
             </a:r>
           </a:p>
         </p:txBody>
@@ -19210,7 +19210,7 @@
           <p:cNvPr id="6" name="">
             <a:extLst xmlns:a="http://schemas.openxmlformats.org/drawingml/2006/main">
               <a:ext uri="{FF2B5EF4-FFF2-40B4-BE49-F238E27FC236}">
-                <a16:creationId xmlns:a16="http://schemas.microsoft.com/office/drawing/2014/main" id="{B5D025E3-5987-4703-80BB-45C427C3EFA3}"/>
+                <a16:creationId xmlns:a16="http://schemas.microsoft.com/office/drawing/2014/main" id="{77FFC623-ADD6-4841-816F-64582399E5E9}"/>
               </a:ext>
             </a:extLst>
           </p:cNvPr>
@@ -19358,7 +19358,7 @@
                 <a:ea typeface="Arial"/>
                 <a:cs typeface="Arial"/>
               </a:rPr>
-              <a:t>CI da main f1669d7 em 25/10</a:t>
+              <a:t>Dos logs à decisão</a:t>
             </a:r>
           </a:p>
         </p:txBody>
@@ -19368,7 +19368,7 @@
           <p:cNvPr id="7" name="">
             <a:extLst xmlns:a="http://schemas.openxmlformats.org/drawingml/2006/main">
               <a:ext uri="{FF2B5EF4-FFF2-40B4-BE49-F238E27FC236}">
-                <a16:creationId xmlns:a16="http://schemas.microsoft.com/office/drawing/2014/main" id="{0E132C86-FC6E-40A9-86F0-7F9DF98086AE}"/>
+                <a16:creationId xmlns:a16="http://schemas.microsoft.com/office/drawing/2014/main" id="{39C72503-F14C-40A1-AAFE-3DC548476D99}"/>
               </a:ext>
             </a:extLst>
           </p:cNvPr>
@@ -19520,7 +19520,7 @@
                 <a:ea typeface="Arial"/>
                 <a:cs typeface="Arial"/>
               </a:rPr>
-              <a:t>application: 252 aprovados, 14 ignorados</a:t>
+              <a:t>Funil F1→F2→F3 e SLA cumprido</a:t>
             </a:r>
           </a:p>
           <a:p xmlns:a="http://schemas.openxmlformats.org/drawingml/2006/main">
@@ -19547,7 +19547,7 @@
                 <a:ea typeface="Arial"/>
                 <a:cs typeface="Arial"/>
               </a:rPr>
-              <a:t>postgresql: 262 aprovados, 4 ignorados</a:t>
+              <a:t>Atraso de despacho por consumidor</a:t>
             </a:r>
           </a:p>
           <a:p xmlns:a="http://schemas.openxmlformats.org/drawingml/2006/main">
@@ -19574,7 +19574,7 @@
                 <a:ea typeface="Arial"/>
                 <a:cs typeface="Arial"/>
               </a:rPr>
-              <a:t>rabbitmq: 22 aprovados</a:t>
+              <a:t>Falhas, retentativas e duplicidades evitadas</a:t>
             </a:r>
           </a:p>
           <a:p xmlns:a="http://schemas.openxmlformats.org/drawingml/2006/main">
@@ -19601,7 +19601,7 @@
                 <a:ea typeface="Arial"/>
                 <a:cs typeface="Arial"/>
               </a:rPr>
-              <a:t>e2e: 25 aprovados; axe: 1 aprovado</a:t>
+              <a:t>p95 e erros por código, uso por módulo</a:t>
             </a:r>
           </a:p>
         </p:txBody>
@@ -19611,7 +19611,7 @@
           <p:cNvPr id="8" name="">
             <a:extLst xmlns:a="http://schemas.openxmlformats.org/drawingml/2006/main">
               <a:ext uri="{FF2B5EF4-FFF2-40B4-BE49-F238E27FC236}">
-                <a16:creationId xmlns:a16="http://schemas.microsoft.com/office/drawing/2014/main" id="{4824ED5F-873C-443C-9EB1-ED45EE453488}"/>
+                <a16:creationId xmlns:a16="http://schemas.microsoft.com/office/drawing/2014/main" id="{D3633599-E936-401F-BFB2-2513FA2B1FA9}"/>
               </a:ext>
             </a:extLst>
           </p:cNvPr>
@@ -19759,7 +19759,7 @@
                 <a:ea typeface="Arial"/>
                 <a:cs typeface="Arial"/>
               </a:rPr>
-              <a:t>CI 40199072801 com quatro jobs concluídos com sucesso.</a:t>
+              <a:t>Números gerados das execuções, sem transcrição manual.</a:t>
             </a:r>
           </a:p>
           <a:p xmlns:a="http://schemas.openxmlformats.org/drawingml/2006/main">
@@ -19782,7 +19782,7 @@
                 <a:ea typeface="Arial"/>
                 <a:cs typeface="Arial"/>
               </a:rPr>
-              <a:t>As suítes se sobrepõem. Não somar as contagens. p95 histórico de 20/10.</a:t>
+              <a:t>CI com PostgreSQL 16, RabbitMQ e navegador a cada PR.</a:t>
             </a:r>
           </a:p>
         </p:txBody>
@@ -19790,7 +19790,7 @@
     </p:spTree>
     <p:extLst>
       <p:ext uri="{BB962C8B-B14F-4D97-AF65-F5344CB8AC3E}">
-        <p14:creationId xmlns:p14="http://schemas.microsoft.com/office/powerpoint/2010/main" val="867088316"/>
+        <p14:creationId xmlns:p14="http://schemas.microsoft.com/office/powerpoint/2010/main" val="2129002908"/>
       </p:ext>
     </p:extLst>
   </p:cSld>
@@ -19821,7 +19821,7 @@
           <p:cNvPr id="9" name="">
             <a:extLst xmlns:a="http://schemas.openxmlformats.org/drawingml/2006/main">
               <a:ext uri="{FF2B5EF4-FFF2-40B4-BE49-F238E27FC236}">
-                <a16:creationId xmlns:a16="http://schemas.microsoft.com/office/drawing/2014/main" id="{A281C31D-F9DF-4CBF-8BC7-5F64E4F4103E}"/>
+                <a16:creationId xmlns:a16="http://schemas.microsoft.com/office/drawing/2014/main" id="{45B7CB61-047E-457C-A0BA-C1FBE804022A}"/>
               </a:ext>
             </a:extLst>
           </p:cNvPr>
@@ -19851,7 +19851,7 @@
           <p:cNvPr id="2" name="">
             <a:extLst xmlns:a="http://schemas.openxmlformats.org/drawingml/2006/main">
               <a:ext uri="{FF2B5EF4-FFF2-40B4-BE49-F238E27FC236}">
-                <a16:creationId xmlns:a16="http://schemas.microsoft.com/office/drawing/2014/main" id="{8145D540-06F8-440C-A193-761B38997B4A}"/>
+                <a16:creationId xmlns:a16="http://schemas.microsoft.com/office/drawing/2014/main" id="{D82BC29C-99DB-4223-8AB4-8C02BFAE5175}"/>
               </a:ext>
             </a:extLst>
           </p:cNvPr>
@@ -20009,7 +20009,7 @@
           <p:cNvPr id="3" name="">
             <a:extLst xmlns:a="http://schemas.openxmlformats.org/drawingml/2006/main">
               <a:ext uri="{FF2B5EF4-FFF2-40B4-BE49-F238E27FC236}">
-                <a16:creationId xmlns:a16="http://schemas.microsoft.com/office/drawing/2014/main" id="{F6F40B37-7B7A-4651-BEC1-3956C19FB131}"/>
+                <a16:creationId xmlns:a16="http://schemas.microsoft.com/office/drawing/2014/main" id="{85BF6E1F-EC87-4D8D-A5DC-97571A939CF1}"/>
               </a:ext>
             </a:extLst>
           </p:cNvPr>
@@ -20157,7 +20157,7 @@
                 <a:ea typeface="Arial"/>
                 <a:cs typeface="Arial"/>
               </a:rPr>
-              <a:t>Projeto Aplicado Cenário 4  ·  Versão 28/10/2026</a:t>
+              <a:t>Projeto Aplicado Cenário 4  ·  Versão 29/10/2026</a:t>
             </a:r>
           </a:p>
         </p:txBody>
@@ -20167,7 +20167,7 @@
           <p:cNvPr id="4" name="">
             <a:extLst xmlns:a="http://schemas.openxmlformats.org/drawingml/2006/main">
               <a:ext uri="{FF2B5EF4-FFF2-40B4-BE49-F238E27FC236}">
-                <a16:creationId xmlns:a16="http://schemas.microsoft.com/office/drawing/2014/main" id="{7E368321-6D83-42E4-A7E7-755A6F8DF465}"/>
+                <a16:creationId xmlns:a16="http://schemas.microsoft.com/office/drawing/2014/main" id="{14EEF640-4F9A-4614-BCF9-F843F87CD6E2}"/>
               </a:ext>
             </a:extLst>
           </p:cNvPr>
@@ -20325,7 +20325,7 @@
           <p:cNvPr id="5" name="">
             <a:extLst xmlns:a="http://schemas.openxmlformats.org/drawingml/2006/main">
               <a:ext uri="{FF2B5EF4-FFF2-40B4-BE49-F238E27FC236}">
-                <a16:creationId xmlns:a16="http://schemas.microsoft.com/office/drawing/2014/main" id="{9D773938-6CD3-4CC2-BC19-5ABC67646DE9}"/>
+                <a16:creationId xmlns:a16="http://schemas.microsoft.com/office/drawing/2014/main" id="{19C5F430-9318-45B6-83AE-08DB737B5F4F}"/>
               </a:ext>
             </a:extLst>
           </p:cNvPr>
@@ -20541,7 +20541,7 @@
           <p:cNvPr id="6" name="">
             <a:extLst xmlns:a="http://schemas.openxmlformats.org/drawingml/2006/main">
               <a:ext uri="{FF2B5EF4-FFF2-40B4-BE49-F238E27FC236}">
-                <a16:creationId xmlns:a16="http://schemas.microsoft.com/office/drawing/2014/main" id="{1041FD32-59BE-4494-9646-7FBE10560535}"/>
+                <a16:creationId xmlns:a16="http://schemas.microsoft.com/office/drawing/2014/main" id="{03043AA3-9F3C-48B3-8EEE-78CCC6182EC5}"/>
               </a:ext>
             </a:extLst>
           </p:cNvPr>
@@ -20699,7 +20699,7 @@
           <p:cNvPr id="7" name="">
             <a:extLst xmlns:a="http://schemas.openxmlformats.org/drawingml/2006/main">
               <a:ext uri="{FF2B5EF4-FFF2-40B4-BE49-F238E27FC236}">
-                <a16:creationId xmlns:a16="http://schemas.microsoft.com/office/drawing/2014/main" id="{B8BB2A3B-77AE-4AA2-91D4-19B704E563FC}"/>
+                <a16:creationId xmlns:a16="http://schemas.microsoft.com/office/drawing/2014/main" id="{644EF9CB-D2B1-4EE9-93A2-C1E7E06E8930}"/>
               </a:ext>
             </a:extLst>
           </p:cNvPr>
@@ -20932,7 +20932,7 @@
                 <a:ea typeface="Arial"/>
                 <a:cs typeface="Arial"/>
               </a:rPr>
-              <a:t>Roger Quinelato e Raquel: autoria preenchida</a:t>
+              <a:t>Roger Quinelato e Raquel Pereira: autoria preenchida</a:t>
             </a:r>
           </a:p>
         </p:txBody>
@@ -20942,7 +20942,7 @@
           <p:cNvPr id="8" name="">
             <a:extLst xmlns:a="http://schemas.openxmlformats.org/drawingml/2006/main">
               <a:ext uri="{FF2B5EF4-FFF2-40B4-BE49-F238E27FC236}">
-                <a16:creationId xmlns:a16="http://schemas.microsoft.com/office/drawing/2014/main" id="{D01B77BF-31C0-45F1-8C3C-2FDDB8C2AA3E}"/>
+                <a16:creationId xmlns:a16="http://schemas.microsoft.com/office/drawing/2014/main" id="{68AA4FCE-95C8-4B90-B8F0-98846D17B997}"/>
               </a:ext>
             </a:extLst>
           </p:cNvPr>
@@ -21121,7 +21121,7 @@
     </p:spTree>
     <p:extLst>
       <p:ext uri="{BB962C8B-B14F-4D97-AF65-F5344CB8AC3E}">
-        <p14:creationId xmlns:p14="http://schemas.microsoft.com/office/powerpoint/2010/main" val="891064582"/>
+        <p14:creationId xmlns:p14="http://schemas.microsoft.com/office/powerpoint/2010/main" val="1018313988"/>
       </p:ext>
     </p:extLst>
   </p:cSld>
@@ -21152,7 +21152,7 @@
           <p:cNvPr id="10" name="">
             <a:extLst xmlns:a="http://schemas.openxmlformats.org/drawingml/2006/main">
               <a:ext uri="{FF2B5EF4-FFF2-40B4-BE49-F238E27FC236}">
-                <a16:creationId xmlns:a16="http://schemas.microsoft.com/office/drawing/2014/main" id="{A729199B-0D7C-4073-BE01-5316BD5DB9E8}"/>
+                <a16:creationId xmlns:a16="http://schemas.microsoft.com/office/drawing/2014/main" id="{3B241224-983B-4BBB-A9A3-04BCB22ADE4F}"/>
               </a:ext>
             </a:extLst>
           </p:cNvPr>
@@ -21182,7 +21182,7 @@
           <p:cNvPr id="2" name="">
             <a:extLst xmlns:a="http://schemas.openxmlformats.org/drawingml/2006/main">
               <a:ext uri="{FF2B5EF4-FFF2-40B4-BE49-F238E27FC236}">
-                <a16:creationId xmlns:a16="http://schemas.microsoft.com/office/drawing/2014/main" id="{8FF22229-C8DA-4D79-B152-407D4B5823EC}"/>
+                <a16:creationId xmlns:a16="http://schemas.microsoft.com/office/drawing/2014/main" id="{33754449-29F2-45C4-951F-943E627F60BE}"/>
               </a:ext>
             </a:extLst>
           </p:cNvPr>
@@ -21340,7 +21340,7 @@
           <p:cNvPr id="3" name="">
             <a:extLst xmlns:a="http://schemas.openxmlformats.org/drawingml/2006/main">
               <a:ext uri="{FF2B5EF4-FFF2-40B4-BE49-F238E27FC236}">
-                <a16:creationId xmlns:a16="http://schemas.microsoft.com/office/drawing/2014/main" id="{D9756849-E03C-4BF5-9ED1-FF68DF236A01}"/>
+                <a16:creationId xmlns:a16="http://schemas.microsoft.com/office/drawing/2014/main" id="{9374072B-C137-46CD-802B-55A40BB15BDB}"/>
               </a:ext>
             </a:extLst>
           </p:cNvPr>
@@ -21488,7 +21488,7 @@
                 <a:ea typeface="Arial"/>
                 <a:cs typeface="Arial"/>
               </a:rPr>
-              <a:t>Projeto Aplicado Cenário 4  ·  Versão 28/10/2026</a:t>
+              <a:t>Projeto Aplicado Cenário 4  ·  Versão 29/10/2026</a:t>
             </a:r>
           </a:p>
         </p:txBody>
@@ -21498,7 +21498,7 @@
           <p:cNvPr id="4" name="">
             <a:extLst xmlns:a="http://schemas.openxmlformats.org/drawingml/2006/main">
               <a:ext uri="{FF2B5EF4-FFF2-40B4-BE49-F238E27FC236}">
-                <a16:creationId xmlns:a16="http://schemas.microsoft.com/office/drawing/2014/main" id="{AECC6C73-1ABE-482C-8F6F-8F790D6F81E7}"/>
+                <a16:creationId xmlns:a16="http://schemas.microsoft.com/office/drawing/2014/main" id="{79B424F9-B0D6-4A98-9A96-6CF152182AA3}"/>
               </a:ext>
             </a:extLst>
           </p:cNvPr>
@@ -21741,7 +21741,7 @@
           <p:cNvPr id="5" name="">
             <a:extLst xmlns:a="http://schemas.openxmlformats.org/drawingml/2006/main">
               <a:ext uri="{FF2B5EF4-FFF2-40B4-BE49-F238E27FC236}">
-                <a16:creationId xmlns:a16="http://schemas.microsoft.com/office/drawing/2014/main" id="{E4AD27AF-29AE-413B-8E63-4879CE4426E2}"/>
+                <a16:creationId xmlns:a16="http://schemas.microsoft.com/office/drawing/2014/main" id="{140EA013-3CDC-4ADB-8C9F-C883ADFF73CC}"/>
               </a:ext>
             </a:extLst>
           </p:cNvPr>
@@ -21906,7 +21906,7 @@
           <p:cNvPr id="6" name="">
             <a:extLst xmlns:a="http://schemas.openxmlformats.org/drawingml/2006/main">
               <a:ext uri="{FF2B5EF4-FFF2-40B4-BE49-F238E27FC236}">
-                <a16:creationId xmlns:a16="http://schemas.microsoft.com/office/drawing/2014/main" id="{4F5E2B0E-B3E7-4C6E-B3A3-F5C1F2FF3F08}"/>
+                <a16:creationId xmlns:a16="http://schemas.microsoft.com/office/drawing/2014/main" id="{E6E59113-472F-45CB-8314-7DBEEC3CD498}"/>
               </a:ext>
             </a:extLst>
           </p:cNvPr>
@@ -22071,7 +22071,7 @@
           <p:cNvPr id="7" name="">
             <a:extLst xmlns:a="http://schemas.openxmlformats.org/drawingml/2006/main">
               <a:ext uri="{FF2B5EF4-FFF2-40B4-BE49-F238E27FC236}">
-                <a16:creationId xmlns:a16="http://schemas.microsoft.com/office/drawing/2014/main" id="{E416FCEC-C2A3-4B05-BBE5-BE2208A1362A}"/>
+                <a16:creationId xmlns:a16="http://schemas.microsoft.com/office/drawing/2014/main" id="{95D427EB-5556-4A38-9938-9C0BAB595E4D}"/>
               </a:ext>
             </a:extLst>
           </p:cNvPr>
@@ -22236,7 +22236,7 @@
           <p:cNvPr id="8" name="">
             <a:extLst xmlns:a="http://schemas.openxmlformats.org/drawingml/2006/main">
               <a:ext uri="{FF2B5EF4-FFF2-40B4-BE49-F238E27FC236}">
-                <a16:creationId xmlns:a16="http://schemas.microsoft.com/office/drawing/2014/main" id="{B8CCA3AD-1FB4-45C0-A919-8930A0F30DDE}"/>
+                <a16:creationId xmlns:a16="http://schemas.microsoft.com/office/drawing/2014/main" id="{6D098389-9ABD-4901-88A4-2342FDEEFE98}"/>
               </a:ext>
             </a:extLst>
           </p:cNvPr>
@@ -22401,7 +22401,7 @@
           <p:cNvPr id="9" name="">
             <a:extLst xmlns:a="http://schemas.openxmlformats.org/drawingml/2006/main">
               <a:ext uri="{FF2B5EF4-FFF2-40B4-BE49-F238E27FC236}">
-                <a16:creationId xmlns:a16="http://schemas.microsoft.com/office/drawing/2014/main" id="{7153BF96-D821-4DCF-AAA1-86B5EE2E72BA}"/>
+                <a16:creationId xmlns:a16="http://schemas.microsoft.com/office/drawing/2014/main" id="{04EADE84-7180-4653-95C5-A2C1F190D612}"/>
               </a:ext>
             </a:extLst>
           </p:cNvPr>
@@ -22564,7 +22564,7 @@
     </p:spTree>
     <p:extLst>
       <p:ext uri="{BB962C8B-B14F-4D97-AF65-F5344CB8AC3E}">
-        <p14:creationId xmlns:p14="http://schemas.microsoft.com/office/powerpoint/2010/main" val="2110506220"/>
+        <p14:creationId xmlns:p14="http://schemas.microsoft.com/office/powerpoint/2010/main" val="1034903060"/>
       </p:ext>
     </p:extLst>
   </p:cSld>
@@ -22595,7 +22595,7 @@
           <p:cNvPr id="7" name="">
             <a:extLst xmlns:a="http://schemas.openxmlformats.org/drawingml/2006/main">
               <a:ext uri="{FF2B5EF4-FFF2-40B4-BE49-F238E27FC236}">
-                <a16:creationId xmlns:a16="http://schemas.microsoft.com/office/drawing/2014/main" id="{81CA6177-A006-46AA-833F-32CFA53A57EA}"/>
+                <a16:creationId xmlns:a16="http://schemas.microsoft.com/office/drawing/2014/main" id="{F8F22A5E-BCB4-4254-94B7-63BB9FEE8F95}"/>
               </a:ext>
             </a:extLst>
           </p:cNvPr>
@@ -22625,7 +22625,7 @@
           <p:cNvPr id="2" name="">
             <a:extLst xmlns:a="http://schemas.openxmlformats.org/drawingml/2006/main">
               <a:ext uri="{FF2B5EF4-FFF2-40B4-BE49-F238E27FC236}">
-                <a16:creationId xmlns:a16="http://schemas.microsoft.com/office/drawing/2014/main" id="{1584A404-D6ED-48E3-BE90-F45C36303AEE}"/>
+                <a16:creationId xmlns:a16="http://schemas.microsoft.com/office/drawing/2014/main" id="{B92EF821-79E8-459B-BDDE-5F8E5A3A7888}"/>
               </a:ext>
             </a:extLst>
           </p:cNvPr>
@@ -22783,7 +22783,7 @@
           <p:cNvPr id="3" name="">
             <a:extLst xmlns:a="http://schemas.openxmlformats.org/drawingml/2006/main">
               <a:ext uri="{FF2B5EF4-FFF2-40B4-BE49-F238E27FC236}">
-                <a16:creationId xmlns:a16="http://schemas.microsoft.com/office/drawing/2014/main" id="{D25D91BD-9C20-4987-A3F7-E6FB362DDB80}"/>
+                <a16:creationId xmlns:a16="http://schemas.microsoft.com/office/drawing/2014/main" id="{D282F15E-A871-4F7D-B3DF-AF4998C6AA9F}"/>
               </a:ext>
             </a:extLst>
           </p:cNvPr>
@@ -22931,7 +22931,7 @@
                 <a:ea typeface="Arial"/>
                 <a:cs typeface="Arial"/>
               </a:rPr>
-              <a:t>Projeto Aplicado Cenário 4  ·  Versão 28/10/2026</a:t>
+              <a:t>Projeto Aplicado Cenário 4  ·  Versão 29/10/2026</a:t>
             </a:r>
           </a:p>
         </p:txBody>
@@ -22941,7 +22941,7 @@
           <p:cNvPr id="4" name="">
             <a:extLst xmlns:a="http://schemas.openxmlformats.org/drawingml/2006/main">
               <a:ext uri="{FF2B5EF4-FFF2-40B4-BE49-F238E27FC236}">
-                <a16:creationId xmlns:a16="http://schemas.microsoft.com/office/drawing/2014/main" id="{D4A54234-01ED-4877-BCF7-82154F223D79}"/>
+                <a16:creationId xmlns:a16="http://schemas.microsoft.com/office/drawing/2014/main" id="{11A9AB72-B665-43DE-AC87-D1E4711ABF4A}"/>
               </a:ext>
             </a:extLst>
           </p:cNvPr>
@@ -23099,7 +23099,7 @@
           <p:cNvPr id="5" name="">
             <a:extLst xmlns:a="http://schemas.openxmlformats.org/drawingml/2006/main">
               <a:ext uri="{FF2B5EF4-FFF2-40B4-BE49-F238E27FC236}">
-                <a16:creationId xmlns:a16="http://schemas.microsoft.com/office/drawing/2014/main" id="{3C6EAD13-2D80-48D0-8BED-BE04AEE04B65}"/>
+                <a16:creationId xmlns:a16="http://schemas.microsoft.com/office/drawing/2014/main" id="{F78ED191-CCDF-430C-B7ED-EF0A54DC91A1}"/>
               </a:ext>
             </a:extLst>
           </p:cNvPr>
@@ -23109,7 +23109,7 @@
           <p:nvPr/>
         </p:nvPicPr>
         <p:blipFill>
-          <a:blip xmlns:r="http://schemas.openxmlformats.org/officeDocument/2006/relationships" xmlns:a="http://schemas.openxmlformats.org/drawingml/2006/main" r:embed="R5d559bf6cc6a4ef0"/>
+          <a:blip xmlns:r="http://schemas.openxmlformats.org/officeDocument/2006/relationships" xmlns:a="http://schemas.openxmlformats.org/drawingml/2006/main" r:embed="Re349bed3316b4c27"/>
           <a:stretch xmlns:a="http://schemas.openxmlformats.org/drawingml/2006/main"/>
         </p:blipFill>
         <p:spPr>
@@ -23127,7 +23127,7 @@
           <p:cNvPr id="6" name="">
             <a:extLst xmlns:a="http://schemas.openxmlformats.org/drawingml/2006/main">
               <a:ext uri="{FF2B5EF4-FFF2-40B4-BE49-F238E27FC236}">
-                <a16:creationId xmlns:a16="http://schemas.microsoft.com/office/drawing/2014/main" id="{1FFABC91-902C-4359-8DB3-2D2FCDB7E7C8}"/>
+                <a16:creationId xmlns:a16="http://schemas.microsoft.com/office/drawing/2014/main" id="{64606D81-3CE1-49B4-A21A-C198AEDF3676}"/>
               </a:ext>
             </a:extLst>
           </p:cNvPr>
@@ -23283,7 +23283,7 @@
     </p:spTree>
     <p:extLst>
       <p:ext uri="{BB962C8B-B14F-4D97-AF65-F5344CB8AC3E}">
-        <p14:creationId xmlns:p14="http://schemas.microsoft.com/office/powerpoint/2010/main" val="2085770446"/>
+        <p14:creationId xmlns:p14="http://schemas.microsoft.com/office/powerpoint/2010/main" val="821054741"/>
       </p:ext>
     </p:extLst>
   </p:cSld>
@@ -23314,7 +23314,7 @@
           <p:cNvPr id="7" name="">
             <a:extLst xmlns:a="http://schemas.openxmlformats.org/drawingml/2006/main">
               <a:ext uri="{FF2B5EF4-FFF2-40B4-BE49-F238E27FC236}">
-                <a16:creationId xmlns:a16="http://schemas.microsoft.com/office/drawing/2014/main" id="{72D0320C-A6B9-404F-8BA9-46C98C0AB942}"/>
+                <a16:creationId xmlns:a16="http://schemas.microsoft.com/office/drawing/2014/main" id="{9A222ADD-ED8E-4A65-A7F1-9CA054D63E1B}"/>
               </a:ext>
             </a:extLst>
           </p:cNvPr>
@@ -23344,7 +23344,7 @@
           <p:cNvPr id="2" name="">
             <a:extLst xmlns:a="http://schemas.openxmlformats.org/drawingml/2006/main">
               <a:ext uri="{FF2B5EF4-FFF2-40B4-BE49-F238E27FC236}">
-                <a16:creationId xmlns:a16="http://schemas.microsoft.com/office/drawing/2014/main" id="{8C462DDC-9C83-4269-9B70-492403B6DB03}"/>
+                <a16:creationId xmlns:a16="http://schemas.microsoft.com/office/drawing/2014/main" id="{9BAA11FE-8C13-4922-96AA-BA9F2DEB39D6}"/>
               </a:ext>
             </a:extLst>
           </p:cNvPr>
@@ -23502,7 +23502,7 @@
           <p:cNvPr id="3" name="">
             <a:extLst xmlns:a="http://schemas.openxmlformats.org/drawingml/2006/main">
               <a:ext uri="{FF2B5EF4-FFF2-40B4-BE49-F238E27FC236}">
-                <a16:creationId xmlns:a16="http://schemas.microsoft.com/office/drawing/2014/main" id="{72B20F14-E47C-496B-BFDC-F11B5EEB2D5B}"/>
+                <a16:creationId xmlns:a16="http://schemas.microsoft.com/office/drawing/2014/main" id="{35DDCE08-941E-4EE4-BBB4-EA3C34715153}"/>
               </a:ext>
             </a:extLst>
           </p:cNvPr>
@@ -23650,7 +23650,7 @@
                 <a:ea typeface="Arial"/>
                 <a:cs typeface="Arial"/>
               </a:rPr>
-              <a:t>Projeto Aplicado Cenário 4  ·  Versão 28/10/2026</a:t>
+              <a:t>Projeto Aplicado Cenário 4  ·  Versão 29/10/2026</a:t>
             </a:r>
           </a:p>
         </p:txBody>
@@ -23660,7 +23660,7 @@
           <p:cNvPr id="4" name="">
             <a:extLst xmlns:a="http://schemas.openxmlformats.org/drawingml/2006/main">
               <a:ext uri="{FF2B5EF4-FFF2-40B4-BE49-F238E27FC236}">
-                <a16:creationId xmlns:a16="http://schemas.microsoft.com/office/drawing/2014/main" id="{163874C6-71A9-4EF5-9075-49B1C2631A71}"/>
+                <a16:creationId xmlns:a16="http://schemas.microsoft.com/office/drawing/2014/main" id="{81C439BF-4C20-4C3F-A32D-C70D8103B276}"/>
               </a:ext>
             </a:extLst>
           </p:cNvPr>
@@ -23903,7 +23903,7 @@
           <p:cNvPr id="5" name="">
             <a:extLst xmlns:a="http://schemas.openxmlformats.org/drawingml/2006/main">
               <a:ext uri="{FF2B5EF4-FFF2-40B4-BE49-F238E27FC236}">
-                <a16:creationId xmlns:a16="http://schemas.microsoft.com/office/drawing/2014/main" id="{8B143341-4D39-42B1-951D-4531190DD204}"/>
+                <a16:creationId xmlns:a16="http://schemas.microsoft.com/office/drawing/2014/main" id="{7C1F18A9-8199-4F4D-82E8-5FA233CF723A}"/>
               </a:ext>
             </a:extLst>
           </p:cNvPr>
@@ -24061,7 +24061,7 @@
           <p:cNvPr id="6" name="">
             <a:extLst xmlns:a="http://schemas.openxmlformats.org/drawingml/2006/main">
               <a:ext uri="{FF2B5EF4-FFF2-40B4-BE49-F238E27FC236}">
-                <a16:creationId xmlns:a16="http://schemas.microsoft.com/office/drawing/2014/main" id="{531E5E86-2D21-48AD-B285-A724B860E7B2}"/>
+                <a16:creationId xmlns:a16="http://schemas.microsoft.com/office/drawing/2014/main" id="{D26DA615-AC98-4FEC-B04F-98599B30C680}"/>
               </a:ext>
             </a:extLst>
           </p:cNvPr>
@@ -24383,7 +24383,7 @@
     </p:spTree>
     <p:extLst>
       <p:ext uri="{BB962C8B-B14F-4D97-AF65-F5344CB8AC3E}">
-        <p14:creationId xmlns:p14="http://schemas.microsoft.com/office/powerpoint/2010/main" val="896559721"/>
+        <p14:creationId xmlns:p14="http://schemas.microsoft.com/office/powerpoint/2010/main" val="2102073055"/>
       </p:ext>
     </p:extLst>
   </p:cSld>
@@ -24414,7 +24414,7 @@
           <p:cNvPr id="7" name="">
             <a:extLst xmlns:a="http://schemas.openxmlformats.org/drawingml/2006/main">
               <a:ext uri="{FF2B5EF4-FFF2-40B4-BE49-F238E27FC236}">
-                <a16:creationId xmlns:a16="http://schemas.microsoft.com/office/drawing/2014/main" id="{6E5F427D-5927-414D-80C3-76B25A95D7BF}"/>
+                <a16:creationId xmlns:a16="http://schemas.microsoft.com/office/drawing/2014/main" id="{71EB0367-E3A3-4831-8DFE-B1E529B38978}"/>
               </a:ext>
             </a:extLst>
           </p:cNvPr>
@@ -24444,7 +24444,7 @@
           <p:cNvPr id="2" name="">
             <a:extLst xmlns:a="http://schemas.openxmlformats.org/drawingml/2006/main">
               <a:ext uri="{FF2B5EF4-FFF2-40B4-BE49-F238E27FC236}">
-                <a16:creationId xmlns:a16="http://schemas.microsoft.com/office/drawing/2014/main" id="{2B6A41D9-2755-47FC-8005-25D4EAA2067D}"/>
+                <a16:creationId xmlns:a16="http://schemas.microsoft.com/office/drawing/2014/main" id="{A9A75A63-C0D9-4ADF-865F-B24D3E2FF882}"/>
               </a:ext>
             </a:extLst>
           </p:cNvPr>
@@ -24602,7 +24602,7 @@
           <p:cNvPr id="3" name="">
             <a:extLst xmlns:a="http://schemas.openxmlformats.org/drawingml/2006/main">
               <a:ext uri="{FF2B5EF4-FFF2-40B4-BE49-F238E27FC236}">
-                <a16:creationId xmlns:a16="http://schemas.microsoft.com/office/drawing/2014/main" id="{9F2DEE94-107F-4B13-8DEB-8ADA938EDED9}"/>
+                <a16:creationId xmlns:a16="http://schemas.microsoft.com/office/drawing/2014/main" id="{26291377-B43B-44EF-840E-825869177A42}"/>
               </a:ext>
             </a:extLst>
           </p:cNvPr>
@@ -24750,7 +24750,7 @@
                 <a:ea typeface="Arial"/>
                 <a:cs typeface="Arial"/>
               </a:rPr>
-              <a:t>Projeto Aplicado Cenário 4  ·  Versão 28/10/2026</a:t>
+              <a:t>Projeto Aplicado Cenário 4  ·  Versão 29/10/2026</a:t>
             </a:r>
           </a:p>
         </p:txBody>
@@ -24760,7 +24760,7 @@
           <p:cNvPr id="4" name="">
             <a:extLst xmlns:a="http://schemas.openxmlformats.org/drawingml/2006/main">
               <a:ext uri="{FF2B5EF4-FFF2-40B4-BE49-F238E27FC236}">
-                <a16:creationId xmlns:a16="http://schemas.microsoft.com/office/drawing/2014/main" id="{96A8B86E-480C-4FB3-8A69-04EA121512FB}"/>
+                <a16:creationId xmlns:a16="http://schemas.microsoft.com/office/drawing/2014/main" id="{4AC25FE3-2F9F-47EF-B9BA-150E61ED2D5C}"/>
               </a:ext>
             </a:extLst>
           </p:cNvPr>
@@ -24918,7 +24918,7 @@
           <p:cNvPr id="5" name="">
             <a:extLst xmlns:a="http://schemas.openxmlformats.org/drawingml/2006/main">
               <a:ext uri="{FF2B5EF4-FFF2-40B4-BE49-F238E27FC236}">
-                <a16:creationId xmlns:a16="http://schemas.microsoft.com/office/drawing/2014/main" id="{75A8626A-1C6C-462C-A021-FA390929457C}"/>
+                <a16:creationId xmlns:a16="http://schemas.microsoft.com/office/drawing/2014/main" id="{DE97CD48-8089-42B1-95DC-62C6556E10EA}"/>
               </a:ext>
             </a:extLst>
           </p:cNvPr>
@@ -25161,7 +25161,7 @@
           <p:cNvPr id="6" name="">
             <a:extLst xmlns:a="http://schemas.openxmlformats.org/drawingml/2006/main">
               <a:ext uri="{FF2B5EF4-FFF2-40B4-BE49-F238E27FC236}">
-                <a16:creationId xmlns:a16="http://schemas.microsoft.com/office/drawing/2014/main" id="{D27420BE-A591-4776-B9BB-0869875C1696}"/>
+                <a16:creationId xmlns:a16="http://schemas.microsoft.com/office/drawing/2014/main" id="{DBEAA1B4-1E1D-437E-9FF5-DAD58F109A34}"/>
               </a:ext>
             </a:extLst>
           </p:cNvPr>
@@ -25317,7 +25317,7 @@
     </p:spTree>
     <p:extLst>
       <p:ext uri="{BB962C8B-B14F-4D97-AF65-F5344CB8AC3E}">
-        <p14:creationId xmlns:p14="http://schemas.microsoft.com/office/powerpoint/2010/main" val="258086028"/>
+        <p14:creationId xmlns:p14="http://schemas.microsoft.com/office/powerpoint/2010/main" val="1180027671"/>
       </p:ext>
     </p:extLst>
   </p:cSld>
@@ -25348,7 +25348,7 @@
           <p:cNvPr id="7" name="">
             <a:extLst xmlns:a="http://schemas.openxmlformats.org/drawingml/2006/main">
               <a:ext uri="{FF2B5EF4-FFF2-40B4-BE49-F238E27FC236}">
-                <a16:creationId xmlns:a16="http://schemas.microsoft.com/office/drawing/2014/main" id="{F906B4C5-3BA7-447D-B518-B1875DF04C4E}"/>
+                <a16:creationId xmlns:a16="http://schemas.microsoft.com/office/drawing/2014/main" id="{59920C8B-4422-484C-B47D-6C4A6ABFDB9E}"/>
               </a:ext>
             </a:extLst>
           </p:cNvPr>
@@ -25378,7 +25378,7 @@
           <p:cNvPr id="2" name="">
             <a:extLst xmlns:a="http://schemas.openxmlformats.org/drawingml/2006/main">
               <a:ext uri="{FF2B5EF4-FFF2-40B4-BE49-F238E27FC236}">
-                <a16:creationId xmlns:a16="http://schemas.microsoft.com/office/drawing/2014/main" id="{D9278438-CD38-40E9-97C4-60A82AB1633E}"/>
+                <a16:creationId xmlns:a16="http://schemas.microsoft.com/office/drawing/2014/main" id="{7E65A3E9-5638-4F09-A33C-83C7B2E9EF66}"/>
               </a:ext>
             </a:extLst>
           </p:cNvPr>
@@ -25536,7 +25536,7 @@
           <p:cNvPr id="3" name="">
             <a:extLst xmlns:a="http://schemas.openxmlformats.org/drawingml/2006/main">
               <a:ext uri="{FF2B5EF4-FFF2-40B4-BE49-F238E27FC236}">
-                <a16:creationId xmlns:a16="http://schemas.microsoft.com/office/drawing/2014/main" id="{D54ECF8E-004B-45A6-BBA7-97E86262A636}"/>
+                <a16:creationId xmlns:a16="http://schemas.microsoft.com/office/drawing/2014/main" id="{D6433658-D798-4567-BA52-6AFC36EC8E1A}"/>
               </a:ext>
             </a:extLst>
           </p:cNvPr>
@@ -25684,7 +25684,7 @@
                 <a:ea typeface="Arial"/>
                 <a:cs typeface="Arial"/>
               </a:rPr>
-              <a:t>Projeto Aplicado Cenário 4  ·  Versão 28/10/2026</a:t>
+              <a:t>Projeto Aplicado Cenário 4  ·  Versão 29/10/2026</a:t>
             </a:r>
           </a:p>
         </p:txBody>
@@ -25694,7 +25694,7 @@
           <p:cNvPr id="4" name="">
             <a:extLst xmlns:a="http://schemas.openxmlformats.org/drawingml/2006/main">
               <a:ext uri="{FF2B5EF4-FFF2-40B4-BE49-F238E27FC236}">
-                <a16:creationId xmlns:a16="http://schemas.microsoft.com/office/drawing/2014/main" id="{9F3924FC-730F-4034-B385-F0B13F7AF0DD}"/>
+                <a16:creationId xmlns:a16="http://schemas.microsoft.com/office/drawing/2014/main" id="{2DF6EF58-1181-4E42-850D-7C17668F7DE0}"/>
               </a:ext>
             </a:extLst>
           </p:cNvPr>
@@ -25704,7 +25704,7 @@
           <p:nvPr/>
         </p:nvPicPr>
         <p:blipFill>
-          <a:blip xmlns:r="http://schemas.openxmlformats.org/officeDocument/2006/relationships" xmlns:a="http://schemas.openxmlformats.org/drawingml/2006/main" r:embed="Rfc50d45d6e07439c"/>
+          <a:blip xmlns:r="http://schemas.openxmlformats.org/officeDocument/2006/relationships" xmlns:a="http://schemas.openxmlformats.org/drawingml/2006/main" r:embed="R8689646595564467"/>
           <a:stretch xmlns:a="http://schemas.openxmlformats.org/drawingml/2006/main"/>
         </p:blipFill>
         <p:spPr>
@@ -25722,7 +25722,7 @@
           <p:cNvPr id="5" name="">
             <a:extLst xmlns:a="http://schemas.openxmlformats.org/drawingml/2006/main">
               <a:ext uri="{FF2B5EF4-FFF2-40B4-BE49-F238E27FC236}">
-                <a16:creationId xmlns:a16="http://schemas.microsoft.com/office/drawing/2014/main" id="{F151DC41-510B-453B-8D79-38A4708507FD}"/>
+                <a16:creationId xmlns:a16="http://schemas.microsoft.com/office/drawing/2014/main" id="{54632E61-2C0B-478F-8F34-ADB254AB485A}"/>
               </a:ext>
             </a:extLst>
           </p:cNvPr>
@@ -25965,7 +25965,7 @@
           <p:cNvPr id="6" name="">
             <a:extLst xmlns:a="http://schemas.openxmlformats.org/drawingml/2006/main">
               <a:ext uri="{FF2B5EF4-FFF2-40B4-BE49-F238E27FC236}">
-                <a16:creationId xmlns:a16="http://schemas.microsoft.com/office/drawing/2014/main" id="{705AFA24-544B-4EEA-B007-1E860F8A0A79}"/>
+                <a16:creationId xmlns:a16="http://schemas.microsoft.com/office/drawing/2014/main" id="{1E9255A9-62CD-45FA-871F-1AFCB06A1246}"/>
               </a:ext>
             </a:extLst>
           </p:cNvPr>
@@ -26121,7 +26121,7 @@
     </p:spTree>
     <p:extLst>
       <p:ext uri="{BB962C8B-B14F-4D97-AF65-F5344CB8AC3E}">
-        <p14:creationId xmlns:p14="http://schemas.microsoft.com/office/powerpoint/2010/main" val="1694691005"/>
+        <p14:creationId xmlns:p14="http://schemas.microsoft.com/office/powerpoint/2010/main" val="804402729"/>
       </p:ext>
     </p:extLst>
   </p:cSld>
@@ -26152,7 +26152,7 @@
           <p:cNvPr id="19" name="">
             <a:extLst xmlns:a="http://schemas.openxmlformats.org/drawingml/2006/main">
               <a:ext uri="{FF2B5EF4-FFF2-40B4-BE49-F238E27FC236}">
-                <a16:creationId xmlns:a16="http://schemas.microsoft.com/office/drawing/2014/main" id="{E99A3812-0970-4815-B151-06F8E427FA6B}"/>
+                <a16:creationId xmlns:a16="http://schemas.microsoft.com/office/drawing/2014/main" id="{82412831-AC0C-4A24-9200-17852F6C955B}"/>
               </a:ext>
             </a:extLst>
           </p:cNvPr>
@@ -26182,7 +26182,7 @@
           <p:cNvPr id="2" name="">
             <a:extLst xmlns:a="http://schemas.openxmlformats.org/drawingml/2006/main">
               <a:ext uri="{FF2B5EF4-FFF2-40B4-BE49-F238E27FC236}">
-                <a16:creationId xmlns:a16="http://schemas.microsoft.com/office/drawing/2014/main" id="{2EC04EDC-23A7-4076-A6B9-385F1B57241B}"/>
+                <a16:creationId xmlns:a16="http://schemas.microsoft.com/office/drawing/2014/main" id="{86E14475-A30C-4E08-A6B0-09DF8511E632}"/>
               </a:ext>
             </a:extLst>
           </p:cNvPr>
@@ -26340,7 +26340,7 @@
           <p:cNvPr id="3" name="">
             <a:extLst xmlns:a="http://schemas.openxmlformats.org/drawingml/2006/main">
               <a:ext uri="{FF2B5EF4-FFF2-40B4-BE49-F238E27FC236}">
-                <a16:creationId xmlns:a16="http://schemas.microsoft.com/office/drawing/2014/main" id="{A0BD0718-0216-41B6-8C25-EBCBDD163B91}"/>
+                <a16:creationId xmlns:a16="http://schemas.microsoft.com/office/drawing/2014/main" id="{A8367CDE-C12C-4612-B59E-BC9CD1708BCB}"/>
               </a:ext>
             </a:extLst>
           </p:cNvPr>
@@ -26488,7 +26488,7 @@
                 <a:ea typeface="Arial"/>
                 <a:cs typeface="Arial"/>
               </a:rPr>
-              <a:t>Projeto Aplicado Cenário 4  ·  Versão 28/10/2026</a:t>
+              <a:t>Projeto Aplicado Cenário 4  ·  Versão 29/10/2026</a:t>
             </a:r>
           </a:p>
         </p:txBody>
@@ -26498,7 +26498,7 @@
           <p:cNvPr id="4" name="">
             <a:extLst xmlns:a="http://schemas.openxmlformats.org/drawingml/2006/main">
               <a:ext uri="{FF2B5EF4-FFF2-40B4-BE49-F238E27FC236}">
-                <a16:creationId xmlns:a16="http://schemas.microsoft.com/office/drawing/2014/main" id="{8A53F9B0-D381-46C2-9D21-277656D4C2F5}"/>
+                <a16:creationId xmlns:a16="http://schemas.microsoft.com/office/drawing/2014/main" id="{6EF39C0B-ADBC-4836-93A9-DE32EE180A6A}"/>
               </a:ext>
             </a:extLst>
           </p:cNvPr>
@@ -26663,7 +26663,7 @@
           <p:cNvPr id="5" name="">
             <a:extLst xmlns:a="http://schemas.openxmlformats.org/drawingml/2006/main">
               <a:ext uri="{FF2B5EF4-FFF2-40B4-BE49-F238E27FC236}">
-                <a16:creationId xmlns:a16="http://schemas.microsoft.com/office/drawing/2014/main" id="{87A67EA3-88EF-4A0D-8D81-D1E504D9611E}"/>
+                <a16:creationId xmlns:a16="http://schemas.microsoft.com/office/drawing/2014/main" id="{50EF44BB-016A-45CB-A470-7EB57ECEECD2}"/>
               </a:ext>
             </a:extLst>
           </p:cNvPr>
@@ -26821,7 +26821,7 @@
           <p:cNvPr id="6" name="">
             <a:extLst xmlns:a="http://schemas.openxmlformats.org/drawingml/2006/main">
               <a:ext uri="{FF2B5EF4-FFF2-40B4-BE49-F238E27FC236}">
-                <a16:creationId xmlns:a16="http://schemas.microsoft.com/office/drawing/2014/main" id="{2B4DCA79-481B-43E3-898E-A257D13DD99F}"/>
+                <a16:creationId xmlns:a16="http://schemas.microsoft.com/office/drawing/2014/main" id="{3D484D3E-EC7F-4865-A5B7-EFCB905B001F}"/>
               </a:ext>
             </a:extLst>
           </p:cNvPr>
@@ -26979,7 +26979,7 @@
           <p:cNvPr id="7" name="">
             <a:extLst xmlns:a="http://schemas.openxmlformats.org/drawingml/2006/main">
               <a:ext uri="{FF2B5EF4-FFF2-40B4-BE49-F238E27FC236}">
-                <a16:creationId xmlns:a16="http://schemas.microsoft.com/office/drawing/2014/main" id="{6F55CD49-58C2-48FD-9D78-EE2E40D5F267}"/>
+                <a16:creationId xmlns:a16="http://schemas.microsoft.com/office/drawing/2014/main" id="{8DF87124-3088-4030-BE15-3439FD759E43}"/>
               </a:ext>
             </a:extLst>
           </p:cNvPr>
@@ -27144,7 +27144,7 @@
           <p:cNvPr id="8" name="">
             <a:extLst xmlns:a="http://schemas.openxmlformats.org/drawingml/2006/main">
               <a:ext uri="{FF2B5EF4-FFF2-40B4-BE49-F238E27FC236}">
-                <a16:creationId xmlns:a16="http://schemas.microsoft.com/office/drawing/2014/main" id="{2097DA58-23C6-483F-954D-2CA5B47FBADB}"/>
+                <a16:creationId xmlns:a16="http://schemas.microsoft.com/office/drawing/2014/main" id="{56ADE886-58AC-4ADA-9D54-C1709923DFB5}"/>
               </a:ext>
             </a:extLst>
           </p:cNvPr>
@@ -27302,7 +27302,7 @@
           <p:cNvPr id="9" name="">
             <a:extLst xmlns:a="http://schemas.openxmlformats.org/drawingml/2006/main">
               <a:ext uri="{FF2B5EF4-FFF2-40B4-BE49-F238E27FC236}">
-                <a16:creationId xmlns:a16="http://schemas.microsoft.com/office/drawing/2014/main" id="{40E8332B-F9F3-44CB-B9A6-F9C7CA96743C}"/>
+                <a16:creationId xmlns:a16="http://schemas.microsoft.com/office/drawing/2014/main" id="{E638BEF1-7934-4BB1-AA35-CA5D60277096}"/>
               </a:ext>
             </a:extLst>
           </p:cNvPr>
@@ -27460,7 +27460,7 @@
           <p:cNvPr id="10" name="">
             <a:extLst xmlns:a="http://schemas.openxmlformats.org/drawingml/2006/main">
               <a:ext uri="{FF2B5EF4-FFF2-40B4-BE49-F238E27FC236}">
-                <a16:creationId xmlns:a16="http://schemas.microsoft.com/office/drawing/2014/main" id="{CD024895-19D0-4815-8296-FBCBD5B51894}"/>
+                <a16:creationId xmlns:a16="http://schemas.microsoft.com/office/drawing/2014/main" id="{668B8053-AF04-4DA0-984B-63D3E4E27B66}"/>
               </a:ext>
             </a:extLst>
           </p:cNvPr>
@@ -27625,7 +27625,7 @@
           <p:cNvPr id="11" name="">
             <a:extLst xmlns:a="http://schemas.openxmlformats.org/drawingml/2006/main">
               <a:ext uri="{FF2B5EF4-FFF2-40B4-BE49-F238E27FC236}">
-                <a16:creationId xmlns:a16="http://schemas.microsoft.com/office/drawing/2014/main" id="{AA3D61AD-1854-457B-A734-66DFBA8B170F}"/>
+                <a16:creationId xmlns:a16="http://schemas.microsoft.com/office/drawing/2014/main" id="{98F4FAF4-5697-48E8-A951-71046CA67F3C}"/>
               </a:ext>
             </a:extLst>
           </p:cNvPr>
@@ -27783,7 +27783,7 @@
           <p:cNvPr id="12" name="">
             <a:extLst xmlns:a="http://schemas.openxmlformats.org/drawingml/2006/main">
               <a:ext uri="{FF2B5EF4-FFF2-40B4-BE49-F238E27FC236}">
-                <a16:creationId xmlns:a16="http://schemas.microsoft.com/office/drawing/2014/main" id="{0AB3ABC7-E2E8-4F71-82E3-658391BD63E8}"/>
+                <a16:creationId xmlns:a16="http://schemas.microsoft.com/office/drawing/2014/main" id="{13D1936F-0F3A-45E9-8CFC-5DF0A1A8095F}"/>
               </a:ext>
             </a:extLst>
           </p:cNvPr>
@@ -27941,7 +27941,7 @@
           <p:cNvPr id="13" name="">
             <a:extLst xmlns:a="http://schemas.openxmlformats.org/drawingml/2006/main">
               <a:ext uri="{FF2B5EF4-FFF2-40B4-BE49-F238E27FC236}">
-                <a16:creationId xmlns:a16="http://schemas.microsoft.com/office/drawing/2014/main" id="{C72FA73D-C084-48A7-9951-3339A32382E6}"/>
+                <a16:creationId xmlns:a16="http://schemas.microsoft.com/office/drawing/2014/main" id="{45D74BFC-72B7-4F99-ADC9-748D432E92FD}"/>
               </a:ext>
             </a:extLst>
           </p:cNvPr>
@@ -28106,7 +28106,7 @@
           <p:cNvPr id="14" name="">
             <a:extLst xmlns:a="http://schemas.openxmlformats.org/drawingml/2006/main">
               <a:ext uri="{FF2B5EF4-FFF2-40B4-BE49-F238E27FC236}">
-                <a16:creationId xmlns:a16="http://schemas.microsoft.com/office/drawing/2014/main" id="{9AAFABA8-9A78-4768-B270-1370FADB2E2A}"/>
+                <a16:creationId xmlns:a16="http://schemas.microsoft.com/office/drawing/2014/main" id="{2748F6A9-62E8-441F-B379-C63A4FCFE4FC}"/>
               </a:ext>
             </a:extLst>
           </p:cNvPr>
@@ -28264,7 +28264,7 @@
           <p:cNvPr id="15" name="">
             <a:extLst xmlns:a="http://schemas.openxmlformats.org/drawingml/2006/main">
               <a:ext uri="{FF2B5EF4-FFF2-40B4-BE49-F238E27FC236}">
-                <a16:creationId xmlns:a16="http://schemas.microsoft.com/office/drawing/2014/main" id="{650FE3BD-87CD-45F4-8032-718369B23AE5}"/>
+                <a16:creationId xmlns:a16="http://schemas.microsoft.com/office/drawing/2014/main" id="{4285A071-E483-4912-B414-ED891560CAA8}"/>
               </a:ext>
             </a:extLst>
           </p:cNvPr>
@@ -28422,7 +28422,7 @@
           <p:cNvPr id="16" name="">
             <a:extLst xmlns:a="http://schemas.openxmlformats.org/drawingml/2006/main">
               <a:ext uri="{FF2B5EF4-FFF2-40B4-BE49-F238E27FC236}">
-                <a16:creationId xmlns:a16="http://schemas.microsoft.com/office/drawing/2014/main" id="{8D625F3E-4860-425E-ADEE-16EBD06C4D05}"/>
+                <a16:creationId xmlns:a16="http://schemas.microsoft.com/office/drawing/2014/main" id="{10E12C4F-C5F2-41BA-941F-B72B722B0A96}"/>
               </a:ext>
             </a:extLst>
           </p:cNvPr>
@@ -28587,7 +28587,7 @@
           <p:cNvPr id="17" name="">
             <a:extLst xmlns:a="http://schemas.openxmlformats.org/drawingml/2006/main">
               <a:ext uri="{FF2B5EF4-FFF2-40B4-BE49-F238E27FC236}">
-                <a16:creationId xmlns:a16="http://schemas.microsoft.com/office/drawing/2014/main" id="{1C7BA545-3E2D-4B91-AAAD-45FFB5A71547}"/>
+                <a16:creationId xmlns:a16="http://schemas.microsoft.com/office/drawing/2014/main" id="{F229D0F6-13A3-4E73-946E-C628C8AD39F3}"/>
               </a:ext>
             </a:extLst>
           </p:cNvPr>
@@ -28745,7 +28745,7 @@
           <p:cNvPr id="18" name="">
             <a:extLst xmlns:a="http://schemas.openxmlformats.org/drawingml/2006/main">
               <a:ext uri="{FF2B5EF4-FFF2-40B4-BE49-F238E27FC236}">
-                <a16:creationId xmlns:a16="http://schemas.microsoft.com/office/drawing/2014/main" id="{8E2E6204-8F12-48F5-8941-97F82B01186C}"/>
+                <a16:creationId xmlns:a16="http://schemas.microsoft.com/office/drawing/2014/main" id="{13447EA8-1598-4EEE-869E-48E5E879228E}"/>
               </a:ext>
             </a:extLst>
           </p:cNvPr>
@@ -28901,7 +28901,7 @@
     </p:spTree>
     <p:extLst>
       <p:ext uri="{BB962C8B-B14F-4D97-AF65-F5344CB8AC3E}">
-        <p14:creationId xmlns:p14="http://schemas.microsoft.com/office/powerpoint/2010/main" val="253188042"/>
+        <p14:creationId xmlns:p14="http://schemas.microsoft.com/office/powerpoint/2010/main" val="193246916"/>
       </p:ext>
     </p:extLst>
   </p:cSld>
@@ -28932,7 +28932,7 @@
           <p:cNvPr id="16" name="">
             <a:extLst xmlns:a="http://schemas.openxmlformats.org/drawingml/2006/main">
               <a:ext uri="{FF2B5EF4-FFF2-40B4-BE49-F238E27FC236}">
-                <a16:creationId xmlns:a16="http://schemas.microsoft.com/office/drawing/2014/main" id="{02BE0C9B-86A4-4F22-8713-A7B9077D0DBA}"/>
+                <a16:creationId xmlns:a16="http://schemas.microsoft.com/office/drawing/2014/main" id="{0A95D97F-B47D-4505-858F-F0BB489866F6}"/>
               </a:ext>
             </a:extLst>
           </p:cNvPr>
@@ -28962,7 +28962,7 @@
           <p:cNvPr id="2" name="">
             <a:extLst xmlns:a="http://schemas.openxmlformats.org/drawingml/2006/main">
               <a:ext uri="{FF2B5EF4-FFF2-40B4-BE49-F238E27FC236}">
-                <a16:creationId xmlns:a16="http://schemas.microsoft.com/office/drawing/2014/main" id="{F4396842-A241-4A95-82F6-7080BFBF77B3}"/>
+                <a16:creationId xmlns:a16="http://schemas.microsoft.com/office/drawing/2014/main" id="{EFD941C2-0773-4757-8D91-2A5BD83AFABF}"/>
               </a:ext>
             </a:extLst>
           </p:cNvPr>
@@ -29120,7 +29120,7 @@
           <p:cNvPr id="3" name="">
             <a:extLst xmlns:a="http://schemas.openxmlformats.org/drawingml/2006/main">
               <a:ext uri="{FF2B5EF4-FFF2-40B4-BE49-F238E27FC236}">
-                <a16:creationId xmlns:a16="http://schemas.microsoft.com/office/drawing/2014/main" id="{588253B7-6293-4A99-902F-5A60606C9F1C}"/>
+                <a16:creationId xmlns:a16="http://schemas.microsoft.com/office/drawing/2014/main" id="{71789CF9-7CE6-44F9-B82B-B53A3D0775DB}"/>
               </a:ext>
             </a:extLst>
           </p:cNvPr>
@@ -29268,7 +29268,7 @@
                 <a:ea typeface="Arial"/>
                 <a:cs typeface="Arial"/>
               </a:rPr>
-              <a:t>Projeto Aplicado Cenário 4  ·  Versão 28/10/2026</a:t>
+              <a:t>Projeto Aplicado Cenário 4  ·  Versão 29/10/2026</a:t>
             </a:r>
           </a:p>
         </p:txBody>
@@ -29278,7 +29278,7 @@
           <p:cNvPr id="4" name="">
             <a:extLst xmlns:a="http://schemas.openxmlformats.org/drawingml/2006/main">
               <a:ext uri="{FF2B5EF4-FFF2-40B4-BE49-F238E27FC236}">
-                <a16:creationId xmlns:a16="http://schemas.microsoft.com/office/drawing/2014/main" id="{623E169B-4D79-469F-AA6E-987639252455}"/>
+                <a16:creationId xmlns:a16="http://schemas.microsoft.com/office/drawing/2014/main" id="{00A64AF7-AAEE-40CE-B3DD-2AE9D1458333}"/>
               </a:ext>
             </a:extLst>
           </p:cNvPr>
@@ -29436,7 +29436,7 @@
           <p:cNvPr id="5" name="">
             <a:extLst xmlns:a="http://schemas.openxmlformats.org/drawingml/2006/main">
               <a:ext uri="{FF2B5EF4-FFF2-40B4-BE49-F238E27FC236}">
-                <a16:creationId xmlns:a16="http://schemas.microsoft.com/office/drawing/2014/main" id="{F18AF2BF-E458-4D9D-B0DF-14FB549328AB}"/>
+                <a16:creationId xmlns:a16="http://schemas.microsoft.com/office/drawing/2014/main" id="{92B1E99B-8C22-4893-9B23-FF8843313AA8}"/>
               </a:ext>
             </a:extLst>
           </p:cNvPr>
@@ -29594,7 +29594,7 @@
           <p:cNvPr id="6" name="">
             <a:extLst xmlns:a="http://schemas.openxmlformats.org/drawingml/2006/main">
               <a:ext uri="{FF2B5EF4-FFF2-40B4-BE49-F238E27FC236}">
-                <a16:creationId xmlns:a16="http://schemas.microsoft.com/office/drawing/2014/main" id="{EB83C95D-EC79-4147-B7CB-7609011CD42A}"/>
+                <a16:creationId xmlns:a16="http://schemas.microsoft.com/office/drawing/2014/main" id="{2F68076B-25B3-4BF8-80A0-D07F85F90DD8}"/>
               </a:ext>
             </a:extLst>
           </p:cNvPr>
@@ -29752,7 +29752,7 @@
           <p:cNvPr id="7" name="">
             <a:extLst xmlns:a="http://schemas.openxmlformats.org/drawingml/2006/main">
               <a:ext uri="{FF2B5EF4-FFF2-40B4-BE49-F238E27FC236}">
-                <a16:creationId xmlns:a16="http://schemas.microsoft.com/office/drawing/2014/main" id="{6613E00B-77D4-4CEC-8BF0-2A3C2372CC66}"/>
+                <a16:creationId xmlns:a16="http://schemas.microsoft.com/office/drawing/2014/main" id="{736C2578-58F2-4B17-A6E7-9DC9B38486BD}"/>
               </a:ext>
             </a:extLst>
           </p:cNvPr>
@@ -29910,7 +29910,7 @@
           <p:cNvPr id="8" name="">
             <a:extLst xmlns:a="http://schemas.openxmlformats.org/drawingml/2006/main">
               <a:ext uri="{FF2B5EF4-FFF2-40B4-BE49-F238E27FC236}">
-                <a16:creationId xmlns:a16="http://schemas.microsoft.com/office/drawing/2014/main" id="{8D77D24F-7031-4E99-9F91-0050DA026CC0}"/>
+                <a16:creationId xmlns:a16="http://schemas.microsoft.com/office/drawing/2014/main" id="{48F3546D-8126-481F-8341-2022EA79DBB3}"/>
               </a:ext>
             </a:extLst>
           </p:cNvPr>
@@ -30068,7 +30068,7 @@
           <p:cNvPr id="9" name="">
             <a:extLst xmlns:a="http://schemas.openxmlformats.org/drawingml/2006/main">
               <a:ext uri="{FF2B5EF4-FFF2-40B4-BE49-F238E27FC236}">
-                <a16:creationId xmlns:a16="http://schemas.microsoft.com/office/drawing/2014/main" id="{BA6D99B1-EB46-482D-AFE4-CD84FC9C468B}"/>
+                <a16:creationId xmlns:a16="http://schemas.microsoft.com/office/drawing/2014/main" id="{61207949-A9D9-415D-BFCB-49374A919B89}"/>
               </a:ext>
             </a:extLst>
           </p:cNvPr>
@@ -30226,7 +30226,7 @@
           <p:cNvPr id="10" name="">
             <a:extLst xmlns:a="http://schemas.openxmlformats.org/drawingml/2006/main">
               <a:ext uri="{FF2B5EF4-FFF2-40B4-BE49-F238E27FC236}">
-                <a16:creationId xmlns:a16="http://schemas.microsoft.com/office/drawing/2014/main" id="{665EF8C1-12EB-4F6C-A839-5D2E4CA4E552}"/>
+                <a16:creationId xmlns:a16="http://schemas.microsoft.com/office/drawing/2014/main" id="{CE4193D5-AC86-475A-8F6D-0010033317F4}"/>
               </a:ext>
             </a:extLst>
           </p:cNvPr>
@@ -30384,7 +30384,7 @@
           <p:cNvPr id="11" name="">
             <a:extLst xmlns:a="http://schemas.openxmlformats.org/drawingml/2006/main">
               <a:ext uri="{FF2B5EF4-FFF2-40B4-BE49-F238E27FC236}">
-                <a16:creationId xmlns:a16="http://schemas.microsoft.com/office/drawing/2014/main" id="{3140CD44-B8B9-4AB6-B214-0786B68061CD}"/>
+                <a16:creationId xmlns:a16="http://schemas.microsoft.com/office/drawing/2014/main" id="{6E0D2CC4-7983-4D27-AE3E-E6A2D820E1C6}"/>
               </a:ext>
             </a:extLst>
           </p:cNvPr>
@@ -30542,7 +30542,7 @@
           <p:cNvPr id="12" name="">
             <a:extLst xmlns:a="http://schemas.openxmlformats.org/drawingml/2006/main">
               <a:ext uri="{FF2B5EF4-FFF2-40B4-BE49-F238E27FC236}">
-                <a16:creationId xmlns:a16="http://schemas.microsoft.com/office/drawing/2014/main" id="{0E117F58-37E0-4085-AC9A-56D9568B8356}"/>
+                <a16:creationId xmlns:a16="http://schemas.microsoft.com/office/drawing/2014/main" id="{C88CD185-EF48-481F-BBDD-651A9C8C8A07}"/>
               </a:ext>
             </a:extLst>
           </p:cNvPr>
@@ -30700,7 +30700,7 @@
           <p:cNvPr id="13" name="">
             <a:extLst xmlns:a="http://schemas.openxmlformats.org/drawingml/2006/main">
               <a:ext uri="{FF2B5EF4-FFF2-40B4-BE49-F238E27FC236}">
-                <a16:creationId xmlns:a16="http://schemas.microsoft.com/office/drawing/2014/main" id="{8DB49035-E2CD-404D-98B5-363D6A6BC8A8}"/>
+                <a16:creationId xmlns:a16="http://schemas.microsoft.com/office/drawing/2014/main" id="{5DF02BF0-D39F-4D07-99A0-EF974BFCBBB2}"/>
               </a:ext>
             </a:extLst>
           </p:cNvPr>
@@ -30858,7 +30858,7 @@
           <p:cNvPr id="14" name="">
             <a:extLst xmlns:a="http://schemas.openxmlformats.org/drawingml/2006/main">
               <a:ext uri="{FF2B5EF4-FFF2-40B4-BE49-F238E27FC236}">
-                <a16:creationId xmlns:a16="http://schemas.microsoft.com/office/drawing/2014/main" id="{744B909B-FEF9-4756-820E-E78DB10C340E}"/>
+                <a16:creationId xmlns:a16="http://schemas.microsoft.com/office/drawing/2014/main" id="{3C38AC2F-D5E5-4B8C-AAD2-003B08957667}"/>
               </a:ext>
             </a:extLst>
           </p:cNvPr>
@@ -31016,7 +31016,7 @@
           <p:cNvPr id="15" name="">
             <a:extLst xmlns:a="http://schemas.openxmlformats.org/drawingml/2006/main">
               <a:ext uri="{FF2B5EF4-FFF2-40B4-BE49-F238E27FC236}">
-                <a16:creationId xmlns:a16="http://schemas.microsoft.com/office/drawing/2014/main" id="{56CE7D92-C779-486C-9E83-9BD466667256}"/>
+                <a16:creationId xmlns:a16="http://schemas.microsoft.com/office/drawing/2014/main" id="{523C6292-68A9-4C71-B578-D12D99BD7B99}"/>
               </a:ext>
             </a:extLst>
           </p:cNvPr>
@@ -31172,7 +31172,7 @@
     </p:spTree>
     <p:extLst>
       <p:ext uri="{BB962C8B-B14F-4D97-AF65-F5344CB8AC3E}">
-        <p14:creationId xmlns:p14="http://schemas.microsoft.com/office/powerpoint/2010/main" val="1369230454"/>
+        <p14:creationId xmlns:p14="http://schemas.microsoft.com/office/powerpoint/2010/main" val="360847459"/>
       </p:ext>
     </p:extLst>
   </p:cSld>
@@ -31203,7 +31203,7 @@
           <p:cNvPr id="9" name="">
             <a:extLst xmlns:a="http://schemas.openxmlformats.org/drawingml/2006/main">
               <a:ext uri="{FF2B5EF4-FFF2-40B4-BE49-F238E27FC236}">
-                <a16:creationId xmlns:a16="http://schemas.microsoft.com/office/drawing/2014/main" id="{2D3F6ADD-F4AB-42A9-BC1D-7628FF00DB1F}"/>
+                <a16:creationId xmlns:a16="http://schemas.microsoft.com/office/drawing/2014/main" id="{170BF175-CF12-4BFE-9F5F-AD8C67939423}"/>
               </a:ext>
             </a:extLst>
           </p:cNvPr>
@@ -31233,7 +31233,7 @@
           <p:cNvPr id="2" name="">
             <a:extLst xmlns:a="http://schemas.openxmlformats.org/drawingml/2006/main">
               <a:ext uri="{FF2B5EF4-FFF2-40B4-BE49-F238E27FC236}">
-                <a16:creationId xmlns:a16="http://schemas.microsoft.com/office/drawing/2014/main" id="{76D04C20-0358-4811-B453-D63133E84ADD}"/>
+                <a16:creationId xmlns:a16="http://schemas.microsoft.com/office/drawing/2014/main" id="{59931569-FD31-4872-9E92-310B8E71E06F}"/>
               </a:ext>
             </a:extLst>
           </p:cNvPr>
@@ -31391,7 +31391,7 @@
           <p:cNvPr id="3" name="">
             <a:extLst xmlns:a="http://schemas.openxmlformats.org/drawingml/2006/main">
               <a:ext uri="{FF2B5EF4-FFF2-40B4-BE49-F238E27FC236}">
-                <a16:creationId xmlns:a16="http://schemas.microsoft.com/office/drawing/2014/main" id="{F52C1492-7596-4C04-9976-6DBDFCAE3FC0}"/>
+                <a16:creationId xmlns:a16="http://schemas.microsoft.com/office/drawing/2014/main" id="{AB8D1F41-3051-49B8-9413-FF185D653AAC}"/>
               </a:ext>
             </a:extLst>
           </p:cNvPr>
@@ -31539,7 +31539,7 @@
                 <a:ea typeface="Arial"/>
                 <a:cs typeface="Arial"/>
               </a:rPr>
-              <a:t>Projeto Aplicado Cenário 4  ·  Versão 28/10/2026</a:t>
+              <a:t>Projeto Aplicado Cenário 4  ·  Versão 29/10/2026</a:t>
             </a:r>
           </a:p>
         </p:txBody>
@@ -31549,7 +31549,7 @@
           <p:cNvPr id="4" name="">
             <a:extLst xmlns:a="http://schemas.openxmlformats.org/drawingml/2006/main">
               <a:ext uri="{FF2B5EF4-FFF2-40B4-BE49-F238E27FC236}">
-                <a16:creationId xmlns:a16="http://schemas.microsoft.com/office/drawing/2014/main" id="{BA45F0E4-EF2D-4577-BB4C-38F4D0FD7AAE}"/>
+                <a16:creationId xmlns:a16="http://schemas.microsoft.com/office/drawing/2014/main" id="{97C35E0C-BC24-43AF-9FB1-935DEB24DABD}"/>
               </a:ext>
             </a:extLst>
           </p:cNvPr>
@@ -31819,7 +31819,7 @@
           <p:cNvPr id="5" name="">
             <a:extLst xmlns:a="http://schemas.openxmlformats.org/drawingml/2006/main">
               <a:ext uri="{FF2B5EF4-FFF2-40B4-BE49-F238E27FC236}">
-                <a16:creationId xmlns:a16="http://schemas.microsoft.com/office/drawing/2014/main" id="{971BA5F0-80B6-42AF-B889-E6E234906203}"/>
+                <a16:creationId xmlns:a16="http://schemas.microsoft.com/office/drawing/2014/main" id="{E687C994-4A95-4882-99D3-6CC8CFC3249D}"/>
               </a:ext>
             </a:extLst>
           </p:cNvPr>
@@ -32007,7 +32007,7 @@
           <p:cNvPr id="6" name="">
             <a:extLst xmlns:a="http://schemas.openxmlformats.org/drawingml/2006/main">
               <a:ext uri="{FF2B5EF4-FFF2-40B4-BE49-F238E27FC236}">
-                <a16:creationId xmlns:a16="http://schemas.microsoft.com/office/drawing/2014/main" id="{9BC3E2B3-8192-4F15-A9FF-1CB9DBB14BEC}"/>
+                <a16:creationId xmlns:a16="http://schemas.microsoft.com/office/drawing/2014/main" id="{CB2CB099-FCDF-4054-972E-1530F3C034F7}"/>
               </a:ext>
             </a:extLst>
           </p:cNvPr>
@@ -32195,7 +32195,7 @@
           <p:cNvPr id="7" name="">
             <a:extLst xmlns:a="http://schemas.openxmlformats.org/drawingml/2006/main">
               <a:ext uri="{FF2B5EF4-FFF2-40B4-BE49-F238E27FC236}">
-                <a16:creationId xmlns:a16="http://schemas.microsoft.com/office/drawing/2014/main" id="{735D7432-D8C2-44EC-B6EE-C9D8FF282C8B}"/>
+                <a16:creationId xmlns:a16="http://schemas.microsoft.com/office/drawing/2014/main" id="{8504567C-9DDA-42FD-9DFD-BB1815D7FBA3}"/>
               </a:ext>
             </a:extLst>
           </p:cNvPr>
@@ -32383,7 +32383,7 @@
           <p:cNvPr id="8" name="">
             <a:extLst xmlns:a="http://schemas.openxmlformats.org/drawingml/2006/main">
               <a:ext uri="{FF2B5EF4-FFF2-40B4-BE49-F238E27FC236}">
-                <a16:creationId xmlns:a16="http://schemas.microsoft.com/office/drawing/2014/main" id="{6A557B02-747B-4504-9677-66620B8CDC27}"/>
+                <a16:creationId xmlns:a16="http://schemas.microsoft.com/office/drawing/2014/main" id="{016B405F-0AEC-4B7A-8BF4-FA24839B29F7}"/>
               </a:ext>
             </a:extLst>
           </p:cNvPr>
@@ -32539,7 +32539,7 @@
     </p:spTree>
     <p:extLst>
       <p:ext uri="{BB962C8B-B14F-4D97-AF65-F5344CB8AC3E}">
-        <p14:creationId xmlns:p14="http://schemas.microsoft.com/office/powerpoint/2010/main" val="169823913"/>
+        <p14:creationId xmlns:p14="http://schemas.microsoft.com/office/powerpoint/2010/main" val="834830175"/>
       </p:ext>
     </p:extLst>
   </p:cSld>

</xml_diff>

<commit_message>
docs: ADR-006 não adotado e retirada dos agentes cavecrew/caveman
- ADR-006 marcado como não adotado: com a demonstração local e o CRM no
  mesmo processo, a leitura resiliente não tem efeito real. O adaptador e
  os testes permanecem como evolução para um CRM externo; README, matriz,
  cronograma, estado, relatório e slides deixam de apresentá-lo.
- Removidos os agentes cavecrew-* e as skills cavecrew, caveman e
  caveman-commit (e o skills-lock.json), que podiam ocupar o lugar do
  archcorp-qa ou comprimir textos em português.
- Relatório (20 páginas) e slides gerados de novo.
</commit_message>
<xml_diff>
--- a/output/Apresentacao_Cenario_4.pptx
+++ b/output/Apresentacao_Cenario_4.pptx
@@ -2,30 +2,30 @@
 <file path=ppt/presentation.xml><?xml version="1.0" encoding="utf-8"?>
 <p:presentation xmlns:p="http://schemas.openxmlformats.org/presentationml/2006/main">
   <p:sldMasterIdLst>
-    <p:sldMasterId xmlns:r="http://schemas.openxmlformats.org/officeDocument/2006/relationships" id="2147483648" r:id="Rd41158fea8ef483c"/>
+    <p:sldMasterId xmlns:r="http://schemas.openxmlformats.org/officeDocument/2006/relationships" id="2147483648" r:id="R3cded503b6b64539"/>
   </p:sldMasterIdLst>
   <p:notesMasterIdLst>
-    <p:notesMasterId xmlns:r="http://schemas.openxmlformats.org/officeDocument/2006/relationships" r:id="R5367f4dd3df14d4a"/>
+    <p:notesMasterId xmlns:r="http://schemas.openxmlformats.org/officeDocument/2006/relationships" r:id="R48e168b386d54ff5"/>
   </p:notesMasterIdLst>
   <p:sldIdLst>
-    <p:sldId xmlns:r="http://schemas.openxmlformats.org/officeDocument/2006/relationships" id="256" r:id="R566469cf66584c9a"/>
-    <p:sldId xmlns:r="http://schemas.openxmlformats.org/officeDocument/2006/relationships" id="257" r:id="Rb810065a080b4ccd"/>
-    <p:sldId xmlns:r="http://schemas.openxmlformats.org/officeDocument/2006/relationships" id="258" r:id="Rd69bee85e6444565"/>
-    <p:sldId xmlns:r="http://schemas.openxmlformats.org/officeDocument/2006/relationships" id="259" r:id="R6802f6c557d748e5"/>
-    <p:sldId xmlns:r="http://schemas.openxmlformats.org/officeDocument/2006/relationships" id="260" r:id="R600c0856ee624af4"/>
-    <p:sldId xmlns:r="http://schemas.openxmlformats.org/officeDocument/2006/relationships" id="261" r:id="R5c1076a1e30d4165"/>
-    <p:sldId xmlns:r="http://schemas.openxmlformats.org/officeDocument/2006/relationships" id="262" r:id="R6d2d7b7a8dd94392"/>
-    <p:sldId xmlns:r="http://schemas.openxmlformats.org/officeDocument/2006/relationships" id="263" r:id="R6fd1a1555291485c"/>
-    <p:sldId xmlns:r="http://schemas.openxmlformats.org/officeDocument/2006/relationships" id="264" r:id="Ra0897982c1ee4259"/>
-    <p:sldId xmlns:r="http://schemas.openxmlformats.org/officeDocument/2006/relationships" id="265" r:id="Rd8088677689e4703"/>
-    <p:sldId xmlns:r="http://schemas.openxmlformats.org/officeDocument/2006/relationships" id="266" r:id="R26e4208e61274c36"/>
-    <p:sldId xmlns:r="http://schemas.openxmlformats.org/officeDocument/2006/relationships" id="267" r:id="R74f01b4d9c4d4eba"/>
-    <p:sldId xmlns:r="http://schemas.openxmlformats.org/officeDocument/2006/relationships" id="268" r:id="Rf49b0efbdc204a1f"/>
-    <p:sldId xmlns:r="http://schemas.openxmlformats.org/officeDocument/2006/relationships" id="269" r:id="Rc0d7e8180f4f41d5"/>
-    <p:sldId xmlns:r="http://schemas.openxmlformats.org/officeDocument/2006/relationships" id="270" r:id="Raf881635198f4112"/>
-    <p:sldId xmlns:r="http://schemas.openxmlformats.org/officeDocument/2006/relationships" id="271" r:id="Re43eb0c434e44aa1"/>
-    <p:sldId xmlns:r="http://schemas.openxmlformats.org/officeDocument/2006/relationships" id="272" r:id="R10ed9c71453c4df0"/>
-    <p:sldId xmlns:r="http://schemas.openxmlformats.org/officeDocument/2006/relationships" id="273" r:id="Reb180658b99f4a58"/>
+    <p:sldId xmlns:r="http://schemas.openxmlformats.org/officeDocument/2006/relationships" id="256" r:id="R0a6444bcd1244550"/>
+    <p:sldId xmlns:r="http://schemas.openxmlformats.org/officeDocument/2006/relationships" id="257" r:id="Rcc4101aaf7374dae"/>
+    <p:sldId xmlns:r="http://schemas.openxmlformats.org/officeDocument/2006/relationships" id="258" r:id="Rbb609206622d40a2"/>
+    <p:sldId xmlns:r="http://schemas.openxmlformats.org/officeDocument/2006/relationships" id="259" r:id="Rbf60524d27924717"/>
+    <p:sldId xmlns:r="http://schemas.openxmlformats.org/officeDocument/2006/relationships" id="260" r:id="Re8c22ded83e245ae"/>
+    <p:sldId xmlns:r="http://schemas.openxmlformats.org/officeDocument/2006/relationships" id="261" r:id="R17d5cc7ae5164bd7"/>
+    <p:sldId xmlns:r="http://schemas.openxmlformats.org/officeDocument/2006/relationships" id="262" r:id="R9623ea21aaf7433b"/>
+    <p:sldId xmlns:r="http://schemas.openxmlformats.org/officeDocument/2006/relationships" id="263" r:id="R51df56b68f1740ce"/>
+    <p:sldId xmlns:r="http://schemas.openxmlformats.org/officeDocument/2006/relationships" id="264" r:id="Re855f7c87e814690"/>
+    <p:sldId xmlns:r="http://schemas.openxmlformats.org/officeDocument/2006/relationships" id="265" r:id="R72469c5b00524fd9"/>
+    <p:sldId xmlns:r="http://schemas.openxmlformats.org/officeDocument/2006/relationships" id="266" r:id="R1cc324e98f5d4e59"/>
+    <p:sldId xmlns:r="http://schemas.openxmlformats.org/officeDocument/2006/relationships" id="267" r:id="Rb629da31d5ce4a8b"/>
+    <p:sldId xmlns:r="http://schemas.openxmlformats.org/officeDocument/2006/relationships" id="268" r:id="Rd803a2e14b1c4b5a"/>
+    <p:sldId xmlns:r="http://schemas.openxmlformats.org/officeDocument/2006/relationships" id="269" r:id="Rad2df1d363e44a4c"/>
+    <p:sldId xmlns:r="http://schemas.openxmlformats.org/officeDocument/2006/relationships" id="270" r:id="R8ce73002f0ca446f"/>
+    <p:sldId xmlns:r="http://schemas.openxmlformats.org/officeDocument/2006/relationships" id="271" r:id="R59989f8f9be64bee"/>
+    <p:sldId xmlns:r="http://schemas.openxmlformats.org/officeDocument/2006/relationships" id="272" r:id="Rb70e15ba4ac94230"/>
+    <p:sldId xmlns:r="http://schemas.openxmlformats.org/officeDocument/2006/relationships" id="273" r:id="Rc132952c8c9f4ae6"/>
   </p:sldIdLst>
   <p:sldSz cx="12192000" cy="6858000"/>
   <p:notesSz cx="6858000" cy="9144000"/>
@@ -529,7 +529,7 @@
           <a:lstStyle xmlns:a="http://schemas.openxmlformats.org/drawingml/2006/main"/>
           <a:p xmlns:a="http://schemas.openxmlformats.org/drawingml/2006/main">
             <a:r>
-              <a:t>Fonte: docs/INTEGRACOES.md, scripts/demo_f1.py e evidência histórica consolidada em docs/EVIDENCIAS_VALIDACAO.md (20/10/2026). Não reexecutado em 28/10. ADR-006 permanece Proposto, aguardando aceite do responsável. A chamada no mesmo processo não tem interrupção por timeout de rede.</a:t>
+              <a:t>Fonte: docs/INTEGRACOES.md, scripts/demo_f1.py e evidência histórica consolidada em docs/EVIDENCIAS_VALIDACAO.md (20/10/2026). Não reexecutado em 28/10. ADR-006 não adotado: evolução para quando o CRM for externo. A chamada no mesmo processo não tem interrupção por timeout de rede.</a:t>
             </a:r>
           </a:p>
         </p:txBody>
@@ -1696,7 +1696,7 @@
           <p:cNvPr id="3" name="Title">
             <a:extLst xmlns:a="http://schemas.openxmlformats.org/drawingml/2006/main">
               <a:ext uri="{FF2B5EF4-FFF2-40B4-BE49-F238E27FC236}">
-                <a16:creationId xmlns:a16="http://schemas.microsoft.com/office/drawing/2014/main" id="{9AA102E5-F89D-4632-A19A-5A3850669A54}"/>
+                <a16:creationId xmlns:a16="http://schemas.microsoft.com/office/drawing/2014/main" id="{91BC7677-4172-48BC-BD3C-80EED31AD954}"/>
               </a:ext>
             </a:extLst>
           </p:cNvPr>
@@ -1925,7 +1925,7 @@
           <p:cNvPr id="2" name="Subtitle">
             <a:extLst xmlns:a="http://schemas.openxmlformats.org/drawingml/2006/main">
               <a:ext uri="{FF2B5EF4-FFF2-40B4-BE49-F238E27FC236}">
-                <a16:creationId xmlns:a16="http://schemas.microsoft.com/office/drawing/2014/main" id="{5F6EA76C-C82F-4CC2-9670-4403FCA916C3}"/>
+                <a16:creationId xmlns:a16="http://schemas.microsoft.com/office/drawing/2014/main" id="{E9F03DFC-1122-4BA0-BC62-2C2FA6CD2B35}"/>
               </a:ext>
             </a:extLst>
           </p:cNvPr>
@@ -2171,7 +2171,7 @@
           <p:cNvPr id="2" name="Section title">
             <a:extLst xmlns:a="http://schemas.openxmlformats.org/drawingml/2006/main">
               <a:ext uri="{FF2B5EF4-FFF2-40B4-BE49-F238E27FC236}">
-                <a16:creationId xmlns:a16="http://schemas.microsoft.com/office/drawing/2014/main" id="{3AD36F8B-7093-4426-9EE1-48C1A7EFC3A1}"/>
+                <a16:creationId xmlns:a16="http://schemas.microsoft.com/office/drawing/2014/main" id="{C2016B5C-15B6-4902-BA12-06BAD0EEDF20}"/>
               </a:ext>
             </a:extLst>
           </p:cNvPr>
@@ -2417,7 +2417,7 @@
           <p:cNvPr id="3" name="Title">
             <a:extLst xmlns:a="http://schemas.openxmlformats.org/drawingml/2006/main">
               <a:ext uri="{FF2B5EF4-FFF2-40B4-BE49-F238E27FC236}">
-                <a16:creationId xmlns:a16="http://schemas.microsoft.com/office/drawing/2014/main" id="{90C89FDD-2725-47C4-9A99-C449438B4A9D}"/>
+                <a16:creationId xmlns:a16="http://schemas.microsoft.com/office/drawing/2014/main" id="{0DA52986-1FC5-46CF-8892-243976EF7EA7}"/>
               </a:ext>
             </a:extLst>
           </p:cNvPr>
@@ -2646,7 +2646,7 @@
           <p:cNvPr id="2" name="Body">
             <a:extLst xmlns:a="http://schemas.openxmlformats.org/drawingml/2006/main">
               <a:ext uri="{FF2B5EF4-FFF2-40B4-BE49-F238E27FC236}">
-                <a16:creationId xmlns:a16="http://schemas.microsoft.com/office/drawing/2014/main" id="{6A134C65-B850-42E4-9B3B-8FAFB8847DF7}"/>
+                <a16:creationId xmlns:a16="http://schemas.microsoft.com/office/drawing/2014/main" id="{038516C6-1690-4AD4-A682-E5763DABB48A}"/>
               </a:ext>
             </a:extLst>
           </p:cNvPr>
@@ -2892,7 +2892,7 @@
           <p:cNvPr id="4" name="Title">
             <a:extLst xmlns:a="http://schemas.openxmlformats.org/drawingml/2006/main">
               <a:ext uri="{FF2B5EF4-FFF2-40B4-BE49-F238E27FC236}">
-                <a16:creationId xmlns:a16="http://schemas.microsoft.com/office/drawing/2014/main" id="{A5B52A49-DD2E-417E-81E5-0E8DC5986D0B}"/>
+                <a16:creationId xmlns:a16="http://schemas.microsoft.com/office/drawing/2014/main" id="{2707651D-1F53-4D0E-9C7C-3B8B53407166}"/>
               </a:ext>
             </a:extLst>
           </p:cNvPr>
@@ -3121,7 +3121,7 @@
           <p:cNvPr id="2" name="Left column">
             <a:extLst xmlns:a="http://schemas.openxmlformats.org/drawingml/2006/main">
               <a:ext uri="{FF2B5EF4-FFF2-40B4-BE49-F238E27FC236}">
-                <a16:creationId xmlns:a16="http://schemas.microsoft.com/office/drawing/2014/main" id="{072D5F21-CB76-4B97-A44C-3E9B8C886E97}"/>
+                <a16:creationId xmlns:a16="http://schemas.microsoft.com/office/drawing/2014/main" id="{04750F68-DBB3-4CCD-8ED2-213C8FC7CF6F}"/>
               </a:ext>
             </a:extLst>
           </p:cNvPr>
@@ -3350,7 +3350,7 @@
           <p:cNvPr id="3" name="Right column">
             <a:extLst xmlns:a="http://schemas.openxmlformats.org/drawingml/2006/main">
               <a:ext uri="{FF2B5EF4-FFF2-40B4-BE49-F238E27FC236}">
-                <a16:creationId xmlns:a16="http://schemas.microsoft.com/office/drawing/2014/main" id="{210E4041-F794-47C5-A7D6-1A8D161E540C}"/>
+                <a16:creationId xmlns:a16="http://schemas.microsoft.com/office/drawing/2014/main" id="{E7095CDA-0832-41E6-9D2D-975868B41671}"/>
               </a:ext>
             </a:extLst>
           </p:cNvPr>
@@ -3596,7 +3596,7 @@
           <p:cNvPr id="3" name="Title">
             <a:extLst xmlns:a="http://schemas.openxmlformats.org/drawingml/2006/main">
               <a:ext uri="{FF2B5EF4-FFF2-40B4-BE49-F238E27FC236}">
-                <a16:creationId xmlns:a16="http://schemas.microsoft.com/office/drawing/2014/main" id="{84EE5A09-02DF-49A0-83DE-A2E82FAE128B}"/>
+                <a16:creationId xmlns:a16="http://schemas.microsoft.com/office/drawing/2014/main" id="{BBED4B2E-7A07-4F0E-989B-4A7F44C15DDD}"/>
               </a:ext>
             </a:extLst>
           </p:cNvPr>
@@ -3825,7 +3825,7 @@
           <p:cNvPr id="2" name="Left column">
             <a:extLst xmlns:a="http://schemas.openxmlformats.org/drawingml/2006/main">
               <a:ext uri="{FF2B5EF4-FFF2-40B4-BE49-F238E27FC236}">
-                <a16:creationId xmlns:a16="http://schemas.microsoft.com/office/drawing/2014/main" id="{4A63F8A7-3B58-4A03-A040-C1D829A8E9C7}"/>
+                <a16:creationId xmlns:a16="http://schemas.microsoft.com/office/drawing/2014/main" id="{42B5DE39-6E75-409F-872B-1811DA466E2A}"/>
               </a:ext>
             </a:extLst>
           </p:cNvPr>
@@ -4092,12 +4092,12 @@
   </p:cSld>
   <p:clrMap bg1="lt1" tx1="dk1" bg2="lt2" tx2="dk2" accent1="accent1" accent2="accent2" accent3="accent3" accent4="accent4" accent5="accent5" accent6="accent6" hlink="hlink" folHlink="folHlink"/>
   <p:sldLayoutIdLst>
-    <p:sldLayoutId xmlns:r="http://schemas.openxmlformats.org/officeDocument/2006/relationships" id="2147483649" r:id="Rffa414c81f9144e5"/>
-    <p:sldLayoutId xmlns:r="http://schemas.openxmlformats.org/officeDocument/2006/relationships" id="2147483650" r:id="R7c90641b895e41aa"/>
-    <p:sldLayoutId xmlns:r="http://schemas.openxmlformats.org/officeDocument/2006/relationships" id="2147483651" r:id="R5f95b560205c4b28"/>
-    <p:sldLayoutId xmlns:r="http://schemas.openxmlformats.org/officeDocument/2006/relationships" id="2147483652" r:id="R93e37e7dc6de4a3f"/>
-    <p:sldLayoutId xmlns:r="http://schemas.openxmlformats.org/officeDocument/2006/relationships" id="2147483653" r:id="R902f3b9f3e8c45d4"/>
-    <p:sldLayoutId xmlns:r="http://schemas.openxmlformats.org/officeDocument/2006/relationships" id="2147483654" r:id="R0bac7e476ec3465c"/>
+    <p:sldLayoutId xmlns:r="http://schemas.openxmlformats.org/officeDocument/2006/relationships" id="2147483649" r:id="R3b3bd16c218d44c3"/>
+    <p:sldLayoutId xmlns:r="http://schemas.openxmlformats.org/officeDocument/2006/relationships" id="2147483650" r:id="R61e59fe576744fcf"/>
+    <p:sldLayoutId xmlns:r="http://schemas.openxmlformats.org/officeDocument/2006/relationships" id="2147483651" r:id="Rf7270209f18e4dc6"/>
+    <p:sldLayoutId xmlns:r="http://schemas.openxmlformats.org/officeDocument/2006/relationships" id="2147483652" r:id="Rb7dd734e0537478d"/>
+    <p:sldLayoutId xmlns:r="http://schemas.openxmlformats.org/officeDocument/2006/relationships" id="2147483653" r:id="Ra175f4137d96493f"/>
+    <p:sldLayoutId xmlns:r="http://schemas.openxmlformats.org/officeDocument/2006/relationships" id="2147483654" r:id="R9fda460fe3774ac1"/>
   </p:sldLayoutIdLst>
   <p:txStyles>
     <p:titleStyle>
@@ -4648,7 +4648,7 @@
           <p:cNvPr id="5" name="">
             <a:extLst xmlns:a="http://schemas.openxmlformats.org/drawingml/2006/main">
               <a:ext uri="{FF2B5EF4-FFF2-40B4-BE49-F238E27FC236}">
-                <a16:creationId xmlns:a16="http://schemas.microsoft.com/office/drawing/2014/main" id="{19E902CE-B7DD-48CE-8FF0-9F4715E2AB84}"/>
+                <a16:creationId xmlns:a16="http://schemas.microsoft.com/office/drawing/2014/main" id="{5A3C237D-0E0D-4D83-A30A-E09082DD4BD0}"/>
               </a:ext>
             </a:extLst>
           </p:cNvPr>
@@ -4829,7 +4829,7 @@
           <p:cNvPr id="2" name="">
             <a:extLst xmlns:a="http://schemas.openxmlformats.org/drawingml/2006/main">
               <a:ext uri="{FF2B5EF4-FFF2-40B4-BE49-F238E27FC236}">
-                <a16:creationId xmlns:a16="http://schemas.microsoft.com/office/drawing/2014/main" id="{BCD16174-470A-4163-B158-9EC05DBBCBB9}"/>
+                <a16:creationId xmlns:a16="http://schemas.microsoft.com/office/drawing/2014/main" id="{9892F5F9-407E-4A01-A3FB-275F84FE3BCC}"/>
               </a:ext>
             </a:extLst>
           </p:cNvPr>
@@ -4987,7 +4987,7 @@
           <p:cNvPr id="3" name="">
             <a:extLst xmlns:a="http://schemas.openxmlformats.org/drawingml/2006/main">
               <a:ext uri="{FF2B5EF4-FFF2-40B4-BE49-F238E27FC236}">
-                <a16:creationId xmlns:a16="http://schemas.microsoft.com/office/drawing/2014/main" id="{D5BD39C5-7B7F-4672-80C8-21E3F59D785E}"/>
+                <a16:creationId xmlns:a16="http://schemas.microsoft.com/office/drawing/2014/main" id="{13B8FB66-4401-432F-9B1E-A5C9298D2598}"/>
               </a:ext>
             </a:extLst>
           </p:cNvPr>
@@ -5017,7 +5017,7 @@
           <p:cNvPr id="4" name="">
             <a:extLst xmlns:a="http://schemas.openxmlformats.org/drawingml/2006/main">
               <a:ext uri="{FF2B5EF4-FFF2-40B4-BE49-F238E27FC236}">
-                <a16:creationId xmlns:a16="http://schemas.microsoft.com/office/drawing/2014/main" id="{22175279-7608-49B8-8A1B-076AC60F4162}"/>
+                <a16:creationId xmlns:a16="http://schemas.microsoft.com/office/drawing/2014/main" id="{D0167446-3576-4CE4-BF77-6A911DFCACAC}"/>
               </a:ext>
             </a:extLst>
           </p:cNvPr>
@@ -5242,7 +5242,7 @@
     </p:spTree>
     <p:extLst>
       <p:ext uri="{BB962C8B-B14F-4D97-AF65-F5344CB8AC3E}">
-        <p14:creationId xmlns:p14="http://schemas.microsoft.com/office/powerpoint/2010/main" val="126891129"/>
+        <p14:creationId xmlns:p14="http://schemas.microsoft.com/office/powerpoint/2010/main" val="2138575146"/>
       </p:ext>
     </p:extLst>
   </p:cSld>
@@ -5273,7 +5273,7 @@
           <p:cNvPr id="8" name="">
             <a:extLst xmlns:a="http://schemas.openxmlformats.org/drawingml/2006/main">
               <a:ext uri="{FF2B5EF4-FFF2-40B4-BE49-F238E27FC236}">
-                <a16:creationId xmlns:a16="http://schemas.microsoft.com/office/drawing/2014/main" id="{2952DDB7-7237-46B3-A268-B8B42B08CCC9}"/>
+                <a16:creationId xmlns:a16="http://schemas.microsoft.com/office/drawing/2014/main" id="{89274338-A8F9-4C20-8ABB-C6EAB47F69C7}"/>
               </a:ext>
             </a:extLst>
           </p:cNvPr>
@@ -5305,7 +5305,7 @@
           <p:cNvPr id="7" name="">
             <a:extLst xmlns:a="http://schemas.openxmlformats.org/drawingml/2006/main">
               <a:ext uri="{FF2B5EF4-FFF2-40B4-BE49-F238E27FC236}">
-                <a16:creationId xmlns:a16="http://schemas.microsoft.com/office/drawing/2014/main" id="{2E80D9D7-70E9-43BC-96AF-A5CBAC461659}"/>
+                <a16:creationId xmlns:a16="http://schemas.microsoft.com/office/drawing/2014/main" id="{DFFF3283-FB9D-4B11-8641-8F246B9D75F9}"/>
               </a:ext>
             </a:extLst>
           </p:cNvPr>
@@ -5337,7 +5337,7 @@
           <p:cNvPr id="12" name="">
             <a:extLst xmlns:a="http://schemas.openxmlformats.org/drawingml/2006/main">
               <a:ext uri="{FF2B5EF4-FFF2-40B4-BE49-F238E27FC236}">
-                <a16:creationId xmlns:a16="http://schemas.microsoft.com/office/drawing/2014/main" id="{94891469-9D79-4944-BD93-7A673D4AA148}"/>
+                <a16:creationId xmlns:a16="http://schemas.microsoft.com/office/drawing/2014/main" id="{1B069AAC-0FEF-4C3F-8EC3-02B32670AB44}"/>
               </a:ext>
             </a:extLst>
           </p:cNvPr>
@@ -5367,7 +5367,7 @@
           <p:cNvPr id="2" name="">
             <a:extLst xmlns:a="http://schemas.openxmlformats.org/drawingml/2006/main">
               <a:ext uri="{FF2B5EF4-FFF2-40B4-BE49-F238E27FC236}">
-                <a16:creationId xmlns:a16="http://schemas.microsoft.com/office/drawing/2014/main" id="{9CCF4DF1-A929-4A33-8616-10E2DFD6F39C}"/>
+                <a16:creationId xmlns:a16="http://schemas.microsoft.com/office/drawing/2014/main" id="{2DD0C0EB-6F2F-4E55-B761-33103C65A802}"/>
               </a:ext>
             </a:extLst>
           </p:cNvPr>
@@ -5525,7 +5525,7 @@
           <p:cNvPr id="3" name="">
             <a:extLst xmlns:a="http://schemas.openxmlformats.org/drawingml/2006/main">
               <a:ext uri="{FF2B5EF4-FFF2-40B4-BE49-F238E27FC236}">
-                <a16:creationId xmlns:a16="http://schemas.microsoft.com/office/drawing/2014/main" id="{CDDAC8E6-68F3-44D5-9A06-AA51DA5D35A8}"/>
+                <a16:creationId xmlns:a16="http://schemas.microsoft.com/office/drawing/2014/main" id="{3498B45A-4E98-4A47-8FE6-1CF08048DCE5}"/>
               </a:ext>
             </a:extLst>
           </p:cNvPr>
@@ -5683,7 +5683,7 @@
           <p:cNvPr id="4" name="">
             <a:extLst xmlns:a="http://schemas.openxmlformats.org/drawingml/2006/main">
               <a:ext uri="{FF2B5EF4-FFF2-40B4-BE49-F238E27FC236}">
-                <a16:creationId xmlns:a16="http://schemas.microsoft.com/office/drawing/2014/main" id="{10BD2622-613A-4195-965B-45C561BB5226}"/>
+                <a16:creationId xmlns:a16="http://schemas.microsoft.com/office/drawing/2014/main" id="{2E9674CB-6756-42D1-B7D0-E70A1944C9C9}"/>
               </a:ext>
             </a:extLst>
           </p:cNvPr>
@@ -5871,7 +5871,7 @@
           <p:cNvPr id="5" name="">
             <a:extLst xmlns:a="http://schemas.openxmlformats.org/drawingml/2006/main">
               <a:ext uri="{FF2B5EF4-FFF2-40B4-BE49-F238E27FC236}">
-                <a16:creationId xmlns:a16="http://schemas.microsoft.com/office/drawing/2014/main" id="{33C1CFF4-ED2F-4241-8BCB-DAC985BDFD65}"/>
+                <a16:creationId xmlns:a16="http://schemas.microsoft.com/office/drawing/2014/main" id="{5EFA9DB1-CC9D-46C5-98E7-5EB79D4B0E1B}"/>
               </a:ext>
             </a:extLst>
           </p:cNvPr>
@@ -6059,7 +6059,7 @@
           <p:cNvPr id="6" name="">
             <a:extLst xmlns:a="http://schemas.openxmlformats.org/drawingml/2006/main">
               <a:ext uri="{FF2B5EF4-FFF2-40B4-BE49-F238E27FC236}">
-                <a16:creationId xmlns:a16="http://schemas.microsoft.com/office/drawing/2014/main" id="{9E3609B4-883B-4CF4-99B5-48DD70F5DB94}"/>
+                <a16:creationId xmlns:a16="http://schemas.microsoft.com/office/drawing/2014/main" id="{0C5E75A8-E816-4A72-BCA1-D6B16F6A609C}"/>
               </a:ext>
             </a:extLst>
           </p:cNvPr>
@@ -6247,7 +6247,7 @@
           <p:cNvPr id="9" name="">
             <a:extLst xmlns:a="http://schemas.openxmlformats.org/drawingml/2006/main">
               <a:ext uri="{FF2B5EF4-FFF2-40B4-BE49-F238E27FC236}">
-                <a16:creationId xmlns:a16="http://schemas.microsoft.com/office/drawing/2014/main" id="{A842D84A-7F76-4007-841A-7806ED340234}"/>
+                <a16:creationId xmlns:a16="http://schemas.microsoft.com/office/drawing/2014/main" id="{743200DA-DC43-4B91-8CAD-F546116893C7}"/>
               </a:ext>
             </a:extLst>
           </p:cNvPr>
@@ -6405,7 +6405,7 @@
           <p:cNvPr id="10" name="">
             <a:extLst xmlns:a="http://schemas.openxmlformats.org/drawingml/2006/main">
               <a:ext uri="{FF2B5EF4-FFF2-40B4-BE49-F238E27FC236}">
-                <a16:creationId xmlns:a16="http://schemas.microsoft.com/office/drawing/2014/main" id="{8B6FC505-313C-4065-A185-F7A2488E9DFA}"/>
+                <a16:creationId xmlns:a16="http://schemas.microsoft.com/office/drawing/2014/main" id="{9C9EFCF3-9DFD-4AB4-A84D-FEFAAC268004}"/>
               </a:ext>
             </a:extLst>
           </p:cNvPr>
@@ -6553,7 +6553,7 @@
                 <a:ea typeface="Arial"/>
                 <a:cs typeface="Arial"/>
               </a:rPr>
-              <a:t>CRM fora do ar: retentativa limitada com jitter e 503 sem efeito</a:t>
+              <a:t>Mesmo customerId do CRM: sem recadastro nem cliente duplicado</a:t>
             </a:r>
           </a:p>
         </p:txBody>
@@ -6563,7 +6563,7 @@
           <p:cNvPr id="11" name="">
             <a:extLst xmlns:a="http://schemas.openxmlformats.org/drawingml/2006/main">
               <a:ext uri="{FF2B5EF4-FFF2-40B4-BE49-F238E27FC236}">
-                <a16:creationId xmlns:a16="http://schemas.microsoft.com/office/drawing/2014/main" id="{06026431-62B0-42FC-B140-596D9F755245}"/>
+                <a16:creationId xmlns:a16="http://schemas.microsoft.com/office/drawing/2014/main" id="{D1018EF9-28BC-4D74-898E-271635F6DD78}"/>
               </a:ext>
             </a:extLst>
           </p:cNvPr>
@@ -6719,7 +6719,7 @@
     </p:spTree>
     <p:extLst>
       <p:ext uri="{BB962C8B-B14F-4D97-AF65-F5344CB8AC3E}">
-        <p14:creationId xmlns:p14="http://schemas.microsoft.com/office/powerpoint/2010/main" val="2015259319"/>
+        <p14:creationId xmlns:p14="http://schemas.microsoft.com/office/powerpoint/2010/main" val="385466547"/>
       </p:ext>
     </p:extLst>
   </p:cSld>
@@ -6750,7 +6750,7 @@
           <p:cNvPr id="10" name="">
             <a:extLst xmlns:a="http://schemas.openxmlformats.org/drawingml/2006/main">
               <a:ext uri="{FF2B5EF4-FFF2-40B4-BE49-F238E27FC236}">
-                <a16:creationId xmlns:a16="http://schemas.microsoft.com/office/drawing/2014/main" id="{0354A235-5341-416E-89EB-93072DC01E8A}"/>
+                <a16:creationId xmlns:a16="http://schemas.microsoft.com/office/drawing/2014/main" id="{79241A81-2C5C-49FC-9BC7-9C2D0989CFE5}"/>
               </a:ext>
             </a:extLst>
           </p:cNvPr>
@@ -6784,7 +6784,7 @@
           <p:cNvPr id="9" name="">
             <a:extLst xmlns:a="http://schemas.openxmlformats.org/drawingml/2006/main">
               <a:ext uri="{FF2B5EF4-FFF2-40B4-BE49-F238E27FC236}">
-                <a16:creationId xmlns:a16="http://schemas.microsoft.com/office/drawing/2014/main" id="{29EAEAEE-97EA-448F-970F-F071032CDF4C}"/>
+                <a16:creationId xmlns:a16="http://schemas.microsoft.com/office/drawing/2014/main" id="{F06F680C-39A4-476F-88C0-4523B5E42A36}"/>
               </a:ext>
             </a:extLst>
           </p:cNvPr>
@@ -6818,7 +6818,7 @@
           <p:cNvPr id="8" name="">
             <a:extLst xmlns:a="http://schemas.openxmlformats.org/drawingml/2006/main">
               <a:ext uri="{FF2B5EF4-FFF2-40B4-BE49-F238E27FC236}">
-                <a16:creationId xmlns:a16="http://schemas.microsoft.com/office/drawing/2014/main" id="{EF690F9E-F5CA-4A2D-A3C3-2BAC11159329}"/>
+                <a16:creationId xmlns:a16="http://schemas.microsoft.com/office/drawing/2014/main" id="{D27BED96-967D-4200-8B22-DA4BF2556DAC}"/>
               </a:ext>
             </a:extLst>
           </p:cNvPr>
@@ -6850,7 +6850,7 @@
           <p:cNvPr id="13" name="">
             <a:extLst xmlns:a="http://schemas.openxmlformats.org/drawingml/2006/main">
               <a:ext uri="{FF2B5EF4-FFF2-40B4-BE49-F238E27FC236}">
-                <a16:creationId xmlns:a16="http://schemas.microsoft.com/office/drawing/2014/main" id="{4EECBECE-EB96-4143-8E37-B0F3869362EF}"/>
+                <a16:creationId xmlns:a16="http://schemas.microsoft.com/office/drawing/2014/main" id="{1A650957-D0ED-4A2B-AD72-9CCF7E87A4F2}"/>
               </a:ext>
             </a:extLst>
           </p:cNvPr>
@@ -6880,7 +6880,7 @@
           <p:cNvPr id="2" name="">
             <a:extLst xmlns:a="http://schemas.openxmlformats.org/drawingml/2006/main">
               <a:ext uri="{FF2B5EF4-FFF2-40B4-BE49-F238E27FC236}">
-                <a16:creationId xmlns:a16="http://schemas.microsoft.com/office/drawing/2014/main" id="{A7D3A45E-F6AD-4F59-96C1-32B7AC0AFED8}"/>
+                <a16:creationId xmlns:a16="http://schemas.microsoft.com/office/drawing/2014/main" id="{4AF45A0D-BFAB-4A44-B334-1824C84F0DC7}"/>
               </a:ext>
             </a:extLst>
           </p:cNvPr>
@@ -7038,7 +7038,7 @@
           <p:cNvPr id="3" name="">
             <a:extLst xmlns:a="http://schemas.openxmlformats.org/drawingml/2006/main">
               <a:ext uri="{FF2B5EF4-FFF2-40B4-BE49-F238E27FC236}">
-                <a16:creationId xmlns:a16="http://schemas.microsoft.com/office/drawing/2014/main" id="{A291D903-8249-4DFB-8F22-5786C088183A}"/>
+                <a16:creationId xmlns:a16="http://schemas.microsoft.com/office/drawing/2014/main" id="{B60D7A27-EE91-402A-A35A-579258D2CF06}"/>
               </a:ext>
             </a:extLst>
           </p:cNvPr>
@@ -7196,7 +7196,7 @@
           <p:cNvPr id="4" name="">
             <a:extLst xmlns:a="http://schemas.openxmlformats.org/drawingml/2006/main">
               <a:ext uri="{FF2B5EF4-FFF2-40B4-BE49-F238E27FC236}">
-                <a16:creationId xmlns:a16="http://schemas.microsoft.com/office/drawing/2014/main" id="{6B253BC4-CE36-4A66-87E9-272D0A7D1DDF}"/>
+                <a16:creationId xmlns:a16="http://schemas.microsoft.com/office/drawing/2014/main" id="{59852B5F-496B-4861-BECB-6523FC2C4B28}"/>
               </a:ext>
             </a:extLst>
           </p:cNvPr>
@@ -7384,7 +7384,7 @@
           <p:cNvPr id="5" name="">
             <a:extLst xmlns:a="http://schemas.openxmlformats.org/drawingml/2006/main">
               <a:ext uri="{FF2B5EF4-FFF2-40B4-BE49-F238E27FC236}">
-                <a16:creationId xmlns:a16="http://schemas.microsoft.com/office/drawing/2014/main" id="{F9130336-CB93-4DDB-BFE0-8577D810C70E}"/>
+                <a16:creationId xmlns:a16="http://schemas.microsoft.com/office/drawing/2014/main" id="{C9E4FD4C-5A6C-4FBA-8AAA-D9D1DD713A20}"/>
               </a:ext>
             </a:extLst>
           </p:cNvPr>
@@ -7572,7 +7572,7 @@
           <p:cNvPr id="6" name="">
             <a:extLst xmlns:a="http://schemas.openxmlformats.org/drawingml/2006/main">
               <a:ext uri="{FF2B5EF4-FFF2-40B4-BE49-F238E27FC236}">
-                <a16:creationId xmlns:a16="http://schemas.microsoft.com/office/drawing/2014/main" id="{B2099862-92D3-4D23-B9E4-C5E5962F2994}"/>
+                <a16:creationId xmlns:a16="http://schemas.microsoft.com/office/drawing/2014/main" id="{64B31098-F907-49EF-B5D5-475B3F766195}"/>
               </a:ext>
             </a:extLst>
           </p:cNvPr>
@@ -7760,7 +7760,7 @@
           <p:cNvPr id="7" name="">
             <a:extLst xmlns:a="http://schemas.openxmlformats.org/drawingml/2006/main">
               <a:ext uri="{FF2B5EF4-FFF2-40B4-BE49-F238E27FC236}">
-                <a16:creationId xmlns:a16="http://schemas.microsoft.com/office/drawing/2014/main" id="{34137EC9-5A69-40A6-B8BC-5DFF3B1D9346}"/>
+                <a16:creationId xmlns:a16="http://schemas.microsoft.com/office/drawing/2014/main" id="{8CED0775-9169-4D1D-938A-5BCF128B9375}"/>
               </a:ext>
             </a:extLst>
           </p:cNvPr>
@@ -7948,7 +7948,7 @@
           <p:cNvPr id="11" name="">
             <a:extLst xmlns:a="http://schemas.openxmlformats.org/drawingml/2006/main">
               <a:ext uri="{FF2B5EF4-FFF2-40B4-BE49-F238E27FC236}">
-                <a16:creationId xmlns:a16="http://schemas.microsoft.com/office/drawing/2014/main" id="{7D0E2AA3-4CA6-4FAA-8CEA-08532C059A9B}"/>
+                <a16:creationId xmlns:a16="http://schemas.microsoft.com/office/drawing/2014/main" id="{E81BDD74-0C33-472B-A749-1F9F45946114}"/>
               </a:ext>
             </a:extLst>
           </p:cNvPr>
@@ -8106,7 +8106,7 @@
           <p:cNvPr id="12" name="">
             <a:extLst xmlns:a="http://schemas.openxmlformats.org/drawingml/2006/main">
               <a:ext uri="{FF2B5EF4-FFF2-40B4-BE49-F238E27FC236}">
-                <a16:creationId xmlns:a16="http://schemas.microsoft.com/office/drawing/2014/main" id="{68912780-4105-409A-ABA4-18F02EE63187}"/>
+                <a16:creationId xmlns:a16="http://schemas.microsoft.com/office/drawing/2014/main" id="{CAE148F5-C312-479E-BB14-B58DB1FFA0F1}"/>
               </a:ext>
             </a:extLst>
           </p:cNvPr>
@@ -8262,7 +8262,7 @@
     </p:spTree>
     <p:extLst>
       <p:ext uri="{BB962C8B-B14F-4D97-AF65-F5344CB8AC3E}">
-        <p14:creationId xmlns:p14="http://schemas.microsoft.com/office/powerpoint/2010/main" val="667982043"/>
+        <p14:creationId xmlns:p14="http://schemas.microsoft.com/office/powerpoint/2010/main" val="442045535"/>
       </p:ext>
     </p:extLst>
   </p:cSld>
@@ -8293,7 +8293,7 @@
           <p:cNvPr id="10" name="">
             <a:extLst xmlns:a="http://schemas.openxmlformats.org/drawingml/2006/main">
               <a:ext uri="{FF2B5EF4-FFF2-40B4-BE49-F238E27FC236}">
-                <a16:creationId xmlns:a16="http://schemas.microsoft.com/office/drawing/2014/main" id="{F3328531-5D41-406A-B694-5CC36FAAAF15}"/>
+                <a16:creationId xmlns:a16="http://schemas.microsoft.com/office/drawing/2014/main" id="{82EC16F6-ECEC-4DB5-879D-A5E6ABD2B094}"/>
               </a:ext>
             </a:extLst>
           </p:cNvPr>
@@ -8325,7 +8325,7 @@
           <p:cNvPr id="9" name="">
             <a:extLst xmlns:a="http://schemas.openxmlformats.org/drawingml/2006/main">
               <a:ext uri="{FF2B5EF4-FFF2-40B4-BE49-F238E27FC236}">
-                <a16:creationId xmlns:a16="http://schemas.microsoft.com/office/drawing/2014/main" id="{4E51A862-6184-4970-9EA2-6568322143CE}"/>
+                <a16:creationId xmlns:a16="http://schemas.microsoft.com/office/drawing/2014/main" id="{AF28BBE1-FDA0-47F0-B520-2A08C56EAB8F}"/>
               </a:ext>
             </a:extLst>
           </p:cNvPr>
@@ -8357,7 +8357,7 @@
           <p:cNvPr id="8" name="">
             <a:extLst xmlns:a="http://schemas.openxmlformats.org/drawingml/2006/main">
               <a:ext uri="{FF2B5EF4-FFF2-40B4-BE49-F238E27FC236}">
-                <a16:creationId xmlns:a16="http://schemas.microsoft.com/office/drawing/2014/main" id="{7B3E442D-D6D2-439C-8B50-81388F209CD0}"/>
+                <a16:creationId xmlns:a16="http://schemas.microsoft.com/office/drawing/2014/main" id="{AB70ED59-A022-4F10-8F1B-F163626D1A7E}"/>
               </a:ext>
             </a:extLst>
           </p:cNvPr>
@@ -8391,7 +8391,7 @@
           <p:cNvPr id="13" name="">
             <a:extLst xmlns:a="http://schemas.openxmlformats.org/drawingml/2006/main">
               <a:ext uri="{FF2B5EF4-FFF2-40B4-BE49-F238E27FC236}">
-                <a16:creationId xmlns:a16="http://schemas.microsoft.com/office/drawing/2014/main" id="{1C2C04D5-20BC-4BF7-8E77-877F95C16317}"/>
+                <a16:creationId xmlns:a16="http://schemas.microsoft.com/office/drawing/2014/main" id="{0FFC7E14-F8CE-4078-8585-75B460A7F437}"/>
               </a:ext>
             </a:extLst>
           </p:cNvPr>
@@ -8421,7 +8421,7 @@
           <p:cNvPr id="2" name="">
             <a:extLst xmlns:a="http://schemas.openxmlformats.org/drawingml/2006/main">
               <a:ext uri="{FF2B5EF4-FFF2-40B4-BE49-F238E27FC236}">
-                <a16:creationId xmlns:a16="http://schemas.microsoft.com/office/drawing/2014/main" id="{32649F3A-C7DB-4874-88D9-7EA19CD40482}"/>
+                <a16:creationId xmlns:a16="http://schemas.microsoft.com/office/drawing/2014/main" id="{7DAED385-A036-4725-8172-7D9E4D60B679}"/>
               </a:ext>
             </a:extLst>
           </p:cNvPr>
@@ -8579,7 +8579,7 @@
           <p:cNvPr id="3" name="">
             <a:extLst xmlns:a="http://schemas.openxmlformats.org/drawingml/2006/main">
               <a:ext uri="{FF2B5EF4-FFF2-40B4-BE49-F238E27FC236}">
-                <a16:creationId xmlns:a16="http://schemas.microsoft.com/office/drawing/2014/main" id="{222D795F-0C1F-4C63-B545-14E6E2FF5A85}"/>
+                <a16:creationId xmlns:a16="http://schemas.microsoft.com/office/drawing/2014/main" id="{563EBFE3-C387-453C-BF83-B2EC4E8350EB}"/>
               </a:ext>
             </a:extLst>
           </p:cNvPr>
@@ -8737,7 +8737,7 @@
           <p:cNvPr id="4" name="">
             <a:extLst xmlns:a="http://schemas.openxmlformats.org/drawingml/2006/main">
               <a:ext uri="{FF2B5EF4-FFF2-40B4-BE49-F238E27FC236}">
-                <a16:creationId xmlns:a16="http://schemas.microsoft.com/office/drawing/2014/main" id="{65AA1E53-0B2E-4F02-B7F5-B263D69D4770}"/>
+                <a16:creationId xmlns:a16="http://schemas.microsoft.com/office/drawing/2014/main" id="{5D62B7B8-491F-494A-8E67-111CC883BD1B}"/>
               </a:ext>
             </a:extLst>
           </p:cNvPr>
@@ -8925,7 +8925,7 @@
           <p:cNvPr id="5" name="">
             <a:extLst xmlns:a="http://schemas.openxmlformats.org/drawingml/2006/main">
               <a:ext uri="{FF2B5EF4-FFF2-40B4-BE49-F238E27FC236}">
-                <a16:creationId xmlns:a16="http://schemas.microsoft.com/office/drawing/2014/main" id="{1C404933-79D3-4193-AF8C-9600120325AE}"/>
+                <a16:creationId xmlns:a16="http://schemas.microsoft.com/office/drawing/2014/main" id="{B6E13F66-9032-4033-AA93-7DC571172F38}"/>
               </a:ext>
             </a:extLst>
           </p:cNvPr>
@@ -9113,7 +9113,7 @@
           <p:cNvPr id="6" name="">
             <a:extLst xmlns:a="http://schemas.openxmlformats.org/drawingml/2006/main">
               <a:ext uri="{FF2B5EF4-FFF2-40B4-BE49-F238E27FC236}">
-                <a16:creationId xmlns:a16="http://schemas.microsoft.com/office/drawing/2014/main" id="{1301C448-E507-4350-833B-15C5D6FCCE3D}"/>
+                <a16:creationId xmlns:a16="http://schemas.microsoft.com/office/drawing/2014/main" id="{6CE10870-9214-4596-B96E-BF453123B09C}"/>
               </a:ext>
             </a:extLst>
           </p:cNvPr>
@@ -9301,7 +9301,7 @@
           <p:cNvPr id="7" name="">
             <a:extLst xmlns:a="http://schemas.openxmlformats.org/drawingml/2006/main">
               <a:ext uri="{FF2B5EF4-FFF2-40B4-BE49-F238E27FC236}">
-                <a16:creationId xmlns:a16="http://schemas.microsoft.com/office/drawing/2014/main" id="{1351637C-E787-4996-A7AB-93CBA43AB94A}"/>
+                <a16:creationId xmlns:a16="http://schemas.microsoft.com/office/drawing/2014/main" id="{701CA121-D621-464F-B394-01197AB166BA}"/>
               </a:ext>
             </a:extLst>
           </p:cNvPr>
@@ -9489,7 +9489,7 @@
           <p:cNvPr id="11" name="">
             <a:extLst xmlns:a="http://schemas.openxmlformats.org/drawingml/2006/main">
               <a:ext uri="{FF2B5EF4-FFF2-40B4-BE49-F238E27FC236}">
-                <a16:creationId xmlns:a16="http://schemas.microsoft.com/office/drawing/2014/main" id="{C236A9A8-D16B-46FA-A17D-A19BE11C64EE}"/>
+                <a16:creationId xmlns:a16="http://schemas.microsoft.com/office/drawing/2014/main" id="{45863AB0-86B3-407B-920F-EAA7B1821E7B}"/>
               </a:ext>
             </a:extLst>
           </p:cNvPr>
@@ -9647,7 +9647,7 @@
           <p:cNvPr id="12" name="">
             <a:extLst xmlns:a="http://schemas.openxmlformats.org/drawingml/2006/main">
               <a:ext uri="{FF2B5EF4-FFF2-40B4-BE49-F238E27FC236}">
-                <a16:creationId xmlns:a16="http://schemas.microsoft.com/office/drawing/2014/main" id="{A4611D56-F9DC-4936-A7AE-171772F30965}"/>
+                <a16:creationId xmlns:a16="http://schemas.microsoft.com/office/drawing/2014/main" id="{74D0FF28-D216-4A5B-B4BC-86F3A53E3F20}"/>
               </a:ext>
             </a:extLst>
           </p:cNvPr>
@@ -9803,7 +9803,7 @@
     </p:spTree>
     <p:extLst>
       <p:ext uri="{BB962C8B-B14F-4D97-AF65-F5344CB8AC3E}">
-        <p14:creationId xmlns:p14="http://schemas.microsoft.com/office/powerpoint/2010/main" val="1630788221"/>
+        <p14:creationId xmlns:p14="http://schemas.microsoft.com/office/powerpoint/2010/main" val="2013859304"/>
       </p:ext>
     </p:extLst>
   </p:cSld>
@@ -9834,7 +9834,7 @@
           <p:cNvPr id="7" name="">
             <a:extLst xmlns:a="http://schemas.openxmlformats.org/drawingml/2006/main">
               <a:ext uri="{FF2B5EF4-FFF2-40B4-BE49-F238E27FC236}">
-                <a16:creationId xmlns:a16="http://schemas.microsoft.com/office/drawing/2014/main" id="{C6110F86-7665-4445-A40F-487A785B04C5}"/>
+                <a16:creationId xmlns:a16="http://schemas.microsoft.com/office/drawing/2014/main" id="{EEF5E18F-3E8D-4FF9-93AA-FE4D8FF77C06}"/>
               </a:ext>
             </a:extLst>
           </p:cNvPr>
@@ -9864,7 +9864,7 @@
           <p:cNvPr id="2" name="">
             <a:extLst xmlns:a="http://schemas.openxmlformats.org/drawingml/2006/main">
               <a:ext uri="{FF2B5EF4-FFF2-40B4-BE49-F238E27FC236}">
-                <a16:creationId xmlns:a16="http://schemas.microsoft.com/office/drawing/2014/main" id="{8BDC85AA-98B4-459B-8726-6FCF135BED19}"/>
+                <a16:creationId xmlns:a16="http://schemas.microsoft.com/office/drawing/2014/main" id="{F94EF26A-776F-4FBF-B752-27FD4B7EBE73}"/>
               </a:ext>
             </a:extLst>
           </p:cNvPr>
@@ -10022,7 +10022,7 @@
           <p:cNvPr id="3" name="">
             <a:extLst xmlns:a="http://schemas.openxmlformats.org/drawingml/2006/main">
               <a:ext uri="{FF2B5EF4-FFF2-40B4-BE49-F238E27FC236}">
-                <a16:creationId xmlns:a16="http://schemas.microsoft.com/office/drawing/2014/main" id="{721B79B4-B5D7-496F-BAFB-94D4658DBB40}"/>
+                <a16:creationId xmlns:a16="http://schemas.microsoft.com/office/drawing/2014/main" id="{E607E770-344E-4D3E-ABCF-E64214B826AB}"/>
               </a:ext>
             </a:extLst>
           </p:cNvPr>
@@ -10180,7 +10180,7 @@
           <p:cNvPr id="4" name="">
             <a:extLst xmlns:a="http://schemas.openxmlformats.org/drawingml/2006/main">
               <a:ext uri="{FF2B5EF4-FFF2-40B4-BE49-F238E27FC236}">
-                <a16:creationId xmlns:a16="http://schemas.microsoft.com/office/drawing/2014/main" id="{FB496CA7-44AD-4957-8549-CA8E8205C22A}"/>
+                <a16:creationId xmlns:a16="http://schemas.microsoft.com/office/drawing/2014/main" id="{4F989A18-3976-423E-928D-82E0C4C984E9}"/>
               </a:ext>
             </a:extLst>
           </p:cNvPr>
@@ -10450,7 +10450,7 @@
           <p:cNvPr id="5" name="">
             <a:extLst xmlns:a="http://schemas.openxmlformats.org/drawingml/2006/main">
               <a:ext uri="{FF2B5EF4-FFF2-40B4-BE49-F238E27FC236}">
-                <a16:creationId xmlns:a16="http://schemas.microsoft.com/office/drawing/2014/main" id="{4BF48A46-8CDC-43D9-8ECD-613E785BEFB5}"/>
+                <a16:creationId xmlns:a16="http://schemas.microsoft.com/office/drawing/2014/main" id="{49FDB843-3361-4511-AD3A-68067A28A6F4}"/>
               </a:ext>
             </a:extLst>
           </p:cNvPr>
@@ -10776,7 +10776,7 @@
           <p:cNvPr id="6" name="">
             <a:extLst xmlns:a="http://schemas.openxmlformats.org/drawingml/2006/main">
               <a:ext uri="{FF2B5EF4-FFF2-40B4-BE49-F238E27FC236}">
-                <a16:creationId xmlns:a16="http://schemas.microsoft.com/office/drawing/2014/main" id="{11DF69DD-5D06-4286-9756-DF220A1EB281}"/>
+                <a16:creationId xmlns:a16="http://schemas.microsoft.com/office/drawing/2014/main" id="{91AEE42F-C393-4D4D-BCA9-E6840C6E3812}"/>
               </a:ext>
             </a:extLst>
           </p:cNvPr>
@@ -10932,7 +10932,7 @@
     </p:spTree>
     <p:extLst>
       <p:ext uri="{BB962C8B-B14F-4D97-AF65-F5344CB8AC3E}">
-        <p14:creationId xmlns:p14="http://schemas.microsoft.com/office/powerpoint/2010/main" val="413238972"/>
+        <p14:creationId xmlns:p14="http://schemas.microsoft.com/office/powerpoint/2010/main" val="1258112592"/>
       </p:ext>
     </p:extLst>
   </p:cSld>
@@ -10963,7 +10963,7 @@
           <p:cNvPr id="28" name="">
             <a:extLst xmlns:a="http://schemas.openxmlformats.org/drawingml/2006/main">
               <a:ext uri="{FF2B5EF4-FFF2-40B4-BE49-F238E27FC236}">
-                <a16:creationId xmlns:a16="http://schemas.microsoft.com/office/drawing/2014/main" id="{B5B6C7BB-A6E3-477B-A13F-73F932992821}"/>
+                <a16:creationId xmlns:a16="http://schemas.microsoft.com/office/drawing/2014/main" id="{38BA6166-733A-4E76-9B01-2E3BEDBD7A4B}"/>
               </a:ext>
             </a:extLst>
           </p:cNvPr>
@@ -10993,7 +10993,7 @@
           <p:cNvPr id="2" name="">
             <a:extLst xmlns:a="http://schemas.openxmlformats.org/drawingml/2006/main">
               <a:ext uri="{FF2B5EF4-FFF2-40B4-BE49-F238E27FC236}">
-                <a16:creationId xmlns:a16="http://schemas.microsoft.com/office/drawing/2014/main" id="{F81A125C-C5E9-4408-96C6-7E3212BCE66A}"/>
+                <a16:creationId xmlns:a16="http://schemas.microsoft.com/office/drawing/2014/main" id="{9D981C02-4421-4661-BC02-CB4D4EAE8A62}"/>
               </a:ext>
             </a:extLst>
           </p:cNvPr>
@@ -11151,7 +11151,7 @@
           <p:cNvPr id="3" name="">
             <a:extLst xmlns:a="http://schemas.openxmlformats.org/drawingml/2006/main">
               <a:ext uri="{FF2B5EF4-FFF2-40B4-BE49-F238E27FC236}">
-                <a16:creationId xmlns:a16="http://schemas.microsoft.com/office/drawing/2014/main" id="{87D369F5-1E96-4A74-B47C-232A82FDAB75}"/>
+                <a16:creationId xmlns:a16="http://schemas.microsoft.com/office/drawing/2014/main" id="{FB813F3B-CF1E-47EE-A005-C584EC8BA634}"/>
               </a:ext>
             </a:extLst>
           </p:cNvPr>
@@ -11309,7 +11309,7 @@
           <p:cNvPr id="4" name="">
             <a:extLst xmlns:a="http://schemas.openxmlformats.org/drawingml/2006/main">
               <a:ext uri="{FF2B5EF4-FFF2-40B4-BE49-F238E27FC236}">
-                <a16:creationId xmlns:a16="http://schemas.microsoft.com/office/drawing/2014/main" id="{16D059CF-3824-4765-892A-82917A6F1C80}"/>
+                <a16:creationId xmlns:a16="http://schemas.microsoft.com/office/drawing/2014/main" id="{CF51B274-9419-4FA9-945A-3014632098DF}"/>
               </a:ext>
             </a:extLst>
           </p:cNvPr>
@@ -11467,7 +11467,7 @@
           <p:cNvPr id="5" name="">
             <a:extLst xmlns:a="http://schemas.openxmlformats.org/drawingml/2006/main">
               <a:ext uri="{FF2B5EF4-FFF2-40B4-BE49-F238E27FC236}">
-                <a16:creationId xmlns:a16="http://schemas.microsoft.com/office/drawing/2014/main" id="{C7465027-C3D5-4A04-9154-C5E80571AF7E}"/>
+                <a16:creationId xmlns:a16="http://schemas.microsoft.com/office/drawing/2014/main" id="{0085FD0F-641A-4EC1-8975-63D1458268C0}"/>
               </a:ext>
             </a:extLst>
           </p:cNvPr>
@@ -11625,7 +11625,7 @@
           <p:cNvPr id="6" name="">
             <a:extLst xmlns:a="http://schemas.openxmlformats.org/drawingml/2006/main">
               <a:ext uri="{FF2B5EF4-FFF2-40B4-BE49-F238E27FC236}">
-                <a16:creationId xmlns:a16="http://schemas.microsoft.com/office/drawing/2014/main" id="{7FF056F4-906D-4677-BA79-159E34CDFED6}"/>
+                <a16:creationId xmlns:a16="http://schemas.microsoft.com/office/drawing/2014/main" id="{D38F5BBC-5F5E-4D3A-B776-ABB082F105DC}"/>
               </a:ext>
             </a:extLst>
           </p:cNvPr>
@@ -11783,7 +11783,7 @@
           <p:cNvPr id="7" name="">
             <a:extLst xmlns:a="http://schemas.openxmlformats.org/drawingml/2006/main">
               <a:ext uri="{FF2B5EF4-FFF2-40B4-BE49-F238E27FC236}">
-                <a16:creationId xmlns:a16="http://schemas.microsoft.com/office/drawing/2014/main" id="{CAFF39EF-8F15-4A7B-B632-56EA607AF605}"/>
+                <a16:creationId xmlns:a16="http://schemas.microsoft.com/office/drawing/2014/main" id="{295752AD-7BA4-48C1-BB28-963648719CEB}"/>
               </a:ext>
             </a:extLst>
           </p:cNvPr>
@@ -11941,7 +11941,7 @@
           <p:cNvPr id="8" name="">
             <a:extLst xmlns:a="http://schemas.openxmlformats.org/drawingml/2006/main">
               <a:ext uri="{FF2B5EF4-FFF2-40B4-BE49-F238E27FC236}">
-                <a16:creationId xmlns:a16="http://schemas.microsoft.com/office/drawing/2014/main" id="{5241EAD3-EBA5-4A16-BA00-49972D5C9043}"/>
+                <a16:creationId xmlns:a16="http://schemas.microsoft.com/office/drawing/2014/main" id="{7EBE1ABE-2980-4244-9D10-5651F750CACC}"/>
               </a:ext>
             </a:extLst>
           </p:cNvPr>
@@ -12099,7 +12099,7 @@
           <p:cNvPr id="9" name="">
             <a:extLst xmlns:a="http://schemas.openxmlformats.org/drawingml/2006/main">
               <a:ext uri="{FF2B5EF4-FFF2-40B4-BE49-F238E27FC236}">
-                <a16:creationId xmlns:a16="http://schemas.microsoft.com/office/drawing/2014/main" id="{0B902029-035B-41D3-9CCD-1FCD23985E8F}"/>
+                <a16:creationId xmlns:a16="http://schemas.microsoft.com/office/drawing/2014/main" id="{1E13F9B4-F81A-42E3-B008-4C5E01FF3C70}"/>
               </a:ext>
             </a:extLst>
           </p:cNvPr>
@@ -12257,7 +12257,7 @@
           <p:cNvPr id="10" name="">
             <a:extLst xmlns:a="http://schemas.openxmlformats.org/drawingml/2006/main">
               <a:ext uri="{FF2B5EF4-FFF2-40B4-BE49-F238E27FC236}">
-                <a16:creationId xmlns:a16="http://schemas.microsoft.com/office/drawing/2014/main" id="{2DACBABC-008D-41A8-846D-C585EAAA1357}"/>
+                <a16:creationId xmlns:a16="http://schemas.microsoft.com/office/drawing/2014/main" id="{85876333-6284-4C7A-BC6E-5892DD5B0337}"/>
               </a:ext>
             </a:extLst>
           </p:cNvPr>
@@ -12415,7 +12415,7 @@
           <p:cNvPr id="11" name="">
             <a:extLst xmlns:a="http://schemas.openxmlformats.org/drawingml/2006/main">
               <a:ext uri="{FF2B5EF4-FFF2-40B4-BE49-F238E27FC236}">
-                <a16:creationId xmlns:a16="http://schemas.microsoft.com/office/drawing/2014/main" id="{81034C17-7380-4FE7-BDED-2600F8147454}"/>
+                <a16:creationId xmlns:a16="http://schemas.microsoft.com/office/drawing/2014/main" id="{28416515-7B42-4B6B-B287-BEF0505C2F88}"/>
               </a:ext>
             </a:extLst>
           </p:cNvPr>
@@ -12573,7 +12573,7 @@
           <p:cNvPr id="12" name="">
             <a:extLst xmlns:a="http://schemas.openxmlformats.org/drawingml/2006/main">
               <a:ext uri="{FF2B5EF4-FFF2-40B4-BE49-F238E27FC236}">
-                <a16:creationId xmlns:a16="http://schemas.microsoft.com/office/drawing/2014/main" id="{DAF2CD92-905A-45A9-B838-ED04C4C3E497}"/>
+                <a16:creationId xmlns:a16="http://schemas.microsoft.com/office/drawing/2014/main" id="{9D7F37F3-E4B7-4541-A37B-CB02B75DE72E}"/>
               </a:ext>
             </a:extLst>
           </p:cNvPr>
@@ -12731,7 +12731,7 @@
           <p:cNvPr id="13" name="">
             <a:extLst xmlns:a="http://schemas.openxmlformats.org/drawingml/2006/main">
               <a:ext uri="{FF2B5EF4-FFF2-40B4-BE49-F238E27FC236}">
-                <a16:creationId xmlns:a16="http://schemas.microsoft.com/office/drawing/2014/main" id="{2EF24851-6272-409E-AEB8-5F34AC8CF7BD}"/>
+                <a16:creationId xmlns:a16="http://schemas.microsoft.com/office/drawing/2014/main" id="{284017B6-D999-45A6-8A44-831BD34AC8C4}"/>
               </a:ext>
             </a:extLst>
           </p:cNvPr>
@@ -12889,7 +12889,7 @@
           <p:cNvPr id="14" name="">
             <a:extLst xmlns:a="http://schemas.openxmlformats.org/drawingml/2006/main">
               <a:ext uri="{FF2B5EF4-FFF2-40B4-BE49-F238E27FC236}">
-                <a16:creationId xmlns:a16="http://schemas.microsoft.com/office/drawing/2014/main" id="{EF12734C-5A80-4142-8E7F-462A83986026}"/>
+                <a16:creationId xmlns:a16="http://schemas.microsoft.com/office/drawing/2014/main" id="{D750F052-C8F5-4603-A2ED-1BB562BCA75C}"/>
               </a:ext>
             </a:extLst>
           </p:cNvPr>
@@ -13047,7 +13047,7 @@
           <p:cNvPr id="15" name="">
             <a:extLst xmlns:a="http://schemas.openxmlformats.org/drawingml/2006/main">
               <a:ext uri="{FF2B5EF4-FFF2-40B4-BE49-F238E27FC236}">
-                <a16:creationId xmlns:a16="http://schemas.microsoft.com/office/drawing/2014/main" id="{F559049E-16D3-4704-B802-ACE317253D38}"/>
+                <a16:creationId xmlns:a16="http://schemas.microsoft.com/office/drawing/2014/main" id="{9EA854C9-8A5B-41A9-A76A-C85F661A0B25}"/>
               </a:ext>
             </a:extLst>
           </p:cNvPr>
@@ -13205,7 +13205,7 @@
           <p:cNvPr id="16" name="">
             <a:extLst xmlns:a="http://schemas.openxmlformats.org/drawingml/2006/main">
               <a:ext uri="{FF2B5EF4-FFF2-40B4-BE49-F238E27FC236}">
-                <a16:creationId xmlns:a16="http://schemas.microsoft.com/office/drawing/2014/main" id="{FB2A4CF6-8452-4C84-BB33-A97B7E645F57}"/>
+                <a16:creationId xmlns:a16="http://schemas.microsoft.com/office/drawing/2014/main" id="{F033A29C-F8FC-43DE-A0B5-36622AB0FC27}"/>
               </a:ext>
             </a:extLst>
           </p:cNvPr>
@@ -13363,7 +13363,7 @@
           <p:cNvPr id="17" name="">
             <a:extLst xmlns:a="http://schemas.openxmlformats.org/drawingml/2006/main">
               <a:ext uri="{FF2B5EF4-FFF2-40B4-BE49-F238E27FC236}">
-                <a16:creationId xmlns:a16="http://schemas.microsoft.com/office/drawing/2014/main" id="{3559150F-8180-49EB-9D17-B79198A10E2E}"/>
+                <a16:creationId xmlns:a16="http://schemas.microsoft.com/office/drawing/2014/main" id="{A3995667-B4C9-40CA-8343-6250A8C36140}"/>
               </a:ext>
             </a:extLst>
           </p:cNvPr>
@@ -13521,7 +13521,7 @@
           <p:cNvPr id="18" name="">
             <a:extLst xmlns:a="http://schemas.openxmlformats.org/drawingml/2006/main">
               <a:ext uri="{FF2B5EF4-FFF2-40B4-BE49-F238E27FC236}">
-                <a16:creationId xmlns:a16="http://schemas.microsoft.com/office/drawing/2014/main" id="{A4003447-5F99-4F3E-838B-09E74CB8D06C}"/>
+                <a16:creationId xmlns:a16="http://schemas.microsoft.com/office/drawing/2014/main" id="{D0BBE760-98DA-491B-9C27-32B6FFA79802}"/>
               </a:ext>
             </a:extLst>
           </p:cNvPr>
@@ -13679,7 +13679,7 @@
           <p:cNvPr id="19" name="">
             <a:extLst xmlns:a="http://schemas.openxmlformats.org/drawingml/2006/main">
               <a:ext uri="{FF2B5EF4-FFF2-40B4-BE49-F238E27FC236}">
-                <a16:creationId xmlns:a16="http://schemas.microsoft.com/office/drawing/2014/main" id="{90979CC4-C291-49A5-97A6-6C0A83F44701}"/>
+                <a16:creationId xmlns:a16="http://schemas.microsoft.com/office/drawing/2014/main" id="{F310254C-F7DF-40D8-8E1E-4D4D5A8DB11B}"/>
               </a:ext>
             </a:extLst>
           </p:cNvPr>
@@ -13837,7 +13837,7 @@
           <p:cNvPr id="20" name="">
             <a:extLst xmlns:a="http://schemas.openxmlformats.org/drawingml/2006/main">
               <a:ext uri="{FF2B5EF4-FFF2-40B4-BE49-F238E27FC236}">
-                <a16:creationId xmlns:a16="http://schemas.microsoft.com/office/drawing/2014/main" id="{F8D47440-523A-4CD8-8530-86A84CBA1EA2}"/>
+                <a16:creationId xmlns:a16="http://schemas.microsoft.com/office/drawing/2014/main" id="{66286A73-F2CF-4A85-95B2-039FC7A8B20A}"/>
               </a:ext>
             </a:extLst>
           </p:cNvPr>
@@ -13995,7 +13995,7 @@
           <p:cNvPr id="21" name="">
             <a:extLst xmlns:a="http://schemas.openxmlformats.org/drawingml/2006/main">
               <a:ext uri="{FF2B5EF4-FFF2-40B4-BE49-F238E27FC236}">
-                <a16:creationId xmlns:a16="http://schemas.microsoft.com/office/drawing/2014/main" id="{5E1FAF02-9153-419E-9E1B-2DF9DD271226}"/>
+                <a16:creationId xmlns:a16="http://schemas.microsoft.com/office/drawing/2014/main" id="{2AD6A639-11CF-4A39-BA8E-C765BC87D275}"/>
               </a:ext>
             </a:extLst>
           </p:cNvPr>
@@ -14153,7 +14153,7 @@
           <p:cNvPr id="22" name="">
             <a:extLst xmlns:a="http://schemas.openxmlformats.org/drawingml/2006/main">
               <a:ext uri="{FF2B5EF4-FFF2-40B4-BE49-F238E27FC236}">
-                <a16:creationId xmlns:a16="http://schemas.microsoft.com/office/drawing/2014/main" id="{1A525301-B2ED-476F-834B-B6E552988BA4}"/>
+                <a16:creationId xmlns:a16="http://schemas.microsoft.com/office/drawing/2014/main" id="{F73C42A1-805C-46BB-9644-2C89CDB1434F}"/>
               </a:ext>
             </a:extLst>
           </p:cNvPr>
@@ -14311,7 +14311,7 @@
           <p:cNvPr id="23" name="">
             <a:extLst xmlns:a="http://schemas.openxmlformats.org/drawingml/2006/main">
               <a:ext uri="{FF2B5EF4-FFF2-40B4-BE49-F238E27FC236}">
-                <a16:creationId xmlns:a16="http://schemas.microsoft.com/office/drawing/2014/main" id="{6569C80D-2034-4ABB-9E61-DD50443C29A3}"/>
+                <a16:creationId xmlns:a16="http://schemas.microsoft.com/office/drawing/2014/main" id="{A6C0980F-EAA5-4019-8338-244322818B68}"/>
               </a:ext>
             </a:extLst>
           </p:cNvPr>
@@ -14469,7 +14469,7 @@
           <p:cNvPr id="24" name="">
             <a:extLst xmlns:a="http://schemas.openxmlformats.org/drawingml/2006/main">
               <a:ext uri="{FF2B5EF4-FFF2-40B4-BE49-F238E27FC236}">
-                <a16:creationId xmlns:a16="http://schemas.microsoft.com/office/drawing/2014/main" id="{767FE549-4C1D-4F92-AFC1-28511AB3BCAA}"/>
+                <a16:creationId xmlns:a16="http://schemas.microsoft.com/office/drawing/2014/main" id="{4EA2EC36-7AEC-4214-A2ED-1CAACA167C31}"/>
               </a:ext>
             </a:extLst>
           </p:cNvPr>
@@ -14627,7 +14627,7 @@
           <p:cNvPr id="25" name="">
             <a:extLst xmlns:a="http://schemas.openxmlformats.org/drawingml/2006/main">
               <a:ext uri="{FF2B5EF4-FFF2-40B4-BE49-F238E27FC236}">
-                <a16:creationId xmlns:a16="http://schemas.microsoft.com/office/drawing/2014/main" id="{36A067EB-9D8B-4B23-8838-725306A5F7F5}"/>
+                <a16:creationId xmlns:a16="http://schemas.microsoft.com/office/drawing/2014/main" id="{B176AC80-1465-4D90-90BE-2FFE83F0CE9F}"/>
               </a:ext>
             </a:extLst>
           </p:cNvPr>
@@ -14785,7 +14785,7 @@
           <p:cNvPr id="26" name="">
             <a:extLst xmlns:a="http://schemas.openxmlformats.org/drawingml/2006/main">
               <a:ext uri="{FF2B5EF4-FFF2-40B4-BE49-F238E27FC236}">
-                <a16:creationId xmlns:a16="http://schemas.microsoft.com/office/drawing/2014/main" id="{93DABC70-2853-4521-8F68-0CDE2089F70A}"/>
+                <a16:creationId xmlns:a16="http://schemas.microsoft.com/office/drawing/2014/main" id="{70C2DB36-15B0-4C65-99E1-23DCB5CB47B2}"/>
               </a:ext>
             </a:extLst>
           </p:cNvPr>
@@ -14943,7 +14943,7 @@
           <p:cNvPr id="27" name="">
             <a:extLst xmlns:a="http://schemas.openxmlformats.org/drawingml/2006/main">
               <a:ext uri="{FF2B5EF4-FFF2-40B4-BE49-F238E27FC236}">
-                <a16:creationId xmlns:a16="http://schemas.microsoft.com/office/drawing/2014/main" id="{2CC33238-DCA7-4374-B349-D7D535200A03}"/>
+                <a16:creationId xmlns:a16="http://schemas.microsoft.com/office/drawing/2014/main" id="{753C98E0-0A2D-4A2C-AE6D-C6C7D35E63F3}"/>
               </a:ext>
             </a:extLst>
           </p:cNvPr>
@@ -15099,7 +15099,7 @@
     </p:spTree>
     <p:extLst>
       <p:ext uri="{BB962C8B-B14F-4D97-AF65-F5344CB8AC3E}">
-        <p14:creationId xmlns:p14="http://schemas.microsoft.com/office/powerpoint/2010/main" val="405967811"/>
+        <p14:creationId xmlns:p14="http://schemas.microsoft.com/office/powerpoint/2010/main" val="1834164158"/>
       </p:ext>
     </p:extLst>
   </p:cSld>
@@ -15130,7 +15130,7 @@
           <p:cNvPr id="11" name="">
             <a:extLst xmlns:a="http://schemas.openxmlformats.org/drawingml/2006/main">
               <a:ext uri="{FF2B5EF4-FFF2-40B4-BE49-F238E27FC236}">
-                <a16:creationId xmlns:a16="http://schemas.microsoft.com/office/drawing/2014/main" id="{034851BF-B7EE-4CBE-A125-06C1FE6159F8}"/>
+                <a16:creationId xmlns:a16="http://schemas.microsoft.com/office/drawing/2014/main" id="{D9621A97-83B4-4B0D-B326-14EE08186348}"/>
               </a:ext>
             </a:extLst>
           </p:cNvPr>
@@ -15160,7 +15160,7 @@
           <p:cNvPr id="2" name="">
             <a:extLst xmlns:a="http://schemas.openxmlformats.org/drawingml/2006/main">
               <a:ext uri="{FF2B5EF4-FFF2-40B4-BE49-F238E27FC236}">
-                <a16:creationId xmlns:a16="http://schemas.microsoft.com/office/drawing/2014/main" id="{0B5F719E-8EAF-4F90-8ED2-A7A7E599DF68}"/>
+                <a16:creationId xmlns:a16="http://schemas.microsoft.com/office/drawing/2014/main" id="{7337A3F2-DA2C-40B7-BBFB-384C6E4E8703}"/>
               </a:ext>
             </a:extLst>
           </p:cNvPr>
@@ -15318,7 +15318,7 @@
           <p:cNvPr id="3" name="">
             <a:extLst xmlns:a="http://schemas.openxmlformats.org/drawingml/2006/main">
               <a:ext uri="{FF2B5EF4-FFF2-40B4-BE49-F238E27FC236}">
-                <a16:creationId xmlns:a16="http://schemas.microsoft.com/office/drawing/2014/main" id="{D610CB1C-8BD5-41CF-B9AD-D5D8234C625A}"/>
+                <a16:creationId xmlns:a16="http://schemas.microsoft.com/office/drawing/2014/main" id="{B712281B-8691-4656-A9E0-8F08FCB28CFE}"/>
               </a:ext>
             </a:extLst>
           </p:cNvPr>
@@ -15476,7 +15476,7 @@
           <p:cNvPr id="4" name="">
             <a:extLst xmlns:a="http://schemas.openxmlformats.org/drawingml/2006/main">
               <a:ext uri="{FF2B5EF4-FFF2-40B4-BE49-F238E27FC236}">
-                <a16:creationId xmlns:a16="http://schemas.microsoft.com/office/drawing/2014/main" id="{A2289252-9834-448D-BED5-7DC6F003431B}"/>
+                <a16:creationId xmlns:a16="http://schemas.microsoft.com/office/drawing/2014/main" id="{7ED88C3E-888B-41B3-8C1E-F5EEFE29C218}"/>
               </a:ext>
             </a:extLst>
           </p:cNvPr>
@@ -15634,7 +15634,7 @@
           <p:cNvPr id="5" name="">
             <a:extLst xmlns:a="http://schemas.openxmlformats.org/drawingml/2006/main">
               <a:ext uri="{FF2B5EF4-FFF2-40B4-BE49-F238E27FC236}">
-                <a16:creationId xmlns:a16="http://schemas.microsoft.com/office/drawing/2014/main" id="{2CD0DC23-7EB3-4CEA-B1F8-EC0670754C4E}"/>
+                <a16:creationId xmlns:a16="http://schemas.microsoft.com/office/drawing/2014/main" id="{1E55372A-92AA-4128-A208-BCDE788D5911}"/>
               </a:ext>
             </a:extLst>
           </p:cNvPr>
@@ -15850,7 +15850,7 @@
           <p:cNvPr id="6" name="">
             <a:extLst xmlns:a="http://schemas.openxmlformats.org/drawingml/2006/main">
               <a:ext uri="{FF2B5EF4-FFF2-40B4-BE49-F238E27FC236}">
-                <a16:creationId xmlns:a16="http://schemas.microsoft.com/office/drawing/2014/main" id="{C94CD34D-8C21-4AB8-B0C4-64B3868986DD}"/>
+                <a16:creationId xmlns:a16="http://schemas.microsoft.com/office/drawing/2014/main" id="{E93FEC5D-999F-4BF8-A0EB-CF7E06BBAF19}"/>
               </a:ext>
             </a:extLst>
           </p:cNvPr>
@@ -16008,7 +16008,7 @@
           <p:cNvPr id="7" name="">
             <a:extLst xmlns:a="http://schemas.openxmlformats.org/drawingml/2006/main">
               <a:ext uri="{FF2B5EF4-FFF2-40B4-BE49-F238E27FC236}">
-                <a16:creationId xmlns:a16="http://schemas.microsoft.com/office/drawing/2014/main" id="{8E237868-2EE3-47F1-9A6E-EC807DF79465}"/>
+                <a16:creationId xmlns:a16="http://schemas.microsoft.com/office/drawing/2014/main" id="{9B9E1A99-83E2-4E65-A58B-5EA6CED4BCB0}"/>
               </a:ext>
             </a:extLst>
           </p:cNvPr>
@@ -16224,7 +16224,7 @@
           <p:cNvPr id="8" name="">
             <a:extLst xmlns:a="http://schemas.openxmlformats.org/drawingml/2006/main">
               <a:ext uri="{FF2B5EF4-FFF2-40B4-BE49-F238E27FC236}">
-                <a16:creationId xmlns:a16="http://schemas.microsoft.com/office/drawing/2014/main" id="{67F053E3-8F22-430A-8882-F4DD3B05D246}"/>
+                <a16:creationId xmlns:a16="http://schemas.microsoft.com/office/drawing/2014/main" id="{E973EB99-D5AD-4B0F-8DCC-4326207E22BE}"/>
               </a:ext>
             </a:extLst>
           </p:cNvPr>
@@ -16382,7 +16382,7 @@
           <p:cNvPr id="9" name="">
             <a:extLst xmlns:a="http://schemas.openxmlformats.org/drawingml/2006/main">
               <a:ext uri="{FF2B5EF4-FFF2-40B4-BE49-F238E27FC236}">
-                <a16:creationId xmlns:a16="http://schemas.microsoft.com/office/drawing/2014/main" id="{BF57E21A-DEB3-4213-9864-7B9919C68FB2}"/>
+                <a16:creationId xmlns:a16="http://schemas.microsoft.com/office/drawing/2014/main" id="{0B52D22E-3203-4136-9161-A4FF46441382}"/>
               </a:ext>
             </a:extLst>
           </p:cNvPr>
@@ -16598,7 +16598,7 @@
           <p:cNvPr id="10" name="">
             <a:extLst xmlns:a="http://schemas.openxmlformats.org/drawingml/2006/main">
               <a:ext uri="{FF2B5EF4-FFF2-40B4-BE49-F238E27FC236}">
-                <a16:creationId xmlns:a16="http://schemas.microsoft.com/office/drawing/2014/main" id="{80722866-5342-40CD-9129-FF0BB902745E}"/>
+                <a16:creationId xmlns:a16="http://schemas.microsoft.com/office/drawing/2014/main" id="{9DADEE49-F063-4C3B-A482-E9EBC8958BF0}"/>
               </a:ext>
             </a:extLst>
           </p:cNvPr>
@@ -16777,7 +16777,7 @@
     </p:spTree>
     <p:extLst>
       <p:ext uri="{BB962C8B-B14F-4D97-AF65-F5344CB8AC3E}">
-        <p14:creationId xmlns:p14="http://schemas.microsoft.com/office/powerpoint/2010/main" val="1880809440"/>
+        <p14:creationId xmlns:p14="http://schemas.microsoft.com/office/powerpoint/2010/main" val="1592074993"/>
       </p:ext>
     </p:extLst>
   </p:cSld>
@@ -16808,7 +16808,7 @@
           <p:cNvPr id="11" name="">
             <a:extLst xmlns:a="http://schemas.openxmlformats.org/drawingml/2006/main">
               <a:ext uri="{FF2B5EF4-FFF2-40B4-BE49-F238E27FC236}">
-                <a16:creationId xmlns:a16="http://schemas.microsoft.com/office/drawing/2014/main" id="{309A3EFE-AC24-4FE5-8835-DB733022B30E}"/>
+                <a16:creationId xmlns:a16="http://schemas.microsoft.com/office/drawing/2014/main" id="{8507C037-C4E2-436C-A0CF-F4E2EE93EEC2}"/>
               </a:ext>
             </a:extLst>
           </p:cNvPr>
@@ -16838,7 +16838,7 @@
           <p:cNvPr id="2" name="">
             <a:extLst xmlns:a="http://schemas.openxmlformats.org/drawingml/2006/main">
               <a:ext uri="{FF2B5EF4-FFF2-40B4-BE49-F238E27FC236}">
-                <a16:creationId xmlns:a16="http://schemas.microsoft.com/office/drawing/2014/main" id="{9FFFE221-5ED7-402F-9968-FBC10542DE25}"/>
+                <a16:creationId xmlns:a16="http://schemas.microsoft.com/office/drawing/2014/main" id="{3E2740BD-070C-4EA0-B5C8-1F96DD0158FF}"/>
               </a:ext>
             </a:extLst>
           </p:cNvPr>
@@ -16996,7 +16996,7 @@
           <p:cNvPr id="3" name="">
             <a:extLst xmlns:a="http://schemas.openxmlformats.org/drawingml/2006/main">
               <a:ext uri="{FF2B5EF4-FFF2-40B4-BE49-F238E27FC236}">
-                <a16:creationId xmlns:a16="http://schemas.microsoft.com/office/drawing/2014/main" id="{D5A979B8-BCBD-44BF-A877-614CE9523DAB}"/>
+                <a16:creationId xmlns:a16="http://schemas.microsoft.com/office/drawing/2014/main" id="{40566456-88A8-45B2-B8D7-AAFC0DEE82D2}"/>
               </a:ext>
             </a:extLst>
           </p:cNvPr>
@@ -17154,7 +17154,7 @@
           <p:cNvPr id="4" name="">
             <a:extLst xmlns:a="http://schemas.openxmlformats.org/drawingml/2006/main">
               <a:ext uri="{FF2B5EF4-FFF2-40B4-BE49-F238E27FC236}">
-                <a16:creationId xmlns:a16="http://schemas.microsoft.com/office/drawing/2014/main" id="{1949E378-7F0E-4D09-9F85-57800C1EA0CB}"/>
+                <a16:creationId xmlns:a16="http://schemas.microsoft.com/office/drawing/2014/main" id="{ABB8AE56-8C48-4F08-9EC1-009E28892886}"/>
               </a:ext>
             </a:extLst>
           </p:cNvPr>
@@ -17312,7 +17312,7 @@
           <p:cNvPr id="5" name="">
             <a:extLst xmlns:a="http://schemas.openxmlformats.org/drawingml/2006/main">
               <a:ext uri="{FF2B5EF4-FFF2-40B4-BE49-F238E27FC236}">
-                <a16:creationId xmlns:a16="http://schemas.microsoft.com/office/drawing/2014/main" id="{9A9E0E04-91FA-44E6-B685-1F36656AE4EB}"/>
+                <a16:creationId xmlns:a16="http://schemas.microsoft.com/office/drawing/2014/main" id="{F6B535C1-CA59-48B9-933B-C79CD4252D41}"/>
               </a:ext>
             </a:extLst>
           </p:cNvPr>
@@ -17528,7 +17528,7 @@
           <p:cNvPr id="6" name="">
             <a:extLst xmlns:a="http://schemas.openxmlformats.org/drawingml/2006/main">
               <a:ext uri="{FF2B5EF4-FFF2-40B4-BE49-F238E27FC236}">
-                <a16:creationId xmlns:a16="http://schemas.microsoft.com/office/drawing/2014/main" id="{9B11A4B3-7A3E-4472-A918-CC35E4919EA6}"/>
+                <a16:creationId xmlns:a16="http://schemas.microsoft.com/office/drawing/2014/main" id="{5B12E0EF-4755-43C9-86B9-623FADA13CD8}"/>
               </a:ext>
             </a:extLst>
           </p:cNvPr>
@@ -17686,7 +17686,7 @@
           <p:cNvPr id="7" name="">
             <a:extLst xmlns:a="http://schemas.openxmlformats.org/drawingml/2006/main">
               <a:ext uri="{FF2B5EF4-FFF2-40B4-BE49-F238E27FC236}">
-                <a16:creationId xmlns:a16="http://schemas.microsoft.com/office/drawing/2014/main" id="{660EA618-35B7-4546-99A5-C9F6DAD47CFF}"/>
+                <a16:creationId xmlns:a16="http://schemas.microsoft.com/office/drawing/2014/main" id="{F298C17E-0A40-4541-8F41-66203394FDEC}"/>
               </a:ext>
             </a:extLst>
           </p:cNvPr>
@@ -17902,7 +17902,7 @@
           <p:cNvPr id="8" name="">
             <a:extLst xmlns:a="http://schemas.openxmlformats.org/drawingml/2006/main">
               <a:ext uri="{FF2B5EF4-FFF2-40B4-BE49-F238E27FC236}">
-                <a16:creationId xmlns:a16="http://schemas.microsoft.com/office/drawing/2014/main" id="{A153A063-E443-45D3-B820-203DE211044F}"/>
+                <a16:creationId xmlns:a16="http://schemas.microsoft.com/office/drawing/2014/main" id="{95809508-F744-4365-ABB6-4417311FB71F}"/>
               </a:ext>
             </a:extLst>
           </p:cNvPr>
@@ -18060,7 +18060,7 @@
           <p:cNvPr id="9" name="">
             <a:extLst xmlns:a="http://schemas.openxmlformats.org/drawingml/2006/main">
               <a:ext uri="{FF2B5EF4-FFF2-40B4-BE49-F238E27FC236}">
-                <a16:creationId xmlns:a16="http://schemas.microsoft.com/office/drawing/2014/main" id="{348BA83B-F3B8-4F65-B326-B819864C1479}"/>
+                <a16:creationId xmlns:a16="http://schemas.microsoft.com/office/drawing/2014/main" id="{E685C956-435D-491B-B176-C7F40525A460}"/>
               </a:ext>
             </a:extLst>
           </p:cNvPr>
@@ -18276,7 +18276,7 @@
           <p:cNvPr id="10" name="">
             <a:extLst xmlns:a="http://schemas.openxmlformats.org/drawingml/2006/main">
               <a:ext uri="{FF2B5EF4-FFF2-40B4-BE49-F238E27FC236}">
-                <a16:creationId xmlns:a16="http://schemas.microsoft.com/office/drawing/2014/main" id="{A9A6C1E0-F7C7-4798-BF87-B47DDED9A996}"/>
+                <a16:creationId xmlns:a16="http://schemas.microsoft.com/office/drawing/2014/main" id="{1E3DF0EF-B70F-48E3-88DD-DDA548FB573A}"/>
               </a:ext>
             </a:extLst>
           </p:cNvPr>
@@ -18432,7 +18432,7 @@
     </p:spTree>
     <p:extLst>
       <p:ext uri="{BB962C8B-B14F-4D97-AF65-F5344CB8AC3E}">
-        <p14:creationId xmlns:p14="http://schemas.microsoft.com/office/powerpoint/2010/main" val="1076678735"/>
+        <p14:creationId xmlns:p14="http://schemas.microsoft.com/office/powerpoint/2010/main" val="769639740"/>
       </p:ext>
     </p:extLst>
   </p:cSld>
@@ -18463,7 +18463,7 @@
           <p:cNvPr id="9" name="">
             <a:extLst xmlns:a="http://schemas.openxmlformats.org/drawingml/2006/main">
               <a:ext uri="{FF2B5EF4-FFF2-40B4-BE49-F238E27FC236}">
-                <a16:creationId xmlns:a16="http://schemas.microsoft.com/office/drawing/2014/main" id="{EA2C5962-15CC-425B-A7A8-50D1C97E4829}"/>
+                <a16:creationId xmlns:a16="http://schemas.microsoft.com/office/drawing/2014/main" id="{57D4E440-FB65-4C33-9D03-DC62CE6835FD}"/>
               </a:ext>
             </a:extLst>
           </p:cNvPr>
@@ -18493,7 +18493,7 @@
           <p:cNvPr id="2" name="">
             <a:extLst xmlns:a="http://schemas.openxmlformats.org/drawingml/2006/main">
               <a:ext uri="{FF2B5EF4-FFF2-40B4-BE49-F238E27FC236}">
-                <a16:creationId xmlns:a16="http://schemas.microsoft.com/office/drawing/2014/main" id="{48EFFE59-3AE6-497A-89CD-AF8630856697}"/>
+                <a16:creationId xmlns:a16="http://schemas.microsoft.com/office/drawing/2014/main" id="{8CB6FD9B-030E-4F3E-983E-6137C801C667}"/>
               </a:ext>
             </a:extLst>
           </p:cNvPr>
@@ -18651,7 +18651,7 @@
           <p:cNvPr id="3" name="">
             <a:extLst xmlns:a="http://schemas.openxmlformats.org/drawingml/2006/main">
               <a:ext uri="{FF2B5EF4-FFF2-40B4-BE49-F238E27FC236}">
-                <a16:creationId xmlns:a16="http://schemas.microsoft.com/office/drawing/2014/main" id="{9B12EF14-2E9F-405D-BA65-6AA2731AF321}"/>
+                <a16:creationId xmlns:a16="http://schemas.microsoft.com/office/drawing/2014/main" id="{48382208-8065-4375-8DD1-1DB75CE50343}"/>
               </a:ext>
             </a:extLst>
           </p:cNvPr>
@@ -18809,7 +18809,7 @@
           <p:cNvPr id="4" name="">
             <a:extLst xmlns:a="http://schemas.openxmlformats.org/drawingml/2006/main">
               <a:ext uri="{FF2B5EF4-FFF2-40B4-BE49-F238E27FC236}">
-                <a16:creationId xmlns:a16="http://schemas.microsoft.com/office/drawing/2014/main" id="{8E23279B-3B69-4F76-8EB4-79F4F05A291F}"/>
+                <a16:creationId xmlns:a16="http://schemas.microsoft.com/office/drawing/2014/main" id="{E51C6172-8DEA-4AEA-BF1A-B045568A4590}"/>
               </a:ext>
             </a:extLst>
           </p:cNvPr>
@@ -18967,7 +18967,7 @@
           <p:cNvPr id="5" name="">
             <a:extLst xmlns:a="http://schemas.openxmlformats.org/drawingml/2006/main">
               <a:ext uri="{FF2B5EF4-FFF2-40B4-BE49-F238E27FC236}">
-                <a16:creationId xmlns:a16="http://schemas.microsoft.com/office/drawing/2014/main" id="{898180BB-1C85-496F-B724-1303EEC30CA4}"/>
+                <a16:creationId xmlns:a16="http://schemas.microsoft.com/office/drawing/2014/main" id="{E84951D8-5D77-4E13-9D82-23A248A27052}"/>
               </a:ext>
             </a:extLst>
           </p:cNvPr>
@@ -19210,7 +19210,7 @@
           <p:cNvPr id="6" name="">
             <a:extLst xmlns:a="http://schemas.openxmlformats.org/drawingml/2006/main">
               <a:ext uri="{FF2B5EF4-FFF2-40B4-BE49-F238E27FC236}">
-                <a16:creationId xmlns:a16="http://schemas.microsoft.com/office/drawing/2014/main" id="{77FFC623-ADD6-4841-816F-64582399E5E9}"/>
+                <a16:creationId xmlns:a16="http://schemas.microsoft.com/office/drawing/2014/main" id="{3E7A5B11-732F-4E36-A58F-7258C0C09E8D}"/>
               </a:ext>
             </a:extLst>
           </p:cNvPr>
@@ -19368,7 +19368,7 @@
           <p:cNvPr id="7" name="">
             <a:extLst xmlns:a="http://schemas.openxmlformats.org/drawingml/2006/main">
               <a:ext uri="{FF2B5EF4-FFF2-40B4-BE49-F238E27FC236}">
-                <a16:creationId xmlns:a16="http://schemas.microsoft.com/office/drawing/2014/main" id="{39C72503-F14C-40A1-AAFE-3DC548476D99}"/>
+                <a16:creationId xmlns:a16="http://schemas.microsoft.com/office/drawing/2014/main" id="{450D124E-581C-4894-BF64-328AC2C80ABB}"/>
               </a:ext>
             </a:extLst>
           </p:cNvPr>
@@ -19611,7 +19611,7 @@
           <p:cNvPr id="8" name="">
             <a:extLst xmlns:a="http://schemas.openxmlformats.org/drawingml/2006/main">
               <a:ext uri="{FF2B5EF4-FFF2-40B4-BE49-F238E27FC236}">
-                <a16:creationId xmlns:a16="http://schemas.microsoft.com/office/drawing/2014/main" id="{D3633599-E936-401F-BFB2-2513FA2B1FA9}"/>
+                <a16:creationId xmlns:a16="http://schemas.microsoft.com/office/drawing/2014/main" id="{70E99B1B-8FCD-4DBE-BFC6-8C15B216D60A}"/>
               </a:ext>
             </a:extLst>
           </p:cNvPr>
@@ -19790,7 +19790,7 @@
     </p:spTree>
     <p:extLst>
       <p:ext uri="{BB962C8B-B14F-4D97-AF65-F5344CB8AC3E}">
-        <p14:creationId xmlns:p14="http://schemas.microsoft.com/office/powerpoint/2010/main" val="2129002908"/>
+        <p14:creationId xmlns:p14="http://schemas.microsoft.com/office/powerpoint/2010/main" val="835262853"/>
       </p:ext>
     </p:extLst>
   </p:cSld>
@@ -19821,7 +19821,7 @@
           <p:cNvPr id="9" name="">
             <a:extLst xmlns:a="http://schemas.openxmlformats.org/drawingml/2006/main">
               <a:ext uri="{FF2B5EF4-FFF2-40B4-BE49-F238E27FC236}">
-                <a16:creationId xmlns:a16="http://schemas.microsoft.com/office/drawing/2014/main" id="{45B7CB61-047E-457C-A0BA-C1FBE804022A}"/>
+                <a16:creationId xmlns:a16="http://schemas.microsoft.com/office/drawing/2014/main" id="{DB48E024-D397-49F8-AEC5-0E695F53AFEC}"/>
               </a:ext>
             </a:extLst>
           </p:cNvPr>
@@ -19851,7 +19851,7 @@
           <p:cNvPr id="2" name="">
             <a:extLst xmlns:a="http://schemas.openxmlformats.org/drawingml/2006/main">
               <a:ext uri="{FF2B5EF4-FFF2-40B4-BE49-F238E27FC236}">
-                <a16:creationId xmlns:a16="http://schemas.microsoft.com/office/drawing/2014/main" id="{D82BC29C-99DB-4223-8AB4-8C02BFAE5175}"/>
+                <a16:creationId xmlns:a16="http://schemas.microsoft.com/office/drawing/2014/main" id="{234D113F-3AB0-4D6F-88CC-88F359BD3579}"/>
               </a:ext>
             </a:extLst>
           </p:cNvPr>
@@ -20009,7 +20009,7 @@
           <p:cNvPr id="3" name="">
             <a:extLst xmlns:a="http://schemas.openxmlformats.org/drawingml/2006/main">
               <a:ext uri="{FF2B5EF4-FFF2-40B4-BE49-F238E27FC236}">
-                <a16:creationId xmlns:a16="http://schemas.microsoft.com/office/drawing/2014/main" id="{85BF6E1F-EC87-4D8D-A5DC-97571A939CF1}"/>
+                <a16:creationId xmlns:a16="http://schemas.microsoft.com/office/drawing/2014/main" id="{19F545AA-4DC4-4494-A706-885EDD5C3964}"/>
               </a:ext>
             </a:extLst>
           </p:cNvPr>
@@ -20167,7 +20167,7 @@
           <p:cNvPr id="4" name="">
             <a:extLst xmlns:a="http://schemas.openxmlformats.org/drawingml/2006/main">
               <a:ext uri="{FF2B5EF4-FFF2-40B4-BE49-F238E27FC236}">
-                <a16:creationId xmlns:a16="http://schemas.microsoft.com/office/drawing/2014/main" id="{14EEF640-4F9A-4614-BCF9-F843F87CD6E2}"/>
+                <a16:creationId xmlns:a16="http://schemas.microsoft.com/office/drawing/2014/main" id="{F83B1A5D-64B8-4A81-8045-F486C97ABD90}"/>
               </a:ext>
             </a:extLst>
           </p:cNvPr>
@@ -20325,7 +20325,7 @@
           <p:cNvPr id="5" name="">
             <a:extLst xmlns:a="http://schemas.openxmlformats.org/drawingml/2006/main">
               <a:ext uri="{FF2B5EF4-FFF2-40B4-BE49-F238E27FC236}">
-                <a16:creationId xmlns:a16="http://schemas.microsoft.com/office/drawing/2014/main" id="{19C5F430-9318-45B6-83AE-08DB737B5F4F}"/>
+                <a16:creationId xmlns:a16="http://schemas.microsoft.com/office/drawing/2014/main" id="{71B33E28-50AA-45A6-8BBE-B27C1719BFF5}"/>
               </a:ext>
             </a:extLst>
           </p:cNvPr>
@@ -20541,7 +20541,7 @@
           <p:cNvPr id="6" name="">
             <a:extLst xmlns:a="http://schemas.openxmlformats.org/drawingml/2006/main">
               <a:ext uri="{FF2B5EF4-FFF2-40B4-BE49-F238E27FC236}">
-                <a16:creationId xmlns:a16="http://schemas.microsoft.com/office/drawing/2014/main" id="{03043AA3-9F3C-48B3-8EEE-78CCC6182EC5}"/>
+                <a16:creationId xmlns:a16="http://schemas.microsoft.com/office/drawing/2014/main" id="{74959C8E-8451-4EA0-8262-A6CB0DBB9CA3}"/>
               </a:ext>
             </a:extLst>
           </p:cNvPr>
@@ -20699,7 +20699,7 @@
           <p:cNvPr id="7" name="">
             <a:extLst xmlns:a="http://schemas.openxmlformats.org/drawingml/2006/main">
               <a:ext uri="{FF2B5EF4-FFF2-40B4-BE49-F238E27FC236}">
-                <a16:creationId xmlns:a16="http://schemas.microsoft.com/office/drawing/2014/main" id="{644EF9CB-D2B1-4EE9-93A2-C1E7E06E8930}"/>
+                <a16:creationId xmlns:a16="http://schemas.microsoft.com/office/drawing/2014/main" id="{4FB8EB7D-7358-47C2-87E5-4E0F354D2BCE}"/>
               </a:ext>
             </a:extLst>
           </p:cNvPr>
@@ -20942,7 +20942,7 @@
           <p:cNvPr id="8" name="">
             <a:extLst xmlns:a="http://schemas.openxmlformats.org/drawingml/2006/main">
               <a:ext uri="{FF2B5EF4-FFF2-40B4-BE49-F238E27FC236}">
-                <a16:creationId xmlns:a16="http://schemas.microsoft.com/office/drawing/2014/main" id="{68AA4FCE-95C8-4B90-B8F0-98846D17B997}"/>
+                <a16:creationId xmlns:a16="http://schemas.microsoft.com/office/drawing/2014/main" id="{827ACBF0-A319-4114-BF9D-1BA41F0BE071}"/>
               </a:ext>
             </a:extLst>
           </p:cNvPr>
@@ -21121,7 +21121,7 @@
     </p:spTree>
     <p:extLst>
       <p:ext uri="{BB962C8B-B14F-4D97-AF65-F5344CB8AC3E}">
-        <p14:creationId xmlns:p14="http://schemas.microsoft.com/office/powerpoint/2010/main" val="1018313988"/>
+        <p14:creationId xmlns:p14="http://schemas.microsoft.com/office/powerpoint/2010/main" val="783865956"/>
       </p:ext>
     </p:extLst>
   </p:cSld>
@@ -21152,7 +21152,7 @@
           <p:cNvPr id="10" name="">
             <a:extLst xmlns:a="http://schemas.openxmlformats.org/drawingml/2006/main">
               <a:ext uri="{FF2B5EF4-FFF2-40B4-BE49-F238E27FC236}">
-                <a16:creationId xmlns:a16="http://schemas.microsoft.com/office/drawing/2014/main" id="{3B241224-983B-4BBB-A9A3-04BCB22ADE4F}"/>
+                <a16:creationId xmlns:a16="http://schemas.microsoft.com/office/drawing/2014/main" id="{DF7B3207-B575-40EA-AA05-C525FE68171A}"/>
               </a:ext>
             </a:extLst>
           </p:cNvPr>
@@ -21182,7 +21182,7 @@
           <p:cNvPr id="2" name="">
             <a:extLst xmlns:a="http://schemas.openxmlformats.org/drawingml/2006/main">
               <a:ext uri="{FF2B5EF4-FFF2-40B4-BE49-F238E27FC236}">
-                <a16:creationId xmlns:a16="http://schemas.microsoft.com/office/drawing/2014/main" id="{33754449-29F2-45C4-951F-943E627F60BE}"/>
+                <a16:creationId xmlns:a16="http://schemas.microsoft.com/office/drawing/2014/main" id="{1993522D-5B4E-4898-BA7F-99D39E9C35E9}"/>
               </a:ext>
             </a:extLst>
           </p:cNvPr>
@@ -21340,7 +21340,7 @@
           <p:cNvPr id="3" name="">
             <a:extLst xmlns:a="http://schemas.openxmlformats.org/drawingml/2006/main">
               <a:ext uri="{FF2B5EF4-FFF2-40B4-BE49-F238E27FC236}">
-                <a16:creationId xmlns:a16="http://schemas.microsoft.com/office/drawing/2014/main" id="{9374072B-C137-46CD-802B-55A40BB15BDB}"/>
+                <a16:creationId xmlns:a16="http://schemas.microsoft.com/office/drawing/2014/main" id="{1F40F535-D704-4AD0-8F25-ACE7B95C470D}"/>
               </a:ext>
             </a:extLst>
           </p:cNvPr>
@@ -21498,7 +21498,7 @@
           <p:cNvPr id="4" name="">
             <a:extLst xmlns:a="http://schemas.openxmlformats.org/drawingml/2006/main">
               <a:ext uri="{FF2B5EF4-FFF2-40B4-BE49-F238E27FC236}">
-                <a16:creationId xmlns:a16="http://schemas.microsoft.com/office/drawing/2014/main" id="{79B424F9-B0D6-4A98-9A96-6CF152182AA3}"/>
+                <a16:creationId xmlns:a16="http://schemas.microsoft.com/office/drawing/2014/main" id="{9AF32EAE-DA40-4C27-B939-1780AD5E1CA5}"/>
               </a:ext>
             </a:extLst>
           </p:cNvPr>
@@ -21741,7 +21741,7 @@
           <p:cNvPr id="5" name="">
             <a:extLst xmlns:a="http://schemas.openxmlformats.org/drawingml/2006/main">
               <a:ext uri="{FF2B5EF4-FFF2-40B4-BE49-F238E27FC236}">
-                <a16:creationId xmlns:a16="http://schemas.microsoft.com/office/drawing/2014/main" id="{140EA013-3CDC-4ADB-8C9F-C883ADFF73CC}"/>
+                <a16:creationId xmlns:a16="http://schemas.microsoft.com/office/drawing/2014/main" id="{DB9C386A-E87F-44A5-8C5A-079EB4D15254}"/>
               </a:ext>
             </a:extLst>
           </p:cNvPr>
@@ -21906,7 +21906,7 @@
           <p:cNvPr id="6" name="">
             <a:extLst xmlns:a="http://schemas.openxmlformats.org/drawingml/2006/main">
               <a:ext uri="{FF2B5EF4-FFF2-40B4-BE49-F238E27FC236}">
-                <a16:creationId xmlns:a16="http://schemas.microsoft.com/office/drawing/2014/main" id="{E6E59113-472F-45CB-8314-7DBEEC3CD498}"/>
+                <a16:creationId xmlns:a16="http://schemas.microsoft.com/office/drawing/2014/main" id="{EC5A47AB-30A2-4134-B814-AF5B93AECA8E}"/>
               </a:ext>
             </a:extLst>
           </p:cNvPr>
@@ -22071,7 +22071,7 @@
           <p:cNvPr id="7" name="">
             <a:extLst xmlns:a="http://schemas.openxmlformats.org/drawingml/2006/main">
               <a:ext uri="{FF2B5EF4-FFF2-40B4-BE49-F238E27FC236}">
-                <a16:creationId xmlns:a16="http://schemas.microsoft.com/office/drawing/2014/main" id="{95D427EB-5556-4A38-9938-9C0BAB595E4D}"/>
+                <a16:creationId xmlns:a16="http://schemas.microsoft.com/office/drawing/2014/main" id="{E63B9D23-D116-403E-BA4A-D408FB0EFB2B}"/>
               </a:ext>
             </a:extLst>
           </p:cNvPr>
@@ -22236,7 +22236,7 @@
           <p:cNvPr id="8" name="">
             <a:extLst xmlns:a="http://schemas.openxmlformats.org/drawingml/2006/main">
               <a:ext uri="{FF2B5EF4-FFF2-40B4-BE49-F238E27FC236}">
-                <a16:creationId xmlns:a16="http://schemas.microsoft.com/office/drawing/2014/main" id="{6D098389-9ABD-4901-88A4-2342FDEEFE98}"/>
+                <a16:creationId xmlns:a16="http://schemas.microsoft.com/office/drawing/2014/main" id="{C7A36C09-30D3-42DA-9D39-135DFC19982A}"/>
               </a:ext>
             </a:extLst>
           </p:cNvPr>
@@ -22401,7 +22401,7 @@
           <p:cNvPr id="9" name="">
             <a:extLst xmlns:a="http://schemas.openxmlformats.org/drawingml/2006/main">
               <a:ext uri="{FF2B5EF4-FFF2-40B4-BE49-F238E27FC236}">
-                <a16:creationId xmlns:a16="http://schemas.microsoft.com/office/drawing/2014/main" id="{04EADE84-7180-4653-95C5-A2C1F190D612}"/>
+                <a16:creationId xmlns:a16="http://schemas.microsoft.com/office/drawing/2014/main" id="{E045D716-40BB-406B-92CF-A3C1F1EBFCAD}"/>
               </a:ext>
             </a:extLst>
           </p:cNvPr>
@@ -22564,7 +22564,7 @@
     </p:spTree>
     <p:extLst>
       <p:ext uri="{BB962C8B-B14F-4D97-AF65-F5344CB8AC3E}">
-        <p14:creationId xmlns:p14="http://schemas.microsoft.com/office/powerpoint/2010/main" val="1034903060"/>
+        <p14:creationId xmlns:p14="http://schemas.microsoft.com/office/powerpoint/2010/main" val="297164487"/>
       </p:ext>
     </p:extLst>
   </p:cSld>
@@ -22595,7 +22595,7 @@
           <p:cNvPr id="7" name="">
             <a:extLst xmlns:a="http://schemas.openxmlformats.org/drawingml/2006/main">
               <a:ext uri="{FF2B5EF4-FFF2-40B4-BE49-F238E27FC236}">
-                <a16:creationId xmlns:a16="http://schemas.microsoft.com/office/drawing/2014/main" id="{F8F22A5E-BCB4-4254-94B7-63BB9FEE8F95}"/>
+                <a16:creationId xmlns:a16="http://schemas.microsoft.com/office/drawing/2014/main" id="{305DEDA9-AA51-4587-83D3-5344106D7030}"/>
               </a:ext>
             </a:extLst>
           </p:cNvPr>
@@ -22625,7 +22625,7 @@
           <p:cNvPr id="2" name="">
             <a:extLst xmlns:a="http://schemas.openxmlformats.org/drawingml/2006/main">
               <a:ext uri="{FF2B5EF4-FFF2-40B4-BE49-F238E27FC236}">
-                <a16:creationId xmlns:a16="http://schemas.microsoft.com/office/drawing/2014/main" id="{B92EF821-79E8-459B-BDDE-5F8E5A3A7888}"/>
+                <a16:creationId xmlns:a16="http://schemas.microsoft.com/office/drawing/2014/main" id="{137B1160-2C7A-4704-A55A-488EFF2F8D12}"/>
               </a:ext>
             </a:extLst>
           </p:cNvPr>
@@ -22783,7 +22783,7 @@
           <p:cNvPr id="3" name="">
             <a:extLst xmlns:a="http://schemas.openxmlformats.org/drawingml/2006/main">
               <a:ext uri="{FF2B5EF4-FFF2-40B4-BE49-F238E27FC236}">
-                <a16:creationId xmlns:a16="http://schemas.microsoft.com/office/drawing/2014/main" id="{D282F15E-A871-4F7D-B3DF-AF4998C6AA9F}"/>
+                <a16:creationId xmlns:a16="http://schemas.microsoft.com/office/drawing/2014/main" id="{C5CB4DA4-5677-4386-86F4-7BF5FB02F6A1}"/>
               </a:ext>
             </a:extLst>
           </p:cNvPr>
@@ -22941,7 +22941,7 @@
           <p:cNvPr id="4" name="">
             <a:extLst xmlns:a="http://schemas.openxmlformats.org/drawingml/2006/main">
               <a:ext uri="{FF2B5EF4-FFF2-40B4-BE49-F238E27FC236}">
-                <a16:creationId xmlns:a16="http://schemas.microsoft.com/office/drawing/2014/main" id="{11A9AB72-B665-43DE-AC87-D1E4711ABF4A}"/>
+                <a16:creationId xmlns:a16="http://schemas.microsoft.com/office/drawing/2014/main" id="{D3571E37-DD73-4A50-A3C0-8147E1544687}"/>
               </a:ext>
             </a:extLst>
           </p:cNvPr>
@@ -23099,7 +23099,7 @@
           <p:cNvPr id="5" name="">
             <a:extLst xmlns:a="http://schemas.openxmlformats.org/drawingml/2006/main">
               <a:ext uri="{FF2B5EF4-FFF2-40B4-BE49-F238E27FC236}">
-                <a16:creationId xmlns:a16="http://schemas.microsoft.com/office/drawing/2014/main" id="{F78ED191-CCDF-430C-B7ED-EF0A54DC91A1}"/>
+                <a16:creationId xmlns:a16="http://schemas.microsoft.com/office/drawing/2014/main" id="{E9D5495C-9A58-4720-AEA9-0C469AD67935}"/>
               </a:ext>
             </a:extLst>
           </p:cNvPr>
@@ -23109,7 +23109,7 @@
           <p:nvPr/>
         </p:nvPicPr>
         <p:blipFill>
-          <a:blip xmlns:r="http://schemas.openxmlformats.org/officeDocument/2006/relationships" xmlns:a="http://schemas.openxmlformats.org/drawingml/2006/main" r:embed="Re349bed3316b4c27"/>
+          <a:blip xmlns:r="http://schemas.openxmlformats.org/officeDocument/2006/relationships" xmlns:a="http://schemas.openxmlformats.org/drawingml/2006/main" r:embed="R60fb467f074b4dc4"/>
           <a:stretch xmlns:a="http://schemas.openxmlformats.org/drawingml/2006/main"/>
         </p:blipFill>
         <p:spPr>
@@ -23127,7 +23127,7 @@
           <p:cNvPr id="6" name="">
             <a:extLst xmlns:a="http://schemas.openxmlformats.org/drawingml/2006/main">
               <a:ext uri="{FF2B5EF4-FFF2-40B4-BE49-F238E27FC236}">
-                <a16:creationId xmlns:a16="http://schemas.microsoft.com/office/drawing/2014/main" id="{64606D81-3CE1-49B4-A21A-C198AEDF3676}"/>
+                <a16:creationId xmlns:a16="http://schemas.microsoft.com/office/drawing/2014/main" id="{437F726C-6CC9-4E3B-8F2C-CF30E6D3CD36}"/>
               </a:ext>
             </a:extLst>
           </p:cNvPr>
@@ -23283,7 +23283,7 @@
     </p:spTree>
     <p:extLst>
       <p:ext uri="{BB962C8B-B14F-4D97-AF65-F5344CB8AC3E}">
-        <p14:creationId xmlns:p14="http://schemas.microsoft.com/office/powerpoint/2010/main" val="821054741"/>
+        <p14:creationId xmlns:p14="http://schemas.microsoft.com/office/powerpoint/2010/main" val="654046096"/>
       </p:ext>
     </p:extLst>
   </p:cSld>
@@ -23314,7 +23314,7 @@
           <p:cNvPr id="7" name="">
             <a:extLst xmlns:a="http://schemas.openxmlformats.org/drawingml/2006/main">
               <a:ext uri="{FF2B5EF4-FFF2-40B4-BE49-F238E27FC236}">
-                <a16:creationId xmlns:a16="http://schemas.microsoft.com/office/drawing/2014/main" id="{9A222ADD-ED8E-4A65-A7F1-9CA054D63E1B}"/>
+                <a16:creationId xmlns:a16="http://schemas.microsoft.com/office/drawing/2014/main" id="{DBB34D0E-A520-4130-90A7-956EEE1C621A}"/>
               </a:ext>
             </a:extLst>
           </p:cNvPr>
@@ -23344,7 +23344,7 @@
           <p:cNvPr id="2" name="">
             <a:extLst xmlns:a="http://schemas.openxmlformats.org/drawingml/2006/main">
               <a:ext uri="{FF2B5EF4-FFF2-40B4-BE49-F238E27FC236}">
-                <a16:creationId xmlns:a16="http://schemas.microsoft.com/office/drawing/2014/main" id="{9BAA11FE-8C13-4922-96AA-BA9F2DEB39D6}"/>
+                <a16:creationId xmlns:a16="http://schemas.microsoft.com/office/drawing/2014/main" id="{B59B67A4-0CA5-469F-A53B-219EEEF68BCC}"/>
               </a:ext>
             </a:extLst>
           </p:cNvPr>
@@ -23502,7 +23502,7 @@
           <p:cNvPr id="3" name="">
             <a:extLst xmlns:a="http://schemas.openxmlformats.org/drawingml/2006/main">
               <a:ext uri="{FF2B5EF4-FFF2-40B4-BE49-F238E27FC236}">
-                <a16:creationId xmlns:a16="http://schemas.microsoft.com/office/drawing/2014/main" id="{35DDCE08-941E-4EE4-BBB4-EA3C34715153}"/>
+                <a16:creationId xmlns:a16="http://schemas.microsoft.com/office/drawing/2014/main" id="{D6C6FF98-B1C4-4676-834E-6F1DE81B6368}"/>
               </a:ext>
             </a:extLst>
           </p:cNvPr>
@@ -23660,7 +23660,7 @@
           <p:cNvPr id="4" name="">
             <a:extLst xmlns:a="http://schemas.openxmlformats.org/drawingml/2006/main">
               <a:ext uri="{FF2B5EF4-FFF2-40B4-BE49-F238E27FC236}">
-                <a16:creationId xmlns:a16="http://schemas.microsoft.com/office/drawing/2014/main" id="{81C439BF-4C20-4C3F-A32D-C70D8103B276}"/>
+                <a16:creationId xmlns:a16="http://schemas.microsoft.com/office/drawing/2014/main" id="{7D5464BA-69D9-4214-94E3-7BF71DC3D6E3}"/>
               </a:ext>
             </a:extLst>
           </p:cNvPr>
@@ -23903,7 +23903,7 @@
           <p:cNvPr id="5" name="">
             <a:extLst xmlns:a="http://schemas.openxmlformats.org/drawingml/2006/main">
               <a:ext uri="{FF2B5EF4-FFF2-40B4-BE49-F238E27FC236}">
-                <a16:creationId xmlns:a16="http://schemas.microsoft.com/office/drawing/2014/main" id="{7C1F18A9-8199-4F4D-82E8-5FA233CF723A}"/>
+                <a16:creationId xmlns:a16="http://schemas.microsoft.com/office/drawing/2014/main" id="{CCB7153D-442E-4617-90D1-F7573B41BEBD}"/>
               </a:ext>
             </a:extLst>
           </p:cNvPr>
@@ -24061,7 +24061,7 @@
           <p:cNvPr id="6" name="">
             <a:extLst xmlns:a="http://schemas.openxmlformats.org/drawingml/2006/main">
               <a:ext uri="{FF2B5EF4-FFF2-40B4-BE49-F238E27FC236}">
-                <a16:creationId xmlns:a16="http://schemas.microsoft.com/office/drawing/2014/main" id="{D26DA615-AC98-4FEC-B04F-98599B30C680}"/>
+                <a16:creationId xmlns:a16="http://schemas.microsoft.com/office/drawing/2014/main" id="{F205F092-47BA-4815-A177-FF364B27816F}"/>
               </a:ext>
             </a:extLst>
           </p:cNvPr>
@@ -24383,7 +24383,7 @@
     </p:spTree>
     <p:extLst>
       <p:ext uri="{BB962C8B-B14F-4D97-AF65-F5344CB8AC3E}">
-        <p14:creationId xmlns:p14="http://schemas.microsoft.com/office/powerpoint/2010/main" val="2102073055"/>
+        <p14:creationId xmlns:p14="http://schemas.microsoft.com/office/powerpoint/2010/main" val="937151232"/>
       </p:ext>
     </p:extLst>
   </p:cSld>
@@ -24414,7 +24414,7 @@
           <p:cNvPr id="7" name="">
             <a:extLst xmlns:a="http://schemas.openxmlformats.org/drawingml/2006/main">
               <a:ext uri="{FF2B5EF4-FFF2-40B4-BE49-F238E27FC236}">
-                <a16:creationId xmlns:a16="http://schemas.microsoft.com/office/drawing/2014/main" id="{71EB0367-E3A3-4831-8DFE-B1E529B38978}"/>
+                <a16:creationId xmlns:a16="http://schemas.microsoft.com/office/drawing/2014/main" id="{9643CA77-DC90-45DC-8009-C8EDC3CAD69B}"/>
               </a:ext>
             </a:extLst>
           </p:cNvPr>
@@ -24444,7 +24444,7 @@
           <p:cNvPr id="2" name="">
             <a:extLst xmlns:a="http://schemas.openxmlformats.org/drawingml/2006/main">
               <a:ext uri="{FF2B5EF4-FFF2-40B4-BE49-F238E27FC236}">
-                <a16:creationId xmlns:a16="http://schemas.microsoft.com/office/drawing/2014/main" id="{A9A75A63-C0D9-4ADF-865F-B24D3E2FF882}"/>
+                <a16:creationId xmlns:a16="http://schemas.microsoft.com/office/drawing/2014/main" id="{8CF357D0-3F06-428A-BFF6-CBAFB939A4F8}"/>
               </a:ext>
             </a:extLst>
           </p:cNvPr>
@@ -24602,7 +24602,7 @@
           <p:cNvPr id="3" name="">
             <a:extLst xmlns:a="http://schemas.openxmlformats.org/drawingml/2006/main">
               <a:ext uri="{FF2B5EF4-FFF2-40B4-BE49-F238E27FC236}">
-                <a16:creationId xmlns:a16="http://schemas.microsoft.com/office/drawing/2014/main" id="{26291377-B43B-44EF-840E-825869177A42}"/>
+                <a16:creationId xmlns:a16="http://schemas.microsoft.com/office/drawing/2014/main" id="{B4FB0CCB-EAE0-4607-A688-3E37DAEA7810}"/>
               </a:ext>
             </a:extLst>
           </p:cNvPr>
@@ -24760,7 +24760,7 @@
           <p:cNvPr id="4" name="">
             <a:extLst xmlns:a="http://schemas.openxmlformats.org/drawingml/2006/main">
               <a:ext uri="{FF2B5EF4-FFF2-40B4-BE49-F238E27FC236}">
-                <a16:creationId xmlns:a16="http://schemas.microsoft.com/office/drawing/2014/main" id="{4AC25FE3-2F9F-47EF-B9BA-150E61ED2D5C}"/>
+                <a16:creationId xmlns:a16="http://schemas.microsoft.com/office/drawing/2014/main" id="{1018593C-7978-4EF8-A1EB-174F0BD47F1F}"/>
               </a:ext>
             </a:extLst>
           </p:cNvPr>
@@ -24918,7 +24918,7 @@
           <p:cNvPr id="5" name="">
             <a:extLst xmlns:a="http://schemas.openxmlformats.org/drawingml/2006/main">
               <a:ext uri="{FF2B5EF4-FFF2-40B4-BE49-F238E27FC236}">
-                <a16:creationId xmlns:a16="http://schemas.microsoft.com/office/drawing/2014/main" id="{DE97CD48-8089-42B1-95DC-62C6556E10EA}"/>
+                <a16:creationId xmlns:a16="http://schemas.microsoft.com/office/drawing/2014/main" id="{118CB688-89DE-42C4-B427-8B01CA8BECE4}"/>
               </a:ext>
             </a:extLst>
           </p:cNvPr>
@@ -25161,7 +25161,7 @@
           <p:cNvPr id="6" name="">
             <a:extLst xmlns:a="http://schemas.openxmlformats.org/drawingml/2006/main">
               <a:ext uri="{FF2B5EF4-FFF2-40B4-BE49-F238E27FC236}">
-                <a16:creationId xmlns:a16="http://schemas.microsoft.com/office/drawing/2014/main" id="{DBEAA1B4-1E1D-437E-9FF5-DAD58F109A34}"/>
+                <a16:creationId xmlns:a16="http://schemas.microsoft.com/office/drawing/2014/main" id="{12D0FAF1-4A54-4F7C-80A2-97246A48CC3F}"/>
               </a:ext>
             </a:extLst>
           </p:cNvPr>
@@ -25317,7 +25317,7 @@
     </p:spTree>
     <p:extLst>
       <p:ext uri="{BB962C8B-B14F-4D97-AF65-F5344CB8AC3E}">
-        <p14:creationId xmlns:p14="http://schemas.microsoft.com/office/powerpoint/2010/main" val="1180027671"/>
+        <p14:creationId xmlns:p14="http://schemas.microsoft.com/office/powerpoint/2010/main" val="1093041311"/>
       </p:ext>
     </p:extLst>
   </p:cSld>
@@ -25348,7 +25348,7 @@
           <p:cNvPr id="7" name="">
             <a:extLst xmlns:a="http://schemas.openxmlformats.org/drawingml/2006/main">
               <a:ext uri="{FF2B5EF4-FFF2-40B4-BE49-F238E27FC236}">
-                <a16:creationId xmlns:a16="http://schemas.microsoft.com/office/drawing/2014/main" id="{59920C8B-4422-484C-B47D-6C4A6ABFDB9E}"/>
+                <a16:creationId xmlns:a16="http://schemas.microsoft.com/office/drawing/2014/main" id="{A25099E3-C90F-445D-9476-C0FB5C8A5980}"/>
               </a:ext>
             </a:extLst>
           </p:cNvPr>
@@ -25378,7 +25378,7 @@
           <p:cNvPr id="2" name="">
             <a:extLst xmlns:a="http://schemas.openxmlformats.org/drawingml/2006/main">
               <a:ext uri="{FF2B5EF4-FFF2-40B4-BE49-F238E27FC236}">
-                <a16:creationId xmlns:a16="http://schemas.microsoft.com/office/drawing/2014/main" id="{7E65A3E9-5638-4F09-A33C-83C7B2E9EF66}"/>
+                <a16:creationId xmlns:a16="http://schemas.microsoft.com/office/drawing/2014/main" id="{5BD37C22-329F-4CDC-97C7-B61E3A812165}"/>
               </a:ext>
             </a:extLst>
           </p:cNvPr>
@@ -25536,7 +25536,7 @@
           <p:cNvPr id="3" name="">
             <a:extLst xmlns:a="http://schemas.openxmlformats.org/drawingml/2006/main">
               <a:ext uri="{FF2B5EF4-FFF2-40B4-BE49-F238E27FC236}">
-                <a16:creationId xmlns:a16="http://schemas.microsoft.com/office/drawing/2014/main" id="{D6433658-D798-4567-BA52-6AFC36EC8E1A}"/>
+                <a16:creationId xmlns:a16="http://schemas.microsoft.com/office/drawing/2014/main" id="{37A4AC6B-B1A0-404A-B7A0-B57E41AFA792}"/>
               </a:ext>
             </a:extLst>
           </p:cNvPr>
@@ -25694,7 +25694,7 @@
           <p:cNvPr id="4" name="">
             <a:extLst xmlns:a="http://schemas.openxmlformats.org/drawingml/2006/main">
               <a:ext uri="{FF2B5EF4-FFF2-40B4-BE49-F238E27FC236}">
-                <a16:creationId xmlns:a16="http://schemas.microsoft.com/office/drawing/2014/main" id="{2DF6EF58-1181-4E42-850D-7C17668F7DE0}"/>
+                <a16:creationId xmlns:a16="http://schemas.microsoft.com/office/drawing/2014/main" id="{727FBE07-D82A-4372-B147-F05428F25039}"/>
               </a:ext>
             </a:extLst>
           </p:cNvPr>
@@ -25704,7 +25704,7 @@
           <p:nvPr/>
         </p:nvPicPr>
         <p:blipFill>
-          <a:blip xmlns:r="http://schemas.openxmlformats.org/officeDocument/2006/relationships" xmlns:a="http://schemas.openxmlformats.org/drawingml/2006/main" r:embed="R8689646595564467"/>
+          <a:blip xmlns:r="http://schemas.openxmlformats.org/officeDocument/2006/relationships" xmlns:a="http://schemas.openxmlformats.org/drawingml/2006/main" r:embed="R8b0f3b902c0c49f7"/>
           <a:stretch xmlns:a="http://schemas.openxmlformats.org/drawingml/2006/main"/>
         </p:blipFill>
         <p:spPr>
@@ -25722,7 +25722,7 @@
           <p:cNvPr id="5" name="">
             <a:extLst xmlns:a="http://schemas.openxmlformats.org/drawingml/2006/main">
               <a:ext uri="{FF2B5EF4-FFF2-40B4-BE49-F238E27FC236}">
-                <a16:creationId xmlns:a16="http://schemas.microsoft.com/office/drawing/2014/main" id="{54632E61-2C0B-478F-8F34-ADB254AB485A}"/>
+                <a16:creationId xmlns:a16="http://schemas.microsoft.com/office/drawing/2014/main" id="{C7FD3C69-548C-4365-B85B-A298ED25D952}"/>
               </a:ext>
             </a:extLst>
           </p:cNvPr>
@@ -25965,7 +25965,7 @@
           <p:cNvPr id="6" name="">
             <a:extLst xmlns:a="http://schemas.openxmlformats.org/drawingml/2006/main">
               <a:ext uri="{FF2B5EF4-FFF2-40B4-BE49-F238E27FC236}">
-                <a16:creationId xmlns:a16="http://schemas.microsoft.com/office/drawing/2014/main" id="{1E9255A9-62CD-45FA-871F-1AFCB06A1246}"/>
+                <a16:creationId xmlns:a16="http://schemas.microsoft.com/office/drawing/2014/main" id="{0DA7B85D-0588-45A6-A1E6-5C5DC3584815}"/>
               </a:ext>
             </a:extLst>
           </p:cNvPr>
@@ -26121,7 +26121,7 @@
     </p:spTree>
     <p:extLst>
       <p:ext uri="{BB962C8B-B14F-4D97-AF65-F5344CB8AC3E}">
-        <p14:creationId xmlns:p14="http://schemas.microsoft.com/office/powerpoint/2010/main" val="804402729"/>
+        <p14:creationId xmlns:p14="http://schemas.microsoft.com/office/powerpoint/2010/main" val="71631333"/>
       </p:ext>
     </p:extLst>
   </p:cSld>
@@ -26152,7 +26152,7 @@
           <p:cNvPr id="19" name="">
             <a:extLst xmlns:a="http://schemas.openxmlformats.org/drawingml/2006/main">
               <a:ext uri="{FF2B5EF4-FFF2-40B4-BE49-F238E27FC236}">
-                <a16:creationId xmlns:a16="http://schemas.microsoft.com/office/drawing/2014/main" id="{82412831-AC0C-4A24-9200-17852F6C955B}"/>
+                <a16:creationId xmlns:a16="http://schemas.microsoft.com/office/drawing/2014/main" id="{958EEF90-9BC5-476D-8E4E-17CDA892F43B}"/>
               </a:ext>
             </a:extLst>
           </p:cNvPr>
@@ -26182,7 +26182,7 @@
           <p:cNvPr id="2" name="">
             <a:extLst xmlns:a="http://schemas.openxmlformats.org/drawingml/2006/main">
               <a:ext uri="{FF2B5EF4-FFF2-40B4-BE49-F238E27FC236}">
-                <a16:creationId xmlns:a16="http://schemas.microsoft.com/office/drawing/2014/main" id="{86E14475-A30C-4E08-A6B0-09DF8511E632}"/>
+                <a16:creationId xmlns:a16="http://schemas.microsoft.com/office/drawing/2014/main" id="{278AC29D-876B-49C9-9869-6136077CA752}"/>
               </a:ext>
             </a:extLst>
           </p:cNvPr>
@@ -26340,7 +26340,7 @@
           <p:cNvPr id="3" name="">
             <a:extLst xmlns:a="http://schemas.openxmlformats.org/drawingml/2006/main">
               <a:ext uri="{FF2B5EF4-FFF2-40B4-BE49-F238E27FC236}">
-                <a16:creationId xmlns:a16="http://schemas.microsoft.com/office/drawing/2014/main" id="{A8367CDE-C12C-4612-B59E-BC9CD1708BCB}"/>
+                <a16:creationId xmlns:a16="http://schemas.microsoft.com/office/drawing/2014/main" id="{838A4DEC-DBB1-406D-B2B5-04A3041AE63B}"/>
               </a:ext>
             </a:extLst>
           </p:cNvPr>
@@ -26498,7 +26498,7 @@
           <p:cNvPr id="4" name="">
             <a:extLst xmlns:a="http://schemas.openxmlformats.org/drawingml/2006/main">
               <a:ext uri="{FF2B5EF4-FFF2-40B4-BE49-F238E27FC236}">
-                <a16:creationId xmlns:a16="http://schemas.microsoft.com/office/drawing/2014/main" id="{6EF39C0B-ADBC-4836-93A9-DE32EE180A6A}"/>
+                <a16:creationId xmlns:a16="http://schemas.microsoft.com/office/drawing/2014/main" id="{D63FE6BE-56A4-4D83-BAC8-B6BB87557E3A}"/>
               </a:ext>
             </a:extLst>
           </p:cNvPr>
@@ -26663,7 +26663,7 @@
           <p:cNvPr id="5" name="">
             <a:extLst xmlns:a="http://schemas.openxmlformats.org/drawingml/2006/main">
               <a:ext uri="{FF2B5EF4-FFF2-40B4-BE49-F238E27FC236}">
-                <a16:creationId xmlns:a16="http://schemas.microsoft.com/office/drawing/2014/main" id="{50EF44BB-016A-45CB-A470-7EB57ECEECD2}"/>
+                <a16:creationId xmlns:a16="http://schemas.microsoft.com/office/drawing/2014/main" id="{D64D8E30-A523-4B6F-AAC8-1F1AFA5CA1CF}"/>
               </a:ext>
             </a:extLst>
           </p:cNvPr>
@@ -26821,7 +26821,7 @@
           <p:cNvPr id="6" name="">
             <a:extLst xmlns:a="http://schemas.openxmlformats.org/drawingml/2006/main">
               <a:ext uri="{FF2B5EF4-FFF2-40B4-BE49-F238E27FC236}">
-                <a16:creationId xmlns:a16="http://schemas.microsoft.com/office/drawing/2014/main" id="{3D484D3E-EC7F-4865-A5B7-EFCB905B001F}"/>
+                <a16:creationId xmlns:a16="http://schemas.microsoft.com/office/drawing/2014/main" id="{5E97241B-922F-471F-9F6A-3CC7B4731392}"/>
               </a:ext>
             </a:extLst>
           </p:cNvPr>
@@ -26979,7 +26979,7 @@
           <p:cNvPr id="7" name="">
             <a:extLst xmlns:a="http://schemas.openxmlformats.org/drawingml/2006/main">
               <a:ext uri="{FF2B5EF4-FFF2-40B4-BE49-F238E27FC236}">
-                <a16:creationId xmlns:a16="http://schemas.microsoft.com/office/drawing/2014/main" id="{8DF87124-3088-4030-BE15-3439FD759E43}"/>
+                <a16:creationId xmlns:a16="http://schemas.microsoft.com/office/drawing/2014/main" id="{676D1F29-F8BA-4DD8-B127-2A4A4BBAFFD1}"/>
               </a:ext>
             </a:extLst>
           </p:cNvPr>
@@ -27144,7 +27144,7 @@
           <p:cNvPr id="8" name="">
             <a:extLst xmlns:a="http://schemas.openxmlformats.org/drawingml/2006/main">
               <a:ext uri="{FF2B5EF4-FFF2-40B4-BE49-F238E27FC236}">
-                <a16:creationId xmlns:a16="http://schemas.microsoft.com/office/drawing/2014/main" id="{56ADE886-58AC-4ADA-9D54-C1709923DFB5}"/>
+                <a16:creationId xmlns:a16="http://schemas.microsoft.com/office/drawing/2014/main" id="{69778DE6-DDAF-4E7F-815B-23061C19FF69}"/>
               </a:ext>
             </a:extLst>
           </p:cNvPr>
@@ -27302,7 +27302,7 @@
           <p:cNvPr id="9" name="">
             <a:extLst xmlns:a="http://schemas.openxmlformats.org/drawingml/2006/main">
               <a:ext uri="{FF2B5EF4-FFF2-40B4-BE49-F238E27FC236}">
-                <a16:creationId xmlns:a16="http://schemas.microsoft.com/office/drawing/2014/main" id="{E638BEF1-7934-4BB1-AA35-CA5D60277096}"/>
+                <a16:creationId xmlns:a16="http://schemas.microsoft.com/office/drawing/2014/main" id="{5280BB77-9129-4439-87CA-C7C9C237C355}"/>
               </a:ext>
             </a:extLst>
           </p:cNvPr>
@@ -27460,7 +27460,7 @@
           <p:cNvPr id="10" name="">
             <a:extLst xmlns:a="http://schemas.openxmlformats.org/drawingml/2006/main">
               <a:ext uri="{FF2B5EF4-FFF2-40B4-BE49-F238E27FC236}">
-                <a16:creationId xmlns:a16="http://schemas.microsoft.com/office/drawing/2014/main" id="{668B8053-AF04-4DA0-984B-63D3E4E27B66}"/>
+                <a16:creationId xmlns:a16="http://schemas.microsoft.com/office/drawing/2014/main" id="{77F47A08-07FD-4715-A796-B97830029C5D}"/>
               </a:ext>
             </a:extLst>
           </p:cNvPr>
@@ -27625,7 +27625,7 @@
           <p:cNvPr id="11" name="">
             <a:extLst xmlns:a="http://schemas.openxmlformats.org/drawingml/2006/main">
               <a:ext uri="{FF2B5EF4-FFF2-40B4-BE49-F238E27FC236}">
-                <a16:creationId xmlns:a16="http://schemas.microsoft.com/office/drawing/2014/main" id="{98F4FAF4-5697-48E8-A951-71046CA67F3C}"/>
+                <a16:creationId xmlns:a16="http://schemas.microsoft.com/office/drawing/2014/main" id="{6C78BB0F-CD99-404B-B3E9-B36D8FECA4EE}"/>
               </a:ext>
             </a:extLst>
           </p:cNvPr>
@@ -27783,7 +27783,7 @@
           <p:cNvPr id="12" name="">
             <a:extLst xmlns:a="http://schemas.openxmlformats.org/drawingml/2006/main">
               <a:ext uri="{FF2B5EF4-FFF2-40B4-BE49-F238E27FC236}">
-                <a16:creationId xmlns:a16="http://schemas.microsoft.com/office/drawing/2014/main" id="{13D1936F-0F3A-45E9-8CFC-5DF0A1A8095F}"/>
+                <a16:creationId xmlns:a16="http://schemas.microsoft.com/office/drawing/2014/main" id="{F29AB026-950F-4171-8559-A82CCBF3CFFA}"/>
               </a:ext>
             </a:extLst>
           </p:cNvPr>
@@ -27941,7 +27941,7 @@
           <p:cNvPr id="13" name="">
             <a:extLst xmlns:a="http://schemas.openxmlformats.org/drawingml/2006/main">
               <a:ext uri="{FF2B5EF4-FFF2-40B4-BE49-F238E27FC236}">
-                <a16:creationId xmlns:a16="http://schemas.microsoft.com/office/drawing/2014/main" id="{45D74BFC-72B7-4F99-ADC9-748D432E92FD}"/>
+                <a16:creationId xmlns:a16="http://schemas.microsoft.com/office/drawing/2014/main" id="{081B5370-8174-4BA8-8EF4-D6B8F14FD3EC}"/>
               </a:ext>
             </a:extLst>
           </p:cNvPr>
@@ -28106,7 +28106,7 @@
           <p:cNvPr id="14" name="">
             <a:extLst xmlns:a="http://schemas.openxmlformats.org/drawingml/2006/main">
               <a:ext uri="{FF2B5EF4-FFF2-40B4-BE49-F238E27FC236}">
-                <a16:creationId xmlns:a16="http://schemas.microsoft.com/office/drawing/2014/main" id="{2748F6A9-62E8-441F-B379-C63A4FCFE4FC}"/>
+                <a16:creationId xmlns:a16="http://schemas.microsoft.com/office/drawing/2014/main" id="{8337F65E-54A0-4071-86C0-AA46A416E8F0}"/>
               </a:ext>
             </a:extLst>
           </p:cNvPr>
@@ -28264,7 +28264,7 @@
           <p:cNvPr id="15" name="">
             <a:extLst xmlns:a="http://schemas.openxmlformats.org/drawingml/2006/main">
               <a:ext uri="{FF2B5EF4-FFF2-40B4-BE49-F238E27FC236}">
-                <a16:creationId xmlns:a16="http://schemas.microsoft.com/office/drawing/2014/main" id="{4285A071-E483-4912-B414-ED891560CAA8}"/>
+                <a16:creationId xmlns:a16="http://schemas.microsoft.com/office/drawing/2014/main" id="{B1B7A4CC-51E2-4591-B659-236D33009EAD}"/>
               </a:ext>
             </a:extLst>
           </p:cNvPr>
@@ -28422,7 +28422,7 @@
           <p:cNvPr id="16" name="">
             <a:extLst xmlns:a="http://schemas.openxmlformats.org/drawingml/2006/main">
               <a:ext uri="{FF2B5EF4-FFF2-40B4-BE49-F238E27FC236}">
-                <a16:creationId xmlns:a16="http://schemas.microsoft.com/office/drawing/2014/main" id="{10E12C4F-C5F2-41BA-941F-B72B722B0A96}"/>
+                <a16:creationId xmlns:a16="http://schemas.microsoft.com/office/drawing/2014/main" id="{4AC81138-F6B5-42DC-BBED-077016E97D7A}"/>
               </a:ext>
             </a:extLst>
           </p:cNvPr>
@@ -28587,7 +28587,7 @@
           <p:cNvPr id="17" name="">
             <a:extLst xmlns:a="http://schemas.openxmlformats.org/drawingml/2006/main">
               <a:ext uri="{FF2B5EF4-FFF2-40B4-BE49-F238E27FC236}">
-                <a16:creationId xmlns:a16="http://schemas.microsoft.com/office/drawing/2014/main" id="{F229D0F6-13A3-4E73-946E-C628C8AD39F3}"/>
+                <a16:creationId xmlns:a16="http://schemas.microsoft.com/office/drawing/2014/main" id="{706662D6-B771-44CD-97C6-9B2388AB6279}"/>
               </a:ext>
             </a:extLst>
           </p:cNvPr>
@@ -28745,7 +28745,7 @@
           <p:cNvPr id="18" name="">
             <a:extLst xmlns:a="http://schemas.openxmlformats.org/drawingml/2006/main">
               <a:ext uri="{FF2B5EF4-FFF2-40B4-BE49-F238E27FC236}">
-                <a16:creationId xmlns:a16="http://schemas.microsoft.com/office/drawing/2014/main" id="{13447EA8-1598-4EEE-869E-48E5E879228E}"/>
+                <a16:creationId xmlns:a16="http://schemas.microsoft.com/office/drawing/2014/main" id="{FA1E6525-E79F-47BF-A13F-A61DCEF4ABA0}"/>
               </a:ext>
             </a:extLst>
           </p:cNvPr>
@@ -28901,7 +28901,7 @@
     </p:spTree>
     <p:extLst>
       <p:ext uri="{BB962C8B-B14F-4D97-AF65-F5344CB8AC3E}">
-        <p14:creationId xmlns:p14="http://schemas.microsoft.com/office/powerpoint/2010/main" val="193246916"/>
+        <p14:creationId xmlns:p14="http://schemas.microsoft.com/office/powerpoint/2010/main" val="1519346495"/>
       </p:ext>
     </p:extLst>
   </p:cSld>
@@ -28932,7 +28932,7 @@
           <p:cNvPr id="16" name="">
             <a:extLst xmlns:a="http://schemas.openxmlformats.org/drawingml/2006/main">
               <a:ext uri="{FF2B5EF4-FFF2-40B4-BE49-F238E27FC236}">
-                <a16:creationId xmlns:a16="http://schemas.microsoft.com/office/drawing/2014/main" id="{0A95D97F-B47D-4505-858F-F0BB489866F6}"/>
+                <a16:creationId xmlns:a16="http://schemas.microsoft.com/office/drawing/2014/main" id="{6F50DCBA-47CE-4480-A157-3E775EF77637}"/>
               </a:ext>
             </a:extLst>
           </p:cNvPr>
@@ -28962,7 +28962,7 @@
           <p:cNvPr id="2" name="">
             <a:extLst xmlns:a="http://schemas.openxmlformats.org/drawingml/2006/main">
               <a:ext uri="{FF2B5EF4-FFF2-40B4-BE49-F238E27FC236}">
-                <a16:creationId xmlns:a16="http://schemas.microsoft.com/office/drawing/2014/main" id="{EFD941C2-0773-4757-8D91-2A5BD83AFABF}"/>
+                <a16:creationId xmlns:a16="http://schemas.microsoft.com/office/drawing/2014/main" id="{717C4209-7F19-49C7-A9D2-CE7C0AD39E4F}"/>
               </a:ext>
             </a:extLst>
           </p:cNvPr>
@@ -29120,7 +29120,7 @@
           <p:cNvPr id="3" name="">
             <a:extLst xmlns:a="http://schemas.openxmlformats.org/drawingml/2006/main">
               <a:ext uri="{FF2B5EF4-FFF2-40B4-BE49-F238E27FC236}">
-                <a16:creationId xmlns:a16="http://schemas.microsoft.com/office/drawing/2014/main" id="{71789CF9-7CE6-44F9-B82B-B53A3D0775DB}"/>
+                <a16:creationId xmlns:a16="http://schemas.microsoft.com/office/drawing/2014/main" id="{9EEFACB2-901C-40E3-AC2C-BBA0F55BC9EB}"/>
               </a:ext>
             </a:extLst>
           </p:cNvPr>
@@ -29278,7 +29278,7 @@
           <p:cNvPr id="4" name="">
             <a:extLst xmlns:a="http://schemas.openxmlformats.org/drawingml/2006/main">
               <a:ext uri="{FF2B5EF4-FFF2-40B4-BE49-F238E27FC236}">
-                <a16:creationId xmlns:a16="http://schemas.microsoft.com/office/drawing/2014/main" id="{00A64AF7-AAEE-40CE-B3DD-2AE9D1458333}"/>
+                <a16:creationId xmlns:a16="http://schemas.microsoft.com/office/drawing/2014/main" id="{EF896F71-2571-486D-8768-EA45D8159D4A}"/>
               </a:ext>
             </a:extLst>
           </p:cNvPr>
@@ -29436,7 +29436,7 @@
           <p:cNvPr id="5" name="">
             <a:extLst xmlns:a="http://schemas.openxmlformats.org/drawingml/2006/main">
               <a:ext uri="{FF2B5EF4-FFF2-40B4-BE49-F238E27FC236}">
-                <a16:creationId xmlns:a16="http://schemas.microsoft.com/office/drawing/2014/main" id="{92B1E99B-8C22-4893-9B23-FF8843313AA8}"/>
+                <a16:creationId xmlns:a16="http://schemas.microsoft.com/office/drawing/2014/main" id="{94B88D44-249F-4C2C-8A33-621001366F64}"/>
               </a:ext>
             </a:extLst>
           </p:cNvPr>
@@ -29594,7 +29594,7 @@
           <p:cNvPr id="6" name="">
             <a:extLst xmlns:a="http://schemas.openxmlformats.org/drawingml/2006/main">
               <a:ext uri="{FF2B5EF4-FFF2-40B4-BE49-F238E27FC236}">
-                <a16:creationId xmlns:a16="http://schemas.microsoft.com/office/drawing/2014/main" id="{2F68076B-25B3-4BF8-80A0-D07F85F90DD8}"/>
+                <a16:creationId xmlns:a16="http://schemas.microsoft.com/office/drawing/2014/main" id="{F21D1EA1-A68E-4C8A-A16D-4480822E3AB5}"/>
               </a:ext>
             </a:extLst>
           </p:cNvPr>
@@ -29752,7 +29752,7 @@
           <p:cNvPr id="7" name="">
             <a:extLst xmlns:a="http://schemas.openxmlformats.org/drawingml/2006/main">
               <a:ext uri="{FF2B5EF4-FFF2-40B4-BE49-F238E27FC236}">
-                <a16:creationId xmlns:a16="http://schemas.microsoft.com/office/drawing/2014/main" id="{736C2578-58F2-4B17-A6E7-9DC9B38486BD}"/>
+                <a16:creationId xmlns:a16="http://schemas.microsoft.com/office/drawing/2014/main" id="{87E8C632-001F-432C-BDA5-15B47E419ED6}"/>
               </a:ext>
             </a:extLst>
           </p:cNvPr>
@@ -29910,7 +29910,7 @@
           <p:cNvPr id="8" name="">
             <a:extLst xmlns:a="http://schemas.openxmlformats.org/drawingml/2006/main">
               <a:ext uri="{FF2B5EF4-FFF2-40B4-BE49-F238E27FC236}">
-                <a16:creationId xmlns:a16="http://schemas.microsoft.com/office/drawing/2014/main" id="{48F3546D-8126-481F-8341-2022EA79DBB3}"/>
+                <a16:creationId xmlns:a16="http://schemas.microsoft.com/office/drawing/2014/main" id="{0B2924B8-900E-4F39-9C69-74E34FA51FB0}"/>
               </a:ext>
             </a:extLst>
           </p:cNvPr>
@@ -30068,7 +30068,7 @@
           <p:cNvPr id="9" name="">
             <a:extLst xmlns:a="http://schemas.openxmlformats.org/drawingml/2006/main">
               <a:ext uri="{FF2B5EF4-FFF2-40B4-BE49-F238E27FC236}">
-                <a16:creationId xmlns:a16="http://schemas.microsoft.com/office/drawing/2014/main" id="{61207949-A9D9-415D-BFCB-49374A919B89}"/>
+                <a16:creationId xmlns:a16="http://schemas.microsoft.com/office/drawing/2014/main" id="{948884BE-B2BF-46AB-93D4-32C985E03F6F}"/>
               </a:ext>
             </a:extLst>
           </p:cNvPr>
@@ -30226,7 +30226,7 @@
           <p:cNvPr id="10" name="">
             <a:extLst xmlns:a="http://schemas.openxmlformats.org/drawingml/2006/main">
               <a:ext uri="{FF2B5EF4-FFF2-40B4-BE49-F238E27FC236}">
-                <a16:creationId xmlns:a16="http://schemas.microsoft.com/office/drawing/2014/main" id="{CE4193D5-AC86-475A-8F6D-0010033317F4}"/>
+                <a16:creationId xmlns:a16="http://schemas.microsoft.com/office/drawing/2014/main" id="{A4C5DC11-B4A3-4DC0-9034-3A86C3B5BE0F}"/>
               </a:ext>
             </a:extLst>
           </p:cNvPr>
@@ -30384,7 +30384,7 @@
           <p:cNvPr id="11" name="">
             <a:extLst xmlns:a="http://schemas.openxmlformats.org/drawingml/2006/main">
               <a:ext uri="{FF2B5EF4-FFF2-40B4-BE49-F238E27FC236}">
-                <a16:creationId xmlns:a16="http://schemas.microsoft.com/office/drawing/2014/main" id="{6E0D2CC4-7983-4D27-AE3E-E6A2D820E1C6}"/>
+                <a16:creationId xmlns:a16="http://schemas.microsoft.com/office/drawing/2014/main" id="{D7745CD4-8EE7-4842-A954-4DAF478DD4A1}"/>
               </a:ext>
             </a:extLst>
           </p:cNvPr>
@@ -30542,7 +30542,7 @@
           <p:cNvPr id="12" name="">
             <a:extLst xmlns:a="http://schemas.openxmlformats.org/drawingml/2006/main">
               <a:ext uri="{FF2B5EF4-FFF2-40B4-BE49-F238E27FC236}">
-                <a16:creationId xmlns:a16="http://schemas.microsoft.com/office/drawing/2014/main" id="{C88CD185-EF48-481F-BBDD-651A9C8C8A07}"/>
+                <a16:creationId xmlns:a16="http://schemas.microsoft.com/office/drawing/2014/main" id="{FFEFD701-2349-4303-A735-9DD818391C67}"/>
               </a:ext>
             </a:extLst>
           </p:cNvPr>
@@ -30700,7 +30700,7 @@
           <p:cNvPr id="13" name="">
             <a:extLst xmlns:a="http://schemas.openxmlformats.org/drawingml/2006/main">
               <a:ext uri="{FF2B5EF4-FFF2-40B4-BE49-F238E27FC236}">
-                <a16:creationId xmlns:a16="http://schemas.microsoft.com/office/drawing/2014/main" id="{5DF02BF0-D39F-4D07-99A0-EF974BFCBBB2}"/>
+                <a16:creationId xmlns:a16="http://schemas.microsoft.com/office/drawing/2014/main" id="{DB22A5DA-F1BC-498D-A217-2B338B95987A}"/>
               </a:ext>
             </a:extLst>
           </p:cNvPr>
@@ -30858,7 +30858,7 @@
           <p:cNvPr id="14" name="">
             <a:extLst xmlns:a="http://schemas.openxmlformats.org/drawingml/2006/main">
               <a:ext uri="{FF2B5EF4-FFF2-40B4-BE49-F238E27FC236}">
-                <a16:creationId xmlns:a16="http://schemas.microsoft.com/office/drawing/2014/main" id="{3C38AC2F-D5E5-4B8C-AAD2-003B08957667}"/>
+                <a16:creationId xmlns:a16="http://schemas.microsoft.com/office/drawing/2014/main" id="{AC19797F-AB16-40A1-AC9D-AFEFFD38197E}"/>
               </a:ext>
             </a:extLst>
           </p:cNvPr>
@@ -31016,7 +31016,7 @@
           <p:cNvPr id="15" name="">
             <a:extLst xmlns:a="http://schemas.openxmlformats.org/drawingml/2006/main">
               <a:ext uri="{FF2B5EF4-FFF2-40B4-BE49-F238E27FC236}">
-                <a16:creationId xmlns:a16="http://schemas.microsoft.com/office/drawing/2014/main" id="{523C6292-68A9-4C71-B578-D12D99BD7B99}"/>
+                <a16:creationId xmlns:a16="http://schemas.microsoft.com/office/drawing/2014/main" id="{B90A2202-726D-46A1-AEEA-D123F919288D}"/>
               </a:ext>
             </a:extLst>
           </p:cNvPr>
@@ -31172,7 +31172,7 @@
     </p:spTree>
     <p:extLst>
       <p:ext uri="{BB962C8B-B14F-4D97-AF65-F5344CB8AC3E}">
-        <p14:creationId xmlns:p14="http://schemas.microsoft.com/office/powerpoint/2010/main" val="360847459"/>
+        <p14:creationId xmlns:p14="http://schemas.microsoft.com/office/powerpoint/2010/main" val="1817115236"/>
       </p:ext>
     </p:extLst>
   </p:cSld>
@@ -31203,7 +31203,7 @@
           <p:cNvPr id="9" name="">
             <a:extLst xmlns:a="http://schemas.openxmlformats.org/drawingml/2006/main">
               <a:ext uri="{FF2B5EF4-FFF2-40B4-BE49-F238E27FC236}">
-                <a16:creationId xmlns:a16="http://schemas.microsoft.com/office/drawing/2014/main" id="{170BF175-CF12-4BFE-9F5F-AD8C67939423}"/>
+                <a16:creationId xmlns:a16="http://schemas.microsoft.com/office/drawing/2014/main" id="{135D45DE-26EC-4BE3-A8E7-81DDC2732214}"/>
               </a:ext>
             </a:extLst>
           </p:cNvPr>
@@ -31233,7 +31233,7 @@
           <p:cNvPr id="2" name="">
             <a:extLst xmlns:a="http://schemas.openxmlformats.org/drawingml/2006/main">
               <a:ext uri="{FF2B5EF4-FFF2-40B4-BE49-F238E27FC236}">
-                <a16:creationId xmlns:a16="http://schemas.microsoft.com/office/drawing/2014/main" id="{59931569-FD31-4872-9E92-310B8E71E06F}"/>
+                <a16:creationId xmlns:a16="http://schemas.microsoft.com/office/drawing/2014/main" id="{B262931A-A1F0-4A0C-A55C-1645B58AA5DF}"/>
               </a:ext>
             </a:extLst>
           </p:cNvPr>
@@ -31391,7 +31391,7 @@
           <p:cNvPr id="3" name="">
             <a:extLst xmlns:a="http://schemas.openxmlformats.org/drawingml/2006/main">
               <a:ext uri="{FF2B5EF4-FFF2-40B4-BE49-F238E27FC236}">
-                <a16:creationId xmlns:a16="http://schemas.microsoft.com/office/drawing/2014/main" id="{AB8D1F41-3051-49B8-9413-FF185D653AAC}"/>
+                <a16:creationId xmlns:a16="http://schemas.microsoft.com/office/drawing/2014/main" id="{38960127-E457-4BE3-AE39-58334A5DB048}"/>
               </a:ext>
             </a:extLst>
           </p:cNvPr>
@@ -31549,7 +31549,7 @@
           <p:cNvPr id="4" name="">
             <a:extLst xmlns:a="http://schemas.openxmlformats.org/drawingml/2006/main">
               <a:ext uri="{FF2B5EF4-FFF2-40B4-BE49-F238E27FC236}">
-                <a16:creationId xmlns:a16="http://schemas.microsoft.com/office/drawing/2014/main" id="{97C35E0C-BC24-43AF-9FB1-935DEB24DABD}"/>
+                <a16:creationId xmlns:a16="http://schemas.microsoft.com/office/drawing/2014/main" id="{B056B21A-7603-4873-B929-10EAD3144516}"/>
               </a:ext>
             </a:extLst>
           </p:cNvPr>
@@ -31819,7 +31819,7 @@
           <p:cNvPr id="5" name="">
             <a:extLst xmlns:a="http://schemas.openxmlformats.org/drawingml/2006/main">
               <a:ext uri="{FF2B5EF4-FFF2-40B4-BE49-F238E27FC236}">
-                <a16:creationId xmlns:a16="http://schemas.microsoft.com/office/drawing/2014/main" id="{E687C994-4A95-4882-99D3-6CC8CFC3249D}"/>
+                <a16:creationId xmlns:a16="http://schemas.microsoft.com/office/drawing/2014/main" id="{9F59B3A7-E453-4424-9FF4-BD30FC813459}"/>
               </a:ext>
             </a:extLst>
           </p:cNvPr>
@@ -32007,7 +32007,7 @@
           <p:cNvPr id="6" name="">
             <a:extLst xmlns:a="http://schemas.openxmlformats.org/drawingml/2006/main">
               <a:ext uri="{FF2B5EF4-FFF2-40B4-BE49-F238E27FC236}">
-                <a16:creationId xmlns:a16="http://schemas.microsoft.com/office/drawing/2014/main" id="{CB2CB099-FCDF-4054-972E-1530F3C034F7}"/>
+                <a16:creationId xmlns:a16="http://schemas.microsoft.com/office/drawing/2014/main" id="{43918596-D00A-400F-9484-5001FB59C23F}"/>
               </a:ext>
             </a:extLst>
           </p:cNvPr>
@@ -32195,7 +32195,7 @@
           <p:cNvPr id="7" name="">
             <a:extLst xmlns:a="http://schemas.openxmlformats.org/drawingml/2006/main">
               <a:ext uri="{FF2B5EF4-FFF2-40B4-BE49-F238E27FC236}">
-                <a16:creationId xmlns:a16="http://schemas.microsoft.com/office/drawing/2014/main" id="{8504567C-9DDA-42FD-9DFD-BB1815D7FBA3}"/>
+                <a16:creationId xmlns:a16="http://schemas.microsoft.com/office/drawing/2014/main" id="{8F23A61A-CD23-46D1-9A20-D7B084171AF9}"/>
               </a:ext>
             </a:extLst>
           </p:cNvPr>
@@ -32383,7 +32383,7 @@
           <p:cNvPr id="8" name="">
             <a:extLst xmlns:a="http://schemas.openxmlformats.org/drawingml/2006/main">
               <a:ext uri="{FF2B5EF4-FFF2-40B4-BE49-F238E27FC236}">
-                <a16:creationId xmlns:a16="http://schemas.microsoft.com/office/drawing/2014/main" id="{016B405F-0AEC-4B7A-8BF4-FA24839B29F7}"/>
+                <a16:creationId xmlns:a16="http://schemas.microsoft.com/office/drawing/2014/main" id="{692FC273-4FEF-406F-A78E-2C5691C44D98}"/>
               </a:ext>
             </a:extLst>
           </p:cNvPr>
@@ -32539,7 +32539,7 @@
     </p:spTree>
     <p:extLst>
       <p:ext uri="{BB962C8B-B14F-4D97-AF65-F5344CB8AC3E}">
-        <p14:creationId xmlns:p14="http://schemas.microsoft.com/office/powerpoint/2010/main" val="834830175"/>
+        <p14:creationId xmlns:p14="http://schemas.microsoft.com/office/powerpoint/2010/main" val="595131947"/>
       </p:ext>
     </p:extLst>
   </p:cSld>

</xml_diff>